<commit_message>
docs: clarify admin owns evaluation periods
</commit_message>
<xml_diff>
--- a/docs/MSU-EVA-อบรมสายวิชาการ-ฉบับวิทยากร.pptx
+++ b/docs/MSU-EVA-อบรมสายวิชาการ-ฉบับวิทยากร.pptx
@@ -2,28 +2,28 @@
 <file path=ppt/presentation.xml><?xml version="1.0" encoding="utf-8"?>
 <p:presentation xmlns:p="http://schemas.openxmlformats.org/presentationml/2006/main">
   <p:sldMasterIdLst>
-    <p:sldMasterId xmlns:r="http://schemas.openxmlformats.org/officeDocument/2006/relationships" id="2147483648" r:id="R54e6dcdfb20f4797"/>
+    <p:sldMasterId xmlns:r="http://schemas.openxmlformats.org/officeDocument/2006/relationships" id="2147483648" r:id="R99021c31b38b4d55"/>
   </p:sldMasterIdLst>
   <p:notesMasterIdLst>
-    <p:notesMasterId xmlns:r="http://schemas.openxmlformats.org/officeDocument/2006/relationships" r:id="R1fff17271c9c4c1d"/>
+    <p:notesMasterId xmlns:r="http://schemas.openxmlformats.org/officeDocument/2006/relationships" r:id="Rdf32fbece9df492d"/>
   </p:notesMasterIdLst>
   <p:sldIdLst>
-    <p:sldId xmlns:r="http://schemas.openxmlformats.org/officeDocument/2006/relationships" id="256" r:id="R32379dcc9f9e4b19"/>
-    <p:sldId xmlns:r="http://schemas.openxmlformats.org/officeDocument/2006/relationships" id="257" r:id="R70ef60c332114f00"/>
-    <p:sldId xmlns:r="http://schemas.openxmlformats.org/officeDocument/2006/relationships" id="258" r:id="Rb191716a1a20422a"/>
-    <p:sldId xmlns:r="http://schemas.openxmlformats.org/officeDocument/2006/relationships" id="259" r:id="R4362d3c2c89c4922"/>
-    <p:sldId xmlns:r="http://schemas.openxmlformats.org/officeDocument/2006/relationships" id="260" r:id="R14fe7f64c4444f13"/>
-    <p:sldId xmlns:r="http://schemas.openxmlformats.org/officeDocument/2006/relationships" id="261" r:id="R3865783d164840ef"/>
-    <p:sldId xmlns:r="http://schemas.openxmlformats.org/officeDocument/2006/relationships" id="262" r:id="R3a893490759a4468"/>
-    <p:sldId xmlns:r="http://schemas.openxmlformats.org/officeDocument/2006/relationships" id="263" r:id="Rd63bc9f837bc4370"/>
-    <p:sldId xmlns:r="http://schemas.openxmlformats.org/officeDocument/2006/relationships" id="264" r:id="R6952fcc15739459f"/>
-    <p:sldId xmlns:r="http://schemas.openxmlformats.org/officeDocument/2006/relationships" id="265" r:id="Re6c0df1fc2184e26"/>
-    <p:sldId xmlns:r="http://schemas.openxmlformats.org/officeDocument/2006/relationships" id="266" r:id="R8da3e496a3ef451d"/>
-    <p:sldId xmlns:r="http://schemas.openxmlformats.org/officeDocument/2006/relationships" id="267" r:id="R1b1e9775e31f4862"/>
-    <p:sldId xmlns:r="http://schemas.openxmlformats.org/officeDocument/2006/relationships" id="268" r:id="R9d073fd2ba0240f2"/>
-    <p:sldId xmlns:r="http://schemas.openxmlformats.org/officeDocument/2006/relationships" id="269" r:id="R991d38e6a47e4653"/>
-    <p:sldId xmlns:r="http://schemas.openxmlformats.org/officeDocument/2006/relationships" id="270" r:id="R1875be1f87ea4d8d"/>
-    <p:sldId xmlns:r="http://schemas.openxmlformats.org/officeDocument/2006/relationships" id="271" r:id="Rd80acda6515d4737"/>
+    <p:sldId xmlns:r="http://schemas.openxmlformats.org/officeDocument/2006/relationships" id="256" r:id="R2bc8af4fd37148a4"/>
+    <p:sldId xmlns:r="http://schemas.openxmlformats.org/officeDocument/2006/relationships" id="257" r:id="R7f2df4a22aa44c32"/>
+    <p:sldId xmlns:r="http://schemas.openxmlformats.org/officeDocument/2006/relationships" id="258" r:id="Rdf70a8c98a004301"/>
+    <p:sldId xmlns:r="http://schemas.openxmlformats.org/officeDocument/2006/relationships" id="259" r:id="R4a5bfddb1b874b9a"/>
+    <p:sldId xmlns:r="http://schemas.openxmlformats.org/officeDocument/2006/relationships" id="260" r:id="Rc5a30986f1ce4aaf"/>
+    <p:sldId xmlns:r="http://schemas.openxmlformats.org/officeDocument/2006/relationships" id="261" r:id="Rc296ae0669c94f53"/>
+    <p:sldId xmlns:r="http://schemas.openxmlformats.org/officeDocument/2006/relationships" id="262" r:id="Rd88a5213eb244c20"/>
+    <p:sldId xmlns:r="http://schemas.openxmlformats.org/officeDocument/2006/relationships" id="263" r:id="Re5ed9512873a496d"/>
+    <p:sldId xmlns:r="http://schemas.openxmlformats.org/officeDocument/2006/relationships" id="264" r:id="Rda9992d4db834ee1"/>
+    <p:sldId xmlns:r="http://schemas.openxmlformats.org/officeDocument/2006/relationships" id="265" r:id="R2fa934525db9412d"/>
+    <p:sldId xmlns:r="http://schemas.openxmlformats.org/officeDocument/2006/relationships" id="266" r:id="R2e08ff17b3d84f2b"/>
+    <p:sldId xmlns:r="http://schemas.openxmlformats.org/officeDocument/2006/relationships" id="267" r:id="R12b09154aa474711"/>
+    <p:sldId xmlns:r="http://schemas.openxmlformats.org/officeDocument/2006/relationships" id="268" r:id="R865c88a83a5a44f4"/>
+    <p:sldId xmlns:r="http://schemas.openxmlformats.org/officeDocument/2006/relationships" id="269" r:id="Rcb200849748a4af3"/>
+    <p:sldId xmlns:r="http://schemas.openxmlformats.org/officeDocument/2006/relationships" id="270" r:id="Rdd92d21bc30342a6"/>
+    <p:sldId xmlns:r="http://schemas.openxmlformats.org/officeDocument/2006/relationships" id="271" r:id="R60e956c8da604adc"/>
   </p:sldIdLst>
   <p:sldSz cx="12192000" cy="6858000"/>
   <p:notesSz cx="6858000" cy="9144000"/>
@@ -1287,7 +1287,7 @@
           <a:lstStyle xmlns:a="http://schemas.openxmlformats.org/drawingml/2006/main"/>
           <a:p xmlns:a="http://schemas.openxmlformats.org/drawingml/2006/main">
             <a:r>
-              <a:t>[พูด] เป้าหมายของช่วงเช้าไม่ใช่การจำทุกปุ่ม แต่คือการทำงานหนึ่งรายการให้พร้อมส่ง ทุกท่านจะได้เห็นวิธีเลือกรอบประเมิน กรอกภาระงานและผลงาน แนบหลักฐาน และแยกให้ชัดว่าบันทึกร่างต่างจากส่งแบบประเมินอย่างไร ผู้ที่เคยทดสอบแล้วช่วยตรวจความครบถ้วน ผู้ที่เพิ่งเริ่มให้ทำตามจังหวะของวิทยากร ส่วนผู้บริหารและผู้ประเมินให้สังเกตข้อมูลที่จะได้รับในขั้นถัดไป</a:t>
+              <a:t>[พูด] เป้าหมายของช่วงเช้าไม่ใช่การจำทุกปุ่ม แต่คือการทำงานหนึ่งรายการให้พร้อมส่ง รอบประเมินจะกำหนดโดยผู้ดูแลระบบ ส่วนผู้ใช้งานมีหน้าที่ตรวจสอบว่ารอบและรายการที่ได้รับมอบหมายถูกต้อง จากนั้นเราจะกรอกภาระงานและผลงาน แนบหลักฐาน และแยกให้ชัดว่าบันทึกร่างต่างจากส่งแบบประเมินอย่างไร ผู้ที่เคยทดสอบแล้วช่วยตรวจความครบถ้วน ผู้ที่เพิ่งเริ่มให้ทำตามจังหวะของวิทยากร ส่วนผู้บริหารและผู้ประเมินให้สังเกตข้อมูลที่จะได้รับในขั้นถัดไป</a:t>
             </a:r>
           </a:p>
           <a:p xmlns:a="http://schemas.openxmlformats.org/drawingml/2006/main">
@@ -1572,12 +1572,12 @@
           <a:lstStyle xmlns:a="http://schemas.openxmlformats.org/drawingml/2006/main"/>
           <a:p xmlns:a="http://schemas.openxmlformats.org/drawingml/2006/main">
             <a:r>
-              <a:t>[พูด] จุดเริ่มต้นคือแดชบอร์ดของฉัน ให้ตรวจสามอย่างก่อนเปิดงาน ได้แก่ รอบประเมิน รายการที่ได้รับมอบหมาย และสถานะของงาน หากเลือกผิดรอบหรือเปิดรายการที่สิทธิ์ไม่ตรง ขั้นตอนถัดไปอาจไม่เหมือนที่สาธิต ต่อไปผมจะเปิดหนึ่งรายการให้ดู ทุกท่านยังไม่ต้องทำตาม ให้สังเกตตำแหน่งรอบประเมิน ชื่อรายการ และปุ่มเปิดงาน</a:t>
-            </a:r>
-          </a:p>
-          <a:p xmlns:a="http://schemas.openxmlformats.org/drawingml/2006/main">
-            <a:r>
-              <a:t>[สาธิต] เปิดแดชบอร์ด ตรวจรอบประเมิน แล้วเปิดรายการสายวิชาการที่เตรียมไว้</a:t>
+              <a:t>[พูด] จุดเริ่มต้นคือแดชบอร์ดของฉัน ให้ตรวจสามอย่างก่อนเปิดงาน ได้แก่ รอบประเมินที่ผู้ดูแลระบบกำหนด รายการที่ได้รับมอบหมาย และสถานะของงาน ผู้ใช้งานไม่ต้องเลือกรอบประเมินเอง หากรอบหรือรายการไม่ถูกต้อง ให้แจ้งผู้ดูแลระบบก่อนดำเนินการต่อ ต่อไปผมจะเปิดหนึ่งรายการให้ดู ทุกท่านยังไม่ต้องทำตาม ให้สังเกตตำแหน่งรอบประเมิน ชื่อรายการ และปุ่มเปิดงาน</a:t>
+            </a:r>
+          </a:p>
+          <a:p xmlns:a="http://schemas.openxmlformats.org/drawingml/2006/main">
+            <a:r>
+              <a:t>[สาธิต] เปิดแดชบอร์ด ตรวจสอบรอบประเมินที่ได้รับมอบหมาย แล้วเปิดรายการสายวิชาการที่เตรียมไว้</a:t>
             </a:r>
           </a:p>
           <a:p xmlns:a="http://schemas.openxmlformats.org/drawingml/2006/main">
@@ -2045,7 +2045,7 @@
   </p:cSld>
   <p:clrMap bg1="lt1" tx1="dk1" bg2="lt2" tx2="dk2" accent1="accent1" accent2="accent2" accent3="accent3" accent4="accent4" accent5="accent5" accent6="accent6" hlink="hlink" folHlink="folHlink"/>
   <p:sldLayoutIdLst>
-    <p:sldLayoutId xmlns:r="http://schemas.openxmlformats.org/officeDocument/2006/relationships" id="2147483649" r:id="Rd0c2bfe7bf704b12"/>
+    <p:sldLayoutId xmlns:r="http://schemas.openxmlformats.org/officeDocument/2006/relationships" id="2147483649" r:id="R1e768acf76ae4bd3"/>
   </p:sldLayoutIdLst>
   <p:txStyles>
     <p:titleStyle>
@@ -2600,7 +2600,7 @@
           <p:nvPr/>
         </p:nvPicPr>
         <p:blipFill>
-          <a:blip xmlns:r="http://schemas.openxmlformats.org/officeDocument/2006/relationships" xmlns:a="http://schemas.openxmlformats.org/drawingml/2006/main" r:embed="R7c46f78e0aa043c4"/>
+          <a:blip xmlns:r="http://schemas.openxmlformats.org/officeDocument/2006/relationships" xmlns:a="http://schemas.openxmlformats.org/drawingml/2006/main" r:embed="Rcb5e4453f8c446e7"/>
           <a:srcRect xmlns:a="http://schemas.openxmlformats.org/drawingml/2006/main" l="2579" t="0" r="2579" b="0"/>
           <a:stretch xmlns:a="http://schemas.openxmlformats.org/drawingml/2006/main">
             <a:fillRect l="0" t="0" r="0" b="0"/>
@@ -2621,7 +2621,7 @@
           <p:cNvPr id="2" name="cover-panel">
             <a:extLst xmlns:a="http://schemas.openxmlformats.org/drawingml/2006/main">
               <a:ext uri="{FF2B5EF4-FFF2-40B4-BE49-F238E27FC236}">
-                <a16:creationId xmlns:a16="http://schemas.microsoft.com/office/drawing/2014/main" id="{1972B509-FF21-4575-8F44-CDD5A23997B1}"/>
+                <a16:creationId xmlns:a16="http://schemas.microsoft.com/office/drawing/2014/main" id="{D933ECFE-1EC5-4F52-B11E-2F6D719CAC1B}"/>
               </a:ext>
             </a:extLst>
           </p:cNvPr>
@@ -2652,7 +2652,7 @@
           <p:cNvPr id="3" name="cover-accent">
             <a:extLst xmlns:a="http://schemas.openxmlformats.org/drawingml/2006/main">
               <a:ext uri="{FF2B5EF4-FFF2-40B4-BE49-F238E27FC236}">
-                <a16:creationId xmlns:a16="http://schemas.microsoft.com/office/drawing/2014/main" id="{7F6E7554-2438-461E-BA70-91B22B4BDFE8}"/>
+                <a16:creationId xmlns:a16="http://schemas.microsoft.com/office/drawing/2014/main" id="{2E43BE9E-3227-4129-8B40-3886104530E5}"/>
               </a:ext>
             </a:extLst>
           </p:cNvPr>
@@ -2687,7 +2687,7 @@
           <p:nvPr/>
         </p:nvPicPr>
         <p:blipFill>
-          <a:blip xmlns:r="http://schemas.openxmlformats.org/officeDocument/2006/relationships" xmlns:a="http://schemas.openxmlformats.org/drawingml/2006/main" r:embed="R1f4e300f08e648fe"/>
+          <a:blip xmlns:r="http://schemas.openxmlformats.org/officeDocument/2006/relationships" xmlns:a="http://schemas.openxmlformats.org/drawingml/2006/main" r:embed="R279b62d852ac4f6e"/>
           <a:stretch xmlns:a="http://schemas.openxmlformats.org/drawingml/2006/main"/>
         </p:blipFill>
         <p:spPr>
@@ -2705,7 +2705,7 @@
           <p:cNvPr id="5" name="cover-institution">
             <a:extLst xmlns:a="http://schemas.openxmlformats.org/drawingml/2006/main">
               <a:ext uri="{FF2B5EF4-FFF2-40B4-BE49-F238E27FC236}">
-                <a16:creationId xmlns:a16="http://schemas.microsoft.com/office/drawing/2014/main" id="{07255179-CFED-4BBB-8566-FF30CB93103F}"/>
+                <a16:creationId xmlns:a16="http://schemas.microsoft.com/office/drawing/2014/main" id="{BCB2B5E4-2137-482B-A7F0-092A87D32E61}"/>
               </a:ext>
             </a:extLst>
           </p:cNvPr>
@@ -2767,7 +2767,7 @@
           <p:cNvPr id="6" name="cover-session">
             <a:extLst xmlns:a="http://schemas.openxmlformats.org/drawingml/2006/main">
               <a:ext uri="{FF2B5EF4-FFF2-40B4-BE49-F238E27FC236}">
-                <a16:creationId xmlns:a16="http://schemas.microsoft.com/office/drawing/2014/main" id="{289E15A5-D942-4FB0-A165-67ABD5EFA08F}"/>
+                <a16:creationId xmlns:a16="http://schemas.microsoft.com/office/drawing/2014/main" id="{27FB2FDE-DDB4-400B-AF88-60F79E287122}"/>
               </a:ext>
             </a:extLst>
           </p:cNvPr>
@@ -2829,7 +2829,7 @@
           <p:cNvPr id="7" name="cover-title">
             <a:extLst xmlns:a="http://schemas.openxmlformats.org/drawingml/2006/main">
               <a:ext uri="{FF2B5EF4-FFF2-40B4-BE49-F238E27FC236}">
-                <a16:creationId xmlns:a16="http://schemas.microsoft.com/office/drawing/2014/main" id="{FF1E04BE-D4C0-4E2D-B675-336E085B8BBB}"/>
+                <a16:creationId xmlns:a16="http://schemas.microsoft.com/office/drawing/2014/main" id="{531D7982-9308-4B44-9E94-7B489F820044}"/>
               </a:ext>
             </a:extLst>
           </p:cNvPr>
@@ -2918,7 +2918,7 @@
           <p:cNvPr id="8" name="cover-gold-rule">
             <a:extLst xmlns:a="http://schemas.openxmlformats.org/drawingml/2006/main">
               <a:ext uri="{FF2B5EF4-FFF2-40B4-BE49-F238E27FC236}">
-                <a16:creationId xmlns:a16="http://schemas.microsoft.com/office/drawing/2014/main" id="{CCE71C91-97CE-49EE-A926-3B5A3BA384DF}"/>
+                <a16:creationId xmlns:a16="http://schemas.microsoft.com/office/drawing/2014/main" id="{2DDA3660-538D-46A7-9777-FDD1996302BE}"/>
               </a:ext>
             </a:extLst>
           </p:cNvPr>
@@ -2949,7 +2949,7 @@
           <p:cNvPr id="9" name="cover-promise">
             <a:extLst xmlns:a="http://schemas.openxmlformats.org/drawingml/2006/main">
               <a:ext uri="{FF2B5EF4-FFF2-40B4-BE49-F238E27FC236}">
-                <a16:creationId xmlns:a16="http://schemas.microsoft.com/office/drawing/2014/main" id="{FF22584E-A9B7-4319-B4EA-EE5BA8E8A370}"/>
+                <a16:creationId xmlns:a16="http://schemas.microsoft.com/office/drawing/2014/main" id="{F1D087DB-AECE-44BD-9FCF-83AD674A84B7}"/>
               </a:ext>
             </a:extLst>
           </p:cNvPr>
@@ -3011,7 +3011,7 @@
           <p:cNvPr id="10" name="cover-style">
             <a:extLst xmlns:a="http://schemas.openxmlformats.org/drawingml/2006/main">
               <a:ext uri="{FF2B5EF4-FFF2-40B4-BE49-F238E27FC236}">
-                <a16:creationId xmlns:a16="http://schemas.microsoft.com/office/drawing/2014/main" id="{E0C7972B-1446-4E2A-9D9F-1461D564813E}"/>
+                <a16:creationId xmlns:a16="http://schemas.microsoft.com/office/drawing/2014/main" id="{609EFAE0-403E-44DE-A298-6DC87227E447}"/>
               </a:ext>
             </a:extLst>
           </p:cNvPr>
@@ -3077,7 +3077,7 @@
           <p:nvPr/>
         </p:nvPicPr>
         <p:blipFill>
-          <a:blip xmlns:r="http://schemas.openxmlformats.org/officeDocument/2006/relationships" xmlns:a="http://schemas.openxmlformats.org/drawingml/2006/main" r:embed="R0338ce18b8804f2e"/>
+          <a:blip xmlns:r="http://schemas.openxmlformats.org/officeDocument/2006/relationships" xmlns:a="http://schemas.openxmlformats.org/drawingml/2006/main" r:embed="R3fe55aa9655b4dc5"/>
           <a:stretch xmlns:a="http://schemas.openxmlformats.org/drawingml/2006/main"/>
         </p:blipFill>
         <p:spPr>
@@ -3093,7 +3093,7 @@
     </p:spTree>
     <p:extLst>
       <p:ext uri="{BB962C8B-B14F-4D97-AF65-F5344CB8AC3E}">
-        <p14:creationId xmlns:p14="http://schemas.microsoft.com/office/powerpoint/2010/main" val="1545323287"/>
+        <p14:creationId xmlns:p14="http://schemas.microsoft.com/office/powerpoint/2010/main" val="1901187569"/>
       </p:ext>
     </p:extLst>
   </p:cSld>
@@ -3124,7 +3124,7 @@
           <p:cNvPr id="14" name="side-accent-10">
             <a:extLst xmlns:a="http://schemas.openxmlformats.org/drawingml/2006/main">
               <a:ext uri="{FF2B5EF4-FFF2-40B4-BE49-F238E27FC236}">
-                <a16:creationId xmlns:a16="http://schemas.microsoft.com/office/drawing/2014/main" id="{59993EFB-00FC-4505-A7A7-93570D95B572}"/>
+                <a16:creationId xmlns:a16="http://schemas.microsoft.com/office/drawing/2014/main" id="{2A42A116-53CF-4875-BD9E-90B0A807A921}"/>
               </a:ext>
             </a:extLst>
           </p:cNvPr>
@@ -3155,7 +3155,7 @@
           <p:cNvPr id="2" name="kicker-10">
             <a:extLst xmlns:a="http://schemas.openxmlformats.org/drawingml/2006/main">
               <a:ext uri="{FF2B5EF4-FFF2-40B4-BE49-F238E27FC236}">
-                <a16:creationId xmlns:a16="http://schemas.microsoft.com/office/drawing/2014/main" id="{A4709366-B4A7-4561-83E8-DF2994AF4339}"/>
+                <a16:creationId xmlns:a16="http://schemas.microsoft.com/office/drawing/2014/main" id="{27AC9F3C-3A84-4280-A98A-1EA155D00054}"/>
               </a:ext>
             </a:extLst>
           </p:cNvPr>
@@ -3217,7 +3217,7 @@
           <p:cNvPr id="3" name="title-10">
             <a:extLst xmlns:a="http://schemas.openxmlformats.org/drawingml/2006/main">
               <a:ext uri="{FF2B5EF4-FFF2-40B4-BE49-F238E27FC236}">
-                <a16:creationId xmlns:a16="http://schemas.microsoft.com/office/drawing/2014/main" id="{85DDFD01-A965-4592-8BC5-7E51A15B97E2}"/>
+                <a16:creationId xmlns:a16="http://schemas.microsoft.com/office/drawing/2014/main" id="{964B9EEF-8E8C-46E8-9B6C-4EA4A1C9DD18}"/>
               </a:ext>
             </a:extLst>
           </p:cNvPr>
@@ -3279,7 +3279,7 @@
           <p:cNvPr id="4" name="draft-panel">
             <a:extLst xmlns:a="http://schemas.openxmlformats.org/drawingml/2006/main">
               <a:ext uri="{FF2B5EF4-FFF2-40B4-BE49-F238E27FC236}">
-                <a16:creationId xmlns:a16="http://schemas.microsoft.com/office/drawing/2014/main" id="{C30FF935-8C5F-47CA-8EEA-52453490C8F7}"/>
+                <a16:creationId xmlns:a16="http://schemas.microsoft.com/office/drawing/2014/main" id="{BE33EAA4-D08C-4E6C-9F59-769EF6F9D4D0}"/>
               </a:ext>
             </a:extLst>
           </p:cNvPr>
@@ -3314,7 +3314,7 @@
           <p:cNvPr id="5" name="">
             <a:extLst xmlns:a="http://schemas.openxmlformats.org/drawingml/2006/main">
               <a:ext uri="{FF2B5EF4-FFF2-40B4-BE49-F238E27FC236}">
-                <a16:creationId xmlns:a16="http://schemas.microsoft.com/office/drawing/2014/main" id="{2DEBFB81-CFF6-4C33-AEF8-C9FD7B334BB2}"/>
+                <a16:creationId xmlns:a16="http://schemas.microsoft.com/office/drawing/2014/main" id="{02E48298-2F5B-4AB0-A8C7-295C8F3D1740}"/>
               </a:ext>
             </a:extLst>
           </p:cNvPr>
@@ -3376,7 +3376,7 @@
           <p:cNvPr id="6" name="">
             <a:extLst xmlns:a="http://schemas.openxmlformats.org/drawingml/2006/main">
               <a:ext uri="{FF2B5EF4-FFF2-40B4-BE49-F238E27FC236}">
-                <a16:creationId xmlns:a16="http://schemas.microsoft.com/office/drawing/2014/main" id="{D3ED13B8-F153-46D1-B317-9817057E83DA}"/>
+                <a16:creationId xmlns:a16="http://schemas.microsoft.com/office/drawing/2014/main" id="{AC204051-892A-4B85-A71F-5B55BCB7C6EC}"/>
               </a:ext>
             </a:extLst>
           </p:cNvPr>
@@ -3492,7 +3492,7 @@
           <p:cNvPr id="7" name="submit-panel">
             <a:extLst xmlns:a="http://schemas.openxmlformats.org/drawingml/2006/main">
               <a:ext uri="{FF2B5EF4-FFF2-40B4-BE49-F238E27FC236}">
-                <a16:creationId xmlns:a16="http://schemas.microsoft.com/office/drawing/2014/main" id="{54AADB0C-78B9-4C17-AE7C-B706C5E4AF06}"/>
+                <a16:creationId xmlns:a16="http://schemas.microsoft.com/office/drawing/2014/main" id="{1D458B92-F49B-4242-9996-3ACC08D0D446}"/>
               </a:ext>
             </a:extLst>
           </p:cNvPr>
@@ -3527,7 +3527,7 @@
           <p:cNvPr id="8" name="">
             <a:extLst xmlns:a="http://schemas.openxmlformats.org/drawingml/2006/main">
               <a:ext uri="{FF2B5EF4-FFF2-40B4-BE49-F238E27FC236}">
-                <a16:creationId xmlns:a16="http://schemas.microsoft.com/office/drawing/2014/main" id="{AA880223-0855-4A3A-8B80-E5B7B69213E9}"/>
+                <a16:creationId xmlns:a16="http://schemas.microsoft.com/office/drawing/2014/main" id="{53F88D9A-0E77-4F64-92E9-02A9B5FFAAD9}"/>
               </a:ext>
             </a:extLst>
           </p:cNvPr>
@@ -3589,7 +3589,7 @@
           <p:cNvPr id="9" name="">
             <a:extLst xmlns:a="http://schemas.openxmlformats.org/drawingml/2006/main">
               <a:ext uri="{FF2B5EF4-FFF2-40B4-BE49-F238E27FC236}">
-                <a16:creationId xmlns:a16="http://schemas.microsoft.com/office/drawing/2014/main" id="{C34B7FE8-72BC-4791-9EA3-6FB1EEEDE2AE}"/>
+                <a16:creationId xmlns:a16="http://schemas.microsoft.com/office/drawing/2014/main" id="{B311C435-7F50-43E9-A3F7-DB5893A3F4C6}"/>
               </a:ext>
             </a:extLst>
           </p:cNvPr>
@@ -3705,7 +3705,7 @@
           <p:cNvPr id="10" name="">
             <a:extLst xmlns:a="http://schemas.openxmlformats.org/drawingml/2006/main">
               <a:ext uri="{FF2B5EF4-FFF2-40B4-BE49-F238E27FC236}">
-                <a16:creationId xmlns:a16="http://schemas.microsoft.com/office/drawing/2014/main" id="{89308F3B-E537-467D-BAD3-FDC28408D945}"/>
+                <a16:creationId xmlns:a16="http://schemas.microsoft.com/office/drawing/2014/main" id="{A23C4AB4-956E-4178-B5E6-29E5DB53ABC4}"/>
               </a:ext>
             </a:extLst>
           </p:cNvPr>
@@ -3767,7 +3767,7 @@
           <p:cNvPr id="11" name="footer-rule-10">
             <a:extLst xmlns:a="http://schemas.openxmlformats.org/drawingml/2006/main">
               <a:ext uri="{FF2B5EF4-FFF2-40B4-BE49-F238E27FC236}">
-                <a16:creationId xmlns:a16="http://schemas.microsoft.com/office/drawing/2014/main" id="{05A55A7B-1E11-44B9-9346-9949962CC712}"/>
+                <a16:creationId xmlns:a16="http://schemas.microsoft.com/office/drawing/2014/main" id="{4C0F0850-9C76-4384-BAC2-B1F4ABF6A440}"/>
               </a:ext>
             </a:extLst>
           </p:cNvPr>
@@ -3798,7 +3798,7 @@
           <p:cNvPr id="12" name="footer-label-10">
             <a:extLst xmlns:a="http://schemas.openxmlformats.org/drawingml/2006/main">
               <a:ext uri="{FF2B5EF4-FFF2-40B4-BE49-F238E27FC236}">
-                <a16:creationId xmlns:a16="http://schemas.microsoft.com/office/drawing/2014/main" id="{E6A06A30-FF24-44B0-9EDF-356AAFFF7834}"/>
+                <a16:creationId xmlns:a16="http://schemas.microsoft.com/office/drawing/2014/main" id="{7BE4CD8D-D20E-4361-AC3A-F989EBC9DFA5}"/>
               </a:ext>
             </a:extLst>
           </p:cNvPr>
@@ -3860,7 +3860,7 @@
           <p:cNvPr id="13" name="footer-page-10">
             <a:extLst xmlns:a="http://schemas.openxmlformats.org/drawingml/2006/main">
               <a:ext uri="{FF2B5EF4-FFF2-40B4-BE49-F238E27FC236}">
-                <a16:creationId xmlns:a16="http://schemas.microsoft.com/office/drawing/2014/main" id="{45A73C81-1DCB-4DEA-B285-F6B5018BC820}"/>
+                <a16:creationId xmlns:a16="http://schemas.microsoft.com/office/drawing/2014/main" id="{CD8CB78F-ED47-4E58-A648-3058451003FE}"/>
               </a:ext>
             </a:extLst>
           </p:cNvPr>
@@ -3920,7 +3920,7 @@
     </p:spTree>
     <p:extLst>
       <p:ext uri="{BB962C8B-B14F-4D97-AF65-F5344CB8AC3E}">
-        <p14:creationId xmlns:p14="http://schemas.microsoft.com/office/powerpoint/2010/main" val="217542475"/>
+        <p14:creationId xmlns:p14="http://schemas.microsoft.com/office/powerpoint/2010/main" val="1752571594"/>
       </p:ext>
     </p:extLst>
   </p:cSld>
@@ -3951,7 +3951,7 @@
           <p:cNvPr id="25" name="side-accent-11">
             <a:extLst xmlns:a="http://schemas.openxmlformats.org/drawingml/2006/main">
               <a:ext uri="{FF2B5EF4-FFF2-40B4-BE49-F238E27FC236}">
-                <a16:creationId xmlns:a16="http://schemas.microsoft.com/office/drawing/2014/main" id="{EC01C189-7BCE-4861-979A-F6B7637F956A}"/>
+                <a16:creationId xmlns:a16="http://schemas.microsoft.com/office/drawing/2014/main" id="{905FB47A-5E5C-40D2-A678-7EF946432012}"/>
               </a:ext>
             </a:extLst>
           </p:cNvPr>
@@ -3982,7 +3982,7 @@
           <p:cNvPr id="2" name="kicker-11">
             <a:extLst xmlns:a="http://schemas.openxmlformats.org/drawingml/2006/main">
               <a:ext uri="{FF2B5EF4-FFF2-40B4-BE49-F238E27FC236}">
-                <a16:creationId xmlns:a16="http://schemas.microsoft.com/office/drawing/2014/main" id="{82A4DA38-7D99-4268-8444-B71BBBB2395C}"/>
+                <a16:creationId xmlns:a16="http://schemas.microsoft.com/office/drawing/2014/main" id="{CE00831D-4737-4F1E-AE29-70BB6362F403}"/>
               </a:ext>
             </a:extLst>
           </p:cNvPr>
@@ -4044,7 +4044,7 @@
           <p:cNvPr id="3" name="title-11">
             <a:extLst xmlns:a="http://schemas.openxmlformats.org/drawingml/2006/main">
               <a:ext uri="{FF2B5EF4-FFF2-40B4-BE49-F238E27FC236}">
-                <a16:creationId xmlns:a16="http://schemas.microsoft.com/office/drawing/2014/main" id="{DD505B16-4F49-49CF-A395-8A1699BE4A34}"/>
+                <a16:creationId xmlns:a16="http://schemas.microsoft.com/office/drawing/2014/main" id="{EA203767-059A-4D10-9A6A-BF446ACEC111}"/>
               </a:ext>
             </a:extLst>
           </p:cNvPr>
@@ -4106,7 +4106,7 @@
           <p:cNvPr id="4" name="">
             <a:extLst xmlns:a="http://schemas.openxmlformats.org/drawingml/2006/main">
               <a:ext uri="{FF2B5EF4-FFF2-40B4-BE49-F238E27FC236}">
-                <a16:creationId xmlns:a16="http://schemas.microsoft.com/office/drawing/2014/main" id="{156D9F3C-877B-42B9-9F22-A3D8FD72BF59}"/>
+                <a16:creationId xmlns:a16="http://schemas.microsoft.com/office/drawing/2014/main" id="{797B1A99-DD14-4735-B1B5-923D2C387A36}"/>
               </a:ext>
             </a:extLst>
           </p:cNvPr>
@@ -4137,7 +4137,7 @@
           <p:cNvPr id="5" name="">
             <a:extLst xmlns:a="http://schemas.openxmlformats.org/drawingml/2006/main">
               <a:ext uri="{FF2B5EF4-FFF2-40B4-BE49-F238E27FC236}">
-                <a16:creationId xmlns:a16="http://schemas.microsoft.com/office/drawing/2014/main" id="{C088281D-5175-431D-8371-07CAEE97FD0F}"/>
+                <a16:creationId xmlns:a16="http://schemas.microsoft.com/office/drawing/2014/main" id="{A3B3593F-79FF-49FA-9254-9EB380887A24}"/>
               </a:ext>
             </a:extLst>
           </p:cNvPr>
@@ -4168,7 +4168,7 @@
           <p:cNvPr id="6" name="">
             <a:extLst xmlns:a="http://schemas.openxmlformats.org/drawingml/2006/main">
               <a:ext uri="{FF2B5EF4-FFF2-40B4-BE49-F238E27FC236}">
-                <a16:creationId xmlns:a16="http://schemas.microsoft.com/office/drawing/2014/main" id="{7086A14B-05AD-4C9E-98C5-F7BBC569DDF2}"/>
+                <a16:creationId xmlns:a16="http://schemas.microsoft.com/office/drawing/2014/main" id="{52FACA70-86AC-44F6-A4D4-E9D7511D63E9}"/>
               </a:ext>
             </a:extLst>
           </p:cNvPr>
@@ -4230,7 +4230,7 @@
           <p:cNvPr id="7" name="">
             <a:extLst xmlns:a="http://schemas.openxmlformats.org/drawingml/2006/main">
               <a:ext uri="{FF2B5EF4-FFF2-40B4-BE49-F238E27FC236}">
-                <a16:creationId xmlns:a16="http://schemas.microsoft.com/office/drawing/2014/main" id="{AD9166DB-2917-4C7A-92CA-6371ECCEEFAA}"/>
+                <a16:creationId xmlns:a16="http://schemas.microsoft.com/office/drawing/2014/main" id="{D190D792-3880-4440-8B05-BD150259A8EF}"/>
               </a:ext>
             </a:extLst>
           </p:cNvPr>
@@ -4292,7 +4292,7 @@
           <p:cNvPr id="8" name="">
             <a:extLst xmlns:a="http://schemas.openxmlformats.org/drawingml/2006/main">
               <a:ext uri="{FF2B5EF4-FFF2-40B4-BE49-F238E27FC236}">
-                <a16:creationId xmlns:a16="http://schemas.microsoft.com/office/drawing/2014/main" id="{1A19DEBF-CD3E-49E2-95B9-CEFC83451EED}"/>
+                <a16:creationId xmlns:a16="http://schemas.microsoft.com/office/drawing/2014/main" id="{4A3C980B-FDEA-467A-BABA-DBE21C43D7A1}"/>
               </a:ext>
             </a:extLst>
           </p:cNvPr>
@@ -4354,7 +4354,7 @@
           <p:cNvPr id="9" name="">
             <a:extLst xmlns:a="http://schemas.openxmlformats.org/drawingml/2006/main">
               <a:ext uri="{FF2B5EF4-FFF2-40B4-BE49-F238E27FC236}">
-                <a16:creationId xmlns:a16="http://schemas.microsoft.com/office/drawing/2014/main" id="{598FF8E9-C1E9-4BA4-8C98-0C4D03EB4318}"/>
+                <a16:creationId xmlns:a16="http://schemas.microsoft.com/office/drawing/2014/main" id="{473FCE9D-5DD3-4D1E-A2B7-1167EF1F16F1}"/>
               </a:ext>
             </a:extLst>
           </p:cNvPr>
@@ -4385,7 +4385,7 @@
           <p:cNvPr id="10" name="">
             <a:extLst xmlns:a="http://schemas.openxmlformats.org/drawingml/2006/main">
               <a:ext uri="{FF2B5EF4-FFF2-40B4-BE49-F238E27FC236}">
-                <a16:creationId xmlns:a16="http://schemas.microsoft.com/office/drawing/2014/main" id="{CBF4C04F-C296-4B2F-9CA4-AF228FA661FC}"/>
+                <a16:creationId xmlns:a16="http://schemas.microsoft.com/office/drawing/2014/main" id="{C37A13F1-E82C-4878-BB6E-92C32119105B}"/>
               </a:ext>
             </a:extLst>
           </p:cNvPr>
@@ -4447,7 +4447,7 @@
           <p:cNvPr id="11" name="">
             <a:extLst xmlns:a="http://schemas.openxmlformats.org/drawingml/2006/main">
               <a:ext uri="{FF2B5EF4-FFF2-40B4-BE49-F238E27FC236}">
-                <a16:creationId xmlns:a16="http://schemas.microsoft.com/office/drawing/2014/main" id="{C2E32382-384F-41AE-8919-7B6340F8435D}"/>
+                <a16:creationId xmlns:a16="http://schemas.microsoft.com/office/drawing/2014/main" id="{BE1A49B8-CCC3-4FF0-8CA9-AB263A2E234B}"/>
               </a:ext>
             </a:extLst>
           </p:cNvPr>
@@ -4509,7 +4509,7 @@
           <p:cNvPr id="12" name="">
             <a:extLst xmlns:a="http://schemas.openxmlformats.org/drawingml/2006/main">
               <a:ext uri="{FF2B5EF4-FFF2-40B4-BE49-F238E27FC236}">
-                <a16:creationId xmlns:a16="http://schemas.microsoft.com/office/drawing/2014/main" id="{C784A735-04E3-44A8-A3D4-E144695A58D7}"/>
+                <a16:creationId xmlns:a16="http://schemas.microsoft.com/office/drawing/2014/main" id="{9FFCAE29-2D1E-4337-81F5-F93C36D2E252}"/>
               </a:ext>
             </a:extLst>
           </p:cNvPr>
@@ -4571,7 +4571,7 @@
           <p:cNvPr id="13" name="">
             <a:extLst xmlns:a="http://schemas.openxmlformats.org/drawingml/2006/main">
               <a:ext uri="{FF2B5EF4-FFF2-40B4-BE49-F238E27FC236}">
-                <a16:creationId xmlns:a16="http://schemas.microsoft.com/office/drawing/2014/main" id="{0A079CEA-61CE-4BF2-ABDD-A3342615A0CB}"/>
+                <a16:creationId xmlns:a16="http://schemas.microsoft.com/office/drawing/2014/main" id="{358FFBF9-4B4E-4AC9-BF60-20970113CBC0}"/>
               </a:ext>
             </a:extLst>
           </p:cNvPr>
@@ -4602,7 +4602,7 @@
           <p:cNvPr id="14" name="">
             <a:extLst xmlns:a="http://schemas.openxmlformats.org/drawingml/2006/main">
               <a:ext uri="{FF2B5EF4-FFF2-40B4-BE49-F238E27FC236}">
-                <a16:creationId xmlns:a16="http://schemas.microsoft.com/office/drawing/2014/main" id="{D94AF413-73D3-4B46-8316-C0131F281A98}"/>
+                <a16:creationId xmlns:a16="http://schemas.microsoft.com/office/drawing/2014/main" id="{C6EC9762-AD48-4EE4-86F9-2D42F0C4F097}"/>
               </a:ext>
             </a:extLst>
           </p:cNvPr>
@@ -4664,7 +4664,7 @@
           <p:cNvPr id="15" name="">
             <a:extLst xmlns:a="http://schemas.openxmlformats.org/drawingml/2006/main">
               <a:ext uri="{FF2B5EF4-FFF2-40B4-BE49-F238E27FC236}">
-                <a16:creationId xmlns:a16="http://schemas.microsoft.com/office/drawing/2014/main" id="{7019416E-A771-4EF2-86A1-0330A20AF9E0}"/>
+                <a16:creationId xmlns:a16="http://schemas.microsoft.com/office/drawing/2014/main" id="{F8631F58-7F70-4D7F-85B1-A6847163D4F6}"/>
               </a:ext>
             </a:extLst>
           </p:cNvPr>
@@ -4726,7 +4726,7 @@
           <p:cNvPr id="16" name="">
             <a:extLst xmlns:a="http://schemas.openxmlformats.org/drawingml/2006/main">
               <a:ext uri="{FF2B5EF4-FFF2-40B4-BE49-F238E27FC236}">
-                <a16:creationId xmlns:a16="http://schemas.microsoft.com/office/drawing/2014/main" id="{38574171-8EA4-4416-9882-664B0F7B4890}"/>
+                <a16:creationId xmlns:a16="http://schemas.microsoft.com/office/drawing/2014/main" id="{1A1AFDE3-FA0C-4906-8DF8-4B9B53ED2FCB}"/>
               </a:ext>
             </a:extLst>
           </p:cNvPr>
@@ -4788,7 +4788,7 @@
           <p:cNvPr id="17" name="">
             <a:extLst xmlns:a="http://schemas.openxmlformats.org/drawingml/2006/main">
               <a:ext uri="{FF2B5EF4-FFF2-40B4-BE49-F238E27FC236}">
-                <a16:creationId xmlns:a16="http://schemas.microsoft.com/office/drawing/2014/main" id="{B6098980-0B23-4941-B97A-31596E9A203B}"/>
+                <a16:creationId xmlns:a16="http://schemas.microsoft.com/office/drawing/2014/main" id="{3127554B-9478-4118-AA04-DC0813042877}"/>
               </a:ext>
             </a:extLst>
           </p:cNvPr>
@@ -4819,7 +4819,7 @@
           <p:cNvPr id="18" name="">
             <a:extLst xmlns:a="http://schemas.openxmlformats.org/drawingml/2006/main">
               <a:ext uri="{FF2B5EF4-FFF2-40B4-BE49-F238E27FC236}">
-                <a16:creationId xmlns:a16="http://schemas.microsoft.com/office/drawing/2014/main" id="{076AC9B9-4784-47BF-BB59-894F383BDB75}"/>
+                <a16:creationId xmlns:a16="http://schemas.microsoft.com/office/drawing/2014/main" id="{BA02A725-A99D-4E13-945D-01B6EEFFE5AB}"/>
               </a:ext>
             </a:extLst>
           </p:cNvPr>
@@ -4881,7 +4881,7 @@
           <p:cNvPr id="19" name="">
             <a:extLst xmlns:a="http://schemas.openxmlformats.org/drawingml/2006/main">
               <a:ext uri="{FF2B5EF4-FFF2-40B4-BE49-F238E27FC236}">
-                <a16:creationId xmlns:a16="http://schemas.microsoft.com/office/drawing/2014/main" id="{ED0F9DF8-EAD5-4241-B405-73B0A993542A}"/>
+                <a16:creationId xmlns:a16="http://schemas.microsoft.com/office/drawing/2014/main" id="{A4D2025B-2628-45BF-B0F7-436EC135F17D}"/>
               </a:ext>
             </a:extLst>
           </p:cNvPr>
@@ -4943,7 +4943,7 @@
           <p:cNvPr id="20" name="">
             <a:extLst xmlns:a="http://schemas.openxmlformats.org/drawingml/2006/main">
               <a:ext uri="{FF2B5EF4-FFF2-40B4-BE49-F238E27FC236}">
-                <a16:creationId xmlns:a16="http://schemas.microsoft.com/office/drawing/2014/main" id="{604D1807-E55D-455E-A7CE-DE9F26728175}"/>
+                <a16:creationId xmlns:a16="http://schemas.microsoft.com/office/drawing/2014/main" id="{93549E2C-B70D-4E71-9BF1-934EDAAE5A00}"/>
               </a:ext>
             </a:extLst>
           </p:cNvPr>
@@ -5005,7 +5005,7 @@
           <p:cNvPr id="21" name="">
             <a:extLst xmlns:a="http://schemas.openxmlformats.org/drawingml/2006/main">
               <a:ext uri="{FF2B5EF4-FFF2-40B4-BE49-F238E27FC236}">
-                <a16:creationId xmlns:a16="http://schemas.microsoft.com/office/drawing/2014/main" id="{6E8354B8-08E0-457E-B34D-B2BAB56911A8}"/>
+                <a16:creationId xmlns:a16="http://schemas.microsoft.com/office/drawing/2014/main" id="{044B5596-71AB-4859-97DB-CB8A416F4739}"/>
               </a:ext>
             </a:extLst>
           </p:cNvPr>
@@ -5067,7 +5067,7 @@
           <p:cNvPr id="22" name="footer-rule-11">
             <a:extLst xmlns:a="http://schemas.openxmlformats.org/drawingml/2006/main">
               <a:ext uri="{FF2B5EF4-FFF2-40B4-BE49-F238E27FC236}">
-                <a16:creationId xmlns:a16="http://schemas.microsoft.com/office/drawing/2014/main" id="{AA065F90-FD23-4E1C-B9B7-722FFEA5B482}"/>
+                <a16:creationId xmlns:a16="http://schemas.microsoft.com/office/drawing/2014/main" id="{F2C36D89-8319-45C4-A750-78B93EAF2571}"/>
               </a:ext>
             </a:extLst>
           </p:cNvPr>
@@ -5098,7 +5098,7 @@
           <p:cNvPr id="23" name="footer-label-11">
             <a:extLst xmlns:a="http://schemas.openxmlformats.org/drawingml/2006/main">
               <a:ext uri="{FF2B5EF4-FFF2-40B4-BE49-F238E27FC236}">
-                <a16:creationId xmlns:a16="http://schemas.microsoft.com/office/drawing/2014/main" id="{97250880-9326-4A63-A4EC-63392B180F1D}"/>
+                <a16:creationId xmlns:a16="http://schemas.microsoft.com/office/drawing/2014/main" id="{B9C55A43-A3A6-447E-AB82-C7EE7A5365CC}"/>
               </a:ext>
             </a:extLst>
           </p:cNvPr>
@@ -5160,7 +5160,7 @@
           <p:cNvPr id="24" name="footer-page-11">
             <a:extLst xmlns:a="http://schemas.openxmlformats.org/drawingml/2006/main">
               <a:ext uri="{FF2B5EF4-FFF2-40B4-BE49-F238E27FC236}">
-                <a16:creationId xmlns:a16="http://schemas.microsoft.com/office/drawing/2014/main" id="{FB4BEF8B-F339-428A-BF3E-6B7155757853}"/>
+                <a16:creationId xmlns:a16="http://schemas.microsoft.com/office/drawing/2014/main" id="{71CB2021-CC71-4DB6-916A-3ACEEEDF6421}"/>
               </a:ext>
             </a:extLst>
           </p:cNvPr>
@@ -5220,7 +5220,7 @@
     </p:spTree>
     <p:extLst>
       <p:ext uri="{BB962C8B-B14F-4D97-AF65-F5344CB8AC3E}">
-        <p14:creationId xmlns:p14="http://schemas.microsoft.com/office/powerpoint/2010/main" val="429530263"/>
+        <p14:creationId xmlns:p14="http://schemas.microsoft.com/office/powerpoint/2010/main" val="1298910819"/>
       </p:ext>
     </p:extLst>
   </p:cSld>
@@ -5251,7 +5251,7 @@
           <p:cNvPr id="24" name="side-accent-12">
             <a:extLst xmlns:a="http://schemas.openxmlformats.org/drawingml/2006/main">
               <a:ext uri="{FF2B5EF4-FFF2-40B4-BE49-F238E27FC236}">
-                <a16:creationId xmlns:a16="http://schemas.microsoft.com/office/drawing/2014/main" id="{A112D3DC-00D7-4121-B5D3-EEADE05728C1}"/>
+                <a16:creationId xmlns:a16="http://schemas.microsoft.com/office/drawing/2014/main" id="{72B3D41B-E7BF-41EE-B792-ED06659FEC01}"/>
               </a:ext>
             </a:extLst>
           </p:cNvPr>
@@ -5282,7 +5282,7 @@
           <p:cNvPr id="2" name="kicker-12">
             <a:extLst xmlns:a="http://schemas.openxmlformats.org/drawingml/2006/main">
               <a:ext uri="{FF2B5EF4-FFF2-40B4-BE49-F238E27FC236}">
-                <a16:creationId xmlns:a16="http://schemas.microsoft.com/office/drawing/2014/main" id="{66592450-0F3B-400D-BBF8-96615B6166B0}"/>
+                <a16:creationId xmlns:a16="http://schemas.microsoft.com/office/drawing/2014/main" id="{105A2C5C-C262-4881-A7B4-0893BF17F793}"/>
               </a:ext>
             </a:extLst>
           </p:cNvPr>
@@ -5344,7 +5344,7 @@
           <p:cNvPr id="3" name="title-12">
             <a:extLst xmlns:a="http://schemas.openxmlformats.org/drawingml/2006/main">
               <a:ext uri="{FF2B5EF4-FFF2-40B4-BE49-F238E27FC236}">
-                <a16:creationId xmlns:a16="http://schemas.microsoft.com/office/drawing/2014/main" id="{70F0CD9E-F55C-485A-A729-BCAB65BDC5D2}"/>
+                <a16:creationId xmlns:a16="http://schemas.microsoft.com/office/drawing/2014/main" id="{52B3002D-68B8-4314-AC6C-577FFBA8A78C}"/>
               </a:ext>
             </a:extLst>
           </p:cNvPr>
@@ -5406,7 +5406,7 @@
           <p:cNvPr id="4" name="">
             <a:extLst xmlns:a="http://schemas.openxmlformats.org/drawingml/2006/main">
               <a:ext uri="{FF2B5EF4-FFF2-40B4-BE49-F238E27FC236}">
-                <a16:creationId xmlns:a16="http://schemas.microsoft.com/office/drawing/2014/main" id="{8B81E2BF-7DA2-499F-B514-E50E3F90D001}"/>
+                <a16:creationId xmlns:a16="http://schemas.microsoft.com/office/drawing/2014/main" id="{FFD4DB5B-88FA-42DA-B76A-436F5FC2C6B1}"/>
               </a:ext>
             </a:extLst>
           </p:cNvPr>
@@ -5468,7 +5468,7 @@
           <p:cNvPr id="5" name="">
             <a:extLst xmlns:a="http://schemas.openxmlformats.org/drawingml/2006/main">
               <a:ext uri="{FF2B5EF4-FFF2-40B4-BE49-F238E27FC236}">
-                <a16:creationId xmlns:a16="http://schemas.microsoft.com/office/drawing/2014/main" id="{527EE8DA-7678-4798-9A38-CF57FF4B0677}"/>
+                <a16:creationId xmlns:a16="http://schemas.microsoft.com/office/drawing/2014/main" id="{0E72688F-58D3-4A9D-ABEF-9856155DEA83}"/>
               </a:ext>
             </a:extLst>
           </p:cNvPr>
@@ -5530,7 +5530,7 @@
           <p:cNvPr id="6" name="">
             <a:extLst xmlns:a="http://schemas.openxmlformats.org/drawingml/2006/main">
               <a:ext uri="{FF2B5EF4-FFF2-40B4-BE49-F238E27FC236}">
-                <a16:creationId xmlns:a16="http://schemas.microsoft.com/office/drawing/2014/main" id="{DA91BE02-DEE3-4067-AFA7-1C51C5FE2F95}"/>
+                <a16:creationId xmlns:a16="http://schemas.microsoft.com/office/drawing/2014/main" id="{4EB279D0-071D-448F-B639-42A22082E5D7}"/>
               </a:ext>
             </a:extLst>
           </p:cNvPr>
@@ -5592,7 +5592,7 @@
           <p:cNvPr id="7" name="">
             <a:extLst xmlns:a="http://schemas.openxmlformats.org/drawingml/2006/main">
               <a:ext uri="{FF2B5EF4-FFF2-40B4-BE49-F238E27FC236}">
-                <a16:creationId xmlns:a16="http://schemas.microsoft.com/office/drawing/2014/main" id="{F4F30DDC-811E-465B-8FB4-28E84EE796F0}"/>
+                <a16:creationId xmlns:a16="http://schemas.microsoft.com/office/drawing/2014/main" id="{FC2042B8-9E2E-497C-B443-E92DB4C7396F}"/>
               </a:ext>
             </a:extLst>
           </p:cNvPr>
@@ -5623,7 +5623,7 @@
           <p:cNvPr id="8" name="">
             <a:extLst xmlns:a="http://schemas.openxmlformats.org/drawingml/2006/main">
               <a:ext uri="{FF2B5EF4-FFF2-40B4-BE49-F238E27FC236}">
-                <a16:creationId xmlns:a16="http://schemas.microsoft.com/office/drawing/2014/main" id="{BB62863C-7CD9-4509-8094-DDB1C6B90769}"/>
+                <a16:creationId xmlns:a16="http://schemas.microsoft.com/office/drawing/2014/main" id="{AE7F6005-F64D-475F-B74E-87ED3F2AD125}"/>
               </a:ext>
             </a:extLst>
           </p:cNvPr>
@@ -5685,7 +5685,7 @@
           <p:cNvPr id="9" name="">
             <a:extLst xmlns:a="http://schemas.openxmlformats.org/drawingml/2006/main">
               <a:ext uri="{FF2B5EF4-FFF2-40B4-BE49-F238E27FC236}">
-                <a16:creationId xmlns:a16="http://schemas.microsoft.com/office/drawing/2014/main" id="{C261C490-584D-48BE-AD4A-38FFA705BA85}"/>
+                <a16:creationId xmlns:a16="http://schemas.microsoft.com/office/drawing/2014/main" id="{1B4286E5-87AF-475F-B9DE-1D12FCA2FFC3}"/>
               </a:ext>
             </a:extLst>
           </p:cNvPr>
@@ -5747,7 +5747,7 @@
           <p:cNvPr id="10" name="">
             <a:extLst xmlns:a="http://schemas.openxmlformats.org/drawingml/2006/main">
               <a:ext uri="{FF2B5EF4-FFF2-40B4-BE49-F238E27FC236}">
-                <a16:creationId xmlns:a16="http://schemas.microsoft.com/office/drawing/2014/main" id="{97FBA188-167E-4D68-B102-BDFC253B32D8}"/>
+                <a16:creationId xmlns:a16="http://schemas.microsoft.com/office/drawing/2014/main" id="{4ED2DB2B-D498-4327-ADFA-24ED6A7EC470}"/>
               </a:ext>
             </a:extLst>
           </p:cNvPr>
@@ -5809,7 +5809,7 @@
           <p:cNvPr id="11" name="">
             <a:extLst xmlns:a="http://schemas.openxmlformats.org/drawingml/2006/main">
               <a:ext uri="{FF2B5EF4-FFF2-40B4-BE49-F238E27FC236}">
-                <a16:creationId xmlns:a16="http://schemas.microsoft.com/office/drawing/2014/main" id="{1A535307-930A-4FC5-936B-76ECF4672E62}"/>
+                <a16:creationId xmlns:a16="http://schemas.microsoft.com/office/drawing/2014/main" id="{26F215E8-1533-4F15-BBB2-B938737C2D82}"/>
               </a:ext>
             </a:extLst>
           </p:cNvPr>
@@ -5840,7 +5840,7 @@
           <p:cNvPr id="12" name="">
             <a:extLst xmlns:a="http://schemas.openxmlformats.org/drawingml/2006/main">
               <a:ext uri="{FF2B5EF4-FFF2-40B4-BE49-F238E27FC236}">
-                <a16:creationId xmlns:a16="http://schemas.microsoft.com/office/drawing/2014/main" id="{AE59AD2B-3884-4802-85AD-484A7AFF8A2D}"/>
+                <a16:creationId xmlns:a16="http://schemas.microsoft.com/office/drawing/2014/main" id="{913DFD85-4117-4ED3-8DC4-8D4FDF278639}"/>
               </a:ext>
             </a:extLst>
           </p:cNvPr>
@@ -5902,7 +5902,7 @@
           <p:cNvPr id="13" name="">
             <a:extLst xmlns:a="http://schemas.openxmlformats.org/drawingml/2006/main">
               <a:ext uri="{FF2B5EF4-FFF2-40B4-BE49-F238E27FC236}">
-                <a16:creationId xmlns:a16="http://schemas.microsoft.com/office/drawing/2014/main" id="{FD564CDF-2F45-47B6-9826-920ECCA0535A}"/>
+                <a16:creationId xmlns:a16="http://schemas.microsoft.com/office/drawing/2014/main" id="{535DEAF5-95D1-4286-8D89-321BBEA6E573}"/>
               </a:ext>
             </a:extLst>
           </p:cNvPr>
@@ -5964,7 +5964,7 @@
           <p:cNvPr id="14" name="">
             <a:extLst xmlns:a="http://schemas.openxmlformats.org/drawingml/2006/main">
               <a:ext uri="{FF2B5EF4-FFF2-40B4-BE49-F238E27FC236}">
-                <a16:creationId xmlns:a16="http://schemas.microsoft.com/office/drawing/2014/main" id="{C635BC57-2E24-4B37-BCEA-A1A5004D3160}"/>
+                <a16:creationId xmlns:a16="http://schemas.microsoft.com/office/drawing/2014/main" id="{9DAB29DC-17E6-4291-BDA3-087509DCBCC0}"/>
               </a:ext>
             </a:extLst>
           </p:cNvPr>
@@ -6026,7 +6026,7 @@
           <p:cNvPr id="15" name="">
             <a:extLst xmlns:a="http://schemas.openxmlformats.org/drawingml/2006/main">
               <a:ext uri="{FF2B5EF4-FFF2-40B4-BE49-F238E27FC236}">
-                <a16:creationId xmlns:a16="http://schemas.microsoft.com/office/drawing/2014/main" id="{DA6D585D-3853-49B4-AEF8-A9FDEA14B1A3}"/>
+                <a16:creationId xmlns:a16="http://schemas.microsoft.com/office/drawing/2014/main" id="{6F468F41-9BB2-415B-8FA2-889033B53AB5}"/>
               </a:ext>
             </a:extLst>
           </p:cNvPr>
@@ -6057,7 +6057,7 @@
           <p:cNvPr id="16" name="">
             <a:extLst xmlns:a="http://schemas.openxmlformats.org/drawingml/2006/main">
               <a:ext uri="{FF2B5EF4-FFF2-40B4-BE49-F238E27FC236}">
-                <a16:creationId xmlns:a16="http://schemas.microsoft.com/office/drawing/2014/main" id="{45DD9ED6-1E43-46C4-8A76-9221171EB816}"/>
+                <a16:creationId xmlns:a16="http://schemas.microsoft.com/office/drawing/2014/main" id="{87790B24-8555-47F3-8555-6421F19AA974}"/>
               </a:ext>
             </a:extLst>
           </p:cNvPr>
@@ -6119,7 +6119,7 @@
           <p:cNvPr id="17" name="">
             <a:extLst xmlns:a="http://schemas.openxmlformats.org/drawingml/2006/main">
               <a:ext uri="{FF2B5EF4-FFF2-40B4-BE49-F238E27FC236}">
-                <a16:creationId xmlns:a16="http://schemas.microsoft.com/office/drawing/2014/main" id="{3C7C9107-A4B6-48EA-B456-12233400CC6F}"/>
+                <a16:creationId xmlns:a16="http://schemas.microsoft.com/office/drawing/2014/main" id="{43756E16-6182-4831-967A-512D5F1B7542}"/>
               </a:ext>
             </a:extLst>
           </p:cNvPr>
@@ -6181,7 +6181,7 @@
           <p:cNvPr id="18" name="">
             <a:extLst xmlns:a="http://schemas.openxmlformats.org/drawingml/2006/main">
               <a:ext uri="{FF2B5EF4-FFF2-40B4-BE49-F238E27FC236}">
-                <a16:creationId xmlns:a16="http://schemas.microsoft.com/office/drawing/2014/main" id="{73340E41-D546-4256-9C91-A429BE2472E6}"/>
+                <a16:creationId xmlns:a16="http://schemas.microsoft.com/office/drawing/2014/main" id="{CE79F59F-AAF7-4C73-A85C-7929FB6A8211}"/>
               </a:ext>
             </a:extLst>
           </p:cNvPr>
@@ -6243,7 +6243,7 @@
           <p:cNvPr id="19" name="">
             <a:extLst xmlns:a="http://schemas.openxmlformats.org/drawingml/2006/main">
               <a:ext uri="{FF2B5EF4-FFF2-40B4-BE49-F238E27FC236}">
-                <a16:creationId xmlns:a16="http://schemas.microsoft.com/office/drawing/2014/main" id="{7E9749C3-003D-4F30-A043-412162C79E30}"/>
+                <a16:creationId xmlns:a16="http://schemas.microsoft.com/office/drawing/2014/main" id="{E9ED053B-8262-46B7-AE17-126CB7CAE334}"/>
               </a:ext>
             </a:extLst>
           </p:cNvPr>
@@ -6276,7 +6276,7 @@
           <p:cNvPr id="20" name="">
             <a:extLst xmlns:a="http://schemas.openxmlformats.org/drawingml/2006/main">
               <a:ext uri="{FF2B5EF4-FFF2-40B4-BE49-F238E27FC236}">
-                <a16:creationId xmlns:a16="http://schemas.microsoft.com/office/drawing/2014/main" id="{53FCA283-B7DC-4D46-8974-8BAEE0755AAB}"/>
+                <a16:creationId xmlns:a16="http://schemas.microsoft.com/office/drawing/2014/main" id="{E7DA12CC-4246-4417-8183-509641F98106}"/>
               </a:ext>
             </a:extLst>
           </p:cNvPr>
@@ -6338,7 +6338,7 @@
           <p:cNvPr id="21" name="footer-rule-12">
             <a:extLst xmlns:a="http://schemas.openxmlformats.org/drawingml/2006/main">
               <a:ext uri="{FF2B5EF4-FFF2-40B4-BE49-F238E27FC236}">
-                <a16:creationId xmlns:a16="http://schemas.microsoft.com/office/drawing/2014/main" id="{6CAC213C-EABB-4C17-9FE4-6F78D9C6783B}"/>
+                <a16:creationId xmlns:a16="http://schemas.microsoft.com/office/drawing/2014/main" id="{E84259E0-5C12-475C-B4EA-1754E7E49D89}"/>
               </a:ext>
             </a:extLst>
           </p:cNvPr>
@@ -6369,7 +6369,7 @@
           <p:cNvPr id="22" name="footer-label-12">
             <a:extLst xmlns:a="http://schemas.openxmlformats.org/drawingml/2006/main">
               <a:ext uri="{FF2B5EF4-FFF2-40B4-BE49-F238E27FC236}">
-                <a16:creationId xmlns:a16="http://schemas.microsoft.com/office/drawing/2014/main" id="{3630077A-804B-4932-902E-962C0E401285}"/>
+                <a16:creationId xmlns:a16="http://schemas.microsoft.com/office/drawing/2014/main" id="{C52A09ED-D14B-42D7-93D0-823998DFE6D3}"/>
               </a:ext>
             </a:extLst>
           </p:cNvPr>
@@ -6431,7 +6431,7 @@
           <p:cNvPr id="23" name="footer-page-12">
             <a:extLst xmlns:a="http://schemas.openxmlformats.org/drawingml/2006/main">
               <a:ext uri="{FF2B5EF4-FFF2-40B4-BE49-F238E27FC236}">
-                <a16:creationId xmlns:a16="http://schemas.microsoft.com/office/drawing/2014/main" id="{E8020650-FD1B-4F00-8A52-4C35E1AB99F3}"/>
+                <a16:creationId xmlns:a16="http://schemas.microsoft.com/office/drawing/2014/main" id="{451F8ADD-EDA6-419B-99CD-E2D1C3D5B158}"/>
               </a:ext>
             </a:extLst>
           </p:cNvPr>
@@ -6491,7 +6491,7 @@
     </p:spTree>
     <p:extLst>
       <p:ext uri="{BB962C8B-B14F-4D97-AF65-F5344CB8AC3E}">
-        <p14:creationId xmlns:p14="http://schemas.microsoft.com/office/powerpoint/2010/main" val="256699700"/>
+        <p14:creationId xmlns:p14="http://schemas.microsoft.com/office/powerpoint/2010/main" val="741767953"/>
       </p:ext>
     </p:extLst>
   </p:cSld>
@@ -6522,7 +6522,7 @@
           <p:cNvPr id="21" name="side-accent-13">
             <a:extLst xmlns:a="http://schemas.openxmlformats.org/drawingml/2006/main">
               <a:ext uri="{FF2B5EF4-FFF2-40B4-BE49-F238E27FC236}">
-                <a16:creationId xmlns:a16="http://schemas.microsoft.com/office/drawing/2014/main" id="{D3F850A8-2CC7-409A-92C3-E72A2CCFFBFD}"/>
+                <a16:creationId xmlns:a16="http://schemas.microsoft.com/office/drawing/2014/main" id="{458AE651-C05E-4775-BBC2-D6A1C15B3CFE}"/>
               </a:ext>
             </a:extLst>
           </p:cNvPr>
@@ -6553,7 +6553,7 @@
           <p:cNvPr id="2" name="kicker-13">
             <a:extLst xmlns:a="http://schemas.openxmlformats.org/drawingml/2006/main">
               <a:ext uri="{FF2B5EF4-FFF2-40B4-BE49-F238E27FC236}">
-                <a16:creationId xmlns:a16="http://schemas.microsoft.com/office/drawing/2014/main" id="{5B1AAE7E-52E0-4CCC-99A7-E464DD017A33}"/>
+                <a16:creationId xmlns:a16="http://schemas.microsoft.com/office/drawing/2014/main" id="{183A4187-C6E8-469D-BA50-F4F4237B00AF}"/>
               </a:ext>
             </a:extLst>
           </p:cNvPr>
@@ -6615,7 +6615,7 @@
           <p:cNvPr id="3" name="title-13">
             <a:extLst xmlns:a="http://schemas.openxmlformats.org/drawingml/2006/main">
               <a:ext uri="{FF2B5EF4-FFF2-40B4-BE49-F238E27FC236}">
-                <a16:creationId xmlns:a16="http://schemas.microsoft.com/office/drawing/2014/main" id="{7A9B6B49-C754-4497-A8D5-D696AA9BD9E8}"/>
+                <a16:creationId xmlns:a16="http://schemas.microsoft.com/office/drawing/2014/main" id="{5A8EE055-9D09-425F-B3E0-81FB39A51783}"/>
               </a:ext>
             </a:extLst>
           </p:cNvPr>
@@ -6677,7 +6677,7 @@
           <p:cNvPr id="4" name="">
             <a:extLst xmlns:a="http://schemas.openxmlformats.org/drawingml/2006/main">
               <a:ext uri="{FF2B5EF4-FFF2-40B4-BE49-F238E27FC236}">
-                <a16:creationId xmlns:a16="http://schemas.microsoft.com/office/drawing/2014/main" id="{2038749D-EA5A-45EB-AA77-66B5851BD89C}"/>
+                <a16:creationId xmlns:a16="http://schemas.microsoft.com/office/drawing/2014/main" id="{094DFBF2-13E1-48EE-A1D0-C712F69FDC4C}"/>
               </a:ext>
             </a:extLst>
           </p:cNvPr>
@@ -6708,7 +6708,7 @@
           <p:cNvPr id="5" name="">
             <a:extLst xmlns:a="http://schemas.openxmlformats.org/drawingml/2006/main">
               <a:ext uri="{FF2B5EF4-FFF2-40B4-BE49-F238E27FC236}">
-                <a16:creationId xmlns:a16="http://schemas.microsoft.com/office/drawing/2014/main" id="{1788A556-9024-41C9-BC67-9890884D6B56}"/>
+                <a16:creationId xmlns:a16="http://schemas.microsoft.com/office/drawing/2014/main" id="{C297C346-DB95-433A-BE08-CD7736385F7A}"/>
               </a:ext>
             </a:extLst>
           </p:cNvPr>
@@ -6739,7 +6739,7 @@
           <p:cNvPr id="6" name="">
             <a:extLst xmlns:a="http://schemas.openxmlformats.org/drawingml/2006/main">
               <a:ext uri="{FF2B5EF4-FFF2-40B4-BE49-F238E27FC236}">
-                <a16:creationId xmlns:a16="http://schemas.microsoft.com/office/drawing/2014/main" id="{73A6F23C-AD75-4D37-AA48-8036AF5B201A}"/>
+                <a16:creationId xmlns:a16="http://schemas.microsoft.com/office/drawing/2014/main" id="{5DBA852F-DC4D-4907-B636-6415A5E58128}"/>
               </a:ext>
             </a:extLst>
           </p:cNvPr>
@@ -6801,7 +6801,7 @@
           <p:cNvPr id="7" name="">
             <a:extLst xmlns:a="http://schemas.openxmlformats.org/drawingml/2006/main">
               <a:ext uri="{FF2B5EF4-FFF2-40B4-BE49-F238E27FC236}">
-                <a16:creationId xmlns:a16="http://schemas.microsoft.com/office/drawing/2014/main" id="{FEDFCA32-07D0-4064-A5EC-B76B9C1DBA50}"/>
+                <a16:creationId xmlns:a16="http://schemas.microsoft.com/office/drawing/2014/main" id="{08C908DE-A783-4E35-8A64-0A781CB82B27}"/>
               </a:ext>
             </a:extLst>
           </p:cNvPr>
@@ -6863,7 +6863,7 @@
           <p:cNvPr id="8" name="">
             <a:extLst xmlns:a="http://schemas.openxmlformats.org/drawingml/2006/main">
               <a:ext uri="{FF2B5EF4-FFF2-40B4-BE49-F238E27FC236}">
-                <a16:creationId xmlns:a16="http://schemas.microsoft.com/office/drawing/2014/main" id="{AFA56DBB-9A19-45D4-9E19-61388E90AA1D}"/>
+                <a16:creationId xmlns:a16="http://schemas.microsoft.com/office/drawing/2014/main" id="{4D52C448-E088-4E4A-AE7B-C8C523F181A5}"/>
               </a:ext>
             </a:extLst>
           </p:cNvPr>
@@ -6925,7 +6925,7 @@
           <p:cNvPr id="9" name="">
             <a:extLst xmlns:a="http://schemas.openxmlformats.org/drawingml/2006/main">
               <a:ext uri="{FF2B5EF4-FFF2-40B4-BE49-F238E27FC236}">
-                <a16:creationId xmlns:a16="http://schemas.microsoft.com/office/drawing/2014/main" id="{795D401A-DC0A-4C39-96C7-EF7AB71559DF}"/>
+                <a16:creationId xmlns:a16="http://schemas.microsoft.com/office/drawing/2014/main" id="{49970407-37F0-45EA-B504-541B65E824EE}"/>
               </a:ext>
             </a:extLst>
           </p:cNvPr>
@@ -6956,7 +6956,7 @@
           <p:cNvPr id="10" name="">
             <a:extLst xmlns:a="http://schemas.openxmlformats.org/drawingml/2006/main">
               <a:ext uri="{FF2B5EF4-FFF2-40B4-BE49-F238E27FC236}">
-                <a16:creationId xmlns:a16="http://schemas.microsoft.com/office/drawing/2014/main" id="{EE40D6A1-EB78-477E-8798-E703CCEED2EE}"/>
+                <a16:creationId xmlns:a16="http://schemas.microsoft.com/office/drawing/2014/main" id="{82B0983F-2A2E-44CF-BBEE-365AE99447A1}"/>
               </a:ext>
             </a:extLst>
           </p:cNvPr>
@@ -7018,7 +7018,7 @@
           <p:cNvPr id="11" name="">
             <a:extLst xmlns:a="http://schemas.openxmlformats.org/drawingml/2006/main">
               <a:ext uri="{FF2B5EF4-FFF2-40B4-BE49-F238E27FC236}">
-                <a16:creationId xmlns:a16="http://schemas.microsoft.com/office/drawing/2014/main" id="{ADAA2E09-BE0A-4A4D-975E-5FCF2E3EDA20}"/>
+                <a16:creationId xmlns:a16="http://schemas.microsoft.com/office/drawing/2014/main" id="{D7188719-052F-42DC-B6E9-386476804F30}"/>
               </a:ext>
             </a:extLst>
           </p:cNvPr>
@@ -7080,7 +7080,7 @@
           <p:cNvPr id="12" name="">
             <a:extLst xmlns:a="http://schemas.openxmlformats.org/drawingml/2006/main">
               <a:ext uri="{FF2B5EF4-FFF2-40B4-BE49-F238E27FC236}">
-                <a16:creationId xmlns:a16="http://schemas.microsoft.com/office/drawing/2014/main" id="{E6BF635C-9F46-41A8-B106-2B5F0D76BC49}"/>
+                <a16:creationId xmlns:a16="http://schemas.microsoft.com/office/drawing/2014/main" id="{D835C6AC-2F95-40F2-8665-B9FBBFB3BBB0}"/>
               </a:ext>
             </a:extLst>
           </p:cNvPr>
@@ -7142,7 +7142,7 @@
           <p:cNvPr id="13" name="">
             <a:extLst xmlns:a="http://schemas.openxmlformats.org/drawingml/2006/main">
               <a:ext uri="{FF2B5EF4-FFF2-40B4-BE49-F238E27FC236}">
-                <a16:creationId xmlns:a16="http://schemas.microsoft.com/office/drawing/2014/main" id="{ED654E51-F3FF-4216-BDD8-C4ECFD8A2A77}"/>
+                <a16:creationId xmlns:a16="http://schemas.microsoft.com/office/drawing/2014/main" id="{CF096C19-A735-4406-A988-A355025F25D5}"/>
               </a:ext>
             </a:extLst>
           </p:cNvPr>
@@ -7173,7 +7173,7 @@
           <p:cNvPr id="14" name="">
             <a:extLst xmlns:a="http://schemas.openxmlformats.org/drawingml/2006/main">
               <a:ext uri="{FF2B5EF4-FFF2-40B4-BE49-F238E27FC236}">
-                <a16:creationId xmlns:a16="http://schemas.microsoft.com/office/drawing/2014/main" id="{2350CF31-601F-456E-889D-B666E3B2AE2A}"/>
+                <a16:creationId xmlns:a16="http://schemas.microsoft.com/office/drawing/2014/main" id="{3451E3FD-070E-483B-9091-A1E0515F436E}"/>
               </a:ext>
             </a:extLst>
           </p:cNvPr>
@@ -7235,7 +7235,7 @@
           <p:cNvPr id="15" name="">
             <a:extLst xmlns:a="http://schemas.openxmlformats.org/drawingml/2006/main">
               <a:ext uri="{FF2B5EF4-FFF2-40B4-BE49-F238E27FC236}">
-                <a16:creationId xmlns:a16="http://schemas.microsoft.com/office/drawing/2014/main" id="{2791AB41-778B-4757-8DCE-ABB9C6DB366E}"/>
+                <a16:creationId xmlns:a16="http://schemas.microsoft.com/office/drawing/2014/main" id="{54379609-888C-4362-AD40-DAE3F8992EAA}"/>
               </a:ext>
             </a:extLst>
           </p:cNvPr>
@@ -7297,7 +7297,7 @@
           <p:cNvPr id="16" name="">
             <a:extLst xmlns:a="http://schemas.openxmlformats.org/drawingml/2006/main">
               <a:ext uri="{FF2B5EF4-FFF2-40B4-BE49-F238E27FC236}">
-                <a16:creationId xmlns:a16="http://schemas.microsoft.com/office/drawing/2014/main" id="{70E5D41E-98B4-4A29-B05F-FB41034AD256}"/>
+                <a16:creationId xmlns:a16="http://schemas.microsoft.com/office/drawing/2014/main" id="{064C47C7-44F1-46FF-BB46-07653B7FD141}"/>
               </a:ext>
             </a:extLst>
           </p:cNvPr>
@@ -7359,7 +7359,7 @@
           <p:cNvPr id="17" name="">
             <a:extLst xmlns:a="http://schemas.openxmlformats.org/drawingml/2006/main">
               <a:ext uri="{FF2B5EF4-FFF2-40B4-BE49-F238E27FC236}">
-                <a16:creationId xmlns:a16="http://schemas.microsoft.com/office/drawing/2014/main" id="{01082791-F744-4C82-B1A7-997C8A516F2C}"/>
+                <a16:creationId xmlns:a16="http://schemas.microsoft.com/office/drawing/2014/main" id="{E356D537-DC91-4EE2-95B0-9CF00A09E7DC}"/>
               </a:ext>
             </a:extLst>
           </p:cNvPr>
@@ -7421,7 +7421,7 @@
           <p:cNvPr id="18" name="footer-rule-13">
             <a:extLst xmlns:a="http://schemas.openxmlformats.org/drawingml/2006/main">
               <a:ext uri="{FF2B5EF4-FFF2-40B4-BE49-F238E27FC236}">
-                <a16:creationId xmlns:a16="http://schemas.microsoft.com/office/drawing/2014/main" id="{69E223C1-C3FE-40E4-80A0-A79663FA6328}"/>
+                <a16:creationId xmlns:a16="http://schemas.microsoft.com/office/drawing/2014/main" id="{ADD16157-F6D0-44A6-9650-AE72E6831E78}"/>
               </a:ext>
             </a:extLst>
           </p:cNvPr>
@@ -7452,7 +7452,7 @@
           <p:cNvPr id="19" name="footer-label-13">
             <a:extLst xmlns:a="http://schemas.openxmlformats.org/drawingml/2006/main">
               <a:ext uri="{FF2B5EF4-FFF2-40B4-BE49-F238E27FC236}">
-                <a16:creationId xmlns:a16="http://schemas.microsoft.com/office/drawing/2014/main" id="{51ED7077-5D11-4E78-853A-F97628C37309}"/>
+                <a16:creationId xmlns:a16="http://schemas.microsoft.com/office/drawing/2014/main" id="{FB08CA2A-5802-4192-8E69-119318C2950F}"/>
               </a:ext>
             </a:extLst>
           </p:cNvPr>
@@ -7514,7 +7514,7 @@
           <p:cNvPr id="20" name="footer-page-13">
             <a:extLst xmlns:a="http://schemas.openxmlformats.org/drawingml/2006/main">
               <a:ext uri="{FF2B5EF4-FFF2-40B4-BE49-F238E27FC236}">
-                <a16:creationId xmlns:a16="http://schemas.microsoft.com/office/drawing/2014/main" id="{93588948-37DB-47E7-8D20-C54ADAE4EE0B}"/>
+                <a16:creationId xmlns:a16="http://schemas.microsoft.com/office/drawing/2014/main" id="{8E021203-3CCA-4005-B2BA-6CE8628E37E7}"/>
               </a:ext>
             </a:extLst>
           </p:cNvPr>
@@ -7574,7 +7574,7 @@
     </p:spTree>
     <p:extLst>
       <p:ext uri="{BB962C8B-B14F-4D97-AF65-F5344CB8AC3E}">
-        <p14:creationId xmlns:p14="http://schemas.microsoft.com/office/powerpoint/2010/main" val="339151109"/>
+        <p14:creationId xmlns:p14="http://schemas.microsoft.com/office/powerpoint/2010/main" val="502465273"/>
       </p:ext>
     </p:extLst>
   </p:cSld>
@@ -7605,7 +7605,7 @@
           <p:cNvPr id="11" name="">
             <a:extLst xmlns:a="http://schemas.openxmlformats.org/drawingml/2006/main">
               <a:ext uri="{FF2B5EF4-FFF2-40B4-BE49-F238E27FC236}">
-                <a16:creationId xmlns:a16="http://schemas.microsoft.com/office/drawing/2014/main" id="{7F3376BD-84B3-4CC8-936C-402EBA6E7F40}"/>
+                <a16:creationId xmlns:a16="http://schemas.microsoft.com/office/drawing/2014/main" id="{430E6419-ED27-44B0-B4F8-374FBD6C8564}"/>
               </a:ext>
             </a:extLst>
           </p:cNvPr>
@@ -7636,7 +7636,7 @@
           <p:cNvPr id="2" name="">
             <a:extLst xmlns:a="http://schemas.openxmlformats.org/drawingml/2006/main">
               <a:ext uri="{FF2B5EF4-FFF2-40B4-BE49-F238E27FC236}">
-                <a16:creationId xmlns:a16="http://schemas.microsoft.com/office/drawing/2014/main" id="{D80A213F-F8C1-41A2-9A0F-EA97B25282E8}"/>
+                <a16:creationId xmlns:a16="http://schemas.microsoft.com/office/drawing/2014/main" id="{E6645AE2-942C-404C-BD69-323F708875AB}"/>
               </a:ext>
             </a:extLst>
           </p:cNvPr>
@@ -7698,7 +7698,7 @@
           <p:cNvPr id="3" name="">
             <a:extLst xmlns:a="http://schemas.openxmlformats.org/drawingml/2006/main">
               <a:ext uri="{FF2B5EF4-FFF2-40B4-BE49-F238E27FC236}">
-                <a16:creationId xmlns:a16="http://schemas.microsoft.com/office/drawing/2014/main" id="{0AB3D176-007A-41E3-8F8E-BCC62514E027}"/>
+                <a16:creationId xmlns:a16="http://schemas.microsoft.com/office/drawing/2014/main" id="{3738DB87-C45F-400E-8FDC-CC94335ADBEA}"/>
               </a:ext>
             </a:extLst>
           </p:cNvPr>
@@ -7787,7 +7787,7 @@
           <p:cNvPr id="4" name="">
             <a:extLst xmlns:a="http://schemas.openxmlformats.org/drawingml/2006/main">
               <a:ext uri="{FF2B5EF4-FFF2-40B4-BE49-F238E27FC236}">
-                <a16:creationId xmlns:a16="http://schemas.microsoft.com/office/drawing/2014/main" id="{999C7F31-B00F-4160-B524-6D07889085B5}"/>
+                <a16:creationId xmlns:a16="http://schemas.microsoft.com/office/drawing/2014/main" id="{D6328328-72BA-47F3-AD7B-E3D66A021666}"/>
               </a:ext>
             </a:extLst>
           </p:cNvPr>
@@ -7849,7 +7849,7 @@
           <p:cNvPr id="5" name="">
             <a:extLst xmlns:a="http://schemas.openxmlformats.org/drawingml/2006/main">
               <a:ext uri="{FF2B5EF4-FFF2-40B4-BE49-F238E27FC236}">
-                <a16:creationId xmlns:a16="http://schemas.microsoft.com/office/drawing/2014/main" id="{FC7B95BF-06D7-4CB0-8AA9-C0991F7F9B62}"/>
+                <a16:creationId xmlns:a16="http://schemas.microsoft.com/office/drawing/2014/main" id="{DCDA70E4-3DAB-491A-AF48-5B0F48688DD6}"/>
               </a:ext>
             </a:extLst>
           </p:cNvPr>
@@ -7882,7 +7882,7 @@
           <p:cNvPr id="6" name="">
             <a:extLst xmlns:a="http://schemas.openxmlformats.org/drawingml/2006/main">
               <a:ext uri="{FF2B5EF4-FFF2-40B4-BE49-F238E27FC236}">
-                <a16:creationId xmlns:a16="http://schemas.microsoft.com/office/drawing/2014/main" id="{9D5896A5-C2D6-41D9-BBED-437D8F2E0D05}"/>
+                <a16:creationId xmlns:a16="http://schemas.microsoft.com/office/drawing/2014/main" id="{F5EF9543-A81B-4C8C-9FFA-1B0DA1BD2BAC}"/>
               </a:ext>
             </a:extLst>
           </p:cNvPr>
@@ -7944,7 +7944,7 @@
           <p:cNvPr id="7" name="">
             <a:extLst xmlns:a="http://schemas.openxmlformats.org/drawingml/2006/main">
               <a:ext uri="{FF2B5EF4-FFF2-40B4-BE49-F238E27FC236}">
-                <a16:creationId xmlns:a16="http://schemas.microsoft.com/office/drawing/2014/main" id="{E5A663FA-122E-4D42-8F71-B4AA146420BE}"/>
+                <a16:creationId xmlns:a16="http://schemas.microsoft.com/office/drawing/2014/main" id="{5DDB026A-3C56-43C7-BD6E-807D262BC440}"/>
               </a:ext>
             </a:extLst>
           </p:cNvPr>
@@ -8006,7 +8006,7 @@
           <p:cNvPr id="8" name="">
             <a:extLst xmlns:a="http://schemas.openxmlformats.org/drawingml/2006/main">
               <a:ext uri="{FF2B5EF4-FFF2-40B4-BE49-F238E27FC236}">
-                <a16:creationId xmlns:a16="http://schemas.microsoft.com/office/drawing/2014/main" id="{F1225693-3539-4084-81FA-A06F8CE75D9F}"/>
+                <a16:creationId xmlns:a16="http://schemas.microsoft.com/office/drawing/2014/main" id="{0DF060D4-C10A-4E96-A939-75DBB5E4D227}"/>
               </a:ext>
             </a:extLst>
           </p:cNvPr>
@@ -8095,7 +8095,7 @@
           <p:cNvPr id="9" name="">
             <a:extLst xmlns:a="http://schemas.openxmlformats.org/drawingml/2006/main">
               <a:ext uri="{FF2B5EF4-FFF2-40B4-BE49-F238E27FC236}">
-                <a16:creationId xmlns:a16="http://schemas.microsoft.com/office/drawing/2014/main" id="{9752AD62-C9F6-4C10-B9CE-7F2D11193F9B}"/>
+                <a16:creationId xmlns:a16="http://schemas.microsoft.com/office/drawing/2014/main" id="{1AA6B4EC-966C-4103-9726-F67AF2129EA6}"/>
               </a:ext>
             </a:extLst>
           </p:cNvPr>
@@ -8157,7 +8157,7 @@
           <p:cNvPr id="10" name="">
             <a:extLst xmlns:a="http://schemas.openxmlformats.org/drawingml/2006/main">
               <a:ext uri="{FF2B5EF4-FFF2-40B4-BE49-F238E27FC236}">
-                <a16:creationId xmlns:a16="http://schemas.microsoft.com/office/drawing/2014/main" id="{F907595B-D025-4E68-AF51-5A3E9C6319B9}"/>
+                <a16:creationId xmlns:a16="http://schemas.microsoft.com/office/drawing/2014/main" id="{29EE5D97-4E28-4399-972D-25655F4AC1A6}"/>
               </a:ext>
             </a:extLst>
           </p:cNvPr>
@@ -8217,7 +8217,7 @@
     </p:spTree>
     <p:extLst>
       <p:ext uri="{BB962C8B-B14F-4D97-AF65-F5344CB8AC3E}">
-        <p14:creationId xmlns:p14="http://schemas.microsoft.com/office/powerpoint/2010/main" val="734645601"/>
+        <p14:creationId xmlns:p14="http://schemas.microsoft.com/office/powerpoint/2010/main" val="1155538153"/>
       </p:ext>
     </p:extLst>
   </p:cSld>
@@ -8248,7 +8248,7 @@
           <p:cNvPr id="22" name="side-accent-15">
             <a:extLst xmlns:a="http://schemas.openxmlformats.org/drawingml/2006/main">
               <a:ext uri="{FF2B5EF4-FFF2-40B4-BE49-F238E27FC236}">
-                <a16:creationId xmlns:a16="http://schemas.microsoft.com/office/drawing/2014/main" id="{1E40B7D8-1615-40F5-BE8C-5B58DCB0C18C}"/>
+                <a16:creationId xmlns:a16="http://schemas.microsoft.com/office/drawing/2014/main" id="{C82A7676-98C2-47B8-A3E3-7BD432A1E66D}"/>
               </a:ext>
             </a:extLst>
           </p:cNvPr>
@@ -8279,7 +8279,7 @@
           <p:cNvPr id="2" name="kicker-15">
             <a:extLst xmlns:a="http://schemas.openxmlformats.org/drawingml/2006/main">
               <a:ext uri="{FF2B5EF4-FFF2-40B4-BE49-F238E27FC236}">
-                <a16:creationId xmlns:a16="http://schemas.microsoft.com/office/drawing/2014/main" id="{701FC34B-4055-432A-BB9F-F36DAA1BC26D}"/>
+                <a16:creationId xmlns:a16="http://schemas.microsoft.com/office/drawing/2014/main" id="{68DF2160-5313-4E37-9022-1CB63574B1D9}"/>
               </a:ext>
             </a:extLst>
           </p:cNvPr>
@@ -8341,7 +8341,7 @@
           <p:cNvPr id="3" name="title-15">
             <a:extLst xmlns:a="http://schemas.openxmlformats.org/drawingml/2006/main">
               <a:ext uri="{FF2B5EF4-FFF2-40B4-BE49-F238E27FC236}">
-                <a16:creationId xmlns:a16="http://schemas.microsoft.com/office/drawing/2014/main" id="{15217000-7D89-4921-9860-B67CF75A4373}"/>
+                <a16:creationId xmlns:a16="http://schemas.microsoft.com/office/drawing/2014/main" id="{B35CE51F-1D9E-409E-8785-36A11A6467C6}"/>
               </a:ext>
             </a:extLst>
           </p:cNvPr>
@@ -8403,7 +8403,7 @@
           <p:cNvPr id="4" name="">
             <a:extLst xmlns:a="http://schemas.openxmlformats.org/drawingml/2006/main">
               <a:ext uri="{FF2B5EF4-FFF2-40B4-BE49-F238E27FC236}">
-                <a16:creationId xmlns:a16="http://schemas.microsoft.com/office/drawing/2014/main" id="{ED107B48-CA48-40A5-BBCD-07FC487361E2}"/>
+                <a16:creationId xmlns:a16="http://schemas.microsoft.com/office/drawing/2014/main" id="{324D68F0-53B7-4838-B9D5-BBF3A9F43C54}"/>
               </a:ext>
             </a:extLst>
           </p:cNvPr>
@@ -8465,7 +8465,7 @@
           <p:cNvPr id="5" name="">
             <a:extLst xmlns:a="http://schemas.openxmlformats.org/drawingml/2006/main">
               <a:ext uri="{FF2B5EF4-FFF2-40B4-BE49-F238E27FC236}">
-                <a16:creationId xmlns:a16="http://schemas.microsoft.com/office/drawing/2014/main" id="{8025F06D-B016-4C15-BEEC-23233608232A}"/>
+                <a16:creationId xmlns:a16="http://schemas.microsoft.com/office/drawing/2014/main" id="{B127D407-EFA2-4CAE-A45E-669155C55EF7}"/>
               </a:ext>
             </a:extLst>
           </p:cNvPr>
@@ -8496,7 +8496,7 @@
           <p:cNvPr id="6" name="">
             <a:extLst xmlns:a="http://schemas.openxmlformats.org/drawingml/2006/main">
               <a:ext uri="{FF2B5EF4-FFF2-40B4-BE49-F238E27FC236}">
-                <a16:creationId xmlns:a16="http://schemas.microsoft.com/office/drawing/2014/main" id="{F6823422-F875-4B6C-ABC6-A9640F568CDE}"/>
+                <a16:creationId xmlns:a16="http://schemas.microsoft.com/office/drawing/2014/main" id="{19797FB1-1754-4166-97B7-FAF71A02A6F9}"/>
               </a:ext>
             </a:extLst>
           </p:cNvPr>
@@ -8558,7 +8558,7 @@
           <p:cNvPr id="7" name="">
             <a:extLst xmlns:a="http://schemas.openxmlformats.org/drawingml/2006/main">
               <a:ext uri="{FF2B5EF4-FFF2-40B4-BE49-F238E27FC236}">
-                <a16:creationId xmlns:a16="http://schemas.microsoft.com/office/drawing/2014/main" id="{21CA650E-2E73-42C9-B5ED-815CBBA0DE6D}"/>
+                <a16:creationId xmlns:a16="http://schemas.microsoft.com/office/drawing/2014/main" id="{839B2CE4-18D0-4A2C-8DD1-BA30789A09E2}"/>
               </a:ext>
             </a:extLst>
           </p:cNvPr>
@@ -8620,7 +8620,7 @@
           <p:cNvPr id="8" name="">
             <a:extLst xmlns:a="http://schemas.openxmlformats.org/drawingml/2006/main">
               <a:ext uri="{FF2B5EF4-FFF2-40B4-BE49-F238E27FC236}">
-                <a16:creationId xmlns:a16="http://schemas.microsoft.com/office/drawing/2014/main" id="{FC216AA9-528C-4CD4-ABC8-7C077336B5A8}"/>
+                <a16:creationId xmlns:a16="http://schemas.microsoft.com/office/drawing/2014/main" id="{CF5BF157-713E-4624-8182-7214ACD6BDEA}"/>
               </a:ext>
             </a:extLst>
           </p:cNvPr>
@@ -8651,7 +8651,7 @@
           <p:cNvPr id="9" name="">
             <a:extLst xmlns:a="http://schemas.openxmlformats.org/drawingml/2006/main">
               <a:ext uri="{FF2B5EF4-FFF2-40B4-BE49-F238E27FC236}">
-                <a16:creationId xmlns:a16="http://schemas.microsoft.com/office/drawing/2014/main" id="{A8D3F96B-C1A1-4807-A91D-2748E995B125}"/>
+                <a16:creationId xmlns:a16="http://schemas.microsoft.com/office/drawing/2014/main" id="{B0646DF9-5828-4801-BCD7-23C9DBE10B31}"/>
               </a:ext>
             </a:extLst>
           </p:cNvPr>
@@ -8713,7 +8713,7 @@
           <p:cNvPr id="10" name="">
             <a:extLst xmlns:a="http://schemas.openxmlformats.org/drawingml/2006/main">
               <a:ext uri="{FF2B5EF4-FFF2-40B4-BE49-F238E27FC236}">
-                <a16:creationId xmlns:a16="http://schemas.microsoft.com/office/drawing/2014/main" id="{098A7B40-2AD7-41E4-9F73-D1232B3A01E2}"/>
+                <a16:creationId xmlns:a16="http://schemas.microsoft.com/office/drawing/2014/main" id="{A01E1F97-3685-4D66-85E3-3AA9C0F5EFA2}"/>
               </a:ext>
             </a:extLst>
           </p:cNvPr>
@@ -8775,7 +8775,7 @@
           <p:cNvPr id="11" name="">
             <a:extLst xmlns:a="http://schemas.openxmlformats.org/drawingml/2006/main">
               <a:ext uri="{FF2B5EF4-FFF2-40B4-BE49-F238E27FC236}">
-                <a16:creationId xmlns:a16="http://schemas.microsoft.com/office/drawing/2014/main" id="{80F3E1AC-8C83-4AA4-9425-6FE0CFC42CFC}"/>
+                <a16:creationId xmlns:a16="http://schemas.microsoft.com/office/drawing/2014/main" id="{36F9B1CE-71EB-456C-A43F-C8E62397656B}"/>
               </a:ext>
             </a:extLst>
           </p:cNvPr>
@@ -8806,7 +8806,7 @@
           <p:cNvPr id="12" name="">
             <a:extLst xmlns:a="http://schemas.openxmlformats.org/drawingml/2006/main">
               <a:ext uri="{FF2B5EF4-FFF2-40B4-BE49-F238E27FC236}">
-                <a16:creationId xmlns:a16="http://schemas.microsoft.com/office/drawing/2014/main" id="{02F932F9-0D1D-467E-A90D-C4D9285F9797}"/>
+                <a16:creationId xmlns:a16="http://schemas.microsoft.com/office/drawing/2014/main" id="{E19CFD95-F90A-4D3C-B960-B3E98BEBB25A}"/>
               </a:ext>
             </a:extLst>
           </p:cNvPr>
@@ -8868,7 +8868,7 @@
           <p:cNvPr id="13" name="">
             <a:extLst xmlns:a="http://schemas.openxmlformats.org/drawingml/2006/main">
               <a:ext uri="{FF2B5EF4-FFF2-40B4-BE49-F238E27FC236}">
-                <a16:creationId xmlns:a16="http://schemas.microsoft.com/office/drawing/2014/main" id="{1C5A4FDF-B677-4AAB-B6C0-0D32C1F3AC63}"/>
+                <a16:creationId xmlns:a16="http://schemas.microsoft.com/office/drawing/2014/main" id="{4CD2FD39-4516-4704-A74B-968234F07C10}"/>
               </a:ext>
             </a:extLst>
           </p:cNvPr>
@@ -8930,7 +8930,7 @@
           <p:cNvPr id="14" name="">
             <a:extLst xmlns:a="http://schemas.openxmlformats.org/drawingml/2006/main">
               <a:ext uri="{FF2B5EF4-FFF2-40B4-BE49-F238E27FC236}">
-                <a16:creationId xmlns:a16="http://schemas.microsoft.com/office/drawing/2014/main" id="{490E194C-0EAA-4AC5-BE8D-EE768DBF70FE}"/>
+                <a16:creationId xmlns:a16="http://schemas.microsoft.com/office/drawing/2014/main" id="{55D19307-406F-4DA6-B493-FE503BF76F45}"/>
               </a:ext>
             </a:extLst>
           </p:cNvPr>
@@ -8961,7 +8961,7 @@
           <p:cNvPr id="15" name="">
             <a:extLst xmlns:a="http://schemas.openxmlformats.org/drawingml/2006/main">
               <a:ext uri="{FF2B5EF4-FFF2-40B4-BE49-F238E27FC236}">
-                <a16:creationId xmlns:a16="http://schemas.microsoft.com/office/drawing/2014/main" id="{0F32EFF1-D6E0-47F6-9190-35CD33AB4EF8}"/>
+                <a16:creationId xmlns:a16="http://schemas.microsoft.com/office/drawing/2014/main" id="{9A894F92-85EE-4B57-BF6F-E6E034B0AAF0}"/>
               </a:ext>
             </a:extLst>
           </p:cNvPr>
@@ -9023,7 +9023,7 @@
           <p:cNvPr id="16" name="">
             <a:extLst xmlns:a="http://schemas.openxmlformats.org/drawingml/2006/main">
               <a:ext uri="{FF2B5EF4-FFF2-40B4-BE49-F238E27FC236}">
-                <a16:creationId xmlns:a16="http://schemas.microsoft.com/office/drawing/2014/main" id="{26DA2104-BE1B-462E-9490-228D94C33544}"/>
+                <a16:creationId xmlns:a16="http://schemas.microsoft.com/office/drawing/2014/main" id="{380EBF1A-0248-4A74-88EC-3B458A0F993D}"/>
               </a:ext>
             </a:extLst>
           </p:cNvPr>
@@ -9085,7 +9085,7 @@
           <p:cNvPr id="17" name="">
             <a:extLst xmlns:a="http://schemas.openxmlformats.org/drawingml/2006/main">
               <a:ext uri="{FF2B5EF4-FFF2-40B4-BE49-F238E27FC236}">
-                <a16:creationId xmlns:a16="http://schemas.microsoft.com/office/drawing/2014/main" id="{06A32FA1-1A52-42BB-87CB-9C916C42D91A}"/>
+                <a16:creationId xmlns:a16="http://schemas.microsoft.com/office/drawing/2014/main" id="{E56E1FC4-3838-485E-92E5-64B15741C17B}"/>
               </a:ext>
             </a:extLst>
           </p:cNvPr>
@@ -9118,7 +9118,7 @@
           <p:cNvPr id="18" name="">
             <a:extLst xmlns:a="http://schemas.openxmlformats.org/drawingml/2006/main">
               <a:ext uri="{FF2B5EF4-FFF2-40B4-BE49-F238E27FC236}">
-                <a16:creationId xmlns:a16="http://schemas.microsoft.com/office/drawing/2014/main" id="{8459E29E-5E2F-4BCE-9A77-3380D98CE439}"/>
+                <a16:creationId xmlns:a16="http://schemas.microsoft.com/office/drawing/2014/main" id="{9F5EA1FF-C3B8-482A-885A-D8B53A6F65E7}"/>
               </a:ext>
             </a:extLst>
           </p:cNvPr>
@@ -9180,7 +9180,7 @@
           <p:cNvPr id="19" name="footer-rule-15">
             <a:extLst xmlns:a="http://schemas.openxmlformats.org/drawingml/2006/main">
               <a:ext uri="{FF2B5EF4-FFF2-40B4-BE49-F238E27FC236}">
-                <a16:creationId xmlns:a16="http://schemas.microsoft.com/office/drawing/2014/main" id="{502A7363-0B7A-4464-9708-4D7F560E0AD8}"/>
+                <a16:creationId xmlns:a16="http://schemas.microsoft.com/office/drawing/2014/main" id="{E921E08F-0424-43A9-A6B7-B0CD6AE8812F}"/>
               </a:ext>
             </a:extLst>
           </p:cNvPr>
@@ -9211,7 +9211,7 @@
           <p:cNvPr id="20" name="footer-label-15">
             <a:extLst xmlns:a="http://schemas.openxmlformats.org/drawingml/2006/main">
               <a:ext uri="{FF2B5EF4-FFF2-40B4-BE49-F238E27FC236}">
-                <a16:creationId xmlns:a16="http://schemas.microsoft.com/office/drawing/2014/main" id="{DEBB26B6-64F8-45DB-BC5B-3AE3EF52D08B}"/>
+                <a16:creationId xmlns:a16="http://schemas.microsoft.com/office/drawing/2014/main" id="{5F46F65F-3361-44AE-8ACB-9CA3D952905B}"/>
               </a:ext>
             </a:extLst>
           </p:cNvPr>
@@ -9273,7 +9273,7 @@
           <p:cNvPr id="21" name="footer-page-15">
             <a:extLst xmlns:a="http://schemas.openxmlformats.org/drawingml/2006/main">
               <a:ext uri="{FF2B5EF4-FFF2-40B4-BE49-F238E27FC236}">
-                <a16:creationId xmlns:a16="http://schemas.microsoft.com/office/drawing/2014/main" id="{17FA5314-BEDF-41FC-B9A8-0E16E75FBB96}"/>
+                <a16:creationId xmlns:a16="http://schemas.microsoft.com/office/drawing/2014/main" id="{F524A415-0C58-4655-9CFA-2879E788F1A9}"/>
               </a:ext>
             </a:extLst>
           </p:cNvPr>
@@ -9333,7 +9333,7 @@
     </p:spTree>
     <p:extLst>
       <p:ext uri="{BB962C8B-B14F-4D97-AF65-F5344CB8AC3E}">
-        <p14:creationId xmlns:p14="http://schemas.microsoft.com/office/powerpoint/2010/main" val="354382165"/>
+        <p14:creationId xmlns:p14="http://schemas.microsoft.com/office/powerpoint/2010/main" val="1135470900"/>
       </p:ext>
     </p:extLst>
   </p:cSld>
@@ -9364,7 +9364,7 @@
           <p:cNvPr id="25" name="side-accent-16">
             <a:extLst xmlns:a="http://schemas.openxmlformats.org/drawingml/2006/main">
               <a:ext uri="{FF2B5EF4-FFF2-40B4-BE49-F238E27FC236}">
-                <a16:creationId xmlns:a16="http://schemas.microsoft.com/office/drawing/2014/main" id="{889ADBF9-C94F-439E-8663-90A0B08001E6}"/>
+                <a16:creationId xmlns:a16="http://schemas.microsoft.com/office/drawing/2014/main" id="{5E57E268-57B7-4E11-86BC-B0F1201F2785}"/>
               </a:ext>
             </a:extLst>
           </p:cNvPr>
@@ -9395,7 +9395,7 @@
           <p:cNvPr id="2" name="kicker-16">
             <a:extLst xmlns:a="http://schemas.openxmlformats.org/drawingml/2006/main">
               <a:ext uri="{FF2B5EF4-FFF2-40B4-BE49-F238E27FC236}">
-                <a16:creationId xmlns:a16="http://schemas.microsoft.com/office/drawing/2014/main" id="{99F7969A-E41F-4174-90E3-720042D6C5A1}"/>
+                <a16:creationId xmlns:a16="http://schemas.microsoft.com/office/drawing/2014/main" id="{DA595B37-32E1-4B67-906E-C8F624DC527C}"/>
               </a:ext>
             </a:extLst>
           </p:cNvPr>
@@ -9457,7 +9457,7 @@
           <p:cNvPr id="3" name="title-16">
             <a:extLst xmlns:a="http://schemas.openxmlformats.org/drawingml/2006/main">
               <a:ext uri="{FF2B5EF4-FFF2-40B4-BE49-F238E27FC236}">
-                <a16:creationId xmlns:a16="http://schemas.microsoft.com/office/drawing/2014/main" id="{8B808330-FFEB-4C10-91E1-7B29A7BF5194}"/>
+                <a16:creationId xmlns:a16="http://schemas.microsoft.com/office/drawing/2014/main" id="{11C746E9-8260-4CC2-926F-8977FBDF43BC}"/>
               </a:ext>
             </a:extLst>
           </p:cNvPr>
@@ -9519,7 +9519,7 @@
           <p:cNvPr id="4" name="">
             <a:extLst xmlns:a="http://schemas.openxmlformats.org/drawingml/2006/main">
               <a:ext uri="{FF2B5EF4-FFF2-40B4-BE49-F238E27FC236}">
-                <a16:creationId xmlns:a16="http://schemas.microsoft.com/office/drawing/2014/main" id="{25EA720C-C8D1-43D8-B147-0A323B6CCA61}"/>
+                <a16:creationId xmlns:a16="http://schemas.microsoft.com/office/drawing/2014/main" id="{F073074C-B4E0-4EA1-BBB8-14F4B047FFA9}"/>
               </a:ext>
             </a:extLst>
           </p:cNvPr>
@@ -9581,7 +9581,7 @@
           <p:cNvPr id="5" name="">
             <a:extLst xmlns:a="http://schemas.openxmlformats.org/drawingml/2006/main">
               <a:ext uri="{FF2B5EF4-FFF2-40B4-BE49-F238E27FC236}">
-                <a16:creationId xmlns:a16="http://schemas.microsoft.com/office/drawing/2014/main" id="{85D5C7E0-D43D-416A-9521-6F717A4D743C}"/>
+                <a16:creationId xmlns:a16="http://schemas.microsoft.com/office/drawing/2014/main" id="{21F46B2B-470B-4CDF-BDDF-5A43AAE1DD4A}"/>
               </a:ext>
             </a:extLst>
           </p:cNvPr>
@@ -9643,7 +9643,7 @@
           <p:cNvPr id="6" name="">
             <a:extLst xmlns:a="http://schemas.openxmlformats.org/drawingml/2006/main">
               <a:ext uri="{FF2B5EF4-FFF2-40B4-BE49-F238E27FC236}">
-                <a16:creationId xmlns:a16="http://schemas.microsoft.com/office/drawing/2014/main" id="{546303E7-5CB4-4A11-9ADC-CC21E735B491}"/>
+                <a16:creationId xmlns:a16="http://schemas.microsoft.com/office/drawing/2014/main" id="{28ACCD9D-3D93-4328-BE09-2C3CC316AE32}"/>
               </a:ext>
             </a:extLst>
           </p:cNvPr>
@@ -9695,7 +9695,7 @@
                 <a:ea typeface="Tahoma"/>
                 <a:cs typeface="Tahoma"/>
               </a:rPr>
-              <a:t>ตรวจรอบประเมิน บทบาท และงานที่ได้รับมอบหมาย</a:t>
+              <a:t>ตรวจงานที่ได้รับมอบหมาย และแจ้งผู้ดูแลระบบหากรอบไม่ถูกต้อง</a:t>
             </a:r>
           </a:p>
         </p:txBody>
@@ -9705,7 +9705,7 @@
           <p:cNvPr id="7" name="">
             <a:extLst xmlns:a="http://schemas.openxmlformats.org/drawingml/2006/main">
               <a:ext uri="{FF2B5EF4-FFF2-40B4-BE49-F238E27FC236}">
-                <a16:creationId xmlns:a16="http://schemas.microsoft.com/office/drawing/2014/main" id="{31134161-B878-4C37-8F74-6B35C379FEDC}"/>
+                <a16:creationId xmlns:a16="http://schemas.microsoft.com/office/drawing/2014/main" id="{3631EEFF-BA3C-425D-B1A2-45DDBD04439F}"/>
               </a:ext>
             </a:extLst>
           </p:cNvPr>
@@ -9736,7 +9736,7 @@
           <p:cNvPr id="8" name="">
             <a:extLst xmlns:a="http://schemas.openxmlformats.org/drawingml/2006/main">
               <a:ext uri="{FF2B5EF4-FFF2-40B4-BE49-F238E27FC236}">
-                <a16:creationId xmlns:a16="http://schemas.microsoft.com/office/drawing/2014/main" id="{88B28FA7-6FEC-4886-A9B1-2557CF7E3D71}"/>
+                <a16:creationId xmlns:a16="http://schemas.microsoft.com/office/drawing/2014/main" id="{5D328DA1-1B82-4757-996A-4C12D09776EB}"/>
               </a:ext>
             </a:extLst>
           </p:cNvPr>
@@ -9798,7 +9798,7 @@
           <p:cNvPr id="9" name="">
             <a:extLst xmlns:a="http://schemas.openxmlformats.org/drawingml/2006/main">
               <a:ext uri="{FF2B5EF4-FFF2-40B4-BE49-F238E27FC236}">
-                <a16:creationId xmlns:a16="http://schemas.microsoft.com/office/drawing/2014/main" id="{AA6B8A6E-39A0-4FE4-877A-C84987AF7D88}"/>
+                <a16:creationId xmlns:a16="http://schemas.microsoft.com/office/drawing/2014/main" id="{CAE52549-D43A-4E30-B1B1-DA44BEDF5D3E}"/>
               </a:ext>
             </a:extLst>
           </p:cNvPr>
@@ -9860,7 +9860,7 @@
           <p:cNvPr id="10" name="">
             <a:extLst xmlns:a="http://schemas.openxmlformats.org/drawingml/2006/main">
               <a:ext uri="{FF2B5EF4-FFF2-40B4-BE49-F238E27FC236}">
-                <a16:creationId xmlns:a16="http://schemas.microsoft.com/office/drawing/2014/main" id="{2D1DD469-ACAF-4322-8EFC-81EBE89F9139}"/>
+                <a16:creationId xmlns:a16="http://schemas.microsoft.com/office/drawing/2014/main" id="{0057197B-CEDB-4E7F-9143-54A85A27C037}"/>
               </a:ext>
             </a:extLst>
           </p:cNvPr>
@@ -9922,7 +9922,7 @@
           <p:cNvPr id="11" name="">
             <a:extLst xmlns:a="http://schemas.openxmlformats.org/drawingml/2006/main">
               <a:ext uri="{FF2B5EF4-FFF2-40B4-BE49-F238E27FC236}">
-                <a16:creationId xmlns:a16="http://schemas.microsoft.com/office/drawing/2014/main" id="{5BE19846-7B18-45BC-B10D-C1578025356B}"/>
+                <a16:creationId xmlns:a16="http://schemas.microsoft.com/office/drawing/2014/main" id="{6F07CF7C-F071-4692-9F8B-37BC6FED22B7}"/>
               </a:ext>
             </a:extLst>
           </p:cNvPr>
@@ -9953,7 +9953,7 @@
           <p:cNvPr id="12" name="">
             <a:extLst xmlns:a="http://schemas.openxmlformats.org/drawingml/2006/main">
               <a:ext uri="{FF2B5EF4-FFF2-40B4-BE49-F238E27FC236}">
-                <a16:creationId xmlns:a16="http://schemas.microsoft.com/office/drawing/2014/main" id="{37FE4C76-F1EE-467E-8ED7-9D3A513530C5}"/>
+                <a16:creationId xmlns:a16="http://schemas.microsoft.com/office/drawing/2014/main" id="{5D7F6448-C37E-42CA-833A-5C5C22D40ADE}"/>
               </a:ext>
             </a:extLst>
           </p:cNvPr>
@@ -10015,7 +10015,7 @@
           <p:cNvPr id="13" name="">
             <a:extLst xmlns:a="http://schemas.openxmlformats.org/drawingml/2006/main">
               <a:ext uri="{FF2B5EF4-FFF2-40B4-BE49-F238E27FC236}">
-                <a16:creationId xmlns:a16="http://schemas.microsoft.com/office/drawing/2014/main" id="{C3033F49-0DF2-40C3-83F4-F27E68B2E597}"/>
+                <a16:creationId xmlns:a16="http://schemas.microsoft.com/office/drawing/2014/main" id="{FC6FE5D3-E748-4C55-9583-5F38C81753A3}"/>
               </a:ext>
             </a:extLst>
           </p:cNvPr>
@@ -10077,7 +10077,7 @@
           <p:cNvPr id="14" name="">
             <a:extLst xmlns:a="http://schemas.openxmlformats.org/drawingml/2006/main">
               <a:ext uri="{FF2B5EF4-FFF2-40B4-BE49-F238E27FC236}">
-                <a16:creationId xmlns:a16="http://schemas.microsoft.com/office/drawing/2014/main" id="{A3E80153-3151-4064-B072-9431A0041310}"/>
+                <a16:creationId xmlns:a16="http://schemas.microsoft.com/office/drawing/2014/main" id="{6E338B55-EF01-4769-8893-8A48A8A5CA5E}"/>
               </a:ext>
             </a:extLst>
           </p:cNvPr>
@@ -10139,7 +10139,7 @@
           <p:cNvPr id="15" name="">
             <a:extLst xmlns:a="http://schemas.openxmlformats.org/drawingml/2006/main">
               <a:ext uri="{FF2B5EF4-FFF2-40B4-BE49-F238E27FC236}">
-                <a16:creationId xmlns:a16="http://schemas.microsoft.com/office/drawing/2014/main" id="{79AA8EF6-3F6C-4C89-887E-3743F94DC4EB}"/>
+                <a16:creationId xmlns:a16="http://schemas.microsoft.com/office/drawing/2014/main" id="{7BE5044D-57C4-4EF7-895C-B57B0336926C}"/>
               </a:ext>
             </a:extLst>
           </p:cNvPr>
@@ -10170,7 +10170,7 @@
           <p:cNvPr id="16" name="">
             <a:extLst xmlns:a="http://schemas.openxmlformats.org/drawingml/2006/main">
               <a:ext uri="{FF2B5EF4-FFF2-40B4-BE49-F238E27FC236}">
-                <a16:creationId xmlns:a16="http://schemas.microsoft.com/office/drawing/2014/main" id="{7CF29499-D5B7-4461-8180-508A1884A2CF}"/>
+                <a16:creationId xmlns:a16="http://schemas.microsoft.com/office/drawing/2014/main" id="{0F30588B-9022-4D33-B0F4-F742C84B32BF}"/>
               </a:ext>
             </a:extLst>
           </p:cNvPr>
@@ -10232,7 +10232,7 @@
           <p:cNvPr id="17" name="">
             <a:extLst xmlns:a="http://schemas.openxmlformats.org/drawingml/2006/main">
               <a:ext uri="{FF2B5EF4-FFF2-40B4-BE49-F238E27FC236}">
-                <a16:creationId xmlns:a16="http://schemas.microsoft.com/office/drawing/2014/main" id="{D85B557C-A2C5-40A6-8DB9-D36FB8E6CF7F}"/>
+                <a16:creationId xmlns:a16="http://schemas.microsoft.com/office/drawing/2014/main" id="{9FA25929-466F-4D2A-AB31-C25D090F0E51}"/>
               </a:ext>
             </a:extLst>
           </p:cNvPr>
@@ -10294,7 +10294,7 @@
           <p:cNvPr id="18" name="">
             <a:extLst xmlns:a="http://schemas.openxmlformats.org/drawingml/2006/main">
               <a:ext uri="{FF2B5EF4-FFF2-40B4-BE49-F238E27FC236}">
-                <a16:creationId xmlns:a16="http://schemas.microsoft.com/office/drawing/2014/main" id="{1D69347B-F82F-48E9-A729-4DC0A98BCF7A}"/>
+                <a16:creationId xmlns:a16="http://schemas.microsoft.com/office/drawing/2014/main" id="{1D6F649E-0783-4140-94C4-99B2A8D019DF}"/>
               </a:ext>
             </a:extLst>
           </p:cNvPr>
@@ -10356,7 +10356,7 @@
           <p:cNvPr id="19" name="">
             <a:extLst xmlns:a="http://schemas.openxmlformats.org/drawingml/2006/main">
               <a:ext uri="{FF2B5EF4-FFF2-40B4-BE49-F238E27FC236}">
-                <a16:creationId xmlns:a16="http://schemas.microsoft.com/office/drawing/2014/main" id="{D796DF8D-F0AD-4C03-8665-296EE4005C27}"/>
+                <a16:creationId xmlns:a16="http://schemas.microsoft.com/office/drawing/2014/main" id="{40F22667-C681-4B34-80DF-AB7C1FD899E4}"/>
               </a:ext>
             </a:extLst>
           </p:cNvPr>
@@ -10389,7 +10389,7 @@
           <p:cNvPr id="20" name="">
             <a:extLst xmlns:a="http://schemas.openxmlformats.org/drawingml/2006/main">
               <a:ext uri="{FF2B5EF4-FFF2-40B4-BE49-F238E27FC236}">
-                <a16:creationId xmlns:a16="http://schemas.microsoft.com/office/drawing/2014/main" id="{46051EDE-F713-4210-91ED-84D467C660E9}"/>
+                <a16:creationId xmlns:a16="http://schemas.microsoft.com/office/drawing/2014/main" id="{79DAA081-89C0-45C8-BD33-9F5F432EF0F3}"/>
               </a:ext>
             </a:extLst>
           </p:cNvPr>
@@ -10455,7 +10455,7 @@
           <p:nvPr/>
         </p:nvPicPr>
         <p:blipFill>
-          <a:blip xmlns:r="http://schemas.openxmlformats.org/officeDocument/2006/relationships" xmlns:a="http://schemas.openxmlformats.org/drawingml/2006/main" r:embed="R506b29f47afb4b40"/>
+          <a:blip xmlns:r="http://schemas.openxmlformats.org/officeDocument/2006/relationships" xmlns:a="http://schemas.openxmlformats.org/drawingml/2006/main" r:embed="R0548bceb68a34ac5"/>
           <a:stretch xmlns:a="http://schemas.openxmlformats.org/drawingml/2006/main"/>
         </p:blipFill>
         <p:spPr>
@@ -10473,7 +10473,7 @@
           <p:cNvPr id="22" name="footer-rule-16">
             <a:extLst xmlns:a="http://schemas.openxmlformats.org/drawingml/2006/main">
               <a:ext uri="{FF2B5EF4-FFF2-40B4-BE49-F238E27FC236}">
-                <a16:creationId xmlns:a16="http://schemas.microsoft.com/office/drawing/2014/main" id="{6C45DDEE-4CCF-4E82-B73C-F40915BF4378}"/>
+                <a16:creationId xmlns:a16="http://schemas.microsoft.com/office/drawing/2014/main" id="{2E0EF384-BFF2-4AFF-9485-FA5CE5EA05D7}"/>
               </a:ext>
             </a:extLst>
           </p:cNvPr>
@@ -10504,7 +10504,7 @@
           <p:cNvPr id="23" name="footer-label-16">
             <a:extLst xmlns:a="http://schemas.openxmlformats.org/drawingml/2006/main">
               <a:ext uri="{FF2B5EF4-FFF2-40B4-BE49-F238E27FC236}">
-                <a16:creationId xmlns:a16="http://schemas.microsoft.com/office/drawing/2014/main" id="{350E1048-B121-444D-9E79-AA0958CEDEA6}"/>
+                <a16:creationId xmlns:a16="http://schemas.microsoft.com/office/drawing/2014/main" id="{F377DF82-0182-4AEA-A8CE-0E506B2D9084}"/>
               </a:ext>
             </a:extLst>
           </p:cNvPr>
@@ -10566,7 +10566,7 @@
           <p:cNvPr id="24" name="footer-page-16">
             <a:extLst xmlns:a="http://schemas.openxmlformats.org/drawingml/2006/main">
               <a:ext uri="{FF2B5EF4-FFF2-40B4-BE49-F238E27FC236}">
-                <a16:creationId xmlns:a16="http://schemas.microsoft.com/office/drawing/2014/main" id="{3623E4FD-9EDF-4DCC-B336-2792D44E3227}"/>
+                <a16:creationId xmlns:a16="http://schemas.microsoft.com/office/drawing/2014/main" id="{E16989D5-3316-4AE2-B7EF-BF9155C02FA7}"/>
               </a:ext>
             </a:extLst>
           </p:cNvPr>
@@ -10626,7 +10626,7 @@
     </p:spTree>
     <p:extLst>
       <p:ext uri="{BB962C8B-B14F-4D97-AF65-F5344CB8AC3E}">
-        <p14:creationId xmlns:p14="http://schemas.microsoft.com/office/powerpoint/2010/main" val="1183643120"/>
+        <p14:creationId xmlns:p14="http://schemas.microsoft.com/office/powerpoint/2010/main" val="2053517621"/>
       </p:ext>
     </p:extLst>
   </p:cSld>
@@ -10657,7 +10657,7 @@
           <p:cNvPr id="20" name="side-accent-2">
             <a:extLst xmlns:a="http://schemas.openxmlformats.org/drawingml/2006/main">
               <a:ext uri="{FF2B5EF4-FFF2-40B4-BE49-F238E27FC236}">
-                <a16:creationId xmlns:a16="http://schemas.microsoft.com/office/drawing/2014/main" id="{7C76EDB2-92F8-4617-8EF7-DAC7F25AF240}"/>
+                <a16:creationId xmlns:a16="http://schemas.microsoft.com/office/drawing/2014/main" id="{B0854040-7F63-4F73-A13F-450796088423}"/>
               </a:ext>
             </a:extLst>
           </p:cNvPr>
@@ -10688,7 +10688,7 @@
           <p:cNvPr id="2" name="kicker-2">
             <a:extLst xmlns:a="http://schemas.openxmlformats.org/drawingml/2006/main">
               <a:ext uri="{FF2B5EF4-FFF2-40B4-BE49-F238E27FC236}">
-                <a16:creationId xmlns:a16="http://schemas.microsoft.com/office/drawing/2014/main" id="{FC90F58C-9396-4BE8-87B9-740445926A67}"/>
+                <a16:creationId xmlns:a16="http://schemas.microsoft.com/office/drawing/2014/main" id="{08198DAA-29B3-4E11-A64E-770CD156D546}"/>
               </a:ext>
             </a:extLst>
           </p:cNvPr>
@@ -10750,7 +10750,7 @@
           <p:cNvPr id="3" name="title-2">
             <a:extLst xmlns:a="http://schemas.openxmlformats.org/drawingml/2006/main">
               <a:ext uri="{FF2B5EF4-FFF2-40B4-BE49-F238E27FC236}">
-                <a16:creationId xmlns:a16="http://schemas.microsoft.com/office/drawing/2014/main" id="{F30889F2-34C7-401F-BDB3-8FA0E6B1B179}"/>
+                <a16:creationId xmlns:a16="http://schemas.microsoft.com/office/drawing/2014/main" id="{0C19A1CF-FCCB-4DA7-BC24-D29E4A6D1D80}"/>
               </a:ext>
             </a:extLst>
           </p:cNvPr>
@@ -10812,7 +10812,7 @@
           <p:cNvPr id="4" name="">
             <a:extLst xmlns:a="http://schemas.openxmlformats.org/drawingml/2006/main">
               <a:ext uri="{FF2B5EF4-FFF2-40B4-BE49-F238E27FC236}">
-                <a16:creationId xmlns:a16="http://schemas.microsoft.com/office/drawing/2014/main" id="{7A0E1BE5-128A-4336-B363-7577A5713D9A}"/>
+                <a16:creationId xmlns:a16="http://schemas.microsoft.com/office/drawing/2014/main" id="{3360224A-B1FE-4297-AE9E-741DB4EF2FF1}"/>
               </a:ext>
             </a:extLst>
           </p:cNvPr>
@@ -10874,7 +10874,7 @@
           <p:cNvPr id="5" name="">
             <a:extLst xmlns:a="http://schemas.openxmlformats.org/drawingml/2006/main">
               <a:ext uri="{FF2B5EF4-FFF2-40B4-BE49-F238E27FC236}">
-                <a16:creationId xmlns:a16="http://schemas.microsoft.com/office/drawing/2014/main" id="{C715542F-B032-4814-97ED-592D17CE18EA}"/>
+                <a16:creationId xmlns:a16="http://schemas.microsoft.com/office/drawing/2014/main" id="{6DDAB654-9DDD-4617-9A09-203539078902}"/>
               </a:ext>
             </a:extLst>
           </p:cNvPr>
@@ -10936,7 +10936,7 @@
           <p:cNvPr id="6" name="">
             <a:extLst xmlns:a="http://schemas.openxmlformats.org/drawingml/2006/main">
               <a:ext uri="{FF2B5EF4-FFF2-40B4-BE49-F238E27FC236}">
-                <a16:creationId xmlns:a16="http://schemas.microsoft.com/office/drawing/2014/main" id="{1CBF73A2-7813-464C-AC8B-7D245092140F}"/>
+                <a16:creationId xmlns:a16="http://schemas.microsoft.com/office/drawing/2014/main" id="{26FE68FE-6850-4728-ACB6-40FCC95F34C1}"/>
               </a:ext>
             </a:extLst>
           </p:cNvPr>
@@ -10967,7 +10967,7 @@
           <p:cNvPr id="7" name="">
             <a:extLst xmlns:a="http://schemas.openxmlformats.org/drawingml/2006/main">
               <a:ext uri="{FF2B5EF4-FFF2-40B4-BE49-F238E27FC236}">
-                <a16:creationId xmlns:a16="http://schemas.microsoft.com/office/drawing/2014/main" id="{980F2618-DF3F-43DE-A35B-A356C16F89A0}"/>
+                <a16:creationId xmlns:a16="http://schemas.microsoft.com/office/drawing/2014/main" id="{A42B230D-5598-4315-850A-D9E585B137FA}"/>
               </a:ext>
             </a:extLst>
           </p:cNvPr>
@@ -11029,7 +11029,7 @@
           <p:cNvPr id="8" name="">
             <a:extLst xmlns:a="http://schemas.openxmlformats.org/drawingml/2006/main">
               <a:ext uri="{FF2B5EF4-FFF2-40B4-BE49-F238E27FC236}">
-                <a16:creationId xmlns:a16="http://schemas.microsoft.com/office/drawing/2014/main" id="{90CA0F6E-8BB6-4E61-A92F-795CB5A1FE25}"/>
+                <a16:creationId xmlns:a16="http://schemas.microsoft.com/office/drawing/2014/main" id="{0D4BED09-18BF-41C8-B3AD-C17B3086322C}"/>
               </a:ext>
             </a:extLst>
           </p:cNvPr>
@@ -11091,7 +11091,7 @@
           <p:cNvPr id="9" name="">
             <a:extLst xmlns:a="http://schemas.openxmlformats.org/drawingml/2006/main">
               <a:ext uri="{FF2B5EF4-FFF2-40B4-BE49-F238E27FC236}">
-                <a16:creationId xmlns:a16="http://schemas.microsoft.com/office/drawing/2014/main" id="{EB539CC6-507E-4160-AE1A-F34D0A6E6E4C}"/>
+                <a16:creationId xmlns:a16="http://schemas.microsoft.com/office/drawing/2014/main" id="{51E8B1AA-30B4-4CC2-8B8F-E02AC6BC50DB}"/>
               </a:ext>
             </a:extLst>
           </p:cNvPr>
@@ -11122,7 +11122,7 @@
           <p:cNvPr id="10" name="">
             <a:extLst xmlns:a="http://schemas.openxmlformats.org/drawingml/2006/main">
               <a:ext uri="{FF2B5EF4-FFF2-40B4-BE49-F238E27FC236}">
-                <a16:creationId xmlns:a16="http://schemas.microsoft.com/office/drawing/2014/main" id="{A0A1D9D3-FEB5-4556-9D44-BDACAA16655E}"/>
+                <a16:creationId xmlns:a16="http://schemas.microsoft.com/office/drawing/2014/main" id="{B17006CE-AED6-4391-9E0D-73B0DDB49595}"/>
               </a:ext>
             </a:extLst>
           </p:cNvPr>
@@ -11184,7 +11184,7 @@
           <p:cNvPr id="11" name="">
             <a:extLst xmlns:a="http://schemas.openxmlformats.org/drawingml/2006/main">
               <a:ext uri="{FF2B5EF4-FFF2-40B4-BE49-F238E27FC236}">
-                <a16:creationId xmlns:a16="http://schemas.microsoft.com/office/drawing/2014/main" id="{DFC95702-E6C9-4280-86E3-60663662D695}"/>
+                <a16:creationId xmlns:a16="http://schemas.microsoft.com/office/drawing/2014/main" id="{D69D3507-CA2E-4F43-AEC4-A518A197E553}"/>
               </a:ext>
             </a:extLst>
           </p:cNvPr>
@@ -11246,7 +11246,7 @@
           <p:cNvPr id="12" name="">
             <a:extLst xmlns:a="http://schemas.openxmlformats.org/drawingml/2006/main">
               <a:ext uri="{FF2B5EF4-FFF2-40B4-BE49-F238E27FC236}">
-                <a16:creationId xmlns:a16="http://schemas.microsoft.com/office/drawing/2014/main" id="{C2D1817C-9B90-4753-AF3E-E0652D25FB4F}"/>
+                <a16:creationId xmlns:a16="http://schemas.microsoft.com/office/drawing/2014/main" id="{78BAC655-2400-4DD3-9C93-9201A10BCFDF}"/>
               </a:ext>
             </a:extLst>
           </p:cNvPr>
@@ -11277,7 +11277,7 @@
           <p:cNvPr id="13" name="">
             <a:extLst xmlns:a="http://schemas.openxmlformats.org/drawingml/2006/main">
               <a:ext uri="{FF2B5EF4-FFF2-40B4-BE49-F238E27FC236}">
-                <a16:creationId xmlns:a16="http://schemas.microsoft.com/office/drawing/2014/main" id="{E3114E12-C5CA-4490-9707-FCD728CC3BB0}"/>
+                <a16:creationId xmlns:a16="http://schemas.microsoft.com/office/drawing/2014/main" id="{0C95A9E6-43DE-4FC8-9596-DFC789ADE55C}"/>
               </a:ext>
             </a:extLst>
           </p:cNvPr>
@@ -11339,7 +11339,7 @@
           <p:cNvPr id="14" name="outcome-mark">
             <a:extLst xmlns:a="http://schemas.openxmlformats.org/drawingml/2006/main">
               <a:ext uri="{FF2B5EF4-FFF2-40B4-BE49-F238E27FC236}">
-                <a16:creationId xmlns:a16="http://schemas.microsoft.com/office/drawing/2014/main" id="{93A322B8-15DA-438E-A279-2197B5B9DA26}"/>
+                <a16:creationId xmlns:a16="http://schemas.microsoft.com/office/drawing/2014/main" id="{8FC2F258-A51A-412B-A7A9-053E3BCB4645}"/>
               </a:ext>
             </a:extLst>
           </p:cNvPr>
@@ -11374,7 +11374,7 @@
           <p:cNvPr id="15" name="">
             <a:extLst xmlns:a="http://schemas.openxmlformats.org/drawingml/2006/main">
               <a:ext uri="{FF2B5EF4-FFF2-40B4-BE49-F238E27FC236}">
-                <a16:creationId xmlns:a16="http://schemas.microsoft.com/office/drawing/2014/main" id="{7AC921E6-A5E1-4E8E-9858-F5B2C7CF2F0C}"/>
+                <a16:creationId xmlns:a16="http://schemas.microsoft.com/office/drawing/2014/main" id="{0DA38F24-9B0C-43FC-8823-D694F41B5B15}"/>
               </a:ext>
             </a:extLst>
           </p:cNvPr>
@@ -11436,7 +11436,7 @@
           <p:cNvPr id="16" name="">
             <a:extLst xmlns:a="http://schemas.openxmlformats.org/drawingml/2006/main">
               <a:ext uri="{FF2B5EF4-FFF2-40B4-BE49-F238E27FC236}">
-                <a16:creationId xmlns:a16="http://schemas.microsoft.com/office/drawing/2014/main" id="{B5A05EA7-3CF6-409F-8E8E-48EB13414C66}"/>
+                <a16:creationId xmlns:a16="http://schemas.microsoft.com/office/drawing/2014/main" id="{9B79A591-BD1E-4E7B-ABB0-77F9D811D6F7}"/>
               </a:ext>
             </a:extLst>
           </p:cNvPr>
@@ -11525,7 +11525,7 @@
           <p:cNvPr id="17" name="footer-rule-2">
             <a:extLst xmlns:a="http://schemas.openxmlformats.org/drawingml/2006/main">
               <a:ext uri="{FF2B5EF4-FFF2-40B4-BE49-F238E27FC236}">
-                <a16:creationId xmlns:a16="http://schemas.microsoft.com/office/drawing/2014/main" id="{46FB83B7-DCCE-47D2-8A16-F80DF9EBF4AD}"/>
+                <a16:creationId xmlns:a16="http://schemas.microsoft.com/office/drawing/2014/main" id="{D2491CEF-1F6F-458D-864F-816A423E6D19}"/>
               </a:ext>
             </a:extLst>
           </p:cNvPr>
@@ -11556,7 +11556,7 @@
           <p:cNvPr id="18" name="footer-label-2">
             <a:extLst xmlns:a="http://schemas.openxmlformats.org/drawingml/2006/main">
               <a:ext uri="{FF2B5EF4-FFF2-40B4-BE49-F238E27FC236}">
-                <a16:creationId xmlns:a16="http://schemas.microsoft.com/office/drawing/2014/main" id="{2ACC078B-E728-4028-8BB9-3490D8AD5D84}"/>
+                <a16:creationId xmlns:a16="http://schemas.microsoft.com/office/drawing/2014/main" id="{D9764220-237A-4D40-BC6C-7C9F37A1F1D2}"/>
               </a:ext>
             </a:extLst>
           </p:cNvPr>
@@ -11618,7 +11618,7 @@
           <p:cNvPr id="19" name="footer-page-2">
             <a:extLst xmlns:a="http://schemas.openxmlformats.org/drawingml/2006/main">
               <a:ext uri="{FF2B5EF4-FFF2-40B4-BE49-F238E27FC236}">
-                <a16:creationId xmlns:a16="http://schemas.microsoft.com/office/drawing/2014/main" id="{83DB992E-6375-43A2-A4D6-35FBA984867E}"/>
+                <a16:creationId xmlns:a16="http://schemas.microsoft.com/office/drawing/2014/main" id="{AE49F28F-5457-4FFB-874C-7C9F0D9DC733}"/>
               </a:ext>
             </a:extLst>
           </p:cNvPr>
@@ -11678,7 +11678,7 @@
     </p:spTree>
     <p:extLst>
       <p:ext uri="{BB962C8B-B14F-4D97-AF65-F5344CB8AC3E}">
-        <p14:creationId xmlns:p14="http://schemas.microsoft.com/office/powerpoint/2010/main" val="521656781"/>
+        <p14:creationId xmlns:p14="http://schemas.microsoft.com/office/powerpoint/2010/main" val="1534645399"/>
       </p:ext>
     </p:extLst>
   </p:cSld>
@@ -11709,7 +11709,7 @@
           <p:cNvPr id="31" name="side-accent-3">
             <a:extLst xmlns:a="http://schemas.openxmlformats.org/drawingml/2006/main">
               <a:ext uri="{FF2B5EF4-FFF2-40B4-BE49-F238E27FC236}">
-                <a16:creationId xmlns:a16="http://schemas.microsoft.com/office/drawing/2014/main" id="{03109EEB-976C-40D0-B827-8F73CC24C0A7}"/>
+                <a16:creationId xmlns:a16="http://schemas.microsoft.com/office/drawing/2014/main" id="{75D4CF61-D461-4C10-A6D9-31CF7D504317}"/>
               </a:ext>
             </a:extLst>
           </p:cNvPr>
@@ -11740,7 +11740,7 @@
           <p:cNvPr id="2" name="kicker-3">
             <a:extLst xmlns:a="http://schemas.openxmlformats.org/drawingml/2006/main">
               <a:ext uri="{FF2B5EF4-FFF2-40B4-BE49-F238E27FC236}">
-                <a16:creationId xmlns:a16="http://schemas.microsoft.com/office/drawing/2014/main" id="{5928B333-2A1B-4AC0-8148-3610425E7D98}"/>
+                <a16:creationId xmlns:a16="http://schemas.microsoft.com/office/drawing/2014/main" id="{8ADC3A55-646F-43BE-AE5B-995B9EAFCF36}"/>
               </a:ext>
             </a:extLst>
           </p:cNvPr>
@@ -11802,7 +11802,7 @@
           <p:cNvPr id="3" name="title-3">
             <a:extLst xmlns:a="http://schemas.openxmlformats.org/drawingml/2006/main">
               <a:ext uri="{FF2B5EF4-FFF2-40B4-BE49-F238E27FC236}">
-                <a16:creationId xmlns:a16="http://schemas.microsoft.com/office/drawing/2014/main" id="{4BD5648E-025D-4CDB-96F1-9DEC01DA5543}"/>
+                <a16:creationId xmlns:a16="http://schemas.microsoft.com/office/drawing/2014/main" id="{EB56D318-D2BA-40CE-A3B6-A0252C2844E9}"/>
               </a:ext>
             </a:extLst>
           </p:cNvPr>
@@ -11864,7 +11864,7 @@
           <p:cNvPr id="4" name="">
             <a:extLst xmlns:a="http://schemas.openxmlformats.org/drawingml/2006/main">
               <a:ext uri="{FF2B5EF4-FFF2-40B4-BE49-F238E27FC236}">
-                <a16:creationId xmlns:a16="http://schemas.microsoft.com/office/drawing/2014/main" id="{2CE020A3-29EA-46C8-B6E7-776E0153D42A}"/>
+                <a16:creationId xmlns:a16="http://schemas.microsoft.com/office/drawing/2014/main" id="{68CA41E4-9A51-4618-A4D9-A1632188A4CC}"/>
               </a:ext>
             </a:extLst>
           </p:cNvPr>
@@ -11926,7 +11926,7 @@
           <p:cNvPr id="5" name="workflow-line">
             <a:extLst xmlns:a="http://schemas.openxmlformats.org/drawingml/2006/main">
               <a:ext uri="{FF2B5EF4-FFF2-40B4-BE49-F238E27FC236}">
-                <a16:creationId xmlns:a16="http://schemas.microsoft.com/office/drawing/2014/main" id="{B14A37D5-AB7A-470E-BAA2-D0A4B351821D}"/>
+                <a16:creationId xmlns:a16="http://schemas.microsoft.com/office/drawing/2014/main" id="{07C6E741-B7AE-4B02-B06E-FFBBB1E4DA5B}"/>
               </a:ext>
             </a:extLst>
           </p:cNvPr>
@@ -11957,7 +11957,7 @@
           <p:cNvPr id="6" name="workflow-arrow">
             <a:extLst xmlns:a="http://schemas.openxmlformats.org/drawingml/2006/main">
               <a:ext uri="{FF2B5EF4-FFF2-40B4-BE49-F238E27FC236}">
-                <a16:creationId xmlns:a16="http://schemas.microsoft.com/office/drawing/2014/main" id="{80B1C96B-E4A1-4DA5-A127-E6B3FA1ADFBA}"/>
+                <a16:creationId xmlns:a16="http://schemas.microsoft.com/office/drawing/2014/main" id="{7F138BEE-CE70-463C-A0A1-309B1B12CFE5}"/>
               </a:ext>
             </a:extLst>
           </p:cNvPr>
@@ -11988,7 +11988,7 @@
           <p:cNvPr id="7" name="">
             <a:extLst xmlns:a="http://schemas.openxmlformats.org/drawingml/2006/main">
               <a:ext uri="{FF2B5EF4-FFF2-40B4-BE49-F238E27FC236}">
-                <a16:creationId xmlns:a16="http://schemas.microsoft.com/office/drawing/2014/main" id="{D3245745-AD69-4F2F-A555-CC80304F0931}"/>
+                <a16:creationId xmlns:a16="http://schemas.microsoft.com/office/drawing/2014/main" id="{FCDA4DA1-5B18-40F6-BCC8-5C2261E79AED}"/>
               </a:ext>
             </a:extLst>
           </p:cNvPr>
@@ -12019,7 +12019,7 @@
           <p:cNvPr id="8" name="">
             <a:extLst xmlns:a="http://schemas.openxmlformats.org/drawingml/2006/main">
               <a:ext uri="{FF2B5EF4-FFF2-40B4-BE49-F238E27FC236}">
-                <a16:creationId xmlns:a16="http://schemas.microsoft.com/office/drawing/2014/main" id="{B5510E93-8DBD-4481-A58F-CA8F840F8687}"/>
+                <a16:creationId xmlns:a16="http://schemas.microsoft.com/office/drawing/2014/main" id="{2EB048C7-B2DC-48B3-A6BC-95CE07ECB3F3}"/>
               </a:ext>
             </a:extLst>
           </p:cNvPr>
@@ -12081,7 +12081,7 @@
           <p:cNvPr id="9" name="">
             <a:extLst xmlns:a="http://schemas.openxmlformats.org/drawingml/2006/main">
               <a:ext uri="{FF2B5EF4-FFF2-40B4-BE49-F238E27FC236}">
-                <a16:creationId xmlns:a16="http://schemas.microsoft.com/office/drawing/2014/main" id="{248B9334-736B-459C-80AF-D71187267889}"/>
+                <a16:creationId xmlns:a16="http://schemas.microsoft.com/office/drawing/2014/main" id="{3DF8A8F0-9159-4E88-8389-9CB3AFA37C29}"/>
               </a:ext>
             </a:extLst>
           </p:cNvPr>
@@ -12143,7 +12143,7 @@
           <p:cNvPr id="10" name="">
             <a:extLst xmlns:a="http://schemas.openxmlformats.org/drawingml/2006/main">
               <a:ext uri="{FF2B5EF4-FFF2-40B4-BE49-F238E27FC236}">
-                <a16:creationId xmlns:a16="http://schemas.microsoft.com/office/drawing/2014/main" id="{11F69A5C-889D-4F97-B02A-B79E03701AA3}"/>
+                <a16:creationId xmlns:a16="http://schemas.microsoft.com/office/drawing/2014/main" id="{B48A6BE8-5887-41B3-B026-386ECF4059D4}"/>
               </a:ext>
             </a:extLst>
           </p:cNvPr>
@@ -12195,7 +12195,7 @@
                 <a:ea typeface="Tahoma"/>
                 <a:cs typeface="Tahoma"/>
               </a:rPr>
-              <a:t>เลือกรอบและรายการ</a:t>
+              <a:t>ตรวจรอบและรายการ</a:t>
             </a:r>
           </a:p>
         </p:txBody>
@@ -12205,7 +12205,7 @@
           <p:cNvPr id="11" name="">
             <a:extLst xmlns:a="http://schemas.openxmlformats.org/drawingml/2006/main">
               <a:ext uri="{FF2B5EF4-FFF2-40B4-BE49-F238E27FC236}">
-                <a16:creationId xmlns:a16="http://schemas.microsoft.com/office/drawing/2014/main" id="{A3F7B4F0-18D9-4C84-97DF-E89776A0C0D7}"/>
+                <a16:creationId xmlns:a16="http://schemas.microsoft.com/office/drawing/2014/main" id="{2473178E-3607-410D-9543-C6856BA01A7E}"/>
               </a:ext>
             </a:extLst>
           </p:cNvPr>
@@ -12236,7 +12236,7 @@
           <p:cNvPr id="12" name="">
             <a:extLst xmlns:a="http://schemas.openxmlformats.org/drawingml/2006/main">
               <a:ext uri="{FF2B5EF4-FFF2-40B4-BE49-F238E27FC236}">
-                <a16:creationId xmlns:a16="http://schemas.microsoft.com/office/drawing/2014/main" id="{CA482892-08C1-412C-9728-E995E7A10FE6}"/>
+                <a16:creationId xmlns:a16="http://schemas.microsoft.com/office/drawing/2014/main" id="{C043A41D-745C-4584-A9E0-D5CAAABA3279}"/>
               </a:ext>
             </a:extLst>
           </p:cNvPr>
@@ -12298,7 +12298,7 @@
           <p:cNvPr id="13" name="">
             <a:extLst xmlns:a="http://schemas.openxmlformats.org/drawingml/2006/main">
               <a:ext uri="{FF2B5EF4-FFF2-40B4-BE49-F238E27FC236}">
-                <a16:creationId xmlns:a16="http://schemas.microsoft.com/office/drawing/2014/main" id="{679580D8-CD03-479D-97F9-7B1C58125DD5}"/>
+                <a16:creationId xmlns:a16="http://schemas.microsoft.com/office/drawing/2014/main" id="{BA551201-7B98-4C6B-AEA2-D0B205C6CA27}"/>
               </a:ext>
             </a:extLst>
           </p:cNvPr>
@@ -12360,7 +12360,7 @@
           <p:cNvPr id="14" name="">
             <a:extLst xmlns:a="http://schemas.openxmlformats.org/drawingml/2006/main">
               <a:ext uri="{FF2B5EF4-FFF2-40B4-BE49-F238E27FC236}">
-                <a16:creationId xmlns:a16="http://schemas.microsoft.com/office/drawing/2014/main" id="{A5BC9F75-C7E9-4D65-AB31-2FE31A68DB4D}"/>
+                <a16:creationId xmlns:a16="http://schemas.microsoft.com/office/drawing/2014/main" id="{953D2E49-23DF-4440-9FD2-A8C97D914948}"/>
               </a:ext>
             </a:extLst>
           </p:cNvPr>
@@ -12422,7 +12422,7 @@
           <p:cNvPr id="15" name="">
             <a:extLst xmlns:a="http://schemas.openxmlformats.org/drawingml/2006/main">
               <a:ext uri="{FF2B5EF4-FFF2-40B4-BE49-F238E27FC236}">
-                <a16:creationId xmlns:a16="http://schemas.microsoft.com/office/drawing/2014/main" id="{C7DF4698-159D-4D30-8135-D3381DCEC981}"/>
+                <a16:creationId xmlns:a16="http://schemas.microsoft.com/office/drawing/2014/main" id="{714714BF-3B91-40E1-836C-1E27A0ED64E4}"/>
               </a:ext>
             </a:extLst>
           </p:cNvPr>
@@ -12453,7 +12453,7 @@
           <p:cNvPr id="16" name="">
             <a:extLst xmlns:a="http://schemas.openxmlformats.org/drawingml/2006/main">
               <a:ext uri="{FF2B5EF4-FFF2-40B4-BE49-F238E27FC236}">
-                <a16:creationId xmlns:a16="http://schemas.microsoft.com/office/drawing/2014/main" id="{C797999B-B9C7-442B-8E3F-C3D5434FB4DA}"/>
+                <a16:creationId xmlns:a16="http://schemas.microsoft.com/office/drawing/2014/main" id="{2766800D-3AA5-4673-8378-A322300923F0}"/>
               </a:ext>
             </a:extLst>
           </p:cNvPr>
@@ -12515,7 +12515,7 @@
           <p:cNvPr id="17" name="">
             <a:extLst xmlns:a="http://schemas.openxmlformats.org/drawingml/2006/main">
               <a:ext uri="{FF2B5EF4-FFF2-40B4-BE49-F238E27FC236}">
-                <a16:creationId xmlns:a16="http://schemas.microsoft.com/office/drawing/2014/main" id="{5F2CFBB0-958F-4B3F-8D9F-E62F5A5FDF3E}"/>
+                <a16:creationId xmlns:a16="http://schemas.microsoft.com/office/drawing/2014/main" id="{3E02E839-CEA7-46E8-848B-D89BFCF744BB}"/>
               </a:ext>
             </a:extLst>
           </p:cNvPr>
@@ -12577,7 +12577,7 @@
           <p:cNvPr id="18" name="">
             <a:extLst xmlns:a="http://schemas.openxmlformats.org/drawingml/2006/main">
               <a:ext uri="{FF2B5EF4-FFF2-40B4-BE49-F238E27FC236}">
-                <a16:creationId xmlns:a16="http://schemas.microsoft.com/office/drawing/2014/main" id="{6AD5817A-DA0A-4CD1-A7B4-DD214DDF52F7}"/>
+                <a16:creationId xmlns:a16="http://schemas.microsoft.com/office/drawing/2014/main" id="{23D1159E-930A-4AF2-B16B-B2DA7C8DC728}"/>
               </a:ext>
             </a:extLst>
           </p:cNvPr>
@@ -12639,7 +12639,7 @@
           <p:cNvPr id="19" name="">
             <a:extLst xmlns:a="http://schemas.openxmlformats.org/drawingml/2006/main">
               <a:ext uri="{FF2B5EF4-FFF2-40B4-BE49-F238E27FC236}">
-                <a16:creationId xmlns:a16="http://schemas.microsoft.com/office/drawing/2014/main" id="{E5AB2FF4-3D95-41F4-8BA1-8F1A98B73D39}"/>
+                <a16:creationId xmlns:a16="http://schemas.microsoft.com/office/drawing/2014/main" id="{84BCBE77-1B2E-4122-A2BE-3DF01E4822C1}"/>
               </a:ext>
             </a:extLst>
           </p:cNvPr>
@@ -12670,7 +12670,7 @@
           <p:cNvPr id="20" name="">
             <a:extLst xmlns:a="http://schemas.openxmlformats.org/drawingml/2006/main">
               <a:ext uri="{FF2B5EF4-FFF2-40B4-BE49-F238E27FC236}">
-                <a16:creationId xmlns:a16="http://schemas.microsoft.com/office/drawing/2014/main" id="{5B850B4B-52ED-4D56-B0BA-8E7F58A3D9C8}"/>
+                <a16:creationId xmlns:a16="http://schemas.microsoft.com/office/drawing/2014/main" id="{4DA36328-692B-40EF-827F-41947485C4E1}"/>
               </a:ext>
             </a:extLst>
           </p:cNvPr>
@@ -12732,7 +12732,7 @@
           <p:cNvPr id="21" name="">
             <a:extLst xmlns:a="http://schemas.openxmlformats.org/drawingml/2006/main">
               <a:ext uri="{FF2B5EF4-FFF2-40B4-BE49-F238E27FC236}">
-                <a16:creationId xmlns:a16="http://schemas.microsoft.com/office/drawing/2014/main" id="{B0226586-DDED-40A2-8C17-7B6C5393FBB9}"/>
+                <a16:creationId xmlns:a16="http://schemas.microsoft.com/office/drawing/2014/main" id="{0ADA37A2-95B1-4058-A4C4-9D505B35D8FE}"/>
               </a:ext>
             </a:extLst>
           </p:cNvPr>
@@ -12794,7 +12794,7 @@
           <p:cNvPr id="22" name="">
             <a:extLst xmlns:a="http://schemas.openxmlformats.org/drawingml/2006/main">
               <a:ext uri="{FF2B5EF4-FFF2-40B4-BE49-F238E27FC236}">
-                <a16:creationId xmlns:a16="http://schemas.microsoft.com/office/drawing/2014/main" id="{F6771CC3-0964-4458-BE24-4A717295744A}"/>
+                <a16:creationId xmlns:a16="http://schemas.microsoft.com/office/drawing/2014/main" id="{4931325D-BF85-4DD8-8343-D8ED9DD27475}"/>
               </a:ext>
             </a:extLst>
           </p:cNvPr>
@@ -12856,7 +12856,7 @@
           <p:cNvPr id="23" name="">
             <a:extLst xmlns:a="http://schemas.openxmlformats.org/drawingml/2006/main">
               <a:ext uri="{FF2B5EF4-FFF2-40B4-BE49-F238E27FC236}">
-                <a16:creationId xmlns:a16="http://schemas.microsoft.com/office/drawing/2014/main" id="{B7EB5A66-8D01-426A-8382-A17151390D95}"/>
+                <a16:creationId xmlns:a16="http://schemas.microsoft.com/office/drawing/2014/main" id="{9C2E6CF0-3462-4DA2-B9A3-322CEF47DE94}"/>
               </a:ext>
             </a:extLst>
           </p:cNvPr>
@@ -12887,7 +12887,7 @@
           <p:cNvPr id="24" name="">
             <a:extLst xmlns:a="http://schemas.openxmlformats.org/drawingml/2006/main">
               <a:ext uri="{FF2B5EF4-FFF2-40B4-BE49-F238E27FC236}">
-                <a16:creationId xmlns:a16="http://schemas.microsoft.com/office/drawing/2014/main" id="{A4BD90AA-BC53-46AE-ADCB-D7CBD869BD24}"/>
+                <a16:creationId xmlns:a16="http://schemas.microsoft.com/office/drawing/2014/main" id="{82389CE8-1614-45E9-9409-58D6D3317C86}"/>
               </a:ext>
             </a:extLst>
           </p:cNvPr>
@@ -12949,7 +12949,7 @@
           <p:cNvPr id="25" name="">
             <a:extLst xmlns:a="http://schemas.openxmlformats.org/drawingml/2006/main">
               <a:ext uri="{FF2B5EF4-FFF2-40B4-BE49-F238E27FC236}">
-                <a16:creationId xmlns:a16="http://schemas.microsoft.com/office/drawing/2014/main" id="{990DC728-A84C-406A-9E0D-AAB10D5E7846}"/>
+                <a16:creationId xmlns:a16="http://schemas.microsoft.com/office/drawing/2014/main" id="{FD4EBE5F-D108-4117-B0EE-BB3E0481F131}"/>
               </a:ext>
             </a:extLst>
           </p:cNvPr>
@@ -13011,7 +13011,7 @@
           <p:cNvPr id="26" name="">
             <a:extLst xmlns:a="http://schemas.openxmlformats.org/drawingml/2006/main">
               <a:ext uri="{FF2B5EF4-FFF2-40B4-BE49-F238E27FC236}">
-                <a16:creationId xmlns:a16="http://schemas.microsoft.com/office/drawing/2014/main" id="{81D8FCEA-A4DB-4123-A9AD-03F31856E790}"/>
+                <a16:creationId xmlns:a16="http://schemas.microsoft.com/office/drawing/2014/main" id="{DCD41557-B428-4ECC-861A-EDC28AD1D3CC}"/>
               </a:ext>
             </a:extLst>
           </p:cNvPr>
@@ -13073,7 +13073,7 @@
           <p:cNvPr id="27" name="">
             <a:extLst xmlns:a="http://schemas.openxmlformats.org/drawingml/2006/main">
               <a:ext uri="{FF2B5EF4-FFF2-40B4-BE49-F238E27FC236}">
-                <a16:creationId xmlns:a16="http://schemas.microsoft.com/office/drawing/2014/main" id="{0C874311-310B-458E-89C8-B8538F276F19}"/>
+                <a16:creationId xmlns:a16="http://schemas.microsoft.com/office/drawing/2014/main" id="{40A7AA00-7D02-4A92-883F-B1AD0BAAB4DA}"/>
               </a:ext>
             </a:extLst>
           </p:cNvPr>
@@ -13135,7 +13135,7 @@
           <p:cNvPr id="28" name="footer-rule-3">
             <a:extLst xmlns:a="http://schemas.openxmlformats.org/drawingml/2006/main">
               <a:ext uri="{FF2B5EF4-FFF2-40B4-BE49-F238E27FC236}">
-                <a16:creationId xmlns:a16="http://schemas.microsoft.com/office/drawing/2014/main" id="{F0051213-4D69-4106-B604-A026581289FE}"/>
+                <a16:creationId xmlns:a16="http://schemas.microsoft.com/office/drawing/2014/main" id="{0843C7AC-BAD2-41EC-BF02-6657AC9A2D20}"/>
               </a:ext>
             </a:extLst>
           </p:cNvPr>
@@ -13166,7 +13166,7 @@
           <p:cNvPr id="29" name="footer-label-3">
             <a:extLst xmlns:a="http://schemas.openxmlformats.org/drawingml/2006/main">
               <a:ext uri="{FF2B5EF4-FFF2-40B4-BE49-F238E27FC236}">
-                <a16:creationId xmlns:a16="http://schemas.microsoft.com/office/drawing/2014/main" id="{96B79571-6101-4747-9D8F-49EDD5EE17A1}"/>
+                <a16:creationId xmlns:a16="http://schemas.microsoft.com/office/drawing/2014/main" id="{777957AF-7F86-4E98-8187-3173087ED5CC}"/>
               </a:ext>
             </a:extLst>
           </p:cNvPr>
@@ -13228,7 +13228,7 @@
           <p:cNvPr id="30" name="footer-page-3">
             <a:extLst xmlns:a="http://schemas.openxmlformats.org/drawingml/2006/main">
               <a:ext uri="{FF2B5EF4-FFF2-40B4-BE49-F238E27FC236}">
-                <a16:creationId xmlns:a16="http://schemas.microsoft.com/office/drawing/2014/main" id="{91458F2C-2923-4066-A50D-9018386E8A7A}"/>
+                <a16:creationId xmlns:a16="http://schemas.microsoft.com/office/drawing/2014/main" id="{6444A86D-DA91-4151-96B7-A4A95862CF2F}"/>
               </a:ext>
             </a:extLst>
           </p:cNvPr>
@@ -13288,7 +13288,7 @@
     </p:spTree>
     <p:extLst>
       <p:ext uri="{BB962C8B-B14F-4D97-AF65-F5344CB8AC3E}">
-        <p14:creationId xmlns:p14="http://schemas.microsoft.com/office/powerpoint/2010/main" val="282073255"/>
+        <p14:creationId xmlns:p14="http://schemas.microsoft.com/office/powerpoint/2010/main" val="800553994"/>
       </p:ext>
     </p:extLst>
   </p:cSld>
@@ -13319,7 +13319,7 @@
           <p:cNvPr id="22" name="side-accent-4">
             <a:extLst xmlns:a="http://schemas.openxmlformats.org/drawingml/2006/main">
               <a:ext uri="{FF2B5EF4-FFF2-40B4-BE49-F238E27FC236}">
-                <a16:creationId xmlns:a16="http://schemas.microsoft.com/office/drawing/2014/main" id="{B4C3BC11-B112-4232-A89B-EB38386643B9}"/>
+                <a16:creationId xmlns:a16="http://schemas.microsoft.com/office/drawing/2014/main" id="{4FB840FA-F481-49F5-8216-2FAD91CA0CF8}"/>
               </a:ext>
             </a:extLst>
           </p:cNvPr>
@@ -13350,7 +13350,7 @@
           <p:cNvPr id="2" name="kicker-4">
             <a:extLst xmlns:a="http://schemas.openxmlformats.org/drawingml/2006/main">
               <a:ext uri="{FF2B5EF4-FFF2-40B4-BE49-F238E27FC236}">
-                <a16:creationId xmlns:a16="http://schemas.microsoft.com/office/drawing/2014/main" id="{9BDF0C27-ABCA-464A-8364-480B170A0FD3}"/>
+                <a16:creationId xmlns:a16="http://schemas.microsoft.com/office/drawing/2014/main" id="{2A7EE57D-BB4C-46BA-AA94-1CB50BC41FE1}"/>
               </a:ext>
             </a:extLst>
           </p:cNvPr>
@@ -13412,7 +13412,7 @@
           <p:cNvPr id="3" name="title-4">
             <a:extLst xmlns:a="http://schemas.openxmlformats.org/drawingml/2006/main">
               <a:ext uri="{FF2B5EF4-FFF2-40B4-BE49-F238E27FC236}">
-                <a16:creationId xmlns:a16="http://schemas.microsoft.com/office/drawing/2014/main" id="{1959FDE9-65FE-462C-983A-B1A45114A97C}"/>
+                <a16:creationId xmlns:a16="http://schemas.microsoft.com/office/drawing/2014/main" id="{2BE994D5-125D-494B-B7EF-AA2BC8700BCA}"/>
               </a:ext>
             </a:extLst>
           </p:cNvPr>
@@ -13474,7 +13474,7 @@
           <p:cNvPr id="4" name="">
             <a:extLst xmlns:a="http://schemas.openxmlformats.org/drawingml/2006/main">
               <a:ext uri="{FF2B5EF4-FFF2-40B4-BE49-F238E27FC236}">
-                <a16:creationId xmlns:a16="http://schemas.microsoft.com/office/drawing/2014/main" id="{B1A5880C-4083-48EF-9023-30867EF3D17B}"/>
+                <a16:creationId xmlns:a16="http://schemas.microsoft.com/office/drawing/2014/main" id="{84E0BD08-66C3-49D1-ACC2-A348F6B84C59}"/>
               </a:ext>
             </a:extLst>
           </p:cNvPr>
@@ -13536,7 +13536,7 @@
           <p:cNvPr id="5" name="">
             <a:extLst xmlns:a="http://schemas.openxmlformats.org/drawingml/2006/main">
               <a:ext uri="{FF2B5EF4-FFF2-40B4-BE49-F238E27FC236}">
-                <a16:creationId xmlns:a16="http://schemas.microsoft.com/office/drawing/2014/main" id="{A8FF67F4-5563-4816-96AD-B0FF5DD74677}"/>
+                <a16:creationId xmlns:a16="http://schemas.microsoft.com/office/drawing/2014/main" id="{A1A65ABD-7EBB-42D5-B31A-4B5BF55664BA}"/>
               </a:ext>
             </a:extLst>
           </p:cNvPr>
@@ -13598,7 +13598,7 @@
           <p:cNvPr id="6" name="">
             <a:extLst xmlns:a="http://schemas.openxmlformats.org/drawingml/2006/main">
               <a:ext uri="{FF2B5EF4-FFF2-40B4-BE49-F238E27FC236}">
-                <a16:creationId xmlns:a16="http://schemas.microsoft.com/office/drawing/2014/main" id="{091EF728-8916-4114-BCFE-651A7327D0C5}"/>
+                <a16:creationId xmlns:a16="http://schemas.microsoft.com/office/drawing/2014/main" id="{0BFD66C9-4C27-41C4-9F19-C01BB4CE1B1D}"/>
               </a:ext>
             </a:extLst>
           </p:cNvPr>
@@ -13660,7 +13660,7 @@
           <p:cNvPr id="7" name="">
             <a:extLst xmlns:a="http://schemas.openxmlformats.org/drawingml/2006/main">
               <a:ext uri="{FF2B5EF4-FFF2-40B4-BE49-F238E27FC236}">
-                <a16:creationId xmlns:a16="http://schemas.microsoft.com/office/drawing/2014/main" id="{1E4707B4-B57B-499D-B5A4-797228932BC2}"/>
+                <a16:creationId xmlns:a16="http://schemas.microsoft.com/office/drawing/2014/main" id="{82FFE33C-81EF-45C5-97C9-A5FE3A903C94}"/>
               </a:ext>
             </a:extLst>
           </p:cNvPr>
@@ -13691,7 +13691,7 @@
           <p:cNvPr id="8" name="">
             <a:extLst xmlns:a="http://schemas.openxmlformats.org/drawingml/2006/main">
               <a:ext uri="{FF2B5EF4-FFF2-40B4-BE49-F238E27FC236}">
-                <a16:creationId xmlns:a16="http://schemas.microsoft.com/office/drawing/2014/main" id="{30CC9681-7C63-4D51-878D-CA7BEA656ABF}"/>
+                <a16:creationId xmlns:a16="http://schemas.microsoft.com/office/drawing/2014/main" id="{EF350E18-2AD2-42C8-94FC-7C22570885D6}"/>
               </a:ext>
             </a:extLst>
           </p:cNvPr>
@@ -13780,7 +13780,7 @@
           <p:cNvPr id="9" name="">
             <a:extLst xmlns:a="http://schemas.openxmlformats.org/drawingml/2006/main">
               <a:ext uri="{FF2B5EF4-FFF2-40B4-BE49-F238E27FC236}">
-                <a16:creationId xmlns:a16="http://schemas.microsoft.com/office/drawing/2014/main" id="{93FA3CA3-E521-4558-90D7-29E35C83770B}"/>
+                <a16:creationId xmlns:a16="http://schemas.microsoft.com/office/drawing/2014/main" id="{9D850645-5BDD-4F87-97B5-B1E937D21E9A}"/>
               </a:ext>
             </a:extLst>
           </p:cNvPr>
@@ -13842,7 +13842,7 @@
           <p:cNvPr id="10" name="">
             <a:extLst xmlns:a="http://schemas.openxmlformats.org/drawingml/2006/main">
               <a:ext uri="{FF2B5EF4-FFF2-40B4-BE49-F238E27FC236}">
-                <a16:creationId xmlns:a16="http://schemas.microsoft.com/office/drawing/2014/main" id="{A0EDBD8D-0E88-4648-9DCE-EBA22BFFC808}"/>
+                <a16:creationId xmlns:a16="http://schemas.microsoft.com/office/drawing/2014/main" id="{DF56F8B5-33C4-4858-A625-5E0E0B38C0CC}"/>
               </a:ext>
             </a:extLst>
           </p:cNvPr>
@@ -13904,7 +13904,7 @@
           <p:cNvPr id="11" name="">
             <a:extLst xmlns:a="http://schemas.openxmlformats.org/drawingml/2006/main">
               <a:ext uri="{FF2B5EF4-FFF2-40B4-BE49-F238E27FC236}">
-                <a16:creationId xmlns:a16="http://schemas.microsoft.com/office/drawing/2014/main" id="{973B1642-477F-405C-9A90-6B2D9F43D545}"/>
+                <a16:creationId xmlns:a16="http://schemas.microsoft.com/office/drawing/2014/main" id="{5CA1C823-E964-4719-97E3-A5D03F9D3D43}"/>
               </a:ext>
             </a:extLst>
           </p:cNvPr>
@@ -13935,7 +13935,7 @@
           <p:cNvPr id="12" name="">
             <a:extLst xmlns:a="http://schemas.openxmlformats.org/drawingml/2006/main">
               <a:ext uri="{FF2B5EF4-FFF2-40B4-BE49-F238E27FC236}">
-                <a16:creationId xmlns:a16="http://schemas.microsoft.com/office/drawing/2014/main" id="{82975BEF-33D6-4A30-8915-AF45DB5A5E93}"/>
+                <a16:creationId xmlns:a16="http://schemas.microsoft.com/office/drawing/2014/main" id="{BDBD0D85-0848-403D-BEF6-FE12C30AE7FE}"/>
               </a:ext>
             </a:extLst>
           </p:cNvPr>
@@ -14024,7 +14024,7 @@
           <p:cNvPr id="13" name="">
             <a:extLst xmlns:a="http://schemas.openxmlformats.org/drawingml/2006/main">
               <a:ext uri="{FF2B5EF4-FFF2-40B4-BE49-F238E27FC236}">
-                <a16:creationId xmlns:a16="http://schemas.microsoft.com/office/drawing/2014/main" id="{DF461252-9E44-4E7D-94A8-4220F6A44925}"/>
+                <a16:creationId xmlns:a16="http://schemas.microsoft.com/office/drawing/2014/main" id="{109BB469-4BA8-4968-BD2E-3665216F87DB}"/>
               </a:ext>
             </a:extLst>
           </p:cNvPr>
@@ -14086,7 +14086,7 @@
           <p:cNvPr id="14" name="">
             <a:extLst xmlns:a="http://schemas.openxmlformats.org/drawingml/2006/main">
               <a:ext uri="{FF2B5EF4-FFF2-40B4-BE49-F238E27FC236}">
-                <a16:creationId xmlns:a16="http://schemas.microsoft.com/office/drawing/2014/main" id="{1E25747A-5AF3-4CFB-B28A-7CED9D9484A2}"/>
+                <a16:creationId xmlns:a16="http://schemas.microsoft.com/office/drawing/2014/main" id="{8522716D-1DD7-412F-910B-2582C1D3E213}"/>
               </a:ext>
             </a:extLst>
           </p:cNvPr>
@@ -14148,7 +14148,7 @@
           <p:cNvPr id="15" name="">
             <a:extLst xmlns:a="http://schemas.openxmlformats.org/drawingml/2006/main">
               <a:ext uri="{FF2B5EF4-FFF2-40B4-BE49-F238E27FC236}">
-                <a16:creationId xmlns:a16="http://schemas.microsoft.com/office/drawing/2014/main" id="{F0E84841-481F-4061-B417-660F4C207683}"/>
+                <a16:creationId xmlns:a16="http://schemas.microsoft.com/office/drawing/2014/main" id="{346E4B39-C937-4D6C-A517-20823E21769F}"/>
               </a:ext>
             </a:extLst>
           </p:cNvPr>
@@ -14179,7 +14179,7 @@
           <p:cNvPr id="16" name="">
             <a:extLst xmlns:a="http://schemas.openxmlformats.org/drawingml/2006/main">
               <a:ext uri="{FF2B5EF4-FFF2-40B4-BE49-F238E27FC236}">
-                <a16:creationId xmlns:a16="http://schemas.microsoft.com/office/drawing/2014/main" id="{AD84F903-A53F-41B0-B79C-E694A8FFF514}"/>
+                <a16:creationId xmlns:a16="http://schemas.microsoft.com/office/drawing/2014/main" id="{F208E3D1-B53F-49A1-9990-A7FAC2758F14}"/>
               </a:ext>
             </a:extLst>
           </p:cNvPr>
@@ -14268,7 +14268,7 @@
           <p:cNvPr id="17" name="">
             <a:extLst xmlns:a="http://schemas.openxmlformats.org/drawingml/2006/main">
               <a:ext uri="{FF2B5EF4-FFF2-40B4-BE49-F238E27FC236}">
-                <a16:creationId xmlns:a16="http://schemas.microsoft.com/office/drawing/2014/main" id="{09E7CFF7-EB6A-41C6-BED8-0F14280EEDA4}"/>
+                <a16:creationId xmlns:a16="http://schemas.microsoft.com/office/drawing/2014/main" id="{102CDDEC-99A1-4C09-97EF-714E7066BF81}"/>
               </a:ext>
             </a:extLst>
           </p:cNvPr>
@@ -14301,7 +14301,7 @@
           <p:cNvPr id="18" name="">
             <a:extLst xmlns:a="http://schemas.openxmlformats.org/drawingml/2006/main">
               <a:ext uri="{FF2B5EF4-FFF2-40B4-BE49-F238E27FC236}">
-                <a16:creationId xmlns:a16="http://schemas.microsoft.com/office/drawing/2014/main" id="{60BA03BB-D50E-4761-8C70-64B3ACA15182}"/>
+                <a16:creationId xmlns:a16="http://schemas.microsoft.com/office/drawing/2014/main" id="{21D64D01-592F-4429-83FA-1CCB4C66049E}"/>
               </a:ext>
             </a:extLst>
           </p:cNvPr>
@@ -14390,7 +14390,7 @@
           <p:cNvPr id="19" name="footer-rule-4">
             <a:extLst xmlns:a="http://schemas.openxmlformats.org/drawingml/2006/main">
               <a:ext uri="{FF2B5EF4-FFF2-40B4-BE49-F238E27FC236}">
-                <a16:creationId xmlns:a16="http://schemas.microsoft.com/office/drawing/2014/main" id="{C830BCFD-5F21-45CB-B7E7-62289485E46B}"/>
+                <a16:creationId xmlns:a16="http://schemas.microsoft.com/office/drawing/2014/main" id="{A34922B0-B46E-48AB-A7D4-8E5F74939802}"/>
               </a:ext>
             </a:extLst>
           </p:cNvPr>
@@ -14421,7 +14421,7 @@
           <p:cNvPr id="20" name="footer-label-4">
             <a:extLst xmlns:a="http://schemas.openxmlformats.org/drawingml/2006/main">
               <a:ext uri="{FF2B5EF4-FFF2-40B4-BE49-F238E27FC236}">
-                <a16:creationId xmlns:a16="http://schemas.microsoft.com/office/drawing/2014/main" id="{B183D57D-CF37-4A42-BF2F-8557271C0055}"/>
+                <a16:creationId xmlns:a16="http://schemas.microsoft.com/office/drawing/2014/main" id="{A9BF57A3-4646-4B44-9084-EE4500143537}"/>
               </a:ext>
             </a:extLst>
           </p:cNvPr>
@@ -14483,7 +14483,7 @@
           <p:cNvPr id="21" name="footer-page-4">
             <a:extLst xmlns:a="http://schemas.openxmlformats.org/drawingml/2006/main">
               <a:ext uri="{FF2B5EF4-FFF2-40B4-BE49-F238E27FC236}">
-                <a16:creationId xmlns:a16="http://schemas.microsoft.com/office/drawing/2014/main" id="{60C9DC50-EB4F-43D1-8BE7-38C428EE470F}"/>
+                <a16:creationId xmlns:a16="http://schemas.microsoft.com/office/drawing/2014/main" id="{BCF8C06F-FA3A-41BD-8A3C-EA5D3017A058}"/>
               </a:ext>
             </a:extLst>
           </p:cNvPr>
@@ -14543,7 +14543,7 @@
     </p:spTree>
     <p:extLst>
       <p:ext uri="{BB962C8B-B14F-4D97-AF65-F5344CB8AC3E}">
-        <p14:creationId xmlns:p14="http://schemas.microsoft.com/office/powerpoint/2010/main" val="997858921"/>
+        <p14:creationId xmlns:p14="http://schemas.microsoft.com/office/powerpoint/2010/main" val="881906816"/>
       </p:ext>
     </p:extLst>
   </p:cSld>
@@ -14574,7 +14574,7 @@
           <p:cNvPr id="28" name="side-accent-5">
             <a:extLst xmlns:a="http://schemas.openxmlformats.org/drawingml/2006/main">
               <a:ext uri="{FF2B5EF4-FFF2-40B4-BE49-F238E27FC236}">
-                <a16:creationId xmlns:a16="http://schemas.microsoft.com/office/drawing/2014/main" id="{26ECB741-8343-4948-8415-0AFEB85700E5}"/>
+                <a16:creationId xmlns:a16="http://schemas.microsoft.com/office/drawing/2014/main" id="{A0491177-76E7-46EA-B7A0-F352BB2CCA1A}"/>
               </a:ext>
             </a:extLst>
           </p:cNvPr>
@@ -14605,7 +14605,7 @@
           <p:cNvPr id="2" name="kicker-5">
             <a:extLst xmlns:a="http://schemas.openxmlformats.org/drawingml/2006/main">
               <a:ext uri="{FF2B5EF4-FFF2-40B4-BE49-F238E27FC236}">
-                <a16:creationId xmlns:a16="http://schemas.microsoft.com/office/drawing/2014/main" id="{8060340F-2A09-407D-9D7F-404B2A163C77}"/>
+                <a16:creationId xmlns:a16="http://schemas.microsoft.com/office/drawing/2014/main" id="{8315EED3-3924-4009-B384-728ACA39647C}"/>
               </a:ext>
             </a:extLst>
           </p:cNvPr>
@@ -14667,7 +14667,7 @@
           <p:cNvPr id="3" name="title-5">
             <a:extLst xmlns:a="http://schemas.openxmlformats.org/drawingml/2006/main">
               <a:ext uri="{FF2B5EF4-FFF2-40B4-BE49-F238E27FC236}">
-                <a16:creationId xmlns:a16="http://schemas.microsoft.com/office/drawing/2014/main" id="{CD64F7BC-D004-44E9-9430-06C2CF596458}"/>
+                <a16:creationId xmlns:a16="http://schemas.microsoft.com/office/drawing/2014/main" id="{F0408664-A2C6-4C35-AAE9-DEBC33A9E6F3}"/>
               </a:ext>
             </a:extLst>
           </p:cNvPr>
@@ -14719,7 +14719,7 @@
                 <a:ea typeface="Tahoma"/>
                 <a:cs typeface="Tahoma"/>
               </a:rPr>
-              <a:t>เริ่มจากตรวจสอบรอบประเมินและรายการของคุณ</a:t>
+              <a:t>ตรวจสอบรอบประเมินและรายการที่ได้รับมอบหมาย</a:t>
             </a:r>
           </a:p>
         </p:txBody>
@@ -14729,7 +14729,7 @@
           <p:cNvPr id="4" name="">
             <a:extLst xmlns:a="http://schemas.openxmlformats.org/drawingml/2006/main">
               <a:ext uri="{FF2B5EF4-FFF2-40B4-BE49-F238E27FC236}">
-                <a16:creationId xmlns:a16="http://schemas.microsoft.com/office/drawing/2014/main" id="{DD109B48-BF7A-4B7B-9C79-9ADFB9817BE7}"/>
+                <a16:creationId xmlns:a16="http://schemas.microsoft.com/office/drawing/2014/main" id="{FE728AB2-26E6-4FAC-94FA-E70A9EE016CE}"/>
               </a:ext>
             </a:extLst>
           </p:cNvPr>
@@ -14791,7 +14791,7 @@
           <p:cNvPr id="5" name="">
             <a:extLst xmlns:a="http://schemas.openxmlformats.org/drawingml/2006/main">
               <a:ext uri="{FF2B5EF4-FFF2-40B4-BE49-F238E27FC236}">
-                <a16:creationId xmlns:a16="http://schemas.microsoft.com/office/drawing/2014/main" id="{7F9A890A-E237-4ABE-8A2B-79FEC10E4A4C}"/>
+                <a16:creationId xmlns:a16="http://schemas.microsoft.com/office/drawing/2014/main" id="{BC75DF3C-78A9-438B-A7E2-B3B63A5520D2}"/>
               </a:ext>
             </a:extLst>
           </p:cNvPr>
@@ -14822,7 +14822,7 @@
           <p:cNvPr id="6" name="">
             <a:extLst xmlns:a="http://schemas.openxmlformats.org/drawingml/2006/main">
               <a:ext uri="{FF2B5EF4-FFF2-40B4-BE49-F238E27FC236}">
-                <a16:creationId xmlns:a16="http://schemas.microsoft.com/office/drawing/2014/main" id="{03E74FE7-CA17-4422-8FFF-D5E50C4870EA}"/>
+                <a16:creationId xmlns:a16="http://schemas.microsoft.com/office/drawing/2014/main" id="{85FF8200-0D92-4491-9050-554483D5758D}"/>
               </a:ext>
             </a:extLst>
           </p:cNvPr>
@@ -14884,7 +14884,7 @@
           <p:cNvPr id="7" name="">
             <a:extLst xmlns:a="http://schemas.openxmlformats.org/drawingml/2006/main">
               <a:ext uri="{FF2B5EF4-FFF2-40B4-BE49-F238E27FC236}">
-                <a16:creationId xmlns:a16="http://schemas.microsoft.com/office/drawing/2014/main" id="{AAF17D8A-98BD-46AF-8EE0-E6CDF818B0E1}"/>
+                <a16:creationId xmlns:a16="http://schemas.microsoft.com/office/drawing/2014/main" id="{A06D179E-64B9-4466-99DA-BE331D05704C}"/>
               </a:ext>
             </a:extLst>
           </p:cNvPr>
@@ -14946,7 +14946,7 @@
           <p:cNvPr id="8" name="">
             <a:extLst xmlns:a="http://schemas.openxmlformats.org/drawingml/2006/main">
               <a:ext uri="{FF2B5EF4-FFF2-40B4-BE49-F238E27FC236}">
-                <a16:creationId xmlns:a16="http://schemas.microsoft.com/office/drawing/2014/main" id="{52BB090F-1D80-4BFB-9E16-D4E0182A1566}"/>
+                <a16:creationId xmlns:a16="http://schemas.microsoft.com/office/drawing/2014/main" id="{5DDF703B-A929-4038-904B-5636B788B958}"/>
               </a:ext>
             </a:extLst>
           </p:cNvPr>
@@ -14998,7 +14998,7 @@
                 <a:ea typeface="Tahoma"/>
                 <a:cs typeface="Tahoma"/>
               </a:rPr>
-              <a:t>ปีและช่วงเวลาถูกต้อง</a:t>
+              <a:t>ผู้ดูแลระบบกำหนดไว้ถูกต้อง</a:t>
             </a:r>
           </a:p>
         </p:txBody>
@@ -15008,7 +15008,7 @@
           <p:cNvPr id="9" name="">
             <a:extLst xmlns:a="http://schemas.openxmlformats.org/drawingml/2006/main">
               <a:ext uri="{FF2B5EF4-FFF2-40B4-BE49-F238E27FC236}">
-                <a16:creationId xmlns:a16="http://schemas.microsoft.com/office/drawing/2014/main" id="{81B76822-541F-495B-BC8D-8633C8AB4FE6}"/>
+                <a16:creationId xmlns:a16="http://schemas.microsoft.com/office/drawing/2014/main" id="{C6FA265F-152B-4642-ABB6-3F36FB9DEF21}"/>
               </a:ext>
             </a:extLst>
           </p:cNvPr>
@@ -15039,7 +15039,7 @@
           <p:cNvPr id="10" name="">
             <a:extLst xmlns:a="http://schemas.openxmlformats.org/drawingml/2006/main">
               <a:ext uri="{FF2B5EF4-FFF2-40B4-BE49-F238E27FC236}">
-                <a16:creationId xmlns:a16="http://schemas.microsoft.com/office/drawing/2014/main" id="{A323304A-76E1-448D-9766-28D7E238C040}"/>
+                <a16:creationId xmlns:a16="http://schemas.microsoft.com/office/drawing/2014/main" id="{D88B9388-0CBD-4C49-8376-5CD7BD608091}"/>
               </a:ext>
             </a:extLst>
           </p:cNvPr>
@@ -15101,7 +15101,7 @@
           <p:cNvPr id="11" name="">
             <a:extLst xmlns:a="http://schemas.openxmlformats.org/drawingml/2006/main">
               <a:ext uri="{FF2B5EF4-FFF2-40B4-BE49-F238E27FC236}">
-                <a16:creationId xmlns:a16="http://schemas.microsoft.com/office/drawing/2014/main" id="{DD6448EC-9D38-486A-BC74-BC82AC56318F}"/>
+                <a16:creationId xmlns:a16="http://schemas.microsoft.com/office/drawing/2014/main" id="{E1967B8D-6B5B-406A-A320-8BE1EF20AA42}"/>
               </a:ext>
             </a:extLst>
           </p:cNvPr>
@@ -15163,7 +15163,7 @@
           <p:cNvPr id="12" name="">
             <a:extLst xmlns:a="http://schemas.openxmlformats.org/drawingml/2006/main">
               <a:ext uri="{FF2B5EF4-FFF2-40B4-BE49-F238E27FC236}">
-                <a16:creationId xmlns:a16="http://schemas.microsoft.com/office/drawing/2014/main" id="{9FD722C5-383E-435D-80DE-DF57E1E6B39C}"/>
+                <a16:creationId xmlns:a16="http://schemas.microsoft.com/office/drawing/2014/main" id="{EB758072-3AB8-4A6E-A33B-CAEE2C056306}"/>
               </a:ext>
             </a:extLst>
           </p:cNvPr>
@@ -15225,7 +15225,7 @@
           <p:cNvPr id="13" name="">
             <a:extLst xmlns:a="http://schemas.openxmlformats.org/drawingml/2006/main">
               <a:ext uri="{FF2B5EF4-FFF2-40B4-BE49-F238E27FC236}">
-                <a16:creationId xmlns:a16="http://schemas.microsoft.com/office/drawing/2014/main" id="{2CB74E92-8A82-4919-B359-1E38BAADD32B}"/>
+                <a16:creationId xmlns:a16="http://schemas.microsoft.com/office/drawing/2014/main" id="{E78F45AF-51BC-46ED-87E7-DE34F4040A10}"/>
               </a:ext>
             </a:extLst>
           </p:cNvPr>
@@ -15256,7 +15256,7 @@
           <p:cNvPr id="14" name="">
             <a:extLst xmlns:a="http://schemas.openxmlformats.org/drawingml/2006/main">
               <a:ext uri="{FF2B5EF4-FFF2-40B4-BE49-F238E27FC236}">
-                <a16:creationId xmlns:a16="http://schemas.microsoft.com/office/drawing/2014/main" id="{0684C304-B22A-4170-90C2-D247D2F28A2B}"/>
+                <a16:creationId xmlns:a16="http://schemas.microsoft.com/office/drawing/2014/main" id="{00E70706-99FE-4072-9E49-01B40722F6C9}"/>
               </a:ext>
             </a:extLst>
           </p:cNvPr>
@@ -15318,7 +15318,7 @@
           <p:cNvPr id="15" name="">
             <a:extLst xmlns:a="http://schemas.openxmlformats.org/drawingml/2006/main">
               <a:ext uri="{FF2B5EF4-FFF2-40B4-BE49-F238E27FC236}">
-                <a16:creationId xmlns:a16="http://schemas.microsoft.com/office/drawing/2014/main" id="{9F95F4D6-8ADC-48DA-894D-5288D84CEB71}"/>
+                <a16:creationId xmlns:a16="http://schemas.microsoft.com/office/drawing/2014/main" id="{B256A59F-C98E-478B-8936-E460A027DD09}"/>
               </a:ext>
             </a:extLst>
           </p:cNvPr>
@@ -15380,7 +15380,7 @@
           <p:cNvPr id="16" name="">
             <a:extLst xmlns:a="http://schemas.openxmlformats.org/drawingml/2006/main">
               <a:ext uri="{FF2B5EF4-FFF2-40B4-BE49-F238E27FC236}">
-                <a16:creationId xmlns:a16="http://schemas.microsoft.com/office/drawing/2014/main" id="{CEBEBFBF-A5C0-402D-A78E-0EFA189727C3}"/>
+                <a16:creationId xmlns:a16="http://schemas.microsoft.com/office/drawing/2014/main" id="{1F0BF007-BCA3-47A3-9DE9-36663BC58D40}"/>
               </a:ext>
             </a:extLst>
           </p:cNvPr>
@@ -15442,7 +15442,7 @@
           <p:cNvPr id="17" name="dashboard-preview">
             <a:extLst xmlns:a="http://schemas.openxmlformats.org/drawingml/2006/main">
               <a:ext uri="{FF2B5EF4-FFF2-40B4-BE49-F238E27FC236}">
-                <a16:creationId xmlns:a16="http://schemas.microsoft.com/office/drawing/2014/main" id="{C4B0849A-64D8-4962-9290-1BEBBF940844}"/>
+                <a16:creationId xmlns:a16="http://schemas.microsoft.com/office/drawing/2014/main" id="{9ADCF46D-2466-4EF9-BB90-EC288DA555B6}"/>
               </a:ext>
             </a:extLst>
           </p:cNvPr>
@@ -15477,7 +15477,7 @@
           <p:cNvPr id="18" name="">
             <a:extLst xmlns:a="http://schemas.openxmlformats.org/drawingml/2006/main">
               <a:ext uri="{FF2B5EF4-FFF2-40B4-BE49-F238E27FC236}">
-                <a16:creationId xmlns:a16="http://schemas.microsoft.com/office/drawing/2014/main" id="{46B4CC8D-EE6E-4DD3-82A9-A21E7183F746}"/>
+                <a16:creationId xmlns:a16="http://schemas.microsoft.com/office/drawing/2014/main" id="{C226645B-95BE-4612-AD50-EF5B5365AF43}"/>
               </a:ext>
             </a:extLst>
           </p:cNvPr>
@@ -15539,7 +15539,7 @@
           <p:cNvPr id="19" name="">
             <a:extLst xmlns:a="http://schemas.openxmlformats.org/drawingml/2006/main">
               <a:ext uri="{FF2B5EF4-FFF2-40B4-BE49-F238E27FC236}">
-                <a16:creationId xmlns:a16="http://schemas.microsoft.com/office/drawing/2014/main" id="{4A64E148-876D-4687-9070-4B5898954BC9}"/>
+                <a16:creationId xmlns:a16="http://schemas.microsoft.com/office/drawing/2014/main" id="{66295E29-C389-4CE7-BB06-736A6DF9D996}"/>
               </a:ext>
             </a:extLst>
           </p:cNvPr>
@@ -15570,7 +15570,7 @@
           <p:cNvPr id="20" name="">
             <a:extLst xmlns:a="http://schemas.openxmlformats.org/drawingml/2006/main">
               <a:ext uri="{FF2B5EF4-FFF2-40B4-BE49-F238E27FC236}">
-                <a16:creationId xmlns:a16="http://schemas.microsoft.com/office/drawing/2014/main" id="{BD1C5F5A-6F61-4FCC-AA21-867E2EB09A37}"/>
+                <a16:creationId xmlns:a16="http://schemas.microsoft.com/office/drawing/2014/main" id="{B7D9DF0F-9343-4AC6-B736-8F5BE00FF9EB}"/>
               </a:ext>
             </a:extLst>
           </p:cNvPr>
@@ -15632,7 +15632,7 @@
           <p:cNvPr id="21" name="">
             <a:extLst xmlns:a="http://schemas.openxmlformats.org/drawingml/2006/main">
               <a:ext uri="{FF2B5EF4-FFF2-40B4-BE49-F238E27FC236}">
-                <a16:creationId xmlns:a16="http://schemas.microsoft.com/office/drawing/2014/main" id="{F047FE98-7E7E-4E95-97EC-12E3D1F4AF73}"/>
+                <a16:creationId xmlns:a16="http://schemas.microsoft.com/office/drawing/2014/main" id="{D54CC63A-B430-4BAB-A138-1C9BFEF491DB}"/>
               </a:ext>
             </a:extLst>
           </p:cNvPr>
@@ -15663,7 +15663,7 @@
           <p:cNvPr id="22" name="">
             <a:extLst xmlns:a="http://schemas.openxmlformats.org/drawingml/2006/main">
               <a:ext uri="{FF2B5EF4-FFF2-40B4-BE49-F238E27FC236}">
-                <a16:creationId xmlns:a16="http://schemas.microsoft.com/office/drawing/2014/main" id="{289ACFAB-2F42-4FC1-8E65-2E6A694FA1ED}"/>
+                <a16:creationId xmlns:a16="http://schemas.microsoft.com/office/drawing/2014/main" id="{556DBCE2-EF11-419C-B09C-DD032C3EE4BB}"/>
               </a:ext>
             </a:extLst>
           </p:cNvPr>
@@ -15694,7 +15694,7 @@
           <p:cNvPr id="23" name="">
             <a:extLst xmlns:a="http://schemas.openxmlformats.org/drawingml/2006/main">
               <a:ext uri="{FF2B5EF4-FFF2-40B4-BE49-F238E27FC236}">
-                <a16:creationId xmlns:a16="http://schemas.microsoft.com/office/drawing/2014/main" id="{89697910-D0A5-4C59-A2D0-4A217A3B1D60}"/>
+                <a16:creationId xmlns:a16="http://schemas.microsoft.com/office/drawing/2014/main" id="{A01344CD-5E47-4D9B-854A-568558CF4AE2}"/>
               </a:ext>
             </a:extLst>
           </p:cNvPr>
@@ -15727,7 +15727,7 @@
           <p:cNvPr id="24" name="">
             <a:extLst xmlns:a="http://schemas.openxmlformats.org/drawingml/2006/main">
               <a:ext uri="{FF2B5EF4-FFF2-40B4-BE49-F238E27FC236}">
-                <a16:creationId xmlns:a16="http://schemas.microsoft.com/office/drawing/2014/main" id="{AFBF005A-ADDC-40F1-BAF8-73E6F62BCED2}"/>
+                <a16:creationId xmlns:a16="http://schemas.microsoft.com/office/drawing/2014/main" id="{A5EABB7E-864C-4986-9504-A38E6195E283}"/>
               </a:ext>
             </a:extLst>
           </p:cNvPr>
@@ -15789,7 +15789,7 @@
           <p:cNvPr id="25" name="footer-rule-5">
             <a:extLst xmlns:a="http://schemas.openxmlformats.org/drawingml/2006/main">
               <a:ext uri="{FF2B5EF4-FFF2-40B4-BE49-F238E27FC236}">
-                <a16:creationId xmlns:a16="http://schemas.microsoft.com/office/drawing/2014/main" id="{AFAD61D2-79AA-439A-95AD-1B622D3CF101}"/>
+                <a16:creationId xmlns:a16="http://schemas.microsoft.com/office/drawing/2014/main" id="{D9D97D7A-0DBD-4D24-99BD-3DBF9FA7BC1F}"/>
               </a:ext>
             </a:extLst>
           </p:cNvPr>
@@ -15820,7 +15820,7 @@
           <p:cNvPr id="26" name="footer-label-5">
             <a:extLst xmlns:a="http://schemas.openxmlformats.org/drawingml/2006/main">
               <a:ext uri="{FF2B5EF4-FFF2-40B4-BE49-F238E27FC236}">
-                <a16:creationId xmlns:a16="http://schemas.microsoft.com/office/drawing/2014/main" id="{17573C5B-03BB-4752-BCA0-36049A8C7E14}"/>
+                <a16:creationId xmlns:a16="http://schemas.microsoft.com/office/drawing/2014/main" id="{F80CF7A7-14AD-4A33-BD07-01A978C9D045}"/>
               </a:ext>
             </a:extLst>
           </p:cNvPr>
@@ -15882,7 +15882,7 @@
           <p:cNvPr id="27" name="footer-page-5">
             <a:extLst xmlns:a="http://schemas.openxmlformats.org/drawingml/2006/main">
               <a:ext uri="{FF2B5EF4-FFF2-40B4-BE49-F238E27FC236}">
-                <a16:creationId xmlns:a16="http://schemas.microsoft.com/office/drawing/2014/main" id="{BA884BDC-FDE8-4800-962A-97AD3B2C61C9}"/>
+                <a16:creationId xmlns:a16="http://schemas.microsoft.com/office/drawing/2014/main" id="{099CB187-7EF4-4145-B0FF-C2F451F0FE34}"/>
               </a:ext>
             </a:extLst>
           </p:cNvPr>
@@ -15942,7 +15942,7 @@
     </p:spTree>
     <p:extLst>
       <p:ext uri="{BB962C8B-B14F-4D97-AF65-F5344CB8AC3E}">
-        <p14:creationId xmlns:p14="http://schemas.microsoft.com/office/powerpoint/2010/main" val="1859145354"/>
+        <p14:creationId xmlns:p14="http://schemas.microsoft.com/office/powerpoint/2010/main" val="2034692291"/>
       </p:ext>
     </p:extLst>
   </p:cSld>
@@ -15973,7 +15973,7 @@
           <p:cNvPr id="26" name="side-accent-6">
             <a:extLst xmlns:a="http://schemas.openxmlformats.org/drawingml/2006/main">
               <a:ext uri="{FF2B5EF4-FFF2-40B4-BE49-F238E27FC236}">
-                <a16:creationId xmlns:a16="http://schemas.microsoft.com/office/drawing/2014/main" id="{BA936510-FBAF-4330-BBDA-1518C62F1185}"/>
+                <a16:creationId xmlns:a16="http://schemas.microsoft.com/office/drawing/2014/main" id="{9445EB16-40A4-46CF-B2C1-E92ECF8EC96C}"/>
               </a:ext>
             </a:extLst>
           </p:cNvPr>
@@ -16004,7 +16004,7 @@
           <p:cNvPr id="2" name="kicker-6">
             <a:extLst xmlns:a="http://schemas.openxmlformats.org/drawingml/2006/main">
               <a:ext uri="{FF2B5EF4-FFF2-40B4-BE49-F238E27FC236}">
-                <a16:creationId xmlns:a16="http://schemas.microsoft.com/office/drawing/2014/main" id="{D917C9D4-12DF-4B8B-AD7A-096F05ABDEE9}"/>
+                <a16:creationId xmlns:a16="http://schemas.microsoft.com/office/drawing/2014/main" id="{A48013BF-43AD-4682-BC5E-D9EED2F2C1D5}"/>
               </a:ext>
             </a:extLst>
           </p:cNvPr>
@@ -16066,7 +16066,7 @@
           <p:cNvPr id="3" name="title-6">
             <a:extLst xmlns:a="http://schemas.openxmlformats.org/drawingml/2006/main">
               <a:ext uri="{FF2B5EF4-FFF2-40B4-BE49-F238E27FC236}">
-                <a16:creationId xmlns:a16="http://schemas.microsoft.com/office/drawing/2014/main" id="{C31ADFE3-047B-4B30-8C41-71FF6E5CF467}"/>
+                <a16:creationId xmlns:a16="http://schemas.microsoft.com/office/drawing/2014/main" id="{7E0E1E30-0796-4A2E-A912-533F5AECBBF7}"/>
               </a:ext>
             </a:extLst>
           </p:cNvPr>
@@ -16128,7 +16128,7 @@
           <p:cNvPr id="4" name="">
             <a:extLst xmlns:a="http://schemas.openxmlformats.org/drawingml/2006/main">
               <a:ext uri="{FF2B5EF4-FFF2-40B4-BE49-F238E27FC236}">
-                <a16:creationId xmlns:a16="http://schemas.microsoft.com/office/drawing/2014/main" id="{E6D220F8-E471-45C8-93A5-F6E8BEECDA25}"/>
+                <a16:creationId xmlns:a16="http://schemas.microsoft.com/office/drawing/2014/main" id="{D439972D-9829-4CA0-B475-7D67B1BCEB7A}"/>
               </a:ext>
             </a:extLst>
           </p:cNvPr>
@@ -16190,7 +16190,7 @@
           <p:cNvPr id="5" name="">
             <a:extLst xmlns:a="http://schemas.openxmlformats.org/drawingml/2006/main">
               <a:ext uri="{FF2B5EF4-FFF2-40B4-BE49-F238E27FC236}">
-                <a16:creationId xmlns:a16="http://schemas.microsoft.com/office/drawing/2014/main" id="{3CF77391-7BC7-43BC-9D8F-7D4F98C46DB5}"/>
+                <a16:creationId xmlns:a16="http://schemas.microsoft.com/office/drawing/2014/main" id="{68D08B4A-3822-442B-A8A5-12476F17D1A0}"/>
               </a:ext>
             </a:extLst>
           </p:cNvPr>
@@ -16221,7 +16221,7 @@
           <p:cNvPr id="6" name="">
             <a:extLst xmlns:a="http://schemas.openxmlformats.org/drawingml/2006/main">
               <a:ext uri="{FF2B5EF4-FFF2-40B4-BE49-F238E27FC236}">
-                <a16:creationId xmlns:a16="http://schemas.microsoft.com/office/drawing/2014/main" id="{D47EAB4E-C91F-47ED-8D49-B0B52E1B4D6E}"/>
+                <a16:creationId xmlns:a16="http://schemas.microsoft.com/office/drawing/2014/main" id="{B59EA17B-BBEE-40ED-BC1A-3F0AAA647767}"/>
               </a:ext>
             </a:extLst>
           </p:cNvPr>
@@ -16252,7 +16252,7 @@
           <p:cNvPr id="7" name="">
             <a:extLst xmlns:a="http://schemas.openxmlformats.org/drawingml/2006/main">
               <a:ext uri="{FF2B5EF4-FFF2-40B4-BE49-F238E27FC236}">
-                <a16:creationId xmlns:a16="http://schemas.microsoft.com/office/drawing/2014/main" id="{F6D88BEF-BCB9-4DC9-8516-DB02FFDA38F4}"/>
+                <a16:creationId xmlns:a16="http://schemas.microsoft.com/office/drawing/2014/main" id="{E0411BC4-988E-43D4-90EA-A91FC838E191}"/>
               </a:ext>
             </a:extLst>
           </p:cNvPr>
@@ -16314,7 +16314,7 @@
           <p:cNvPr id="8" name="">
             <a:extLst xmlns:a="http://schemas.openxmlformats.org/drawingml/2006/main">
               <a:ext uri="{FF2B5EF4-FFF2-40B4-BE49-F238E27FC236}">
-                <a16:creationId xmlns:a16="http://schemas.microsoft.com/office/drawing/2014/main" id="{3600D5A4-AB61-4F5F-A1DB-137FD92E8014}"/>
+                <a16:creationId xmlns:a16="http://schemas.microsoft.com/office/drawing/2014/main" id="{2E48BFB8-499C-4886-A26A-4357076BAC43}"/>
               </a:ext>
             </a:extLst>
           </p:cNvPr>
@@ -16376,7 +16376,7 @@
           <p:cNvPr id="9" name="">
             <a:extLst xmlns:a="http://schemas.openxmlformats.org/drawingml/2006/main">
               <a:ext uri="{FF2B5EF4-FFF2-40B4-BE49-F238E27FC236}">
-                <a16:creationId xmlns:a16="http://schemas.microsoft.com/office/drawing/2014/main" id="{8C81550B-48B7-4535-A00D-CF5B38AEAF8C}"/>
+                <a16:creationId xmlns:a16="http://schemas.microsoft.com/office/drawing/2014/main" id="{FD89CF10-E416-4BE1-A735-6A4FB608BC30}"/>
               </a:ext>
             </a:extLst>
           </p:cNvPr>
@@ -16438,7 +16438,7 @@
           <p:cNvPr id="10" name="">
             <a:extLst xmlns:a="http://schemas.openxmlformats.org/drawingml/2006/main">
               <a:ext uri="{FF2B5EF4-FFF2-40B4-BE49-F238E27FC236}">
-                <a16:creationId xmlns:a16="http://schemas.microsoft.com/office/drawing/2014/main" id="{03DF5E2B-8D67-4654-BF09-B4EC1EDB10E8}"/>
+                <a16:creationId xmlns:a16="http://schemas.microsoft.com/office/drawing/2014/main" id="{86036CFA-7593-4489-ADE4-3346B54D8A46}"/>
               </a:ext>
             </a:extLst>
           </p:cNvPr>
@@ -16469,7 +16469,7 @@
           <p:cNvPr id="11" name="">
             <a:extLst xmlns:a="http://schemas.openxmlformats.org/drawingml/2006/main">
               <a:ext uri="{FF2B5EF4-FFF2-40B4-BE49-F238E27FC236}">
-                <a16:creationId xmlns:a16="http://schemas.microsoft.com/office/drawing/2014/main" id="{F130E19D-74A9-4F45-9AC8-F97FFBF62323}"/>
+                <a16:creationId xmlns:a16="http://schemas.microsoft.com/office/drawing/2014/main" id="{4A666201-32FE-4929-9B64-DFFA28365C98}"/>
               </a:ext>
             </a:extLst>
           </p:cNvPr>
@@ -16531,7 +16531,7 @@
           <p:cNvPr id="12" name="">
             <a:extLst xmlns:a="http://schemas.openxmlformats.org/drawingml/2006/main">
               <a:ext uri="{FF2B5EF4-FFF2-40B4-BE49-F238E27FC236}">
-                <a16:creationId xmlns:a16="http://schemas.microsoft.com/office/drawing/2014/main" id="{7F65E530-EEF7-4C6F-9C69-6AD9312563F1}"/>
+                <a16:creationId xmlns:a16="http://schemas.microsoft.com/office/drawing/2014/main" id="{7D63C05B-81A2-4F04-99AE-0A15AA9441B3}"/>
               </a:ext>
             </a:extLst>
           </p:cNvPr>
@@ -16593,7 +16593,7 @@
           <p:cNvPr id="13" name="">
             <a:extLst xmlns:a="http://schemas.openxmlformats.org/drawingml/2006/main">
               <a:ext uri="{FF2B5EF4-FFF2-40B4-BE49-F238E27FC236}">
-                <a16:creationId xmlns:a16="http://schemas.microsoft.com/office/drawing/2014/main" id="{FFF83CD1-C0B9-42D1-B7DC-9F0F2023D5A4}"/>
+                <a16:creationId xmlns:a16="http://schemas.microsoft.com/office/drawing/2014/main" id="{0D718D22-29E1-4A05-90EE-9CB69E622FE0}"/>
               </a:ext>
             </a:extLst>
           </p:cNvPr>
@@ -16655,7 +16655,7 @@
           <p:cNvPr id="14" name="">
             <a:extLst xmlns:a="http://schemas.openxmlformats.org/drawingml/2006/main">
               <a:ext uri="{FF2B5EF4-FFF2-40B4-BE49-F238E27FC236}">
-                <a16:creationId xmlns:a16="http://schemas.microsoft.com/office/drawing/2014/main" id="{40441E3B-81C2-4D0B-B92D-204C1F99E420}"/>
+                <a16:creationId xmlns:a16="http://schemas.microsoft.com/office/drawing/2014/main" id="{D62E0EA4-9956-437A-88A1-AAD8B5B2FA3D}"/>
               </a:ext>
             </a:extLst>
           </p:cNvPr>
@@ -16686,7 +16686,7 @@
           <p:cNvPr id="15" name="">
             <a:extLst xmlns:a="http://schemas.openxmlformats.org/drawingml/2006/main">
               <a:ext uri="{FF2B5EF4-FFF2-40B4-BE49-F238E27FC236}">
-                <a16:creationId xmlns:a16="http://schemas.microsoft.com/office/drawing/2014/main" id="{9D78328B-3FE4-4905-9FC5-98E815169AB9}"/>
+                <a16:creationId xmlns:a16="http://schemas.microsoft.com/office/drawing/2014/main" id="{0624C764-FC80-4C86-9787-804BCE4E6E41}"/>
               </a:ext>
             </a:extLst>
           </p:cNvPr>
@@ -16748,7 +16748,7 @@
           <p:cNvPr id="16" name="">
             <a:extLst xmlns:a="http://schemas.openxmlformats.org/drawingml/2006/main">
               <a:ext uri="{FF2B5EF4-FFF2-40B4-BE49-F238E27FC236}">
-                <a16:creationId xmlns:a16="http://schemas.microsoft.com/office/drawing/2014/main" id="{6DF03BC8-748F-40BB-833D-B863DCF38EC1}"/>
+                <a16:creationId xmlns:a16="http://schemas.microsoft.com/office/drawing/2014/main" id="{52F438AD-B085-4D88-9907-0145750FEF7A}"/>
               </a:ext>
             </a:extLst>
           </p:cNvPr>
@@ -16810,7 +16810,7 @@
           <p:cNvPr id="17" name="">
             <a:extLst xmlns:a="http://schemas.openxmlformats.org/drawingml/2006/main">
               <a:ext uri="{FF2B5EF4-FFF2-40B4-BE49-F238E27FC236}">
-                <a16:creationId xmlns:a16="http://schemas.microsoft.com/office/drawing/2014/main" id="{20D3101A-93B2-4DB2-B769-DE0278C94CED}"/>
+                <a16:creationId xmlns:a16="http://schemas.microsoft.com/office/drawing/2014/main" id="{9B39C03B-09BA-4E1D-990E-D04474830D04}"/>
               </a:ext>
             </a:extLst>
           </p:cNvPr>
@@ -16872,7 +16872,7 @@
           <p:cNvPr id="18" name="">
             <a:extLst xmlns:a="http://schemas.openxmlformats.org/drawingml/2006/main">
               <a:ext uri="{FF2B5EF4-FFF2-40B4-BE49-F238E27FC236}">
-                <a16:creationId xmlns:a16="http://schemas.microsoft.com/office/drawing/2014/main" id="{31AEF8F5-7D52-4BEC-8940-9F52B325BFBA}"/>
+                <a16:creationId xmlns:a16="http://schemas.microsoft.com/office/drawing/2014/main" id="{B9769D68-7AD6-4916-9604-92C87D4AF1C2}"/>
               </a:ext>
             </a:extLst>
           </p:cNvPr>
@@ -16903,7 +16903,7 @@
           <p:cNvPr id="19" name="">
             <a:extLst xmlns:a="http://schemas.openxmlformats.org/drawingml/2006/main">
               <a:ext uri="{FF2B5EF4-FFF2-40B4-BE49-F238E27FC236}">
-                <a16:creationId xmlns:a16="http://schemas.microsoft.com/office/drawing/2014/main" id="{CD68E5BB-8030-4427-8528-F8A3807028C0}"/>
+                <a16:creationId xmlns:a16="http://schemas.microsoft.com/office/drawing/2014/main" id="{A44101A8-58E3-4E48-86EF-2C29256FFD26}"/>
               </a:ext>
             </a:extLst>
           </p:cNvPr>
@@ -16965,7 +16965,7 @@
           <p:cNvPr id="20" name="">
             <a:extLst xmlns:a="http://schemas.openxmlformats.org/drawingml/2006/main">
               <a:ext uri="{FF2B5EF4-FFF2-40B4-BE49-F238E27FC236}">
-                <a16:creationId xmlns:a16="http://schemas.microsoft.com/office/drawing/2014/main" id="{31974B79-7BD1-4132-8340-68ABF4C0EC44}"/>
+                <a16:creationId xmlns:a16="http://schemas.microsoft.com/office/drawing/2014/main" id="{D70C2908-4264-4A5D-ACB0-E892D63B89F0}"/>
               </a:ext>
             </a:extLst>
           </p:cNvPr>
@@ -17027,7 +17027,7 @@
           <p:cNvPr id="21" name="">
             <a:extLst xmlns:a="http://schemas.openxmlformats.org/drawingml/2006/main">
               <a:ext uri="{FF2B5EF4-FFF2-40B4-BE49-F238E27FC236}">
-                <a16:creationId xmlns:a16="http://schemas.microsoft.com/office/drawing/2014/main" id="{BC245BE4-5A5C-4144-B72F-5CB6DB9B30E8}"/>
+                <a16:creationId xmlns:a16="http://schemas.microsoft.com/office/drawing/2014/main" id="{B46C15D3-598F-49C3-835E-504249A37E40}"/>
               </a:ext>
             </a:extLst>
           </p:cNvPr>
@@ -17089,7 +17089,7 @@
           <p:cNvPr id="22" name="">
             <a:extLst xmlns:a="http://schemas.openxmlformats.org/drawingml/2006/main">
               <a:ext uri="{FF2B5EF4-FFF2-40B4-BE49-F238E27FC236}">
-                <a16:creationId xmlns:a16="http://schemas.microsoft.com/office/drawing/2014/main" id="{C32F2F64-9FF3-4125-860B-1BA0C7AFB96A}"/>
+                <a16:creationId xmlns:a16="http://schemas.microsoft.com/office/drawing/2014/main" id="{3D8005A4-F100-444A-BD8D-0FAA37DFED1A}"/>
               </a:ext>
             </a:extLst>
           </p:cNvPr>
@@ -17151,7 +17151,7 @@
           <p:cNvPr id="23" name="footer-rule-6">
             <a:extLst xmlns:a="http://schemas.openxmlformats.org/drawingml/2006/main">
               <a:ext uri="{FF2B5EF4-FFF2-40B4-BE49-F238E27FC236}">
-                <a16:creationId xmlns:a16="http://schemas.microsoft.com/office/drawing/2014/main" id="{DBA7EE00-93A3-4EFC-90F9-79486F56D2AF}"/>
+                <a16:creationId xmlns:a16="http://schemas.microsoft.com/office/drawing/2014/main" id="{41DE4222-2938-4F13-B922-6B0CE9E58C6B}"/>
               </a:ext>
             </a:extLst>
           </p:cNvPr>
@@ -17182,7 +17182,7 @@
           <p:cNvPr id="24" name="footer-label-6">
             <a:extLst xmlns:a="http://schemas.openxmlformats.org/drawingml/2006/main">
               <a:ext uri="{FF2B5EF4-FFF2-40B4-BE49-F238E27FC236}">
-                <a16:creationId xmlns:a16="http://schemas.microsoft.com/office/drawing/2014/main" id="{AFE05C07-A9FA-403D-9AEE-1588465E657B}"/>
+                <a16:creationId xmlns:a16="http://schemas.microsoft.com/office/drawing/2014/main" id="{26A7766D-6F8F-425F-A59B-BAED37AACC3E}"/>
               </a:ext>
             </a:extLst>
           </p:cNvPr>
@@ -17244,7 +17244,7 @@
           <p:cNvPr id="25" name="footer-page-6">
             <a:extLst xmlns:a="http://schemas.openxmlformats.org/drawingml/2006/main">
               <a:ext uri="{FF2B5EF4-FFF2-40B4-BE49-F238E27FC236}">
-                <a16:creationId xmlns:a16="http://schemas.microsoft.com/office/drawing/2014/main" id="{4662313E-38A8-4546-9B40-5A92E8AC4C42}"/>
+                <a16:creationId xmlns:a16="http://schemas.microsoft.com/office/drawing/2014/main" id="{67EED4C2-D44A-44D3-BFEF-D4CE10031E3A}"/>
               </a:ext>
             </a:extLst>
           </p:cNvPr>
@@ -17304,7 +17304,7 @@
     </p:spTree>
     <p:extLst>
       <p:ext uri="{BB962C8B-B14F-4D97-AF65-F5344CB8AC3E}">
-        <p14:creationId xmlns:p14="http://schemas.microsoft.com/office/powerpoint/2010/main" val="915447238"/>
+        <p14:creationId xmlns:p14="http://schemas.microsoft.com/office/powerpoint/2010/main" val="1803797323"/>
       </p:ext>
     </p:extLst>
   </p:cSld>
@@ -17335,7 +17335,7 @@
           <p:cNvPr id="25" name="side-accent-7">
             <a:extLst xmlns:a="http://schemas.openxmlformats.org/drawingml/2006/main">
               <a:ext uri="{FF2B5EF4-FFF2-40B4-BE49-F238E27FC236}">
-                <a16:creationId xmlns:a16="http://schemas.microsoft.com/office/drawing/2014/main" id="{02E269B6-114F-4C6C-B89C-282FC93620C4}"/>
+                <a16:creationId xmlns:a16="http://schemas.microsoft.com/office/drawing/2014/main" id="{24B17B88-AA1F-4B28-89D0-0C88EB47CA45}"/>
               </a:ext>
             </a:extLst>
           </p:cNvPr>
@@ -17366,7 +17366,7 @@
           <p:cNvPr id="2" name="kicker-7">
             <a:extLst xmlns:a="http://schemas.openxmlformats.org/drawingml/2006/main">
               <a:ext uri="{FF2B5EF4-FFF2-40B4-BE49-F238E27FC236}">
-                <a16:creationId xmlns:a16="http://schemas.microsoft.com/office/drawing/2014/main" id="{E0C63E7D-F15B-4BF4-A742-28FF8A087C60}"/>
+                <a16:creationId xmlns:a16="http://schemas.microsoft.com/office/drawing/2014/main" id="{139C8D9D-F442-4EB2-B8A0-93E524324E5E}"/>
               </a:ext>
             </a:extLst>
           </p:cNvPr>
@@ -17428,7 +17428,7 @@
           <p:cNvPr id="3" name="title-7">
             <a:extLst xmlns:a="http://schemas.openxmlformats.org/drawingml/2006/main">
               <a:ext uri="{FF2B5EF4-FFF2-40B4-BE49-F238E27FC236}">
-                <a16:creationId xmlns:a16="http://schemas.microsoft.com/office/drawing/2014/main" id="{5B22712B-CD6B-491F-AF89-38AAAFD9529C}"/>
+                <a16:creationId xmlns:a16="http://schemas.microsoft.com/office/drawing/2014/main" id="{9711542A-9EED-43BF-816C-ED8479253D10}"/>
               </a:ext>
             </a:extLst>
           </p:cNvPr>
@@ -17490,7 +17490,7 @@
           <p:cNvPr id="4" name="">
             <a:extLst xmlns:a="http://schemas.openxmlformats.org/drawingml/2006/main">
               <a:ext uri="{FF2B5EF4-FFF2-40B4-BE49-F238E27FC236}">
-                <a16:creationId xmlns:a16="http://schemas.microsoft.com/office/drawing/2014/main" id="{DE51D360-0BBC-43F5-A1D2-686A62B01D63}"/>
+                <a16:creationId xmlns:a16="http://schemas.microsoft.com/office/drawing/2014/main" id="{0C5B3C41-AFA7-425E-A5AB-700FE55E1508}"/>
               </a:ext>
             </a:extLst>
           </p:cNvPr>
@@ -17552,7 +17552,7 @@
           <p:cNvPr id="5" name="">
             <a:extLst xmlns:a="http://schemas.openxmlformats.org/drawingml/2006/main">
               <a:ext uri="{FF2B5EF4-FFF2-40B4-BE49-F238E27FC236}">
-                <a16:creationId xmlns:a16="http://schemas.microsoft.com/office/drawing/2014/main" id="{617D934B-E5BB-4537-BE7E-92704E7054D2}"/>
+                <a16:creationId xmlns:a16="http://schemas.microsoft.com/office/drawing/2014/main" id="{F234DE34-0DC7-470A-96E2-37F3AC63ACC1}"/>
               </a:ext>
             </a:extLst>
           </p:cNvPr>
@@ -17587,7 +17587,7 @@
           <p:cNvPr id="6" name="">
             <a:extLst xmlns:a="http://schemas.openxmlformats.org/drawingml/2006/main">
               <a:ext uri="{FF2B5EF4-FFF2-40B4-BE49-F238E27FC236}">
-                <a16:creationId xmlns:a16="http://schemas.microsoft.com/office/drawing/2014/main" id="{912A7229-EC47-4CA2-9957-A3978BBC7655}"/>
+                <a16:creationId xmlns:a16="http://schemas.microsoft.com/office/drawing/2014/main" id="{5B260567-4BDC-4667-99BE-8BE59ABEF316}"/>
               </a:ext>
             </a:extLst>
           </p:cNvPr>
@@ -17649,7 +17649,7 @@
           <p:cNvPr id="7" name="">
             <a:extLst xmlns:a="http://schemas.openxmlformats.org/drawingml/2006/main">
               <a:ext uri="{FF2B5EF4-FFF2-40B4-BE49-F238E27FC236}">
-                <a16:creationId xmlns:a16="http://schemas.microsoft.com/office/drawing/2014/main" id="{ADE68C96-BFB3-469A-8774-EE0948FBA097}"/>
+                <a16:creationId xmlns:a16="http://schemas.microsoft.com/office/drawing/2014/main" id="{E3C2AA1B-CFAD-482C-97EE-F2E451435144}"/>
               </a:ext>
             </a:extLst>
           </p:cNvPr>
@@ -17711,7 +17711,7 @@
           <p:cNvPr id="8" name="">
             <a:extLst xmlns:a="http://schemas.openxmlformats.org/drawingml/2006/main">
               <a:ext uri="{FF2B5EF4-FFF2-40B4-BE49-F238E27FC236}">
-                <a16:creationId xmlns:a16="http://schemas.microsoft.com/office/drawing/2014/main" id="{8079E14A-3A49-4E02-929D-E5707551C716}"/>
+                <a16:creationId xmlns:a16="http://schemas.microsoft.com/office/drawing/2014/main" id="{B4E685AE-1FC3-41CE-A44E-0E2553A49589}"/>
               </a:ext>
             </a:extLst>
           </p:cNvPr>
@@ -17773,7 +17773,7 @@
           <p:cNvPr id="9" name="">
             <a:extLst xmlns:a="http://schemas.openxmlformats.org/drawingml/2006/main">
               <a:ext uri="{FF2B5EF4-FFF2-40B4-BE49-F238E27FC236}">
-                <a16:creationId xmlns:a16="http://schemas.microsoft.com/office/drawing/2014/main" id="{91B9409F-E109-46B4-B483-3F610EF4F738}"/>
+                <a16:creationId xmlns:a16="http://schemas.microsoft.com/office/drawing/2014/main" id="{CA32B853-AAEF-4212-8FBC-A4DC50551ECD}"/>
               </a:ext>
             </a:extLst>
           </p:cNvPr>
@@ -17808,7 +17808,7 @@
           <p:cNvPr id="10" name="">
             <a:extLst xmlns:a="http://schemas.openxmlformats.org/drawingml/2006/main">
               <a:ext uri="{FF2B5EF4-FFF2-40B4-BE49-F238E27FC236}">
-                <a16:creationId xmlns:a16="http://schemas.microsoft.com/office/drawing/2014/main" id="{B252B367-B6C4-4D4B-B64F-4BE01FE25E0A}"/>
+                <a16:creationId xmlns:a16="http://schemas.microsoft.com/office/drawing/2014/main" id="{6E409605-2EF1-4680-AC2B-2632B8D6F0D8}"/>
               </a:ext>
             </a:extLst>
           </p:cNvPr>
@@ -17870,7 +17870,7 @@
           <p:cNvPr id="11" name="">
             <a:extLst xmlns:a="http://schemas.openxmlformats.org/drawingml/2006/main">
               <a:ext uri="{FF2B5EF4-FFF2-40B4-BE49-F238E27FC236}">
-                <a16:creationId xmlns:a16="http://schemas.microsoft.com/office/drawing/2014/main" id="{D1597A61-BEB7-40A6-9BB3-17EAD7AA26CC}"/>
+                <a16:creationId xmlns:a16="http://schemas.microsoft.com/office/drawing/2014/main" id="{C153D369-B40E-4AE7-BA8E-03D42A5E8052}"/>
               </a:ext>
             </a:extLst>
           </p:cNvPr>
@@ -17932,7 +17932,7 @@
           <p:cNvPr id="12" name="">
             <a:extLst xmlns:a="http://schemas.openxmlformats.org/drawingml/2006/main">
               <a:ext uri="{FF2B5EF4-FFF2-40B4-BE49-F238E27FC236}">
-                <a16:creationId xmlns:a16="http://schemas.microsoft.com/office/drawing/2014/main" id="{7F229670-0C32-4D7D-BE4A-C16FC14CB188}"/>
+                <a16:creationId xmlns:a16="http://schemas.microsoft.com/office/drawing/2014/main" id="{5D93CA2E-D36D-4F29-85EE-ACF5EECA6279}"/>
               </a:ext>
             </a:extLst>
           </p:cNvPr>
@@ -17994,7 +17994,7 @@
           <p:cNvPr id="13" name="">
             <a:extLst xmlns:a="http://schemas.openxmlformats.org/drawingml/2006/main">
               <a:ext uri="{FF2B5EF4-FFF2-40B4-BE49-F238E27FC236}">
-                <a16:creationId xmlns:a16="http://schemas.microsoft.com/office/drawing/2014/main" id="{26C1B5DB-FB73-465C-BFFD-6F6594BCD3C9}"/>
+                <a16:creationId xmlns:a16="http://schemas.microsoft.com/office/drawing/2014/main" id="{7371F1C5-7CBD-4CCB-ACE8-7012538428A7}"/>
               </a:ext>
             </a:extLst>
           </p:cNvPr>
@@ -18029,7 +18029,7 @@
           <p:cNvPr id="14" name="">
             <a:extLst xmlns:a="http://schemas.openxmlformats.org/drawingml/2006/main">
               <a:ext uri="{FF2B5EF4-FFF2-40B4-BE49-F238E27FC236}">
-                <a16:creationId xmlns:a16="http://schemas.microsoft.com/office/drawing/2014/main" id="{81B8170D-E50D-45E9-AD7C-C5A57C2ACF3E}"/>
+                <a16:creationId xmlns:a16="http://schemas.microsoft.com/office/drawing/2014/main" id="{19586AF7-985F-4E6F-A7AD-9CDFE2FA0F41}"/>
               </a:ext>
             </a:extLst>
           </p:cNvPr>
@@ -18091,7 +18091,7 @@
           <p:cNvPr id="15" name="">
             <a:extLst xmlns:a="http://schemas.openxmlformats.org/drawingml/2006/main">
               <a:ext uri="{FF2B5EF4-FFF2-40B4-BE49-F238E27FC236}">
-                <a16:creationId xmlns:a16="http://schemas.microsoft.com/office/drawing/2014/main" id="{62BD9D63-6F32-4254-AA3E-5E317F5C8B1D}"/>
+                <a16:creationId xmlns:a16="http://schemas.microsoft.com/office/drawing/2014/main" id="{4567A161-DFB9-4CE6-8C3C-2F1791457AE6}"/>
               </a:ext>
             </a:extLst>
           </p:cNvPr>
@@ -18153,7 +18153,7 @@
           <p:cNvPr id="16" name="">
             <a:extLst xmlns:a="http://schemas.openxmlformats.org/drawingml/2006/main">
               <a:ext uri="{FF2B5EF4-FFF2-40B4-BE49-F238E27FC236}">
-                <a16:creationId xmlns:a16="http://schemas.microsoft.com/office/drawing/2014/main" id="{97D63AEA-A9B7-436F-89F2-03F793D1A6F7}"/>
+                <a16:creationId xmlns:a16="http://schemas.microsoft.com/office/drawing/2014/main" id="{77463926-DC0D-4ED3-8133-24743F4ABE81}"/>
               </a:ext>
             </a:extLst>
           </p:cNvPr>
@@ -18215,7 +18215,7 @@
           <p:cNvPr id="17" name="">
             <a:extLst xmlns:a="http://schemas.openxmlformats.org/drawingml/2006/main">
               <a:ext uri="{FF2B5EF4-FFF2-40B4-BE49-F238E27FC236}">
-                <a16:creationId xmlns:a16="http://schemas.microsoft.com/office/drawing/2014/main" id="{52EB541E-A8B7-44AA-99F6-A61F258C42F0}"/>
+                <a16:creationId xmlns:a16="http://schemas.microsoft.com/office/drawing/2014/main" id="{67866E86-799F-4A48-A35B-1862CAC9A2DB}"/>
               </a:ext>
             </a:extLst>
           </p:cNvPr>
@@ -18250,7 +18250,7 @@
           <p:cNvPr id="18" name="">
             <a:extLst xmlns:a="http://schemas.openxmlformats.org/drawingml/2006/main">
               <a:ext uri="{FF2B5EF4-FFF2-40B4-BE49-F238E27FC236}">
-                <a16:creationId xmlns:a16="http://schemas.microsoft.com/office/drawing/2014/main" id="{04023A48-A7DF-469B-9E0C-A0AE2A6A20C5}"/>
+                <a16:creationId xmlns:a16="http://schemas.microsoft.com/office/drawing/2014/main" id="{F31A1EA6-1AA5-42EA-9BD3-368AB137B508}"/>
               </a:ext>
             </a:extLst>
           </p:cNvPr>
@@ -18312,7 +18312,7 @@
           <p:cNvPr id="19" name="">
             <a:extLst xmlns:a="http://schemas.openxmlformats.org/drawingml/2006/main">
               <a:ext uri="{FF2B5EF4-FFF2-40B4-BE49-F238E27FC236}">
-                <a16:creationId xmlns:a16="http://schemas.microsoft.com/office/drawing/2014/main" id="{C4F6B37A-E55A-43D6-AB43-17BC4B906166}"/>
+                <a16:creationId xmlns:a16="http://schemas.microsoft.com/office/drawing/2014/main" id="{E3F88B96-979F-4B8C-BCE5-08317741764D}"/>
               </a:ext>
             </a:extLst>
           </p:cNvPr>
@@ -18374,7 +18374,7 @@
           <p:cNvPr id="20" name="">
             <a:extLst xmlns:a="http://schemas.openxmlformats.org/drawingml/2006/main">
               <a:ext uri="{FF2B5EF4-FFF2-40B4-BE49-F238E27FC236}">
-                <a16:creationId xmlns:a16="http://schemas.microsoft.com/office/drawing/2014/main" id="{9ED03949-192A-4B44-9517-0C532B3CB35A}"/>
+                <a16:creationId xmlns:a16="http://schemas.microsoft.com/office/drawing/2014/main" id="{9DD37021-F652-46AE-916D-8A673AA49B3A}"/>
               </a:ext>
             </a:extLst>
           </p:cNvPr>
@@ -18436,7 +18436,7 @@
           <p:cNvPr id="21" name="">
             <a:extLst xmlns:a="http://schemas.openxmlformats.org/drawingml/2006/main">
               <a:ext uri="{FF2B5EF4-FFF2-40B4-BE49-F238E27FC236}">
-                <a16:creationId xmlns:a16="http://schemas.microsoft.com/office/drawing/2014/main" id="{9B9E12D8-1341-4960-AAFD-17FB44197CFC}"/>
+                <a16:creationId xmlns:a16="http://schemas.microsoft.com/office/drawing/2014/main" id="{9DFCC3D5-678D-4F50-9779-7E1C7086E8A6}"/>
               </a:ext>
             </a:extLst>
           </p:cNvPr>
@@ -18498,7 +18498,7 @@
           <p:cNvPr id="22" name="footer-rule-7">
             <a:extLst xmlns:a="http://schemas.openxmlformats.org/drawingml/2006/main">
               <a:ext uri="{FF2B5EF4-FFF2-40B4-BE49-F238E27FC236}">
-                <a16:creationId xmlns:a16="http://schemas.microsoft.com/office/drawing/2014/main" id="{69FF7D4E-4E24-4CE5-9854-408567B5FB23}"/>
+                <a16:creationId xmlns:a16="http://schemas.microsoft.com/office/drawing/2014/main" id="{07E12F1A-30E4-4E91-AECA-870B5A4C2853}"/>
               </a:ext>
             </a:extLst>
           </p:cNvPr>
@@ -18529,7 +18529,7 @@
           <p:cNvPr id="23" name="footer-label-7">
             <a:extLst xmlns:a="http://schemas.openxmlformats.org/drawingml/2006/main">
               <a:ext uri="{FF2B5EF4-FFF2-40B4-BE49-F238E27FC236}">
-                <a16:creationId xmlns:a16="http://schemas.microsoft.com/office/drawing/2014/main" id="{C64A76EC-A0D5-4B37-ADA5-F2F09A0E3DC0}"/>
+                <a16:creationId xmlns:a16="http://schemas.microsoft.com/office/drawing/2014/main" id="{02C1CBC2-90CE-4628-AE6E-FF71D09ACA2A}"/>
               </a:ext>
             </a:extLst>
           </p:cNvPr>
@@ -18591,7 +18591,7 @@
           <p:cNvPr id="24" name="footer-page-7">
             <a:extLst xmlns:a="http://schemas.openxmlformats.org/drawingml/2006/main">
               <a:ext uri="{FF2B5EF4-FFF2-40B4-BE49-F238E27FC236}">
-                <a16:creationId xmlns:a16="http://schemas.microsoft.com/office/drawing/2014/main" id="{2AFCCC3F-BFCB-41CA-AF56-93C3FD0B5358}"/>
+                <a16:creationId xmlns:a16="http://schemas.microsoft.com/office/drawing/2014/main" id="{3C651546-2057-471A-B36E-3D5662D23103}"/>
               </a:ext>
             </a:extLst>
           </p:cNvPr>
@@ -18651,7 +18651,7 @@
     </p:spTree>
     <p:extLst>
       <p:ext uri="{BB962C8B-B14F-4D97-AF65-F5344CB8AC3E}">
-        <p14:creationId xmlns:p14="http://schemas.microsoft.com/office/powerpoint/2010/main" val="631205627"/>
+        <p14:creationId xmlns:p14="http://schemas.microsoft.com/office/powerpoint/2010/main" val="1250511536"/>
       </p:ext>
     </p:extLst>
   </p:cSld>
@@ -18682,7 +18682,7 @@
           <p:cNvPr id="21" name="side-accent-8">
             <a:extLst xmlns:a="http://schemas.openxmlformats.org/drawingml/2006/main">
               <a:ext uri="{FF2B5EF4-FFF2-40B4-BE49-F238E27FC236}">
-                <a16:creationId xmlns:a16="http://schemas.microsoft.com/office/drawing/2014/main" id="{630EF2C6-A950-456D-AB7E-818D2DD440FE}"/>
+                <a16:creationId xmlns:a16="http://schemas.microsoft.com/office/drawing/2014/main" id="{FDA5A7EB-12D0-4350-8EA8-4D9074CF88B1}"/>
               </a:ext>
             </a:extLst>
           </p:cNvPr>
@@ -18713,7 +18713,7 @@
           <p:cNvPr id="2" name="kicker-8">
             <a:extLst xmlns:a="http://schemas.openxmlformats.org/drawingml/2006/main">
               <a:ext uri="{FF2B5EF4-FFF2-40B4-BE49-F238E27FC236}">
-                <a16:creationId xmlns:a16="http://schemas.microsoft.com/office/drawing/2014/main" id="{184ABAD0-5712-4AEF-B75F-F3409954618C}"/>
+                <a16:creationId xmlns:a16="http://schemas.microsoft.com/office/drawing/2014/main" id="{BE20900A-AC94-4A49-B954-D2C5DDFD17FC}"/>
               </a:ext>
             </a:extLst>
           </p:cNvPr>
@@ -18775,7 +18775,7 @@
           <p:cNvPr id="3" name="title-8">
             <a:extLst xmlns:a="http://schemas.openxmlformats.org/drawingml/2006/main">
               <a:ext uri="{FF2B5EF4-FFF2-40B4-BE49-F238E27FC236}">
-                <a16:creationId xmlns:a16="http://schemas.microsoft.com/office/drawing/2014/main" id="{21DB7395-CA03-4F47-8D83-970524121EC2}"/>
+                <a16:creationId xmlns:a16="http://schemas.microsoft.com/office/drawing/2014/main" id="{ABB59984-A15F-4EC4-9CF7-4E071643FB77}"/>
               </a:ext>
             </a:extLst>
           </p:cNvPr>
@@ -18837,7 +18837,7 @@
           <p:cNvPr id="4" name="">
             <a:extLst xmlns:a="http://schemas.openxmlformats.org/drawingml/2006/main">
               <a:ext uri="{FF2B5EF4-FFF2-40B4-BE49-F238E27FC236}">
-                <a16:creationId xmlns:a16="http://schemas.microsoft.com/office/drawing/2014/main" id="{6E47BC65-A6B5-4657-A7A1-A4C42BFC8F20}"/>
+                <a16:creationId xmlns:a16="http://schemas.microsoft.com/office/drawing/2014/main" id="{8592F363-7680-44AB-A2C7-DCF939C2AD74}"/>
               </a:ext>
             </a:extLst>
           </p:cNvPr>
@@ -18899,7 +18899,7 @@
           <p:cNvPr id="5" name="">
             <a:extLst xmlns:a="http://schemas.openxmlformats.org/drawingml/2006/main">
               <a:ext uri="{FF2B5EF4-FFF2-40B4-BE49-F238E27FC236}">
-                <a16:creationId xmlns:a16="http://schemas.microsoft.com/office/drawing/2014/main" id="{BB22776A-28C2-4904-B358-635DE1D370F3}"/>
+                <a16:creationId xmlns:a16="http://schemas.microsoft.com/office/drawing/2014/main" id="{F293ACE2-0F6D-45F2-90A7-DFAE62CFF74E}"/>
               </a:ext>
             </a:extLst>
           </p:cNvPr>
@@ -18961,7 +18961,7 @@
           <p:cNvPr id="6" name="">
             <a:extLst xmlns:a="http://schemas.openxmlformats.org/drawingml/2006/main">
               <a:ext uri="{FF2B5EF4-FFF2-40B4-BE49-F238E27FC236}">
-                <a16:creationId xmlns:a16="http://schemas.microsoft.com/office/drawing/2014/main" id="{4BDEAC64-F9DE-41FC-81C0-F76FF4A75117}"/>
+                <a16:creationId xmlns:a16="http://schemas.microsoft.com/office/drawing/2014/main" id="{43028E6D-4652-4C16-B604-79F4E458E33D}"/>
               </a:ext>
             </a:extLst>
           </p:cNvPr>
@@ -19023,7 +19023,7 @@
           <p:cNvPr id="7" name="">
             <a:extLst xmlns:a="http://schemas.openxmlformats.org/drawingml/2006/main">
               <a:ext uri="{FF2B5EF4-FFF2-40B4-BE49-F238E27FC236}">
-                <a16:creationId xmlns:a16="http://schemas.microsoft.com/office/drawing/2014/main" id="{322F24E9-BCF5-488A-A1B8-88F5C024CA66}"/>
+                <a16:creationId xmlns:a16="http://schemas.microsoft.com/office/drawing/2014/main" id="{4778118F-D8EF-48F1-9D6C-696391E53C92}"/>
               </a:ext>
             </a:extLst>
           </p:cNvPr>
@@ -19085,7 +19085,7 @@
           <p:cNvPr id="8" name="">
             <a:extLst xmlns:a="http://schemas.openxmlformats.org/drawingml/2006/main">
               <a:ext uri="{FF2B5EF4-FFF2-40B4-BE49-F238E27FC236}">
-                <a16:creationId xmlns:a16="http://schemas.microsoft.com/office/drawing/2014/main" id="{D6C4C2DF-1134-4FEC-AD8E-4C4A8A92D691}"/>
+                <a16:creationId xmlns:a16="http://schemas.microsoft.com/office/drawing/2014/main" id="{396A186D-0237-4AEA-93FA-25C09625D934}"/>
               </a:ext>
             </a:extLst>
           </p:cNvPr>
@@ -19116,7 +19116,7 @@
           <p:cNvPr id="9" name="">
             <a:extLst xmlns:a="http://schemas.openxmlformats.org/drawingml/2006/main">
               <a:ext uri="{FF2B5EF4-FFF2-40B4-BE49-F238E27FC236}">
-                <a16:creationId xmlns:a16="http://schemas.microsoft.com/office/drawing/2014/main" id="{74A66B0A-3FC3-44E7-B0ED-DEE4A0373FF4}"/>
+                <a16:creationId xmlns:a16="http://schemas.microsoft.com/office/drawing/2014/main" id="{7740FAA6-1515-4F11-93C6-BFC71532C187}"/>
               </a:ext>
             </a:extLst>
           </p:cNvPr>
@@ -19178,7 +19178,7 @@
           <p:cNvPr id="10" name="">
             <a:extLst xmlns:a="http://schemas.openxmlformats.org/drawingml/2006/main">
               <a:ext uri="{FF2B5EF4-FFF2-40B4-BE49-F238E27FC236}">
-                <a16:creationId xmlns:a16="http://schemas.microsoft.com/office/drawing/2014/main" id="{1A670FAF-44DF-4978-8F41-57DA854A511C}"/>
+                <a16:creationId xmlns:a16="http://schemas.microsoft.com/office/drawing/2014/main" id="{A321EC42-8E5C-4E6E-B773-D3C7ABEE63F9}"/>
               </a:ext>
             </a:extLst>
           </p:cNvPr>
@@ -19240,7 +19240,7 @@
           <p:cNvPr id="11" name="">
             <a:extLst xmlns:a="http://schemas.openxmlformats.org/drawingml/2006/main">
               <a:ext uri="{FF2B5EF4-FFF2-40B4-BE49-F238E27FC236}">
-                <a16:creationId xmlns:a16="http://schemas.microsoft.com/office/drawing/2014/main" id="{70306C56-C3A4-4AAF-B24F-6B3C1279F675}"/>
+                <a16:creationId xmlns:a16="http://schemas.microsoft.com/office/drawing/2014/main" id="{2B5613C5-B956-415A-9677-CFBFBF4A792E}"/>
               </a:ext>
             </a:extLst>
           </p:cNvPr>
@@ -19302,7 +19302,7 @@
           <p:cNvPr id="12" name="">
             <a:extLst xmlns:a="http://schemas.openxmlformats.org/drawingml/2006/main">
               <a:ext uri="{FF2B5EF4-FFF2-40B4-BE49-F238E27FC236}">
-                <a16:creationId xmlns:a16="http://schemas.microsoft.com/office/drawing/2014/main" id="{E2889A61-FADA-41F0-AE21-DB008DDC8CF9}"/>
+                <a16:creationId xmlns:a16="http://schemas.microsoft.com/office/drawing/2014/main" id="{3595F064-E061-401D-AF3E-C947635CDE32}"/>
               </a:ext>
             </a:extLst>
           </p:cNvPr>
@@ -19333,7 +19333,7 @@
           <p:cNvPr id="13" name="">
             <a:extLst xmlns:a="http://schemas.openxmlformats.org/drawingml/2006/main">
               <a:ext uri="{FF2B5EF4-FFF2-40B4-BE49-F238E27FC236}">
-                <a16:creationId xmlns:a16="http://schemas.microsoft.com/office/drawing/2014/main" id="{EFF232B1-3C97-4B01-9581-752031388417}"/>
+                <a16:creationId xmlns:a16="http://schemas.microsoft.com/office/drawing/2014/main" id="{01CF19A3-84FD-4740-A652-53F85E95EB16}"/>
               </a:ext>
             </a:extLst>
           </p:cNvPr>
@@ -19395,7 +19395,7 @@
           <p:cNvPr id="14" name="">
             <a:extLst xmlns:a="http://schemas.openxmlformats.org/drawingml/2006/main">
               <a:ext uri="{FF2B5EF4-FFF2-40B4-BE49-F238E27FC236}">
-                <a16:creationId xmlns:a16="http://schemas.microsoft.com/office/drawing/2014/main" id="{AA16C5CB-2AB1-49D5-ACBB-E937AF9027F2}"/>
+                <a16:creationId xmlns:a16="http://schemas.microsoft.com/office/drawing/2014/main" id="{77DA5367-BC5B-4F4B-9339-1966AD17E8BC}"/>
               </a:ext>
             </a:extLst>
           </p:cNvPr>
@@ -19457,7 +19457,7 @@
           <p:cNvPr id="15" name="">
             <a:extLst xmlns:a="http://schemas.openxmlformats.org/drawingml/2006/main">
               <a:ext uri="{FF2B5EF4-FFF2-40B4-BE49-F238E27FC236}">
-                <a16:creationId xmlns:a16="http://schemas.microsoft.com/office/drawing/2014/main" id="{2C66E665-6E54-487A-8EB7-094C785BA3DD}"/>
+                <a16:creationId xmlns:a16="http://schemas.microsoft.com/office/drawing/2014/main" id="{A7C4DFCE-F77B-4127-BC3F-809AA97701BB}"/>
               </a:ext>
             </a:extLst>
           </p:cNvPr>
@@ -19519,7 +19519,7 @@
           <p:cNvPr id="16" name="">
             <a:extLst xmlns:a="http://schemas.openxmlformats.org/drawingml/2006/main">
               <a:ext uri="{FF2B5EF4-FFF2-40B4-BE49-F238E27FC236}">
-                <a16:creationId xmlns:a16="http://schemas.microsoft.com/office/drawing/2014/main" id="{DCFCDF88-7017-4181-B929-0D1BAFCE6DD5}"/>
+                <a16:creationId xmlns:a16="http://schemas.microsoft.com/office/drawing/2014/main" id="{4BFEB7A1-9B0D-414B-918E-1C78C75015AA}"/>
               </a:ext>
             </a:extLst>
           </p:cNvPr>
@@ -19552,7 +19552,7 @@
           <p:cNvPr id="17" name="">
             <a:extLst xmlns:a="http://schemas.openxmlformats.org/drawingml/2006/main">
               <a:ext uri="{FF2B5EF4-FFF2-40B4-BE49-F238E27FC236}">
-                <a16:creationId xmlns:a16="http://schemas.microsoft.com/office/drawing/2014/main" id="{B4DC556B-9C17-4B1B-A3C7-10B046B4ADB2}"/>
+                <a16:creationId xmlns:a16="http://schemas.microsoft.com/office/drawing/2014/main" id="{062DEEBF-4054-48F1-B8D9-7E3FFF08F6BC}"/>
               </a:ext>
             </a:extLst>
           </p:cNvPr>
@@ -19614,7 +19614,7 @@
           <p:cNvPr id="18" name="footer-rule-8">
             <a:extLst xmlns:a="http://schemas.openxmlformats.org/drawingml/2006/main">
               <a:ext uri="{FF2B5EF4-FFF2-40B4-BE49-F238E27FC236}">
-                <a16:creationId xmlns:a16="http://schemas.microsoft.com/office/drawing/2014/main" id="{C203DBEC-719B-4644-8FFD-743D7015B487}"/>
+                <a16:creationId xmlns:a16="http://schemas.microsoft.com/office/drawing/2014/main" id="{3B9E256C-132E-4D75-BF07-6880A0499D52}"/>
               </a:ext>
             </a:extLst>
           </p:cNvPr>
@@ -19645,7 +19645,7 @@
           <p:cNvPr id="19" name="footer-label-8">
             <a:extLst xmlns:a="http://schemas.openxmlformats.org/drawingml/2006/main">
               <a:ext uri="{FF2B5EF4-FFF2-40B4-BE49-F238E27FC236}">
-                <a16:creationId xmlns:a16="http://schemas.microsoft.com/office/drawing/2014/main" id="{BC750CB3-21A1-47FC-A594-5ADCAD756C17}"/>
+                <a16:creationId xmlns:a16="http://schemas.microsoft.com/office/drawing/2014/main" id="{65EA5361-ED02-4127-B54B-77532CE52566}"/>
               </a:ext>
             </a:extLst>
           </p:cNvPr>
@@ -19707,7 +19707,7 @@
           <p:cNvPr id="20" name="footer-page-8">
             <a:extLst xmlns:a="http://schemas.openxmlformats.org/drawingml/2006/main">
               <a:ext uri="{FF2B5EF4-FFF2-40B4-BE49-F238E27FC236}">
-                <a16:creationId xmlns:a16="http://schemas.microsoft.com/office/drawing/2014/main" id="{7D0AB9F9-0C75-434A-A6D6-09CA6A38BB83}"/>
+                <a16:creationId xmlns:a16="http://schemas.microsoft.com/office/drawing/2014/main" id="{BADA527C-AA7F-4A8B-A513-3C4D086D9A4F}"/>
               </a:ext>
             </a:extLst>
           </p:cNvPr>
@@ -19767,7 +19767,7 @@
     </p:spTree>
     <p:extLst>
       <p:ext uri="{BB962C8B-B14F-4D97-AF65-F5344CB8AC3E}">
-        <p14:creationId xmlns:p14="http://schemas.microsoft.com/office/powerpoint/2010/main" val="2010836424"/>
+        <p14:creationId xmlns:p14="http://schemas.microsoft.com/office/powerpoint/2010/main" val="450419575"/>
       </p:ext>
     </p:extLst>
   </p:cSld>
@@ -19798,7 +19798,7 @@
           <p:cNvPr id="22" name="side-accent-9">
             <a:extLst xmlns:a="http://schemas.openxmlformats.org/drawingml/2006/main">
               <a:ext uri="{FF2B5EF4-FFF2-40B4-BE49-F238E27FC236}">
-                <a16:creationId xmlns:a16="http://schemas.microsoft.com/office/drawing/2014/main" id="{E8652B17-8DFC-46E7-9EB0-5299BDF64D2F}"/>
+                <a16:creationId xmlns:a16="http://schemas.microsoft.com/office/drawing/2014/main" id="{D2F262E0-EFF7-4A06-B78D-47F096CB564B}"/>
               </a:ext>
             </a:extLst>
           </p:cNvPr>
@@ -19829,7 +19829,7 @@
           <p:cNvPr id="2" name="kicker-9">
             <a:extLst xmlns:a="http://schemas.openxmlformats.org/drawingml/2006/main">
               <a:ext uri="{FF2B5EF4-FFF2-40B4-BE49-F238E27FC236}">
-                <a16:creationId xmlns:a16="http://schemas.microsoft.com/office/drawing/2014/main" id="{819755AF-72B5-4CC7-A918-C06409DFA218}"/>
+                <a16:creationId xmlns:a16="http://schemas.microsoft.com/office/drawing/2014/main" id="{D480F920-827C-465C-BE6D-8966055B3D53}"/>
               </a:ext>
             </a:extLst>
           </p:cNvPr>
@@ -19891,7 +19891,7 @@
           <p:cNvPr id="3" name="title-9">
             <a:extLst xmlns:a="http://schemas.openxmlformats.org/drawingml/2006/main">
               <a:ext uri="{FF2B5EF4-FFF2-40B4-BE49-F238E27FC236}">
-                <a16:creationId xmlns:a16="http://schemas.microsoft.com/office/drawing/2014/main" id="{0520974E-6162-45FE-81F3-A3AD8BA47E68}"/>
+                <a16:creationId xmlns:a16="http://schemas.microsoft.com/office/drawing/2014/main" id="{978142E1-51FF-4958-8DF2-FCB8140C1B8C}"/>
               </a:ext>
             </a:extLst>
           </p:cNvPr>
@@ -19953,7 +19953,7 @@
           <p:cNvPr id="4" name="">
             <a:extLst xmlns:a="http://schemas.openxmlformats.org/drawingml/2006/main">
               <a:ext uri="{FF2B5EF4-FFF2-40B4-BE49-F238E27FC236}">
-                <a16:creationId xmlns:a16="http://schemas.microsoft.com/office/drawing/2014/main" id="{E7ECAB45-1CEE-4AF7-B16E-90967F7C3A04}"/>
+                <a16:creationId xmlns:a16="http://schemas.microsoft.com/office/drawing/2014/main" id="{1D946499-7AB9-4EE1-B85D-928043BC2159}"/>
               </a:ext>
             </a:extLst>
           </p:cNvPr>
@@ -20015,7 +20015,7 @@
           <p:cNvPr id="5" name="">
             <a:extLst xmlns:a="http://schemas.openxmlformats.org/drawingml/2006/main">
               <a:ext uri="{FF2B5EF4-FFF2-40B4-BE49-F238E27FC236}">
-                <a16:creationId xmlns:a16="http://schemas.microsoft.com/office/drawing/2014/main" id="{B5140A3D-FBF9-4106-AA23-39AE8A3BF2CC}"/>
+                <a16:creationId xmlns:a16="http://schemas.microsoft.com/office/drawing/2014/main" id="{8965C0C6-ADB1-4041-80C5-26823DA014BE}"/>
               </a:ext>
             </a:extLst>
           </p:cNvPr>
@@ -20046,7 +20046,7 @@
           <p:cNvPr id="6" name="">
             <a:extLst xmlns:a="http://schemas.openxmlformats.org/drawingml/2006/main">
               <a:ext uri="{FF2B5EF4-FFF2-40B4-BE49-F238E27FC236}">
-                <a16:creationId xmlns:a16="http://schemas.microsoft.com/office/drawing/2014/main" id="{772C4088-ED5C-41E6-AF8C-D66F6484BC62}"/>
+                <a16:creationId xmlns:a16="http://schemas.microsoft.com/office/drawing/2014/main" id="{0CADBE81-C83D-407F-8BE4-3A64F6C54830}"/>
               </a:ext>
             </a:extLst>
           </p:cNvPr>
@@ -20108,7 +20108,7 @@
           <p:cNvPr id="7" name="">
             <a:extLst xmlns:a="http://schemas.openxmlformats.org/drawingml/2006/main">
               <a:ext uri="{FF2B5EF4-FFF2-40B4-BE49-F238E27FC236}">
-                <a16:creationId xmlns:a16="http://schemas.microsoft.com/office/drawing/2014/main" id="{82198A7D-83F0-4959-BCFA-936247559A2F}"/>
+                <a16:creationId xmlns:a16="http://schemas.microsoft.com/office/drawing/2014/main" id="{F12A96FA-E767-4A04-A7AF-0A6D6BC9CEB5}"/>
               </a:ext>
             </a:extLst>
           </p:cNvPr>
@@ -20170,7 +20170,7 @@
           <p:cNvPr id="8" name="">
             <a:extLst xmlns:a="http://schemas.openxmlformats.org/drawingml/2006/main">
               <a:ext uri="{FF2B5EF4-FFF2-40B4-BE49-F238E27FC236}">
-                <a16:creationId xmlns:a16="http://schemas.microsoft.com/office/drawing/2014/main" id="{4CF1D6C8-4A88-4623-835C-431E786E5443}"/>
+                <a16:creationId xmlns:a16="http://schemas.microsoft.com/office/drawing/2014/main" id="{1CECFFAC-1110-4C5F-8CFD-188B39A80820}"/>
               </a:ext>
             </a:extLst>
           </p:cNvPr>
@@ -20232,7 +20232,7 @@
           <p:cNvPr id="9" name="">
             <a:extLst xmlns:a="http://schemas.openxmlformats.org/drawingml/2006/main">
               <a:ext uri="{FF2B5EF4-FFF2-40B4-BE49-F238E27FC236}">
-                <a16:creationId xmlns:a16="http://schemas.microsoft.com/office/drawing/2014/main" id="{EE2B240B-CBDB-4B48-AE22-97AF79744629}"/>
+                <a16:creationId xmlns:a16="http://schemas.microsoft.com/office/drawing/2014/main" id="{B785ACE1-B0F1-45BF-9E41-D344EACA96FD}"/>
               </a:ext>
             </a:extLst>
           </p:cNvPr>
@@ -20263,7 +20263,7 @@
           <p:cNvPr id="10" name="">
             <a:extLst xmlns:a="http://schemas.openxmlformats.org/drawingml/2006/main">
               <a:ext uri="{FF2B5EF4-FFF2-40B4-BE49-F238E27FC236}">
-                <a16:creationId xmlns:a16="http://schemas.microsoft.com/office/drawing/2014/main" id="{8EB07BC4-7F10-4E73-A14E-00E4BC4074B2}"/>
+                <a16:creationId xmlns:a16="http://schemas.microsoft.com/office/drawing/2014/main" id="{E7291B7B-CB9D-467D-BC76-C5B6AAD64247}"/>
               </a:ext>
             </a:extLst>
           </p:cNvPr>
@@ -20325,7 +20325,7 @@
           <p:cNvPr id="11" name="">
             <a:extLst xmlns:a="http://schemas.openxmlformats.org/drawingml/2006/main">
               <a:ext uri="{FF2B5EF4-FFF2-40B4-BE49-F238E27FC236}">
-                <a16:creationId xmlns:a16="http://schemas.microsoft.com/office/drawing/2014/main" id="{51836874-1596-473E-A243-56BA32D48BEF}"/>
+                <a16:creationId xmlns:a16="http://schemas.microsoft.com/office/drawing/2014/main" id="{F18100C2-E4D0-4594-8581-546D67E1A60B}"/>
               </a:ext>
             </a:extLst>
           </p:cNvPr>
@@ -20387,7 +20387,7 @@
           <p:cNvPr id="12" name="">
             <a:extLst xmlns:a="http://schemas.openxmlformats.org/drawingml/2006/main">
               <a:ext uri="{FF2B5EF4-FFF2-40B4-BE49-F238E27FC236}">
-                <a16:creationId xmlns:a16="http://schemas.microsoft.com/office/drawing/2014/main" id="{904B4E6E-5FB7-421A-A920-0982B84AC359}"/>
+                <a16:creationId xmlns:a16="http://schemas.microsoft.com/office/drawing/2014/main" id="{F76EE559-65C7-4789-B496-C316AF75D0AB}"/>
               </a:ext>
             </a:extLst>
           </p:cNvPr>
@@ -20449,7 +20449,7 @@
           <p:cNvPr id="13" name="">
             <a:extLst xmlns:a="http://schemas.openxmlformats.org/drawingml/2006/main">
               <a:ext uri="{FF2B5EF4-FFF2-40B4-BE49-F238E27FC236}">
-                <a16:creationId xmlns:a16="http://schemas.microsoft.com/office/drawing/2014/main" id="{98115C70-80CC-4B28-A415-D672DE8E5D4F}"/>
+                <a16:creationId xmlns:a16="http://schemas.microsoft.com/office/drawing/2014/main" id="{D346B0CF-4ACF-4F0A-9ADE-E864E90E6A04}"/>
               </a:ext>
             </a:extLst>
           </p:cNvPr>
@@ -20480,7 +20480,7 @@
           <p:cNvPr id="14" name="">
             <a:extLst xmlns:a="http://schemas.openxmlformats.org/drawingml/2006/main">
               <a:ext uri="{FF2B5EF4-FFF2-40B4-BE49-F238E27FC236}">
-                <a16:creationId xmlns:a16="http://schemas.microsoft.com/office/drawing/2014/main" id="{8F32C413-662E-4449-B958-2DE93E88999C}"/>
+                <a16:creationId xmlns:a16="http://schemas.microsoft.com/office/drawing/2014/main" id="{9AAABCA7-72AC-4170-AB9C-BF899ED09138}"/>
               </a:ext>
             </a:extLst>
           </p:cNvPr>
@@ -20542,7 +20542,7 @@
           <p:cNvPr id="15" name="">
             <a:extLst xmlns:a="http://schemas.openxmlformats.org/drawingml/2006/main">
               <a:ext uri="{FF2B5EF4-FFF2-40B4-BE49-F238E27FC236}">
-                <a16:creationId xmlns:a16="http://schemas.microsoft.com/office/drawing/2014/main" id="{2E14E296-202C-485B-ADAB-DFC6BE932E35}"/>
+                <a16:creationId xmlns:a16="http://schemas.microsoft.com/office/drawing/2014/main" id="{2CD67E7A-9454-4A0D-9B7D-F313AE6741D8}"/>
               </a:ext>
             </a:extLst>
           </p:cNvPr>
@@ -20604,7 +20604,7 @@
           <p:cNvPr id="16" name="">
             <a:extLst xmlns:a="http://schemas.openxmlformats.org/drawingml/2006/main">
               <a:ext uri="{FF2B5EF4-FFF2-40B4-BE49-F238E27FC236}">
-                <a16:creationId xmlns:a16="http://schemas.microsoft.com/office/drawing/2014/main" id="{12774178-9CE0-4E11-BDE6-D7BDE19FFE98}"/>
+                <a16:creationId xmlns:a16="http://schemas.microsoft.com/office/drawing/2014/main" id="{F425A46D-1771-4CF2-8C4E-12CC3033DBF4}"/>
               </a:ext>
             </a:extLst>
           </p:cNvPr>
@@ -20666,7 +20666,7 @@
           <p:cNvPr id="17" name="">
             <a:extLst xmlns:a="http://schemas.openxmlformats.org/drawingml/2006/main">
               <a:ext uri="{FF2B5EF4-FFF2-40B4-BE49-F238E27FC236}">
-                <a16:creationId xmlns:a16="http://schemas.microsoft.com/office/drawing/2014/main" id="{8CF8D9C6-DD39-406A-B92A-C0E229C50CDB}"/>
+                <a16:creationId xmlns:a16="http://schemas.microsoft.com/office/drawing/2014/main" id="{2C9E2341-3152-4F35-A671-6D54A55EDDEC}"/>
               </a:ext>
             </a:extLst>
           </p:cNvPr>
@@ -20701,7 +20701,7 @@
           <p:cNvPr id="18" name="">
             <a:extLst xmlns:a="http://schemas.openxmlformats.org/drawingml/2006/main">
               <a:ext uri="{FF2B5EF4-FFF2-40B4-BE49-F238E27FC236}">
-                <a16:creationId xmlns:a16="http://schemas.microsoft.com/office/drawing/2014/main" id="{774D8978-764A-433E-9804-2CCBB2A827CC}"/>
+                <a16:creationId xmlns:a16="http://schemas.microsoft.com/office/drawing/2014/main" id="{2080F313-CF91-45D1-8F79-BC1CD412B94F}"/>
               </a:ext>
             </a:extLst>
           </p:cNvPr>
@@ -20790,7 +20790,7 @@
           <p:cNvPr id="19" name="footer-rule-9">
             <a:extLst xmlns:a="http://schemas.openxmlformats.org/drawingml/2006/main">
               <a:ext uri="{FF2B5EF4-FFF2-40B4-BE49-F238E27FC236}">
-                <a16:creationId xmlns:a16="http://schemas.microsoft.com/office/drawing/2014/main" id="{6B28561F-243F-41EE-A57F-7EE6E3976292}"/>
+                <a16:creationId xmlns:a16="http://schemas.microsoft.com/office/drawing/2014/main" id="{4059299D-2761-49C5-8431-CF9EE51141AA}"/>
               </a:ext>
             </a:extLst>
           </p:cNvPr>
@@ -20821,7 +20821,7 @@
           <p:cNvPr id="20" name="footer-label-9">
             <a:extLst xmlns:a="http://schemas.openxmlformats.org/drawingml/2006/main">
               <a:ext uri="{FF2B5EF4-FFF2-40B4-BE49-F238E27FC236}">
-                <a16:creationId xmlns:a16="http://schemas.microsoft.com/office/drawing/2014/main" id="{5EFE6947-85B2-4DB6-B109-11F62CFBDF33}"/>
+                <a16:creationId xmlns:a16="http://schemas.microsoft.com/office/drawing/2014/main" id="{25C9B808-075B-4DB6-B772-B7BE36155D49}"/>
               </a:ext>
             </a:extLst>
           </p:cNvPr>
@@ -20883,7 +20883,7 @@
           <p:cNvPr id="21" name="footer-page-9">
             <a:extLst xmlns:a="http://schemas.openxmlformats.org/drawingml/2006/main">
               <a:ext uri="{FF2B5EF4-FFF2-40B4-BE49-F238E27FC236}">
-                <a16:creationId xmlns:a16="http://schemas.microsoft.com/office/drawing/2014/main" id="{94B06FE9-6C94-48D3-B597-5024C22C965D}"/>
+                <a16:creationId xmlns:a16="http://schemas.microsoft.com/office/drawing/2014/main" id="{71C3C1F4-91ED-4335-9054-9BB8D7B87A1A}"/>
               </a:ext>
             </a:extLst>
           </p:cNvPr>
@@ -20943,7 +20943,7 @@
     </p:spTree>
     <p:extLst>
       <p:ext uri="{BB962C8B-B14F-4D97-AF65-F5344CB8AC3E}">
-        <p14:creationId xmlns:p14="http://schemas.microsoft.com/office/powerpoint/2010/main" val="1587384856"/>
+        <p14:creationId xmlns:p14="http://schemas.microsoft.com/office/powerpoint/2010/main" val="388942478"/>
       </p:ext>
     </p:extLst>
   </p:cSld>

</xml_diff>

<commit_message>
docs: make facilitator scripts conversational
</commit_message>
<xml_diff>
--- a/docs/MSU-EVA-อบรมสายวิชาการ-ฉบับวิทยากร.pptx
+++ b/docs/MSU-EVA-อบรมสายวิชาการ-ฉบับวิทยากร.pptx
@@ -2,30 +2,30 @@
 <file path=ppt/presentation.xml><?xml version="1.0" encoding="utf-8"?>
 <p:presentation xmlns:p="http://schemas.openxmlformats.org/presentationml/2006/main">
   <p:sldMasterIdLst>
-    <p:sldMasterId xmlns:r="http://schemas.openxmlformats.org/officeDocument/2006/relationships" id="2147483648" r:id="Rd34d4fd84e4a4e5b"/>
+    <p:sldMasterId xmlns:r="http://schemas.openxmlformats.org/officeDocument/2006/relationships" id="2147483648" r:id="R31010d4792f44304"/>
   </p:sldMasterIdLst>
   <p:notesMasterIdLst>
-    <p:notesMasterId xmlns:r="http://schemas.openxmlformats.org/officeDocument/2006/relationships" r:id="R735cb67919df472e"/>
+    <p:notesMasterId xmlns:r="http://schemas.openxmlformats.org/officeDocument/2006/relationships" r:id="R2d8c23fd8a864642"/>
   </p:notesMasterIdLst>
   <p:sldIdLst>
-    <p:sldId xmlns:r="http://schemas.openxmlformats.org/officeDocument/2006/relationships" id="256" r:id="Raa48ceaddca54b4a"/>
-    <p:sldId xmlns:r="http://schemas.openxmlformats.org/officeDocument/2006/relationships" id="257" r:id="R017f3b77cad2429c"/>
-    <p:sldId xmlns:r="http://schemas.openxmlformats.org/officeDocument/2006/relationships" id="258" r:id="R4709647d88544122"/>
-    <p:sldId xmlns:r="http://schemas.openxmlformats.org/officeDocument/2006/relationships" id="259" r:id="R939814f76aab4abb"/>
-    <p:sldId xmlns:r="http://schemas.openxmlformats.org/officeDocument/2006/relationships" id="260" r:id="R327919f6a82d463d"/>
-    <p:sldId xmlns:r="http://schemas.openxmlformats.org/officeDocument/2006/relationships" id="261" r:id="R099966fb4e344031"/>
-    <p:sldId xmlns:r="http://schemas.openxmlformats.org/officeDocument/2006/relationships" id="262" r:id="Rf43be59709204059"/>
-    <p:sldId xmlns:r="http://schemas.openxmlformats.org/officeDocument/2006/relationships" id="263" r:id="R657c25397ac6411c"/>
-    <p:sldId xmlns:r="http://schemas.openxmlformats.org/officeDocument/2006/relationships" id="264" r:id="Rceb1c459ce5f4c0e"/>
-    <p:sldId xmlns:r="http://schemas.openxmlformats.org/officeDocument/2006/relationships" id="265" r:id="R8b2fb7d5864d4241"/>
-    <p:sldId xmlns:r="http://schemas.openxmlformats.org/officeDocument/2006/relationships" id="266" r:id="Rbbb608ab0e9b4ea1"/>
-    <p:sldId xmlns:r="http://schemas.openxmlformats.org/officeDocument/2006/relationships" id="267" r:id="Ra49e36cdbf654a6a"/>
-    <p:sldId xmlns:r="http://schemas.openxmlformats.org/officeDocument/2006/relationships" id="268" r:id="R2f88b511128a4c96"/>
-    <p:sldId xmlns:r="http://schemas.openxmlformats.org/officeDocument/2006/relationships" id="269" r:id="R7c7b15022d0041c7"/>
-    <p:sldId xmlns:r="http://schemas.openxmlformats.org/officeDocument/2006/relationships" id="270" r:id="Rd908844a9c624d4b"/>
-    <p:sldId xmlns:r="http://schemas.openxmlformats.org/officeDocument/2006/relationships" id="271" r:id="R30cf6ed5d8c14966"/>
-    <p:sldId xmlns:r="http://schemas.openxmlformats.org/officeDocument/2006/relationships" id="272" r:id="R7b2eceba641d40f4"/>
-    <p:sldId xmlns:r="http://schemas.openxmlformats.org/officeDocument/2006/relationships" id="273" r:id="R0b802848cd3c4767"/>
+    <p:sldId xmlns:r="http://schemas.openxmlformats.org/officeDocument/2006/relationships" id="256" r:id="R682b4cc223d64642"/>
+    <p:sldId xmlns:r="http://schemas.openxmlformats.org/officeDocument/2006/relationships" id="257" r:id="Ra401ba5c9bad44d3"/>
+    <p:sldId xmlns:r="http://schemas.openxmlformats.org/officeDocument/2006/relationships" id="258" r:id="R6f54b557eaf64d10"/>
+    <p:sldId xmlns:r="http://schemas.openxmlformats.org/officeDocument/2006/relationships" id="259" r:id="R5ac53dd30cf34a45"/>
+    <p:sldId xmlns:r="http://schemas.openxmlformats.org/officeDocument/2006/relationships" id="260" r:id="R293764fc8dfc4171"/>
+    <p:sldId xmlns:r="http://schemas.openxmlformats.org/officeDocument/2006/relationships" id="261" r:id="Rdb21b033615744ab"/>
+    <p:sldId xmlns:r="http://schemas.openxmlformats.org/officeDocument/2006/relationships" id="262" r:id="Rd37f424a62044f78"/>
+    <p:sldId xmlns:r="http://schemas.openxmlformats.org/officeDocument/2006/relationships" id="263" r:id="R42bfb9e26f524eda"/>
+    <p:sldId xmlns:r="http://schemas.openxmlformats.org/officeDocument/2006/relationships" id="264" r:id="Rd286f93f33514710"/>
+    <p:sldId xmlns:r="http://schemas.openxmlformats.org/officeDocument/2006/relationships" id="265" r:id="R5939fcd18888485c"/>
+    <p:sldId xmlns:r="http://schemas.openxmlformats.org/officeDocument/2006/relationships" id="266" r:id="R242ebc30cd0a40f7"/>
+    <p:sldId xmlns:r="http://schemas.openxmlformats.org/officeDocument/2006/relationships" id="267" r:id="Rafc956c5f2554476"/>
+    <p:sldId xmlns:r="http://schemas.openxmlformats.org/officeDocument/2006/relationships" id="268" r:id="R724797f174a64ecd"/>
+    <p:sldId xmlns:r="http://schemas.openxmlformats.org/officeDocument/2006/relationships" id="269" r:id="Rf900bf09e2f84b76"/>
+    <p:sldId xmlns:r="http://schemas.openxmlformats.org/officeDocument/2006/relationships" id="270" r:id="Rbf346bd8e133449b"/>
+    <p:sldId xmlns:r="http://schemas.openxmlformats.org/officeDocument/2006/relationships" id="271" r:id="Rf33643b9ba914ff6"/>
+    <p:sldId xmlns:r="http://schemas.openxmlformats.org/officeDocument/2006/relationships" id="272" r:id="R5e1ad202a0664d32"/>
+    <p:sldId xmlns:r="http://schemas.openxmlformats.org/officeDocument/2006/relationships" id="273" r:id="R3d274938c9c149e3"/>
   </p:sldIdLst>
   <p:sldSz cx="12192000" cy="6858000"/>
   <p:notesSz cx="6858000" cy="9144000"/>
@@ -459,7 +459,7 @@
           <a:lstStyle xmlns:a="http://schemas.openxmlformats.org/drawingml/2006/main"/>
           <a:p xmlns:a="http://schemas.openxmlformats.org/drawingml/2006/main">
             <a:r>
-              <a:t>[พูด] สวัสดีทุกท่าน ขอต้อนรับเข้าสู่การอบรมการใช้งานระบบ MSU EVA สำหรับบุคลากรสายวิชาการ วันนี้มีทั้งท่านที่เคยร่วมทดสอบระบบแล้ว ท่านที่เพิ่งเริ่มใช้งาน รวมถึงผู้ประเมิน กรรมการ และผู้บริหาร เราจะเริ่มจากทำความรู้จักระบบ บทบาท และฟังก์ชันที่เกี่ยวข้อง จากนั้นผมจะสาธิตการกรอกแบบประเมินหนึ่งรายการให้ดูก่อน แล้วทุกท่านจะได้ทดลองด้วยบัญชีที่เตรียมไว้ เป้าหมายคือให้ทุกคนเข้าใจทั้งงานของตนเองและขั้นตอนที่ส่งต่อไปยังบุคคลถัดไป</a:t>
+              <a:t>[พูด] สวัสดีทุกท่านครับ ขอต้อนรับเข้าสู่การอบรมการใช้งานระบบ MSU EVA สำหรับบุคลากรสายวิชาการนะครับ วันนี้ในห้องนี้มีทั้งท่านที่เคยช่วยทดสอบระบบมาแล้ว ท่านที่เพิ่งเข้ามาใช้งานครั้งแรก รวมถึงผู้ประเมิน กรรมการ และผู้บริหาร ไม่เป็นไรครับ เดี๋ยวเราจะค่อย ๆ ไปด้วยกัน ช่วงแรกผมจะพาทำความรู้จักระบบและบทบาทต่าง ๆ ก่อน หลังจากนั้นผมจะสาธิตหนึ่งรอบ แล้วทุกท่านจะได้ลองใช้บัญชีที่เตรียมไว้ครับ</a:t>
             </a:r>
           </a:p>
           <a:p xmlns:a="http://schemas.openxmlformats.org/drawingml/2006/main">
@@ -564,7 +564,7 @@
           <a:lstStyle xmlns:a="http://schemas.openxmlformats.org/drawingml/2006/main"/>
           <a:p xmlns:a="http://schemas.openxmlformats.org/drawingml/2006/main">
             <a:r>
-              <a:t>[พูด] ข้อมูลเชิงคุณภาพควรช่วยให้ผู้ประเมินเข้าใจผลงานได้ในครั้งเดียว ใช้โครงง่าย ๆ ว่าทำอะไร เกิดผลอย่างไร และตรวจจากหลักฐานใด หลีกเลี่ยงคำกว้างที่ไม่บอกบทบาทหรือผลลัพธ์ และไม่จำเป็นต้องเขียนยาวเกินไป ขอให้ข้อความสัมพันธ์กับเกณฑ์และหลักฐานที่เลือก หากผู้ประเมินอ่านแล้วรู้ว่างานคืออะไร ผลคืออะไร และเปิดตรวจจากที่ไหน แสดงว่าข้อมูลมีความพร้อม</a:t>
+              <a:t>[พูด] ทีนี้มาดูข้อมูลเชิงคุณภาพครับ ส่วนนี้ไม่จำเป็นต้องเขียนยาว แต่ควรตอบให้ครบสามเรื่องว่าเราทำอะไร เกิดผลอย่างไร และตรวจจากหลักฐานใด ลองคิดว่าผู้ประเมินอ่านเพียงครั้งเดียวแล้วควรเห็นภาพงานของเราได้ครับ หลีกเลี่ยงคำกว้าง ๆ ที่ไม่บอกบทบาทหรือผลลัพธ์ ถ้าข้อความสัมพันธ์กับเกณฑ์และหลักฐาน ก็ถือว่าพร้อมในระดับหนึ่งแล้ว ต่อไปเรามาตรวจว่าหลักฐานแบบไหนจึงจะใช้งานได้จริงครับ</a:t>
             </a:r>
           </a:p>
           <a:p xmlns:a="http://schemas.openxmlformats.org/drawingml/2006/main">
@@ -659,7 +659,7 @@
           <a:lstStyle xmlns:a="http://schemas.openxmlformats.org/drawingml/2006/main"/>
           <a:p xmlns:a="http://schemas.openxmlformats.org/drawingml/2006/main">
             <a:r>
-              <a:t>[พูด] หลักฐานที่ดีต้องเปิดได้ ตรงกับรายการ และระบุตัวตนของเอกสารได้ ควรทดลองเปิดลิงก์ในหน้าต่างที่ไม่ได้ใช้บัญชีเจ้าของเอกสาร เพื่อดูว่าผู้ประเมินเข้าถึงได้จริงหรือไม่ ตั้งชื่อไฟล์หรือโฟลเดอร์ให้เข้าใจง่าย และหลีกเลี่ยงการแนบหลักฐานรวมที่หาเนื้อหาของรายการไม่พบ</a:t>
+              <a:t>[พูด] ตรงนี้ขอเน้นนิดหนึ่งครับ หลักฐานที่แนบไม่ได้วัดแค่ว่ามีหรือไม่มี แต่ต้องเปิดได้ ตรงกับรายการ และรู้ว่าเป็นเอกสารอะไร ทางที่ดีให้ทดลองเปิดลิงก์ในหน้าต่างที่ไม่ได้ใช้บัญชีเจ้าของเอกสาร จะได้เห็นเหมือนที่ผู้ประเมินเห็น เดี๋ยวผมทำให้ดูก่อนครับ ทุกท่านยังไม่ต้องทำตาม ให้สังเกตตั้งแต่การกรอกผลงาน การแนบลิงก์ ไปจนถึงการทดลองเปิดหลักฐานครับ</a:t>
             </a:r>
           </a:p>
           <a:p xmlns:a="http://schemas.openxmlformats.org/drawingml/2006/main">
@@ -759,7 +759,7 @@
           <a:lstStyle xmlns:a="http://schemas.openxmlformats.org/drawingml/2006/main"/>
           <a:p xmlns:a="http://schemas.openxmlformats.org/drawingml/2006/main">
             <a:r>
-              <a:t>[พูด] หากข้อมูลยังไม่ครบ ให้เลือกบันทึกร่าง เพราะสามารถกลับมาแก้ไขได้และงานยังไม่ถูกส่งต่อ ส่วนส่งแบบประเมินควรใช้เมื่อข้อมูลบังคับและหลักฐานครบแล้ว ระบบจะนำงานเข้าสู่ลำดับผู้ประเมิน และผู้รับการประเมินอาจแก้ไขไม่ได้ในขั้นนั้น ก่อนกดส่งจึงควรถามตัวเองว่าผู้ประเมินเห็นข้อมูลครบและเข้าใจที่มาของคะแนนแล้วหรือยัง วันนี้ช่วงทดลองเราจะหยุดที่บันทึกร่างก่อน</a:t>
+              <a:t>[พูด] เมื่อกรอกข้อมูลแล้ว เราจะเจอสองทางเลือกครับ ถ้ายังมีส่วนที่ต้องกลับมาแก้ ให้เลือกบันทึกร่าง งานจะยังไม่ถูกส่งต่อ แต่ถ้าข้อมูลบังคับและหลักฐานครบแล้ว จึงเลือกส่งแบบประเมิน เพราะหลังส่ง งานจะเข้าสู่ลำดับผู้ประเมินและเราอาจแก้ไขไม่ได้ในช่วงนั้น ก่อนกดยืนยัน ลองถามตัวเองสั้น ๆ ครับว่า ผู้ประเมินเห็นข้อมูลครบและเข้าใจที่มาของคะแนนแล้วหรือยัง วันนี้ตอนทดลอง ทุกท่านหยุดที่บันทึกร่างก่อนนะครับ แล้วเรามาดูกันต่อว่าเมื่อส่งจริง งานจะไปไหน</a:t>
             </a:r>
           </a:p>
           <a:p xmlns:a="http://schemas.openxmlformats.org/drawingml/2006/main">
@@ -859,7 +859,7 @@
           <a:lstStyle xmlns:a="http://schemas.openxmlformats.org/drawingml/2006/main"/>
           <a:p xmlns:a="http://schemas.openxmlformats.org/drawingml/2006/main">
             <a:r>
-              <a:t>[พูด] หลังส่งแบบประเมิน งานจะไม่ไปถึงทุกคนพร้อมกัน แต่เดินตามลำดับผู้ประเมินที่ผู้ดูแลระบบกำหนด ผู้ประเมินแต่ละคนจะตรวจ ให้ผล และส่งต่องานไปยังคนถัดไป จำนวนผู้ประเมินอาจต่างกันในแต่ละรายการ จึงควรดูสถานะและลำดับของงานนั้น ไม่ควรคาดเดาจากชื่อตำแหน่ง เมื่อถึงผู้ประเมินคนสุดท้าย การยืนยันของบุคคลนั้นจะทำให้งานเข้าสู่สถานะสุดท้าย</a:t>
+              <a:t>[พูด] ใช่ครับ หลังจากกดส่ง งานไม่ได้หายไปและไม่ได้ไปถึงทุกคนพร้อมกัน ระบบจะส่งให้ผู้ประเมินตามลำดับที่ Admin กำหนดไว้ ผู้ประเมินคนปัจจุบันจะเห็นงานและดำเนินการได้ ส่วนคนถัดไปต้องรอการส่งต่อก่อน จำนวนผู้ประเมินอาจต่างกันในแต่ละงานนะครับ เพราะฉะนั้นเวลาอยากรู้ว่างานอยู่ที่ใคร ให้ดูสถานะและลำดับของรายการนั้นเป็นหลัก ต่อไปผมจะสลับไปดูมุมของผู้ประเมินครับ</a:t>
             </a:r>
           </a:p>
           <a:p xmlns:a="http://schemas.openxmlformats.org/drawingml/2006/main">
@@ -954,12 +954,12 @@
           <a:lstStyle xmlns:a="http://schemas.openxmlformats.org/drawingml/2006/main"/>
           <a:p xmlns:a="http://schemas.openxmlformats.org/drawingml/2006/main">
             <a:r>
-              <a:t>[พูด] เมื่อได้รับงานประเมิน ให้เริ่มจากตรวจว่าข้อมูลตรงกับเกณฑ์ เปิดหลักฐานได้ และเนื้อหาสอดคล้องกัน จากนั้นจึงให้คะแนนหรือความเห็นตามสิทธิ์ของตน หากข้อมูลไม่ครบควรใช้วิธีดำเนินการที่ระบบรองรับ ไม่ควรให้ผลจากการคาดเดา ผู้บริหารหรือผู้ประเมินที่ยังไม่เคยใช้ระบบ ให้สังเกตว่าหน้าจอของผู้ประเมินต่างจากหน้าของผู้รับการประเมินตรงไหน</a:t>
-            </a:r>
-          </a:p>
-          <a:p xmlns:a="http://schemas.openxmlformats.org/drawingml/2006/main">
-            <a:r>
-              <a:t>[สาธิต] เปลี่ยนเป็นบัญชีผู้ประเมิน เปิดงาน ตรวจข้อมูลและหลักฐาน แล้วบันทึกผล</a:t>
+              <a:t>[พูด] ตอนนี้เรามองจากฝั่งผู้ประเมินนะครับ เมื่อได้รับงาน สิ่งแรกที่ควรทำคืออ่านข้อมูลให้ตรงกับเกณฑ์ ตรวจคะแนน และเปิดหลักฐานจริงก่อนให้ผล ถ้าข้อมูลไม่ครบ ให้ใช้ตัวเลือกที่ระบบเปิดให้ตามสิทธิ์ ไม่ควรเดาจากชื่อรายการอย่างเดียว เดี๋ยวผมสาธิตให้ดูครับ ให้สังเกตว่าข้อมูลส่วนใดมาจากผู้รับการประเมิน และส่วนใดเป็นการตัดสินใจของผู้ประเมิน</a:t>
+            </a:r>
+          </a:p>
+          <a:p xmlns:a="http://schemas.openxmlformats.org/drawingml/2006/main">
+            <a:r>
+              <a:t>[สาธิต] เปิดรายการในบัญชีผู้ประเมิน ตรวจข้อมูล คะแนน และหลักฐาน แล้วบันทึกผลการประเมิน</a:t>
             </a:r>
           </a:p>
           <a:p xmlns:a="http://schemas.openxmlformats.org/drawingml/2006/main">
@@ -1059,12 +1059,12 @@
           <a:lstStyle xmlns:a="http://schemas.openxmlformats.org/drawingml/2006/main"/>
           <a:p xmlns:a="http://schemas.openxmlformats.org/drawingml/2006/main">
             <a:r>
-              <a:t>[พูด] ผู้ประเมินแต่ละคนรับผิดชอบขั้นของตนเอง เมื่อตรวจครบแล้วจึงส่งต่องาน ผู้ประเมินคนถัดไปจะเห็นข้อมูลและผลตามสิทธิ์ที่กำหนด ส่วนผู้ประเมินคนสุดท้ายมีหน้าที่ยืนยันขั้นสุดท้าย ลำดับนี้อาจไม่ตรงกับตำแหน่งบริหารแบบตายตัว ให้ยึดลำดับที่แสดงในงานเป็นหลัก</a:t>
-            </a:r>
-          </a:p>
-          <a:p xmlns:a="http://schemas.openxmlformats.org/drawingml/2006/main">
-            <a:r>
-              <a:t>[สาธิต] ส่งต่องานหนึ่งลำดับ แล้วเปิดด้วยบัญชีผู้ประเมินคนสุดท้ายเพื่อให้เห็นปุ่มและสถานะก่อนยืนยัน</a:t>
+              <a:t>[พูด] เมื่อผู้ประเมินคนหนึ่งตรวจเสร็จ งานยังไม่ถือว่าปิดนะครับ ต้องส่งต่อไปยังคนถัดไปตามลำดับ ผู้ประเมินคนถัดไปจึงจะรับงานและเห็นข้อมูลที่เกี่ยวข้อง ตรงนี้สำคัญครับ เพราะแต่ละงานอาจมีจำนวนขั้นไม่เท่ากัน เดี๋ยวผมส่งต่องานหนึ่งขั้นให้ดู แล้วเปิดบัญชีของผู้ประเมินคนถัดไป เพื่อให้เห็นการเปลี่ยนสถานะจริงครับ</a:t>
+            </a:r>
+          </a:p>
+          <a:p xmlns:a="http://schemas.openxmlformats.org/drawingml/2006/main">
+            <a:r>
+              <a:t>[สาธิต] ส่งต่องานหนึ่งขั้น แล้วสลับไปยังบัญชีผู้ประเมินลำดับถัดไปเพื่อตรวจสถานะ</a:t>
             </a:r>
           </a:p>
           <a:p xmlns:a="http://schemas.openxmlformats.org/drawingml/2006/main">
@@ -1159,17 +1159,17 @@
           <a:lstStyle xmlns:a="http://schemas.openxmlformats.org/drawingml/2006/main"/>
           <a:p xmlns:a="http://schemas.openxmlformats.org/drawingml/2006/main">
             <a:r>
-              <a:t>[พูด] เมื่อผู้ประเมินคนสุดท้ายยืนยัน สถานะงานจะเปลี่ยนเป็น ประเมินเสร็จสิ้น หรือ Completed นั่นหมายถึงกระบวนการของรายการนี้ครบตามลำดับแล้ว ผู้ปิดงานไม่จำเป็นต้องเป็นบทบาทเดิมในทุกงาน จึงต้องดูผู้ประเมินคนสุดท้ายที่กำหนดไว้กับรายการนั้นเสมอ</a:t>
-            </a:r>
-          </a:p>
-          <a:p xmlns:a="http://schemas.openxmlformats.org/drawingml/2006/main">
-            <a:r>
-              <a:t>[สาธิต] ยืนยันขั้นสุดท้ายและแสดงสถานะ Completed</a:t>
-            </a:r>
-          </a:p>
-          <a:p xmlns:a="http://schemas.openxmlformats.org/drawingml/2006/main">
-            <a:r>
-              <a:t>[กลับมาที่สไลด์] ย้ำว่าการปิดงานเกิดจากลำดับ ไม่ได้ผูกกับชื่อตำแหน่งเดียว</a:t>
+              <a:t>[พูด] ทีนี้มาถึงขั้นสุดท้ายครับ เมื่อผู้ประเมินคนสุดท้ายยืนยัน ระบบจึงเปลี่ยนสถานะเป็นประเมินเสร็จสิ้น หรือ Completed คำว่า “คนสุดท้าย” ให้ดูจากลำดับของงานจริงนะครับ ไม่ได้หมายความว่าต้องเป็นผู้บริหารเสมอไป เดี๋ยวผมยืนยันขั้นสุดท้ายให้ดู แล้วเราจะกลับมาที่สไลด์เพื่อทบทวนว่าจุดสังเกตมีอะไรบ้างครับ</a:t>
+            </a:r>
+          </a:p>
+          <a:p xmlns:a="http://schemas.openxmlformats.org/drawingml/2006/main">
+            <a:r>
+              <a:t>[สาธิต] เปิดบัญชีผู้ประเมินคนสุดท้าย ยืนยันผล และแสดงสถานะ Completed</a:t>
+            </a:r>
+          </a:p>
+          <a:p xmlns:a="http://schemas.openxmlformats.org/drawingml/2006/main">
+            <a:r>
+              <a:t>[กลับมาที่สไลด์] ชี้ให้เห็นว่างานปิดเมื่อผู้ประเมินคนสุดท้ายในลำดับยืนยันแล้ว</a:t>
             </a:r>
           </a:p>
           <a:p xmlns:a="http://schemas.openxmlformats.org/drawingml/2006/main">
@@ -1264,7 +1264,7 @@
           <a:lstStyle xmlns:a="http://schemas.openxmlformats.org/drawingml/2006/main"/>
           <a:p xmlns:a="http://schemas.openxmlformats.org/drawingml/2006/main">
             <a:r>
-              <a:t>[พูด] ต่อไปเป็นช่วงทดลองใช้งาน ผู้ที่เคยทดสอบแล้วให้เลือกตรวจความครบถ้วนและช่วยสังเกตจุดที่ต่างจากครั้งก่อน ผู้ที่เข้ามาใหม่ให้ทำตามรายการทีละข้อ เป้าหมายคือเปิดงาน กรอกข้อมูลหนึ่งรายการ แนบหลักฐาน และบันทึกร่าง เมื่อเสร็จให้ยกมือหรือเรียกผู้ช่วย ยังไม่ต้องกดส่งแบบประเมิน เพราะเราจะตรวจความพร้อมและทำขั้นส่งพร้อมกันภายหลัง</a:t>
+              <a:t>[พูด] เมื่อเห็นภาพครบแล้ว ต่อไปเป็นเวลาของทุกท่านครับ ให้เปิดบัญชีที่เตรียมไว้ ผู้ที่เคยทดสอบแล้วลองเน้นตรวจความครบถ้วนและช่วยสังเกตสิ่งที่เปลี่ยนไป ส่วนผู้ที่เพิ่งเริ่ม ให้ทำทีละข้อ ไม่ต้องรีบครับ เลือกรายการ กรอกข้อมูล ตรวจคะแนน แนบหลักฐาน แล้วบันทึกร่าง เมื่อทำเสร็จให้ยกมือเรียกผมหรือทีมงานได้เลย ยังไม่ต้องกดส่งแบบประเมินนะครับ เราจะตรวจความพร้อมร่วมกันก่อน</a:t>
             </a:r>
           </a:p>
           <a:p xmlns:a="http://schemas.openxmlformats.org/drawingml/2006/main">
@@ -1369,17 +1369,17 @@
           <a:lstStyle xmlns:a="http://schemas.openxmlformats.org/drawingml/2006/main"/>
           <a:p xmlns:a="http://schemas.openxmlformats.org/drawingml/2006/main">
             <a:r>
-              <a:t>[พูด] หากติดขัด ให้ตรวจสี่จุดก่อน ได้แก่ รอบและรายการ สิทธิ์ของบัญชี สถานะปัจจุบัน และข้อมูลบังคับหรือหลักฐาน หากยังแก้ไม่ได้ ให้จดชื่อรายการ สถานะ และข้อความที่ปรากฏ แล้วแจ้งผู้ดูแลระบบ ข้อมูลเหล่านี้ช่วยวิเคราะห์ได้เร็วกว่าแจ้งเพียงว่าใช้งานไม่ได้</a:t>
-            </a:r>
-          </a:p>
-          <a:p xmlns:a="http://schemas.openxmlformats.org/drawingml/2006/main">
-            <a:r>
-              <a:t>[ถามผู้เข้าอบรม] มีใครติดที่การเปิดงาน การบันทึกร่าง หรือการเปิดหลักฐานหรือไม่</a:t>
-            </a:r>
-          </a:p>
-          <a:p xmlns:a="http://schemas.openxmlformats.org/drawingml/2006/main">
-            <a:r>
-              <a:t>[พูด] เมื่อทุกคนพร้อม เราจะตรวจข้อมูลร่วมกัน กดส่งแบบประเมิน แล้วให้ผู้ประเมินทดลองรับงานต่อ</a:t>
+              <a:t>[พูด] ก่อนจบช่วงนี้ ถ้าใครติดขัดให้ลองตรวจสี่จุดก่อนครับ หนึ่ง รอบและรายการที่ได้รับมอบหมาย สอง สิทธิ์ของบัญชี สาม สถานะปัจจุบันของงาน และสี่ ข้อมูลบังคับหรือหลักฐาน ถ้าคะแนนผิดปกติ ให้ย้อนดูค่าที่กรอกกับหน่วยก่อน หากยังแก้ไม่ได้ ให้จดชื่อรายการ สถานะ และข้อความที่พบ จะช่วยให้ผู้ดูแลระบบตรวจได้เร็วขึ้นครับ</a:t>
+            </a:r>
+          </a:p>
+          <a:p xmlns:a="http://schemas.openxmlformats.org/drawingml/2006/main">
+            <a:r>
+              <a:t>[ถามผู้เข้าอบรม] ตอนนี้มีใครติดที่การเปิดงาน การกรอกข้อมูล การคำนวณคะแนน หรือการแนบหลักฐานไหมครับ</a:t>
+            </a:r>
+          </a:p>
+          <a:p xmlns:a="http://schemas.openxmlformats.org/drawingml/2006/main">
+            <a:r>
+              <a:t>[พูด] ถ้าไม่มีคำถามเพิ่มเติม วันนี้ขอให้จำไว้สามเรื่องครับ ตรวจงานให้ถูก กรอกข้อมูลให้ครบ และบันทึกร่างก่อนส่งจริง ขอบคุณทุกท่านครับ</a:t>
             </a:r>
           </a:p>
           <a:p xmlns:a="http://schemas.openxmlformats.org/drawingml/2006/main">
@@ -1484,7 +1484,7 @@
           <a:lstStyle xmlns:a="http://schemas.openxmlformats.org/drawingml/2006/main"/>
           <a:p xmlns:a="http://schemas.openxmlformats.org/drawingml/2006/main">
             <a:r>
-              <a:t>[พูด] เป้าหมายของช่วงเช้าไม่ใช่การจำทุกปุ่ม แต่คือการทำงานหนึ่งรายการให้พร้อมส่ง รอบประเมินจะกำหนดโดยผู้ดูแลระบบ ส่วนผู้ใช้งานมีหน้าที่ตรวจสอบว่ารอบและรายการที่ได้รับมอบหมายถูกต้อง จากนั้นเราจะกรอกภาระงานและผลงาน แนบหลักฐาน และแยกให้ชัดว่าบันทึกร่างต่างจากส่งแบบประเมินอย่างไร ผู้ที่เคยทดสอบแล้วช่วยตรวจความครบถ้วน ผู้ที่เพิ่งเริ่มให้ทำตามจังหวะของวิทยากร ส่วนผู้บริหารและผู้ประเมินให้สังเกตข้อมูลที่จะได้รับในขั้นถัดไป</a:t>
+              <a:t>[พูด] ก่อนเริ่ม ขอชวนทุกท่านตั้งเป้าหมายร่วมกันนิดหนึ่งครับ วันนี้เราไม่จำเป็นต้องจำทุกปุ่ม สิ่งที่อยากให้ทำได้คือเปิดงานหนึ่งรายการ ตรวจข้อมูล กรอกผลงาน แนบหลักฐาน แล้วแยกให้ออกว่าเมื่อไรควรบันทึกร่างและเมื่อไรจึงควรส่งแบบประเมิน รอบประเมินเป็นสิ่งที่ผู้ดูแลระบบกำหนดไว้ให้แล้วนะครับ เรามีหน้าที่ตรวจว่ารอบและงานที่ได้รับมอบหมายถูกต้อง เมื่อเห็นเป้าหมายตรงกันแล้ว ต่อไปเรามาดูว่าระบบนี้ช่วยงานส่วนใดบ้างครับ</a:t>
             </a:r>
           </a:p>
           <a:p xmlns:a="http://schemas.openxmlformats.org/drawingml/2006/main">
@@ -1579,7 +1579,7 @@
           <a:lstStyle xmlns:a="http://schemas.openxmlformats.org/drawingml/2006/main"/>
           <a:p xmlns:a="http://schemas.openxmlformats.org/drawingml/2006/main">
             <a:r>
-              <a:t>[พูด] MSU EVA ไม่ได้มีเฉพาะหน้ากรอกแบบประเมิน แต่ช่วยจัดการงานตั้งแต่การเตรียมผู้ใช้และสิทธิ์ จัดทำเกณฑ์ สร้างรอบและมอบหมายงาน ไปจนถึงการกรอกข้อมูล การประเมิน ติดตามสถานะ และส่งออกรายงาน ฟังก์ชันด้านการเตรียมระบบเป็นหน้าที่ของ Admin ผู้เข้าอบรมทั่วไปจึงไม่ต้องสร้างหรือเลือกรอบประเมินเอง แต่ตรวจสอบรอบและรายการที่ได้รับมอบหมาย แล้วดำเนินงานตามสิทธิ์ของตน</a:t>
+              <a:t>[พูด] ใช่ครับ หลายท่านอาจคุ้นกับ MSU EVA ในฐานะหน้ากรอกแบบประเมิน แต่จริง ๆ ระบบดูแลงานตั้งแต่ต้นจนจบเลยครับ เริ่มจากผู้ใช้และสิทธิ์ เกณฑ์ประเมิน รอบและการมอบหมายงาน ไปจนถึงการกรอก การประเมิน การติดตามสถานะ และการส่งออกรายงาน ส่วนการเตรียมระบบเหล่านี้เป็นหน้าที่ของ Admin ผู้ใช้งานทั่วไปจึงไม่ต้องสร้างหรือเลือกรอบประเมินเองครับ เราเพียงตรวจรอบกับงานที่ได้รับ แล้วทำตามสิทธิ์ของเรา ทีนี้เรามาดูกันครับว่าในระบบมีใครบ้าง</a:t>
             </a:r>
           </a:p>
           <a:p xmlns:a="http://schemas.openxmlformats.org/drawingml/2006/main">
@@ -1684,7 +1684,7 @@
           <a:lstStyle xmlns:a="http://schemas.openxmlformats.org/drawingml/2006/main"/>
           <a:p xmlns:a="http://schemas.openxmlformats.org/drawingml/2006/main">
             <a:r>
-              <a:t>[พูด] ระบบมีห้าบทบาทหลัก ได้แก่ Admin ผู้รับการประเมิน ผู้ประเมิน กรรมการ และผู้บริหาร แต่ละบทบาทจะเห็นเมนูและปุ่มไม่เหมือนกัน Admin เป็นผู้กำหนดผู้ใช้งาน เกณฑ์ รอบประเมิน การมอบหมาย และลำดับผู้ประเมิน ส่วนผู้ประเมิน กรรมการ และผู้บริหารเป็นขั้นการตรวจที่ Admin เลือกใช้และจัดลำดับในแต่ละรอบ บางรอบอาจใช้ไม่ครบทุกบทบาท และผู้ปิดงานคือผู้ที่อยู่ลำดับสุดท้ายของงานนั้น</a:t>
+              <a:t>[พูด] ระบบมีผู้ใช้งานหลักห้าบทบาทครับ ได้แก่ Admin ผู้รับการประเมิน ผู้ประเมิน กรรมการ และผู้บริหาร แต่ละคนจะเห็นเมนูและปุ่มไม่เหมือนกัน ตรงนี้ขอเน้นนิดหนึ่งครับ Admin เป็นผู้กำหนดผู้ใช้ เกณฑ์ รอบประเมิน การมอบหมาย และลำดับผู้ประเมิน ส่วนผู้ประเมิน กรรมการ และผู้บริหารจะเป็นขั้นตรวจตามที่ Admin จัดไว้ บางงานอาจไม่ได้ใช้ครบทุกบทบาท และคนที่ปิดงานคือคนสุดท้ายในลำดับของงานนั้นครับ เมื่อรู้จักคนในระบบแล้ว ต่อไปมาดูเส้นทางของงานกันครับ</a:t>
             </a:r>
           </a:p>
           <a:p xmlns:a="http://schemas.openxmlformats.org/drawingml/2006/main">
@@ -1784,7 +1784,7 @@
           <a:lstStyle xmlns:a="http://schemas.openxmlformats.org/drawingml/2006/main"/>
           <a:p xmlns:a="http://schemas.openxmlformats.org/drawingml/2006/main">
             <a:r>
-              <a:t>[พูด] ก่อนลงรายละเอียด เรามาดูเส้นทางทั้งหมดก่อน งานเริ่มจากผู้รับการประเมินเปิดรายการและกรอกข้อมูล เมื่อพร้อมจึงส่งแบบประเมิน ระบบจะส่งต่อไปยังผู้ประเมินตามลำดับที่กำหนด ผู้ประเมินแต่ละคนตรวจและส่งต่องาน จนผู้ประเมินคนสุดท้ายยืนยันและสถานะเปลี่ยนเป็น ประเมินเสร็จสิ้น หรือ Completed ภาพนี้จะช่วยให้เราเข้าใจว่าทุกปุ่มมีผลต่อคนถัดไปอย่างไร</a:t>
+              <a:t>[พูด] ทีนี้ลองมองภาพรวมจากซ้ายไปขวานะครับ งานเริ่มจากผู้รับการประเมินเปิดรายการและกรอกข้อมูล เมื่อข้อมูลพร้อมจึงกดส่งแบบประเมิน จากนั้นระบบจะส่งงานไปยังผู้ประเมินทีละคนตามลำดับที่กำหนดไว้ ไม่ได้ส่งให้ทุกคนพร้อมกันครับ เมื่อผู้ประเมินคนสุดท้ายยืนยัน สถานะจึงเปลี่ยนเป็นประเมินเสร็จสิ้น หรือ Completed จำภาพนี้ไว้ก่อนนะครับ เพราะอีกสักครู่ทุกปุ่มที่เราดูจะสัมพันธ์กับเส้นทางนี้</a:t>
             </a:r>
           </a:p>
           <a:p xmlns:a="http://schemas.openxmlformats.org/drawingml/2006/main">
@@ -1879,7 +1879,7 @@
           <a:lstStyle xmlns:a="http://schemas.openxmlformats.org/drawingml/2006/main"/>
           <a:p xmlns:a="http://schemas.openxmlformats.org/drawingml/2006/main">
             <a:r>
-              <a:t>[พูด] ในขั้นแรก ผู้รับการประเมินเป็นเจ้าของความครบถ้วนของข้อมูล ต้องเตรียมข้อมูล ตรวจค่าที่กรอกและหลักฐาน แล้วตัดสินใจว่าจะบันทึกร่างหรือส่งแบบประเมิน หากข้อมูลยังไม่ครบให้บันทึกร่างไว้ก่อน การส่งควรทำเมื่อข้อมูลพร้อมให้ผู้อื่นตรวจแล้ว ผู้ประเมินไม่ได้เริ่มจากศูนย์ แต่จะตัดสินใจจากข้อมูลและหลักฐานที่เราเตรียมไว้ ดังนั้นความชัดเจนในขั้นนี้ช่วยลดการย้อนกลับมาแก้ไข</a:t>
+              <a:t>[พูด] ในขั้นแรก ผู้รับการประเมินเป็นเจ้าของความครบถ้วนของข้อมูลครับ หมายความว่าเราต้องตรวจทั้งค่าที่กรอก รายละเอียดผลงาน และหลักฐานให้พร้อม ถ้ายังไม่ครบก็ไม่ต้องรีบส่งนะครับ บันทึกร่างไว้ก่อนได้ ผู้ประเมินจะตัดสินใจจากสิ่งที่เราเตรียมไว้ ถ้าข้อมูลชัดและหลักฐานเปิดได้ งานก็เดินต่อได้ง่าย ตรงนี้เข้าใจตรงกันแล้ว เดี๋ยวผมพาไปดูจุดเริ่มต้นบนหน้าจอจริงครับ</a:t>
             </a:r>
           </a:p>
           <a:p xmlns:a="http://schemas.openxmlformats.org/drawingml/2006/main">
@@ -1974,7 +1974,7 @@
           <a:lstStyle xmlns:a="http://schemas.openxmlformats.org/drawingml/2006/main"/>
           <a:p xmlns:a="http://schemas.openxmlformats.org/drawingml/2006/main">
             <a:r>
-              <a:t>[พูด] จุดเริ่มต้นคือแดชบอร์ดของฉัน ให้ตรวจสามอย่างก่อนเปิดงาน ได้แก่ รอบประเมินที่ผู้ดูแลระบบกำหนด รายการที่ได้รับมอบหมาย และสถานะของงาน ผู้ใช้งานไม่ต้องเลือกรอบประเมินเอง หากรอบหรือรายการไม่ถูกต้อง ให้แจ้งผู้ดูแลระบบก่อนดำเนินการต่อ ต่อไปผมจะเปิดหนึ่งรายการให้ดู ทุกท่านยังไม่ต้องทำตาม ให้สังเกตตำแหน่งรอบประเมิน ชื่อรายการ และปุ่มเปิดงาน</a:t>
+              <a:t>[พูด] ต่อไปขอพาทุกท่านมาที่แดชบอร์ดของฉันครับ ก่อนเปิดงานให้ตรวจสามอย่าง คือรอบประเมินที่ผู้ดูแลระบบกำหนด รายการที่ได้รับมอบหมาย และสถานะปัจจุบัน ผู้ใช้งานไม่ต้องเลือกรอบเองนะครับ ถ้ารอบหรือรายการไม่ถูกต้องให้แจ้งผู้ดูแลระบบก่อน เดี๋ยวผมเปิดให้ดูก่อนครับ ทุกท่านยังไม่ต้องกดตาม ให้สังเกตตำแหน่งชื่อรอบ ชื่อรายการ และปุ่มเปิดงานครับ</a:t>
             </a:r>
           </a:p>
           <a:p xmlns:a="http://schemas.openxmlformats.org/drawingml/2006/main">
@@ -2069,7 +2069,7 @@
           <a:lstStyle xmlns:a="http://schemas.openxmlformats.org/drawingml/2006/main"/>
           <a:p xmlns:a="http://schemas.openxmlformats.org/drawingml/2006/main">
             <a:r>
-              <a:t>[พูด] เมื่อเปิดรายการแล้ว ให้ตรวจว่ารายวิชา ภาระงาน ผลงาน และหลักฐานเล่าเรื่องเดียวกัน รายวิชาบอกบริบท ภาระงานบอกสิ่งที่ทำและปริมาณ ผลงานอธิบายผลที่เกิดขึ้น และหลักฐานยืนยันว่าข้อมูลนั้นตรวจสอบได้ หากส่วนใดไม่สอดคล้อง ผู้ประเมินจะต้องเดาความหมายหรือขอข้อมูลเพิ่ม ก่อนกรอกจึงควรเลือกเกณฑ์และเตรียมหลักฐานให้ตรงกับงานจริงของเรา</a:t>
+              <a:t>[พูด] เมื่อเปิดรายการเข้ามาแล้ว ลองสังเกตนะครับว่ารายวิชา ภาระงาน ผลงาน และหลักฐานควรเล่าเรื่องเดียวกัน รายวิชาบอกบริบท ภาระงานบอกว่าเราทำอะไรและทำมากน้อยเพียงใด ผลงานบอกผลที่เกิดขึ้น ส่วนหลักฐานช่วยยืนยันข้อมูล ถ้าสี่ส่วนนี้ไม่สัมพันธ์กัน ผู้ประเมินก็จะต้องเดาหรือขอข้อมูลเพิ่มครับ เพราะฉะนั้นก่อนกรอก เราควรเลือกเกณฑ์ให้ตรงกับงานจริงก่อน แล้วค่อยไปดูข้อมูลเชิงปริมาณครับ</a:t>
             </a:r>
           </a:p>
           <a:p xmlns:a="http://schemas.openxmlformats.org/drawingml/2006/main">
@@ -2164,7 +2164,7 @@
           <a:lstStyle xmlns:a="http://schemas.openxmlformats.org/drawingml/2006/main"/>
           <a:p xmlns:a="http://schemas.openxmlformats.org/drawingml/2006/main">
             <a:r>
-              <a:t>[พูด] สำหรับข้อมูลเชิงปริมาณ ให้ไล่ดูจากค่าน้ำหนักและภาระงานมาตรฐานไปยังภาระงานที่ทำได้ ซึ่งเป็นช่องที่ผู้รับการประเมินกรอก จากนั้นตรวจคะแนนที่ระบบคำนวณ ไม่ควรดูเฉพาะตัวเลขสุดท้าย แต่ต้องตรวจหน่วย ช่วงค่า และทศนิยมด้วย หากตัวเลขผิดปกติให้ย้อนกลับไปตรวจค่าที่กรอกก่อนบันทึก วิธีนี้ช่วยให้พบข้อผิดพลาดได้ตั้งแต่ต้นและอธิบายที่มาของคะแนนได้</a:t>
+              <a:t>[พูด] สำหรับข้อมูลเชิงปริมาณ ให้ไล่ดูทีละช่องนะครับ เริ่มจากค่าน้ำหนัก ภาระงานมาตรฐาน แล้วจึงกรอกภาระงานที่ทำได้ ระบบจะคำนวณคะแนนให้ ตรงนี้อย่าดูเฉพาะตัวเลขสุดท้ายครับ ให้ตรวจหน่วย ช่วงค่า และทศนิยมด้วย ถ้าคะแนนดูแปลก ให้ย้อนกลับไปดูค่าที่กรอกก่อนเป็นอันดับแรก วิธีนี้ช่วยให้เราอธิบายที่มาของคะแนนได้ชัดเจน แล้วต่อไปเราจะดูข้อมูลอีกแบบหนึ่ง คือผลงานเชิงคุณภาพครับ</a:t>
             </a:r>
           </a:p>
           <a:p xmlns:a="http://schemas.openxmlformats.org/drawingml/2006/main">
@@ -2252,7 +2252,7 @@
   </p:cSld>
   <p:clrMap bg1="lt1" tx1="dk1" bg2="lt2" tx2="dk2" accent1="accent1" accent2="accent2" accent3="accent3" accent4="accent4" accent5="accent5" accent6="accent6" hlink="hlink" folHlink="folHlink"/>
   <p:sldLayoutIdLst>
-    <p:sldLayoutId xmlns:r="http://schemas.openxmlformats.org/officeDocument/2006/relationships" id="2147483649" r:id="R2e632a66e667459a"/>
+    <p:sldLayoutId xmlns:r="http://schemas.openxmlformats.org/officeDocument/2006/relationships" id="2147483649" r:id="R3501ce47c6d94cac"/>
   </p:sldLayoutIdLst>
   <p:txStyles>
     <p:titleStyle>
@@ -2807,7 +2807,7 @@
           <p:nvPr/>
         </p:nvPicPr>
         <p:blipFill>
-          <a:blip xmlns:r="http://schemas.openxmlformats.org/officeDocument/2006/relationships" xmlns:a="http://schemas.openxmlformats.org/drawingml/2006/main" r:embed="R8220d083e10b4fb7"/>
+          <a:blip xmlns:r="http://schemas.openxmlformats.org/officeDocument/2006/relationships" xmlns:a="http://schemas.openxmlformats.org/drawingml/2006/main" r:embed="R50b759110ae14d15"/>
           <a:srcRect xmlns:a="http://schemas.openxmlformats.org/drawingml/2006/main" l="2579" t="0" r="2579" b="0"/>
           <a:stretch xmlns:a="http://schemas.openxmlformats.org/drawingml/2006/main">
             <a:fillRect l="0" t="0" r="0" b="0"/>
@@ -2828,7 +2828,7 @@
           <p:cNvPr id="2" name="cover-panel">
             <a:extLst xmlns:a="http://schemas.openxmlformats.org/drawingml/2006/main">
               <a:ext uri="{FF2B5EF4-FFF2-40B4-BE49-F238E27FC236}">
-                <a16:creationId xmlns:a16="http://schemas.microsoft.com/office/drawing/2014/main" id="{9242EDEC-1B4C-4781-A81E-8FFD7A62C641}"/>
+                <a16:creationId xmlns:a16="http://schemas.microsoft.com/office/drawing/2014/main" id="{1940AAA3-CC28-459E-9777-B184A744E9A6}"/>
               </a:ext>
             </a:extLst>
           </p:cNvPr>
@@ -2859,7 +2859,7 @@
           <p:cNvPr id="3" name="cover-accent">
             <a:extLst xmlns:a="http://schemas.openxmlformats.org/drawingml/2006/main">
               <a:ext uri="{FF2B5EF4-FFF2-40B4-BE49-F238E27FC236}">
-                <a16:creationId xmlns:a16="http://schemas.microsoft.com/office/drawing/2014/main" id="{D08C9BA9-824F-4F49-B7FE-460CCA6B7893}"/>
+                <a16:creationId xmlns:a16="http://schemas.microsoft.com/office/drawing/2014/main" id="{17251C57-D60F-424A-8D23-7E615DB85FA4}"/>
               </a:ext>
             </a:extLst>
           </p:cNvPr>
@@ -2894,7 +2894,7 @@
           <p:nvPr/>
         </p:nvPicPr>
         <p:blipFill>
-          <a:blip xmlns:r="http://schemas.openxmlformats.org/officeDocument/2006/relationships" xmlns:a="http://schemas.openxmlformats.org/drawingml/2006/main" r:embed="Rb48302174df14012"/>
+          <a:blip xmlns:r="http://schemas.openxmlformats.org/officeDocument/2006/relationships" xmlns:a="http://schemas.openxmlformats.org/drawingml/2006/main" r:embed="R9378b61eb4544747"/>
           <a:stretch xmlns:a="http://schemas.openxmlformats.org/drawingml/2006/main"/>
         </p:blipFill>
         <p:spPr>
@@ -2912,7 +2912,7 @@
           <p:cNvPr id="5" name="cover-institution">
             <a:extLst xmlns:a="http://schemas.openxmlformats.org/drawingml/2006/main">
               <a:ext uri="{FF2B5EF4-FFF2-40B4-BE49-F238E27FC236}">
-                <a16:creationId xmlns:a16="http://schemas.microsoft.com/office/drawing/2014/main" id="{83F7CC74-1BAF-4FF6-B635-F61A138AACAD}"/>
+                <a16:creationId xmlns:a16="http://schemas.microsoft.com/office/drawing/2014/main" id="{6EAA55FF-BA4F-490D-B093-7DC15885E6E7}"/>
               </a:ext>
             </a:extLst>
           </p:cNvPr>
@@ -2974,7 +2974,7 @@
           <p:cNvPr id="6" name="cover-session">
             <a:extLst xmlns:a="http://schemas.openxmlformats.org/drawingml/2006/main">
               <a:ext uri="{FF2B5EF4-FFF2-40B4-BE49-F238E27FC236}">
-                <a16:creationId xmlns:a16="http://schemas.microsoft.com/office/drawing/2014/main" id="{E2BA134D-4FCD-4082-8244-2AEE97520792}"/>
+                <a16:creationId xmlns:a16="http://schemas.microsoft.com/office/drawing/2014/main" id="{1ED752B1-88B4-43AA-8827-1B1DCC69D11A}"/>
               </a:ext>
             </a:extLst>
           </p:cNvPr>
@@ -3036,7 +3036,7 @@
           <p:cNvPr id="7" name="cover-title">
             <a:extLst xmlns:a="http://schemas.openxmlformats.org/drawingml/2006/main">
               <a:ext uri="{FF2B5EF4-FFF2-40B4-BE49-F238E27FC236}">
-                <a16:creationId xmlns:a16="http://schemas.microsoft.com/office/drawing/2014/main" id="{D282C833-0753-44A6-843A-DBCD5E27E7D8}"/>
+                <a16:creationId xmlns:a16="http://schemas.microsoft.com/office/drawing/2014/main" id="{BA0E3F31-2CC4-4EEF-A0D5-130ECE7C69CC}"/>
               </a:ext>
             </a:extLst>
           </p:cNvPr>
@@ -3125,7 +3125,7 @@
           <p:cNvPr id="8" name="cover-gold-rule">
             <a:extLst xmlns:a="http://schemas.openxmlformats.org/drawingml/2006/main">
               <a:ext uri="{FF2B5EF4-FFF2-40B4-BE49-F238E27FC236}">
-                <a16:creationId xmlns:a16="http://schemas.microsoft.com/office/drawing/2014/main" id="{FA0544A7-4936-4360-9EA0-D5ADF46FED2C}"/>
+                <a16:creationId xmlns:a16="http://schemas.microsoft.com/office/drawing/2014/main" id="{11DA346F-E8A0-4892-A679-08070EC26315}"/>
               </a:ext>
             </a:extLst>
           </p:cNvPr>
@@ -3156,7 +3156,7 @@
           <p:cNvPr id="9" name="cover-promise">
             <a:extLst xmlns:a="http://schemas.openxmlformats.org/drawingml/2006/main">
               <a:ext uri="{FF2B5EF4-FFF2-40B4-BE49-F238E27FC236}">
-                <a16:creationId xmlns:a16="http://schemas.microsoft.com/office/drawing/2014/main" id="{541F68F8-AA0A-4324-A036-CB02F488F949}"/>
+                <a16:creationId xmlns:a16="http://schemas.microsoft.com/office/drawing/2014/main" id="{F48D2DE3-1815-46B5-9C03-EADDBADBD841}"/>
               </a:ext>
             </a:extLst>
           </p:cNvPr>
@@ -3218,7 +3218,7 @@
           <p:cNvPr id="10" name="cover-style">
             <a:extLst xmlns:a="http://schemas.openxmlformats.org/drawingml/2006/main">
               <a:ext uri="{FF2B5EF4-FFF2-40B4-BE49-F238E27FC236}">
-                <a16:creationId xmlns:a16="http://schemas.microsoft.com/office/drawing/2014/main" id="{EED69F5C-A9FE-4D17-BEF7-D6A23D43BB77}"/>
+                <a16:creationId xmlns:a16="http://schemas.microsoft.com/office/drawing/2014/main" id="{C0D81C89-B964-46FB-B869-0B7E0A8B3E8D}"/>
               </a:ext>
             </a:extLst>
           </p:cNvPr>
@@ -3284,7 +3284,7 @@
           <p:nvPr/>
         </p:nvPicPr>
         <p:blipFill>
-          <a:blip xmlns:r="http://schemas.openxmlformats.org/officeDocument/2006/relationships" xmlns:a="http://schemas.openxmlformats.org/drawingml/2006/main" r:embed="R8913fa83345245b8"/>
+          <a:blip xmlns:r="http://schemas.openxmlformats.org/officeDocument/2006/relationships" xmlns:a="http://schemas.openxmlformats.org/drawingml/2006/main" r:embed="R0d45e321cf984c57"/>
           <a:stretch xmlns:a="http://schemas.openxmlformats.org/drawingml/2006/main"/>
         </p:blipFill>
         <p:spPr>
@@ -3300,7 +3300,7 @@
     </p:spTree>
     <p:extLst>
       <p:ext uri="{BB962C8B-B14F-4D97-AF65-F5344CB8AC3E}">
-        <p14:creationId xmlns:p14="http://schemas.microsoft.com/office/powerpoint/2010/main" val="999100227"/>
+        <p14:creationId xmlns:p14="http://schemas.microsoft.com/office/powerpoint/2010/main" val="1669697331"/>
       </p:ext>
     </p:extLst>
   </p:cSld>
@@ -3331,7 +3331,7 @@
           <p:cNvPr id="21" name="side-accent-10">
             <a:extLst xmlns:a="http://schemas.openxmlformats.org/drawingml/2006/main">
               <a:ext uri="{FF2B5EF4-FFF2-40B4-BE49-F238E27FC236}">
-                <a16:creationId xmlns:a16="http://schemas.microsoft.com/office/drawing/2014/main" id="{6EE22F4F-7FC5-4132-80F7-9708F9F80652}"/>
+                <a16:creationId xmlns:a16="http://schemas.microsoft.com/office/drawing/2014/main" id="{4CFA6D5F-AF04-464A-B23B-A10C962E1674}"/>
               </a:ext>
             </a:extLst>
           </p:cNvPr>
@@ -3362,7 +3362,7 @@
           <p:cNvPr id="2" name="kicker-10">
             <a:extLst xmlns:a="http://schemas.openxmlformats.org/drawingml/2006/main">
               <a:ext uri="{FF2B5EF4-FFF2-40B4-BE49-F238E27FC236}">
-                <a16:creationId xmlns:a16="http://schemas.microsoft.com/office/drawing/2014/main" id="{7E981119-B365-4DA5-83D9-A6F724A3A086}"/>
+                <a16:creationId xmlns:a16="http://schemas.microsoft.com/office/drawing/2014/main" id="{381C64D6-862C-40AC-8F5D-06F1D56D9DA9}"/>
               </a:ext>
             </a:extLst>
           </p:cNvPr>
@@ -3424,7 +3424,7 @@
           <p:cNvPr id="3" name="title-10">
             <a:extLst xmlns:a="http://schemas.openxmlformats.org/drawingml/2006/main">
               <a:ext uri="{FF2B5EF4-FFF2-40B4-BE49-F238E27FC236}">
-                <a16:creationId xmlns:a16="http://schemas.microsoft.com/office/drawing/2014/main" id="{1C0D6A2D-62A4-491F-919D-1671365B1893}"/>
+                <a16:creationId xmlns:a16="http://schemas.microsoft.com/office/drawing/2014/main" id="{6885A6D0-4755-4DBF-BC29-F2ED31526096}"/>
               </a:ext>
             </a:extLst>
           </p:cNvPr>
@@ -3486,7 +3486,7 @@
           <p:cNvPr id="4" name="">
             <a:extLst xmlns:a="http://schemas.openxmlformats.org/drawingml/2006/main">
               <a:ext uri="{FF2B5EF4-FFF2-40B4-BE49-F238E27FC236}">
-                <a16:creationId xmlns:a16="http://schemas.microsoft.com/office/drawing/2014/main" id="{5411E435-A604-4700-BA0C-DAD11340986C}"/>
+                <a16:creationId xmlns:a16="http://schemas.microsoft.com/office/drawing/2014/main" id="{F2D3A870-7EC9-47A3-8B8D-8BC92DB95596}"/>
               </a:ext>
             </a:extLst>
           </p:cNvPr>
@@ -3548,7 +3548,7 @@
           <p:cNvPr id="5" name="">
             <a:extLst xmlns:a="http://schemas.openxmlformats.org/drawingml/2006/main">
               <a:ext uri="{FF2B5EF4-FFF2-40B4-BE49-F238E27FC236}">
-                <a16:creationId xmlns:a16="http://schemas.microsoft.com/office/drawing/2014/main" id="{959FD301-CBA5-49AE-93FC-F7C3DDC593A6}"/>
+                <a16:creationId xmlns:a16="http://schemas.microsoft.com/office/drawing/2014/main" id="{F9DCE39D-B7C0-42C6-98D7-6DE28F0800A8}"/>
               </a:ext>
             </a:extLst>
           </p:cNvPr>
@@ -3610,7 +3610,7 @@
           <p:cNvPr id="6" name="">
             <a:extLst xmlns:a="http://schemas.openxmlformats.org/drawingml/2006/main">
               <a:ext uri="{FF2B5EF4-FFF2-40B4-BE49-F238E27FC236}">
-                <a16:creationId xmlns:a16="http://schemas.microsoft.com/office/drawing/2014/main" id="{A16AD64D-B17F-4A40-BF3C-BA816FDC9BB7}"/>
+                <a16:creationId xmlns:a16="http://schemas.microsoft.com/office/drawing/2014/main" id="{8BB21438-6FA1-494C-9DC1-7C108676338C}"/>
               </a:ext>
             </a:extLst>
           </p:cNvPr>
@@ -3672,7 +3672,7 @@
           <p:cNvPr id="7" name="">
             <a:extLst xmlns:a="http://schemas.openxmlformats.org/drawingml/2006/main">
               <a:ext uri="{FF2B5EF4-FFF2-40B4-BE49-F238E27FC236}">
-                <a16:creationId xmlns:a16="http://schemas.microsoft.com/office/drawing/2014/main" id="{9BD84E0D-E386-4F21-B6DC-7F4078BD3AFB}"/>
+                <a16:creationId xmlns:a16="http://schemas.microsoft.com/office/drawing/2014/main" id="{8DFDE4DD-DA76-4A11-974C-B822AE6B4081}"/>
               </a:ext>
             </a:extLst>
           </p:cNvPr>
@@ -3734,7 +3734,7 @@
           <p:cNvPr id="8" name="">
             <a:extLst xmlns:a="http://schemas.openxmlformats.org/drawingml/2006/main">
               <a:ext uri="{FF2B5EF4-FFF2-40B4-BE49-F238E27FC236}">
-                <a16:creationId xmlns:a16="http://schemas.microsoft.com/office/drawing/2014/main" id="{76B40287-9703-4678-B95E-2FE567546CA3}"/>
+                <a16:creationId xmlns:a16="http://schemas.microsoft.com/office/drawing/2014/main" id="{C04B62A6-4733-4FA8-8A96-82B552323005}"/>
               </a:ext>
             </a:extLst>
           </p:cNvPr>
@@ -3765,7 +3765,7 @@
           <p:cNvPr id="9" name="">
             <a:extLst xmlns:a="http://schemas.openxmlformats.org/drawingml/2006/main">
               <a:ext uri="{FF2B5EF4-FFF2-40B4-BE49-F238E27FC236}">
-                <a16:creationId xmlns:a16="http://schemas.microsoft.com/office/drawing/2014/main" id="{7C9C1B4C-1982-452F-9D60-9054E0CCC4FC}"/>
+                <a16:creationId xmlns:a16="http://schemas.microsoft.com/office/drawing/2014/main" id="{4FBBDF97-0BC3-45EF-BB2E-1FB7E7AB9C60}"/>
               </a:ext>
             </a:extLst>
           </p:cNvPr>
@@ -3827,7 +3827,7 @@
           <p:cNvPr id="10" name="">
             <a:extLst xmlns:a="http://schemas.openxmlformats.org/drawingml/2006/main">
               <a:ext uri="{FF2B5EF4-FFF2-40B4-BE49-F238E27FC236}">
-                <a16:creationId xmlns:a16="http://schemas.microsoft.com/office/drawing/2014/main" id="{B4E8B378-6AE0-49DD-8634-B195C276DA87}"/>
+                <a16:creationId xmlns:a16="http://schemas.microsoft.com/office/drawing/2014/main" id="{4D4B4162-D252-4A05-833D-24D6BB1848EA}"/>
               </a:ext>
             </a:extLst>
           </p:cNvPr>
@@ -3889,7 +3889,7 @@
           <p:cNvPr id="11" name="">
             <a:extLst xmlns:a="http://schemas.openxmlformats.org/drawingml/2006/main">
               <a:ext uri="{FF2B5EF4-FFF2-40B4-BE49-F238E27FC236}">
-                <a16:creationId xmlns:a16="http://schemas.microsoft.com/office/drawing/2014/main" id="{18193105-A38E-42FD-B088-8447B4D76FB1}"/>
+                <a16:creationId xmlns:a16="http://schemas.microsoft.com/office/drawing/2014/main" id="{AC352C44-0B32-40B7-A155-8592C6604AA7}"/>
               </a:ext>
             </a:extLst>
           </p:cNvPr>
@@ -3951,7 +3951,7 @@
           <p:cNvPr id="12" name="">
             <a:extLst xmlns:a="http://schemas.openxmlformats.org/drawingml/2006/main">
               <a:ext uri="{FF2B5EF4-FFF2-40B4-BE49-F238E27FC236}">
-                <a16:creationId xmlns:a16="http://schemas.microsoft.com/office/drawing/2014/main" id="{89051BF2-3834-46C5-8F7B-1F74B262C537}"/>
+                <a16:creationId xmlns:a16="http://schemas.microsoft.com/office/drawing/2014/main" id="{DE5DF7CE-2807-44D2-8DFB-A058F1BE1205}"/>
               </a:ext>
             </a:extLst>
           </p:cNvPr>
@@ -3982,7 +3982,7 @@
           <p:cNvPr id="13" name="">
             <a:extLst xmlns:a="http://schemas.openxmlformats.org/drawingml/2006/main">
               <a:ext uri="{FF2B5EF4-FFF2-40B4-BE49-F238E27FC236}">
-                <a16:creationId xmlns:a16="http://schemas.microsoft.com/office/drawing/2014/main" id="{DE678BB0-F3FA-4A52-81EA-1A7262A44101}"/>
+                <a16:creationId xmlns:a16="http://schemas.microsoft.com/office/drawing/2014/main" id="{ABB533AF-7D15-4D21-98F8-FE56B02E8872}"/>
               </a:ext>
             </a:extLst>
           </p:cNvPr>
@@ -4044,7 +4044,7 @@
           <p:cNvPr id="14" name="">
             <a:extLst xmlns:a="http://schemas.openxmlformats.org/drawingml/2006/main">
               <a:ext uri="{FF2B5EF4-FFF2-40B4-BE49-F238E27FC236}">
-                <a16:creationId xmlns:a16="http://schemas.microsoft.com/office/drawing/2014/main" id="{0950C387-A0C3-488A-BEB0-3AD16576AC9A}"/>
+                <a16:creationId xmlns:a16="http://schemas.microsoft.com/office/drawing/2014/main" id="{3FF51788-C174-4A2E-B404-816CF1992673}"/>
               </a:ext>
             </a:extLst>
           </p:cNvPr>
@@ -4106,7 +4106,7 @@
           <p:cNvPr id="15" name="">
             <a:extLst xmlns:a="http://schemas.openxmlformats.org/drawingml/2006/main">
               <a:ext uri="{FF2B5EF4-FFF2-40B4-BE49-F238E27FC236}">
-                <a16:creationId xmlns:a16="http://schemas.microsoft.com/office/drawing/2014/main" id="{EE459594-CFFA-41CE-BC1E-AFD2E26FC4A3}"/>
+                <a16:creationId xmlns:a16="http://schemas.microsoft.com/office/drawing/2014/main" id="{A45D6905-F38E-4D0C-A9A1-13F88FB5F0D4}"/>
               </a:ext>
             </a:extLst>
           </p:cNvPr>
@@ -4168,7 +4168,7 @@
           <p:cNvPr id="16" name="">
             <a:extLst xmlns:a="http://schemas.openxmlformats.org/drawingml/2006/main">
               <a:ext uri="{FF2B5EF4-FFF2-40B4-BE49-F238E27FC236}">
-                <a16:creationId xmlns:a16="http://schemas.microsoft.com/office/drawing/2014/main" id="{7B420F54-E3E4-4115-BBF8-29802260AC9B}"/>
+                <a16:creationId xmlns:a16="http://schemas.microsoft.com/office/drawing/2014/main" id="{AEBD0995-CF37-417C-B8A6-A72750874F27}"/>
               </a:ext>
             </a:extLst>
           </p:cNvPr>
@@ -4201,7 +4201,7 @@
           <p:cNvPr id="17" name="">
             <a:extLst xmlns:a="http://schemas.openxmlformats.org/drawingml/2006/main">
               <a:ext uri="{FF2B5EF4-FFF2-40B4-BE49-F238E27FC236}">
-                <a16:creationId xmlns:a16="http://schemas.microsoft.com/office/drawing/2014/main" id="{AD1000C8-27EA-4CB4-A803-7DACD29C7480}"/>
+                <a16:creationId xmlns:a16="http://schemas.microsoft.com/office/drawing/2014/main" id="{896A23D1-CDDD-4D8F-A02C-65EF38734BD1}"/>
               </a:ext>
             </a:extLst>
           </p:cNvPr>
@@ -4263,7 +4263,7 @@
           <p:cNvPr id="18" name="footer-rule-10">
             <a:extLst xmlns:a="http://schemas.openxmlformats.org/drawingml/2006/main">
               <a:ext uri="{FF2B5EF4-FFF2-40B4-BE49-F238E27FC236}">
-                <a16:creationId xmlns:a16="http://schemas.microsoft.com/office/drawing/2014/main" id="{40D47AB6-DA1E-4F9A-B872-ECCE5D870AB3}"/>
+                <a16:creationId xmlns:a16="http://schemas.microsoft.com/office/drawing/2014/main" id="{F19E9D18-7BFA-4635-9048-D5F03BCFA146}"/>
               </a:ext>
             </a:extLst>
           </p:cNvPr>
@@ -4294,7 +4294,7 @@
           <p:cNvPr id="19" name="footer-label-10">
             <a:extLst xmlns:a="http://schemas.openxmlformats.org/drawingml/2006/main">
               <a:ext uri="{FF2B5EF4-FFF2-40B4-BE49-F238E27FC236}">
-                <a16:creationId xmlns:a16="http://schemas.microsoft.com/office/drawing/2014/main" id="{0D496566-95FA-41D2-A0C9-A2651EFA4048}"/>
+                <a16:creationId xmlns:a16="http://schemas.microsoft.com/office/drawing/2014/main" id="{6A070A15-B3D0-45F6-A88E-BA184A85FB30}"/>
               </a:ext>
             </a:extLst>
           </p:cNvPr>
@@ -4356,7 +4356,7 @@
           <p:cNvPr id="20" name="footer-page-10">
             <a:extLst xmlns:a="http://schemas.openxmlformats.org/drawingml/2006/main">
               <a:ext uri="{FF2B5EF4-FFF2-40B4-BE49-F238E27FC236}">
-                <a16:creationId xmlns:a16="http://schemas.microsoft.com/office/drawing/2014/main" id="{8F559CA5-9505-48D4-B667-E3ECABCD993D}"/>
+                <a16:creationId xmlns:a16="http://schemas.microsoft.com/office/drawing/2014/main" id="{749A98E9-EE40-4EF5-9990-FF87DE4B308C}"/>
               </a:ext>
             </a:extLst>
           </p:cNvPr>
@@ -4416,7 +4416,7 @@
     </p:spTree>
     <p:extLst>
       <p:ext uri="{BB962C8B-B14F-4D97-AF65-F5344CB8AC3E}">
-        <p14:creationId xmlns:p14="http://schemas.microsoft.com/office/powerpoint/2010/main" val="1044340304"/>
+        <p14:creationId xmlns:p14="http://schemas.microsoft.com/office/powerpoint/2010/main" val="2030559342"/>
       </p:ext>
     </p:extLst>
   </p:cSld>
@@ -4447,7 +4447,7 @@
           <p:cNvPr id="22" name="side-accent-11">
             <a:extLst xmlns:a="http://schemas.openxmlformats.org/drawingml/2006/main">
               <a:ext uri="{FF2B5EF4-FFF2-40B4-BE49-F238E27FC236}">
-                <a16:creationId xmlns:a16="http://schemas.microsoft.com/office/drawing/2014/main" id="{D2714398-5BF6-4E6E-A36E-14BB00E1B30B}"/>
+                <a16:creationId xmlns:a16="http://schemas.microsoft.com/office/drawing/2014/main" id="{71CEA988-02B1-4C1A-A3B5-9BDD8C5AD5AF}"/>
               </a:ext>
             </a:extLst>
           </p:cNvPr>
@@ -4478,7 +4478,7 @@
           <p:cNvPr id="2" name="kicker-11">
             <a:extLst xmlns:a="http://schemas.openxmlformats.org/drawingml/2006/main">
               <a:ext uri="{FF2B5EF4-FFF2-40B4-BE49-F238E27FC236}">
-                <a16:creationId xmlns:a16="http://schemas.microsoft.com/office/drawing/2014/main" id="{BEA924F7-546E-4934-9E70-5F7A9A1CB2C9}"/>
+                <a16:creationId xmlns:a16="http://schemas.microsoft.com/office/drawing/2014/main" id="{9EB85E06-97A2-4423-B517-7163F499E479}"/>
               </a:ext>
             </a:extLst>
           </p:cNvPr>
@@ -4540,7 +4540,7 @@
           <p:cNvPr id="3" name="title-11">
             <a:extLst xmlns:a="http://schemas.openxmlformats.org/drawingml/2006/main">
               <a:ext uri="{FF2B5EF4-FFF2-40B4-BE49-F238E27FC236}">
-                <a16:creationId xmlns:a16="http://schemas.microsoft.com/office/drawing/2014/main" id="{AF87D112-A70A-4CC2-AD98-01B4593DDA3E}"/>
+                <a16:creationId xmlns:a16="http://schemas.microsoft.com/office/drawing/2014/main" id="{AAB05D03-1A4C-45D8-B94D-18D71C04D4D9}"/>
               </a:ext>
             </a:extLst>
           </p:cNvPr>
@@ -4602,7 +4602,7 @@
           <p:cNvPr id="4" name="">
             <a:extLst xmlns:a="http://schemas.openxmlformats.org/drawingml/2006/main">
               <a:ext uri="{FF2B5EF4-FFF2-40B4-BE49-F238E27FC236}">
-                <a16:creationId xmlns:a16="http://schemas.microsoft.com/office/drawing/2014/main" id="{FF4E2314-C7A8-454F-81F6-41DBB4B5A48D}"/>
+                <a16:creationId xmlns:a16="http://schemas.microsoft.com/office/drawing/2014/main" id="{3C9F61A8-8CD2-4197-8D93-BFC5C53201A0}"/>
               </a:ext>
             </a:extLst>
           </p:cNvPr>
@@ -4664,7 +4664,7 @@
           <p:cNvPr id="5" name="">
             <a:extLst xmlns:a="http://schemas.openxmlformats.org/drawingml/2006/main">
               <a:ext uri="{FF2B5EF4-FFF2-40B4-BE49-F238E27FC236}">
-                <a16:creationId xmlns:a16="http://schemas.microsoft.com/office/drawing/2014/main" id="{86728AA2-62AC-4A5A-AF16-48DC724116BC}"/>
+                <a16:creationId xmlns:a16="http://schemas.microsoft.com/office/drawing/2014/main" id="{51040D3F-9C5B-40ED-90BF-00F952D0CB1D}"/>
               </a:ext>
             </a:extLst>
           </p:cNvPr>
@@ -4695,7 +4695,7 @@
           <p:cNvPr id="6" name="">
             <a:extLst xmlns:a="http://schemas.openxmlformats.org/drawingml/2006/main">
               <a:ext uri="{FF2B5EF4-FFF2-40B4-BE49-F238E27FC236}">
-                <a16:creationId xmlns:a16="http://schemas.microsoft.com/office/drawing/2014/main" id="{F24B040B-C18F-4781-913E-F60381BA3F4E}"/>
+                <a16:creationId xmlns:a16="http://schemas.microsoft.com/office/drawing/2014/main" id="{CF854111-52EE-40F2-965D-BD91297D2C2B}"/>
               </a:ext>
             </a:extLst>
           </p:cNvPr>
@@ -4757,7 +4757,7 @@
           <p:cNvPr id="7" name="">
             <a:extLst xmlns:a="http://schemas.openxmlformats.org/drawingml/2006/main">
               <a:ext uri="{FF2B5EF4-FFF2-40B4-BE49-F238E27FC236}">
-                <a16:creationId xmlns:a16="http://schemas.microsoft.com/office/drawing/2014/main" id="{AF5F755E-B5E8-4CDE-8E91-D99934208D30}"/>
+                <a16:creationId xmlns:a16="http://schemas.microsoft.com/office/drawing/2014/main" id="{C66429F4-525D-4039-A91E-A6EC48198C28}"/>
               </a:ext>
             </a:extLst>
           </p:cNvPr>
@@ -4819,7 +4819,7 @@
           <p:cNvPr id="8" name="">
             <a:extLst xmlns:a="http://schemas.openxmlformats.org/drawingml/2006/main">
               <a:ext uri="{FF2B5EF4-FFF2-40B4-BE49-F238E27FC236}">
-                <a16:creationId xmlns:a16="http://schemas.microsoft.com/office/drawing/2014/main" id="{C42B6C1D-8D8C-46E0-B6B7-A99F5385770E}"/>
+                <a16:creationId xmlns:a16="http://schemas.microsoft.com/office/drawing/2014/main" id="{88B9EAB1-7F4E-44E1-8D3D-4A06CD1F750D}"/>
               </a:ext>
             </a:extLst>
           </p:cNvPr>
@@ -4881,7 +4881,7 @@
           <p:cNvPr id="9" name="">
             <a:extLst xmlns:a="http://schemas.openxmlformats.org/drawingml/2006/main">
               <a:ext uri="{FF2B5EF4-FFF2-40B4-BE49-F238E27FC236}">
-                <a16:creationId xmlns:a16="http://schemas.microsoft.com/office/drawing/2014/main" id="{A76BDF43-BE21-447A-BF17-FBFAB491FFE5}"/>
+                <a16:creationId xmlns:a16="http://schemas.microsoft.com/office/drawing/2014/main" id="{779DF10C-640A-4BCA-8637-6DA639A1E086}"/>
               </a:ext>
             </a:extLst>
           </p:cNvPr>
@@ -4912,7 +4912,7 @@
           <p:cNvPr id="10" name="">
             <a:extLst xmlns:a="http://schemas.openxmlformats.org/drawingml/2006/main">
               <a:ext uri="{FF2B5EF4-FFF2-40B4-BE49-F238E27FC236}">
-                <a16:creationId xmlns:a16="http://schemas.microsoft.com/office/drawing/2014/main" id="{BEBBC259-6FF9-461C-8D78-CEA485027DB8}"/>
+                <a16:creationId xmlns:a16="http://schemas.microsoft.com/office/drawing/2014/main" id="{948428D0-DD77-4384-9227-C72D62192010}"/>
               </a:ext>
             </a:extLst>
           </p:cNvPr>
@@ -4974,7 +4974,7 @@
           <p:cNvPr id="11" name="">
             <a:extLst xmlns:a="http://schemas.openxmlformats.org/drawingml/2006/main">
               <a:ext uri="{FF2B5EF4-FFF2-40B4-BE49-F238E27FC236}">
-                <a16:creationId xmlns:a16="http://schemas.microsoft.com/office/drawing/2014/main" id="{2147D9DA-9691-4545-8E0B-28F3BF3DD165}"/>
+                <a16:creationId xmlns:a16="http://schemas.microsoft.com/office/drawing/2014/main" id="{0242C9D7-D56F-4898-9626-3085C6C7E122}"/>
               </a:ext>
             </a:extLst>
           </p:cNvPr>
@@ -5036,7 +5036,7 @@
           <p:cNvPr id="12" name="">
             <a:extLst xmlns:a="http://schemas.openxmlformats.org/drawingml/2006/main">
               <a:ext uri="{FF2B5EF4-FFF2-40B4-BE49-F238E27FC236}">
-                <a16:creationId xmlns:a16="http://schemas.microsoft.com/office/drawing/2014/main" id="{D560ECFD-D949-4E2C-86C4-C3301351A4AC}"/>
+                <a16:creationId xmlns:a16="http://schemas.microsoft.com/office/drawing/2014/main" id="{5BB804E5-C04D-4989-9A93-280E927071F3}"/>
               </a:ext>
             </a:extLst>
           </p:cNvPr>
@@ -5098,7 +5098,7 @@
           <p:cNvPr id="13" name="">
             <a:extLst xmlns:a="http://schemas.openxmlformats.org/drawingml/2006/main">
               <a:ext uri="{FF2B5EF4-FFF2-40B4-BE49-F238E27FC236}">
-                <a16:creationId xmlns:a16="http://schemas.microsoft.com/office/drawing/2014/main" id="{1129798E-EB4E-41DD-A8D0-1068DCC27506}"/>
+                <a16:creationId xmlns:a16="http://schemas.microsoft.com/office/drawing/2014/main" id="{2D4A7D32-5DE0-4D3E-9671-AE4ED621E1B4}"/>
               </a:ext>
             </a:extLst>
           </p:cNvPr>
@@ -5129,7 +5129,7 @@
           <p:cNvPr id="14" name="">
             <a:extLst xmlns:a="http://schemas.openxmlformats.org/drawingml/2006/main">
               <a:ext uri="{FF2B5EF4-FFF2-40B4-BE49-F238E27FC236}">
-                <a16:creationId xmlns:a16="http://schemas.microsoft.com/office/drawing/2014/main" id="{06FAEDA2-646A-43D6-8B8B-4FDD58C9A60A}"/>
+                <a16:creationId xmlns:a16="http://schemas.microsoft.com/office/drawing/2014/main" id="{E98298DA-BB2B-4622-8A2D-999659CD87A7}"/>
               </a:ext>
             </a:extLst>
           </p:cNvPr>
@@ -5191,7 +5191,7 @@
           <p:cNvPr id="15" name="">
             <a:extLst xmlns:a="http://schemas.openxmlformats.org/drawingml/2006/main">
               <a:ext uri="{FF2B5EF4-FFF2-40B4-BE49-F238E27FC236}">
-                <a16:creationId xmlns:a16="http://schemas.microsoft.com/office/drawing/2014/main" id="{89645165-7765-4455-9455-303E5E7E0952}"/>
+                <a16:creationId xmlns:a16="http://schemas.microsoft.com/office/drawing/2014/main" id="{E4BAD448-A3CA-4BCF-BF13-0E84F9240A31}"/>
               </a:ext>
             </a:extLst>
           </p:cNvPr>
@@ -5253,7 +5253,7 @@
           <p:cNvPr id="16" name="">
             <a:extLst xmlns:a="http://schemas.openxmlformats.org/drawingml/2006/main">
               <a:ext uri="{FF2B5EF4-FFF2-40B4-BE49-F238E27FC236}">
-                <a16:creationId xmlns:a16="http://schemas.microsoft.com/office/drawing/2014/main" id="{1F01914B-C237-4A71-8D12-0C751CFCB339}"/>
+                <a16:creationId xmlns:a16="http://schemas.microsoft.com/office/drawing/2014/main" id="{5C5622CD-E322-4995-B77A-68DD0E930231}"/>
               </a:ext>
             </a:extLst>
           </p:cNvPr>
@@ -5315,7 +5315,7 @@
           <p:cNvPr id="17" name="">
             <a:extLst xmlns:a="http://schemas.openxmlformats.org/drawingml/2006/main">
               <a:ext uri="{FF2B5EF4-FFF2-40B4-BE49-F238E27FC236}">
-                <a16:creationId xmlns:a16="http://schemas.microsoft.com/office/drawing/2014/main" id="{D7D651E8-65B1-4B44-88C4-9BF539546966}"/>
+                <a16:creationId xmlns:a16="http://schemas.microsoft.com/office/drawing/2014/main" id="{9E49CA8B-C4EB-44F4-BF44-505404D1ED70}"/>
               </a:ext>
             </a:extLst>
           </p:cNvPr>
@@ -5350,7 +5350,7 @@
           <p:cNvPr id="18" name="">
             <a:extLst xmlns:a="http://schemas.openxmlformats.org/drawingml/2006/main">
               <a:ext uri="{FF2B5EF4-FFF2-40B4-BE49-F238E27FC236}">
-                <a16:creationId xmlns:a16="http://schemas.microsoft.com/office/drawing/2014/main" id="{C7FFCA3C-E966-4854-8FAD-26D1B219D2BD}"/>
+                <a16:creationId xmlns:a16="http://schemas.microsoft.com/office/drawing/2014/main" id="{35B830D6-7C36-45EC-A9BB-78B6A40AF3F2}"/>
               </a:ext>
             </a:extLst>
           </p:cNvPr>
@@ -5439,7 +5439,7 @@
           <p:cNvPr id="19" name="footer-rule-11">
             <a:extLst xmlns:a="http://schemas.openxmlformats.org/drawingml/2006/main">
               <a:ext uri="{FF2B5EF4-FFF2-40B4-BE49-F238E27FC236}">
-                <a16:creationId xmlns:a16="http://schemas.microsoft.com/office/drawing/2014/main" id="{79FA44BA-161E-4657-A6D9-E5AB111E45E9}"/>
+                <a16:creationId xmlns:a16="http://schemas.microsoft.com/office/drawing/2014/main" id="{B04E4057-44CD-4FA7-B903-19582E55C0CB}"/>
               </a:ext>
             </a:extLst>
           </p:cNvPr>
@@ -5470,7 +5470,7 @@
           <p:cNvPr id="20" name="footer-label-11">
             <a:extLst xmlns:a="http://schemas.openxmlformats.org/drawingml/2006/main">
               <a:ext uri="{FF2B5EF4-FFF2-40B4-BE49-F238E27FC236}">
-                <a16:creationId xmlns:a16="http://schemas.microsoft.com/office/drawing/2014/main" id="{504692BF-3552-48BF-929B-2A21C18A70F7}"/>
+                <a16:creationId xmlns:a16="http://schemas.microsoft.com/office/drawing/2014/main" id="{6CFDC52A-937D-4A03-BF9F-DD7CBDE7BD53}"/>
               </a:ext>
             </a:extLst>
           </p:cNvPr>
@@ -5532,7 +5532,7 @@
           <p:cNvPr id="21" name="footer-page-11">
             <a:extLst xmlns:a="http://schemas.openxmlformats.org/drawingml/2006/main">
               <a:ext uri="{FF2B5EF4-FFF2-40B4-BE49-F238E27FC236}">
-                <a16:creationId xmlns:a16="http://schemas.microsoft.com/office/drawing/2014/main" id="{4F7CE26A-0C4B-4A0F-B333-F72780EF2728}"/>
+                <a16:creationId xmlns:a16="http://schemas.microsoft.com/office/drawing/2014/main" id="{D1C2A40C-B35B-4C8D-8A3A-6CE1A47885C4}"/>
               </a:ext>
             </a:extLst>
           </p:cNvPr>
@@ -5592,7 +5592,7 @@
     </p:spTree>
     <p:extLst>
       <p:ext uri="{BB962C8B-B14F-4D97-AF65-F5344CB8AC3E}">
-        <p14:creationId xmlns:p14="http://schemas.microsoft.com/office/powerpoint/2010/main" val="1013089819"/>
+        <p14:creationId xmlns:p14="http://schemas.microsoft.com/office/powerpoint/2010/main" val="2040543563"/>
       </p:ext>
     </p:extLst>
   </p:cSld>
@@ -5623,7 +5623,7 @@
           <p:cNvPr id="14" name="side-accent-12">
             <a:extLst xmlns:a="http://schemas.openxmlformats.org/drawingml/2006/main">
               <a:ext uri="{FF2B5EF4-FFF2-40B4-BE49-F238E27FC236}">
-                <a16:creationId xmlns:a16="http://schemas.microsoft.com/office/drawing/2014/main" id="{84289187-5394-4918-B24B-523B39C111D4}"/>
+                <a16:creationId xmlns:a16="http://schemas.microsoft.com/office/drawing/2014/main" id="{AE22D311-A5E9-4E87-9135-EC2332C84145}"/>
               </a:ext>
             </a:extLst>
           </p:cNvPr>
@@ -5654,7 +5654,7 @@
           <p:cNvPr id="2" name="kicker-12">
             <a:extLst xmlns:a="http://schemas.openxmlformats.org/drawingml/2006/main">
               <a:ext uri="{FF2B5EF4-FFF2-40B4-BE49-F238E27FC236}">
-                <a16:creationId xmlns:a16="http://schemas.microsoft.com/office/drawing/2014/main" id="{C7206BB4-6590-4F0B-A9DB-D1174F014AF0}"/>
+                <a16:creationId xmlns:a16="http://schemas.microsoft.com/office/drawing/2014/main" id="{408C12A9-E46C-4C77-8425-B4257ED10472}"/>
               </a:ext>
             </a:extLst>
           </p:cNvPr>
@@ -5716,7 +5716,7 @@
           <p:cNvPr id="3" name="title-12">
             <a:extLst xmlns:a="http://schemas.openxmlformats.org/drawingml/2006/main">
               <a:ext uri="{FF2B5EF4-FFF2-40B4-BE49-F238E27FC236}">
-                <a16:creationId xmlns:a16="http://schemas.microsoft.com/office/drawing/2014/main" id="{60C19E1E-C8A5-4F18-A37A-9A1367C04B24}"/>
+                <a16:creationId xmlns:a16="http://schemas.microsoft.com/office/drawing/2014/main" id="{56F00F9C-BC02-4B86-AEE9-431B4466154C}"/>
               </a:ext>
             </a:extLst>
           </p:cNvPr>
@@ -5778,7 +5778,7 @@
           <p:cNvPr id="4" name="draft-panel">
             <a:extLst xmlns:a="http://schemas.openxmlformats.org/drawingml/2006/main">
               <a:ext uri="{FF2B5EF4-FFF2-40B4-BE49-F238E27FC236}">
-                <a16:creationId xmlns:a16="http://schemas.microsoft.com/office/drawing/2014/main" id="{E518F7BC-5296-4EC8-ABC5-85CC1342C8C1}"/>
+                <a16:creationId xmlns:a16="http://schemas.microsoft.com/office/drawing/2014/main" id="{7D6BE7F5-4AE2-49CF-A03D-AF1172C2A9A1}"/>
               </a:ext>
             </a:extLst>
           </p:cNvPr>
@@ -5813,7 +5813,7 @@
           <p:cNvPr id="5" name="">
             <a:extLst xmlns:a="http://schemas.openxmlformats.org/drawingml/2006/main">
               <a:ext uri="{FF2B5EF4-FFF2-40B4-BE49-F238E27FC236}">
-                <a16:creationId xmlns:a16="http://schemas.microsoft.com/office/drawing/2014/main" id="{D614E548-4757-4623-BCDC-0237D94A9B3E}"/>
+                <a16:creationId xmlns:a16="http://schemas.microsoft.com/office/drawing/2014/main" id="{A861AB5A-E213-4F44-B745-D1F46AAA84DE}"/>
               </a:ext>
             </a:extLst>
           </p:cNvPr>
@@ -5875,7 +5875,7 @@
           <p:cNvPr id="6" name="">
             <a:extLst xmlns:a="http://schemas.openxmlformats.org/drawingml/2006/main">
               <a:ext uri="{FF2B5EF4-FFF2-40B4-BE49-F238E27FC236}">
-                <a16:creationId xmlns:a16="http://schemas.microsoft.com/office/drawing/2014/main" id="{F6D2D8A5-FDAA-40DB-B3FD-9C7266C8E8CA}"/>
+                <a16:creationId xmlns:a16="http://schemas.microsoft.com/office/drawing/2014/main" id="{7617E20F-0DD1-44B8-8B8A-0B9A6430C981}"/>
               </a:ext>
             </a:extLst>
           </p:cNvPr>
@@ -5991,7 +5991,7 @@
           <p:cNvPr id="7" name="submit-panel">
             <a:extLst xmlns:a="http://schemas.openxmlformats.org/drawingml/2006/main">
               <a:ext uri="{FF2B5EF4-FFF2-40B4-BE49-F238E27FC236}">
-                <a16:creationId xmlns:a16="http://schemas.microsoft.com/office/drawing/2014/main" id="{DBF2AC59-33A3-46EB-A220-9C9495773253}"/>
+                <a16:creationId xmlns:a16="http://schemas.microsoft.com/office/drawing/2014/main" id="{A24728AB-E867-41AC-AFA5-EADFAEF35617}"/>
               </a:ext>
             </a:extLst>
           </p:cNvPr>
@@ -6026,7 +6026,7 @@
           <p:cNvPr id="8" name="">
             <a:extLst xmlns:a="http://schemas.openxmlformats.org/drawingml/2006/main">
               <a:ext uri="{FF2B5EF4-FFF2-40B4-BE49-F238E27FC236}">
-                <a16:creationId xmlns:a16="http://schemas.microsoft.com/office/drawing/2014/main" id="{05D98C1F-0682-4EE7-9273-174AAECD4BAD}"/>
+                <a16:creationId xmlns:a16="http://schemas.microsoft.com/office/drawing/2014/main" id="{10848F36-641B-4DEC-B27B-2283742D3E6A}"/>
               </a:ext>
             </a:extLst>
           </p:cNvPr>
@@ -6088,7 +6088,7 @@
           <p:cNvPr id="9" name="">
             <a:extLst xmlns:a="http://schemas.openxmlformats.org/drawingml/2006/main">
               <a:ext uri="{FF2B5EF4-FFF2-40B4-BE49-F238E27FC236}">
-                <a16:creationId xmlns:a16="http://schemas.microsoft.com/office/drawing/2014/main" id="{AB42A2D1-D17E-4106-B21B-0FCCFE3AA9F8}"/>
+                <a16:creationId xmlns:a16="http://schemas.microsoft.com/office/drawing/2014/main" id="{FBCC3743-9026-415D-B26D-FDD77452C3EE}"/>
               </a:ext>
             </a:extLst>
           </p:cNvPr>
@@ -6204,7 +6204,7 @@
           <p:cNvPr id="10" name="">
             <a:extLst xmlns:a="http://schemas.openxmlformats.org/drawingml/2006/main">
               <a:ext uri="{FF2B5EF4-FFF2-40B4-BE49-F238E27FC236}">
-                <a16:creationId xmlns:a16="http://schemas.microsoft.com/office/drawing/2014/main" id="{2EA1C638-718F-4A55-957B-ABC32A819497}"/>
+                <a16:creationId xmlns:a16="http://schemas.microsoft.com/office/drawing/2014/main" id="{7EDB3F9D-A96C-4109-98AA-D054F1C7E738}"/>
               </a:ext>
             </a:extLst>
           </p:cNvPr>
@@ -6266,7 +6266,7 @@
           <p:cNvPr id="11" name="footer-rule-12">
             <a:extLst xmlns:a="http://schemas.openxmlformats.org/drawingml/2006/main">
               <a:ext uri="{FF2B5EF4-FFF2-40B4-BE49-F238E27FC236}">
-                <a16:creationId xmlns:a16="http://schemas.microsoft.com/office/drawing/2014/main" id="{7CEAD7C1-6D73-4CBC-92A1-6AAAD18D1EC8}"/>
+                <a16:creationId xmlns:a16="http://schemas.microsoft.com/office/drawing/2014/main" id="{4CFF9040-45CA-4986-B94D-1AB3FE77339B}"/>
               </a:ext>
             </a:extLst>
           </p:cNvPr>
@@ -6297,7 +6297,7 @@
           <p:cNvPr id="12" name="footer-label-12">
             <a:extLst xmlns:a="http://schemas.openxmlformats.org/drawingml/2006/main">
               <a:ext uri="{FF2B5EF4-FFF2-40B4-BE49-F238E27FC236}">
-                <a16:creationId xmlns:a16="http://schemas.microsoft.com/office/drawing/2014/main" id="{FE2DD1E0-9314-47A0-83EC-16BC459BF833}"/>
+                <a16:creationId xmlns:a16="http://schemas.microsoft.com/office/drawing/2014/main" id="{6AD79874-FA2B-43A7-9222-BAB81FAF760E}"/>
               </a:ext>
             </a:extLst>
           </p:cNvPr>
@@ -6359,7 +6359,7 @@
           <p:cNvPr id="13" name="footer-page-12">
             <a:extLst xmlns:a="http://schemas.openxmlformats.org/drawingml/2006/main">
               <a:ext uri="{FF2B5EF4-FFF2-40B4-BE49-F238E27FC236}">
-                <a16:creationId xmlns:a16="http://schemas.microsoft.com/office/drawing/2014/main" id="{27A5E40B-F2F4-4404-AD8E-24C19B603FF2}"/>
+                <a16:creationId xmlns:a16="http://schemas.microsoft.com/office/drawing/2014/main" id="{B9A8F3A5-C5E1-4DE2-A577-0CB3D1EA195A}"/>
               </a:ext>
             </a:extLst>
           </p:cNvPr>
@@ -6419,7 +6419,7 @@
     </p:spTree>
     <p:extLst>
       <p:ext uri="{BB962C8B-B14F-4D97-AF65-F5344CB8AC3E}">
-        <p14:creationId xmlns:p14="http://schemas.microsoft.com/office/powerpoint/2010/main" val="1890508005"/>
+        <p14:creationId xmlns:p14="http://schemas.microsoft.com/office/powerpoint/2010/main" val="1669767877"/>
       </p:ext>
     </p:extLst>
   </p:cSld>
@@ -6450,7 +6450,7 @@
           <p:cNvPr id="25" name="side-accent-13">
             <a:extLst xmlns:a="http://schemas.openxmlformats.org/drawingml/2006/main">
               <a:ext uri="{FF2B5EF4-FFF2-40B4-BE49-F238E27FC236}">
-                <a16:creationId xmlns:a16="http://schemas.microsoft.com/office/drawing/2014/main" id="{6C1950B0-7A37-4EFE-85B4-9B4337EE0E90}"/>
+                <a16:creationId xmlns:a16="http://schemas.microsoft.com/office/drawing/2014/main" id="{AC0187DB-7B9F-4A50-9D18-E6C2E0090CD8}"/>
               </a:ext>
             </a:extLst>
           </p:cNvPr>
@@ -6481,7 +6481,7 @@
           <p:cNvPr id="2" name="kicker-13">
             <a:extLst xmlns:a="http://schemas.openxmlformats.org/drawingml/2006/main">
               <a:ext uri="{FF2B5EF4-FFF2-40B4-BE49-F238E27FC236}">
-                <a16:creationId xmlns:a16="http://schemas.microsoft.com/office/drawing/2014/main" id="{73D77D46-46B2-45BF-9729-D65AB78F65D4}"/>
+                <a16:creationId xmlns:a16="http://schemas.microsoft.com/office/drawing/2014/main" id="{3F1D89AE-ACAD-4F91-A51E-5435F7F2DA85}"/>
               </a:ext>
             </a:extLst>
           </p:cNvPr>
@@ -6543,7 +6543,7 @@
           <p:cNvPr id="3" name="title-13">
             <a:extLst xmlns:a="http://schemas.openxmlformats.org/drawingml/2006/main">
               <a:ext uri="{FF2B5EF4-FFF2-40B4-BE49-F238E27FC236}">
-                <a16:creationId xmlns:a16="http://schemas.microsoft.com/office/drawing/2014/main" id="{A3D2C004-F41A-4D8A-A8CA-D0E490542CE2}"/>
+                <a16:creationId xmlns:a16="http://schemas.microsoft.com/office/drawing/2014/main" id="{B393AF6D-F76C-4F5E-B0E5-AED1A1C596C8}"/>
               </a:ext>
             </a:extLst>
           </p:cNvPr>
@@ -6605,7 +6605,7 @@
           <p:cNvPr id="4" name="">
             <a:extLst xmlns:a="http://schemas.openxmlformats.org/drawingml/2006/main">
               <a:ext uri="{FF2B5EF4-FFF2-40B4-BE49-F238E27FC236}">
-                <a16:creationId xmlns:a16="http://schemas.microsoft.com/office/drawing/2014/main" id="{5DF8D4E8-79A4-4CBB-ADA0-103ED6B06E13}"/>
+                <a16:creationId xmlns:a16="http://schemas.microsoft.com/office/drawing/2014/main" id="{A6A40765-F10C-4C9E-9813-3B83D9AF910C}"/>
               </a:ext>
             </a:extLst>
           </p:cNvPr>
@@ -6636,7 +6636,7 @@
           <p:cNvPr id="5" name="">
             <a:extLst xmlns:a="http://schemas.openxmlformats.org/drawingml/2006/main">
               <a:ext uri="{FF2B5EF4-FFF2-40B4-BE49-F238E27FC236}">
-                <a16:creationId xmlns:a16="http://schemas.microsoft.com/office/drawing/2014/main" id="{67AE401F-680F-4DFD-89B5-0AB7725CF347}"/>
+                <a16:creationId xmlns:a16="http://schemas.microsoft.com/office/drawing/2014/main" id="{DA150BE0-5F08-495F-9175-D1372545A876}"/>
               </a:ext>
             </a:extLst>
           </p:cNvPr>
@@ -6667,7 +6667,7 @@
           <p:cNvPr id="6" name="">
             <a:extLst xmlns:a="http://schemas.openxmlformats.org/drawingml/2006/main">
               <a:ext uri="{FF2B5EF4-FFF2-40B4-BE49-F238E27FC236}">
-                <a16:creationId xmlns:a16="http://schemas.microsoft.com/office/drawing/2014/main" id="{BFE2864D-D4DE-4A61-80A3-756F1A4FBF59}"/>
+                <a16:creationId xmlns:a16="http://schemas.microsoft.com/office/drawing/2014/main" id="{94B1E5C5-AD94-4CE8-B04C-B972FC02BC77}"/>
               </a:ext>
             </a:extLst>
           </p:cNvPr>
@@ -6729,7 +6729,7 @@
           <p:cNvPr id="7" name="">
             <a:extLst xmlns:a="http://schemas.openxmlformats.org/drawingml/2006/main">
               <a:ext uri="{FF2B5EF4-FFF2-40B4-BE49-F238E27FC236}">
-                <a16:creationId xmlns:a16="http://schemas.microsoft.com/office/drawing/2014/main" id="{FA6EE86B-68C2-4C7C-8032-A81BB57B2EE7}"/>
+                <a16:creationId xmlns:a16="http://schemas.microsoft.com/office/drawing/2014/main" id="{4F7294BC-1F5A-4504-BFE7-9558A9919833}"/>
               </a:ext>
             </a:extLst>
           </p:cNvPr>
@@ -6791,7 +6791,7 @@
           <p:cNvPr id="8" name="">
             <a:extLst xmlns:a="http://schemas.openxmlformats.org/drawingml/2006/main">
               <a:ext uri="{FF2B5EF4-FFF2-40B4-BE49-F238E27FC236}">
-                <a16:creationId xmlns:a16="http://schemas.microsoft.com/office/drawing/2014/main" id="{120C5E9E-2660-458D-B8CB-D0E3BD3A6D5E}"/>
+                <a16:creationId xmlns:a16="http://schemas.microsoft.com/office/drawing/2014/main" id="{2DD18EFA-FFE4-4C9D-9C0F-B34DA618820E}"/>
               </a:ext>
             </a:extLst>
           </p:cNvPr>
@@ -6853,7 +6853,7 @@
           <p:cNvPr id="9" name="">
             <a:extLst xmlns:a="http://schemas.openxmlformats.org/drawingml/2006/main">
               <a:ext uri="{FF2B5EF4-FFF2-40B4-BE49-F238E27FC236}">
-                <a16:creationId xmlns:a16="http://schemas.microsoft.com/office/drawing/2014/main" id="{68EFE3DA-FED3-43C5-824B-AFCEDCCAFDA6}"/>
+                <a16:creationId xmlns:a16="http://schemas.microsoft.com/office/drawing/2014/main" id="{23A2FC34-A118-4F01-88ED-23545AD52454}"/>
               </a:ext>
             </a:extLst>
           </p:cNvPr>
@@ -6884,7 +6884,7 @@
           <p:cNvPr id="10" name="">
             <a:extLst xmlns:a="http://schemas.openxmlformats.org/drawingml/2006/main">
               <a:ext uri="{FF2B5EF4-FFF2-40B4-BE49-F238E27FC236}">
-                <a16:creationId xmlns:a16="http://schemas.microsoft.com/office/drawing/2014/main" id="{EEC5EB88-05F6-4A11-AF33-09B9E0E42004}"/>
+                <a16:creationId xmlns:a16="http://schemas.microsoft.com/office/drawing/2014/main" id="{41949CE9-78DE-4828-8145-3725D337F4D3}"/>
               </a:ext>
             </a:extLst>
           </p:cNvPr>
@@ -6946,7 +6946,7 @@
           <p:cNvPr id="11" name="">
             <a:extLst xmlns:a="http://schemas.openxmlformats.org/drawingml/2006/main">
               <a:ext uri="{FF2B5EF4-FFF2-40B4-BE49-F238E27FC236}">
-                <a16:creationId xmlns:a16="http://schemas.microsoft.com/office/drawing/2014/main" id="{766F4C29-B8E1-481B-9645-D90163533E6C}"/>
+                <a16:creationId xmlns:a16="http://schemas.microsoft.com/office/drawing/2014/main" id="{7A6FC464-7867-47A4-B7B8-3FF11D0FCE3D}"/>
               </a:ext>
             </a:extLst>
           </p:cNvPr>
@@ -7008,7 +7008,7 @@
           <p:cNvPr id="12" name="">
             <a:extLst xmlns:a="http://schemas.openxmlformats.org/drawingml/2006/main">
               <a:ext uri="{FF2B5EF4-FFF2-40B4-BE49-F238E27FC236}">
-                <a16:creationId xmlns:a16="http://schemas.microsoft.com/office/drawing/2014/main" id="{2F53037E-51B1-4E00-9AC2-AFFA6D6EA91F}"/>
+                <a16:creationId xmlns:a16="http://schemas.microsoft.com/office/drawing/2014/main" id="{A1A1BB88-F645-4605-8C64-ACC1004C4895}"/>
               </a:ext>
             </a:extLst>
           </p:cNvPr>
@@ -7070,7 +7070,7 @@
           <p:cNvPr id="13" name="">
             <a:extLst xmlns:a="http://schemas.openxmlformats.org/drawingml/2006/main">
               <a:ext uri="{FF2B5EF4-FFF2-40B4-BE49-F238E27FC236}">
-                <a16:creationId xmlns:a16="http://schemas.microsoft.com/office/drawing/2014/main" id="{418BA672-B335-4F04-854F-B04E56B4CCD0}"/>
+                <a16:creationId xmlns:a16="http://schemas.microsoft.com/office/drawing/2014/main" id="{2F9137BA-3A20-4319-8B47-C98031A679D1}"/>
               </a:ext>
             </a:extLst>
           </p:cNvPr>
@@ -7101,7 +7101,7 @@
           <p:cNvPr id="14" name="">
             <a:extLst xmlns:a="http://schemas.openxmlformats.org/drawingml/2006/main">
               <a:ext uri="{FF2B5EF4-FFF2-40B4-BE49-F238E27FC236}">
-                <a16:creationId xmlns:a16="http://schemas.microsoft.com/office/drawing/2014/main" id="{D2779D18-A1B4-46A6-A54D-592A6413AD67}"/>
+                <a16:creationId xmlns:a16="http://schemas.microsoft.com/office/drawing/2014/main" id="{0268E472-4ABF-497C-8903-F3E0AEE968B2}"/>
               </a:ext>
             </a:extLst>
           </p:cNvPr>
@@ -7163,7 +7163,7 @@
           <p:cNvPr id="15" name="">
             <a:extLst xmlns:a="http://schemas.openxmlformats.org/drawingml/2006/main">
               <a:ext uri="{FF2B5EF4-FFF2-40B4-BE49-F238E27FC236}">
-                <a16:creationId xmlns:a16="http://schemas.microsoft.com/office/drawing/2014/main" id="{FA108165-8438-4ACE-BA97-E14F05B763E7}"/>
+                <a16:creationId xmlns:a16="http://schemas.microsoft.com/office/drawing/2014/main" id="{1A4D6C14-2FB1-4CC9-B391-20B6CEA89A62}"/>
               </a:ext>
             </a:extLst>
           </p:cNvPr>
@@ -7225,7 +7225,7 @@
           <p:cNvPr id="16" name="">
             <a:extLst xmlns:a="http://schemas.openxmlformats.org/drawingml/2006/main">
               <a:ext uri="{FF2B5EF4-FFF2-40B4-BE49-F238E27FC236}">
-                <a16:creationId xmlns:a16="http://schemas.microsoft.com/office/drawing/2014/main" id="{9E9A3068-0A60-482C-9DA9-B9DAC70EA3BA}"/>
+                <a16:creationId xmlns:a16="http://schemas.microsoft.com/office/drawing/2014/main" id="{6971ADBC-B600-43C7-A1FC-4A94DF6E1CF0}"/>
               </a:ext>
             </a:extLst>
           </p:cNvPr>
@@ -7287,7 +7287,7 @@
           <p:cNvPr id="17" name="">
             <a:extLst xmlns:a="http://schemas.openxmlformats.org/drawingml/2006/main">
               <a:ext uri="{FF2B5EF4-FFF2-40B4-BE49-F238E27FC236}">
-                <a16:creationId xmlns:a16="http://schemas.microsoft.com/office/drawing/2014/main" id="{684603FC-EEF0-4B28-B9D9-184DDDD9A4EA}"/>
+                <a16:creationId xmlns:a16="http://schemas.microsoft.com/office/drawing/2014/main" id="{4D56C13C-12F1-4EF5-AD8F-86EF299F3346}"/>
               </a:ext>
             </a:extLst>
           </p:cNvPr>
@@ -7318,7 +7318,7 @@
           <p:cNvPr id="18" name="">
             <a:extLst xmlns:a="http://schemas.openxmlformats.org/drawingml/2006/main">
               <a:ext uri="{FF2B5EF4-FFF2-40B4-BE49-F238E27FC236}">
-                <a16:creationId xmlns:a16="http://schemas.microsoft.com/office/drawing/2014/main" id="{7B22277C-4762-407B-A5DC-935D63CFB537}"/>
+                <a16:creationId xmlns:a16="http://schemas.microsoft.com/office/drawing/2014/main" id="{B76ECC90-E52C-412E-B072-99D59627DFEC}"/>
               </a:ext>
             </a:extLst>
           </p:cNvPr>
@@ -7380,7 +7380,7 @@
           <p:cNvPr id="19" name="">
             <a:extLst xmlns:a="http://schemas.openxmlformats.org/drawingml/2006/main">
               <a:ext uri="{FF2B5EF4-FFF2-40B4-BE49-F238E27FC236}">
-                <a16:creationId xmlns:a16="http://schemas.microsoft.com/office/drawing/2014/main" id="{762D32AF-F8A8-4874-A4FD-4985023FB5E1}"/>
+                <a16:creationId xmlns:a16="http://schemas.microsoft.com/office/drawing/2014/main" id="{6A26B5FA-6A31-4CA8-9248-958B46C90407}"/>
               </a:ext>
             </a:extLst>
           </p:cNvPr>
@@ -7442,7 +7442,7 @@
           <p:cNvPr id="20" name="">
             <a:extLst xmlns:a="http://schemas.openxmlformats.org/drawingml/2006/main">
               <a:ext uri="{FF2B5EF4-FFF2-40B4-BE49-F238E27FC236}">
-                <a16:creationId xmlns:a16="http://schemas.microsoft.com/office/drawing/2014/main" id="{5DAD0949-07D6-4C47-BBD6-CDCFD996D416}"/>
+                <a16:creationId xmlns:a16="http://schemas.microsoft.com/office/drawing/2014/main" id="{C2F1D809-D49E-41B0-B21B-EE20E6D56283}"/>
               </a:ext>
             </a:extLst>
           </p:cNvPr>
@@ -7504,7 +7504,7 @@
           <p:cNvPr id="21" name="">
             <a:extLst xmlns:a="http://schemas.openxmlformats.org/drawingml/2006/main">
               <a:ext uri="{FF2B5EF4-FFF2-40B4-BE49-F238E27FC236}">
-                <a16:creationId xmlns:a16="http://schemas.microsoft.com/office/drawing/2014/main" id="{EA5F31B2-2C5E-4CEB-A6F2-EEDB8297C4CC}"/>
+                <a16:creationId xmlns:a16="http://schemas.microsoft.com/office/drawing/2014/main" id="{25D6B741-9DE2-4C36-941E-5E770015145C}"/>
               </a:ext>
             </a:extLst>
           </p:cNvPr>
@@ -7566,7 +7566,7 @@
           <p:cNvPr id="22" name="footer-rule-13">
             <a:extLst xmlns:a="http://schemas.openxmlformats.org/drawingml/2006/main">
               <a:ext uri="{FF2B5EF4-FFF2-40B4-BE49-F238E27FC236}">
-                <a16:creationId xmlns:a16="http://schemas.microsoft.com/office/drawing/2014/main" id="{BF8D7340-A1AD-4EBC-9973-0F90BE2ACAC8}"/>
+                <a16:creationId xmlns:a16="http://schemas.microsoft.com/office/drawing/2014/main" id="{F695B6C1-0AE7-4E7D-A80C-5C89039054C4}"/>
               </a:ext>
             </a:extLst>
           </p:cNvPr>
@@ -7597,7 +7597,7 @@
           <p:cNvPr id="23" name="footer-label-13">
             <a:extLst xmlns:a="http://schemas.openxmlformats.org/drawingml/2006/main">
               <a:ext uri="{FF2B5EF4-FFF2-40B4-BE49-F238E27FC236}">
-                <a16:creationId xmlns:a16="http://schemas.microsoft.com/office/drawing/2014/main" id="{78066F77-A11F-43E1-9BE0-9B05094F5BFB}"/>
+                <a16:creationId xmlns:a16="http://schemas.microsoft.com/office/drawing/2014/main" id="{484F9DE7-7639-4C2F-ABAA-26E1092724A8}"/>
               </a:ext>
             </a:extLst>
           </p:cNvPr>
@@ -7659,7 +7659,7 @@
           <p:cNvPr id="24" name="footer-page-13">
             <a:extLst xmlns:a="http://schemas.openxmlformats.org/drawingml/2006/main">
               <a:ext uri="{FF2B5EF4-FFF2-40B4-BE49-F238E27FC236}">
-                <a16:creationId xmlns:a16="http://schemas.microsoft.com/office/drawing/2014/main" id="{2095CA90-40DD-44C8-93A7-1F5E8360B22D}"/>
+                <a16:creationId xmlns:a16="http://schemas.microsoft.com/office/drawing/2014/main" id="{E4DAC4D3-2D97-4B33-A32B-FA1677B45B50}"/>
               </a:ext>
             </a:extLst>
           </p:cNvPr>
@@ -7719,7 +7719,7 @@
     </p:spTree>
     <p:extLst>
       <p:ext uri="{BB962C8B-B14F-4D97-AF65-F5344CB8AC3E}">
-        <p14:creationId xmlns:p14="http://schemas.microsoft.com/office/powerpoint/2010/main" val="961682666"/>
+        <p14:creationId xmlns:p14="http://schemas.microsoft.com/office/powerpoint/2010/main" val="35330864"/>
       </p:ext>
     </p:extLst>
   </p:cSld>
@@ -7750,7 +7750,7 @@
           <p:cNvPr id="24" name="side-accent-14">
             <a:extLst xmlns:a="http://schemas.openxmlformats.org/drawingml/2006/main">
               <a:ext uri="{FF2B5EF4-FFF2-40B4-BE49-F238E27FC236}">
-                <a16:creationId xmlns:a16="http://schemas.microsoft.com/office/drawing/2014/main" id="{FD0DDA3D-F2B3-4169-8ADC-AF3A4524C4FF}"/>
+                <a16:creationId xmlns:a16="http://schemas.microsoft.com/office/drawing/2014/main" id="{5CAF681E-7A94-4325-9862-3A640C3A2937}"/>
               </a:ext>
             </a:extLst>
           </p:cNvPr>
@@ -7781,7 +7781,7 @@
           <p:cNvPr id="2" name="kicker-14">
             <a:extLst xmlns:a="http://schemas.openxmlformats.org/drawingml/2006/main">
               <a:ext uri="{FF2B5EF4-FFF2-40B4-BE49-F238E27FC236}">
-                <a16:creationId xmlns:a16="http://schemas.microsoft.com/office/drawing/2014/main" id="{3B79C55C-53AB-48A8-9727-4C9A5E2F9798}"/>
+                <a16:creationId xmlns:a16="http://schemas.microsoft.com/office/drawing/2014/main" id="{EAA6E2F7-0B78-4A3E-93FA-9D9F5C58035D}"/>
               </a:ext>
             </a:extLst>
           </p:cNvPr>
@@ -7843,7 +7843,7 @@
           <p:cNvPr id="3" name="title-14">
             <a:extLst xmlns:a="http://schemas.openxmlformats.org/drawingml/2006/main">
               <a:ext uri="{FF2B5EF4-FFF2-40B4-BE49-F238E27FC236}">
-                <a16:creationId xmlns:a16="http://schemas.microsoft.com/office/drawing/2014/main" id="{F8C661A0-7141-4235-9582-934D4672036C}"/>
+                <a16:creationId xmlns:a16="http://schemas.microsoft.com/office/drawing/2014/main" id="{26ADA42C-4514-42BF-93AB-937AAEC6001D}"/>
               </a:ext>
             </a:extLst>
           </p:cNvPr>
@@ -7905,7 +7905,7 @@
           <p:cNvPr id="4" name="">
             <a:extLst xmlns:a="http://schemas.openxmlformats.org/drawingml/2006/main">
               <a:ext uri="{FF2B5EF4-FFF2-40B4-BE49-F238E27FC236}">
-                <a16:creationId xmlns:a16="http://schemas.microsoft.com/office/drawing/2014/main" id="{B625F9D0-2A91-4A3D-81F5-039747EFC114}"/>
+                <a16:creationId xmlns:a16="http://schemas.microsoft.com/office/drawing/2014/main" id="{25F45A5E-F383-48C0-8CE9-AB3ACAB81708}"/>
               </a:ext>
             </a:extLst>
           </p:cNvPr>
@@ -7967,7 +7967,7 @@
           <p:cNvPr id="5" name="">
             <a:extLst xmlns:a="http://schemas.openxmlformats.org/drawingml/2006/main">
               <a:ext uri="{FF2B5EF4-FFF2-40B4-BE49-F238E27FC236}">
-                <a16:creationId xmlns:a16="http://schemas.microsoft.com/office/drawing/2014/main" id="{73045362-426C-4637-931E-F1E7FCE751A8}"/>
+                <a16:creationId xmlns:a16="http://schemas.microsoft.com/office/drawing/2014/main" id="{AB3DA1BE-86E8-40C4-A50A-7FE834B45156}"/>
               </a:ext>
             </a:extLst>
           </p:cNvPr>
@@ -8029,7 +8029,7 @@
           <p:cNvPr id="6" name="">
             <a:extLst xmlns:a="http://schemas.openxmlformats.org/drawingml/2006/main">
               <a:ext uri="{FF2B5EF4-FFF2-40B4-BE49-F238E27FC236}">
-                <a16:creationId xmlns:a16="http://schemas.microsoft.com/office/drawing/2014/main" id="{856491B0-DA6D-4D49-BADC-BF4E3A2A95FF}"/>
+                <a16:creationId xmlns:a16="http://schemas.microsoft.com/office/drawing/2014/main" id="{C8692C11-7EC1-419D-961A-AFB805D31C48}"/>
               </a:ext>
             </a:extLst>
           </p:cNvPr>
@@ -8091,7 +8091,7 @@
           <p:cNvPr id="7" name="">
             <a:extLst xmlns:a="http://schemas.openxmlformats.org/drawingml/2006/main">
               <a:ext uri="{FF2B5EF4-FFF2-40B4-BE49-F238E27FC236}">
-                <a16:creationId xmlns:a16="http://schemas.microsoft.com/office/drawing/2014/main" id="{A4DE3E18-7328-483F-88B8-BC2885322405}"/>
+                <a16:creationId xmlns:a16="http://schemas.microsoft.com/office/drawing/2014/main" id="{C560D9E4-0DE3-4AD2-A662-79C1FA9BC4A9}"/>
               </a:ext>
             </a:extLst>
           </p:cNvPr>
@@ -8122,7 +8122,7 @@
           <p:cNvPr id="8" name="">
             <a:extLst xmlns:a="http://schemas.openxmlformats.org/drawingml/2006/main">
               <a:ext uri="{FF2B5EF4-FFF2-40B4-BE49-F238E27FC236}">
-                <a16:creationId xmlns:a16="http://schemas.microsoft.com/office/drawing/2014/main" id="{A20F2879-BB52-424F-BA64-A9BEEFF6157D}"/>
+                <a16:creationId xmlns:a16="http://schemas.microsoft.com/office/drawing/2014/main" id="{F935DED7-B3D7-46E2-AFCB-F0736A057E1C}"/>
               </a:ext>
             </a:extLst>
           </p:cNvPr>
@@ -8184,7 +8184,7 @@
           <p:cNvPr id="9" name="">
             <a:extLst xmlns:a="http://schemas.openxmlformats.org/drawingml/2006/main">
               <a:ext uri="{FF2B5EF4-FFF2-40B4-BE49-F238E27FC236}">
-                <a16:creationId xmlns:a16="http://schemas.microsoft.com/office/drawing/2014/main" id="{7E6EA6A2-1E3E-4133-8E2B-A4E8A2C71D99}"/>
+                <a16:creationId xmlns:a16="http://schemas.microsoft.com/office/drawing/2014/main" id="{BD5FC1A4-7369-466E-A27C-4F57FB182073}"/>
               </a:ext>
             </a:extLst>
           </p:cNvPr>
@@ -8246,7 +8246,7 @@
           <p:cNvPr id="10" name="">
             <a:extLst xmlns:a="http://schemas.openxmlformats.org/drawingml/2006/main">
               <a:ext uri="{FF2B5EF4-FFF2-40B4-BE49-F238E27FC236}">
-                <a16:creationId xmlns:a16="http://schemas.microsoft.com/office/drawing/2014/main" id="{EA66181B-B766-4688-AC8D-A9B78CEB9B0A}"/>
+                <a16:creationId xmlns:a16="http://schemas.microsoft.com/office/drawing/2014/main" id="{0EEEB38C-C5E1-475D-9D40-45458C75B9A5}"/>
               </a:ext>
             </a:extLst>
           </p:cNvPr>
@@ -8308,7 +8308,7 @@
           <p:cNvPr id="11" name="">
             <a:extLst xmlns:a="http://schemas.openxmlformats.org/drawingml/2006/main">
               <a:ext uri="{FF2B5EF4-FFF2-40B4-BE49-F238E27FC236}">
-                <a16:creationId xmlns:a16="http://schemas.microsoft.com/office/drawing/2014/main" id="{EA8928FD-AA68-495A-9C3F-535380555A34}"/>
+                <a16:creationId xmlns:a16="http://schemas.microsoft.com/office/drawing/2014/main" id="{F065CCAA-B565-4515-ACE5-82260FA89642}"/>
               </a:ext>
             </a:extLst>
           </p:cNvPr>
@@ -8339,7 +8339,7 @@
           <p:cNvPr id="12" name="">
             <a:extLst xmlns:a="http://schemas.openxmlformats.org/drawingml/2006/main">
               <a:ext uri="{FF2B5EF4-FFF2-40B4-BE49-F238E27FC236}">
-                <a16:creationId xmlns:a16="http://schemas.microsoft.com/office/drawing/2014/main" id="{A30D5565-38DA-4BBB-AA4D-A419C7AA7E73}"/>
+                <a16:creationId xmlns:a16="http://schemas.microsoft.com/office/drawing/2014/main" id="{31D4C0D7-CFB3-4526-BE33-D56CEF0FFB58}"/>
               </a:ext>
             </a:extLst>
           </p:cNvPr>
@@ -8401,7 +8401,7 @@
           <p:cNvPr id="13" name="">
             <a:extLst xmlns:a="http://schemas.openxmlformats.org/drawingml/2006/main">
               <a:ext uri="{FF2B5EF4-FFF2-40B4-BE49-F238E27FC236}">
-                <a16:creationId xmlns:a16="http://schemas.microsoft.com/office/drawing/2014/main" id="{BB8B4116-1133-42DD-934C-8B4E0C1E7F15}"/>
+                <a16:creationId xmlns:a16="http://schemas.microsoft.com/office/drawing/2014/main" id="{D6C8B293-45A5-4EA4-96AA-9110149BC860}"/>
               </a:ext>
             </a:extLst>
           </p:cNvPr>
@@ -8463,7 +8463,7 @@
           <p:cNvPr id="14" name="">
             <a:extLst xmlns:a="http://schemas.openxmlformats.org/drawingml/2006/main">
               <a:ext uri="{FF2B5EF4-FFF2-40B4-BE49-F238E27FC236}">
-                <a16:creationId xmlns:a16="http://schemas.microsoft.com/office/drawing/2014/main" id="{41643A6F-9F98-414D-BE89-6E4D77723B1C}"/>
+                <a16:creationId xmlns:a16="http://schemas.microsoft.com/office/drawing/2014/main" id="{F04983B2-BAD1-4108-8A93-566791E05AE6}"/>
               </a:ext>
             </a:extLst>
           </p:cNvPr>
@@ -8525,7 +8525,7 @@
           <p:cNvPr id="15" name="">
             <a:extLst xmlns:a="http://schemas.openxmlformats.org/drawingml/2006/main">
               <a:ext uri="{FF2B5EF4-FFF2-40B4-BE49-F238E27FC236}">
-                <a16:creationId xmlns:a16="http://schemas.microsoft.com/office/drawing/2014/main" id="{3B070B0B-1DD5-4637-B526-126449756912}"/>
+                <a16:creationId xmlns:a16="http://schemas.microsoft.com/office/drawing/2014/main" id="{CCFF5D61-165E-4134-A2F0-AA98576A762A}"/>
               </a:ext>
             </a:extLst>
           </p:cNvPr>
@@ -8556,7 +8556,7 @@
           <p:cNvPr id="16" name="">
             <a:extLst xmlns:a="http://schemas.openxmlformats.org/drawingml/2006/main">
               <a:ext uri="{FF2B5EF4-FFF2-40B4-BE49-F238E27FC236}">
-                <a16:creationId xmlns:a16="http://schemas.microsoft.com/office/drawing/2014/main" id="{E847B969-6BDC-4CFC-9358-1524FE263FB4}"/>
+                <a16:creationId xmlns:a16="http://schemas.microsoft.com/office/drawing/2014/main" id="{D9293EF3-00CA-4D67-BF90-2C62298D5D25}"/>
               </a:ext>
             </a:extLst>
           </p:cNvPr>
@@ -8618,7 +8618,7 @@
           <p:cNvPr id="17" name="">
             <a:extLst xmlns:a="http://schemas.openxmlformats.org/drawingml/2006/main">
               <a:ext uri="{FF2B5EF4-FFF2-40B4-BE49-F238E27FC236}">
-                <a16:creationId xmlns:a16="http://schemas.microsoft.com/office/drawing/2014/main" id="{1FCA3740-CA25-4C4B-8F3D-21BA6BA17D06}"/>
+                <a16:creationId xmlns:a16="http://schemas.microsoft.com/office/drawing/2014/main" id="{E6D72638-68E1-42ED-90DC-DC2C5B112281}"/>
               </a:ext>
             </a:extLst>
           </p:cNvPr>
@@ -8680,7 +8680,7 @@
           <p:cNvPr id="18" name="">
             <a:extLst xmlns:a="http://schemas.openxmlformats.org/drawingml/2006/main">
               <a:ext uri="{FF2B5EF4-FFF2-40B4-BE49-F238E27FC236}">
-                <a16:creationId xmlns:a16="http://schemas.microsoft.com/office/drawing/2014/main" id="{FC67848B-274C-4D14-BDC5-0C7A2FA4EFF0}"/>
+                <a16:creationId xmlns:a16="http://schemas.microsoft.com/office/drawing/2014/main" id="{F7B1BBFE-7789-47A4-AF84-877B8ADD8DC1}"/>
               </a:ext>
             </a:extLst>
           </p:cNvPr>
@@ -8742,7 +8742,7 @@
           <p:cNvPr id="19" name="">
             <a:extLst xmlns:a="http://schemas.openxmlformats.org/drawingml/2006/main">
               <a:ext uri="{FF2B5EF4-FFF2-40B4-BE49-F238E27FC236}">
-                <a16:creationId xmlns:a16="http://schemas.microsoft.com/office/drawing/2014/main" id="{AB140C6C-BA06-49B7-BF32-FD0CA7F75DD6}"/>
+                <a16:creationId xmlns:a16="http://schemas.microsoft.com/office/drawing/2014/main" id="{2D92D0F2-BCE6-4B5D-8CB3-540C6E13AF9B}"/>
               </a:ext>
             </a:extLst>
           </p:cNvPr>
@@ -8775,7 +8775,7 @@
           <p:cNvPr id="20" name="">
             <a:extLst xmlns:a="http://schemas.openxmlformats.org/drawingml/2006/main">
               <a:ext uri="{FF2B5EF4-FFF2-40B4-BE49-F238E27FC236}">
-                <a16:creationId xmlns:a16="http://schemas.microsoft.com/office/drawing/2014/main" id="{0F701F47-EA7E-4C0E-90FD-764520DCD34D}"/>
+                <a16:creationId xmlns:a16="http://schemas.microsoft.com/office/drawing/2014/main" id="{533BE162-58D0-4C8F-AC85-B2446BD9C6D5}"/>
               </a:ext>
             </a:extLst>
           </p:cNvPr>
@@ -8837,7 +8837,7 @@
           <p:cNvPr id="21" name="footer-rule-14">
             <a:extLst xmlns:a="http://schemas.openxmlformats.org/drawingml/2006/main">
               <a:ext uri="{FF2B5EF4-FFF2-40B4-BE49-F238E27FC236}">
-                <a16:creationId xmlns:a16="http://schemas.microsoft.com/office/drawing/2014/main" id="{EF0BF6AE-7028-4DC8-909C-B3C685C65828}"/>
+                <a16:creationId xmlns:a16="http://schemas.microsoft.com/office/drawing/2014/main" id="{40AD2B26-4FD6-47B3-AFC4-8AB59555785D}"/>
               </a:ext>
             </a:extLst>
           </p:cNvPr>
@@ -8868,7 +8868,7 @@
           <p:cNvPr id="22" name="footer-label-14">
             <a:extLst xmlns:a="http://schemas.openxmlformats.org/drawingml/2006/main">
               <a:ext uri="{FF2B5EF4-FFF2-40B4-BE49-F238E27FC236}">
-                <a16:creationId xmlns:a16="http://schemas.microsoft.com/office/drawing/2014/main" id="{DEFAB2B6-6439-4974-BD57-9332CCC9A724}"/>
+                <a16:creationId xmlns:a16="http://schemas.microsoft.com/office/drawing/2014/main" id="{5DF11258-0A42-4D3D-AD90-36E13ACCF82E}"/>
               </a:ext>
             </a:extLst>
           </p:cNvPr>
@@ -8930,7 +8930,7 @@
           <p:cNvPr id="23" name="footer-page-14">
             <a:extLst xmlns:a="http://schemas.openxmlformats.org/drawingml/2006/main">
               <a:ext uri="{FF2B5EF4-FFF2-40B4-BE49-F238E27FC236}">
-                <a16:creationId xmlns:a16="http://schemas.microsoft.com/office/drawing/2014/main" id="{2BC54362-552F-4CB4-B9D0-76FD3303F08F}"/>
+                <a16:creationId xmlns:a16="http://schemas.microsoft.com/office/drawing/2014/main" id="{1DC121E5-0D09-400F-846F-32338C89A620}"/>
               </a:ext>
             </a:extLst>
           </p:cNvPr>
@@ -8990,7 +8990,7 @@
     </p:spTree>
     <p:extLst>
       <p:ext uri="{BB962C8B-B14F-4D97-AF65-F5344CB8AC3E}">
-        <p14:creationId xmlns:p14="http://schemas.microsoft.com/office/powerpoint/2010/main" val="1469562172"/>
+        <p14:creationId xmlns:p14="http://schemas.microsoft.com/office/powerpoint/2010/main" val="1296421465"/>
       </p:ext>
     </p:extLst>
   </p:cSld>
@@ -9021,7 +9021,7 @@
           <p:cNvPr id="21" name="side-accent-15">
             <a:extLst xmlns:a="http://schemas.openxmlformats.org/drawingml/2006/main">
               <a:ext uri="{FF2B5EF4-FFF2-40B4-BE49-F238E27FC236}">
-                <a16:creationId xmlns:a16="http://schemas.microsoft.com/office/drawing/2014/main" id="{B665A6A1-5CE6-44B9-8B63-BCB7A6BA96DB}"/>
+                <a16:creationId xmlns:a16="http://schemas.microsoft.com/office/drawing/2014/main" id="{2B2C8978-F7A6-45B5-B1F9-A0ADE0225F96}"/>
               </a:ext>
             </a:extLst>
           </p:cNvPr>
@@ -9052,7 +9052,7 @@
           <p:cNvPr id="2" name="kicker-15">
             <a:extLst xmlns:a="http://schemas.openxmlformats.org/drawingml/2006/main">
               <a:ext uri="{FF2B5EF4-FFF2-40B4-BE49-F238E27FC236}">
-                <a16:creationId xmlns:a16="http://schemas.microsoft.com/office/drawing/2014/main" id="{8752682D-0280-4844-9884-C1263317B005}"/>
+                <a16:creationId xmlns:a16="http://schemas.microsoft.com/office/drawing/2014/main" id="{490F830F-46FF-45A4-BF83-501A7A59BBAE}"/>
               </a:ext>
             </a:extLst>
           </p:cNvPr>
@@ -9114,7 +9114,7 @@
           <p:cNvPr id="3" name="title-15">
             <a:extLst xmlns:a="http://schemas.openxmlformats.org/drawingml/2006/main">
               <a:ext uri="{FF2B5EF4-FFF2-40B4-BE49-F238E27FC236}">
-                <a16:creationId xmlns:a16="http://schemas.microsoft.com/office/drawing/2014/main" id="{A70D4B35-3ABD-4BF5-A1BF-2A7A043B1D15}"/>
+                <a16:creationId xmlns:a16="http://schemas.microsoft.com/office/drawing/2014/main" id="{809E0F1B-1AA5-4965-9111-7D8ED2E75FBC}"/>
               </a:ext>
             </a:extLst>
           </p:cNvPr>
@@ -9176,7 +9176,7 @@
           <p:cNvPr id="4" name="">
             <a:extLst xmlns:a="http://schemas.openxmlformats.org/drawingml/2006/main">
               <a:ext uri="{FF2B5EF4-FFF2-40B4-BE49-F238E27FC236}">
-                <a16:creationId xmlns:a16="http://schemas.microsoft.com/office/drawing/2014/main" id="{E78C6202-4EF5-43D4-BB1B-D6AC75642848}"/>
+                <a16:creationId xmlns:a16="http://schemas.microsoft.com/office/drawing/2014/main" id="{0B9F08C4-1AAE-4F22-A8B3-0396E95B3F84}"/>
               </a:ext>
             </a:extLst>
           </p:cNvPr>
@@ -9207,7 +9207,7 @@
           <p:cNvPr id="5" name="">
             <a:extLst xmlns:a="http://schemas.openxmlformats.org/drawingml/2006/main">
               <a:ext uri="{FF2B5EF4-FFF2-40B4-BE49-F238E27FC236}">
-                <a16:creationId xmlns:a16="http://schemas.microsoft.com/office/drawing/2014/main" id="{6871DD30-05A0-47E2-9908-C04103D7A944}"/>
+                <a16:creationId xmlns:a16="http://schemas.microsoft.com/office/drawing/2014/main" id="{BFC8198D-F8E2-431D-8239-5B5608060FCF}"/>
               </a:ext>
             </a:extLst>
           </p:cNvPr>
@@ -9238,7 +9238,7 @@
           <p:cNvPr id="6" name="">
             <a:extLst xmlns:a="http://schemas.openxmlformats.org/drawingml/2006/main">
               <a:ext uri="{FF2B5EF4-FFF2-40B4-BE49-F238E27FC236}">
-                <a16:creationId xmlns:a16="http://schemas.microsoft.com/office/drawing/2014/main" id="{7D99A2FF-A610-48AA-9F73-B29D7E3ED643}"/>
+                <a16:creationId xmlns:a16="http://schemas.microsoft.com/office/drawing/2014/main" id="{2B9C6965-E199-42AE-AE64-0F5D3CEC982D}"/>
               </a:ext>
             </a:extLst>
           </p:cNvPr>
@@ -9300,7 +9300,7 @@
           <p:cNvPr id="7" name="">
             <a:extLst xmlns:a="http://schemas.openxmlformats.org/drawingml/2006/main">
               <a:ext uri="{FF2B5EF4-FFF2-40B4-BE49-F238E27FC236}">
-                <a16:creationId xmlns:a16="http://schemas.microsoft.com/office/drawing/2014/main" id="{9320F350-B39F-48A9-B6EF-76AD16072ABF}"/>
+                <a16:creationId xmlns:a16="http://schemas.microsoft.com/office/drawing/2014/main" id="{E34DDFF1-FC54-4C8F-8CE3-95C5D98048AA}"/>
               </a:ext>
             </a:extLst>
           </p:cNvPr>
@@ -9362,7 +9362,7 @@
           <p:cNvPr id="8" name="">
             <a:extLst xmlns:a="http://schemas.openxmlformats.org/drawingml/2006/main">
               <a:ext uri="{FF2B5EF4-FFF2-40B4-BE49-F238E27FC236}">
-                <a16:creationId xmlns:a16="http://schemas.microsoft.com/office/drawing/2014/main" id="{692A4C51-6F82-4AF2-95D2-A88342938D9B}"/>
+                <a16:creationId xmlns:a16="http://schemas.microsoft.com/office/drawing/2014/main" id="{51509D11-55EF-44B1-B189-CE99D0650694}"/>
               </a:ext>
             </a:extLst>
           </p:cNvPr>
@@ -9424,7 +9424,7 @@
           <p:cNvPr id="9" name="">
             <a:extLst xmlns:a="http://schemas.openxmlformats.org/drawingml/2006/main">
               <a:ext uri="{FF2B5EF4-FFF2-40B4-BE49-F238E27FC236}">
-                <a16:creationId xmlns:a16="http://schemas.microsoft.com/office/drawing/2014/main" id="{B2BE5B80-0E1C-4039-B64A-C7336FD7F122}"/>
+                <a16:creationId xmlns:a16="http://schemas.microsoft.com/office/drawing/2014/main" id="{B8BBA993-2CD2-477D-A22A-BD1581DBCE03}"/>
               </a:ext>
             </a:extLst>
           </p:cNvPr>
@@ -9455,7 +9455,7 @@
           <p:cNvPr id="10" name="">
             <a:extLst xmlns:a="http://schemas.openxmlformats.org/drawingml/2006/main">
               <a:ext uri="{FF2B5EF4-FFF2-40B4-BE49-F238E27FC236}">
-                <a16:creationId xmlns:a16="http://schemas.microsoft.com/office/drawing/2014/main" id="{18B1BA9A-FA14-4171-86CF-D90CBE29942A}"/>
+                <a16:creationId xmlns:a16="http://schemas.microsoft.com/office/drawing/2014/main" id="{D9DBF50F-48CA-464C-95E1-47CDAC0E638C}"/>
               </a:ext>
             </a:extLst>
           </p:cNvPr>
@@ -9517,7 +9517,7 @@
           <p:cNvPr id="11" name="">
             <a:extLst xmlns:a="http://schemas.openxmlformats.org/drawingml/2006/main">
               <a:ext uri="{FF2B5EF4-FFF2-40B4-BE49-F238E27FC236}">
-                <a16:creationId xmlns:a16="http://schemas.microsoft.com/office/drawing/2014/main" id="{3CCDCDBD-E6A2-4285-B5B0-91C81A61B61D}"/>
+                <a16:creationId xmlns:a16="http://schemas.microsoft.com/office/drawing/2014/main" id="{611234C6-F492-492F-854F-D3436E274777}"/>
               </a:ext>
             </a:extLst>
           </p:cNvPr>
@@ -9579,7 +9579,7 @@
           <p:cNvPr id="12" name="">
             <a:extLst xmlns:a="http://schemas.openxmlformats.org/drawingml/2006/main">
               <a:ext uri="{FF2B5EF4-FFF2-40B4-BE49-F238E27FC236}">
-                <a16:creationId xmlns:a16="http://schemas.microsoft.com/office/drawing/2014/main" id="{CD3CFCEC-6F5F-4AE1-9D8B-95F0063F379A}"/>
+                <a16:creationId xmlns:a16="http://schemas.microsoft.com/office/drawing/2014/main" id="{D6DE0CDC-EDC7-41DF-BACF-B4D7A5B2B9B3}"/>
               </a:ext>
             </a:extLst>
           </p:cNvPr>
@@ -9641,7 +9641,7 @@
           <p:cNvPr id="13" name="">
             <a:extLst xmlns:a="http://schemas.openxmlformats.org/drawingml/2006/main">
               <a:ext uri="{FF2B5EF4-FFF2-40B4-BE49-F238E27FC236}">
-                <a16:creationId xmlns:a16="http://schemas.microsoft.com/office/drawing/2014/main" id="{770FD511-65FF-4284-A9C6-C78DB91FE6D7}"/>
+                <a16:creationId xmlns:a16="http://schemas.microsoft.com/office/drawing/2014/main" id="{E45C73C3-D359-4281-B993-A32187CD1FC0}"/>
               </a:ext>
             </a:extLst>
           </p:cNvPr>
@@ -9672,7 +9672,7 @@
           <p:cNvPr id="14" name="">
             <a:extLst xmlns:a="http://schemas.openxmlformats.org/drawingml/2006/main">
               <a:ext uri="{FF2B5EF4-FFF2-40B4-BE49-F238E27FC236}">
-                <a16:creationId xmlns:a16="http://schemas.microsoft.com/office/drawing/2014/main" id="{34E0218C-D6BF-4EDB-9DAA-E24A626878C9}"/>
+                <a16:creationId xmlns:a16="http://schemas.microsoft.com/office/drawing/2014/main" id="{25F8BE8C-A99A-458B-ACC8-0283FA64CE26}"/>
               </a:ext>
             </a:extLst>
           </p:cNvPr>
@@ -9734,7 +9734,7 @@
           <p:cNvPr id="15" name="">
             <a:extLst xmlns:a="http://schemas.openxmlformats.org/drawingml/2006/main">
               <a:ext uri="{FF2B5EF4-FFF2-40B4-BE49-F238E27FC236}">
-                <a16:creationId xmlns:a16="http://schemas.microsoft.com/office/drawing/2014/main" id="{630F18EF-348E-4EFD-940D-9AB36147F20D}"/>
+                <a16:creationId xmlns:a16="http://schemas.microsoft.com/office/drawing/2014/main" id="{81495BE5-FAA9-495E-81AC-77C162D503B2}"/>
               </a:ext>
             </a:extLst>
           </p:cNvPr>
@@ -9796,7 +9796,7 @@
           <p:cNvPr id="16" name="">
             <a:extLst xmlns:a="http://schemas.openxmlformats.org/drawingml/2006/main">
               <a:ext uri="{FF2B5EF4-FFF2-40B4-BE49-F238E27FC236}">
-                <a16:creationId xmlns:a16="http://schemas.microsoft.com/office/drawing/2014/main" id="{591A32B4-D3E4-4E53-B035-861C41A88B17}"/>
+                <a16:creationId xmlns:a16="http://schemas.microsoft.com/office/drawing/2014/main" id="{237AD098-F5CF-43F2-B26E-DE8F2263D0FC}"/>
               </a:ext>
             </a:extLst>
           </p:cNvPr>
@@ -9858,7 +9858,7 @@
           <p:cNvPr id="17" name="">
             <a:extLst xmlns:a="http://schemas.openxmlformats.org/drawingml/2006/main">
               <a:ext uri="{FF2B5EF4-FFF2-40B4-BE49-F238E27FC236}">
-                <a16:creationId xmlns:a16="http://schemas.microsoft.com/office/drawing/2014/main" id="{433B9A5E-6A47-465B-B43F-638D00CE56AA}"/>
+                <a16:creationId xmlns:a16="http://schemas.microsoft.com/office/drawing/2014/main" id="{F418769C-5952-40F8-8E31-5268204E941F}"/>
               </a:ext>
             </a:extLst>
           </p:cNvPr>
@@ -9920,7 +9920,7 @@
           <p:cNvPr id="18" name="footer-rule-15">
             <a:extLst xmlns:a="http://schemas.openxmlformats.org/drawingml/2006/main">
               <a:ext uri="{FF2B5EF4-FFF2-40B4-BE49-F238E27FC236}">
-                <a16:creationId xmlns:a16="http://schemas.microsoft.com/office/drawing/2014/main" id="{EC8C07B2-195A-4063-9538-2A6CD9E05F24}"/>
+                <a16:creationId xmlns:a16="http://schemas.microsoft.com/office/drawing/2014/main" id="{1E386E32-D8F8-4C82-B4A9-846276A3E079}"/>
               </a:ext>
             </a:extLst>
           </p:cNvPr>
@@ -9951,7 +9951,7 @@
           <p:cNvPr id="19" name="footer-label-15">
             <a:extLst xmlns:a="http://schemas.openxmlformats.org/drawingml/2006/main">
               <a:ext uri="{FF2B5EF4-FFF2-40B4-BE49-F238E27FC236}">
-                <a16:creationId xmlns:a16="http://schemas.microsoft.com/office/drawing/2014/main" id="{4D95CEEC-2495-4CD0-B1C1-4E02B38815E5}"/>
+                <a16:creationId xmlns:a16="http://schemas.microsoft.com/office/drawing/2014/main" id="{4AA8B687-7012-48CB-9175-C26B5DD38AC0}"/>
               </a:ext>
             </a:extLst>
           </p:cNvPr>
@@ -10013,7 +10013,7 @@
           <p:cNvPr id="20" name="footer-page-15">
             <a:extLst xmlns:a="http://schemas.openxmlformats.org/drawingml/2006/main">
               <a:ext uri="{FF2B5EF4-FFF2-40B4-BE49-F238E27FC236}">
-                <a16:creationId xmlns:a16="http://schemas.microsoft.com/office/drawing/2014/main" id="{51BAEA40-0D46-4139-9274-CFF0D12D67D1}"/>
+                <a16:creationId xmlns:a16="http://schemas.microsoft.com/office/drawing/2014/main" id="{E67EB628-93AE-44B6-8DCB-4BE9C01283C6}"/>
               </a:ext>
             </a:extLst>
           </p:cNvPr>
@@ -10073,7 +10073,7 @@
     </p:spTree>
     <p:extLst>
       <p:ext uri="{BB962C8B-B14F-4D97-AF65-F5344CB8AC3E}">
-        <p14:creationId xmlns:p14="http://schemas.microsoft.com/office/powerpoint/2010/main" val="593227930"/>
+        <p14:creationId xmlns:p14="http://schemas.microsoft.com/office/powerpoint/2010/main" val="1439225652"/>
       </p:ext>
     </p:extLst>
   </p:cSld>
@@ -10104,7 +10104,7 @@
           <p:cNvPr id="11" name="">
             <a:extLst xmlns:a="http://schemas.openxmlformats.org/drawingml/2006/main">
               <a:ext uri="{FF2B5EF4-FFF2-40B4-BE49-F238E27FC236}">
-                <a16:creationId xmlns:a16="http://schemas.microsoft.com/office/drawing/2014/main" id="{26D30274-151C-4034-8E0C-5C4252321811}"/>
+                <a16:creationId xmlns:a16="http://schemas.microsoft.com/office/drawing/2014/main" id="{330829C5-F181-4A87-B1D8-3A03E6AB62E4}"/>
               </a:ext>
             </a:extLst>
           </p:cNvPr>
@@ -10135,7 +10135,7 @@
           <p:cNvPr id="2" name="">
             <a:extLst xmlns:a="http://schemas.openxmlformats.org/drawingml/2006/main">
               <a:ext uri="{FF2B5EF4-FFF2-40B4-BE49-F238E27FC236}">
-                <a16:creationId xmlns:a16="http://schemas.microsoft.com/office/drawing/2014/main" id="{81ED5BE8-74B0-4127-91AA-5C08F23DCCBD}"/>
+                <a16:creationId xmlns:a16="http://schemas.microsoft.com/office/drawing/2014/main" id="{8C3338AE-D6E4-4140-B850-8A5B925AFDD6}"/>
               </a:ext>
             </a:extLst>
           </p:cNvPr>
@@ -10197,7 +10197,7 @@
           <p:cNvPr id="3" name="">
             <a:extLst xmlns:a="http://schemas.openxmlformats.org/drawingml/2006/main">
               <a:ext uri="{FF2B5EF4-FFF2-40B4-BE49-F238E27FC236}">
-                <a16:creationId xmlns:a16="http://schemas.microsoft.com/office/drawing/2014/main" id="{9CE94D3E-8504-4128-8D25-1C9795B9BD4C}"/>
+                <a16:creationId xmlns:a16="http://schemas.microsoft.com/office/drawing/2014/main" id="{71D00702-5BAE-4A23-95F0-D190C5577901}"/>
               </a:ext>
             </a:extLst>
           </p:cNvPr>
@@ -10286,7 +10286,7 @@
           <p:cNvPr id="4" name="">
             <a:extLst xmlns:a="http://schemas.openxmlformats.org/drawingml/2006/main">
               <a:ext uri="{FF2B5EF4-FFF2-40B4-BE49-F238E27FC236}">
-                <a16:creationId xmlns:a16="http://schemas.microsoft.com/office/drawing/2014/main" id="{3168C9D1-187B-45DC-A9A9-421D444ED9B6}"/>
+                <a16:creationId xmlns:a16="http://schemas.microsoft.com/office/drawing/2014/main" id="{9D22E3BF-4FBC-4503-A23C-00870D739DBA}"/>
               </a:ext>
             </a:extLst>
           </p:cNvPr>
@@ -10348,7 +10348,7 @@
           <p:cNvPr id="5" name="">
             <a:extLst xmlns:a="http://schemas.openxmlformats.org/drawingml/2006/main">
               <a:ext uri="{FF2B5EF4-FFF2-40B4-BE49-F238E27FC236}">
-                <a16:creationId xmlns:a16="http://schemas.microsoft.com/office/drawing/2014/main" id="{476CCB34-D4F5-480F-B430-D361C93718A4}"/>
+                <a16:creationId xmlns:a16="http://schemas.microsoft.com/office/drawing/2014/main" id="{B09DEEE7-063E-4A1C-9B93-3900D7F2F40E}"/>
               </a:ext>
             </a:extLst>
           </p:cNvPr>
@@ -10381,7 +10381,7 @@
           <p:cNvPr id="6" name="">
             <a:extLst xmlns:a="http://schemas.openxmlformats.org/drawingml/2006/main">
               <a:ext uri="{FF2B5EF4-FFF2-40B4-BE49-F238E27FC236}">
-                <a16:creationId xmlns:a16="http://schemas.microsoft.com/office/drawing/2014/main" id="{CAE191AD-FFF3-4F14-B2B9-C28B71E4E986}"/>
+                <a16:creationId xmlns:a16="http://schemas.microsoft.com/office/drawing/2014/main" id="{11F9FA32-EFAB-42DB-9505-04EE55DA3E15}"/>
               </a:ext>
             </a:extLst>
           </p:cNvPr>
@@ -10443,7 +10443,7 @@
           <p:cNvPr id="7" name="">
             <a:extLst xmlns:a="http://schemas.openxmlformats.org/drawingml/2006/main">
               <a:ext uri="{FF2B5EF4-FFF2-40B4-BE49-F238E27FC236}">
-                <a16:creationId xmlns:a16="http://schemas.microsoft.com/office/drawing/2014/main" id="{B38BBD68-182B-4AC0-9D49-08E83EBDC1E5}"/>
+                <a16:creationId xmlns:a16="http://schemas.microsoft.com/office/drawing/2014/main" id="{43CC05E6-B83C-4F5D-A228-8D509E593F43}"/>
               </a:ext>
             </a:extLst>
           </p:cNvPr>
@@ -10505,7 +10505,7 @@
           <p:cNvPr id="8" name="">
             <a:extLst xmlns:a="http://schemas.openxmlformats.org/drawingml/2006/main">
               <a:ext uri="{FF2B5EF4-FFF2-40B4-BE49-F238E27FC236}">
-                <a16:creationId xmlns:a16="http://schemas.microsoft.com/office/drawing/2014/main" id="{97012D6D-05A2-42C8-A352-1A60C70DC23F}"/>
+                <a16:creationId xmlns:a16="http://schemas.microsoft.com/office/drawing/2014/main" id="{5A0777A1-4FA1-467A-9282-C7EA52A6B8B3}"/>
               </a:ext>
             </a:extLst>
           </p:cNvPr>
@@ -10594,7 +10594,7 @@
           <p:cNvPr id="9" name="">
             <a:extLst xmlns:a="http://schemas.openxmlformats.org/drawingml/2006/main">
               <a:ext uri="{FF2B5EF4-FFF2-40B4-BE49-F238E27FC236}">
-                <a16:creationId xmlns:a16="http://schemas.microsoft.com/office/drawing/2014/main" id="{433B8FB3-E4B4-4676-9FB5-9BA437A61255}"/>
+                <a16:creationId xmlns:a16="http://schemas.microsoft.com/office/drawing/2014/main" id="{3ACECE34-6C5E-4D75-ABC0-3DA2CCB30835}"/>
               </a:ext>
             </a:extLst>
           </p:cNvPr>
@@ -10656,7 +10656,7 @@
           <p:cNvPr id="10" name="">
             <a:extLst xmlns:a="http://schemas.openxmlformats.org/drawingml/2006/main">
               <a:ext uri="{FF2B5EF4-FFF2-40B4-BE49-F238E27FC236}">
-                <a16:creationId xmlns:a16="http://schemas.microsoft.com/office/drawing/2014/main" id="{C13FABEA-E3A3-457B-9EEC-167943CC5560}"/>
+                <a16:creationId xmlns:a16="http://schemas.microsoft.com/office/drawing/2014/main" id="{9C7E143B-BD45-42B0-839F-A81D56B129A1}"/>
               </a:ext>
             </a:extLst>
           </p:cNvPr>
@@ -10716,7 +10716,7 @@
     </p:spTree>
     <p:extLst>
       <p:ext uri="{BB962C8B-B14F-4D97-AF65-F5344CB8AC3E}">
-        <p14:creationId xmlns:p14="http://schemas.microsoft.com/office/powerpoint/2010/main" val="1173988449"/>
+        <p14:creationId xmlns:p14="http://schemas.microsoft.com/office/powerpoint/2010/main" val="1503821441"/>
       </p:ext>
     </p:extLst>
   </p:cSld>
@@ -10747,7 +10747,7 @@
           <p:cNvPr id="22" name="side-accent-17">
             <a:extLst xmlns:a="http://schemas.openxmlformats.org/drawingml/2006/main">
               <a:ext uri="{FF2B5EF4-FFF2-40B4-BE49-F238E27FC236}">
-                <a16:creationId xmlns:a16="http://schemas.microsoft.com/office/drawing/2014/main" id="{74D74FE4-2578-4901-86C5-AB969AC5E822}"/>
+                <a16:creationId xmlns:a16="http://schemas.microsoft.com/office/drawing/2014/main" id="{C3365D58-EBB9-4CED-A079-CF378B733262}"/>
               </a:ext>
             </a:extLst>
           </p:cNvPr>
@@ -10778,7 +10778,7 @@
           <p:cNvPr id="2" name="kicker-17">
             <a:extLst xmlns:a="http://schemas.openxmlformats.org/drawingml/2006/main">
               <a:ext uri="{FF2B5EF4-FFF2-40B4-BE49-F238E27FC236}">
-                <a16:creationId xmlns:a16="http://schemas.microsoft.com/office/drawing/2014/main" id="{C5E1BB44-ED13-4CB6-8896-5CD0D15B5185}"/>
+                <a16:creationId xmlns:a16="http://schemas.microsoft.com/office/drawing/2014/main" id="{93BD6036-F509-461B-9999-F013D84266D1}"/>
               </a:ext>
             </a:extLst>
           </p:cNvPr>
@@ -10840,7 +10840,7 @@
           <p:cNvPr id="3" name="title-17">
             <a:extLst xmlns:a="http://schemas.openxmlformats.org/drawingml/2006/main">
               <a:ext uri="{FF2B5EF4-FFF2-40B4-BE49-F238E27FC236}">
-                <a16:creationId xmlns:a16="http://schemas.microsoft.com/office/drawing/2014/main" id="{9A33E2B6-961D-4BB8-84EC-794DF64FCAD8}"/>
+                <a16:creationId xmlns:a16="http://schemas.microsoft.com/office/drawing/2014/main" id="{39742768-3E2B-4A96-8FAE-815D3384A532}"/>
               </a:ext>
             </a:extLst>
           </p:cNvPr>
@@ -10902,7 +10902,7 @@
           <p:cNvPr id="4" name="">
             <a:extLst xmlns:a="http://schemas.openxmlformats.org/drawingml/2006/main">
               <a:ext uri="{FF2B5EF4-FFF2-40B4-BE49-F238E27FC236}">
-                <a16:creationId xmlns:a16="http://schemas.microsoft.com/office/drawing/2014/main" id="{482BFCC6-55FB-4EDD-AB2D-6AF8AE2A4A70}"/>
+                <a16:creationId xmlns:a16="http://schemas.microsoft.com/office/drawing/2014/main" id="{5D5DA65A-E880-49AA-884F-141E9B56BE6B}"/>
               </a:ext>
             </a:extLst>
           </p:cNvPr>
@@ -10964,7 +10964,7 @@
           <p:cNvPr id="5" name="">
             <a:extLst xmlns:a="http://schemas.openxmlformats.org/drawingml/2006/main">
               <a:ext uri="{FF2B5EF4-FFF2-40B4-BE49-F238E27FC236}">
-                <a16:creationId xmlns:a16="http://schemas.microsoft.com/office/drawing/2014/main" id="{06612FDE-D22B-41E6-8CA0-C2753CBB39AF}"/>
+                <a16:creationId xmlns:a16="http://schemas.microsoft.com/office/drawing/2014/main" id="{05331815-2FA9-4A14-8177-FF7614FD121D}"/>
               </a:ext>
             </a:extLst>
           </p:cNvPr>
@@ -10995,7 +10995,7 @@
           <p:cNvPr id="6" name="">
             <a:extLst xmlns:a="http://schemas.openxmlformats.org/drawingml/2006/main">
               <a:ext uri="{FF2B5EF4-FFF2-40B4-BE49-F238E27FC236}">
-                <a16:creationId xmlns:a16="http://schemas.microsoft.com/office/drawing/2014/main" id="{F3F54690-87BA-42B4-A337-F0F3D9DB5781}"/>
+                <a16:creationId xmlns:a16="http://schemas.microsoft.com/office/drawing/2014/main" id="{969C017F-EF04-4919-A387-9AA4ED14C4BA}"/>
               </a:ext>
             </a:extLst>
           </p:cNvPr>
@@ -11057,7 +11057,7 @@
           <p:cNvPr id="7" name="">
             <a:extLst xmlns:a="http://schemas.openxmlformats.org/drawingml/2006/main">
               <a:ext uri="{FF2B5EF4-FFF2-40B4-BE49-F238E27FC236}">
-                <a16:creationId xmlns:a16="http://schemas.microsoft.com/office/drawing/2014/main" id="{8DEC2820-36F9-4CB4-B0E8-6A145CEE55BC}"/>
+                <a16:creationId xmlns:a16="http://schemas.microsoft.com/office/drawing/2014/main" id="{040B5CD3-FE4B-4828-B235-9B9AA957953A}"/>
               </a:ext>
             </a:extLst>
           </p:cNvPr>
@@ -11119,7 +11119,7 @@
           <p:cNvPr id="8" name="">
             <a:extLst xmlns:a="http://schemas.openxmlformats.org/drawingml/2006/main">
               <a:ext uri="{FF2B5EF4-FFF2-40B4-BE49-F238E27FC236}">
-                <a16:creationId xmlns:a16="http://schemas.microsoft.com/office/drawing/2014/main" id="{92E35FAE-68DB-4072-91A1-A58259AE3763}"/>
+                <a16:creationId xmlns:a16="http://schemas.microsoft.com/office/drawing/2014/main" id="{0879DA7E-DB8C-425B-AF25-4999EBD1E420}"/>
               </a:ext>
             </a:extLst>
           </p:cNvPr>
@@ -11150,7 +11150,7 @@
           <p:cNvPr id="9" name="">
             <a:extLst xmlns:a="http://schemas.openxmlformats.org/drawingml/2006/main">
               <a:ext uri="{FF2B5EF4-FFF2-40B4-BE49-F238E27FC236}">
-                <a16:creationId xmlns:a16="http://schemas.microsoft.com/office/drawing/2014/main" id="{5C190FC3-6BF2-4A36-BBE4-18E0D5C9D5BF}"/>
+                <a16:creationId xmlns:a16="http://schemas.microsoft.com/office/drawing/2014/main" id="{2AFA1596-FD58-42A7-8559-DE3A11CF0213}"/>
               </a:ext>
             </a:extLst>
           </p:cNvPr>
@@ -11212,7 +11212,7 @@
           <p:cNvPr id="10" name="">
             <a:extLst xmlns:a="http://schemas.openxmlformats.org/drawingml/2006/main">
               <a:ext uri="{FF2B5EF4-FFF2-40B4-BE49-F238E27FC236}">
-                <a16:creationId xmlns:a16="http://schemas.microsoft.com/office/drawing/2014/main" id="{0936D88B-8156-49C5-A717-A84CF8493FAB}"/>
+                <a16:creationId xmlns:a16="http://schemas.microsoft.com/office/drawing/2014/main" id="{63F90E8D-1F2B-4F1B-ABA6-488504BCEE6C}"/>
               </a:ext>
             </a:extLst>
           </p:cNvPr>
@@ -11274,7 +11274,7 @@
           <p:cNvPr id="11" name="">
             <a:extLst xmlns:a="http://schemas.openxmlformats.org/drawingml/2006/main">
               <a:ext uri="{FF2B5EF4-FFF2-40B4-BE49-F238E27FC236}">
-                <a16:creationId xmlns:a16="http://schemas.microsoft.com/office/drawing/2014/main" id="{0591E462-6922-466C-BC58-2759450A483D}"/>
+                <a16:creationId xmlns:a16="http://schemas.microsoft.com/office/drawing/2014/main" id="{81EFC562-FA9A-4679-9507-A4090DAA750F}"/>
               </a:ext>
             </a:extLst>
           </p:cNvPr>
@@ -11305,7 +11305,7 @@
           <p:cNvPr id="12" name="">
             <a:extLst xmlns:a="http://schemas.openxmlformats.org/drawingml/2006/main">
               <a:ext uri="{FF2B5EF4-FFF2-40B4-BE49-F238E27FC236}">
-                <a16:creationId xmlns:a16="http://schemas.microsoft.com/office/drawing/2014/main" id="{E56D0C5D-419E-4112-88E2-678E7F64E3C6}"/>
+                <a16:creationId xmlns:a16="http://schemas.microsoft.com/office/drawing/2014/main" id="{E9150BDA-20F8-4E5F-A4E1-E4BBCC3A38AC}"/>
               </a:ext>
             </a:extLst>
           </p:cNvPr>
@@ -11367,7 +11367,7 @@
           <p:cNvPr id="13" name="">
             <a:extLst xmlns:a="http://schemas.openxmlformats.org/drawingml/2006/main">
               <a:ext uri="{FF2B5EF4-FFF2-40B4-BE49-F238E27FC236}">
-                <a16:creationId xmlns:a16="http://schemas.microsoft.com/office/drawing/2014/main" id="{A99894D9-1391-445E-84E8-FC299F1895F0}"/>
+                <a16:creationId xmlns:a16="http://schemas.microsoft.com/office/drawing/2014/main" id="{EB1FE53C-7D2C-402E-A9F5-EFB29E883482}"/>
               </a:ext>
             </a:extLst>
           </p:cNvPr>
@@ -11429,7 +11429,7 @@
           <p:cNvPr id="14" name="">
             <a:extLst xmlns:a="http://schemas.openxmlformats.org/drawingml/2006/main">
               <a:ext uri="{FF2B5EF4-FFF2-40B4-BE49-F238E27FC236}">
-                <a16:creationId xmlns:a16="http://schemas.microsoft.com/office/drawing/2014/main" id="{12C1DEE9-AF1A-424E-8F9D-403180D2A838}"/>
+                <a16:creationId xmlns:a16="http://schemas.microsoft.com/office/drawing/2014/main" id="{B8893576-BE1C-4E9C-A833-8131221BD98E}"/>
               </a:ext>
             </a:extLst>
           </p:cNvPr>
@@ -11460,7 +11460,7 @@
           <p:cNvPr id="15" name="">
             <a:extLst xmlns:a="http://schemas.openxmlformats.org/drawingml/2006/main">
               <a:ext uri="{FF2B5EF4-FFF2-40B4-BE49-F238E27FC236}">
-                <a16:creationId xmlns:a16="http://schemas.microsoft.com/office/drawing/2014/main" id="{81F8E3F6-22BB-4C21-8712-5BEC60AD5A35}"/>
+                <a16:creationId xmlns:a16="http://schemas.microsoft.com/office/drawing/2014/main" id="{C0DC59E6-A784-41E4-989C-58CDE74E51C9}"/>
               </a:ext>
             </a:extLst>
           </p:cNvPr>
@@ -11522,7 +11522,7 @@
           <p:cNvPr id="16" name="">
             <a:extLst xmlns:a="http://schemas.openxmlformats.org/drawingml/2006/main">
               <a:ext uri="{FF2B5EF4-FFF2-40B4-BE49-F238E27FC236}">
-                <a16:creationId xmlns:a16="http://schemas.microsoft.com/office/drawing/2014/main" id="{080A8E68-3A98-4D43-8C66-4168038FC1E7}"/>
+                <a16:creationId xmlns:a16="http://schemas.microsoft.com/office/drawing/2014/main" id="{BA17C824-9A9D-4CE0-BF7A-BA28DE9DD55D}"/>
               </a:ext>
             </a:extLst>
           </p:cNvPr>
@@ -11584,7 +11584,7 @@
           <p:cNvPr id="17" name="">
             <a:extLst xmlns:a="http://schemas.openxmlformats.org/drawingml/2006/main">
               <a:ext uri="{FF2B5EF4-FFF2-40B4-BE49-F238E27FC236}">
-                <a16:creationId xmlns:a16="http://schemas.microsoft.com/office/drawing/2014/main" id="{53402B50-E222-4D44-82D1-F3B9B8D04C61}"/>
+                <a16:creationId xmlns:a16="http://schemas.microsoft.com/office/drawing/2014/main" id="{1FE4DD7E-3C03-49E2-AF53-C24A472DF23B}"/>
               </a:ext>
             </a:extLst>
           </p:cNvPr>
@@ -11617,7 +11617,7 @@
           <p:cNvPr id="18" name="">
             <a:extLst xmlns:a="http://schemas.openxmlformats.org/drawingml/2006/main">
               <a:ext uri="{FF2B5EF4-FFF2-40B4-BE49-F238E27FC236}">
-                <a16:creationId xmlns:a16="http://schemas.microsoft.com/office/drawing/2014/main" id="{4DCC0CA9-6A7D-448C-AF39-8061FF646E67}"/>
+                <a16:creationId xmlns:a16="http://schemas.microsoft.com/office/drawing/2014/main" id="{92B07FC7-AA85-42C2-A759-742408935174}"/>
               </a:ext>
             </a:extLst>
           </p:cNvPr>
@@ -11679,7 +11679,7 @@
           <p:cNvPr id="19" name="footer-rule-17">
             <a:extLst xmlns:a="http://schemas.openxmlformats.org/drawingml/2006/main">
               <a:ext uri="{FF2B5EF4-FFF2-40B4-BE49-F238E27FC236}">
-                <a16:creationId xmlns:a16="http://schemas.microsoft.com/office/drawing/2014/main" id="{6723F60A-F7E3-45B1-94D6-C43BE422067A}"/>
+                <a16:creationId xmlns:a16="http://schemas.microsoft.com/office/drawing/2014/main" id="{DBCF8CEB-7B16-4833-8EE0-D25ECC37CE56}"/>
               </a:ext>
             </a:extLst>
           </p:cNvPr>
@@ -11710,7 +11710,7 @@
           <p:cNvPr id="20" name="footer-label-17">
             <a:extLst xmlns:a="http://schemas.openxmlformats.org/drawingml/2006/main">
               <a:ext uri="{FF2B5EF4-FFF2-40B4-BE49-F238E27FC236}">
-                <a16:creationId xmlns:a16="http://schemas.microsoft.com/office/drawing/2014/main" id="{EDF57969-FA51-4E7E-8D1A-6D0826D78B60}"/>
+                <a16:creationId xmlns:a16="http://schemas.microsoft.com/office/drawing/2014/main" id="{15B261A6-9EB5-4BD9-908F-62A244B8E883}"/>
               </a:ext>
             </a:extLst>
           </p:cNvPr>
@@ -11772,7 +11772,7 @@
           <p:cNvPr id="21" name="footer-page-17">
             <a:extLst xmlns:a="http://schemas.openxmlformats.org/drawingml/2006/main">
               <a:ext uri="{FF2B5EF4-FFF2-40B4-BE49-F238E27FC236}">
-                <a16:creationId xmlns:a16="http://schemas.microsoft.com/office/drawing/2014/main" id="{25DBCDED-D13D-4B1B-A0B7-223F84AA2408}"/>
+                <a16:creationId xmlns:a16="http://schemas.microsoft.com/office/drawing/2014/main" id="{DD0BE16E-1E44-4D33-936C-47E9AD3E6168}"/>
               </a:ext>
             </a:extLst>
           </p:cNvPr>
@@ -11832,7 +11832,7 @@
     </p:spTree>
     <p:extLst>
       <p:ext uri="{BB962C8B-B14F-4D97-AF65-F5344CB8AC3E}">
-        <p14:creationId xmlns:p14="http://schemas.microsoft.com/office/powerpoint/2010/main" val="387451107"/>
+        <p14:creationId xmlns:p14="http://schemas.microsoft.com/office/powerpoint/2010/main" val="153758474"/>
       </p:ext>
     </p:extLst>
   </p:cSld>
@@ -11863,7 +11863,7 @@
           <p:cNvPr id="25" name="side-accent-18">
             <a:extLst xmlns:a="http://schemas.openxmlformats.org/drawingml/2006/main">
               <a:ext uri="{FF2B5EF4-FFF2-40B4-BE49-F238E27FC236}">
-                <a16:creationId xmlns:a16="http://schemas.microsoft.com/office/drawing/2014/main" id="{DB4DD2F2-CCFA-422A-8A8B-329FFFF5FD58}"/>
+                <a16:creationId xmlns:a16="http://schemas.microsoft.com/office/drawing/2014/main" id="{0C2917FE-0239-451B-A6F5-1ADC76609035}"/>
               </a:ext>
             </a:extLst>
           </p:cNvPr>
@@ -11894,7 +11894,7 @@
           <p:cNvPr id="2" name="kicker-18">
             <a:extLst xmlns:a="http://schemas.openxmlformats.org/drawingml/2006/main">
               <a:ext uri="{FF2B5EF4-FFF2-40B4-BE49-F238E27FC236}">
-                <a16:creationId xmlns:a16="http://schemas.microsoft.com/office/drawing/2014/main" id="{FD4A6512-EC10-45B8-971C-5295F7D8DFC8}"/>
+                <a16:creationId xmlns:a16="http://schemas.microsoft.com/office/drawing/2014/main" id="{1E5B76A4-8F67-4D40-B2D7-40E9AFB85EEC}"/>
               </a:ext>
             </a:extLst>
           </p:cNvPr>
@@ -11956,7 +11956,7 @@
           <p:cNvPr id="3" name="title-18">
             <a:extLst xmlns:a="http://schemas.openxmlformats.org/drawingml/2006/main">
               <a:ext uri="{FF2B5EF4-FFF2-40B4-BE49-F238E27FC236}">
-                <a16:creationId xmlns:a16="http://schemas.microsoft.com/office/drawing/2014/main" id="{C3F40A4F-45F0-47B1-A100-0BA22524BD1E}"/>
+                <a16:creationId xmlns:a16="http://schemas.microsoft.com/office/drawing/2014/main" id="{0C1FF12C-42DF-4303-A846-5704ABBC67E8}"/>
               </a:ext>
             </a:extLst>
           </p:cNvPr>
@@ -12018,7 +12018,7 @@
           <p:cNvPr id="4" name="">
             <a:extLst xmlns:a="http://schemas.openxmlformats.org/drawingml/2006/main">
               <a:ext uri="{FF2B5EF4-FFF2-40B4-BE49-F238E27FC236}">
-                <a16:creationId xmlns:a16="http://schemas.microsoft.com/office/drawing/2014/main" id="{7578F252-BE4E-41BE-ACC3-AC7736C49629}"/>
+                <a16:creationId xmlns:a16="http://schemas.microsoft.com/office/drawing/2014/main" id="{4410A51F-1853-49A7-B287-D6D29EDD6639}"/>
               </a:ext>
             </a:extLst>
           </p:cNvPr>
@@ -12080,7 +12080,7 @@
           <p:cNvPr id="5" name="">
             <a:extLst xmlns:a="http://schemas.openxmlformats.org/drawingml/2006/main">
               <a:ext uri="{FF2B5EF4-FFF2-40B4-BE49-F238E27FC236}">
-                <a16:creationId xmlns:a16="http://schemas.microsoft.com/office/drawing/2014/main" id="{CD874918-A6F9-413A-81D0-DAC9A6BFE58F}"/>
+                <a16:creationId xmlns:a16="http://schemas.microsoft.com/office/drawing/2014/main" id="{7F00A4D4-06FB-4B4E-98B9-20CA38C90704}"/>
               </a:ext>
             </a:extLst>
           </p:cNvPr>
@@ -12142,7 +12142,7 @@
           <p:cNvPr id="6" name="">
             <a:extLst xmlns:a="http://schemas.openxmlformats.org/drawingml/2006/main">
               <a:ext uri="{FF2B5EF4-FFF2-40B4-BE49-F238E27FC236}">
-                <a16:creationId xmlns:a16="http://schemas.microsoft.com/office/drawing/2014/main" id="{54F56A30-A40E-4C78-A7BA-1E76FDC18F0E}"/>
+                <a16:creationId xmlns:a16="http://schemas.microsoft.com/office/drawing/2014/main" id="{055F94D3-8CEC-42F5-9AEA-D52AE56F25C4}"/>
               </a:ext>
             </a:extLst>
           </p:cNvPr>
@@ -12204,7 +12204,7 @@
           <p:cNvPr id="7" name="">
             <a:extLst xmlns:a="http://schemas.openxmlformats.org/drawingml/2006/main">
               <a:ext uri="{FF2B5EF4-FFF2-40B4-BE49-F238E27FC236}">
-                <a16:creationId xmlns:a16="http://schemas.microsoft.com/office/drawing/2014/main" id="{011F3D14-95E1-41E4-9B00-2BA68A283454}"/>
+                <a16:creationId xmlns:a16="http://schemas.microsoft.com/office/drawing/2014/main" id="{AEBC3589-81C0-4AE2-903E-9E366046FC2D}"/>
               </a:ext>
             </a:extLst>
           </p:cNvPr>
@@ -12235,7 +12235,7 @@
           <p:cNvPr id="8" name="">
             <a:extLst xmlns:a="http://schemas.openxmlformats.org/drawingml/2006/main">
               <a:ext uri="{FF2B5EF4-FFF2-40B4-BE49-F238E27FC236}">
-                <a16:creationId xmlns:a16="http://schemas.microsoft.com/office/drawing/2014/main" id="{1B9E1A23-0C64-442C-9084-1ED9305AB9EC}"/>
+                <a16:creationId xmlns:a16="http://schemas.microsoft.com/office/drawing/2014/main" id="{38625ADC-364D-41EB-8D15-C14D60CAC7EE}"/>
               </a:ext>
             </a:extLst>
           </p:cNvPr>
@@ -12297,7 +12297,7 @@
           <p:cNvPr id="9" name="">
             <a:extLst xmlns:a="http://schemas.openxmlformats.org/drawingml/2006/main">
               <a:ext uri="{FF2B5EF4-FFF2-40B4-BE49-F238E27FC236}">
-                <a16:creationId xmlns:a16="http://schemas.microsoft.com/office/drawing/2014/main" id="{AA49C62E-8770-4CA4-88C3-744FC87FA997}"/>
+                <a16:creationId xmlns:a16="http://schemas.microsoft.com/office/drawing/2014/main" id="{EC9DBF57-F6C6-4193-AA4C-0F609D543625}"/>
               </a:ext>
             </a:extLst>
           </p:cNvPr>
@@ -12359,7 +12359,7 @@
           <p:cNvPr id="10" name="">
             <a:extLst xmlns:a="http://schemas.openxmlformats.org/drawingml/2006/main">
               <a:ext uri="{FF2B5EF4-FFF2-40B4-BE49-F238E27FC236}">
-                <a16:creationId xmlns:a16="http://schemas.microsoft.com/office/drawing/2014/main" id="{FC3816B9-217D-4020-B4D0-C026A6D657A1}"/>
+                <a16:creationId xmlns:a16="http://schemas.microsoft.com/office/drawing/2014/main" id="{069FE736-6924-4EAF-BD97-22FF4BA8DC4D}"/>
               </a:ext>
             </a:extLst>
           </p:cNvPr>
@@ -12421,7 +12421,7 @@
           <p:cNvPr id="11" name="">
             <a:extLst xmlns:a="http://schemas.openxmlformats.org/drawingml/2006/main">
               <a:ext uri="{FF2B5EF4-FFF2-40B4-BE49-F238E27FC236}">
-                <a16:creationId xmlns:a16="http://schemas.microsoft.com/office/drawing/2014/main" id="{C0AF622E-03BA-403C-8554-AD7A8F3FFCFC}"/>
+                <a16:creationId xmlns:a16="http://schemas.microsoft.com/office/drawing/2014/main" id="{2707CD9A-D6D7-47F4-85AE-9E9A9092B0AB}"/>
               </a:ext>
             </a:extLst>
           </p:cNvPr>
@@ -12452,7 +12452,7 @@
           <p:cNvPr id="12" name="">
             <a:extLst xmlns:a="http://schemas.openxmlformats.org/drawingml/2006/main">
               <a:ext uri="{FF2B5EF4-FFF2-40B4-BE49-F238E27FC236}">
-                <a16:creationId xmlns:a16="http://schemas.microsoft.com/office/drawing/2014/main" id="{B266FD88-B1CF-48F2-84A3-84B059A2675B}"/>
+                <a16:creationId xmlns:a16="http://schemas.microsoft.com/office/drawing/2014/main" id="{9809FDE8-8130-46B4-93FD-39D594C4336D}"/>
               </a:ext>
             </a:extLst>
           </p:cNvPr>
@@ -12514,7 +12514,7 @@
           <p:cNvPr id="13" name="">
             <a:extLst xmlns:a="http://schemas.openxmlformats.org/drawingml/2006/main">
               <a:ext uri="{FF2B5EF4-FFF2-40B4-BE49-F238E27FC236}">
-                <a16:creationId xmlns:a16="http://schemas.microsoft.com/office/drawing/2014/main" id="{980CFA89-B6E8-4D38-9943-98FCCF5DB10D}"/>
+                <a16:creationId xmlns:a16="http://schemas.microsoft.com/office/drawing/2014/main" id="{A830A8AB-99A8-45BE-A6F7-0F312D79CDF6}"/>
               </a:ext>
             </a:extLst>
           </p:cNvPr>
@@ -12576,7 +12576,7 @@
           <p:cNvPr id="14" name="">
             <a:extLst xmlns:a="http://schemas.openxmlformats.org/drawingml/2006/main">
               <a:ext uri="{FF2B5EF4-FFF2-40B4-BE49-F238E27FC236}">
-                <a16:creationId xmlns:a16="http://schemas.microsoft.com/office/drawing/2014/main" id="{71D87DBF-FDA2-43E0-9B27-FAA2EC298717}"/>
+                <a16:creationId xmlns:a16="http://schemas.microsoft.com/office/drawing/2014/main" id="{E1C32058-42C0-48FE-8C32-A00C4F7FE2DE}"/>
               </a:ext>
             </a:extLst>
           </p:cNvPr>
@@ -12638,7 +12638,7 @@
           <p:cNvPr id="15" name="">
             <a:extLst xmlns:a="http://schemas.openxmlformats.org/drawingml/2006/main">
               <a:ext uri="{FF2B5EF4-FFF2-40B4-BE49-F238E27FC236}">
-                <a16:creationId xmlns:a16="http://schemas.microsoft.com/office/drawing/2014/main" id="{27EAEE4C-1B73-4E69-8D91-E66624B49571}"/>
+                <a16:creationId xmlns:a16="http://schemas.microsoft.com/office/drawing/2014/main" id="{45FBFA27-BEB7-480B-8238-EABCB3CD3427}"/>
               </a:ext>
             </a:extLst>
           </p:cNvPr>
@@ -12669,7 +12669,7 @@
           <p:cNvPr id="16" name="">
             <a:extLst xmlns:a="http://schemas.openxmlformats.org/drawingml/2006/main">
               <a:ext uri="{FF2B5EF4-FFF2-40B4-BE49-F238E27FC236}">
-                <a16:creationId xmlns:a16="http://schemas.microsoft.com/office/drawing/2014/main" id="{B25E666B-A6D2-4125-8D20-A12E56A37666}"/>
+                <a16:creationId xmlns:a16="http://schemas.microsoft.com/office/drawing/2014/main" id="{39F2362B-F24B-4D98-BED5-B97B6498ABC2}"/>
               </a:ext>
             </a:extLst>
           </p:cNvPr>
@@ -12731,7 +12731,7 @@
           <p:cNvPr id="17" name="">
             <a:extLst xmlns:a="http://schemas.openxmlformats.org/drawingml/2006/main">
               <a:ext uri="{FF2B5EF4-FFF2-40B4-BE49-F238E27FC236}">
-                <a16:creationId xmlns:a16="http://schemas.microsoft.com/office/drawing/2014/main" id="{14A7464D-0C40-4921-BBDE-FDA37B1D48A6}"/>
+                <a16:creationId xmlns:a16="http://schemas.microsoft.com/office/drawing/2014/main" id="{B9EBD184-9FDD-44D8-86A3-F60E584C719B}"/>
               </a:ext>
             </a:extLst>
           </p:cNvPr>
@@ -12793,7 +12793,7 @@
           <p:cNvPr id="18" name="">
             <a:extLst xmlns:a="http://schemas.openxmlformats.org/drawingml/2006/main">
               <a:ext uri="{FF2B5EF4-FFF2-40B4-BE49-F238E27FC236}">
-                <a16:creationId xmlns:a16="http://schemas.microsoft.com/office/drawing/2014/main" id="{4E933D88-CB31-4AE7-A2E2-751C8517EB3F}"/>
+                <a16:creationId xmlns:a16="http://schemas.microsoft.com/office/drawing/2014/main" id="{3858DB52-48B9-4D58-BA07-E875A553C2AD}"/>
               </a:ext>
             </a:extLst>
           </p:cNvPr>
@@ -12855,7 +12855,7 @@
           <p:cNvPr id="19" name="">
             <a:extLst xmlns:a="http://schemas.openxmlformats.org/drawingml/2006/main">
               <a:ext uri="{FF2B5EF4-FFF2-40B4-BE49-F238E27FC236}">
-                <a16:creationId xmlns:a16="http://schemas.microsoft.com/office/drawing/2014/main" id="{7AEC494B-69BD-41B2-9C98-96E17ACAD6C9}"/>
+                <a16:creationId xmlns:a16="http://schemas.microsoft.com/office/drawing/2014/main" id="{DAEF58E4-F0D4-4E20-921D-37A0B82B9B02}"/>
               </a:ext>
             </a:extLst>
           </p:cNvPr>
@@ -12888,7 +12888,7 @@
           <p:cNvPr id="20" name="">
             <a:extLst xmlns:a="http://schemas.openxmlformats.org/drawingml/2006/main">
               <a:ext uri="{FF2B5EF4-FFF2-40B4-BE49-F238E27FC236}">
-                <a16:creationId xmlns:a16="http://schemas.microsoft.com/office/drawing/2014/main" id="{131CE959-E489-4932-95B0-E8B07EBEAB74}"/>
+                <a16:creationId xmlns:a16="http://schemas.microsoft.com/office/drawing/2014/main" id="{F0E87097-3FED-4386-A4E0-B82E0E28F160}"/>
               </a:ext>
             </a:extLst>
           </p:cNvPr>
@@ -12954,7 +12954,7 @@
           <p:nvPr/>
         </p:nvPicPr>
         <p:blipFill>
-          <a:blip xmlns:r="http://schemas.openxmlformats.org/officeDocument/2006/relationships" xmlns:a="http://schemas.openxmlformats.org/drawingml/2006/main" r:embed="R06f8e8bec77349ac"/>
+          <a:blip xmlns:r="http://schemas.openxmlformats.org/officeDocument/2006/relationships" xmlns:a="http://schemas.openxmlformats.org/drawingml/2006/main" r:embed="R1658ba2a62a14b85"/>
           <a:stretch xmlns:a="http://schemas.openxmlformats.org/drawingml/2006/main"/>
         </p:blipFill>
         <p:spPr>
@@ -12972,7 +12972,7 @@
           <p:cNvPr id="22" name="footer-rule-18">
             <a:extLst xmlns:a="http://schemas.openxmlformats.org/drawingml/2006/main">
               <a:ext uri="{FF2B5EF4-FFF2-40B4-BE49-F238E27FC236}">
-                <a16:creationId xmlns:a16="http://schemas.microsoft.com/office/drawing/2014/main" id="{328D1FDA-D950-4318-B7DA-44E4E6BE2752}"/>
+                <a16:creationId xmlns:a16="http://schemas.microsoft.com/office/drawing/2014/main" id="{31FB325F-6C72-45E2-99D6-78FB0F7CFDCA}"/>
               </a:ext>
             </a:extLst>
           </p:cNvPr>
@@ -13003,7 +13003,7 @@
           <p:cNvPr id="23" name="footer-label-18">
             <a:extLst xmlns:a="http://schemas.openxmlformats.org/drawingml/2006/main">
               <a:ext uri="{FF2B5EF4-FFF2-40B4-BE49-F238E27FC236}">
-                <a16:creationId xmlns:a16="http://schemas.microsoft.com/office/drawing/2014/main" id="{46CE13FA-8B2D-4566-93F7-2EED7571E28C}"/>
+                <a16:creationId xmlns:a16="http://schemas.microsoft.com/office/drawing/2014/main" id="{4B3F1854-7D7E-411D-9616-594769F049EC}"/>
               </a:ext>
             </a:extLst>
           </p:cNvPr>
@@ -13065,7 +13065,7 @@
           <p:cNvPr id="24" name="footer-page-18">
             <a:extLst xmlns:a="http://schemas.openxmlformats.org/drawingml/2006/main">
               <a:ext uri="{FF2B5EF4-FFF2-40B4-BE49-F238E27FC236}">
-                <a16:creationId xmlns:a16="http://schemas.microsoft.com/office/drawing/2014/main" id="{9014A6A1-7B31-4088-A8EA-F28DD36C998D}"/>
+                <a16:creationId xmlns:a16="http://schemas.microsoft.com/office/drawing/2014/main" id="{5BCF4E73-1735-4108-BCE8-31C0FE35B30B}"/>
               </a:ext>
             </a:extLst>
           </p:cNvPr>
@@ -13125,7 +13125,7 @@
     </p:spTree>
     <p:extLst>
       <p:ext uri="{BB962C8B-B14F-4D97-AF65-F5344CB8AC3E}">
-        <p14:creationId xmlns:p14="http://schemas.microsoft.com/office/powerpoint/2010/main" val="1563051294"/>
+        <p14:creationId xmlns:p14="http://schemas.microsoft.com/office/powerpoint/2010/main" val="1140389926"/>
       </p:ext>
     </p:extLst>
   </p:cSld>
@@ -13156,7 +13156,7 @@
           <p:cNvPr id="20" name="side-accent-2">
             <a:extLst xmlns:a="http://schemas.openxmlformats.org/drawingml/2006/main">
               <a:ext uri="{FF2B5EF4-FFF2-40B4-BE49-F238E27FC236}">
-                <a16:creationId xmlns:a16="http://schemas.microsoft.com/office/drawing/2014/main" id="{9332EC01-06D2-4E39-8917-C2352B2E3AD7}"/>
+                <a16:creationId xmlns:a16="http://schemas.microsoft.com/office/drawing/2014/main" id="{69832A42-1576-4CF4-8830-89E4B3722902}"/>
               </a:ext>
             </a:extLst>
           </p:cNvPr>
@@ -13187,7 +13187,7 @@
           <p:cNvPr id="2" name="kicker-2">
             <a:extLst xmlns:a="http://schemas.openxmlformats.org/drawingml/2006/main">
               <a:ext uri="{FF2B5EF4-FFF2-40B4-BE49-F238E27FC236}">
-                <a16:creationId xmlns:a16="http://schemas.microsoft.com/office/drawing/2014/main" id="{674C4074-8954-4645-ABA1-0F01498C3603}"/>
+                <a16:creationId xmlns:a16="http://schemas.microsoft.com/office/drawing/2014/main" id="{DE1E720B-18B1-41D3-953B-C453114E0948}"/>
               </a:ext>
             </a:extLst>
           </p:cNvPr>
@@ -13249,7 +13249,7 @@
           <p:cNvPr id="3" name="title-2">
             <a:extLst xmlns:a="http://schemas.openxmlformats.org/drawingml/2006/main">
               <a:ext uri="{FF2B5EF4-FFF2-40B4-BE49-F238E27FC236}">
-                <a16:creationId xmlns:a16="http://schemas.microsoft.com/office/drawing/2014/main" id="{D0B222E7-3744-421D-9B07-6E0895FD08B0}"/>
+                <a16:creationId xmlns:a16="http://schemas.microsoft.com/office/drawing/2014/main" id="{D88EFE35-E163-403B-8F27-5B5A9A406862}"/>
               </a:ext>
             </a:extLst>
           </p:cNvPr>
@@ -13311,7 +13311,7 @@
           <p:cNvPr id="4" name="">
             <a:extLst xmlns:a="http://schemas.openxmlformats.org/drawingml/2006/main">
               <a:ext uri="{FF2B5EF4-FFF2-40B4-BE49-F238E27FC236}">
-                <a16:creationId xmlns:a16="http://schemas.microsoft.com/office/drawing/2014/main" id="{4C295794-D3AC-4E04-866D-0259078EE520}"/>
+                <a16:creationId xmlns:a16="http://schemas.microsoft.com/office/drawing/2014/main" id="{C958171D-E332-47BA-A936-5B8B3BB2AD2E}"/>
               </a:ext>
             </a:extLst>
           </p:cNvPr>
@@ -13373,7 +13373,7 @@
           <p:cNvPr id="5" name="">
             <a:extLst xmlns:a="http://schemas.openxmlformats.org/drawingml/2006/main">
               <a:ext uri="{FF2B5EF4-FFF2-40B4-BE49-F238E27FC236}">
-                <a16:creationId xmlns:a16="http://schemas.microsoft.com/office/drawing/2014/main" id="{471B03C3-F25E-4546-AF96-44825037162D}"/>
+                <a16:creationId xmlns:a16="http://schemas.microsoft.com/office/drawing/2014/main" id="{0801F9C8-370E-4AA4-A9B9-1AC7B68B4CB6}"/>
               </a:ext>
             </a:extLst>
           </p:cNvPr>
@@ -13435,7 +13435,7 @@
           <p:cNvPr id="6" name="">
             <a:extLst xmlns:a="http://schemas.openxmlformats.org/drawingml/2006/main">
               <a:ext uri="{FF2B5EF4-FFF2-40B4-BE49-F238E27FC236}">
-                <a16:creationId xmlns:a16="http://schemas.microsoft.com/office/drawing/2014/main" id="{9479F327-EB47-4A55-9834-7063B163F527}"/>
+                <a16:creationId xmlns:a16="http://schemas.microsoft.com/office/drawing/2014/main" id="{83288E8A-9A11-4ACE-924B-A028F59A4007}"/>
               </a:ext>
             </a:extLst>
           </p:cNvPr>
@@ -13466,7 +13466,7 @@
           <p:cNvPr id="7" name="">
             <a:extLst xmlns:a="http://schemas.openxmlformats.org/drawingml/2006/main">
               <a:ext uri="{FF2B5EF4-FFF2-40B4-BE49-F238E27FC236}">
-                <a16:creationId xmlns:a16="http://schemas.microsoft.com/office/drawing/2014/main" id="{5F2A01BD-4446-493C-AA65-CAEA9ABFA003}"/>
+                <a16:creationId xmlns:a16="http://schemas.microsoft.com/office/drawing/2014/main" id="{82AA0F53-C5AA-4B04-A1D2-AB69D2DBC4A6}"/>
               </a:ext>
             </a:extLst>
           </p:cNvPr>
@@ -13528,7 +13528,7 @@
           <p:cNvPr id="8" name="">
             <a:extLst xmlns:a="http://schemas.openxmlformats.org/drawingml/2006/main">
               <a:ext uri="{FF2B5EF4-FFF2-40B4-BE49-F238E27FC236}">
-                <a16:creationId xmlns:a16="http://schemas.microsoft.com/office/drawing/2014/main" id="{EF5DFB0C-9A7B-4B9D-8F0C-85363024B74F}"/>
+                <a16:creationId xmlns:a16="http://schemas.microsoft.com/office/drawing/2014/main" id="{26CE0FC8-7421-4F85-978C-5ECECBA02DF0}"/>
               </a:ext>
             </a:extLst>
           </p:cNvPr>
@@ -13590,7 +13590,7 @@
           <p:cNvPr id="9" name="">
             <a:extLst xmlns:a="http://schemas.openxmlformats.org/drawingml/2006/main">
               <a:ext uri="{FF2B5EF4-FFF2-40B4-BE49-F238E27FC236}">
-                <a16:creationId xmlns:a16="http://schemas.microsoft.com/office/drawing/2014/main" id="{23F89A4C-CB5F-4756-AF56-7F4E17A833C3}"/>
+                <a16:creationId xmlns:a16="http://schemas.microsoft.com/office/drawing/2014/main" id="{80FBFA47-EF61-4070-A37B-C0AFA027FBCD}"/>
               </a:ext>
             </a:extLst>
           </p:cNvPr>
@@ -13621,7 +13621,7 @@
           <p:cNvPr id="10" name="">
             <a:extLst xmlns:a="http://schemas.openxmlformats.org/drawingml/2006/main">
               <a:ext uri="{FF2B5EF4-FFF2-40B4-BE49-F238E27FC236}">
-                <a16:creationId xmlns:a16="http://schemas.microsoft.com/office/drawing/2014/main" id="{92A6D56A-F588-4786-8243-03210D7580D1}"/>
+                <a16:creationId xmlns:a16="http://schemas.microsoft.com/office/drawing/2014/main" id="{6AF3F4F4-69F6-47AF-B5C0-1F5567063BA5}"/>
               </a:ext>
             </a:extLst>
           </p:cNvPr>
@@ -13683,7 +13683,7 @@
           <p:cNvPr id="11" name="">
             <a:extLst xmlns:a="http://schemas.openxmlformats.org/drawingml/2006/main">
               <a:ext uri="{FF2B5EF4-FFF2-40B4-BE49-F238E27FC236}">
-                <a16:creationId xmlns:a16="http://schemas.microsoft.com/office/drawing/2014/main" id="{AD34C66E-93C3-4767-814E-AE40D4364214}"/>
+                <a16:creationId xmlns:a16="http://schemas.microsoft.com/office/drawing/2014/main" id="{AFC63D7B-3A39-431C-8E74-FAC0BBABB33E}"/>
               </a:ext>
             </a:extLst>
           </p:cNvPr>
@@ -13745,7 +13745,7 @@
           <p:cNvPr id="12" name="">
             <a:extLst xmlns:a="http://schemas.openxmlformats.org/drawingml/2006/main">
               <a:ext uri="{FF2B5EF4-FFF2-40B4-BE49-F238E27FC236}">
-                <a16:creationId xmlns:a16="http://schemas.microsoft.com/office/drawing/2014/main" id="{ACD7D337-2921-4DA1-9D08-EECD3C521741}"/>
+                <a16:creationId xmlns:a16="http://schemas.microsoft.com/office/drawing/2014/main" id="{E52A1D06-DD9D-4C38-831E-BCB25A0717EB}"/>
               </a:ext>
             </a:extLst>
           </p:cNvPr>
@@ -13776,7 +13776,7 @@
           <p:cNvPr id="13" name="">
             <a:extLst xmlns:a="http://schemas.openxmlformats.org/drawingml/2006/main">
               <a:ext uri="{FF2B5EF4-FFF2-40B4-BE49-F238E27FC236}">
-                <a16:creationId xmlns:a16="http://schemas.microsoft.com/office/drawing/2014/main" id="{BA4453CC-6C6D-4328-970D-2A3036911590}"/>
+                <a16:creationId xmlns:a16="http://schemas.microsoft.com/office/drawing/2014/main" id="{F979027C-5270-4D53-8B59-074A6890526B}"/>
               </a:ext>
             </a:extLst>
           </p:cNvPr>
@@ -13838,7 +13838,7 @@
           <p:cNvPr id="14" name="outcome-mark">
             <a:extLst xmlns:a="http://schemas.openxmlformats.org/drawingml/2006/main">
               <a:ext uri="{FF2B5EF4-FFF2-40B4-BE49-F238E27FC236}">
-                <a16:creationId xmlns:a16="http://schemas.microsoft.com/office/drawing/2014/main" id="{152BFBF4-AD87-494A-B840-3E61E0E80FA4}"/>
+                <a16:creationId xmlns:a16="http://schemas.microsoft.com/office/drawing/2014/main" id="{08DFD324-0EFF-4BFF-9867-37AD435EC0D6}"/>
               </a:ext>
             </a:extLst>
           </p:cNvPr>
@@ -13873,7 +13873,7 @@
           <p:cNvPr id="15" name="">
             <a:extLst xmlns:a="http://schemas.openxmlformats.org/drawingml/2006/main">
               <a:ext uri="{FF2B5EF4-FFF2-40B4-BE49-F238E27FC236}">
-                <a16:creationId xmlns:a16="http://schemas.microsoft.com/office/drawing/2014/main" id="{9F75476D-3434-4D84-A466-0A8E7B40DD61}"/>
+                <a16:creationId xmlns:a16="http://schemas.microsoft.com/office/drawing/2014/main" id="{B19635E9-EC8A-4F34-AC5D-649247B15DD6}"/>
               </a:ext>
             </a:extLst>
           </p:cNvPr>
@@ -13935,7 +13935,7 @@
           <p:cNvPr id="16" name="">
             <a:extLst xmlns:a="http://schemas.openxmlformats.org/drawingml/2006/main">
               <a:ext uri="{FF2B5EF4-FFF2-40B4-BE49-F238E27FC236}">
-                <a16:creationId xmlns:a16="http://schemas.microsoft.com/office/drawing/2014/main" id="{7BA54EFF-D78F-4E11-87D4-9DD4BA4CF5E1}"/>
+                <a16:creationId xmlns:a16="http://schemas.microsoft.com/office/drawing/2014/main" id="{120231D1-76C0-412F-97A0-BB5DA05EA050}"/>
               </a:ext>
             </a:extLst>
           </p:cNvPr>
@@ -14024,7 +14024,7 @@
           <p:cNvPr id="17" name="footer-rule-2">
             <a:extLst xmlns:a="http://schemas.openxmlformats.org/drawingml/2006/main">
               <a:ext uri="{FF2B5EF4-FFF2-40B4-BE49-F238E27FC236}">
-                <a16:creationId xmlns:a16="http://schemas.microsoft.com/office/drawing/2014/main" id="{BEED8F76-B1FD-40B3-BA1B-2FE7D61AC556}"/>
+                <a16:creationId xmlns:a16="http://schemas.microsoft.com/office/drawing/2014/main" id="{08DC8ADB-8835-4BE9-BA51-3962D2FEE0F6}"/>
               </a:ext>
             </a:extLst>
           </p:cNvPr>
@@ -14055,7 +14055,7 @@
           <p:cNvPr id="18" name="footer-label-2">
             <a:extLst xmlns:a="http://schemas.openxmlformats.org/drawingml/2006/main">
               <a:ext uri="{FF2B5EF4-FFF2-40B4-BE49-F238E27FC236}">
-                <a16:creationId xmlns:a16="http://schemas.microsoft.com/office/drawing/2014/main" id="{D1C96599-2204-437D-84C7-408E33DF69A3}"/>
+                <a16:creationId xmlns:a16="http://schemas.microsoft.com/office/drawing/2014/main" id="{D4A20EB2-0337-4BB3-A192-A3B7AD3F39FB}"/>
               </a:ext>
             </a:extLst>
           </p:cNvPr>
@@ -14117,7 +14117,7 @@
           <p:cNvPr id="19" name="footer-page-2">
             <a:extLst xmlns:a="http://schemas.openxmlformats.org/drawingml/2006/main">
               <a:ext uri="{FF2B5EF4-FFF2-40B4-BE49-F238E27FC236}">
-                <a16:creationId xmlns:a16="http://schemas.microsoft.com/office/drawing/2014/main" id="{B77811F2-33C3-48BA-840F-E857B74AE349}"/>
+                <a16:creationId xmlns:a16="http://schemas.microsoft.com/office/drawing/2014/main" id="{A48051B9-4BD5-471C-8D5C-2775CDA6FA0A}"/>
               </a:ext>
             </a:extLst>
           </p:cNvPr>
@@ -14177,7 +14177,7 @@
     </p:spTree>
     <p:extLst>
       <p:ext uri="{BB962C8B-B14F-4D97-AF65-F5344CB8AC3E}">
-        <p14:creationId xmlns:p14="http://schemas.microsoft.com/office/powerpoint/2010/main" val="1724612114"/>
+        <p14:creationId xmlns:p14="http://schemas.microsoft.com/office/powerpoint/2010/main" val="2142908979"/>
       </p:ext>
     </p:extLst>
   </p:cSld>
@@ -14208,7 +14208,7 @@
           <p:cNvPr id="31" name="side-accent-3">
             <a:extLst xmlns:a="http://schemas.openxmlformats.org/drawingml/2006/main">
               <a:ext uri="{FF2B5EF4-FFF2-40B4-BE49-F238E27FC236}">
-                <a16:creationId xmlns:a16="http://schemas.microsoft.com/office/drawing/2014/main" id="{D61C985E-CCFE-4EC1-A16A-AE3613F7084A}"/>
+                <a16:creationId xmlns:a16="http://schemas.microsoft.com/office/drawing/2014/main" id="{E319DFCC-41AF-4734-8793-C99BD37C48F4}"/>
               </a:ext>
             </a:extLst>
           </p:cNvPr>
@@ -14239,7 +14239,7 @@
           <p:cNvPr id="2" name="kicker-3">
             <a:extLst xmlns:a="http://schemas.openxmlformats.org/drawingml/2006/main">
               <a:ext uri="{FF2B5EF4-FFF2-40B4-BE49-F238E27FC236}">
-                <a16:creationId xmlns:a16="http://schemas.microsoft.com/office/drawing/2014/main" id="{27FC400C-EB2A-4DBB-85D7-FD3EC247D852}"/>
+                <a16:creationId xmlns:a16="http://schemas.microsoft.com/office/drawing/2014/main" id="{9FA018E2-8405-47D9-8E8A-76F8B9EDD958}"/>
               </a:ext>
             </a:extLst>
           </p:cNvPr>
@@ -14301,7 +14301,7 @@
           <p:cNvPr id="3" name="title-3">
             <a:extLst xmlns:a="http://schemas.openxmlformats.org/drawingml/2006/main">
               <a:ext uri="{FF2B5EF4-FFF2-40B4-BE49-F238E27FC236}">
-                <a16:creationId xmlns:a16="http://schemas.microsoft.com/office/drawing/2014/main" id="{F1D6536C-056F-4FBA-BB0D-DE4DDF0A4C91}"/>
+                <a16:creationId xmlns:a16="http://schemas.microsoft.com/office/drawing/2014/main" id="{92A3D680-277B-4AC8-9500-7849C439F555}"/>
               </a:ext>
             </a:extLst>
           </p:cNvPr>
@@ -14363,7 +14363,7 @@
           <p:cNvPr id="4" name="">
             <a:extLst xmlns:a="http://schemas.openxmlformats.org/drawingml/2006/main">
               <a:ext uri="{FF2B5EF4-FFF2-40B4-BE49-F238E27FC236}">
-                <a16:creationId xmlns:a16="http://schemas.microsoft.com/office/drawing/2014/main" id="{31074998-3697-4006-AFBA-D934B53D42BF}"/>
+                <a16:creationId xmlns:a16="http://schemas.microsoft.com/office/drawing/2014/main" id="{08B2F3D1-1FFD-47C0-BCA3-CDB233D02E69}"/>
               </a:ext>
             </a:extLst>
           </p:cNvPr>
@@ -14425,7 +14425,7 @@
           <p:cNvPr id="5" name="system-function-line">
             <a:extLst xmlns:a="http://schemas.openxmlformats.org/drawingml/2006/main">
               <a:ext uri="{FF2B5EF4-FFF2-40B4-BE49-F238E27FC236}">
-                <a16:creationId xmlns:a16="http://schemas.microsoft.com/office/drawing/2014/main" id="{41EDD8AD-FB3C-44F9-B41A-15B9DEF66DA5}"/>
+                <a16:creationId xmlns:a16="http://schemas.microsoft.com/office/drawing/2014/main" id="{804C54B6-D464-4127-AE57-B7C3D17189F5}"/>
               </a:ext>
             </a:extLst>
           </p:cNvPr>
@@ -14456,7 +14456,7 @@
           <p:cNvPr id="6" name="">
             <a:extLst xmlns:a="http://schemas.openxmlformats.org/drawingml/2006/main">
               <a:ext uri="{FF2B5EF4-FFF2-40B4-BE49-F238E27FC236}">
-                <a16:creationId xmlns:a16="http://schemas.microsoft.com/office/drawing/2014/main" id="{B97BE578-31A0-4D74-A90D-1CAEFA095E78}"/>
+                <a16:creationId xmlns:a16="http://schemas.microsoft.com/office/drawing/2014/main" id="{2B37D13C-D6C4-4538-AF82-450AB90E5227}"/>
               </a:ext>
             </a:extLst>
           </p:cNvPr>
@@ -14487,7 +14487,7 @@
           <p:cNvPr id="7" name="">
             <a:extLst xmlns:a="http://schemas.openxmlformats.org/drawingml/2006/main">
               <a:ext uri="{FF2B5EF4-FFF2-40B4-BE49-F238E27FC236}">
-                <a16:creationId xmlns:a16="http://schemas.microsoft.com/office/drawing/2014/main" id="{DFB57FF4-067C-4454-A797-E0606586C5F8}"/>
+                <a16:creationId xmlns:a16="http://schemas.microsoft.com/office/drawing/2014/main" id="{53EB65E9-29DA-4236-BB8F-6A3300B9D617}"/>
               </a:ext>
             </a:extLst>
           </p:cNvPr>
@@ -14549,7 +14549,7 @@
           <p:cNvPr id="8" name="">
             <a:extLst xmlns:a="http://schemas.openxmlformats.org/drawingml/2006/main">
               <a:ext uri="{FF2B5EF4-FFF2-40B4-BE49-F238E27FC236}">
-                <a16:creationId xmlns:a16="http://schemas.microsoft.com/office/drawing/2014/main" id="{AEA64692-A834-43B2-9735-ECFFFB285675}"/>
+                <a16:creationId xmlns:a16="http://schemas.microsoft.com/office/drawing/2014/main" id="{73DB0EE7-311F-4BEE-8F0B-76E4FBB740B7}"/>
               </a:ext>
             </a:extLst>
           </p:cNvPr>
@@ -14611,7 +14611,7 @@
           <p:cNvPr id="9" name="">
             <a:extLst xmlns:a="http://schemas.openxmlformats.org/drawingml/2006/main">
               <a:ext uri="{FF2B5EF4-FFF2-40B4-BE49-F238E27FC236}">
-                <a16:creationId xmlns:a16="http://schemas.microsoft.com/office/drawing/2014/main" id="{B896D765-CE47-49CE-95FA-7B2BE245B4F1}"/>
+                <a16:creationId xmlns:a16="http://schemas.microsoft.com/office/drawing/2014/main" id="{A9CAEAF8-7FD1-49DA-9869-622C3C822DCB}"/>
               </a:ext>
             </a:extLst>
           </p:cNvPr>
@@ -14673,7 +14673,7 @@
           <p:cNvPr id="10" name="">
             <a:extLst xmlns:a="http://schemas.openxmlformats.org/drawingml/2006/main">
               <a:ext uri="{FF2B5EF4-FFF2-40B4-BE49-F238E27FC236}">
-                <a16:creationId xmlns:a16="http://schemas.microsoft.com/office/drawing/2014/main" id="{168299F4-A9A5-4684-BAFC-C1248EB0B2F5}"/>
+                <a16:creationId xmlns:a16="http://schemas.microsoft.com/office/drawing/2014/main" id="{FEDA7F7C-9FC7-4899-B164-00211CCB9276}"/>
               </a:ext>
             </a:extLst>
           </p:cNvPr>
@@ -14704,7 +14704,7 @@
           <p:cNvPr id="11" name="">
             <a:extLst xmlns:a="http://schemas.openxmlformats.org/drawingml/2006/main">
               <a:ext uri="{FF2B5EF4-FFF2-40B4-BE49-F238E27FC236}">
-                <a16:creationId xmlns:a16="http://schemas.microsoft.com/office/drawing/2014/main" id="{1D6499C0-2556-40D0-8816-7ADEE01E01E7}"/>
+                <a16:creationId xmlns:a16="http://schemas.microsoft.com/office/drawing/2014/main" id="{3AE2870F-A93A-45AA-864A-74CFF848DB90}"/>
               </a:ext>
             </a:extLst>
           </p:cNvPr>
@@ -14766,7 +14766,7 @@
           <p:cNvPr id="12" name="">
             <a:extLst xmlns:a="http://schemas.openxmlformats.org/drawingml/2006/main">
               <a:ext uri="{FF2B5EF4-FFF2-40B4-BE49-F238E27FC236}">
-                <a16:creationId xmlns:a16="http://schemas.microsoft.com/office/drawing/2014/main" id="{07C9BC2F-29AA-413B-BFDF-454AD975165A}"/>
+                <a16:creationId xmlns:a16="http://schemas.microsoft.com/office/drawing/2014/main" id="{501F94A4-96ED-4355-BB3F-43D84622DF1A}"/>
               </a:ext>
             </a:extLst>
           </p:cNvPr>
@@ -14828,7 +14828,7 @@
           <p:cNvPr id="13" name="">
             <a:extLst xmlns:a="http://schemas.openxmlformats.org/drawingml/2006/main">
               <a:ext uri="{FF2B5EF4-FFF2-40B4-BE49-F238E27FC236}">
-                <a16:creationId xmlns:a16="http://schemas.microsoft.com/office/drawing/2014/main" id="{3DD2D9B7-E31D-4CF9-BADE-08B37E3B543F}"/>
+                <a16:creationId xmlns:a16="http://schemas.microsoft.com/office/drawing/2014/main" id="{A13004E6-BACC-4FB0-8BED-199058C92909}"/>
               </a:ext>
             </a:extLst>
           </p:cNvPr>
@@ -14890,7 +14890,7 @@
           <p:cNvPr id="14" name="">
             <a:extLst xmlns:a="http://schemas.openxmlformats.org/drawingml/2006/main">
               <a:ext uri="{FF2B5EF4-FFF2-40B4-BE49-F238E27FC236}">
-                <a16:creationId xmlns:a16="http://schemas.microsoft.com/office/drawing/2014/main" id="{056E15F2-F5FE-4CC7-AA64-C0766FDBD822}"/>
+                <a16:creationId xmlns:a16="http://schemas.microsoft.com/office/drawing/2014/main" id="{52E66C0C-98DC-4085-8775-81938AD06665}"/>
               </a:ext>
             </a:extLst>
           </p:cNvPr>
@@ -14921,7 +14921,7 @@
           <p:cNvPr id="15" name="">
             <a:extLst xmlns:a="http://schemas.openxmlformats.org/drawingml/2006/main">
               <a:ext uri="{FF2B5EF4-FFF2-40B4-BE49-F238E27FC236}">
-                <a16:creationId xmlns:a16="http://schemas.microsoft.com/office/drawing/2014/main" id="{7C0F84A0-C700-45AC-B8C2-92F11A20BF08}"/>
+                <a16:creationId xmlns:a16="http://schemas.microsoft.com/office/drawing/2014/main" id="{3123529F-F171-478D-94FD-E3316D481454}"/>
               </a:ext>
             </a:extLst>
           </p:cNvPr>
@@ -14983,7 +14983,7 @@
           <p:cNvPr id="16" name="">
             <a:extLst xmlns:a="http://schemas.openxmlformats.org/drawingml/2006/main">
               <a:ext uri="{FF2B5EF4-FFF2-40B4-BE49-F238E27FC236}">
-                <a16:creationId xmlns:a16="http://schemas.microsoft.com/office/drawing/2014/main" id="{BE850952-3641-4F73-A1E6-051EBCEF8591}"/>
+                <a16:creationId xmlns:a16="http://schemas.microsoft.com/office/drawing/2014/main" id="{9A6FE34D-840F-4FB7-9E56-2BD6D444CBA9}"/>
               </a:ext>
             </a:extLst>
           </p:cNvPr>
@@ -15045,7 +15045,7 @@
           <p:cNvPr id="17" name="">
             <a:extLst xmlns:a="http://schemas.openxmlformats.org/drawingml/2006/main">
               <a:ext uri="{FF2B5EF4-FFF2-40B4-BE49-F238E27FC236}">
-                <a16:creationId xmlns:a16="http://schemas.microsoft.com/office/drawing/2014/main" id="{2BAB14E6-06C5-4118-8400-29928E0EF3CD}"/>
+                <a16:creationId xmlns:a16="http://schemas.microsoft.com/office/drawing/2014/main" id="{3D54A52B-58E4-45EB-87EC-FFF8CCD7A22D}"/>
               </a:ext>
             </a:extLst>
           </p:cNvPr>
@@ -15107,7 +15107,7 @@
           <p:cNvPr id="18" name="">
             <a:extLst xmlns:a="http://schemas.openxmlformats.org/drawingml/2006/main">
               <a:ext uri="{FF2B5EF4-FFF2-40B4-BE49-F238E27FC236}">
-                <a16:creationId xmlns:a16="http://schemas.microsoft.com/office/drawing/2014/main" id="{22AB5F41-F6E6-430C-BE65-33FF54A2BF09}"/>
+                <a16:creationId xmlns:a16="http://schemas.microsoft.com/office/drawing/2014/main" id="{497E182B-145A-4694-BFE0-72C7A2C70F02}"/>
               </a:ext>
             </a:extLst>
           </p:cNvPr>
@@ -15138,7 +15138,7 @@
           <p:cNvPr id="19" name="">
             <a:extLst xmlns:a="http://schemas.openxmlformats.org/drawingml/2006/main">
               <a:ext uri="{FF2B5EF4-FFF2-40B4-BE49-F238E27FC236}">
-                <a16:creationId xmlns:a16="http://schemas.microsoft.com/office/drawing/2014/main" id="{AA54E6E6-7800-4748-BF3F-438757F232F5}"/>
+                <a16:creationId xmlns:a16="http://schemas.microsoft.com/office/drawing/2014/main" id="{8A4EE923-99F8-4674-A6D4-E6A9431763B4}"/>
               </a:ext>
             </a:extLst>
           </p:cNvPr>
@@ -15200,7 +15200,7 @@
           <p:cNvPr id="20" name="">
             <a:extLst xmlns:a="http://schemas.openxmlformats.org/drawingml/2006/main">
               <a:ext uri="{FF2B5EF4-FFF2-40B4-BE49-F238E27FC236}">
-                <a16:creationId xmlns:a16="http://schemas.microsoft.com/office/drawing/2014/main" id="{52AD6644-66CB-4178-9DF7-A3C804A90CDB}"/>
+                <a16:creationId xmlns:a16="http://schemas.microsoft.com/office/drawing/2014/main" id="{CCC8B402-D913-4F58-93FD-8E065F356BE6}"/>
               </a:ext>
             </a:extLst>
           </p:cNvPr>
@@ -15262,7 +15262,7 @@
           <p:cNvPr id="21" name="">
             <a:extLst xmlns:a="http://schemas.openxmlformats.org/drawingml/2006/main">
               <a:ext uri="{FF2B5EF4-FFF2-40B4-BE49-F238E27FC236}">
-                <a16:creationId xmlns:a16="http://schemas.microsoft.com/office/drawing/2014/main" id="{20992086-F462-4947-913D-C64ACEDF0B31}"/>
+                <a16:creationId xmlns:a16="http://schemas.microsoft.com/office/drawing/2014/main" id="{3A86D0D6-C4E6-49E8-842E-A041D15D7053}"/>
               </a:ext>
             </a:extLst>
           </p:cNvPr>
@@ -15324,7 +15324,7 @@
           <p:cNvPr id="22" name="">
             <a:extLst xmlns:a="http://schemas.openxmlformats.org/drawingml/2006/main">
               <a:ext uri="{FF2B5EF4-FFF2-40B4-BE49-F238E27FC236}">
-                <a16:creationId xmlns:a16="http://schemas.microsoft.com/office/drawing/2014/main" id="{7D0C59CC-6F38-421D-8DA7-75182E84042F}"/>
+                <a16:creationId xmlns:a16="http://schemas.microsoft.com/office/drawing/2014/main" id="{A274698B-5C8C-47AC-9F97-21850C12E053}"/>
               </a:ext>
             </a:extLst>
           </p:cNvPr>
@@ -15355,7 +15355,7 @@
           <p:cNvPr id="23" name="">
             <a:extLst xmlns:a="http://schemas.openxmlformats.org/drawingml/2006/main">
               <a:ext uri="{FF2B5EF4-FFF2-40B4-BE49-F238E27FC236}">
-                <a16:creationId xmlns:a16="http://schemas.microsoft.com/office/drawing/2014/main" id="{81261C94-4683-4175-92F8-B9988B862AC6}"/>
+                <a16:creationId xmlns:a16="http://schemas.microsoft.com/office/drawing/2014/main" id="{9211D4F2-D847-47B4-AD8B-C5BA955FF7BF}"/>
               </a:ext>
             </a:extLst>
           </p:cNvPr>
@@ -15417,7 +15417,7 @@
           <p:cNvPr id="24" name="">
             <a:extLst xmlns:a="http://schemas.openxmlformats.org/drawingml/2006/main">
               <a:ext uri="{FF2B5EF4-FFF2-40B4-BE49-F238E27FC236}">
-                <a16:creationId xmlns:a16="http://schemas.microsoft.com/office/drawing/2014/main" id="{D294DC47-2868-422B-9CFF-D176C0AC754F}"/>
+                <a16:creationId xmlns:a16="http://schemas.microsoft.com/office/drawing/2014/main" id="{3C80EB5B-1B38-42BA-94DE-4D299198637F}"/>
               </a:ext>
             </a:extLst>
           </p:cNvPr>
@@ -15479,7 +15479,7 @@
           <p:cNvPr id="25" name="">
             <a:extLst xmlns:a="http://schemas.openxmlformats.org/drawingml/2006/main">
               <a:ext uri="{FF2B5EF4-FFF2-40B4-BE49-F238E27FC236}">
-                <a16:creationId xmlns:a16="http://schemas.microsoft.com/office/drawing/2014/main" id="{CDE2405E-D5C8-4977-BA42-38B5F15AA7C4}"/>
+                <a16:creationId xmlns:a16="http://schemas.microsoft.com/office/drawing/2014/main" id="{4775F8D6-9820-49CF-BEB1-CEE887C7C5CE}"/>
               </a:ext>
             </a:extLst>
           </p:cNvPr>
@@ -15541,7 +15541,7 @@
           <p:cNvPr id="26" name="">
             <a:extLst xmlns:a="http://schemas.openxmlformats.org/drawingml/2006/main">
               <a:ext uri="{FF2B5EF4-FFF2-40B4-BE49-F238E27FC236}">
-                <a16:creationId xmlns:a16="http://schemas.microsoft.com/office/drawing/2014/main" id="{4B64FE83-303B-40EF-801E-B5D35D2D1546}"/>
+                <a16:creationId xmlns:a16="http://schemas.microsoft.com/office/drawing/2014/main" id="{4B912E60-0A82-4275-A654-D443D40938F7}"/>
               </a:ext>
             </a:extLst>
           </p:cNvPr>
@@ -15574,7 +15574,7 @@
           <p:cNvPr id="27" name="">
             <a:extLst xmlns:a="http://schemas.openxmlformats.org/drawingml/2006/main">
               <a:ext uri="{FF2B5EF4-FFF2-40B4-BE49-F238E27FC236}">
-                <a16:creationId xmlns:a16="http://schemas.microsoft.com/office/drawing/2014/main" id="{9DF6B230-E751-484D-99F7-615C7A4BAFF6}"/>
+                <a16:creationId xmlns:a16="http://schemas.microsoft.com/office/drawing/2014/main" id="{E7E52375-5B1C-4715-98FA-DC8A35D03C42}"/>
               </a:ext>
             </a:extLst>
           </p:cNvPr>
@@ -15636,7 +15636,7 @@
           <p:cNvPr id="28" name="footer-rule-3">
             <a:extLst xmlns:a="http://schemas.openxmlformats.org/drawingml/2006/main">
               <a:ext uri="{FF2B5EF4-FFF2-40B4-BE49-F238E27FC236}">
-                <a16:creationId xmlns:a16="http://schemas.microsoft.com/office/drawing/2014/main" id="{1C11A256-F3B3-4B40-AA1D-1B9D3C569179}"/>
+                <a16:creationId xmlns:a16="http://schemas.microsoft.com/office/drawing/2014/main" id="{DEB47926-6FDF-4824-8D95-B838DAF9007E}"/>
               </a:ext>
             </a:extLst>
           </p:cNvPr>
@@ -15667,7 +15667,7 @@
           <p:cNvPr id="29" name="footer-label-3">
             <a:extLst xmlns:a="http://schemas.openxmlformats.org/drawingml/2006/main">
               <a:ext uri="{FF2B5EF4-FFF2-40B4-BE49-F238E27FC236}">
-                <a16:creationId xmlns:a16="http://schemas.microsoft.com/office/drawing/2014/main" id="{60FB5FD7-F688-46AA-A68B-73AFACAF6E35}"/>
+                <a16:creationId xmlns:a16="http://schemas.microsoft.com/office/drawing/2014/main" id="{27306F08-C7C0-4257-8605-4A43CE0DFB87}"/>
               </a:ext>
             </a:extLst>
           </p:cNvPr>
@@ -15729,7 +15729,7 @@
           <p:cNvPr id="30" name="footer-page-3">
             <a:extLst xmlns:a="http://schemas.openxmlformats.org/drawingml/2006/main">
               <a:ext uri="{FF2B5EF4-FFF2-40B4-BE49-F238E27FC236}">
-                <a16:creationId xmlns:a16="http://schemas.microsoft.com/office/drawing/2014/main" id="{B31B76F2-AF00-45C3-96CE-22110BA12479}"/>
+                <a16:creationId xmlns:a16="http://schemas.microsoft.com/office/drawing/2014/main" id="{3CDAF321-AFF0-4412-B6FD-D9FBFE589415}"/>
               </a:ext>
             </a:extLst>
           </p:cNvPr>
@@ -15789,7 +15789,7 @@
     </p:spTree>
     <p:extLst>
       <p:ext uri="{BB962C8B-B14F-4D97-AF65-F5344CB8AC3E}">
-        <p14:creationId xmlns:p14="http://schemas.microsoft.com/office/powerpoint/2010/main" val="130319284"/>
+        <p14:creationId xmlns:p14="http://schemas.microsoft.com/office/powerpoint/2010/main" val="65232191"/>
       </p:ext>
     </p:extLst>
   </p:cSld>
@@ -15820,7 +15820,7 @@
           <p:cNvPr id="28" name="side-accent-4">
             <a:extLst xmlns:a="http://schemas.openxmlformats.org/drawingml/2006/main">
               <a:ext uri="{FF2B5EF4-FFF2-40B4-BE49-F238E27FC236}">
-                <a16:creationId xmlns:a16="http://schemas.microsoft.com/office/drawing/2014/main" id="{7B42B271-6EC8-4EE8-ADAF-955715454641}"/>
+                <a16:creationId xmlns:a16="http://schemas.microsoft.com/office/drawing/2014/main" id="{D31499DD-2820-4848-8992-01D95EECFC92}"/>
               </a:ext>
             </a:extLst>
           </p:cNvPr>
@@ -15851,7 +15851,7 @@
           <p:cNvPr id="2" name="kicker-4">
             <a:extLst xmlns:a="http://schemas.openxmlformats.org/drawingml/2006/main">
               <a:ext uri="{FF2B5EF4-FFF2-40B4-BE49-F238E27FC236}">
-                <a16:creationId xmlns:a16="http://schemas.microsoft.com/office/drawing/2014/main" id="{44AEF445-226E-4879-9CEC-FBE6E7C571E1}"/>
+                <a16:creationId xmlns:a16="http://schemas.microsoft.com/office/drawing/2014/main" id="{7503136E-0878-4669-89A0-0B793E747227}"/>
               </a:ext>
             </a:extLst>
           </p:cNvPr>
@@ -15913,7 +15913,7 @@
           <p:cNvPr id="3" name="title-4">
             <a:extLst xmlns:a="http://schemas.openxmlformats.org/drawingml/2006/main">
               <a:ext uri="{FF2B5EF4-FFF2-40B4-BE49-F238E27FC236}">
-                <a16:creationId xmlns:a16="http://schemas.microsoft.com/office/drawing/2014/main" id="{51778203-E848-4C42-B23B-29EABA9755A1}"/>
+                <a16:creationId xmlns:a16="http://schemas.microsoft.com/office/drawing/2014/main" id="{FB179923-5B99-44CA-BDE4-8E8FB59E6943}"/>
               </a:ext>
             </a:extLst>
           </p:cNvPr>
@@ -15975,7 +15975,7 @@
           <p:cNvPr id="4" name="">
             <a:extLst xmlns:a="http://schemas.openxmlformats.org/drawingml/2006/main">
               <a:ext uri="{FF2B5EF4-FFF2-40B4-BE49-F238E27FC236}">
-                <a16:creationId xmlns:a16="http://schemas.microsoft.com/office/drawing/2014/main" id="{EF41F879-5B9F-4FB6-B162-B7151C01088A}"/>
+                <a16:creationId xmlns:a16="http://schemas.microsoft.com/office/drawing/2014/main" id="{25DAD468-B67A-4BF9-B2B6-923181B359A2}"/>
               </a:ext>
             </a:extLst>
           </p:cNvPr>
@@ -16037,7 +16037,7 @@
           <p:cNvPr id="5" name="">
             <a:extLst xmlns:a="http://schemas.openxmlformats.org/drawingml/2006/main">
               <a:ext uri="{FF2B5EF4-FFF2-40B4-BE49-F238E27FC236}">
-                <a16:creationId xmlns:a16="http://schemas.microsoft.com/office/drawing/2014/main" id="{C15E0BC2-35D3-4648-9290-46C88967D9F8}"/>
+                <a16:creationId xmlns:a16="http://schemas.microsoft.com/office/drawing/2014/main" id="{973CF169-4758-4B71-96BC-32D11B04595B}"/>
               </a:ext>
             </a:extLst>
           </p:cNvPr>
@@ -16099,7 +16099,7 @@
           <p:cNvPr id="6" name="">
             <a:extLst xmlns:a="http://schemas.openxmlformats.org/drawingml/2006/main">
               <a:ext uri="{FF2B5EF4-FFF2-40B4-BE49-F238E27FC236}">
-                <a16:creationId xmlns:a16="http://schemas.microsoft.com/office/drawing/2014/main" id="{A20734C7-0CD1-4871-A8EE-A01F50605869}"/>
+                <a16:creationId xmlns:a16="http://schemas.microsoft.com/office/drawing/2014/main" id="{5CE8E667-EB23-4412-95F2-280CF4D598B5}"/>
               </a:ext>
             </a:extLst>
           </p:cNvPr>
@@ -16161,7 +16161,7 @@
           <p:cNvPr id="7" name="">
             <a:extLst xmlns:a="http://schemas.openxmlformats.org/drawingml/2006/main">
               <a:ext uri="{FF2B5EF4-FFF2-40B4-BE49-F238E27FC236}">
-                <a16:creationId xmlns:a16="http://schemas.microsoft.com/office/drawing/2014/main" id="{E5ACD655-2285-4AC9-9C97-9294CD1C4EFD}"/>
+                <a16:creationId xmlns:a16="http://schemas.microsoft.com/office/drawing/2014/main" id="{A5ACE70B-FF82-48F7-8F2D-E02A53D8A802}"/>
               </a:ext>
             </a:extLst>
           </p:cNvPr>
@@ -16192,7 +16192,7 @@
           <p:cNvPr id="8" name="">
             <a:extLst xmlns:a="http://schemas.openxmlformats.org/drawingml/2006/main">
               <a:ext uri="{FF2B5EF4-FFF2-40B4-BE49-F238E27FC236}">
-                <a16:creationId xmlns:a16="http://schemas.microsoft.com/office/drawing/2014/main" id="{074F8046-AFB0-42E4-BF79-1B5F76D9C568}"/>
+                <a16:creationId xmlns:a16="http://schemas.microsoft.com/office/drawing/2014/main" id="{B55F37DB-2B94-4C43-82A3-A15409023DE6}"/>
               </a:ext>
             </a:extLst>
           </p:cNvPr>
@@ -16254,7 +16254,7 @@
           <p:cNvPr id="9" name="">
             <a:extLst xmlns:a="http://schemas.openxmlformats.org/drawingml/2006/main">
               <a:ext uri="{FF2B5EF4-FFF2-40B4-BE49-F238E27FC236}">
-                <a16:creationId xmlns:a16="http://schemas.microsoft.com/office/drawing/2014/main" id="{B288753E-7F7D-460A-A590-884C54FD37C4}"/>
+                <a16:creationId xmlns:a16="http://schemas.microsoft.com/office/drawing/2014/main" id="{69A7BA28-E7CC-49EE-8CB1-6911AE4C69D7}"/>
               </a:ext>
             </a:extLst>
           </p:cNvPr>
@@ -16316,7 +16316,7 @@
           <p:cNvPr id="10" name="">
             <a:extLst xmlns:a="http://schemas.openxmlformats.org/drawingml/2006/main">
               <a:ext uri="{FF2B5EF4-FFF2-40B4-BE49-F238E27FC236}">
-                <a16:creationId xmlns:a16="http://schemas.microsoft.com/office/drawing/2014/main" id="{20EE1C79-1633-44CE-8E1D-18F851CA87E5}"/>
+                <a16:creationId xmlns:a16="http://schemas.microsoft.com/office/drawing/2014/main" id="{435ACFD9-BBB5-406A-AA01-41077D1ABDC7}"/>
               </a:ext>
             </a:extLst>
           </p:cNvPr>
@@ -16378,7 +16378,7 @@
           <p:cNvPr id="11" name="">
             <a:extLst xmlns:a="http://schemas.openxmlformats.org/drawingml/2006/main">
               <a:ext uri="{FF2B5EF4-FFF2-40B4-BE49-F238E27FC236}">
-                <a16:creationId xmlns:a16="http://schemas.microsoft.com/office/drawing/2014/main" id="{95EE5BE2-C506-4D43-9DEB-E3D541BAEF3F}"/>
+                <a16:creationId xmlns:a16="http://schemas.microsoft.com/office/drawing/2014/main" id="{D7454B77-D71A-4443-A346-BED7D3E81331}"/>
               </a:ext>
             </a:extLst>
           </p:cNvPr>
@@ -16409,7 +16409,7 @@
           <p:cNvPr id="12" name="">
             <a:extLst xmlns:a="http://schemas.openxmlformats.org/drawingml/2006/main">
               <a:ext uri="{FF2B5EF4-FFF2-40B4-BE49-F238E27FC236}">
-                <a16:creationId xmlns:a16="http://schemas.microsoft.com/office/drawing/2014/main" id="{0D2014AA-BF02-4FCF-A57A-9E8D0E443FFF}"/>
+                <a16:creationId xmlns:a16="http://schemas.microsoft.com/office/drawing/2014/main" id="{21A62FB8-5842-4836-B056-A9A3FFCB4BE6}"/>
               </a:ext>
             </a:extLst>
           </p:cNvPr>
@@ -16471,7 +16471,7 @@
           <p:cNvPr id="13" name="">
             <a:extLst xmlns:a="http://schemas.openxmlformats.org/drawingml/2006/main">
               <a:ext uri="{FF2B5EF4-FFF2-40B4-BE49-F238E27FC236}">
-                <a16:creationId xmlns:a16="http://schemas.microsoft.com/office/drawing/2014/main" id="{38BE669F-FF6E-425C-99FC-C7DDE33A0333}"/>
+                <a16:creationId xmlns:a16="http://schemas.microsoft.com/office/drawing/2014/main" id="{3A0781C9-43EE-4570-8F84-DC101AD5DA0D}"/>
               </a:ext>
             </a:extLst>
           </p:cNvPr>
@@ -16533,7 +16533,7 @@
           <p:cNvPr id="14" name="">
             <a:extLst xmlns:a="http://schemas.openxmlformats.org/drawingml/2006/main">
               <a:ext uri="{FF2B5EF4-FFF2-40B4-BE49-F238E27FC236}">
-                <a16:creationId xmlns:a16="http://schemas.microsoft.com/office/drawing/2014/main" id="{2E1CF12B-0130-4AFD-AD87-2613D42E1C50}"/>
+                <a16:creationId xmlns:a16="http://schemas.microsoft.com/office/drawing/2014/main" id="{8CD4B94A-1AB8-4FE3-AEC4-60C82FE96C4B}"/>
               </a:ext>
             </a:extLst>
           </p:cNvPr>
@@ -16595,7 +16595,7 @@
           <p:cNvPr id="15" name="">
             <a:extLst xmlns:a="http://schemas.openxmlformats.org/drawingml/2006/main">
               <a:ext uri="{FF2B5EF4-FFF2-40B4-BE49-F238E27FC236}">
-                <a16:creationId xmlns:a16="http://schemas.microsoft.com/office/drawing/2014/main" id="{F52E6C6D-3702-4FD9-AEA7-093ECE1D321D}"/>
+                <a16:creationId xmlns:a16="http://schemas.microsoft.com/office/drawing/2014/main" id="{C7A56E49-7B1D-4B10-A986-E4E0838D7ACF}"/>
               </a:ext>
             </a:extLst>
           </p:cNvPr>
@@ -16626,7 +16626,7 @@
           <p:cNvPr id="16" name="">
             <a:extLst xmlns:a="http://schemas.openxmlformats.org/drawingml/2006/main">
               <a:ext uri="{FF2B5EF4-FFF2-40B4-BE49-F238E27FC236}">
-                <a16:creationId xmlns:a16="http://schemas.microsoft.com/office/drawing/2014/main" id="{5EDEBB25-9796-4568-B45B-29413866D007}"/>
+                <a16:creationId xmlns:a16="http://schemas.microsoft.com/office/drawing/2014/main" id="{F9DC74C6-116A-48B5-8D09-0DD6A00A451A}"/>
               </a:ext>
             </a:extLst>
           </p:cNvPr>
@@ -16688,7 +16688,7 @@
           <p:cNvPr id="17" name="">
             <a:extLst xmlns:a="http://schemas.openxmlformats.org/drawingml/2006/main">
               <a:ext uri="{FF2B5EF4-FFF2-40B4-BE49-F238E27FC236}">
-                <a16:creationId xmlns:a16="http://schemas.microsoft.com/office/drawing/2014/main" id="{F40F2E17-894A-4CAA-B3F2-663A1ED522BE}"/>
+                <a16:creationId xmlns:a16="http://schemas.microsoft.com/office/drawing/2014/main" id="{67B3EC37-4C7A-4F22-9FF2-162EA05C8E86}"/>
               </a:ext>
             </a:extLst>
           </p:cNvPr>
@@ -16750,7 +16750,7 @@
           <p:cNvPr id="18" name="">
             <a:extLst xmlns:a="http://schemas.openxmlformats.org/drawingml/2006/main">
               <a:ext uri="{FF2B5EF4-FFF2-40B4-BE49-F238E27FC236}">
-                <a16:creationId xmlns:a16="http://schemas.microsoft.com/office/drawing/2014/main" id="{AD8F2097-E220-4B19-81F0-B57B2C004D6D}"/>
+                <a16:creationId xmlns:a16="http://schemas.microsoft.com/office/drawing/2014/main" id="{6ABA3AEB-D964-4A94-AEFC-96D877123B38}"/>
               </a:ext>
             </a:extLst>
           </p:cNvPr>
@@ -16812,7 +16812,7 @@
           <p:cNvPr id="19" name="">
             <a:extLst xmlns:a="http://schemas.openxmlformats.org/drawingml/2006/main">
               <a:ext uri="{FF2B5EF4-FFF2-40B4-BE49-F238E27FC236}">
-                <a16:creationId xmlns:a16="http://schemas.microsoft.com/office/drawing/2014/main" id="{A07BF628-33A8-43AE-860B-1B60A61FDFFB}"/>
+                <a16:creationId xmlns:a16="http://schemas.microsoft.com/office/drawing/2014/main" id="{1C1C1DBE-E338-4CBA-B874-A36E1ED2B341}"/>
               </a:ext>
             </a:extLst>
           </p:cNvPr>
@@ -16843,7 +16843,7 @@
           <p:cNvPr id="20" name="">
             <a:extLst xmlns:a="http://schemas.openxmlformats.org/drawingml/2006/main">
               <a:ext uri="{FF2B5EF4-FFF2-40B4-BE49-F238E27FC236}">
-                <a16:creationId xmlns:a16="http://schemas.microsoft.com/office/drawing/2014/main" id="{8395796C-A3F7-42CD-8D1A-91AA13711271}"/>
+                <a16:creationId xmlns:a16="http://schemas.microsoft.com/office/drawing/2014/main" id="{042A601B-F88B-475C-84F8-B6450FB232B6}"/>
               </a:ext>
             </a:extLst>
           </p:cNvPr>
@@ -16905,7 +16905,7 @@
           <p:cNvPr id="21" name="">
             <a:extLst xmlns:a="http://schemas.openxmlformats.org/drawingml/2006/main">
               <a:ext uri="{FF2B5EF4-FFF2-40B4-BE49-F238E27FC236}">
-                <a16:creationId xmlns:a16="http://schemas.microsoft.com/office/drawing/2014/main" id="{9E478619-1A2A-4DE3-8052-31E7AAB9B80A}"/>
+                <a16:creationId xmlns:a16="http://schemas.microsoft.com/office/drawing/2014/main" id="{48B81871-8544-4032-A60E-E45D4A6092AF}"/>
               </a:ext>
             </a:extLst>
           </p:cNvPr>
@@ -16967,7 +16967,7 @@
           <p:cNvPr id="22" name="">
             <a:extLst xmlns:a="http://schemas.openxmlformats.org/drawingml/2006/main">
               <a:ext uri="{FF2B5EF4-FFF2-40B4-BE49-F238E27FC236}">
-                <a16:creationId xmlns:a16="http://schemas.microsoft.com/office/drawing/2014/main" id="{E54FC6DE-C722-43C1-9C26-CEF9921AA37B}"/>
+                <a16:creationId xmlns:a16="http://schemas.microsoft.com/office/drawing/2014/main" id="{0D74FE08-7381-4145-88E7-8FAF82A686F0}"/>
               </a:ext>
             </a:extLst>
           </p:cNvPr>
@@ -17029,7 +17029,7 @@
           <p:cNvPr id="23" name="">
             <a:extLst xmlns:a="http://schemas.openxmlformats.org/drawingml/2006/main">
               <a:ext uri="{FF2B5EF4-FFF2-40B4-BE49-F238E27FC236}">
-                <a16:creationId xmlns:a16="http://schemas.microsoft.com/office/drawing/2014/main" id="{10D7EAA6-68A9-4892-AEEE-32F4358E0EB1}"/>
+                <a16:creationId xmlns:a16="http://schemas.microsoft.com/office/drawing/2014/main" id="{0E2DCD64-62C5-435D-8439-8D83AAB0685F}"/>
               </a:ext>
             </a:extLst>
           </p:cNvPr>
@@ -17062,7 +17062,7 @@
           <p:cNvPr id="24" name="">
             <a:extLst xmlns:a="http://schemas.openxmlformats.org/drawingml/2006/main">
               <a:ext uri="{FF2B5EF4-FFF2-40B4-BE49-F238E27FC236}">
-                <a16:creationId xmlns:a16="http://schemas.microsoft.com/office/drawing/2014/main" id="{E25E5B9F-D608-435A-A132-462693EF1553}"/>
+                <a16:creationId xmlns:a16="http://schemas.microsoft.com/office/drawing/2014/main" id="{A122A5F8-4E6F-4BF2-BBE8-1F95AAEA4111}"/>
               </a:ext>
             </a:extLst>
           </p:cNvPr>
@@ -17124,7 +17124,7 @@
           <p:cNvPr id="25" name="footer-rule-4">
             <a:extLst xmlns:a="http://schemas.openxmlformats.org/drawingml/2006/main">
               <a:ext uri="{FF2B5EF4-FFF2-40B4-BE49-F238E27FC236}">
-                <a16:creationId xmlns:a16="http://schemas.microsoft.com/office/drawing/2014/main" id="{2F35BB4D-AEC4-4F79-97B2-A72EED8FDED4}"/>
+                <a16:creationId xmlns:a16="http://schemas.microsoft.com/office/drawing/2014/main" id="{AB4ADCAC-FA43-4F39-9FB1-874D2541848F}"/>
               </a:ext>
             </a:extLst>
           </p:cNvPr>
@@ -17155,7 +17155,7 @@
           <p:cNvPr id="26" name="footer-label-4">
             <a:extLst xmlns:a="http://schemas.openxmlformats.org/drawingml/2006/main">
               <a:ext uri="{FF2B5EF4-FFF2-40B4-BE49-F238E27FC236}">
-                <a16:creationId xmlns:a16="http://schemas.microsoft.com/office/drawing/2014/main" id="{A0015350-1845-4059-BE62-F16A3F6116A1}"/>
+                <a16:creationId xmlns:a16="http://schemas.microsoft.com/office/drawing/2014/main" id="{4CFE9F27-DE4A-491B-8044-6FBF9F131D28}"/>
               </a:ext>
             </a:extLst>
           </p:cNvPr>
@@ -17217,7 +17217,7 @@
           <p:cNvPr id="27" name="footer-page-4">
             <a:extLst xmlns:a="http://schemas.openxmlformats.org/drawingml/2006/main">
               <a:ext uri="{FF2B5EF4-FFF2-40B4-BE49-F238E27FC236}">
-                <a16:creationId xmlns:a16="http://schemas.microsoft.com/office/drawing/2014/main" id="{ACCD8E68-7287-46BF-B9D5-2D6611317054}"/>
+                <a16:creationId xmlns:a16="http://schemas.microsoft.com/office/drawing/2014/main" id="{EBDA8AF5-D1B8-48C1-AAEC-D474E48060F4}"/>
               </a:ext>
             </a:extLst>
           </p:cNvPr>
@@ -17277,7 +17277,7 @@
     </p:spTree>
     <p:extLst>
       <p:ext uri="{BB962C8B-B14F-4D97-AF65-F5344CB8AC3E}">
-        <p14:creationId xmlns:p14="http://schemas.microsoft.com/office/powerpoint/2010/main" val="861944906"/>
+        <p14:creationId xmlns:p14="http://schemas.microsoft.com/office/powerpoint/2010/main" val="344074961"/>
       </p:ext>
     </p:extLst>
   </p:cSld>
@@ -17308,7 +17308,7 @@
           <p:cNvPr id="31" name="side-accent-5">
             <a:extLst xmlns:a="http://schemas.openxmlformats.org/drawingml/2006/main">
               <a:ext uri="{FF2B5EF4-FFF2-40B4-BE49-F238E27FC236}">
-                <a16:creationId xmlns:a16="http://schemas.microsoft.com/office/drawing/2014/main" id="{D4B251A3-BCE3-45DB-AEFE-258561F4B732}"/>
+                <a16:creationId xmlns:a16="http://schemas.microsoft.com/office/drawing/2014/main" id="{9DDE14B9-D281-4FF2-9D75-20077D7717E2}"/>
               </a:ext>
             </a:extLst>
           </p:cNvPr>
@@ -17339,7 +17339,7 @@
           <p:cNvPr id="2" name="kicker-5">
             <a:extLst xmlns:a="http://schemas.openxmlformats.org/drawingml/2006/main">
               <a:ext uri="{FF2B5EF4-FFF2-40B4-BE49-F238E27FC236}">
-                <a16:creationId xmlns:a16="http://schemas.microsoft.com/office/drawing/2014/main" id="{EFBF045A-628F-4F21-8C08-6DC59AD9A512}"/>
+                <a16:creationId xmlns:a16="http://schemas.microsoft.com/office/drawing/2014/main" id="{4A0A9D09-93FB-43ED-8A7E-F0461BC57F55}"/>
               </a:ext>
             </a:extLst>
           </p:cNvPr>
@@ -17401,7 +17401,7 @@
           <p:cNvPr id="3" name="title-5">
             <a:extLst xmlns:a="http://schemas.openxmlformats.org/drawingml/2006/main">
               <a:ext uri="{FF2B5EF4-FFF2-40B4-BE49-F238E27FC236}">
-                <a16:creationId xmlns:a16="http://schemas.microsoft.com/office/drawing/2014/main" id="{B8EF9CEC-DBE8-4925-93F9-C22EE6A09E98}"/>
+                <a16:creationId xmlns:a16="http://schemas.microsoft.com/office/drawing/2014/main" id="{98D73485-6FF7-458B-BC02-33C86409E5A2}"/>
               </a:ext>
             </a:extLst>
           </p:cNvPr>
@@ -17463,7 +17463,7 @@
           <p:cNvPr id="4" name="">
             <a:extLst xmlns:a="http://schemas.openxmlformats.org/drawingml/2006/main">
               <a:ext uri="{FF2B5EF4-FFF2-40B4-BE49-F238E27FC236}">
-                <a16:creationId xmlns:a16="http://schemas.microsoft.com/office/drawing/2014/main" id="{7E307A59-10A3-48A4-9B61-4DFEC8D05B73}"/>
+                <a16:creationId xmlns:a16="http://schemas.microsoft.com/office/drawing/2014/main" id="{C76BEB27-1824-4E8A-B188-94B8AC8E475E}"/>
               </a:ext>
             </a:extLst>
           </p:cNvPr>
@@ -17525,7 +17525,7 @@
           <p:cNvPr id="5" name="workflow-line">
             <a:extLst xmlns:a="http://schemas.openxmlformats.org/drawingml/2006/main">
               <a:ext uri="{FF2B5EF4-FFF2-40B4-BE49-F238E27FC236}">
-                <a16:creationId xmlns:a16="http://schemas.microsoft.com/office/drawing/2014/main" id="{9C1CC4B5-413E-4D0A-B20C-EB36245D034C}"/>
+                <a16:creationId xmlns:a16="http://schemas.microsoft.com/office/drawing/2014/main" id="{F2E5F51C-E061-4511-90FA-CAC6CF03C724}"/>
               </a:ext>
             </a:extLst>
           </p:cNvPr>
@@ -17556,7 +17556,7 @@
           <p:cNvPr id="6" name="workflow-arrow">
             <a:extLst xmlns:a="http://schemas.openxmlformats.org/drawingml/2006/main">
               <a:ext uri="{FF2B5EF4-FFF2-40B4-BE49-F238E27FC236}">
-                <a16:creationId xmlns:a16="http://schemas.microsoft.com/office/drawing/2014/main" id="{52CBF924-5503-4A60-96DA-A12CE1DD91A4}"/>
+                <a16:creationId xmlns:a16="http://schemas.microsoft.com/office/drawing/2014/main" id="{2673BCD0-27E3-4379-B09F-19A86377428F}"/>
               </a:ext>
             </a:extLst>
           </p:cNvPr>
@@ -17587,7 +17587,7 @@
           <p:cNvPr id="7" name="">
             <a:extLst xmlns:a="http://schemas.openxmlformats.org/drawingml/2006/main">
               <a:ext uri="{FF2B5EF4-FFF2-40B4-BE49-F238E27FC236}">
-                <a16:creationId xmlns:a16="http://schemas.microsoft.com/office/drawing/2014/main" id="{5C8F0EC8-E7EE-44C4-BF51-46151EBBE138}"/>
+                <a16:creationId xmlns:a16="http://schemas.microsoft.com/office/drawing/2014/main" id="{F8F56DB3-9A8F-4852-8456-8D74D3C2CC35}"/>
               </a:ext>
             </a:extLst>
           </p:cNvPr>
@@ -17618,7 +17618,7 @@
           <p:cNvPr id="8" name="">
             <a:extLst xmlns:a="http://schemas.openxmlformats.org/drawingml/2006/main">
               <a:ext uri="{FF2B5EF4-FFF2-40B4-BE49-F238E27FC236}">
-                <a16:creationId xmlns:a16="http://schemas.microsoft.com/office/drawing/2014/main" id="{29BE9915-9239-472B-ACEB-096EF14A6676}"/>
+                <a16:creationId xmlns:a16="http://schemas.microsoft.com/office/drawing/2014/main" id="{E087DB93-86DF-4817-AF08-2CA837BACE9D}"/>
               </a:ext>
             </a:extLst>
           </p:cNvPr>
@@ -17680,7 +17680,7 @@
           <p:cNvPr id="9" name="">
             <a:extLst xmlns:a="http://schemas.openxmlformats.org/drawingml/2006/main">
               <a:ext uri="{FF2B5EF4-FFF2-40B4-BE49-F238E27FC236}">
-                <a16:creationId xmlns:a16="http://schemas.microsoft.com/office/drawing/2014/main" id="{85552915-E26B-42FE-9351-2468B8F1D585}"/>
+                <a16:creationId xmlns:a16="http://schemas.microsoft.com/office/drawing/2014/main" id="{81225C70-C4E7-40D0-8687-6D001D39F801}"/>
               </a:ext>
             </a:extLst>
           </p:cNvPr>
@@ -17742,7 +17742,7 @@
           <p:cNvPr id="10" name="">
             <a:extLst xmlns:a="http://schemas.openxmlformats.org/drawingml/2006/main">
               <a:ext uri="{FF2B5EF4-FFF2-40B4-BE49-F238E27FC236}">
-                <a16:creationId xmlns:a16="http://schemas.microsoft.com/office/drawing/2014/main" id="{3D564DE8-28C8-4047-82F4-56938573940C}"/>
+                <a16:creationId xmlns:a16="http://schemas.microsoft.com/office/drawing/2014/main" id="{7420ABA8-A94C-45FC-82B2-C5CD42B38D70}"/>
               </a:ext>
             </a:extLst>
           </p:cNvPr>
@@ -17804,7 +17804,7 @@
           <p:cNvPr id="11" name="">
             <a:extLst xmlns:a="http://schemas.openxmlformats.org/drawingml/2006/main">
               <a:ext uri="{FF2B5EF4-FFF2-40B4-BE49-F238E27FC236}">
-                <a16:creationId xmlns:a16="http://schemas.microsoft.com/office/drawing/2014/main" id="{3F9FED89-094F-4036-BCD2-1BD0A2CA6BFC}"/>
+                <a16:creationId xmlns:a16="http://schemas.microsoft.com/office/drawing/2014/main" id="{1DCE798A-313D-4BC6-8B46-712C01A89E0B}"/>
               </a:ext>
             </a:extLst>
           </p:cNvPr>
@@ -17835,7 +17835,7 @@
           <p:cNvPr id="12" name="">
             <a:extLst xmlns:a="http://schemas.openxmlformats.org/drawingml/2006/main">
               <a:ext uri="{FF2B5EF4-FFF2-40B4-BE49-F238E27FC236}">
-                <a16:creationId xmlns:a16="http://schemas.microsoft.com/office/drawing/2014/main" id="{A8558F39-49CA-4045-82E8-BAD42D62312A}"/>
+                <a16:creationId xmlns:a16="http://schemas.microsoft.com/office/drawing/2014/main" id="{6BE569E1-C33A-4A53-A779-7E4754E02ACE}"/>
               </a:ext>
             </a:extLst>
           </p:cNvPr>
@@ -17897,7 +17897,7 @@
           <p:cNvPr id="13" name="">
             <a:extLst xmlns:a="http://schemas.openxmlformats.org/drawingml/2006/main">
               <a:ext uri="{FF2B5EF4-FFF2-40B4-BE49-F238E27FC236}">
-                <a16:creationId xmlns:a16="http://schemas.microsoft.com/office/drawing/2014/main" id="{8059C6E6-D1EF-4D09-8EDF-60F1385C6CAD}"/>
+                <a16:creationId xmlns:a16="http://schemas.microsoft.com/office/drawing/2014/main" id="{97AC2260-9F7F-40B5-BC9B-CA6F132FADCA}"/>
               </a:ext>
             </a:extLst>
           </p:cNvPr>
@@ -17959,7 +17959,7 @@
           <p:cNvPr id="14" name="">
             <a:extLst xmlns:a="http://schemas.openxmlformats.org/drawingml/2006/main">
               <a:ext uri="{FF2B5EF4-FFF2-40B4-BE49-F238E27FC236}">
-                <a16:creationId xmlns:a16="http://schemas.microsoft.com/office/drawing/2014/main" id="{52C56FB3-F4F6-4CC6-9181-F7E1F5A0C977}"/>
+                <a16:creationId xmlns:a16="http://schemas.microsoft.com/office/drawing/2014/main" id="{99DE9E7A-F496-4755-A065-8F67540771E9}"/>
               </a:ext>
             </a:extLst>
           </p:cNvPr>
@@ -18021,7 +18021,7 @@
           <p:cNvPr id="15" name="">
             <a:extLst xmlns:a="http://schemas.openxmlformats.org/drawingml/2006/main">
               <a:ext uri="{FF2B5EF4-FFF2-40B4-BE49-F238E27FC236}">
-                <a16:creationId xmlns:a16="http://schemas.microsoft.com/office/drawing/2014/main" id="{2484579C-744C-4CA4-9ACC-2A4CE3A7BB25}"/>
+                <a16:creationId xmlns:a16="http://schemas.microsoft.com/office/drawing/2014/main" id="{ECEFFB12-4187-4602-80A8-3C2C520A8059}"/>
               </a:ext>
             </a:extLst>
           </p:cNvPr>
@@ -18052,7 +18052,7 @@
           <p:cNvPr id="16" name="">
             <a:extLst xmlns:a="http://schemas.openxmlformats.org/drawingml/2006/main">
               <a:ext uri="{FF2B5EF4-FFF2-40B4-BE49-F238E27FC236}">
-                <a16:creationId xmlns:a16="http://schemas.microsoft.com/office/drawing/2014/main" id="{C2B52EE0-BA1E-45BC-BC93-C2FBD66ACC80}"/>
+                <a16:creationId xmlns:a16="http://schemas.microsoft.com/office/drawing/2014/main" id="{40298C63-E0BA-4F98-969F-6BE9EEC175AC}"/>
               </a:ext>
             </a:extLst>
           </p:cNvPr>
@@ -18114,7 +18114,7 @@
           <p:cNvPr id="17" name="">
             <a:extLst xmlns:a="http://schemas.openxmlformats.org/drawingml/2006/main">
               <a:ext uri="{FF2B5EF4-FFF2-40B4-BE49-F238E27FC236}">
-                <a16:creationId xmlns:a16="http://schemas.microsoft.com/office/drawing/2014/main" id="{09664984-4014-41E4-AE16-044631729918}"/>
+                <a16:creationId xmlns:a16="http://schemas.microsoft.com/office/drawing/2014/main" id="{16506EF0-75F4-408F-9BF1-10CCB644EF9A}"/>
               </a:ext>
             </a:extLst>
           </p:cNvPr>
@@ -18176,7 +18176,7 @@
           <p:cNvPr id="18" name="">
             <a:extLst xmlns:a="http://schemas.openxmlformats.org/drawingml/2006/main">
               <a:ext uri="{FF2B5EF4-FFF2-40B4-BE49-F238E27FC236}">
-                <a16:creationId xmlns:a16="http://schemas.microsoft.com/office/drawing/2014/main" id="{87912DA4-2A7F-4C74-870F-34A53CDE4052}"/>
+                <a16:creationId xmlns:a16="http://schemas.microsoft.com/office/drawing/2014/main" id="{5DC65BFD-4D3B-4A0A-964E-D0642CB51AFC}"/>
               </a:ext>
             </a:extLst>
           </p:cNvPr>
@@ -18238,7 +18238,7 @@
           <p:cNvPr id="19" name="">
             <a:extLst xmlns:a="http://schemas.openxmlformats.org/drawingml/2006/main">
               <a:ext uri="{FF2B5EF4-FFF2-40B4-BE49-F238E27FC236}">
-                <a16:creationId xmlns:a16="http://schemas.microsoft.com/office/drawing/2014/main" id="{008EC3B3-80BC-435F-84FA-109352D590CA}"/>
+                <a16:creationId xmlns:a16="http://schemas.microsoft.com/office/drawing/2014/main" id="{8A19E523-7CA6-4692-A3CC-F522C9978909}"/>
               </a:ext>
             </a:extLst>
           </p:cNvPr>
@@ -18269,7 +18269,7 @@
           <p:cNvPr id="20" name="">
             <a:extLst xmlns:a="http://schemas.openxmlformats.org/drawingml/2006/main">
               <a:ext uri="{FF2B5EF4-FFF2-40B4-BE49-F238E27FC236}">
-                <a16:creationId xmlns:a16="http://schemas.microsoft.com/office/drawing/2014/main" id="{62CA7E28-245D-4C80-9CB7-3B637744E658}"/>
+                <a16:creationId xmlns:a16="http://schemas.microsoft.com/office/drawing/2014/main" id="{09DFDA7B-7CE5-4CC6-88EF-412C754B5DB5}"/>
               </a:ext>
             </a:extLst>
           </p:cNvPr>
@@ -18331,7 +18331,7 @@
           <p:cNvPr id="21" name="">
             <a:extLst xmlns:a="http://schemas.openxmlformats.org/drawingml/2006/main">
               <a:ext uri="{FF2B5EF4-FFF2-40B4-BE49-F238E27FC236}">
-                <a16:creationId xmlns:a16="http://schemas.microsoft.com/office/drawing/2014/main" id="{E2155F56-314B-409A-9E67-1AC6A84FE31C}"/>
+                <a16:creationId xmlns:a16="http://schemas.microsoft.com/office/drawing/2014/main" id="{59BE715C-E327-477F-93C5-90CCF4178E84}"/>
               </a:ext>
             </a:extLst>
           </p:cNvPr>
@@ -18393,7 +18393,7 @@
           <p:cNvPr id="22" name="">
             <a:extLst xmlns:a="http://schemas.openxmlformats.org/drawingml/2006/main">
               <a:ext uri="{FF2B5EF4-FFF2-40B4-BE49-F238E27FC236}">
-                <a16:creationId xmlns:a16="http://schemas.microsoft.com/office/drawing/2014/main" id="{099CC764-C0DD-424E-8ACB-C72A8D0D57EB}"/>
+                <a16:creationId xmlns:a16="http://schemas.microsoft.com/office/drawing/2014/main" id="{E746DD18-D77F-43F2-816F-012854DE5A98}"/>
               </a:ext>
             </a:extLst>
           </p:cNvPr>
@@ -18455,7 +18455,7 @@
           <p:cNvPr id="23" name="">
             <a:extLst xmlns:a="http://schemas.openxmlformats.org/drawingml/2006/main">
               <a:ext uri="{FF2B5EF4-FFF2-40B4-BE49-F238E27FC236}">
-                <a16:creationId xmlns:a16="http://schemas.microsoft.com/office/drawing/2014/main" id="{395EC289-E9B5-4370-BDAA-AEB32A67AF24}"/>
+                <a16:creationId xmlns:a16="http://schemas.microsoft.com/office/drawing/2014/main" id="{7BB3F870-7E3E-4962-842B-DE41D130AE9F}"/>
               </a:ext>
             </a:extLst>
           </p:cNvPr>
@@ -18486,7 +18486,7 @@
           <p:cNvPr id="24" name="">
             <a:extLst xmlns:a="http://schemas.openxmlformats.org/drawingml/2006/main">
               <a:ext uri="{FF2B5EF4-FFF2-40B4-BE49-F238E27FC236}">
-                <a16:creationId xmlns:a16="http://schemas.microsoft.com/office/drawing/2014/main" id="{6C3176AF-E9A7-4D4D-BF29-147EB9B5EB81}"/>
+                <a16:creationId xmlns:a16="http://schemas.microsoft.com/office/drawing/2014/main" id="{0A1BDCAB-499F-4DD9-A59D-CCA731807DDB}"/>
               </a:ext>
             </a:extLst>
           </p:cNvPr>
@@ -18548,7 +18548,7 @@
           <p:cNvPr id="25" name="">
             <a:extLst xmlns:a="http://schemas.openxmlformats.org/drawingml/2006/main">
               <a:ext uri="{FF2B5EF4-FFF2-40B4-BE49-F238E27FC236}">
-                <a16:creationId xmlns:a16="http://schemas.microsoft.com/office/drawing/2014/main" id="{41102BC8-1812-458B-B853-5FBAEB7FCD1C}"/>
+                <a16:creationId xmlns:a16="http://schemas.microsoft.com/office/drawing/2014/main" id="{FAA304F5-4121-4573-AD05-9A6F50A3F3F9}"/>
               </a:ext>
             </a:extLst>
           </p:cNvPr>
@@ -18610,7 +18610,7 @@
           <p:cNvPr id="26" name="">
             <a:extLst xmlns:a="http://schemas.openxmlformats.org/drawingml/2006/main">
               <a:ext uri="{FF2B5EF4-FFF2-40B4-BE49-F238E27FC236}">
-                <a16:creationId xmlns:a16="http://schemas.microsoft.com/office/drawing/2014/main" id="{56950E24-2837-4DDD-B332-15CDAB8EE422}"/>
+                <a16:creationId xmlns:a16="http://schemas.microsoft.com/office/drawing/2014/main" id="{7B3FF5BB-B396-4CA1-BD24-C2E0DDA003A1}"/>
               </a:ext>
             </a:extLst>
           </p:cNvPr>
@@ -18672,7 +18672,7 @@
           <p:cNvPr id="27" name="">
             <a:extLst xmlns:a="http://schemas.openxmlformats.org/drawingml/2006/main">
               <a:ext uri="{FF2B5EF4-FFF2-40B4-BE49-F238E27FC236}">
-                <a16:creationId xmlns:a16="http://schemas.microsoft.com/office/drawing/2014/main" id="{6EF9AAD5-D6E9-438E-B305-997D7F634BAF}"/>
+                <a16:creationId xmlns:a16="http://schemas.microsoft.com/office/drawing/2014/main" id="{506DCA7E-3420-4283-890C-A58A58CBF9B0}"/>
               </a:ext>
             </a:extLst>
           </p:cNvPr>
@@ -18734,7 +18734,7 @@
           <p:cNvPr id="28" name="footer-rule-5">
             <a:extLst xmlns:a="http://schemas.openxmlformats.org/drawingml/2006/main">
               <a:ext uri="{FF2B5EF4-FFF2-40B4-BE49-F238E27FC236}">
-                <a16:creationId xmlns:a16="http://schemas.microsoft.com/office/drawing/2014/main" id="{41A28CAC-8078-4AA9-A130-215154AC22F1}"/>
+                <a16:creationId xmlns:a16="http://schemas.microsoft.com/office/drawing/2014/main" id="{FB5147A1-EFEE-487B-83C5-CC35337456BA}"/>
               </a:ext>
             </a:extLst>
           </p:cNvPr>
@@ -18765,7 +18765,7 @@
           <p:cNvPr id="29" name="footer-label-5">
             <a:extLst xmlns:a="http://schemas.openxmlformats.org/drawingml/2006/main">
               <a:ext uri="{FF2B5EF4-FFF2-40B4-BE49-F238E27FC236}">
-                <a16:creationId xmlns:a16="http://schemas.microsoft.com/office/drawing/2014/main" id="{285B1F73-F465-450A-8907-B3E2736E71EA}"/>
+                <a16:creationId xmlns:a16="http://schemas.microsoft.com/office/drawing/2014/main" id="{F13ADDBC-8ACE-47C1-8A87-E204E86FFAE2}"/>
               </a:ext>
             </a:extLst>
           </p:cNvPr>
@@ -18827,7 +18827,7 @@
           <p:cNvPr id="30" name="footer-page-5">
             <a:extLst xmlns:a="http://schemas.openxmlformats.org/drawingml/2006/main">
               <a:ext uri="{FF2B5EF4-FFF2-40B4-BE49-F238E27FC236}">
-                <a16:creationId xmlns:a16="http://schemas.microsoft.com/office/drawing/2014/main" id="{69B78C32-F44D-4AA9-A04D-C2798F906DDD}"/>
+                <a16:creationId xmlns:a16="http://schemas.microsoft.com/office/drawing/2014/main" id="{1F5E970C-E712-4236-BA4A-81DE0EE0B5E6}"/>
               </a:ext>
             </a:extLst>
           </p:cNvPr>
@@ -18887,7 +18887,7 @@
     </p:spTree>
     <p:extLst>
       <p:ext uri="{BB962C8B-B14F-4D97-AF65-F5344CB8AC3E}">
-        <p14:creationId xmlns:p14="http://schemas.microsoft.com/office/powerpoint/2010/main" val="1888193887"/>
+        <p14:creationId xmlns:p14="http://schemas.microsoft.com/office/powerpoint/2010/main" val="43301419"/>
       </p:ext>
     </p:extLst>
   </p:cSld>
@@ -18918,7 +18918,7 @@
           <p:cNvPr id="22" name="side-accent-6">
             <a:extLst xmlns:a="http://schemas.openxmlformats.org/drawingml/2006/main">
               <a:ext uri="{FF2B5EF4-FFF2-40B4-BE49-F238E27FC236}">
-                <a16:creationId xmlns:a16="http://schemas.microsoft.com/office/drawing/2014/main" id="{F02EA730-C2A7-4489-8D1A-5F3119E0964C}"/>
+                <a16:creationId xmlns:a16="http://schemas.microsoft.com/office/drawing/2014/main" id="{A2E1D8A2-1302-477F-991C-F0DE7A1B5BF1}"/>
               </a:ext>
             </a:extLst>
           </p:cNvPr>
@@ -18949,7 +18949,7 @@
           <p:cNvPr id="2" name="kicker-6">
             <a:extLst xmlns:a="http://schemas.openxmlformats.org/drawingml/2006/main">
               <a:ext uri="{FF2B5EF4-FFF2-40B4-BE49-F238E27FC236}">
-                <a16:creationId xmlns:a16="http://schemas.microsoft.com/office/drawing/2014/main" id="{24D4BB08-63EE-4450-8929-BB93B8CB7C94}"/>
+                <a16:creationId xmlns:a16="http://schemas.microsoft.com/office/drawing/2014/main" id="{9773BF82-FAC1-4AF4-858D-E4BC8862C9DE}"/>
               </a:ext>
             </a:extLst>
           </p:cNvPr>
@@ -19011,7 +19011,7 @@
           <p:cNvPr id="3" name="title-6">
             <a:extLst xmlns:a="http://schemas.openxmlformats.org/drawingml/2006/main">
               <a:ext uri="{FF2B5EF4-FFF2-40B4-BE49-F238E27FC236}">
-                <a16:creationId xmlns:a16="http://schemas.microsoft.com/office/drawing/2014/main" id="{9DAAB156-5307-47CC-9E36-FD556F01AE4A}"/>
+                <a16:creationId xmlns:a16="http://schemas.microsoft.com/office/drawing/2014/main" id="{D75D9114-BF69-47AB-B2D1-7038B6E30BB9}"/>
               </a:ext>
             </a:extLst>
           </p:cNvPr>
@@ -19073,7 +19073,7 @@
           <p:cNvPr id="4" name="">
             <a:extLst xmlns:a="http://schemas.openxmlformats.org/drawingml/2006/main">
               <a:ext uri="{FF2B5EF4-FFF2-40B4-BE49-F238E27FC236}">
-                <a16:creationId xmlns:a16="http://schemas.microsoft.com/office/drawing/2014/main" id="{EE033490-4BD7-4919-8605-75CED540A69E}"/>
+                <a16:creationId xmlns:a16="http://schemas.microsoft.com/office/drawing/2014/main" id="{C703409B-5076-4B9F-95FB-01879CFD1DBD}"/>
               </a:ext>
             </a:extLst>
           </p:cNvPr>
@@ -19135,7 +19135,7 @@
           <p:cNvPr id="5" name="">
             <a:extLst xmlns:a="http://schemas.openxmlformats.org/drawingml/2006/main">
               <a:ext uri="{FF2B5EF4-FFF2-40B4-BE49-F238E27FC236}">
-                <a16:creationId xmlns:a16="http://schemas.microsoft.com/office/drawing/2014/main" id="{4A246B51-C05D-44DE-BF4D-CA734745D88D}"/>
+                <a16:creationId xmlns:a16="http://schemas.microsoft.com/office/drawing/2014/main" id="{672E18BB-7074-496A-86ED-6B29E7026F1E}"/>
               </a:ext>
             </a:extLst>
           </p:cNvPr>
@@ -19197,7 +19197,7 @@
           <p:cNvPr id="6" name="">
             <a:extLst xmlns:a="http://schemas.openxmlformats.org/drawingml/2006/main">
               <a:ext uri="{FF2B5EF4-FFF2-40B4-BE49-F238E27FC236}">
-                <a16:creationId xmlns:a16="http://schemas.microsoft.com/office/drawing/2014/main" id="{FCA043FC-C10C-40EA-9361-FF73B22FF270}"/>
+                <a16:creationId xmlns:a16="http://schemas.microsoft.com/office/drawing/2014/main" id="{E89301DF-BC55-483E-B716-77B3C3E56B4B}"/>
               </a:ext>
             </a:extLst>
           </p:cNvPr>
@@ -19259,7 +19259,7 @@
           <p:cNvPr id="7" name="">
             <a:extLst xmlns:a="http://schemas.openxmlformats.org/drawingml/2006/main">
               <a:ext uri="{FF2B5EF4-FFF2-40B4-BE49-F238E27FC236}">
-                <a16:creationId xmlns:a16="http://schemas.microsoft.com/office/drawing/2014/main" id="{48BE81DE-F81C-4206-8DFD-38883F2A7361}"/>
+                <a16:creationId xmlns:a16="http://schemas.microsoft.com/office/drawing/2014/main" id="{BC191F82-6172-4D27-A067-FB04D6CD1FA3}"/>
               </a:ext>
             </a:extLst>
           </p:cNvPr>
@@ -19290,7 +19290,7 @@
           <p:cNvPr id="8" name="">
             <a:extLst xmlns:a="http://schemas.openxmlformats.org/drawingml/2006/main">
               <a:ext uri="{FF2B5EF4-FFF2-40B4-BE49-F238E27FC236}">
-                <a16:creationId xmlns:a16="http://schemas.microsoft.com/office/drawing/2014/main" id="{9A01F317-6C61-4939-8E35-DF393F2879B2}"/>
+                <a16:creationId xmlns:a16="http://schemas.microsoft.com/office/drawing/2014/main" id="{E0CC3943-5459-4EF9-B322-E31C06E6A573}"/>
               </a:ext>
             </a:extLst>
           </p:cNvPr>
@@ -19379,7 +19379,7 @@
           <p:cNvPr id="9" name="">
             <a:extLst xmlns:a="http://schemas.openxmlformats.org/drawingml/2006/main">
               <a:ext uri="{FF2B5EF4-FFF2-40B4-BE49-F238E27FC236}">
-                <a16:creationId xmlns:a16="http://schemas.microsoft.com/office/drawing/2014/main" id="{421F7416-2E7B-4AEF-9174-6B6D4B24FBEE}"/>
+                <a16:creationId xmlns:a16="http://schemas.microsoft.com/office/drawing/2014/main" id="{078BB010-12A0-4FF8-BDD7-328373073133}"/>
               </a:ext>
             </a:extLst>
           </p:cNvPr>
@@ -19441,7 +19441,7 @@
           <p:cNvPr id="10" name="">
             <a:extLst xmlns:a="http://schemas.openxmlformats.org/drawingml/2006/main">
               <a:ext uri="{FF2B5EF4-FFF2-40B4-BE49-F238E27FC236}">
-                <a16:creationId xmlns:a16="http://schemas.microsoft.com/office/drawing/2014/main" id="{D7130F38-24C8-4E04-B343-B0AC95055430}"/>
+                <a16:creationId xmlns:a16="http://schemas.microsoft.com/office/drawing/2014/main" id="{C0637D30-069C-4310-B5F2-15659BCD7BE4}"/>
               </a:ext>
             </a:extLst>
           </p:cNvPr>
@@ -19503,7 +19503,7 @@
           <p:cNvPr id="11" name="">
             <a:extLst xmlns:a="http://schemas.openxmlformats.org/drawingml/2006/main">
               <a:ext uri="{FF2B5EF4-FFF2-40B4-BE49-F238E27FC236}">
-                <a16:creationId xmlns:a16="http://schemas.microsoft.com/office/drawing/2014/main" id="{AFEB7732-7F5F-48D5-99A6-1BF0B1970011}"/>
+                <a16:creationId xmlns:a16="http://schemas.microsoft.com/office/drawing/2014/main" id="{C21C42E8-15A7-4D76-B036-C4DE1360B280}"/>
               </a:ext>
             </a:extLst>
           </p:cNvPr>
@@ -19534,7 +19534,7 @@
           <p:cNvPr id="12" name="">
             <a:extLst xmlns:a="http://schemas.openxmlformats.org/drawingml/2006/main">
               <a:ext uri="{FF2B5EF4-FFF2-40B4-BE49-F238E27FC236}">
-                <a16:creationId xmlns:a16="http://schemas.microsoft.com/office/drawing/2014/main" id="{FF95C453-ED1E-4B20-BC8F-871344B42A04}"/>
+                <a16:creationId xmlns:a16="http://schemas.microsoft.com/office/drawing/2014/main" id="{577661BE-8C6D-4236-A54B-94F33865DE4F}"/>
               </a:ext>
             </a:extLst>
           </p:cNvPr>
@@ -19623,7 +19623,7 @@
           <p:cNvPr id="13" name="">
             <a:extLst xmlns:a="http://schemas.openxmlformats.org/drawingml/2006/main">
               <a:ext uri="{FF2B5EF4-FFF2-40B4-BE49-F238E27FC236}">
-                <a16:creationId xmlns:a16="http://schemas.microsoft.com/office/drawing/2014/main" id="{46D2CCB8-BA89-43C1-9024-76C27BE6F96F}"/>
+                <a16:creationId xmlns:a16="http://schemas.microsoft.com/office/drawing/2014/main" id="{DF59CBE1-FB00-49F6-99E4-1609D87A6D10}"/>
               </a:ext>
             </a:extLst>
           </p:cNvPr>
@@ -19685,7 +19685,7 @@
           <p:cNvPr id="14" name="">
             <a:extLst xmlns:a="http://schemas.openxmlformats.org/drawingml/2006/main">
               <a:ext uri="{FF2B5EF4-FFF2-40B4-BE49-F238E27FC236}">
-                <a16:creationId xmlns:a16="http://schemas.microsoft.com/office/drawing/2014/main" id="{B9D6BFFD-E023-4249-9EB3-DF845D131DAC}"/>
+                <a16:creationId xmlns:a16="http://schemas.microsoft.com/office/drawing/2014/main" id="{121AB038-0B8D-48EE-8B3C-13DAADD4AC68}"/>
               </a:ext>
             </a:extLst>
           </p:cNvPr>
@@ -19747,7 +19747,7 @@
           <p:cNvPr id="15" name="">
             <a:extLst xmlns:a="http://schemas.openxmlformats.org/drawingml/2006/main">
               <a:ext uri="{FF2B5EF4-FFF2-40B4-BE49-F238E27FC236}">
-                <a16:creationId xmlns:a16="http://schemas.microsoft.com/office/drawing/2014/main" id="{A8FACE93-B9BD-40D6-BA7E-AE1BF1F226BB}"/>
+                <a16:creationId xmlns:a16="http://schemas.microsoft.com/office/drawing/2014/main" id="{FA47FFD3-4202-4EA0-916E-6AF5247E601B}"/>
               </a:ext>
             </a:extLst>
           </p:cNvPr>
@@ -19778,7 +19778,7 @@
           <p:cNvPr id="16" name="">
             <a:extLst xmlns:a="http://schemas.openxmlformats.org/drawingml/2006/main">
               <a:ext uri="{FF2B5EF4-FFF2-40B4-BE49-F238E27FC236}">
-                <a16:creationId xmlns:a16="http://schemas.microsoft.com/office/drawing/2014/main" id="{E77F1030-0294-477A-B522-3C37349FAE7C}"/>
+                <a16:creationId xmlns:a16="http://schemas.microsoft.com/office/drawing/2014/main" id="{1A7EA295-6F61-4358-B1ED-1FA0C391FE8C}"/>
               </a:ext>
             </a:extLst>
           </p:cNvPr>
@@ -19867,7 +19867,7 @@
           <p:cNvPr id="17" name="">
             <a:extLst xmlns:a="http://schemas.openxmlformats.org/drawingml/2006/main">
               <a:ext uri="{FF2B5EF4-FFF2-40B4-BE49-F238E27FC236}">
-                <a16:creationId xmlns:a16="http://schemas.microsoft.com/office/drawing/2014/main" id="{BC9BAD16-63F3-427B-BCDA-ECA39CF1AB78}"/>
+                <a16:creationId xmlns:a16="http://schemas.microsoft.com/office/drawing/2014/main" id="{89AF74DB-4C74-44C2-9F1B-E9399B6B4112}"/>
               </a:ext>
             </a:extLst>
           </p:cNvPr>
@@ -19900,7 +19900,7 @@
           <p:cNvPr id="18" name="">
             <a:extLst xmlns:a="http://schemas.openxmlformats.org/drawingml/2006/main">
               <a:ext uri="{FF2B5EF4-FFF2-40B4-BE49-F238E27FC236}">
-                <a16:creationId xmlns:a16="http://schemas.microsoft.com/office/drawing/2014/main" id="{7C762FDD-5792-43F2-8C9C-181ABD923F71}"/>
+                <a16:creationId xmlns:a16="http://schemas.microsoft.com/office/drawing/2014/main" id="{82E5CCA7-31DC-43E0-9A77-E7EDB63633B7}"/>
               </a:ext>
             </a:extLst>
           </p:cNvPr>
@@ -19989,7 +19989,7 @@
           <p:cNvPr id="19" name="footer-rule-6">
             <a:extLst xmlns:a="http://schemas.openxmlformats.org/drawingml/2006/main">
               <a:ext uri="{FF2B5EF4-FFF2-40B4-BE49-F238E27FC236}">
-                <a16:creationId xmlns:a16="http://schemas.microsoft.com/office/drawing/2014/main" id="{414E3714-6BCD-42A0-9B65-664CF227AAD0}"/>
+                <a16:creationId xmlns:a16="http://schemas.microsoft.com/office/drawing/2014/main" id="{7296C25B-0226-474F-91C6-325FFB8DF6F4}"/>
               </a:ext>
             </a:extLst>
           </p:cNvPr>
@@ -20020,7 +20020,7 @@
           <p:cNvPr id="20" name="footer-label-6">
             <a:extLst xmlns:a="http://schemas.openxmlformats.org/drawingml/2006/main">
               <a:ext uri="{FF2B5EF4-FFF2-40B4-BE49-F238E27FC236}">
-                <a16:creationId xmlns:a16="http://schemas.microsoft.com/office/drawing/2014/main" id="{766F02FA-D12A-4492-9DFD-981EFB03AF53}"/>
+                <a16:creationId xmlns:a16="http://schemas.microsoft.com/office/drawing/2014/main" id="{870230F6-D7C5-441A-B57B-7D6A9702FEFB}"/>
               </a:ext>
             </a:extLst>
           </p:cNvPr>
@@ -20082,7 +20082,7 @@
           <p:cNvPr id="21" name="footer-page-6">
             <a:extLst xmlns:a="http://schemas.openxmlformats.org/drawingml/2006/main">
               <a:ext uri="{FF2B5EF4-FFF2-40B4-BE49-F238E27FC236}">
-                <a16:creationId xmlns:a16="http://schemas.microsoft.com/office/drawing/2014/main" id="{011C9920-DB05-4FD8-8202-229EA142843C}"/>
+                <a16:creationId xmlns:a16="http://schemas.microsoft.com/office/drawing/2014/main" id="{989B1DE4-63A0-4D29-A2EE-587B5B950794}"/>
               </a:ext>
             </a:extLst>
           </p:cNvPr>
@@ -20142,7 +20142,7 @@
     </p:spTree>
     <p:extLst>
       <p:ext uri="{BB962C8B-B14F-4D97-AF65-F5344CB8AC3E}">
-        <p14:creationId xmlns:p14="http://schemas.microsoft.com/office/powerpoint/2010/main" val="1900746084"/>
+        <p14:creationId xmlns:p14="http://schemas.microsoft.com/office/powerpoint/2010/main" val="969674079"/>
       </p:ext>
     </p:extLst>
   </p:cSld>
@@ -20173,7 +20173,7 @@
           <p:cNvPr id="28" name="side-accent-7">
             <a:extLst xmlns:a="http://schemas.openxmlformats.org/drawingml/2006/main">
               <a:ext uri="{FF2B5EF4-FFF2-40B4-BE49-F238E27FC236}">
-                <a16:creationId xmlns:a16="http://schemas.microsoft.com/office/drawing/2014/main" id="{F7F23E5C-05EA-4CA2-B932-936A4DE2E2BC}"/>
+                <a16:creationId xmlns:a16="http://schemas.microsoft.com/office/drawing/2014/main" id="{74234F19-B694-41CF-B937-6D0E8E38C58E}"/>
               </a:ext>
             </a:extLst>
           </p:cNvPr>
@@ -20204,7 +20204,7 @@
           <p:cNvPr id="2" name="kicker-7">
             <a:extLst xmlns:a="http://schemas.openxmlformats.org/drawingml/2006/main">
               <a:ext uri="{FF2B5EF4-FFF2-40B4-BE49-F238E27FC236}">
-                <a16:creationId xmlns:a16="http://schemas.microsoft.com/office/drawing/2014/main" id="{61FBF00F-42CF-453A-92A6-4365B2C0B19A}"/>
+                <a16:creationId xmlns:a16="http://schemas.microsoft.com/office/drawing/2014/main" id="{CD45F80E-EEA4-4879-B2A3-283862EC28F4}"/>
               </a:ext>
             </a:extLst>
           </p:cNvPr>
@@ -20266,7 +20266,7 @@
           <p:cNvPr id="3" name="title-7">
             <a:extLst xmlns:a="http://schemas.openxmlformats.org/drawingml/2006/main">
               <a:ext uri="{FF2B5EF4-FFF2-40B4-BE49-F238E27FC236}">
-                <a16:creationId xmlns:a16="http://schemas.microsoft.com/office/drawing/2014/main" id="{E0773657-5533-46BC-A73F-DD59B3945051}"/>
+                <a16:creationId xmlns:a16="http://schemas.microsoft.com/office/drawing/2014/main" id="{C155EF22-9374-42CA-8D17-CF4F6660BC89}"/>
               </a:ext>
             </a:extLst>
           </p:cNvPr>
@@ -20328,7 +20328,7 @@
           <p:cNvPr id="4" name="">
             <a:extLst xmlns:a="http://schemas.openxmlformats.org/drawingml/2006/main">
               <a:ext uri="{FF2B5EF4-FFF2-40B4-BE49-F238E27FC236}">
-                <a16:creationId xmlns:a16="http://schemas.microsoft.com/office/drawing/2014/main" id="{228C8B68-91F3-4D13-901F-6DA6B3C82DAC}"/>
+                <a16:creationId xmlns:a16="http://schemas.microsoft.com/office/drawing/2014/main" id="{1647F25A-186A-4135-8AB3-BF137E53F493}"/>
               </a:ext>
             </a:extLst>
           </p:cNvPr>
@@ -20390,7 +20390,7 @@
           <p:cNvPr id="5" name="">
             <a:extLst xmlns:a="http://schemas.openxmlformats.org/drawingml/2006/main">
               <a:ext uri="{FF2B5EF4-FFF2-40B4-BE49-F238E27FC236}">
-                <a16:creationId xmlns:a16="http://schemas.microsoft.com/office/drawing/2014/main" id="{3282078C-5676-44D7-B210-4FE4D1286ECB}"/>
+                <a16:creationId xmlns:a16="http://schemas.microsoft.com/office/drawing/2014/main" id="{7DBC8389-CE78-4DC0-BA8C-5FB86DEE7C92}"/>
               </a:ext>
             </a:extLst>
           </p:cNvPr>
@@ -20421,7 +20421,7 @@
           <p:cNvPr id="6" name="">
             <a:extLst xmlns:a="http://schemas.openxmlformats.org/drawingml/2006/main">
               <a:ext uri="{FF2B5EF4-FFF2-40B4-BE49-F238E27FC236}">
-                <a16:creationId xmlns:a16="http://schemas.microsoft.com/office/drawing/2014/main" id="{2FAF214D-8017-426E-8864-441F1FC19531}"/>
+                <a16:creationId xmlns:a16="http://schemas.microsoft.com/office/drawing/2014/main" id="{DEA0BB91-D6C0-455E-B086-D29DCDFC10E5}"/>
               </a:ext>
             </a:extLst>
           </p:cNvPr>
@@ -20483,7 +20483,7 @@
           <p:cNvPr id="7" name="">
             <a:extLst xmlns:a="http://schemas.openxmlformats.org/drawingml/2006/main">
               <a:ext uri="{FF2B5EF4-FFF2-40B4-BE49-F238E27FC236}">
-                <a16:creationId xmlns:a16="http://schemas.microsoft.com/office/drawing/2014/main" id="{FD3140C0-E624-43A5-96D2-9E894C862516}"/>
+                <a16:creationId xmlns:a16="http://schemas.microsoft.com/office/drawing/2014/main" id="{133F7A98-D1D1-4313-95F6-95176DCAD1FB}"/>
               </a:ext>
             </a:extLst>
           </p:cNvPr>
@@ -20545,7 +20545,7 @@
           <p:cNvPr id="8" name="">
             <a:extLst xmlns:a="http://schemas.openxmlformats.org/drawingml/2006/main">
               <a:ext uri="{FF2B5EF4-FFF2-40B4-BE49-F238E27FC236}">
-                <a16:creationId xmlns:a16="http://schemas.microsoft.com/office/drawing/2014/main" id="{B87A3401-7FC3-46E2-8058-3F6290D8AB94}"/>
+                <a16:creationId xmlns:a16="http://schemas.microsoft.com/office/drawing/2014/main" id="{B1738C6D-FCFD-44DF-8032-C1DF51356751}"/>
               </a:ext>
             </a:extLst>
           </p:cNvPr>
@@ -20607,7 +20607,7 @@
           <p:cNvPr id="9" name="">
             <a:extLst xmlns:a="http://schemas.openxmlformats.org/drawingml/2006/main">
               <a:ext uri="{FF2B5EF4-FFF2-40B4-BE49-F238E27FC236}">
-                <a16:creationId xmlns:a16="http://schemas.microsoft.com/office/drawing/2014/main" id="{F9F137A1-25B9-44E6-8FA0-09A11EE6F445}"/>
+                <a16:creationId xmlns:a16="http://schemas.microsoft.com/office/drawing/2014/main" id="{8C26387D-551D-4766-BFFC-9502E79BD752}"/>
               </a:ext>
             </a:extLst>
           </p:cNvPr>
@@ -20638,7 +20638,7 @@
           <p:cNvPr id="10" name="">
             <a:extLst xmlns:a="http://schemas.openxmlformats.org/drawingml/2006/main">
               <a:ext uri="{FF2B5EF4-FFF2-40B4-BE49-F238E27FC236}">
-                <a16:creationId xmlns:a16="http://schemas.microsoft.com/office/drawing/2014/main" id="{A0C44A02-F0F2-4DC0-808F-779D2E0CC2EE}"/>
+                <a16:creationId xmlns:a16="http://schemas.microsoft.com/office/drawing/2014/main" id="{87BFF72E-F565-49FD-9147-A80DA1A50B7E}"/>
               </a:ext>
             </a:extLst>
           </p:cNvPr>
@@ -20700,7 +20700,7 @@
           <p:cNvPr id="11" name="">
             <a:extLst xmlns:a="http://schemas.openxmlformats.org/drawingml/2006/main">
               <a:ext uri="{FF2B5EF4-FFF2-40B4-BE49-F238E27FC236}">
-                <a16:creationId xmlns:a16="http://schemas.microsoft.com/office/drawing/2014/main" id="{A76AE628-B5D2-4A64-AE24-FE9EFED88E12}"/>
+                <a16:creationId xmlns:a16="http://schemas.microsoft.com/office/drawing/2014/main" id="{F9458316-5848-4DF8-8E65-B483660A1F97}"/>
               </a:ext>
             </a:extLst>
           </p:cNvPr>
@@ -20762,7 +20762,7 @@
           <p:cNvPr id="12" name="">
             <a:extLst xmlns:a="http://schemas.openxmlformats.org/drawingml/2006/main">
               <a:ext uri="{FF2B5EF4-FFF2-40B4-BE49-F238E27FC236}">
-                <a16:creationId xmlns:a16="http://schemas.microsoft.com/office/drawing/2014/main" id="{285AB2ED-D37B-44F4-931A-AF00136F93D1}"/>
+                <a16:creationId xmlns:a16="http://schemas.microsoft.com/office/drawing/2014/main" id="{579E13B6-7727-4D52-ACFF-DA75DD7C28E9}"/>
               </a:ext>
             </a:extLst>
           </p:cNvPr>
@@ -20824,7 +20824,7 @@
           <p:cNvPr id="13" name="">
             <a:extLst xmlns:a="http://schemas.openxmlformats.org/drawingml/2006/main">
               <a:ext uri="{FF2B5EF4-FFF2-40B4-BE49-F238E27FC236}">
-                <a16:creationId xmlns:a16="http://schemas.microsoft.com/office/drawing/2014/main" id="{A05D47AE-A04A-4EEC-9FCB-129D3DF0E759}"/>
+                <a16:creationId xmlns:a16="http://schemas.microsoft.com/office/drawing/2014/main" id="{579D29E3-5C50-4406-AA3D-8A034B79CEF2}"/>
               </a:ext>
             </a:extLst>
           </p:cNvPr>
@@ -20855,7 +20855,7 @@
           <p:cNvPr id="14" name="">
             <a:extLst xmlns:a="http://schemas.openxmlformats.org/drawingml/2006/main">
               <a:ext uri="{FF2B5EF4-FFF2-40B4-BE49-F238E27FC236}">
-                <a16:creationId xmlns:a16="http://schemas.microsoft.com/office/drawing/2014/main" id="{958F1788-8717-496E-ABCF-3EF2EEDF655C}"/>
+                <a16:creationId xmlns:a16="http://schemas.microsoft.com/office/drawing/2014/main" id="{AE20CF6C-D820-428C-B650-D9A3068EC8BF}"/>
               </a:ext>
             </a:extLst>
           </p:cNvPr>
@@ -20917,7 +20917,7 @@
           <p:cNvPr id="15" name="">
             <a:extLst xmlns:a="http://schemas.openxmlformats.org/drawingml/2006/main">
               <a:ext uri="{FF2B5EF4-FFF2-40B4-BE49-F238E27FC236}">
-                <a16:creationId xmlns:a16="http://schemas.microsoft.com/office/drawing/2014/main" id="{58757240-1219-493C-BF3A-D82A7AE9337D}"/>
+                <a16:creationId xmlns:a16="http://schemas.microsoft.com/office/drawing/2014/main" id="{A82AA7D2-9014-414A-A593-360954E2D7DE}"/>
               </a:ext>
             </a:extLst>
           </p:cNvPr>
@@ -20979,7 +20979,7 @@
           <p:cNvPr id="16" name="">
             <a:extLst xmlns:a="http://schemas.openxmlformats.org/drawingml/2006/main">
               <a:ext uri="{FF2B5EF4-FFF2-40B4-BE49-F238E27FC236}">
-                <a16:creationId xmlns:a16="http://schemas.microsoft.com/office/drawing/2014/main" id="{68D7E2D2-4F25-47B6-8AEF-F8B93FEDDECA}"/>
+                <a16:creationId xmlns:a16="http://schemas.microsoft.com/office/drawing/2014/main" id="{76292D17-1CB7-45F1-8665-84168F4B2947}"/>
               </a:ext>
             </a:extLst>
           </p:cNvPr>
@@ -21041,7 +21041,7 @@
           <p:cNvPr id="17" name="dashboard-preview">
             <a:extLst xmlns:a="http://schemas.openxmlformats.org/drawingml/2006/main">
               <a:ext uri="{FF2B5EF4-FFF2-40B4-BE49-F238E27FC236}">
-                <a16:creationId xmlns:a16="http://schemas.microsoft.com/office/drawing/2014/main" id="{99223EF1-430F-44E0-BAD5-984756B933D9}"/>
+                <a16:creationId xmlns:a16="http://schemas.microsoft.com/office/drawing/2014/main" id="{F74F5885-4EA7-4C50-8F06-B13EA59D4B3F}"/>
               </a:ext>
             </a:extLst>
           </p:cNvPr>
@@ -21076,7 +21076,7 @@
           <p:cNvPr id="18" name="">
             <a:extLst xmlns:a="http://schemas.openxmlformats.org/drawingml/2006/main">
               <a:ext uri="{FF2B5EF4-FFF2-40B4-BE49-F238E27FC236}">
-                <a16:creationId xmlns:a16="http://schemas.microsoft.com/office/drawing/2014/main" id="{68BE4F3B-9AB6-4599-9CC6-43866CC63DC4}"/>
+                <a16:creationId xmlns:a16="http://schemas.microsoft.com/office/drawing/2014/main" id="{1505D54E-BE2E-48D8-9F24-0348FD276A60}"/>
               </a:ext>
             </a:extLst>
           </p:cNvPr>
@@ -21138,7 +21138,7 @@
           <p:cNvPr id="19" name="">
             <a:extLst xmlns:a="http://schemas.openxmlformats.org/drawingml/2006/main">
               <a:ext uri="{FF2B5EF4-FFF2-40B4-BE49-F238E27FC236}">
-                <a16:creationId xmlns:a16="http://schemas.microsoft.com/office/drawing/2014/main" id="{37C1998A-A3D3-470D-87E5-614C938F4D11}"/>
+                <a16:creationId xmlns:a16="http://schemas.microsoft.com/office/drawing/2014/main" id="{665AD0B9-3A49-44C0-A962-247D054E3CA0}"/>
               </a:ext>
             </a:extLst>
           </p:cNvPr>
@@ -21169,7 +21169,7 @@
           <p:cNvPr id="20" name="">
             <a:extLst xmlns:a="http://schemas.openxmlformats.org/drawingml/2006/main">
               <a:ext uri="{FF2B5EF4-FFF2-40B4-BE49-F238E27FC236}">
-                <a16:creationId xmlns:a16="http://schemas.microsoft.com/office/drawing/2014/main" id="{C70F0D6E-7149-474D-96F4-AE33BD8571F1}"/>
+                <a16:creationId xmlns:a16="http://schemas.microsoft.com/office/drawing/2014/main" id="{1B87F18B-6D0A-44B8-8F14-4FEBF94D66B7}"/>
               </a:ext>
             </a:extLst>
           </p:cNvPr>
@@ -21231,7 +21231,7 @@
           <p:cNvPr id="21" name="">
             <a:extLst xmlns:a="http://schemas.openxmlformats.org/drawingml/2006/main">
               <a:ext uri="{FF2B5EF4-FFF2-40B4-BE49-F238E27FC236}">
-                <a16:creationId xmlns:a16="http://schemas.microsoft.com/office/drawing/2014/main" id="{72F0541E-5EA8-40BF-B588-64B8F622C43E}"/>
+                <a16:creationId xmlns:a16="http://schemas.microsoft.com/office/drawing/2014/main" id="{ADE7A2C3-B41D-48DC-AFF0-60A4282698B9}"/>
               </a:ext>
             </a:extLst>
           </p:cNvPr>
@@ -21262,7 +21262,7 @@
           <p:cNvPr id="22" name="">
             <a:extLst xmlns:a="http://schemas.openxmlformats.org/drawingml/2006/main">
               <a:ext uri="{FF2B5EF4-FFF2-40B4-BE49-F238E27FC236}">
-                <a16:creationId xmlns:a16="http://schemas.microsoft.com/office/drawing/2014/main" id="{17AF8A78-9D00-488B-B35B-2B3B6D57F074}"/>
+                <a16:creationId xmlns:a16="http://schemas.microsoft.com/office/drawing/2014/main" id="{7159A110-1C47-452D-B6B6-E453C0E5EFC3}"/>
               </a:ext>
             </a:extLst>
           </p:cNvPr>
@@ -21293,7 +21293,7 @@
           <p:cNvPr id="23" name="">
             <a:extLst xmlns:a="http://schemas.openxmlformats.org/drawingml/2006/main">
               <a:ext uri="{FF2B5EF4-FFF2-40B4-BE49-F238E27FC236}">
-                <a16:creationId xmlns:a16="http://schemas.microsoft.com/office/drawing/2014/main" id="{0BEE4405-1637-4DFA-9E22-C05DB273D0D1}"/>
+                <a16:creationId xmlns:a16="http://schemas.microsoft.com/office/drawing/2014/main" id="{74BDE1BD-9256-4AE1-9333-2FA1D0AA65C3}"/>
               </a:ext>
             </a:extLst>
           </p:cNvPr>
@@ -21326,7 +21326,7 @@
           <p:cNvPr id="24" name="">
             <a:extLst xmlns:a="http://schemas.openxmlformats.org/drawingml/2006/main">
               <a:ext uri="{FF2B5EF4-FFF2-40B4-BE49-F238E27FC236}">
-                <a16:creationId xmlns:a16="http://schemas.microsoft.com/office/drawing/2014/main" id="{724F096F-31D7-4BB8-8215-CDEF582A36DA}"/>
+                <a16:creationId xmlns:a16="http://schemas.microsoft.com/office/drawing/2014/main" id="{1E92EACC-17F4-4CAD-9B81-962DF261F6B1}"/>
               </a:ext>
             </a:extLst>
           </p:cNvPr>
@@ -21388,7 +21388,7 @@
           <p:cNvPr id="25" name="footer-rule-7">
             <a:extLst xmlns:a="http://schemas.openxmlformats.org/drawingml/2006/main">
               <a:ext uri="{FF2B5EF4-FFF2-40B4-BE49-F238E27FC236}">
-                <a16:creationId xmlns:a16="http://schemas.microsoft.com/office/drawing/2014/main" id="{A0F45E81-CAD9-4A7D-B8D5-8B23397FFA86}"/>
+                <a16:creationId xmlns:a16="http://schemas.microsoft.com/office/drawing/2014/main" id="{4438F1B3-9D5D-4540-B0A6-282FBEC722B0}"/>
               </a:ext>
             </a:extLst>
           </p:cNvPr>
@@ -21419,7 +21419,7 @@
           <p:cNvPr id="26" name="footer-label-7">
             <a:extLst xmlns:a="http://schemas.openxmlformats.org/drawingml/2006/main">
               <a:ext uri="{FF2B5EF4-FFF2-40B4-BE49-F238E27FC236}">
-                <a16:creationId xmlns:a16="http://schemas.microsoft.com/office/drawing/2014/main" id="{490DD374-DE31-445E-895C-C57A4B6CAF2A}"/>
+                <a16:creationId xmlns:a16="http://schemas.microsoft.com/office/drawing/2014/main" id="{2DC48D4A-1B9E-4AC1-88CF-A223566B71FF}"/>
               </a:ext>
             </a:extLst>
           </p:cNvPr>
@@ -21481,7 +21481,7 @@
           <p:cNvPr id="27" name="footer-page-7">
             <a:extLst xmlns:a="http://schemas.openxmlformats.org/drawingml/2006/main">
               <a:ext uri="{FF2B5EF4-FFF2-40B4-BE49-F238E27FC236}">
-                <a16:creationId xmlns:a16="http://schemas.microsoft.com/office/drawing/2014/main" id="{C0EEB473-92E2-4CEB-B426-D3AB6FACB541}"/>
+                <a16:creationId xmlns:a16="http://schemas.microsoft.com/office/drawing/2014/main" id="{6DBF8A94-C5A1-46FB-89BC-F43F32FC6582}"/>
               </a:ext>
             </a:extLst>
           </p:cNvPr>
@@ -21541,7 +21541,7 @@
     </p:spTree>
     <p:extLst>
       <p:ext uri="{BB962C8B-B14F-4D97-AF65-F5344CB8AC3E}">
-        <p14:creationId xmlns:p14="http://schemas.microsoft.com/office/powerpoint/2010/main" val="1820485337"/>
+        <p14:creationId xmlns:p14="http://schemas.microsoft.com/office/powerpoint/2010/main" val="633073213"/>
       </p:ext>
     </p:extLst>
   </p:cSld>
@@ -21572,7 +21572,7 @@
           <p:cNvPr id="26" name="side-accent-8">
             <a:extLst xmlns:a="http://schemas.openxmlformats.org/drawingml/2006/main">
               <a:ext uri="{FF2B5EF4-FFF2-40B4-BE49-F238E27FC236}">
-                <a16:creationId xmlns:a16="http://schemas.microsoft.com/office/drawing/2014/main" id="{61129F19-9D26-4C34-802F-8F236341B81E}"/>
+                <a16:creationId xmlns:a16="http://schemas.microsoft.com/office/drawing/2014/main" id="{3DC39E9C-DBAF-4242-B812-E5909EC4C73D}"/>
               </a:ext>
             </a:extLst>
           </p:cNvPr>
@@ -21603,7 +21603,7 @@
           <p:cNvPr id="2" name="kicker-8">
             <a:extLst xmlns:a="http://schemas.openxmlformats.org/drawingml/2006/main">
               <a:ext uri="{FF2B5EF4-FFF2-40B4-BE49-F238E27FC236}">
-                <a16:creationId xmlns:a16="http://schemas.microsoft.com/office/drawing/2014/main" id="{9621EFC9-D7D3-403B-9475-C9D3FC4E544C}"/>
+                <a16:creationId xmlns:a16="http://schemas.microsoft.com/office/drawing/2014/main" id="{22C99369-C27D-4777-A16C-62FEEE25C1F8}"/>
               </a:ext>
             </a:extLst>
           </p:cNvPr>
@@ -21665,7 +21665,7 @@
           <p:cNvPr id="3" name="title-8">
             <a:extLst xmlns:a="http://schemas.openxmlformats.org/drawingml/2006/main">
               <a:ext uri="{FF2B5EF4-FFF2-40B4-BE49-F238E27FC236}">
-                <a16:creationId xmlns:a16="http://schemas.microsoft.com/office/drawing/2014/main" id="{8FD23C6B-BED2-454F-ADF5-A232CBCD0C56}"/>
+                <a16:creationId xmlns:a16="http://schemas.microsoft.com/office/drawing/2014/main" id="{7AED49B5-9E8D-4231-9740-B13B45BA75DB}"/>
               </a:ext>
             </a:extLst>
           </p:cNvPr>
@@ -21727,7 +21727,7 @@
           <p:cNvPr id="4" name="">
             <a:extLst xmlns:a="http://schemas.openxmlformats.org/drawingml/2006/main">
               <a:ext uri="{FF2B5EF4-FFF2-40B4-BE49-F238E27FC236}">
-                <a16:creationId xmlns:a16="http://schemas.microsoft.com/office/drawing/2014/main" id="{76804277-C396-41F2-B4DB-BA1A594B7018}"/>
+                <a16:creationId xmlns:a16="http://schemas.microsoft.com/office/drawing/2014/main" id="{C3719E43-211E-4C35-9C30-CFFDB0E62AA3}"/>
               </a:ext>
             </a:extLst>
           </p:cNvPr>
@@ -21789,7 +21789,7 @@
           <p:cNvPr id="5" name="">
             <a:extLst xmlns:a="http://schemas.openxmlformats.org/drawingml/2006/main">
               <a:ext uri="{FF2B5EF4-FFF2-40B4-BE49-F238E27FC236}">
-                <a16:creationId xmlns:a16="http://schemas.microsoft.com/office/drawing/2014/main" id="{E77C7108-D4FC-4799-9941-AA9A3F5D6B1A}"/>
+                <a16:creationId xmlns:a16="http://schemas.microsoft.com/office/drawing/2014/main" id="{4F4E0251-74E3-4475-80C9-4233906E670E}"/>
               </a:ext>
             </a:extLst>
           </p:cNvPr>
@@ -21820,7 +21820,7 @@
           <p:cNvPr id="6" name="">
             <a:extLst xmlns:a="http://schemas.openxmlformats.org/drawingml/2006/main">
               <a:ext uri="{FF2B5EF4-FFF2-40B4-BE49-F238E27FC236}">
-                <a16:creationId xmlns:a16="http://schemas.microsoft.com/office/drawing/2014/main" id="{0251EC0F-AFA1-4325-B0D1-FB68A98C455F}"/>
+                <a16:creationId xmlns:a16="http://schemas.microsoft.com/office/drawing/2014/main" id="{E2893843-ECE6-466D-92CC-13EA84DDC923}"/>
               </a:ext>
             </a:extLst>
           </p:cNvPr>
@@ -21851,7 +21851,7 @@
           <p:cNvPr id="7" name="">
             <a:extLst xmlns:a="http://schemas.openxmlformats.org/drawingml/2006/main">
               <a:ext uri="{FF2B5EF4-FFF2-40B4-BE49-F238E27FC236}">
-                <a16:creationId xmlns:a16="http://schemas.microsoft.com/office/drawing/2014/main" id="{138FE144-EC31-4F51-B365-4565A28AD095}"/>
+                <a16:creationId xmlns:a16="http://schemas.microsoft.com/office/drawing/2014/main" id="{A60B7BE2-D2D8-4149-A7D2-B7D317C52ACE}"/>
               </a:ext>
             </a:extLst>
           </p:cNvPr>
@@ -21913,7 +21913,7 @@
           <p:cNvPr id="8" name="">
             <a:extLst xmlns:a="http://schemas.openxmlformats.org/drawingml/2006/main">
               <a:ext uri="{FF2B5EF4-FFF2-40B4-BE49-F238E27FC236}">
-                <a16:creationId xmlns:a16="http://schemas.microsoft.com/office/drawing/2014/main" id="{D7F2FF50-D21C-47F1-8EF3-693C3A590E7A}"/>
+                <a16:creationId xmlns:a16="http://schemas.microsoft.com/office/drawing/2014/main" id="{D1511AA5-6019-45E6-9EC0-FA0584D933AB}"/>
               </a:ext>
             </a:extLst>
           </p:cNvPr>
@@ -21975,7 +21975,7 @@
           <p:cNvPr id="9" name="">
             <a:extLst xmlns:a="http://schemas.openxmlformats.org/drawingml/2006/main">
               <a:ext uri="{FF2B5EF4-FFF2-40B4-BE49-F238E27FC236}">
-                <a16:creationId xmlns:a16="http://schemas.microsoft.com/office/drawing/2014/main" id="{FF71CB07-4A61-44AA-BA31-BA3974F7782A}"/>
+                <a16:creationId xmlns:a16="http://schemas.microsoft.com/office/drawing/2014/main" id="{F5000F7F-56AF-4BD2-B2A2-7DF46746F8E2}"/>
               </a:ext>
             </a:extLst>
           </p:cNvPr>
@@ -22037,7 +22037,7 @@
           <p:cNvPr id="10" name="">
             <a:extLst xmlns:a="http://schemas.openxmlformats.org/drawingml/2006/main">
               <a:ext uri="{FF2B5EF4-FFF2-40B4-BE49-F238E27FC236}">
-                <a16:creationId xmlns:a16="http://schemas.microsoft.com/office/drawing/2014/main" id="{DEF86FFF-C3AE-45DF-8157-C2049102DE1E}"/>
+                <a16:creationId xmlns:a16="http://schemas.microsoft.com/office/drawing/2014/main" id="{B7FA89B8-649A-470E-ADD7-E626CB3C8BE7}"/>
               </a:ext>
             </a:extLst>
           </p:cNvPr>
@@ -22068,7 +22068,7 @@
           <p:cNvPr id="11" name="">
             <a:extLst xmlns:a="http://schemas.openxmlformats.org/drawingml/2006/main">
               <a:ext uri="{FF2B5EF4-FFF2-40B4-BE49-F238E27FC236}">
-                <a16:creationId xmlns:a16="http://schemas.microsoft.com/office/drawing/2014/main" id="{6B4F92C6-4EB2-41CD-9193-FAC536BE1ED0}"/>
+                <a16:creationId xmlns:a16="http://schemas.microsoft.com/office/drawing/2014/main" id="{7FB9B9EE-52E8-4365-8E0C-0BB354CD0375}"/>
               </a:ext>
             </a:extLst>
           </p:cNvPr>
@@ -22130,7 +22130,7 @@
           <p:cNvPr id="12" name="">
             <a:extLst xmlns:a="http://schemas.openxmlformats.org/drawingml/2006/main">
               <a:ext uri="{FF2B5EF4-FFF2-40B4-BE49-F238E27FC236}">
-                <a16:creationId xmlns:a16="http://schemas.microsoft.com/office/drawing/2014/main" id="{8C8EDABE-1B8B-44A4-BDE9-5D4C5C11DC1C}"/>
+                <a16:creationId xmlns:a16="http://schemas.microsoft.com/office/drawing/2014/main" id="{300328B7-FEAE-4E63-A164-F2153FB5BC75}"/>
               </a:ext>
             </a:extLst>
           </p:cNvPr>
@@ -22192,7 +22192,7 @@
           <p:cNvPr id="13" name="">
             <a:extLst xmlns:a="http://schemas.openxmlformats.org/drawingml/2006/main">
               <a:ext uri="{FF2B5EF4-FFF2-40B4-BE49-F238E27FC236}">
-                <a16:creationId xmlns:a16="http://schemas.microsoft.com/office/drawing/2014/main" id="{CAA25F41-37E6-4E20-8EA0-09A935E12402}"/>
+                <a16:creationId xmlns:a16="http://schemas.microsoft.com/office/drawing/2014/main" id="{E1E6B84D-40B3-45C3-812A-21614D972C4D}"/>
               </a:ext>
             </a:extLst>
           </p:cNvPr>
@@ -22254,7 +22254,7 @@
           <p:cNvPr id="14" name="">
             <a:extLst xmlns:a="http://schemas.openxmlformats.org/drawingml/2006/main">
               <a:ext uri="{FF2B5EF4-FFF2-40B4-BE49-F238E27FC236}">
-                <a16:creationId xmlns:a16="http://schemas.microsoft.com/office/drawing/2014/main" id="{CD7F68FD-EBCC-473F-BA7A-90B8ED392688}"/>
+                <a16:creationId xmlns:a16="http://schemas.microsoft.com/office/drawing/2014/main" id="{A3830EE2-FAEE-4CA8-8113-B53D20AB2137}"/>
               </a:ext>
             </a:extLst>
           </p:cNvPr>
@@ -22285,7 +22285,7 @@
           <p:cNvPr id="15" name="">
             <a:extLst xmlns:a="http://schemas.openxmlformats.org/drawingml/2006/main">
               <a:ext uri="{FF2B5EF4-FFF2-40B4-BE49-F238E27FC236}">
-                <a16:creationId xmlns:a16="http://schemas.microsoft.com/office/drawing/2014/main" id="{0285180A-7756-4C22-9EAB-04104157F1EF}"/>
+                <a16:creationId xmlns:a16="http://schemas.microsoft.com/office/drawing/2014/main" id="{B35BA54E-1A9C-4303-8BE1-7B383DF30231}"/>
               </a:ext>
             </a:extLst>
           </p:cNvPr>
@@ -22347,7 +22347,7 @@
           <p:cNvPr id="16" name="">
             <a:extLst xmlns:a="http://schemas.openxmlformats.org/drawingml/2006/main">
               <a:ext uri="{FF2B5EF4-FFF2-40B4-BE49-F238E27FC236}">
-                <a16:creationId xmlns:a16="http://schemas.microsoft.com/office/drawing/2014/main" id="{211AC018-E708-4BA4-BAB4-2666B1ECD421}"/>
+                <a16:creationId xmlns:a16="http://schemas.microsoft.com/office/drawing/2014/main" id="{D67EDB78-88FB-4697-8E1F-9EE78B8ADF5F}"/>
               </a:ext>
             </a:extLst>
           </p:cNvPr>
@@ -22409,7 +22409,7 @@
           <p:cNvPr id="17" name="">
             <a:extLst xmlns:a="http://schemas.openxmlformats.org/drawingml/2006/main">
               <a:ext uri="{FF2B5EF4-FFF2-40B4-BE49-F238E27FC236}">
-                <a16:creationId xmlns:a16="http://schemas.microsoft.com/office/drawing/2014/main" id="{83D2DD82-C079-45F6-BB46-D06FA9BEF562}"/>
+                <a16:creationId xmlns:a16="http://schemas.microsoft.com/office/drawing/2014/main" id="{CBD0B8AE-23A8-4A87-A002-7EEA22E91C37}"/>
               </a:ext>
             </a:extLst>
           </p:cNvPr>
@@ -22471,7 +22471,7 @@
           <p:cNvPr id="18" name="">
             <a:extLst xmlns:a="http://schemas.openxmlformats.org/drawingml/2006/main">
               <a:ext uri="{FF2B5EF4-FFF2-40B4-BE49-F238E27FC236}">
-                <a16:creationId xmlns:a16="http://schemas.microsoft.com/office/drawing/2014/main" id="{F9DA1A75-39F7-409E-8BC5-07CCD39D7569}"/>
+                <a16:creationId xmlns:a16="http://schemas.microsoft.com/office/drawing/2014/main" id="{ACE69F09-0315-45CF-845B-DFBDACC465A3}"/>
               </a:ext>
             </a:extLst>
           </p:cNvPr>
@@ -22502,7 +22502,7 @@
           <p:cNvPr id="19" name="">
             <a:extLst xmlns:a="http://schemas.openxmlformats.org/drawingml/2006/main">
               <a:ext uri="{FF2B5EF4-FFF2-40B4-BE49-F238E27FC236}">
-                <a16:creationId xmlns:a16="http://schemas.microsoft.com/office/drawing/2014/main" id="{1AC73EE4-184B-4FCF-A313-31DE969D3836}"/>
+                <a16:creationId xmlns:a16="http://schemas.microsoft.com/office/drawing/2014/main" id="{DF148678-B462-4648-A20B-787F27D12ED2}"/>
               </a:ext>
             </a:extLst>
           </p:cNvPr>
@@ -22564,7 +22564,7 @@
           <p:cNvPr id="20" name="">
             <a:extLst xmlns:a="http://schemas.openxmlformats.org/drawingml/2006/main">
               <a:ext uri="{FF2B5EF4-FFF2-40B4-BE49-F238E27FC236}">
-                <a16:creationId xmlns:a16="http://schemas.microsoft.com/office/drawing/2014/main" id="{267F5C4A-9E40-4A45-BC05-4B1A5CAB4CFC}"/>
+                <a16:creationId xmlns:a16="http://schemas.microsoft.com/office/drawing/2014/main" id="{46185002-5EE2-4234-87FB-1E9AB5B4D489}"/>
               </a:ext>
             </a:extLst>
           </p:cNvPr>
@@ -22626,7 +22626,7 @@
           <p:cNvPr id="21" name="">
             <a:extLst xmlns:a="http://schemas.openxmlformats.org/drawingml/2006/main">
               <a:ext uri="{FF2B5EF4-FFF2-40B4-BE49-F238E27FC236}">
-                <a16:creationId xmlns:a16="http://schemas.microsoft.com/office/drawing/2014/main" id="{E3A37E71-FB25-450E-AE10-C956705887D7}"/>
+                <a16:creationId xmlns:a16="http://schemas.microsoft.com/office/drawing/2014/main" id="{B3A11DEE-CE6B-456B-9328-EBE937016B5B}"/>
               </a:ext>
             </a:extLst>
           </p:cNvPr>
@@ -22688,7 +22688,7 @@
           <p:cNvPr id="22" name="">
             <a:extLst xmlns:a="http://schemas.openxmlformats.org/drawingml/2006/main">
               <a:ext uri="{FF2B5EF4-FFF2-40B4-BE49-F238E27FC236}">
-                <a16:creationId xmlns:a16="http://schemas.microsoft.com/office/drawing/2014/main" id="{260E5E87-01CF-4992-B814-1EB50C7EF729}"/>
+                <a16:creationId xmlns:a16="http://schemas.microsoft.com/office/drawing/2014/main" id="{E4DBD94E-7345-40DE-B1B0-32632B62A1EC}"/>
               </a:ext>
             </a:extLst>
           </p:cNvPr>
@@ -22750,7 +22750,7 @@
           <p:cNvPr id="23" name="footer-rule-8">
             <a:extLst xmlns:a="http://schemas.openxmlformats.org/drawingml/2006/main">
               <a:ext uri="{FF2B5EF4-FFF2-40B4-BE49-F238E27FC236}">
-                <a16:creationId xmlns:a16="http://schemas.microsoft.com/office/drawing/2014/main" id="{B2CA0351-BA38-4FED-B216-6744EB0DA499}"/>
+                <a16:creationId xmlns:a16="http://schemas.microsoft.com/office/drawing/2014/main" id="{60D956C9-2132-4025-B095-FF06C9C5744F}"/>
               </a:ext>
             </a:extLst>
           </p:cNvPr>
@@ -22781,7 +22781,7 @@
           <p:cNvPr id="24" name="footer-label-8">
             <a:extLst xmlns:a="http://schemas.openxmlformats.org/drawingml/2006/main">
               <a:ext uri="{FF2B5EF4-FFF2-40B4-BE49-F238E27FC236}">
-                <a16:creationId xmlns:a16="http://schemas.microsoft.com/office/drawing/2014/main" id="{C9068024-D850-4534-A680-F476BA82B686}"/>
+                <a16:creationId xmlns:a16="http://schemas.microsoft.com/office/drawing/2014/main" id="{8ED755D3-B9E0-484F-B6A2-C453B009F7A4}"/>
               </a:ext>
             </a:extLst>
           </p:cNvPr>
@@ -22843,7 +22843,7 @@
           <p:cNvPr id="25" name="footer-page-8">
             <a:extLst xmlns:a="http://schemas.openxmlformats.org/drawingml/2006/main">
               <a:ext uri="{FF2B5EF4-FFF2-40B4-BE49-F238E27FC236}">
-                <a16:creationId xmlns:a16="http://schemas.microsoft.com/office/drawing/2014/main" id="{DE14E792-8600-468B-BE59-6D71FCB9CD21}"/>
+                <a16:creationId xmlns:a16="http://schemas.microsoft.com/office/drawing/2014/main" id="{D2F3932E-7027-4586-A74C-D9EDA2325B2D}"/>
               </a:ext>
             </a:extLst>
           </p:cNvPr>
@@ -22903,7 +22903,7 @@
     </p:spTree>
     <p:extLst>
       <p:ext uri="{BB962C8B-B14F-4D97-AF65-F5344CB8AC3E}">
-        <p14:creationId xmlns:p14="http://schemas.microsoft.com/office/powerpoint/2010/main" val="435608072"/>
+        <p14:creationId xmlns:p14="http://schemas.microsoft.com/office/powerpoint/2010/main" val="1753216743"/>
       </p:ext>
     </p:extLst>
   </p:cSld>
@@ -22934,7 +22934,7 @@
           <p:cNvPr id="25" name="side-accent-9">
             <a:extLst xmlns:a="http://schemas.openxmlformats.org/drawingml/2006/main">
               <a:ext uri="{FF2B5EF4-FFF2-40B4-BE49-F238E27FC236}">
-                <a16:creationId xmlns:a16="http://schemas.microsoft.com/office/drawing/2014/main" id="{D2D6A377-7385-4A59-AE23-B9A58D158B40}"/>
+                <a16:creationId xmlns:a16="http://schemas.microsoft.com/office/drawing/2014/main" id="{9EE2C900-0722-4B69-A796-06D077143404}"/>
               </a:ext>
             </a:extLst>
           </p:cNvPr>
@@ -22965,7 +22965,7 @@
           <p:cNvPr id="2" name="kicker-9">
             <a:extLst xmlns:a="http://schemas.openxmlformats.org/drawingml/2006/main">
               <a:ext uri="{FF2B5EF4-FFF2-40B4-BE49-F238E27FC236}">
-                <a16:creationId xmlns:a16="http://schemas.microsoft.com/office/drawing/2014/main" id="{EE62A615-E86D-4090-A038-628EF6DED894}"/>
+                <a16:creationId xmlns:a16="http://schemas.microsoft.com/office/drawing/2014/main" id="{4766B836-8847-40DE-85C3-C8C78251CD53}"/>
               </a:ext>
             </a:extLst>
           </p:cNvPr>
@@ -23027,7 +23027,7 @@
           <p:cNvPr id="3" name="title-9">
             <a:extLst xmlns:a="http://schemas.openxmlformats.org/drawingml/2006/main">
               <a:ext uri="{FF2B5EF4-FFF2-40B4-BE49-F238E27FC236}">
-                <a16:creationId xmlns:a16="http://schemas.microsoft.com/office/drawing/2014/main" id="{D82B576F-C721-4157-B6B4-B70EE9B68CBE}"/>
+                <a16:creationId xmlns:a16="http://schemas.microsoft.com/office/drawing/2014/main" id="{D65A391D-25B4-492E-9B1A-4C303776DF0C}"/>
               </a:ext>
             </a:extLst>
           </p:cNvPr>
@@ -23089,7 +23089,7 @@
           <p:cNvPr id="4" name="">
             <a:extLst xmlns:a="http://schemas.openxmlformats.org/drawingml/2006/main">
               <a:ext uri="{FF2B5EF4-FFF2-40B4-BE49-F238E27FC236}">
-                <a16:creationId xmlns:a16="http://schemas.microsoft.com/office/drawing/2014/main" id="{33F06A60-629F-48ED-B83F-8C6B0264F5D1}"/>
+                <a16:creationId xmlns:a16="http://schemas.microsoft.com/office/drawing/2014/main" id="{A378A7A0-E46E-4227-B824-E1C42C239B4A}"/>
               </a:ext>
             </a:extLst>
           </p:cNvPr>
@@ -23151,7 +23151,7 @@
           <p:cNvPr id="5" name="">
             <a:extLst xmlns:a="http://schemas.openxmlformats.org/drawingml/2006/main">
               <a:ext uri="{FF2B5EF4-FFF2-40B4-BE49-F238E27FC236}">
-                <a16:creationId xmlns:a16="http://schemas.microsoft.com/office/drawing/2014/main" id="{9C2E8E20-A6B6-4C92-9FBA-5E566D2EE66E}"/>
+                <a16:creationId xmlns:a16="http://schemas.microsoft.com/office/drawing/2014/main" id="{5328A382-CFCD-4610-A3EB-423BC493923C}"/>
               </a:ext>
             </a:extLst>
           </p:cNvPr>
@@ -23186,7 +23186,7 @@
           <p:cNvPr id="6" name="">
             <a:extLst xmlns:a="http://schemas.openxmlformats.org/drawingml/2006/main">
               <a:ext uri="{FF2B5EF4-FFF2-40B4-BE49-F238E27FC236}">
-                <a16:creationId xmlns:a16="http://schemas.microsoft.com/office/drawing/2014/main" id="{7476F2C9-29C9-4359-B158-13D2241DB4A8}"/>
+                <a16:creationId xmlns:a16="http://schemas.microsoft.com/office/drawing/2014/main" id="{1FB4E8C3-23B1-40C5-B7B0-FC13F33FB772}"/>
               </a:ext>
             </a:extLst>
           </p:cNvPr>
@@ -23248,7 +23248,7 @@
           <p:cNvPr id="7" name="">
             <a:extLst xmlns:a="http://schemas.openxmlformats.org/drawingml/2006/main">
               <a:ext uri="{FF2B5EF4-FFF2-40B4-BE49-F238E27FC236}">
-                <a16:creationId xmlns:a16="http://schemas.microsoft.com/office/drawing/2014/main" id="{544AB7FA-9BA7-44DE-8026-466A03245891}"/>
+                <a16:creationId xmlns:a16="http://schemas.microsoft.com/office/drawing/2014/main" id="{98B986D4-A49A-4537-8BF7-A456B2D7EFFC}"/>
               </a:ext>
             </a:extLst>
           </p:cNvPr>
@@ -23310,7 +23310,7 @@
           <p:cNvPr id="8" name="">
             <a:extLst xmlns:a="http://schemas.openxmlformats.org/drawingml/2006/main">
               <a:ext uri="{FF2B5EF4-FFF2-40B4-BE49-F238E27FC236}">
-                <a16:creationId xmlns:a16="http://schemas.microsoft.com/office/drawing/2014/main" id="{CC45D3CD-8160-4F72-80EF-D26624301E41}"/>
+                <a16:creationId xmlns:a16="http://schemas.microsoft.com/office/drawing/2014/main" id="{A7A0DE38-8957-4488-9D83-9D7A142ED80D}"/>
               </a:ext>
             </a:extLst>
           </p:cNvPr>
@@ -23372,7 +23372,7 @@
           <p:cNvPr id="9" name="">
             <a:extLst xmlns:a="http://schemas.openxmlformats.org/drawingml/2006/main">
               <a:ext uri="{FF2B5EF4-FFF2-40B4-BE49-F238E27FC236}">
-                <a16:creationId xmlns:a16="http://schemas.microsoft.com/office/drawing/2014/main" id="{14161DAA-9BC8-4128-A3CA-8857F35C312E}"/>
+                <a16:creationId xmlns:a16="http://schemas.microsoft.com/office/drawing/2014/main" id="{7AB382DB-C115-4023-BCB8-2FA6ECFA74E8}"/>
               </a:ext>
             </a:extLst>
           </p:cNvPr>
@@ -23407,7 +23407,7 @@
           <p:cNvPr id="10" name="">
             <a:extLst xmlns:a="http://schemas.openxmlformats.org/drawingml/2006/main">
               <a:ext uri="{FF2B5EF4-FFF2-40B4-BE49-F238E27FC236}">
-                <a16:creationId xmlns:a16="http://schemas.microsoft.com/office/drawing/2014/main" id="{59063A46-FA2B-488B-8D67-9039ED4935F8}"/>
+                <a16:creationId xmlns:a16="http://schemas.microsoft.com/office/drawing/2014/main" id="{E21B8E9B-1669-40B6-A6DA-E84125E4B26D}"/>
               </a:ext>
             </a:extLst>
           </p:cNvPr>
@@ -23469,7 +23469,7 @@
           <p:cNvPr id="11" name="">
             <a:extLst xmlns:a="http://schemas.openxmlformats.org/drawingml/2006/main">
               <a:ext uri="{FF2B5EF4-FFF2-40B4-BE49-F238E27FC236}">
-                <a16:creationId xmlns:a16="http://schemas.microsoft.com/office/drawing/2014/main" id="{A642A99F-77ED-478E-B2D1-7A08CA19BC48}"/>
+                <a16:creationId xmlns:a16="http://schemas.microsoft.com/office/drawing/2014/main" id="{AF0AEEA1-CB51-43EB-8C44-7F08C553711C}"/>
               </a:ext>
             </a:extLst>
           </p:cNvPr>
@@ -23531,7 +23531,7 @@
           <p:cNvPr id="12" name="">
             <a:extLst xmlns:a="http://schemas.openxmlformats.org/drawingml/2006/main">
               <a:ext uri="{FF2B5EF4-FFF2-40B4-BE49-F238E27FC236}">
-                <a16:creationId xmlns:a16="http://schemas.microsoft.com/office/drawing/2014/main" id="{018DA19E-7720-4347-A87C-3B56DE64C0DE}"/>
+                <a16:creationId xmlns:a16="http://schemas.microsoft.com/office/drawing/2014/main" id="{B8A200E2-32FE-42D6-AB01-DCBC934E97C7}"/>
               </a:ext>
             </a:extLst>
           </p:cNvPr>
@@ -23593,7 +23593,7 @@
           <p:cNvPr id="13" name="">
             <a:extLst xmlns:a="http://schemas.openxmlformats.org/drawingml/2006/main">
               <a:ext uri="{FF2B5EF4-FFF2-40B4-BE49-F238E27FC236}">
-                <a16:creationId xmlns:a16="http://schemas.microsoft.com/office/drawing/2014/main" id="{04D5067F-6CD6-4C45-BA78-1D0D82B85026}"/>
+                <a16:creationId xmlns:a16="http://schemas.microsoft.com/office/drawing/2014/main" id="{9BCB4A7D-EACE-436D-9A24-F1D468E2567F}"/>
               </a:ext>
             </a:extLst>
           </p:cNvPr>
@@ -23628,7 +23628,7 @@
           <p:cNvPr id="14" name="">
             <a:extLst xmlns:a="http://schemas.openxmlformats.org/drawingml/2006/main">
               <a:ext uri="{FF2B5EF4-FFF2-40B4-BE49-F238E27FC236}">
-                <a16:creationId xmlns:a16="http://schemas.microsoft.com/office/drawing/2014/main" id="{F0C0ADBF-1F51-4BE5-B154-2D8EE77BFC1E}"/>
+                <a16:creationId xmlns:a16="http://schemas.microsoft.com/office/drawing/2014/main" id="{2EEA0CC7-6C28-417A-8529-27D20C41B7F8}"/>
               </a:ext>
             </a:extLst>
           </p:cNvPr>
@@ -23690,7 +23690,7 @@
           <p:cNvPr id="15" name="">
             <a:extLst xmlns:a="http://schemas.openxmlformats.org/drawingml/2006/main">
               <a:ext uri="{FF2B5EF4-FFF2-40B4-BE49-F238E27FC236}">
-                <a16:creationId xmlns:a16="http://schemas.microsoft.com/office/drawing/2014/main" id="{AB01FEBE-6AA6-4DFC-BAB2-233706842627}"/>
+                <a16:creationId xmlns:a16="http://schemas.microsoft.com/office/drawing/2014/main" id="{17BB385C-733A-4018-8084-1E14BD42FC7C}"/>
               </a:ext>
             </a:extLst>
           </p:cNvPr>
@@ -23752,7 +23752,7 @@
           <p:cNvPr id="16" name="">
             <a:extLst xmlns:a="http://schemas.openxmlformats.org/drawingml/2006/main">
               <a:ext uri="{FF2B5EF4-FFF2-40B4-BE49-F238E27FC236}">
-                <a16:creationId xmlns:a16="http://schemas.microsoft.com/office/drawing/2014/main" id="{946B980E-4429-4E70-BB57-7ADC5F9999C7}"/>
+                <a16:creationId xmlns:a16="http://schemas.microsoft.com/office/drawing/2014/main" id="{5FE6D2EE-C13D-4A81-ADCE-5EEBF1268413}"/>
               </a:ext>
             </a:extLst>
           </p:cNvPr>
@@ -23814,7 +23814,7 @@
           <p:cNvPr id="17" name="">
             <a:extLst xmlns:a="http://schemas.openxmlformats.org/drawingml/2006/main">
               <a:ext uri="{FF2B5EF4-FFF2-40B4-BE49-F238E27FC236}">
-                <a16:creationId xmlns:a16="http://schemas.microsoft.com/office/drawing/2014/main" id="{ACD19F60-B7AE-4ADB-8F97-A9FA92E3F0A8}"/>
+                <a16:creationId xmlns:a16="http://schemas.microsoft.com/office/drawing/2014/main" id="{1696C40A-D24C-49F2-887C-C986C72EB99C}"/>
               </a:ext>
             </a:extLst>
           </p:cNvPr>
@@ -23849,7 +23849,7 @@
           <p:cNvPr id="18" name="">
             <a:extLst xmlns:a="http://schemas.openxmlformats.org/drawingml/2006/main">
               <a:ext uri="{FF2B5EF4-FFF2-40B4-BE49-F238E27FC236}">
-                <a16:creationId xmlns:a16="http://schemas.microsoft.com/office/drawing/2014/main" id="{1F7D7048-E833-462F-9136-9A1732D9EC74}"/>
+                <a16:creationId xmlns:a16="http://schemas.microsoft.com/office/drawing/2014/main" id="{B090F62F-90AC-4009-86E5-988243CC3790}"/>
               </a:ext>
             </a:extLst>
           </p:cNvPr>
@@ -23911,7 +23911,7 @@
           <p:cNvPr id="19" name="">
             <a:extLst xmlns:a="http://schemas.openxmlformats.org/drawingml/2006/main">
               <a:ext uri="{FF2B5EF4-FFF2-40B4-BE49-F238E27FC236}">
-                <a16:creationId xmlns:a16="http://schemas.microsoft.com/office/drawing/2014/main" id="{A0402FC1-A3A7-4C54-983D-7AE340A34F02}"/>
+                <a16:creationId xmlns:a16="http://schemas.microsoft.com/office/drawing/2014/main" id="{4628D9D5-B68F-4BD6-B0C0-51281F478009}"/>
               </a:ext>
             </a:extLst>
           </p:cNvPr>
@@ -23973,7 +23973,7 @@
           <p:cNvPr id="20" name="">
             <a:extLst xmlns:a="http://schemas.openxmlformats.org/drawingml/2006/main">
               <a:ext uri="{FF2B5EF4-FFF2-40B4-BE49-F238E27FC236}">
-                <a16:creationId xmlns:a16="http://schemas.microsoft.com/office/drawing/2014/main" id="{D752EE70-26C4-485A-8E6C-AB0A37FF9081}"/>
+                <a16:creationId xmlns:a16="http://schemas.microsoft.com/office/drawing/2014/main" id="{ADDB198B-E48F-4067-A239-2BAEC6291AC2}"/>
               </a:ext>
             </a:extLst>
           </p:cNvPr>
@@ -24035,7 +24035,7 @@
           <p:cNvPr id="21" name="">
             <a:extLst xmlns:a="http://schemas.openxmlformats.org/drawingml/2006/main">
               <a:ext uri="{FF2B5EF4-FFF2-40B4-BE49-F238E27FC236}">
-                <a16:creationId xmlns:a16="http://schemas.microsoft.com/office/drawing/2014/main" id="{CEF827AE-C64A-4839-BD39-DDA63C381903}"/>
+                <a16:creationId xmlns:a16="http://schemas.microsoft.com/office/drawing/2014/main" id="{763F2761-75B8-48FC-B54C-605E9CDCCA64}"/>
               </a:ext>
             </a:extLst>
           </p:cNvPr>
@@ -24097,7 +24097,7 @@
           <p:cNvPr id="22" name="footer-rule-9">
             <a:extLst xmlns:a="http://schemas.openxmlformats.org/drawingml/2006/main">
               <a:ext uri="{FF2B5EF4-FFF2-40B4-BE49-F238E27FC236}">
-                <a16:creationId xmlns:a16="http://schemas.microsoft.com/office/drawing/2014/main" id="{FB278C13-AF0A-41F0-B6D4-934FB45F5142}"/>
+                <a16:creationId xmlns:a16="http://schemas.microsoft.com/office/drawing/2014/main" id="{7C92D9FC-8368-4834-9CF1-956D26ED3D6A}"/>
               </a:ext>
             </a:extLst>
           </p:cNvPr>
@@ -24128,7 +24128,7 @@
           <p:cNvPr id="23" name="footer-label-9">
             <a:extLst xmlns:a="http://schemas.openxmlformats.org/drawingml/2006/main">
               <a:ext uri="{FF2B5EF4-FFF2-40B4-BE49-F238E27FC236}">
-                <a16:creationId xmlns:a16="http://schemas.microsoft.com/office/drawing/2014/main" id="{2B68AAB9-609B-477B-A4B1-E751D8FA6780}"/>
+                <a16:creationId xmlns:a16="http://schemas.microsoft.com/office/drawing/2014/main" id="{B464C367-291D-4A8E-A1FF-0E48A7EFD4BF}"/>
               </a:ext>
             </a:extLst>
           </p:cNvPr>
@@ -24190,7 +24190,7 @@
           <p:cNvPr id="24" name="footer-page-9">
             <a:extLst xmlns:a="http://schemas.openxmlformats.org/drawingml/2006/main">
               <a:ext uri="{FF2B5EF4-FFF2-40B4-BE49-F238E27FC236}">
-                <a16:creationId xmlns:a16="http://schemas.microsoft.com/office/drawing/2014/main" id="{2A8256D5-5C32-4377-B7BA-56F6BB2483FF}"/>
+                <a16:creationId xmlns:a16="http://schemas.microsoft.com/office/drawing/2014/main" id="{61B5B7DC-3462-4689-92D0-67D1CA4B0144}"/>
               </a:ext>
             </a:extLst>
           </p:cNvPr>
@@ -24250,7 +24250,7 @@
     </p:spTree>
     <p:extLst>
       <p:ext uri="{BB962C8B-B14F-4D97-AF65-F5344CB8AC3E}">
-        <p14:creationId xmlns:p14="http://schemas.microsoft.com/office/powerpoint/2010/main" val="260571125"/>
+        <p14:creationId xmlns:p14="http://schemas.microsoft.com/office/powerpoint/2010/main" val="650540245"/>
       </p:ext>
     </p:extLst>
   </p:cSld>

</xml_diff>

<commit_message>
docs: clarify facilitator demo timing
</commit_message>
<xml_diff>
--- a/docs/MSU-EVA-อบรมสายวิชาการ-ฉบับวิทยากร.pptx
+++ b/docs/MSU-EVA-อบรมสายวิชาการ-ฉบับวิทยากร.pptx
@@ -2,30 +2,30 @@
 <file path=ppt/presentation.xml><?xml version="1.0" encoding="utf-8"?>
 <p:presentation xmlns:p="http://schemas.openxmlformats.org/presentationml/2006/main">
   <p:sldMasterIdLst>
-    <p:sldMasterId xmlns:r="http://schemas.openxmlformats.org/officeDocument/2006/relationships" id="2147483648" r:id="R31010d4792f44304"/>
+    <p:sldMasterId xmlns:r="http://schemas.openxmlformats.org/officeDocument/2006/relationships" id="2147483648" r:id="R3c11d32156b442f5"/>
   </p:sldMasterIdLst>
   <p:notesMasterIdLst>
-    <p:notesMasterId xmlns:r="http://schemas.openxmlformats.org/officeDocument/2006/relationships" r:id="R2d8c23fd8a864642"/>
+    <p:notesMasterId xmlns:r="http://schemas.openxmlformats.org/officeDocument/2006/relationships" r:id="Rbc28fcabc26a4dfb"/>
   </p:notesMasterIdLst>
   <p:sldIdLst>
-    <p:sldId xmlns:r="http://schemas.openxmlformats.org/officeDocument/2006/relationships" id="256" r:id="R682b4cc223d64642"/>
-    <p:sldId xmlns:r="http://schemas.openxmlformats.org/officeDocument/2006/relationships" id="257" r:id="Ra401ba5c9bad44d3"/>
-    <p:sldId xmlns:r="http://schemas.openxmlformats.org/officeDocument/2006/relationships" id="258" r:id="R6f54b557eaf64d10"/>
-    <p:sldId xmlns:r="http://schemas.openxmlformats.org/officeDocument/2006/relationships" id="259" r:id="R5ac53dd30cf34a45"/>
-    <p:sldId xmlns:r="http://schemas.openxmlformats.org/officeDocument/2006/relationships" id="260" r:id="R293764fc8dfc4171"/>
-    <p:sldId xmlns:r="http://schemas.openxmlformats.org/officeDocument/2006/relationships" id="261" r:id="Rdb21b033615744ab"/>
-    <p:sldId xmlns:r="http://schemas.openxmlformats.org/officeDocument/2006/relationships" id="262" r:id="Rd37f424a62044f78"/>
-    <p:sldId xmlns:r="http://schemas.openxmlformats.org/officeDocument/2006/relationships" id="263" r:id="R42bfb9e26f524eda"/>
-    <p:sldId xmlns:r="http://schemas.openxmlformats.org/officeDocument/2006/relationships" id="264" r:id="Rd286f93f33514710"/>
-    <p:sldId xmlns:r="http://schemas.openxmlformats.org/officeDocument/2006/relationships" id="265" r:id="R5939fcd18888485c"/>
-    <p:sldId xmlns:r="http://schemas.openxmlformats.org/officeDocument/2006/relationships" id="266" r:id="R242ebc30cd0a40f7"/>
-    <p:sldId xmlns:r="http://schemas.openxmlformats.org/officeDocument/2006/relationships" id="267" r:id="Rafc956c5f2554476"/>
-    <p:sldId xmlns:r="http://schemas.openxmlformats.org/officeDocument/2006/relationships" id="268" r:id="R724797f174a64ecd"/>
-    <p:sldId xmlns:r="http://schemas.openxmlformats.org/officeDocument/2006/relationships" id="269" r:id="Rf900bf09e2f84b76"/>
-    <p:sldId xmlns:r="http://schemas.openxmlformats.org/officeDocument/2006/relationships" id="270" r:id="Rbf346bd8e133449b"/>
-    <p:sldId xmlns:r="http://schemas.openxmlformats.org/officeDocument/2006/relationships" id="271" r:id="Rf33643b9ba914ff6"/>
-    <p:sldId xmlns:r="http://schemas.openxmlformats.org/officeDocument/2006/relationships" id="272" r:id="R5e1ad202a0664d32"/>
-    <p:sldId xmlns:r="http://schemas.openxmlformats.org/officeDocument/2006/relationships" id="273" r:id="R3d274938c9c149e3"/>
+    <p:sldId xmlns:r="http://schemas.openxmlformats.org/officeDocument/2006/relationships" id="256" r:id="R6ccc4321486a4137"/>
+    <p:sldId xmlns:r="http://schemas.openxmlformats.org/officeDocument/2006/relationships" id="257" r:id="R90a3a745f0734b00"/>
+    <p:sldId xmlns:r="http://schemas.openxmlformats.org/officeDocument/2006/relationships" id="258" r:id="Ra07d888c46f2479d"/>
+    <p:sldId xmlns:r="http://schemas.openxmlformats.org/officeDocument/2006/relationships" id="259" r:id="Rb66bbd8551c44419"/>
+    <p:sldId xmlns:r="http://schemas.openxmlformats.org/officeDocument/2006/relationships" id="260" r:id="R7676b3bc7d10404c"/>
+    <p:sldId xmlns:r="http://schemas.openxmlformats.org/officeDocument/2006/relationships" id="261" r:id="R56fcfdb51a664976"/>
+    <p:sldId xmlns:r="http://schemas.openxmlformats.org/officeDocument/2006/relationships" id="262" r:id="R7165cbe5d35741f0"/>
+    <p:sldId xmlns:r="http://schemas.openxmlformats.org/officeDocument/2006/relationships" id="263" r:id="R2c32fe6a5b4443c2"/>
+    <p:sldId xmlns:r="http://schemas.openxmlformats.org/officeDocument/2006/relationships" id="264" r:id="R21a97dbf181f49c5"/>
+    <p:sldId xmlns:r="http://schemas.openxmlformats.org/officeDocument/2006/relationships" id="265" r:id="R6a21abdf65564b0b"/>
+    <p:sldId xmlns:r="http://schemas.openxmlformats.org/officeDocument/2006/relationships" id="266" r:id="Raa41046c0d954e30"/>
+    <p:sldId xmlns:r="http://schemas.openxmlformats.org/officeDocument/2006/relationships" id="267" r:id="R85868b9a15454521"/>
+    <p:sldId xmlns:r="http://schemas.openxmlformats.org/officeDocument/2006/relationships" id="268" r:id="Rf34b23d06abf452f"/>
+    <p:sldId xmlns:r="http://schemas.openxmlformats.org/officeDocument/2006/relationships" id="269" r:id="Rfa4412faca6e4ee3"/>
+    <p:sldId xmlns:r="http://schemas.openxmlformats.org/officeDocument/2006/relationships" id="270" r:id="R3fb7fc9bd5da477a"/>
+    <p:sldId xmlns:r="http://schemas.openxmlformats.org/officeDocument/2006/relationships" id="271" r:id="R7e163eb071d04098"/>
+    <p:sldId xmlns:r="http://schemas.openxmlformats.org/officeDocument/2006/relationships" id="272" r:id="R2c29a33583164639"/>
+    <p:sldId xmlns:r="http://schemas.openxmlformats.org/officeDocument/2006/relationships" id="273" r:id="R8737c7f9047845aa"/>
   </p:sldIdLst>
   <p:sldSz cx="12192000" cy="6858000"/>
   <p:notesSz cx="6858000" cy="9144000"/>
@@ -664,7 +664,17 @@
           </a:p>
           <a:p xmlns:a="http://schemas.openxmlformats.org/drawingml/2006/main">
             <a:r>
+              <a:t>[เปลี่ยนไปสาธิตระบบ] ต่อไปผมจะเปิดระบบตามหัวข้อนี้ให้ดูครับ ทุกท่านยังไม่ต้องกดตาม ให้สังเกตขั้นตอนบนหน้าจอก่อน</a:t>
+            </a:r>
+          </a:p>
+          <a:p xmlns:a="http://schemas.openxmlformats.org/drawingml/2006/main">
+            <a:r>
               <a:t>[สาธิต] กรอกผลงานหนึ่งรายการ แนบลิงก์หลักฐาน และทดลองเปิดลิงก์จากมุมมองผู้ประเมิน</a:t>
+            </a:r>
+          </a:p>
+          <a:p xmlns:a="http://schemas.openxmlformats.org/drawingml/2006/main">
+            <a:r>
+              <a:t>[กลับมานำเสนอ] เมื่อเห็นวิธีแนบและเปิดหลักฐานแล้ว ต่อไปเรามาแยกบันทึกร่างกับส่งแบบประเมินให้ชัดครับ</a:t>
             </a:r>
           </a:p>
           <a:p xmlns:a="http://schemas.openxmlformats.org/drawingml/2006/main">
@@ -959,7 +969,17 @@
           </a:p>
           <a:p xmlns:a="http://schemas.openxmlformats.org/drawingml/2006/main">
             <a:r>
+              <a:t>[เปลี่ยนไปสาธิตระบบ] ต่อไปผมจะเปิดระบบตามหัวข้อนี้ให้ดูครับ ทุกท่านยังไม่ต้องกดตาม ให้สังเกตขั้นตอนบนหน้าจอก่อน</a:t>
+            </a:r>
+          </a:p>
+          <a:p xmlns:a="http://schemas.openxmlformats.org/drawingml/2006/main">
+            <a:r>
               <a:t>[สาธิต] เปิดรายการในบัญชีผู้ประเมิน ตรวจข้อมูล คะแนน และหลักฐาน แล้วบันทึกผลการประเมิน</a:t>
+            </a:r>
+          </a:p>
+          <a:p xmlns:a="http://schemas.openxmlformats.org/drawingml/2006/main">
+            <a:r>
+              <a:t>[กลับมานำเสนอ] เมื่อเห็นมุมของผู้ประเมินแล้ว ต่อไปเรามาดูการส่งต่องานไปยังผู้ประเมินคนถัดไปครับ</a:t>
             </a:r>
           </a:p>
           <a:p xmlns:a="http://schemas.openxmlformats.org/drawingml/2006/main">
@@ -1064,7 +1084,17 @@
           </a:p>
           <a:p xmlns:a="http://schemas.openxmlformats.org/drawingml/2006/main">
             <a:r>
+              <a:t>[เปลี่ยนไปสาธิตระบบ] ต่อไปผมจะเปิดระบบตามหัวข้อนี้ให้ดูครับ ทุกท่านยังไม่ต้องกดตาม ให้สังเกตขั้นตอนบนหน้าจอก่อน</a:t>
+            </a:r>
+          </a:p>
+          <a:p xmlns:a="http://schemas.openxmlformats.org/drawingml/2006/main">
+            <a:r>
               <a:t>[สาธิต] ส่งต่องานหนึ่งขั้น แล้วสลับไปยังบัญชีผู้ประเมินลำดับถัดไปเพื่อตรวจสถานะ</a:t>
+            </a:r>
+          </a:p>
+          <a:p xmlns:a="http://schemas.openxmlformats.org/drawingml/2006/main">
+            <a:r>
+              <a:t>[กลับมานำเสนอ] เมื่อเห็นการส่งต่องานแล้ว ต่อไปเรามาดูว่าผู้ประเมินคนสุดท้ายปิดงานอย่างไรครับ</a:t>
             </a:r>
           </a:p>
           <a:p xmlns:a="http://schemas.openxmlformats.org/drawingml/2006/main">
@@ -1164,12 +1194,22 @@
           </a:p>
           <a:p xmlns:a="http://schemas.openxmlformats.org/drawingml/2006/main">
             <a:r>
+              <a:t>[เปลี่ยนไปสาธิตระบบ] ต่อไปผมจะเปิดระบบตามหัวข้อนี้ให้ดูครับ ทุกท่านยังไม่ต้องกดตาม ให้สังเกตขั้นตอนบนหน้าจอก่อน</a:t>
+            </a:r>
+          </a:p>
+          <a:p xmlns:a="http://schemas.openxmlformats.org/drawingml/2006/main">
+            <a:r>
               <a:t>[สาธิต] เปิดบัญชีผู้ประเมินคนสุดท้าย ยืนยันผล และแสดงสถานะ Completed</a:t>
             </a:r>
           </a:p>
           <a:p xmlns:a="http://schemas.openxmlformats.org/drawingml/2006/main">
             <a:r>
-              <a:t>[กลับมาที่สไลด์] ชี้ให้เห็นว่างานปิดเมื่อผู้ประเมินคนสุดท้ายในลำดับยืนยันแล้ว</a:t>
+              <a:t>[กลับมานำเสนอ] เมื่อเห็นสถานะ Completed แล้ว ต่อไปจะเป็นช่วงที่ทุกท่านได้ทดลองใช้งานครับ</a:t>
+            </a:r>
+          </a:p>
+          <a:p xmlns:a="http://schemas.openxmlformats.org/drawingml/2006/main">
+            <a:r>
+              <a:t> ชี้ให้เห็นว่างานปิดเมื่อผู้ประเมินคนสุดท้ายในลำดับยืนยันแล้ว</a:t>
             </a:r>
           </a:p>
           <a:p xmlns:a="http://schemas.openxmlformats.org/drawingml/2006/main">
@@ -1879,7 +1919,12 @@
           <a:lstStyle xmlns:a="http://schemas.openxmlformats.org/drawingml/2006/main"/>
           <a:p xmlns:a="http://schemas.openxmlformats.org/drawingml/2006/main">
             <a:r>
-              <a:t>[พูด] ในขั้นแรก ผู้รับการประเมินเป็นเจ้าของความครบถ้วนของข้อมูลครับ หมายความว่าเราต้องตรวจทั้งค่าที่กรอก รายละเอียดผลงาน และหลักฐานให้พร้อม ถ้ายังไม่ครบก็ไม่ต้องรีบส่งนะครับ บันทึกร่างไว้ก่อนได้ ผู้ประเมินจะตัดสินใจจากสิ่งที่เราเตรียมไว้ ถ้าข้อมูลชัดและหลักฐานเปิดได้ งานก็เดินต่อได้ง่าย ตรงนี้เข้าใจตรงกันแล้ว เดี๋ยวผมพาไปดูจุดเริ่มต้นบนหน้าจอจริงครับ</a:t>
+              <a:t>[พูด] ในขั้นแรก ผู้รับการประเมินต้องกรอกข้อมูลและแนบหลักฐานให้ครบครับ ถ้ายังไม่ครบ ให้บันทึกร่างไว้ก่อน ยังไม่ต้องส่งแบบประเมิน ผู้ประเมินจะตัดสินใจจากสิ่งที่เราเตรียมไว้ ถ้าข้อมูลชัดและหลักฐานเปิดได้ งานก็เดินต่อได้ง่าย ตรงนี้เข้าใจตรงกันแล้ว เดี๋ยวผมพาไปดูจุดเริ่มต้นบนหน้าจอจริงครับ</a:t>
+            </a:r>
+          </a:p>
+          <a:p xmlns:a="http://schemas.openxmlformats.org/drawingml/2006/main">
+            <a:r>
+              <a:t>[เตรียมสาธิต] ตั้งแต่สไลด์ถัดไป ผมจะเปิดระบบให้ดูเป็นช่วง ๆ ครับ ทุกท่านยังไม่ต้องกดตาม จนกว่าจะถึงช่วงทดลองใช้งาน</a:t>
             </a:r>
           </a:p>
           <a:p xmlns:a="http://schemas.openxmlformats.org/drawingml/2006/main">
@@ -1979,7 +2024,17 @@
           </a:p>
           <a:p xmlns:a="http://schemas.openxmlformats.org/drawingml/2006/main">
             <a:r>
+              <a:t>[เปลี่ยนไปสาธิตระบบ] ต่อไปผมจะเปิดระบบตามหัวข้อนี้ให้ดูครับ ทุกท่านยังไม่ต้องกดตาม ให้สังเกตขั้นตอนบนหน้าจอก่อน</a:t>
+            </a:r>
+          </a:p>
+          <a:p xmlns:a="http://schemas.openxmlformats.org/drawingml/2006/main">
+            <a:r>
               <a:t>[สาธิต] เปิดแดชบอร์ด ตรวจสอบรอบประเมินที่ได้รับมอบหมาย แล้วเปิดรายการสายวิชาการที่เตรียมไว้</a:t>
+            </a:r>
+          </a:p>
+          <a:p xmlns:a="http://schemas.openxmlformats.org/drawingml/2006/main">
+            <a:r>
+              <a:t>[กลับมานำเสนอ] เมื่อเห็นจุดเริ่มต้นบนระบบแล้ว ต่อไปเรามาดูว่าข้อมูลแต่ละส่วนต้องสัมพันธ์กันอย่างไรครับ</a:t>
             </a:r>
           </a:p>
           <a:p xmlns:a="http://schemas.openxmlformats.org/drawingml/2006/main">
@@ -2252,7 +2307,7 @@
   </p:cSld>
   <p:clrMap bg1="lt1" tx1="dk1" bg2="lt2" tx2="dk2" accent1="accent1" accent2="accent2" accent3="accent3" accent4="accent4" accent5="accent5" accent6="accent6" hlink="hlink" folHlink="folHlink"/>
   <p:sldLayoutIdLst>
-    <p:sldLayoutId xmlns:r="http://schemas.openxmlformats.org/officeDocument/2006/relationships" id="2147483649" r:id="R3501ce47c6d94cac"/>
+    <p:sldLayoutId xmlns:r="http://schemas.openxmlformats.org/officeDocument/2006/relationships" id="2147483649" r:id="R4f49d2c4e6104704"/>
   </p:sldLayoutIdLst>
   <p:txStyles>
     <p:titleStyle>
@@ -2807,7 +2862,7 @@
           <p:nvPr/>
         </p:nvPicPr>
         <p:blipFill>
-          <a:blip xmlns:r="http://schemas.openxmlformats.org/officeDocument/2006/relationships" xmlns:a="http://schemas.openxmlformats.org/drawingml/2006/main" r:embed="R50b759110ae14d15"/>
+          <a:blip xmlns:r="http://schemas.openxmlformats.org/officeDocument/2006/relationships" xmlns:a="http://schemas.openxmlformats.org/drawingml/2006/main" r:embed="R823c57051a67428b"/>
           <a:srcRect xmlns:a="http://schemas.openxmlformats.org/drawingml/2006/main" l="2579" t="0" r="2579" b="0"/>
           <a:stretch xmlns:a="http://schemas.openxmlformats.org/drawingml/2006/main">
             <a:fillRect l="0" t="0" r="0" b="0"/>
@@ -2828,7 +2883,7 @@
           <p:cNvPr id="2" name="cover-panel">
             <a:extLst xmlns:a="http://schemas.openxmlformats.org/drawingml/2006/main">
               <a:ext uri="{FF2B5EF4-FFF2-40B4-BE49-F238E27FC236}">
-                <a16:creationId xmlns:a16="http://schemas.microsoft.com/office/drawing/2014/main" id="{1940AAA3-CC28-459E-9777-B184A744E9A6}"/>
+                <a16:creationId xmlns:a16="http://schemas.microsoft.com/office/drawing/2014/main" id="{EDEDFE9A-3066-4793-A4F2-A7060248380C}"/>
               </a:ext>
             </a:extLst>
           </p:cNvPr>
@@ -2859,7 +2914,7 @@
           <p:cNvPr id="3" name="cover-accent">
             <a:extLst xmlns:a="http://schemas.openxmlformats.org/drawingml/2006/main">
               <a:ext uri="{FF2B5EF4-FFF2-40B4-BE49-F238E27FC236}">
-                <a16:creationId xmlns:a16="http://schemas.microsoft.com/office/drawing/2014/main" id="{17251C57-D60F-424A-8D23-7E615DB85FA4}"/>
+                <a16:creationId xmlns:a16="http://schemas.microsoft.com/office/drawing/2014/main" id="{E15F5367-19D2-42EF-8D53-4E0E8CC1DC60}"/>
               </a:ext>
             </a:extLst>
           </p:cNvPr>
@@ -2894,7 +2949,7 @@
           <p:nvPr/>
         </p:nvPicPr>
         <p:blipFill>
-          <a:blip xmlns:r="http://schemas.openxmlformats.org/officeDocument/2006/relationships" xmlns:a="http://schemas.openxmlformats.org/drawingml/2006/main" r:embed="R9378b61eb4544747"/>
+          <a:blip xmlns:r="http://schemas.openxmlformats.org/officeDocument/2006/relationships" xmlns:a="http://schemas.openxmlformats.org/drawingml/2006/main" r:embed="Rc2ad2bfa71a64297"/>
           <a:stretch xmlns:a="http://schemas.openxmlformats.org/drawingml/2006/main"/>
         </p:blipFill>
         <p:spPr>
@@ -2912,7 +2967,7 @@
           <p:cNvPr id="5" name="cover-institution">
             <a:extLst xmlns:a="http://schemas.openxmlformats.org/drawingml/2006/main">
               <a:ext uri="{FF2B5EF4-FFF2-40B4-BE49-F238E27FC236}">
-                <a16:creationId xmlns:a16="http://schemas.microsoft.com/office/drawing/2014/main" id="{6EAA55FF-BA4F-490D-B093-7DC15885E6E7}"/>
+                <a16:creationId xmlns:a16="http://schemas.microsoft.com/office/drawing/2014/main" id="{90DB7532-2371-4634-B3A3-DAE7A3FF05CA}"/>
               </a:ext>
             </a:extLst>
           </p:cNvPr>
@@ -2974,7 +3029,7 @@
           <p:cNvPr id="6" name="cover-session">
             <a:extLst xmlns:a="http://schemas.openxmlformats.org/drawingml/2006/main">
               <a:ext uri="{FF2B5EF4-FFF2-40B4-BE49-F238E27FC236}">
-                <a16:creationId xmlns:a16="http://schemas.microsoft.com/office/drawing/2014/main" id="{1ED752B1-88B4-43AA-8827-1B1DCC69D11A}"/>
+                <a16:creationId xmlns:a16="http://schemas.microsoft.com/office/drawing/2014/main" id="{5E3D0F6D-C201-4699-89F5-4E17CAC9D0A2}"/>
               </a:ext>
             </a:extLst>
           </p:cNvPr>
@@ -3036,7 +3091,7 @@
           <p:cNvPr id="7" name="cover-title">
             <a:extLst xmlns:a="http://schemas.openxmlformats.org/drawingml/2006/main">
               <a:ext uri="{FF2B5EF4-FFF2-40B4-BE49-F238E27FC236}">
-                <a16:creationId xmlns:a16="http://schemas.microsoft.com/office/drawing/2014/main" id="{BA0E3F31-2CC4-4EEF-A0D5-130ECE7C69CC}"/>
+                <a16:creationId xmlns:a16="http://schemas.microsoft.com/office/drawing/2014/main" id="{B6680FBE-C190-40CE-AC48-62C9F45074E7}"/>
               </a:ext>
             </a:extLst>
           </p:cNvPr>
@@ -3125,7 +3180,7 @@
           <p:cNvPr id="8" name="cover-gold-rule">
             <a:extLst xmlns:a="http://schemas.openxmlformats.org/drawingml/2006/main">
               <a:ext uri="{FF2B5EF4-FFF2-40B4-BE49-F238E27FC236}">
-                <a16:creationId xmlns:a16="http://schemas.microsoft.com/office/drawing/2014/main" id="{11DA346F-E8A0-4892-A679-08070EC26315}"/>
+                <a16:creationId xmlns:a16="http://schemas.microsoft.com/office/drawing/2014/main" id="{3865BD96-140B-4384-99BD-6C5DA49E4214}"/>
               </a:ext>
             </a:extLst>
           </p:cNvPr>
@@ -3156,7 +3211,7 @@
           <p:cNvPr id="9" name="cover-promise">
             <a:extLst xmlns:a="http://schemas.openxmlformats.org/drawingml/2006/main">
               <a:ext uri="{FF2B5EF4-FFF2-40B4-BE49-F238E27FC236}">
-                <a16:creationId xmlns:a16="http://schemas.microsoft.com/office/drawing/2014/main" id="{F48D2DE3-1815-46B5-9C03-EADDBADBD841}"/>
+                <a16:creationId xmlns:a16="http://schemas.microsoft.com/office/drawing/2014/main" id="{E9D520EA-C614-4957-84EE-C7AA6DE31B97}"/>
               </a:ext>
             </a:extLst>
           </p:cNvPr>
@@ -3218,7 +3273,7 @@
           <p:cNvPr id="10" name="cover-style">
             <a:extLst xmlns:a="http://schemas.openxmlformats.org/drawingml/2006/main">
               <a:ext uri="{FF2B5EF4-FFF2-40B4-BE49-F238E27FC236}">
-                <a16:creationId xmlns:a16="http://schemas.microsoft.com/office/drawing/2014/main" id="{C0D81C89-B964-46FB-B869-0B7E0A8B3E8D}"/>
+                <a16:creationId xmlns:a16="http://schemas.microsoft.com/office/drawing/2014/main" id="{594271CF-1B2E-4132-B327-4C36032AF557}"/>
               </a:ext>
             </a:extLst>
           </p:cNvPr>
@@ -3284,7 +3339,7 @@
           <p:nvPr/>
         </p:nvPicPr>
         <p:blipFill>
-          <a:blip xmlns:r="http://schemas.openxmlformats.org/officeDocument/2006/relationships" xmlns:a="http://schemas.openxmlformats.org/drawingml/2006/main" r:embed="R0d45e321cf984c57"/>
+          <a:blip xmlns:r="http://schemas.openxmlformats.org/officeDocument/2006/relationships" xmlns:a="http://schemas.openxmlformats.org/drawingml/2006/main" r:embed="Rb1a5facf1ea64135"/>
           <a:stretch xmlns:a="http://schemas.openxmlformats.org/drawingml/2006/main"/>
         </p:blipFill>
         <p:spPr>
@@ -3300,7 +3355,7 @@
     </p:spTree>
     <p:extLst>
       <p:ext uri="{BB962C8B-B14F-4D97-AF65-F5344CB8AC3E}">
-        <p14:creationId xmlns:p14="http://schemas.microsoft.com/office/powerpoint/2010/main" val="1669697331"/>
+        <p14:creationId xmlns:p14="http://schemas.microsoft.com/office/powerpoint/2010/main" val="1937744159"/>
       </p:ext>
     </p:extLst>
   </p:cSld>
@@ -3331,7 +3386,7 @@
           <p:cNvPr id="21" name="side-accent-10">
             <a:extLst xmlns:a="http://schemas.openxmlformats.org/drawingml/2006/main">
               <a:ext uri="{FF2B5EF4-FFF2-40B4-BE49-F238E27FC236}">
-                <a16:creationId xmlns:a16="http://schemas.microsoft.com/office/drawing/2014/main" id="{4CFA6D5F-AF04-464A-B23B-A10C962E1674}"/>
+                <a16:creationId xmlns:a16="http://schemas.microsoft.com/office/drawing/2014/main" id="{469E2506-D8FD-4170-9C99-D3BC7B8502D2}"/>
               </a:ext>
             </a:extLst>
           </p:cNvPr>
@@ -3362,7 +3417,7 @@
           <p:cNvPr id="2" name="kicker-10">
             <a:extLst xmlns:a="http://schemas.openxmlformats.org/drawingml/2006/main">
               <a:ext uri="{FF2B5EF4-FFF2-40B4-BE49-F238E27FC236}">
-                <a16:creationId xmlns:a16="http://schemas.microsoft.com/office/drawing/2014/main" id="{381C64D6-862C-40AC-8F5D-06F1D56D9DA9}"/>
+                <a16:creationId xmlns:a16="http://schemas.microsoft.com/office/drawing/2014/main" id="{A474F4FF-734A-4DFF-BCAA-D5F1144022FA}"/>
               </a:ext>
             </a:extLst>
           </p:cNvPr>
@@ -3424,7 +3479,7 @@
           <p:cNvPr id="3" name="title-10">
             <a:extLst xmlns:a="http://schemas.openxmlformats.org/drawingml/2006/main">
               <a:ext uri="{FF2B5EF4-FFF2-40B4-BE49-F238E27FC236}">
-                <a16:creationId xmlns:a16="http://schemas.microsoft.com/office/drawing/2014/main" id="{6885A6D0-4755-4DBF-BC29-F2ED31526096}"/>
+                <a16:creationId xmlns:a16="http://schemas.microsoft.com/office/drawing/2014/main" id="{FE7E7304-F16E-4DB9-BEF1-6E9C66BE6A6A}"/>
               </a:ext>
             </a:extLst>
           </p:cNvPr>
@@ -3486,7 +3541,7 @@
           <p:cNvPr id="4" name="">
             <a:extLst xmlns:a="http://schemas.openxmlformats.org/drawingml/2006/main">
               <a:ext uri="{FF2B5EF4-FFF2-40B4-BE49-F238E27FC236}">
-                <a16:creationId xmlns:a16="http://schemas.microsoft.com/office/drawing/2014/main" id="{F2D3A870-7EC9-47A3-8B8D-8BC92DB95596}"/>
+                <a16:creationId xmlns:a16="http://schemas.microsoft.com/office/drawing/2014/main" id="{9571000C-889F-4720-A871-4D2247552889}"/>
               </a:ext>
             </a:extLst>
           </p:cNvPr>
@@ -3548,7 +3603,7 @@
           <p:cNvPr id="5" name="">
             <a:extLst xmlns:a="http://schemas.openxmlformats.org/drawingml/2006/main">
               <a:ext uri="{FF2B5EF4-FFF2-40B4-BE49-F238E27FC236}">
-                <a16:creationId xmlns:a16="http://schemas.microsoft.com/office/drawing/2014/main" id="{F9DCE39D-B7C0-42C6-98D7-6DE28F0800A8}"/>
+                <a16:creationId xmlns:a16="http://schemas.microsoft.com/office/drawing/2014/main" id="{CF1A5E81-A92A-43E1-90F1-E5D7528FDF92}"/>
               </a:ext>
             </a:extLst>
           </p:cNvPr>
@@ -3610,7 +3665,7 @@
           <p:cNvPr id="6" name="">
             <a:extLst xmlns:a="http://schemas.openxmlformats.org/drawingml/2006/main">
               <a:ext uri="{FF2B5EF4-FFF2-40B4-BE49-F238E27FC236}">
-                <a16:creationId xmlns:a16="http://schemas.microsoft.com/office/drawing/2014/main" id="{8BB21438-6FA1-494C-9DC1-7C108676338C}"/>
+                <a16:creationId xmlns:a16="http://schemas.microsoft.com/office/drawing/2014/main" id="{4EBFD44E-351D-44B1-93C8-4D3825DBB496}"/>
               </a:ext>
             </a:extLst>
           </p:cNvPr>
@@ -3672,7 +3727,7 @@
           <p:cNvPr id="7" name="">
             <a:extLst xmlns:a="http://schemas.openxmlformats.org/drawingml/2006/main">
               <a:ext uri="{FF2B5EF4-FFF2-40B4-BE49-F238E27FC236}">
-                <a16:creationId xmlns:a16="http://schemas.microsoft.com/office/drawing/2014/main" id="{8DFDE4DD-DA76-4A11-974C-B822AE6B4081}"/>
+                <a16:creationId xmlns:a16="http://schemas.microsoft.com/office/drawing/2014/main" id="{51C34F9C-CECC-42CF-AFA8-60BBFBA60E4B}"/>
               </a:ext>
             </a:extLst>
           </p:cNvPr>
@@ -3734,7 +3789,7 @@
           <p:cNvPr id="8" name="">
             <a:extLst xmlns:a="http://schemas.openxmlformats.org/drawingml/2006/main">
               <a:ext uri="{FF2B5EF4-FFF2-40B4-BE49-F238E27FC236}">
-                <a16:creationId xmlns:a16="http://schemas.microsoft.com/office/drawing/2014/main" id="{C04B62A6-4733-4FA8-8A96-82B552323005}"/>
+                <a16:creationId xmlns:a16="http://schemas.microsoft.com/office/drawing/2014/main" id="{D424FD62-3A03-47F5-A6C4-E7E7B60F57D8}"/>
               </a:ext>
             </a:extLst>
           </p:cNvPr>
@@ -3765,7 +3820,7 @@
           <p:cNvPr id="9" name="">
             <a:extLst xmlns:a="http://schemas.openxmlformats.org/drawingml/2006/main">
               <a:ext uri="{FF2B5EF4-FFF2-40B4-BE49-F238E27FC236}">
-                <a16:creationId xmlns:a16="http://schemas.microsoft.com/office/drawing/2014/main" id="{4FBBDF97-0BC3-45EF-BB2E-1FB7E7AB9C60}"/>
+                <a16:creationId xmlns:a16="http://schemas.microsoft.com/office/drawing/2014/main" id="{3C47494B-18CB-4345-BBFF-4D5CC002BCEB}"/>
               </a:ext>
             </a:extLst>
           </p:cNvPr>
@@ -3827,7 +3882,7 @@
           <p:cNvPr id="10" name="">
             <a:extLst xmlns:a="http://schemas.openxmlformats.org/drawingml/2006/main">
               <a:ext uri="{FF2B5EF4-FFF2-40B4-BE49-F238E27FC236}">
-                <a16:creationId xmlns:a16="http://schemas.microsoft.com/office/drawing/2014/main" id="{4D4B4162-D252-4A05-833D-24D6BB1848EA}"/>
+                <a16:creationId xmlns:a16="http://schemas.microsoft.com/office/drawing/2014/main" id="{F40A62BA-33C2-48A9-8013-2091E99A0749}"/>
               </a:ext>
             </a:extLst>
           </p:cNvPr>
@@ -3889,7 +3944,7 @@
           <p:cNvPr id="11" name="">
             <a:extLst xmlns:a="http://schemas.openxmlformats.org/drawingml/2006/main">
               <a:ext uri="{FF2B5EF4-FFF2-40B4-BE49-F238E27FC236}">
-                <a16:creationId xmlns:a16="http://schemas.microsoft.com/office/drawing/2014/main" id="{AC352C44-0B32-40B7-A155-8592C6604AA7}"/>
+                <a16:creationId xmlns:a16="http://schemas.microsoft.com/office/drawing/2014/main" id="{A45597E9-D86D-4FBC-B953-C88B158282AB}"/>
               </a:ext>
             </a:extLst>
           </p:cNvPr>
@@ -3951,7 +4006,7 @@
           <p:cNvPr id="12" name="">
             <a:extLst xmlns:a="http://schemas.openxmlformats.org/drawingml/2006/main">
               <a:ext uri="{FF2B5EF4-FFF2-40B4-BE49-F238E27FC236}">
-                <a16:creationId xmlns:a16="http://schemas.microsoft.com/office/drawing/2014/main" id="{DE5DF7CE-2807-44D2-8DFB-A058F1BE1205}"/>
+                <a16:creationId xmlns:a16="http://schemas.microsoft.com/office/drawing/2014/main" id="{44CEC4C6-643A-471F-8E12-3F913FAE9CFD}"/>
               </a:ext>
             </a:extLst>
           </p:cNvPr>
@@ -3982,7 +4037,7 @@
           <p:cNvPr id="13" name="">
             <a:extLst xmlns:a="http://schemas.openxmlformats.org/drawingml/2006/main">
               <a:ext uri="{FF2B5EF4-FFF2-40B4-BE49-F238E27FC236}">
-                <a16:creationId xmlns:a16="http://schemas.microsoft.com/office/drawing/2014/main" id="{ABB533AF-7D15-4D21-98F8-FE56B02E8872}"/>
+                <a16:creationId xmlns:a16="http://schemas.microsoft.com/office/drawing/2014/main" id="{753044D7-2AA2-4A29-84F3-C33BC70DC244}"/>
               </a:ext>
             </a:extLst>
           </p:cNvPr>
@@ -4044,7 +4099,7 @@
           <p:cNvPr id="14" name="">
             <a:extLst xmlns:a="http://schemas.openxmlformats.org/drawingml/2006/main">
               <a:ext uri="{FF2B5EF4-FFF2-40B4-BE49-F238E27FC236}">
-                <a16:creationId xmlns:a16="http://schemas.microsoft.com/office/drawing/2014/main" id="{3FF51788-C174-4A2E-B404-816CF1992673}"/>
+                <a16:creationId xmlns:a16="http://schemas.microsoft.com/office/drawing/2014/main" id="{139604BD-B72C-4374-83B2-F2AF2AF74487}"/>
               </a:ext>
             </a:extLst>
           </p:cNvPr>
@@ -4106,7 +4161,7 @@
           <p:cNvPr id="15" name="">
             <a:extLst xmlns:a="http://schemas.openxmlformats.org/drawingml/2006/main">
               <a:ext uri="{FF2B5EF4-FFF2-40B4-BE49-F238E27FC236}">
-                <a16:creationId xmlns:a16="http://schemas.microsoft.com/office/drawing/2014/main" id="{A45D6905-F38E-4D0C-A9A1-13F88FB5F0D4}"/>
+                <a16:creationId xmlns:a16="http://schemas.microsoft.com/office/drawing/2014/main" id="{7565134A-167B-4781-8B91-60C41D962777}"/>
               </a:ext>
             </a:extLst>
           </p:cNvPr>
@@ -4168,7 +4223,7 @@
           <p:cNvPr id="16" name="">
             <a:extLst xmlns:a="http://schemas.openxmlformats.org/drawingml/2006/main">
               <a:ext uri="{FF2B5EF4-FFF2-40B4-BE49-F238E27FC236}">
-                <a16:creationId xmlns:a16="http://schemas.microsoft.com/office/drawing/2014/main" id="{AEBD0995-CF37-417C-B8A6-A72750874F27}"/>
+                <a16:creationId xmlns:a16="http://schemas.microsoft.com/office/drawing/2014/main" id="{02A79529-C4E3-43F1-87D3-F6E13E3B04B7}"/>
               </a:ext>
             </a:extLst>
           </p:cNvPr>
@@ -4201,7 +4256,7 @@
           <p:cNvPr id="17" name="">
             <a:extLst xmlns:a="http://schemas.openxmlformats.org/drawingml/2006/main">
               <a:ext uri="{FF2B5EF4-FFF2-40B4-BE49-F238E27FC236}">
-                <a16:creationId xmlns:a16="http://schemas.microsoft.com/office/drawing/2014/main" id="{896A23D1-CDDD-4D8F-A02C-65EF38734BD1}"/>
+                <a16:creationId xmlns:a16="http://schemas.microsoft.com/office/drawing/2014/main" id="{9FFA7244-356F-480C-ACD0-8A73899D1334}"/>
               </a:ext>
             </a:extLst>
           </p:cNvPr>
@@ -4263,7 +4318,7 @@
           <p:cNvPr id="18" name="footer-rule-10">
             <a:extLst xmlns:a="http://schemas.openxmlformats.org/drawingml/2006/main">
               <a:ext uri="{FF2B5EF4-FFF2-40B4-BE49-F238E27FC236}">
-                <a16:creationId xmlns:a16="http://schemas.microsoft.com/office/drawing/2014/main" id="{F19E9D18-7BFA-4635-9048-D5F03BCFA146}"/>
+                <a16:creationId xmlns:a16="http://schemas.microsoft.com/office/drawing/2014/main" id="{A063E138-D417-4F7D-8A39-DC5C43F3C4B4}"/>
               </a:ext>
             </a:extLst>
           </p:cNvPr>
@@ -4294,7 +4349,7 @@
           <p:cNvPr id="19" name="footer-label-10">
             <a:extLst xmlns:a="http://schemas.openxmlformats.org/drawingml/2006/main">
               <a:ext uri="{FF2B5EF4-FFF2-40B4-BE49-F238E27FC236}">
-                <a16:creationId xmlns:a16="http://schemas.microsoft.com/office/drawing/2014/main" id="{6A070A15-B3D0-45F6-A88E-BA184A85FB30}"/>
+                <a16:creationId xmlns:a16="http://schemas.microsoft.com/office/drawing/2014/main" id="{7EFD8D0C-77D7-4E44-B6EB-227D6D02F18B}"/>
               </a:ext>
             </a:extLst>
           </p:cNvPr>
@@ -4356,7 +4411,7 @@
           <p:cNvPr id="20" name="footer-page-10">
             <a:extLst xmlns:a="http://schemas.openxmlformats.org/drawingml/2006/main">
               <a:ext uri="{FF2B5EF4-FFF2-40B4-BE49-F238E27FC236}">
-                <a16:creationId xmlns:a16="http://schemas.microsoft.com/office/drawing/2014/main" id="{749A98E9-EE40-4EF5-9990-FF87DE4B308C}"/>
+                <a16:creationId xmlns:a16="http://schemas.microsoft.com/office/drawing/2014/main" id="{656F18F9-A675-481D-9293-E7B99769EE79}"/>
               </a:ext>
             </a:extLst>
           </p:cNvPr>
@@ -4416,7 +4471,7 @@
     </p:spTree>
     <p:extLst>
       <p:ext uri="{BB962C8B-B14F-4D97-AF65-F5344CB8AC3E}">
-        <p14:creationId xmlns:p14="http://schemas.microsoft.com/office/powerpoint/2010/main" val="2030559342"/>
+        <p14:creationId xmlns:p14="http://schemas.microsoft.com/office/powerpoint/2010/main" val="702507020"/>
       </p:ext>
     </p:extLst>
   </p:cSld>
@@ -4447,7 +4502,7 @@
           <p:cNvPr id="22" name="side-accent-11">
             <a:extLst xmlns:a="http://schemas.openxmlformats.org/drawingml/2006/main">
               <a:ext uri="{FF2B5EF4-FFF2-40B4-BE49-F238E27FC236}">
-                <a16:creationId xmlns:a16="http://schemas.microsoft.com/office/drawing/2014/main" id="{71CEA988-02B1-4C1A-A3B5-9BDD8C5AD5AF}"/>
+                <a16:creationId xmlns:a16="http://schemas.microsoft.com/office/drawing/2014/main" id="{894B4EC7-13E1-495D-9CC3-90FDEDA830FD}"/>
               </a:ext>
             </a:extLst>
           </p:cNvPr>
@@ -4478,7 +4533,7 @@
           <p:cNvPr id="2" name="kicker-11">
             <a:extLst xmlns:a="http://schemas.openxmlformats.org/drawingml/2006/main">
               <a:ext uri="{FF2B5EF4-FFF2-40B4-BE49-F238E27FC236}">
-                <a16:creationId xmlns:a16="http://schemas.microsoft.com/office/drawing/2014/main" id="{9EB85E06-97A2-4423-B517-7163F499E479}"/>
+                <a16:creationId xmlns:a16="http://schemas.microsoft.com/office/drawing/2014/main" id="{C368E8B2-1762-48E9-88C0-B8705D8D128C}"/>
               </a:ext>
             </a:extLst>
           </p:cNvPr>
@@ -4540,7 +4595,7 @@
           <p:cNvPr id="3" name="title-11">
             <a:extLst xmlns:a="http://schemas.openxmlformats.org/drawingml/2006/main">
               <a:ext uri="{FF2B5EF4-FFF2-40B4-BE49-F238E27FC236}">
-                <a16:creationId xmlns:a16="http://schemas.microsoft.com/office/drawing/2014/main" id="{AAB05D03-1A4C-45D8-B94D-18D71C04D4D9}"/>
+                <a16:creationId xmlns:a16="http://schemas.microsoft.com/office/drawing/2014/main" id="{0A5762D6-15EA-4B96-80D1-03A889F25364}"/>
               </a:ext>
             </a:extLst>
           </p:cNvPr>
@@ -4602,7 +4657,7 @@
           <p:cNvPr id="4" name="">
             <a:extLst xmlns:a="http://schemas.openxmlformats.org/drawingml/2006/main">
               <a:ext uri="{FF2B5EF4-FFF2-40B4-BE49-F238E27FC236}">
-                <a16:creationId xmlns:a16="http://schemas.microsoft.com/office/drawing/2014/main" id="{3C9F61A8-8CD2-4197-8D93-BFC5C53201A0}"/>
+                <a16:creationId xmlns:a16="http://schemas.microsoft.com/office/drawing/2014/main" id="{B9EF7722-C62C-4992-9A17-E9319E0634B3}"/>
               </a:ext>
             </a:extLst>
           </p:cNvPr>
@@ -4664,7 +4719,7 @@
           <p:cNvPr id="5" name="">
             <a:extLst xmlns:a="http://schemas.openxmlformats.org/drawingml/2006/main">
               <a:ext uri="{FF2B5EF4-FFF2-40B4-BE49-F238E27FC236}">
-                <a16:creationId xmlns:a16="http://schemas.microsoft.com/office/drawing/2014/main" id="{51040D3F-9C5B-40ED-90BF-00F952D0CB1D}"/>
+                <a16:creationId xmlns:a16="http://schemas.microsoft.com/office/drawing/2014/main" id="{28D9EC18-A341-46F9-B4BA-C69B15DCF422}"/>
               </a:ext>
             </a:extLst>
           </p:cNvPr>
@@ -4695,7 +4750,7 @@
           <p:cNvPr id="6" name="">
             <a:extLst xmlns:a="http://schemas.openxmlformats.org/drawingml/2006/main">
               <a:ext uri="{FF2B5EF4-FFF2-40B4-BE49-F238E27FC236}">
-                <a16:creationId xmlns:a16="http://schemas.microsoft.com/office/drawing/2014/main" id="{CF854111-52EE-40F2-965D-BD91297D2C2B}"/>
+                <a16:creationId xmlns:a16="http://schemas.microsoft.com/office/drawing/2014/main" id="{C5C329A4-3341-4A66-9E16-67E8A03E3609}"/>
               </a:ext>
             </a:extLst>
           </p:cNvPr>
@@ -4757,7 +4812,7 @@
           <p:cNvPr id="7" name="">
             <a:extLst xmlns:a="http://schemas.openxmlformats.org/drawingml/2006/main">
               <a:ext uri="{FF2B5EF4-FFF2-40B4-BE49-F238E27FC236}">
-                <a16:creationId xmlns:a16="http://schemas.microsoft.com/office/drawing/2014/main" id="{C66429F4-525D-4039-A91E-A6EC48198C28}"/>
+                <a16:creationId xmlns:a16="http://schemas.microsoft.com/office/drawing/2014/main" id="{CF1CE825-4EAB-41AA-9D17-24DA3FE46B9A}"/>
               </a:ext>
             </a:extLst>
           </p:cNvPr>
@@ -4819,7 +4874,7 @@
           <p:cNvPr id="8" name="">
             <a:extLst xmlns:a="http://schemas.openxmlformats.org/drawingml/2006/main">
               <a:ext uri="{FF2B5EF4-FFF2-40B4-BE49-F238E27FC236}">
-                <a16:creationId xmlns:a16="http://schemas.microsoft.com/office/drawing/2014/main" id="{88B9EAB1-7F4E-44E1-8D3D-4A06CD1F750D}"/>
+                <a16:creationId xmlns:a16="http://schemas.microsoft.com/office/drawing/2014/main" id="{9B1A0B9E-82D2-4677-A3AE-A629995476A0}"/>
               </a:ext>
             </a:extLst>
           </p:cNvPr>
@@ -4881,7 +4936,7 @@
           <p:cNvPr id="9" name="">
             <a:extLst xmlns:a="http://schemas.openxmlformats.org/drawingml/2006/main">
               <a:ext uri="{FF2B5EF4-FFF2-40B4-BE49-F238E27FC236}">
-                <a16:creationId xmlns:a16="http://schemas.microsoft.com/office/drawing/2014/main" id="{779DF10C-640A-4BCA-8637-6DA639A1E086}"/>
+                <a16:creationId xmlns:a16="http://schemas.microsoft.com/office/drawing/2014/main" id="{37BA4A30-AB3B-4FF4-A2B5-D7C10ED404BA}"/>
               </a:ext>
             </a:extLst>
           </p:cNvPr>
@@ -4912,7 +4967,7 @@
           <p:cNvPr id="10" name="">
             <a:extLst xmlns:a="http://schemas.openxmlformats.org/drawingml/2006/main">
               <a:ext uri="{FF2B5EF4-FFF2-40B4-BE49-F238E27FC236}">
-                <a16:creationId xmlns:a16="http://schemas.microsoft.com/office/drawing/2014/main" id="{948428D0-DD77-4384-9227-C72D62192010}"/>
+                <a16:creationId xmlns:a16="http://schemas.microsoft.com/office/drawing/2014/main" id="{3C606A2E-0EEF-4A3D-9390-D758BEB42166}"/>
               </a:ext>
             </a:extLst>
           </p:cNvPr>
@@ -4974,7 +5029,7 @@
           <p:cNvPr id="11" name="">
             <a:extLst xmlns:a="http://schemas.openxmlformats.org/drawingml/2006/main">
               <a:ext uri="{FF2B5EF4-FFF2-40B4-BE49-F238E27FC236}">
-                <a16:creationId xmlns:a16="http://schemas.microsoft.com/office/drawing/2014/main" id="{0242C9D7-D56F-4898-9626-3085C6C7E122}"/>
+                <a16:creationId xmlns:a16="http://schemas.microsoft.com/office/drawing/2014/main" id="{1777D7A7-7D2A-400F-A2C8-59FA49FE0D54}"/>
               </a:ext>
             </a:extLst>
           </p:cNvPr>
@@ -5036,7 +5091,7 @@
           <p:cNvPr id="12" name="">
             <a:extLst xmlns:a="http://schemas.openxmlformats.org/drawingml/2006/main">
               <a:ext uri="{FF2B5EF4-FFF2-40B4-BE49-F238E27FC236}">
-                <a16:creationId xmlns:a16="http://schemas.microsoft.com/office/drawing/2014/main" id="{5BB804E5-C04D-4989-9A93-280E927071F3}"/>
+                <a16:creationId xmlns:a16="http://schemas.microsoft.com/office/drawing/2014/main" id="{04376867-0C00-42A9-83E6-28166B3E897C}"/>
               </a:ext>
             </a:extLst>
           </p:cNvPr>
@@ -5098,7 +5153,7 @@
           <p:cNvPr id="13" name="">
             <a:extLst xmlns:a="http://schemas.openxmlformats.org/drawingml/2006/main">
               <a:ext uri="{FF2B5EF4-FFF2-40B4-BE49-F238E27FC236}">
-                <a16:creationId xmlns:a16="http://schemas.microsoft.com/office/drawing/2014/main" id="{2D4A7D32-5DE0-4D3E-9671-AE4ED621E1B4}"/>
+                <a16:creationId xmlns:a16="http://schemas.microsoft.com/office/drawing/2014/main" id="{77F3ECDA-174F-48A9-B1AA-CA53D8F61E73}"/>
               </a:ext>
             </a:extLst>
           </p:cNvPr>
@@ -5129,7 +5184,7 @@
           <p:cNvPr id="14" name="">
             <a:extLst xmlns:a="http://schemas.openxmlformats.org/drawingml/2006/main">
               <a:ext uri="{FF2B5EF4-FFF2-40B4-BE49-F238E27FC236}">
-                <a16:creationId xmlns:a16="http://schemas.microsoft.com/office/drawing/2014/main" id="{E98298DA-BB2B-4622-8A2D-999659CD87A7}"/>
+                <a16:creationId xmlns:a16="http://schemas.microsoft.com/office/drawing/2014/main" id="{19C7E749-FB26-4119-9B94-F2347845A67A}"/>
               </a:ext>
             </a:extLst>
           </p:cNvPr>
@@ -5191,7 +5246,7 @@
           <p:cNvPr id="15" name="">
             <a:extLst xmlns:a="http://schemas.openxmlformats.org/drawingml/2006/main">
               <a:ext uri="{FF2B5EF4-FFF2-40B4-BE49-F238E27FC236}">
-                <a16:creationId xmlns:a16="http://schemas.microsoft.com/office/drawing/2014/main" id="{E4BAD448-A3CA-4BCF-BF13-0E84F9240A31}"/>
+                <a16:creationId xmlns:a16="http://schemas.microsoft.com/office/drawing/2014/main" id="{2DB32F34-CB38-44F4-94DB-6444EBBA85BB}"/>
               </a:ext>
             </a:extLst>
           </p:cNvPr>
@@ -5253,7 +5308,7 @@
           <p:cNvPr id="16" name="">
             <a:extLst xmlns:a="http://schemas.openxmlformats.org/drawingml/2006/main">
               <a:ext uri="{FF2B5EF4-FFF2-40B4-BE49-F238E27FC236}">
-                <a16:creationId xmlns:a16="http://schemas.microsoft.com/office/drawing/2014/main" id="{5C5622CD-E322-4995-B77A-68DD0E930231}"/>
+                <a16:creationId xmlns:a16="http://schemas.microsoft.com/office/drawing/2014/main" id="{8CFEDC64-BA7F-4A2E-9912-42F022AF04C1}"/>
               </a:ext>
             </a:extLst>
           </p:cNvPr>
@@ -5315,7 +5370,7 @@
           <p:cNvPr id="17" name="">
             <a:extLst xmlns:a="http://schemas.openxmlformats.org/drawingml/2006/main">
               <a:ext uri="{FF2B5EF4-FFF2-40B4-BE49-F238E27FC236}">
-                <a16:creationId xmlns:a16="http://schemas.microsoft.com/office/drawing/2014/main" id="{9E49CA8B-C4EB-44F4-BF44-505404D1ED70}"/>
+                <a16:creationId xmlns:a16="http://schemas.microsoft.com/office/drawing/2014/main" id="{B55C6FF7-A675-4425-9CAF-3A54A5F216D0}"/>
               </a:ext>
             </a:extLst>
           </p:cNvPr>
@@ -5350,7 +5405,7 @@
           <p:cNvPr id="18" name="">
             <a:extLst xmlns:a="http://schemas.openxmlformats.org/drawingml/2006/main">
               <a:ext uri="{FF2B5EF4-FFF2-40B4-BE49-F238E27FC236}">
-                <a16:creationId xmlns:a16="http://schemas.microsoft.com/office/drawing/2014/main" id="{35B830D6-7C36-45EC-A9BB-78B6A40AF3F2}"/>
+                <a16:creationId xmlns:a16="http://schemas.microsoft.com/office/drawing/2014/main" id="{178378E8-4E86-4386-9252-2C6883CB6446}"/>
               </a:ext>
             </a:extLst>
           </p:cNvPr>
@@ -5439,7 +5494,7 @@
           <p:cNvPr id="19" name="footer-rule-11">
             <a:extLst xmlns:a="http://schemas.openxmlformats.org/drawingml/2006/main">
               <a:ext uri="{FF2B5EF4-FFF2-40B4-BE49-F238E27FC236}">
-                <a16:creationId xmlns:a16="http://schemas.microsoft.com/office/drawing/2014/main" id="{B04E4057-44CD-4FA7-B903-19582E55C0CB}"/>
+                <a16:creationId xmlns:a16="http://schemas.microsoft.com/office/drawing/2014/main" id="{ECB33085-38C5-4020-9A48-577252B682B8}"/>
               </a:ext>
             </a:extLst>
           </p:cNvPr>
@@ -5470,7 +5525,7 @@
           <p:cNvPr id="20" name="footer-label-11">
             <a:extLst xmlns:a="http://schemas.openxmlformats.org/drawingml/2006/main">
               <a:ext uri="{FF2B5EF4-FFF2-40B4-BE49-F238E27FC236}">
-                <a16:creationId xmlns:a16="http://schemas.microsoft.com/office/drawing/2014/main" id="{6CFDC52A-937D-4A03-BF9F-DD7CBDE7BD53}"/>
+                <a16:creationId xmlns:a16="http://schemas.microsoft.com/office/drawing/2014/main" id="{FC726F7A-E046-485F-946E-DAD7C8242904}"/>
               </a:ext>
             </a:extLst>
           </p:cNvPr>
@@ -5532,7 +5587,7 @@
           <p:cNvPr id="21" name="footer-page-11">
             <a:extLst xmlns:a="http://schemas.openxmlformats.org/drawingml/2006/main">
               <a:ext uri="{FF2B5EF4-FFF2-40B4-BE49-F238E27FC236}">
-                <a16:creationId xmlns:a16="http://schemas.microsoft.com/office/drawing/2014/main" id="{D1C2A40C-B35B-4C8D-8A3A-6CE1A47885C4}"/>
+                <a16:creationId xmlns:a16="http://schemas.microsoft.com/office/drawing/2014/main" id="{7916DEB0-97C6-41A4-B351-72D42FCAE349}"/>
               </a:ext>
             </a:extLst>
           </p:cNvPr>
@@ -5592,7 +5647,7 @@
     </p:spTree>
     <p:extLst>
       <p:ext uri="{BB962C8B-B14F-4D97-AF65-F5344CB8AC3E}">
-        <p14:creationId xmlns:p14="http://schemas.microsoft.com/office/powerpoint/2010/main" val="2040543563"/>
+        <p14:creationId xmlns:p14="http://schemas.microsoft.com/office/powerpoint/2010/main" val="625551778"/>
       </p:ext>
     </p:extLst>
   </p:cSld>
@@ -5623,7 +5678,7 @@
           <p:cNvPr id="14" name="side-accent-12">
             <a:extLst xmlns:a="http://schemas.openxmlformats.org/drawingml/2006/main">
               <a:ext uri="{FF2B5EF4-FFF2-40B4-BE49-F238E27FC236}">
-                <a16:creationId xmlns:a16="http://schemas.microsoft.com/office/drawing/2014/main" id="{AE22D311-A5E9-4E87-9135-EC2332C84145}"/>
+                <a16:creationId xmlns:a16="http://schemas.microsoft.com/office/drawing/2014/main" id="{CE5EDF8C-BA6C-43D0-9D4F-AFA0C80B7736}"/>
               </a:ext>
             </a:extLst>
           </p:cNvPr>
@@ -5654,7 +5709,7 @@
           <p:cNvPr id="2" name="kicker-12">
             <a:extLst xmlns:a="http://schemas.openxmlformats.org/drawingml/2006/main">
               <a:ext uri="{FF2B5EF4-FFF2-40B4-BE49-F238E27FC236}">
-                <a16:creationId xmlns:a16="http://schemas.microsoft.com/office/drawing/2014/main" id="{408C12A9-E46C-4C77-8425-B4257ED10472}"/>
+                <a16:creationId xmlns:a16="http://schemas.microsoft.com/office/drawing/2014/main" id="{FF0AE551-BF92-45CD-B416-CC02EFD43F62}"/>
               </a:ext>
             </a:extLst>
           </p:cNvPr>
@@ -5716,7 +5771,7 @@
           <p:cNvPr id="3" name="title-12">
             <a:extLst xmlns:a="http://schemas.openxmlformats.org/drawingml/2006/main">
               <a:ext uri="{FF2B5EF4-FFF2-40B4-BE49-F238E27FC236}">
-                <a16:creationId xmlns:a16="http://schemas.microsoft.com/office/drawing/2014/main" id="{56F00F9C-BC02-4B86-AEE9-431B4466154C}"/>
+                <a16:creationId xmlns:a16="http://schemas.microsoft.com/office/drawing/2014/main" id="{85121D36-C873-4C40-84DB-6A0ADA725109}"/>
               </a:ext>
             </a:extLst>
           </p:cNvPr>
@@ -5778,7 +5833,7 @@
           <p:cNvPr id="4" name="draft-panel">
             <a:extLst xmlns:a="http://schemas.openxmlformats.org/drawingml/2006/main">
               <a:ext uri="{FF2B5EF4-FFF2-40B4-BE49-F238E27FC236}">
-                <a16:creationId xmlns:a16="http://schemas.microsoft.com/office/drawing/2014/main" id="{7D6BE7F5-4AE2-49CF-A03D-AF1172C2A9A1}"/>
+                <a16:creationId xmlns:a16="http://schemas.microsoft.com/office/drawing/2014/main" id="{C6E0E93E-06C7-42AA-9709-13E396401BCA}"/>
               </a:ext>
             </a:extLst>
           </p:cNvPr>
@@ -5813,7 +5868,7 @@
           <p:cNvPr id="5" name="">
             <a:extLst xmlns:a="http://schemas.openxmlformats.org/drawingml/2006/main">
               <a:ext uri="{FF2B5EF4-FFF2-40B4-BE49-F238E27FC236}">
-                <a16:creationId xmlns:a16="http://schemas.microsoft.com/office/drawing/2014/main" id="{A861AB5A-E213-4F44-B745-D1F46AAA84DE}"/>
+                <a16:creationId xmlns:a16="http://schemas.microsoft.com/office/drawing/2014/main" id="{79E5B32F-1B81-4F7F-AFA1-F4911F5F8709}"/>
               </a:ext>
             </a:extLst>
           </p:cNvPr>
@@ -5875,7 +5930,7 @@
           <p:cNvPr id="6" name="">
             <a:extLst xmlns:a="http://schemas.openxmlformats.org/drawingml/2006/main">
               <a:ext uri="{FF2B5EF4-FFF2-40B4-BE49-F238E27FC236}">
-                <a16:creationId xmlns:a16="http://schemas.microsoft.com/office/drawing/2014/main" id="{7617E20F-0DD1-44B8-8B8A-0B9A6430C981}"/>
+                <a16:creationId xmlns:a16="http://schemas.microsoft.com/office/drawing/2014/main" id="{0104D7FC-AF9C-4F0E-9CA6-907A42BEF344}"/>
               </a:ext>
             </a:extLst>
           </p:cNvPr>
@@ -5991,7 +6046,7 @@
           <p:cNvPr id="7" name="submit-panel">
             <a:extLst xmlns:a="http://schemas.openxmlformats.org/drawingml/2006/main">
               <a:ext uri="{FF2B5EF4-FFF2-40B4-BE49-F238E27FC236}">
-                <a16:creationId xmlns:a16="http://schemas.microsoft.com/office/drawing/2014/main" id="{A24728AB-E867-41AC-AFA5-EADFAEF35617}"/>
+                <a16:creationId xmlns:a16="http://schemas.microsoft.com/office/drawing/2014/main" id="{B6656F9A-7F52-4243-9D82-4A91E5A057B1}"/>
               </a:ext>
             </a:extLst>
           </p:cNvPr>
@@ -6026,7 +6081,7 @@
           <p:cNvPr id="8" name="">
             <a:extLst xmlns:a="http://schemas.openxmlformats.org/drawingml/2006/main">
               <a:ext uri="{FF2B5EF4-FFF2-40B4-BE49-F238E27FC236}">
-                <a16:creationId xmlns:a16="http://schemas.microsoft.com/office/drawing/2014/main" id="{10848F36-641B-4DEC-B27B-2283742D3E6A}"/>
+                <a16:creationId xmlns:a16="http://schemas.microsoft.com/office/drawing/2014/main" id="{83B8F8AD-D281-4133-AD48-66C6FE1745D3}"/>
               </a:ext>
             </a:extLst>
           </p:cNvPr>
@@ -6088,7 +6143,7 @@
           <p:cNvPr id="9" name="">
             <a:extLst xmlns:a="http://schemas.openxmlformats.org/drawingml/2006/main">
               <a:ext uri="{FF2B5EF4-FFF2-40B4-BE49-F238E27FC236}">
-                <a16:creationId xmlns:a16="http://schemas.microsoft.com/office/drawing/2014/main" id="{FBCC3743-9026-415D-B26D-FDD77452C3EE}"/>
+                <a16:creationId xmlns:a16="http://schemas.microsoft.com/office/drawing/2014/main" id="{87987C12-347B-4DDC-91F3-B5AE9D22A700}"/>
               </a:ext>
             </a:extLst>
           </p:cNvPr>
@@ -6204,7 +6259,7 @@
           <p:cNvPr id="10" name="">
             <a:extLst xmlns:a="http://schemas.openxmlformats.org/drawingml/2006/main">
               <a:ext uri="{FF2B5EF4-FFF2-40B4-BE49-F238E27FC236}">
-                <a16:creationId xmlns:a16="http://schemas.microsoft.com/office/drawing/2014/main" id="{7EDB3F9D-A96C-4109-98AA-D054F1C7E738}"/>
+                <a16:creationId xmlns:a16="http://schemas.microsoft.com/office/drawing/2014/main" id="{5E816DD1-8A73-4F01-8872-E34DB06BDD47}"/>
               </a:ext>
             </a:extLst>
           </p:cNvPr>
@@ -6266,7 +6321,7 @@
           <p:cNvPr id="11" name="footer-rule-12">
             <a:extLst xmlns:a="http://schemas.openxmlformats.org/drawingml/2006/main">
               <a:ext uri="{FF2B5EF4-FFF2-40B4-BE49-F238E27FC236}">
-                <a16:creationId xmlns:a16="http://schemas.microsoft.com/office/drawing/2014/main" id="{4CFF9040-45CA-4986-B94D-1AB3FE77339B}"/>
+                <a16:creationId xmlns:a16="http://schemas.microsoft.com/office/drawing/2014/main" id="{3E143C96-9793-4BE7-A0B8-DADA9E4D6154}"/>
               </a:ext>
             </a:extLst>
           </p:cNvPr>
@@ -6297,7 +6352,7 @@
           <p:cNvPr id="12" name="footer-label-12">
             <a:extLst xmlns:a="http://schemas.openxmlformats.org/drawingml/2006/main">
               <a:ext uri="{FF2B5EF4-FFF2-40B4-BE49-F238E27FC236}">
-                <a16:creationId xmlns:a16="http://schemas.microsoft.com/office/drawing/2014/main" id="{6AD79874-FA2B-43A7-9222-BAB81FAF760E}"/>
+                <a16:creationId xmlns:a16="http://schemas.microsoft.com/office/drawing/2014/main" id="{1A96F4BC-C76C-4EE5-AD24-B777E72A294F}"/>
               </a:ext>
             </a:extLst>
           </p:cNvPr>
@@ -6359,7 +6414,7 @@
           <p:cNvPr id="13" name="footer-page-12">
             <a:extLst xmlns:a="http://schemas.openxmlformats.org/drawingml/2006/main">
               <a:ext uri="{FF2B5EF4-FFF2-40B4-BE49-F238E27FC236}">
-                <a16:creationId xmlns:a16="http://schemas.microsoft.com/office/drawing/2014/main" id="{B9A8F3A5-C5E1-4DE2-A577-0CB3D1EA195A}"/>
+                <a16:creationId xmlns:a16="http://schemas.microsoft.com/office/drawing/2014/main" id="{3785749E-FD17-4407-BB59-5DE772573ACE}"/>
               </a:ext>
             </a:extLst>
           </p:cNvPr>
@@ -6419,7 +6474,7 @@
     </p:spTree>
     <p:extLst>
       <p:ext uri="{BB962C8B-B14F-4D97-AF65-F5344CB8AC3E}">
-        <p14:creationId xmlns:p14="http://schemas.microsoft.com/office/powerpoint/2010/main" val="1669767877"/>
+        <p14:creationId xmlns:p14="http://schemas.microsoft.com/office/powerpoint/2010/main" val="1456232372"/>
       </p:ext>
     </p:extLst>
   </p:cSld>
@@ -6450,7 +6505,7 @@
           <p:cNvPr id="25" name="side-accent-13">
             <a:extLst xmlns:a="http://schemas.openxmlformats.org/drawingml/2006/main">
               <a:ext uri="{FF2B5EF4-FFF2-40B4-BE49-F238E27FC236}">
-                <a16:creationId xmlns:a16="http://schemas.microsoft.com/office/drawing/2014/main" id="{AC0187DB-7B9F-4A50-9D18-E6C2E0090CD8}"/>
+                <a16:creationId xmlns:a16="http://schemas.microsoft.com/office/drawing/2014/main" id="{A95327C1-119B-4BBD-8E7E-99F3D5922955}"/>
               </a:ext>
             </a:extLst>
           </p:cNvPr>
@@ -6481,7 +6536,7 @@
           <p:cNvPr id="2" name="kicker-13">
             <a:extLst xmlns:a="http://schemas.openxmlformats.org/drawingml/2006/main">
               <a:ext uri="{FF2B5EF4-FFF2-40B4-BE49-F238E27FC236}">
-                <a16:creationId xmlns:a16="http://schemas.microsoft.com/office/drawing/2014/main" id="{3F1D89AE-ACAD-4F91-A51E-5435F7F2DA85}"/>
+                <a16:creationId xmlns:a16="http://schemas.microsoft.com/office/drawing/2014/main" id="{97996D9B-B233-4A1C-995D-AFE7F665B8B2}"/>
               </a:ext>
             </a:extLst>
           </p:cNvPr>
@@ -6543,7 +6598,7 @@
           <p:cNvPr id="3" name="title-13">
             <a:extLst xmlns:a="http://schemas.openxmlformats.org/drawingml/2006/main">
               <a:ext uri="{FF2B5EF4-FFF2-40B4-BE49-F238E27FC236}">
-                <a16:creationId xmlns:a16="http://schemas.microsoft.com/office/drawing/2014/main" id="{B393AF6D-F76C-4F5E-B0E5-AED1A1C596C8}"/>
+                <a16:creationId xmlns:a16="http://schemas.microsoft.com/office/drawing/2014/main" id="{8748D4B5-30B8-4A4C-A464-2EBCC6C2EC6F}"/>
               </a:ext>
             </a:extLst>
           </p:cNvPr>
@@ -6605,7 +6660,7 @@
           <p:cNvPr id="4" name="">
             <a:extLst xmlns:a="http://schemas.openxmlformats.org/drawingml/2006/main">
               <a:ext uri="{FF2B5EF4-FFF2-40B4-BE49-F238E27FC236}">
-                <a16:creationId xmlns:a16="http://schemas.microsoft.com/office/drawing/2014/main" id="{A6A40765-F10C-4C9E-9813-3B83D9AF910C}"/>
+                <a16:creationId xmlns:a16="http://schemas.microsoft.com/office/drawing/2014/main" id="{E1BE7F93-D0EB-413A-8196-27EC38D917F6}"/>
               </a:ext>
             </a:extLst>
           </p:cNvPr>
@@ -6636,7 +6691,7 @@
           <p:cNvPr id="5" name="">
             <a:extLst xmlns:a="http://schemas.openxmlformats.org/drawingml/2006/main">
               <a:ext uri="{FF2B5EF4-FFF2-40B4-BE49-F238E27FC236}">
-                <a16:creationId xmlns:a16="http://schemas.microsoft.com/office/drawing/2014/main" id="{DA150BE0-5F08-495F-9175-D1372545A876}"/>
+                <a16:creationId xmlns:a16="http://schemas.microsoft.com/office/drawing/2014/main" id="{DE688A35-DEBC-4C22-B713-1D8EA090A474}"/>
               </a:ext>
             </a:extLst>
           </p:cNvPr>
@@ -6667,7 +6722,7 @@
           <p:cNvPr id="6" name="">
             <a:extLst xmlns:a="http://schemas.openxmlformats.org/drawingml/2006/main">
               <a:ext uri="{FF2B5EF4-FFF2-40B4-BE49-F238E27FC236}">
-                <a16:creationId xmlns:a16="http://schemas.microsoft.com/office/drawing/2014/main" id="{94B1E5C5-AD94-4CE8-B04C-B972FC02BC77}"/>
+                <a16:creationId xmlns:a16="http://schemas.microsoft.com/office/drawing/2014/main" id="{A522E588-E7B0-40F5-809A-5FC419223CB0}"/>
               </a:ext>
             </a:extLst>
           </p:cNvPr>
@@ -6729,7 +6784,7 @@
           <p:cNvPr id="7" name="">
             <a:extLst xmlns:a="http://schemas.openxmlformats.org/drawingml/2006/main">
               <a:ext uri="{FF2B5EF4-FFF2-40B4-BE49-F238E27FC236}">
-                <a16:creationId xmlns:a16="http://schemas.microsoft.com/office/drawing/2014/main" id="{4F7294BC-1F5A-4504-BFE7-9558A9919833}"/>
+                <a16:creationId xmlns:a16="http://schemas.microsoft.com/office/drawing/2014/main" id="{C4DA91F4-561C-460A-9A9E-0130BFCAC3EF}"/>
               </a:ext>
             </a:extLst>
           </p:cNvPr>
@@ -6791,7 +6846,7 @@
           <p:cNvPr id="8" name="">
             <a:extLst xmlns:a="http://schemas.openxmlformats.org/drawingml/2006/main">
               <a:ext uri="{FF2B5EF4-FFF2-40B4-BE49-F238E27FC236}">
-                <a16:creationId xmlns:a16="http://schemas.microsoft.com/office/drawing/2014/main" id="{2DD18EFA-FFE4-4C9D-9C0F-B34DA618820E}"/>
+                <a16:creationId xmlns:a16="http://schemas.microsoft.com/office/drawing/2014/main" id="{911D346C-B280-48E1-811A-E88B9C01FBFA}"/>
               </a:ext>
             </a:extLst>
           </p:cNvPr>
@@ -6853,7 +6908,7 @@
           <p:cNvPr id="9" name="">
             <a:extLst xmlns:a="http://schemas.openxmlformats.org/drawingml/2006/main">
               <a:ext uri="{FF2B5EF4-FFF2-40B4-BE49-F238E27FC236}">
-                <a16:creationId xmlns:a16="http://schemas.microsoft.com/office/drawing/2014/main" id="{23A2FC34-A118-4F01-88ED-23545AD52454}"/>
+                <a16:creationId xmlns:a16="http://schemas.microsoft.com/office/drawing/2014/main" id="{B9BAA831-F18F-496F-B320-59B889A8B96E}"/>
               </a:ext>
             </a:extLst>
           </p:cNvPr>
@@ -6884,7 +6939,7 @@
           <p:cNvPr id="10" name="">
             <a:extLst xmlns:a="http://schemas.openxmlformats.org/drawingml/2006/main">
               <a:ext uri="{FF2B5EF4-FFF2-40B4-BE49-F238E27FC236}">
-                <a16:creationId xmlns:a16="http://schemas.microsoft.com/office/drawing/2014/main" id="{41949CE9-78DE-4828-8145-3725D337F4D3}"/>
+                <a16:creationId xmlns:a16="http://schemas.microsoft.com/office/drawing/2014/main" id="{EE093179-3DBB-46A3-B653-83DBABCD469B}"/>
               </a:ext>
             </a:extLst>
           </p:cNvPr>
@@ -6946,7 +7001,7 @@
           <p:cNvPr id="11" name="">
             <a:extLst xmlns:a="http://schemas.openxmlformats.org/drawingml/2006/main">
               <a:ext uri="{FF2B5EF4-FFF2-40B4-BE49-F238E27FC236}">
-                <a16:creationId xmlns:a16="http://schemas.microsoft.com/office/drawing/2014/main" id="{7A6FC464-7867-47A4-B7B8-3FF11D0FCE3D}"/>
+                <a16:creationId xmlns:a16="http://schemas.microsoft.com/office/drawing/2014/main" id="{6011E26E-85B0-44F3-9BA8-3EDE824BEBA7}"/>
               </a:ext>
             </a:extLst>
           </p:cNvPr>
@@ -7008,7 +7063,7 @@
           <p:cNvPr id="12" name="">
             <a:extLst xmlns:a="http://schemas.openxmlformats.org/drawingml/2006/main">
               <a:ext uri="{FF2B5EF4-FFF2-40B4-BE49-F238E27FC236}">
-                <a16:creationId xmlns:a16="http://schemas.microsoft.com/office/drawing/2014/main" id="{A1A1BB88-F645-4605-8C64-ACC1004C4895}"/>
+                <a16:creationId xmlns:a16="http://schemas.microsoft.com/office/drawing/2014/main" id="{4368F111-A11B-48A5-9959-47BE2B82B628}"/>
               </a:ext>
             </a:extLst>
           </p:cNvPr>
@@ -7070,7 +7125,7 @@
           <p:cNvPr id="13" name="">
             <a:extLst xmlns:a="http://schemas.openxmlformats.org/drawingml/2006/main">
               <a:ext uri="{FF2B5EF4-FFF2-40B4-BE49-F238E27FC236}">
-                <a16:creationId xmlns:a16="http://schemas.microsoft.com/office/drawing/2014/main" id="{2F9137BA-3A20-4319-8B47-C98031A679D1}"/>
+                <a16:creationId xmlns:a16="http://schemas.microsoft.com/office/drawing/2014/main" id="{D92B9BB6-2590-4A1A-806E-DAB4528F1DEF}"/>
               </a:ext>
             </a:extLst>
           </p:cNvPr>
@@ -7101,7 +7156,7 @@
           <p:cNvPr id="14" name="">
             <a:extLst xmlns:a="http://schemas.openxmlformats.org/drawingml/2006/main">
               <a:ext uri="{FF2B5EF4-FFF2-40B4-BE49-F238E27FC236}">
-                <a16:creationId xmlns:a16="http://schemas.microsoft.com/office/drawing/2014/main" id="{0268E472-4ABF-497C-8903-F3E0AEE968B2}"/>
+                <a16:creationId xmlns:a16="http://schemas.microsoft.com/office/drawing/2014/main" id="{9590A63D-0AD4-4071-88EB-080DB6F4A8E7}"/>
               </a:ext>
             </a:extLst>
           </p:cNvPr>
@@ -7163,7 +7218,7 @@
           <p:cNvPr id="15" name="">
             <a:extLst xmlns:a="http://schemas.openxmlformats.org/drawingml/2006/main">
               <a:ext uri="{FF2B5EF4-FFF2-40B4-BE49-F238E27FC236}">
-                <a16:creationId xmlns:a16="http://schemas.microsoft.com/office/drawing/2014/main" id="{1A4D6C14-2FB1-4CC9-B391-20B6CEA89A62}"/>
+                <a16:creationId xmlns:a16="http://schemas.microsoft.com/office/drawing/2014/main" id="{A97EA03D-1E41-421E-9D0D-C784DFDAC7D2}"/>
               </a:ext>
             </a:extLst>
           </p:cNvPr>
@@ -7225,7 +7280,7 @@
           <p:cNvPr id="16" name="">
             <a:extLst xmlns:a="http://schemas.openxmlformats.org/drawingml/2006/main">
               <a:ext uri="{FF2B5EF4-FFF2-40B4-BE49-F238E27FC236}">
-                <a16:creationId xmlns:a16="http://schemas.microsoft.com/office/drawing/2014/main" id="{6971ADBC-B600-43C7-A1FC-4A94DF6E1CF0}"/>
+                <a16:creationId xmlns:a16="http://schemas.microsoft.com/office/drawing/2014/main" id="{3185C4CD-AE51-46B9-AE2E-CA165D68BA73}"/>
               </a:ext>
             </a:extLst>
           </p:cNvPr>
@@ -7287,7 +7342,7 @@
           <p:cNvPr id="17" name="">
             <a:extLst xmlns:a="http://schemas.openxmlformats.org/drawingml/2006/main">
               <a:ext uri="{FF2B5EF4-FFF2-40B4-BE49-F238E27FC236}">
-                <a16:creationId xmlns:a16="http://schemas.microsoft.com/office/drawing/2014/main" id="{4D56C13C-12F1-4EF5-AD8F-86EF299F3346}"/>
+                <a16:creationId xmlns:a16="http://schemas.microsoft.com/office/drawing/2014/main" id="{0BD77E96-C317-43E9-A080-D108BDCC301D}"/>
               </a:ext>
             </a:extLst>
           </p:cNvPr>
@@ -7318,7 +7373,7 @@
           <p:cNvPr id="18" name="">
             <a:extLst xmlns:a="http://schemas.openxmlformats.org/drawingml/2006/main">
               <a:ext uri="{FF2B5EF4-FFF2-40B4-BE49-F238E27FC236}">
-                <a16:creationId xmlns:a16="http://schemas.microsoft.com/office/drawing/2014/main" id="{B76ECC90-E52C-412E-B072-99D59627DFEC}"/>
+                <a16:creationId xmlns:a16="http://schemas.microsoft.com/office/drawing/2014/main" id="{D85558C6-5F96-487D-9BFA-93811EAD155B}"/>
               </a:ext>
             </a:extLst>
           </p:cNvPr>
@@ -7380,7 +7435,7 @@
           <p:cNvPr id="19" name="">
             <a:extLst xmlns:a="http://schemas.openxmlformats.org/drawingml/2006/main">
               <a:ext uri="{FF2B5EF4-FFF2-40B4-BE49-F238E27FC236}">
-                <a16:creationId xmlns:a16="http://schemas.microsoft.com/office/drawing/2014/main" id="{6A26B5FA-6A31-4CA8-9248-958B46C90407}"/>
+                <a16:creationId xmlns:a16="http://schemas.microsoft.com/office/drawing/2014/main" id="{6BA7EF6A-DCF9-4B60-B205-92740822CD14}"/>
               </a:ext>
             </a:extLst>
           </p:cNvPr>
@@ -7442,7 +7497,7 @@
           <p:cNvPr id="20" name="">
             <a:extLst xmlns:a="http://schemas.openxmlformats.org/drawingml/2006/main">
               <a:ext uri="{FF2B5EF4-FFF2-40B4-BE49-F238E27FC236}">
-                <a16:creationId xmlns:a16="http://schemas.microsoft.com/office/drawing/2014/main" id="{C2F1D809-D49E-41B0-B21B-EE20E6D56283}"/>
+                <a16:creationId xmlns:a16="http://schemas.microsoft.com/office/drawing/2014/main" id="{310C93BC-3762-4E44-9187-DCE83D46B710}"/>
               </a:ext>
             </a:extLst>
           </p:cNvPr>
@@ -7504,7 +7559,7 @@
           <p:cNvPr id="21" name="">
             <a:extLst xmlns:a="http://schemas.openxmlformats.org/drawingml/2006/main">
               <a:ext uri="{FF2B5EF4-FFF2-40B4-BE49-F238E27FC236}">
-                <a16:creationId xmlns:a16="http://schemas.microsoft.com/office/drawing/2014/main" id="{25D6B741-9DE2-4C36-941E-5E770015145C}"/>
+                <a16:creationId xmlns:a16="http://schemas.microsoft.com/office/drawing/2014/main" id="{6F35FE72-D085-4E80-87BA-D75A7FC28CCE}"/>
               </a:ext>
             </a:extLst>
           </p:cNvPr>
@@ -7566,7 +7621,7 @@
           <p:cNvPr id="22" name="footer-rule-13">
             <a:extLst xmlns:a="http://schemas.openxmlformats.org/drawingml/2006/main">
               <a:ext uri="{FF2B5EF4-FFF2-40B4-BE49-F238E27FC236}">
-                <a16:creationId xmlns:a16="http://schemas.microsoft.com/office/drawing/2014/main" id="{F695B6C1-0AE7-4E7D-A80C-5C89039054C4}"/>
+                <a16:creationId xmlns:a16="http://schemas.microsoft.com/office/drawing/2014/main" id="{D97228D2-CF8B-42DB-8FDD-C475749C573A}"/>
               </a:ext>
             </a:extLst>
           </p:cNvPr>
@@ -7597,7 +7652,7 @@
           <p:cNvPr id="23" name="footer-label-13">
             <a:extLst xmlns:a="http://schemas.openxmlformats.org/drawingml/2006/main">
               <a:ext uri="{FF2B5EF4-FFF2-40B4-BE49-F238E27FC236}">
-                <a16:creationId xmlns:a16="http://schemas.microsoft.com/office/drawing/2014/main" id="{484F9DE7-7639-4C2F-ABAA-26E1092724A8}"/>
+                <a16:creationId xmlns:a16="http://schemas.microsoft.com/office/drawing/2014/main" id="{D968E51C-4D1F-4914-86E4-08B3BAF9C5F2}"/>
               </a:ext>
             </a:extLst>
           </p:cNvPr>
@@ -7659,7 +7714,7 @@
           <p:cNvPr id="24" name="footer-page-13">
             <a:extLst xmlns:a="http://schemas.openxmlformats.org/drawingml/2006/main">
               <a:ext uri="{FF2B5EF4-FFF2-40B4-BE49-F238E27FC236}">
-                <a16:creationId xmlns:a16="http://schemas.microsoft.com/office/drawing/2014/main" id="{E4DAC4D3-2D97-4B33-A32B-FA1677B45B50}"/>
+                <a16:creationId xmlns:a16="http://schemas.microsoft.com/office/drawing/2014/main" id="{8A6A3EC7-EF5F-4393-BFF1-DD2D2366BB18}"/>
               </a:ext>
             </a:extLst>
           </p:cNvPr>
@@ -7719,7 +7774,7 @@
     </p:spTree>
     <p:extLst>
       <p:ext uri="{BB962C8B-B14F-4D97-AF65-F5344CB8AC3E}">
-        <p14:creationId xmlns:p14="http://schemas.microsoft.com/office/powerpoint/2010/main" val="35330864"/>
+        <p14:creationId xmlns:p14="http://schemas.microsoft.com/office/powerpoint/2010/main" val="1301108603"/>
       </p:ext>
     </p:extLst>
   </p:cSld>
@@ -7750,7 +7805,7 @@
           <p:cNvPr id="24" name="side-accent-14">
             <a:extLst xmlns:a="http://schemas.openxmlformats.org/drawingml/2006/main">
               <a:ext uri="{FF2B5EF4-FFF2-40B4-BE49-F238E27FC236}">
-                <a16:creationId xmlns:a16="http://schemas.microsoft.com/office/drawing/2014/main" id="{5CAF681E-7A94-4325-9862-3A640C3A2937}"/>
+                <a16:creationId xmlns:a16="http://schemas.microsoft.com/office/drawing/2014/main" id="{DD2CF9C4-BDD9-459D-9EF7-3D8D65051F92}"/>
               </a:ext>
             </a:extLst>
           </p:cNvPr>
@@ -7781,7 +7836,7 @@
           <p:cNvPr id="2" name="kicker-14">
             <a:extLst xmlns:a="http://schemas.openxmlformats.org/drawingml/2006/main">
               <a:ext uri="{FF2B5EF4-FFF2-40B4-BE49-F238E27FC236}">
-                <a16:creationId xmlns:a16="http://schemas.microsoft.com/office/drawing/2014/main" id="{EAA6E2F7-0B78-4A3E-93FA-9D9F5C58035D}"/>
+                <a16:creationId xmlns:a16="http://schemas.microsoft.com/office/drawing/2014/main" id="{34D7ADAC-B11F-46B9-88D2-B1A627B65D3C}"/>
               </a:ext>
             </a:extLst>
           </p:cNvPr>
@@ -7843,7 +7898,7 @@
           <p:cNvPr id="3" name="title-14">
             <a:extLst xmlns:a="http://schemas.openxmlformats.org/drawingml/2006/main">
               <a:ext uri="{FF2B5EF4-FFF2-40B4-BE49-F238E27FC236}">
-                <a16:creationId xmlns:a16="http://schemas.microsoft.com/office/drawing/2014/main" id="{26ADA42C-4514-42BF-93AB-937AAEC6001D}"/>
+                <a16:creationId xmlns:a16="http://schemas.microsoft.com/office/drawing/2014/main" id="{85A71818-E03F-4EE2-8C4C-162703B80185}"/>
               </a:ext>
             </a:extLst>
           </p:cNvPr>
@@ -7905,7 +7960,7 @@
           <p:cNvPr id="4" name="">
             <a:extLst xmlns:a="http://schemas.openxmlformats.org/drawingml/2006/main">
               <a:ext uri="{FF2B5EF4-FFF2-40B4-BE49-F238E27FC236}">
-                <a16:creationId xmlns:a16="http://schemas.microsoft.com/office/drawing/2014/main" id="{25F45A5E-F383-48C0-8CE9-AB3ACAB81708}"/>
+                <a16:creationId xmlns:a16="http://schemas.microsoft.com/office/drawing/2014/main" id="{C6585A16-2622-424F-95F4-EEA21B9A6218}"/>
               </a:ext>
             </a:extLst>
           </p:cNvPr>
@@ -7967,7 +8022,7 @@
           <p:cNvPr id="5" name="">
             <a:extLst xmlns:a="http://schemas.openxmlformats.org/drawingml/2006/main">
               <a:ext uri="{FF2B5EF4-FFF2-40B4-BE49-F238E27FC236}">
-                <a16:creationId xmlns:a16="http://schemas.microsoft.com/office/drawing/2014/main" id="{AB3DA1BE-86E8-40C4-A50A-7FE834B45156}"/>
+                <a16:creationId xmlns:a16="http://schemas.microsoft.com/office/drawing/2014/main" id="{8E3FFA7D-E241-4F92-9230-85B061F205E4}"/>
               </a:ext>
             </a:extLst>
           </p:cNvPr>
@@ -8029,7 +8084,7 @@
           <p:cNvPr id="6" name="">
             <a:extLst xmlns:a="http://schemas.openxmlformats.org/drawingml/2006/main">
               <a:ext uri="{FF2B5EF4-FFF2-40B4-BE49-F238E27FC236}">
-                <a16:creationId xmlns:a16="http://schemas.microsoft.com/office/drawing/2014/main" id="{C8692C11-7EC1-419D-961A-AFB805D31C48}"/>
+                <a16:creationId xmlns:a16="http://schemas.microsoft.com/office/drawing/2014/main" id="{448D3FFC-24BC-4F3F-B6DD-802EEFED659B}"/>
               </a:ext>
             </a:extLst>
           </p:cNvPr>
@@ -8091,7 +8146,7 @@
           <p:cNvPr id="7" name="">
             <a:extLst xmlns:a="http://schemas.openxmlformats.org/drawingml/2006/main">
               <a:ext uri="{FF2B5EF4-FFF2-40B4-BE49-F238E27FC236}">
-                <a16:creationId xmlns:a16="http://schemas.microsoft.com/office/drawing/2014/main" id="{C560D9E4-0DE3-4AD2-A662-79C1FA9BC4A9}"/>
+                <a16:creationId xmlns:a16="http://schemas.microsoft.com/office/drawing/2014/main" id="{75E8E096-7A55-4C86-A347-034AB71A7AFB}"/>
               </a:ext>
             </a:extLst>
           </p:cNvPr>
@@ -8122,7 +8177,7 @@
           <p:cNvPr id="8" name="">
             <a:extLst xmlns:a="http://schemas.openxmlformats.org/drawingml/2006/main">
               <a:ext uri="{FF2B5EF4-FFF2-40B4-BE49-F238E27FC236}">
-                <a16:creationId xmlns:a16="http://schemas.microsoft.com/office/drawing/2014/main" id="{F935DED7-B3D7-46E2-AFCB-F0736A057E1C}"/>
+                <a16:creationId xmlns:a16="http://schemas.microsoft.com/office/drawing/2014/main" id="{B4F595B5-DA5E-4E8A-ADFB-8CBF11F54DDB}"/>
               </a:ext>
             </a:extLst>
           </p:cNvPr>
@@ -8184,7 +8239,7 @@
           <p:cNvPr id="9" name="">
             <a:extLst xmlns:a="http://schemas.openxmlformats.org/drawingml/2006/main">
               <a:ext uri="{FF2B5EF4-FFF2-40B4-BE49-F238E27FC236}">
-                <a16:creationId xmlns:a16="http://schemas.microsoft.com/office/drawing/2014/main" id="{BD5FC1A4-7369-466E-A27C-4F57FB182073}"/>
+                <a16:creationId xmlns:a16="http://schemas.microsoft.com/office/drawing/2014/main" id="{28C3CCDD-339E-4EF7-9FBE-9C1129970D69}"/>
               </a:ext>
             </a:extLst>
           </p:cNvPr>
@@ -8246,7 +8301,7 @@
           <p:cNvPr id="10" name="">
             <a:extLst xmlns:a="http://schemas.openxmlformats.org/drawingml/2006/main">
               <a:ext uri="{FF2B5EF4-FFF2-40B4-BE49-F238E27FC236}">
-                <a16:creationId xmlns:a16="http://schemas.microsoft.com/office/drawing/2014/main" id="{0EEEB38C-C5E1-475D-9D40-45458C75B9A5}"/>
+                <a16:creationId xmlns:a16="http://schemas.microsoft.com/office/drawing/2014/main" id="{82C0201D-13B3-418D-9131-57DD12B4B3FE}"/>
               </a:ext>
             </a:extLst>
           </p:cNvPr>
@@ -8308,7 +8363,7 @@
           <p:cNvPr id="11" name="">
             <a:extLst xmlns:a="http://schemas.openxmlformats.org/drawingml/2006/main">
               <a:ext uri="{FF2B5EF4-FFF2-40B4-BE49-F238E27FC236}">
-                <a16:creationId xmlns:a16="http://schemas.microsoft.com/office/drawing/2014/main" id="{F065CCAA-B565-4515-ACE5-82260FA89642}"/>
+                <a16:creationId xmlns:a16="http://schemas.microsoft.com/office/drawing/2014/main" id="{1B193EE9-F1EA-431A-8972-3791ADC77FE9}"/>
               </a:ext>
             </a:extLst>
           </p:cNvPr>
@@ -8339,7 +8394,7 @@
           <p:cNvPr id="12" name="">
             <a:extLst xmlns:a="http://schemas.openxmlformats.org/drawingml/2006/main">
               <a:ext uri="{FF2B5EF4-FFF2-40B4-BE49-F238E27FC236}">
-                <a16:creationId xmlns:a16="http://schemas.microsoft.com/office/drawing/2014/main" id="{31D4C0D7-CFB3-4526-BE33-D56CEF0FFB58}"/>
+                <a16:creationId xmlns:a16="http://schemas.microsoft.com/office/drawing/2014/main" id="{5E2AE5FA-9C87-4965-B92D-2D049C049290}"/>
               </a:ext>
             </a:extLst>
           </p:cNvPr>
@@ -8401,7 +8456,7 @@
           <p:cNvPr id="13" name="">
             <a:extLst xmlns:a="http://schemas.openxmlformats.org/drawingml/2006/main">
               <a:ext uri="{FF2B5EF4-FFF2-40B4-BE49-F238E27FC236}">
-                <a16:creationId xmlns:a16="http://schemas.microsoft.com/office/drawing/2014/main" id="{D6C8B293-45A5-4EA4-96AA-9110149BC860}"/>
+                <a16:creationId xmlns:a16="http://schemas.microsoft.com/office/drawing/2014/main" id="{37D8F55A-D7F7-4EC9-885F-5A3339F1D51C}"/>
               </a:ext>
             </a:extLst>
           </p:cNvPr>
@@ -8463,7 +8518,7 @@
           <p:cNvPr id="14" name="">
             <a:extLst xmlns:a="http://schemas.openxmlformats.org/drawingml/2006/main">
               <a:ext uri="{FF2B5EF4-FFF2-40B4-BE49-F238E27FC236}">
-                <a16:creationId xmlns:a16="http://schemas.microsoft.com/office/drawing/2014/main" id="{F04983B2-BAD1-4108-8A93-566791E05AE6}"/>
+                <a16:creationId xmlns:a16="http://schemas.microsoft.com/office/drawing/2014/main" id="{D4B6E7B3-BCA1-450C-9D36-0EC21398EE93}"/>
               </a:ext>
             </a:extLst>
           </p:cNvPr>
@@ -8525,7 +8580,7 @@
           <p:cNvPr id="15" name="">
             <a:extLst xmlns:a="http://schemas.openxmlformats.org/drawingml/2006/main">
               <a:ext uri="{FF2B5EF4-FFF2-40B4-BE49-F238E27FC236}">
-                <a16:creationId xmlns:a16="http://schemas.microsoft.com/office/drawing/2014/main" id="{CCFF5D61-165E-4134-A2F0-AA98576A762A}"/>
+                <a16:creationId xmlns:a16="http://schemas.microsoft.com/office/drawing/2014/main" id="{C42E0063-B19A-4015-9232-23EC5367F94C}"/>
               </a:ext>
             </a:extLst>
           </p:cNvPr>
@@ -8556,7 +8611,7 @@
           <p:cNvPr id="16" name="">
             <a:extLst xmlns:a="http://schemas.openxmlformats.org/drawingml/2006/main">
               <a:ext uri="{FF2B5EF4-FFF2-40B4-BE49-F238E27FC236}">
-                <a16:creationId xmlns:a16="http://schemas.microsoft.com/office/drawing/2014/main" id="{D9293EF3-00CA-4D67-BF90-2C62298D5D25}"/>
+                <a16:creationId xmlns:a16="http://schemas.microsoft.com/office/drawing/2014/main" id="{AED389A7-F2F5-485D-8251-81F40DCB231E}"/>
               </a:ext>
             </a:extLst>
           </p:cNvPr>
@@ -8618,7 +8673,7 @@
           <p:cNvPr id="17" name="">
             <a:extLst xmlns:a="http://schemas.openxmlformats.org/drawingml/2006/main">
               <a:ext uri="{FF2B5EF4-FFF2-40B4-BE49-F238E27FC236}">
-                <a16:creationId xmlns:a16="http://schemas.microsoft.com/office/drawing/2014/main" id="{E6D72638-68E1-42ED-90DC-DC2C5B112281}"/>
+                <a16:creationId xmlns:a16="http://schemas.microsoft.com/office/drawing/2014/main" id="{F94EA714-C0D7-4407-AE63-557916E91265}"/>
               </a:ext>
             </a:extLst>
           </p:cNvPr>
@@ -8680,7 +8735,7 @@
           <p:cNvPr id="18" name="">
             <a:extLst xmlns:a="http://schemas.openxmlformats.org/drawingml/2006/main">
               <a:ext uri="{FF2B5EF4-FFF2-40B4-BE49-F238E27FC236}">
-                <a16:creationId xmlns:a16="http://schemas.microsoft.com/office/drawing/2014/main" id="{F7B1BBFE-7789-47A4-AF84-877B8ADD8DC1}"/>
+                <a16:creationId xmlns:a16="http://schemas.microsoft.com/office/drawing/2014/main" id="{15EF1225-DD40-454A-AF8D-09BB56D37100}"/>
               </a:ext>
             </a:extLst>
           </p:cNvPr>
@@ -8742,7 +8797,7 @@
           <p:cNvPr id="19" name="">
             <a:extLst xmlns:a="http://schemas.openxmlformats.org/drawingml/2006/main">
               <a:ext uri="{FF2B5EF4-FFF2-40B4-BE49-F238E27FC236}">
-                <a16:creationId xmlns:a16="http://schemas.microsoft.com/office/drawing/2014/main" id="{2D92D0F2-BCE6-4B5D-8CB3-540C6E13AF9B}"/>
+                <a16:creationId xmlns:a16="http://schemas.microsoft.com/office/drawing/2014/main" id="{E22F7152-9BF8-4076-966F-6B78E0824B5A}"/>
               </a:ext>
             </a:extLst>
           </p:cNvPr>
@@ -8775,7 +8830,7 @@
           <p:cNvPr id="20" name="">
             <a:extLst xmlns:a="http://schemas.openxmlformats.org/drawingml/2006/main">
               <a:ext uri="{FF2B5EF4-FFF2-40B4-BE49-F238E27FC236}">
-                <a16:creationId xmlns:a16="http://schemas.microsoft.com/office/drawing/2014/main" id="{533BE162-58D0-4C8F-AC85-B2446BD9C6D5}"/>
+                <a16:creationId xmlns:a16="http://schemas.microsoft.com/office/drawing/2014/main" id="{6F0FCC07-F458-477D-9393-53B28231DD38}"/>
               </a:ext>
             </a:extLst>
           </p:cNvPr>
@@ -8837,7 +8892,7 @@
           <p:cNvPr id="21" name="footer-rule-14">
             <a:extLst xmlns:a="http://schemas.openxmlformats.org/drawingml/2006/main">
               <a:ext uri="{FF2B5EF4-FFF2-40B4-BE49-F238E27FC236}">
-                <a16:creationId xmlns:a16="http://schemas.microsoft.com/office/drawing/2014/main" id="{40AD2B26-4FD6-47B3-AFC4-8AB59555785D}"/>
+                <a16:creationId xmlns:a16="http://schemas.microsoft.com/office/drawing/2014/main" id="{09A2B17F-31CF-426D-B070-4300B4E7C859}"/>
               </a:ext>
             </a:extLst>
           </p:cNvPr>
@@ -8868,7 +8923,7 @@
           <p:cNvPr id="22" name="footer-label-14">
             <a:extLst xmlns:a="http://schemas.openxmlformats.org/drawingml/2006/main">
               <a:ext uri="{FF2B5EF4-FFF2-40B4-BE49-F238E27FC236}">
-                <a16:creationId xmlns:a16="http://schemas.microsoft.com/office/drawing/2014/main" id="{5DF11258-0A42-4D3D-AD90-36E13ACCF82E}"/>
+                <a16:creationId xmlns:a16="http://schemas.microsoft.com/office/drawing/2014/main" id="{CAD364FB-FE66-4EBA-A48C-1DCB0068043B}"/>
               </a:ext>
             </a:extLst>
           </p:cNvPr>
@@ -8930,7 +8985,7 @@
           <p:cNvPr id="23" name="footer-page-14">
             <a:extLst xmlns:a="http://schemas.openxmlformats.org/drawingml/2006/main">
               <a:ext uri="{FF2B5EF4-FFF2-40B4-BE49-F238E27FC236}">
-                <a16:creationId xmlns:a16="http://schemas.microsoft.com/office/drawing/2014/main" id="{1DC121E5-0D09-400F-846F-32338C89A620}"/>
+                <a16:creationId xmlns:a16="http://schemas.microsoft.com/office/drawing/2014/main" id="{A4067B83-0AC5-4ED3-A996-94564CEF45E3}"/>
               </a:ext>
             </a:extLst>
           </p:cNvPr>
@@ -8990,7 +9045,7 @@
     </p:spTree>
     <p:extLst>
       <p:ext uri="{BB962C8B-B14F-4D97-AF65-F5344CB8AC3E}">
-        <p14:creationId xmlns:p14="http://schemas.microsoft.com/office/powerpoint/2010/main" val="1296421465"/>
+        <p14:creationId xmlns:p14="http://schemas.microsoft.com/office/powerpoint/2010/main" val="1272256928"/>
       </p:ext>
     </p:extLst>
   </p:cSld>
@@ -9021,7 +9076,7 @@
           <p:cNvPr id="21" name="side-accent-15">
             <a:extLst xmlns:a="http://schemas.openxmlformats.org/drawingml/2006/main">
               <a:ext uri="{FF2B5EF4-FFF2-40B4-BE49-F238E27FC236}">
-                <a16:creationId xmlns:a16="http://schemas.microsoft.com/office/drawing/2014/main" id="{2B2C8978-F7A6-45B5-B1F9-A0ADE0225F96}"/>
+                <a16:creationId xmlns:a16="http://schemas.microsoft.com/office/drawing/2014/main" id="{C6B52308-FB10-4F77-8D3B-E3204B55C92D}"/>
               </a:ext>
             </a:extLst>
           </p:cNvPr>
@@ -9052,7 +9107,7 @@
           <p:cNvPr id="2" name="kicker-15">
             <a:extLst xmlns:a="http://schemas.openxmlformats.org/drawingml/2006/main">
               <a:ext uri="{FF2B5EF4-FFF2-40B4-BE49-F238E27FC236}">
-                <a16:creationId xmlns:a16="http://schemas.microsoft.com/office/drawing/2014/main" id="{490F830F-46FF-45A4-BF83-501A7A59BBAE}"/>
+                <a16:creationId xmlns:a16="http://schemas.microsoft.com/office/drawing/2014/main" id="{C264ABFD-1543-4935-B5D8-A9B024CB21E3}"/>
               </a:ext>
             </a:extLst>
           </p:cNvPr>
@@ -9114,7 +9169,7 @@
           <p:cNvPr id="3" name="title-15">
             <a:extLst xmlns:a="http://schemas.openxmlformats.org/drawingml/2006/main">
               <a:ext uri="{FF2B5EF4-FFF2-40B4-BE49-F238E27FC236}">
-                <a16:creationId xmlns:a16="http://schemas.microsoft.com/office/drawing/2014/main" id="{809E0F1B-1AA5-4965-9111-7D8ED2E75FBC}"/>
+                <a16:creationId xmlns:a16="http://schemas.microsoft.com/office/drawing/2014/main" id="{17D37D0A-2504-4DA2-AD5E-D31BA6C3DB95}"/>
               </a:ext>
             </a:extLst>
           </p:cNvPr>
@@ -9176,7 +9231,7 @@
           <p:cNvPr id="4" name="">
             <a:extLst xmlns:a="http://schemas.openxmlformats.org/drawingml/2006/main">
               <a:ext uri="{FF2B5EF4-FFF2-40B4-BE49-F238E27FC236}">
-                <a16:creationId xmlns:a16="http://schemas.microsoft.com/office/drawing/2014/main" id="{0B9F08C4-1AAE-4F22-A8B3-0396E95B3F84}"/>
+                <a16:creationId xmlns:a16="http://schemas.microsoft.com/office/drawing/2014/main" id="{BC306BF7-BFDD-4843-AFFE-B25239270D6B}"/>
               </a:ext>
             </a:extLst>
           </p:cNvPr>
@@ -9207,7 +9262,7 @@
           <p:cNvPr id="5" name="">
             <a:extLst xmlns:a="http://schemas.openxmlformats.org/drawingml/2006/main">
               <a:ext uri="{FF2B5EF4-FFF2-40B4-BE49-F238E27FC236}">
-                <a16:creationId xmlns:a16="http://schemas.microsoft.com/office/drawing/2014/main" id="{BFC8198D-F8E2-431D-8239-5B5608060FCF}"/>
+                <a16:creationId xmlns:a16="http://schemas.microsoft.com/office/drawing/2014/main" id="{28192596-C9F0-44A2-AFF6-5EC62779EC5C}"/>
               </a:ext>
             </a:extLst>
           </p:cNvPr>
@@ -9238,7 +9293,7 @@
           <p:cNvPr id="6" name="">
             <a:extLst xmlns:a="http://schemas.openxmlformats.org/drawingml/2006/main">
               <a:ext uri="{FF2B5EF4-FFF2-40B4-BE49-F238E27FC236}">
-                <a16:creationId xmlns:a16="http://schemas.microsoft.com/office/drawing/2014/main" id="{2B9C6965-E199-42AE-AE64-0F5D3CEC982D}"/>
+                <a16:creationId xmlns:a16="http://schemas.microsoft.com/office/drawing/2014/main" id="{56C6B01F-7506-46B9-9A37-F1349CA8C852}"/>
               </a:ext>
             </a:extLst>
           </p:cNvPr>
@@ -9300,7 +9355,7 @@
           <p:cNvPr id="7" name="">
             <a:extLst xmlns:a="http://schemas.openxmlformats.org/drawingml/2006/main">
               <a:ext uri="{FF2B5EF4-FFF2-40B4-BE49-F238E27FC236}">
-                <a16:creationId xmlns:a16="http://schemas.microsoft.com/office/drawing/2014/main" id="{E34DDFF1-FC54-4C8F-8CE3-95C5D98048AA}"/>
+                <a16:creationId xmlns:a16="http://schemas.microsoft.com/office/drawing/2014/main" id="{048B205D-577E-4789-BE22-0870E8645AEE}"/>
               </a:ext>
             </a:extLst>
           </p:cNvPr>
@@ -9362,7 +9417,7 @@
           <p:cNvPr id="8" name="">
             <a:extLst xmlns:a="http://schemas.openxmlformats.org/drawingml/2006/main">
               <a:ext uri="{FF2B5EF4-FFF2-40B4-BE49-F238E27FC236}">
-                <a16:creationId xmlns:a16="http://schemas.microsoft.com/office/drawing/2014/main" id="{51509D11-55EF-44B1-B189-CE99D0650694}"/>
+                <a16:creationId xmlns:a16="http://schemas.microsoft.com/office/drawing/2014/main" id="{8950560D-06C8-49B1-9EC7-56E1CE717113}"/>
               </a:ext>
             </a:extLst>
           </p:cNvPr>
@@ -9424,7 +9479,7 @@
           <p:cNvPr id="9" name="">
             <a:extLst xmlns:a="http://schemas.openxmlformats.org/drawingml/2006/main">
               <a:ext uri="{FF2B5EF4-FFF2-40B4-BE49-F238E27FC236}">
-                <a16:creationId xmlns:a16="http://schemas.microsoft.com/office/drawing/2014/main" id="{B8BBA993-2CD2-477D-A22A-BD1581DBCE03}"/>
+                <a16:creationId xmlns:a16="http://schemas.microsoft.com/office/drawing/2014/main" id="{EF5E01CA-2149-4435-BE3D-1D403AF6782B}"/>
               </a:ext>
             </a:extLst>
           </p:cNvPr>
@@ -9455,7 +9510,7 @@
           <p:cNvPr id="10" name="">
             <a:extLst xmlns:a="http://schemas.openxmlformats.org/drawingml/2006/main">
               <a:ext uri="{FF2B5EF4-FFF2-40B4-BE49-F238E27FC236}">
-                <a16:creationId xmlns:a16="http://schemas.microsoft.com/office/drawing/2014/main" id="{D9DBF50F-48CA-464C-95E1-47CDAC0E638C}"/>
+                <a16:creationId xmlns:a16="http://schemas.microsoft.com/office/drawing/2014/main" id="{C7DA054E-3CCC-4291-8EFD-7E5289F19547}"/>
               </a:ext>
             </a:extLst>
           </p:cNvPr>
@@ -9517,7 +9572,7 @@
           <p:cNvPr id="11" name="">
             <a:extLst xmlns:a="http://schemas.openxmlformats.org/drawingml/2006/main">
               <a:ext uri="{FF2B5EF4-FFF2-40B4-BE49-F238E27FC236}">
-                <a16:creationId xmlns:a16="http://schemas.microsoft.com/office/drawing/2014/main" id="{611234C6-F492-492F-854F-D3436E274777}"/>
+                <a16:creationId xmlns:a16="http://schemas.microsoft.com/office/drawing/2014/main" id="{5C10FFBF-354D-4E36-B1B1-687CC3F2912D}"/>
               </a:ext>
             </a:extLst>
           </p:cNvPr>
@@ -9579,7 +9634,7 @@
           <p:cNvPr id="12" name="">
             <a:extLst xmlns:a="http://schemas.openxmlformats.org/drawingml/2006/main">
               <a:ext uri="{FF2B5EF4-FFF2-40B4-BE49-F238E27FC236}">
-                <a16:creationId xmlns:a16="http://schemas.microsoft.com/office/drawing/2014/main" id="{D6DE0CDC-EDC7-41DF-BACF-B4D7A5B2B9B3}"/>
+                <a16:creationId xmlns:a16="http://schemas.microsoft.com/office/drawing/2014/main" id="{CD9B4B83-7DF0-4F50-A847-8355622BC910}"/>
               </a:ext>
             </a:extLst>
           </p:cNvPr>
@@ -9641,7 +9696,7 @@
           <p:cNvPr id="13" name="">
             <a:extLst xmlns:a="http://schemas.openxmlformats.org/drawingml/2006/main">
               <a:ext uri="{FF2B5EF4-FFF2-40B4-BE49-F238E27FC236}">
-                <a16:creationId xmlns:a16="http://schemas.microsoft.com/office/drawing/2014/main" id="{E45C73C3-D359-4281-B993-A32187CD1FC0}"/>
+                <a16:creationId xmlns:a16="http://schemas.microsoft.com/office/drawing/2014/main" id="{3F4CE83D-0943-46BD-B1C8-350E506FB6B8}"/>
               </a:ext>
             </a:extLst>
           </p:cNvPr>
@@ -9672,7 +9727,7 @@
           <p:cNvPr id="14" name="">
             <a:extLst xmlns:a="http://schemas.openxmlformats.org/drawingml/2006/main">
               <a:ext uri="{FF2B5EF4-FFF2-40B4-BE49-F238E27FC236}">
-                <a16:creationId xmlns:a16="http://schemas.microsoft.com/office/drawing/2014/main" id="{25F8BE8C-A99A-458B-ACC8-0283FA64CE26}"/>
+                <a16:creationId xmlns:a16="http://schemas.microsoft.com/office/drawing/2014/main" id="{177527E6-7ED0-43B1-99CD-1AEE2F293047}"/>
               </a:ext>
             </a:extLst>
           </p:cNvPr>
@@ -9734,7 +9789,7 @@
           <p:cNvPr id="15" name="">
             <a:extLst xmlns:a="http://schemas.openxmlformats.org/drawingml/2006/main">
               <a:ext uri="{FF2B5EF4-FFF2-40B4-BE49-F238E27FC236}">
-                <a16:creationId xmlns:a16="http://schemas.microsoft.com/office/drawing/2014/main" id="{81495BE5-FAA9-495E-81AC-77C162D503B2}"/>
+                <a16:creationId xmlns:a16="http://schemas.microsoft.com/office/drawing/2014/main" id="{0376916A-AAB5-47AE-8FB7-6798651D6D8B}"/>
               </a:ext>
             </a:extLst>
           </p:cNvPr>
@@ -9796,7 +9851,7 @@
           <p:cNvPr id="16" name="">
             <a:extLst xmlns:a="http://schemas.openxmlformats.org/drawingml/2006/main">
               <a:ext uri="{FF2B5EF4-FFF2-40B4-BE49-F238E27FC236}">
-                <a16:creationId xmlns:a16="http://schemas.microsoft.com/office/drawing/2014/main" id="{237AD098-F5CF-43F2-B26E-DE8F2263D0FC}"/>
+                <a16:creationId xmlns:a16="http://schemas.microsoft.com/office/drawing/2014/main" id="{8D2891F2-2BC1-4AA4-8E08-5F646D68A43A}"/>
               </a:ext>
             </a:extLst>
           </p:cNvPr>
@@ -9858,7 +9913,7 @@
           <p:cNvPr id="17" name="">
             <a:extLst xmlns:a="http://schemas.openxmlformats.org/drawingml/2006/main">
               <a:ext uri="{FF2B5EF4-FFF2-40B4-BE49-F238E27FC236}">
-                <a16:creationId xmlns:a16="http://schemas.microsoft.com/office/drawing/2014/main" id="{F418769C-5952-40F8-8E31-5268204E941F}"/>
+                <a16:creationId xmlns:a16="http://schemas.microsoft.com/office/drawing/2014/main" id="{3BDC4BF2-7B8D-4D5B-B79B-7ADC3951E598}"/>
               </a:ext>
             </a:extLst>
           </p:cNvPr>
@@ -9920,7 +9975,7 @@
           <p:cNvPr id="18" name="footer-rule-15">
             <a:extLst xmlns:a="http://schemas.openxmlformats.org/drawingml/2006/main">
               <a:ext uri="{FF2B5EF4-FFF2-40B4-BE49-F238E27FC236}">
-                <a16:creationId xmlns:a16="http://schemas.microsoft.com/office/drawing/2014/main" id="{1E386E32-D8F8-4C82-B4A9-846276A3E079}"/>
+                <a16:creationId xmlns:a16="http://schemas.microsoft.com/office/drawing/2014/main" id="{0814231B-0D57-4EDF-A17D-72A92E883EBA}"/>
               </a:ext>
             </a:extLst>
           </p:cNvPr>
@@ -9951,7 +10006,7 @@
           <p:cNvPr id="19" name="footer-label-15">
             <a:extLst xmlns:a="http://schemas.openxmlformats.org/drawingml/2006/main">
               <a:ext uri="{FF2B5EF4-FFF2-40B4-BE49-F238E27FC236}">
-                <a16:creationId xmlns:a16="http://schemas.microsoft.com/office/drawing/2014/main" id="{4AA8B687-7012-48CB-9175-C26B5DD38AC0}"/>
+                <a16:creationId xmlns:a16="http://schemas.microsoft.com/office/drawing/2014/main" id="{87CDDD18-8A3F-4BB3-B7D6-69A5449E2B32}"/>
               </a:ext>
             </a:extLst>
           </p:cNvPr>
@@ -10013,7 +10068,7 @@
           <p:cNvPr id="20" name="footer-page-15">
             <a:extLst xmlns:a="http://schemas.openxmlformats.org/drawingml/2006/main">
               <a:ext uri="{FF2B5EF4-FFF2-40B4-BE49-F238E27FC236}">
-                <a16:creationId xmlns:a16="http://schemas.microsoft.com/office/drawing/2014/main" id="{E67EB628-93AE-44B6-8DCB-4BE9C01283C6}"/>
+                <a16:creationId xmlns:a16="http://schemas.microsoft.com/office/drawing/2014/main" id="{45E108D1-7EFC-45AA-B983-1ABF90B50C66}"/>
               </a:ext>
             </a:extLst>
           </p:cNvPr>
@@ -10073,7 +10128,7 @@
     </p:spTree>
     <p:extLst>
       <p:ext uri="{BB962C8B-B14F-4D97-AF65-F5344CB8AC3E}">
-        <p14:creationId xmlns:p14="http://schemas.microsoft.com/office/powerpoint/2010/main" val="1439225652"/>
+        <p14:creationId xmlns:p14="http://schemas.microsoft.com/office/powerpoint/2010/main" val="598176331"/>
       </p:ext>
     </p:extLst>
   </p:cSld>
@@ -10104,7 +10159,7 @@
           <p:cNvPr id="11" name="">
             <a:extLst xmlns:a="http://schemas.openxmlformats.org/drawingml/2006/main">
               <a:ext uri="{FF2B5EF4-FFF2-40B4-BE49-F238E27FC236}">
-                <a16:creationId xmlns:a16="http://schemas.microsoft.com/office/drawing/2014/main" id="{330829C5-F181-4A87-B1D8-3A03E6AB62E4}"/>
+                <a16:creationId xmlns:a16="http://schemas.microsoft.com/office/drawing/2014/main" id="{09BC0D08-F98F-44D1-B5CA-C27234A5B9C8}"/>
               </a:ext>
             </a:extLst>
           </p:cNvPr>
@@ -10135,7 +10190,7 @@
           <p:cNvPr id="2" name="">
             <a:extLst xmlns:a="http://schemas.openxmlformats.org/drawingml/2006/main">
               <a:ext uri="{FF2B5EF4-FFF2-40B4-BE49-F238E27FC236}">
-                <a16:creationId xmlns:a16="http://schemas.microsoft.com/office/drawing/2014/main" id="{8C3338AE-D6E4-4140-B850-8A5B925AFDD6}"/>
+                <a16:creationId xmlns:a16="http://schemas.microsoft.com/office/drawing/2014/main" id="{B60F0916-11C0-4A71-A1DA-F810957A0690}"/>
               </a:ext>
             </a:extLst>
           </p:cNvPr>
@@ -10197,7 +10252,7 @@
           <p:cNvPr id="3" name="">
             <a:extLst xmlns:a="http://schemas.openxmlformats.org/drawingml/2006/main">
               <a:ext uri="{FF2B5EF4-FFF2-40B4-BE49-F238E27FC236}">
-                <a16:creationId xmlns:a16="http://schemas.microsoft.com/office/drawing/2014/main" id="{71D00702-5BAE-4A23-95F0-D190C5577901}"/>
+                <a16:creationId xmlns:a16="http://schemas.microsoft.com/office/drawing/2014/main" id="{F19450D7-F92E-45D6-B055-168B1304117B}"/>
               </a:ext>
             </a:extLst>
           </p:cNvPr>
@@ -10286,7 +10341,7 @@
           <p:cNvPr id="4" name="">
             <a:extLst xmlns:a="http://schemas.openxmlformats.org/drawingml/2006/main">
               <a:ext uri="{FF2B5EF4-FFF2-40B4-BE49-F238E27FC236}">
-                <a16:creationId xmlns:a16="http://schemas.microsoft.com/office/drawing/2014/main" id="{9D22E3BF-4FBC-4503-A23C-00870D739DBA}"/>
+                <a16:creationId xmlns:a16="http://schemas.microsoft.com/office/drawing/2014/main" id="{FDDE8B3F-5C6D-4C01-AC09-EBB22DA8AA10}"/>
               </a:ext>
             </a:extLst>
           </p:cNvPr>
@@ -10348,7 +10403,7 @@
           <p:cNvPr id="5" name="">
             <a:extLst xmlns:a="http://schemas.openxmlformats.org/drawingml/2006/main">
               <a:ext uri="{FF2B5EF4-FFF2-40B4-BE49-F238E27FC236}">
-                <a16:creationId xmlns:a16="http://schemas.microsoft.com/office/drawing/2014/main" id="{B09DEEE7-063E-4A1C-9B93-3900D7F2F40E}"/>
+                <a16:creationId xmlns:a16="http://schemas.microsoft.com/office/drawing/2014/main" id="{C35CCAB1-F866-4BF6-B180-85683033ED27}"/>
               </a:ext>
             </a:extLst>
           </p:cNvPr>
@@ -10381,7 +10436,7 @@
           <p:cNvPr id="6" name="">
             <a:extLst xmlns:a="http://schemas.openxmlformats.org/drawingml/2006/main">
               <a:ext uri="{FF2B5EF4-FFF2-40B4-BE49-F238E27FC236}">
-                <a16:creationId xmlns:a16="http://schemas.microsoft.com/office/drawing/2014/main" id="{11F9FA32-EFAB-42DB-9505-04EE55DA3E15}"/>
+                <a16:creationId xmlns:a16="http://schemas.microsoft.com/office/drawing/2014/main" id="{D4BC960E-E2E8-42F6-98BC-2430C5093C7C}"/>
               </a:ext>
             </a:extLst>
           </p:cNvPr>
@@ -10443,7 +10498,7 @@
           <p:cNvPr id="7" name="">
             <a:extLst xmlns:a="http://schemas.openxmlformats.org/drawingml/2006/main">
               <a:ext uri="{FF2B5EF4-FFF2-40B4-BE49-F238E27FC236}">
-                <a16:creationId xmlns:a16="http://schemas.microsoft.com/office/drawing/2014/main" id="{43CC05E6-B83C-4F5D-A228-8D509E593F43}"/>
+                <a16:creationId xmlns:a16="http://schemas.microsoft.com/office/drawing/2014/main" id="{F3DFD911-C729-4B7A-AA66-E3982CDAB693}"/>
               </a:ext>
             </a:extLst>
           </p:cNvPr>
@@ -10505,7 +10560,7 @@
           <p:cNvPr id="8" name="">
             <a:extLst xmlns:a="http://schemas.openxmlformats.org/drawingml/2006/main">
               <a:ext uri="{FF2B5EF4-FFF2-40B4-BE49-F238E27FC236}">
-                <a16:creationId xmlns:a16="http://schemas.microsoft.com/office/drawing/2014/main" id="{5A0777A1-4FA1-467A-9282-C7EA52A6B8B3}"/>
+                <a16:creationId xmlns:a16="http://schemas.microsoft.com/office/drawing/2014/main" id="{38B1AB1A-35A0-440B-8447-3D9FD85B7D88}"/>
               </a:ext>
             </a:extLst>
           </p:cNvPr>
@@ -10594,7 +10649,7 @@
           <p:cNvPr id="9" name="">
             <a:extLst xmlns:a="http://schemas.openxmlformats.org/drawingml/2006/main">
               <a:ext uri="{FF2B5EF4-FFF2-40B4-BE49-F238E27FC236}">
-                <a16:creationId xmlns:a16="http://schemas.microsoft.com/office/drawing/2014/main" id="{3ACECE34-6C5E-4D75-ABC0-3DA2CCB30835}"/>
+                <a16:creationId xmlns:a16="http://schemas.microsoft.com/office/drawing/2014/main" id="{CBB52404-B2BD-4BCC-BA44-B434D787DDDA}"/>
               </a:ext>
             </a:extLst>
           </p:cNvPr>
@@ -10656,7 +10711,7 @@
           <p:cNvPr id="10" name="">
             <a:extLst xmlns:a="http://schemas.openxmlformats.org/drawingml/2006/main">
               <a:ext uri="{FF2B5EF4-FFF2-40B4-BE49-F238E27FC236}">
-                <a16:creationId xmlns:a16="http://schemas.microsoft.com/office/drawing/2014/main" id="{9C7E143B-BD45-42B0-839F-A81D56B129A1}"/>
+                <a16:creationId xmlns:a16="http://schemas.microsoft.com/office/drawing/2014/main" id="{A2111124-4C93-443C-8587-47A5A479C7C8}"/>
               </a:ext>
             </a:extLst>
           </p:cNvPr>
@@ -10716,7 +10771,7 @@
     </p:spTree>
     <p:extLst>
       <p:ext uri="{BB962C8B-B14F-4D97-AF65-F5344CB8AC3E}">
-        <p14:creationId xmlns:p14="http://schemas.microsoft.com/office/powerpoint/2010/main" val="1503821441"/>
+        <p14:creationId xmlns:p14="http://schemas.microsoft.com/office/powerpoint/2010/main" val="2054646819"/>
       </p:ext>
     </p:extLst>
   </p:cSld>
@@ -10747,7 +10802,7 @@
           <p:cNvPr id="22" name="side-accent-17">
             <a:extLst xmlns:a="http://schemas.openxmlformats.org/drawingml/2006/main">
               <a:ext uri="{FF2B5EF4-FFF2-40B4-BE49-F238E27FC236}">
-                <a16:creationId xmlns:a16="http://schemas.microsoft.com/office/drawing/2014/main" id="{C3365D58-EBB9-4CED-A079-CF378B733262}"/>
+                <a16:creationId xmlns:a16="http://schemas.microsoft.com/office/drawing/2014/main" id="{CE669EEA-70FC-4EEE-BFB0-189183B1C3F3}"/>
               </a:ext>
             </a:extLst>
           </p:cNvPr>
@@ -10778,7 +10833,7 @@
           <p:cNvPr id="2" name="kicker-17">
             <a:extLst xmlns:a="http://schemas.openxmlformats.org/drawingml/2006/main">
               <a:ext uri="{FF2B5EF4-FFF2-40B4-BE49-F238E27FC236}">
-                <a16:creationId xmlns:a16="http://schemas.microsoft.com/office/drawing/2014/main" id="{93BD6036-F509-461B-9999-F013D84266D1}"/>
+                <a16:creationId xmlns:a16="http://schemas.microsoft.com/office/drawing/2014/main" id="{792B58D1-2FB2-4D03-9CC9-FCAB0644F5E9}"/>
               </a:ext>
             </a:extLst>
           </p:cNvPr>
@@ -10840,7 +10895,7 @@
           <p:cNvPr id="3" name="title-17">
             <a:extLst xmlns:a="http://schemas.openxmlformats.org/drawingml/2006/main">
               <a:ext uri="{FF2B5EF4-FFF2-40B4-BE49-F238E27FC236}">
-                <a16:creationId xmlns:a16="http://schemas.microsoft.com/office/drawing/2014/main" id="{39742768-3E2B-4A96-8FAE-815D3384A532}"/>
+                <a16:creationId xmlns:a16="http://schemas.microsoft.com/office/drawing/2014/main" id="{A7D0019C-4B75-44D0-BC1E-41EBA49F1956}"/>
               </a:ext>
             </a:extLst>
           </p:cNvPr>
@@ -10902,7 +10957,7 @@
           <p:cNvPr id="4" name="">
             <a:extLst xmlns:a="http://schemas.openxmlformats.org/drawingml/2006/main">
               <a:ext uri="{FF2B5EF4-FFF2-40B4-BE49-F238E27FC236}">
-                <a16:creationId xmlns:a16="http://schemas.microsoft.com/office/drawing/2014/main" id="{5D5DA65A-E880-49AA-884F-141E9B56BE6B}"/>
+                <a16:creationId xmlns:a16="http://schemas.microsoft.com/office/drawing/2014/main" id="{18115665-8848-425E-A937-313BA0663DD3}"/>
               </a:ext>
             </a:extLst>
           </p:cNvPr>
@@ -10964,7 +11019,7 @@
           <p:cNvPr id="5" name="">
             <a:extLst xmlns:a="http://schemas.openxmlformats.org/drawingml/2006/main">
               <a:ext uri="{FF2B5EF4-FFF2-40B4-BE49-F238E27FC236}">
-                <a16:creationId xmlns:a16="http://schemas.microsoft.com/office/drawing/2014/main" id="{05331815-2FA9-4A14-8177-FF7614FD121D}"/>
+                <a16:creationId xmlns:a16="http://schemas.microsoft.com/office/drawing/2014/main" id="{005884C0-2E18-4A2B-88F6-736C5B3348D2}"/>
               </a:ext>
             </a:extLst>
           </p:cNvPr>
@@ -10995,7 +11050,7 @@
           <p:cNvPr id="6" name="">
             <a:extLst xmlns:a="http://schemas.openxmlformats.org/drawingml/2006/main">
               <a:ext uri="{FF2B5EF4-FFF2-40B4-BE49-F238E27FC236}">
-                <a16:creationId xmlns:a16="http://schemas.microsoft.com/office/drawing/2014/main" id="{969C017F-EF04-4919-A387-9AA4ED14C4BA}"/>
+                <a16:creationId xmlns:a16="http://schemas.microsoft.com/office/drawing/2014/main" id="{A783B70E-8183-4EDE-93FC-8426AB1DE1E4}"/>
               </a:ext>
             </a:extLst>
           </p:cNvPr>
@@ -11057,7 +11112,7 @@
           <p:cNvPr id="7" name="">
             <a:extLst xmlns:a="http://schemas.openxmlformats.org/drawingml/2006/main">
               <a:ext uri="{FF2B5EF4-FFF2-40B4-BE49-F238E27FC236}">
-                <a16:creationId xmlns:a16="http://schemas.microsoft.com/office/drawing/2014/main" id="{040B5CD3-FE4B-4828-B235-9B9AA957953A}"/>
+                <a16:creationId xmlns:a16="http://schemas.microsoft.com/office/drawing/2014/main" id="{9FA8ECF9-A3C2-4F71-A78D-E04370953DF7}"/>
               </a:ext>
             </a:extLst>
           </p:cNvPr>
@@ -11119,7 +11174,7 @@
           <p:cNvPr id="8" name="">
             <a:extLst xmlns:a="http://schemas.openxmlformats.org/drawingml/2006/main">
               <a:ext uri="{FF2B5EF4-FFF2-40B4-BE49-F238E27FC236}">
-                <a16:creationId xmlns:a16="http://schemas.microsoft.com/office/drawing/2014/main" id="{0879DA7E-DB8C-425B-AF25-4999EBD1E420}"/>
+                <a16:creationId xmlns:a16="http://schemas.microsoft.com/office/drawing/2014/main" id="{FFC92AB5-68D7-4978-B349-BB29ADFC8742}"/>
               </a:ext>
             </a:extLst>
           </p:cNvPr>
@@ -11150,7 +11205,7 @@
           <p:cNvPr id="9" name="">
             <a:extLst xmlns:a="http://schemas.openxmlformats.org/drawingml/2006/main">
               <a:ext uri="{FF2B5EF4-FFF2-40B4-BE49-F238E27FC236}">
-                <a16:creationId xmlns:a16="http://schemas.microsoft.com/office/drawing/2014/main" id="{2AFA1596-FD58-42A7-8559-DE3A11CF0213}"/>
+                <a16:creationId xmlns:a16="http://schemas.microsoft.com/office/drawing/2014/main" id="{21E3C7C7-3D8D-4E06-8ABC-B118D15343D9}"/>
               </a:ext>
             </a:extLst>
           </p:cNvPr>
@@ -11212,7 +11267,7 @@
           <p:cNvPr id="10" name="">
             <a:extLst xmlns:a="http://schemas.openxmlformats.org/drawingml/2006/main">
               <a:ext uri="{FF2B5EF4-FFF2-40B4-BE49-F238E27FC236}">
-                <a16:creationId xmlns:a16="http://schemas.microsoft.com/office/drawing/2014/main" id="{63F90E8D-1F2B-4F1B-ABA6-488504BCEE6C}"/>
+                <a16:creationId xmlns:a16="http://schemas.microsoft.com/office/drawing/2014/main" id="{E03C329C-B4E4-4B0D-82F9-7683971BD32E}"/>
               </a:ext>
             </a:extLst>
           </p:cNvPr>
@@ -11274,7 +11329,7 @@
           <p:cNvPr id="11" name="">
             <a:extLst xmlns:a="http://schemas.openxmlformats.org/drawingml/2006/main">
               <a:ext uri="{FF2B5EF4-FFF2-40B4-BE49-F238E27FC236}">
-                <a16:creationId xmlns:a16="http://schemas.microsoft.com/office/drawing/2014/main" id="{81EFC562-FA9A-4679-9507-A4090DAA750F}"/>
+                <a16:creationId xmlns:a16="http://schemas.microsoft.com/office/drawing/2014/main" id="{A3B100B7-8CA6-4B0B-B4B9-1E932A464960}"/>
               </a:ext>
             </a:extLst>
           </p:cNvPr>
@@ -11305,7 +11360,7 @@
           <p:cNvPr id="12" name="">
             <a:extLst xmlns:a="http://schemas.openxmlformats.org/drawingml/2006/main">
               <a:ext uri="{FF2B5EF4-FFF2-40B4-BE49-F238E27FC236}">
-                <a16:creationId xmlns:a16="http://schemas.microsoft.com/office/drawing/2014/main" id="{E9150BDA-20F8-4E5F-A4E1-E4BBCC3A38AC}"/>
+                <a16:creationId xmlns:a16="http://schemas.microsoft.com/office/drawing/2014/main" id="{E9F8ABE1-D6ED-490E-AD1B-AF69F764004A}"/>
               </a:ext>
             </a:extLst>
           </p:cNvPr>
@@ -11367,7 +11422,7 @@
           <p:cNvPr id="13" name="">
             <a:extLst xmlns:a="http://schemas.openxmlformats.org/drawingml/2006/main">
               <a:ext uri="{FF2B5EF4-FFF2-40B4-BE49-F238E27FC236}">
-                <a16:creationId xmlns:a16="http://schemas.microsoft.com/office/drawing/2014/main" id="{EB1FE53C-7D2C-402E-A9F5-EFB29E883482}"/>
+                <a16:creationId xmlns:a16="http://schemas.microsoft.com/office/drawing/2014/main" id="{662E2367-AB9C-4C75-B61E-4706AB4EC74A}"/>
               </a:ext>
             </a:extLst>
           </p:cNvPr>
@@ -11429,7 +11484,7 @@
           <p:cNvPr id="14" name="">
             <a:extLst xmlns:a="http://schemas.openxmlformats.org/drawingml/2006/main">
               <a:ext uri="{FF2B5EF4-FFF2-40B4-BE49-F238E27FC236}">
-                <a16:creationId xmlns:a16="http://schemas.microsoft.com/office/drawing/2014/main" id="{B8893576-BE1C-4E9C-A833-8131221BD98E}"/>
+                <a16:creationId xmlns:a16="http://schemas.microsoft.com/office/drawing/2014/main" id="{18440C20-5DDA-4385-8F1D-910E9E75AD18}"/>
               </a:ext>
             </a:extLst>
           </p:cNvPr>
@@ -11460,7 +11515,7 @@
           <p:cNvPr id="15" name="">
             <a:extLst xmlns:a="http://schemas.openxmlformats.org/drawingml/2006/main">
               <a:ext uri="{FF2B5EF4-FFF2-40B4-BE49-F238E27FC236}">
-                <a16:creationId xmlns:a16="http://schemas.microsoft.com/office/drawing/2014/main" id="{C0DC59E6-A784-41E4-989C-58CDE74E51C9}"/>
+                <a16:creationId xmlns:a16="http://schemas.microsoft.com/office/drawing/2014/main" id="{316BEDF8-0F8B-469C-AA36-32D8698904BD}"/>
               </a:ext>
             </a:extLst>
           </p:cNvPr>
@@ -11522,7 +11577,7 @@
           <p:cNvPr id="16" name="">
             <a:extLst xmlns:a="http://schemas.openxmlformats.org/drawingml/2006/main">
               <a:ext uri="{FF2B5EF4-FFF2-40B4-BE49-F238E27FC236}">
-                <a16:creationId xmlns:a16="http://schemas.microsoft.com/office/drawing/2014/main" id="{BA17C824-9A9D-4CE0-BF7A-BA28DE9DD55D}"/>
+                <a16:creationId xmlns:a16="http://schemas.microsoft.com/office/drawing/2014/main" id="{A2052DC4-B073-4899-A55E-A6415AD06E4F}"/>
               </a:ext>
             </a:extLst>
           </p:cNvPr>
@@ -11584,7 +11639,7 @@
           <p:cNvPr id="17" name="">
             <a:extLst xmlns:a="http://schemas.openxmlformats.org/drawingml/2006/main">
               <a:ext uri="{FF2B5EF4-FFF2-40B4-BE49-F238E27FC236}">
-                <a16:creationId xmlns:a16="http://schemas.microsoft.com/office/drawing/2014/main" id="{1FE4DD7E-3C03-49E2-AF53-C24A472DF23B}"/>
+                <a16:creationId xmlns:a16="http://schemas.microsoft.com/office/drawing/2014/main" id="{48ED56BB-6C4B-4159-8AC0-CA057B991213}"/>
               </a:ext>
             </a:extLst>
           </p:cNvPr>
@@ -11617,7 +11672,7 @@
           <p:cNvPr id="18" name="">
             <a:extLst xmlns:a="http://schemas.openxmlformats.org/drawingml/2006/main">
               <a:ext uri="{FF2B5EF4-FFF2-40B4-BE49-F238E27FC236}">
-                <a16:creationId xmlns:a16="http://schemas.microsoft.com/office/drawing/2014/main" id="{92B07FC7-AA85-42C2-A759-742408935174}"/>
+                <a16:creationId xmlns:a16="http://schemas.microsoft.com/office/drawing/2014/main" id="{0874FA3E-188F-48B9-969C-8E01806456D1}"/>
               </a:ext>
             </a:extLst>
           </p:cNvPr>
@@ -11679,7 +11734,7 @@
           <p:cNvPr id="19" name="footer-rule-17">
             <a:extLst xmlns:a="http://schemas.openxmlformats.org/drawingml/2006/main">
               <a:ext uri="{FF2B5EF4-FFF2-40B4-BE49-F238E27FC236}">
-                <a16:creationId xmlns:a16="http://schemas.microsoft.com/office/drawing/2014/main" id="{DBCF8CEB-7B16-4833-8EE0-D25ECC37CE56}"/>
+                <a16:creationId xmlns:a16="http://schemas.microsoft.com/office/drawing/2014/main" id="{363D99BB-603D-4BB2-A488-108C99CFEA1E}"/>
               </a:ext>
             </a:extLst>
           </p:cNvPr>
@@ -11710,7 +11765,7 @@
           <p:cNvPr id="20" name="footer-label-17">
             <a:extLst xmlns:a="http://schemas.openxmlformats.org/drawingml/2006/main">
               <a:ext uri="{FF2B5EF4-FFF2-40B4-BE49-F238E27FC236}">
-                <a16:creationId xmlns:a16="http://schemas.microsoft.com/office/drawing/2014/main" id="{15B261A6-9EB5-4BD9-908F-62A244B8E883}"/>
+                <a16:creationId xmlns:a16="http://schemas.microsoft.com/office/drawing/2014/main" id="{EA46A3EA-049A-4399-BD65-8CAF1D2CD75D}"/>
               </a:ext>
             </a:extLst>
           </p:cNvPr>
@@ -11772,7 +11827,7 @@
           <p:cNvPr id="21" name="footer-page-17">
             <a:extLst xmlns:a="http://schemas.openxmlformats.org/drawingml/2006/main">
               <a:ext uri="{FF2B5EF4-FFF2-40B4-BE49-F238E27FC236}">
-                <a16:creationId xmlns:a16="http://schemas.microsoft.com/office/drawing/2014/main" id="{DD0BE16E-1E44-4D33-936C-47E9AD3E6168}"/>
+                <a16:creationId xmlns:a16="http://schemas.microsoft.com/office/drawing/2014/main" id="{9B09BBAE-441E-4BDF-B801-0803D001DA51}"/>
               </a:ext>
             </a:extLst>
           </p:cNvPr>
@@ -11832,7 +11887,7 @@
     </p:spTree>
     <p:extLst>
       <p:ext uri="{BB962C8B-B14F-4D97-AF65-F5344CB8AC3E}">
-        <p14:creationId xmlns:p14="http://schemas.microsoft.com/office/powerpoint/2010/main" val="153758474"/>
+        <p14:creationId xmlns:p14="http://schemas.microsoft.com/office/powerpoint/2010/main" val="1388238102"/>
       </p:ext>
     </p:extLst>
   </p:cSld>
@@ -11863,7 +11918,7 @@
           <p:cNvPr id="25" name="side-accent-18">
             <a:extLst xmlns:a="http://schemas.openxmlformats.org/drawingml/2006/main">
               <a:ext uri="{FF2B5EF4-FFF2-40B4-BE49-F238E27FC236}">
-                <a16:creationId xmlns:a16="http://schemas.microsoft.com/office/drawing/2014/main" id="{0C2917FE-0239-451B-A6F5-1ADC76609035}"/>
+                <a16:creationId xmlns:a16="http://schemas.microsoft.com/office/drawing/2014/main" id="{D208D931-7560-4EFE-A7D9-D5D4A92A8CE2}"/>
               </a:ext>
             </a:extLst>
           </p:cNvPr>
@@ -11894,7 +11949,7 @@
           <p:cNvPr id="2" name="kicker-18">
             <a:extLst xmlns:a="http://schemas.openxmlformats.org/drawingml/2006/main">
               <a:ext uri="{FF2B5EF4-FFF2-40B4-BE49-F238E27FC236}">
-                <a16:creationId xmlns:a16="http://schemas.microsoft.com/office/drawing/2014/main" id="{1E5B76A4-8F67-4D40-B2D7-40E9AFB85EEC}"/>
+                <a16:creationId xmlns:a16="http://schemas.microsoft.com/office/drawing/2014/main" id="{37012921-8C41-4B7D-8BFF-A262C734ECCC}"/>
               </a:ext>
             </a:extLst>
           </p:cNvPr>
@@ -11956,7 +12011,7 @@
           <p:cNvPr id="3" name="title-18">
             <a:extLst xmlns:a="http://schemas.openxmlformats.org/drawingml/2006/main">
               <a:ext uri="{FF2B5EF4-FFF2-40B4-BE49-F238E27FC236}">
-                <a16:creationId xmlns:a16="http://schemas.microsoft.com/office/drawing/2014/main" id="{0C1FF12C-42DF-4303-A846-5704ABBC67E8}"/>
+                <a16:creationId xmlns:a16="http://schemas.microsoft.com/office/drawing/2014/main" id="{24AC7303-5C79-4EE2-9839-6FEA596922FB}"/>
               </a:ext>
             </a:extLst>
           </p:cNvPr>
@@ -12018,7 +12073,7 @@
           <p:cNvPr id="4" name="">
             <a:extLst xmlns:a="http://schemas.openxmlformats.org/drawingml/2006/main">
               <a:ext uri="{FF2B5EF4-FFF2-40B4-BE49-F238E27FC236}">
-                <a16:creationId xmlns:a16="http://schemas.microsoft.com/office/drawing/2014/main" id="{4410A51F-1853-49A7-B287-D6D29EDD6639}"/>
+                <a16:creationId xmlns:a16="http://schemas.microsoft.com/office/drawing/2014/main" id="{20A8FC33-163D-490F-8D3C-7B880EADA1BB}"/>
               </a:ext>
             </a:extLst>
           </p:cNvPr>
@@ -12080,7 +12135,7 @@
           <p:cNvPr id="5" name="">
             <a:extLst xmlns:a="http://schemas.openxmlformats.org/drawingml/2006/main">
               <a:ext uri="{FF2B5EF4-FFF2-40B4-BE49-F238E27FC236}">
-                <a16:creationId xmlns:a16="http://schemas.microsoft.com/office/drawing/2014/main" id="{7F00A4D4-06FB-4B4E-98B9-20CA38C90704}"/>
+                <a16:creationId xmlns:a16="http://schemas.microsoft.com/office/drawing/2014/main" id="{A6CD318C-5F97-4B54-8669-8E55ABC67112}"/>
               </a:ext>
             </a:extLst>
           </p:cNvPr>
@@ -12142,7 +12197,7 @@
           <p:cNvPr id="6" name="">
             <a:extLst xmlns:a="http://schemas.openxmlformats.org/drawingml/2006/main">
               <a:ext uri="{FF2B5EF4-FFF2-40B4-BE49-F238E27FC236}">
-                <a16:creationId xmlns:a16="http://schemas.microsoft.com/office/drawing/2014/main" id="{055F94D3-8CEC-42F5-9AEA-D52AE56F25C4}"/>
+                <a16:creationId xmlns:a16="http://schemas.microsoft.com/office/drawing/2014/main" id="{247CFA0D-72E4-4F18-931D-237DCE51F2F0}"/>
               </a:ext>
             </a:extLst>
           </p:cNvPr>
@@ -12204,7 +12259,7 @@
           <p:cNvPr id="7" name="">
             <a:extLst xmlns:a="http://schemas.openxmlformats.org/drawingml/2006/main">
               <a:ext uri="{FF2B5EF4-FFF2-40B4-BE49-F238E27FC236}">
-                <a16:creationId xmlns:a16="http://schemas.microsoft.com/office/drawing/2014/main" id="{AEBC3589-81C0-4AE2-903E-9E366046FC2D}"/>
+                <a16:creationId xmlns:a16="http://schemas.microsoft.com/office/drawing/2014/main" id="{07FCBC81-0692-49A0-B2A4-886DBC3D54A0}"/>
               </a:ext>
             </a:extLst>
           </p:cNvPr>
@@ -12235,7 +12290,7 @@
           <p:cNvPr id="8" name="">
             <a:extLst xmlns:a="http://schemas.openxmlformats.org/drawingml/2006/main">
               <a:ext uri="{FF2B5EF4-FFF2-40B4-BE49-F238E27FC236}">
-                <a16:creationId xmlns:a16="http://schemas.microsoft.com/office/drawing/2014/main" id="{38625ADC-364D-41EB-8D15-C14D60CAC7EE}"/>
+                <a16:creationId xmlns:a16="http://schemas.microsoft.com/office/drawing/2014/main" id="{D62B4E05-6D03-49C2-B8A6-1567A94D8B58}"/>
               </a:ext>
             </a:extLst>
           </p:cNvPr>
@@ -12297,7 +12352,7 @@
           <p:cNvPr id="9" name="">
             <a:extLst xmlns:a="http://schemas.openxmlformats.org/drawingml/2006/main">
               <a:ext uri="{FF2B5EF4-FFF2-40B4-BE49-F238E27FC236}">
-                <a16:creationId xmlns:a16="http://schemas.microsoft.com/office/drawing/2014/main" id="{EC9DBF57-F6C6-4193-AA4C-0F609D543625}"/>
+                <a16:creationId xmlns:a16="http://schemas.microsoft.com/office/drawing/2014/main" id="{364FB094-2E02-47EC-B424-2844A4DAB836}"/>
               </a:ext>
             </a:extLst>
           </p:cNvPr>
@@ -12359,7 +12414,7 @@
           <p:cNvPr id="10" name="">
             <a:extLst xmlns:a="http://schemas.openxmlformats.org/drawingml/2006/main">
               <a:ext uri="{FF2B5EF4-FFF2-40B4-BE49-F238E27FC236}">
-                <a16:creationId xmlns:a16="http://schemas.microsoft.com/office/drawing/2014/main" id="{069FE736-6924-4EAF-BD97-22FF4BA8DC4D}"/>
+                <a16:creationId xmlns:a16="http://schemas.microsoft.com/office/drawing/2014/main" id="{300D9BF5-7575-4CC7-A3EF-50C04F190974}"/>
               </a:ext>
             </a:extLst>
           </p:cNvPr>
@@ -12421,7 +12476,7 @@
           <p:cNvPr id="11" name="">
             <a:extLst xmlns:a="http://schemas.openxmlformats.org/drawingml/2006/main">
               <a:ext uri="{FF2B5EF4-FFF2-40B4-BE49-F238E27FC236}">
-                <a16:creationId xmlns:a16="http://schemas.microsoft.com/office/drawing/2014/main" id="{2707CD9A-D6D7-47F4-85AE-9E9A9092B0AB}"/>
+                <a16:creationId xmlns:a16="http://schemas.microsoft.com/office/drawing/2014/main" id="{B2394D6B-1626-45C3-857B-E0C4DEA28E25}"/>
               </a:ext>
             </a:extLst>
           </p:cNvPr>
@@ -12452,7 +12507,7 @@
           <p:cNvPr id="12" name="">
             <a:extLst xmlns:a="http://schemas.openxmlformats.org/drawingml/2006/main">
               <a:ext uri="{FF2B5EF4-FFF2-40B4-BE49-F238E27FC236}">
-                <a16:creationId xmlns:a16="http://schemas.microsoft.com/office/drawing/2014/main" id="{9809FDE8-8130-46B4-93FD-39D594C4336D}"/>
+                <a16:creationId xmlns:a16="http://schemas.microsoft.com/office/drawing/2014/main" id="{E2173D45-BFFE-4164-84AA-1ACBE6A64C8D}"/>
               </a:ext>
             </a:extLst>
           </p:cNvPr>
@@ -12514,7 +12569,7 @@
           <p:cNvPr id="13" name="">
             <a:extLst xmlns:a="http://schemas.openxmlformats.org/drawingml/2006/main">
               <a:ext uri="{FF2B5EF4-FFF2-40B4-BE49-F238E27FC236}">
-                <a16:creationId xmlns:a16="http://schemas.microsoft.com/office/drawing/2014/main" id="{A830A8AB-99A8-45BE-A6F7-0F312D79CDF6}"/>
+                <a16:creationId xmlns:a16="http://schemas.microsoft.com/office/drawing/2014/main" id="{4E6EA503-6024-4413-81E5-02344565112D}"/>
               </a:ext>
             </a:extLst>
           </p:cNvPr>
@@ -12576,7 +12631,7 @@
           <p:cNvPr id="14" name="">
             <a:extLst xmlns:a="http://schemas.openxmlformats.org/drawingml/2006/main">
               <a:ext uri="{FF2B5EF4-FFF2-40B4-BE49-F238E27FC236}">
-                <a16:creationId xmlns:a16="http://schemas.microsoft.com/office/drawing/2014/main" id="{E1C32058-42C0-48FE-8C32-A00C4F7FE2DE}"/>
+                <a16:creationId xmlns:a16="http://schemas.microsoft.com/office/drawing/2014/main" id="{D57A9F9C-72FB-4A01-8100-45FC0EEC6F8C}"/>
               </a:ext>
             </a:extLst>
           </p:cNvPr>
@@ -12638,7 +12693,7 @@
           <p:cNvPr id="15" name="">
             <a:extLst xmlns:a="http://schemas.openxmlformats.org/drawingml/2006/main">
               <a:ext uri="{FF2B5EF4-FFF2-40B4-BE49-F238E27FC236}">
-                <a16:creationId xmlns:a16="http://schemas.microsoft.com/office/drawing/2014/main" id="{45FBFA27-BEB7-480B-8238-EABCB3CD3427}"/>
+                <a16:creationId xmlns:a16="http://schemas.microsoft.com/office/drawing/2014/main" id="{E65C7F8B-01E3-4AEA-908C-080A6350BE34}"/>
               </a:ext>
             </a:extLst>
           </p:cNvPr>
@@ -12669,7 +12724,7 @@
           <p:cNvPr id="16" name="">
             <a:extLst xmlns:a="http://schemas.openxmlformats.org/drawingml/2006/main">
               <a:ext uri="{FF2B5EF4-FFF2-40B4-BE49-F238E27FC236}">
-                <a16:creationId xmlns:a16="http://schemas.microsoft.com/office/drawing/2014/main" id="{39F2362B-F24B-4D98-BED5-B97B6498ABC2}"/>
+                <a16:creationId xmlns:a16="http://schemas.microsoft.com/office/drawing/2014/main" id="{6F9ACC67-395E-4741-A200-37A9DBE856FA}"/>
               </a:ext>
             </a:extLst>
           </p:cNvPr>
@@ -12731,7 +12786,7 @@
           <p:cNvPr id="17" name="">
             <a:extLst xmlns:a="http://schemas.openxmlformats.org/drawingml/2006/main">
               <a:ext uri="{FF2B5EF4-FFF2-40B4-BE49-F238E27FC236}">
-                <a16:creationId xmlns:a16="http://schemas.microsoft.com/office/drawing/2014/main" id="{B9EBD184-9FDD-44D8-86A3-F60E584C719B}"/>
+                <a16:creationId xmlns:a16="http://schemas.microsoft.com/office/drawing/2014/main" id="{0505064E-4153-40EA-B9CF-0BA10E4AA3D4}"/>
               </a:ext>
             </a:extLst>
           </p:cNvPr>
@@ -12793,7 +12848,7 @@
           <p:cNvPr id="18" name="">
             <a:extLst xmlns:a="http://schemas.openxmlformats.org/drawingml/2006/main">
               <a:ext uri="{FF2B5EF4-FFF2-40B4-BE49-F238E27FC236}">
-                <a16:creationId xmlns:a16="http://schemas.microsoft.com/office/drawing/2014/main" id="{3858DB52-48B9-4D58-BA07-E875A553C2AD}"/>
+                <a16:creationId xmlns:a16="http://schemas.microsoft.com/office/drawing/2014/main" id="{AE5731F3-25F0-4BB0-A04F-D72AEC72C39A}"/>
               </a:ext>
             </a:extLst>
           </p:cNvPr>
@@ -12855,7 +12910,7 @@
           <p:cNvPr id="19" name="">
             <a:extLst xmlns:a="http://schemas.openxmlformats.org/drawingml/2006/main">
               <a:ext uri="{FF2B5EF4-FFF2-40B4-BE49-F238E27FC236}">
-                <a16:creationId xmlns:a16="http://schemas.microsoft.com/office/drawing/2014/main" id="{DAEF58E4-F0D4-4E20-921D-37A0B82B9B02}"/>
+                <a16:creationId xmlns:a16="http://schemas.microsoft.com/office/drawing/2014/main" id="{BBE25F73-7AAE-4D1B-9AC4-5636B25DEEA8}"/>
               </a:ext>
             </a:extLst>
           </p:cNvPr>
@@ -12888,7 +12943,7 @@
           <p:cNvPr id="20" name="">
             <a:extLst xmlns:a="http://schemas.openxmlformats.org/drawingml/2006/main">
               <a:ext uri="{FF2B5EF4-FFF2-40B4-BE49-F238E27FC236}">
-                <a16:creationId xmlns:a16="http://schemas.microsoft.com/office/drawing/2014/main" id="{F0E87097-3FED-4386-A4E0-B82E0E28F160}"/>
+                <a16:creationId xmlns:a16="http://schemas.microsoft.com/office/drawing/2014/main" id="{803D69E9-05A6-4B26-814F-E4C1C5E2419C}"/>
               </a:ext>
             </a:extLst>
           </p:cNvPr>
@@ -12954,7 +13009,7 @@
           <p:nvPr/>
         </p:nvPicPr>
         <p:blipFill>
-          <a:blip xmlns:r="http://schemas.openxmlformats.org/officeDocument/2006/relationships" xmlns:a="http://schemas.openxmlformats.org/drawingml/2006/main" r:embed="R1658ba2a62a14b85"/>
+          <a:blip xmlns:r="http://schemas.openxmlformats.org/officeDocument/2006/relationships" xmlns:a="http://schemas.openxmlformats.org/drawingml/2006/main" r:embed="R88e609d9314d464b"/>
           <a:stretch xmlns:a="http://schemas.openxmlformats.org/drawingml/2006/main"/>
         </p:blipFill>
         <p:spPr>
@@ -12972,7 +13027,7 @@
           <p:cNvPr id="22" name="footer-rule-18">
             <a:extLst xmlns:a="http://schemas.openxmlformats.org/drawingml/2006/main">
               <a:ext uri="{FF2B5EF4-FFF2-40B4-BE49-F238E27FC236}">
-                <a16:creationId xmlns:a16="http://schemas.microsoft.com/office/drawing/2014/main" id="{31FB325F-6C72-45E2-99D6-78FB0F7CFDCA}"/>
+                <a16:creationId xmlns:a16="http://schemas.microsoft.com/office/drawing/2014/main" id="{B3D8DDDC-04CA-428A-89B6-0576677529BA}"/>
               </a:ext>
             </a:extLst>
           </p:cNvPr>
@@ -13003,7 +13058,7 @@
           <p:cNvPr id="23" name="footer-label-18">
             <a:extLst xmlns:a="http://schemas.openxmlformats.org/drawingml/2006/main">
               <a:ext uri="{FF2B5EF4-FFF2-40B4-BE49-F238E27FC236}">
-                <a16:creationId xmlns:a16="http://schemas.microsoft.com/office/drawing/2014/main" id="{4B3F1854-7D7E-411D-9616-594769F049EC}"/>
+                <a16:creationId xmlns:a16="http://schemas.microsoft.com/office/drawing/2014/main" id="{0CCD65DF-D858-43DF-97CD-7C4E1C193F15}"/>
               </a:ext>
             </a:extLst>
           </p:cNvPr>
@@ -13065,7 +13120,7 @@
           <p:cNvPr id="24" name="footer-page-18">
             <a:extLst xmlns:a="http://schemas.openxmlformats.org/drawingml/2006/main">
               <a:ext uri="{FF2B5EF4-FFF2-40B4-BE49-F238E27FC236}">
-                <a16:creationId xmlns:a16="http://schemas.microsoft.com/office/drawing/2014/main" id="{5BCF4E73-1735-4108-BCE8-31C0FE35B30B}"/>
+                <a16:creationId xmlns:a16="http://schemas.microsoft.com/office/drawing/2014/main" id="{C053B509-92B5-4DC2-BE6D-9A773DA5A4A0}"/>
               </a:ext>
             </a:extLst>
           </p:cNvPr>
@@ -13125,7 +13180,7 @@
     </p:spTree>
     <p:extLst>
       <p:ext uri="{BB962C8B-B14F-4D97-AF65-F5344CB8AC3E}">
-        <p14:creationId xmlns:p14="http://schemas.microsoft.com/office/powerpoint/2010/main" val="1140389926"/>
+        <p14:creationId xmlns:p14="http://schemas.microsoft.com/office/powerpoint/2010/main" val="897520443"/>
       </p:ext>
     </p:extLst>
   </p:cSld>
@@ -13156,7 +13211,7 @@
           <p:cNvPr id="20" name="side-accent-2">
             <a:extLst xmlns:a="http://schemas.openxmlformats.org/drawingml/2006/main">
               <a:ext uri="{FF2B5EF4-FFF2-40B4-BE49-F238E27FC236}">
-                <a16:creationId xmlns:a16="http://schemas.microsoft.com/office/drawing/2014/main" id="{69832A42-1576-4CF4-8830-89E4B3722902}"/>
+                <a16:creationId xmlns:a16="http://schemas.microsoft.com/office/drawing/2014/main" id="{EE8A3F75-B425-406A-B6A9-30A30EE235FE}"/>
               </a:ext>
             </a:extLst>
           </p:cNvPr>
@@ -13187,7 +13242,7 @@
           <p:cNvPr id="2" name="kicker-2">
             <a:extLst xmlns:a="http://schemas.openxmlformats.org/drawingml/2006/main">
               <a:ext uri="{FF2B5EF4-FFF2-40B4-BE49-F238E27FC236}">
-                <a16:creationId xmlns:a16="http://schemas.microsoft.com/office/drawing/2014/main" id="{DE1E720B-18B1-41D3-953B-C453114E0948}"/>
+                <a16:creationId xmlns:a16="http://schemas.microsoft.com/office/drawing/2014/main" id="{BDDDBBA2-59A2-4847-8A99-AEAA3AA12F0C}"/>
               </a:ext>
             </a:extLst>
           </p:cNvPr>
@@ -13249,7 +13304,7 @@
           <p:cNvPr id="3" name="title-2">
             <a:extLst xmlns:a="http://schemas.openxmlformats.org/drawingml/2006/main">
               <a:ext uri="{FF2B5EF4-FFF2-40B4-BE49-F238E27FC236}">
-                <a16:creationId xmlns:a16="http://schemas.microsoft.com/office/drawing/2014/main" id="{D88EFE35-E163-403B-8F27-5B5A9A406862}"/>
+                <a16:creationId xmlns:a16="http://schemas.microsoft.com/office/drawing/2014/main" id="{7593CAD0-66FB-4C18-9A19-80234E461F3F}"/>
               </a:ext>
             </a:extLst>
           </p:cNvPr>
@@ -13311,7 +13366,7 @@
           <p:cNvPr id="4" name="">
             <a:extLst xmlns:a="http://schemas.openxmlformats.org/drawingml/2006/main">
               <a:ext uri="{FF2B5EF4-FFF2-40B4-BE49-F238E27FC236}">
-                <a16:creationId xmlns:a16="http://schemas.microsoft.com/office/drawing/2014/main" id="{C958171D-E332-47BA-A936-5B8B3BB2AD2E}"/>
+                <a16:creationId xmlns:a16="http://schemas.microsoft.com/office/drawing/2014/main" id="{B9029C25-9C7E-460E-BCD0-AE5E01276E31}"/>
               </a:ext>
             </a:extLst>
           </p:cNvPr>
@@ -13373,7 +13428,7 @@
           <p:cNvPr id="5" name="">
             <a:extLst xmlns:a="http://schemas.openxmlformats.org/drawingml/2006/main">
               <a:ext uri="{FF2B5EF4-FFF2-40B4-BE49-F238E27FC236}">
-                <a16:creationId xmlns:a16="http://schemas.microsoft.com/office/drawing/2014/main" id="{0801F9C8-370E-4AA4-A9B9-1AC7B68B4CB6}"/>
+                <a16:creationId xmlns:a16="http://schemas.microsoft.com/office/drawing/2014/main" id="{C799D2F9-CA0E-4D40-9CEC-BF90B2B4DC92}"/>
               </a:ext>
             </a:extLst>
           </p:cNvPr>
@@ -13435,7 +13490,7 @@
           <p:cNvPr id="6" name="">
             <a:extLst xmlns:a="http://schemas.openxmlformats.org/drawingml/2006/main">
               <a:ext uri="{FF2B5EF4-FFF2-40B4-BE49-F238E27FC236}">
-                <a16:creationId xmlns:a16="http://schemas.microsoft.com/office/drawing/2014/main" id="{83288E8A-9A11-4ACE-924B-A028F59A4007}"/>
+                <a16:creationId xmlns:a16="http://schemas.microsoft.com/office/drawing/2014/main" id="{A731E552-EBF8-4D6E-A249-068B8BAA3B31}"/>
               </a:ext>
             </a:extLst>
           </p:cNvPr>
@@ -13466,7 +13521,7 @@
           <p:cNvPr id="7" name="">
             <a:extLst xmlns:a="http://schemas.openxmlformats.org/drawingml/2006/main">
               <a:ext uri="{FF2B5EF4-FFF2-40B4-BE49-F238E27FC236}">
-                <a16:creationId xmlns:a16="http://schemas.microsoft.com/office/drawing/2014/main" id="{82AA0F53-C5AA-4B04-A1D2-AB69D2DBC4A6}"/>
+                <a16:creationId xmlns:a16="http://schemas.microsoft.com/office/drawing/2014/main" id="{8031B009-2DD2-4C7B-979C-7E16FBE59324}"/>
               </a:ext>
             </a:extLst>
           </p:cNvPr>
@@ -13528,7 +13583,7 @@
           <p:cNvPr id="8" name="">
             <a:extLst xmlns:a="http://schemas.openxmlformats.org/drawingml/2006/main">
               <a:ext uri="{FF2B5EF4-FFF2-40B4-BE49-F238E27FC236}">
-                <a16:creationId xmlns:a16="http://schemas.microsoft.com/office/drawing/2014/main" id="{26CE0FC8-7421-4F85-978C-5ECECBA02DF0}"/>
+                <a16:creationId xmlns:a16="http://schemas.microsoft.com/office/drawing/2014/main" id="{E27C3D08-E09F-4B15-A1EE-38B6C2090D9B}"/>
               </a:ext>
             </a:extLst>
           </p:cNvPr>
@@ -13590,7 +13645,7 @@
           <p:cNvPr id="9" name="">
             <a:extLst xmlns:a="http://schemas.openxmlformats.org/drawingml/2006/main">
               <a:ext uri="{FF2B5EF4-FFF2-40B4-BE49-F238E27FC236}">
-                <a16:creationId xmlns:a16="http://schemas.microsoft.com/office/drawing/2014/main" id="{80FBFA47-EF61-4070-A37B-C0AFA027FBCD}"/>
+                <a16:creationId xmlns:a16="http://schemas.microsoft.com/office/drawing/2014/main" id="{0F075DAF-6F6A-4BAD-963B-0580D3923AE0}"/>
               </a:ext>
             </a:extLst>
           </p:cNvPr>
@@ -13621,7 +13676,7 @@
           <p:cNvPr id="10" name="">
             <a:extLst xmlns:a="http://schemas.openxmlformats.org/drawingml/2006/main">
               <a:ext uri="{FF2B5EF4-FFF2-40B4-BE49-F238E27FC236}">
-                <a16:creationId xmlns:a16="http://schemas.microsoft.com/office/drawing/2014/main" id="{6AF3F4F4-69F6-47AF-B5C0-1F5567063BA5}"/>
+                <a16:creationId xmlns:a16="http://schemas.microsoft.com/office/drawing/2014/main" id="{84B44EEA-65B8-4DC7-BCBB-2CA2813234E3}"/>
               </a:ext>
             </a:extLst>
           </p:cNvPr>
@@ -13683,7 +13738,7 @@
           <p:cNvPr id="11" name="">
             <a:extLst xmlns:a="http://schemas.openxmlformats.org/drawingml/2006/main">
               <a:ext uri="{FF2B5EF4-FFF2-40B4-BE49-F238E27FC236}">
-                <a16:creationId xmlns:a16="http://schemas.microsoft.com/office/drawing/2014/main" id="{AFC63D7B-3A39-431C-8E74-FAC0BBABB33E}"/>
+                <a16:creationId xmlns:a16="http://schemas.microsoft.com/office/drawing/2014/main" id="{2412198E-4478-4B75-8FD7-A9477A8488E7}"/>
               </a:ext>
             </a:extLst>
           </p:cNvPr>
@@ -13745,7 +13800,7 @@
           <p:cNvPr id="12" name="">
             <a:extLst xmlns:a="http://schemas.openxmlformats.org/drawingml/2006/main">
               <a:ext uri="{FF2B5EF4-FFF2-40B4-BE49-F238E27FC236}">
-                <a16:creationId xmlns:a16="http://schemas.microsoft.com/office/drawing/2014/main" id="{E52A1D06-DD9D-4C38-831E-BCB25A0717EB}"/>
+                <a16:creationId xmlns:a16="http://schemas.microsoft.com/office/drawing/2014/main" id="{0E71CEAE-6A1F-4800-AE16-CFB1F7B8EC0E}"/>
               </a:ext>
             </a:extLst>
           </p:cNvPr>
@@ -13776,7 +13831,7 @@
           <p:cNvPr id="13" name="">
             <a:extLst xmlns:a="http://schemas.openxmlformats.org/drawingml/2006/main">
               <a:ext uri="{FF2B5EF4-FFF2-40B4-BE49-F238E27FC236}">
-                <a16:creationId xmlns:a16="http://schemas.microsoft.com/office/drawing/2014/main" id="{F979027C-5270-4D53-8B59-074A6890526B}"/>
+                <a16:creationId xmlns:a16="http://schemas.microsoft.com/office/drawing/2014/main" id="{B5FD0107-3079-4A45-8FFC-1CCF52730E5C}"/>
               </a:ext>
             </a:extLst>
           </p:cNvPr>
@@ -13838,7 +13893,7 @@
           <p:cNvPr id="14" name="outcome-mark">
             <a:extLst xmlns:a="http://schemas.openxmlformats.org/drawingml/2006/main">
               <a:ext uri="{FF2B5EF4-FFF2-40B4-BE49-F238E27FC236}">
-                <a16:creationId xmlns:a16="http://schemas.microsoft.com/office/drawing/2014/main" id="{08DFD324-0EFF-4BFF-9867-37AD435EC0D6}"/>
+                <a16:creationId xmlns:a16="http://schemas.microsoft.com/office/drawing/2014/main" id="{02E8A56F-AFFB-424C-BEEE-FA97CABF241C}"/>
               </a:ext>
             </a:extLst>
           </p:cNvPr>
@@ -13873,7 +13928,7 @@
           <p:cNvPr id="15" name="">
             <a:extLst xmlns:a="http://schemas.openxmlformats.org/drawingml/2006/main">
               <a:ext uri="{FF2B5EF4-FFF2-40B4-BE49-F238E27FC236}">
-                <a16:creationId xmlns:a16="http://schemas.microsoft.com/office/drawing/2014/main" id="{B19635E9-EC8A-4F34-AC5D-649247B15DD6}"/>
+                <a16:creationId xmlns:a16="http://schemas.microsoft.com/office/drawing/2014/main" id="{88EAFD99-1FED-4657-B621-2D3E0D4BBB1A}"/>
               </a:ext>
             </a:extLst>
           </p:cNvPr>
@@ -13935,7 +13990,7 @@
           <p:cNvPr id="16" name="">
             <a:extLst xmlns:a="http://schemas.openxmlformats.org/drawingml/2006/main">
               <a:ext uri="{FF2B5EF4-FFF2-40B4-BE49-F238E27FC236}">
-                <a16:creationId xmlns:a16="http://schemas.microsoft.com/office/drawing/2014/main" id="{120231D1-76C0-412F-97A0-BB5DA05EA050}"/>
+                <a16:creationId xmlns:a16="http://schemas.microsoft.com/office/drawing/2014/main" id="{58169EAD-BD52-4E62-AAD7-99C290704F3F}"/>
               </a:ext>
             </a:extLst>
           </p:cNvPr>
@@ -14024,7 +14079,7 @@
           <p:cNvPr id="17" name="footer-rule-2">
             <a:extLst xmlns:a="http://schemas.openxmlformats.org/drawingml/2006/main">
               <a:ext uri="{FF2B5EF4-FFF2-40B4-BE49-F238E27FC236}">
-                <a16:creationId xmlns:a16="http://schemas.microsoft.com/office/drawing/2014/main" id="{08DC8ADB-8835-4BE9-BA51-3962D2FEE0F6}"/>
+                <a16:creationId xmlns:a16="http://schemas.microsoft.com/office/drawing/2014/main" id="{9DC6E4E1-5657-45A8-8A4C-CC2CD98AE1D8}"/>
               </a:ext>
             </a:extLst>
           </p:cNvPr>
@@ -14055,7 +14110,7 @@
           <p:cNvPr id="18" name="footer-label-2">
             <a:extLst xmlns:a="http://schemas.openxmlformats.org/drawingml/2006/main">
               <a:ext uri="{FF2B5EF4-FFF2-40B4-BE49-F238E27FC236}">
-                <a16:creationId xmlns:a16="http://schemas.microsoft.com/office/drawing/2014/main" id="{D4A20EB2-0337-4BB3-A192-A3B7AD3F39FB}"/>
+                <a16:creationId xmlns:a16="http://schemas.microsoft.com/office/drawing/2014/main" id="{FE0F0C69-BF5A-44BD-A8A9-782E06506D9C}"/>
               </a:ext>
             </a:extLst>
           </p:cNvPr>
@@ -14117,7 +14172,7 @@
           <p:cNvPr id="19" name="footer-page-2">
             <a:extLst xmlns:a="http://schemas.openxmlformats.org/drawingml/2006/main">
               <a:ext uri="{FF2B5EF4-FFF2-40B4-BE49-F238E27FC236}">
-                <a16:creationId xmlns:a16="http://schemas.microsoft.com/office/drawing/2014/main" id="{A48051B9-4BD5-471C-8D5C-2775CDA6FA0A}"/>
+                <a16:creationId xmlns:a16="http://schemas.microsoft.com/office/drawing/2014/main" id="{004075C1-C592-4AF7-8DE1-8A0FA9183507}"/>
               </a:ext>
             </a:extLst>
           </p:cNvPr>
@@ -14177,7 +14232,7 @@
     </p:spTree>
     <p:extLst>
       <p:ext uri="{BB962C8B-B14F-4D97-AF65-F5344CB8AC3E}">
-        <p14:creationId xmlns:p14="http://schemas.microsoft.com/office/powerpoint/2010/main" val="2142908979"/>
+        <p14:creationId xmlns:p14="http://schemas.microsoft.com/office/powerpoint/2010/main" val="1838097806"/>
       </p:ext>
     </p:extLst>
   </p:cSld>
@@ -14208,7 +14263,7 @@
           <p:cNvPr id="31" name="side-accent-3">
             <a:extLst xmlns:a="http://schemas.openxmlformats.org/drawingml/2006/main">
               <a:ext uri="{FF2B5EF4-FFF2-40B4-BE49-F238E27FC236}">
-                <a16:creationId xmlns:a16="http://schemas.microsoft.com/office/drawing/2014/main" id="{E319DFCC-41AF-4734-8793-C99BD37C48F4}"/>
+                <a16:creationId xmlns:a16="http://schemas.microsoft.com/office/drawing/2014/main" id="{F2E350E8-9B64-4BA8-8EE1-F66125DF7E96}"/>
               </a:ext>
             </a:extLst>
           </p:cNvPr>
@@ -14239,7 +14294,7 @@
           <p:cNvPr id="2" name="kicker-3">
             <a:extLst xmlns:a="http://schemas.openxmlformats.org/drawingml/2006/main">
               <a:ext uri="{FF2B5EF4-FFF2-40B4-BE49-F238E27FC236}">
-                <a16:creationId xmlns:a16="http://schemas.microsoft.com/office/drawing/2014/main" id="{9FA018E2-8405-47D9-8E8A-76F8B9EDD958}"/>
+                <a16:creationId xmlns:a16="http://schemas.microsoft.com/office/drawing/2014/main" id="{755AF7D8-07C1-4B94-B6E5-47C0B56E22C8}"/>
               </a:ext>
             </a:extLst>
           </p:cNvPr>
@@ -14301,7 +14356,7 @@
           <p:cNvPr id="3" name="title-3">
             <a:extLst xmlns:a="http://schemas.openxmlformats.org/drawingml/2006/main">
               <a:ext uri="{FF2B5EF4-FFF2-40B4-BE49-F238E27FC236}">
-                <a16:creationId xmlns:a16="http://schemas.microsoft.com/office/drawing/2014/main" id="{92A3D680-277B-4AC8-9500-7849C439F555}"/>
+                <a16:creationId xmlns:a16="http://schemas.microsoft.com/office/drawing/2014/main" id="{C7C896D8-C0FF-43C4-9C68-575DBE1605BD}"/>
               </a:ext>
             </a:extLst>
           </p:cNvPr>
@@ -14363,7 +14418,7 @@
           <p:cNvPr id="4" name="">
             <a:extLst xmlns:a="http://schemas.openxmlformats.org/drawingml/2006/main">
               <a:ext uri="{FF2B5EF4-FFF2-40B4-BE49-F238E27FC236}">
-                <a16:creationId xmlns:a16="http://schemas.microsoft.com/office/drawing/2014/main" id="{08B2F3D1-1FFD-47C0-BCA3-CDB233D02E69}"/>
+                <a16:creationId xmlns:a16="http://schemas.microsoft.com/office/drawing/2014/main" id="{500C65A0-3DE4-4DB8-84C1-D802003D6475}"/>
               </a:ext>
             </a:extLst>
           </p:cNvPr>
@@ -14425,7 +14480,7 @@
           <p:cNvPr id="5" name="system-function-line">
             <a:extLst xmlns:a="http://schemas.openxmlformats.org/drawingml/2006/main">
               <a:ext uri="{FF2B5EF4-FFF2-40B4-BE49-F238E27FC236}">
-                <a16:creationId xmlns:a16="http://schemas.microsoft.com/office/drawing/2014/main" id="{804C54B6-D464-4127-AE57-B7C3D17189F5}"/>
+                <a16:creationId xmlns:a16="http://schemas.microsoft.com/office/drawing/2014/main" id="{F45968E9-5875-4A22-AC07-205A5ACF7FED}"/>
               </a:ext>
             </a:extLst>
           </p:cNvPr>
@@ -14456,7 +14511,7 @@
           <p:cNvPr id="6" name="">
             <a:extLst xmlns:a="http://schemas.openxmlformats.org/drawingml/2006/main">
               <a:ext uri="{FF2B5EF4-FFF2-40B4-BE49-F238E27FC236}">
-                <a16:creationId xmlns:a16="http://schemas.microsoft.com/office/drawing/2014/main" id="{2B37D13C-D6C4-4538-AF82-450AB90E5227}"/>
+                <a16:creationId xmlns:a16="http://schemas.microsoft.com/office/drawing/2014/main" id="{A0E5350C-610C-4CF3-B7B2-497BFAEF7601}"/>
               </a:ext>
             </a:extLst>
           </p:cNvPr>
@@ -14487,7 +14542,7 @@
           <p:cNvPr id="7" name="">
             <a:extLst xmlns:a="http://schemas.openxmlformats.org/drawingml/2006/main">
               <a:ext uri="{FF2B5EF4-FFF2-40B4-BE49-F238E27FC236}">
-                <a16:creationId xmlns:a16="http://schemas.microsoft.com/office/drawing/2014/main" id="{53EB65E9-29DA-4236-BB8F-6A3300B9D617}"/>
+                <a16:creationId xmlns:a16="http://schemas.microsoft.com/office/drawing/2014/main" id="{2C358611-6D5F-4338-ABF2-23557F3C65D4}"/>
               </a:ext>
             </a:extLst>
           </p:cNvPr>
@@ -14549,7 +14604,7 @@
           <p:cNvPr id="8" name="">
             <a:extLst xmlns:a="http://schemas.openxmlformats.org/drawingml/2006/main">
               <a:ext uri="{FF2B5EF4-FFF2-40B4-BE49-F238E27FC236}">
-                <a16:creationId xmlns:a16="http://schemas.microsoft.com/office/drawing/2014/main" id="{73DB0EE7-311F-4BEE-8F0B-76E4FBB740B7}"/>
+                <a16:creationId xmlns:a16="http://schemas.microsoft.com/office/drawing/2014/main" id="{36044F85-BD7D-4592-986A-88B5C1508703}"/>
               </a:ext>
             </a:extLst>
           </p:cNvPr>
@@ -14611,7 +14666,7 @@
           <p:cNvPr id="9" name="">
             <a:extLst xmlns:a="http://schemas.openxmlformats.org/drawingml/2006/main">
               <a:ext uri="{FF2B5EF4-FFF2-40B4-BE49-F238E27FC236}">
-                <a16:creationId xmlns:a16="http://schemas.microsoft.com/office/drawing/2014/main" id="{A9CAEAF8-7FD1-49DA-9869-622C3C822DCB}"/>
+                <a16:creationId xmlns:a16="http://schemas.microsoft.com/office/drawing/2014/main" id="{B8C76204-D484-46D7-B0F3-532A14D56477}"/>
               </a:ext>
             </a:extLst>
           </p:cNvPr>
@@ -14673,7 +14728,7 @@
           <p:cNvPr id="10" name="">
             <a:extLst xmlns:a="http://schemas.openxmlformats.org/drawingml/2006/main">
               <a:ext uri="{FF2B5EF4-FFF2-40B4-BE49-F238E27FC236}">
-                <a16:creationId xmlns:a16="http://schemas.microsoft.com/office/drawing/2014/main" id="{FEDA7F7C-9FC7-4899-B164-00211CCB9276}"/>
+                <a16:creationId xmlns:a16="http://schemas.microsoft.com/office/drawing/2014/main" id="{C631E163-3942-4161-B3F8-E06C9BFE9A32}"/>
               </a:ext>
             </a:extLst>
           </p:cNvPr>
@@ -14704,7 +14759,7 @@
           <p:cNvPr id="11" name="">
             <a:extLst xmlns:a="http://schemas.openxmlformats.org/drawingml/2006/main">
               <a:ext uri="{FF2B5EF4-FFF2-40B4-BE49-F238E27FC236}">
-                <a16:creationId xmlns:a16="http://schemas.microsoft.com/office/drawing/2014/main" id="{3AE2870F-A93A-45AA-864A-74CFF848DB90}"/>
+                <a16:creationId xmlns:a16="http://schemas.microsoft.com/office/drawing/2014/main" id="{1AF38157-8A5E-4FF4-9786-FD8BEF09FA47}"/>
               </a:ext>
             </a:extLst>
           </p:cNvPr>
@@ -14766,7 +14821,7 @@
           <p:cNvPr id="12" name="">
             <a:extLst xmlns:a="http://schemas.openxmlformats.org/drawingml/2006/main">
               <a:ext uri="{FF2B5EF4-FFF2-40B4-BE49-F238E27FC236}">
-                <a16:creationId xmlns:a16="http://schemas.microsoft.com/office/drawing/2014/main" id="{501F94A4-96ED-4355-BB3F-43D84622DF1A}"/>
+                <a16:creationId xmlns:a16="http://schemas.microsoft.com/office/drawing/2014/main" id="{717FC8FA-1E74-4A46-970A-2BCA1CFD0D20}"/>
               </a:ext>
             </a:extLst>
           </p:cNvPr>
@@ -14828,7 +14883,7 @@
           <p:cNvPr id="13" name="">
             <a:extLst xmlns:a="http://schemas.openxmlformats.org/drawingml/2006/main">
               <a:ext uri="{FF2B5EF4-FFF2-40B4-BE49-F238E27FC236}">
-                <a16:creationId xmlns:a16="http://schemas.microsoft.com/office/drawing/2014/main" id="{A13004E6-BACC-4FB0-8BED-199058C92909}"/>
+                <a16:creationId xmlns:a16="http://schemas.microsoft.com/office/drawing/2014/main" id="{701FFD51-A058-4B9A-AB1A-1A75CD48BA91}"/>
               </a:ext>
             </a:extLst>
           </p:cNvPr>
@@ -14890,7 +14945,7 @@
           <p:cNvPr id="14" name="">
             <a:extLst xmlns:a="http://schemas.openxmlformats.org/drawingml/2006/main">
               <a:ext uri="{FF2B5EF4-FFF2-40B4-BE49-F238E27FC236}">
-                <a16:creationId xmlns:a16="http://schemas.microsoft.com/office/drawing/2014/main" id="{52E66C0C-98DC-4085-8775-81938AD06665}"/>
+                <a16:creationId xmlns:a16="http://schemas.microsoft.com/office/drawing/2014/main" id="{9B497B34-37EA-494E-B7E7-6CE077F62E45}"/>
               </a:ext>
             </a:extLst>
           </p:cNvPr>
@@ -14921,7 +14976,7 @@
           <p:cNvPr id="15" name="">
             <a:extLst xmlns:a="http://schemas.openxmlformats.org/drawingml/2006/main">
               <a:ext uri="{FF2B5EF4-FFF2-40B4-BE49-F238E27FC236}">
-                <a16:creationId xmlns:a16="http://schemas.microsoft.com/office/drawing/2014/main" id="{3123529F-F171-478D-94FD-E3316D481454}"/>
+                <a16:creationId xmlns:a16="http://schemas.microsoft.com/office/drawing/2014/main" id="{11FC374A-2C92-4777-90AF-5DDC10C8DA7E}"/>
               </a:ext>
             </a:extLst>
           </p:cNvPr>
@@ -14983,7 +15038,7 @@
           <p:cNvPr id="16" name="">
             <a:extLst xmlns:a="http://schemas.openxmlformats.org/drawingml/2006/main">
               <a:ext uri="{FF2B5EF4-FFF2-40B4-BE49-F238E27FC236}">
-                <a16:creationId xmlns:a16="http://schemas.microsoft.com/office/drawing/2014/main" id="{9A6FE34D-840F-4FB7-9E56-2BD6D444CBA9}"/>
+                <a16:creationId xmlns:a16="http://schemas.microsoft.com/office/drawing/2014/main" id="{E0A752C5-CE54-4415-98D2-AC8FAC459350}"/>
               </a:ext>
             </a:extLst>
           </p:cNvPr>
@@ -15045,7 +15100,7 @@
           <p:cNvPr id="17" name="">
             <a:extLst xmlns:a="http://schemas.openxmlformats.org/drawingml/2006/main">
               <a:ext uri="{FF2B5EF4-FFF2-40B4-BE49-F238E27FC236}">
-                <a16:creationId xmlns:a16="http://schemas.microsoft.com/office/drawing/2014/main" id="{3D54A52B-58E4-45EB-87EC-FFF8CCD7A22D}"/>
+                <a16:creationId xmlns:a16="http://schemas.microsoft.com/office/drawing/2014/main" id="{DF6D1A83-69D9-4FDF-AD36-3301E04693C0}"/>
               </a:ext>
             </a:extLst>
           </p:cNvPr>
@@ -15107,7 +15162,7 @@
           <p:cNvPr id="18" name="">
             <a:extLst xmlns:a="http://schemas.openxmlformats.org/drawingml/2006/main">
               <a:ext uri="{FF2B5EF4-FFF2-40B4-BE49-F238E27FC236}">
-                <a16:creationId xmlns:a16="http://schemas.microsoft.com/office/drawing/2014/main" id="{497E182B-145A-4694-BFE0-72C7A2C70F02}"/>
+                <a16:creationId xmlns:a16="http://schemas.microsoft.com/office/drawing/2014/main" id="{F953ADB7-262F-47AA-9812-D960A9E129E2}"/>
               </a:ext>
             </a:extLst>
           </p:cNvPr>
@@ -15138,7 +15193,7 @@
           <p:cNvPr id="19" name="">
             <a:extLst xmlns:a="http://schemas.openxmlformats.org/drawingml/2006/main">
               <a:ext uri="{FF2B5EF4-FFF2-40B4-BE49-F238E27FC236}">
-                <a16:creationId xmlns:a16="http://schemas.microsoft.com/office/drawing/2014/main" id="{8A4EE923-99F8-4674-A6D4-E6A9431763B4}"/>
+                <a16:creationId xmlns:a16="http://schemas.microsoft.com/office/drawing/2014/main" id="{8B538E05-922F-42B2-8AAF-019D98CC70DC}"/>
               </a:ext>
             </a:extLst>
           </p:cNvPr>
@@ -15200,7 +15255,7 @@
           <p:cNvPr id="20" name="">
             <a:extLst xmlns:a="http://schemas.openxmlformats.org/drawingml/2006/main">
               <a:ext uri="{FF2B5EF4-FFF2-40B4-BE49-F238E27FC236}">
-                <a16:creationId xmlns:a16="http://schemas.microsoft.com/office/drawing/2014/main" id="{CCC8B402-D913-4F58-93FD-8E065F356BE6}"/>
+                <a16:creationId xmlns:a16="http://schemas.microsoft.com/office/drawing/2014/main" id="{CA3AB3C8-95A7-4130-90D5-49F078DD56F9}"/>
               </a:ext>
             </a:extLst>
           </p:cNvPr>
@@ -15262,7 +15317,7 @@
           <p:cNvPr id="21" name="">
             <a:extLst xmlns:a="http://schemas.openxmlformats.org/drawingml/2006/main">
               <a:ext uri="{FF2B5EF4-FFF2-40B4-BE49-F238E27FC236}">
-                <a16:creationId xmlns:a16="http://schemas.microsoft.com/office/drawing/2014/main" id="{3A86D0D6-C4E6-49E8-842E-A041D15D7053}"/>
+                <a16:creationId xmlns:a16="http://schemas.microsoft.com/office/drawing/2014/main" id="{21722920-4CE9-4626-8B70-BA3659698E4D}"/>
               </a:ext>
             </a:extLst>
           </p:cNvPr>
@@ -15324,7 +15379,7 @@
           <p:cNvPr id="22" name="">
             <a:extLst xmlns:a="http://schemas.openxmlformats.org/drawingml/2006/main">
               <a:ext uri="{FF2B5EF4-FFF2-40B4-BE49-F238E27FC236}">
-                <a16:creationId xmlns:a16="http://schemas.microsoft.com/office/drawing/2014/main" id="{A274698B-5C8C-47AC-9F97-21850C12E053}"/>
+                <a16:creationId xmlns:a16="http://schemas.microsoft.com/office/drawing/2014/main" id="{D3759146-FA85-46C3-BFE5-F5D7E1E2EC55}"/>
               </a:ext>
             </a:extLst>
           </p:cNvPr>
@@ -15355,7 +15410,7 @@
           <p:cNvPr id="23" name="">
             <a:extLst xmlns:a="http://schemas.openxmlformats.org/drawingml/2006/main">
               <a:ext uri="{FF2B5EF4-FFF2-40B4-BE49-F238E27FC236}">
-                <a16:creationId xmlns:a16="http://schemas.microsoft.com/office/drawing/2014/main" id="{9211D4F2-D847-47B4-AD8B-C5BA955FF7BF}"/>
+                <a16:creationId xmlns:a16="http://schemas.microsoft.com/office/drawing/2014/main" id="{7C5F5DBB-ED5E-4842-8440-86E8E7EF44F3}"/>
               </a:ext>
             </a:extLst>
           </p:cNvPr>
@@ -15417,7 +15472,7 @@
           <p:cNvPr id="24" name="">
             <a:extLst xmlns:a="http://schemas.openxmlformats.org/drawingml/2006/main">
               <a:ext uri="{FF2B5EF4-FFF2-40B4-BE49-F238E27FC236}">
-                <a16:creationId xmlns:a16="http://schemas.microsoft.com/office/drawing/2014/main" id="{3C80EB5B-1B38-42BA-94DE-4D299198637F}"/>
+                <a16:creationId xmlns:a16="http://schemas.microsoft.com/office/drawing/2014/main" id="{7D35BF76-BCE7-4C04-952C-54115CEDC6BB}"/>
               </a:ext>
             </a:extLst>
           </p:cNvPr>
@@ -15479,7 +15534,7 @@
           <p:cNvPr id="25" name="">
             <a:extLst xmlns:a="http://schemas.openxmlformats.org/drawingml/2006/main">
               <a:ext uri="{FF2B5EF4-FFF2-40B4-BE49-F238E27FC236}">
-                <a16:creationId xmlns:a16="http://schemas.microsoft.com/office/drawing/2014/main" id="{4775F8D6-9820-49CF-BEB1-CEE887C7C5CE}"/>
+                <a16:creationId xmlns:a16="http://schemas.microsoft.com/office/drawing/2014/main" id="{C845F128-A7D1-4D32-B128-529857B80E6B}"/>
               </a:ext>
             </a:extLst>
           </p:cNvPr>
@@ -15541,7 +15596,7 @@
           <p:cNvPr id="26" name="">
             <a:extLst xmlns:a="http://schemas.openxmlformats.org/drawingml/2006/main">
               <a:ext uri="{FF2B5EF4-FFF2-40B4-BE49-F238E27FC236}">
-                <a16:creationId xmlns:a16="http://schemas.microsoft.com/office/drawing/2014/main" id="{4B912E60-0A82-4275-A654-D443D40938F7}"/>
+                <a16:creationId xmlns:a16="http://schemas.microsoft.com/office/drawing/2014/main" id="{D203165F-FFD6-4E64-83C2-CDECD946F402}"/>
               </a:ext>
             </a:extLst>
           </p:cNvPr>
@@ -15574,7 +15629,7 @@
           <p:cNvPr id="27" name="">
             <a:extLst xmlns:a="http://schemas.openxmlformats.org/drawingml/2006/main">
               <a:ext uri="{FF2B5EF4-FFF2-40B4-BE49-F238E27FC236}">
-                <a16:creationId xmlns:a16="http://schemas.microsoft.com/office/drawing/2014/main" id="{E7E52375-5B1C-4715-98FA-DC8A35D03C42}"/>
+                <a16:creationId xmlns:a16="http://schemas.microsoft.com/office/drawing/2014/main" id="{8AB96B50-978D-4B3D-9D2E-89B2573273E1}"/>
               </a:ext>
             </a:extLst>
           </p:cNvPr>
@@ -15636,7 +15691,7 @@
           <p:cNvPr id="28" name="footer-rule-3">
             <a:extLst xmlns:a="http://schemas.openxmlformats.org/drawingml/2006/main">
               <a:ext uri="{FF2B5EF4-FFF2-40B4-BE49-F238E27FC236}">
-                <a16:creationId xmlns:a16="http://schemas.microsoft.com/office/drawing/2014/main" id="{DEB47926-6FDF-4824-8D95-B838DAF9007E}"/>
+                <a16:creationId xmlns:a16="http://schemas.microsoft.com/office/drawing/2014/main" id="{15F456C0-CBD7-43C4-8075-074AA5A49D0B}"/>
               </a:ext>
             </a:extLst>
           </p:cNvPr>
@@ -15667,7 +15722,7 @@
           <p:cNvPr id="29" name="footer-label-3">
             <a:extLst xmlns:a="http://schemas.openxmlformats.org/drawingml/2006/main">
               <a:ext uri="{FF2B5EF4-FFF2-40B4-BE49-F238E27FC236}">
-                <a16:creationId xmlns:a16="http://schemas.microsoft.com/office/drawing/2014/main" id="{27306F08-C7C0-4257-8605-4A43CE0DFB87}"/>
+                <a16:creationId xmlns:a16="http://schemas.microsoft.com/office/drawing/2014/main" id="{00D6ADE4-2136-4044-9CF5-E266E14FD47D}"/>
               </a:ext>
             </a:extLst>
           </p:cNvPr>
@@ -15729,7 +15784,7 @@
           <p:cNvPr id="30" name="footer-page-3">
             <a:extLst xmlns:a="http://schemas.openxmlformats.org/drawingml/2006/main">
               <a:ext uri="{FF2B5EF4-FFF2-40B4-BE49-F238E27FC236}">
-                <a16:creationId xmlns:a16="http://schemas.microsoft.com/office/drawing/2014/main" id="{3CDAF321-AFF0-4412-B6FD-D9FBFE589415}"/>
+                <a16:creationId xmlns:a16="http://schemas.microsoft.com/office/drawing/2014/main" id="{20D260B9-E033-4037-9D16-02716B6349B4}"/>
               </a:ext>
             </a:extLst>
           </p:cNvPr>
@@ -15789,7 +15844,7 @@
     </p:spTree>
     <p:extLst>
       <p:ext uri="{BB962C8B-B14F-4D97-AF65-F5344CB8AC3E}">
-        <p14:creationId xmlns:p14="http://schemas.microsoft.com/office/powerpoint/2010/main" val="65232191"/>
+        <p14:creationId xmlns:p14="http://schemas.microsoft.com/office/powerpoint/2010/main" val="1816140772"/>
       </p:ext>
     </p:extLst>
   </p:cSld>
@@ -15820,7 +15875,7 @@
           <p:cNvPr id="28" name="side-accent-4">
             <a:extLst xmlns:a="http://schemas.openxmlformats.org/drawingml/2006/main">
               <a:ext uri="{FF2B5EF4-FFF2-40B4-BE49-F238E27FC236}">
-                <a16:creationId xmlns:a16="http://schemas.microsoft.com/office/drawing/2014/main" id="{D31499DD-2820-4848-8992-01D95EECFC92}"/>
+                <a16:creationId xmlns:a16="http://schemas.microsoft.com/office/drawing/2014/main" id="{AF00E0AF-FBC2-4F69-9A99-733C509CCA5F}"/>
               </a:ext>
             </a:extLst>
           </p:cNvPr>
@@ -15851,7 +15906,7 @@
           <p:cNvPr id="2" name="kicker-4">
             <a:extLst xmlns:a="http://schemas.openxmlformats.org/drawingml/2006/main">
               <a:ext uri="{FF2B5EF4-FFF2-40B4-BE49-F238E27FC236}">
-                <a16:creationId xmlns:a16="http://schemas.microsoft.com/office/drawing/2014/main" id="{7503136E-0878-4669-89A0-0B793E747227}"/>
+                <a16:creationId xmlns:a16="http://schemas.microsoft.com/office/drawing/2014/main" id="{78DF0453-3038-49C3-BF02-8C9E5BA50A4C}"/>
               </a:ext>
             </a:extLst>
           </p:cNvPr>
@@ -15913,7 +15968,7 @@
           <p:cNvPr id="3" name="title-4">
             <a:extLst xmlns:a="http://schemas.openxmlformats.org/drawingml/2006/main">
               <a:ext uri="{FF2B5EF4-FFF2-40B4-BE49-F238E27FC236}">
-                <a16:creationId xmlns:a16="http://schemas.microsoft.com/office/drawing/2014/main" id="{FB179923-5B99-44CA-BDE4-8E8FB59E6943}"/>
+                <a16:creationId xmlns:a16="http://schemas.microsoft.com/office/drawing/2014/main" id="{32C5FF77-525B-4F49-9BC1-D79AA6DB9AB8}"/>
               </a:ext>
             </a:extLst>
           </p:cNvPr>
@@ -15975,7 +16030,7 @@
           <p:cNvPr id="4" name="">
             <a:extLst xmlns:a="http://schemas.openxmlformats.org/drawingml/2006/main">
               <a:ext uri="{FF2B5EF4-FFF2-40B4-BE49-F238E27FC236}">
-                <a16:creationId xmlns:a16="http://schemas.microsoft.com/office/drawing/2014/main" id="{25DAD468-B67A-4BF9-B2B6-923181B359A2}"/>
+                <a16:creationId xmlns:a16="http://schemas.microsoft.com/office/drawing/2014/main" id="{899D9A1B-F8C3-4EA1-9A6D-BEFCF5F5AF86}"/>
               </a:ext>
             </a:extLst>
           </p:cNvPr>
@@ -16037,7 +16092,7 @@
           <p:cNvPr id="5" name="">
             <a:extLst xmlns:a="http://schemas.openxmlformats.org/drawingml/2006/main">
               <a:ext uri="{FF2B5EF4-FFF2-40B4-BE49-F238E27FC236}">
-                <a16:creationId xmlns:a16="http://schemas.microsoft.com/office/drawing/2014/main" id="{973CF169-4758-4B71-96BC-32D11B04595B}"/>
+                <a16:creationId xmlns:a16="http://schemas.microsoft.com/office/drawing/2014/main" id="{BDDC9ED7-6076-47BA-9098-4B9458F42436}"/>
               </a:ext>
             </a:extLst>
           </p:cNvPr>
@@ -16099,7 +16154,7 @@
           <p:cNvPr id="6" name="">
             <a:extLst xmlns:a="http://schemas.openxmlformats.org/drawingml/2006/main">
               <a:ext uri="{FF2B5EF4-FFF2-40B4-BE49-F238E27FC236}">
-                <a16:creationId xmlns:a16="http://schemas.microsoft.com/office/drawing/2014/main" id="{5CE8E667-EB23-4412-95F2-280CF4D598B5}"/>
+                <a16:creationId xmlns:a16="http://schemas.microsoft.com/office/drawing/2014/main" id="{20AB19FC-4557-42DA-8C7D-F753EE968637}"/>
               </a:ext>
             </a:extLst>
           </p:cNvPr>
@@ -16161,7 +16216,7 @@
           <p:cNvPr id="7" name="">
             <a:extLst xmlns:a="http://schemas.openxmlformats.org/drawingml/2006/main">
               <a:ext uri="{FF2B5EF4-FFF2-40B4-BE49-F238E27FC236}">
-                <a16:creationId xmlns:a16="http://schemas.microsoft.com/office/drawing/2014/main" id="{A5ACE70B-FF82-48F7-8F2D-E02A53D8A802}"/>
+                <a16:creationId xmlns:a16="http://schemas.microsoft.com/office/drawing/2014/main" id="{363FEF46-8F29-4A79-B97A-D76F73C04EA0}"/>
               </a:ext>
             </a:extLst>
           </p:cNvPr>
@@ -16192,7 +16247,7 @@
           <p:cNvPr id="8" name="">
             <a:extLst xmlns:a="http://schemas.openxmlformats.org/drawingml/2006/main">
               <a:ext uri="{FF2B5EF4-FFF2-40B4-BE49-F238E27FC236}">
-                <a16:creationId xmlns:a16="http://schemas.microsoft.com/office/drawing/2014/main" id="{B55F37DB-2B94-4C43-82A3-A15409023DE6}"/>
+                <a16:creationId xmlns:a16="http://schemas.microsoft.com/office/drawing/2014/main" id="{129E2460-47A7-4D80-B84A-9E0549B964B2}"/>
               </a:ext>
             </a:extLst>
           </p:cNvPr>
@@ -16254,7 +16309,7 @@
           <p:cNvPr id="9" name="">
             <a:extLst xmlns:a="http://schemas.openxmlformats.org/drawingml/2006/main">
               <a:ext uri="{FF2B5EF4-FFF2-40B4-BE49-F238E27FC236}">
-                <a16:creationId xmlns:a16="http://schemas.microsoft.com/office/drawing/2014/main" id="{69A7BA28-E7CC-49EE-8CB1-6911AE4C69D7}"/>
+                <a16:creationId xmlns:a16="http://schemas.microsoft.com/office/drawing/2014/main" id="{28003481-D8B8-4506-B823-290B386C8F2A}"/>
               </a:ext>
             </a:extLst>
           </p:cNvPr>
@@ -16316,7 +16371,7 @@
           <p:cNvPr id="10" name="">
             <a:extLst xmlns:a="http://schemas.openxmlformats.org/drawingml/2006/main">
               <a:ext uri="{FF2B5EF4-FFF2-40B4-BE49-F238E27FC236}">
-                <a16:creationId xmlns:a16="http://schemas.microsoft.com/office/drawing/2014/main" id="{435ACFD9-BBB5-406A-AA01-41077D1ABDC7}"/>
+                <a16:creationId xmlns:a16="http://schemas.microsoft.com/office/drawing/2014/main" id="{96925E68-834A-462A-98B2-9537792F18B1}"/>
               </a:ext>
             </a:extLst>
           </p:cNvPr>
@@ -16378,7 +16433,7 @@
           <p:cNvPr id="11" name="">
             <a:extLst xmlns:a="http://schemas.openxmlformats.org/drawingml/2006/main">
               <a:ext uri="{FF2B5EF4-FFF2-40B4-BE49-F238E27FC236}">
-                <a16:creationId xmlns:a16="http://schemas.microsoft.com/office/drawing/2014/main" id="{D7454B77-D71A-4443-A346-BED7D3E81331}"/>
+                <a16:creationId xmlns:a16="http://schemas.microsoft.com/office/drawing/2014/main" id="{8927808A-71D4-4199-B0EF-2976D0C96C51}"/>
               </a:ext>
             </a:extLst>
           </p:cNvPr>
@@ -16409,7 +16464,7 @@
           <p:cNvPr id="12" name="">
             <a:extLst xmlns:a="http://schemas.openxmlformats.org/drawingml/2006/main">
               <a:ext uri="{FF2B5EF4-FFF2-40B4-BE49-F238E27FC236}">
-                <a16:creationId xmlns:a16="http://schemas.microsoft.com/office/drawing/2014/main" id="{21A62FB8-5842-4836-B056-A9A3FFCB4BE6}"/>
+                <a16:creationId xmlns:a16="http://schemas.microsoft.com/office/drawing/2014/main" id="{D70DD5AB-5BB0-4AD3-8ABF-8E57D65F8E9A}"/>
               </a:ext>
             </a:extLst>
           </p:cNvPr>
@@ -16471,7 +16526,7 @@
           <p:cNvPr id="13" name="">
             <a:extLst xmlns:a="http://schemas.openxmlformats.org/drawingml/2006/main">
               <a:ext uri="{FF2B5EF4-FFF2-40B4-BE49-F238E27FC236}">
-                <a16:creationId xmlns:a16="http://schemas.microsoft.com/office/drawing/2014/main" id="{3A0781C9-43EE-4570-8F84-DC101AD5DA0D}"/>
+                <a16:creationId xmlns:a16="http://schemas.microsoft.com/office/drawing/2014/main" id="{5AF8B71A-1022-42A6-B677-953B41D0BE84}"/>
               </a:ext>
             </a:extLst>
           </p:cNvPr>
@@ -16533,7 +16588,7 @@
           <p:cNvPr id="14" name="">
             <a:extLst xmlns:a="http://schemas.openxmlformats.org/drawingml/2006/main">
               <a:ext uri="{FF2B5EF4-FFF2-40B4-BE49-F238E27FC236}">
-                <a16:creationId xmlns:a16="http://schemas.microsoft.com/office/drawing/2014/main" id="{8CD4B94A-1AB8-4FE3-AEC4-60C82FE96C4B}"/>
+                <a16:creationId xmlns:a16="http://schemas.microsoft.com/office/drawing/2014/main" id="{1D7E9109-24B9-4DFC-A484-34C83745D8CC}"/>
               </a:ext>
             </a:extLst>
           </p:cNvPr>
@@ -16595,7 +16650,7 @@
           <p:cNvPr id="15" name="">
             <a:extLst xmlns:a="http://schemas.openxmlformats.org/drawingml/2006/main">
               <a:ext uri="{FF2B5EF4-FFF2-40B4-BE49-F238E27FC236}">
-                <a16:creationId xmlns:a16="http://schemas.microsoft.com/office/drawing/2014/main" id="{C7A56E49-7B1D-4B10-A986-E4E0838D7ACF}"/>
+                <a16:creationId xmlns:a16="http://schemas.microsoft.com/office/drawing/2014/main" id="{DDE91CFD-BC97-4948-A56D-169855BFAF8B}"/>
               </a:ext>
             </a:extLst>
           </p:cNvPr>
@@ -16626,7 +16681,7 @@
           <p:cNvPr id="16" name="">
             <a:extLst xmlns:a="http://schemas.openxmlformats.org/drawingml/2006/main">
               <a:ext uri="{FF2B5EF4-FFF2-40B4-BE49-F238E27FC236}">
-                <a16:creationId xmlns:a16="http://schemas.microsoft.com/office/drawing/2014/main" id="{F9DC74C6-116A-48B5-8D09-0DD6A00A451A}"/>
+                <a16:creationId xmlns:a16="http://schemas.microsoft.com/office/drawing/2014/main" id="{DDB8EEFF-5CD6-49CF-A7BB-6D946724DA2C}"/>
               </a:ext>
             </a:extLst>
           </p:cNvPr>
@@ -16688,7 +16743,7 @@
           <p:cNvPr id="17" name="">
             <a:extLst xmlns:a="http://schemas.openxmlformats.org/drawingml/2006/main">
               <a:ext uri="{FF2B5EF4-FFF2-40B4-BE49-F238E27FC236}">
-                <a16:creationId xmlns:a16="http://schemas.microsoft.com/office/drawing/2014/main" id="{67B3EC37-4C7A-4F22-9FF2-162EA05C8E86}"/>
+                <a16:creationId xmlns:a16="http://schemas.microsoft.com/office/drawing/2014/main" id="{174C4C80-D6D6-4A38-8B67-8562BBB1F800}"/>
               </a:ext>
             </a:extLst>
           </p:cNvPr>
@@ -16750,7 +16805,7 @@
           <p:cNvPr id="18" name="">
             <a:extLst xmlns:a="http://schemas.openxmlformats.org/drawingml/2006/main">
               <a:ext uri="{FF2B5EF4-FFF2-40B4-BE49-F238E27FC236}">
-                <a16:creationId xmlns:a16="http://schemas.microsoft.com/office/drawing/2014/main" id="{6ABA3AEB-D964-4A94-AEFC-96D877123B38}"/>
+                <a16:creationId xmlns:a16="http://schemas.microsoft.com/office/drawing/2014/main" id="{E30698B3-9CBD-4183-BDC7-7AD872B76715}"/>
               </a:ext>
             </a:extLst>
           </p:cNvPr>
@@ -16812,7 +16867,7 @@
           <p:cNvPr id="19" name="">
             <a:extLst xmlns:a="http://schemas.openxmlformats.org/drawingml/2006/main">
               <a:ext uri="{FF2B5EF4-FFF2-40B4-BE49-F238E27FC236}">
-                <a16:creationId xmlns:a16="http://schemas.microsoft.com/office/drawing/2014/main" id="{1C1C1DBE-E338-4CBA-B874-A36E1ED2B341}"/>
+                <a16:creationId xmlns:a16="http://schemas.microsoft.com/office/drawing/2014/main" id="{3485E52B-38BD-4EBC-B257-76A13B6C84C7}"/>
               </a:ext>
             </a:extLst>
           </p:cNvPr>
@@ -16843,7 +16898,7 @@
           <p:cNvPr id="20" name="">
             <a:extLst xmlns:a="http://schemas.openxmlformats.org/drawingml/2006/main">
               <a:ext uri="{FF2B5EF4-FFF2-40B4-BE49-F238E27FC236}">
-                <a16:creationId xmlns:a16="http://schemas.microsoft.com/office/drawing/2014/main" id="{042A601B-F88B-475C-84F8-B6450FB232B6}"/>
+                <a16:creationId xmlns:a16="http://schemas.microsoft.com/office/drawing/2014/main" id="{ACA922A5-11DC-40FB-8057-E5EDDB19C276}"/>
               </a:ext>
             </a:extLst>
           </p:cNvPr>
@@ -16905,7 +16960,7 @@
           <p:cNvPr id="21" name="">
             <a:extLst xmlns:a="http://schemas.openxmlformats.org/drawingml/2006/main">
               <a:ext uri="{FF2B5EF4-FFF2-40B4-BE49-F238E27FC236}">
-                <a16:creationId xmlns:a16="http://schemas.microsoft.com/office/drawing/2014/main" id="{48B81871-8544-4032-A60E-E45D4A6092AF}"/>
+                <a16:creationId xmlns:a16="http://schemas.microsoft.com/office/drawing/2014/main" id="{E4D9214B-CC63-4CFA-806C-BC60CA6AC10C}"/>
               </a:ext>
             </a:extLst>
           </p:cNvPr>
@@ -16967,7 +17022,7 @@
           <p:cNvPr id="22" name="">
             <a:extLst xmlns:a="http://schemas.openxmlformats.org/drawingml/2006/main">
               <a:ext uri="{FF2B5EF4-FFF2-40B4-BE49-F238E27FC236}">
-                <a16:creationId xmlns:a16="http://schemas.microsoft.com/office/drawing/2014/main" id="{0D74FE08-7381-4145-88E7-8FAF82A686F0}"/>
+                <a16:creationId xmlns:a16="http://schemas.microsoft.com/office/drawing/2014/main" id="{D2F7E489-97D8-4F58-91B8-258AF833EAEF}"/>
               </a:ext>
             </a:extLst>
           </p:cNvPr>
@@ -17029,7 +17084,7 @@
           <p:cNvPr id="23" name="">
             <a:extLst xmlns:a="http://schemas.openxmlformats.org/drawingml/2006/main">
               <a:ext uri="{FF2B5EF4-FFF2-40B4-BE49-F238E27FC236}">
-                <a16:creationId xmlns:a16="http://schemas.microsoft.com/office/drawing/2014/main" id="{0E2DCD64-62C5-435D-8439-8D83AAB0685F}"/>
+                <a16:creationId xmlns:a16="http://schemas.microsoft.com/office/drawing/2014/main" id="{91F74158-B3CE-4F19-8A41-D58E73FF88C2}"/>
               </a:ext>
             </a:extLst>
           </p:cNvPr>
@@ -17062,7 +17117,7 @@
           <p:cNvPr id="24" name="">
             <a:extLst xmlns:a="http://schemas.openxmlformats.org/drawingml/2006/main">
               <a:ext uri="{FF2B5EF4-FFF2-40B4-BE49-F238E27FC236}">
-                <a16:creationId xmlns:a16="http://schemas.microsoft.com/office/drawing/2014/main" id="{A122A5F8-4E6F-4BF2-BBE8-1F95AAEA4111}"/>
+                <a16:creationId xmlns:a16="http://schemas.microsoft.com/office/drawing/2014/main" id="{A2C410E8-7D6E-4083-95C2-642F74996DBC}"/>
               </a:ext>
             </a:extLst>
           </p:cNvPr>
@@ -17124,7 +17179,7 @@
           <p:cNvPr id="25" name="footer-rule-4">
             <a:extLst xmlns:a="http://schemas.openxmlformats.org/drawingml/2006/main">
               <a:ext uri="{FF2B5EF4-FFF2-40B4-BE49-F238E27FC236}">
-                <a16:creationId xmlns:a16="http://schemas.microsoft.com/office/drawing/2014/main" id="{AB4ADCAC-FA43-4F39-9FB1-874D2541848F}"/>
+                <a16:creationId xmlns:a16="http://schemas.microsoft.com/office/drawing/2014/main" id="{207E606E-2AC2-4034-ADAA-22FDCFC39E62}"/>
               </a:ext>
             </a:extLst>
           </p:cNvPr>
@@ -17155,7 +17210,7 @@
           <p:cNvPr id="26" name="footer-label-4">
             <a:extLst xmlns:a="http://schemas.openxmlformats.org/drawingml/2006/main">
               <a:ext uri="{FF2B5EF4-FFF2-40B4-BE49-F238E27FC236}">
-                <a16:creationId xmlns:a16="http://schemas.microsoft.com/office/drawing/2014/main" id="{4CFE9F27-DE4A-491B-8044-6FBF9F131D28}"/>
+                <a16:creationId xmlns:a16="http://schemas.microsoft.com/office/drawing/2014/main" id="{2FECCB80-E59D-45C5-807B-DCE5E418176E}"/>
               </a:ext>
             </a:extLst>
           </p:cNvPr>
@@ -17217,7 +17272,7 @@
           <p:cNvPr id="27" name="footer-page-4">
             <a:extLst xmlns:a="http://schemas.openxmlformats.org/drawingml/2006/main">
               <a:ext uri="{FF2B5EF4-FFF2-40B4-BE49-F238E27FC236}">
-                <a16:creationId xmlns:a16="http://schemas.microsoft.com/office/drawing/2014/main" id="{EBDA8AF5-D1B8-48C1-AAEC-D474E48060F4}"/>
+                <a16:creationId xmlns:a16="http://schemas.microsoft.com/office/drawing/2014/main" id="{A5C80AAB-7796-4F65-9783-171AC64F9E72}"/>
               </a:ext>
             </a:extLst>
           </p:cNvPr>
@@ -17277,7 +17332,7 @@
     </p:spTree>
     <p:extLst>
       <p:ext uri="{BB962C8B-B14F-4D97-AF65-F5344CB8AC3E}">
-        <p14:creationId xmlns:p14="http://schemas.microsoft.com/office/powerpoint/2010/main" val="344074961"/>
+        <p14:creationId xmlns:p14="http://schemas.microsoft.com/office/powerpoint/2010/main" val="1056136829"/>
       </p:ext>
     </p:extLst>
   </p:cSld>
@@ -17308,7 +17363,7 @@
           <p:cNvPr id="31" name="side-accent-5">
             <a:extLst xmlns:a="http://schemas.openxmlformats.org/drawingml/2006/main">
               <a:ext uri="{FF2B5EF4-FFF2-40B4-BE49-F238E27FC236}">
-                <a16:creationId xmlns:a16="http://schemas.microsoft.com/office/drawing/2014/main" id="{9DDE14B9-D281-4FF2-9D75-20077D7717E2}"/>
+                <a16:creationId xmlns:a16="http://schemas.microsoft.com/office/drawing/2014/main" id="{A9F5310A-4A41-44D1-8484-0D01500E3813}"/>
               </a:ext>
             </a:extLst>
           </p:cNvPr>
@@ -17339,7 +17394,7 @@
           <p:cNvPr id="2" name="kicker-5">
             <a:extLst xmlns:a="http://schemas.openxmlformats.org/drawingml/2006/main">
               <a:ext uri="{FF2B5EF4-FFF2-40B4-BE49-F238E27FC236}">
-                <a16:creationId xmlns:a16="http://schemas.microsoft.com/office/drawing/2014/main" id="{4A0A9D09-93FB-43ED-8A7E-F0461BC57F55}"/>
+                <a16:creationId xmlns:a16="http://schemas.microsoft.com/office/drawing/2014/main" id="{AA0F3918-D138-46DA-8A6B-EE3FB657185A}"/>
               </a:ext>
             </a:extLst>
           </p:cNvPr>
@@ -17401,7 +17456,7 @@
           <p:cNvPr id="3" name="title-5">
             <a:extLst xmlns:a="http://schemas.openxmlformats.org/drawingml/2006/main">
               <a:ext uri="{FF2B5EF4-FFF2-40B4-BE49-F238E27FC236}">
-                <a16:creationId xmlns:a16="http://schemas.microsoft.com/office/drawing/2014/main" id="{98D73485-6FF7-458B-BC02-33C86409E5A2}"/>
+                <a16:creationId xmlns:a16="http://schemas.microsoft.com/office/drawing/2014/main" id="{2EA22B04-3AC6-46EE-A4B4-9217AB79EFF4}"/>
               </a:ext>
             </a:extLst>
           </p:cNvPr>
@@ -17463,7 +17518,7 @@
           <p:cNvPr id="4" name="">
             <a:extLst xmlns:a="http://schemas.openxmlformats.org/drawingml/2006/main">
               <a:ext uri="{FF2B5EF4-FFF2-40B4-BE49-F238E27FC236}">
-                <a16:creationId xmlns:a16="http://schemas.microsoft.com/office/drawing/2014/main" id="{C76BEB27-1824-4E8A-B188-94B8AC8E475E}"/>
+                <a16:creationId xmlns:a16="http://schemas.microsoft.com/office/drawing/2014/main" id="{AD3229A0-C3A6-43BB-9E92-67EDE55A727F}"/>
               </a:ext>
             </a:extLst>
           </p:cNvPr>
@@ -17525,7 +17580,7 @@
           <p:cNvPr id="5" name="workflow-line">
             <a:extLst xmlns:a="http://schemas.openxmlformats.org/drawingml/2006/main">
               <a:ext uri="{FF2B5EF4-FFF2-40B4-BE49-F238E27FC236}">
-                <a16:creationId xmlns:a16="http://schemas.microsoft.com/office/drawing/2014/main" id="{F2E5F51C-E061-4511-90FA-CAC6CF03C724}"/>
+                <a16:creationId xmlns:a16="http://schemas.microsoft.com/office/drawing/2014/main" id="{7750DC37-722F-4671-9ADB-D47E5886A031}"/>
               </a:ext>
             </a:extLst>
           </p:cNvPr>
@@ -17556,7 +17611,7 @@
           <p:cNvPr id="6" name="workflow-arrow">
             <a:extLst xmlns:a="http://schemas.openxmlformats.org/drawingml/2006/main">
               <a:ext uri="{FF2B5EF4-FFF2-40B4-BE49-F238E27FC236}">
-                <a16:creationId xmlns:a16="http://schemas.microsoft.com/office/drawing/2014/main" id="{2673BCD0-27E3-4379-B09F-19A86377428F}"/>
+                <a16:creationId xmlns:a16="http://schemas.microsoft.com/office/drawing/2014/main" id="{01D047B1-D31B-4D4E-8070-F9F058E3EA83}"/>
               </a:ext>
             </a:extLst>
           </p:cNvPr>
@@ -17587,7 +17642,7 @@
           <p:cNvPr id="7" name="">
             <a:extLst xmlns:a="http://schemas.openxmlformats.org/drawingml/2006/main">
               <a:ext uri="{FF2B5EF4-FFF2-40B4-BE49-F238E27FC236}">
-                <a16:creationId xmlns:a16="http://schemas.microsoft.com/office/drawing/2014/main" id="{F8F56DB3-9A8F-4852-8456-8D74D3C2CC35}"/>
+                <a16:creationId xmlns:a16="http://schemas.microsoft.com/office/drawing/2014/main" id="{B473B625-8F4D-4D9B-8026-FBD80B362A3A}"/>
               </a:ext>
             </a:extLst>
           </p:cNvPr>
@@ -17618,7 +17673,7 @@
           <p:cNvPr id="8" name="">
             <a:extLst xmlns:a="http://schemas.openxmlformats.org/drawingml/2006/main">
               <a:ext uri="{FF2B5EF4-FFF2-40B4-BE49-F238E27FC236}">
-                <a16:creationId xmlns:a16="http://schemas.microsoft.com/office/drawing/2014/main" id="{E087DB93-86DF-4817-AF08-2CA837BACE9D}"/>
+                <a16:creationId xmlns:a16="http://schemas.microsoft.com/office/drawing/2014/main" id="{A008B744-7BB4-4F4D-8FB2-5C0AE626EBC4}"/>
               </a:ext>
             </a:extLst>
           </p:cNvPr>
@@ -17680,7 +17735,7 @@
           <p:cNvPr id="9" name="">
             <a:extLst xmlns:a="http://schemas.openxmlformats.org/drawingml/2006/main">
               <a:ext uri="{FF2B5EF4-FFF2-40B4-BE49-F238E27FC236}">
-                <a16:creationId xmlns:a16="http://schemas.microsoft.com/office/drawing/2014/main" id="{81225C70-C4E7-40D0-8687-6D001D39F801}"/>
+                <a16:creationId xmlns:a16="http://schemas.microsoft.com/office/drawing/2014/main" id="{DD18DAF8-8379-4542-A4C9-B09F264D85C1}"/>
               </a:ext>
             </a:extLst>
           </p:cNvPr>
@@ -17742,7 +17797,7 @@
           <p:cNvPr id="10" name="">
             <a:extLst xmlns:a="http://schemas.openxmlformats.org/drawingml/2006/main">
               <a:ext uri="{FF2B5EF4-FFF2-40B4-BE49-F238E27FC236}">
-                <a16:creationId xmlns:a16="http://schemas.microsoft.com/office/drawing/2014/main" id="{7420ABA8-A94C-45FC-82B2-C5CD42B38D70}"/>
+                <a16:creationId xmlns:a16="http://schemas.microsoft.com/office/drawing/2014/main" id="{285A0C8F-7CB0-4843-A358-AE435B1E8D49}"/>
               </a:ext>
             </a:extLst>
           </p:cNvPr>
@@ -17804,7 +17859,7 @@
           <p:cNvPr id="11" name="">
             <a:extLst xmlns:a="http://schemas.openxmlformats.org/drawingml/2006/main">
               <a:ext uri="{FF2B5EF4-FFF2-40B4-BE49-F238E27FC236}">
-                <a16:creationId xmlns:a16="http://schemas.microsoft.com/office/drawing/2014/main" id="{1DCE798A-313D-4BC6-8B46-712C01A89E0B}"/>
+                <a16:creationId xmlns:a16="http://schemas.microsoft.com/office/drawing/2014/main" id="{38FC74A2-9CDC-4622-B98B-A96A10E990AD}"/>
               </a:ext>
             </a:extLst>
           </p:cNvPr>
@@ -17835,7 +17890,7 @@
           <p:cNvPr id="12" name="">
             <a:extLst xmlns:a="http://schemas.openxmlformats.org/drawingml/2006/main">
               <a:ext uri="{FF2B5EF4-FFF2-40B4-BE49-F238E27FC236}">
-                <a16:creationId xmlns:a16="http://schemas.microsoft.com/office/drawing/2014/main" id="{6BE569E1-C33A-4A53-A779-7E4754E02ACE}"/>
+                <a16:creationId xmlns:a16="http://schemas.microsoft.com/office/drawing/2014/main" id="{15049EBF-395A-44D9-92BC-384501460478}"/>
               </a:ext>
             </a:extLst>
           </p:cNvPr>
@@ -17897,7 +17952,7 @@
           <p:cNvPr id="13" name="">
             <a:extLst xmlns:a="http://schemas.openxmlformats.org/drawingml/2006/main">
               <a:ext uri="{FF2B5EF4-FFF2-40B4-BE49-F238E27FC236}">
-                <a16:creationId xmlns:a16="http://schemas.microsoft.com/office/drawing/2014/main" id="{97AC2260-9F7F-40B5-BC9B-CA6F132FADCA}"/>
+                <a16:creationId xmlns:a16="http://schemas.microsoft.com/office/drawing/2014/main" id="{5E649315-39F7-4BE0-8CEB-4A147F9EF820}"/>
               </a:ext>
             </a:extLst>
           </p:cNvPr>
@@ -17959,7 +18014,7 @@
           <p:cNvPr id="14" name="">
             <a:extLst xmlns:a="http://schemas.openxmlformats.org/drawingml/2006/main">
               <a:ext uri="{FF2B5EF4-FFF2-40B4-BE49-F238E27FC236}">
-                <a16:creationId xmlns:a16="http://schemas.microsoft.com/office/drawing/2014/main" id="{99DE9E7A-F496-4755-A065-8F67540771E9}"/>
+                <a16:creationId xmlns:a16="http://schemas.microsoft.com/office/drawing/2014/main" id="{1FF1F14C-0AF2-4E17-AC77-A58659535497}"/>
               </a:ext>
             </a:extLst>
           </p:cNvPr>
@@ -18021,7 +18076,7 @@
           <p:cNvPr id="15" name="">
             <a:extLst xmlns:a="http://schemas.openxmlformats.org/drawingml/2006/main">
               <a:ext uri="{FF2B5EF4-FFF2-40B4-BE49-F238E27FC236}">
-                <a16:creationId xmlns:a16="http://schemas.microsoft.com/office/drawing/2014/main" id="{ECEFFB12-4187-4602-80A8-3C2C520A8059}"/>
+                <a16:creationId xmlns:a16="http://schemas.microsoft.com/office/drawing/2014/main" id="{D5AEA397-4421-41DB-BBE1-35C5A4B2333F}"/>
               </a:ext>
             </a:extLst>
           </p:cNvPr>
@@ -18052,7 +18107,7 @@
           <p:cNvPr id="16" name="">
             <a:extLst xmlns:a="http://schemas.openxmlformats.org/drawingml/2006/main">
               <a:ext uri="{FF2B5EF4-FFF2-40B4-BE49-F238E27FC236}">
-                <a16:creationId xmlns:a16="http://schemas.microsoft.com/office/drawing/2014/main" id="{40298C63-E0BA-4F98-969F-6BE9EEC175AC}"/>
+                <a16:creationId xmlns:a16="http://schemas.microsoft.com/office/drawing/2014/main" id="{3AB5E57B-88AF-4FCC-AD7B-B683AE95D035}"/>
               </a:ext>
             </a:extLst>
           </p:cNvPr>
@@ -18114,7 +18169,7 @@
           <p:cNvPr id="17" name="">
             <a:extLst xmlns:a="http://schemas.openxmlformats.org/drawingml/2006/main">
               <a:ext uri="{FF2B5EF4-FFF2-40B4-BE49-F238E27FC236}">
-                <a16:creationId xmlns:a16="http://schemas.microsoft.com/office/drawing/2014/main" id="{16506EF0-75F4-408F-9BF1-10CCB644EF9A}"/>
+                <a16:creationId xmlns:a16="http://schemas.microsoft.com/office/drawing/2014/main" id="{0594A60D-6AAB-483E-9635-DEE547395701}"/>
               </a:ext>
             </a:extLst>
           </p:cNvPr>
@@ -18176,7 +18231,7 @@
           <p:cNvPr id="18" name="">
             <a:extLst xmlns:a="http://schemas.openxmlformats.org/drawingml/2006/main">
               <a:ext uri="{FF2B5EF4-FFF2-40B4-BE49-F238E27FC236}">
-                <a16:creationId xmlns:a16="http://schemas.microsoft.com/office/drawing/2014/main" id="{5DC65BFD-4D3B-4A0A-964E-D0642CB51AFC}"/>
+                <a16:creationId xmlns:a16="http://schemas.microsoft.com/office/drawing/2014/main" id="{4D8167A5-2D17-469B-910C-B74F4E8E34AC}"/>
               </a:ext>
             </a:extLst>
           </p:cNvPr>
@@ -18238,7 +18293,7 @@
           <p:cNvPr id="19" name="">
             <a:extLst xmlns:a="http://schemas.openxmlformats.org/drawingml/2006/main">
               <a:ext uri="{FF2B5EF4-FFF2-40B4-BE49-F238E27FC236}">
-                <a16:creationId xmlns:a16="http://schemas.microsoft.com/office/drawing/2014/main" id="{8A19E523-7CA6-4692-A3CC-F522C9978909}"/>
+                <a16:creationId xmlns:a16="http://schemas.microsoft.com/office/drawing/2014/main" id="{DA6B5DF9-FC93-4768-A2EA-E2805E68068A}"/>
               </a:ext>
             </a:extLst>
           </p:cNvPr>
@@ -18269,7 +18324,7 @@
           <p:cNvPr id="20" name="">
             <a:extLst xmlns:a="http://schemas.openxmlformats.org/drawingml/2006/main">
               <a:ext uri="{FF2B5EF4-FFF2-40B4-BE49-F238E27FC236}">
-                <a16:creationId xmlns:a16="http://schemas.microsoft.com/office/drawing/2014/main" id="{09DFDA7B-7CE5-4CC6-88EF-412C754B5DB5}"/>
+                <a16:creationId xmlns:a16="http://schemas.microsoft.com/office/drawing/2014/main" id="{A1523114-BBDF-4270-8E2F-5C84F820BD49}"/>
               </a:ext>
             </a:extLst>
           </p:cNvPr>
@@ -18331,7 +18386,7 @@
           <p:cNvPr id="21" name="">
             <a:extLst xmlns:a="http://schemas.openxmlformats.org/drawingml/2006/main">
               <a:ext uri="{FF2B5EF4-FFF2-40B4-BE49-F238E27FC236}">
-                <a16:creationId xmlns:a16="http://schemas.microsoft.com/office/drawing/2014/main" id="{59BE715C-E327-477F-93C5-90CCF4178E84}"/>
+                <a16:creationId xmlns:a16="http://schemas.microsoft.com/office/drawing/2014/main" id="{1583A780-89E2-4F43-A9C6-EAD94C7959E8}"/>
               </a:ext>
             </a:extLst>
           </p:cNvPr>
@@ -18393,7 +18448,7 @@
           <p:cNvPr id="22" name="">
             <a:extLst xmlns:a="http://schemas.openxmlformats.org/drawingml/2006/main">
               <a:ext uri="{FF2B5EF4-FFF2-40B4-BE49-F238E27FC236}">
-                <a16:creationId xmlns:a16="http://schemas.microsoft.com/office/drawing/2014/main" id="{E746DD18-D77F-43F2-816F-012854DE5A98}"/>
+                <a16:creationId xmlns:a16="http://schemas.microsoft.com/office/drawing/2014/main" id="{C93AD2AC-A501-4DAA-BAC5-9ADCF0D1CCEE}"/>
               </a:ext>
             </a:extLst>
           </p:cNvPr>
@@ -18455,7 +18510,7 @@
           <p:cNvPr id="23" name="">
             <a:extLst xmlns:a="http://schemas.openxmlformats.org/drawingml/2006/main">
               <a:ext uri="{FF2B5EF4-FFF2-40B4-BE49-F238E27FC236}">
-                <a16:creationId xmlns:a16="http://schemas.microsoft.com/office/drawing/2014/main" id="{7BB3F870-7E3E-4962-842B-DE41D130AE9F}"/>
+                <a16:creationId xmlns:a16="http://schemas.microsoft.com/office/drawing/2014/main" id="{BA83E373-C750-488B-B1B0-59A1759F2C02}"/>
               </a:ext>
             </a:extLst>
           </p:cNvPr>
@@ -18486,7 +18541,7 @@
           <p:cNvPr id="24" name="">
             <a:extLst xmlns:a="http://schemas.openxmlformats.org/drawingml/2006/main">
               <a:ext uri="{FF2B5EF4-FFF2-40B4-BE49-F238E27FC236}">
-                <a16:creationId xmlns:a16="http://schemas.microsoft.com/office/drawing/2014/main" id="{0A1BDCAB-499F-4DD9-A59D-CCA731807DDB}"/>
+                <a16:creationId xmlns:a16="http://schemas.microsoft.com/office/drawing/2014/main" id="{71323AFF-7926-4C56-A1E0-DBC91B48C375}"/>
               </a:ext>
             </a:extLst>
           </p:cNvPr>
@@ -18548,7 +18603,7 @@
           <p:cNvPr id="25" name="">
             <a:extLst xmlns:a="http://schemas.openxmlformats.org/drawingml/2006/main">
               <a:ext uri="{FF2B5EF4-FFF2-40B4-BE49-F238E27FC236}">
-                <a16:creationId xmlns:a16="http://schemas.microsoft.com/office/drawing/2014/main" id="{FAA304F5-4121-4573-AD05-9A6F50A3F3F9}"/>
+                <a16:creationId xmlns:a16="http://schemas.microsoft.com/office/drawing/2014/main" id="{1AAA7D33-0ACA-4609-8296-9B8051F4346F}"/>
               </a:ext>
             </a:extLst>
           </p:cNvPr>
@@ -18610,7 +18665,7 @@
           <p:cNvPr id="26" name="">
             <a:extLst xmlns:a="http://schemas.openxmlformats.org/drawingml/2006/main">
               <a:ext uri="{FF2B5EF4-FFF2-40B4-BE49-F238E27FC236}">
-                <a16:creationId xmlns:a16="http://schemas.microsoft.com/office/drawing/2014/main" id="{7B3FF5BB-B396-4CA1-BD24-C2E0DDA003A1}"/>
+                <a16:creationId xmlns:a16="http://schemas.microsoft.com/office/drawing/2014/main" id="{F7899C7A-AEEB-479F-87E8-BE49F3ED5963}"/>
               </a:ext>
             </a:extLst>
           </p:cNvPr>
@@ -18672,7 +18727,7 @@
           <p:cNvPr id="27" name="">
             <a:extLst xmlns:a="http://schemas.openxmlformats.org/drawingml/2006/main">
               <a:ext uri="{FF2B5EF4-FFF2-40B4-BE49-F238E27FC236}">
-                <a16:creationId xmlns:a16="http://schemas.microsoft.com/office/drawing/2014/main" id="{506DCA7E-3420-4283-890C-A58A58CBF9B0}"/>
+                <a16:creationId xmlns:a16="http://schemas.microsoft.com/office/drawing/2014/main" id="{D7B6407D-ABC3-4A3F-ACF3-BAF30258DAD5}"/>
               </a:ext>
             </a:extLst>
           </p:cNvPr>
@@ -18734,7 +18789,7 @@
           <p:cNvPr id="28" name="footer-rule-5">
             <a:extLst xmlns:a="http://schemas.openxmlformats.org/drawingml/2006/main">
               <a:ext uri="{FF2B5EF4-FFF2-40B4-BE49-F238E27FC236}">
-                <a16:creationId xmlns:a16="http://schemas.microsoft.com/office/drawing/2014/main" id="{FB5147A1-EFEE-487B-83C5-CC35337456BA}"/>
+                <a16:creationId xmlns:a16="http://schemas.microsoft.com/office/drawing/2014/main" id="{3BE14F22-552F-44ED-ACAE-C7B7DB877CC6}"/>
               </a:ext>
             </a:extLst>
           </p:cNvPr>
@@ -18765,7 +18820,7 @@
           <p:cNvPr id="29" name="footer-label-5">
             <a:extLst xmlns:a="http://schemas.openxmlformats.org/drawingml/2006/main">
               <a:ext uri="{FF2B5EF4-FFF2-40B4-BE49-F238E27FC236}">
-                <a16:creationId xmlns:a16="http://schemas.microsoft.com/office/drawing/2014/main" id="{F13ADDBC-8ACE-47C1-8A87-E204E86FFAE2}"/>
+                <a16:creationId xmlns:a16="http://schemas.microsoft.com/office/drawing/2014/main" id="{D6CBDD24-7FBE-4F4D-81F3-0E840F1894F6}"/>
               </a:ext>
             </a:extLst>
           </p:cNvPr>
@@ -18827,7 +18882,7 @@
           <p:cNvPr id="30" name="footer-page-5">
             <a:extLst xmlns:a="http://schemas.openxmlformats.org/drawingml/2006/main">
               <a:ext uri="{FF2B5EF4-FFF2-40B4-BE49-F238E27FC236}">
-                <a16:creationId xmlns:a16="http://schemas.microsoft.com/office/drawing/2014/main" id="{1F5E970C-E712-4236-BA4A-81DE0EE0B5E6}"/>
+                <a16:creationId xmlns:a16="http://schemas.microsoft.com/office/drawing/2014/main" id="{BF6D9F3A-B7FE-4F2E-933D-4D712A789451}"/>
               </a:ext>
             </a:extLst>
           </p:cNvPr>
@@ -18887,7 +18942,7 @@
     </p:spTree>
     <p:extLst>
       <p:ext uri="{BB962C8B-B14F-4D97-AF65-F5344CB8AC3E}">
-        <p14:creationId xmlns:p14="http://schemas.microsoft.com/office/powerpoint/2010/main" val="43301419"/>
+        <p14:creationId xmlns:p14="http://schemas.microsoft.com/office/powerpoint/2010/main" val="292594823"/>
       </p:ext>
     </p:extLst>
   </p:cSld>
@@ -18918,7 +18973,7 @@
           <p:cNvPr id="22" name="side-accent-6">
             <a:extLst xmlns:a="http://schemas.openxmlformats.org/drawingml/2006/main">
               <a:ext uri="{FF2B5EF4-FFF2-40B4-BE49-F238E27FC236}">
-                <a16:creationId xmlns:a16="http://schemas.microsoft.com/office/drawing/2014/main" id="{A2E1D8A2-1302-477F-991C-F0DE7A1B5BF1}"/>
+                <a16:creationId xmlns:a16="http://schemas.microsoft.com/office/drawing/2014/main" id="{08B82274-2676-4C98-B402-37841AAB08C8}"/>
               </a:ext>
             </a:extLst>
           </p:cNvPr>
@@ -18949,7 +19004,7 @@
           <p:cNvPr id="2" name="kicker-6">
             <a:extLst xmlns:a="http://schemas.openxmlformats.org/drawingml/2006/main">
               <a:ext uri="{FF2B5EF4-FFF2-40B4-BE49-F238E27FC236}">
-                <a16:creationId xmlns:a16="http://schemas.microsoft.com/office/drawing/2014/main" id="{9773BF82-FAC1-4AF4-858D-E4BC8862C9DE}"/>
+                <a16:creationId xmlns:a16="http://schemas.microsoft.com/office/drawing/2014/main" id="{089E19ED-5626-4940-A5F4-FBE749823386}"/>
               </a:ext>
             </a:extLst>
           </p:cNvPr>
@@ -19011,7 +19066,7 @@
           <p:cNvPr id="3" name="title-6">
             <a:extLst xmlns:a="http://schemas.openxmlformats.org/drawingml/2006/main">
               <a:ext uri="{FF2B5EF4-FFF2-40B4-BE49-F238E27FC236}">
-                <a16:creationId xmlns:a16="http://schemas.microsoft.com/office/drawing/2014/main" id="{D75D9114-BF69-47AB-B2D1-7038B6E30BB9}"/>
+                <a16:creationId xmlns:a16="http://schemas.microsoft.com/office/drawing/2014/main" id="{8DAC3248-F7EC-469D-8913-C862124661B2}"/>
               </a:ext>
             </a:extLst>
           </p:cNvPr>
@@ -19073,7 +19128,7 @@
           <p:cNvPr id="4" name="">
             <a:extLst xmlns:a="http://schemas.openxmlformats.org/drawingml/2006/main">
               <a:ext uri="{FF2B5EF4-FFF2-40B4-BE49-F238E27FC236}">
-                <a16:creationId xmlns:a16="http://schemas.microsoft.com/office/drawing/2014/main" id="{C703409B-5076-4B9F-95FB-01879CFD1DBD}"/>
+                <a16:creationId xmlns:a16="http://schemas.microsoft.com/office/drawing/2014/main" id="{A06C75AF-CE41-4467-AC81-DA35DD8A6DA1}"/>
               </a:ext>
             </a:extLst>
           </p:cNvPr>
@@ -19135,7 +19190,7 @@
           <p:cNvPr id="5" name="">
             <a:extLst xmlns:a="http://schemas.openxmlformats.org/drawingml/2006/main">
               <a:ext uri="{FF2B5EF4-FFF2-40B4-BE49-F238E27FC236}">
-                <a16:creationId xmlns:a16="http://schemas.microsoft.com/office/drawing/2014/main" id="{672E18BB-7074-496A-86ED-6B29E7026F1E}"/>
+                <a16:creationId xmlns:a16="http://schemas.microsoft.com/office/drawing/2014/main" id="{571C5118-7198-4FDE-AC82-7868C27DD014}"/>
               </a:ext>
             </a:extLst>
           </p:cNvPr>
@@ -19197,7 +19252,7 @@
           <p:cNvPr id="6" name="">
             <a:extLst xmlns:a="http://schemas.openxmlformats.org/drawingml/2006/main">
               <a:ext uri="{FF2B5EF4-FFF2-40B4-BE49-F238E27FC236}">
-                <a16:creationId xmlns:a16="http://schemas.microsoft.com/office/drawing/2014/main" id="{E89301DF-BC55-483E-B716-77B3C3E56B4B}"/>
+                <a16:creationId xmlns:a16="http://schemas.microsoft.com/office/drawing/2014/main" id="{59E574C0-6B58-4495-853B-E7156B940FD0}"/>
               </a:ext>
             </a:extLst>
           </p:cNvPr>
@@ -19259,7 +19314,7 @@
           <p:cNvPr id="7" name="">
             <a:extLst xmlns:a="http://schemas.openxmlformats.org/drawingml/2006/main">
               <a:ext uri="{FF2B5EF4-FFF2-40B4-BE49-F238E27FC236}">
-                <a16:creationId xmlns:a16="http://schemas.microsoft.com/office/drawing/2014/main" id="{BC191F82-6172-4D27-A067-FB04D6CD1FA3}"/>
+                <a16:creationId xmlns:a16="http://schemas.microsoft.com/office/drawing/2014/main" id="{B099F24B-4716-4749-A517-53861A7070B1}"/>
               </a:ext>
             </a:extLst>
           </p:cNvPr>
@@ -19290,7 +19345,7 @@
           <p:cNvPr id="8" name="">
             <a:extLst xmlns:a="http://schemas.openxmlformats.org/drawingml/2006/main">
               <a:ext uri="{FF2B5EF4-FFF2-40B4-BE49-F238E27FC236}">
-                <a16:creationId xmlns:a16="http://schemas.microsoft.com/office/drawing/2014/main" id="{E0CC3943-5459-4EF9-B322-E31C06E6A573}"/>
+                <a16:creationId xmlns:a16="http://schemas.microsoft.com/office/drawing/2014/main" id="{477CA12D-A076-4A68-8834-E30D9B6DDE92}"/>
               </a:ext>
             </a:extLst>
           </p:cNvPr>
@@ -19379,7 +19434,7 @@
           <p:cNvPr id="9" name="">
             <a:extLst xmlns:a="http://schemas.openxmlformats.org/drawingml/2006/main">
               <a:ext uri="{FF2B5EF4-FFF2-40B4-BE49-F238E27FC236}">
-                <a16:creationId xmlns:a16="http://schemas.microsoft.com/office/drawing/2014/main" id="{078BB010-12A0-4FF8-BDD7-328373073133}"/>
+                <a16:creationId xmlns:a16="http://schemas.microsoft.com/office/drawing/2014/main" id="{D5EA5B3E-7F09-4BEB-8BA1-0BDF7EA766CF}"/>
               </a:ext>
             </a:extLst>
           </p:cNvPr>
@@ -19441,7 +19496,7 @@
           <p:cNvPr id="10" name="">
             <a:extLst xmlns:a="http://schemas.openxmlformats.org/drawingml/2006/main">
               <a:ext uri="{FF2B5EF4-FFF2-40B4-BE49-F238E27FC236}">
-                <a16:creationId xmlns:a16="http://schemas.microsoft.com/office/drawing/2014/main" id="{C0637D30-069C-4310-B5F2-15659BCD7BE4}"/>
+                <a16:creationId xmlns:a16="http://schemas.microsoft.com/office/drawing/2014/main" id="{AD470F9B-1E16-418C-B37C-A4435EEA59A2}"/>
               </a:ext>
             </a:extLst>
           </p:cNvPr>
@@ -19503,7 +19558,7 @@
           <p:cNvPr id="11" name="">
             <a:extLst xmlns:a="http://schemas.openxmlformats.org/drawingml/2006/main">
               <a:ext uri="{FF2B5EF4-FFF2-40B4-BE49-F238E27FC236}">
-                <a16:creationId xmlns:a16="http://schemas.microsoft.com/office/drawing/2014/main" id="{C21C42E8-15A7-4D76-B036-C4DE1360B280}"/>
+                <a16:creationId xmlns:a16="http://schemas.microsoft.com/office/drawing/2014/main" id="{96BEE2C0-3CA9-43DF-807B-700EF31209F1}"/>
               </a:ext>
             </a:extLst>
           </p:cNvPr>
@@ -19534,7 +19589,7 @@
           <p:cNvPr id="12" name="">
             <a:extLst xmlns:a="http://schemas.openxmlformats.org/drawingml/2006/main">
               <a:ext uri="{FF2B5EF4-FFF2-40B4-BE49-F238E27FC236}">
-                <a16:creationId xmlns:a16="http://schemas.microsoft.com/office/drawing/2014/main" id="{577661BE-8C6D-4236-A54B-94F33865DE4F}"/>
+                <a16:creationId xmlns:a16="http://schemas.microsoft.com/office/drawing/2014/main" id="{847E2F48-8AF0-4959-81EC-DE11133E0751}"/>
               </a:ext>
             </a:extLst>
           </p:cNvPr>
@@ -19623,7 +19678,7 @@
           <p:cNvPr id="13" name="">
             <a:extLst xmlns:a="http://schemas.openxmlformats.org/drawingml/2006/main">
               <a:ext uri="{FF2B5EF4-FFF2-40B4-BE49-F238E27FC236}">
-                <a16:creationId xmlns:a16="http://schemas.microsoft.com/office/drawing/2014/main" id="{DF59CBE1-FB00-49F6-99E4-1609D87A6D10}"/>
+                <a16:creationId xmlns:a16="http://schemas.microsoft.com/office/drawing/2014/main" id="{4755F408-100C-4BB1-81C0-3404C61649D7}"/>
               </a:ext>
             </a:extLst>
           </p:cNvPr>
@@ -19685,7 +19740,7 @@
           <p:cNvPr id="14" name="">
             <a:extLst xmlns:a="http://schemas.openxmlformats.org/drawingml/2006/main">
               <a:ext uri="{FF2B5EF4-FFF2-40B4-BE49-F238E27FC236}">
-                <a16:creationId xmlns:a16="http://schemas.microsoft.com/office/drawing/2014/main" id="{121AB038-0B8D-48EE-8B3C-13DAADD4AC68}"/>
+                <a16:creationId xmlns:a16="http://schemas.microsoft.com/office/drawing/2014/main" id="{1325AC4E-5058-4844-87EE-F316CDAF3382}"/>
               </a:ext>
             </a:extLst>
           </p:cNvPr>
@@ -19747,7 +19802,7 @@
           <p:cNvPr id="15" name="">
             <a:extLst xmlns:a="http://schemas.openxmlformats.org/drawingml/2006/main">
               <a:ext uri="{FF2B5EF4-FFF2-40B4-BE49-F238E27FC236}">
-                <a16:creationId xmlns:a16="http://schemas.microsoft.com/office/drawing/2014/main" id="{FA47FFD3-4202-4EA0-916E-6AF5247E601B}"/>
+                <a16:creationId xmlns:a16="http://schemas.microsoft.com/office/drawing/2014/main" id="{3873A017-9A59-4588-9384-14A4FB16F4D1}"/>
               </a:ext>
             </a:extLst>
           </p:cNvPr>
@@ -19778,7 +19833,7 @@
           <p:cNvPr id="16" name="">
             <a:extLst xmlns:a="http://schemas.openxmlformats.org/drawingml/2006/main">
               <a:ext uri="{FF2B5EF4-FFF2-40B4-BE49-F238E27FC236}">
-                <a16:creationId xmlns:a16="http://schemas.microsoft.com/office/drawing/2014/main" id="{1A7EA295-6F61-4358-B1ED-1FA0C391FE8C}"/>
+                <a16:creationId xmlns:a16="http://schemas.microsoft.com/office/drawing/2014/main" id="{7C7FCDDD-D0FD-4AF4-B5AE-56E86F41669A}"/>
               </a:ext>
             </a:extLst>
           </p:cNvPr>
@@ -19867,7 +19922,7 @@
           <p:cNvPr id="17" name="">
             <a:extLst xmlns:a="http://schemas.openxmlformats.org/drawingml/2006/main">
               <a:ext uri="{FF2B5EF4-FFF2-40B4-BE49-F238E27FC236}">
-                <a16:creationId xmlns:a16="http://schemas.microsoft.com/office/drawing/2014/main" id="{89AF74DB-4C74-44C2-9F1B-E9399B6B4112}"/>
+                <a16:creationId xmlns:a16="http://schemas.microsoft.com/office/drawing/2014/main" id="{AB087133-F43E-4D05-AC6F-732CADEEE2A4}"/>
               </a:ext>
             </a:extLst>
           </p:cNvPr>
@@ -19900,7 +19955,7 @@
           <p:cNvPr id="18" name="">
             <a:extLst xmlns:a="http://schemas.openxmlformats.org/drawingml/2006/main">
               <a:ext uri="{FF2B5EF4-FFF2-40B4-BE49-F238E27FC236}">
-                <a16:creationId xmlns:a16="http://schemas.microsoft.com/office/drawing/2014/main" id="{82E5CCA7-31DC-43E0-9A77-E7EDB63633B7}"/>
+                <a16:creationId xmlns:a16="http://schemas.microsoft.com/office/drawing/2014/main" id="{E56E1ABF-EDC2-4B71-9C3B-401F47861C91}"/>
               </a:ext>
             </a:extLst>
           </p:cNvPr>
@@ -19989,7 +20044,7 @@
           <p:cNvPr id="19" name="footer-rule-6">
             <a:extLst xmlns:a="http://schemas.openxmlformats.org/drawingml/2006/main">
               <a:ext uri="{FF2B5EF4-FFF2-40B4-BE49-F238E27FC236}">
-                <a16:creationId xmlns:a16="http://schemas.microsoft.com/office/drawing/2014/main" id="{7296C25B-0226-474F-91C6-325FFB8DF6F4}"/>
+                <a16:creationId xmlns:a16="http://schemas.microsoft.com/office/drawing/2014/main" id="{F9AA92EA-9266-4868-B2FF-5CA1733C4AA7}"/>
               </a:ext>
             </a:extLst>
           </p:cNvPr>
@@ -20020,7 +20075,7 @@
           <p:cNvPr id="20" name="footer-label-6">
             <a:extLst xmlns:a="http://schemas.openxmlformats.org/drawingml/2006/main">
               <a:ext uri="{FF2B5EF4-FFF2-40B4-BE49-F238E27FC236}">
-                <a16:creationId xmlns:a16="http://schemas.microsoft.com/office/drawing/2014/main" id="{870230F6-D7C5-441A-B57B-7D6A9702FEFB}"/>
+                <a16:creationId xmlns:a16="http://schemas.microsoft.com/office/drawing/2014/main" id="{E14B8F3F-E8AA-48D0-9EB5-794A482B8CAB}"/>
               </a:ext>
             </a:extLst>
           </p:cNvPr>
@@ -20082,7 +20137,7 @@
           <p:cNvPr id="21" name="footer-page-6">
             <a:extLst xmlns:a="http://schemas.openxmlformats.org/drawingml/2006/main">
               <a:ext uri="{FF2B5EF4-FFF2-40B4-BE49-F238E27FC236}">
-                <a16:creationId xmlns:a16="http://schemas.microsoft.com/office/drawing/2014/main" id="{989B1DE4-63A0-4D29-A2EE-587B5B950794}"/>
+                <a16:creationId xmlns:a16="http://schemas.microsoft.com/office/drawing/2014/main" id="{0D0E7C3E-E62B-4ECB-9111-B6F8A63C5670}"/>
               </a:ext>
             </a:extLst>
           </p:cNvPr>
@@ -20142,7 +20197,7 @@
     </p:spTree>
     <p:extLst>
       <p:ext uri="{BB962C8B-B14F-4D97-AF65-F5344CB8AC3E}">
-        <p14:creationId xmlns:p14="http://schemas.microsoft.com/office/powerpoint/2010/main" val="969674079"/>
+        <p14:creationId xmlns:p14="http://schemas.microsoft.com/office/powerpoint/2010/main" val="580058649"/>
       </p:ext>
     </p:extLst>
   </p:cSld>
@@ -20173,7 +20228,7 @@
           <p:cNvPr id="28" name="side-accent-7">
             <a:extLst xmlns:a="http://schemas.openxmlformats.org/drawingml/2006/main">
               <a:ext uri="{FF2B5EF4-FFF2-40B4-BE49-F238E27FC236}">
-                <a16:creationId xmlns:a16="http://schemas.microsoft.com/office/drawing/2014/main" id="{74234F19-B694-41CF-B937-6D0E8E38C58E}"/>
+                <a16:creationId xmlns:a16="http://schemas.microsoft.com/office/drawing/2014/main" id="{743C3FDC-DA8F-499D-980B-F4668B081176}"/>
               </a:ext>
             </a:extLst>
           </p:cNvPr>
@@ -20204,7 +20259,7 @@
           <p:cNvPr id="2" name="kicker-7">
             <a:extLst xmlns:a="http://schemas.openxmlformats.org/drawingml/2006/main">
               <a:ext uri="{FF2B5EF4-FFF2-40B4-BE49-F238E27FC236}">
-                <a16:creationId xmlns:a16="http://schemas.microsoft.com/office/drawing/2014/main" id="{CD45F80E-EEA4-4879-B2A3-283862EC28F4}"/>
+                <a16:creationId xmlns:a16="http://schemas.microsoft.com/office/drawing/2014/main" id="{94B8A7CF-0657-416D-BB1D-466442A5CF1F}"/>
               </a:ext>
             </a:extLst>
           </p:cNvPr>
@@ -20266,7 +20321,7 @@
           <p:cNvPr id="3" name="title-7">
             <a:extLst xmlns:a="http://schemas.openxmlformats.org/drawingml/2006/main">
               <a:ext uri="{FF2B5EF4-FFF2-40B4-BE49-F238E27FC236}">
-                <a16:creationId xmlns:a16="http://schemas.microsoft.com/office/drawing/2014/main" id="{C155EF22-9374-42CA-8D17-CF4F6660BC89}"/>
+                <a16:creationId xmlns:a16="http://schemas.microsoft.com/office/drawing/2014/main" id="{716230D0-FE21-48A0-BA3C-84D47A29D8B9}"/>
               </a:ext>
             </a:extLst>
           </p:cNvPr>
@@ -20328,7 +20383,7 @@
           <p:cNvPr id="4" name="">
             <a:extLst xmlns:a="http://schemas.openxmlformats.org/drawingml/2006/main">
               <a:ext uri="{FF2B5EF4-FFF2-40B4-BE49-F238E27FC236}">
-                <a16:creationId xmlns:a16="http://schemas.microsoft.com/office/drawing/2014/main" id="{1647F25A-186A-4135-8AB3-BF137E53F493}"/>
+                <a16:creationId xmlns:a16="http://schemas.microsoft.com/office/drawing/2014/main" id="{1470CC01-FE85-4553-B035-D0D6AF2266A1}"/>
               </a:ext>
             </a:extLst>
           </p:cNvPr>
@@ -20390,7 +20445,7 @@
           <p:cNvPr id="5" name="">
             <a:extLst xmlns:a="http://schemas.openxmlformats.org/drawingml/2006/main">
               <a:ext uri="{FF2B5EF4-FFF2-40B4-BE49-F238E27FC236}">
-                <a16:creationId xmlns:a16="http://schemas.microsoft.com/office/drawing/2014/main" id="{7DBC8389-CE78-4DC0-BA8C-5FB86DEE7C92}"/>
+                <a16:creationId xmlns:a16="http://schemas.microsoft.com/office/drawing/2014/main" id="{F2D558EF-906C-4DC3-917C-1AED70A39419}"/>
               </a:ext>
             </a:extLst>
           </p:cNvPr>
@@ -20421,7 +20476,7 @@
           <p:cNvPr id="6" name="">
             <a:extLst xmlns:a="http://schemas.openxmlformats.org/drawingml/2006/main">
               <a:ext uri="{FF2B5EF4-FFF2-40B4-BE49-F238E27FC236}">
-                <a16:creationId xmlns:a16="http://schemas.microsoft.com/office/drawing/2014/main" id="{DEA0BB91-D6C0-455E-B086-D29DCDFC10E5}"/>
+                <a16:creationId xmlns:a16="http://schemas.microsoft.com/office/drawing/2014/main" id="{F1414EA3-590B-4B42-B6F3-C95BB3E45B9E}"/>
               </a:ext>
             </a:extLst>
           </p:cNvPr>
@@ -20483,7 +20538,7 @@
           <p:cNvPr id="7" name="">
             <a:extLst xmlns:a="http://schemas.openxmlformats.org/drawingml/2006/main">
               <a:ext uri="{FF2B5EF4-FFF2-40B4-BE49-F238E27FC236}">
-                <a16:creationId xmlns:a16="http://schemas.microsoft.com/office/drawing/2014/main" id="{133F7A98-D1D1-4313-95F6-95176DCAD1FB}"/>
+                <a16:creationId xmlns:a16="http://schemas.microsoft.com/office/drawing/2014/main" id="{77975472-9E56-4CD5-A95E-B6CC37F856D4}"/>
               </a:ext>
             </a:extLst>
           </p:cNvPr>
@@ -20545,7 +20600,7 @@
           <p:cNvPr id="8" name="">
             <a:extLst xmlns:a="http://schemas.openxmlformats.org/drawingml/2006/main">
               <a:ext uri="{FF2B5EF4-FFF2-40B4-BE49-F238E27FC236}">
-                <a16:creationId xmlns:a16="http://schemas.microsoft.com/office/drawing/2014/main" id="{B1738C6D-FCFD-44DF-8032-C1DF51356751}"/>
+                <a16:creationId xmlns:a16="http://schemas.microsoft.com/office/drawing/2014/main" id="{7C25A229-92B3-4E97-B3CD-6D7C321DBFF9}"/>
               </a:ext>
             </a:extLst>
           </p:cNvPr>
@@ -20607,7 +20662,7 @@
           <p:cNvPr id="9" name="">
             <a:extLst xmlns:a="http://schemas.openxmlformats.org/drawingml/2006/main">
               <a:ext uri="{FF2B5EF4-FFF2-40B4-BE49-F238E27FC236}">
-                <a16:creationId xmlns:a16="http://schemas.microsoft.com/office/drawing/2014/main" id="{8C26387D-551D-4766-BFFC-9502E79BD752}"/>
+                <a16:creationId xmlns:a16="http://schemas.microsoft.com/office/drawing/2014/main" id="{F81FA25A-E9D7-42E8-98F1-25326B192E53}"/>
               </a:ext>
             </a:extLst>
           </p:cNvPr>
@@ -20638,7 +20693,7 @@
           <p:cNvPr id="10" name="">
             <a:extLst xmlns:a="http://schemas.openxmlformats.org/drawingml/2006/main">
               <a:ext uri="{FF2B5EF4-FFF2-40B4-BE49-F238E27FC236}">
-                <a16:creationId xmlns:a16="http://schemas.microsoft.com/office/drawing/2014/main" id="{87BFF72E-F565-49FD-9147-A80DA1A50B7E}"/>
+                <a16:creationId xmlns:a16="http://schemas.microsoft.com/office/drawing/2014/main" id="{987F74DC-A21A-408F-9D8C-9F74DADC8769}"/>
               </a:ext>
             </a:extLst>
           </p:cNvPr>
@@ -20700,7 +20755,7 @@
           <p:cNvPr id="11" name="">
             <a:extLst xmlns:a="http://schemas.openxmlformats.org/drawingml/2006/main">
               <a:ext uri="{FF2B5EF4-FFF2-40B4-BE49-F238E27FC236}">
-                <a16:creationId xmlns:a16="http://schemas.microsoft.com/office/drawing/2014/main" id="{F9458316-5848-4DF8-8E65-B483660A1F97}"/>
+                <a16:creationId xmlns:a16="http://schemas.microsoft.com/office/drawing/2014/main" id="{72AEF54B-D9C6-4920-B71C-4F78409C9587}"/>
               </a:ext>
             </a:extLst>
           </p:cNvPr>
@@ -20762,7 +20817,7 @@
           <p:cNvPr id="12" name="">
             <a:extLst xmlns:a="http://schemas.openxmlformats.org/drawingml/2006/main">
               <a:ext uri="{FF2B5EF4-FFF2-40B4-BE49-F238E27FC236}">
-                <a16:creationId xmlns:a16="http://schemas.microsoft.com/office/drawing/2014/main" id="{579E13B6-7727-4D52-ACFF-DA75DD7C28E9}"/>
+                <a16:creationId xmlns:a16="http://schemas.microsoft.com/office/drawing/2014/main" id="{D0E5241A-65F1-4F3D-8FB9-4430B65C7583}"/>
               </a:ext>
             </a:extLst>
           </p:cNvPr>
@@ -20824,7 +20879,7 @@
           <p:cNvPr id="13" name="">
             <a:extLst xmlns:a="http://schemas.openxmlformats.org/drawingml/2006/main">
               <a:ext uri="{FF2B5EF4-FFF2-40B4-BE49-F238E27FC236}">
-                <a16:creationId xmlns:a16="http://schemas.microsoft.com/office/drawing/2014/main" id="{579D29E3-5C50-4406-AA3D-8A034B79CEF2}"/>
+                <a16:creationId xmlns:a16="http://schemas.microsoft.com/office/drawing/2014/main" id="{5D5FF8C5-129A-40B1-B3BC-4AFE1B830CAD}"/>
               </a:ext>
             </a:extLst>
           </p:cNvPr>
@@ -20855,7 +20910,7 @@
           <p:cNvPr id="14" name="">
             <a:extLst xmlns:a="http://schemas.openxmlformats.org/drawingml/2006/main">
               <a:ext uri="{FF2B5EF4-FFF2-40B4-BE49-F238E27FC236}">
-                <a16:creationId xmlns:a16="http://schemas.microsoft.com/office/drawing/2014/main" id="{AE20CF6C-D820-428C-B650-D9A3068EC8BF}"/>
+                <a16:creationId xmlns:a16="http://schemas.microsoft.com/office/drawing/2014/main" id="{5F2748DC-FFA9-432D-85A9-BF167F57C81A}"/>
               </a:ext>
             </a:extLst>
           </p:cNvPr>
@@ -20917,7 +20972,7 @@
           <p:cNvPr id="15" name="">
             <a:extLst xmlns:a="http://schemas.openxmlformats.org/drawingml/2006/main">
               <a:ext uri="{FF2B5EF4-FFF2-40B4-BE49-F238E27FC236}">
-                <a16:creationId xmlns:a16="http://schemas.microsoft.com/office/drawing/2014/main" id="{A82AA7D2-9014-414A-A593-360954E2D7DE}"/>
+                <a16:creationId xmlns:a16="http://schemas.microsoft.com/office/drawing/2014/main" id="{5780B206-ADE0-490C-B106-C5012789FC2B}"/>
               </a:ext>
             </a:extLst>
           </p:cNvPr>
@@ -20979,7 +21034,7 @@
           <p:cNvPr id="16" name="">
             <a:extLst xmlns:a="http://schemas.openxmlformats.org/drawingml/2006/main">
               <a:ext uri="{FF2B5EF4-FFF2-40B4-BE49-F238E27FC236}">
-                <a16:creationId xmlns:a16="http://schemas.microsoft.com/office/drawing/2014/main" id="{76292D17-1CB7-45F1-8665-84168F4B2947}"/>
+                <a16:creationId xmlns:a16="http://schemas.microsoft.com/office/drawing/2014/main" id="{9A264074-9089-4236-9DE0-3ADA50667B07}"/>
               </a:ext>
             </a:extLst>
           </p:cNvPr>
@@ -21041,7 +21096,7 @@
           <p:cNvPr id="17" name="dashboard-preview">
             <a:extLst xmlns:a="http://schemas.openxmlformats.org/drawingml/2006/main">
               <a:ext uri="{FF2B5EF4-FFF2-40B4-BE49-F238E27FC236}">
-                <a16:creationId xmlns:a16="http://schemas.microsoft.com/office/drawing/2014/main" id="{F74F5885-4EA7-4C50-8F06-B13EA59D4B3F}"/>
+                <a16:creationId xmlns:a16="http://schemas.microsoft.com/office/drawing/2014/main" id="{AE3C4AE4-75FD-4E1A-8C62-0967DF6919A1}"/>
               </a:ext>
             </a:extLst>
           </p:cNvPr>
@@ -21076,7 +21131,7 @@
           <p:cNvPr id="18" name="">
             <a:extLst xmlns:a="http://schemas.openxmlformats.org/drawingml/2006/main">
               <a:ext uri="{FF2B5EF4-FFF2-40B4-BE49-F238E27FC236}">
-                <a16:creationId xmlns:a16="http://schemas.microsoft.com/office/drawing/2014/main" id="{1505D54E-BE2E-48D8-9F24-0348FD276A60}"/>
+                <a16:creationId xmlns:a16="http://schemas.microsoft.com/office/drawing/2014/main" id="{1CF807D2-C72E-4865-A408-CBFDF3385A2B}"/>
               </a:ext>
             </a:extLst>
           </p:cNvPr>
@@ -21138,7 +21193,7 @@
           <p:cNvPr id="19" name="">
             <a:extLst xmlns:a="http://schemas.openxmlformats.org/drawingml/2006/main">
               <a:ext uri="{FF2B5EF4-FFF2-40B4-BE49-F238E27FC236}">
-                <a16:creationId xmlns:a16="http://schemas.microsoft.com/office/drawing/2014/main" id="{665AD0B9-3A49-44C0-A962-247D054E3CA0}"/>
+                <a16:creationId xmlns:a16="http://schemas.microsoft.com/office/drawing/2014/main" id="{067A7428-0EEE-4A98-8CAB-5E08BB2E13EB}"/>
               </a:ext>
             </a:extLst>
           </p:cNvPr>
@@ -21169,7 +21224,7 @@
           <p:cNvPr id="20" name="">
             <a:extLst xmlns:a="http://schemas.openxmlformats.org/drawingml/2006/main">
               <a:ext uri="{FF2B5EF4-FFF2-40B4-BE49-F238E27FC236}">
-                <a16:creationId xmlns:a16="http://schemas.microsoft.com/office/drawing/2014/main" id="{1B87F18B-6D0A-44B8-8F14-4FEBF94D66B7}"/>
+                <a16:creationId xmlns:a16="http://schemas.microsoft.com/office/drawing/2014/main" id="{586D340B-0DEC-46B0-BCB4-F3448F8B56E9}"/>
               </a:ext>
             </a:extLst>
           </p:cNvPr>
@@ -21231,7 +21286,7 @@
           <p:cNvPr id="21" name="">
             <a:extLst xmlns:a="http://schemas.openxmlformats.org/drawingml/2006/main">
               <a:ext uri="{FF2B5EF4-FFF2-40B4-BE49-F238E27FC236}">
-                <a16:creationId xmlns:a16="http://schemas.microsoft.com/office/drawing/2014/main" id="{ADE7A2C3-B41D-48DC-AFF0-60A4282698B9}"/>
+                <a16:creationId xmlns:a16="http://schemas.microsoft.com/office/drawing/2014/main" id="{6C9C8E0B-D410-46F6-B9D9-3EE431D3805A}"/>
               </a:ext>
             </a:extLst>
           </p:cNvPr>
@@ -21262,7 +21317,7 @@
           <p:cNvPr id="22" name="">
             <a:extLst xmlns:a="http://schemas.openxmlformats.org/drawingml/2006/main">
               <a:ext uri="{FF2B5EF4-FFF2-40B4-BE49-F238E27FC236}">
-                <a16:creationId xmlns:a16="http://schemas.microsoft.com/office/drawing/2014/main" id="{7159A110-1C47-452D-B6B6-E453C0E5EFC3}"/>
+                <a16:creationId xmlns:a16="http://schemas.microsoft.com/office/drawing/2014/main" id="{2101623E-CFA5-4ACB-8747-44B077166D6F}"/>
               </a:ext>
             </a:extLst>
           </p:cNvPr>
@@ -21293,7 +21348,7 @@
           <p:cNvPr id="23" name="">
             <a:extLst xmlns:a="http://schemas.openxmlformats.org/drawingml/2006/main">
               <a:ext uri="{FF2B5EF4-FFF2-40B4-BE49-F238E27FC236}">
-                <a16:creationId xmlns:a16="http://schemas.microsoft.com/office/drawing/2014/main" id="{74BDE1BD-9256-4AE1-9333-2FA1D0AA65C3}"/>
+                <a16:creationId xmlns:a16="http://schemas.microsoft.com/office/drawing/2014/main" id="{B8D18998-39B8-4C5F-8588-03EDACA3CCC7}"/>
               </a:ext>
             </a:extLst>
           </p:cNvPr>
@@ -21326,7 +21381,7 @@
           <p:cNvPr id="24" name="">
             <a:extLst xmlns:a="http://schemas.openxmlformats.org/drawingml/2006/main">
               <a:ext uri="{FF2B5EF4-FFF2-40B4-BE49-F238E27FC236}">
-                <a16:creationId xmlns:a16="http://schemas.microsoft.com/office/drawing/2014/main" id="{1E92EACC-17F4-4CAD-9B81-962DF261F6B1}"/>
+                <a16:creationId xmlns:a16="http://schemas.microsoft.com/office/drawing/2014/main" id="{2548911E-7F92-406A-AEB1-C351AE81F8DF}"/>
               </a:ext>
             </a:extLst>
           </p:cNvPr>
@@ -21388,7 +21443,7 @@
           <p:cNvPr id="25" name="footer-rule-7">
             <a:extLst xmlns:a="http://schemas.openxmlformats.org/drawingml/2006/main">
               <a:ext uri="{FF2B5EF4-FFF2-40B4-BE49-F238E27FC236}">
-                <a16:creationId xmlns:a16="http://schemas.microsoft.com/office/drawing/2014/main" id="{4438F1B3-9D5D-4540-B0A6-282FBEC722B0}"/>
+                <a16:creationId xmlns:a16="http://schemas.microsoft.com/office/drawing/2014/main" id="{47B9DDCB-A88D-4FD1-9264-3FEB38D6D2B8}"/>
               </a:ext>
             </a:extLst>
           </p:cNvPr>
@@ -21419,7 +21474,7 @@
           <p:cNvPr id="26" name="footer-label-7">
             <a:extLst xmlns:a="http://schemas.openxmlformats.org/drawingml/2006/main">
               <a:ext uri="{FF2B5EF4-FFF2-40B4-BE49-F238E27FC236}">
-                <a16:creationId xmlns:a16="http://schemas.microsoft.com/office/drawing/2014/main" id="{2DC48D4A-1B9E-4AC1-88CF-A223566B71FF}"/>
+                <a16:creationId xmlns:a16="http://schemas.microsoft.com/office/drawing/2014/main" id="{82651EA9-2095-47C5-A224-87B5952D87D6}"/>
               </a:ext>
             </a:extLst>
           </p:cNvPr>
@@ -21481,7 +21536,7 @@
           <p:cNvPr id="27" name="footer-page-7">
             <a:extLst xmlns:a="http://schemas.openxmlformats.org/drawingml/2006/main">
               <a:ext uri="{FF2B5EF4-FFF2-40B4-BE49-F238E27FC236}">
-                <a16:creationId xmlns:a16="http://schemas.microsoft.com/office/drawing/2014/main" id="{6DBF8A94-C5A1-46FB-89BC-F43F32FC6582}"/>
+                <a16:creationId xmlns:a16="http://schemas.microsoft.com/office/drawing/2014/main" id="{0ADCEE67-7A69-4C62-939D-BD396A0A8E3C}"/>
               </a:ext>
             </a:extLst>
           </p:cNvPr>
@@ -21541,7 +21596,7 @@
     </p:spTree>
     <p:extLst>
       <p:ext uri="{BB962C8B-B14F-4D97-AF65-F5344CB8AC3E}">
-        <p14:creationId xmlns:p14="http://schemas.microsoft.com/office/powerpoint/2010/main" val="633073213"/>
+        <p14:creationId xmlns:p14="http://schemas.microsoft.com/office/powerpoint/2010/main" val="1379327683"/>
       </p:ext>
     </p:extLst>
   </p:cSld>
@@ -21572,7 +21627,7 @@
           <p:cNvPr id="26" name="side-accent-8">
             <a:extLst xmlns:a="http://schemas.openxmlformats.org/drawingml/2006/main">
               <a:ext uri="{FF2B5EF4-FFF2-40B4-BE49-F238E27FC236}">
-                <a16:creationId xmlns:a16="http://schemas.microsoft.com/office/drawing/2014/main" id="{3DC39E9C-DBAF-4242-B812-E5909EC4C73D}"/>
+                <a16:creationId xmlns:a16="http://schemas.microsoft.com/office/drawing/2014/main" id="{6088CEB0-DFC9-476E-BD4C-2AE91B75EB36}"/>
               </a:ext>
             </a:extLst>
           </p:cNvPr>
@@ -21603,7 +21658,7 @@
           <p:cNvPr id="2" name="kicker-8">
             <a:extLst xmlns:a="http://schemas.openxmlformats.org/drawingml/2006/main">
               <a:ext uri="{FF2B5EF4-FFF2-40B4-BE49-F238E27FC236}">
-                <a16:creationId xmlns:a16="http://schemas.microsoft.com/office/drawing/2014/main" id="{22C99369-C27D-4777-A16C-62FEEE25C1F8}"/>
+                <a16:creationId xmlns:a16="http://schemas.microsoft.com/office/drawing/2014/main" id="{097605F7-AE51-4C5A-90BB-7DE68BF9B306}"/>
               </a:ext>
             </a:extLst>
           </p:cNvPr>
@@ -21665,7 +21720,7 @@
           <p:cNvPr id="3" name="title-8">
             <a:extLst xmlns:a="http://schemas.openxmlformats.org/drawingml/2006/main">
               <a:ext uri="{FF2B5EF4-FFF2-40B4-BE49-F238E27FC236}">
-                <a16:creationId xmlns:a16="http://schemas.microsoft.com/office/drawing/2014/main" id="{7AED49B5-9E8D-4231-9740-B13B45BA75DB}"/>
+                <a16:creationId xmlns:a16="http://schemas.microsoft.com/office/drawing/2014/main" id="{8EA7359A-4DFF-4D75-ADC0-E9505C0C0493}"/>
               </a:ext>
             </a:extLst>
           </p:cNvPr>
@@ -21727,7 +21782,7 @@
           <p:cNvPr id="4" name="">
             <a:extLst xmlns:a="http://schemas.openxmlformats.org/drawingml/2006/main">
               <a:ext uri="{FF2B5EF4-FFF2-40B4-BE49-F238E27FC236}">
-                <a16:creationId xmlns:a16="http://schemas.microsoft.com/office/drawing/2014/main" id="{C3719E43-211E-4C35-9C30-CFFDB0E62AA3}"/>
+                <a16:creationId xmlns:a16="http://schemas.microsoft.com/office/drawing/2014/main" id="{B66E1CBF-1CC0-47BF-8098-7A637AA7F98F}"/>
               </a:ext>
             </a:extLst>
           </p:cNvPr>
@@ -21789,7 +21844,7 @@
           <p:cNvPr id="5" name="">
             <a:extLst xmlns:a="http://schemas.openxmlformats.org/drawingml/2006/main">
               <a:ext uri="{FF2B5EF4-FFF2-40B4-BE49-F238E27FC236}">
-                <a16:creationId xmlns:a16="http://schemas.microsoft.com/office/drawing/2014/main" id="{4F4E0251-74E3-4475-80C9-4233906E670E}"/>
+                <a16:creationId xmlns:a16="http://schemas.microsoft.com/office/drawing/2014/main" id="{54985F4A-C957-45CF-80F3-0AC5B106EA19}"/>
               </a:ext>
             </a:extLst>
           </p:cNvPr>
@@ -21820,7 +21875,7 @@
           <p:cNvPr id="6" name="">
             <a:extLst xmlns:a="http://schemas.openxmlformats.org/drawingml/2006/main">
               <a:ext uri="{FF2B5EF4-FFF2-40B4-BE49-F238E27FC236}">
-                <a16:creationId xmlns:a16="http://schemas.microsoft.com/office/drawing/2014/main" id="{E2893843-ECE6-466D-92CC-13EA84DDC923}"/>
+                <a16:creationId xmlns:a16="http://schemas.microsoft.com/office/drawing/2014/main" id="{28FF82B7-4FAD-4D94-B281-D3CA923B59E8}"/>
               </a:ext>
             </a:extLst>
           </p:cNvPr>
@@ -21851,7 +21906,7 @@
           <p:cNvPr id="7" name="">
             <a:extLst xmlns:a="http://schemas.openxmlformats.org/drawingml/2006/main">
               <a:ext uri="{FF2B5EF4-FFF2-40B4-BE49-F238E27FC236}">
-                <a16:creationId xmlns:a16="http://schemas.microsoft.com/office/drawing/2014/main" id="{A60B7BE2-D2D8-4149-A7D2-B7D317C52ACE}"/>
+                <a16:creationId xmlns:a16="http://schemas.microsoft.com/office/drawing/2014/main" id="{33F79624-9434-4BA4-9A2F-D0E0415DB4EE}"/>
               </a:ext>
             </a:extLst>
           </p:cNvPr>
@@ -21913,7 +21968,7 @@
           <p:cNvPr id="8" name="">
             <a:extLst xmlns:a="http://schemas.openxmlformats.org/drawingml/2006/main">
               <a:ext uri="{FF2B5EF4-FFF2-40B4-BE49-F238E27FC236}">
-                <a16:creationId xmlns:a16="http://schemas.microsoft.com/office/drawing/2014/main" id="{D1511AA5-6019-45E6-9EC0-FA0584D933AB}"/>
+                <a16:creationId xmlns:a16="http://schemas.microsoft.com/office/drawing/2014/main" id="{B228E3A6-2108-4F58-B71B-6538EC559241}"/>
               </a:ext>
             </a:extLst>
           </p:cNvPr>
@@ -21975,7 +22030,7 @@
           <p:cNvPr id="9" name="">
             <a:extLst xmlns:a="http://schemas.openxmlformats.org/drawingml/2006/main">
               <a:ext uri="{FF2B5EF4-FFF2-40B4-BE49-F238E27FC236}">
-                <a16:creationId xmlns:a16="http://schemas.microsoft.com/office/drawing/2014/main" id="{F5000F7F-56AF-4BD2-B2A2-7DF46746F8E2}"/>
+                <a16:creationId xmlns:a16="http://schemas.microsoft.com/office/drawing/2014/main" id="{649B24AB-EF61-42C5-A170-022FADCB6F9A}"/>
               </a:ext>
             </a:extLst>
           </p:cNvPr>
@@ -22037,7 +22092,7 @@
           <p:cNvPr id="10" name="">
             <a:extLst xmlns:a="http://schemas.openxmlformats.org/drawingml/2006/main">
               <a:ext uri="{FF2B5EF4-FFF2-40B4-BE49-F238E27FC236}">
-                <a16:creationId xmlns:a16="http://schemas.microsoft.com/office/drawing/2014/main" id="{B7FA89B8-649A-470E-ADD7-E626CB3C8BE7}"/>
+                <a16:creationId xmlns:a16="http://schemas.microsoft.com/office/drawing/2014/main" id="{EB48BE4F-D324-48A9-B2EA-5E5B2B134D98}"/>
               </a:ext>
             </a:extLst>
           </p:cNvPr>
@@ -22068,7 +22123,7 @@
           <p:cNvPr id="11" name="">
             <a:extLst xmlns:a="http://schemas.openxmlformats.org/drawingml/2006/main">
               <a:ext uri="{FF2B5EF4-FFF2-40B4-BE49-F238E27FC236}">
-                <a16:creationId xmlns:a16="http://schemas.microsoft.com/office/drawing/2014/main" id="{7FB9B9EE-52E8-4365-8E0C-0BB354CD0375}"/>
+                <a16:creationId xmlns:a16="http://schemas.microsoft.com/office/drawing/2014/main" id="{C4601E7F-A568-4941-9627-DE1DA21F7839}"/>
               </a:ext>
             </a:extLst>
           </p:cNvPr>
@@ -22130,7 +22185,7 @@
           <p:cNvPr id="12" name="">
             <a:extLst xmlns:a="http://schemas.openxmlformats.org/drawingml/2006/main">
               <a:ext uri="{FF2B5EF4-FFF2-40B4-BE49-F238E27FC236}">
-                <a16:creationId xmlns:a16="http://schemas.microsoft.com/office/drawing/2014/main" id="{300328B7-FEAE-4E63-A164-F2153FB5BC75}"/>
+                <a16:creationId xmlns:a16="http://schemas.microsoft.com/office/drawing/2014/main" id="{DEF07C8D-FE62-4D70-BB77-B24BC188199E}"/>
               </a:ext>
             </a:extLst>
           </p:cNvPr>
@@ -22192,7 +22247,7 @@
           <p:cNvPr id="13" name="">
             <a:extLst xmlns:a="http://schemas.openxmlformats.org/drawingml/2006/main">
               <a:ext uri="{FF2B5EF4-FFF2-40B4-BE49-F238E27FC236}">
-                <a16:creationId xmlns:a16="http://schemas.microsoft.com/office/drawing/2014/main" id="{E1E6B84D-40B3-45C3-812A-21614D972C4D}"/>
+                <a16:creationId xmlns:a16="http://schemas.microsoft.com/office/drawing/2014/main" id="{3633401C-4505-4535-83A1-6899DCF50B90}"/>
               </a:ext>
             </a:extLst>
           </p:cNvPr>
@@ -22254,7 +22309,7 @@
           <p:cNvPr id="14" name="">
             <a:extLst xmlns:a="http://schemas.openxmlformats.org/drawingml/2006/main">
               <a:ext uri="{FF2B5EF4-FFF2-40B4-BE49-F238E27FC236}">
-                <a16:creationId xmlns:a16="http://schemas.microsoft.com/office/drawing/2014/main" id="{A3830EE2-FAEE-4CA8-8113-B53D20AB2137}"/>
+                <a16:creationId xmlns:a16="http://schemas.microsoft.com/office/drawing/2014/main" id="{83F97852-5025-4AD2-8E3F-8EBF610B6E91}"/>
               </a:ext>
             </a:extLst>
           </p:cNvPr>
@@ -22285,7 +22340,7 @@
           <p:cNvPr id="15" name="">
             <a:extLst xmlns:a="http://schemas.openxmlformats.org/drawingml/2006/main">
               <a:ext uri="{FF2B5EF4-FFF2-40B4-BE49-F238E27FC236}">
-                <a16:creationId xmlns:a16="http://schemas.microsoft.com/office/drawing/2014/main" id="{B35BA54E-1A9C-4303-8BE1-7B383DF30231}"/>
+                <a16:creationId xmlns:a16="http://schemas.microsoft.com/office/drawing/2014/main" id="{24812787-4C2B-44A5-94A3-1A4F5C4F3190}"/>
               </a:ext>
             </a:extLst>
           </p:cNvPr>
@@ -22347,7 +22402,7 @@
           <p:cNvPr id="16" name="">
             <a:extLst xmlns:a="http://schemas.openxmlformats.org/drawingml/2006/main">
               <a:ext uri="{FF2B5EF4-FFF2-40B4-BE49-F238E27FC236}">
-                <a16:creationId xmlns:a16="http://schemas.microsoft.com/office/drawing/2014/main" id="{D67EDB78-88FB-4697-8E1F-9EE78B8ADF5F}"/>
+                <a16:creationId xmlns:a16="http://schemas.microsoft.com/office/drawing/2014/main" id="{4BE6DF6C-5BF1-4650-B940-02EFB096E908}"/>
               </a:ext>
             </a:extLst>
           </p:cNvPr>
@@ -22409,7 +22464,7 @@
           <p:cNvPr id="17" name="">
             <a:extLst xmlns:a="http://schemas.openxmlformats.org/drawingml/2006/main">
               <a:ext uri="{FF2B5EF4-FFF2-40B4-BE49-F238E27FC236}">
-                <a16:creationId xmlns:a16="http://schemas.microsoft.com/office/drawing/2014/main" id="{CBD0B8AE-23A8-4A87-A002-7EEA22E91C37}"/>
+                <a16:creationId xmlns:a16="http://schemas.microsoft.com/office/drawing/2014/main" id="{8314782A-EA78-4221-8B97-134D876E1716}"/>
               </a:ext>
             </a:extLst>
           </p:cNvPr>
@@ -22471,7 +22526,7 @@
           <p:cNvPr id="18" name="">
             <a:extLst xmlns:a="http://schemas.openxmlformats.org/drawingml/2006/main">
               <a:ext uri="{FF2B5EF4-FFF2-40B4-BE49-F238E27FC236}">
-                <a16:creationId xmlns:a16="http://schemas.microsoft.com/office/drawing/2014/main" id="{ACE69F09-0315-45CF-845B-DFBDACC465A3}"/>
+                <a16:creationId xmlns:a16="http://schemas.microsoft.com/office/drawing/2014/main" id="{A3A0CBF2-3824-443F-B986-509DE34F4A67}"/>
               </a:ext>
             </a:extLst>
           </p:cNvPr>
@@ -22502,7 +22557,7 @@
           <p:cNvPr id="19" name="">
             <a:extLst xmlns:a="http://schemas.openxmlformats.org/drawingml/2006/main">
               <a:ext uri="{FF2B5EF4-FFF2-40B4-BE49-F238E27FC236}">
-                <a16:creationId xmlns:a16="http://schemas.microsoft.com/office/drawing/2014/main" id="{DF148678-B462-4648-A20B-787F27D12ED2}"/>
+                <a16:creationId xmlns:a16="http://schemas.microsoft.com/office/drawing/2014/main" id="{FEABD2E4-82E1-47A9-96DC-6C81B19F3BBB}"/>
               </a:ext>
             </a:extLst>
           </p:cNvPr>
@@ -22564,7 +22619,7 @@
           <p:cNvPr id="20" name="">
             <a:extLst xmlns:a="http://schemas.openxmlformats.org/drawingml/2006/main">
               <a:ext uri="{FF2B5EF4-FFF2-40B4-BE49-F238E27FC236}">
-                <a16:creationId xmlns:a16="http://schemas.microsoft.com/office/drawing/2014/main" id="{46185002-5EE2-4234-87FB-1E9AB5B4D489}"/>
+                <a16:creationId xmlns:a16="http://schemas.microsoft.com/office/drawing/2014/main" id="{55C70AC8-935C-434D-B0C8-9185C28EF203}"/>
               </a:ext>
             </a:extLst>
           </p:cNvPr>
@@ -22626,7 +22681,7 @@
           <p:cNvPr id="21" name="">
             <a:extLst xmlns:a="http://schemas.openxmlformats.org/drawingml/2006/main">
               <a:ext uri="{FF2B5EF4-FFF2-40B4-BE49-F238E27FC236}">
-                <a16:creationId xmlns:a16="http://schemas.microsoft.com/office/drawing/2014/main" id="{B3A11DEE-CE6B-456B-9328-EBE937016B5B}"/>
+                <a16:creationId xmlns:a16="http://schemas.microsoft.com/office/drawing/2014/main" id="{4B5EB7FB-469A-44B4-9219-5DCE0C7DA5CB}"/>
               </a:ext>
             </a:extLst>
           </p:cNvPr>
@@ -22688,7 +22743,7 @@
           <p:cNvPr id="22" name="">
             <a:extLst xmlns:a="http://schemas.openxmlformats.org/drawingml/2006/main">
               <a:ext uri="{FF2B5EF4-FFF2-40B4-BE49-F238E27FC236}">
-                <a16:creationId xmlns:a16="http://schemas.microsoft.com/office/drawing/2014/main" id="{E4DBD94E-7345-40DE-B1B0-32632B62A1EC}"/>
+                <a16:creationId xmlns:a16="http://schemas.microsoft.com/office/drawing/2014/main" id="{14399573-CC11-4F1C-9B6D-79CEA4F073A8}"/>
               </a:ext>
             </a:extLst>
           </p:cNvPr>
@@ -22750,7 +22805,7 @@
           <p:cNvPr id="23" name="footer-rule-8">
             <a:extLst xmlns:a="http://schemas.openxmlformats.org/drawingml/2006/main">
               <a:ext uri="{FF2B5EF4-FFF2-40B4-BE49-F238E27FC236}">
-                <a16:creationId xmlns:a16="http://schemas.microsoft.com/office/drawing/2014/main" id="{60D956C9-2132-4025-B095-FF06C9C5744F}"/>
+                <a16:creationId xmlns:a16="http://schemas.microsoft.com/office/drawing/2014/main" id="{359B2593-5AFF-4CF5-956E-6E6DD81A07F7}"/>
               </a:ext>
             </a:extLst>
           </p:cNvPr>
@@ -22781,7 +22836,7 @@
           <p:cNvPr id="24" name="footer-label-8">
             <a:extLst xmlns:a="http://schemas.openxmlformats.org/drawingml/2006/main">
               <a:ext uri="{FF2B5EF4-FFF2-40B4-BE49-F238E27FC236}">
-                <a16:creationId xmlns:a16="http://schemas.microsoft.com/office/drawing/2014/main" id="{8ED755D3-B9E0-484F-B6A2-C453B009F7A4}"/>
+                <a16:creationId xmlns:a16="http://schemas.microsoft.com/office/drawing/2014/main" id="{3E545D3F-F3AE-4707-9A3B-1688D0B57B86}"/>
               </a:ext>
             </a:extLst>
           </p:cNvPr>
@@ -22843,7 +22898,7 @@
           <p:cNvPr id="25" name="footer-page-8">
             <a:extLst xmlns:a="http://schemas.openxmlformats.org/drawingml/2006/main">
               <a:ext uri="{FF2B5EF4-FFF2-40B4-BE49-F238E27FC236}">
-                <a16:creationId xmlns:a16="http://schemas.microsoft.com/office/drawing/2014/main" id="{D2F3932E-7027-4586-A74C-D9EDA2325B2D}"/>
+                <a16:creationId xmlns:a16="http://schemas.microsoft.com/office/drawing/2014/main" id="{B8928B59-9720-44FF-8411-DBEF0A651946}"/>
               </a:ext>
             </a:extLst>
           </p:cNvPr>
@@ -22903,7 +22958,7 @@
     </p:spTree>
     <p:extLst>
       <p:ext uri="{BB962C8B-B14F-4D97-AF65-F5344CB8AC3E}">
-        <p14:creationId xmlns:p14="http://schemas.microsoft.com/office/powerpoint/2010/main" val="1753216743"/>
+        <p14:creationId xmlns:p14="http://schemas.microsoft.com/office/powerpoint/2010/main" val="1924688387"/>
       </p:ext>
     </p:extLst>
   </p:cSld>
@@ -22934,7 +22989,7 @@
           <p:cNvPr id="25" name="side-accent-9">
             <a:extLst xmlns:a="http://schemas.openxmlformats.org/drawingml/2006/main">
               <a:ext uri="{FF2B5EF4-FFF2-40B4-BE49-F238E27FC236}">
-                <a16:creationId xmlns:a16="http://schemas.microsoft.com/office/drawing/2014/main" id="{9EE2C900-0722-4B69-A796-06D077143404}"/>
+                <a16:creationId xmlns:a16="http://schemas.microsoft.com/office/drawing/2014/main" id="{BB8B4E10-7A34-4B1D-B03A-5818E79CA17C}"/>
               </a:ext>
             </a:extLst>
           </p:cNvPr>
@@ -22965,7 +23020,7 @@
           <p:cNvPr id="2" name="kicker-9">
             <a:extLst xmlns:a="http://schemas.openxmlformats.org/drawingml/2006/main">
               <a:ext uri="{FF2B5EF4-FFF2-40B4-BE49-F238E27FC236}">
-                <a16:creationId xmlns:a16="http://schemas.microsoft.com/office/drawing/2014/main" id="{4766B836-8847-40DE-85C3-C8C78251CD53}"/>
+                <a16:creationId xmlns:a16="http://schemas.microsoft.com/office/drawing/2014/main" id="{7BEC781B-4647-48E5-A137-FCAE7CB47080}"/>
               </a:ext>
             </a:extLst>
           </p:cNvPr>
@@ -23027,7 +23082,7 @@
           <p:cNvPr id="3" name="title-9">
             <a:extLst xmlns:a="http://schemas.openxmlformats.org/drawingml/2006/main">
               <a:ext uri="{FF2B5EF4-FFF2-40B4-BE49-F238E27FC236}">
-                <a16:creationId xmlns:a16="http://schemas.microsoft.com/office/drawing/2014/main" id="{D65A391D-25B4-492E-9B1A-4C303776DF0C}"/>
+                <a16:creationId xmlns:a16="http://schemas.microsoft.com/office/drawing/2014/main" id="{A04EE715-6D94-42C9-B490-B659F6F2C6E9}"/>
               </a:ext>
             </a:extLst>
           </p:cNvPr>
@@ -23089,7 +23144,7 @@
           <p:cNvPr id="4" name="">
             <a:extLst xmlns:a="http://schemas.openxmlformats.org/drawingml/2006/main">
               <a:ext uri="{FF2B5EF4-FFF2-40B4-BE49-F238E27FC236}">
-                <a16:creationId xmlns:a16="http://schemas.microsoft.com/office/drawing/2014/main" id="{A378A7A0-E46E-4227-B824-E1C42C239B4A}"/>
+                <a16:creationId xmlns:a16="http://schemas.microsoft.com/office/drawing/2014/main" id="{949424B7-BBC4-42C6-B2B9-A8330EE4181A}"/>
               </a:ext>
             </a:extLst>
           </p:cNvPr>
@@ -23151,7 +23206,7 @@
           <p:cNvPr id="5" name="">
             <a:extLst xmlns:a="http://schemas.openxmlformats.org/drawingml/2006/main">
               <a:ext uri="{FF2B5EF4-FFF2-40B4-BE49-F238E27FC236}">
-                <a16:creationId xmlns:a16="http://schemas.microsoft.com/office/drawing/2014/main" id="{5328A382-CFCD-4610-A3EB-423BC493923C}"/>
+                <a16:creationId xmlns:a16="http://schemas.microsoft.com/office/drawing/2014/main" id="{77D398FA-0A1C-4714-9CEC-6F51B632ADA1}"/>
               </a:ext>
             </a:extLst>
           </p:cNvPr>
@@ -23186,7 +23241,7 @@
           <p:cNvPr id="6" name="">
             <a:extLst xmlns:a="http://schemas.openxmlformats.org/drawingml/2006/main">
               <a:ext uri="{FF2B5EF4-FFF2-40B4-BE49-F238E27FC236}">
-                <a16:creationId xmlns:a16="http://schemas.microsoft.com/office/drawing/2014/main" id="{1FB4E8C3-23B1-40C5-B7B0-FC13F33FB772}"/>
+                <a16:creationId xmlns:a16="http://schemas.microsoft.com/office/drawing/2014/main" id="{5D15F334-6B8B-4CF3-9983-9A92D60DA7E4}"/>
               </a:ext>
             </a:extLst>
           </p:cNvPr>
@@ -23248,7 +23303,7 @@
           <p:cNvPr id="7" name="">
             <a:extLst xmlns:a="http://schemas.openxmlformats.org/drawingml/2006/main">
               <a:ext uri="{FF2B5EF4-FFF2-40B4-BE49-F238E27FC236}">
-                <a16:creationId xmlns:a16="http://schemas.microsoft.com/office/drawing/2014/main" id="{98B986D4-A49A-4537-8BF7-A456B2D7EFFC}"/>
+                <a16:creationId xmlns:a16="http://schemas.microsoft.com/office/drawing/2014/main" id="{98669488-1705-4C6B-AE2D-5D97E433726C}"/>
               </a:ext>
             </a:extLst>
           </p:cNvPr>
@@ -23310,7 +23365,7 @@
           <p:cNvPr id="8" name="">
             <a:extLst xmlns:a="http://schemas.openxmlformats.org/drawingml/2006/main">
               <a:ext uri="{FF2B5EF4-FFF2-40B4-BE49-F238E27FC236}">
-                <a16:creationId xmlns:a16="http://schemas.microsoft.com/office/drawing/2014/main" id="{A7A0DE38-8957-4488-9D83-9D7A142ED80D}"/>
+                <a16:creationId xmlns:a16="http://schemas.microsoft.com/office/drawing/2014/main" id="{7361A7C8-0145-48E3-B774-C71F8B114655}"/>
               </a:ext>
             </a:extLst>
           </p:cNvPr>
@@ -23372,7 +23427,7 @@
           <p:cNvPr id="9" name="">
             <a:extLst xmlns:a="http://schemas.openxmlformats.org/drawingml/2006/main">
               <a:ext uri="{FF2B5EF4-FFF2-40B4-BE49-F238E27FC236}">
-                <a16:creationId xmlns:a16="http://schemas.microsoft.com/office/drawing/2014/main" id="{7AB382DB-C115-4023-BCB8-2FA6ECFA74E8}"/>
+                <a16:creationId xmlns:a16="http://schemas.microsoft.com/office/drawing/2014/main" id="{3553A077-6820-4FFE-BB52-62526CAD3049}"/>
               </a:ext>
             </a:extLst>
           </p:cNvPr>
@@ -23407,7 +23462,7 @@
           <p:cNvPr id="10" name="">
             <a:extLst xmlns:a="http://schemas.openxmlformats.org/drawingml/2006/main">
               <a:ext uri="{FF2B5EF4-FFF2-40B4-BE49-F238E27FC236}">
-                <a16:creationId xmlns:a16="http://schemas.microsoft.com/office/drawing/2014/main" id="{E21B8E9B-1669-40B6-A6DA-E84125E4B26D}"/>
+                <a16:creationId xmlns:a16="http://schemas.microsoft.com/office/drawing/2014/main" id="{69B2814C-34E8-4C13-865F-F072A93B33B3}"/>
               </a:ext>
             </a:extLst>
           </p:cNvPr>
@@ -23469,7 +23524,7 @@
           <p:cNvPr id="11" name="">
             <a:extLst xmlns:a="http://schemas.openxmlformats.org/drawingml/2006/main">
               <a:ext uri="{FF2B5EF4-FFF2-40B4-BE49-F238E27FC236}">
-                <a16:creationId xmlns:a16="http://schemas.microsoft.com/office/drawing/2014/main" id="{AF0AEEA1-CB51-43EB-8C44-7F08C553711C}"/>
+                <a16:creationId xmlns:a16="http://schemas.microsoft.com/office/drawing/2014/main" id="{188F45D3-D718-4B50-B9F0-F0D92766DEE9}"/>
               </a:ext>
             </a:extLst>
           </p:cNvPr>
@@ -23531,7 +23586,7 @@
           <p:cNvPr id="12" name="">
             <a:extLst xmlns:a="http://schemas.openxmlformats.org/drawingml/2006/main">
               <a:ext uri="{FF2B5EF4-FFF2-40B4-BE49-F238E27FC236}">
-                <a16:creationId xmlns:a16="http://schemas.microsoft.com/office/drawing/2014/main" id="{B8A200E2-32FE-42D6-AB01-DCBC934E97C7}"/>
+                <a16:creationId xmlns:a16="http://schemas.microsoft.com/office/drawing/2014/main" id="{950C5460-A9F9-40BA-930A-2F908CAA3BDD}"/>
               </a:ext>
             </a:extLst>
           </p:cNvPr>
@@ -23593,7 +23648,7 @@
           <p:cNvPr id="13" name="">
             <a:extLst xmlns:a="http://schemas.openxmlformats.org/drawingml/2006/main">
               <a:ext uri="{FF2B5EF4-FFF2-40B4-BE49-F238E27FC236}">
-                <a16:creationId xmlns:a16="http://schemas.microsoft.com/office/drawing/2014/main" id="{9BCB4A7D-EACE-436D-9A24-F1D468E2567F}"/>
+                <a16:creationId xmlns:a16="http://schemas.microsoft.com/office/drawing/2014/main" id="{1CD593FE-0107-439B-81E1-362CD83675B9}"/>
               </a:ext>
             </a:extLst>
           </p:cNvPr>
@@ -23628,7 +23683,7 @@
           <p:cNvPr id="14" name="">
             <a:extLst xmlns:a="http://schemas.openxmlformats.org/drawingml/2006/main">
               <a:ext uri="{FF2B5EF4-FFF2-40B4-BE49-F238E27FC236}">
-                <a16:creationId xmlns:a16="http://schemas.microsoft.com/office/drawing/2014/main" id="{2EEA0CC7-6C28-417A-8529-27D20C41B7F8}"/>
+                <a16:creationId xmlns:a16="http://schemas.microsoft.com/office/drawing/2014/main" id="{F67B5687-30F5-4ED0-8C35-A83203ECCA92}"/>
               </a:ext>
             </a:extLst>
           </p:cNvPr>
@@ -23690,7 +23745,7 @@
           <p:cNvPr id="15" name="">
             <a:extLst xmlns:a="http://schemas.openxmlformats.org/drawingml/2006/main">
               <a:ext uri="{FF2B5EF4-FFF2-40B4-BE49-F238E27FC236}">
-                <a16:creationId xmlns:a16="http://schemas.microsoft.com/office/drawing/2014/main" id="{17BB385C-733A-4018-8084-1E14BD42FC7C}"/>
+                <a16:creationId xmlns:a16="http://schemas.microsoft.com/office/drawing/2014/main" id="{B9C0FC4A-21B0-4F7F-88A4-7227852048AA}"/>
               </a:ext>
             </a:extLst>
           </p:cNvPr>
@@ -23752,7 +23807,7 @@
           <p:cNvPr id="16" name="">
             <a:extLst xmlns:a="http://schemas.openxmlformats.org/drawingml/2006/main">
               <a:ext uri="{FF2B5EF4-FFF2-40B4-BE49-F238E27FC236}">
-                <a16:creationId xmlns:a16="http://schemas.microsoft.com/office/drawing/2014/main" id="{5FE6D2EE-C13D-4A81-ADCE-5EEBF1268413}"/>
+                <a16:creationId xmlns:a16="http://schemas.microsoft.com/office/drawing/2014/main" id="{DACFD5A8-63AA-4EBA-AEBA-91F2F6DF790B}"/>
               </a:ext>
             </a:extLst>
           </p:cNvPr>
@@ -23814,7 +23869,7 @@
           <p:cNvPr id="17" name="">
             <a:extLst xmlns:a="http://schemas.openxmlformats.org/drawingml/2006/main">
               <a:ext uri="{FF2B5EF4-FFF2-40B4-BE49-F238E27FC236}">
-                <a16:creationId xmlns:a16="http://schemas.microsoft.com/office/drawing/2014/main" id="{1696C40A-D24C-49F2-887C-C986C72EB99C}"/>
+                <a16:creationId xmlns:a16="http://schemas.microsoft.com/office/drawing/2014/main" id="{B7403C0E-BB63-49A4-A15D-0A62D2BF81BE}"/>
               </a:ext>
             </a:extLst>
           </p:cNvPr>
@@ -23849,7 +23904,7 @@
           <p:cNvPr id="18" name="">
             <a:extLst xmlns:a="http://schemas.openxmlformats.org/drawingml/2006/main">
               <a:ext uri="{FF2B5EF4-FFF2-40B4-BE49-F238E27FC236}">
-                <a16:creationId xmlns:a16="http://schemas.microsoft.com/office/drawing/2014/main" id="{B090F62F-90AC-4009-86E5-988243CC3790}"/>
+                <a16:creationId xmlns:a16="http://schemas.microsoft.com/office/drawing/2014/main" id="{06B1439F-4A20-4C65-B7EF-62A1928ADB15}"/>
               </a:ext>
             </a:extLst>
           </p:cNvPr>
@@ -23911,7 +23966,7 @@
           <p:cNvPr id="19" name="">
             <a:extLst xmlns:a="http://schemas.openxmlformats.org/drawingml/2006/main">
               <a:ext uri="{FF2B5EF4-FFF2-40B4-BE49-F238E27FC236}">
-                <a16:creationId xmlns:a16="http://schemas.microsoft.com/office/drawing/2014/main" id="{4628D9D5-B68F-4BD6-B0C0-51281F478009}"/>
+                <a16:creationId xmlns:a16="http://schemas.microsoft.com/office/drawing/2014/main" id="{8BCB8CF4-795F-4A40-8D54-4BA116571A1D}"/>
               </a:ext>
             </a:extLst>
           </p:cNvPr>
@@ -23973,7 +24028,7 @@
           <p:cNvPr id="20" name="">
             <a:extLst xmlns:a="http://schemas.openxmlformats.org/drawingml/2006/main">
               <a:ext uri="{FF2B5EF4-FFF2-40B4-BE49-F238E27FC236}">
-                <a16:creationId xmlns:a16="http://schemas.microsoft.com/office/drawing/2014/main" id="{ADDB198B-E48F-4067-A239-2BAEC6291AC2}"/>
+                <a16:creationId xmlns:a16="http://schemas.microsoft.com/office/drawing/2014/main" id="{192986F3-464E-422D-AC0F-C69BC9718148}"/>
               </a:ext>
             </a:extLst>
           </p:cNvPr>
@@ -24035,7 +24090,7 @@
           <p:cNvPr id="21" name="">
             <a:extLst xmlns:a="http://schemas.openxmlformats.org/drawingml/2006/main">
               <a:ext uri="{FF2B5EF4-FFF2-40B4-BE49-F238E27FC236}">
-                <a16:creationId xmlns:a16="http://schemas.microsoft.com/office/drawing/2014/main" id="{763F2761-75B8-48FC-B54C-605E9CDCCA64}"/>
+                <a16:creationId xmlns:a16="http://schemas.microsoft.com/office/drawing/2014/main" id="{363550FD-F982-4C21-81DF-51C45B4C3A10}"/>
               </a:ext>
             </a:extLst>
           </p:cNvPr>
@@ -24097,7 +24152,7 @@
           <p:cNvPr id="22" name="footer-rule-9">
             <a:extLst xmlns:a="http://schemas.openxmlformats.org/drawingml/2006/main">
               <a:ext uri="{FF2B5EF4-FFF2-40B4-BE49-F238E27FC236}">
-                <a16:creationId xmlns:a16="http://schemas.microsoft.com/office/drawing/2014/main" id="{7C92D9FC-8368-4834-9CF1-956D26ED3D6A}"/>
+                <a16:creationId xmlns:a16="http://schemas.microsoft.com/office/drawing/2014/main" id="{DF07D955-E616-4E4E-BE94-C43D356B691C}"/>
               </a:ext>
             </a:extLst>
           </p:cNvPr>
@@ -24128,7 +24183,7 @@
           <p:cNvPr id="23" name="footer-label-9">
             <a:extLst xmlns:a="http://schemas.openxmlformats.org/drawingml/2006/main">
               <a:ext uri="{FF2B5EF4-FFF2-40B4-BE49-F238E27FC236}">
-                <a16:creationId xmlns:a16="http://schemas.microsoft.com/office/drawing/2014/main" id="{B464C367-291D-4A8E-A1FF-0E48A7EFD4BF}"/>
+                <a16:creationId xmlns:a16="http://schemas.microsoft.com/office/drawing/2014/main" id="{C87C135E-8AE2-4733-8A83-9BD7DA93A4D7}"/>
               </a:ext>
             </a:extLst>
           </p:cNvPr>
@@ -24190,7 +24245,7 @@
           <p:cNvPr id="24" name="footer-page-9">
             <a:extLst xmlns:a="http://schemas.openxmlformats.org/drawingml/2006/main">
               <a:ext uri="{FF2B5EF4-FFF2-40B4-BE49-F238E27FC236}">
-                <a16:creationId xmlns:a16="http://schemas.microsoft.com/office/drawing/2014/main" id="{61B5B7DC-3462-4689-92D0-67D1CA4B0144}"/>
+                <a16:creationId xmlns:a16="http://schemas.microsoft.com/office/drawing/2014/main" id="{2911B33D-5151-43B3-A18A-842E2D4A70B0}"/>
               </a:ext>
             </a:extLst>
           </p:cNvPr>
@@ -24250,7 +24305,7 @@
     </p:spTree>
     <p:extLst>
       <p:ext uri="{BB962C8B-B14F-4D97-AF65-F5344CB8AC3E}">
-        <p14:creationId xmlns:p14="http://schemas.microsoft.com/office/powerpoint/2010/main" val="650540245"/>
+        <p14:creationId xmlns:p14="http://schemas.microsoft.com/office/powerpoint/2010/main" val="1561813498"/>
       </p:ext>
     </p:extLst>
   </p:cSld>

</xml_diff>

<commit_message>
docs: use full system name in training decks
</commit_message>
<xml_diff>
--- a/docs/MSU-EVA-อบรมสายวิชาการ-ฉบับวิทยากร.pptx
+++ b/docs/MSU-EVA-อบรมสายวิชาการ-ฉบับวิทยากร.pptx
@@ -2,30 +2,30 @@
 <file path=ppt/presentation.xml><?xml version="1.0" encoding="utf-8"?>
 <p:presentation xmlns:p="http://schemas.openxmlformats.org/presentationml/2006/main">
   <p:sldMasterIdLst>
-    <p:sldMasterId xmlns:r="http://schemas.openxmlformats.org/officeDocument/2006/relationships" id="2147483648" r:id="R3c11d32156b442f5"/>
+    <p:sldMasterId xmlns:r="http://schemas.openxmlformats.org/officeDocument/2006/relationships" id="2147483648" r:id="Ra04a4c173d3a4f10"/>
   </p:sldMasterIdLst>
   <p:notesMasterIdLst>
-    <p:notesMasterId xmlns:r="http://schemas.openxmlformats.org/officeDocument/2006/relationships" r:id="Rbc28fcabc26a4dfb"/>
+    <p:notesMasterId xmlns:r="http://schemas.openxmlformats.org/officeDocument/2006/relationships" r:id="Rc7ee0a15df244a36"/>
   </p:notesMasterIdLst>
   <p:sldIdLst>
-    <p:sldId xmlns:r="http://schemas.openxmlformats.org/officeDocument/2006/relationships" id="256" r:id="R6ccc4321486a4137"/>
-    <p:sldId xmlns:r="http://schemas.openxmlformats.org/officeDocument/2006/relationships" id="257" r:id="R90a3a745f0734b00"/>
-    <p:sldId xmlns:r="http://schemas.openxmlformats.org/officeDocument/2006/relationships" id="258" r:id="Ra07d888c46f2479d"/>
-    <p:sldId xmlns:r="http://schemas.openxmlformats.org/officeDocument/2006/relationships" id="259" r:id="Rb66bbd8551c44419"/>
-    <p:sldId xmlns:r="http://schemas.openxmlformats.org/officeDocument/2006/relationships" id="260" r:id="R7676b3bc7d10404c"/>
-    <p:sldId xmlns:r="http://schemas.openxmlformats.org/officeDocument/2006/relationships" id="261" r:id="R56fcfdb51a664976"/>
-    <p:sldId xmlns:r="http://schemas.openxmlformats.org/officeDocument/2006/relationships" id="262" r:id="R7165cbe5d35741f0"/>
-    <p:sldId xmlns:r="http://schemas.openxmlformats.org/officeDocument/2006/relationships" id="263" r:id="R2c32fe6a5b4443c2"/>
-    <p:sldId xmlns:r="http://schemas.openxmlformats.org/officeDocument/2006/relationships" id="264" r:id="R21a97dbf181f49c5"/>
-    <p:sldId xmlns:r="http://schemas.openxmlformats.org/officeDocument/2006/relationships" id="265" r:id="R6a21abdf65564b0b"/>
-    <p:sldId xmlns:r="http://schemas.openxmlformats.org/officeDocument/2006/relationships" id="266" r:id="Raa41046c0d954e30"/>
-    <p:sldId xmlns:r="http://schemas.openxmlformats.org/officeDocument/2006/relationships" id="267" r:id="R85868b9a15454521"/>
-    <p:sldId xmlns:r="http://schemas.openxmlformats.org/officeDocument/2006/relationships" id="268" r:id="Rf34b23d06abf452f"/>
-    <p:sldId xmlns:r="http://schemas.openxmlformats.org/officeDocument/2006/relationships" id="269" r:id="Rfa4412faca6e4ee3"/>
-    <p:sldId xmlns:r="http://schemas.openxmlformats.org/officeDocument/2006/relationships" id="270" r:id="R3fb7fc9bd5da477a"/>
-    <p:sldId xmlns:r="http://schemas.openxmlformats.org/officeDocument/2006/relationships" id="271" r:id="R7e163eb071d04098"/>
-    <p:sldId xmlns:r="http://schemas.openxmlformats.org/officeDocument/2006/relationships" id="272" r:id="R2c29a33583164639"/>
-    <p:sldId xmlns:r="http://schemas.openxmlformats.org/officeDocument/2006/relationships" id="273" r:id="R8737c7f9047845aa"/>
+    <p:sldId xmlns:r="http://schemas.openxmlformats.org/officeDocument/2006/relationships" id="256" r:id="R4da5979d9f0440fc"/>
+    <p:sldId xmlns:r="http://schemas.openxmlformats.org/officeDocument/2006/relationships" id="257" r:id="R30881cb8185b4929"/>
+    <p:sldId xmlns:r="http://schemas.openxmlformats.org/officeDocument/2006/relationships" id="258" r:id="R4fd327abd4544ba2"/>
+    <p:sldId xmlns:r="http://schemas.openxmlformats.org/officeDocument/2006/relationships" id="259" r:id="Re9c49037aadc4d2a"/>
+    <p:sldId xmlns:r="http://schemas.openxmlformats.org/officeDocument/2006/relationships" id="260" r:id="R8e53e2150f2a4c7a"/>
+    <p:sldId xmlns:r="http://schemas.openxmlformats.org/officeDocument/2006/relationships" id="261" r:id="Rae64c44533554ec6"/>
+    <p:sldId xmlns:r="http://schemas.openxmlformats.org/officeDocument/2006/relationships" id="262" r:id="Ra98b16d9928640ea"/>
+    <p:sldId xmlns:r="http://schemas.openxmlformats.org/officeDocument/2006/relationships" id="263" r:id="Rc3a6d4731fbf4489"/>
+    <p:sldId xmlns:r="http://schemas.openxmlformats.org/officeDocument/2006/relationships" id="264" r:id="R4a14473e47114145"/>
+    <p:sldId xmlns:r="http://schemas.openxmlformats.org/officeDocument/2006/relationships" id="265" r:id="Ra3c8c505ede243c7"/>
+    <p:sldId xmlns:r="http://schemas.openxmlformats.org/officeDocument/2006/relationships" id="266" r:id="Rc4f6dcf0ad594beb"/>
+    <p:sldId xmlns:r="http://schemas.openxmlformats.org/officeDocument/2006/relationships" id="267" r:id="R2354fe53ca8e4e1d"/>
+    <p:sldId xmlns:r="http://schemas.openxmlformats.org/officeDocument/2006/relationships" id="268" r:id="Rf6e76c7d8ed64970"/>
+    <p:sldId xmlns:r="http://schemas.openxmlformats.org/officeDocument/2006/relationships" id="269" r:id="R7c3444840e65419d"/>
+    <p:sldId xmlns:r="http://schemas.openxmlformats.org/officeDocument/2006/relationships" id="270" r:id="Rf6c1f84c565d4344"/>
+    <p:sldId xmlns:r="http://schemas.openxmlformats.org/officeDocument/2006/relationships" id="271" r:id="R414211a9be644962"/>
+    <p:sldId xmlns:r="http://schemas.openxmlformats.org/officeDocument/2006/relationships" id="272" r:id="Re50a27d8c1f74930"/>
+    <p:sldId xmlns:r="http://schemas.openxmlformats.org/officeDocument/2006/relationships" id="273" r:id="Rd24a60f8c07a4aef"/>
   </p:sldIdLst>
   <p:sldSz cx="12192000" cy="6858000"/>
   <p:notesSz cx="6858000" cy="9144000"/>
@@ -459,7 +459,7 @@
           <a:lstStyle xmlns:a="http://schemas.openxmlformats.org/drawingml/2006/main"/>
           <a:p xmlns:a="http://schemas.openxmlformats.org/drawingml/2006/main">
             <a:r>
-              <a:t>[พูด] สวัสดีทุกท่านครับ ขอต้อนรับเข้าสู่การอบรมการใช้งานระบบ MSU EVA สำหรับบุคลากรสายวิชาการนะครับ วันนี้ในห้องนี้มีทั้งท่านที่เคยช่วยทดสอบระบบมาแล้ว ท่านที่เพิ่งเข้ามาใช้งานครั้งแรก รวมถึงผู้ประเมิน กรรมการ และผู้บริหาร ไม่เป็นไรครับ เดี๋ยวเราจะค่อย ๆ ไปด้วยกัน ช่วงแรกผมจะพาทำความรู้จักระบบและบทบาทต่าง ๆ ก่อน หลังจากนั้นผมจะสาธิตหนึ่งรอบ แล้วทุกท่านจะได้ลองใช้บัญชีที่เตรียมไว้ครับ</a:t>
+              <a:t>[พูด] สวัสดีทุกท่านครับ ขอต้อนรับเข้าสู่การอบรมการใช้งานระบบประเมินผลการปฏิบัติงานบุคลากร หรือ MSU EVA สำหรับบุคลากรสายวิชาการนะครับ วันนี้ในห้องนี้มีทั้งท่านที่เคยช่วยทดสอบระบบมาแล้ว ท่านที่เพิ่งเข้ามาใช้งานครั้งแรก รวมถึงผู้ประเมิน กรรมการ และผู้บริหาร ไม่เป็นไรครับ เดี๋ยวเราจะค่อย ๆ ไปด้วยกัน ช่วงแรกผมจะพาทำความรู้จักระบบและบทบาทต่าง ๆ ก่อน หลังจากนั้นผมจะสาธิตหนึ่งรอบ แล้วทุกท่านจะได้ลองใช้บัญชีที่เตรียมไว้ครับ</a:t>
             </a:r>
           </a:p>
           <a:p xmlns:a="http://schemas.openxmlformats.org/drawingml/2006/main">
@@ -1524,7 +1524,7 @@
           <a:lstStyle xmlns:a="http://schemas.openxmlformats.org/drawingml/2006/main"/>
           <a:p xmlns:a="http://schemas.openxmlformats.org/drawingml/2006/main">
             <a:r>
-              <a:t>[พูด] ก่อนเริ่ม ขอชวนทุกท่านตั้งเป้าหมายร่วมกันนิดหนึ่งครับ วันนี้เราไม่จำเป็นต้องจำทุกปุ่ม สิ่งที่อยากให้ทำได้คือเปิดงานหนึ่งรายการ ตรวจข้อมูล กรอกผลงาน แนบหลักฐาน แล้วแยกให้ออกว่าเมื่อไรควรบันทึกร่างและเมื่อไรจึงควรส่งแบบประเมิน รอบประเมินเป็นสิ่งที่ผู้ดูแลระบบกำหนดไว้ให้แล้วนะครับ เรามีหน้าที่ตรวจว่ารอบและงานที่ได้รับมอบหมายถูกต้อง เมื่อเห็นเป้าหมายตรงกันแล้ว ต่อไปเรามาดูว่าระบบนี้ช่วยงานส่วนใดบ้างครับ</a:t>
+              <a:t>[พูด] ก่อนเริ่ม ขอชวนทุกท่านตั้งเป้าหมายร่วมกันนิดหนึ่งครับ วันนี้เราไม่จำเป็นต้องจำทุกปุ่ม สิ่งที่อยากให้ทำได้คือเปิดงานหนึ่งรายการ ตรวจข้อมูล กรอกผลงาน แนบหลักฐาน ถ้าข้อมูลยังไม่ครบ ให้บันทึกร่างไว้ก่อน เมื่อข้อมูลและหลักฐานครบแล้วจึงส่งแบบประเมินครับ รอบประเมินเป็นสิ่งที่ผู้ดูแลระบบกำหนดไว้ให้แล้วนะครับ เรามีหน้าที่ตรวจว่ารอบและงานที่ได้รับมอบหมายถูกต้อง เมื่อเห็นเป้าหมายตรงกันแล้ว ต่อไปเรามาดูว่าระบบนี้ช่วยงานส่วนใดบ้างครับ</a:t>
             </a:r>
           </a:p>
           <a:p xmlns:a="http://schemas.openxmlformats.org/drawingml/2006/main">
@@ -1619,7 +1619,7 @@
           <a:lstStyle xmlns:a="http://schemas.openxmlformats.org/drawingml/2006/main"/>
           <a:p xmlns:a="http://schemas.openxmlformats.org/drawingml/2006/main">
             <a:r>
-              <a:t>[พูด] ใช่ครับ หลายท่านอาจคุ้นกับ MSU EVA ในฐานะหน้ากรอกแบบประเมิน แต่จริง ๆ ระบบดูแลงานตั้งแต่ต้นจนจบเลยครับ เริ่มจากผู้ใช้และสิทธิ์ เกณฑ์ประเมิน รอบและการมอบหมายงาน ไปจนถึงการกรอก การประเมิน การติดตามสถานะ และการส่งออกรายงาน ส่วนการเตรียมระบบเหล่านี้เป็นหน้าที่ของ Admin ผู้ใช้งานทั่วไปจึงไม่ต้องสร้างหรือเลือกรอบประเมินเองครับ เราเพียงตรวจรอบกับงานที่ได้รับ แล้วทำตามสิทธิ์ของเรา ทีนี้เรามาดูกันครับว่าในระบบมีใครบ้าง</a:t>
+              <a:t>[พูด] ใช่ครับ หลายท่านอาจคุ้นกับระบบในฐานะหน้ากรอกแบบประเมิน แต่จริง ๆ ระบบดูแลงานตั้งแต่ต้นจนจบเลยครับ เริ่มจากผู้ใช้และสิทธิ์ เกณฑ์ประเมิน รอบและการมอบหมายงาน ไปจนถึงการกรอก การประเมิน การติดตามสถานะ และการส่งออกรายงาน ส่วนการเตรียมระบบเหล่านี้เป็นหน้าที่ของ Admin ผู้ใช้งานทั่วไปจึงไม่ต้องสร้างหรือเลือกรอบประเมินเองครับ เราเพียงตรวจรอบกับงานที่ได้รับ แล้วทำตามสิทธิ์ของเรา ทีนี้เรามาดูกันครับว่าในระบบมีใครบ้าง</a:t>
             </a:r>
           </a:p>
           <a:p xmlns:a="http://schemas.openxmlformats.org/drawingml/2006/main">
@@ -1724,7 +1724,7 @@
           <a:lstStyle xmlns:a="http://schemas.openxmlformats.org/drawingml/2006/main"/>
           <a:p xmlns:a="http://schemas.openxmlformats.org/drawingml/2006/main">
             <a:r>
-              <a:t>[พูด] ระบบมีผู้ใช้งานหลักห้าบทบาทครับ ได้แก่ Admin ผู้รับการประเมิน ผู้ประเมิน กรรมการ และผู้บริหาร แต่ละคนจะเห็นเมนูและปุ่มไม่เหมือนกัน ตรงนี้ขอเน้นนิดหนึ่งครับ Admin เป็นผู้กำหนดผู้ใช้ เกณฑ์ รอบประเมิน การมอบหมาย และลำดับผู้ประเมิน ส่วนผู้ประเมิน กรรมการ และผู้บริหารจะเป็นขั้นตรวจตามที่ Admin จัดไว้ บางงานอาจไม่ได้ใช้ครบทุกบทบาท และคนที่ปิดงานคือคนสุดท้ายในลำดับของงานนั้นครับ เมื่อรู้จักคนในระบบแล้ว ต่อไปมาดูเส้นทางของงานกันครับ</a:t>
+              <a:t>[พูด] ระบบมีผู้ใช้งานหลักห้าบทบาทครับ ได้แก่ Admin ผู้รับการประเมิน ผู้ประเมิน กรรมการ และผู้บริหาร แต่ละคนจะเห็นเมนูและปุ่มไม่เหมือนกัน ตรงนี้ขอเน้นนิดหนึ่งครับ Admin เป็นผู้กำหนดผู้ใช้ เกณฑ์ รอบประเมิน การมอบหมาย และลำดับผู้ประเมิน ส่วนผู้ประเมิน กรรมการ และผู้บริหารจะเป็นขั้นตรวจตามที่ Admin จัดไว้ บางงานอาจไม่ได้ใช้ครบทุกบทบาท และงานจะเสร็จสมบูรณ์เมื่อผู้ประเมินลำดับสุดท้ายกดยืนยันผลครับ เมื่อรู้จักคนในระบบแล้ว ต่อไปมาดูเส้นทางของงานกันครับ</a:t>
             </a:r>
           </a:p>
           <a:p xmlns:a="http://schemas.openxmlformats.org/drawingml/2006/main">
@@ -2307,7 +2307,7 @@
   </p:cSld>
   <p:clrMap bg1="lt1" tx1="dk1" bg2="lt2" tx2="dk2" accent1="accent1" accent2="accent2" accent3="accent3" accent4="accent4" accent5="accent5" accent6="accent6" hlink="hlink" folHlink="folHlink"/>
   <p:sldLayoutIdLst>
-    <p:sldLayoutId xmlns:r="http://schemas.openxmlformats.org/officeDocument/2006/relationships" id="2147483649" r:id="R4f49d2c4e6104704"/>
+    <p:sldLayoutId xmlns:r="http://schemas.openxmlformats.org/officeDocument/2006/relationships" id="2147483649" r:id="R34d0ed1c50534536"/>
   </p:sldLayoutIdLst>
   <p:txStyles>
     <p:titleStyle>
@@ -2855,14 +2855,14 @@
       </p:grpSpPr>
       <p:pic>
         <p:nvPicPr>
-          <p:cNvPr id="12" name=""/>
+          <p:cNvPr id="13" name=""/>
           <p:cNvPicPr>
             <a:picLocks xmlns:a="http://schemas.openxmlformats.org/drawingml/2006/main" noChangeAspect="1"/>
           </p:cNvPicPr>
           <p:nvPr/>
         </p:nvPicPr>
         <p:blipFill>
-          <a:blip xmlns:r="http://schemas.openxmlformats.org/officeDocument/2006/relationships" xmlns:a="http://schemas.openxmlformats.org/drawingml/2006/main" r:embed="R823c57051a67428b"/>
+          <a:blip xmlns:r="http://schemas.openxmlformats.org/officeDocument/2006/relationships" xmlns:a="http://schemas.openxmlformats.org/drawingml/2006/main" r:embed="R0c853ac313f94ab8"/>
           <a:srcRect xmlns:a="http://schemas.openxmlformats.org/drawingml/2006/main" l="2579" t="0" r="2579" b="0"/>
           <a:stretch xmlns:a="http://schemas.openxmlformats.org/drawingml/2006/main">
             <a:fillRect l="0" t="0" r="0" b="0"/>
@@ -2883,7 +2883,7 @@
           <p:cNvPr id="2" name="cover-panel">
             <a:extLst xmlns:a="http://schemas.openxmlformats.org/drawingml/2006/main">
               <a:ext uri="{FF2B5EF4-FFF2-40B4-BE49-F238E27FC236}">
-                <a16:creationId xmlns:a16="http://schemas.microsoft.com/office/drawing/2014/main" id="{EDEDFE9A-3066-4793-A4F2-A7060248380C}"/>
+                <a16:creationId xmlns:a16="http://schemas.microsoft.com/office/drawing/2014/main" id="{1FE4C569-934E-447F-A97F-B924341FDCC0}"/>
               </a:ext>
             </a:extLst>
           </p:cNvPr>
@@ -2914,7 +2914,7 @@
           <p:cNvPr id="3" name="cover-accent">
             <a:extLst xmlns:a="http://schemas.openxmlformats.org/drawingml/2006/main">
               <a:ext uri="{FF2B5EF4-FFF2-40B4-BE49-F238E27FC236}">
-                <a16:creationId xmlns:a16="http://schemas.microsoft.com/office/drawing/2014/main" id="{E15F5367-19D2-42EF-8D53-4E0E8CC1DC60}"/>
+                <a16:creationId xmlns:a16="http://schemas.microsoft.com/office/drawing/2014/main" id="{25370A7E-47A8-46DB-99CE-3C1915398347}"/>
               </a:ext>
             </a:extLst>
           </p:cNvPr>
@@ -2942,14 +2942,14 @@
       </p:sp>
       <p:pic>
         <p:nvPicPr>
-          <p:cNvPr id="15" name=""/>
+          <p:cNvPr id="16" name=""/>
           <p:cNvPicPr>
             <a:picLocks xmlns:a="http://schemas.openxmlformats.org/drawingml/2006/main" noChangeAspect="1"/>
           </p:cNvPicPr>
           <p:nvPr/>
         </p:nvPicPr>
         <p:blipFill>
-          <a:blip xmlns:r="http://schemas.openxmlformats.org/officeDocument/2006/relationships" xmlns:a="http://schemas.openxmlformats.org/drawingml/2006/main" r:embed="Rc2ad2bfa71a64297"/>
+          <a:blip xmlns:r="http://schemas.openxmlformats.org/officeDocument/2006/relationships" xmlns:a="http://schemas.openxmlformats.org/drawingml/2006/main" r:embed="Rcd43ed0132624e19"/>
           <a:stretch xmlns:a="http://schemas.openxmlformats.org/drawingml/2006/main"/>
         </p:blipFill>
         <p:spPr>
@@ -2967,7 +2967,7 @@
           <p:cNvPr id="5" name="cover-institution">
             <a:extLst xmlns:a="http://schemas.openxmlformats.org/drawingml/2006/main">
               <a:ext uri="{FF2B5EF4-FFF2-40B4-BE49-F238E27FC236}">
-                <a16:creationId xmlns:a16="http://schemas.microsoft.com/office/drawing/2014/main" id="{90DB7532-2371-4634-B3A3-DAE7A3FF05CA}"/>
+                <a16:creationId xmlns:a16="http://schemas.microsoft.com/office/drawing/2014/main" id="{308854BB-39D6-418C-9492-A0B63ABD75CE}"/>
               </a:ext>
             </a:extLst>
           </p:cNvPr>
@@ -3029,7 +3029,7 @@
           <p:cNvPr id="6" name="cover-session">
             <a:extLst xmlns:a="http://schemas.openxmlformats.org/drawingml/2006/main">
               <a:ext uri="{FF2B5EF4-FFF2-40B4-BE49-F238E27FC236}">
-                <a16:creationId xmlns:a16="http://schemas.microsoft.com/office/drawing/2014/main" id="{5E3D0F6D-C201-4699-89F5-4E17CAC9D0A2}"/>
+                <a16:creationId xmlns:a16="http://schemas.microsoft.com/office/drawing/2014/main" id="{D43ADFC5-7E2C-4CBC-8AEF-64F80C4C6733}"/>
               </a:ext>
             </a:extLst>
           </p:cNvPr>
@@ -3091,7 +3091,7 @@
           <p:cNvPr id="7" name="cover-title">
             <a:extLst xmlns:a="http://schemas.openxmlformats.org/drawingml/2006/main">
               <a:ext uri="{FF2B5EF4-FFF2-40B4-BE49-F238E27FC236}">
-                <a16:creationId xmlns:a16="http://schemas.microsoft.com/office/drawing/2014/main" id="{B6680FBE-C190-40CE-AC48-62C9F45074E7}"/>
+                <a16:creationId xmlns:a16="http://schemas.microsoft.com/office/drawing/2014/main" id="{5368E868-B3A3-4C1E-A798-24E02784E6E6}"/>
               </a:ext>
             </a:extLst>
           </p:cNvPr>
@@ -3103,7 +3103,7 @@
         <p:spPr>
           <a:xfrm xmlns:a="http://schemas.openxmlformats.org/drawingml/2006/main">
             <a:off x="647700" y="2095500"/>
-            <a:ext cx="6191250" cy="1695450"/>
+            <a:ext cx="6477000" cy="1504950"/>
           </a:xfrm>
           <a:prstGeom xmlns:a="http://schemas.openxmlformats.org/drawingml/2006/main" prst="rect">
             <a:avLst/>
@@ -3122,10 +3122,10 @@
           <a:p xmlns:a="http://schemas.openxmlformats.org/drawingml/2006/main">
             <a:pPr algn="l">
               <a:lnSpc>
-                <a:spcPct val="92000"/>
-              </a:lnSpc>
-              <a:buNone/>
-              <a:defRPr sz="3975" b="1">
+                <a:spcPct val="96000"/>
+              </a:lnSpc>
+              <a:buNone/>
+              <a:defRPr sz="3525" b="1">
                 <a:solidFill>
                   <a:srgbClr val="102A43"/>
                 </a:solidFill>
@@ -3135,7 +3135,7 @@
               </a:defRPr>
             </a:pPr>
             <a:r>
-              <a:rPr sz="3975" b="1">
+              <a:rPr sz="3525" b="1">
                 <a:solidFill>
                   <a:srgbClr val="102A43"/>
                 </a:solidFill>
@@ -3143,55 +3143,90 @@
                 <a:ea typeface="Tahoma"/>
                 <a:cs typeface="Tahoma"/>
               </a:rPr>
-              <a:t>การใช้งานระบบ MSU EVA</a:t>
-            </a:r>
-          </a:p>
+              <a:t>ระบบประเมินผลการปฏิบัติงานบุคลากร</a:t>
+            </a:r>
+          </a:p>
+        </p:txBody>
+      </p:sp>
+      <p:sp>
+        <p:nvSpPr>
+          <p:cNvPr id="8" name="cover-system-short-name">
+            <a:extLst xmlns:a="http://schemas.openxmlformats.org/drawingml/2006/main">
+              <a:ext uri="{FF2B5EF4-FFF2-40B4-BE49-F238E27FC236}">
+                <a16:creationId xmlns:a16="http://schemas.microsoft.com/office/drawing/2014/main" id="{F1B4D6CC-ADA2-404B-826A-F2E18478A05E}"/>
+              </a:ext>
+            </a:extLst>
+          </p:cNvPr>
+          <p:cNvSpPr>
+            <a:spLocks xmlns:a="http://schemas.openxmlformats.org/drawingml/2006/main" noGrp="1"/>
+          </p:cNvSpPr>
+          <p:nvPr/>
+        </p:nvSpPr>
+        <p:spPr>
+          <a:xfrm xmlns:a="http://schemas.openxmlformats.org/drawingml/2006/main">
+            <a:off x="647700" y="3714750"/>
+            <a:ext cx="5715000" cy="400050"/>
+          </a:xfrm>
+          <a:prstGeom xmlns:a="http://schemas.openxmlformats.org/drawingml/2006/main" prst="rect">
+            <a:avLst/>
+          </a:prstGeom>
+          <a:noFill xmlns:a="http://schemas.openxmlformats.org/drawingml/2006/main"/>
+          <a:ln xmlns:a="http://schemas.openxmlformats.org/drawingml/2006/main" w="0">
+            <a:noFill/>
+            <a:prstDash val="solid"/>
+          </a:ln>
+        </p:spPr>
+        <p:txBody>
+          <a:bodyPr xmlns:a="http://schemas.openxmlformats.org/drawingml/2006/main" lIns="0" tIns="0" rIns="0" bIns="0" anchor="t">
+            <a:noAutofit/>
+          </a:bodyPr>
+          <a:lstStyle xmlns:a="http://schemas.openxmlformats.org/drawingml/2006/main"/>
           <a:p xmlns:a="http://schemas.openxmlformats.org/drawingml/2006/main">
             <a:pPr algn="l">
               <a:lnSpc>
-                <a:spcPct val="92000"/>
-              </a:lnSpc>
-              <a:buNone/>
-              <a:defRPr sz="3975" b="1">
-                <a:solidFill>
-                  <a:srgbClr val="102A43"/>
-                </a:solidFill>
-                <a:latin typeface="Tahoma"/>
-                <a:ea typeface="Tahoma"/>
-                <a:cs typeface="Tahoma"/>
-              </a:defRPr>
-            </a:pPr>
-            <a:r>
-              <a:rPr sz="3975" b="1">
-                <a:solidFill>
-                  <a:srgbClr val="102A43"/>
-                </a:solidFill>
-                <a:latin typeface="Tahoma"/>
-                <a:ea typeface="Tahoma"/>
-                <a:cs typeface="Tahoma"/>
-              </a:rPr>
-              <a:t>สำหรับบุคลากรสายวิชาการ</a:t>
-            </a:r>
-          </a:p>
-        </p:txBody>
-      </p:sp>
-      <p:sp>
-        <p:nvSpPr>
-          <p:cNvPr id="8" name="cover-gold-rule">
-            <a:extLst xmlns:a="http://schemas.openxmlformats.org/drawingml/2006/main">
-              <a:ext uri="{FF2B5EF4-FFF2-40B4-BE49-F238E27FC236}">
-                <a16:creationId xmlns:a16="http://schemas.microsoft.com/office/drawing/2014/main" id="{3865BD96-140B-4384-99BD-6C5DA49E4214}"/>
-              </a:ext>
-            </a:extLst>
-          </p:cNvPr>
-          <p:cNvSpPr>
-            <a:spLocks xmlns:a="http://schemas.openxmlformats.org/drawingml/2006/main" noGrp="1"/>
-          </p:cNvSpPr>
-          <p:nvPr/>
-        </p:nvSpPr>
-        <p:spPr>
-          <a:xfrm xmlns:a="http://schemas.openxmlformats.org/drawingml/2006/main">
-            <a:off x="647700" y="4095750"/>
+                <a:spcPct val="100000"/>
+              </a:lnSpc>
+              <a:buNone/>
+              <a:defRPr sz="2025" b="1">
+                <a:solidFill>
+                  <a:srgbClr val="4356C7"/>
+                </a:solidFill>
+                <a:latin typeface="Tahoma"/>
+                <a:ea typeface="Tahoma"/>
+                <a:cs typeface="Tahoma"/>
+              </a:defRPr>
+            </a:pPr>
+            <a:r>
+              <a:rPr sz="2025" b="1">
+                <a:solidFill>
+                  <a:srgbClr val="4356C7"/>
+                </a:solidFill>
+                <a:latin typeface="Tahoma"/>
+                <a:ea typeface="Tahoma"/>
+                <a:cs typeface="Tahoma"/>
+              </a:rPr>
+              <a:t>(MSU EVA)  •  สายวิชาการ</a:t>
+            </a:r>
+          </a:p>
+        </p:txBody>
+      </p:sp>
+      <p:sp>
+        <p:nvSpPr>
+          <p:cNvPr id="9" name="cover-gold-rule">
+            <a:extLst xmlns:a="http://schemas.openxmlformats.org/drawingml/2006/main">
+              <a:ext uri="{FF2B5EF4-FFF2-40B4-BE49-F238E27FC236}">
+                <a16:creationId xmlns:a16="http://schemas.microsoft.com/office/drawing/2014/main" id="{7F5815A5-F854-4FE3-8BE0-0CC9EDFDEF93}"/>
+              </a:ext>
+            </a:extLst>
+          </p:cNvPr>
+          <p:cNvSpPr>
+            <a:spLocks xmlns:a="http://schemas.openxmlformats.org/drawingml/2006/main" noGrp="1"/>
+          </p:cNvSpPr>
+          <p:nvPr/>
+        </p:nvSpPr>
+        <p:spPr>
+          <a:xfrm xmlns:a="http://schemas.openxmlformats.org/drawingml/2006/main">
+            <a:off x="647700" y="4305300"/>
             <a:ext cx="876300" cy="57150"/>
           </a:xfrm>
           <a:prstGeom xmlns:a="http://schemas.openxmlformats.org/drawingml/2006/main" prst="rect">
@@ -3208,21 +3243,21 @@
       </p:sp>
       <p:sp>
         <p:nvSpPr>
-          <p:cNvPr id="9" name="cover-promise">
-            <a:extLst xmlns:a="http://schemas.openxmlformats.org/drawingml/2006/main">
-              <a:ext uri="{FF2B5EF4-FFF2-40B4-BE49-F238E27FC236}">
-                <a16:creationId xmlns:a16="http://schemas.microsoft.com/office/drawing/2014/main" id="{E9D520EA-C614-4957-84EE-C7AA6DE31B97}"/>
-              </a:ext>
-            </a:extLst>
-          </p:cNvPr>
-          <p:cNvSpPr>
-            <a:spLocks xmlns:a="http://schemas.openxmlformats.org/drawingml/2006/main" noGrp="1"/>
-          </p:cNvSpPr>
-          <p:nvPr/>
-        </p:nvSpPr>
-        <p:spPr>
-          <a:xfrm xmlns:a="http://schemas.openxmlformats.org/drawingml/2006/main">
-            <a:off x="647700" y="4457700"/>
+          <p:cNvPr id="10" name="cover-promise">
+            <a:extLst xmlns:a="http://schemas.openxmlformats.org/drawingml/2006/main">
+              <a:ext uri="{FF2B5EF4-FFF2-40B4-BE49-F238E27FC236}">
+                <a16:creationId xmlns:a16="http://schemas.microsoft.com/office/drawing/2014/main" id="{2F4C6382-C650-43BC-9FD8-2A1213152699}"/>
+              </a:ext>
+            </a:extLst>
+          </p:cNvPr>
+          <p:cNvSpPr>
+            <a:spLocks xmlns:a="http://schemas.openxmlformats.org/drawingml/2006/main" noGrp="1"/>
+          </p:cNvSpPr>
+          <p:nvPr/>
+        </p:nvSpPr>
+        <p:spPr>
+          <a:xfrm xmlns:a="http://schemas.openxmlformats.org/drawingml/2006/main">
+            <a:off x="647700" y="4667250"/>
             <a:ext cx="5905500" cy="781050"/>
           </a:xfrm>
           <a:prstGeom xmlns:a="http://schemas.openxmlformats.org/drawingml/2006/main" prst="rect">
@@ -3270,10 +3305,10 @@
       </p:sp>
       <p:sp>
         <p:nvSpPr>
-          <p:cNvPr id="10" name="cover-style">
-            <a:extLst xmlns:a="http://schemas.openxmlformats.org/drawingml/2006/main">
-              <a:ext uri="{FF2B5EF4-FFF2-40B4-BE49-F238E27FC236}">
-                <a16:creationId xmlns:a16="http://schemas.microsoft.com/office/drawing/2014/main" id="{594271CF-1B2E-4132-B327-4C36032AF557}"/>
+          <p:cNvPr id="11" name="cover-style">
+            <a:extLst xmlns:a="http://schemas.openxmlformats.org/drawingml/2006/main">
+              <a:ext uri="{FF2B5EF4-FFF2-40B4-BE49-F238E27FC236}">
+                <a16:creationId xmlns:a16="http://schemas.microsoft.com/office/drawing/2014/main" id="{EB6EC177-AB61-412F-AFA0-782C4DD0976E}"/>
               </a:ext>
             </a:extLst>
           </p:cNvPr>
@@ -3332,14 +3367,14 @@
       </p:sp>
       <p:pic>
         <p:nvPicPr>
-          <p:cNvPr id="22" name=""/>
+          <p:cNvPr id="24" name=""/>
           <p:cNvPicPr>
             <a:picLocks xmlns:a="http://schemas.openxmlformats.org/drawingml/2006/main" noChangeAspect="1"/>
           </p:cNvPicPr>
           <p:nvPr/>
         </p:nvPicPr>
         <p:blipFill>
-          <a:blip xmlns:r="http://schemas.openxmlformats.org/officeDocument/2006/relationships" xmlns:a="http://schemas.openxmlformats.org/drawingml/2006/main" r:embed="Rb1a5facf1ea64135"/>
+          <a:blip xmlns:r="http://schemas.openxmlformats.org/officeDocument/2006/relationships" xmlns:a="http://schemas.openxmlformats.org/drawingml/2006/main" r:embed="R78f68a5fb3ed495c"/>
           <a:stretch xmlns:a="http://schemas.openxmlformats.org/drawingml/2006/main"/>
         </p:blipFill>
         <p:spPr>
@@ -3355,7 +3390,7 @@
     </p:spTree>
     <p:extLst>
       <p:ext uri="{BB962C8B-B14F-4D97-AF65-F5344CB8AC3E}">
-        <p14:creationId xmlns:p14="http://schemas.microsoft.com/office/powerpoint/2010/main" val="1937744159"/>
+        <p14:creationId xmlns:p14="http://schemas.microsoft.com/office/powerpoint/2010/main" val="1274820604"/>
       </p:ext>
     </p:extLst>
   </p:cSld>
@@ -3386,7 +3421,7 @@
           <p:cNvPr id="21" name="side-accent-10">
             <a:extLst xmlns:a="http://schemas.openxmlformats.org/drawingml/2006/main">
               <a:ext uri="{FF2B5EF4-FFF2-40B4-BE49-F238E27FC236}">
-                <a16:creationId xmlns:a16="http://schemas.microsoft.com/office/drawing/2014/main" id="{469E2506-D8FD-4170-9C99-D3BC7B8502D2}"/>
+                <a16:creationId xmlns:a16="http://schemas.microsoft.com/office/drawing/2014/main" id="{29DAD226-491A-44EF-8A4D-CEEDF710DF54}"/>
               </a:ext>
             </a:extLst>
           </p:cNvPr>
@@ -3417,7 +3452,7 @@
           <p:cNvPr id="2" name="kicker-10">
             <a:extLst xmlns:a="http://schemas.openxmlformats.org/drawingml/2006/main">
               <a:ext uri="{FF2B5EF4-FFF2-40B4-BE49-F238E27FC236}">
-                <a16:creationId xmlns:a16="http://schemas.microsoft.com/office/drawing/2014/main" id="{A474F4FF-734A-4DFF-BCAA-D5F1144022FA}"/>
+                <a16:creationId xmlns:a16="http://schemas.microsoft.com/office/drawing/2014/main" id="{CD45A5EF-4E62-40E9-832E-877B0D1F0404}"/>
               </a:ext>
             </a:extLst>
           </p:cNvPr>
@@ -3479,7 +3514,7 @@
           <p:cNvPr id="3" name="title-10">
             <a:extLst xmlns:a="http://schemas.openxmlformats.org/drawingml/2006/main">
               <a:ext uri="{FF2B5EF4-FFF2-40B4-BE49-F238E27FC236}">
-                <a16:creationId xmlns:a16="http://schemas.microsoft.com/office/drawing/2014/main" id="{FE7E7304-F16E-4DB9-BEF1-6E9C66BE6A6A}"/>
+                <a16:creationId xmlns:a16="http://schemas.microsoft.com/office/drawing/2014/main" id="{E16A3BE8-356C-4F80-9B8F-B5CB8B546AAC}"/>
               </a:ext>
             </a:extLst>
           </p:cNvPr>
@@ -3541,7 +3576,7 @@
           <p:cNvPr id="4" name="">
             <a:extLst xmlns:a="http://schemas.openxmlformats.org/drawingml/2006/main">
               <a:ext uri="{FF2B5EF4-FFF2-40B4-BE49-F238E27FC236}">
-                <a16:creationId xmlns:a16="http://schemas.microsoft.com/office/drawing/2014/main" id="{9571000C-889F-4720-A871-4D2247552889}"/>
+                <a16:creationId xmlns:a16="http://schemas.microsoft.com/office/drawing/2014/main" id="{BF442896-1F6B-4D66-B2AE-7F52BC14DF94}"/>
               </a:ext>
             </a:extLst>
           </p:cNvPr>
@@ -3603,7 +3638,7 @@
           <p:cNvPr id="5" name="">
             <a:extLst xmlns:a="http://schemas.openxmlformats.org/drawingml/2006/main">
               <a:ext uri="{FF2B5EF4-FFF2-40B4-BE49-F238E27FC236}">
-                <a16:creationId xmlns:a16="http://schemas.microsoft.com/office/drawing/2014/main" id="{CF1A5E81-A92A-43E1-90F1-E5D7528FDF92}"/>
+                <a16:creationId xmlns:a16="http://schemas.microsoft.com/office/drawing/2014/main" id="{EE291DAF-2399-45B9-B200-D841F7C5B4E6}"/>
               </a:ext>
             </a:extLst>
           </p:cNvPr>
@@ -3665,7 +3700,7 @@
           <p:cNvPr id="6" name="">
             <a:extLst xmlns:a="http://schemas.openxmlformats.org/drawingml/2006/main">
               <a:ext uri="{FF2B5EF4-FFF2-40B4-BE49-F238E27FC236}">
-                <a16:creationId xmlns:a16="http://schemas.microsoft.com/office/drawing/2014/main" id="{4EBFD44E-351D-44B1-93C8-4D3825DBB496}"/>
+                <a16:creationId xmlns:a16="http://schemas.microsoft.com/office/drawing/2014/main" id="{03C63816-826F-4BB9-947B-C3E9D7F8DF45}"/>
               </a:ext>
             </a:extLst>
           </p:cNvPr>
@@ -3727,7 +3762,7 @@
           <p:cNvPr id="7" name="">
             <a:extLst xmlns:a="http://schemas.openxmlformats.org/drawingml/2006/main">
               <a:ext uri="{FF2B5EF4-FFF2-40B4-BE49-F238E27FC236}">
-                <a16:creationId xmlns:a16="http://schemas.microsoft.com/office/drawing/2014/main" id="{51C34F9C-CECC-42CF-AFA8-60BBFBA60E4B}"/>
+                <a16:creationId xmlns:a16="http://schemas.microsoft.com/office/drawing/2014/main" id="{CA68ED3C-099E-453F-8120-46CF25F84287}"/>
               </a:ext>
             </a:extLst>
           </p:cNvPr>
@@ -3789,7 +3824,7 @@
           <p:cNvPr id="8" name="">
             <a:extLst xmlns:a="http://schemas.openxmlformats.org/drawingml/2006/main">
               <a:ext uri="{FF2B5EF4-FFF2-40B4-BE49-F238E27FC236}">
-                <a16:creationId xmlns:a16="http://schemas.microsoft.com/office/drawing/2014/main" id="{D424FD62-3A03-47F5-A6C4-E7E7B60F57D8}"/>
+                <a16:creationId xmlns:a16="http://schemas.microsoft.com/office/drawing/2014/main" id="{F70553FB-2F07-488C-85FC-5DB9E8E44783}"/>
               </a:ext>
             </a:extLst>
           </p:cNvPr>
@@ -3820,7 +3855,7 @@
           <p:cNvPr id="9" name="">
             <a:extLst xmlns:a="http://schemas.openxmlformats.org/drawingml/2006/main">
               <a:ext uri="{FF2B5EF4-FFF2-40B4-BE49-F238E27FC236}">
-                <a16:creationId xmlns:a16="http://schemas.microsoft.com/office/drawing/2014/main" id="{3C47494B-18CB-4345-BBFF-4D5CC002BCEB}"/>
+                <a16:creationId xmlns:a16="http://schemas.microsoft.com/office/drawing/2014/main" id="{E3C73763-665C-42AA-9EB8-3F481474412D}"/>
               </a:ext>
             </a:extLst>
           </p:cNvPr>
@@ -3882,7 +3917,7 @@
           <p:cNvPr id="10" name="">
             <a:extLst xmlns:a="http://schemas.openxmlformats.org/drawingml/2006/main">
               <a:ext uri="{FF2B5EF4-FFF2-40B4-BE49-F238E27FC236}">
-                <a16:creationId xmlns:a16="http://schemas.microsoft.com/office/drawing/2014/main" id="{F40A62BA-33C2-48A9-8013-2091E99A0749}"/>
+                <a16:creationId xmlns:a16="http://schemas.microsoft.com/office/drawing/2014/main" id="{AB3B6E15-398C-4913-9644-15C5985F0491}"/>
               </a:ext>
             </a:extLst>
           </p:cNvPr>
@@ -3944,7 +3979,7 @@
           <p:cNvPr id="11" name="">
             <a:extLst xmlns:a="http://schemas.openxmlformats.org/drawingml/2006/main">
               <a:ext uri="{FF2B5EF4-FFF2-40B4-BE49-F238E27FC236}">
-                <a16:creationId xmlns:a16="http://schemas.microsoft.com/office/drawing/2014/main" id="{A45597E9-D86D-4FBC-B953-C88B158282AB}"/>
+                <a16:creationId xmlns:a16="http://schemas.microsoft.com/office/drawing/2014/main" id="{32943DA4-C529-4D07-B0CE-537808E9E2BE}"/>
               </a:ext>
             </a:extLst>
           </p:cNvPr>
@@ -4006,7 +4041,7 @@
           <p:cNvPr id="12" name="">
             <a:extLst xmlns:a="http://schemas.openxmlformats.org/drawingml/2006/main">
               <a:ext uri="{FF2B5EF4-FFF2-40B4-BE49-F238E27FC236}">
-                <a16:creationId xmlns:a16="http://schemas.microsoft.com/office/drawing/2014/main" id="{44CEC4C6-643A-471F-8E12-3F913FAE9CFD}"/>
+                <a16:creationId xmlns:a16="http://schemas.microsoft.com/office/drawing/2014/main" id="{64337FEE-391E-4C4E-890C-B1628B84E1EA}"/>
               </a:ext>
             </a:extLst>
           </p:cNvPr>
@@ -4037,7 +4072,7 @@
           <p:cNvPr id="13" name="">
             <a:extLst xmlns:a="http://schemas.openxmlformats.org/drawingml/2006/main">
               <a:ext uri="{FF2B5EF4-FFF2-40B4-BE49-F238E27FC236}">
-                <a16:creationId xmlns:a16="http://schemas.microsoft.com/office/drawing/2014/main" id="{753044D7-2AA2-4A29-84F3-C33BC70DC244}"/>
+                <a16:creationId xmlns:a16="http://schemas.microsoft.com/office/drawing/2014/main" id="{293EE86A-E818-4F0E-9583-98C61E2458C2}"/>
               </a:ext>
             </a:extLst>
           </p:cNvPr>
@@ -4099,7 +4134,7 @@
           <p:cNvPr id="14" name="">
             <a:extLst xmlns:a="http://schemas.openxmlformats.org/drawingml/2006/main">
               <a:ext uri="{FF2B5EF4-FFF2-40B4-BE49-F238E27FC236}">
-                <a16:creationId xmlns:a16="http://schemas.microsoft.com/office/drawing/2014/main" id="{139604BD-B72C-4374-83B2-F2AF2AF74487}"/>
+                <a16:creationId xmlns:a16="http://schemas.microsoft.com/office/drawing/2014/main" id="{B1377CE9-047B-4F65-9C04-C0B59861AF14}"/>
               </a:ext>
             </a:extLst>
           </p:cNvPr>
@@ -4161,7 +4196,7 @@
           <p:cNvPr id="15" name="">
             <a:extLst xmlns:a="http://schemas.openxmlformats.org/drawingml/2006/main">
               <a:ext uri="{FF2B5EF4-FFF2-40B4-BE49-F238E27FC236}">
-                <a16:creationId xmlns:a16="http://schemas.microsoft.com/office/drawing/2014/main" id="{7565134A-167B-4781-8B91-60C41D962777}"/>
+                <a16:creationId xmlns:a16="http://schemas.microsoft.com/office/drawing/2014/main" id="{706BDE4E-612C-496F-B2B4-159529051EF3}"/>
               </a:ext>
             </a:extLst>
           </p:cNvPr>
@@ -4223,7 +4258,7 @@
           <p:cNvPr id="16" name="">
             <a:extLst xmlns:a="http://schemas.openxmlformats.org/drawingml/2006/main">
               <a:ext uri="{FF2B5EF4-FFF2-40B4-BE49-F238E27FC236}">
-                <a16:creationId xmlns:a16="http://schemas.microsoft.com/office/drawing/2014/main" id="{02A79529-C4E3-43F1-87D3-F6E13E3B04B7}"/>
+                <a16:creationId xmlns:a16="http://schemas.microsoft.com/office/drawing/2014/main" id="{CA6A88BD-A634-4C78-A500-47C4CBDE5B40}"/>
               </a:ext>
             </a:extLst>
           </p:cNvPr>
@@ -4256,7 +4291,7 @@
           <p:cNvPr id="17" name="">
             <a:extLst xmlns:a="http://schemas.openxmlformats.org/drawingml/2006/main">
               <a:ext uri="{FF2B5EF4-FFF2-40B4-BE49-F238E27FC236}">
-                <a16:creationId xmlns:a16="http://schemas.microsoft.com/office/drawing/2014/main" id="{9FFA7244-356F-480C-ACD0-8A73899D1334}"/>
+                <a16:creationId xmlns:a16="http://schemas.microsoft.com/office/drawing/2014/main" id="{97FEC707-A836-48F9-94C4-248329B9EAC9}"/>
               </a:ext>
             </a:extLst>
           </p:cNvPr>
@@ -4318,7 +4353,7 @@
           <p:cNvPr id="18" name="footer-rule-10">
             <a:extLst xmlns:a="http://schemas.openxmlformats.org/drawingml/2006/main">
               <a:ext uri="{FF2B5EF4-FFF2-40B4-BE49-F238E27FC236}">
-                <a16:creationId xmlns:a16="http://schemas.microsoft.com/office/drawing/2014/main" id="{A063E138-D417-4F7D-8A39-DC5C43F3C4B4}"/>
+                <a16:creationId xmlns:a16="http://schemas.microsoft.com/office/drawing/2014/main" id="{CB1F6351-18A4-4D9A-95CE-B0019E8B2FEF}"/>
               </a:ext>
             </a:extLst>
           </p:cNvPr>
@@ -4349,7 +4384,7 @@
           <p:cNvPr id="19" name="footer-label-10">
             <a:extLst xmlns:a="http://schemas.openxmlformats.org/drawingml/2006/main">
               <a:ext uri="{FF2B5EF4-FFF2-40B4-BE49-F238E27FC236}">
-                <a16:creationId xmlns:a16="http://schemas.microsoft.com/office/drawing/2014/main" id="{7EFD8D0C-77D7-4E44-B6EB-227D6D02F18B}"/>
+                <a16:creationId xmlns:a16="http://schemas.microsoft.com/office/drawing/2014/main" id="{265DF5FA-B7A5-43C5-95CB-171C061550E9}"/>
               </a:ext>
             </a:extLst>
           </p:cNvPr>
@@ -4411,7 +4446,7 @@
           <p:cNvPr id="20" name="footer-page-10">
             <a:extLst xmlns:a="http://schemas.openxmlformats.org/drawingml/2006/main">
               <a:ext uri="{FF2B5EF4-FFF2-40B4-BE49-F238E27FC236}">
-                <a16:creationId xmlns:a16="http://schemas.microsoft.com/office/drawing/2014/main" id="{656F18F9-A675-481D-9293-E7B99769EE79}"/>
+                <a16:creationId xmlns:a16="http://schemas.microsoft.com/office/drawing/2014/main" id="{F4DD4AA7-B5AB-4C13-A368-8CB33E9B075B}"/>
               </a:ext>
             </a:extLst>
           </p:cNvPr>
@@ -4471,7 +4506,7 @@
     </p:spTree>
     <p:extLst>
       <p:ext uri="{BB962C8B-B14F-4D97-AF65-F5344CB8AC3E}">
-        <p14:creationId xmlns:p14="http://schemas.microsoft.com/office/powerpoint/2010/main" val="702507020"/>
+        <p14:creationId xmlns:p14="http://schemas.microsoft.com/office/powerpoint/2010/main" val="6961013"/>
       </p:ext>
     </p:extLst>
   </p:cSld>
@@ -4502,7 +4537,7 @@
           <p:cNvPr id="22" name="side-accent-11">
             <a:extLst xmlns:a="http://schemas.openxmlformats.org/drawingml/2006/main">
               <a:ext uri="{FF2B5EF4-FFF2-40B4-BE49-F238E27FC236}">
-                <a16:creationId xmlns:a16="http://schemas.microsoft.com/office/drawing/2014/main" id="{894B4EC7-13E1-495D-9CC3-90FDEDA830FD}"/>
+                <a16:creationId xmlns:a16="http://schemas.microsoft.com/office/drawing/2014/main" id="{DE3B731A-C948-43BB-B922-FB5265601C59}"/>
               </a:ext>
             </a:extLst>
           </p:cNvPr>
@@ -4533,7 +4568,7 @@
           <p:cNvPr id="2" name="kicker-11">
             <a:extLst xmlns:a="http://schemas.openxmlformats.org/drawingml/2006/main">
               <a:ext uri="{FF2B5EF4-FFF2-40B4-BE49-F238E27FC236}">
-                <a16:creationId xmlns:a16="http://schemas.microsoft.com/office/drawing/2014/main" id="{C368E8B2-1762-48E9-88C0-B8705D8D128C}"/>
+                <a16:creationId xmlns:a16="http://schemas.microsoft.com/office/drawing/2014/main" id="{EDDA1770-5E96-48AC-B357-BF5857D46BB1}"/>
               </a:ext>
             </a:extLst>
           </p:cNvPr>
@@ -4595,7 +4630,7 @@
           <p:cNvPr id="3" name="title-11">
             <a:extLst xmlns:a="http://schemas.openxmlformats.org/drawingml/2006/main">
               <a:ext uri="{FF2B5EF4-FFF2-40B4-BE49-F238E27FC236}">
-                <a16:creationId xmlns:a16="http://schemas.microsoft.com/office/drawing/2014/main" id="{0A5762D6-15EA-4B96-80D1-03A889F25364}"/>
+                <a16:creationId xmlns:a16="http://schemas.microsoft.com/office/drawing/2014/main" id="{9B6B9D03-4170-4C92-AD13-FAD9975D9217}"/>
               </a:ext>
             </a:extLst>
           </p:cNvPr>
@@ -4657,7 +4692,7 @@
           <p:cNvPr id="4" name="">
             <a:extLst xmlns:a="http://schemas.openxmlformats.org/drawingml/2006/main">
               <a:ext uri="{FF2B5EF4-FFF2-40B4-BE49-F238E27FC236}">
-                <a16:creationId xmlns:a16="http://schemas.microsoft.com/office/drawing/2014/main" id="{B9EF7722-C62C-4992-9A17-E9319E0634B3}"/>
+                <a16:creationId xmlns:a16="http://schemas.microsoft.com/office/drawing/2014/main" id="{843B2D6E-FA37-4E52-A991-DE6D49BA3CB7}"/>
               </a:ext>
             </a:extLst>
           </p:cNvPr>
@@ -4719,7 +4754,7 @@
           <p:cNvPr id="5" name="">
             <a:extLst xmlns:a="http://schemas.openxmlformats.org/drawingml/2006/main">
               <a:ext uri="{FF2B5EF4-FFF2-40B4-BE49-F238E27FC236}">
-                <a16:creationId xmlns:a16="http://schemas.microsoft.com/office/drawing/2014/main" id="{28D9EC18-A341-46F9-B4BA-C69B15DCF422}"/>
+                <a16:creationId xmlns:a16="http://schemas.microsoft.com/office/drawing/2014/main" id="{9681E55A-01B2-471D-B53D-3F87CC884272}"/>
               </a:ext>
             </a:extLst>
           </p:cNvPr>
@@ -4750,7 +4785,7 @@
           <p:cNvPr id="6" name="">
             <a:extLst xmlns:a="http://schemas.openxmlformats.org/drawingml/2006/main">
               <a:ext uri="{FF2B5EF4-FFF2-40B4-BE49-F238E27FC236}">
-                <a16:creationId xmlns:a16="http://schemas.microsoft.com/office/drawing/2014/main" id="{C5C329A4-3341-4A66-9E16-67E8A03E3609}"/>
+                <a16:creationId xmlns:a16="http://schemas.microsoft.com/office/drawing/2014/main" id="{2DD18481-CC1B-4D10-B945-9E4C03022CD5}"/>
               </a:ext>
             </a:extLst>
           </p:cNvPr>
@@ -4812,7 +4847,7 @@
           <p:cNvPr id="7" name="">
             <a:extLst xmlns:a="http://schemas.openxmlformats.org/drawingml/2006/main">
               <a:ext uri="{FF2B5EF4-FFF2-40B4-BE49-F238E27FC236}">
-                <a16:creationId xmlns:a16="http://schemas.microsoft.com/office/drawing/2014/main" id="{CF1CE825-4EAB-41AA-9D17-24DA3FE46B9A}"/>
+                <a16:creationId xmlns:a16="http://schemas.microsoft.com/office/drawing/2014/main" id="{E2F9FC33-713F-45F9-BE40-8799BF64BFA1}"/>
               </a:ext>
             </a:extLst>
           </p:cNvPr>
@@ -4874,7 +4909,7 @@
           <p:cNvPr id="8" name="">
             <a:extLst xmlns:a="http://schemas.openxmlformats.org/drawingml/2006/main">
               <a:ext uri="{FF2B5EF4-FFF2-40B4-BE49-F238E27FC236}">
-                <a16:creationId xmlns:a16="http://schemas.microsoft.com/office/drawing/2014/main" id="{9B1A0B9E-82D2-4677-A3AE-A629995476A0}"/>
+                <a16:creationId xmlns:a16="http://schemas.microsoft.com/office/drawing/2014/main" id="{7B4AC2DB-672B-4909-A62E-A0237FDA3F18}"/>
               </a:ext>
             </a:extLst>
           </p:cNvPr>
@@ -4936,7 +4971,7 @@
           <p:cNvPr id="9" name="">
             <a:extLst xmlns:a="http://schemas.openxmlformats.org/drawingml/2006/main">
               <a:ext uri="{FF2B5EF4-FFF2-40B4-BE49-F238E27FC236}">
-                <a16:creationId xmlns:a16="http://schemas.microsoft.com/office/drawing/2014/main" id="{37BA4A30-AB3B-4FF4-A2B5-D7C10ED404BA}"/>
+                <a16:creationId xmlns:a16="http://schemas.microsoft.com/office/drawing/2014/main" id="{00B0382E-A9D6-4BBC-AD57-7D724F1BDDF9}"/>
               </a:ext>
             </a:extLst>
           </p:cNvPr>
@@ -4967,7 +5002,7 @@
           <p:cNvPr id="10" name="">
             <a:extLst xmlns:a="http://schemas.openxmlformats.org/drawingml/2006/main">
               <a:ext uri="{FF2B5EF4-FFF2-40B4-BE49-F238E27FC236}">
-                <a16:creationId xmlns:a16="http://schemas.microsoft.com/office/drawing/2014/main" id="{3C606A2E-0EEF-4A3D-9390-D758BEB42166}"/>
+                <a16:creationId xmlns:a16="http://schemas.microsoft.com/office/drawing/2014/main" id="{E46065E5-9454-4324-9967-20CFF221DAD9}"/>
               </a:ext>
             </a:extLst>
           </p:cNvPr>
@@ -5029,7 +5064,7 @@
           <p:cNvPr id="11" name="">
             <a:extLst xmlns:a="http://schemas.openxmlformats.org/drawingml/2006/main">
               <a:ext uri="{FF2B5EF4-FFF2-40B4-BE49-F238E27FC236}">
-                <a16:creationId xmlns:a16="http://schemas.microsoft.com/office/drawing/2014/main" id="{1777D7A7-7D2A-400F-A2C8-59FA49FE0D54}"/>
+                <a16:creationId xmlns:a16="http://schemas.microsoft.com/office/drawing/2014/main" id="{40FA9E7C-CE15-40D1-BE50-D61E4B1D464C}"/>
               </a:ext>
             </a:extLst>
           </p:cNvPr>
@@ -5091,7 +5126,7 @@
           <p:cNvPr id="12" name="">
             <a:extLst xmlns:a="http://schemas.openxmlformats.org/drawingml/2006/main">
               <a:ext uri="{FF2B5EF4-FFF2-40B4-BE49-F238E27FC236}">
-                <a16:creationId xmlns:a16="http://schemas.microsoft.com/office/drawing/2014/main" id="{04376867-0C00-42A9-83E6-28166B3E897C}"/>
+                <a16:creationId xmlns:a16="http://schemas.microsoft.com/office/drawing/2014/main" id="{AC3D9DE4-BC86-47D9-8295-148949E4CDEE}"/>
               </a:ext>
             </a:extLst>
           </p:cNvPr>
@@ -5153,7 +5188,7 @@
           <p:cNvPr id="13" name="">
             <a:extLst xmlns:a="http://schemas.openxmlformats.org/drawingml/2006/main">
               <a:ext uri="{FF2B5EF4-FFF2-40B4-BE49-F238E27FC236}">
-                <a16:creationId xmlns:a16="http://schemas.microsoft.com/office/drawing/2014/main" id="{77F3ECDA-174F-48A9-B1AA-CA53D8F61E73}"/>
+                <a16:creationId xmlns:a16="http://schemas.microsoft.com/office/drawing/2014/main" id="{AA2D5670-F87A-4485-9952-55D5EB77B8EE}"/>
               </a:ext>
             </a:extLst>
           </p:cNvPr>
@@ -5184,7 +5219,7 @@
           <p:cNvPr id="14" name="">
             <a:extLst xmlns:a="http://schemas.openxmlformats.org/drawingml/2006/main">
               <a:ext uri="{FF2B5EF4-FFF2-40B4-BE49-F238E27FC236}">
-                <a16:creationId xmlns:a16="http://schemas.microsoft.com/office/drawing/2014/main" id="{19C7E749-FB26-4119-9B94-F2347845A67A}"/>
+                <a16:creationId xmlns:a16="http://schemas.microsoft.com/office/drawing/2014/main" id="{743E893A-F78C-4974-87E5-9F6347D80FAC}"/>
               </a:ext>
             </a:extLst>
           </p:cNvPr>
@@ -5246,7 +5281,7 @@
           <p:cNvPr id="15" name="">
             <a:extLst xmlns:a="http://schemas.openxmlformats.org/drawingml/2006/main">
               <a:ext uri="{FF2B5EF4-FFF2-40B4-BE49-F238E27FC236}">
-                <a16:creationId xmlns:a16="http://schemas.microsoft.com/office/drawing/2014/main" id="{2DB32F34-CB38-44F4-94DB-6444EBBA85BB}"/>
+                <a16:creationId xmlns:a16="http://schemas.microsoft.com/office/drawing/2014/main" id="{C5111456-872C-450B-B811-6D56FF057822}"/>
               </a:ext>
             </a:extLst>
           </p:cNvPr>
@@ -5308,7 +5343,7 @@
           <p:cNvPr id="16" name="">
             <a:extLst xmlns:a="http://schemas.openxmlformats.org/drawingml/2006/main">
               <a:ext uri="{FF2B5EF4-FFF2-40B4-BE49-F238E27FC236}">
-                <a16:creationId xmlns:a16="http://schemas.microsoft.com/office/drawing/2014/main" id="{8CFEDC64-BA7F-4A2E-9912-42F022AF04C1}"/>
+                <a16:creationId xmlns:a16="http://schemas.microsoft.com/office/drawing/2014/main" id="{ECF4524E-4FBD-4573-9A51-F8E78D5DBEB7}"/>
               </a:ext>
             </a:extLst>
           </p:cNvPr>
@@ -5370,7 +5405,7 @@
           <p:cNvPr id="17" name="">
             <a:extLst xmlns:a="http://schemas.openxmlformats.org/drawingml/2006/main">
               <a:ext uri="{FF2B5EF4-FFF2-40B4-BE49-F238E27FC236}">
-                <a16:creationId xmlns:a16="http://schemas.microsoft.com/office/drawing/2014/main" id="{B55C6FF7-A675-4425-9CAF-3A54A5F216D0}"/>
+                <a16:creationId xmlns:a16="http://schemas.microsoft.com/office/drawing/2014/main" id="{4BDA3183-26B2-4CED-9671-F2A39FEB09B8}"/>
               </a:ext>
             </a:extLst>
           </p:cNvPr>
@@ -5405,7 +5440,7 @@
           <p:cNvPr id="18" name="">
             <a:extLst xmlns:a="http://schemas.openxmlformats.org/drawingml/2006/main">
               <a:ext uri="{FF2B5EF4-FFF2-40B4-BE49-F238E27FC236}">
-                <a16:creationId xmlns:a16="http://schemas.microsoft.com/office/drawing/2014/main" id="{178378E8-4E86-4386-9252-2C6883CB6446}"/>
+                <a16:creationId xmlns:a16="http://schemas.microsoft.com/office/drawing/2014/main" id="{9941F1E6-7045-4F12-8F25-954410F2A06A}"/>
               </a:ext>
             </a:extLst>
           </p:cNvPr>
@@ -5494,7 +5529,7 @@
           <p:cNvPr id="19" name="footer-rule-11">
             <a:extLst xmlns:a="http://schemas.openxmlformats.org/drawingml/2006/main">
               <a:ext uri="{FF2B5EF4-FFF2-40B4-BE49-F238E27FC236}">
-                <a16:creationId xmlns:a16="http://schemas.microsoft.com/office/drawing/2014/main" id="{ECB33085-38C5-4020-9A48-577252B682B8}"/>
+                <a16:creationId xmlns:a16="http://schemas.microsoft.com/office/drawing/2014/main" id="{984D6D7E-02D2-456C-AF77-86E00A8A1A42}"/>
               </a:ext>
             </a:extLst>
           </p:cNvPr>
@@ -5525,7 +5560,7 @@
           <p:cNvPr id="20" name="footer-label-11">
             <a:extLst xmlns:a="http://schemas.openxmlformats.org/drawingml/2006/main">
               <a:ext uri="{FF2B5EF4-FFF2-40B4-BE49-F238E27FC236}">
-                <a16:creationId xmlns:a16="http://schemas.microsoft.com/office/drawing/2014/main" id="{FC726F7A-E046-485F-946E-DAD7C8242904}"/>
+                <a16:creationId xmlns:a16="http://schemas.microsoft.com/office/drawing/2014/main" id="{63E6C8D5-80DE-4877-A37A-79B5185B8D04}"/>
               </a:ext>
             </a:extLst>
           </p:cNvPr>
@@ -5587,7 +5622,7 @@
           <p:cNvPr id="21" name="footer-page-11">
             <a:extLst xmlns:a="http://schemas.openxmlformats.org/drawingml/2006/main">
               <a:ext uri="{FF2B5EF4-FFF2-40B4-BE49-F238E27FC236}">
-                <a16:creationId xmlns:a16="http://schemas.microsoft.com/office/drawing/2014/main" id="{7916DEB0-97C6-41A4-B351-72D42FCAE349}"/>
+                <a16:creationId xmlns:a16="http://schemas.microsoft.com/office/drawing/2014/main" id="{190E53A6-3270-4E8F-8578-938FA68085D4}"/>
               </a:ext>
             </a:extLst>
           </p:cNvPr>
@@ -5647,7 +5682,7 @@
     </p:spTree>
     <p:extLst>
       <p:ext uri="{BB962C8B-B14F-4D97-AF65-F5344CB8AC3E}">
-        <p14:creationId xmlns:p14="http://schemas.microsoft.com/office/powerpoint/2010/main" val="625551778"/>
+        <p14:creationId xmlns:p14="http://schemas.microsoft.com/office/powerpoint/2010/main" val="431716243"/>
       </p:ext>
     </p:extLst>
   </p:cSld>
@@ -5678,7 +5713,7 @@
           <p:cNvPr id="14" name="side-accent-12">
             <a:extLst xmlns:a="http://schemas.openxmlformats.org/drawingml/2006/main">
               <a:ext uri="{FF2B5EF4-FFF2-40B4-BE49-F238E27FC236}">
-                <a16:creationId xmlns:a16="http://schemas.microsoft.com/office/drawing/2014/main" id="{CE5EDF8C-BA6C-43D0-9D4F-AFA0C80B7736}"/>
+                <a16:creationId xmlns:a16="http://schemas.microsoft.com/office/drawing/2014/main" id="{4113A673-2820-4FD6-AB59-20CF8354F4A7}"/>
               </a:ext>
             </a:extLst>
           </p:cNvPr>
@@ -5709,7 +5744,7 @@
           <p:cNvPr id="2" name="kicker-12">
             <a:extLst xmlns:a="http://schemas.openxmlformats.org/drawingml/2006/main">
               <a:ext uri="{FF2B5EF4-FFF2-40B4-BE49-F238E27FC236}">
-                <a16:creationId xmlns:a16="http://schemas.microsoft.com/office/drawing/2014/main" id="{FF0AE551-BF92-45CD-B416-CC02EFD43F62}"/>
+                <a16:creationId xmlns:a16="http://schemas.microsoft.com/office/drawing/2014/main" id="{447F7D7A-3935-484D-9117-368397CC5F3D}"/>
               </a:ext>
             </a:extLst>
           </p:cNvPr>
@@ -5771,7 +5806,7 @@
           <p:cNvPr id="3" name="title-12">
             <a:extLst xmlns:a="http://schemas.openxmlformats.org/drawingml/2006/main">
               <a:ext uri="{FF2B5EF4-FFF2-40B4-BE49-F238E27FC236}">
-                <a16:creationId xmlns:a16="http://schemas.microsoft.com/office/drawing/2014/main" id="{85121D36-C873-4C40-84DB-6A0ADA725109}"/>
+                <a16:creationId xmlns:a16="http://schemas.microsoft.com/office/drawing/2014/main" id="{203FCF78-FFF1-4CC6-98E5-CCBC7BD51ED6}"/>
               </a:ext>
             </a:extLst>
           </p:cNvPr>
@@ -5833,7 +5868,7 @@
           <p:cNvPr id="4" name="draft-panel">
             <a:extLst xmlns:a="http://schemas.openxmlformats.org/drawingml/2006/main">
               <a:ext uri="{FF2B5EF4-FFF2-40B4-BE49-F238E27FC236}">
-                <a16:creationId xmlns:a16="http://schemas.microsoft.com/office/drawing/2014/main" id="{C6E0E93E-06C7-42AA-9709-13E396401BCA}"/>
+                <a16:creationId xmlns:a16="http://schemas.microsoft.com/office/drawing/2014/main" id="{3EF60557-EF30-409C-A2EE-D89B914B23B9}"/>
               </a:ext>
             </a:extLst>
           </p:cNvPr>
@@ -5868,7 +5903,7 @@
           <p:cNvPr id="5" name="">
             <a:extLst xmlns:a="http://schemas.openxmlformats.org/drawingml/2006/main">
               <a:ext uri="{FF2B5EF4-FFF2-40B4-BE49-F238E27FC236}">
-                <a16:creationId xmlns:a16="http://schemas.microsoft.com/office/drawing/2014/main" id="{79E5B32F-1B81-4F7F-AFA1-F4911F5F8709}"/>
+                <a16:creationId xmlns:a16="http://schemas.microsoft.com/office/drawing/2014/main" id="{34EB6F62-9333-43B7-93A5-28C0EE90BA93}"/>
               </a:ext>
             </a:extLst>
           </p:cNvPr>
@@ -5930,7 +5965,7 @@
           <p:cNvPr id="6" name="">
             <a:extLst xmlns:a="http://schemas.openxmlformats.org/drawingml/2006/main">
               <a:ext uri="{FF2B5EF4-FFF2-40B4-BE49-F238E27FC236}">
-                <a16:creationId xmlns:a16="http://schemas.microsoft.com/office/drawing/2014/main" id="{0104D7FC-AF9C-4F0E-9CA6-907A42BEF344}"/>
+                <a16:creationId xmlns:a16="http://schemas.microsoft.com/office/drawing/2014/main" id="{5CAD1BF1-4F69-421E-B6DA-B207B681E654}"/>
               </a:ext>
             </a:extLst>
           </p:cNvPr>
@@ -6046,7 +6081,7 @@
           <p:cNvPr id="7" name="submit-panel">
             <a:extLst xmlns:a="http://schemas.openxmlformats.org/drawingml/2006/main">
               <a:ext uri="{FF2B5EF4-FFF2-40B4-BE49-F238E27FC236}">
-                <a16:creationId xmlns:a16="http://schemas.microsoft.com/office/drawing/2014/main" id="{B6656F9A-7F52-4243-9D82-4A91E5A057B1}"/>
+                <a16:creationId xmlns:a16="http://schemas.microsoft.com/office/drawing/2014/main" id="{7E11282F-CF76-4A41-ACFD-07AF96839263}"/>
               </a:ext>
             </a:extLst>
           </p:cNvPr>
@@ -6081,7 +6116,7 @@
           <p:cNvPr id="8" name="">
             <a:extLst xmlns:a="http://schemas.openxmlformats.org/drawingml/2006/main">
               <a:ext uri="{FF2B5EF4-FFF2-40B4-BE49-F238E27FC236}">
-                <a16:creationId xmlns:a16="http://schemas.microsoft.com/office/drawing/2014/main" id="{83B8F8AD-D281-4133-AD48-66C6FE1745D3}"/>
+                <a16:creationId xmlns:a16="http://schemas.microsoft.com/office/drawing/2014/main" id="{08A730FD-25AB-48DE-9B0C-C4E76AB6DE13}"/>
               </a:ext>
             </a:extLst>
           </p:cNvPr>
@@ -6143,7 +6178,7 @@
           <p:cNvPr id="9" name="">
             <a:extLst xmlns:a="http://schemas.openxmlformats.org/drawingml/2006/main">
               <a:ext uri="{FF2B5EF4-FFF2-40B4-BE49-F238E27FC236}">
-                <a16:creationId xmlns:a16="http://schemas.microsoft.com/office/drawing/2014/main" id="{87987C12-347B-4DDC-91F3-B5AE9D22A700}"/>
+                <a16:creationId xmlns:a16="http://schemas.microsoft.com/office/drawing/2014/main" id="{D9D90654-26E3-4E28-B9E9-F329EF47A75E}"/>
               </a:ext>
             </a:extLst>
           </p:cNvPr>
@@ -6259,7 +6294,7 @@
           <p:cNvPr id="10" name="">
             <a:extLst xmlns:a="http://schemas.openxmlformats.org/drawingml/2006/main">
               <a:ext uri="{FF2B5EF4-FFF2-40B4-BE49-F238E27FC236}">
-                <a16:creationId xmlns:a16="http://schemas.microsoft.com/office/drawing/2014/main" id="{5E816DD1-8A73-4F01-8872-E34DB06BDD47}"/>
+                <a16:creationId xmlns:a16="http://schemas.microsoft.com/office/drawing/2014/main" id="{76AAE11C-74E2-41A8-9A41-A8FEB886D8B2}"/>
               </a:ext>
             </a:extLst>
           </p:cNvPr>
@@ -6321,7 +6356,7 @@
           <p:cNvPr id="11" name="footer-rule-12">
             <a:extLst xmlns:a="http://schemas.openxmlformats.org/drawingml/2006/main">
               <a:ext uri="{FF2B5EF4-FFF2-40B4-BE49-F238E27FC236}">
-                <a16:creationId xmlns:a16="http://schemas.microsoft.com/office/drawing/2014/main" id="{3E143C96-9793-4BE7-A0B8-DADA9E4D6154}"/>
+                <a16:creationId xmlns:a16="http://schemas.microsoft.com/office/drawing/2014/main" id="{E9FC191C-C444-493C-815F-8A65BBAE11AF}"/>
               </a:ext>
             </a:extLst>
           </p:cNvPr>
@@ -6352,7 +6387,7 @@
           <p:cNvPr id="12" name="footer-label-12">
             <a:extLst xmlns:a="http://schemas.openxmlformats.org/drawingml/2006/main">
               <a:ext uri="{FF2B5EF4-FFF2-40B4-BE49-F238E27FC236}">
-                <a16:creationId xmlns:a16="http://schemas.microsoft.com/office/drawing/2014/main" id="{1A96F4BC-C76C-4EE5-AD24-B777E72A294F}"/>
+                <a16:creationId xmlns:a16="http://schemas.microsoft.com/office/drawing/2014/main" id="{1F0C3F1D-62A7-4B46-8115-57DD0A86EA3B}"/>
               </a:ext>
             </a:extLst>
           </p:cNvPr>
@@ -6414,7 +6449,7 @@
           <p:cNvPr id="13" name="footer-page-12">
             <a:extLst xmlns:a="http://schemas.openxmlformats.org/drawingml/2006/main">
               <a:ext uri="{FF2B5EF4-FFF2-40B4-BE49-F238E27FC236}">
-                <a16:creationId xmlns:a16="http://schemas.microsoft.com/office/drawing/2014/main" id="{3785749E-FD17-4407-BB59-5DE772573ACE}"/>
+                <a16:creationId xmlns:a16="http://schemas.microsoft.com/office/drawing/2014/main" id="{562736BC-B03C-43E5-AE79-6C491B2FB414}"/>
               </a:ext>
             </a:extLst>
           </p:cNvPr>
@@ -6474,7 +6509,7 @@
     </p:spTree>
     <p:extLst>
       <p:ext uri="{BB962C8B-B14F-4D97-AF65-F5344CB8AC3E}">
-        <p14:creationId xmlns:p14="http://schemas.microsoft.com/office/powerpoint/2010/main" val="1456232372"/>
+        <p14:creationId xmlns:p14="http://schemas.microsoft.com/office/powerpoint/2010/main" val="2137468876"/>
       </p:ext>
     </p:extLst>
   </p:cSld>
@@ -6505,7 +6540,7 @@
           <p:cNvPr id="25" name="side-accent-13">
             <a:extLst xmlns:a="http://schemas.openxmlformats.org/drawingml/2006/main">
               <a:ext uri="{FF2B5EF4-FFF2-40B4-BE49-F238E27FC236}">
-                <a16:creationId xmlns:a16="http://schemas.microsoft.com/office/drawing/2014/main" id="{A95327C1-119B-4BBD-8E7E-99F3D5922955}"/>
+                <a16:creationId xmlns:a16="http://schemas.microsoft.com/office/drawing/2014/main" id="{D9625589-91E1-42B5-BD53-BE185759840E}"/>
               </a:ext>
             </a:extLst>
           </p:cNvPr>
@@ -6536,7 +6571,7 @@
           <p:cNvPr id="2" name="kicker-13">
             <a:extLst xmlns:a="http://schemas.openxmlformats.org/drawingml/2006/main">
               <a:ext uri="{FF2B5EF4-FFF2-40B4-BE49-F238E27FC236}">
-                <a16:creationId xmlns:a16="http://schemas.microsoft.com/office/drawing/2014/main" id="{97996D9B-B233-4A1C-995D-AFE7F665B8B2}"/>
+                <a16:creationId xmlns:a16="http://schemas.microsoft.com/office/drawing/2014/main" id="{BBD551B3-B405-48FF-92B7-7DD6652AA0CA}"/>
               </a:ext>
             </a:extLst>
           </p:cNvPr>
@@ -6598,7 +6633,7 @@
           <p:cNvPr id="3" name="title-13">
             <a:extLst xmlns:a="http://schemas.openxmlformats.org/drawingml/2006/main">
               <a:ext uri="{FF2B5EF4-FFF2-40B4-BE49-F238E27FC236}">
-                <a16:creationId xmlns:a16="http://schemas.microsoft.com/office/drawing/2014/main" id="{8748D4B5-30B8-4A4C-A464-2EBCC6C2EC6F}"/>
+                <a16:creationId xmlns:a16="http://schemas.microsoft.com/office/drawing/2014/main" id="{4DBA0593-42DA-4645-BC7A-0B5DA9F4224D}"/>
               </a:ext>
             </a:extLst>
           </p:cNvPr>
@@ -6660,7 +6695,7 @@
           <p:cNvPr id="4" name="">
             <a:extLst xmlns:a="http://schemas.openxmlformats.org/drawingml/2006/main">
               <a:ext uri="{FF2B5EF4-FFF2-40B4-BE49-F238E27FC236}">
-                <a16:creationId xmlns:a16="http://schemas.microsoft.com/office/drawing/2014/main" id="{E1BE7F93-D0EB-413A-8196-27EC38D917F6}"/>
+                <a16:creationId xmlns:a16="http://schemas.microsoft.com/office/drawing/2014/main" id="{A0F38E97-5B95-45BC-A0B7-07578D8CBA56}"/>
               </a:ext>
             </a:extLst>
           </p:cNvPr>
@@ -6691,7 +6726,7 @@
           <p:cNvPr id="5" name="">
             <a:extLst xmlns:a="http://schemas.openxmlformats.org/drawingml/2006/main">
               <a:ext uri="{FF2B5EF4-FFF2-40B4-BE49-F238E27FC236}">
-                <a16:creationId xmlns:a16="http://schemas.microsoft.com/office/drawing/2014/main" id="{DE688A35-DEBC-4C22-B713-1D8EA090A474}"/>
+                <a16:creationId xmlns:a16="http://schemas.microsoft.com/office/drawing/2014/main" id="{514C1BD5-B898-4FB7-8682-D156B5203EE0}"/>
               </a:ext>
             </a:extLst>
           </p:cNvPr>
@@ -6722,7 +6757,7 @@
           <p:cNvPr id="6" name="">
             <a:extLst xmlns:a="http://schemas.openxmlformats.org/drawingml/2006/main">
               <a:ext uri="{FF2B5EF4-FFF2-40B4-BE49-F238E27FC236}">
-                <a16:creationId xmlns:a16="http://schemas.microsoft.com/office/drawing/2014/main" id="{A522E588-E7B0-40F5-809A-5FC419223CB0}"/>
+                <a16:creationId xmlns:a16="http://schemas.microsoft.com/office/drawing/2014/main" id="{E492E348-1FA1-440E-AD1A-98E25C8C6356}"/>
               </a:ext>
             </a:extLst>
           </p:cNvPr>
@@ -6784,7 +6819,7 @@
           <p:cNvPr id="7" name="">
             <a:extLst xmlns:a="http://schemas.openxmlformats.org/drawingml/2006/main">
               <a:ext uri="{FF2B5EF4-FFF2-40B4-BE49-F238E27FC236}">
-                <a16:creationId xmlns:a16="http://schemas.microsoft.com/office/drawing/2014/main" id="{C4DA91F4-561C-460A-9A9E-0130BFCAC3EF}"/>
+                <a16:creationId xmlns:a16="http://schemas.microsoft.com/office/drawing/2014/main" id="{4CE29542-62C7-4247-A036-E272A0385690}"/>
               </a:ext>
             </a:extLst>
           </p:cNvPr>
@@ -6846,7 +6881,7 @@
           <p:cNvPr id="8" name="">
             <a:extLst xmlns:a="http://schemas.openxmlformats.org/drawingml/2006/main">
               <a:ext uri="{FF2B5EF4-FFF2-40B4-BE49-F238E27FC236}">
-                <a16:creationId xmlns:a16="http://schemas.microsoft.com/office/drawing/2014/main" id="{911D346C-B280-48E1-811A-E88B9C01FBFA}"/>
+                <a16:creationId xmlns:a16="http://schemas.microsoft.com/office/drawing/2014/main" id="{BB4F0317-93EE-444E-9550-E06797976BEB}"/>
               </a:ext>
             </a:extLst>
           </p:cNvPr>
@@ -6908,7 +6943,7 @@
           <p:cNvPr id="9" name="">
             <a:extLst xmlns:a="http://schemas.openxmlformats.org/drawingml/2006/main">
               <a:ext uri="{FF2B5EF4-FFF2-40B4-BE49-F238E27FC236}">
-                <a16:creationId xmlns:a16="http://schemas.microsoft.com/office/drawing/2014/main" id="{B9BAA831-F18F-496F-B320-59B889A8B96E}"/>
+                <a16:creationId xmlns:a16="http://schemas.microsoft.com/office/drawing/2014/main" id="{AEDB6AFD-74E7-4680-8DDE-A1A61064CF40}"/>
               </a:ext>
             </a:extLst>
           </p:cNvPr>
@@ -6939,7 +6974,7 @@
           <p:cNvPr id="10" name="">
             <a:extLst xmlns:a="http://schemas.openxmlformats.org/drawingml/2006/main">
               <a:ext uri="{FF2B5EF4-FFF2-40B4-BE49-F238E27FC236}">
-                <a16:creationId xmlns:a16="http://schemas.microsoft.com/office/drawing/2014/main" id="{EE093179-3DBB-46A3-B653-83DBABCD469B}"/>
+                <a16:creationId xmlns:a16="http://schemas.microsoft.com/office/drawing/2014/main" id="{5DFE5673-5151-4144-9F4B-52719685BD46}"/>
               </a:ext>
             </a:extLst>
           </p:cNvPr>
@@ -7001,7 +7036,7 @@
           <p:cNvPr id="11" name="">
             <a:extLst xmlns:a="http://schemas.openxmlformats.org/drawingml/2006/main">
               <a:ext uri="{FF2B5EF4-FFF2-40B4-BE49-F238E27FC236}">
-                <a16:creationId xmlns:a16="http://schemas.microsoft.com/office/drawing/2014/main" id="{6011E26E-85B0-44F3-9BA8-3EDE824BEBA7}"/>
+                <a16:creationId xmlns:a16="http://schemas.microsoft.com/office/drawing/2014/main" id="{5BE3FE00-159E-41C4-AC63-5CF079410990}"/>
               </a:ext>
             </a:extLst>
           </p:cNvPr>
@@ -7063,7 +7098,7 @@
           <p:cNvPr id="12" name="">
             <a:extLst xmlns:a="http://schemas.openxmlformats.org/drawingml/2006/main">
               <a:ext uri="{FF2B5EF4-FFF2-40B4-BE49-F238E27FC236}">
-                <a16:creationId xmlns:a16="http://schemas.microsoft.com/office/drawing/2014/main" id="{4368F111-A11B-48A5-9959-47BE2B82B628}"/>
+                <a16:creationId xmlns:a16="http://schemas.microsoft.com/office/drawing/2014/main" id="{1CFB2BFB-68AE-48C9-A8D6-11BF8F3BF55E}"/>
               </a:ext>
             </a:extLst>
           </p:cNvPr>
@@ -7125,7 +7160,7 @@
           <p:cNvPr id="13" name="">
             <a:extLst xmlns:a="http://schemas.openxmlformats.org/drawingml/2006/main">
               <a:ext uri="{FF2B5EF4-FFF2-40B4-BE49-F238E27FC236}">
-                <a16:creationId xmlns:a16="http://schemas.microsoft.com/office/drawing/2014/main" id="{D92B9BB6-2590-4A1A-806E-DAB4528F1DEF}"/>
+                <a16:creationId xmlns:a16="http://schemas.microsoft.com/office/drawing/2014/main" id="{872DF7DF-2AED-4DAF-8E1E-47B88ED9D052}"/>
               </a:ext>
             </a:extLst>
           </p:cNvPr>
@@ -7156,7 +7191,7 @@
           <p:cNvPr id="14" name="">
             <a:extLst xmlns:a="http://schemas.openxmlformats.org/drawingml/2006/main">
               <a:ext uri="{FF2B5EF4-FFF2-40B4-BE49-F238E27FC236}">
-                <a16:creationId xmlns:a16="http://schemas.microsoft.com/office/drawing/2014/main" id="{9590A63D-0AD4-4071-88EB-080DB6F4A8E7}"/>
+                <a16:creationId xmlns:a16="http://schemas.microsoft.com/office/drawing/2014/main" id="{FDF806A2-0086-4B80-B381-08F63B9046A6}"/>
               </a:ext>
             </a:extLst>
           </p:cNvPr>
@@ -7218,7 +7253,7 @@
           <p:cNvPr id="15" name="">
             <a:extLst xmlns:a="http://schemas.openxmlformats.org/drawingml/2006/main">
               <a:ext uri="{FF2B5EF4-FFF2-40B4-BE49-F238E27FC236}">
-                <a16:creationId xmlns:a16="http://schemas.microsoft.com/office/drawing/2014/main" id="{A97EA03D-1E41-421E-9D0D-C784DFDAC7D2}"/>
+                <a16:creationId xmlns:a16="http://schemas.microsoft.com/office/drawing/2014/main" id="{89D78B69-3F33-4AC5-9BB8-650C06BEA158}"/>
               </a:ext>
             </a:extLst>
           </p:cNvPr>
@@ -7280,7 +7315,7 @@
           <p:cNvPr id="16" name="">
             <a:extLst xmlns:a="http://schemas.openxmlformats.org/drawingml/2006/main">
               <a:ext uri="{FF2B5EF4-FFF2-40B4-BE49-F238E27FC236}">
-                <a16:creationId xmlns:a16="http://schemas.microsoft.com/office/drawing/2014/main" id="{3185C4CD-AE51-46B9-AE2E-CA165D68BA73}"/>
+                <a16:creationId xmlns:a16="http://schemas.microsoft.com/office/drawing/2014/main" id="{9371768B-344D-41F2-9EAE-59A158B837C4}"/>
               </a:ext>
             </a:extLst>
           </p:cNvPr>
@@ -7342,7 +7377,7 @@
           <p:cNvPr id="17" name="">
             <a:extLst xmlns:a="http://schemas.openxmlformats.org/drawingml/2006/main">
               <a:ext uri="{FF2B5EF4-FFF2-40B4-BE49-F238E27FC236}">
-                <a16:creationId xmlns:a16="http://schemas.microsoft.com/office/drawing/2014/main" id="{0BD77E96-C317-43E9-A080-D108BDCC301D}"/>
+                <a16:creationId xmlns:a16="http://schemas.microsoft.com/office/drawing/2014/main" id="{1546DF71-032C-465B-8761-BB47D1ED84AF}"/>
               </a:ext>
             </a:extLst>
           </p:cNvPr>
@@ -7373,7 +7408,7 @@
           <p:cNvPr id="18" name="">
             <a:extLst xmlns:a="http://schemas.openxmlformats.org/drawingml/2006/main">
               <a:ext uri="{FF2B5EF4-FFF2-40B4-BE49-F238E27FC236}">
-                <a16:creationId xmlns:a16="http://schemas.microsoft.com/office/drawing/2014/main" id="{D85558C6-5F96-487D-9BFA-93811EAD155B}"/>
+                <a16:creationId xmlns:a16="http://schemas.microsoft.com/office/drawing/2014/main" id="{2AE84B8B-C6EA-46C5-A464-B5F36A56FEB7}"/>
               </a:ext>
             </a:extLst>
           </p:cNvPr>
@@ -7435,7 +7470,7 @@
           <p:cNvPr id="19" name="">
             <a:extLst xmlns:a="http://schemas.openxmlformats.org/drawingml/2006/main">
               <a:ext uri="{FF2B5EF4-FFF2-40B4-BE49-F238E27FC236}">
-                <a16:creationId xmlns:a16="http://schemas.microsoft.com/office/drawing/2014/main" id="{6BA7EF6A-DCF9-4B60-B205-92740822CD14}"/>
+                <a16:creationId xmlns:a16="http://schemas.microsoft.com/office/drawing/2014/main" id="{9A025E8F-DA8F-47A1-AF39-F1044558A4F9}"/>
               </a:ext>
             </a:extLst>
           </p:cNvPr>
@@ -7487,7 +7522,7 @@
                 <a:ea typeface="Tahoma"/>
                 <a:cs typeface="Tahoma"/>
               </a:rPr>
-              <a:t>ปิดงาน</a:t>
+              <a:t>ยืนยันขั้นสุดท้าย</a:t>
             </a:r>
           </a:p>
         </p:txBody>
@@ -7497,7 +7532,7 @@
           <p:cNvPr id="20" name="">
             <a:extLst xmlns:a="http://schemas.openxmlformats.org/drawingml/2006/main">
               <a:ext uri="{FF2B5EF4-FFF2-40B4-BE49-F238E27FC236}">
-                <a16:creationId xmlns:a16="http://schemas.microsoft.com/office/drawing/2014/main" id="{310C93BC-3762-4E44-9187-DCE83D46B710}"/>
+                <a16:creationId xmlns:a16="http://schemas.microsoft.com/office/drawing/2014/main" id="{A7044C8D-4753-4BA5-9827-DBF290D30D0B}"/>
               </a:ext>
             </a:extLst>
           </p:cNvPr>
@@ -7549,7 +7584,7 @@
                 <a:ea typeface="Tahoma"/>
                 <a:cs typeface="Tahoma"/>
               </a:rPr>
-              <a:t>เมื่อเป็นผู้ประเมินคนสุดท้าย</a:t>
+              <a:t>เมื่ออยู่ในลำดับสุดท้าย</a:t>
             </a:r>
           </a:p>
         </p:txBody>
@@ -7559,7 +7594,7 @@
           <p:cNvPr id="21" name="">
             <a:extLst xmlns:a="http://schemas.openxmlformats.org/drawingml/2006/main">
               <a:ext uri="{FF2B5EF4-FFF2-40B4-BE49-F238E27FC236}">
-                <a16:creationId xmlns:a16="http://schemas.microsoft.com/office/drawing/2014/main" id="{6F35FE72-D085-4E80-87BA-D75A7FC28CCE}"/>
+                <a16:creationId xmlns:a16="http://schemas.microsoft.com/office/drawing/2014/main" id="{3A2D4558-C2A0-41B5-85AC-2D2A24829BD3}"/>
               </a:ext>
             </a:extLst>
           </p:cNvPr>
@@ -7621,7 +7656,7 @@
           <p:cNvPr id="22" name="footer-rule-13">
             <a:extLst xmlns:a="http://schemas.openxmlformats.org/drawingml/2006/main">
               <a:ext uri="{FF2B5EF4-FFF2-40B4-BE49-F238E27FC236}">
-                <a16:creationId xmlns:a16="http://schemas.microsoft.com/office/drawing/2014/main" id="{D97228D2-CF8B-42DB-8FDD-C475749C573A}"/>
+                <a16:creationId xmlns:a16="http://schemas.microsoft.com/office/drawing/2014/main" id="{A41F8105-68A5-4A8C-B630-6B5DE38F879B}"/>
               </a:ext>
             </a:extLst>
           </p:cNvPr>
@@ -7652,7 +7687,7 @@
           <p:cNvPr id="23" name="footer-label-13">
             <a:extLst xmlns:a="http://schemas.openxmlformats.org/drawingml/2006/main">
               <a:ext uri="{FF2B5EF4-FFF2-40B4-BE49-F238E27FC236}">
-                <a16:creationId xmlns:a16="http://schemas.microsoft.com/office/drawing/2014/main" id="{D968E51C-4D1F-4914-86E4-08B3BAF9C5F2}"/>
+                <a16:creationId xmlns:a16="http://schemas.microsoft.com/office/drawing/2014/main" id="{21985A8A-9F26-4551-B1F5-84B945BF3B4A}"/>
               </a:ext>
             </a:extLst>
           </p:cNvPr>
@@ -7714,7 +7749,7 @@
           <p:cNvPr id="24" name="footer-page-13">
             <a:extLst xmlns:a="http://schemas.openxmlformats.org/drawingml/2006/main">
               <a:ext uri="{FF2B5EF4-FFF2-40B4-BE49-F238E27FC236}">
-                <a16:creationId xmlns:a16="http://schemas.microsoft.com/office/drawing/2014/main" id="{8A6A3EC7-EF5F-4393-BFF1-DD2D2366BB18}"/>
+                <a16:creationId xmlns:a16="http://schemas.microsoft.com/office/drawing/2014/main" id="{C29476E7-4348-4C31-AEE9-48582EB2F709}"/>
               </a:ext>
             </a:extLst>
           </p:cNvPr>
@@ -7774,7 +7809,7 @@
     </p:spTree>
     <p:extLst>
       <p:ext uri="{BB962C8B-B14F-4D97-AF65-F5344CB8AC3E}">
-        <p14:creationId xmlns:p14="http://schemas.microsoft.com/office/powerpoint/2010/main" val="1301108603"/>
+        <p14:creationId xmlns:p14="http://schemas.microsoft.com/office/powerpoint/2010/main" val="11830988"/>
       </p:ext>
     </p:extLst>
   </p:cSld>
@@ -7805,7 +7840,7 @@
           <p:cNvPr id="24" name="side-accent-14">
             <a:extLst xmlns:a="http://schemas.openxmlformats.org/drawingml/2006/main">
               <a:ext uri="{FF2B5EF4-FFF2-40B4-BE49-F238E27FC236}">
-                <a16:creationId xmlns:a16="http://schemas.microsoft.com/office/drawing/2014/main" id="{DD2CF9C4-BDD9-459D-9EF7-3D8D65051F92}"/>
+                <a16:creationId xmlns:a16="http://schemas.microsoft.com/office/drawing/2014/main" id="{E7E61249-37B3-44DD-8CD9-E25BAA75A473}"/>
               </a:ext>
             </a:extLst>
           </p:cNvPr>
@@ -7836,7 +7871,7 @@
           <p:cNvPr id="2" name="kicker-14">
             <a:extLst xmlns:a="http://schemas.openxmlformats.org/drawingml/2006/main">
               <a:ext uri="{FF2B5EF4-FFF2-40B4-BE49-F238E27FC236}">
-                <a16:creationId xmlns:a16="http://schemas.microsoft.com/office/drawing/2014/main" id="{34D7ADAC-B11F-46B9-88D2-B1A627B65D3C}"/>
+                <a16:creationId xmlns:a16="http://schemas.microsoft.com/office/drawing/2014/main" id="{BEE148F4-9D10-46FA-8C02-3CFE8C4F73D2}"/>
               </a:ext>
             </a:extLst>
           </p:cNvPr>
@@ -7898,7 +7933,7 @@
           <p:cNvPr id="3" name="title-14">
             <a:extLst xmlns:a="http://schemas.openxmlformats.org/drawingml/2006/main">
               <a:ext uri="{FF2B5EF4-FFF2-40B4-BE49-F238E27FC236}">
-                <a16:creationId xmlns:a16="http://schemas.microsoft.com/office/drawing/2014/main" id="{85A71818-E03F-4EE2-8C4C-162703B80185}"/>
+                <a16:creationId xmlns:a16="http://schemas.microsoft.com/office/drawing/2014/main" id="{2FBF3238-067C-4ED6-9332-2778C9F82473}"/>
               </a:ext>
             </a:extLst>
           </p:cNvPr>
@@ -7960,7 +7995,7 @@
           <p:cNvPr id="4" name="">
             <a:extLst xmlns:a="http://schemas.openxmlformats.org/drawingml/2006/main">
               <a:ext uri="{FF2B5EF4-FFF2-40B4-BE49-F238E27FC236}">
-                <a16:creationId xmlns:a16="http://schemas.microsoft.com/office/drawing/2014/main" id="{C6585A16-2622-424F-95F4-EEA21B9A6218}"/>
+                <a16:creationId xmlns:a16="http://schemas.microsoft.com/office/drawing/2014/main" id="{23DDE482-5C1D-4E41-92AE-10FCAAD513EE}"/>
               </a:ext>
             </a:extLst>
           </p:cNvPr>
@@ -8022,7 +8057,7 @@
           <p:cNvPr id="5" name="">
             <a:extLst xmlns:a="http://schemas.openxmlformats.org/drawingml/2006/main">
               <a:ext uri="{FF2B5EF4-FFF2-40B4-BE49-F238E27FC236}">
-                <a16:creationId xmlns:a16="http://schemas.microsoft.com/office/drawing/2014/main" id="{8E3FFA7D-E241-4F92-9230-85B061F205E4}"/>
+                <a16:creationId xmlns:a16="http://schemas.microsoft.com/office/drawing/2014/main" id="{896010E4-AA49-4ACA-B1F6-C5B85E91267D}"/>
               </a:ext>
             </a:extLst>
           </p:cNvPr>
@@ -8084,7 +8119,7 @@
           <p:cNvPr id="6" name="">
             <a:extLst xmlns:a="http://schemas.openxmlformats.org/drawingml/2006/main">
               <a:ext uri="{FF2B5EF4-FFF2-40B4-BE49-F238E27FC236}">
-                <a16:creationId xmlns:a16="http://schemas.microsoft.com/office/drawing/2014/main" id="{448D3FFC-24BC-4F3F-B6DD-802EEFED659B}"/>
+                <a16:creationId xmlns:a16="http://schemas.microsoft.com/office/drawing/2014/main" id="{7147E208-0B78-4A45-9220-D9A0685DA07A}"/>
               </a:ext>
             </a:extLst>
           </p:cNvPr>
@@ -8146,7 +8181,7 @@
           <p:cNvPr id="7" name="">
             <a:extLst xmlns:a="http://schemas.openxmlformats.org/drawingml/2006/main">
               <a:ext uri="{FF2B5EF4-FFF2-40B4-BE49-F238E27FC236}">
-                <a16:creationId xmlns:a16="http://schemas.microsoft.com/office/drawing/2014/main" id="{75E8E096-7A55-4C86-A347-034AB71A7AFB}"/>
+                <a16:creationId xmlns:a16="http://schemas.microsoft.com/office/drawing/2014/main" id="{9CCBB400-82D2-4EBC-9AD5-51FB9291F958}"/>
               </a:ext>
             </a:extLst>
           </p:cNvPr>
@@ -8177,7 +8212,7 @@
           <p:cNvPr id="8" name="">
             <a:extLst xmlns:a="http://schemas.openxmlformats.org/drawingml/2006/main">
               <a:ext uri="{FF2B5EF4-FFF2-40B4-BE49-F238E27FC236}">
-                <a16:creationId xmlns:a16="http://schemas.microsoft.com/office/drawing/2014/main" id="{B4F595B5-DA5E-4E8A-ADFB-8CBF11F54DDB}"/>
+                <a16:creationId xmlns:a16="http://schemas.microsoft.com/office/drawing/2014/main" id="{9ECB5CDF-65BA-4E5D-9815-4673263F5E63}"/>
               </a:ext>
             </a:extLst>
           </p:cNvPr>
@@ -8239,7 +8274,7 @@
           <p:cNvPr id="9" name="">
             <a:extLst xmlns:a="http://schemas.openxmlformats.org/drawingml/2006/main">
               <a:ext uri="{FF2B5EF4-FFF2-40B4-BE49-F238E27FC236}">
-                <a16:creationId xmlns:a16="http://schemas.microsoft.com/office/drawing/2014/main" id="{28C3CCDD-339E-4EF7-9FBE-9C1129970D69}"/>
+                <a16:creationId xmlns:a16="http://schemas.microsoft.com/office/drawing/2014/main" id="{A0456426-970C-445C-8DA1-AAC5481CA5BA}"/>
               </a:ext>
             </a:extLst>
           </p:cNvPr>
@@ -8301,7 +8336,7 @@
           <p:cNvPr id="10" name="">
             <a:extLst xmlns:a="http://schemas.openxmlformats.org/drawingml/2006/main">
               <a:ext uri="{FF2B5EF4-FFF2-40B4-BE49-F238E27FC236}">
-                <a16:creationId xmlns:a16="http://schemas.microsoft.com/office/drawing/2014/main" id="{82C0201D-13B3-418D-9131-57DD12B4B3FE}"/>
+                <a16:creationId xmlns:a16="http://schemas.microsoft.com/office/drawing/2014/main" id="{AEA78C8F-EAA9-449A-B8DB-3A1D34163F55}"/>
               </a:ext>
             </a:extLst>
           </p:cNvPr>
@@ -8363,7 +8398,7 @@
           <p:cNvPr id="11" name="">
             <a:extLst xmlns:a="http://schemas.openxmlformats.org/drawingml/2006/main">
               <a:ext uri="{FF2B5EF4-FFF2-40B4-BE49-F238E27FC236}">
-                <a16:creationId xmlns:a16="http://schemas.microsoft.com/office/drawing/2014/main" id="{1B193EE9-F1EA-431A-8972-3791ADC77FE9}"/>
+                <a16:creationId xmlns:a16="http://schemas.microsoft.com/office/drawing/2014/main" id="{25CD10ED-9841-4367-9E7E-B0E57FB383F1}"/>
               </a:ext>
             </a:extLst>
           </p:cNvPr>
@@ -8394,7 +8429,7 @@
           <p:cNvPr id="12" name="">
             <a:extLst xmlns:a="http://schemas.openxmlformats.org/drawingml/2006/main">
               <a:ext uri="{FF2B5EF4-FFF2-40B4-BE49-F238E27FC236}">
-                <a16:creationId xmlns:a16="http://schemas.microsoft.com/office/drawing/2014/main" id="{5E2AE5FA-9C87-4965-B92D-2D049C049290}"/>
+                <a16:creationId xmlns:a16="http://schemas.microsoft.com/office/drawing/2014/main" id="{4CF7E23B-5B7B-475E-B2FE-4D928C7B0087}"/>
               </a:ext>
             </a:extLst>
           </p:cNvPr>
@@ -8456,7 +8491,7 @@
           <p:cNvPr id="13" name="">
             <a:extLst xmlns:a="http://schemas.openxmlformats.org/drawingml/2006/main">
               <a:ext uri="{FF2B5EF4-FFF2-40B4-BE49-F238E27FC236}">
-                <a16:creationId xmlns:a16="http://schemas.microsoft.com/office/drawing/2014/main" id="{37D8F55A-D7F7-4EC9-885F-5A3339F1D51C}"/>
+                <a16:creationId xmlns:a16="http://schemas.microsoft.com/office/drawing/2014/main" id="{370B4D10-8229-4A38-AF27-8FC3B2C318FB}"/>
               </a:ext>
             </a:extLst>
           </p:cNvPr>
@@ -8518,7 +8553,7 @@
           <p:cNvPr id="14" name="">
             <a:extLst xmlns:a="http://schemas.openxmlformats.org/drawingml/2006/main">
               <a:ext uri="{FF2B5EF4-FFF2-40B4-BE49-F238E27FC236}">
-                <a16:creationId xmlns:a16="http://schemas.microsoft.com/office/drawing/2014/main" id="{D4B6E7B3-BCA1-450C-9D36-0EC21398EE93}"/>
+                <a16:creationId xmlns:a16="http://schemas.microsoft.com/office/drawing/2014/main" id="{86547992-9363-4C81-B97C-7AB1C73A12B0}"/>
               </a:ext>
             </a:extLst>
           </p:cNvPr>
@@ -8580,7 +8615,7 @@
           <p:cNvPr id="15" name="">
             <a:extLst xmlns:a="http://schemas.openxmlformats.org/drawingml/2006/main">
               <a:ext uri="{FF2B5EF4-FFF2-40B4-BE49-F238E27FC236}">
-                <a16:creationId xmlns:a16="http://schemas.microsoft.com/office/drawing/2014/main" id="{C42E0063-B19A-4015-9232-23EC5367F94C}"/>
+                <a16:creationId xmlns:a16="http://schemas.microsoft.com/office/drawing/2014/main" id="{F3B85ED3-45D0-4DF7-A56D-FEA685D634F0}"/>
               </a:ext>
             </a:extLst>
           </p:cNvPr>
@@ -8611,7 +8646,7 @@
           <p:cNvPr id="16" name="">
             <a:extLst xmlns:a="http://schemas.openxmlformats.org/drawingml/2006/main">
               <a:ext uri="{FF2B5EF4-FFF2-40B4-BE49-F238E27FC236}">
-                <a16:creationId xmlns:a16="http://schemas.microsoft.com/office/drawing/2014/main" id="{AED389A7-F2F5-485D-8251-81F40DCB231E}"/>
+                <a16:creationId xmlns:a16="http://schemas.microsoft.com/office/drawing/2014/main" id="{9CF818E3-94C7-4597-BCB3-062AE8E325CA}"/>
               </a:ext>
             </a:extLst>
           </p:cNvPr>
@@ -8673,7 +8708,7 @@
           <p:cNvPr id="17" name="">
             <a:extLst xmlns:a="http://schemas.openxmlformats.org/drawingml/2006/main">
               <a:ext uri="{FF2B5EF4-FFF2-40B4-BE49-F238E27FC236}">
-                <a16:creationId xmlns:a16="http://schemas.microsoft.com/office/drawing/2014/main" id="{F94EA714-C0D7-4407-AE63-557916E91265}"/>
+                <a16:creationId xmlns:a16="http://schemas.microsoft.com/office/drawing/2014/main" id="{B7346C92-179F-4428-B4F0-097ADA824B15}"/>
               </a:ext>
             </a:extLst>
           </p:cNvPr>
@@ -8735,7 +8770,7 @@
           <p:cNvPr id="18" name="">
             <a:extLst xmlns:a="http://schemas.openxmlformats.org/drawingml/2006/main">
               <a:ext uri="{FF2B5EF4-FFF2-40B4-BE49-F238E27FC236}">
-                <a16:creationId xmlns:a16="http://schemas.microsoft.com/office/drawing/2014/main" id="{15EF1225-DD40-454A-AF8D-09BB56D37100}"/>
+                <a16:creationId xmlns:a16="http://schemas.microsoft.com/office/drawing/2014/main" id="{4B4EA409-4339-4C37-B7C4-83FB1FFDE149}"/>
               </a:ext>
             </a:extLst>
           </p:cNvPr>
@@ -8797,7 +8832,7 @@
           <p:cNvPr id="19" name="">
             <a:extLst xmlns:a="http://schemas.openxmlformats.org/drawingml/2006/main">
               <a:ext uri="{FF2B5EF4-FFF2-40B4-BE49-F238E27FC236}">
-                <a16:creationId xmlns:a16="http://schemas.microsoft.com/office/drawing/2014/main" id="{E22F7152-9BF8-4076-966F-6B78E0824B5A}"/>
+                <a16:creationId xmlns:a16="http://schemas.microsoft.com/office/drawing/2014/main" id="{D005060F-71BB-454F-A5A4-38A9435AAC5E}"/>
               </a:ext>
             </a:extLst>
           </p:cNvPr>
@@ -8830,7 +8865,7 @@
           <p:cNvPr id="20" name="">
             <a:extLst xmlns:a="http://schemas.openxmlformats.org/drawingml/2006/main">
               <a:ext uri="{FF2B5EF4-FFF2-40B4-BE49-F238E27FC236}">
-                <a16:creationId xmlns:a16="http://schemas.microsoft.com/office/drawing/2014/main" id="{6F0FCC07-F458-477D-9393-53B28231DD38}"/>
+                <a16:creationId xmlns:a16="http://schemas.microsoft.com/office/drawing/2014/main" id="{10E49677-5A81-4F99-A204-27409B808362}"/>
               </a:ext>
             </a:extLst>
           </p:cNvPr>
@@ -8892,7 +8927,7 @@
           <p:cNvPr id="21" name="footer-rule-14">
             <a:extLst xmlns:a="http://schemas.openxmlformats.org/drawingml/2006/main">
               <a:ext uri="{FF2B5EF4-FFF2-40B4-BE49-F238E27FC236}">
-                <a16:creationId xmlns:a16="http://schemas.microsoft.com/office/drawing/2014/main" id="{09A2B17F-31CF-426D-B070-4300B4E7C859}"/>
+                <a16:creationId xmlns:a16="http://schemas.microsoft.com/office/drawing/2014/main" id="{8130C154-D678-4D5F-90B9-D3244C2EC448}"/>
               </a:ext>
             </a:extLst>
           </p:cNvPr>
@@ -8923,7 +8958,7 @@
           <p:cNvPr id="22" name="footer-label-14">
             <a:extLst xmlns:a="http://schemas.openxmlformats.org/drawingml/2006/main">
               <a:ext uri="{FF2B5EF4-FFF2-40B4-BE49-F238E27FC236}">
-                <a16:creationId xmlns:a16="http://schemas.microsoft.com/office/drawing/2014/main" id="{CAD364FB-FE66-4EBA-A48C-1DCB0068043B}"/>
+                <a16:creationId xmlns:a16="http://schemas.microsoft.com/office/drawing/2014/main" id="{1ECA81E3-8217-4D0B-BC47-A02AE8B34148}"/>
               </a:ext>
             </a:extLst>
           </p:cNvPr>
@@ -8985,7 +9020,7 @@
           <p:cNvPr id="23" name="footer-page-14">
             <a:extLst xmlns:a="http://schemas.openxmlformats.org/drawingml/2006/main">
               <a:ext uri="{FF2B5EF4-FFF2-40B4-BE49-F238E27FC236}">
-                <a16:creationId xmlns:a16="http://schemas.microsoft.com/office/drawing/2014/main" id="{A4067B83-0AC5-4ED3-A996-94564CEF45E3}"/>
+                <a16:creationId xmlns:a16="http://schemas.microsoft.com/office/drawing/2014/main" id="{EC9CC329-0E3D-4AD8-AF8F-CA7D9094EAA7}"/>
               </a:ext>
             </a:extLst>
           </p:cNvPr>
@@ -9045,7 +9080,7 @@
     </p:spTree>
     <p:extLst>
       <p:ext uri="{BB962C8B-B14F-4D97-AF65-F5344CB8AC3E}">
-        <p14:creationId xmlns:p14="http://schemas.microsoft.com/office/powerpoint/2010/main" val="1272256928"/>
+        <p14:creationId xmlns:p14="http://schemas.microsoft.com/office/powerpoint/2010/main" val="2131735040"/>
       </p:ext>
     </p:extLst>
   </p:cSld>
@@ -9076,7 +9111,7 @@
           <p:cNvPr id="21" name="side-accent-15">
             <a:extLst xmlns:a="http://schemas.openxmlformats.org/drawingml/2006/main">
               <a:ext uri="{FF2B5EF4-FFF2-40B4-BE49-F238E27FC236}">
-                <a16:creationId xmlns:a16="http://schemas.microsoft.com/office/drawing/2014/main" id="{C6B52308-FB10-4F77-8D3B-E3204B55C92D}"/>
+                <a16:creationId xmlns:a16="http://schemas.microsoft.com/office/drawing/2014/main" id="{65E8F0B2-3A22-490F-94A8-E98CA0C95D13}"/>
               </a:ext>
             </a:extLst>
           </p:cNvPr>
@@ -9107,7 +9142,7 @@
           <p:cNvPr id="2" name="kicker-15">
             <a:extLst xmlns:a="http://schemas.openxmlformats.org/drawingml/2006/main">
               <a:ext uri="{FF2B5EF4-FFF2-40B4-BE49-F238E27FC236}">
-                <a16:creationId xmlns:a16="http://schemas.microsoft.com/office/drawing/2014/main" id="{C264ABFD-1543-4935-B5D8-A9B024CB21E3}"/>
+                <a16:creationId xmlns:a16="http://schemas.microsoft.com/office/drawing/2014/main" id="{16D2208A-426C-43E0-A81A-77549A0E4AD0}"/>
               </a:ext>
             </a:extLst>
           </p:cNvPr>
@@ -9169,7 +9204,7 @@
           <p:cNvPr id="3" name="title-15">
             <a:extLst xmlns:a="http://schemas.openxmlformats.org/drawingml/2006/main">
               <a:ext uri="{FF2B5EF4-FFF2-40B4-BE49-F238E27FC236}">
-                <a16:creationId xmlns:a16="http://schemas.microsoft.com/office/drawing/2014/main" id="{17D37D0A-2504-4DA2-AD5E-D31BA6C3DB95}"/>
+                <a16:creationId xmlns:a16="http://schemas.microsoft.com/office/drawing/2014/main" id="{DDCD7F3E-5E38-419B-8FE8-D71410E51A7F}"/>
               </a:ext>
             </a:extLst>
           </p:cNvPr>
@@ -9231,7 +9266,7 @@
           <p:cNvPr id="4" name="">
             <a:extLst xmlns:a="http://schemas.openxmlformats.org/drawingml/2006/main">
               <a:ext uri="{FF2B5EF4-FFF2-40B4-BE49-F238E27FC236}">
-                <a16:creationId xmlns:a16="http://schemas.microsoft.com/office/drawing/2014/main" id="{BC306BF7-BFDD-4843-AFFE-B25239270D6B}"/>
+                <a16:creationId xmlns:a16="http://schemas.microsoft.com/office/drawing/2014/main" id="{068AFDB4-7B4E-466F-9692-839B9AB654B6}"/>
               </a:ext>
             </a:extLst>
           </p:cNvPr>
@@ -9262,7 +9297,7 @@
           <p:cNvPr id="5" name="">
             <a:extLst xmlns:a="http://schemas.openxmlformats.org/drawingml/2006/main">
               <a:ext uri="{FF2B5EF4-FFF2-40B4-BE49-F238E27FC236}">
-                <a16:creationId xmlns:a16="http://schemas.microsoft.com/office/drawing/2014/main" id="{28192596-C9F0-44A2-AFF6-5EC62779EC5C}"/>
+                <a16:creationId xmlns:a16="http://schemas.microsoft.com/office/drawing/2014/main" id="{3A727D31-1855-476A-8FEE-91B2320CAF34}"/>
               </a:ext>
             </a:extLst>
           </p:cNvPr>
@@ -9293,7 +9328,7 @@
           <p:cNvPr id="6" name="">
             <a:extLst xmlns:a="http://schemas.openxmlformats.org/drawingml/2006/main">
               <a:ext uri="{FF2B5EF4-FFF2-40B4-BE49-F238E27FC236}">
-                <a16:creationId xmlns:a16="http://schemas.microsoft.com/office/drawing/2014/main" id="{56C6B01F-7506-46B9-9A37-F1349CA8C852}"/>
+                <a16:creationId xmlns:a16="http://schemas.microsoft.com/office/drawing/2014/main" id="{49BDC3A1-B96E-4B9E-B06E-7B855A156E91}"/>
               </a:ext>
             </a:extLst>
           </p:cNvPr>
@@ -9355,7 +9390,7 @@
           <p:cNvPr id="7" name="">
             <a:extLst xmlns:a="http://schemas.openxmlformats.org/drawingml/2006/main">
               <a:ext uri="{FF2B5EF4-FFF2-40B4-BE49-F238E27FC236}">
-                <a16:creationId xmlns:a16="http://schemas.microsoft.com/office/drawing/2014/main" id="{048B205D-577E-4789-BE22-0870E8645AEE}"/>
+                <a16:creationId xmlns:a16="http://schemas.microsoft.com/office/drawing/2014/main" id="{76C8AE93-5C0A-4F69-986A-645BD28EC842}"/>
               </a:ext>
             </a:extLst>
           </p:cNvPr>
@@ -9417,7 +9452,7 @@
           <p:cNvPr id="8" name="">
             <a:extLst xmlns:a="http://schemas.openxmlformats.org/drawingml/2006/main">
               <a:ext uri="{FF2B5EF4-FFF2-40B4-BE49-F238E27FC236}">
-                <a16:creationId xmlns:a16="http://schemas.microsoft.com/office/drawing/2014/main" id="{8950560D-06C8-49B1-9EC7-56E1CE717113}"/>
+                <a16:creationId xmlns:a16="http://schemas.microsoft.com/office/drawing/2014/main" id="{D87DCC1B-4501-4E3D-86AD-0C0380CFBFF2}"/>
               </a:ext>
             </a:extLst>
           </p:cNvPr>
@@ -9479,7 +9514,7 @@
           <p:cNvPr id="9" name="">
             <a:extLst xmlns:a="http://schemas.openxmlformats.org/drawingml/2006/main">
               <a:ext uri="{FF2B5EF4-FFF2-40B4-BE49-F238E27FC236}">
-                <a16:creationId xmlns:a16="http://schemas.microsoft.com/office/drawing/2014/main" id="{EF5E01CA-2149-4435-BE3D-1D403AF6782B}"/>
+                <a16:creationId xmlns:a16="http://schemas.microsoft.com/office/drawing/2014/main" id="{445471E6-D6E7-4FD5-913F-8AE4D42C551A}"/>
               </a:ext>
             </a:extLst>
           </p:cNvPr>
@@ -9510,7 +9545,7 @@
           <p:cNvPr id="10" name="">
             <a:extLst xmlns:a="http://schemas.openxmlformats.org/drawingml/2006/main">
               <a:ext uri="{FF2B5EF4-FFF2-40B4-BE49-F238E27FC236}">
-                <a16:creationId xmlns:a16="http://schemas.microsoft.com/office/drawing/2014/main" id="{C7DA054E-3CCC-4291-8EFD-7E5289F19547}"/>
+                <a16:creationId xmlns:a16="http://schemas.microsoft.com/office/drawing/2014/main" id="{C28F477F-7705-408A-96D6-0F5FBB36FFAE}"/>
               </a:ext>
             </a:extLst>
           </p:cNvPr>
@@ -9572,7 +9607,7 @@
           <p:cNvPr id="11" name="">
             <a:extLst xmlns:a="http://schemas.openxmlformats.org/drawingml/2006/main">
               <a:ext uri="{FF2B5EF4-FFF2-40B4-BE49-F238E27FC236}">
-                <a16:creationId xmlns:a16="http://schemas.microsoft.com/office/drawing/2014/main" id="{5C10FFBF-354D-4E36-B1B1-687CC3F2912D}"/>
+                <a16:creationId xmlns:a16="http://schemas.microsoft.com/office/drawing/2014/main" id="{D2892893-3206-481C-BADC-46329804D61C}"/>
               </a:ext>
             </a:extLst>
           </p:cNvPr>
@@ -9634,7 +9669,7 @@
           <p:cNvPr id="12" name="">
             <a:extLst xmlns:a="http://schemas.openxmlformats.org/drawingml/2006/main">
               <a:ext uri="{FF2B5EF4-FFF2-40B4-BE49-F238E27FC236}">
-                <a16:creationId xmlns:a16="http://schemas.microsoft.com/office/drawing/2014/main" id="{CD9B4B83-7DF0-4F50-A847-8355622BC910}"/>
+                <a16:creationId xmlns:a16="http://schemas.microsoft.com/office/drawing/2014/main" id="{5D12E9CF-686A-408A-825E-D305F527A20D}"/>
               </a:ext>
             </a:extLst>
           </p:cNvPr>
@@ -9696,7 +9731,7 @@
           <p:cNvPr id="13" name="">
             <a:extLst xmlns:a="http://schemas.openxmlformats.org/drawingml/2006/main">
               <a:ext uri="{FF2B5EF4-FFF2-40B4-BE49-F238E27FC236}">
-                <a16:creationId xmlns:a16="http://schemas.microsoft.com/office/drawing/2014/main" id="{3F4CE83D-0943-46BD-B1C8-350E506FB6B8}"/>
+                <a16:creationId xmlns:a16="http://schemas.microsoft.com/office/drawing/2014/main" id="{4FBAE909-000B-4207-B95B-24951917F2FC}"/>
               </a:ext>
             </a:extLst>
           </p:cNvPr>
@@ -9727,7 +9762,7 @@
           <p:cNvPr id="14" name="">
             <a:extLst xmlns:a="http://schemas.openxmlformats.org/drawingml/2006/main">
               <a:ext uri="{FF2B5EF4-FFF2-40B4-BE49-F238E27FC236}">
-                <a16:creationId xmlns:a16="http://schemas.microsoft.com/office/drawing/2014/main" id="{177527E6-7ED0-43B1-99CD-1AEE2F293047}"/>
+                <a16:creationId xmlns:a16="http://schemas.microsoft.com/office/drawing/2014/main" id="{18C672F4-CCC9-4CBF-A8E3-3978B6ECEB47}"/>
               </a:ext>
             </a:extLst>
           </p:cNvPr>
@@ -9789,7 +9824,7 @@
           <p:cNvPr id="15" name="">
             <a:extLst xmlns:a="http://schemas.openxmlformats.org/drawingml/2006/main">
               <a:ext uri="{FF2B5EF4-FFF2-40B4-BE49-F238E27FC236}">
-                <a16:creationId xmlns:a16="http://schemas.microsoft.com/office/drawing/2014/main" id="{0376916A-AAB5-47AE-8FB7-6798651D6D8B}"/>
+                <a16:creationId xmlns:a16="http://schemas.microsoft.com/office/drawing/2014/main" id="{416B3E0F-7013-4B8D-895E-11718061CC9E}"/>
               </a:ext>
             </a:extLst>
           </p:cNvPr>
@@ -9851,7 +9886,7 @@
           <p:cNvPr id="16" name="">
             <a:extLst xmlns:a="http://schemas.openxmlformats.org/drawingml/2006/main">
               <a:ext uri="{FF2B5EF4-FFF2-40B4-BE49-F238E27FC236}">
-                <a16:creationId xmlns:a16="http://schemas.microsoft.com/office/drawing/2014/main" id="{8D2891F2-2BC1-4AA4-8E08-5F646D68A43A}"/>
+                <a16:creationId xmlns:a16="http://schemas.microsoft.com/office/drawing/2014/main" id="{AB6B2A83-E7BD-47A2-A1B7-D77D835C974F}"/>
               </a:ext>
             </a:extLst>
           </p:cNvPr>
@@ -9913,7 +9948,7 @@
           <p:cNvPr id="17" name="">
             <a:extLst xmlns:a="http://schemas.openxmlformats.org/drawingml/2006/main">
               <a:ext uri="{FF2B5EF4-FFF2-40B4-BE49-F238E27FC236}">
-                <a16:creationId xmlns:a16="http://schemas.microsoft.com/office/drawing/2014/main" id="{3BDC4BF2-7B8D-4D5B-B79B-7ADC3951E598}"/>
+                <a16:creationId xmlns:a16="http://schemas.microsoft.com/office/drawing/2014/main" id="{D77DCBF5-9C4C-4F8A-AB14-6F38ACB26E74}"/>
               </a:ext>
             </a:extLst>
           </p:cNvPr>
@@ -9975,7 +10010,7 @@
           <p:cNvPr id="18" name="footer-rule-15">
             <a:extLst xmlns:a="http://schemas.openxmlformats.org/drawingml/2006/main">
               <a:ext uri="{FF2B5EF4-FFF2-40B4-BE49-F238E27FC236}">
-                <a16:creationId xmlns:a16="http://schemas.microsoft.com/office/drawing/2014/main" id="{0814231B-0D57-4EDF-A17D-72A92E883EBA}"/>
+                <a16:creationId xmlns:a16="http://schemas.microsoft.com/office/drawing/2014/main" id="{F990B003-15A8-49E3-AC2A-869786177975}"/>
               </a:ext>
             </a:extLst>
           </p:cNvPr>
@@ -10006,7 +10041,7 @@
           <p:cNvPr id="19" name="footer-label-15">
             <a:extLst xmlns:a="http://schemas.openxmlformats.org/drawingml/2006/main">
               <a:ext uri="{FF2B5EF4-FFF2-40B4-BE49-F238E27FC236}">
-                <a16:creationId xmlns:a16="http://schemas.microsoft.com/office/drawing/2014/main" id="{87CDDD18-8A3F-4BB3-B7D6-69A5449E2B32}"/>
+                <a16:creationId xmlns:a16="http://schemas.microsoft.com/office/drawing/2014/main" id="{05E30A51-5324-4086-9F23-C37943055C24}"/>
               </a:ext>
             </a:extLst>
           </p:cNvPr>
@@ -10068,7 +10103,7 @@
           <p:cNvPr id="20" name="footer-page-15">
             <a:extLst xmlns:a="http://schemas.openxmlformats.org/drawingml/2006/main">
               <a:ext uri="{FF2B5EF4-FFF2-40B4-BE49-F238E27FC236}">
-                <a16:creationId xmlns:a16="http://schemas.microsoft.com/office/drawing/2014/main" id="{45E108D1-7EFC-45AA-B983-1ABF90B50C66}"/>
+                <a16:creationId xmlns:a16="http://schemas.microsoft.com/office/drawing/2014/main" id="{9B674EBC-4D6F-4DD9-B51F-3BA77CCE0653}"/>
               </a:ext>
             </a:extLst>
           </p:cNvPr>
@@ -10128,7 +10163,7 @@
     </p:spTree>
     <p:extLst>
       <p:ext uri="{BB962C8B-B14F-4D97-AF65-F5344CB8AC3E}">
-        <p14:creationId xmlns:p14="http://schemas.microsoft.com/office/powerpoint/2010/main" val="598176331"/>
+        <p14:creationId xmlns:p14="http://schemas.microsoft.com/office/powerpoint/2010/main" val="952809358"/>
       </p:ext>
     </p:extLst>
   </p:cSld>
@@ -10159,7 +10194,7 @@
           <p:cNvPr id="11" name="">
             <a:extLst xmlns:a="http://schemas.openxmlformats.org/drawingml/2006/main">
               <a:ext uri="{FF2B5EF4-FFF2-40B4-BE49-F238E27FC236}">
-                <a16:creationId xmlns:a16="http://schemas.microsoft.com/office/drawing/2014/main" id="{09BC0D08-F98F-44D1-B5CA-C27234A5B9C8}"/>
+                <a16:creationId xmlns:a16="http://schemas.microsoft.com/office/drawing/2014/main" id="{55C890DD-7F03-4F9B-B5A3-88984F484177}"/>
               </a:ext>
             </a:extLst>
           </p:cNvPr>
@@ -10190,7 +10225,7 @@
           <p:cNvPr id="2" name="">
             <a:extLst xmlns:a="http://schemas.openxmlformats.org/drawingml/2006/main">
               <a:ext uri="{FF2B5EF4-FFF2-40B4-BE49-F238E27FC236}">
-                <a16:creationId xmlns:a16="http://schemas.microsoft.com/office/drawing/2014/main" id="{B60F0916-11C0-4A71-A1DA-F810957A0690}"/>
+                <a16:creationId xmlns:a16="http://schemas.microsoft.com/office/drawing/2014/main" id="{239777F4-E490-4ED1-A880-599EC9E4D284}"/>
               </a:ext>
             </a:extLst>
           </p:cNvPr>
@@ -10252,7 +10287,7 @@
           <p:cNvPr id="3" name="">
             <a:extLst xmlns:a="http://schemas.openxmlformats.org/drawingml/2006/main">
               <a:ext uri="{FF2B5EF4-FFF2-40B4-BE49-F238E27FC236}">
-                <a16:creationId xmlns:a16="http://schemas.microsoft.com/office/drawing/2014/main" id="{F19450D7-F92E-45D6-B055-168B1304117B}"/>
+                <a16:creationId xmlns:a16="http://schemas.microsoft.com/office/drawing/2014/main" id="{E1528C5F-17F7-43A9-823F-BC6C6AF8E68F}"/>
               </a:ext>
             </a:extLst>
           </p:cNvPr>
@@ -10341,7 +10376,7 @@
           <p:cNvPr id="4" name="">
             <a:extLst xmlns:a="http://schemas.openxmlformats.org/drawingml/2006/main">
               <a:ext uri="{FF2B5EF4-FFF2-40B4-BE49-F238E27FC236}">
-                <a16:creationId xmlns:a16="http://schemas.microsoft.com/office/drawing/2014/main" id="{FDDE8B3F-5C6D-4C01-AC09-EBB22DA8AA10}"/>
+                <a16:creationId xmlns:a16="http://schemas.microsoft.com/office/drawing/2014/main" id="{9F91BEC7-C76F-498E-A273-B04B1CFE2D98}"/>
               </a:ext>
             </a:extLst>
           </p:cNvPr>
@@ -10403,7 +10438,7 @@
           <p:cNvPr id="5" name="">
             <a:extLst xmlns:a="http://schemas.openxmlformats.org/drawingml/2006/main">
               <a:ext uri="{FF2B5EF4-FFF2-40B4-BE49-F238E27FC236}">
-                <a16:creationId xmlns:a16="http://schemas.microsoft.com/office/drawing/2014/main" id="{C35CCAB1-F866-4BF6-B180-85683033ED27}"/>
+                <a16:creationId xmlns:a16="http://schemas.microsoft.com/office/drawing/2014/main" id="{F9B9C9D0-85F5-45F0-9B72-2551A871A366}"/>
               </a:ext>
             </a:extLst>
           </p:cNvPr>
@@ -10436,7 +10471,7 @@
           <p:cNvPr id="6" name="">
             <a:extLst xmlns:a="http://schemas.openxmlformats.org/drawingml/2006/main">
               <a:ext uri="{FF2B5EF4-FFF2-40B4-BE49-F238E27FC236}">
-                <a16:creationId xmlns:a16="http://schemas.microsoft.com/office/drawing/2014/main" id="{D4BC960E-E2E8-42F6-98BC-2430C5093C7C}"/>
+                <a16:creationId xmlns:a16="http://schemas.microsoft.com/office/drawing/2014/main" id="{20CDA5A5-B229-4515-BBD1-D7D9A3D252BD}"/>
               </a:ext>
             </a:extLst>
           </p:cNvPr>
@@ -10498,7 +10533,7 @@
           <p:cNvPr id="7" name="">
             <a:extLst xmlns:a="http://schemas.openxmlformats.org/drawingml/2006/main">
               <a:ext uri="{FF2B5EF4-FFF2-40B4-BE49-F238E27FC236}">
-                <a16:creationId xmlns:a16="http://schemas.microsoft.com/office/drawing/2014/main" id="{F3DFD911-C729-4B7A-AA66-E3982CDAB693}"/>
+                <a16:creationId xmlns:a16="http://schemas.microsoft.com/office/drawing/2014/main" id="{25AD7F2A-8C6F-4F70-B9C0-8415D3FD9B1E}"/>
               </a:ext>
             </a:extLst>
           </p:cNvPr>
@@ -10560,7 +10595,7 @@
           <p:cNvPr id="8" name="">
             <a:extLst xmlns:a="http://schemas.openxmlformats.org/drawingml/2006/main">
               <a:ext uri="{FF2B5EF4-FFF2-40B4-BE49-F238E27FC236}">
-                <a16:creationId xmlns:a16="http://schemas.microsoft.com/office/drawing/2014/main" id="{38B1AB1A-35A0-440B-8447-3D9FD85B7D88}"/>
+                <a16:creationId xmlns:a16="http://schemas.microsoft.com/office/drawing/2014/main" id="{D1A97E3D-E0EA-4B00-B094-797013FAA54E}"/>
               </a:ext>
             </a:extLst>
           </p:cNvPr>
@@ -10649,7 +10684,7 @@
           <p:cNvPr id="9" name="">
             <a:extLst xmlns:a="http://schemas.openxmlformats.org/drawingml/2006/main">
               <a:ext uri="{FF2B5EF4-FFF2-40B4-BE49-F238E27FC236}">
-                <a16:creationId xmlns:a16="http://schemas.microsoft.com/office/drawing/2014/main" id="{CBB52404-B2BD-4BCC-BA44-B434D787DDDA}"/>
+                <a16:creationId xmlns:a16="http://schemas.microsoft.com/office/drawing/2014/main" id="{2CDEAE77-25CF-4841-BB14-E5E8F3FF23D2}"/>
               </a:ext>
             </a:extLst>
           </p:cNvPr>
@@ -10711,7 +10746,7 @@
           <p:cNvPr id="10" name="">
             <a:extLst xmlns:a="http://schemas.openxmlformats.org/drawingml/2006/main">
               <a:ext uri="{FF2B5EF4-FFF2-40B4-BE49-F238E27FC236}">
-                <a16:creationId xmlns:a16="http://schemas.microsoft.com/office/drawing/2014/main" id="{A2111124-4C93-443C-8587-47A5A479C7C8}"/>
+                <a16:creationId xmlns:a16="http://schemas.microsoft.com/office/drawing/2014/main" id="{8C70A26D-F96E-493E-B226-558423428A67}"/>
               </a:ext>
             </a:extLst>
           </p:cNvPr>
@@ -10771,7 +10806,7 @@
     </p:spTree>
     <p:extLst>
       <p:ext uri="{BB962C8B-B14F-4D97-AF65-F5344CB8AC3E}">
-        <p14:creationId xmlns:p14="http://schemas.microsoft.com/office/powerpoint/2010/main" val="2054646819"/>
+        <p14:creationId xmlns:p14="http://schemas.microsoft.com/office/powerpoint/2010/main" val="1167331332"/>
       </p:ext>
     </p:extLst>
   </p:cSld>
@@ -10802,7 +10837,7 @@
           <p:cNvPr id="22" name="side-accent-17">
             <a:extLst xmlns:a="http://schemas.openxmlformats.org/drawingml/2006/main">
               <a:ext uri="{FF2B5EF4-FFF2-40B4-BE49-F238E27FC236}">
-                <a16:creationId xmlns:a16="http://schemas.microsoft.com/office/drawing/2014/main" id="{CE669EEA-70FC-4EEE-BFB0-189183B1C3F3}"/>
+                <a16:creationId xmlns:a16="http://schemas.microsoft.com/office/drawing/2014/main" id="{6B13CA2B-202B-42CE-906F-FDEE0BEEC295}"/>
               </a:ext>
             </a:extLst>
           </p:cNvPr>
@@ -10833,7 +10868,7 @@
           <p:cNvPr id="2" name="kicker-17">
             <a:extLst xmlns:a="http://schemas.openxmlformats.org/drawingml/2006/main">
               <a:ext uri="{FF2B5EF4-FFF2-40B4-BE49-F238E27FC236}">
-                <a16:creationId xmlns:a16="http://schemas.microsoft.com/office/drawing/2014/main" id="{792B58D1-2FB2-4D03-9CC9-FCAB0644F5E9}"/>
+                <a16:creationId xmlns:a16="http://schemas.microsoft.com/office/drawing/2014/main" id="{35D5B3CF-B37D-4B54-8F53-60A4F2F62289}"/>
               </a:ext>
             </a:extLst>
           </p:cNvPr>
@@ -10895,7 +10930,7 @@
           <p:cNvPr id="3" name="title-17">
             <a:extLst xmlns:a="http://schemas.openxmlformats.org/drawingml/2006/main">
               <a:ext uri="{FF2B5EF4-FFF2-40B4-BE49-F238E27FC236}">
-                <a16:creationId xmlns:a16="http://schemas.microsoft.com/office/drawing/2014/main" id="{A7D0019C-4B75-44D0-BC1E-41EBA49F1956}"/>
+                <a16:creationId xmlns:a16="http://schemas.microsoft.com/office/drawing/2014/main" id="{4AD2C962-6B18-47EC-B89C-072105A2AC05}"/>
               </a:ext>
             </a:extLst>
           </p:cNvPr>
@@ -10957,7 +10992,7 @@
           <p:cNvPr id="4" name="">
             <a:extLst xmlns:a="http://schemas.openxmlformats.org/drawingml/2006/main">
               <a:ext uri="{FF2B5EF4-FFF2-40B4-BE49-F238E27FC236}">
-                <a16:creationId xmlns:a16="http://schemas.microsoft.com/office/drawing/2014/main" id="{18115665-8848-425E-A937-313BA0663DD3}"/>
+                <a16:creationId xmlns:a16="http://schemas.microsoft.com/office/drawing/2014/main" id="{9F407690-D2E8-4EFE-9F5A-6C4103B5F6C1}"/>
               </a:ext>
             </a:extLst>
           </p:cNvPr>
@@ -11019,7 +11054,7 @@
           <p:cNvPr id="5" name="">
             <a:extLst xmlns:a="http://schemas.openxmlformats.org/drawingml/2006/main">
               <a:ext uri="{FF2B5EF4-FFF2-40B4-BE49-F238E27FC236}">
-                <a16:creationId xmlns:a16="http://schemas.microsoft.com/office/drawing/2014/main" id="{005884C0-2E18-4A2B-88F6-736C5B3348D2}"/>
+                <a16:creationId xmlns:a16="http://schemas.microsoft.com/office/drawing/2014/main" id="{1089F501-1FEC-424C-85E9-F8B7E8CDE27A}"/>
               </a:ext>
             </a:extLst>
           </p:cNvPr>
@@ -11050,7 +11085,7 @@
           <p:cNvPr id="6" name="">
             <a:extLst xmlns:a="http://schemas.openxmlformats.org/drawingml/2006/main">
               <a:ext uri="{FF2B5EF4-FFF2-40B4-BE49-F238E27FC236}">
-                <a16:creationId xmlns:a16="http://schemas.microsoft.com/office/drawing/2014/main" id="{A783B70E-8183-4EDE-93FC-8426AB1DE1E4}"/>
+                <a16:creationId xmlns:a16="http://schemas.microsoft.com/office/drawing/2014/main" id="{E26F98A7-96B9-4784-86A2-B6EA31D46738}"/>
               </a:ext>
             </a:extLst>
           </p:cNvPr>
@@ -11112,7 +11147,7 @@
           <p:cNvPr id="7" name="">
             <a:extLst xmlns:a="http://schemas.openxmlformats.org/drawingml/2006/main">
               <a:ext uri="{FF2B5EF4-FFF2-40B4-BE49-F238E27FC236}">
-                <a16:creationId xmlns:a16="http://schemas.microsoft.com/office/drawing/2014/main" id="{9FA8ECF9-A3C2-4F71-A78D-E04370953DF7}"/>
+                <a16:creationId xmlns:a16="http://schemas.microsoft.com/office/drawing/2014/main" id="{F46DBAC2-D280-4DE3-82BA-FAA233C5E5B8}"/>
               </a:ext>
             </a:extLst>
           </p:cNvPr>
@@ -11174,7 +11209,7 @@
           <p:cNvPr id="8" name="">
             <a:extLst xmlns:a="http://schemas.openxmlformats.org/drawingml/2006/main">
               <a:ext uri="{FF2B5EF4-FFF2-40B4-BE49-F238E27FC236}">
-                <a16:creationId xmlns:a16="http://schemas.microsoft.com/office/drawing/2014/main" id="{FFC92AB5-68D7-4978-B349-BB29ADFC8742}"/>
+                <a16:creationId xmlns:a16="http://schemas.microsoft.com/office/drawing/2014/main" id="{EE9D2A76-936F-46EE-9D06-DA4B67B73539}"/>
               </a:ext>
             </a:extLst>
           </p:cNvPr>
@@ -11205,7 +11240,7 @@
           <p:cNvPr id="9" name="">
             <a:extLst xmlns:a="http://schemas.openxmlformats.org/drawingml/2006/main">
               <a:ext uri="{FF2B5EF4-FFF2-40B4-BE49-F238E27FC236}">
-                <a16:creationId xmlns:a16="http://schemas.microsoft.com/office/drawing/2014/main" id="{21E3C7C7-3D8D-4E06-8ABC-B118D15343D9}"/>
+                <a16:creationId xmlns:a16="http://schemas.microsoft.com/office/drawing/2014/main" id="{7600CEFC-E6A9-4F43-8D9A-78D92D3B0899}"/>
               </a:ext>
             </a:extLst>
           </p:cNvPr>
@@ -11267,7 +11302,7 @@
           <p:cNvPr id="10" name="">
             <a:extLst xmlns:a="http://schemas.openxmlformats.org/drawingml/2006/main">
               <a:ext uri="{FF2B5EF4-FFF2-40B4-BE49-F238E27FC236}">
-                <a16:creationId xmlns:a16="http://schemas.microsoft.com/office/drawing/2014/main" id="{E03C329C-B4E4-4B0D-82F9-7683971BD32E}"/>
+                <a16:creationId xmlns:a16="http://schemas.microsoft.com/office/drawing/2014/main" id="{9209C532-69F5-482F-8172-5D5F21FCFC3F}"/>
               </a:ext>
             </a:extLst>
           </p:cNvPr>
@@ -11329,7 +11364,7 @@
           <p:cNvPr id="11" name="">
             <a:extLst xmlns:a="http://schemas.openxmlformats.org/drawingml/2006/main">
               <a:ext uri="{FF2B5EF4-FFF2-40B4-BE49-F238E27FC236}">
-                <a16:creationId xmlns:a16="http://schemas.microsoft.com/office/drawing/2014/main" id="{A3B100B7-8CA6-4B0B-B4B9-1E932A464960}"/>
+                <a16:creationId xmlns:a16="http://schemas.microsoft.com/office/drawing/2014/main" id="{9CC49C3C-2092-4785-BBC3-422E7A2E0B16}"/>
               </a:ext>
             </a:extLst>
           </p:cNvPr>
@@ -11360,7 +11395,7 @@
           <p:cNvPr id="12" name="">
             <a:extLst xmlns:a="http://schemas.openxmlformats.org/drawingml/2006/main">
               <a:ext uri="{FF2B5EF4-FFF2-40B4-BE49-F238E27FC236}">
-                <a16:creationId xmlns:a16="http://schemas.microsoft.com/office/drawing/2014/main" id="{E9F8ABE1-D6ED-490E-AD1B-AF69F764004A}"/>
+                <a16:creationId xmlns:a16="http://schemas.microsoft.com/office/drawing/2014/main" id="{2BDE9AF3-38F1-4ED3-8116-65124CCE4624}"/>
               </a:ext>
             </a:extLst>
           </p:cNvPr>
@@ -11422,7 +11457,7 @@
           <p:cNvPr id="13" name="">
             <a:extLst xmlns:a="http://schemas.openxmlformats.org/drawingml/2006/main">
               <a:ext uri="{FF2B5EF4-FFF2-40B4-BE49-F238E27FC236}">
-                <a16:creationId xmlns:a16="http://schemas.microsoft.com/office/drawing/2014/main" id="{662E2367-AB9C-4C75-B61E-4706AB4EC74A}"/>
+                <a16:creationId xmlns:a16="http://schemas.microsoft.com/office/drawing/2014/main" id="{8764CC31-3E33-4F79-BFAD-87DACA282EF6}"/>
               </a:ext>
             </a:extLst>
           </p:cNvPr>
@@ -11484,7 +11519,7 @@
           <p:cNvPr id="14" name="">
             <a:extLst xmlns:a="http://schemas.openxmlformats.org/drawingml/2006/main">
               <a:ext uri="{FF2B5EF4-FFF2-40B4-BE49-F238E27FC236}">
-                <a16:creationId xmlns:a16="http://schemas.microsoft.com/office/drawing/2014/main" id="{18440C20-5DDA-4385-8F1D-910E9E75AD18}"/>
+                <a16:creationId xmlns:a16="http://schemas.microsoft.com/office/drawing/2014/main" id="{6E26EBB7-BEB7-41A3-84D5-16A4946EB796}"/>
               </a:ext>
             </a:extLst>
           </p:cNvPr>
@@ -11515,7 +11550,7 @@
           <p:cNvPr id="15" name="">
             <a:extLst xmlns:a="http://schemas.openxmlformats.org/drawingml/2006/main">
               <a:ext uri="{FF2B5EF4-FFF2-40B4-BE49-F238E27FC236}">
-                <a16:creationId xmlns:a16="http://schemas.microsoft.com/office/drawing/2014/main" id="{316BEDF8-0F8B-469C-AA36-32D8698904BD}"/>
+                <a16:creationId xmlns:a16="http://schemas.microsoft.com/office/drawing/2014/main" id="{B9BF14D3-EDAD-4585-BF45-10BD695D8529}"/>
               </a:ext>
             </a:extLst>
           </p:cNvPr>
@@ -11577,7 +11612,7 @@
           <p:cNvPr id="16" name="">
             <a:extLst xmlns:a="http://schemas.openxmlformats.org/drawingml/2006/main">
               <a:ext uri="{FF2B5EF4-FFF2-40B4-BE49-F238E27FC236}">
-                <a16:creationId xmlns:a16="http://schemas.microsoft.com/office/drawing/2014/main" id="{A2052DC4-B073-4899-A55E-A6415AD06E4F}"/>
+                <a16:creationId xmlns:a16="http://schemas.microsoft.com/office/drawing/2014/main" id="{B1CC3479-166E-4609-BE65-224DB69DBA57}"/>
               </a:ext>
             </a:extLst>
           </p:cNvPr>
@@ -11639,7 +11674,7 @@
           <p:cNvPr id="17" name="">
             <a:extLst xmlns:a="http://schemas.openxmlformats.org/drawingml/2006/main">
               <a:ext uri="{FF2B5EF4-FFF2-40B4-BE49-F238E27FC236}">
-                <a16:creationId xmlns:a16="http://schemas.microsoft.com/office/drawing/2014/main" id="{48ED56BB-6C4B-4159-8AC0-CA057B991213}"/>
+                <a16:creationId xmlns:a16="http://schemas.microsoft.com/office/drawing/2014/main" id="{63BEB550-07CA-4037-8C11-CD644C3202CA}"/>
               </a:ext>
             </a:extLst>
           </p:cNvPr>
@@ -11672,7 +11707,7 @@
           <p:cNvPr id="18" name="">
             <a:extLst xmlns:a="http://schemas.openxmlformats.org/drawingml/2006/main">
               <a:ext uri="{FF2B5EF4-FFF2-40B4-BE49-F238E27FC236}">
-                <a16:creationId xmlns:a16="http://schemas.microsoft.com/office/drawing/2014/main" id="{0874FA3E-188F-48B9-969C-8E01806456D1}"/>
+                <a16:creationId xmlns:a16="http://schemas.microsoft.com/office/drawing/2014/main" id="{B1B40B3C-AC2B-4A89-A931-E5588F59C49C}"/>
               </a:ext>
             </a:extLst>
           </p:cNvPr>
@@ -11734,7 +11769,7 @@
           <p:cNvPr id="19" name="footer-rule-17">
             <a:extLst xmlns:a="http://schemas.openxmlformats.org/drawingml/2006/main">
               <a:ext uri="{FF2B5EF4-FFF2-40B4-BE49-F238E27FC236}">
-                <a16:creationId xmlns:a16="http://schemas.microsoft.com/office/drawing/2014/main" id="{363D99BB-603D-4BB2-A488-108C99CFEA1E}"/>
+                <a16:creationId xmlns:a16="http://schemas.microsoft.com/office/drawing/2014/main" id="{CCFE86E3-AB6C-4976-9159-AAB8E098C0E3}"/>
               </a:ext>
             </a:extLst>
           </p:cNvPr>
@@ -11765,7 +11800,7 @@
           <p:cNvPr id="20" name="footer-label-17">
             <a:extLst xmlns:a="http://schemas.openxmlformats.org/drawingml/2006/main">
               <a:ext uri="{FF2B5EF4-FFF2-40B4-BE49-F238E27FC236}">
-                <a16:creationId xmlns:a16="http://schemas.microsoft.com/office/drawing/2014/main" id="{EA46A3EA-049A-4399-BD65-8CAF1D2CD75D}"/>
+                <a16:creationId xmlns:a16="http://schemas.microsoft.com/office/drawing/2014/main" id="{FE077FE7-1031-472B-A8E6-68E5A3DA71F6}"/>
               </a:ext>
             </a:extLst>
           </p:cNvPr>
@@ -11827,7 +11862,7 @@
           <p:cNvPr id="21" name="footer-page-17">
             <a:extLst xmlns:a="http://schemas.openxmlformats.org/drawingml/2006/main">
               <a:ext uri="{FF2B5EF4-FFF2-40B4-BE49-F238E27FC236}">
-                <a16:creationId xmlns:a16="http://schemas.microsoft.com/office/drawing/2014/main" id="{9B09BBAE-441E-4BDF-B801-0803D001DA51}"/>
+                <a16:creationId xmlns:a16="http://schemas.microsoft.com/office/drawing/2014/main" id="{9A9C69F0-8B12-4788-8471-8CD82746A3A3}"/>
               </a:ext>
             </a:extLst>
           </p:cNvPr>
@@ -11887,7 +11922,7 @@
     </p:spTree>
     <p:extLst>
       <p:ext uri="{BB962C8B-B14F-4D97-AF65-F5344CB8AC3E}">
-        <p14:creationId xmlns:p14="http://schemas.microsoft.com/office/powerpoint/2010/main" val="1388238102"/>
+        <p14:creationId xmlns:p14="http://schemas.microsoft.com/office/powerpoint/2010/main" val="427539656"/>
       </p:ext>
     </p:extLst>
   </p:cSld>
@@ -11918,7 +11953,7 @@
           <p:cNvPr id="25" name="side-accent-18">
             <a:extLst xmlns:a="http://schemas.openxmlformats.org/drawingml/2006/main">
               <a:ext uri="{FF2B5EF4-FFF2-40B4-BE49-F238E27FC236}">
-                <a16:creationId xmlns:a16="http://schemas.microsoft.com/office/drawing/2014/main" id="{D208D931-7560-4EFE-A7D9-D5D4A92A8CE2}"/>
+                <a16:creationId xmlns:a16="http://schemas.microsoft.com/office/drawing/2014/main" id="{DD3AC5B3-D01D-4653-BFBA-0F4C4309633A}"/>
               </a:ext>
             </a:extLst>
           </p:cNvPr>
@@ -11949,7 +11984,7 @@
           <p:cNvPr id="2" name="kicker-18">
             <a:extLst xmlns:a="http://schemas.openxmlformats.org/drawingml/2006/main">
               <a:ext uri="{FF2B5EF4-FFF2-40B4-BE49-F238E27FC236}">
-                <a16:creationId xmlns:a16="http://schemas.microsoft.com/office/drawing/2014/main" id="{37012921-8C41-4B7D-8BFF-A262C734ECCC}"/>
+                <a16:creationId xmlns:a16="http://schemas.microsoft.com/office/drawing/2014/main" id="{95F26A6D-48C9-4D32-A312-FC0C66D6883B}"/>
               </a:ext>
             </a:extLst>
           </p:cNvPr>
@@ -12011,7 +12046,7 @@
           <p:cNvPr id="3" name="title-18">
             <a:extLst xmlns:a="http://schemas.openxmlformats.org/drawingml/2006/main">
               <a:ext uri="{FF2B5EF4-FFF2-40B4-BE49-F238E27FC236}">
-                <a16:creationId xmlns:a16="http://schemas.microsoft.com/office/drawing/2014/main" id="{24AC7303-5C79-4EE2-9839-6FEA596922FB}"/>
+                <a16:creationId xmlns:a16="http://schemas.microsoft.com/office/drawing/2014/main" id="{AE753012-99A2-4A4C-A8AC-8CD6102B2C9E}"/>
               </a:ext>
             </a:extLst>
           </p:cNvPr>
@@ -12073,7 +12108,7 @@
           <p:cNvPr id="4" name="">
             <a:extLst xmlns:a="http://schemas.openxmlformats.org/drawingml/2006/main">
               <a:ext uri="{FF2B5EF4-FFF2-40B4-BE49-F238E27FC236}">
-                <a16:creationId xmlns:a16="http://schemas.microsoft.com/office/drawing/2014/main" id="{20A8FC33-163D-490F-8D3C-7B880EADA1BB}"/>
+                <a16:creationId xmlns:a16="http://schemas.microsoft.com/office/drawing/2014/main" id="{AAB41DC0-DE23-484E-81F7-37E076A00CD0}"/>
               </a:ext>
             </a:extLst>
           </p:cNvPr>
@@ -12135,7 +12170,7 @@
           <p:cNvPr id="5" name="">
             <a:extLst xmlns:a="http://schemas.openxmlformats.org/drawingml/2006/main">
               <a:ext uri="{FF2B5EF4-FFF2-40B4-BE49-F238E27FC236}">
-                <a16:creationId xmlns:a16="http://schemas.microsoft.com/office/drawing/2014/main" id="{A6CD318C-5F97-4B54-8669-8E55ABC67112}"/>
+                <a16:creationId xmlns:a16="http://schemas.microsoft.com/office/drawing/2014/main" id="{DAC8F901-CF7A-4F42-B1F7-1D2AD606F4A0}"/>
               </a:ext>
             </a:extLst>
           </p:cNvPr>
@@ -12197,7 +12232,7 @@
           <p:cNvPr id="6" name="">
             <a:extLst xmlns:a="http://schemas.openxmlformats.org/drawingml/2006/main">
               <a:ext uri="{FF2B5EF4-FFF2-40B4-BE49-F238E27FC236}">
-                <a16:creationId xmlns:a16="http://schemas.microsoft.com/office/drawing/2014/main" id="{247CFA0D-72E4-4F18-931D-237DCE51F2F0}"/>
+                <a16:creationId xmlns:a16="http://schemas.microsoft.com/office/drawing/2014/main" id="{234B66DD-572B-41A8-907E-E3DD3E19A7A9}"/>
               </a:ext>
             </a:extLst>
           </p:cNvPr>
@@ -12259,7 +12294,7 @@
           <p:cNvPr id="7" name="">
             <a:extLst xmlns:a="http://schemas.openxmlformats.org/drawingml/2006/main">
               <a:ext uri="{FF2B5EF4-FFF2-40B4-BE49-F238E27FC236}">
-                <a16:creationId xmlns:a16="http://schemas.microsoft.com/office/drawing/2014/main" id="{07FCBC81-0692-49A0-B2A4-886DBC3D54A0}"/>
+                <a16:creationId xmlns:a16="http://schemas.microsoft.com/office/drawing/2014/main" id="{3B373C9B-E12D-4895-A5A7-EA35F8515AE9}"/>
               </a:ext>
             </a:extLst>
           </p:cNvPr>
@@ -12290,7 +12325,7 @@
           <p:cNvPr id="8" name="">
             <a:extLst xmlns:a="http://schemas.openxmlformats.org/drawingml/2006/main">
               <a:ext uri="{FF2B5EF4-FFF2-40B4-BE49-F238E27FC236}">
-                <a16:creationId xmlns:a16="http://schemas.microsoft.com/office/drawing/2014/main" id="{D62B4E05-6D03-49C2-B8A6-1567A94D8B58}"/>
+                <a16:creationId xmlns:a16="http://schemas.microsoft.com/office/drawing/2014/main" id="{AF8D74F4-658B-4305-A6D8-D4F06EE00A7F}"/>
               </a:ext>
             </a:extLst>
           </p:cNvPr>
@@ -12352,7 +12387,7 @@
           <p:cNvPr id="9" name="">
             <a:extLst xmlns:a="http://schemas.openxmlformats.org/drawingml/2006/main">
               <a:ext uri="{FF2B5EF4-FFF2-40B4-BE49-F238E27FC236}">
-                <a16:creationId xmlns:a16="http://schemas.microsoft.com/office/drawing/2014/main" id="{364FB094-2E02-47EC-B424-2844A4DAB836}"/>
+                <a16:creationId xmlns:a16="http://schemas.microsoft.com/office/drawing/2014/main" id="{8D5C9B33-A78C-4C4E-95CD-50955F94459D}"/>
               </a:ext>
             </a:extLst>
           </p:cNvPr>
@@ -12414,7 +12449,7 @@
           <p:cNvPr id="10" name="">
             <a:extLst xmlns:a="http://schemas.openxmlformats.org/drawingml/2006/main">
               <a:ext uri="{FF2B5EF4-FFF2-40B4-BE49-F238E27FC236}">
-                <a16:creationId xmlns:a16="http://schemas.microsoft.com/office/drawing/2014/main" id="{300D9BF5-7575-4CC7-A3EF-50C04F190974}"/>
+                <a16:creationId xmlns:a16="http://schemas.microsoft.com/office/drawing/2014/main" id="{BC99F73A-D465-48C8-82C0-30569FB9857C}"/>
               </a:ext>
             </a:extLst>
           </p:cNvPr>
@@ -12476,7 +12511,7 @@
           <p:cNvPr id="11" name="">
             <a:extLst xmlns:a="http://schemas.openxmlformats.org/drawingml/2006/main">
               <a:ext uri="{FF2B5EF4-FFF2-40B4-BE49-F238E27FC236}">
-                <a16:creationId xmlns:a16="http://schemas.microsoft.com/office/drawing/2014/main" id="{B2394D6B-1626-45C3-857B-E0C4DEA28E25}"/>
+                <a16:creationId xmlns:a16="http://schemas.microsoft.com/office/drawing/2014/main" id="{4F743074-4BCA-47A8-BDA1-58E2569D0128}"/>
               </a:ext>
             </a:extLst>
           </p:cNvPr>
@@ -12507,7 +12542,7 @@
           <p:cNvPr id="12" name="">
             <a:extLst xmlns:a="http://schemas.openxmlformats.org/drawingml/2006/main">
               <a:ext uri="{FF2B5EF4-FFF2-40B4-BE49-F238E27FC236}">
-                <a16:creationId xmlns:a16="http://schemas.microsoft.com/office/drawing/2014/main" id="{E2173D45-BFFE-4164-84AA-1ACBE6A64C8D}"/>
+                <a16:creationId xmlns:a16="http://schemas.microsoft.com/office/drawing/2014/main" id="{072A0386-B8F9-4B00-99CC-D9DB178406CA}"/>
               </a:ext>
             </a:extLst>
           </p:cNvPr>
@@ -12569,7 +12604,7 @@
           <p:cNvPr id="13" name="">
             <a:extLst xmlns:a="http://schemas.openxmlformats.org/drawingml/2006/main">
               <a:ext uri="{FF2B5EF4-FFF2-40B4-BE49-F238E27FC236}">
-                <a16:creationId xmlns:a16="http://schemas.microsoft.com/office/drawing/2014/main" id="{4E6EA503-6024-4413-81E5-02344565112D}"/>
+                <a16:creationId xmlns:a16="http://schemas.microsoft.com/office/drawing/2014/main" id="{66054BB3-9C57-4E3B-8400-B0D7AFD3D680}"/>
               </a:ext>
             </a:extLst>
           </p:cNvPr>
@@ -12631,7 +12666,7 @@
           <p:cNvPr id="14" name="">
             <a:extLst xmlns:a="http://schemas.openxmlformats.org/drawingml/2006/main">
               <a:ext uri="{FF2B5EF4-FFF2-40B4-BE49-F238E27FC236}">
-                <a16:creationId xmlns:a16="http://schemas.microsoft.com/office/drawing/2014/main" id="{D57A9F9C-72FB-4A01-8100-45FC0EEC6F8C}"/>
+                <a16:creationId xmlns:a16="http://schemas.microsoft.com/office/drawing/2014/main" id="{1C023E0C-F1A0-4465-B65A-3CEB8CFEAAC2}"/>
               </a:ext>
             </a:extLst>
           </p:cNvPr>
@@ -12693,7 +12728,7 @@
           <p:cNvPr id="15" name="">
             <a:extLst xmlns:a="http://schemas.openxmlformats.org/drawingml/2006/main">
               <a:ext uri="{FF2B5EF4-FFF2-40B4-BE49-F238E27FC236}">
-                <a16:creationId xmlns:a16="http://schemas.microsoft.com/office/drawing/2014/main" id="{E65C7F8B-01E3-4AEA-908C-080A6350BE34}"/>
+                <a16:creationId xmlns:a16="http://schemas.microsoft.com/office/drawing/2014/main" id="{4FF94DE6-893B-4A4C-AF96-95D4EC4BF395}"/>
               </a:ext>
             </a:extLst>
           </p:cNvPr>
@@ -12724,7 +12759,7 @@
           <p:cNvPr id="16" name="">
             <a:extLst xmlns:a="http://schemas.openxmlformats.org/drawingml/2006/main">
               <a:ext uri="{FF2B5EF4-FFF2-40B4-BE49-F238E27FC236}">
-                <a16:creationId xmlns:a16="http://schemas.microsoft.com/office/drawing/2014/main" id="{6F9ACC67-395E-4741-A200-37A9DBE856FA}"/>
+                <a16:creationId xmlns:a16="http://schemas.microsoft.com/office/drawing/2014/main" id="{F4AD6F69-396C-4DAC-9DA3-7467E37CAC88}"/>
               </a:ext>
             </a:extLst>
           </p:cNvPr>
@@ -12786,7 +12821,7 @@
           <p:cNvPr id="17" name="">
             <a:extLst xmlns:a="http://schemas.openxmlformats.org/drawingml/2006/main">
               <a:ext uri="{FF2B5EF4-FFF2-40B4-BE49-F238E27FC236}">
-                <a16:creationId xmlns:a16="http://schemas.microsoft.com/office/drawing/2014/main" id="{0505064E-4153-40EA-B9CF-0BA10E4AA3D4}"/>
+                <a16:creationId xmlns:a16="http://schemas.microsoft.com/office/drawing/2014/main" id="{0D6A4380-4EEC-4600-97A2-51FC621B2F93}"/>
               </a:ext>
             </a:extLst>
           </p:cNvPr>
@@ -12848,7 +12883,7 @@
           <p:cNvPr id="18" name="">
             <a:extLst xmlns:a="http://schemas.openxmlformats.org/drawingml/2006/main">
               <a:ext uri="{FF2B5EF4-FFF2-40B4-BE49-F238E27FC236}">
-                <a16:creationId xmlns:a16="http://schemas.microsoft.com/office/drawing/2014/main" id="{AE5731F3-25F0-4BB0-A04F-D72AEC72C39A}"/>
+                <a16:creationId xmlns:a16="http://schemas.microsoft.com/office/drawing/2014/main" id="{5ACFEF26-4013-47EC-ABDA-977E5B4C1D57}"/>
               </a:ext>
             </a:extLst>
           </p:cNvPr>
@@ -12910,7 +12945,7 @@
           <p:cNvPr id="19" name="">
             <a:extLst xmlns:a="http://schemas.openxmlformats.org/drawingml/2006/main">
               <a:ext uri="{FF2B5EF4-FFF2-40B4-BE49-F238E27FC236}">
-                <a16:creationId xmlns:a16="http://schemas.microsoft.com/office/drawing/2014/main" id="{BBE25F73-7AAE-4D1B-9AC4-5636B25DEEA8}"/>
+                <a16:creationId xmlns:a16="http://schemas.microsoft.com/office/drawing/2014/main" id="{B1A674B1-BD5B-4D85-B12D-7154F39C02C5}"/>
               </a:ext>
             </a:extLst>
           </p:cNvPr>
@@ -12943,7 +12978,7 @@
           <p:cNvPr id="20" name="">
             <a:extLst xmlns:a="http://schemas.openxmlformats.org/drawingml/2006/main">
               <a:ext uri="{FF2B5EF4-FFF2-40B4-BE49-F238E27FC236}">
-                <a16:creationId xmlns:a16="http://schemas.microsoft.com/office/drawing/2014/main" id="{803D69E9-05A6-4B26-814F-E4C1C5E2419C}"/>
+                <a16:creationId xmlns:a16="http://schemas.microsoft.com/office/drawing/2014/main" id="{3E4F7AD6-2A76-4DDC-9836-263235E8C571}"/>
               </a:ext>
             </a:extLst>
           </p:cNvPr>
@@ -13009,7 +13044,7 @@
           <p:nvPr/>
         </p:nvPicPr>
         <p:blipFill>
-          <a:blip xmlns:r="http://schemas.openxmlformats.org/officeDocument/2006/relationships" xmlns:a="http://schemas.openxmlformats.org/drawingml/2006/main" r:embed="R88e609d9314d464b"/>
+          <a:blip xmlns:r="http://schemas.openxmlformats.org/officeDocument/2006/relationships" xmlns:a="http://schemas.openxmlformats.org/drawingml/2006/main" r:embed="R28175df7ed2f4a88"/>
           <a:stretch xmlns:a="http://schemas.openxmlformats.org/drawingml/2006/main"/>
         </p:blipFill>
         <p:spPr>
@@ -13027,7 +13062,7 @@
           <p:cNvPr id="22" name="footer-rule-18">
             <a:extLst xmlns:a="http://schemas.openxmlformats.org/drawingml/2006/main">
               <a:ext uri="{FF2B5EF4-FFF2-40B4-BE49-F238E27FC236}">
-                <a16:creationId xmlns:a16="http://schemas.microsoft.com/office/drawing/2014/main" id="{B3D8DDDC-04CA-428A-89B6-0576677529BA}"/>
+                <a16:creationId xmlns:a16="http://schemas.microsoft.com/office/drawing/2014/main" id="{363FD4A9-396E-4D38-A995-92B93734CF2D}"/>
               </a:ext>
             </a:extLst>
           </p:cNvPr>
@@ -13058,7 +13093,7 @@
           <p:cNvPr id="23" name="footer-label-18">
             <a:extLst xmlns:a="http://schemas.openxmlformats.org/drawingml/2006/main">
               <a:ext uri="{FF2B5EF4-FFF2-40B4-BE49-F238E27FC236}">
-                <a16:creationId xmlns:a16="http://schemas.microsoft.com/office/drawing/2014/main" id="{0CCD65DF-D858-43DF-97CD-7C4E1C193F15}"/>
+                <a16:creationId xmlns:a16="http://schemas.microsoft.com/office/drawing/2014/main" id="{C9A01771-94FA-4733-8A9D-3A462A460AFB}"/>
               </a:ext>
             </a:extLst>
           </p:cNvPr>
@@ -13120,7 +13155,7 @@
           <p:cNvPr id="24" name="footer-page-18">
             <a:extLst xmlns:a="http://schemas.openxmlformats.org/drawingml/2006/main">
               <a:ext uri="{FF2B5EF4-FFF2-40B4-BE49-F238E27FC236}">
-                <a16:creationId xmlns:a16="http://schemas.microsoft.com/office/drawing/2014/main" id="{C053B509-92B5-4DC2-BE6D-9A773DA5A4A0}"/>
+                <a16:creationId xmlns:a16="http://schemas.microsoft.com/office/drawing/2014/main" id="{B4E1D69A-96CB-47EC-B755-15787404D91F}"/>
               </a:ext>
             </a:extLst>
           </p:cNvPr>
@@ -13180,7 +13215,7 @@
     </p:spTree>
     <p:extLst>
       <p:ext uri="{BB962C8B-B14F-4D97-AF65-F5344CB8AC3E}">
-        <p14:creationId xmlns:p14="http://schemas.microsoft.com/office/powerpoint/2010/main" val="897520443"/>
+        <p14:creationId xmlns:p14="http://schemas.microsoft.com/office/powerpoint/2010/main" val="765405666"/>
       </p:ext>
     </p:extLst>
   </p:cSld>
@@ -13211,7 +13246,7 @@
           <p:cNvPr id="20" name="side-accent-2">
             <a:extLst xmlns:a="http://schemas.openxmlformats.org/drawingml/2006/main">
               <a:ext uri="{FF2B5EF4-FFF2-40B4-BE49-F238E27FC236}">
-                <a16:creationId xmlns:a16="http://schemas.microsoft.com/office/drawing/2014/main" id="{EE8A3F75-B425-406A-B6A9-30A30EE235FE}"/>
+                <a16:creationId xmlns:a16="http://schemas.microsoft.com/office/drawing/2014/main" id="{595D5517-BDB8-4C82-ADB1-24BDBED234EC}"/>
               </a:ext>
             </a:extLst>
           </p:cNvPr>
@@ -13242,7 +13277,7 @@
           <p:cNvPr id="2" name="kicker-2">
             <a:extLst xmlns:a="http://schemas.openxmlformats.org/drawingml/2006/main">
               <a:ext uri="{FF2B5EF4-FFF2-40B4-BE49-F238E27FC236}">
-                <a16:creationId xmlns:a16="http://schemas.microsoft.com/office/drawing/2014/main" id="{BDDDBBA2-59A2-4847-8A99-AEAA3AA12F0C}"/>
+                <a16:creationId xmlns:a16="http://schemas.microsoft.com/office/drawing/2014/main" id="{B6EF33E4-4B40-449F-B216-0F0A823107C5}"/>
               </a:ext>
             </a:extLst>
           </p:cNvPr>
@@ -13304,7 +13339,7 @@
           <p:cNvPr id="3" name="title-2">
             <a:extLst xmlns:a="http://schemas.openxmlformats.org/drawingml/2006/main">
               <a:ext uri="{FF2B5EF4-FFF2-40B4-BE49-F238E27FC236}">
-                <a16:creationId xmlns:a16="http://schemas.microsoft.com/office/drawing/2014/main" id="{7593CAD0-66FB-4C18-9A19-80234E461F3F}"/>
+                <a16:creationId xmlns:a16="http://schemas.microsoft.com/office/drawing/2014/main" id="{8F20A0A4-EE23-457C-BF93-73F45D891BDD}"/>
               </a:ext>
             </a:extLst>
           </p:cNvPr>
@@ -13366,7 +13401,7 @@
           <p:cNvPr id="4" name="">
             <a:extLst xmlns:a="http://schemas.openxmlformats.org/drawingml/2006/main">
               <a:ext uri="{FF2B5EF4-FFF2-40B4-BE49-F238E27FC236}">
-                <a16:creationId xmlns:a16="http://schemas.microsoft.com/office/drawing/2014/main" id="{B9029C25-9C7E-460E-BCD0-AE5E01276E31}"/>
+                <a16:creationId xmlns:a16="http://schemas.microsoft.com/office/drawing/2014/main" id="{3BF35536-ABF3-4C09-84A5-C11F20B37E4E}"/>
               </a:ext>
             </a:extLst>
           </p:cNvPr>
@@ -13428,7 +13463,7 @@
           <p:cNvPr id="5" name="">
             <a:extLst xmlns:a="http://schemas.openxmlformats.org/drawingml/2006/main">
               <a:ext uri="{FF2B5EF4-FFF2-40B4-BE49-F238E27FC236}">
-                <a16:creationId xmlns:a16="http://schemas.microsoft.com/office/drawing/2014/main" id="{C799D2F9-CA0E-4D40-9CEC-BF90B2B4DC92}"/>
+                <a16:creationId xmlns:a16="http://schemas.microsoft.com/office/drawing/2014/main" id="{3972673B-2F60-4828-86B1-856D5929A235}"/>
               </a:ext>
             </a:extLst>
           </p:cNvPr>
@@ -13490,7 +13525,7 @@
           <p:cNvPr id="6" name="">
             <a:extLst xmlns:a="http://schemas.openxmlformats.org/drawingml/2006/main">
               <a:ext uri="{FF2B5EF4-FFF2-40B4-BE49-F238E27FC236}">
-                <a16:creationId xmlns:a16="http://schemas.microsoft.com/office/drawing/2014/main" id="{A731E552-EBF8-4D6E-A249-068B8BAA3B31}"/>
+                <a16:creationId xmlns:a16="http://schemas.microsoft.com/office/drawing/2014/main" id="{0D082179-8453-4DDB-B090-6A2A622497DC}"/>
               </a:ext>
             </a:extLst>
           </p:cNvPr>
@@ -13521,7 +13556,7 @@
           <p:cNvPr id="7" name="">
             <a:extLst xmlns:a="http://schemas.openxmlformats.org/drawingml/2006/main">
               <a:ext uri="{FF2B5EF4-FFF2-40B4-BE49-F238E27FC236}">
-                <a16:creationId xmlns:a16="http://schemas.microsoft.com/office/drawing/2014/main" id="{8031B009-2DD2-4C7B-979C-7E16FBE59324}"/>
+                <a16:creationId xmlns:a16="http://schemas.microsoft.com/office/drawing/2014/main" id="{EF3572E0-F992-498B-8569-EA14E1B10241}"/>
               </a:ext>
             </a:extLst>
           </p:cNvPr>
@@ -13583,7 +13618,7 @@
           <p:cNvPr id="8" name="">
             <a:extLst xmlns:a="http://schemas.openxmlformats.org/drawingml/2006/main">
               <a:ext uri="{FF2B5EF4-FFF2-40B4-BE49-F238E27FC236}">
-                <a16:creationId xmlns:a16="http://schemas.microsoft.com/office/drawing/2014/main" id="{E27C3D08-E09F-4B15-A1EE-38B6C2090D9B}"/>
+                <a16:creationId xmlns:a16="http://schemas.microsoft.com/office/drawing/2014/main" id="{35DA4B7D-EC42-45B8-AD85-CDF50B68C2BD}"/>
               </a:ext>
             </a:extLst>
           </p:cNvPr>
@@ -13645,7 +13680,7 @@
           <p:cNvPr id="9" name="">
             <a:extLst xmlns:a="http://schemas.openxmlformats.org/drawingml/2006/main">
               <a:ext uri="{FF2B5EF4-FFF2-40B4-BE49-F238E27FC236}">
-                <a16:creationId xmlns:a16="http://schemas.microsoft.com/office/drawing/2014/main" id="{0F075DAF-6F6A-4BAD-963B-0580D3923AE0}"/>
+                <a16:creationId xmlns:a16="http://schemas.microsoft.com/office/drawing/2014/main" id="{A2EB07C2-6203-40F3-A9E3-66360130733A}"/>
               </a:ext>
             </a:extLst>
           </p:cNvPr>
@@ -13676,7 +13711,7 @@
           <p:cNvPr id="10" name="">
             <a:extLst xmlns:a="http://schemas.openxmlformats.org/drawingml/2006/main">
               <a:ext uri="{FF2B5EF4-FFF2-40B4-BE49-F238E27FC236}">
-                <a16:creationId xmlns:a16="http://schemas.microsoft.com/office/drawing/2014/main" id="{84B44EEA-65B8-4DC7-BCBB-2CA2813234E3}"/>
+                <a16:creationId xmlns:a16="http://schemas.microsoft.com/office/drawing/2014/main" id="{6BD242B7-0FB2-40C7-98C4-D4DD7519351D}"/>
               </a:ext>
             </a:extLst>
           </p:cNvPr>
@@ -13738,7 +13773,7 @@
           <p:cNvPr id="11" name="">
             <a:extLst xmlns:a="http://schemas.openxmlformats.org/drawingml/2006/main">
               <a:ext uri="{FF2B5EF4-FFF2-40B4-BE49-F238E27FC236}">
-                <a16:creationId xmlns:a16="http://schemas.microsoft.com/office/drawing/2014/main" id="{2412198E-4478-4B75-8FD7-A9477A8488E7}"/>
+                <a16:creationId xmlns:a16="http://schemas.microsoft.com/office/drawing/2014/main" id="{F78712DF-864C-41A3-BF26-4E2F7AC2060C}"/>
               </a:ext>
             </a:extLst>
           </p:cNvPr>
@@ -13800,7 +13835,7 @@
           <p:cNvPr id="12" name="">
             <a:extLst xmlns:a="http://schemas.openxmlformats.org/drawingml/2006/main">
               <a:ext uri="{FF2B5EF4-FFF2-40B4-BE49-F238E27FC236}">
-                <a16:creationId xmlns:a16="http://schemas.microsoft.com/office/drawing/2014/main" id="{0E71CEAE-6A1F-4800-AE16-CFB1F7B8EC0E}"/>
+                <a16:creationId xmlns:a16="http://schemas.microsoft.com/office/drawing/2014/main" id="{4AA49086-F734-40BE-AC97-327DAAE9F011}"/>
               </a:ext>
             </a:extLst>
           </p:cNvPr>
@@ -13831,7 +13866,7 @@
           <p:cNvPr id="13" name="">
             <a:extLst xmlns:a="http://schemas.openxmlformats.org/drawingml/2006/main">
               <a:ext uri="{FF2B5EF4-FFF2-40B4-BE49-F238E27FC236}">
-                <a16:creationId xmlns:a16="http://schemas.microsoft.com/office/drawing/2014/main" id="{B5FD0107-3079-4A45-8FFC-1CCF52730E5C}"/>
+                <a16:creationId xmlns:a16="http://schemas.microsoft.com/office/drawing/2014/main" id="{5A53E785-5E1A-4793-81D7-052BAAE772D2}"/>
               </a:ext>
             </a:extLst>
           </p:cNvPr>
@@ -13893,7 +13928,7 @@
           <p:cNvPr id="14" name="outcome-mark">
             <a:extLst xmlns:a="http://schemas.openxmlformats.org/drawingml/2006/main">
               <a:ext uri="{FF2B5EF4-FFF2-40B4-BE49-F238E27FC236}">
-                <a16:creationId xmlns:a16="http://schemas.microsoft.com/office/drawing/2014/main" id="{02E8A56F-AFFB-424C-BEEE-FA97CABF241C}"/>
+                <a16:creationId xmlns:a16="http://schemas.microsoft.com/office/drawing/2014/main" id="{63ABE921-9B98-4392-BCA2-74FFF5916D17}"/>
               </a:ext>
             </a:extLst>
           </p:cNvPr>
@@ -13928,7 +13963,7 @@
           <p:cNvPr id="15" name="">
             <a:extLst xmlns:a="http://schemas.openxmlformats.org/drawingml/2006/main">
               <a:ext uri="{FF2B5EF4-FFF2-40B4-BE49-F238E27FC236}">
-                <a16:creationId xmlns:a16="http://schemas.microsoft.com/office/drawing/2014/main" id="{88EAFD99-1FED-4657-B621-2D3E0D4BBB1A}"/>
+                <a16:creationId xmlns:a16="http://schemas.microsoft.com/office/drawing/2014/main" id="{FA5D7812-2117-44F3-8C68-ED13A55AF723}"/>
               </a:ext>
             </a:extLst>
           </p:cNvPr>
@@ -13990,7 +14025,7 @@
           <p:cNvPr id="16" name="">
             <a:extLst xmlns:a="http://schemas.openxmlformats.org/drawingml/2006/main">
               <a:ext uri="{FF2B5EF4-FFF2-40B4-BE49-F238E27FC236}">
-                <a16:creationId xmlns:a16="http://schemas.microsoft.com/office/drawing/2014/main" id="{58169EAD-BD52-4E62-AAD7-99C290704F3F}"/>
+                <a16:creationId xmlns:a16="http://schemas.microsoft.com/office/drawing/2014/main" id="{670A6AE7-8547-49AB-B41F-5D20257636F0}"/>
               </a:ext>
             </a:extLst>
           </p:cNvPr>
@@ -14079,7 +14114,7 @@
           <p:cNvPr id="17" name="footer-rule-2">
             <a:extLst xmlns:a="http://schemas.openxmlformats.org/drawingml/2006/main">
               <a:ext uri="{FF2B5EF4-FFF2-40B4-BE49-F238E27FC236}">
-                <a16:creationId xmlns:a16="http://schemas.microsoft.com/office/drawing/2014/main" id="{9DC6E4E1-5657-45A8-8A4C-CC2CD98AE1D8}"/>
+                <a16:creationId xmlns:a16="http://schemas.microsoft.com/office/drawing/2014/main" id="{79BCA9B5-AA47-4686-86C3-BC65643C8FE1}"/>
               </a:ext>
             </a:extLst>
           </p:cNvPr>
@@ -14110,7 +14145,7 @@
           <p:cNvPr id="18" name="footer-label-2">
             <a:extLst xmlns:a="http://schemas.openxmlformats.org/drawingml/2006/main">
               <a:ext uri="{FF2B5EF4-FFF2-40B4-BE49-F238E27FC236}">
-                <a16:creationId xmlns:a16="http://schemas.microsoft.com/office/drawing/2014/main" id="{FE0F0C69-BF5A-44BD-A8A9-782E06506D9C}"/>
+                <a16:creationId xmlns:a16="http://schemas.microsoft.com/office/drawing/2014/main" id="{DFA3F33A-FD33-429F-861D-A3172F6C9F3D}"/>
               </a:ext>
             </a:extLst>
           </p:cNvPr>
@@ -14172,7 +14207,7 @@
           <p:cNvPr id="19" name="footer-page-2">
             <a:extLst xmlns:a="http://schemas.openxmlformats.org/drawingml/2006/main">
               <a:ext uri="{FF2B5EF4-FFF2-40B4-BE49-F238E27FC236}">
-                <a16:creationId xmlns:a16="http://schemas.microsoft.com/office/drawing/2014/main" id="{004075C1-C592-4AF7-8DE1-8A0FA9183507}"/>
+                <a16:creationId xmlns:a16="http://schemas.microsoft.com/office/drawing/2014/main" id="{013C686F-1EAF-492C-80BF-BBA90206CFE6}"/>
               </a:ext>
             </a:extLst>
           </p:cNvPr>
@@ -14232,7 +14267,7 @@
     </p:spTree>
     <p:extLst>
       <p:ext uri="{BB962C8B-B14F-4D97-AF65-F5344CB8AC3E}">
-        <p14:creationId xmlns:p14="http://schemas.microsoft.com/office/powerpoint/2010/main" val="1838097806"/>
+        <p14:creationId xmlns:p14="http://schemas.microsoft.com/office/powerpoint/2010/main" val="1265464420"/>
       </p:ext>
     </p:extLst>
   </p:cSld>
@@ -14263,7 +14298,7 @@
           <p:cNvPr id="31" name="side-accent-3">
             <a:extLst xmlns:a="http://schemas.openxmlformats.org/drawingml/2006/main">
               <a:ext uri="{FF2B5EF4-FFF2-40B4-BE49-F238E27FC236}">
-                <a16:creationId xmlns:a16="http://schemas.microsoft.com/office/drawing/2014/main" id="{F2E350E8-9B64-4BA8-8EE1-F66125DF7E96}"/>
+                <a16:creationId xmlns:a16="http://schemas.microsoft.com/office/drawing/2014/main" id="{40224BDF-F3DD-4277-8D17-C8256EA57152}"/>
               </a:ext>
             </a:extLst>
           </p:cNvPr>
@@ -14294,7 +14329,7 @@
           <p:cNvPr id="2" name="kicker-3">
             <a:extLst xmlns:a="http://schemas.openxmlformats.org/drawingml/2006/main">
               <a:ext uri="{FF2B5EF4-FFF2-40B4-BE49-F238E27FC236}">
-                <a16:creationId xmlns:a16="http://schemas.microsoft.com/office/drawing/2014/main" id="{755AF7D8-07C1-4B94-B6E5-47C0B56E22C8}"/>
+                <a16:creationId xmlns:a16="http://schemas.microsoft.com/office/drawing/2014/main" id="{811B5D4C-16FE-4ED2-8E7C-64A86B412D82}"/>
               </a:ext>
             </a:extLst>
           </p:cNvPr>
@@ -14356,7 +14391,7 @@
           <p:cNvPr id="3" name="title-3">
             <a:extLst xmlns:a="http://schemas.openxmlformats.org/drawingml/2006/main">
               <a:ext uri="{FF2B5EF4-FFF2-40B4-BE49-F238E27FC236}">
-                <a16:creationId xmlns:a16="http://schemas.microsoft.com/office/drawing/2014/main" id="{C7C896D8-C0FF-43C4-9C68-575DBE1605BD}"/>
+                <a16:creationId xmlns:a16="http://schemas.microsoft.com/office/drawing/2014/main" id="{7EFF107A-DF10-43C7-AD13-609B61790CFA}"/>
               </a:ext>
             </a:extLst>
           </p:cNvPr>
@@ -14408,7 +14443,7 @@
                 <a:ea typeface="Tahoma"/>
                 <a:cs typeface="Tahoma"/>
               </a:rPr>
-              <a:t>MSU EVA ช่วยจัดการงานประเมินตั้งแต่เตรียมรอบจนถึงรายงานผล</a:t>
+              <a:t>ระบบช่วยจัดการงานประเมินตั้งแต่เตรียมรอบจนถึงรายงานผล</a:t>
             </a:r>
           </a:p>
         </p:txBody>
@@ -14418,7 +14453,7 @@
           <p:cNvPr id="4" name="">
             <a:extLst xmlns:a="http://schemas.openxmlformats.org/drawingml/2006/main">
               <a:ext uri="{FF2B5EF4-FFF2-40B4-BE49-F238E27FC236}">
-                <a16:creationId xmlns:a16="http://schemas.microsoft.com/office/drawing/2014/main" id="{500C65A0-3DE4-4DB8-84C1-D802003D6475}"/>
+                <a16:creationId xmlns:a16="http://schemas.microsoft.com/office/drawing/2014/main" id="{835F8572-13E0-4F2B-8F42-35042F8F2A21}"/>
               </a:ext>
             </a:extLst>
           </p:cNvPr>
@@ -14480,7 +14515,7 @@
           <p:cNvPr id="5" name="system-function-line">
             <a:extLst xmlns:a="http://schemas.openxmlformats.org/drawingml/2006/main">
               <a:ext uri="{FF2B5EF4-FFF2-40B4-BE49-F238E27FC236}">
-                <a16:creationId xmlns:a16="http://schemas.microsoft.com/office/drawing/2014/main" id="{F45968E9-5875-4A22-AC07-205A5ACF7FED}"/>
+                <a16:creationId xmlns:a16="http://schemas.microsoft.com/office/drawing/2014/main" id="{D2C1CA43-A563-4D85-B7CB-E0540A97630E}"/>
               </a:ext>
             </a:extLst>
           </p:cNvPr>
@@ -14511,7 +14546,7 @@
           <p:cNvPr id="6" name="">
             <a:extLst xmlns:a="http://schemas.openxmlformats.org/drawingml/2006/main">
               <a:ext uri="{FF2B5EF4-FFF2-40B4-BE49-F238E27FC236}">
-                <a16:creationId xmlns:a16="http://schemas.microsoft.com/office/drawing/2014/main" id="{A0E5350C-610C-4CF3-B7B2-497BFAEF7601}"/>
+                <a16:creationId xmlns:a16="http://schemas.microsoft.com/office/drawing/2014/main" id="{0BBA4C0F-3976-414B-ACD7-B3841ADC71F2}"/>
               </a:ext>
             </a:extLst>
           </p:cNvPr>
@@ -14542,7 +14577,7 @@
           <p:cNvPr id="7" name="">
             <a:extLst xmlns:a="http://schemas.openxmlformats.org/drawingml/2006/main">
               <a:ext uri="{FF2B5EF4-FFF2-40B4-BE49-F238E27FC236}">
-                <a16:creationId xmlns:a16="http://schemas.microsoft.com/office/drawing/2014/main" id="{2C358611-6D5F-4338-ABF2-23557F3C65D4}"/>
+                <a16:creationId xmlns:a16="http://schemas.microsoft.com/office/drawing/2014/main" id="{222DE765-EA3C-4FAE-8330-27614B0A7EA3}"/>
               </a:ext>
             </a:extLst>
           </p:cNvPr>
@@ -14604,7 +14639,7 @@
           <p:cNvPr id="8" name="">
             <a:extLst xmlns:a="http://schemas.openxmlformats.org/drawingml/2006/main">
               <a:ext uri="{FF2B5EF4-FFF2-40B4-BE49-F238E27FC236}">
-                <a16:creationId xmlns:a16="http://schemas.microsoft.com/office/drawing/2014/main" id="{36044F85-BD7D-4592-986A-88B5C1508703}"/>
+                <a16:creationId xmlns:a16="http://schemas.microsoft.com/office/drawing/2014/main" id="{EF2488C4-AA4C-4591-9DBD-23D3D457CF7B}"/>
               </a:ext>
             </a:extLst>
           </p:cNvPr>
@@ -14666,7 +14701,7 @@
           <p:cNvPr id="9" name="">
             <a:extLst xmlns:a="http://schemas.openxmlformats.org/drawingml/2006/main">
               <a:ext uri="{FF2B5EF4-FFF2-40B4-BE49-F238E27FC236}">
-                <a16:creationId xmlns:a16="http://schemas.microsoft.com/office/drawing/2014/main" id="{B8C76204-D484-46D7-B0F3-532A14D56477}"/>
+                <a16:creationId xmlns:a16="http://schemas.microsoft.com/office/drawing/2014/main" id="{A5DB427B-84BA-4258-8B33-D80169E1498F}"/>
               </a:ext>
             </a:extLst>
           </p:cNvPr>
@@ -14728,7 +14763,7 @@
           <p:cNvPr id="10" name="">
             <a:extLst xmlns:a="http://schemas.openxmlformats.org/drawingml/2006/main">
               <a:ext uri="{FF2B5EF4-FFF2-40B4-BE49-F238E27FC236}">
-                <a16:creationId xmlns:a16="http://schemas.microsoft.com/office/drawing/2014/main" id="{C631E163-3942-4161-B3F8-E06C9BFE9A32}"/>
+                <a16:creationId xmlns:a16="http://schemas.microsoft.com/office/drawing/2014/main" id="{D35D022C-B608-41A6-9216-4035F887499D}"/>
               </a:ext>
             </a:extLst>
           </p:cNvPr>
@@ -14759,7 +14794,7 @@
           <p:cNvPr id="11" name="">
             <a:extLst xmlns:a="http://schemas.openxmlformats.org/drawingml/2006/main">
               <a:ext uri="{FF2B5EF4-FFF2-40B4-BE49-F238E27FC236}">
-                <a16:creationId xmlns:a16="http://schemas.microsoft.com/office/drawing/2014/main" id="{1AF38157-8A5E-4FF4-9786-FD8BEF09FA47}"/>
+                <a16:creationId xmlns:a16="http://schemas.microsoft.com/office/drawing/2014/main" id="{F34D7062-32B6-497C-84D5-06DE1C5AD158}"/>
               </a:ext>
             </a:extLst>
           </p:cNvPr>
@@ -14821,7 +14856,7 @@
           <p:cNvPr id="12" name="">
             <a:extLst xmlns:a="http://schemas.openxmlformats.org/drawingml/2006/main">
               <a:ext uri="{FF2B5EF4-FFF2-40B4-BE49-F238E27FC236}">
-                <a16:creationId xmlns:a16="http://schemas.microsoft.com/office/drawing/2014/main" id="{717FC8FA-1E74-4A46-970A-2BCA1CFD0D20}"/>
+                <a16:creationId xmlns:a16="http://schemas.microsoft.com/office/drawing/2014/main" id="{8C3A6B27-7834-4FC6-87CC-A23CE75B7627}"/>
               </a:ext>
             </a:extLst>
           </p:cNvPr>
@@ -14883,7 +14918,7 @@
           <p:cNvPr id="13" name="">
             <a:extLst xmlns:a="http://schemas.openxmlformats.org/drawingml/2006/main">
               <a:ext uri="{FF2B5EF4-FFF2-40B4-BE49-F238E27FC236}">
-                <a16:creationId xmlns:a16="http://schemas.microsoft.com/office/drawing/2014/main" id="{701FFD51-A058-4B9A-AB1A-1A75CD48BA91}"/>
+                <a16:creationId xmlns:a16="http://schemas.microsoft.com/office/drawing/2014/main" id="{0E344782-8FD9-486F-B766-EA47A5CFD206}"/>
               </a:ext>
             </a:extLst>
           </p:cNvPr>
@@ -14945,7 +14980,7 @@
           <p:cNvPr id="14" name="">
             <a:extLst xmlns:a="http://schemas.openxmlformats.org/drawingml/2006/main">
               <a:ext uri="{FF2B5EF4-FFF2-40B4-BE49-F238E27FC236}">
-                <a16:creationId xmlns:a16="http://schemas.microsoft.com/office/drawing/2014/main" id="{9B497B34-37EA-494E-B7E7-6CE077F62E45}"/>
+                <a16:creationId xmlns:a16="http://schemas.microsoft.com/office/drawing/2014/main" id="{EAAC5204-A6CE-4091-A537-642E59CB7851}"/>
               </a:ext>
             </a:extLst>
           </p:cNvPr>
@@ -14976,7 +15011,7 @@
           <p:cNvPr id="15" name="">
             <a:extLst xmlns:a="http://schemas.openxmlformats.org/drawingml/2006/main">
               <a:ext uri="{FF2B5EF4-FFF2-40B4-BE49-F238E27FC236}">
-                <a16:creationId xmlns:a16="http://schemas.microsoft.com/office/drawing/2014/main" id="{11FC374A-2C92-4777-90AF-5DDC10C8DA7E}"/>
+                <a16:creationId xmlns:a16="http://schemas.microsoft.com/office/drawing/2014/main" id="{4FFE7BCF-77E1-4638-98EB-84F50004F6F4}"/>
               </a:ext>
             </a:extLst>
           </p:cNvPr>
@@ -15038,7 +15073,7 @@
           <p:cNvPr id="16" name="">
             <a:extLst xmlns:a="http://schemas.openxmlformats.org/drawingml/2006/main">
               <a:ext uri="{FF2B5EF4-FFF2-40B4-BE49-F238E27FC236}">
-                <a16:creationId xmlns:a16="http://schemas.microsoft.com/office/drawing/2014/main" id="{E0A752C5-CE54-4415-98D2-AC8FAC459350}"/>
+                <a16:creationId xmlns:a16="http://schemas.microsoft.com/office/drawing/2014/main" id="{E5276103-1A8F-42A7-A173-F2DF08415FDD}"/>
               </a:ext>
             </a:extLst>
           </p:cNvPr>
@@ -15100,7 +15135,7 @@
           <p:cNvPr id="17" name="">
             <a:extLst xmlns:a="http://schemas.openxmlformats.org/drawingml/2006/main">
               <a:ext uri="{FF2B5EF4-FFF2-40B4-BE49-F238E27FC236}">
-                <a16:creationId xmlns:a16="http://schemas.microsoft.com/office/drawing/2014/main" id="{DF6D1A83-69D9-4FDF-AD36-3301E04693C0}"/>
+                <a16:creationId xmlns:a16="http://schemas.microsoft.com/office/drawing/2014/main" id="{D45B3336-40DF-4162-A9A7-A71AE5A7BF20}"/>
               </a:ext>
             </a:extLst>
           </p:cNvPr>
@@ -15162,7 +15197,7 @@
           <p:cNvPr id="18" name="">
             <a:extLst xmlns:a="http://schemas.openxmlformats.org/drawingml/2006/main">
               <a:ext uri="{FF2B5EF4-FFF2-40B4-BE49-F238E27FC236}">
-                <a16:creationId xmlns:a16="http://schemas.microsoft.com/office/drawing/2014/main" id="{F953ADB7-262F-47AA-9812-D960A9E129E2}"/>
+                <a16:creationId xmlns:a16="http://schemas.microsoft.com/office/drawing/2014/main" id="{BEA7A5F7-F4F2-47D4-B6E4-E4CFDE9F20CB}"/>
               </a:ext>
             </a:extLst>
           </p:cNvPr>
@@ -15193,7 +15228,7 @@
           <p:cNvPr id="19" name="">
             <a:extLst xmlns:a="http://schemas.openxmlformats.org/drawingml/2006/main">
               <a:ext uri="{FF2B5EF4-FFF2-40B4-BE49-F238E27FC236}">
-                <a16:creationId xmlns:a16="http://schemas.microsoft.com/office/drawing/2014/main" id="{8B538E05-922F-42B2-8AAF-019D98CC70DC}"/>
+                <a16:creationId xmlns:a16="http://schemas.microsoft.com/office/drawing/2014/main" id="{86D65A02-415A-44F8-A121-0AFEE6CE45D4}"/>
               </a:ext>
             </a:extLst>
           </p:cNvPr>
@@ -15255,7 +15290,7 @@
           <p:cNvPr id="20" name="">
             <a:extLst xmlns:a="http://schemas.openxmlformats.org/drawingml/2006/main">
               <a:ext uri="{FF2B5EF4-FFF2-40B4-BE49-F238E27FC236}">
-                <a16:creationId xmlns:a16="http://schemas.microsoft.com/office/drawing/2014/main" id="{CA3AB3C8-95A7-4130-90D5-49F078DD56F9}"/>
+                <a16:creationId xmlns:a16="http://schemas.microsoft.com/office/drawing/2014/main" id="{7707FE86-1927-4A19-A495-6E0817D60474}"/>
               </a:ext>
             </a:extLst>
           </p:cNvPr>
@@ -15317,7 +15352,7 @@
           <p:cNvPr id="21" name="">
             <a:extLst xmlns:a="http://schemas.openxmlformats.org/drawingml/2006/main">
               <a:ext uri="{FF2B5EF4-FFF2-40B4-BE49-F238E27FC236}">
-                <a16:creationId xmlns:a16="http://schemas.microsoft.com/office/drawing/2014/main" id="{21722920-4CE9-4626-8B70-BA3659698E4D}"/>
+                <a16:creationId xmlns:a16="http://schemas.microsoft.com/office/drawing/2014/main" id="{C04B04FE-F57A-4DD1-A6C9-E08EDA9484F3}"/>
               </a:ext>
             </a:extLst>
           </p:cNvPr>
@@ -15379,7 +15414,7 @@
           <p:cNvPr id="22" name="">
             <a:extLst xmlns:a="http://schemas.openxmlformats.org/drawingml/2006/main">
               <a:ext uri="{FF2B5EF4-FFF2-40B4-BE49-F238E27FC236}">
-                <a16:creationId xmlns:a16="http://schemas.microsoft.com/office/drawing/2014/main" id="{D3759146-FA85-46C3-BFE5-F5D7E1E2EC55}"/>
+                <a16:creationId xmlns:a16="http://schemas.microsoft.com/office/drawing/2014/main" id="{BDFE7E7F-EA5C-45BE-AC76-DFEFDB7E363B}"/>
               </a:ext>
             </a:extLst>
           </p:cNvPr>
@@ -15410,7 +15445,7 @@
           <p:cNvPr id="23" name="">
             <a:extLst xmlns:a="http://schemas.openxmlformats.org/drawingml/2006/main">
               <a:ext uri="{FF2B5EF4-FFF2-40B4-BE49-F238E27FC236}">
-                <a16:creationId xmlns:a16="http://schemas.microsoft.com/office/drawing/2014/main" id="{7C5F5DBB-ED5E-4842-8440-86E8E7EF44F3}"/>
+                <a16:creationId xmlns:a16="http://schemas.microsoft.com/office/drawing/2014/main" id="{5795F742-A652-485D-8249-07FE7AEF0767}"/>
               </a:ext>
             </a:extLst>
           </p:cNvPr>
@@ -15472,7 +15507,7 @@
           <p:cNvPr id="24" name="">
             <a:extLst xmlns:a="http://schemas.openxmlformats.org/drawingml/2006/main">
               <a:ext uri="{FF2B5EF4-FFF2-40B4-BE49-F238E27FC236}">
-                <a16:creationId xmlns:a16="http://schemas.microsoft.com/office/drawing/2014/main" id="{7D35BF76-BCE7-4C04-952C-54115CEDC6BB}"/>
+                <a16:creationId xmlns:a16="http://schemas.microsoft.com/office/drawing/2014/main" id="{E2686F3D-0ABF-46ED-8622-89423E24835E}"/>
               </a:ext>
             </a:extLst>
           </p:cNvPr>
@@ -15534,7 +15569,7 @@
           <p:cNvPr id="25" name="">
             <a:extLst xmlns:a="http://schemas.openxmlformats.org/drawingml/2006/main">
               <a:ext uri="{FF2B5EF4-FFF2-40B4-BE49-F238E27FC236}">
-                <a16:creationId xmlns:a16="http://schemas.microsoft.com/office/drawing/2014/main" id="{C845F128-A7D1-4D32-B128-529857B80E6B}"/>
+                <a16:creationId xmlns:a16="http://schemas.microsoft.com/office/drawing/2014/main" id="{274D21A2-8CD0-4517-8499-4C1E1749BD59}"/>
               </a:ext>
             </a:extLst>
           </p:cNvPr>
@@ -15596,7 +15631,7 @@
           <p:cNvPr id="26" name="">
             <a:extLst xmlns:a="http://schemas.openxmlformats.org/drawingml/2006/main">
               <a:ext uri="{FF2B5EF4-FFF2-40B4-BE49-F238E27FC236}">
-                <a16:creationId xmlns:a16="http://schemas.microsoft.com/office/drawing/2014/main" id="{D203165F-FFD6-4E64-83C2-CDECD946F402}"/>
+                <a16:creationId xmlns:a16="http://schemas.microsoft.com/office/drawing/2014/main" id="{CAA66A98-E9D2-4923-8182-4EC070C234B8}"/>
               </a:ext>
             </a:extLst>
           </p:cNvPr>
@@ -15629,7 +15664,7 @@
           <p:cNvPr id="27" name="">
             <a:extLst xmlns:a="http://schemas.openxmlformats.org/drawingml/2006/main">
               <a:ext uri="{FF2B5EF4-FFF2-40B4-BE49-F238E27FC236}">
-                <a16:creationId xmlns:a16="http://schemas.microsoft.com/office/drawing/2014/main" id="{8AB96B50-978D-4B3D-9D2E-89B2573273E1}"/>
+                <a16:creationId xmlns:a16="http://schemas.microsoft.com/office/drawing/2014/main" id="{7E3DE113-A9E5-4C65-AF08-A4946DFDBEFE}"/>
               </a:ext>
             </a:extLst>
           </p:cNvPr>
@@ -15691,7 +15726,7 @@
           <p:cNvPr id="28" name="footer-rule-3">
             <a:extLst xmlns:a="http://schemas.openxmlformats.org/drawingml/2006/main">
               <a:ext uri="{FF2B5EF4-FFF2-40B4-BE49-F238E27FC236}">
-                <a16:creationId xmlns:a16="http://schemas.microsoft.com/office/drawing/2014/main" id="{15F456C0-CBD7-43C4-8075-074AA5A49D0B}"/>
+                <a16:creationId xmlns:a16="http://schemas.microsoft.com/office/drawing/2014/main" id="{6E151584-4831-4291-B101-F31A8D10550E}"/>
               </a:ext>
             </a:extLst>
           </p:cNvPr>
@@ -15722,7 +15757,7 @@
           <p:cNvPr id="29" name="footer-label-3">
             <a:extLst xmlns:a="http://schemas.openxmlformats.org/drawingml/2006/main">
               <a:ext uri="{FF2B5EF4-FFF2-40B4-BE49-F238E27FC236}">
-                <a16:creationId xmlns:a16="http://schemas.microsoft.com/office/drawing/2014/main" id="{00D6ADE4-2136-4044-9CF5-E266E14FD47D}"/>
+                <a16:creationId xmlns:a16="http://schemas.microsoft.com/office/drawing/2014/main" id="{AA366E99-6EB2-4D71-BE4F-CB85AEC27641}"/>
               </a:ext>
             </a:extLst>
           </p:cNvPr>
@@ -15784,7 +15819,7 @@
           <p:cNvPr id="30" name="footer-page-3">
             <a:extLst xmlns:a="http://schemas.openxmlformats.org/drawingml/2006/main">
               <a:ext uri="{FF2B5EF4-FFF2-40B4-BE49-F238E27FC236}">
-                <a16:creationId xmlns:a16="http://schemas.microsoft.com/office/drawing/2014/main" id="{20D260B9-E033-4037-9D16-02716B6349B4}"/>
+                <a16:creationId xmlns:a16="http://schemas.microsoft.com/office/drawing/2014/main" id="{226C910F-AA79-4587-A2C3-C6269422A3E1}"/>
               </a:ext>
             </a:extLst>
           </p:cNvPr>
@@ -15844,7 +15879,7 @@
     </p:spTree>
     <p:extLst>
       <p:ext uri="{BB962C8B-B14F-4D97-AF65-F5344CB8AC3E}">
-        <p14:creationId xmlns:p14="http://schemas.microsoft.com/office/powerpoint/2010/main" val="1816140772"/>
+        <p14:creationId xmlns:p14="http://schemas.microsoft.com/office/powerpoint/2010/main" val="436023858"/>
       </p:ext>
     </p:extLst>
   </p:cSld>
@@ -15875,7 +15910,7 @@
           <p:cNvPr id="28" name="side-accent-4">
             <a:extLst xmlns:a="http://schemas.openxmlformats.org/drawingml/2006/main">
               <a:ext uri="{FF2B5EF4-FFF2-40B4-BE49-F238E27FC236}">
-                <a16:creationId xmlns:a16="http://schemas.microsoft.com/office/drawing/2014/main" id="{AF00E0AF-FBC2-4F69-9A99-733C509CCA5F}"/>
+                <a16:creationId xmlns:a16="http://schemas.microsoft.com/office/drawing/2014/main" id="{1C31631C-CB40-4FA5-BD7C-A25307FA990F}"/>
               </a:ext>
             </a:extLst>
           </p:cNvPr>
@@ -15906,7 +15941,7 @@
           <p:cNvPr id="2" name="kicker-4">
             <a:extLst xmlns:a="http://schemas.openxmlformats.org/drawingml/2006/main">
               <a:ext uri="{FF2B5EF4-FFF2-40B4-BE49-F238E27FC236}">
-                <a16:creationId xmlns:a16="http://schemas.microsoft.com/office/drawing/2014/main" id="{78DF0453-3038-49C3-BF02-8C9E5BA50A4C}"/>
+                <a16:creationId xmlns:a16="http://schemas.microsoft.com/office/drawing/2014/main" id="{D61E902E-A8D9-4F85-B759-ACAB9C5EE1F9}"/>
               </a:ext>
             </a:extLst>
           </p:cNvPr>
@@ -15968,7 +16003,7 @@
           <p:cNvPr id="3" name="title-4">
             <a:extLst xmlns:a="http://schemas.openxmlformats.org/drawingml/2006/main">
               <a:ext uri="{FF2B5EF4-FFF2-40B4-BE49-F238E27FC236}">
-                <a16:creationId xmlns:a16="http://schemas.microsoft.com/office/drawing/2014/main" id="{32C5FF77-525B-4F49-9BC1-D79AA6DB9AB8}"/>
+                <a16:creationId xmlns:a16="http://schemas.microsoft.com/office/drawing/2014/main" id="{23D67EA1-22C4-497F-A919-5789291F7141}"/>
               </a:ext>
             </a:extLst>
           </p:cNvPr>
@@ -16030,7 +16065,7 @@
           <p:cNvPr id="4" name="">
             <a:extLst xmlns:a="http://schemas.openxmlformats.org/drawingml/2006/main">
               <a:ext uri="{FF2B5EF4-FFF2-40B4-BE49-F238E27FC236}">
-                <a16:creationId xmlns:a16="http://schemas.microsoft.com/office/drawing/2014/main" id="{899D9A1B-F8C3-4EA1-9A6D-BEFCF5F5AF86}"/>
+                <a16:creationId xmlns:a16="http://schemas.microsoft.com/office/drawing/2014/main" id="{1DA08E93-37E2-4DB7-85B3-F0BCD0F65B85}"/>
               </a:ext>
             </a:extLst>
           </p:cNvPr>
@@ -16092,7 +16127,7 @@
           <p:cNvPr id="5" name="">
             <a:extLst xmlns:a="http://schemas.openxmlformats.org/drawingml/2006/main">
               <a:ext uri="{FF2B5EF4-FFF2-40B4-BE49-F238E27FC236}">
-                <a16:creationId xmlns:a16="http://schemas.microsoft.com/office/drawing/2014/main" id="{BDDC9ED7-6076-47BA-9098-4B9458F42436}"/>
+                <a16:creationId xmlns:a16="http://schemas.microsoft.com/office/drawing/2014/main" id="{18ECF113-32D3-449A-BFEF-A6F33B953427}"/>
               </a:ext>
             </a:extLst>
           </p:cNvPr>
@@ -16154,7 +16189,7 @@
           <p:cNvPr id="6" name="">
             <a:extLst xmlns:a="http://schemas.openxmlformats.org/drawingml/2006/main">
               <a:ext uri="{FF2B5EF4-FFF2-40B4-BE49-F238E27FC236}">
-                <a16:creationId xmlns:a16="http://schemas.microsoft.com/office/drawing/2014/main" id="{20AB19FC-4557-42DA-8C7D-F753EE968637}"/>
+                <a16:creationId xmlns:a16="http://schemas.microsoft.com/office/drawing/2014/main" id="{073F2673-1F94-4F7F-A981-62D6115A7325}"/>
               </a:ext>
             </a:extLst>
           </p:cNvPr>
@@ -16216,7 +16251,7 @@
           <p:cNvPr id="7" name="">
             <a:extLst xmlns:a="http://schemas.openxmlformats.org/drawingml/2006/main">
               <a:ext uri="{FF2B5EF4-FFF2-40B4-BE49-F238E27FC236}">
-                <a16:creationId xmlns:a16="http://schemas.microsoft.com/office/drawing/2014/main" id="{363FEF46-8F29-4A79-B97A-D76F73C04EA0}"/>
+                <a16:creationId xmlns:a16="http://schemas.microsoft.com/office/drawing/2014/main" id="{9CC19653-8A37-4620-9FB1-A1013E7369E7}"/>
               </a:ext>
             </a:extLst>
           </p:cNvPr>
@@ -16247,7 +16282,7 @@
           <p:cNvPr id="8" name="">
             <a:extLst xmlns:a="http://schemas.openxmlformats.org/drawingml/2006/main">
               <a:ext uri="{FF2B5EF4-FFF2-40B4-BE49-F238E27FC236}">
-                <a16:creationId xmlns:a16="http://schemas.microsoft.com/office/drawing/2014/main" id="{129E2460-47A7-4D80-B84A-9E0549B964B2}"/>
+                <a16:creationId xmlns:a16="http://schemas.microsoft.com/office/drawing/2014/main" id="{AAA7BADF-FAB1-4AE3-80A9-B664F921F89B}"/>
               </a:ext>
             </a:extLst>
           </p:cNvPr>
@@ -16309,7 +16344,7 @@
           <p:cNvPr id="9" name="">
             <a:extLst xmlns:a="http://schemas.openxmlformats.org/drawingml/2006/main">
               <a:ext uri="{FF2B5EF4-FFF2-40B4-BE49-F238E27FC236}">
-                <a16:creationId xmlns:a16="http://schemas.microsoft.com/office/drawing/2014/main" id="{28003481-D8B8-4506-B823-290B386C8F2A}"/>
+                <a16:creationId xmlns:a16="http://schemas.microsoft.com/office/drawing/2014/main" id="{18711FDF-BAC0-4A21-B326-FA44BCDC9FD2}"/>
               </a:ext>
             </a:extLst>
           </p:cNvPr>
@@ -16371,7 +16406,7 @@
           <p:cNvPr id="10" name="">
             <a:extLst xmlns:a="http://schemas.openxmlformats.org/drawingml/2006/main">
               <a:ext uri="{FF2B5EF4-FFF2-40B4-BE49-F238E27FC236}">
-                <a16:creationId xmlns:a16="http://schemas.microsoft.com/office/drawing/2014/main" id="{96925E68-834A-462A-98B2-9537792F18B1}"/>
+                <a16:creationId xmlns:a16="http://schemas.microsoft.com/office/drawing/2014/main" id="{FDF3C91D-7E9D-439A-9F9D-E2A8904921BD}"/>
               </a:ext>
             </a:extLst>
           </p:cNvPr>
@@ -16433,7 +16468,7 @@
           <p:cNvPr id="11" name="">
             <a:extLst xmlns:a="http://schemas.openxmlformats.org/drawingml/2006/main">
               <a:ext uri="{FF2B5EF4-FFF2-40B4-BE49-F238E27FC236}">
-                <a16:creationId xmlns:a16="http://schemas.microsoft.com/office/drawing/2014/main" id="{8927808A-71D4-4199-B0EF-2976D0C96C51}"/>
+                <a16:creationId xmlns:a16="http://schemas.microsoft.com/office/drawing/2014/main" id="{5B923009-D664-4A9F-BE06-E3F093D22582}"/>
               </a:ext>
             </a:extLst>
           </p:cNvPr>
@@ -16464,7 +16499,7 @@
           <p:cNvPr id="12" name="">
             <a:extLst xmlns:a="http://schemas.openxmlformats.org/drawingml/2006/main">
               <a:ext uri="{FF2B5EF4-FFF2-40B4-BE49-F238E27FC236}">
-                <a16:creationId xmlns:a16="http://schemas.microsoft.com/office/drawing/2014/main" id="{D70DD5AB-5BB0-4AD3-8ABF-8E57D65F8E9A}"/>
+                <a16:creationId xmlns:a16="http://schemas.microsoft.com/office/drawing/2014/main" id="{70C3CE3C-C0BC-4DAA-8CFB-A6EA298DB6FA}"/>
               </a:ext>
             </a:extLst>
           </p:cNvPr>
@@ -16526,7 +16561,7 @@
           <p:cNvPr id="13" name="">
             <a:extLst xmlns:a="http://schemas.openxmlformats.org/drawingml/2006/main">
               <a:ext uri="{FF2B5EF4-FFF2-40B4-BE49-F238E27FC236}">
-                <a16:creationId xmlns:a16="http://schemas.microsoft.com/office/drawing/2014/main" id="{5AF8B71A-1022-42A6-B677-953B41D0BE84}"/>
+                <a16:creationId xmlns:a16="http://schemas.microsoft.com/office/drawing/2014/main" id="{436C8105-7DAD-4892-9F66-6FA6185F2801}"/>
               </a:ext>
             </a:extLst>
           </p:cNvPr>
@@ -16588,7 +16623,7 @@
           <p:cNvPr id="14" name="">
             <a:extLst xmlns:a="http://schemas.openxmlformats.org/drawingml/2006/main">
               <a:ext uri="{FF2B5EF4-FFF2-40B4-BE49-F238E27FC236}">
-                <a16:creationId xmlns:a16="http://schemas.microsoft.com/office/drawing/2014/main" id="{1D7E9109-24B9-4DFC-A484-34C83745D8CC}"/>
+                <a16:creationId xmlns:a16="http://schemas.microsoft.com/office/drawing/2014/main" id="{2CDF91BE-DC4F-4DCC-8C7D-44E6DD9209A8}"/>
               </a:ext>
             </a:extLst>
           </p:cNvPr>
@@ -16650,7 +16685,7 @@
           <p:cNvPr id="15" name="">
             <a:extLst xmlns:a="http://schemas.openxmlformats.org/drawingml/2006/main">
               <a:ext uri="{FF2B5EF4-FFF2-40B4-BE49-F238E27FC236}">
-                <a16:creationId xmlns:a16="http://schemas.microsoft.com/office/drawing/2014/main" id="{DDE91CFD-BC97-4948-A56D-169855BFAF8B}"/>
+                <a16:creationId xmlns:a16="http://schemas.microsoft.com/office/drawing/2014/main" id="{EBB4EFC4-9C79-4861-A93D-D9B9EA383B84}"/>
               </a:ext>
             </a:extLst>
           </p:cNvPr>
@@ -16681,7 +16716,7 @@
           <p:cNvPr id="16" name="">
             <a:extLst xmlns:a="http://schemas.openxmlformats.org/drawingml/2006/main">
               <a:ext uri="{FF2B5EF4-FFF2-40B4-BE49-F238E27FC236}">
-                <a16:creationId xmlns:a16="http://schemas.microsoft.com/office/drawing/2014/main" id="{DDB8EEFF-5CD6-49CF-A7BB-6D946724DA2C}"/>
+                <a16:creationId xmlns:a16="http://schemas.microsoft.com/office/drawing/2014/main" id="{8555D467-2491-4204-85F5-EF9458F02718}"/>
               </a:ext>
             </a:extLst>
           </p:cNvPr>
@@ -16743,7 +16778,7 @@
           <p:cNvPr id="17" name="">
             <a:extLst xmlns:a="http://schemas.openxmlformats.org/drawingml/2006/main">
               <a:ext uri="{FF2B5EF4-FFF2-40B4-BE49-F238E27FC236}">
-                <a16:creationId xmlns:a16="http://schemas.microsoft.com/office/drawing/2014/main" id="{174C4C80-D6D6-4A38-8B67-8562BBB1F800}"/>
+                <a16:creationId xmlns:a16="http://schemas.microsoft.com/office/drawing/2014/main" id="{15814E78-9889-4D92-95F5-666FEFBF48E0}"/>
               </a:ext>
             </a:extLst>
           </p:cNvPr>
@@ -16805,7 +16840,7 @@
           <p:cNvPr id="18" name="">
             <a:extLst xmlns:a="http://schemas.openxmlformats.org/drawingml/2006/main">
               <a:ext uri="{FF2B5EF4-FFF2-40B4-BE49-F238E27FC236}">
-                <a16:creationId xmlns:a16="http://schemas.microsoft.com/office/drawing/2014/main" id="{E30698B3-9CBD-4183-BDC7-7AD872B76715}"/>
+                <a16:creationId xmlns:a16="http://schemas.microsoft.com/office/drawing/2014/main" id="{CB160DB2-73BA-4FE7-B7BB-2CB244AA8C22}"/>
               </a:ext>
             </a:extLst>
           </p:cNvPr>
@@ -16867,7 +16902,7 @@
           <p:cNvPr id="19" name="">
             <a:extLst xmlns:a="http://schemas.openxmlformats.org/drawingml/2006/main">
               <a:ext uri="{FF2B5EF4-FFF2-40B4-BE49-F238E27FC236}">
-                <a16:creationId xmlns:a16="http://schemas.microsoft.com/office/drawing/2014/main" id="{3485E52B-38BD-4EBC-B257-76A13B6C84C7}"/>
+                <a16:creationId xmlns:a16="http://schemas.microsoft.com/office/drawing/2014/main" id="{3B30BE2A-E669-4B41-8227-14A938E7A1C6}"/>
               </a:ext>
             </a:extLst>
           </p:cNvPr>
@@ -16898,7 +16933,7 @@
           <p:cNvPr id="20" name="">
             <a:extLst xmlns:a="http://schemas.openxmlformats.org/drawingml/2006/main">
               <a:ext uri="{FF2B5EF4-FFF2-40B4-BE49-F238E27FC236}">
-                <a16:creationId xmlns:a16="http://schemas.microsoft.com/office/drawing/2014/main" id="{ACA922A5-11DC-40FB-8057-E5EDDB19C276}"/>
+                <a16:creationId xmlns:a16="http://schemas.microsoft.com/office/drawing/2014/main" id="{AB101D15-D96D-4241-ABCF-141CE2673F6E}"/>
               </a:ext>
             </a:extLst>
           </p:cNvPr>
@@ -16960,7 +16995,7 @@
           <p:cNvPr id="21" name="">
             <a:extLst xmlns:a="http://schemas.openxmlformats.org/drawingml/2006/main">
               <a:ext uri="{FF2B5EF4-FFF2-40B4-BE49-F238E27FC236}">
-                <a16:creationId xmlns:a16="http://schemas.microsoft.com/office/drawing/2014/main" id="{E4D9214B-CC63-4CFA-806C-BC60CA6AC10C}"/>
+                <a16:creationId xmlns:a16="http://schemas.microsoft.com/office/drawing/2014/main" id="{9A14BA09-E2AB-4281-8F94-2F851226AD8B}"/>
               </a:ext>
             </a:extLst>
           </p:cNvPr>
@@ -17022,7 +17057,7 @@
           <p:cNvPr id="22" name="">
             <a:extLst xmlns:a="http://schemas.openxmlformats.org/drawingml/2006/main">
               <a:ext uri="{FF2B5EF4-FFF2-40B4-BE49-F238E27FC236}">
-                <a16:creationId xmlns:a16="http://schemas.microsoft.com/office/drawing/2014/main" id="{D2F7E489-97D8-4F58-91B8-258AF833EAEF}"/>
+                <a16:creationId xmlns:a16="http://schemas.microsoft.com/office/drawing/2014/main" id="{B64F3F27-B149-4FCE-93A2-396643E801F3}"/>
               </a:ext>
             </a:extLst>
           </p:cNvPr>
@@ -17084,7 +17119,7 @@
           <p:cNvPr id="23" name="">
             <a:extLst xmlns:a="http://schemas.openxmlformats.org/drawingml/2006/main">
               <a:ext uri="{FF2B5EF4-FFF2-40B4-BE49-F238E27FC236}">
-                <a16:creationId xmlns:a16="http://schemas.microsoft.com/office/drawing/2014/main" id="{91F74158-B3CE-4F19-8A41-D58E73FF88C2}"/>
+                <a16:creationId xmlns:a16="http://schemas.microsoft.com/office/drawing/2014/main" id="{2D39D6B0-5EAC-4FA0-B1FC-E36F8DE43BE0}"/>
               </a:ext>
             </a:extLst>
           </p:cNvPr>
@@ -17117,7 +17152,7 @@
           <p:cNvPr id="24" name="">
             <a:extLst xmlns:a="http://schemas.openxmlformats.org/drawingml/2006/main">
               <a:ext uri="{FF2B5EF4-FFF2-40B4-BE49-F238E27FC236}">
-                <a16:creationId xmlns:a16="http://schemas.microsoft.com/office/drawing/2014/main" id="{A2C410E8-7D6E-4083-95C2-642F74996DBC}"/>
+                <a16:creationId xmlns:a16="http://schemas.microsoft.com/office/drawing/2014/main" id="{5AA3CF00-82C7-4825-BA5B-FFAF4A46B28B}"/>
               </a:ext>
             </a:extLst>
           </p:cNvPr>
@@ -17179,7 +17214,7 @@
           <p:cNvPr id="25" name="footer-rule-4">
             <a:extLst xmlns:a="http://schemas.openxmlformats.org/drawingml/2006/main">
               <a:ext uri="{FF2B5EF4-FFF2-40B4-BE49-F238E27FC236}">
-                <a16:creationId xmlns:a16="http://schemas.microsoft.com/office/drawing/2014/main" id="{207E606E-2AC2-4034-ADAA-22FDCFC39E62}"/>
+                <a16:creationId xmlns:a16="http://schemas.microsoft.com/office/drawing/2014/main" id="{E16B757F-4FBC-4504-B8C7-7BBEA0E404D4}"/>
               </a:ext>
             </a:extLst>
           </p:cNvPr>
@@ -17210,7 +17245,7 @@
           <p:cNvPr id="26" name="footer-label-4">
             <a:extLst xmlns:a="http://schemas.openxmlformats.org/drawingml/2006/main">
               <a:ext uri="{FF2B5EF4-FFF2-40B4-BE49-F238E27FC236}">
-                <a16:creationId xmlns:a16="http://schemas.microsoft.com/office/drawing/2014/main" id="{2FECCB80-E59D-45C5-807B-DCE5E418176E}"/>
+                <a16:creationId xmlns:a16="http://schemas.microsoft.com/office/drawing/2014/main" id="{E122E80C-1682-4BED-BF81-7B76B1E72127}"/>
               </a:ext>
             </a:extLst>
           </p:cNvPr>
@@ -17272,7 +17307,7 @@
           <p:cNvPr id="27" name="footer-page-4">
             <a:extLst xmlns:a="http://schemas.openxmlformats.org/drawingml/2006/main">
               <a:ext uri="{FF2B5EF4-FFF2-40B4-BE49-F238E27FC236}">
-                <a16:creationId xmlns:a16="http://schemas.microsoft.com/office/drawing/2014/main" id="{A5C80AAB-7796-4F65-9783-171AC64F9E72}"/>
+                <a16:creationId xmlns:a16="http://schemas.microsoft.com/office/drawing/2014/main" id="{2ACC9EEC-A7DC-4435-B4E6-92906AC07800}"/>
               </a:ext>
             </a:extLst>
           </p:cNvPr>
@@ -17332,7 +17367,7 @@
     </p:spTree>
     <p:extLst>
       <p:ext uri="{BB962C8B-B14F-4D97-AF65-F5344CB8AC3E}">
-        <p14:creationId xmlns:p14="http://schemas.microsoft.com/office/powerpoint/2010/main" val="1056136829"/>
+        <p14:creationId xmlns:p14="http://schemas.microsoft.com/office/powerpoint/2010/main" val="275505797"/>
       </p:ext>
     </p:extLst>
   </p:cSld>
@@ -17363,7 +17398,7 @@
           <p:cNvPr id="31" name="side-accent-5">
             <a:extLst xmlns:a="http://schemas.openxmlformats.org/drawingml/2006/main">
               <a:ext uri="{FF2B5EF4-FFF2-40B4-BE49-F238E27FC236}">
-                <a16:creationId xmlns:a16="http://schemas.microsoft.com/office/drawing/2014/main" id="{A9F5310A-4A41-44D1-8484-0D01500E3813}"/>
+                <a16:creationId xmlns:a16="http://schemas.microsoft.com/office/drawing/2014/main" id="{52F0CBEE-DEC6-42DF-AB7D-D998A49DFE77}"/>
               </a:ext>
             </a:extLst>
           </p:cNvPr>
@@ -17394,7 +17429,7 @@
           <p:cNvPr id="2" name="kicker-5">
             <a:extLst xmlns:a="http://schemas.openxmlformats.org/drawingml/2006/main">
               <a:ext uri="{FF2B5EF4-FFF2-40B4-BE49-F238E27FC236}">
-                <a16:creationId xmlns:a16="http://schemas.microsoft.com/office/drawing/2014/main" id="{AA0F3918-D138-46DA-8A6B-EE3FB657185A}"/>
+                <a16:creationId xmlns:a16="http://schemas.microsoft.com/office/drawing/2014/main" id="{876EC145-33D7-43D7-B0E1-6D0D5E550D5B}"/>
               </a:ext>
             </a:extLst>
           </p:cNvPr>
@@ -17456,7 +17491,7 @@
           <p:cNvPr id="3" name="title-5">
             <a:extLst xmlns:a="http://schemas.openxmlformats.org/drawingml/2006/main">
               <a:ext uri="{FF2B5EF4-FFF2-40B4-BE49-F238E27FC236}">
-                <a16:creationId xmlns:a16="http://schemas.microsoft.com/office/drawing/2014/main" id="{2EA22B04-3AC6-46EE-A4B4-9217AB79EFF4}"/>
+                <a16:creationId xmlns:a16="http://schemas.microsoft.com/office/drawing/2014/main" id="{03C44222-23B6-43E6-B77B-CF4A95CB46ED}"/>
               </a:ext>
             </a:extLst>
           </p:cNvPr>
@@ -17518,7 +17553,7 @@
           <p:cNvPr id="4" name="">
             <a:extLst xmlns:a="http://schemas.openxmlformats.org/drawingml/2006/main">
               <a:ext uri="{FF2B5EF4-FFF2-40B4-BE49-F238E27FC236}">
-                <a16:creationId xmlns:a16="http://schemas.microsoft.com/office/drawing/2014/main" id="{AD3229A0-C3A6-43BB-9E92-67EDE55A727F}"/>
+                <a16:creationId xmlns:a16="http://schemas.microsoft.com/office/drawing/2014/main" id="{C6814513-6079-4D5D-AF3D-1463B27BAE02}"/>
               </a:ext>
             </a:extLst>
           </p:cNvPr>
@@ -17580,7 +17615,7 @@
           <p:cNvPr id="5" name="workflow-line">
             <a:extLst xmlns:a="http://schemas.openxmlformats.org/drawingml/2006/main">
               <a:ext uri="{FF2B5EF4-FFF2-40B4-BE49-F238E27FC236}">
-                <a16:creationId xmlns:a16="http://schemas.microsoft.com/office/drawing/2014/main" id="{7750DC37-722F-4671-9ADB-D47E5886A031}"/>
+                <a16:creationId xmlns:a16="http://schemas.microsoft.com/office/drawing/2014/main" id="{8FD48846-3F87-4F7F-89B5-C1537CCBB95F}"/>
               </a:ext>
             </a:extLst>
           </p:cNvPr>
@@ -17611,7 +17646,7 @@
           <p:cNvPr id="6" name="workflow-arrow">
             <a:extLst xmlns:a="http://schemas.openxmlformats.org/drawingml/2006/main">
               <a:ext uri="{FF2B5EF4-FFF2-40B4-BE49-F238E27FC236}">
-                <a16:creationId xmlns:a16="http://schemas.microsoft.com/office/drawing/2014/main" id="{01D047B1-D31B-4D4E-8070-F9F058E3EA83}"/>
+                <a16:creationId xmlns:a16="http://schemas.microsoft.com/office/drawing/2014/main" id="{7A02170A-68FC-4345-A961-FB5A22CA5B80}"/>
               </a:ext>
             </a:extLst>
           </p:cNvPr>
@@ -17642,7 +17677,7 @@
           <p:cNvPr id="7" name="">
             <a:extLst xmlns:a="http://schemas.openxmlformats.org/drawingml/2006/main">
               <a:ext uri="{FF2B5EF4-FFF2-40B4-BE49-F238E27FC236}">
-                <a16:creationId xmlns:a16="http://schemas.microsoft.com/office/drawing/2014/main" id="{B473B625-8F4D-4D9B-8026-FBD80B362A3A}"/>
+                <a16:creationId xmlns:a16="http://schemas.microsoft.com/office/drawing/2014/main" id="{A846D3D6-43F8-4019-A4C4-9F923C259C47}"/>
               </a:ext>
             </a:extLst>
           </p:cNvPr>
@@ -17673,7 +17708,7 @@
           <p:cNvPr id="8" name="">
             <a:extLst xmlns:a="http://schemas.openxmlformats.org/drawingml/2006/main">
               <a:ext uri="{FF2B5EF4-FFF2-40B4-BE49-F238E27FC236}">
-                <a16:creationId xmlns:a16="http://schemas.microsoft.com/office/drawing/2014/main" id="{A008B744-7BB4-4F4D-8FB2-5C0AE626EBC4}"/>
+                <a16:creationId xmlns:a16="http://schemas.microsoft.com/office/drawing/2014/main" id="{AA1EEA82-238C-4D16-993D-DAF308A334BF}"/>
               </a:ext>
             </a:extLst>
           </p:cNvPr>
@@ -17735,7 +17770,7 @@
           <p:cNvPr id="9" name="">
             <a:extLst xmlns:a="http://schemas.openxmlformats.org/drawingml/2006/main">
               <a:ext uri="{FF2B5EF4-FFF2-40B4-BE49-F238E27FC236}">
-                <a16:creationId xmlns:a16="http://schemas.microsoft.com/office/drawing/2014/main" id="{DD18DAF8-8379-4542-A4C9-B09F264D85C1}"/>
+                <a16:creationId xmlns:a16="http://schemas.microsoft.com/office/drawing/2014/main" id="{EA1CED0C-FCEC-4119-90A5-BF3A4C5502E4}"/>
               </a:ext>
             </a:extLst>
           </p:cNvPr>
@@ -17797,7 +17832,7 @@
           <p:cNvPr id="10" name="">
             <a:extLst xmlns:a="http://schemas.openxmlformats.org/drawingml/2006/main">
               <a:ext uri="{FF2B5EF4-FFF2-40B4-BE49-F238E27FC236}">
-                <a16:creationId xmlns:a16="http://schemas.microsoft.com/office/drawing/2014/main" id="{285A0C8F-7CB0-4843-A358-AE435B1E8D49}"/>
+                <a16:creationId xmlns:a16="http://schemas.microsoft.com/office/drawing/2014/main" id="{4E866579-AF2D-4AA0-9C3F-40CAD2F482CC}"/>
               </a:ext>
             </a:extLst>
           </p:cNvPr>
@@ -17859,7 +17894,7 @@
           <p:cNvPr id="11" name="">
             <a:extLst xmlns:a="http://schemas.openxmlformats.org/drawingml/2006/main">
               <a:ext uri="{FF2B5EF4-FFF2-40B4-BE49-F238E27FC236}">
-                <a16:creationId xmlns:a16="http://schemas.microsoft.com/office/drawing/2014/main" id="{38FC74A2-9CDC-4622-B98B-A96A10E990AD}"/>
+                <a16:creationId xmlns:a16="http://schemas.microsoft.com/office/drawing/2014/main" id="{A5DBBAE1-0996-4F7A-B98B-B92783DF4905}"/>
               </a:ext>
             </a:extLst>
           </p:cNvPr>
@@ -17890,7 +17925,7 @@
           <p:cNvPr id="12" name="">
             <a:extLst xmlns:a="http://schemas.openxmlformats.org/drawingml/2006/main">
               <a:ext uri="{FF2B5EF4-FFF2-40B4-BE49-F238E27FC236}">
-                <a16:creationId xmlns:a16="http://schemas.microsoft.com/office/drawing/2014/main" id="{15049EBF-395A-44D9-92BC-384501460478}"/>
+                <a16:creationId xmlns:a16="http://schemas.microsoft.com/office/drawing/2014/main" id="{7F56661D-081C-4D93-9902-A6260E02E367}"/>
               </a:ext>
             </a:extLst>
           </p:cNvPr>
@@ -17952,7 +17987,7 @@
           <p:cNvPr id="13" name="">
             <a:extLst xmlns:a="http://schemas.openxmlformats.org/drawingml/2006/main">
               <a:ext uri="{FF2B5EF4-FFF2-40B4-BE49-F238E27FC236}">
-                <a16:creationId xmlns:a16="http://schemas.microsoft.com/office/drawing/2014/main" id="{5E649315-39F7-4BE0-8CEB-4A147F9EF820}"/>
+                <a16:creationId xmlns:a16="http://schemas.microsoft.com/office/drawing/2014/main" id="{53225F62-D06A-42BE-9271-C28154C64AC8}"/>
               </a:ext>
             </a:extLst>
           </p:cNvPr>
@@ -18014,7 +18049,7 @@
           <p:cNvPr id="14" name="">
             <a:extLst xmlns:a="http://schemas.openxmlformats.org/drawingml/2006/main">
               <a:ext uri="{FF2B5EF4-FFF2-40B4-BE49-F238E27FC236}">
-                <a16:creationId xmlns:a16="http://schemas.microsoft.com/office/drawing/2014/main" id="{1FF1F14C-0AF2-4E17-AC77-A58659535497}"/>
+                <a16:creationId xmlns:a16="http://schemas.microsoft.com/office/drawing/2014/main" id="{00B40E10-1E07-4E9D-95FD-9FE5ABA37DCE}"/>
               </a:ext>
             </a:extLst>
           </p:cNvPr>
@@ -18076,7 +18111,7 @@
           <p:cNvPr id="15" name="">
             <a:extLst xmlns:a="http://schemas.openxmlformats.org/drawingml/2006/main">
               <a:ext uri="{FF2B5EF4-FFF2-40B4-BE49-F238E27FC236}">
-                <a16:creationId xmlns:a16="http://schemas.microsoft.com/office/drawing/2014/main" id="{D5AEA397-4421-41DB-BBE1-35C5A4B2333F}"/>
+                <a16:creationId xmlns:a16="http://schemas.microsoft.com/office/drawing/2014/main" id="{ABC52C5B-EE82-4CF7-9338-C2C335ECF6D3}"/>
               </a:ext>
             </a:extLst>
           </p:cNvPr>
@@ -18107,7 +18142,7 @@
           <p:cNvPr id="16" name="">
             <a:extLst xmlns:a="http://schemas.openxmlformats.org/drawingml/2006/main">
               <a:ext uri="{FF2B5EF4-FFF2-40B4-BE49-F238E27FC236}">
-                <a16:creationId xmlns:a16="http://schemas.microsoft.com/office/drawing/2014/main" id="{3AB5E57B-88AF-4FCC-AD7B-B683AE95D035}"/>
+                <a16:creationId xmlns:a16="http://schemas.microsoft.com/office/drawing/2014/main" id="{BC4B9550-B081-49C0-B8D5-AD910A7ADB0F}"/>
               </a:ext>
             </a:extLst>
           </p:cNvPr>
@@ -18169,7 +18204,7 @@
           <p:cNvPr id="17" name="">
             <a:extLst xmlns:a="http://schemas.openxmlformats.org/drawingml/2006/main">
               <a:ext uri="{FF2B5EF4-FFF2-40B4-BE49-F238E27FC236}">
-                <a16:creationId xmlns:a16="http://schemas.microsoft.com/office/drawing/2014/main" id="{0594A60D-6AAB-483E-9635-DEE547395701}"/>
+                <a16:creationId xmlns:a16="http://schemas.microsoft.com/office/drawing/2014/main" id="{97012519-6F32-4A02-9CAB-407A82B3E444}"/>
               </a:ext>
             </a:extLst>
           </p:cNvPr>
@@ -18231,7 +18266,7 @@
           <p:cNvPr id="18" name="">
             <a:extLst xmlns:a="http://schemas.openxmlformats.org/drawingml/2006/main">
               <a:ext uri="{FF2B5EF4-FFF2-40B4-BE49-F238E27FC236}">
-                <a16:creationId xmlns:a16="http://schemas.microsoft.com/office/drawing/2014/main" id="{4D8167A5-2D17-469B-910C-B74F4E8E34AC}"/>
+                <a16:creationId xmlns:a16="http://schemas.microsoft.com/office/drawing/2014/main" id="{5D92F9C2-57C8-4E59-9308-E54D54069537}"/>
               </a:ext>
             </a:extLst>
           </p:cNvPr>
@@ -18293,7 +18328,7 @@
           <p:cNvPr id="19" name="">
             <a:extLst xmlns:a="http://schemas.openxmlformats.org/drawingml/2006/main">
               <a:ext uri="{FF2B5EF4-FFF2-40B4-BE49-F238E27FC236}">
-                <a16:creationId xmlns:a16="http://schemas.microsoft.com/office/drawing/2014/main" id="{DA6B5DF9-FC93-4768-A2EA-E2805E68068A}"/>
+                <a16:creationId xmlns:a16="http://schemas.microsoft.com/office/drawing/2014/main" id="{247FC7D4-0B97-4F38-B532-602C986DBF66}"/>
               </a:ext>
             </a:extLst>
           </p:cNvPr>
@@ -18324,7 +18359,7 @@
           <p:cNvPr id="20" name="">
             <a:extLst xmlns:a="http://schemas.openxmlformats.org/drawingml/2006/main">
               <a:ext uri="{FF2B5EF4-FFF2-40B4-BE49-F238E27FC236}">
-                <a16:creationId xmlns:a16="http://schemas.microsoft.com/office/drawing/2014/main" id="{A1523114-BBDF-4270-8E2F-5C84F820BD49}"/>
+                <a16:creationId xmlns:a16="http://schemas.microsoft.com/office/drawing/2014/main" id="{53971E38-0A20-4111-AA17-1DA66AD1788B}"/>
               </a:ext>
             </a:extLst>
           </p:cNvPr>
@@ -18386,7 +18421,7 @@
           <p:cNvPr id="21" name="">
             <a:extLst xmlns:a="http://schemas.openxmlformats.org/drawingml/2006/main">
               <a:ext uri="{FF2B5EF4-FFF2-40B4-BE49-F238E27FC236}">
-                <a16:creationId xmlns:a16="http://schemas.microsoft.com/office/drawing/2014/main" id="{1583A780-89E2-4F43-A9C6-EAD94C7959E8}"/>
+                <a16:creationId xmlns:a16="http://schemas.microsoft.com/office/drawing/2014/main" id="{EA95AFD4-06BD-4E37-BD35-975F1E11A56D}"/>
               </a:ext>
             </a:extLst>
           </p:cNvPr>
@@ -18448,7 +18483,7 @@
           <p:cNvPr id="22" name="">
             <a:extLst xmlns:a="http://schemas.openxmlformats.org/drawingml/2006/main">
               <a:ext uri="{FF2B5EF4-FFF2-40B4-BE49-F238E27FC236}">
-                <a16:creationId xmlns:a16="http://schemas.microsoft.com/office/drawing/2014/main" id="{C93AD2AC-A501-4DAA-BAC5-9ADCF0D1CCEE}"/>
+                <a16:creationId xmlns:a16="http://schemas.microsoft.com/office/drawing/2014/main" id="{3FF35B7D-4775-4C98-88A3-09890084AF93}"/>
               </a:ext>
             </a:extLst>
           </p:cNvPr>
@@ -18510,7 +18545,7 @@
           <p:cNvPr id="23" name="">
             <a:extLst xmlns:a="http://schemas.openxmlformats.org/drawingml/2006/main">
               <a:ext uri="{FF2B5EF4-FFF2-40B4-BE49-F238E27FC236}">
-                <a16:creationId xmlns:a16="http://schemas.microsoft.com/office/drawing/2014/main" id="{BA83E373-C750-488B-B1B0-59A1759F2C02}"/>
+                <a16:creationId xmlns:a16="http://schemas.microsoft.com/office/drawing/2014/main" id="{850B7CBD-D5A8-43A7-8F4B-D0BD8F526EB5}"/>
               </a:ext>
             </a:extLst>
           </p:cNvPr>
@@ -18541,7 +18576,7 @@
           <p:cNvPr id="24" name="">
             <a:extLst xmlns:a="http://schemas.openxmlformats.org/drawingml/2006/main">
               <a:ext uri="{FF2B5EF4-FFF2-40B4-BE49-F238E27FC236}">
-                <a16:creationId xmlns:a16="http://schemas.microsoft.com/office/drawing/2014/main" id="{71323AFF-7926-4C56-A1E0-DBC91B48C375}"/>
+                <a16:creationId xmlns:a16="http://schemas.microsoft.com/office/drawing/2014/main" id="{2E5BA04A-F1F7-4610-8F28-F8A4E7B175BE}"/>
               </a:ext>
             </a:extLst>
           </p:cNvPr>
@@ -18603,7 +18638,7 @@
           <p:cNvPr id="25" name="">
             <a:extLst xmlns:a="http://schemas.openxmlformats.org/drawingml/2006/main">
               <a:ext uri="{FF2B5EF4-FFF2-40B4-BE49-F238E27FC236}">
-                <a16:creationId xmlns:a16="http://schemas.microsoft.com/office/drawing/2014/main" id="{1AAA7D33-0ACA-4609-8296-9B8051F4346F}"/>
+                <a16:creationId xmlns:a16="http://schemas.microsoft.com/office/drawing/2014/main" id="{10890EF6-4E15-4C1D-8822-FBF76FA82091}"/>
               </a:ext>
             </a:extLst>
           </p:cNvPr>
@@ -18665,7 +18700,7 @@
           <p:cNvPr id="26" name="">
             <a:extLst xmlns:a="http://schemas.openxmlformats.org/drawingml/2006/main">
               <a:ext uri="{FF2B5EF4-FFF2-40B4-BE49-F238E27FC236}">
-                <a16:creationId xmlns:a16="http://schemas.microsoft.com/office/drawing/2014/main" id="{F7899C7A-AEEB-479F-87E8-BE49F3ED5963}"/>
+                <a16:creationId xmlns:a16="http://schemas.microsoft.com/office/drawing/2014/main" id="{9C4FF5BB-6986-4320-8A6A-D31F51911B55}"/>
               </a:ext>
             </a:extLst>
           </p:cNvPr>
@@ -18727,7 +18762,7 @@
           <p:cNvPr id="27" name="">
             <a:extLst xmlns:a="http://schemas.openxmlformats.org/drawingml/2006/main">
               <a:ext uri="{FF2B5EF4-FFF2-40B4-BE49-F238E27FC236}">
-                <a16:creationId xmlns:a16="http://schemas.microsoft.com/office/drawing/2014/main" id="{D7B6407D-ABC3-4A3F-ACF3-BAF30258DAD5}"/>
+                <a16:creationId xmlns:a16="http://schemas.microsoft.com/office/drawing/2014/main" id="{54F01127-0658-42ED-BAFD-67EF551ABCDB}"/>
               </a:ext>
             </a:extLst>
           </p:cNvPr>
@@ -18789,7 +18824,7 @@
           <p:cNvPr id="28" name="footer-rule-5">
             <a:extLst xmlns:a="http://schemas.openxmlformats.org/drawingml/2006/main">
               <a:ext uri="{FF2B5EF4-FFF2-40B4-BE49-F238E27FC236}">
-                <a16:creationId xmlns:a16="http://schemas.microsoft.com/office/drawing/2014/main" id="{3BE14F22-552F-44ED-ACAE-C7B7DB877CC6}"/>
+                <a16:creationId xmlns:a16="http://schemas.microsoft.com/office/drawing/2014/main" id="{3F36D4D6-5FE4-460D-BBA2-8C8B79A965B2}"/>
               </a:ext>
             </a:extLst>
           </p:cNvPr>
@@ -18820,7 +18855,7 @@
           <p:cNvPr id="29" name="footer-label-5">
             <a:extLst xmlns:a="http://schemas.openxmlformats.org/drawingml/2006/main">
               <a:ext uri="{FF2B5EF4-FFF2-40B4-BE49-F238E27FC236}">
-                <a16:creationId xmlns:a16="http://schemas.microsoft.com/office/drawing/2014/main" id="{D6CBDD24-7FBE-4F4D-81F3-0E840F1894F6}"/>
+                <a16:creationId xmlns:a16="http://schemas.microsoft.com/office/drawing/2014/main" id="{32556ABD-E190-4B00-B65A-E7B1DE6DF186}"/>
               </a:ext>
             </a:extLst>
           </p:cNvPr>
@@ -18882,7 +18917,7 @@
           <p:cNvPr id="30" name="footer-page-5">
             <a:extLst xmlns:a="http://schemas.openxmlformats.org/drawingml/2006/main">
               <a:ext uri="{FF2B5EF4-FFF2-40B4-BE49-F238E27FC236}">
-                <a16:creationId xmlns:a16="http://schemas.microsoft.com/office/drawing/2014/main" id="{BF6D9F3A-B7FE-4F2E-933D-4D712A789451}"/>
+                <a16:creationId xmlns:a16="http://schemas.microsoft.com/office/drawing/2014/main" id="{B3931475-3D09-4038-8A3E-B92551CAF475}"/>
               </a:ext>
             </a:extLst>
           </p:cNvPr>
@@ -18942,7 +18977,7 @@
     </p:spTree>
     <p:extLst>
       <p:ext uri="{BB962C8B-B14F-4D97-AF65-F5344CB8AC3E}">
-        <p14:creationId xmlns:p14="http://schemas.microsoft.com/office/powerpoint/2010/main" val="292594823"/>
+        <p14:creationId xmlns:p14="http://schemas.microsoft.com/office/powerpoint/2010/main" val="548547154"/>
       </p:ext>
     </p:extLst>
   </p:cSld>
@@ -18973,7 +19008,7 @@
           <p:cNvPr id="22" name="side-accent-6">
             <a:extLst xmlns:a="http://schemas.openxmlformats.org/drawingml/2006/main">
               <a:ext uri="{FF2B5EF4-FFF2-40B4-BE49-F238E27FC236}">
-                <a16:creationId xmlns:a16="http://schemas.microsoft.com/office/drawing/2014/main" id="{08B82274-2676-4C98-B402-37841AAB08C8}"/>
+                <a16:creationId xmlns:a16="http://schemas.microsoft.com/office/drawing/2014/main" id="{288255DD-6640-45B5-9DE8-5739CAEF62A9}"/>
               </a:ext>
             </a:extLst>
           </p:cNvPr>
@@ -19004,7 +19039,7 @@
           <p:cNvPr id="2" name="kicker-6">
             <a:extLst xmlns:a="http://schemas.openxmlformats.org/drawingml/2006/main">
               <a:ext uri="{FF2B5EF4-FFF2-40B4-BE49-F238E27FC236}">
-                <a16:creationId xmlns:a16="http://schemas.microsoft.com/office/drawing/2014/main" id="{089E19ED-5626-4940-A5F4-FBE749823386}"/>
+                <a16:creationId xmlns:a16="http://schemas.microsoft.com/office/drawing/2014/main" id="{CA09F1F1-94DA-4AC7-958A-9855ECA9987F}"/>
               </a:ext>
             </a:extLst>
           </p:cNvPr>
@@ -19066,7 +19101,7 @@
           <p:cNvPr id="3" name="title-6">
             <a:extLst xmlns:a="http://schemas.openxmlformats.org/drawingml/2006/main">
               <a:ext uri="{FF2B5EF4-FFF2-40B4-BE49-F238E27FC236}">
-                <a16:creationId xmlns:a16="http://schemas.microsoft.com/office/drawing/2014/main" id="{8DAC3248-F7EC-469D-8913-C862124661B2}"/>
+                <a16:creationId xmlns:a16="http://schemas.microsoft.com/office/drawing/2014/main" id="{1F996BAE-A2BF-484D-9C40-BB8C2E76A2B9}"/>
               </a:ext>
             </a:extLst>
           </p:cNvPr>
@@ -19128,7 +19163,7 @@
           <p:cNvPr id="4" name="">
             <a:extLst xmlns:a="http://schemas.openxmlformats.org/drawingml/2006/main">
               <a:ext uri="{FF2B5EF4-FFF2-40B4-BE49-F238E27FC236}">
-                <a16:creationId xmlns:a16="http://schemas.microsoft.com/office/drawing/2014/main" id="{A06C75AF-CE41-4467-AC81-DA35DD8A6DA1}"/>
+                <a16:creationId xmlns:a16="http://schemas.microsoft.com/office/drawing/2014/main" id="{1F801C2A-10AC-4479-9E3A-82EBEFA9F02D}"/>
               </a:ext>
             </a:extLst>
           </p:cNvPr>
@@ -19180,7 +19215,7 @@
                 <a:ea typeface="Tahoma"/>
                 <a:cs typeface="Tahoma"/>
               </a:rPr>
-              <a:t>คุณเป็นเจ้าของความครบถ้วนของข้อมูลวิชาการในขั้นแรก ผู้ประเมินจึงตรวจต่อได้อย่างมีหลักฐาน</a:t>
+              <a:t>ผู้รับการประเมินกรอกข้อมูลวิชาการและแนบหลักฐานให้ครบ ก่อนส่งให้ผู้ประเมินตรวจ</a:t>
             </a:r>
           </a:p>
         </p:txBody>
@@ -19190,7 +19225,7 @@
           <p:cNvPr id="5" name="">
             <a:extLst xmlns:a="http://schemas.openxmlformats.org/drawingml/2006/main">
               <a:ext uri="{FF2B5EF4-FFF2-40B4-BE49-F238E27FC236}">
-                <a16:creationId xmlns:a16="http://schemas.microsoft.com/office/drawing/2014/main" id="{571C5118-7198-4FDE-AC82-7868C27DD014}"/>
+                <a16:creationId xmlns:a16="http://schemas.microsoft.com/office/drawing/2014/main" id="{E48364ED-AF38-4E0D-AFD0-F8DDB8C6146B}"/>
               </a:ext>
             </a:extLst>
           </p:cNvPr>
@@ -19252,7 +19287,7 @@
           <p:cNvPr id="6" name="">
             <a:extLst xmlns:a="http://schemas.openxmlformats.org/drawingml/2006/main">
               <a:ext uri="{FF2B5EF4-FFF2-40B4-BE49-F238E27FC236}">
-                <a16:creationId xmlns:a16="http://schemas.microsoft.com/office/drawing/2014/main" id="{59E574C0-6B58-4495-853B-E7156B940FD0}"/>
+                <a16:creationId xmlns:a16="http://schemas.microsoft.com/office/drawing/2014/main" id="{5F7727E3-DF84-4D21-A549-6B71835AC368}"/>
               </a:ext>
             </a:extLst>
           </p:cNvPr>
@@ -19314,7 +19349,7 @@
           <p:cNvPr id="7" name="">
             <a:extLst xmlns:a="http://schemas.openxmlformats.org/drawingml/2006/main">
               <a:ext uri="{FF2B5EF4-FFF2-40B4-BE49-F238E27FC236}">
-                <a16:creationId xmlns:a16="http://schemas.microsoft.com/office/drawing/2014/main" id="{B099F24B-4716-4749-A517-53861A7070B1}"/>
+                <a16:creationId xmlns:a16="http://schemas.microsoft.com/office/drawing/2014/main" id="{4E69FECC-6A1E-4364-B438-E21794DA7D47}"/>
               </a:ext>
             </a:extLst>
           </p:cNvPr>
@@ -19345,7 +19380,7 @@
           <p:cNvPr id="8" name="">
             <a:extLst xmlns:a="http://schemas.openxmlformats.org/drawingml/2006/main">
               <a:ext uri="{FF2B5EF4-FFF2-40B4-BE49-F238E27FC236}">
-                <a16:creationId xmlns:a16="http://schemas.microsoft.com/office/drawing/2014/main" id="{477CA12D-A076-4A68-8834-E30D9B6DDE92}"/>
+                <a16:creationId xmlns:a16="http://schemas.microsoft.com/office/drawing/2014/main" id="{D8C0A20F-9180-4DC2-AEE8-B270B9C5A2B0}"/>
               </a:ext>
             </a:extLst>
           </p:cNvPr>
@@ -19434,7 +19469,7 @@
           <p:cNvPr id="9" name="">
             <a:extLst xmlns:a="http://schemas.openxmlformats.org/drawingml/2006/main">
               <a:ext uri="{FF2B5EF4-FFF2-40B4-BE49-F238E27FC236}">
-                <a16:creationId xmlns:a16="http://schemas.microsoft.com/office/drawing/2014/main" id="{D5EA5B3E-7F09-4BEB-8BA1-0BDF7EA766CF}"/>
+                <a16:creationId xmlns:a16="http://schemas.microsoft.com/office/drawing/2014/main" id="{5297DCD2-0CF2-442C-827D-A564A9D6956A}"/>
               </a:ext>
             </a:extLst>
           </p:cNvPr>
@@ -19496,7 +19531,7 @@
           <p:cNvPr id="10" name="">
             <a:extLst xmlns:a="http://schemas.openxmlformats.org/drawingml/2006/main">
               <a:ext uri="{FF2B5EF4-FFF2-40B4-BE49-F238E27FC236}">
-                <a16:creationId xmlns:a16="http://schemas.microsoft.com/office/drawing/2014/main" id="{AD470F9B-1E16-418C-B37C-A4435EEA59A2}"/>
+                <a16:creationId xmlns:a16="http://schemas.microsoft.com/office/drawing/2014/main" id="{EA55E268-FE00-4247-8ED4-BAD8F6C6F39E}"/>
               </a:ext>
             </a:extLst>
           </p:cNvPr>
@@ -19558,7 +19593,7 @@
           <p:cNvPr id="11" name="">
             <a:extLst xmlns:a="http://schemas.openxmlformats.org/drawingml/2006/main">
               <a:ext uri="{FF2B5EF4-FFF2-40B4-BE49-F238E27FC236}">
-                <a16:creationId xmlns:a16="http://schemas.microsoft.com/office/drawing/2014/main" id="{96BEE2C0-3CA9-43DF-807B-700EF31209F1}"/>
+                <a16:creationId xmlns:a16="http://schemas.microsoft.com/office/drawing/2014/main" id="{3CA9F633-A1A5-40CF-82F5-326EF7E96C72}"/>
               </a:ext>
             </a:extLst>
           </p:cNvPr>
@@ -19589,7 +19624,7 @@
           <p:cNvPr id="12" name="">
             <a:extLst xmlns:a="http://schemas.openxmlformats.org/drawingml/2006/main">
               <a:ext uri="{FF2B5EF4-FFF2-40B4-BE49-F238E27FC236}">
-                <a16:creationId xmlns:a16="http://schemas.microsoft.com/office/drawing/2014/main" id="{847E2F48-8AF0-4959-81EC-DE11133E0751}"/>
+                <a16:creationId xmlns:a16="http://schemas.microsoft.com/office/drawing/2014/main" id="{1731B229-A357-4BB2-B3A4-572ED308D0EA}"/>
               </a:ext>
             </a:extLst>
           </p:cNvPr>
@@ -19678,7 +19713,7 @@
           <p:cNvPr id="13" name="">
             <a:extLst xmlns:a="http://schemas.openxmlformats.org/drawingml/2006/main">
               <a:ext uri="{FF2B5EF4-FFF2-40B4-BE49-F238E27FC236}">
-                <a16:creationId xmlns:a16="http://schemas.microsoft.com/office/drawing/2014/main" id="{4755F408-100C-4BB1-81C0-3404C61649D7}"/>
+                <a16:creationId xmlns:a16="http://schemas.microsoft.com/office/drawing/2014/main" id="{FA400A76-1921-42CF-9A1B-4BA40B3CE332}"/>
               </a:ext>
             </a:extLst>
           </p:cNvPr>
@@ -19740,7 +19775,7 @@
           <p:cNvPr id="14" name="">
             <a:extLst xmlns:a="http://schemas.openxmlformats.org/drawingml/2006/main">
               <a:ext uri="{FF2B5EF4-FFF2-40B4-BE49-F238E27FC236}">
-                <a16:creationId xmlns:a16="http://schemas.microsoft.com/office/drawing/2014/main" id="{1325AC4E-5058-4844-87EE-F316CDAF3382}"/>
+                <a16:creationId xmlns:a16="http://schemas.microsoft.com/office/drawing/2014/main" id="{C256F7DF-A3C0-48FA-B5FB-8BC662FAF6F8}"/>
               </a:ext>
             </a:extLst>
           </p:cNvPr>
@@ -19802,7 +19837,7 @@
           <p:cNvPr id="15" name="">
             <a:extLst xmlns:a="http://schemas.openxmlformats.org/drawingml/2006/main">
               <a:ext uri="{FF2B5EF4-FFF2-40B4-BE49-F238E27FC236}">
-                <a16:creationId xmlns:a16="http://schemas.microsoft.com/office/drawing/2014/main" id="{3873A017-9A59-4588-9384-14A4FB16F4D1}"/>
+                <a16:creationId xmlns:a16="http://schemas.microsoft.com/office/drawing/2014/main" id="{6E7279B7-2B13-4F02-9644-7BBBD8F80548}"/>
               </a:ext>
             </a:extLst>
           </p:cNvPr>
@@ -19833,7 +19868,7 @@
           <p:cNvPr id="16" name="">
             <a:extLst xmlns:a="http://schemas.openxmlformats.org/drawingml/2006/main">
               <a:ext uri="{FF2B5EF4-FFF2-40B4-BE49-F238E27FC236}">
-                <a16:creationId xmlns:a16="http://schemas.microsoft.com/office/drawing/2014/main" id="{7C7FCDDD-D0FD-4AF4-B5AE-56E86F41669A}"/>
+                <a16:creationId xmlns:a16="http://schemas.microsoft.com/office/drawing/2014/main" id="{C6D8B489-C11E-4C79-9431-0024095B1B8C}"/>
               </a:ext>
             </a:extLst>
           </p:cNvPr>
@@ -19922,7 +19957,7 @@
           <p:cNvPr id="17" name="">
             <a:extLst xmlns:a="http://schemas.openxmlformats.org/drawingml/2006/main">
               <a:ext uri="{FF2B5EF4-FFF2-40B4-BE49-F238E27FC236}">
-                <a16:creationId xmlns:a16="http://schemas.microsoft.com/office/drawing/2014/main" id="{AB087133-F43E-4D05-AC6F-732CADEEE2A4}"/>
+                <a16:creationId xmlns:a16="http://schemas.microsoft.com/office/drawing/2014/main" id="{601AEBB5-D27A-429C-8BC2-508B896EBFCE}"/>
               </a:ext>
             </a:extLst>
           </p:cNvPr>
@@ -19955,7 +19990,7 @@
           <p:cNvPr id="18" name="">
             <a:extLst xmlns:a="http://schemas.openxmlformats.org/drawingml/2006/main">
               <a:ext uri="{FF2B5EF4-FFF2-40B4-BE49-F238E27FC236}">
-                <a16:creationId xmlns:a16="http://schemas.microsoft.com/office/drawing/2014/main" id="{E56E1ABF-EDC2-4B71-9C3B-401F47861C91}"/>
+                <a16:creationId xmlns:a16="http://schemas.microsoft.com/office/drawing/2014/main" id="{850CA92E-71FF-4368-9EB3-781B54E67C7A}"/>
               </a:ext>
             </a:extLst>
           </p:cNvPr>
@@ -19967,7 +20002,7 @@
         <p:spPr>
           <a:xfrm xmlns:a="http://schemas.openxmlformats.org/drawingml/2006/main">
             <a:off x="8839200" y="1990725"/>
-            <a:ext cx="2476500" cy="533400"/>
+            <a:ext cx="2476500" cy="590550"/>
           </a:xfrm>
           <a:prstGeom xmlns:a="http://schemas.openxmlformats.org/drawingml/2006/main" prst="rect">
             <a:avLst/>
@@ -20007,7 +20042,7 @@
                 <a:ea typeface="Tahoma"/>
                 <a:cs typeface="Tahoma"/>
               </a:rPr>
-              <a:t>ผู้ประเมินคนสุดท้าย</a:t>
+              <a:t>งานเสร็จเมื่อผู้ประเมิน</a:t>
             </a:r>
           </a:p>
           <a:p xmlns:a="http://schemas.openxmlformats.org/drawingml/2006/main">
@@ -20034,7 +20069,7 @@
                 <a:ea typeface="Tahoma"/>
                 <a:cs typeface="Tahoma"/>
               </a:rPr>
-              <a:t>เป็นผู้ปิดงาน</a:t>
+              <a:t>ลำดับสุดท้ายยืนยันผล</a:t>
             </a:r>
           </a:p>
         </p:txBody>
@@ -20044,7 +20079,7 @@
           <p:cNvPr id="19" name="footer-rule-6">
             <a:extLst xmlns:a="http://schemas.openxmlformats.org/drawingml/2006/main">
               <a:ext uri="{FF2B5EF4-FFF2-40B4-BE49-F238E27FC236}">
-                <a16:creationId xmlns:a16="http://schemas.microsoft.com/office/drawing/2014/main" id="{F9AA92EA-9266-4868-B2FF-5CA1733C4AA7}"/>
+                <a16:creationId xmlns:a16="http://schemas.microsoft.com/office/drawing/2014/main" id="{5BD37E18-25B2-4C79-885E-FA5C0A73A1C9}"/>
               </a:ext>
             </a:extLst>
           </p:cNvPr>
@@ -20075,7 +20110,7 @@
           <p:cNvPr id="20" name="footer-label-6">
             <a:extLst xmlns:a="http://schemas.openxmlformats.org/drawingml/2006/main">
               <a:ext uri="{FF2B5EF4-FFF2-40B4-BE49-F238E27FC236}">
-                <a16:creationId xmlns:a16="http://schemas.microsoft.com/office/drawing/2014/main" id="{E14B8F3F-E8AA-48D0-9EB5-794A482B8CAB}"/>
+                <a16:creationId xmlns:a16="http://schemas.microsoft.com/office/drawing/2014/main" id="{56835014-A94C-4DAE-90DE-BA01E59FAFFD}"/>
               </a:ext>
             </a:extLst>
           </p:cNvPr>
@@ -20137,7 +20172,7 @@
           <p:cNvPr id="21" name="footer-page-6">
             <a:extLst xmlns:a="http://schemas.openxmlformats.org/drawingml/2006/main">
               <a:ext uri="{FF2B5EF4-FFF2-40B4-BE49-F238E27FC236}">
-                <a16:creationId xmlns:a16="http://schemas.microsoft.com/office/drawing/2014/main" id="{0D0E7C3E-E62B-4ECB-9111-B6F8A63C5670}"/>
+                <a16:creationId xmlns:a16="http://schemas.microsoft.com/office/drawing/2014/main" id="{903D463F-FA1E-4DC0-A49D-6DFAF7128F13}"/>
               </a:ext>
             </a:extLst>
           </p:cNvPr>
@@ -20197,7 +20232,7 @@
     </p:spTree>
     <p:extLst>
       <p:ext uri="{BB962C8B-B14F-4D97-AF65-F5344CB8AC3E}">
-        <p14:creationId xmlns:p14="http://schemas.microsoft.com/office/powerpoint/2010/main" val="580058649"/>
+        <p14:creationId xmlns:p14="http://schemas.microsoft.com/office/powerpoint/2010/main" val="2027408015"/>
       </p:ext>
     </p:extLst>
   </p:cSld>
@@ -20228,7 +20263,7 @@
           <p:cNvPr id="28" name="side-accent-7">
             <a:extLst xmlns:a="http://schemas.openxmlformats.org/drawingml/2006/main">
               <a:ext uri="{FF2B5EF4-FFF2-40B4-BE49-F238E27FC236}">
-                <a16:creationId xmlns:a16="http://schemas.microsoft.com/office/drawing/2014/main" id="{743C3FDC-DA8F-499D-980B-F4668B081176}"/>
+                <a16:creationId xmlns:a16="http://schemas.microsoft.com/office/drawing/2014/main" id="{B397A22D-859E-455A-9525-C77271CFAFFD}"/>
               </a:ext>
             </a:extLst>
           </p:cNvPr>
@@ -20259,7 +20294,7 @@
           <p:cNvPr id="2" name="kicker-7">
             <a:extLst xmlns:a="http://schemas.openxmlformats.org/drawingml/2006/main">
               <a:ext uri="{FF2B5EF4-FFF2-40B4-BE49-F238E27FC236}">
-                <a16:creationId xmlns:a16="http://schemas.microsoft.com/office/drawing/2014/main" id="{94B8A7CF-0657-416D-BB1D-466442A5CF1F}"/>
+                <a16:creationId xmlns:a16="http://schemas.microsoft.com/office/drawing/2014/main" id="{3FB26EE2-BDD0-4C87-ABEE-3CA7B5DBE007}"/>
               </a:ext>
             </a:extLst>
           </p:cNvPr>
@@ -20321,7 +20356,7 @@
           <p:cNvPr id="3" name="title-7">
             <a:extLst xmlns:a="http://schemas.openxmlformats.org/drawingml/2006/main">
               <a:ext uri="{FF2B5EF4-FFF2-40B4-BE49-F238E27FC236}">
-                <a16:creationId xmlns:a16="http://schemas.microsoft.com/office/drawing/2014/main" id="{716230D0-FE21-48A0-BA3C-84D47A29D8B9}"/>
+                <a16:creationId xmlns:a16="http://schemas.microsoft.com/office/drawing/2014/main" id="{CB8C9C4E-F718-4A15-9696-914A7F00AC6F}"/>
               </a:ext>
             </a:extLst>
           </p:cNvPr>
@@ -20383,7 +20418,7 @@
           <p:cNvPr id="4" name="">
             <a:extLst xmlns:a="http://schemas.openxmlformats.org/drawingml/2006/main">
               <a:ext uri="{FF2B5EF4-FFF2-40B4-BE49-F238E27FC236}">
-                <a16:creationId xmlns:a16="http://schemas.microsoft.com/office/drawing/2014/main" id="{1470CC01-FE85-4553-B035-D0D6AF2266A1}"/>
+                <a16:creationId xmlns:a16="http://schemas.microsoft.com/office/drawing/2014/main" id="{1DD49E9B-1A59-4530-B00B-1ED486364B36}"/>
               </a:ext>
             </a:extLst>
           </p:cNvPr>
@@ -20445,7 +20480,7 @@
           <p:cNvPr id="5" name="">
             <a:extLst xmlns:a="http://schemas.openxmlformats.org/drawingml/2006/main">
               <a:ext uri="{FF2B5EF4-FFF2-40B4-BE49-F238E27FC236}">
-                <a16:creationId xmlns:a16="http://schemas.microsoft.com/office/drawing/2014/main" id="{F2D558EF-906C-4DC3-917C-1AED70A39419}"/>
+                <a16:creationId xmlns:a16="http://schemas.microsoft.com/office/drawing/2014/main" id="{1C804F82-6E80-4F7E-8307-4145FA4F0005}"/>
               </a:ext>
             </a:extLst>
           </p:cNvPr>
@@ -20476,7 +20511,7 @@
           <p:cNvPr id="6" name="">
             <a:extLst xmlns:a="http://schemas.openxmlformats.org/drawingml/2006/main">
               <a:ext uri="{FF2B5EF4-FFF2-40B4-BE49-F238E27FC236}">
-                <a16:creationId xmlns:a16="http://schemas.microsoft.com/office/drawing/2014/main" id="{F1414EA3-590B-4B42-B6F3-C95BB3E45B9E}"/>
+                <a16:creationId xmlns:a16="http://schemas.microsoft.com/office/drawing/2014/main" id="{CA131B23-0426-4E2C-B045-B70AA5A03CFF}"/>
               </a:ext>
             </a:extLst>
           </p:cNvPr>
@@ -20538,7 +20573,7 @@
           <p:cNvPr id="7" name="">
             <a:extLst xmlns:a="http://schemas.openxmlformats.org/drawingml/2006/main">
               <a:ext uri="{FF2B5EF4-FFF2-40B4-BE49-F238E27FC236}">
-                <a16:creationId xmlns:a16="http://schemas.microsoft.com/office/drawing/2014/main" id="{77975472-9E56-4CD5-A95E-B6CC37F856D4}"/>
+                <a16:creationId xmlns:a16="http://schemas.microsoft.com/office/drawing/2014/main" id="{28605076-0D0C-4E0C-B950-9ED870F83B3C}"/>
               </a:ext>
             </a:extLst>
           </p:cNvPr>
@@ -20600,7 +20635,7 @@
           <p:cNvPr id="8" name="">
             <a:extLst xmlns:a="http://schemas.openxmlformats.org/drawingml/2006/main">
               <a:ext uri="{FF2B5EF4-FFF2-40B4-BE49-F238E27FC236}">
-                <a16:creationId xmlns:a16="http://schemas.microsoft.com/office/drawing/2014/main" id="{7C25A229-92B3-4E97-B3CD-6D7C321DBFF9}"/>
+                <a16:creationId xmlns:a16="http://schemas.microsoft.com/office/drawing/2014/main" id="{27AB68E8-A62A-4224-BE2E-A3A6E97225E5}"/>
               </a:ext>
             </a:extLst>
           </p:cNvPr>
@@ -20662,7 +20697,7 @@
           <p:cNvPr id="9" name="">
             <a:extLst xmlns:a="http://schemas.openxmlformats.org/drawingml/2006/main">
               <a:ext uri="{FF2B5EF4-FFF2-40B4-BE49-F238E27FC236}">
-                <a16:creationId xmlns:a16="http://schemas.microsoft.com/office/drawing/2014/main" id="{F81FA25A-E9D7-42E8-98F1-25326B192E53}"/>
+                <a16:creationId xmlns:a16="http://schemas.microsoft.com/office/drawing/2014/main" id="{D7991D8F-EE4C-40AD-91DA-E64EC4BAAD9F}"/>
               </a:ext>
             </a:extLst>
           </p:cNvPr>
@@ -20693,7 +20728,7 @@
           <p:cNvPr id="10" name="">
             <a:extLst xmlns:a="http://schemas.openxmlformats.org/drawingml/2006/main">
               <a:ext uri="{FF2B5EF4-FFF2-40B4-BE49-F238E27FC236}">
-                <a16:creationId xmlns:a16="http://schemas.microsoft.com/office/drawing/2014/main" id="{987F74DC-A21A-408F-9D8C-9F74DADC8769}"/>
+                <a16:creationId xmlns:a16="http://schemas.microsoft.com/office/drawing/2014/main" id="{3851888A-4FF7-4EC1-BFB8-0633E51FC603}"/>
               </a:ext>
             </a:extLst>
           </p:cNvPr>
@@ -20755,7 +20790,7 @@
           <p:cNvPr id="11" name="">
             <a:extLst xmlns:a="http://schemas.openxmlformats.org/drawingml/2006/main">
               <a:ext uri="{FF2B5EF4-FFF2-40B4-BE49-F238E27FC236}">
-                <a16:creationId xmlns:a16="http://schemas.microsoft.com/office/drawing/2014/main" id="{72AEF54B-D9C6-4920-B71C-4F78409C9587}"/>
+                <a16:creationId xmlns:a16="http://schemas.microsoft.com/office/drawing/2014/main" id="{06D5EBAC-4A13-40C5-9901-0113E8E8992F}"/>
               </a:ext>
             </a:extLst>
           </p:cNvPr>
@@ -20817,7 +20852,7 @@
           <p:cNvPr id="12" name="">
             <a:extLst xmlns:a="http://schemas.openxmlformats.org/drawingml/2006/main">
               <a:ext uri="{FF2B5EF4-FFF2-40B4-BE49-F238E27FC236}">
-                <a16:creationId xmlns:a16="http://schemas.microsoft.com/office/drawing/2014/main" id="{D0E5241A-65F1-4F3D-8FB9-4430B65C7583}"/>
+                <a16:creationId xmlns:a16="http://schemas.microsoft.com/office/drawing/2014/main" id="{DAE8955E-788D-41D7-BAE6-6A51820BF8B0}"/>
               </a:ext>
             </a:extLst>
           </p:cNvPr>
@@ -20879,7 +20914,7 @@
           <p:cNvPr id="13" name="">
             <a:extLst xmlns:a="http://schemas.openxmlformats.org/drawingml/2006/main">
               <a:ext uri="{FF2B5EF4-FFF2-40B4-BE49-F238E27FC236}">
-                <a16:creationId xmlns:a16="http://schemas.microsoft.com/office/drawing/2014/main" id="{5D5FF8C5-129A-40B1-B3BC-4AFE1B830CAD}"/>
+                <a16:creationId xmlns:a16="http://schemas.microsoft.com/office/drawing/2014/main" id="{46D98321-D951-4CE4-8C7A-F7B4ECDCC05B}"/>
               </a:ext>
             </a:extLst>
           </p:cNvPr>
@@ -20910,7 +20945,7 @@
           <p:cNvPr id="14" name="">
             <a:extLst xmlns:a="http://schemas.openxmlformats.org/drawingml/2006/main">
               <a:ext uri="{FF2B5EF4-FFF2-40B4-BE49-F238E27FC236}">
-                <a16:creationId xmlns:a16="http://schemas.microsoft.com/office/drawing/2014/main" id="{5F2748DC-FFA9-432D-85A9-BF167F57C81A}"/>
+                <a16:creationId xmlns:a16="http://schemas.microsoft.com/office/drawing/2014/main" id="{7FBAA4FC-034D-4BAA-BAB9-7E11A1F76F40}"/>
               </a:ext>
             </a:extLst>
           </p:cNvPr>
@@ -20972,7 +21007,7 @@
           <p:cNvPr id="15" name="">
             <a:extLst xmlns:a="http://schemas.openxmlformats.org/drawingml/2006/main">
               <a:ext uri="{FF2B5EF4-FFF2-40B4-BE49-F238E27FC236}">
-                <a16:creationId xmlns:a16="http://schemas.microsoft.com/office/drawing/2014/main" id="{5780B206-ADE0-490C-B106-C5012789FC2B}"/>
+                <a16:creationId xmlns:a16="http://schemas.microsoft.com/office/drawing/2014/main" id="{20DED32E-C45E-453E-8044-2405335E5DE7}"/>
               </a:ext>
             </a:extLst>
           </p:cNvPr>
@@ -21034,7 +21069,7 @@
           <p:cNvPr id="16" name="">
             <a:extLst xmlns:a="http://schemas.openxmlformats.org/drawingml/2006/main">
               <a:ext uri="{FF2B5EF4-FFF2-40B4-BE49-F238E27FC236}">
-                <a16:creationId xmlns:a16="http://schemas.microsoft.com/office/drawing/2014/main" id="{9A264074-9089-4236-9DE0-3ADA50667B07}"/>
+                <a16:creationId xmlns:a16="http://schemas.microsoft.com/office/drawing/2014/main" id="{33F42662-CAD9-4A71-8556-1D8B51B1258A}"/>
               </a:ext>
             </a:extLst>
           </p:cNvPr>
@@ -21096,7 +21131,7 @@
           <p:cNvPr id="17" name="dashboard-preview">
             <a:extLst xmlns:a="http://schemas.openxmlformats.org/drawingml/2006/main">
               <a:ext uri="{FF2B5EF4-FFF2-40B4-BE49-F238E27FC236}">
-                <a16:creationId xmlns:a16="http://schemas.microsoft.com/office/drawing/2014/main" id="{AE3C4AE4-75FD-4E1A-8C62-0967DF6919A1}"/>
+                <a16:creationId xmlns:a16="http://schemas.microsoft.com/office/drawing/2014/main" id="{35C85E97-8818-4511-A5B5-F97941446260}"/>
               </a:ext>
             </a:extLst>
           </p:cNvPr>
@@ -21131,7 +21166,7 @@
           <p:cNvPr id="18" name="">
             <a:extLst xmlns:a="http://schemas.openxmlformats.org/drawingml/2006/main">
               <a:ext uri="{FF2B5EF4-FFF2-40B4-BE49-F238E27FC236}">
-                <a16:creationId xmlns:a16="http://schemas.microsoft.com/office/drawing/2014/main" id="{1CF807D2-C72E-4865-A408-CBFDF3385A2B}"/>
+                <a16:creationId xmlns:a16="http://schemas.microsoft.com/office/drawing/2014/main" id="{113BDF15-A151-481A-BC55-672AFBE47B60}"/>
               </a:ext>
             </a:extLst>
           </p:cNvPr>
@@ -21193,7 +21228,7 @@
           <p:cNvPr id="19" name="">
             <a:extLst xmlns:a="http://schemas.openxmlformats.org/drawingml/2006/main">
               <a:ext uri="{FF2B5EF4-FFF2-40B4-BE49-F238E27FC236}">
-                <a16:creationId xmlns:a16="http://schemas.microsoft.com/office/drawing/2014/main" id="{067A7428-0EEE-4A98-8CAB-5E08BB2E13EB}"/>
+                <a16:creationId xmlns:a16="http://schemas.microsoft.com/office/drawing/2014/main" id="{8D97A8C7-8068-441B-B1BE-FF84FFC0735B}"/>
               </a:ext>
             </a:extLst>
           </p:cNvPr>
@@ -21224,7 +21259,7 @@
           <p:cNvPr id="20" name="">
             <a:extLst xmlns:a="http://schemas.openxmlformats.org/drawingml/2006/main">
               <a:ext uri="{FF2B5EF4-FFF2-40B4-BE49-F238E27FC236}">
-                <a16:creationId xmlns:a16="http://schemas.microsoft.com/office/drawing/2014/main" id="{586D340B-0DEC-46B0-BCB4-F3448F8B56E9}"/>
+                <a16:creationId xmlns:a16="http://schemas.microsoft.com/office/drawing/2014/main" id="{7E3B7729-84C2-4009-956B-566C6700FC7A}"/>
               </a:ext>
             </a:extLst>
           </p:cNvPr>
@@ -21286,7 +21321,7 @@
           <p:cNvPr id="21" name="">
             <a:extLst xmlns:a="http://schemas.openxmlformats.org/drawingml/2006/main">
               <a:ext uri="{FF2B5EF4-FFF2-40B4-BE49-F238E27FC236}">
-                <a16:creationId xmlns:a16="http://schemas.microsoft.com/office/drawing/2014/main" id="{6C9C8E0B-D410-46F6-B9D9-3EE431D3805A}"/>
+                <a16:creationId xmlns:a16="http://schemas.microsoft.com/office/drawing/2014/main" id="{FA181EE3-6ECF-45DF-8E68-794451A2DC43}"/>
               </a:ext>
             </a:extLst>
           </p:cNvPr>
@@ -21317,7 +21352,7 @@
           <p:cNvPr id="22" name="">
             <a:extLst xmlns:a="http://schemas.openxmlformats.org/drawingml/2006/main">
               <a:ext uri="{FF2B5EF4-FFF2-40B4-BE49-F238E27FC236}">
-                <a16:creationId xmlns:a16="http://schemas.microsoft.com/office/drawing/2014/main" id="{2101623E-CFA5-4ACB-8747-44B077166D6F}"/>
+                <a16:creationId xmlns:a16="http://schemas.microsoft.com/office/drawing/2014/main" id="{0B729DF3-4972-4B07-9654-F3DFC710FD44}"/>
               </a:ext>
             </a:extLst>
           </p:cNvPr>
@@ -21348,7 +21383,7 @@
           <p:cNvPr id="23" name="">
             <a:extLst xmlns:a="http://schemas.openxmlformats.org/drawingml/2006/main">
               <a:ext uri="{FF2B5EF4-FFF2-40B4-BE49-F238E27FC236}">
-                <a16:creationId xmlns:a16="http://schemas.microsoft.com/office/drawing/2014/main" id="{B8D18998-39B8-4C5F-8588-03EDACA3CCC7}"/>
+                <a16:creationId xmlns:a16="http://schemas.microsoft.com/office/drawing/2014/main" id="{696D28CA-C9EE-43EB-870C-73BDC33019D1}"/>
               </a:ext>
             </a:extLst>
           </p:cNvPr>
@@ -21381,7 +21416,7 @@
           <p:cNvPr id="24" name="">
             <a:extLst xmlns:a="http://schemas.openxmlformats.org/drawingml/2006/main">
               <a:ext uri="{FF2B5EF4-FFF2-40B4-BE49-F238E27FC236}">
-                <a16:creationId xmlns:a16="http://schemas.microsoft.com/office/drawing/2014/main" id="{2548911E-7F92-406A-AEB1-C351AE81F8DF}"/>
+                <a16:creationId xmlns:a16="http://schemas.microsoft.com/office/drawing/2014/main" id="{CB2ECFAA-4E51-4FA4-B495-5EEFCA1A520D}"/>
               </a:ext>
             </a:extLst>
           </p:cNvPr>
@@ -21443,7 +21478,7 @@
           <p:cNvPr id="25" name="footer-rule-7">
             <a:extLst xmlns:a="http://schemas.openxmlformats.org/drawingml/2006/main">
               <a:ext uri="{FF2B5EF4-FFF2-40B4-BE49-F238E27FC236}">
-                <a16:creationId xmlns:a16="http://schemas.microsoft.com/office/drawing/2014/main" id="{47B9DDCB-A88D-4FD1-9264-3FEB38D6D2B8}"/>
+                <a16:creationId xmlns:a16="http://schemas.microsoft.com/office/drawing/2014/main" id="{699AB444-FBA3-4643-B31C-C327C070D298}"/>
               </a:ext>
             </a:extLst>
           </p:cNvPr>
@@ -21474,7 +21509,7 @@
           <p:cNvPr id="26" name="footer-label-7">
             <a:extLst xmlns:a="http://schemas.openxmlformats.org/drawingml/2006/main">
               <a:ext uri="{FF2B5EF4-FFF2-40B4-BE49-F238E27FC236}">
-                <a16:creationId xmlns:a16="http://schemas.microsoft.com/office/drawing/2014/main" id="{82651EA9-2095-47C5-A224-87B5952D87D6}"/>
+                <a16:creationId xmlns:a16="http://schemas.microsoft.com/office/drawing/2014/main" id="{B3B2B729-40C2-4DBB-A48A-07BD8A073ED9}"/>
               </a:ext>
             </a:extLst>
           </p:cNvPr>
@@ -21536,7 +21571,7 @@
           <p:cNvPr id="27" name="footer-page-7">
             <a:extLst xmlns:a="http://schemas.openxmlformats.org/drawingml/2006/main">
               <a:ext uri="{FF2B5EF4-FFF2-40B4-BE49-F238E27FC236}">
-                <a16:creationId xmlns:a16="http://schemas.microsoft.com/office/drawing/2014/main" id="{0ADCEE67-7A69-4C62-939D-BD396A0A8E3C}"/>
+                <a16:creationId xmlns:a16="http://schemas.microsoft.com/office/drawing/2014/main" id="{CD41699A-F334-47ED-9E23-E6EA56DC43BC}"/>
               </a:ext>
             </a:extLst>
           </p:cNvPr>
@@ -21596,7 +21631,7 @@
     </p:spTree>
     <p:extLst>
       <p:ext uri="{BB962C8B-B14F-4D97-AF65-F5344CB8AC3E}">
-        <p14:creationId xmlns:p14="http://schemas.microsoft.com/office/powerpoint/2010/main" val="1379327683"/>
+        <p14:creationId xmlns:p14="http://schemas.microsoft.com/office/powerpoint/2010/main" val="1381427731"/>
       </p:ext>
     </p:extLst>
   </p:cSld>
@@ -21627,7 +21662,7 @@
           <p:cNvPr id="26" name="side-accent-8">
             <a:extLst xmlns:a="http://schemas.openxmlformats.org/drawingml/2006/main">
               <a:ext uri="{FF2B5EF4-FFF2-40B4-BE49-F238E27FC236}">
-                <a16:creationId xmlns:a16="http://schemas.microsoft.com/office/drawing/2014/main" id="{6088CEB0-DFC9-476E-BD4C-2AE91B75EB36}"/>
+                <a16:creationId xmlns:a16="http://schemas.microsoft.com/office/drawing/2014/main" id="{B2E65A84-5630-48BC-8ADA-B74213425ABA}"/>
               </a:ext>
             </a:extLst>
           </p:cNvPr>
@@ -21658,7 +21693,7 @@
           <p:cNvPr id="2" name="kicker-8">
             <a:extLst xmlns:a="http://schemas.openxmlformats.org/drawingml/2006/main">
               <a:ext uri="{FF2B5EF4-FFF2-40B4-BE49-F238E27FC236}">
-                <a16:creationId xmlns:a16="http://schemas.microsoft.com/office/drawing/2014/main" id="{097605F7-AE51-4C5A-90BB-7DE68BF9B306}"/>
+                <a16:creationId xmlns:a16="http://schemas.microsoft.com/office/drawing/2014/main" id="{B4ED36FE-71B6-47E7-9605-29D21EAD9398}"/>
               </a:ext>
             </a:extLst>
           </p:cNvPr>
@@ -21720,7 +21755,7 @@
           <p:cNvPr id="3" name="title-8">
             <a:extLst xmlns:a="http://schemas.openxmlformats.org/drawingml/2006/main">
               <a:ext uri="{FF2B5EF4-FFF2-40B4-BE49-F238E27FC236}">
-                <a16:creationId xmlns:a16="http://schemas.microsoft.com/office/drawing/2014/main" id="{8EA7359A-4DFF-4D75-ADC0-E9505C0C0493}"/>
+                <a16:creationId xmlns:a16="http://schemas.microsoft.com/office/drawing/2014/main" id="{D851C8E6-D24F-4ACB-93EF-A670FECF6440}"/>
               </a:ext>
             </a:extLst>
           </p:cNvPr>
@@ -21782,7 +21817,7 @@
           <p:cNvPr id="4" name="">
             <a:extLst xmlns:a="http://schemas.openxmlformats.org/drawingml/2006/main">
               <a:ext uri="{FF2B5EF4-FFF2-40B4-BE49-F238E27FC236}">
-                <a16:creationId xmlns:a16="http://schemas.microsoft.com/office/drawing/2014/main" id="{B66E1CBF-1CC0-47BF-8098-7A637AA7F98F}"/>
+                <a16:creationId xmlns:a16="http://schemas.microsoft.com/office/drawing/2014/main" id="{0ED3FF94-F5D0-4BD7-BF9E-3AC0E4D585DB}"/>
               </a:ext>
             </a:extLst>
           </p:cNvPr>
@@ -21844,7 +21879,7 @@
           <p:cNvPr id="5" name="">
             <a:extLst xmlns:a="http://schemas.openxmlformats.org/drawingml/2006/main">
               <a:ext uri="{FF2B5EF4-FFF2-40B4-BE49-F238E27FC236}">
-                <a16:creationId xmlns:a16="http://schemas.microsoft.com/office/drawing/2014/main" id="{54985F4A-C957-45CF-80F3-0AC5B106EA19}"/>
+                <a16:creationId xmlns:a16="http://schemas.microsoft.com/office/drawing/2014/main" id="{45350EEB-FAC1-44A2-89D4-1419B27F3056}"/>
               </a:ext>
             </a:extLst>
           </p:cNvPr>
@@ -21875,7 +21910,7 @@
           <p:cNvPr id="6" name="">
             <a:extLst xmlns:a="http://schemas.openxmlformats.org/drawingml/2006/main">
               <a:ext uri="{FF2B5EF4-FFF2-40B4-BE49-F238E27FC236}">
-                <a16:creationId xmlns:a16="http://schemas.microsoft.com/office/drawing/2014/main" id="{28FF82B7-4FAD-4D94-B281-D3CA923B59E8}"/>
+                <a16:creationId xmlns:a16="http://schemas.microsoft.com/office/drawing/2014/main" id="{276A741C-EA45-44CF-BAA1-1F097A4FFDD8}"/>
               </a:ext>
             </a:extLst>
           </p:cNvPr>
@@ -21906,7 +21941,7 @@
           <p:cNvPr id="7" name="">
             <a:extLst xmlns:a="http://schemas.openxmlformats.org/drawingml/2006/main">
               <a:ext uri="{FF2B5EF4-FFF2-40B4-BE49-F238E27FC236}">
-                <a16:creationId xmlns:a16="http://schemas.microsoft.com/office/drawing/2014/main" id="{33F79624-9434-4BA4-9A2F-D0E0415DB4EE}"/>
+                <a16:creationId xmlns:a16="http://schemas.microsoft.com/office/drawing/2014/main" id="{098DC43A-D070-4A82-881A-BBC407FC56D7}"/>
               </a:ext>
             </a:extLst>
           </p:cNvPr>
@@ -21968,7 +22003,7 @@
           <p:cNvPr id="8" name="">
             <a:extLst xmlns:a="http://schemas.openxmlformats.org/drawingml/2006/main">
               <a:ext uri="{FF2B5EF4-FFF2-40B4-BE49-F238E27FC236}">
-                <a16:creationId xmlns:a16="http://schemas.microsoft.com/office/drawing/2014/main" id="{B228E3A6-2108-4F58-B71B-6538EC559241}"/>
+                <a16:creationId xmlns:a16="http://schemas.microsoft.com/office/drawing/2014/main" id="{9BE1325E-4A6D-4DEA-961B-845B49ACA676}"/>
               </a:ext>
             </a:extLst>
           </p:cNvPr>
@@ -22030,7 +22065,7 @@
           <p:cNvPr id="9" name="">
             <a:extLst xmlns:a="http://schemas.openxmlformats.org/drawingml/2006/main">
               <a:ext uri="{FF2B5EF4-FFF2-40B4-BE49-F238E27FC236}">
-                <a16:creationId xmlns:a16="http://schemas.microsoft.com/office/drawing/2014/main" id="{649B24AB-EF61-42C5-A170-022FADCB6F9A}"/>
+                <a16:creationId xmlns:a16="http://schemas.microsoft.com/office/drawing/2014/main" id="{C6CCB6C5-9B23-413F-9DB5-FFC67ABCDF8C}"/>
               </a:ext>
             </a:extLst>
           </p:cNvPr>
@@ -22092,7 +22127,7 @@
           <p:cNvPr id="10" name="">
             <a:extLst xmlns:a="http://schemas.openxmlformats.org/drawingml/2006/main">
               <a:ext uri="{FF2B5EF4-FFF2-40B4-BE49-F238E27FC236}">
-                <a16:creationId xmlns:a16="http://schemas.microsoft.com/office/drawing/2014/main" id="{EB48BE4F-D324-48A9-B2EA-5E5B2B134D98}"/>
+                <a16:creationId xmlns:a16="http://schemas.microsoft.com/office/drawing/2014/main" id="{C067306A-09A9-46C1-B625-DF1B980447C1}"/>
               </a:ext>
             </a:extLst>
           </p:cNvPr>
@@ -22123,7 +22158,7 @@
           <p:cNvPr id="11" name="">
             <a:extLst xmlns:a="http://schemas.openxmlformats.org/drawingml/2006/main">
               <a:ext uri="{FF2B5EF4-FFF2-40B4-BE49-F238E27FC236}">
-                <a16:creationId xmlns:a16="http://schemas.microsoft.com/office/drawing/2014/main" id="{C4601E7F-A568-4941-9627-DE1DA21F7839}"/>
+                <a16:creationId xmlns:a16="http://schemas.microsoft.com/office/drawing/2014/main" id="{A069B195-3D40-47DE-AD54-08BD61E5BC04}"/>
               </a:ext>
             </a:extLst>
           </p:cNvPr>
@@ -22185,7 +22220,7 @@
           <p:cNvPr id="12" name="">
             <a:extLst xmlns:a="http://schemas.openxmlformats.org/drawingml/2006/main">
               <a:ext uri="{FF2B5EF4-FFF2-40B4-BE49-F238E27FC236}">
-                <a16:creationId xmlns:a16="http://schemas.microsoft.com/office/drawing/2014/main" id="{DEF07C8D-FE62-4D70-BB77-B24BC188199E}"/>
+                <a16:creationId xmlns:a16="http://schemas.microsoft.com/office/drawing/2014/main" id="{A583D3A9-319E-4E60-990C-BB7F53AF0408}"/>
               </a:ext>
             </a:extLst>
           </p:cNvPr>
@@ -22247,7 +22282,7 @@
           <p:cNvPr id="13" name="">
             <a:extLst xmlns:a="http://schemas.openxmlformats.org/drawingml/2006/main">
               <a:ext uri="{FF2B5EF4-FFF2-40B4-BE49-F238E27FC236}">
-                <a16:creationId xmlns:a16="http://schemas.microsoft.com/office/drawing/2014/main" id="{3633401C-4505-4535-83A1-6899DCF50B90}"/>
+                <a16:creationId xmlns:a16="http://schemas.microsoft.com/office/drawing/2014/main" id="{A8C017FB-2942-40FC-9005-7FB48EBEA19A}"/>
               </a:ext>
             </a:extLst>
           </p:cNvPr>
@@ -22309,7 +22344,7 @@
           <p:cNvPr id="14" name="">
             <a:extLst xmlns:a="http://schemas.openxmlformats.org/drawingml/2006/main">
               <a:ext uri="{FF2B5EF4-FFF2-40B4-BE49-F238E27FC236}">
-                <a16:creationId xmlns:a16="http://schemas.microsoft.com/office/drawing/2014/main" id="{83F97852-5025-4AD2-8E3F-8EBF610B6E91}"/>
+                <a16:creationId xmlns:a16="http://schemas.microsoft.com/office/drawing/2014/main" id="{E586EC16-D7AC-4847-A868-E0B56493C886}"/>
               </a:ext>
             </a:extLst>
           </p:cNvPr>
@@ -22340,7 +22375,7 @@
           <p:cNvPr id="15" name="">
             <a:extLst xmlns:a="http://schemas.openxmlformats.org/drawingml/2006/main">
               <a:ext uri="{FF2B5EF4-FFF2-40B4-BE49-F238E27FC236}">
-                <a16:creationId xmlns:a16="http://schemas.microsoft.com/office/drawing/2014/main" id="{24812787-4C2B-44A5-94A3-1A4F5C4F3190}"/>
+                <a16:creationId xmlns:a16="http://schemas.microsoft.com/office/drawing/2014/main" id="{7E973665-F06F-4E46-9406-2CC89FC0EBC8}"/>
               </a:ext>
             </a:extLst>
           </p:cNvPr>
@@ -22402,7 +22437,7 @@
           <p:cNvPr id="16" name="">
             <a:extLst xmlns:a="http://schemas.openxmlformats.org/drawingml/2006/main">
               <a:ext uri="{FF2B5EF4-FFF2-40B4-BE49-F238E27FC236}">
-                <a16:creationId xmlns:a16="http://schemas.microsoft.com/office/drawing/2014/main" id="{4BE6DF6C-5BF1-4650-B940-02EFB096E908}"/>
+                <a16:creationId xmlns:a16="http://schemas.microsoft.com/office/drawing/2014/main" id="{542E3932-ACCE-477E-8FD4-6816B0593F56}"/>
               </a:ext>
             </a:extLst>
           </p:cNvPr>
@@ -22464,7 +22499,7 @@
           <p:cNvPr id="17" name="">
             <a:extLst xmlns:a="http://schemas.openxmlformats.org/drawingml/2006/main">
               <a:ext uri="{FF2B5EF4-FFF2-40B4-BE49-F238E27FC236}">
-                <a16:creationId xmlns:a16="http://schemas.microsoft.com/office/drawing/2014/main" id="{8314782A-EA78-4221-8B97-134D876E1716}"/>
+                <a16:creationId xmlns:a16="http://schemas.microsoft.com/office/drawing/2014/main" id="{57AC7C67-A832-4804-AE41-5E4A4FD53A96}"/>
               </a:ext>
             </a:extLst>
           </p:cNvPr>
@@ -22526,7 +22561,7 @@
           <p:cNvPr id="18" name="">
             <a:extLst xmlns:a="http://schemas.openxmlformats.org/drawingml/2006/main">
               <a:ext uri="{FF2B5EF4-FFF2-40B4-BE49-F238E27FC236}">
-                <a16:creationId xmlns:a16="http://schemas.microsoft.com/office/drawing/2014/main" id="{A3A0CBF2-3824-443F-B986-509DE34F4A67}"/>
+                <a16:creationId xmlns:a16="http://schemas.microsoft.com/office/drawing/2014/main" id="{F2AA7947-A0F7-409E-8DE5-B631DCDD4727}"/>
               </a:ext>
             </a:extLst>
           </p:cNvPr>
@@ -22557,7 +22592,7 @@
           <p:cNvPr id="19" name="">
             <a:extLst xmlns:a="http://schemas.openxmlformats.org/drawingml/2006/main">
               <a:ext uri="{FF2B5EF4-FFF2-40B4-BE49-F238E27FC236}">
-                <a16:creationId xmlns:a16="http://schemas.microsoft.com/office/drawing/2014/main" id="{FEABD2E4-82E1-47A9-96DC-6C81B19F3BBB}"/>
+                <a16:creationId xmlns:a16="http://schemas.microsoft.com/office/drawing/2014/main" id="{0BBFBCFF-4399-4F42-A0E9-978A1EB097A0}"/>
               </a:ext>
             </a:extLst>
           </p:cNvPr>
@@ -22619,7 +22654,7 @@
           <p:cNvPr id="20" name="">
             <a:extLst xmlns:a="http://schemas.openxmlformats.org/drawingml/2006/main">
               <a:ext uri="{FF2B5EF4-FFF2-40B4-BE49-F238E27FC236}">
-                <a16:creationId xmlns:a16="http://schemas.microsoft.com/office/drawing/2014/main" id="{55C70AC8-935C-434D-B0C8-9185C28EF203}"/>
+                <a16:creationId xmlns:a16="http://schemas.microsoft.com/office/drawing/2014/main" id="{8ABA09C8-87A1-456B-B0CF-C034C33DD246}"/>
               </a:ext>
             </a:extLst>
           </p:cNvPr>
@@ -22681,7 +22716,7 @@
           <p:cNvPr id="21" name="">
             <a:extLst xmlns:a="http://schemas.openxmlformats.org/drawingml/2006/main">
               <a:ext uri="{FF2B5EF4-FFF2-40B4-BE49-F238E27FC236}">
-                <a16:creationId xmlns:a16="http://schemas.microsoft.com/office/drawing/2014/main" id="{4B5EB7FB-469A-44B4-9219-5DCE0C7DA5CB}"/>
+                <a16:creationId xmlns:a16="http://schemas.microsoft.com/office/drawing/2014/main" id="{A6AD2EEC-5DCE-4DA2-A707-BB49AA5CA6A5}"/>
               </a:ext>
             </a:extLst>
           </p:cNvPr>
@@ -22743,7 +22778,7 @@
           <p:cNvPr id="22" name="">
             <a:extLst xmlns:a="http://schemas.openxmlformats.org/drawingml/2006/main">
               <a:ext uri="{FF2B5EF4-FFF2-40B4-BE49-F238E27FC236}">
-                <a16:creationId xmlns:a16="http://schemas.microsoft.com/office/drawing/2014/main" id="{14399573-CC11-4F1C-9B6D-79CEA4F073A8}"/>
+                <a16:creationId xmlns:a16="http://schemas.microsoft.com/office/drawing/2014/main" id="{57C9426B-CFAF-4A90-B769-5CBC58D86837}"/>
               </a:ext>
             </a:extLst>
           </p:cNvPr>
@@ -22805,7 +22840,7 @@
           <p:cNvPr id="23" name="footer-rule-8">
             <a:extLst xmlns:a="http://schemas.openxmlformats.org/drawingml/2006/main">
               <a:ext uri="{FF2B5EF4-FFF2-40B4-BE49-F238E27FC236}">
-                <a16:creationId xmlns:a16="http://schemas.microsoft.com/office/drawing/2014/main" id="{359B2593-5AFF-4CF5-956E-6E6DD81A07F7}"/>
+                <a16:creationId xmlns:a16="http://schemas.microsoft.com/office/drawing/2014/main" id="{8C7B7E6E-0E46-4710-9CF1-3CEFFA0DEF0D}"/>
               </a:ext>
             </a:extLst>
           </p:cNvPr>
@@ -22836,7 +22871,7 @@
           <p:cNvPr id="24" name="footer-label-8">
             <a:extLst xmlns:a="http://schemas.openxmlformats.org/drawingml/2006/main">
               <a:ext uri="{FF2B5EF4-FFF2-40B4-BE49-F238E27FC236}">
-                <a16:creationId xmlns:a16="http://schemas.microsoft.com/office/drawing/2014/main" id="{3E545D3F-F3AE-4707-9A3B-1688D0B57B86}"/>
+                <a16:creationId xmlns:a16="http://schemas.microsoft.com/office/drawing/2014/main" id="{3B748BCD-342A-46AC-9F03-003BC22E296B}"/>
               </a:ext>
             </a:extLst>
           </p:cNvPr>
@@ -22898,7 +22933,7 @@
           <p:cNvPr id="25" name="footer-page-8">
             <a:extLst xmlns:a="http://schemas.openxmlformats.org/drawingml/2006/main">
               <a:ext uri="{FF2B5EF4-FFF2-40B4-BE49-F238E27FC236}">
-                <a16:creationId xmlns:a16="http://schemas.microsoft.com/office/drawing/2014/main" id="{B8928B59-9720-44FF-8411-DBEF0A651946}"/>
+                <a16:creationId xmlns:a16="http://schemas.microsoft.com/office/drawing/2014/main" id="{D715C5DE-F1F5-487B-88B2-8E5C74ADFC14}"/>
               </a:ext>
             </a:extLst>
           </p:cNvPr>
@@ -22958,7 +22993,7 @@
     </p:spTree>
     <p:extLst>
       <p:ext uri="{BB962C8B-B14F-4D97-AF65-F5344CB8AC3E}">
-        <p14:creationId xmlns:p14="http://schemas.microsoft.com/office/powerpoint/2010/main" val="1924688387"/>
+        <p14:creationId xmlns:p14="http://schemas.microsoft.com/office/powerpoint/2010/main" val="1791987177"/>
       </p:ext>
     </p:extLst>
   </p:cSld>
@@ -22989,7 +23024,7 @@
           <p:cNvPr id="25" name="side-accent-9">
             <a:extLst xmlns:a="http://schemas.openxmlformats.org/drawingml/2006/main">
               <a:ext uri="{FF2B5EF4-FFF2-40B4-BE49-F238E27FC236}">
-                <a16:creationId xmlns:a16="http://schemas.microsoft.com/office/drawing/2014/main" id="{BB8B4E10-7A34-4B1D-B03A-5818E79CA17C}"/>
+                <a16:creationId xmlns:a16="http://schemas.microsoft.com/office/drawing/2014/main" id="{B8D8418E-542F-4661-80A1-7DD5583C312B}"/>
               </a:ext>
             </a:extLst>
           </p:cNvPr>
@@ -23020,7 +23055,7 @@
           <p:cNvPr id="2" name="kicker-9">
             <a:extLst xmlns:a="http://schemas.openxmlformats.org/drawingml/2006/main">
               <a:ext uri="{FF2B5EF4-FFF2-40B4-BE49-F238E27FC236}">
-                <a16:creationId xmlns:a16="http://schemas.microsoft.com/office/drawing/2014/main" id="{7BEC781B-4647-48E5-A137-FCAE7CB47080}"/>
+                <a16:creationId xmlns:a16="http://schemas.microsoft.com/office/drawing/2014/main" id="{F1A90147-21A9-46B7-A10F-B27390433C30}"/>
               </a:ext>
             </a:extLst>
           </p:cNvPr>
@@ -23082,7 +23117,7 @@
           <p:cNvPr id="3" name="title-9">
             <a:extLst xmlns:a="http://schemas.openxmlformats.org/drawingml/2006/main">
               <a:ext uri="{FF2B5EF4-FFF2-40B4-BE49-F238E27FC236}">
-                <a16:creationId xmlns:a16="http://schemas.microsoft.com/office/drawing/2014/main" id="{A04EE715-6D94-42C9-B490-B659F6F2C6E9}"/>
+                <a16:creationId xmlns:a16="http://schemas.microsoft.com/office/drawing/2014/main" id="{22161C86-B410-442C-A5F1-553CD5F31D7D}"/>
               </a:ext>
             </a:extLst>
           </p:cNvPr>
@@ -23144,7 +23179,7 @@
           <p:cNvPr id="4" name="">
             <a:extLst xmlns:a="http://schemas.openxmlformats.org/drawingml/2006/main">
               <a:ext uri="{FF2B5EF4-FFF2-40B4-BE49-F238E27FC236}">
-                <a16:creationId xmlns:a16="http://schemas.microsoft.com/office/drawing/2014/main" id="{949424B7-BBC4-42C6-B2B9-A8330EE4181A}"/>
+                <a16:creationId xmlns:a16="http://schemas.microsoft.com/office/drawing/2014/main" id="{A692A8E0-EB19-4926-B43F-F42F790A6D91}"/>
               </a:ext>
             </a:extLst>
           </p:cNvPr>
@@ -23206,7 +23241,7 @@
           <p:cNvPr id="5" name="">
             <a:extLst xmlns:a="http://schemas.openxmlformats.org/drawingml/2006/main">
               <a:ext uri="{FF2B5EF4-FFF2-40B4-BE49-F238E27FC236}">
-                <a16:creationId xmlns:a16="http://schemas.microsoft.com/office/drawing/2014/main" id="{77D398FA-0A1C-4714-9CEC-6F51B632ADA1}"/>
+                <a16:creationId xmlns:a16="http://schemas.microsoft.com/office/drawing/2014/main" id="{E88ACF05-A9FC-412F-8D0D-7C0902BA660B}"/>
               </a:ext>
             </a:extLst>
           </p:cNvPr>
@@ -23241,7 +23276,7 @@
           <p:cNvPr id="6" name="">
             <a:extLst xmlns:a="http://schemas.openxmlformats.org/drawingml/2006/main">
               <a:ext uri="{FF2B5EF4-FFF2-40B4-BE49-F238E27FC236}">
-                <a16:creationId xmlns:a16="http://schemas.microsoft.com/office/drawing/2014/main" id="{5D15F334-6B8B-4CF3-9983-9A92D60DA7E4}"/>
+                <a16:creationId xmlns:a16="http://schemas.microsoft.com/office/drawing/2014/main" id="{67F5C5CA-71C1-4964-9240-A7D285129D35}"/>
               </a:ext>
             </a:extLst>
           </p:cNvPr>
@@ -23303,7 +23338,7 @@
           <p:cNvPr id="7" name="">
             <a:extLst xmlns:a="http://schemas.openxmlformats.org/drawingml/2006/main">
               <a:ext uri="{FF2B5EF4-FFF2-40B4-BE49-F238E27FC236}">
-                <a16:creationId xmlns:a16="http://schemas.microsoft.com/office/drawing/2014/main" id="{98669488-1705-4C6B-AE2D-5D97E433726C}"/>
+                <a16:creationId xmlns:a16="http://schemas.microsoft.com/office/drawing/2014/main" id="{65ABF04C-039A-4246-BD4D-F05D345F0B97}"/>
               </a:ext>
             </a:extLst>
           </p:cNvPr>
@@ -23365,7 +23400,7 @@
           <p:cNvPr id="8" name="">
             <a:extLst xmlns:a="http://schemas.openxmlformats.org/drawingml/2006/main">
               <a:ext uri="{FF2B5EF4-FFF2-40B4-BE49-F238E27FC236}">
-                <a16:creationId xmlns:a16="http://schemas.microsoft.com/office/drawing/2014/main" id="{7361A7C8-0145-48E3-B774-C71F8B114655}"/>
+                <a16:creationId xmlns:a16="http://schemas.microsoft.com/office/drawing/2014/main" id="{7504D161-B740-464B-8A74-20B27C00BF75}"/>
               </a:ext>
             </a:extLst>
           </p:cNvPr>
@@ -23427,7 +23462,7 @@
           <p:cNvPr id="9" name="">
             <a:extLst xmlns:a="http://schemas.openxmlformats.org/drawingml/2006/main">
               <a:ext uri="{FF2B5EF4-FFF2-40B4-BE49-F238E27FC236}">
-                <a16:creationId xmlns:a16="http://schemas.microsoft.com/office/drawing/2014/main" id="{3553A077-6820-4FFE-BB52-62526CAD3049}"/>
+                <a16:creationId xmlns:a16="http://schemas.microsoft.com/office/drawing/2014/main" id="{84030399-A86B-4C9B-B41F-19DBDE1D22FB}"/>
               </a:ext>
             </a:extLst>
           </p:cNvPr>
@@ -23462,7 +23497,7 @@
           <p:cNvPr id="10" name="">
             <a:extLst xmlns:a="http://schemas.openxmlformats.org/drawingml/2006/main">
               <a:ext uri="{FF2B5EF4-FFF2-40B4-BE49-F238E27FC236}">
-                <a16:creationId xmlns:a16="http://schemas.microsoft.com/office/drawing/2014/main" id="{69B2814C-34E8-4C13-865F-F072A93B33B3}"/>
+                <a16:creationId xmlns:a16="http://schemas.microsoft.com/office/drawing/2014/main" id="{2F8A393A-99C1-47BD-870C-82462FAE54ED}"/>
               </a:ext>
             </a:extLst>
           </p:cNvPr>
@@ -23524,7 +23559,7 @@
           <p:cNvPr id="11" name="">
             <a:extLst xmlns:a="http://schemas.openxmlformats.org/drawingml/2006/main">
               <a:ext uri="{FF2B5EF4-FFF2-40B4-BE49-F238E27FC236}">
-                <a16:creationId xmlns:a16="http://schemas.microsoft.com/office/drawing/2014/main" id="{188F45D3-D718-4B50-B9F0-F0D92766DEE9}"/>
+                <a16:creationId xmlns:a16="http://schemas.microsoft.com/office/drawing/2014/main" id="{94C8307C-9EB8-4854-AB67-C6A72DE8633A}"/>
               </a:ext>
             </a:extLst>
           </p:cNvPr>
@@ -23586,7 +23621,7 @@
           <p:cNvPr id="12" name="">
             <a:extLst xmlns:a="http://schemas.openxmlformats.org/drawingml/2006/main">
               <a:ext uri="{FF2B5EF4-FFF2-40B4-BE49-F238E27FC236}">
-                <a16:creationId xmlns:a16="http://schemas.microsoft.com/office/drawing/2014/main" id="{950C5460-A9F9-40BA-930A-2F908CAA3BDD}"/>
+                <a16:creationId xmlns:a16="http://schemas.microsoft.com/office/drawing/2014/main" id="{84658773-5521-4E6C-B81A-2EF44469326B}"/>
               </a:ext>
             </a:extLst>
           </p:cNvPr>
@@ -23648,7 +23683,7 @@
           <p:cNvPr id="13" name="">
             <a:extLst xmlns:a="http://schemas.openxmlformats.org/drawingml/2006/main">
               <a:ext uri="{FF2B5EF4-FFF2-40B4-BE49-F238E27FC236}">
-                <a16:creationId xmlns:a16="http://schemas.microsoft.com/office/drawing/2014/main" id="{1CD593FE-0107-439B-81E1-362CD83675B9}"/>
+                <a16:creationId xmlns:a16="http://schemas.microsoft.com/office/drawing/2014/main" id="{F8CFA185-7CB8-4997-913B-774619B48C68}"/>
               </a:ext>
             </a:extLst>
           </p:cNvPr>
@@ -23683,7 +23718,7 @@
           <p:cNvPr id="14" name="">
             <a:extLst xmlns:a="http://schemas.openxmlformats.org/drawingml/2006/main">
               <a:ext uri="{FF2B5EF4-FFF2-40B4-BE49-F238E27FC236}">
-                <a16:creationId xmlns:a16="http://schemas.microsoft.com/office/drawing/2014/main" id="{F67B5687-30F5-4ED0-8C35-A83203ECCA92}"/>
+                <a16:creationId xmlns:a16="http://schemas.microsoft.com/office/drawing/2014/main" id="{AA09A41D-97B1-4266-9063-007FE912CD4C}"/>
               </a:ext>
             </a:extLst>
           </p:cNvPr>
@@ -23745,7 +23780,7 @@
           <p:cNvPr id="15" name="">
             <a:extLst xmlns:a="http://schemas.openxmlformats.org/drawingml/2006/main">
               <a:ext uri="{FF2B5EF4-FFF2-40B4-BE49-F238E27FC236}">
-                <a16:creationId xmlns:a16="http://schemas.microsoft.com/office/drawing/2014/main" id="{B9C0FC4A-21B0-4F7F-88A4-7227852048AA}"/>
+                <a16:creationId xmlns:a16="http://schemas.microsoft.com/office/drawing/2014/main" id="{AA3AF012-DB48-49E3-B3A5-4029282E8052}"/>
               </a:ext>
             </a:extLst>
           </p:cNvPr>
@@ -23807,7 +23842,7 @@
           <p:cNvPr id="16" name="">
             <a:extLst xmlns:a="http://schemas.openxmlformats.org/drawingml/2006/main">
               <a:ext uri="{FF2B5EF4-FFF2-40B4-BE49-F238E27FC236}">
-                <a16:creationId xmlns:a16="http://schemas.microsoft.com/office/drawing/2014/main" id="{DACFD5A8-63AA-4EBA-AEBA-91F2F6DF790B}"/>
+                <a16:creationId xmlns:a16="http://schemas.microsoft.com/office/drawing/2014/main" id="{07F38926-9414-48A0-8F1E-77B620956E52}"/>
               </a:ext>
             </a:extLst>
           </p:cNvPr>
@@ -23869,7 +23904,7 @@
           <p:cNvPr id="17" name="">
             <a:extLst xmlns:a="http://schemas.openxmlformats.org/drawingml/2006/main">
               <a:ext uri="{FF2B5EF4-FFF2-40B4-BE49-F238E27FC236}">
-                <a16:creationId xmlns:a16="http://schemas.microsoft.com/office/drawing/2014/main" id="{B7403C0E-BB63-49A4-A15D-0A62D2BF81BE}"/>
+                <a16:creationId xmlns:a16="http://schemas.microsoft.com/office/drawing/2014/main" id="{F8D05DA1-ABAE-4C10-8021-0C1308D29BBF}"/>
               </a:ext>
             </a:extLst>
           </p:cNvPr>
@@ -23904,7 +23939,7 @@
           <p:cNvPr id="18" name="">
             <a:extLst xmlns:a="http://schemas.openxmlformats.org/drawingml/2006/main">
               <a:ext uri="{FF2B5EF4-FFF2-40B4-BE49-F238E27FC236}">
-                <a16:creationId xmlns:a16="http://schemas.microsoft.com/office/drawing/2014/main" id="{06B1439F-4A20-4C65-B7EF-62A1928ADB15}"/>
+                <a16:creationId xmlns:a16="http://schemas.microsoft.com/office/drawing/2014/main" id="{13A4842F-6249-4B19-B8F0-2F094707DA6D}"/>
               </a:ext>
             </a:extLst>
           </p:cNvPr>
@@ -23966,7 +24001,7 @@
           <p:cNvPr id="19" name="">
             <a:extLst xmlns:a="http://schemas.openxmlformats.org/drawingml/2006/main">
               <a:ext uri="{FF2B5EF4-FFF2-40B4-BE49-F238E27FC236}">
-                <a16:creationId xmlns:a16="http://schemas.microsoft.com/office/drawing/2014/main" id="{8BCB8CF4-795F-4A40-8D54-4BA116571A1D}"/>
+                <a16:creationId xmlns:a16="http://schemas.microsoft.com/office/drawing/2014/main" id="{6E6D1012-2B6B-408D-A1CD-575DA157688D}"/>
               </a:ext>
             </a:extLst>
           </p:cNvPr>
@@ -24028,7 +24063,7 @@
           <p:cNvPr id="20" name="">
             <a:extLst xmlns:a="http://schemas.openxmlformats.org/drawingml/2006/main">
               <a:ext uri="{FF2B5EF4-FFF2-40B4-BE49-F238E27FC236}">
-                <a16:creationId xmlns:a16="http://schemas.microsoft.com/office/drawing/2014/main" id="{192986F3-464E-422D-AC0F-C69BC9718148}"/>
+                <a16:creationId xmlns:a16="http://schemas.microsoft.com/office/drawing/2014/main" id="{7346906A-8349-4FE8-B87D-2715DEBA3FCB}"/>
               </a:ext>
             </a:extLst>
           </p:cNvPr>
@@ -24090,7 +24125,7 @@
           <p:cNvPr id="21" name="">
             <a:extLst xmlns:a="http://schemas.openxmlformats.org/drawingml/2006/main">
               <a:ext uri="{FF2B5EF4-FFF2-40B4-BE49-F238E27FC236}">
-                <a16:creationId xmlns:a16="http://schemas.microsoft.com/office/drawing/2014/main" id="{363550FD-F982-4C21-81DF-51C45B4C3A10}"/>
+                <a16:creationId xmlns:a16="http://schemas.microsoft.com/office/drawing/2014/main" id="{D4EBC4BE-9C32-4963-BB5A-4724EF47DF60}"/>
               </a:ext>
             </a:extLst>
           </p:cNvPr>
@@ -24152,7 +24187,7 @@
           <p:cNvPr id="22" name="footer-rule-9">
             <a:extLst xmlns:a="http://schemas.openxmlformats.org/drawingml/2006/main">
               <a:ext uri="{FF2B5EF4-FFF2-40B4-BE49-F238E27FC236}">
-                <a16:creationId xmlns:a16="http://schemas.microsoft.com/office/drawing/2014/main" id="{DF07D955-E616-4E4E-BE94-C43D356B691C}"/>
+                <a16:creationId xmlns:a16="http://schemas.microsoft.com/office/drawing/2014/main" id="{79EE0F16-B2F7-41CD-AB5C-E3B1CD9EFFEE}"/>
               </a:ext>
             </a:extLst>
           </p:cNvPr>
@@ -24183,7 +24218,7 @@
           <p:cNvPr id="23" name="footer-label-9">
             <a:extLst xmlns:a="http://schemas.openxmlformats.org/drawingml/2006/main">
               <a:ext uri="{FF2B5EF4-FFF2-40B4-BE49-F238E27FC236}">
-                <a16:creationId xmlns:a16="http://schemas.microsoft.com/office/drawing/2014/main" id="{C87C135E-8AE2-4733-8A83-9BD7DA93A4D7}"/>
+                <a16:creationId xmlns:a16="http://schemas.microsoft.com/office/drawing/2014/main" id="{98FE90D6-43C8-4D20-BCAD-5A0480C437C6}"/>
               </a:ext>
             </a:extLst>
           </p:cNvPr>
@@ -24245,7 +24280,7 @@
           <p:cNvPr id="24" name="footer-page-9">
             <a:extLst xmlns:a="http://schemas.openxmlformats.org/drawingml/2006/main">
               <a:ext uri="{FF2B5EF4-FFF2-40B4-BE49-F238E27FC236}">
-                <a16:creationId xmlns:a16="http://schemas.microsoft.com/office/drawing/2014/main" id="{2911B33D-5151-43B3-A18A-842E2D4A70B0}"/>
+                <a16:creationId xmlns:a16="http://schemas.microsoft.com/office/drawing/2014/main" id="{6C24F219-6E3C-464A-A6BB-A439357FAE25}"/>
               </a:ext>
             </a:extLst>
           </p:cNvPr>
@@ -24305,7 +24340,7 @@
     </p:spTree>
     <p:extLst>
       <p:ext uri="{BB962C8B-B14F-4D97-AF65-F5344CB8AC3E}">
-        <p14:creationId xmlns:p14="http://schemas.microsoft.com/office/powerpoint/2010/main" val="1561813498"/>
+        <p14:creationId xmlns:p14="http://schemas.microsoft.com/office/powerpoint/2010/main" val="1342875843"/>
       </p:ext>
     </p:extLst>
   </p:cSld>

</xml_diff>

<commit_message>
docs: move training demos after presentation
</commit_message>
<xml_diff>
--- a/docs/MSU-EVA-อบรมสายวิชาการ-ฉบับวิทยากร.pptx
+++ b/docs/MSU-EVA-อบรมสายวิชาการ-ฉบับวิทยากร.pptx
@@ -2,30 +2,30 @@
 <file path=ppt/presentation.xml><?xml version="1.0" encoding="utf-8"?>
 <p:presentation xmlns:p="http://schemas.openxmlformats.org/presentationml/2006/main">
   <p:sldMasterIdLst>
-    <p:sldMasterId xmlns:r="http://schemas.openxmlformats.org/officeDocument/2006/relationships" id="2147483648" r:id="Ra04a4c173d3a4f10"/>
+    <p:sldMasterId xmlns:r="http://schemas.openxmlformats.org/officeDocument/2006/relationships" id="2147483648" r:id="R35f91effc18d4f70"/>
   </p:sldMasterIdLst>
   <p:notesMasterIdLst>
-    <p:notesMasterId xmlns:r="http://schemas.openxmlformats.org/officeDocument/2006/relationships" r:id="Rc7ee0a15df244a36"/>
+    <p:notesMasterId xmlns:r="http://schemas.openxmlformats.org/officeDocument/2006/relationships" r:id="Rc99ea6f0941d4264"/>
   </p:notesMasterIdLst>
   <p:sldIdLst>
-    <p:sldId xmlns:r="http://schemas.openxmlformats.org/officeDocument/2006/relationships" id="256" r:id="R4da5979d9f0440fc"/>
-    <p:sldId xmlns:r="http://schemas.openxmlformats.org/officeDocument/2006/relationships" id="257" r:id="R30881cb8185b4929"/>
-    <p:sldId xmlns:r="http://schemas.openxmlformats.org/officeDocument/2006/relationships" id="258" r:id="R4fd327abd4544ba2"/>
-    <p:sldId xmlns:r="http://schemas.openxmlformats.org/officeDocument/2006/relationships" id="259" r:id="Re9c49037aadc4d2a"/>
-    <p:sldId xmlns:r="http://schemas.openxmlformats.org/officeDocument/2006/relationships" id="260" r:id="R8e53e2150f2a4c7a"/>
-    <p:sldId xmlns:r="http://schemas.openxmlformats.org/officeDocument/2006/relationships" id="261" r:id="Rae64c44533554ec6"/>
-    <p:sldId xmlns:r="http://schemas.openxmlformats.org/officeDocument/2006/relationships" id="262" r:id="Ra98b16d9928640ea"/>
-    <p:sldId xmlns:r="http://schemas.openxmlformats.org/officeDocument/2006/relationships" id="263" r:id="Rc3a6d4731fbf4489"/>
-    <p:sldId xmlns:r="http://schemas.openxmlformats.org/officeDocument/2006/relationships" id="264" r:id="R4a14473e47114145"/>
-    <p:sldId xmlns:r="http://schemas.openxmlformats.org/officeDocument/2006/relationships" id="265" r:id="Ra3c8c505ede243c7"/>
-    <p:sldId xmlns:r="http://schemas.openxmlformats.org/officeDocument/2006/relationships" id="266" r:id="Rc4f6dcf0ad594beb"/>
-    <p:sldId xmlns:r="http://schemas.openxmlformats.org/officeDocument/2006/relationships" id="267" r:id="R2354fe53ca8e4e1d"/>
-    <p:sldId xmlns:r="http://schemas.openxmlformats.org/officeDocument/2006/relationships" id="268" r:id="Rf6e76c7d8ed64970"/>
-    <p:sldId xmlns:r="http://schemas.openxmlformats.org/officeDocument/2006/relationships" id="269" r:id="R7c3444840e65419d"/>
-    <p:sldId xmlns:r="http://schemas.openxmlformats.org/officeDocument/2006/relationships" id="270" r:id="Rf6c1f84c565d4344"/>
-    <p:sldId xmlns:r="http://schemas.openxmlformats.org/officeDocument/2006/relationships" id="271" r:id="R414211a9be644962"/>
-    <p:sldId xmlns:r="http://schemas.openxmlformats.org/officeDocument/2006/relationships" id="272" r:id="Re50a27d8c1f74930"/>
-    <p:sldId xmlns:r="http://schemas.openxmlformats.org/officeDocument/2006/relationships" id="273" r:id="Rd24a60f8c07a4aef"/>
+    <p:sldId xmlns:r="http://schemas.openxmlformats.org/officeDocument/2006/relationships" id="256" r:id="R4a8c07ac9f984cb8"/>
+    <p:sldId xmlns:r="http://schemas.openxmlformats.org/officeDocument/2006/relationships" id="257" r:id="R391983b9ef2b4e75"/>
+    <p:sldId xmlns:r="http://schemas.openxmlformats.org/officeDocument/2006/relationships" id="258" r:id="R8afcdcd27c744aa8"/>
+    <p:sldId xmlns:r="http://schemas.openxmlformats.org/officeDocument/2006/relationships" id="259" r:id="R9702882e7e5f4558"/>
+    <p:sldId xmlns:r="http://schemas.openxmlformats.org/officeDocument/2006/relationships" id="260" r:id="R0a1f5aaf97f24d08"/>
+    <p:sldId xmlns:r="http://schemas.openxmlformats.org/officeDocument/2006/relationships" id="261" r:id="R8a743b8740e34c86"/>
+    <p:sldId xmlns:r="http://schemas.openxmlformats.org/officeDocument/2006/relationships" id="262" r:id="R26129a33df784596"/>
+    <p:sldId xmlns:r="http://schemas.openxmlformats.org/officeDocument/2006/relationships" id="263" r:id="Re44fffe7c81c4644"/>
+    <p:sldId xmlns:r="http://schemas.openxmlformats.org/officeDocument/2006/relationships" id="264" r:id="R134bb089b6254071"/>
+    <p:sldId xmlns:r="http://schemas.openxmlformats.org/officeDocument/2006/relationships" id="265" r:id="Rc3c9a7783c914049"/>
+    <p:sldId xmlns:r="http://schemas.openxmlformats.org/officeDocument/2006/relationships" id="266" r:id="Rb7c23baa118e4c3b"/>
+    <p:sldId xmlns:r="http://schemas.openxmlformats.org/officeDocument/2006/relationships" id="267" r:id="Rf9d6b96246fe4941"/>
+    <p:sldId xmlns:r="http://schemas.openxmlformats.org/officeDocument/2006/relationships" id="268" r:id="R0fbcaf35c4c14903"/>
+    <p:sldId xmlns:r="http://schemas.openxmlformats.org/officeDocument/2006/relationships" id="269" r:id="Rc906777dbc6c4f8d"/>
+    <p:sldId xmlns:r="http://schemas.openxmlformats.org/officeDocument/2006/relationships" id="270" r:id="R6b3c5f8449eb43d4"/>
+    <p:sldId xmlns:r="http://schemas.openxmlformats.org/officeDocument/2006/relationships" id="271" r:id="Ra3a04178a20448d0"/>
+    <p:sldId xmlns:r="http://schemas.openxmlformats.org/officeDocument/2006/relationships" id="272" r:id="R76864a6c612d46ec"/>
+    <p:sldId xmlns:r="http://schemas.openxmlformats.org/officeDocument/2006/relationships" id="273" r:id="R04c3372932944ff7"/>
   </p:sldIdLst>
   <p:sldSz cx="12192000" cy="6858000"/>
   <p:notesSz cx="6858000" cy="9144000"/>
@@ -659,22 +659,7 @@
           <a:lstStyle xmlns:a="http://schemas.openxmlformats.org/drawingml/2006/main"/>
           <a:p xmlns:a="http://schemas.openxmlformats.org/drawingml/2006/main">
             <a:r>
-              <a:t>[พูด] ตรงนี้ขอเน้นนิดหนึ่งครับ หลักฐานที่แนบไม่ได้วัดแค่ว่ามีหรือไม่มี แต่ต้องเปิดได้ ตรงกับรายการ และรู้ว่าเป็นเอกสารอะไร ทางที่ดีให้ทดลองเปิดลิงก์ในหน้าต่างที่ไม่ได้ใช้บัญชีเจ้าของเอกสาร จะได้เห็นเหมือนที่ผู้ประเมินเห็น เดี๋ยวผมทำให้ดูก่อนครับ ทุกท่านยังไม่ต้องทำตาม ให้สังเกตตั้งแต่การกรอกผลงาน การแนบลิงก์ ไปจนถึงการทดลองเปิดหลักฐานครับ</a:t>
-            </a:r>
-          </a:p>
-          <a:p xmlns:a="http://schemas.openxmlformats.org/drawingml/2006/main">
-            <a:r>
-              <a:t>[เปลี่ยนไปสาธิตระบบ] ต่อไปผมจะเปิดระบบตามหัวข้อนี้ให้ดูครับ ทุกท่านยังไม่ต้องกดตาม ให้สังเกตขั้นตอนบนหน้าจอก่อน</a:t>
-            </a:r>
-          </a:p>
-          <a:p xmlns:a="http://schemas.openxmlformats.org/drawingml/2006/main">
-            <a:r>
-              <a:t>[สาธิต] กรอกผลงานหนึ่งรายการ แนบลิงก์หลักฐาน และทดลองเปิดลิงก์จากมุมมองผู้ประเมิน</a:t>
-            </a:r>
-          </a:p>
-          <a:p xmlns:a="http://schemas.openxmlformats.org/drawingml/2006/main">
-            <a:r>
-              <a:t>[กลับมานำเสนอ] เมื่อเห็นวิธีแนบและเปิดหลักฐานแล้ว ต่อไปเรามาแยกบันทึกร่างกับส่งแบบประเมินให้ชัดครับ</a:t>
+              <a:t>[พูด] ตรงนี้ขอเน้นนิดหนึ่งครับ หลักฐานที่แนบไม่ได้วัดแค่ว่ามีหรือไม่มี แต่ต้องเปิดได้ ตรงกับรายการ และรู้ว่าเป็นเอกสารอะไร ทางที่ดีให้ทดลองเปิดลิงก์ในหน้าต่างที่ไม่ได้ใช้บัญชีเจ้าของเอกสาร จะได้เห็นเหมือนที่ผู้ประเมินเห็น หลักฐานควรผ่านการตรวจทั้งการเปิดลิงก์และความตรงกับรายการครับ</a:t>
             </a:r>
           </a:p>
           <a:p xmlns:a="http://schemas.openxmlformats.org/drawingml/2006/main">
@@ -869,7 +854,7 @@
           <a:lstStyle xmlns:a="http://schemas.openxmlformats.org/drawingml/2006/main"/>
           <a:p xmlns:a="http://schemas.openxmlformats.org/drawingml/2006/main">
             <a:r>
-              <a:t>[พูด] ใช่ครับ หลังจากกดส่ง งานไม่ได้หายไปและไม่ได้ไปถึงทุกคนพร้อมกัน ระบบจะส่งให้ผู้ประเมินตามลำดับที่ Admin กำหนดไว้ ผู้ประเมินคนปัจจุบันจะเห็นงานและดำเนินการได้ ส่วนคนถัดไปต้องรอการส่งต่อก่อน จำนวนผู้ประเมินอาจต่างกันในแต่ละงานนะครับ เพราะฉะนั้นเวลาอยากรู้ว่างานอยู่ที่ใคร ให้ดูสถานะและลำดับของรายการนั้นเป็นหลัก ต่อไปผมจะสลับไปดูมุมของผู้ประเมินครับ</a:t>
+              <a:t>[พูด] ใช่ครับ หลังจากกดส่ง งานไม่ได้หายไปและไม่ได้ไปถึงทุกคนพร้อมกัน ระบบจะส่งให้ผู้ประเมินตามลำดับที่ Admin กำหนดไว้ ผู้ประเมินคนปัจจุบันจะเห็นงานและดำเนินการได้ ส่วนคนถัดไปต้องรอการส่งต่อก่อน จำนวนผู้ประเมินอาจต่างกันในแต่ละงานนะครับ เพราะฉะนั้นเวลาอยากรู้ว่างานอยู่ที่ใคร ให้ดูสถานะและลำดับของรายการนั้นเป็นหลัก ต่อไปเรามาดูมุมของผู้ประเมินครับ</a:t>
             </a:r>
           </a:p>
           <a:p xmlns:a="http://schemas.openxmlformats.org/drawingml/2006/main">
@@ -964,22 +949,7 @@
           <a:lstStyle xmlns:a="http://schemas.openxmlformats.org/drawingml/2006/main"/>
           <a:p xmlns:a="http://schemas.openxmlformats.org/drawingml/2006/main">
             <a:r>
-              <a:t>[พูด] ตอนนี้เรามองจากฝั่งผู้ประเมินนะครับ เมื่อได้รับงาน สิ่งแรกที่ควรทำคืออ่านข้อมูลให้ตรงกับเกณฑ์ ตรวจคะแนน และเปิดหลักฐานจริงก่อนให้ผล ถ้าข้อมูลไม่ครบ ให้ใช้ตัวเลือกที่ระบบเปิดให้ตามสิทธิ์ ไม่ควรเดาจากชื่อรายการอย่างเดียว เดี๋ยวผมสาธิตให้ดูครับ ให้สังเกตว่าข้อมูลส่วนใดมาจากผู้รับการประเมิน และส่วนใดเป็นการตัดสินใจของผู้ประเมิน</a:t>
-            </a:r>
-          </a:p>
-          <a:p xmlns:a="http://schemas.openxmlformats.org/drawingml/2006/main">
-            <a:r>
-              <a:t>[เปลี่ยนไปสาธิตระบบ] ต่อไปผมจะเปิดระบบตามหัวข้อนี้ให้ดูครับ ทุกท่านยังไม่ต้องกดตาม ให้สังเกตขั้นตอนบนหน้าจอก่อน</a:t>
-            </a:r>
-          </a:p>
-          <a:p xmlns:a="http://schemas.openxmlformats.org/drawingml/2006/main">
-            <a:r>
-              <a:t>[สาธิต] เปิดรายการในบัญชีผู้ประเมิน ตรวจข้อมูล คะแนน และหลักฐาน แล้วบันทึกผลการประเมิน</a:t>
-            </a:r>
-          </a:p>
-          <a:p xmlns:a="http://schemas.openxmlformats.org/drawingml/2006/main">
-            <a:r>
-              <a:t>[กลับมานำเสนอ] เมื่อเห็นมุมของผู้ประเมินแล้ว ต่อไปเรามาดูการส่งต่องานไปยังผู้ประเมินคนถัดไปครับ</a:t>
+              <a:t>[พูด] ตอนนี้เรามองจากฝั่งผู้ประเมินนะครับ เมื่อได้รับงาน สิ่งแรกที่ควรทำคืออ่านข้อมูลให้ตรงกับเกณฑ์ ตรวจคะแนน และเปิดหลักฐานจริงก่อนให้ผล ถ้าข้อมูลไม่ครบ ให้ใช้ตัวเลือกที่ระบบเปิดให้ตามสิทธิ์ ไม่ควรเดาจากชื่อรายการอย่างเดียว เมื่อผู้ประเมินได้รับงาน ควรแยกให้ชัดว่าข้อมูลใดมาจากผู้รับการประเมิน และส่วนใดเป็นการตัดสินใจของผู้ประเมินครับ</a:t>
             </a:r>
           </a:p>
           <a:p xmlns:a="http://schemas.openxmlformats.org/drawingml/2006/main">
@@ -1079,22 +1049,7 @@
           <a:lstStyle xmlns:a="http://schemas.openxmlformats.org/drawingml/2006/main"/>
           <a:p xmlns:a="http://schemas.openxmlformats.org/drawingml/2006/main">
             <a:r>
-              <a:t>[พูด] เมื่อผู้ประเมินคนหนึ่งตรวจเสร็จ งานยังไม่ถือว่าปิดนะครับ ต้องส่งต่อไปยังคนถัดไปตามลำดับ ผู้ประเมินคนถัดไปจึงจะรับงานและเห็นข้อมูลที่เกี่ยวข้อง ตรงนี้สำคัญครับ เพราะแต่ละงานอาจมีจำนวนขั้นไม่เท่ากัน เดี๋ยวผมส่งต่องานหนึ่งขั้นให้ดู แล้วเปิดบัญชีของผู้ประเมินคนถัดไป เพื่อให้เห็นการเปลี่ยนสถานะจริงครับ</a:t>
-            </a:r>
-          </a:p>
-          <a:p xmlns:a="http://schemas.openxmlformats.org/drawingml/2006/main">
-            <a:r>
-              <a:t>[เปลี่ยนไปสาธิตระบบ] ต่อไปผมจะเปิดระบบตามหัวข้อนี้ให้ดูครับ ทุกท่านยังไม่ต้องกดตาม ให้สังเกตขั้นตอนบนหน้าจอก่อน</a:t>
-            </a:r>
-          </a:p>
-          <a:p xmlns:a="http://schemas.openxmlformats.org/drawingml/2006/main">
-            <a:r>
-              <a:t>[สาธิต] ส่งต่องานหนึ่งขั้น แล้วสลับไปยังบัญชีผู้ประเมินลำดับถัดไปเพื่อตรวจสถานะ</a:t>
-            </a:r>
-          </a:p>
-          <a:p xmlns:a="http://schemas.openxmlformats.org/drawingml/2006/main">
-            <a:r>
-              <a:t>[กลับมานำเสนอ] เมื่อเห็นการส่งต่องานแล้ว ต่อไปเรามาดูว่าผู้ประเมินคนสุดท้ายปิดงานอย่างไรครับ</a:t>
+              <a:t>[พูด] เมื่อผู้ประเมินคนหนึ่งตรวจเสร็จ งานยังไม่ถือว่าปิดนะครับ ต้องส่งต่อไปยังคนถัดไปตามลำดับ ผู้ประเมินคนถัดไปจึงจะรับงานและเห็นข้อมูลที่เกี่ยวข้อง ตรงนี้สำคัญครับ เพราะแต่ละงานอาจมีจำนวนขั้นไม่เท่ากัน เมื่อส่งต่องาน สถานะและผู้รับผิดชอบจะเปลี่ยนไปตามลำดับที่กำหนดครับ</a:t>
             </a:r>
           </a:p>
           <a:p xmlns:a="http://schemas.openxmlformats.org/drawingml/2006/main">
@@ -1189,27 +1144,72 @@
           <a:lstStyle xmlns:a="http://schemas.openxmlformats.org/drawingml/2006/main"/>
           <a:p xmlns:a="http://schemas.openxmlformats.org/drawingml/2006/main">
             <a:r>
-              <a:t>[พูด] ทีนี้มาถึงขั้นสุดท้ายครับ เมื่อผู้ประเมินคนสุดท้ายยืนยัน ระบบจึงเปลี่ยนสถานะเป็นประเมินเสร็จสิ้น หรือ Completed คำว่า “คนสุดท้าย” ให้ดูจากลำดับของงานจริงนะครับ ไม่ได้หมายความว่าต้องเป็นผู้บริหารเสมอไป เดี๋ยวผมยืนยันขั้นสุดท้ายให้ดู แล้วเราจะกลับมาที่สไลด์เพื่อทบทวนว่าจุดสังเกตมีอะไรบ้างครับ</a:t>
-            </a:r>
-          </a:p>
-          <a:p xmlns:a="http://schemas.openxmlformats.org/drawingml/2006/main">
-            <a:r>
-              <a:t>[เปลี่ยนไปสาธิตระบบ] ต่อไปผมจะเปิดระบบตามหัวข้อนี้ให้ดูครับ ทุกท่านยังไม่ต้องกดตาม ให้สังเกตขั้นตอนบนหน้าจอก่อน</a:t>
-            </a:r>
-          </a:p>
-          <a:p xmlns:a="http://schemas.openxmlformats.org/drawingml/2006/main">
-            <a:r>
-              <a:t>[สาธิต] เปิดบัญชีผู้ประเมินคนสุดท้าย ยืนยันผล และแสดงสถานะ Completed</a:t>
-            </a:r>
-          </a:p>
-          <a:p xmlns:a="http://schemas.openxmlformats.org/drawingml/2006/main">
-            <a:r>
-              <a:t>[กลับมานำเสนอ] เมื่อเห็นสถานะ Completed แล้ว ต่อไปจะเป็นช่วงที่ทุกท่านได้ทดลองใช้งานครับ</a:t>
-            </a:r>
-          </a:p>
-          <a:p xmlns:a="http://schemas.openxmlformats.org/drawingml/2006/main">
-            <a:r>
-              <a:t> ชี้ให้เห็นว่างานปิดเมื่อผู้ประเมินคนสุดท้ายในลำดับยืนยันแล้ว</a:t>
+              <a:t>[พูด] ทีนี้มาถึงขั้นสุดท้ายครับ เมื่อผู้ประเมินคนสุดท้ายยืนยัน ระบบจึงเปลี่ยนสถานะเป็นประเมินเสร็จสิ้น หรือ Completed คำว่า “คนสุดท้าย” ให้ดูจากลำดับของงานจริงนะครับ ไม่ได้หมายความว่าต้องเป็นผู้บริหารเสมอไป จากภาพรวมนี้ งานจะปิดเมื่อผู้ประเมินลำดับสุดท้ายยืนยันผลครับ</a:t>
+            </a:r>
+          </a:p>
+          <a:p xmlns:a="http://schemas.openxmlformats.org/drawingml/2006/main">
+            <a:r>
+              <a:t>[เริ่มสาธิตระบบ] ต่อไปผมจะสาธิตขั้นตอนทั้งหมดบนระบบให้ดู ตั้งแต่เริ่มต้นจนงานเสร็จครับ ทุกท่านยังไม่ต้องกดตาม ให้สังเกตลำดับการทำงานก่อน</a:t>
+            </a:r>
+          </a:p>
+          <a:p xmlns:a="http://schemas.openxmlformats.org/drawingml/2006/main">
+            <a:r>
+              <a:t>[สาธิตต่อเนื่อง]</a:t>
+            </a:r>
+          </a:p>
+          <a:p xmlns:a="http://schemas.openxmlformats.org/drawingml/2006/main">
+            <a:r>
+              <a:t>1. เปิดแดชบอร์ดและรายการที่ได้รับมอบหมาย</a:t>
+            </a:r>
+          </a:p>
+          <a:p xmlns:a="http://schemas.openxmlformats.org/drawingml/2006/main">
+            <a:r>
+              <a:t>2. กรอกภาระงานและผลงาน</a:t>
+            </a:r>
+          </a:p>
+          <a:p xmlns:a="http://schemas.openxmlformats.org/drawingml/2006/main">
+            <a:r>
+              <a:t>3. ตรวจคะแนนที่ระบบคำนวณ</a:t>
+            </a:r>
+          </a:p>
+          <a:p xmlns:a="http://schemas.openxmlformats.org/drawingml/2006/main">
+            <a:r>
+              <a:t>4. แนบและเปิดหลักฐาน</a:t>
+            </a:r>
+          </a:p>
+          <a:p xmlns:a="http://schemas.openxmlformats.org/drawingml/2006/main">
+            <a:r>
+              <a:t>5. บันทึกร่าง</a:t>
+            </a:r>
+          </a:p>
+          <a:p xmlns:a="http://schemas.openxmlformats.org/drawingml/2006/main">
+            <a:r>
+              <a:t>6. ตรวจความพร้อมและส่งแบบประเมิน</a:t>
+            </a:r>
+          </a:p>
+          <a:p xmlns:a="http://schemas.openxmlformats.org/drawingml/2006/main">
+            <a:r>
+              <a:t>7. เปิดมุมผู้ประเมิน</a:t>
+            </a:r>
+          </a:p>
+          <a:p xmlns:a="http://schemas.openxmlformats.org/drawingml/2006/main">
+            <a:r>
+              <a:t>8. ตรวจข้อมูล ให้ผล และส่งต่อ</a:t>
+            </a:r>
+          </a:p>
+          <a:p xmlns:a="http://schemas.openxmlformats.org/drawingml/2006/main">
+            <a:r>
+              <a:t>9. เปิดบัญชีผู้ประเมินลำดับสุดท้าย</a:t>
+            </a:r>
+          </a:p>
+          <a:p xmlns:a="http://schemas.openxmlformats.org/drawingml/2006/main">
+            <a:r>
+              <a:t>10. ยืนยันผลจนสถานะเป็น ประเมินเสร็จสิ้น (Completed)</a:t>
+            </a:r>
+          </a:p>
+          <a:p xmlns:a="http://schemas.openxmlformats.org/drawingml/2006/main">
+            <a:r>
+              <a:t>[กลับมานำเสนอ] เมื่อเห็นขั้นตอนทั้งหมดแล้ว ต่อไปทุกท่านจะได้ทดลองทำด้วยบัญชีที่เตรียมไว้ครับ</a:t>
             </a:r>
           </a:p>
           <a:p xmlns:a="http://schemas.openxmlformats.org/drawingml/2006/main">
@@ -1919,12 +1919,7 @@
           <a:lstStyle xmlns:a="http://schemas.openxmlformats.org/drawingml/2006/main"/>
           <a:p xmlns:a="http://schemas.openxmlformats.org/drawingml/2006/main">
             <a:r>
-              <a:t>[พูด] ในขั้นแรก ผู้รับการประเมินต้องกรอกข้อมูลและแนบหลักฐานให้ครบครับ ถ้ายังไม่ครบ ให้บันทึกร่างไว้ก่อน ยังไม่ต้องส่งแบบประเมิน ผู้ประเมินจะตัดสินใจจากสิ่งที่เราเตรียมไว้ ถ้าข้อมูลชัดและหลักฐานเปิดได้ งานก็เดินต่อได้ง่าย ตรงนี้เข้าใจตรงกันแล้ว เดี๋ยวผมพาไปดูจุดเริ่มต้นบนหน้าจอจริงครับ</a:t>
-            </a:r>
-          </a:p>
-          <a:p xmlns:a="http://schemas.openxmlformats.org/drawingml/2006/main">
-            <a:r>
-              <a:t>[เตรียมสาธิต] ตั้งแต่สไลด์ถัดไป ผมจะเปิดระบบให้ดูเป็นช่วง ๆ ครับ ทุกท่านยังไม่ต้องกดตาม จนกว่าจะถึงช่วงทดลองใช้งาน</a:t>
+              <a:t>[พูด] ในขั้นแรก ผู้รับการประเมินต้องกรอกข้อมูลและแนบหลักฐานให้ครบครับ ถ้ายังไม่ครบ ให้บันทึกร่างไว้ก่อน ยังไม่ต้องส่งแบบประเมิน ผู้ประเมินจะตัดสินใจจากสิ่งที่เราเตรียมไว้ ถ้าข้อมูลชัดและหลักฐานเปิดได้ งานก็เดินต่อได้ง่าย เมื่อเข้าใจหน้าที่นี้แล้ว ต่อไปเรามาดูจุดเริ่มต้นบนแดชบอร์ดครับ</a:t>
             </a:r>
           </a:p>
           <a:p xmlns:a="http://schemas.openxmlformats.org/drawingml/2006/main">
@@ -2019,22 +2014,7 @@
           <a:lstStyle xmlns:a="http://schemas.openxmlformats.org/drawingml/2006/main"/>
           <a:p xmlns:a="http://schemas.openxmlformats.org/drawingml/2006/main">
             <a:r>
-              <a:t>[พูด] ต่อไปขอพาทุกท่านมาที่แดชบอร์ดของฉันครับ ก่อนเปิดงานให้ตรวจสามอย่าง คือรอบประเมินที่ผู้ดูแลระบบกำหนด รายการที่ได้รับมอบหมาย และสถานะปัจจุบัน ผู้ใช้งานไม่ต้องเลือกรอบเองนะครับ ถ้ารอบหรือรายการไม่ถูกต้องให้แจ้งผู้ดูแลระบบก่อน เดี๋ยวผมเปิดให้ดูก่อนครับ ทุกท่านยังไม่ต้องกดตาม ให้สังเกตตำแหน่งชื่อรอบ ชื่อรายการ และปุ่มเปิดงานครับ</a:t>
-            </a:r>
-          </a:p>
-          <a:p xmlns:a="http://schemas.openxmlformats.org/drawingml/2006/main">
-            <a:r>
-              <a:t>[เปลี่ยนไปสาธิตระบบ] ต่อไปผมจะเปิดระบบตามหัวข้อนี้ให้ดูครับ ทุกท่านยังไม่ต้องกดตาม ให้สังเกตขั้นตอนบนหน้าจอก่อน</a:t>
-            </a:r>
-          </a:p>
-          <a:p xmlns:a="http://schemas.openxmlformats.org/drawingml/2006/main">
-            <a:r>
-              <a:t>[สาธิต] เปิดแดชบอร์ด ตรวจสอบรอบประเมินที่ได้รับมอบหมาย แล้วเปิดรายการสายวิชาการที่เตรียมไว้</a:t>
-            </a:r>
-          </a:p>
-          <a:p xmlns:a="http://schemas.openxmlformats.org/drawingml/2006/main">
-            <a:r>
-              <a:t>[กลับมานำเสนอ] เมื่อเห็นจุดเริ่มต้นบนระบบแล้ว ต่อไปเรามาดูว่าข้อมูลแต่ละส่วนต้องสัมพันธ์กันอย่างไรครับ</a:t>
+              <a:t>[พูด] ต่อไปขอพาทุกท่านมาที่แดชบอร์ดของฉันครับ ก่อนเปิดงานให้ตรวจสามอย่าง คือรอบประเมินที่ผู้ดูแลระบบกำหนด รายการที่ได้รับมอบหมาย และสถานะปัจจุบัน ผู้ใช้งานไม่ต้องเลือกรอบเองนะครับ ถ้ารอบหรือรายการไม่ถูกต้องให้แจ้งผู้ดูแลระบบก่อน บนแดชบอร์ดให้สังเกตตำแหน่งชื่อรอบ ชื่อรายการ และปุ่มเปิดงานครับ</a:t>
             </a:r>
           </a:p>
           <a:p xmlns:a="http://schemas.openxmlformats.org/drawingml/2006/main">
@@ -2307,7 +2287,7 @@
   </p:cSld>
   <p:clrMap bg1="lt1" tx1="dk1" bg2="lt2" tx2="dk2" accent1="accent1" accent2="accent2" accent3="accent3" accent4="accent4" accent5="accent5" accent6="accent6" hlink="hlink" folHlink="folHlink"/>
   <p:sldLayoutIdLst>
-    <p:sldLayoutId xmlns:r="http://schemas.openxmlformats.org/officeDocument/2006/relationships" id="2147483649" r:id="R34d0ed1c50534536"/>
+    <p:sldLayoutId xmlns:r="http://schemas.openxmlformats.org/officeDocument/2006/relationships" id="2147483649" r:id="R88db4b85b20349f2"/>
   </p:sldLayoutIdLst>
   <p:txStyles>
     <p:titleStyle>
@@ -2862,7 +2842,7 @@
           <p:nvPr/>
         </p:nvPicPr>
         <p:blipFill>
-          <a:blip xmlns:r="http://schemas.openxmlformats.org/officeDocument/2006/relationships" xmlns:a="http://schemas.openxmlformats.org/drawingml/2006/main" r:embed="R0c853ac313f94ab8"/>
+          <a:blip xmlns:r="http://schemas.openxmlformats.org/officeDocument/2006/relationships" xmlns:a="http://schemas.openxmlformats.org/drawingml/2006/main" r:embed="Rdd4b60b12ebb428e"/>
           <a:srcRect xmlns:a="http://schemas.openxmlformats.org/drawingml/2006/main" l="2579" t="0" r="2579" b="0"/>
           <a:stretch xmlns:a="http://schemas.openxmlformats.org/drawingml/2006/main">
             <a:fillRect l="0" t="0" r="0" b="0"/>
@@ -2883,7 +2863,7 @@
           <p:cNvPr id="2" name="cover-panel">
             <a:extLst xmlns:a="http://schemas.openxmlformats.org/drawingml/2006/main">
               <a:ext uri="{FF2B5EF4-FFF2-40B4-BE49-F238E27FC236}">
-                <a16:creationId xmlns:a16="http://schemas.microsoft.com/office/drawing/2014/main" id="{1FE4C569-934E-447F-A97F-B924341FDCC0}"/>
+                <a16:creationId xmlns:a16="http://schemas.microsoft.com/office/drawing/2014/main" id="{C4B0946B-6107-469F-B9D5-B9737BFDEAD7}"/>
               </a:ext>
             </a:extLst>
           </p:cNvPr>
@@ -2914,7 +2894,7 @@
           <p:cNvPr id="3" name="cover-accent">
             <a:extLst xmlns:a="http://schemas.openxmlformats.org/drawingml/2006/main">
               <a:ext uri="{FF2B5EF4-FFF2-40B4-BE49-F238E27FC236}">
-                <a16:creationId xmlns:a16="http://schemas.microsoft.com/office/drawing/2014/main" id="{25370A7E-47A8-46DB-99CE-3C1915398347}"/>
+                <a16:creationId xmlns:a16="http://schemas.microsoft.com/office/drawing/2014/main" id="{C69941B3-44A2-4355-BA98-CA539C172E05}"/>
               </a:ext>
             </a:extLst>
           </p:cNvPr>
@@ -2949,7 +2929,7 @@
           <p:nvPr/>
         </p:nvPicPr>
         <p:blipFill>
-          <a:blip xmlns:r="http://schemas.openxmlformats.org/officeDocument/2006/relationships" xmlns:a="http://schemas.openxmlformats.org/drawingml/2006/main" r:embed="Rcd43ed0132624e19"/>
+          <a:blip xmlns:r="http://schemas.openxmlformats.org/officeDocument/2006/relationships" xmlns:a="http://schemas.openxmlformats.org/drawingml/2006/main" r:embed="R407a9fb1dff74a7a"/>
           <a:stretch xmlns:a="http://schemas.openxmlformats.org/drawingml/2006/main"/>
         </p:blipFill>
         <p:spPr>
@@ -2967,7 +2947,7 @@
           <p:cNvPr id="5" name="cover-institution">
             <a:extLst xmlns:a="http://schemas.openxmlformats.org/drawingml/2006/main">
               <a:ext uri="{FF2B5EF4-FFF2-40B4-BE49-F238E27FC236}">
-                <a16:creationId xmlns:a16="http://schemas.microsoft.com/office/drawing/2014/main" id="{308854BB-39D6-418C-9492-A0B63ABD75CE}"/>
+                <a16:creationId xmlns:a16="http://schemas.microsoft.com/office/drawing/2014/main" id="{BDFE09EA-C2F7-4549-8191-0F2A63B1E17C}"/>
               </a:ext>
             </a:extLst>
           </p:cNvPr>
@@ -3029,7 +3009,7 @@
           <p:cNvPr id="6" name="cover-session">
             <a:extLst xmlns:a="http://schemas.openxmlformats.org/drawingml/2006/main">
               <a:ext uri="{FF2B5EF4-FFF2-40B4-BE49-F238E27FC236}">
-                <a16:creationId xmlns:a16="http://schemas.microsoft.com/office/drawing/2014/main" id="{D43ADFC5-7E2C-4CBC-8AEF-64F80C4C6733}"/>
+                <a16:creationId xmlns:a16="http://schemas.microsoft.com/office/drawing/2014/main" id="{C523DD44-F312-4A39-8F38-11AF213D2310}"/>
               </a:ext>
             </a:extLst>
           </p:cNvPr>
@@ -3091,7 +3071,7 @@
           <p:cNvPr id="7" name="cover-title">
             <a:extLst xmlns:a="http://schemas.openxmlformats.org/drawingml/2006/main">
               <a:ext uri="{FF2B5EF4-FFF2-40B4-BE49-F238E27FC236}">
-                <a16:creationId xmlns:a16="http://schemas.microsoft.com/office/drawing/2014/main" id="{5368E868-B3A3-4C1E-A798-24E02784E6E6}"/>
+                <a16:creationId xmlns:a16="http://schemas.microsoft.com/office/drawing/2014/main" id="{380E5CED-3D5A-4DD7-AA83-CE2095269F58}"/>
               </a:ext>
             </a:extLst>
           </p:cNvPr>
@@ -3153,7 +3133,7 @@
           <p:cNvPr id="8" name="cover-system-short-name">
             <a:extLst xmlns:a="http://schemas.openxmlformats.org/drawingml/2006/main">
               <a:ext uri="{FF2B5EF4-FFF2-40B4-BE49-F238E27FC236}">
-                <a16:creationId xmlns:a16="http://schemas.microsoft.com/office/drawing/2014/main" id="{F1B4D6CC-ADA2-404B-826A-F2E18478A05E}"/>
+                <a16:creationId xmlns:a16="http://schemas.microsoft.com/office/drawing/2014/main" id="{9BE074B6-3789-45FB-AE3E-CA931F0A6145}"/>
               </a:ext>
             </a:extLst>
           </p:cNvPr>
@@ -3215,7 +3195,7 @@
           <p:cNvPr id="9" name="cover-gold-rule">
             <a:extLst xmlns:a="http://schemas.openxmlformats.org/drawingml/2006/main">
               <a:ext uri="{FF2B5EF4-FFF2-40B4-BE49-F238E27FC236}">
-                <a16:creationId xmlns:a16="http://schemas.microsoft.com/office/drawing/2014/main" id="{7F5815A5-F854-4FE3-8BE0-0CC9EDFDEF93}"/>
+                <a16:creationId xmlns:a16="http://schemas.microsoft.com/office/drawing/2014/main" id="{4F427874-3743-4806-929F-DE22DC011ED7}"/>
               </a:ext>
             </a:extLst>
           </p:cNvPr>
@@ -3246,7 +3226,7 @@
           <p:cNvPr id="10" name="cover-promise">
             <a:extLst xmlns:a="http://schemas.openxmlformats.org/drawingml/2006/main">
               <a:ext uri="{FF2B5EF4-FFF2-40B4-BE49-F238E27FC236}">
-                <a16:creationId xmlns:a16="http://schemas.microsoft.com/office/drawing/2014/main" id="{2F4C6382-C650-43BC-9FD8-2A1213152699}"/>
+                <a16:creationId xmlns:a16="http://schemas.microsoft.com/office/drawing/2014/main" id="{ECD510E4-8F15-48FE-B349-4B54024BCD3F}"/>
               </a:ext>
             </a:extLst>
           </p:cNvPr>
@@ -3308,7 +3288,7 @@
           <p:cNvPr id="11" name="cover-style">
             <a:extLst xmlns:a="http://schemas.openxmlformats.org/drawingml/2006/main">
               <a:ext uri="{FF2B5EF4-FFF2-40B4-BE49-F238E27FC236}">
-                <a16:creationId xmlns:a16="http://schemas.microsoft.com/office/drawing/2014/main" id="{EB6EC177-AB61-412F-AFA0-782C4DD0976E}"/>
+                <a16:creationId xmlns:a16="http://schemas.microsoft.com/office/drawing/2014/main" id="{95CBF337-228E-434D-8632-D1B944A39C92}"/>
               </a:ext>
             </a:extLst>
           </p:cNvPr>
@@ -3374,7 +3354,7 @@
           <p:nvPr/>
         </p:nvPicPr>
         <p:blipFill>
-          <a:blip xmlns:r="http://schemas.openxmlformats.org/officeDocument/2006/relationships" xmlns:a="http://schemas.openxmlformats.org/drawingml/2006/main" r:embed="R78f68a5fb3ed495c"/>
+          <a:blip xmlns:r="http://schemas.openxmlformats.org/officeDocument/2006/relationships" xmlns:a="http://schemas.openxmlformats.org/drawingml/2006/main" r:embed="Re8911f8adc144843"/>
           <a:stretch xmlns:a="http://schemas.openxmlformats.org/drawingml/2006/main"/>
         </p:blipFill>
         <p:spPr>
@@ -3390,7 +3370,7 @@
     </p:spTree>
     <p:extLst>
       <p:ext uri="{BB962C8B-B14F-4D97-AF65-F5344CB8AC3E}">
-        <p14:creationId xmlns:p14="http://schemas.microsoft.com/office/powerpoint/2010/main" val="1274820604"/>
+        <p14:creationId xmlns:p14="http://schemas.microsoft.com/office/powerpoint/2010/main" val="2116163541"/>
       </p:ext>
     </p:extLst>
   </p:cSld>
@@ -3421,7 +3401,7 @@
           <p:cNvPr id="21" name="side-accent-10">
             <a:extLst xmlns:a="http://schemas.openxmlformats.org/drawingml/2006/main">
               <a:ext uri="{FF2B5EF4-FFF2-40B4-BE49-F238E27FC236}">
-                <a16:creationId xmlns:a16="http://schemas.microsoft.com/office/drawing/2014/main" id="{29DAD226-491A-44EF-8A4D-CEEDF710DF54}"/>
+                <a16:creationId xmlns:a16="http://schemas.microsoft.com/office/drawing/2014/main" id="{5511CF8E-84FB-494F-A8C3-DB413AE3297F}"/>
               </a:ext>
             </a:extLst>
           </p:cNvPr>
@@ -3452,7 +3432,7 @@
           <p:cNvPr id="2" name="kicker-10">
             <a:extLst xmlns:a="http://schemas.openxmlformats.org/drawingml/2006/main">
               <a:ext uri="{FF2B5EF4-FFF2-40B4-BE49-F238E27FC236}">
-                <a16:creationId xmlns:a16="http://schemas.microsoft.com/office/drawing/2014/main" id="{CD45A5EF-4E62-40E9-832E-877B0D1F0404}"/>
+                <a16:creationId xmlns:a16="http://schemas.microsoft.com/office/drawing/2014/main" id="{6F52CB69-CA90-4CF9-9135-B90F5B056D4C}"/>
               </a:ext>
             </a:extLst>
           </p:cNvPr>
@@ -3514,7 +3494,7 @@
           <p:cNvPr id="3" name="title-10">
             <a:extLst xmlns:a="http://schemas.openxmlformats.org/drawingml/2006/main">
               <a:ext uri="{FF2B5EF4-FFF2-40B4-BE49-F238E27FC236}">
-                <a16:creationId xmlns:a16="http://schemas.microsoft.com/office/drawing/2014/main" id="{E16A3BE8-356C-4F80-9B8F-B5CB8B546AAC}"/>
+                <a16:creationId xmlns:a16="http://schemas.microsoft.com/office/drawing/2014/main" id="{986D3608-D93F-4C19-9B7D-69421AFFF253}"/>
               </a:ext>
             </a:extLst>
           </p:cNvPr>
@@ -3576,7 +3556,7 @@
           <p:cNvPr id="4" name="">
             <a:extLst xmlns:a="http://schemas.openxmlformats.org/drawingml/2006/main">
               <a:ext uri="{FF2B5EF4-FFF2-40B4-BE49-F238E27FC236}">
-                <a16:creationId xmlns:a16="http://schemas.microsoft.com/office/drawing/2014/main" id="{BF442896-1F6B-4D66-B2AE-7F52BC14DF94}"/>
+                <a16:creationId xmlns:a16="http://schemas.microsoft.com/office/drawing/2014/main" id="{5CDD6400-9A25-4B29-9285-B47AA2859579}"/>
               </a:ext>
             </a:extLst>
           </p:cNvPr>
@@ -3638,7 +3618,7 @@
           <p:cNvPr id="5" name="">
             <a:extLst xmlns:a="http://schemas.openxmlformats.org/drawingml/2006/main">
               <a:ext uri="{FF2B5EF4-FFF2-40B4-BE49-F238E27FC236}">
-                <a16:creationId xmlns:a16="http://schemas.microsoft.com/office/drawing/2014/main" id="{EE291DAF-2399-45B9-B200-D841F7C5B4E6}"/>
+                <a16:creationId xmlns:a16="http://schemas.microsoft.com/office/drawing/2014/main" id="{0505CF0D-1487-43AD-8E43-1C47AD90B434}"/>
               </a:ext>
             </a:extLst>
           </p:cNvPr>
@@ -3700,7 +3680,7 @@
           <p:cNvPr id="6" name="">
             <a:extLst xmlns:a="http://schemas.openxmlformats.org/drawingml/2006/main">
               <a:ext uri="{FF2B5EF4-FFF2-40B4-BE49-F238E27FC236}">
-                <a16:creationId xmlns:a16="http://schemas.microsoft.com/office/drawing/2014/main" id="{03C63816-826F-4BB9-947B-C3E9D7F8DF45}"/>
+                <a16:creationId xmlns:a16="http://schemas.microsoft.com/office/drawing/2014/main" id="{CCDB8269-D28A-46AB-ACD6-E7A460D20A0B}"/>
               </a:ext>
             </a:extLst>
           </p:cNvPr>
@@ -3762,7 +3742,7 @@
           <p:cNvPr id="7" name="">
             <a:extLst xmlns:a="http://schemas.openxmlformats.org/drawingml/2006/main">
               <a:ext uri="{FF2B5EF4-FFF2-40B4-BE49-F238E27FC236}">
-                <a16:creationId xmlns:a16="http://schemas.microsoft.com/office/drawing/2014/main" id="{CA68ED3C-099E-453F-8120-46CF25F84287}"/>
+                <a16:creationId xmlns:a16="http://schemas.microsoft.com/office/drawing/2014/main" id="{EFDC43A1-4224-4893-92EC-9F6184AC6D92}"/>
               </a:ext>
             </a:extLst>
           </p:cNvPr>
@@ -3824,7 +3804,7 @@
           <p:cNvPr id="8" name="">
             <a:extLst xmlns:a="http://schemas.openxmlformats.org/drawingml/2006/main">
               <a:ext uri="{FF2B5EF4-FFF2-40B4-BE49-F238E27FC236}">
-                <a16:creationId xmlns:a16="http://schemas.microsoft.com/office/drawing/2014/main" id="{F70553FB-2F07-488C-85FC-5DB9E8E44783}"/>
+                <a16:creationId xmlns:a16="http://schemas.microsoft.com/office/drawing/2014/main" id="{D67033AC-D101-481B-BE28-EB7770645335}"/>
               </a:ext>
             </a:extLst>
           </p:cNvPr>
@@ -3855,7 +3835,7 @@
           <p:cNvPr id="9" name="">
             <a:extLst xmlns:a="http://schemas.openxmlformats.org/drawingml/2006/main">
               <a:ext uri="{FF2B5EF4-FFF2-40B4-BE49-F238E27FC236}">
-                <a16:creationId xmlns:a16="http://schemas.microsoft.com/office/drawing/2014/main" id="{E3C73763-665C-42AA-9EB8-3F481474412D}"/>
+                <a16:creationId xmlns:a16="http://schemas.microsoft.com/office/drawing/2014/main" id="{44011C73-B93C-4EDB-B98B-52D5743306C2}"/>
               </a:ext>
             </a:extLst>
           </p:cNvPr>
@@ -3917,7 +3897,7 @@
           <p:cNvPr id="10" name="">
             <a:extLst xmlns:a="http://schemas.openxmlformats.org/drawingml/2006/main">
               <a:ext uri="{FF2B5EF4-FFF2-40B4-BE49-F238E27FC236}">
-                <a16:creationId xmlns:a16="http://schemas.microsoft.com/office/drawing/2014/main" id="{AB3B6E15-398C-4913-9644-15C5985F0491}"/>
+                <a16:creationId xmlns:a16="http://schemas.microsoft.com/office/drawing/2014/main" id="{E63DBE7F-1AEE-4E11-B2E6-2E3868AD92BA}"/>
               </a:ext>
             </a:extLst>
           </p:cNvPr>
@@ -3979,7 +3959,7 @@
           <p:cNvPr id="11" name="">
             <a:extLst xmlns:a="http://schemas.openxmlformats.org/drawingml/2006/main">
               <a:ext uri="{FF2B5EF4-FFF2-40B4-BE49-F238E27FC236}">
-                <a16:creationId xmlns:a16="http://schemas.microsoft.com/office/drawing/2014/main" id="{32943DA4-C529-4D07-B0CE-537808E9E2BE}"/>
+                <a16:creationId xmlns:a16="http://schemas.microsoft.com/office/drawing/2014/main" id="{C9C93F54-D11A-40AC-AF8B-4491A6E86DD9}"/>
               </a:ext>
             </a:extLst>
           </p:cNvPr>
@@ -4041,7 +4021,7 @@
           <p:cNvPr id="12" name="">
             <a:extLst xmlns:a="http://schemas.openxmlformats.org/drawingml/2006/main">
               <a:ext uri="{FF2B5EF4-FFF2-40B4-BE49-F238E27FC236}">
-                <a16:creationId xmlns:a16="http://schemas.microsoft.com/office/drawing/2014/main" id="{64337FEE-391E-4C4E-890C-B1628B84E1EA}"/>
+                <a16:creationId xmlns:a16="http://schemas.microsoft.com/office/drawing/2014/main" id="{3F7D95C9-1722-4EFC-970B-C5844A87B974}"/>
               </a:ext>
             </a:extLst>
           </p:cNvPr>
@@ -4072,7 +4052,7 @@
           <p:cNvPr id="13" name="">
             <a:extLst xmlns:a="http://schemas.openxmlformats.org/drawingml/2006/main">
               <a:ext uri="{FF2B5EF4-FFF2-40B4-BE49-F238E27FC236}">
-                <a16:creationId xmlns:a16="http://schemas.microsoft.com/office/drawing/2014/main" id="{293EE86A-E818-4F0E-9583-98C61E2458C2}"/>
+                <a16:creationId xmlns:a16="http://schemas.microsoft.com/office/drawing/2014/main" id="{E3C3ACC4-B3A2-4166-A2CD-4382438461BB}"/>
               </a:ext>
             </a:extLst>
           </p:cNvPr>
@@ -4134,7 +4114,7 @@
           <p:cNvPr id="14" name="">
             <a:extLst xmlns:a="http://schemas.openxmlformats.org/drawingml/2006/main">
               <a:ext uri="{FF2B5EF4-FFF2-40B4-BE49-F238E27FC236}">
-                <a16:creationId xmlns:a16="http://schemas.microsoft.com/office/drawing/2014/main" id="{B1377CE9-047B-4F65-9C04-C0B59861AF14}"/>
+                <a16:creationId xmlns:a16="http://schemas.microsoft.com/office/drawing/2014/main" id="{9D095548-C100-452A-BF3F-11E30C8BF745}"/>
               </a:ext>
             </a:extLst>
           </p:cNvPr>
@@ -4196,7 +4176,7 @@
           <p:cNvPr id="15" name="">
             <a:extLst xmlns:a="http://schemas.openxmlformats.org/drawingml/2006/main">
               <a:ext uri="{FF2B5EF4-FFF2-40B4-BE49-F238E27FC236}">
-                <a16:creationId xmlns:a16="http://schemas.microsoft.com/office/drawing/2014/main" id="{706BDE4E-612C-496F-B2B4-159529051EF3}"/>
+                <a16:creationId xmlns:a16="http://schemas.microsoft.com/office/drawing/2014/main" id="{2D499111-C4ED-4F89-86DA-10BB6E4A72EA}"/>
               </a:ext>
             </a:extLst>
           </p:cNvPr>
@@ -4258,7 +4238,7 @@
           <p:cNvPr id="16" name="">
             <a:extLst xmlns:a="http://schemas.openxmlformats.org/drawingml/2006/main">
               <a:ext uri="{FF2B5EF4-FFF2-40B4-BE49-F238E27FC236}">
-                <a16:creationId xmlns:a16="http://schemas.microsoft.com/office/drawing/2014/main" id="{CA6A88BD-A634-4C78-A500-47C4CBDE5B40}"/>
+                <a16:creationId xmlns:a16="http://schemas.microsoft.com/office/drawing/2014/main" id="{C129A65A-D835-4986-98A5-B8337C990F4A}"/>
               </a:ext>
             </a:extLst>
           </p:cNvPr>
@@ -4291,7 +4271,7 @@
           <p:cNvPr id="17" name="">
             <a:extLst xmlns:a="http://schemas.openxmlformats.org/drawingml/2006/main">
               <a:ext uri="{FF2B5EF4-FFF2-40B4-BE49-F238E27FC236}">
-                <a16:creationId xmlns:a16="http://schemas.microsoft.com/office/drawing/2014/main" id="{97FEC707-A836-48F9-94C4-248329B9EAC9}"/>
+                <a16:creationId xmlns:a16="http://schemas.microsoft.com/office/drawing/2014/main" id="{C0B15CD9-9A01-4293-B0E0-F394055A01ED}"/>
               </a:ext>
             </a:extLst>
           </p:cNvPr>
@@ -4353,7 +4333,7 @@
           <p:cNvPr id="18" name="footer-rule-10">
             <a:extLst xmlns:a="http://schemas.openxmlformats.org/drawingml/2006/main">
               <a:ext uri="{FF2B5EF4-FFF2-40B4-BE49-F238E27FC236}">
-                <a16:creationId xmlns:a16="http://schemas.microsoft.com/office/drawing/2014/main" id="{CB1F6351-18A4-4D9A-95CE-B0019E8B2FEF}"/>
+                <a16:creationId xmlns:a16="http://schemas.microsoft.com/office/drawing/2014/main" id="{29D51F18-5E10-4409-ABC5-A38E9BC511BC}"/>
               </a:ext>
             </a:extLst>
           </p:cNvPr>
@@ -4384,7 +4364,7 @@
           <p:cNvPr id="19" name="footer-label-10">
             <a:extLst xmlns:a="http://schemas.openxmlformats.org/drawingml/2006/main">
               <a:ext uri="{FF2B5EF4-FFF2-40B4-BE49-F238E27FC236}">
-                <a16:creationId xmlns:a16="http://schemas.microsoft.com/office/drawing/2014/main" id="{265DF5FA-B7A5-43C5-95CB-171C061550E9}"/>
+                <a16:creationId xmlns:a16="http://schemas.microsoft.com/office/drawing/2014/main" id="{C408B435-58EE-4D98-AA88-A9742775213E}"/>
               </a:ext>
             </a:extLst>
           </p:cNvPr>
@@ -4446,7 +4426,7 @@
           <p:cNvPr id="20" name="footer-page-10">
             <a:extLst xmlns:a="http://schemas.openxmlformats.org/drawingml/2006/main">
               <a:ext uri="{FF2B5EF4-FFF2-40B4-BE49-F238E27FC236}">
-                <a16:creationId xmlns:a16="http://schemas.microsoft.com/office/drawing/2014/main" id="{F4DD4AA7-B5AB-4C13-A368-8CB33E9B075B}"/>
+                <a16:creationId xmlns:a16="http://schemas.microsoft.com/office/drawing/2014/main" id="{6A861462-4ABD-4F84-9174-94A542FDE445}"/>
               </a:ext>
             </a:extLst>
           </p:cNvPr>
@@ -4506,7 +4486,7 @@
     </p:spTree>
     <p:extLst>
       <p:ext uri="{BB962C8B-B14F-4D97-AF65-F5344CB8AC3E}">
-        <p14:creationId xmlns:p14="http://schemas.microsoft.com/office/powerpoint/2010/main" val="6961013"/>
+        <p14:creationId xmlns:p14="http://schemas.microsoft.com/office/powerpoint/2010/main" val="1503182251"/>
       </p:ext>
     </p:extLst>
   </p:cSld>
@@ -4537,7 +4517,7 @@
           <p:cNvPr id="22" name="side-accent-11">
             <a:extLst xmlns:a="http://schemas.openxmlformats.org/drawingml/2006/main">
               <a:ext uri="{FF2B5EF4-FFF2-40B4-BE49-F238E27FC236}">
-                <a16:creationId xmlns:a16="http://schemas.microsoft.com/office/drawing/2014/main" id="{DE3B731A-C948-43BB-B922-FB5265601C59}"/>
+                <a16:creationId xmlns:a16="http://schemas.microsoft.com/office/drawing/2014/main" id="{F994ED44-8431-43AA-940A-81F012E85E74}"/>
               </a:ext>
             </a:extLst>
           </p:cNvPr>
@@ -4568,7 +4548,7 @@
           <p:cNvPr id="2" name="kicker-11">
             <a:extLst xmlns:a="http://schemas.openxmlformats.org/drawingml/2006/main">
               <a:ext uri="{FF2B5EF4-FFF2-40B4-BE49-F238E27FC236}">
-                <a16:creationId xmlns:a16="http://schemas.microsoft.com/office/drawing/2014/main" id="{EDDA1770-5E96-48AC-B357-BF5857D46BB1}"/>
+                <a16:creationId xmlns:a16="http://schemas.microsoft.com/office/drawing/2014/main" id="{1F5F6255-756B-4A18-BE58-F1FBE2E08ABB}"/>
               </a:ext>
             </a:extLst>
           </p:cNvPr>
@@ -4630,7 +4610,7 @@
           <p:cNvPr id="3" name="title-11">
             <a:extLst xmlns:a="http://schemas.openxmlformats.org/drawingml/2006/main">
               <a:ext uri="{FF2B5EF4-FFF2-40B4-BE49-F238E27FC236}">
-                <a16:creationId xmlns:a16="http://schemas.microsoft.com/office/drawing/2014/main" id="{9B6B9D03-4170-4C92-AD13-FAD9975D9217}"/>
+                <a16:creationId xmlns:a16="http://schemas.microsoft.com/office/drawing/2014/main" id="{8FA8193C-DF0C-468D-A868-3DA27BAFE77F}"/>
               </a:ext>
             </a:extLst>
           </p:cNvPr>
@@ -4692,7 +4672,7 @@
           <p:cNvPr id="4" name="">
             <a:extLst xmlns:a="http://schemas.openxmlformats.org/drawingml/2006/main">
               <a:ext uri="{FF2B5EF4-FFF2-40B4-BE49-F238E27FC236}">
-                <a16:creationId xmlns:a16="http://schemas.microsoft.com/office/drawing/2014/main" id="{843B2D6E-FA37-4E52-A991-DE6D49BA3CB7}"/>
+                <a16:creationId xmlns:a16="http://schemas.microsoft.com/office/drawing/2014/main" id="{6EE8EACB-0BFB-4ADF-8AE8-575817347CC1}"/>
               </a:ext>
             </a:extLst>
           </p:cNvPr>
@@ -4754,7 +4734,7 @@
           <p:cNvPr id="5" name="">
             <a:extLst xmlns:a="http://schemas.openxmlformats.org/drawingml/2006/main">
               <a:ext uri="{FF2B5EF4-FFF2-40B4-BE49-F238E27FC236}">
-                <a16:creationId xmlns:a16="http://schemas.microsoft.com/office/drawing/2014/main" id="{9681E55A-01B2-471D-B53D-3F87CC884272}"/>
+                <a16:creationId xmlns:a16="http://schemas.microsoft.com/office/drawing/2014/main" id="{5C7402DD-9FF7-414D-829C-8EE23249EA69}"/>
               </a:ext>
             </a:extLst>
           </p:cNvPr>
@@ -4785,7 +4765,7 @@
           <p:cNvPr id="6" name="">
             <a:extLst xmlns:a="http://schemas.openxmlformats.org/drawingml/2006/main">
               <a:ext uri="{FF2B5EF4-FFF2-40B4-BE49-F238E27FC236}">
-                <a16:creationId xmlns:a16="http://schemas.microsoft.com/office/drawing/2014/main" id="{2DD18481-CC1B-4D10-B945-9E4C03022CD5}"/>
+                <a16:creationId xmlns:a16="http://schemas.microsoft.com/office/drawing/2014/main" id="{1848CCFE-FB2A-4143-933D-38C114442E08}"/>
               </a:ext>
             </a:extLst>
           </p:cNvPr>
@@ -4847,7 +4827,7 @@
           <p:cNvPr id="7" name="">
             <a:extLst xmlns:a="http://schemas.openxmlformats.org/drawingml/2006/main">
               <a:ext uri="{FF2B5EF4-FFF2-40B4-BE49-F238E27FC236}">
-                <a16:creationId xmlns:a16="http://schemas.microsoft.com/office/drawing/2014/main" id="{E2F9FC33-713F-45F9-BE40-8799BF64BFA1}"/>
+                <a16:creationId xmlns:a16="http://schemas.microsoft.com/office/drawing/2014/main" id="{73B0CAD6-BD21-40D9-936D-58B2A7D26CDC}"/>
               </a:ext>
             </a:extLst>
           </p:cNvPr>
@@ -4909,7 +4889,7 @@
           <p:cNvPr id="8" name="">
             <a:extLst xmlns:a="http://schemas.openxmlformats.org/drawingml/2006/main">
               <a:ext uri="{FF2B5EF4-FFF2-40B4-BE49-F238E27FC236}">
-                <a16:creationId xmlns:a16="http://schemas.microsoft.com/office/drawing/2014/main" id="{7B4AC2DB-672B-4909-A62E-A0237FDA3F18}"/>
+                <a16:creationId xmlns:a16="http://schemas.microsoft.com/office/drawing/2014/main" id="{68073530-3336-4211-9675-FAF03F8E203E}"/>
               </a:ext>
             </a:extLst>
           </p:cNvPr>
@@ -4971,7 +4951,7 @@
           <p:cNvPr id="9" name="">
             <a:extLst xmlns:a="http://schemas.openxmlformats.org/drawingml/2006/main">
               <a:ext uri="{FF2B5EF4-FFF2-40B4-BE49-F238E27FC236}">
-                <a16:creationId xmlns:a16="http://schemas.microsoft.com/office/drawing/2014/main" id="{00B0382E-A9D6-4BBC-AD57-7D724F1BDDF9}"/>
+                <a16:creationId xmlns:a16="http://schemas.microsoft.com/office/drawing/2014/main" id="{D7EF8313-0EA9-4386-8895-2ECDD7F92690}"/>
               </a:ext>
             </a:extLst>
           </p:cNvPr>
@@ -5002,7 +4982,7 @@
           <p:cNvPr id="10" name="">
             <a:extLst xmlns:a="http://schemas.openxmlformats.org/drawingml/2006/main">
               <a:ext uri="{FF2B5EF4-FFF2-40B4-BE49-F238E27FC236}">
-                <a16:creationId xmlns:a16="http://schemas.microsoft.com/office/drawing/2014/main" id="{E46065E5-9454-4324-9967-20CFF221DAD9}"/>
+                <a16:creationId xmlns:a16="http://schemas.microsoft.com/office/drawing/2014/main" id="{A07D7A5B-58B5-4024-8A9C-DE9CCA31237E}"/>
               </a:ext>
             </a:extLst>
           </p:cNvPr>
@@ -5064,7 +5044,7 @@
           <p:cNvPr id="11" name="">
             <a:extLst xmlns:a="http://schemas.openxmlformats.org/drawingml/2006/main">
               <a:ext uri="{FF2B5EF4-FFF2-40B4-BE49-F238E27FC236}">
-                <a16:creationId xmlns:a16="http://schemas.microsoft.com/office/drawing/2014/main" id="{40FA9E7C-CE15-40D1-BE50-D61E4B1D464C}"/>
+                <a16:creationId xmlns:a16="http://schemas.microsoft.com/office/drawing/2014/main" id="{B2838495-1034-4BBB-8C84-58BE6095D8F0}"/>
               </a:ext>
             </a:extLst>
           </p:cNvPr>
@@ -5126,7 +5106,7 @@
           <p:cNvPr id="12" name="">
             <a:extLst xmlns:a="http://schemas.openxmlformats.org/drawingml/2006/main">
               <a:ext uri="{FF2B5EF4-FFF2-40B4-BE49-F238E27FC236}">
-                <a16:creationId xmlns:a16="http://schemas.microsoft.com/office/drawing/2014/main" id="{AC3D9DE4-BC86-47D9-8295-148949E4CDEE}"/>
+                <a16:creationId xmlns:a16="http://schemas.microsoft.com/office/drawing/2014/main" id="{77C8A669-AF52-4534-B4F1-BEAD95359C1F}"/>
               </a:ext>
             </a:extLst>
           </p:cNvPr>
@@ -5188,7 +5168,7 @@
           <p:cNvPr id="13" name="">
             <a:extLst xmlns:a="http://schemas.openxmlformats.org/drawingml/2006/main">
               <a:ext uri="{FF2B5EF4-FFF2-40B4-BE49-F238E27FC236}">
-                <a16:creationId xmlns:a16="http://schemas.microsoft.com/office/drawing/2014/main" id="{AA2D5670-F87A-4485-9952-55D5EB77B8EE}"/>
+                <a16:creationId xmlns:a16="http://schemas.microsoft.com/office/drawing/2014/main" id="{F8C3CC84-69F8-43E1-8CF6-AE0926C43500}"/>
               </a:ext>
             </a:extLst>
           </p:cNvPr>
@@ -5219,7 +5199,7 @@
           <p:cNvPr id="14" name="">
             <a:extLst xmlns:a="http://schemas.openxmlformats.org/drawingml/2006/main">
               <a:ext uri="{FF2B5EF4-FFF2-40B4-BE49-F238E27FC236}">
-                <a16:creationId xmlns:a16="http://schemas.microsoft.com/office/drawing/2014/main" id="{743E893A-F78C-4974-87E5-9F6347D80FAC}"/>
+                <a16:creationId xmlns:a16="http://schemas.microsoft.com/office/drawing/2014/main" id="{B14F7F27-F5FF-4F48-A008-99E8E6A2806F}"/>
               </a:ext>
             </a:extLst>
           </p:cNvPr>
@@ -5281,7 +5261,7 @@
           <p:cNvPr id="15" name="">
             <a:extLst xmlns:a="http://schemas.openxmlformats.org/drawingml/2006/main">
               <a:ext uri="{FF2B5EF4-FFF2-40B4-BE49-F238E27FC236}">
-                <a16:creationId xmlns:a16="http://schemas.microsoft.com/office/drawing/2014/main" id="{C5111456-872C-450B-B811-6D56FF057822}"/>
+                <a16:creationId xmlns:a16="http://schemas.microsoft.com/office/drawing/2014/main" id="{E7DF2112-84C0-4CA7-8C90-5903E5EC513E}"/>
               </a:ext>
             </a:extLst>
           </p:cNvPr>
@@ -5343,7 +5323,7 @@
           <p:cNvPr id="16" name="">
             <a:extLst xmlns:a="http://schemas.openxmlformats.org/drawingml/2006/main">
               <a:ext uri="{FF2B5EF4-FFF2-40B4-BE49-F238E27FC236}">
-                <a16:creationId xmlns:a16="http://schemas.microsoft.com/office/drawing/2014/main" id="{ECF4524E-4FBD-4573-9A51-F8E78D5DBEB7}"/>
+                <a16:creationId xmlns:a16="http://schemas.microsoft.com/office/drawing/2014/main" id="{B2B7DF88-FEC4-4440-BF73-18F84B71AD61}"/>
               </a:ext>
             </a:extLst>
           </p:cNvPr>
@@ -5405,7 +5385,7 @@
           <p:cNvPr id="17" name="">
             <a:extLst xmlns:a="http://schemas.openxmlformats.org/drawingml/2006/main">
               <a:ext uri="{FF2B5EF4-FFF2-40B4-BE49-F238E27FC236}">
-                <a16:creationId xmlns:a16="http://schemas.microsoft.com/office/drawing/2014/main" id="{4BDA3183-26B2-4CED-9671-F2A39FEB09B8}"/>
+                <a16:creationId xmlns:a16="http://schemas.microsoft.com/office/drawing/2014/main" id="{C4F8D805-1FD8-4F80-AA06-65DE8CE34350}"/>
               </a:ext>
             </a:extLst>
           </p:cNvPr>
@@ -5440,7 +5420,7 @@
           <p:cNvPr id="18" name="">
             <a:extLst xmlns:a="http://schemas.openxmlformats.org/drawingml/2006/main">
               <a:ext uri="{FF2B5EF4-FFF2-40B4-BE49-F238E27FC236}">
-                <a16:creationId xmlns:a16="http://schemas.microsoft.com/office/drawing/2014/main" id="{9941F1E6-7045-4F12-8F25-954410F2A06A}"/>
+                <a16:creationId xmlns:a16="http://schemas.microsoft.com/office/drawing/2014/main" id="{7066A29D-46B8-4962-B04B-E61882FFD8DC}"/>
               </a:ext>
             </a:extLst>
           </p:cNvPr>
@@ -5529,7 +5509,7 @@
           <p:cNvPr id="19" name="footer-rule-11">
             <a:extLst xmlns:a="http://schemas.openxmlformats.org/drawingml/2006/main">
               <a:ext uri="{FF2B5EF4-FFF2-40B4-BE49-F238E27FC236}">
-                <a16:creationId xmlns:a16="http://schemas.microsoft.com/office/drawing/2014/main" id="{984D6D7E-02D2-456C-AF77-86E00A8A1A42}"/>
+                <a16:creationId xmlns:a16="http://schemas.microsoft.com/office/drawing/2014/main" id="{FB0355AE-D150-4754-AD13-02863A0AB4EC}"/>
               </a:ext>
             </a:extLst>
           </p:cNvPr>
@@ -5560,7 +5540,7 @@
           <p:cNvPr id="20" name="footer-label-11">
             <a:extLst xmlns:a="http://schemas.openxmlformats.org/drawingml/2006/main">
               <a:ext uri="{FF2B5EF4-FFF2-40B4-BE49-F238E27FC236}">
-                <a16:creationId xmlns:a16="http://schemas.microsoft.com/office/drawing/2014/main" id="{63E6C8D5-80DE-4877-A37A-79B5185B8D04}"/>
+                <a16:creationId xmlns:a16="http://schemas.microsoft.com/office/drawing/2014/main" id="{D75E6824-8866-4D23-9F2A-600D73015034}"/>
               </a:ext>
             </a:extLst>
           </p:cNvPr>
@@ -5622,7 +5602,7 @@
           <p:cNvPr id="21" name="footer-page-11">
             <a:extLst xmlns:a="http://schemas.openxmlformats.org/drawingml/2006/main">
               <a:ext uri="{FF2B5EF4-FFF2-40B4-BE49-F238E27FC236}">
-                <a16:creationId xmlns:a16="http://schemas.microsoft.com/office/drawing/2014/main" id="{190E53A6-3270-4E8F-8578-938FA68085D4}"/>
+                <a16:creationId xmlns:a16="http://schemas.microsoft.com/office/drawing/2014/main" id="{DFFA6110-DE81-40C9-A168-2E5266FBD00E}"/>
               </a:ext>
             </a:extLst>
           </p:cNvPr>
@@ -5682,7 +5662,7 @@
     </p:spTree>
     <p:extLst>
       <p:ext uri="{BB962C8B-B14F-4D97-AF65-F5344CB8AC3E}">
-        <p14:creationId xmlns:p14="http://schemas.microsoft.com/office/powerpoint/2010/main" val="431716243"/>
+        <p14:creationId xmlns:p14="http://schemas.microsoft.com/office/powerpoint/2010/main" val="824608286"/>
       </p:ext>
     </p:extLst>
   </p:cSld>
@@ -5713,7 +5693,7 @@
           <p:cNvPr id="14" name="side-accent-12">
             <a:extLst xmlns:a="http://schemas.openxmlformats.org/drawingml/2006/main">
               <a:ext uri="{FF2B5EF4-FFF2-40B4-BE49-F238E27FC236}">
-                <a16:creationId xmlns:a16="http://schemas.microsoft.com/office/drawing/2014/main" id="{4113A673-2820-4FD6-AB59-20CF8354F4A7}"/>
+                <a16:creationId xmlns:a16="http://schemas.microsoft.com/office/drawing/2014/main" id="{B3CE86C3-44B4-4446-B1B2-F0697D658BF5}"/>
               </a:ext>
             </a:extLst>
           </p:cNvPr>
@@ -5744,7 +5724,7 @@
           <p:cNvPr id="2" name="kicker-12">
             <a:extLst xmlns:a="http://schemas.openxmlformats.org/drawingml/2006/main">
               <a:ext uri="{FF2B5EF4-FFF2-40B4-BE49-F238E27FC236}">
-                <a16:creationId xmlns:a16="http://schemas.microsoft.com/office/drawing/2014/main" id="{447F7D7A-3935-484D-9117-368397CC5F3D}"/>
+                <a16:creationId xmlns:a16="http://schemas.microsoft.com/office/drawing/2014/main" id="{C244AD4A-F5DA-48BE-A327-9A8509D0142F}"/>
               </a:ext>
             </a:extLst>
           </p:cNvPr>
@@ -5806,7 +5786,7 @@
           <p:cNvPr id="3" name="title-12">
             <a:extLst xmlns:a="http://schemas.openxmlformats.org/drawingml/2006/main">
               <a:ext uri="{FF2B5EF4-FFF2-40B4-BE49-F238E27FC236}">
-                <a16:creationId xmlns:a16="http://schemas.microsoft.com/office/drawing/2014/main" id="{203FCF78-FFF1-4CC6-98E5-CCBC7BD51ED6}"/>
+                <a16:creationId xmlns:a16="http://schemas.microsoft.com/office/drawing/2014/main" id="{EEB4D030-61EC-43E3-8D5B-38654028BE03}"/>
               </a:ext>
             </a:extLst>
           </p:cNvPr>
@@ -5868,7 +5848,7 @@
           <p:cNvPr id="4" name="draft-panel">
             <a:extLst xmlns:a="http://schemas.openxmlformats.org/drawingml/2006/main">
               <a:ext uri="{FF2B5EF4-FFF2-40B4-BE49-F238E27FC236}">
-                <a16:creationId xmlns:a16="http://schemas.microsoft.com/office/drawing/2014/main" id="{3EF60557-EF30-409C-A2EE-D89B914B23B9}"/>
+                <a16:creationId xmlns:a16="http://schemas.microsoft.com/office/drawing/2014/main" id="{A8911B29-D4B2-469D-971D-96F49431D72A}"/>
               </a:ext>
             </a:extLst>
           </p:cNvPr>
@@ -5903,7 +5883,7 @@
           <p:cNvPr id="5" name="">
             <a:extLst xmlns:a="http://schemas.openxmlformats.org/drawingml/2006/main">
               <a:ext uri="{FF2B5EF4-FFF2-40B4-BE49-F238E27FC236}">
-                <a16:creationId xmlns:a16="http://schemas.microsoft.com/office/drawing/2014/main" id="{34EB6F62-9333-43B7-93A5-28C0EE90BA93}"/>
+                <a16:creationId xmlns:a16="http://schemas.microsoft.com/office/drawing/2014/main" id="{D85D8725-6DFE-437A-8FDF-94FF199926D5}"/>
               </a:ext>
             </a:extLst>
           </p:cNvPr>
@@ -5965,7 +5945,7 @@
           <p:cNvPr id="6" name="">
             <a:extLst xmlns:a="http://schemas.openxmlformats.org/drawingml/2006/main">
               <a:ext uri="{FF2B5EF4-FFF2-40B4-BE49-F238E27FC236}">
-                <a16:creationId xmlns:a16="http://schemas.microsoft.com/office/drawing/2014/main" id="{5CAD1BF1-4F69-421E-B6DA-B207B681E654}"/>
+                <a16:creationId xmlns:a16="http://schemas.microsoft.com/office/drawing/2014/main" id="{41C26044-2E6E-4228-82E9-F4D175CA675A}"/>
               </a:ext>
             </a:extLst>
           </p:cNvPr>
@@ -6081,7 +6061,7 @@
           <p:cNvPr id="7" name="submit-panel">
             <a:extLst xmlns:a="http://schemas.openxmlformats.org/drawingml/2006/main">
               <a:ext uri="{FF2B5EF4-FFF2-40B4-BE49-F238E27FC236}">
-                <a16:creationId xmlns:a16="http://schemas.microsoft.com/office/drawing/2014/main" id="{7E11282F-CF76-4A41-ACFD-07AF96839263}"/>
+                <a16:creationId xmlns:a16="http://schemas.microsoft.com/office/drawing/2014/main" id="{47BE46EC-0404-4B54-AD90-A5BE3A46A204}"/>
               </a:ext>
             </a:extLst>
           </p:cNvPr>
@@ -6116,7 +6096,7 @@
           <p:cNvPr id="8" name="">
             <a:extLst xmlns:a="http://schemas.openxmlformats.org/drawingml/2006/main">
               <a:ext uri="{FF2B5EF4-FFF2-40B4-BE49-F238E27FC236}">
-                <a16:creationId xmlns:a16="http://schemas.microsoft.com/office/drawing/2014/main" id="{08A730FD-25AB-48DE-9B0C-C4E76AB6DE13}"/>
+                <a16:creationId xmlns:a16="http://schemas.microsoft.com/office/drawing/2014/main" id="{5E926FEA-C515-4307-A1D5-12CE5648824F}"/>
               </a:ext>
             </a:extLst>
           </p:cNvPr>
@@ -6178,7 +6158,7 @@
           <p:cNvPr id="9" name="">
             <a:extLst xmlns:a="http://schemas.openxmlformats.org/drawingml/2006/main">
               <a:ext uri="{FF2B5EF4-FFF2-40B4-BE49-F238E27FC236}">
-                <a16:creationId xmlns:a16="http://schemas.microsoft.com/office/drawing/2014/main" id="{D9D90654-26E3-4E28-B9E9-F329EF47A75E}"/>
+                <a16:creationId xmlns:a16="http://schemas.microsoft.com/office/drawing/2014/main" id="{B8EE55A3-E32B-4B43-9390-120307511B44}"/>
               </a:ext>
             </a:extLst>
           </p:cNvPr>
@@ -6294,7 +6274,7 @@
           <p:cNvPr id="10" name="">
             <a:extLst xmlns:a="http://schemas.openxmlformats.org/drawingml/2006/main">
               <a:ext uri="{FF2B5EF4-FFF2-40B4-BE49-F238E27FC236}">
-                <a16:creationId xmlns:a16="http://schemas.microsoft.com/office/drawing/2014/main" id="{76AAE11C-74E2-41A8-9A41-A8FEB886D8B2}"/>
+                <a16:creationId xmlns:a16="http://schemas.microsoft.com/office/drawing/2014/main" id="{A9485C3E-962F-41E7-9F7D-141C49683677}"/>
               </a:ext>
             </a:extLst>
           </p:cNvPr>
@@ -6356,7 +6336,7 @@
           <p:cNvPr id="11" name="footer-rule-12">
             <a:extLst xmlns:a="http://schemas.openxmlformats.org/drawingml/2006/main">
               <a:ext uri="{FF2B5EF4-FFF2-40B4-BE49-F238E27FC236}">
-                <a16:creationId xmlns:a16="http://schemas.microsoft.com/office/drawing/2014/main" id="{E9FC191C-C444-493C-815F-8A65BBAE11AF}"/>
+                <a16:creationId xmlns:a16="http://schemas.microsoft.com/office/drawing/2014/main" id="{5F10302F-AFF3-4549-969B-AEF2B265E971}"/>
               </a:ext>
             </a:extLst>
           </p:cNvPr>
@@ -6387,7 +6367,7 @@
           <p:cNvPr id="12" name="footer-label-12">
             <a:extLst xmlns:a="http://schemas.openxmlformats.org/drawingml/2006/main">
               <a:ext uri="{FF2B5EF4-FFF2-40B4-BE49-F238E27FC236}">
-                <a16:creationId xmlns:a16="http://schemas.microsoft.com/office/drawing/2014/main" id="{1F0C3F1D-62A7-4B46-8115-57DD0A86EA3B}"/>
+                <a16:creationId xmlns:a16="http://schemas.microsoft.com/office/drawing/2014/main" id="{01996034-55CF-4740-8018-7E4A23638541}"/>
               </a:ext>
             </a:extLst>
           </p:cNvPr>
@@ -6449,7 +6429,7 @@
           <p:cNvPr id="13" name="footer-page-12">
             <a:extLst xmlns:a="http://schemas.openxmlformats.org/drawingml/2006/main">
               <a:ext uri="{FF2B5EF4-FFF2-40B4-BE49-F238E27FC236}">
-                <a16:creationId xmlns:a16="http://schemas.microsoft.com/office/drawing/2014/main" id="{562736BC-B03C-43E5-AE79-6C491B2FB414}"/>
+                <a16:creationId xmlns:a16="http://schemas.microsoft.com/office/drawing/2014/main" id="{59D35A8B-5799-4CB5-A100-CEC2703276E4}"/>
               </a:ext>
             </a:extLst>
           </p:cNvPr>
@@ -6509,7 +6489,7 @@
     </p:spTree>
     <p:extLst>
       <p:ext uri="{BB962C8B-B14F-4D97-AF65-F5344CB8AC3E}">
-        <p14:creationId xmlns:p14="http://schemas.microsoft.com/office/powerpoint/2010/main" val="2137468876"/>
+        <p14:creationId xmlns:p14="http://schemas.microsoft.com/office/powerpoint/2010/main" val="545933456"/>
       </p:ext>
     </p:extLst>
   </p:cSld>
@@ -6540,7 +6520,7 @@
           <p:cNvPr id="25" name="side-accent-13">
             <a:extLst xmlns:a="http://schemas.openxmlformats.org/drawingml/2006/main">
               <a:ext uri="{FF2B5EF4-FFF2-40B4-BE49-F238E27FC236}">
-                <a16:creationId xmlns:a16="http://schemas.microsoft.com/office/drawing/2014/main" id="{D9625589-91E1-42B5-BD53-BE185759840E}"/>
+                <a16:creationId xmlns:a16="http://schemas.microsoft.com/office/drawing/2014/main" id="{B22AB5FF-CF1F-404A-A09F-7AD3A3E8FFCE}"/>
               </a:ext>
             </a:extLst>
           </p:cNvPr>
@@ -6571,7 +6551,7 @@
           <p:cNvPr id="2" name="kicker-13">
             <a:extLst xmlns:a="http://schemas.openxmlformats.org/drawingml/2006/main">
               <a:ext uri="{FF2B5EF4-FFF2-40B4-BE49-F238E27FC236}">
-                <a16:creationId xmlns:a16="http://schemas.microsoft.com/office/drawing/2014/main" id="{BBD551B3-B405-48FF-92B7-7DD6652AA0CA}"/>
+                <a16:creationId xmlns:a16="http://schemas.microsoft.com/office/drawing/2014/main" id="{B6B0D437-9C3C-4810-8724-69E2687EE1D6}"/>
               </a:ext>
             </a:extLst>
           </p:cNvPr>
@@ -6633,7 +6613,7 @@
           <p:cNvPr id="3" name="title-13">
             <a:extLst xmlns:a="http://schemas.openxmlformats.org/drawingml/2006/main">
               <a:ext uri="{FF2B5EF4-FFF2-40B4-BE49-F238E27FC236}">
-                <a16:creationId xmlns:a16="http://schemas.microsoft.com/office/drawing/2014/main" id="{4DBA0593-42DA-4645-BC7A-0B5DA9F4224D}"/>
+                <a16:creationId xmlns:a16="http://schemas.microsoft.com/office/drawing/2014/main" id="{33917CF5-E16D-4AF0-9917-7D1FB1FA575A}"/>
               </a:ext>
             </a:extLst>
           </p:cNvPr>
@@ -6695,7 +6675,7 @@
           <p:cNvPr id="4" name="">
             <a:extLst xmlns:a="http://schemas.openxmlformats.org/drawingml/2006/main">
               <a:ext uri="{FF2B5EF4-FFF2-40B4-BE49-F238E27FC236}">
-                <a16:creationId xmlns:a16="http://schemas.microsoft.com/office/drawing/2014/main" id="{A0F38E97-5B95-45BC-A0B7-07578D8CBA56}"/>
+                <a16:creationId xmlns:a16="http://schemas.microsoft.com/office/drawing/2014/main" id="{5DDAF352-9911-4646-AC23-FF569C5698C8}"/>
               </a:ext>
             </a:extLst>
           </p:cNvPr>
@@ -6726,7 +6706,7 @@
           <p:cNvPr id="5" name="">
             <a:extLst xmlns:a="http://schemas.openxmlformats.org/drawingml/2006/main">
               <a:ext uri="{FF2B5EF4-FFF2-40B4-BE49-F238E27FC236}">
-                <a16:creationId xmlns:a16="http://schemas.microsoft.com/office/drawing/2014/main" id="{514C1BD5-B898-4FB7-8682-D156B5203EE0}"/>
+                <a16:creationId xmlns:a16="http://schemas.microsoft.com/office/drawing/2014/main" id="{608EA923-37A9-45AF-A91B-378E3FD62EE9}"/>
               </a:ext>
             </a:extLst>
           </p:cNvPr>
@@ -6757,7 +6737,7 @@
           <p:cNvPr id="6" name="">
             <a:extLst xmlns:a="http://schemas.openxmlformats.org/drawingml/2006/main">
               <a:ext uri="{FF2B5EF4-FFF2-40B4-BE49-F238E27FC236}">
-                <a16:creationId xmlns:a16="http://schemas.microsoft.com/office/drawing/2014/main" id="{E492E348-1FA1-440E-AD1A-98E25C8C6356}"/>
+                <a16:creationId xmlns:a16="http://schemas.microsoft.com/office/drawing/2014/main" id="{C5EC51EB-BB8F-4E55-93C1-5AA52B555409}"/>
               </a:ext>
             </a:extLst>
           </p:cNvPr>
@@ -6819,7 +6799,7 @@
           <p:cNvPr id="7" name="">
             <a:extLst xmlns:a="http://schemas.openxmlformats.org/drawingml/2006/main">
               <a:ext uri="{FF2B5EF4-FFF2-40B4-BE49-F238E27FC236}">
-                <a16:creationId xmlns:a16="http://schemas.microsoft.com/office/drawing/2014/main" id="{4CE29542-62C7-4247-A036-E272A0385690}"/>
+                <a16:creationId xmlns:a16="http://schemas.microsoft.com/office/drawing/2014/main" id="{52C88982-12EF-4D5C-80D1-3C99ADFF7BA5}"/>
               </a:ext>
             </a:extLst>
           </p:cNvPr>
@@ -6881,7 +6861,7 @@
           <p:cNvPr id="8" name="">
             <a:extLst xmlns:a="http://schemas.openxmlformats.org/drawingml/2006/main">
               <a:ext uri="{FF2B5EF4-FFF2-40B4-BE49-F238E27FC236}">
-                <a16:creationId xmlns:a16="http://schemas.microsoft.com/office/drawing/2014/main" id="{BB4F0317-93EE-444E-9550-E06797976BEB}"/>
+                <a16:creationId xmlns:a16="http://schemas.microsoft.com/office/drawing/2014/main" id="{D3D15D18-8122-4FEE-A4D9-E3EF3E012C6F}"/>
               </a:ext>
             </a:extLst>
           </p:cNvPr>
@@ -6943,7 +6923,7 @@
           <p:cNvPr id="9" name="">
             <a:extLst xmlns:a="http://schemas.openxmlformats.org/drawingml/2006/main">
               <a:ext uri="{FF2B5EF4-FFF2-40B4-BE49-F238E27FC236}">
-                <a16:creationId xmlns:a16="http://schemas.microsoft.com/office/drawing/2014/main" id="{AEDB6AFD-74E7-4680-8DDE-A1A61064CF40}"/>
+                <a16:creationId xmlns:a16="http://schemas.microsoft.com/office/drawing/2014/main" id="{62AC64D7-E3BA-4988-99EC-26EE098063C3}"/>
               </a:ext>
             </a:extLst>
           </p:cNvPr>
@@ -6974,7 +6954,7 @@
           <p:cNvPr id="10" name="">
             <a:extLst xmlns:a="http://schemas.openxmlformats.org/drawingml/2006/main">
               <a:ext uri="{FF2B5EF4-FFF2-40B4-BE49-F238E27FC236}">
-                <a16:creationId xmlns:a16="http://schemas.microsoft.com/office/drawing/2014/main" id="{5DFE5673-5151-4144-9F4B-52719685BD46}"/>
+                <a16:creationId xmlns:a16="http://schemas.microsoft.com/office/drawing/2014/main" id="{59EB0917-29BE-4E4F-BE95-C27A8C86AF07}"/>
               </a:ext>
             </a:extLst>
           </p:cNvPr>
@@ -7036,7 +7016,7 @@
           <p:cNvPr id="11" name="">
             <a:extLst xmlns:a="http://schemas.openxmlformats.org/drawingml/2006/main">
               <a:ext uri="{FF2B5EF4-FFF2-40B4-BE49-F238E27FC236}">
-                <a16:creationId xmlns:a16="http://schemas.microsoft.com/office/drawing/2014/main" id="{5BE3FE00-159E-41C4-AC63-5CF079410990}"/>
+                <a16:creationId xmlns:a16="http://schemas.microsoft.com/office/drawing/2014/main" id="{50A95850-1400-40E2-B177-ADB9E4231B03}"/>
               </a:ext>
             </a:extLst>
           </p:cNvPr>
@@ -7098,7 +7078,7 @@
           <p:cNvPr id="12" name="">
             <a:extLst xmlns:a="http://schemas.openxmlformats.org/drawingml/2006/main">
               <a:ext uri="{FF2B5EF4-FFF2-40B4-BE49-F238E27FC236}">
-                <a16:creationId xmlns:a16="http://schemas.microsoft.com/office/drawing/2014/main" id="{1CFB2BFB-68AE-48C9-A8D6-11BF8F3BF55E}"/>
+                <a16:creationId xmlns:a16="http://schemas.microsoft.com/office/drawing/2014/main" id="{13EBC39C-C212-4953-AABD-31B1555BE762}"/>
               </a:ext>
             </a:extLst>
           </p:cNvPr>
@@ -7160,7 +7140,7 @@
           <p:cNvPr id="13" name="">
             <a:extLst xmlns:a="http://schemas.openxmlformats.org/drawingml/2006/main">
               <a:ext uri="{FF2B5EF4-FFF2-40B4-BE49-F238E27FC236}">
-                <a16:creationId xmlns:a16="http://schemas.microsoft.com/office/drawing/2014/main" id="{872DF7DF-2AED-4DAF-8E1E-47B88ED9D052}"/>
+                <a16:creationId xmlns:a16="http://schemas.microsoft.com/office/drawing/2014/main" id="{58D4A3BF-0FC3-4B89-AF03-1491D5285273}"/>
               </a:ext>
             </a:extLst>
           </p:cNvPr>
@@ -7191,7 +7171,7 @@
           <p:cNvPr id="14" name="">
             <a:extLst xmlns:a="http://schemas.openxmlformats.org/drawingml/2006/main">
               <a:ext uri="{FF2B5EF4-FFF2-40B4-BE49-F238E27FC236}">
-                <a16:creationId xmlns:a16="http://schemas.microsoft.com/office/drawing/2014/main" id="{FDF806A2-0086-4B80-B381-08F63B9046A6}"/>
+                <a16:creationId xmlns:a16="http://schemas.microsoft.com/office/drawing/2014/main" id="{FC1871FE-2AD2-4F8F-819E-8F9C4DEE7C74}"/>
               </a:ext>
             </a:extLst>
           </p:cNvPr>
@@ -7253,7 +7233,7 @@
           <p:cNvPr id="15" name="">
             <a:extLst xmlns:a="http://schemas.openxmlformats.org/drawingml/2006/main">
               <a:ext uri="{FF2B5EF4-FFF2-40B4-BE49-F238E27FC236}">
-                <a16:creationId xmlns:a16="http://schemas.microsoft.com/office/drawing/2014/main" id="{89D78B69-3F33-4AC5-9BB8-650C06BEA158}"/>
+                <a16:creationId xmlns:a16="http://schemas.microsoft.com/office/drawing/2014/main" id="{FF9863B1-8043-472C-BDEF-C084CA4F862A}"/>
               </a:ext>
             </a:extLst>
           </p:cNvPr>
@@ -7315,7 +7295,7 @@
           <p:cNvPr id="16" name="">
             <a:extLst xmlns:a="http://schemas.openxmlformats.org/drawingml/2006/main">
               <a:ext uri="{FF2B5EF4-FFF2-40B4-BE49-F238E27FC236}">
-                <a16:creationId xmlns:a16="http://schemas.microsoft.com/office/drawing/2014/main" id="{9371768B-344D-41F2-9EAE-59A158B837C4}"/>
+                <a16:creationId xmlns:a16="http://schemas.microsoft.com/office/drawing/2014/main" id="{C9C34626-5652-4BCB-9E25-6FFDF3385621}"/>
               </a:ext>
             </a:extLst>
           </p:cNvPr>
@@ -7377,7 +7357,7 @@
           <p:cNvPr id="17" name="">
             <a:extLst xmlns:a="http://schemas.openxmlformats.org/drawingml/2006/main">
               <a:ext uri="{FF2B5EF4-FFF2-40B4-BE49-F238E27FC236}">
-                <a16:creationId xmlns:a16="http://schemas.microsoft.com/office/drawing/2014/main" id="{1546DF71-032C-465B-8761-BB47D1ED84AF}"/>
+                <a16:creationId xmlns:a16="http://schemas.microsoft.com/office/drawing/2014/main" id="{D4D1CA06-5428-4019-9AC7-A98A8AEE814C}"/>
               </a:ext>
             </a:extLst>
           </p:cNvPr>
@@ -7408,7 +7388,7 @@
           <p:cNvPr id="18" name="">
             <a:extLst xmlns:a="http://schemas.openxmlformats.org/drawingml/2006/main">
               <a:ext uri="{FF2B5EF4-FFF2-40B4-BE49-F238E27FC236}">
-                <a16:creationId xmlns:a16="http://schemas.microsoft.com/office/drawing/2014/main" id="{2AE84B8B-C6EA-46C5-A464-B5F36A56FEB7}"/>
+                <a16:creationId xmlns:a16="http://schemas.microsoft.com/office/drawing/2014/main" id="{342565EF-CF20-4B06-9478-916B566CA08F}"/>
               </a:ext>
             </a:extLst>
           </p:cNvPr>
@@ -7470,7 +7450,7 @@
           <p:cNvPr id="19" name="">
             <a:extLst xmlns:a="http://schemas.openxmlformats.org/drawingml/2006/main">
               <a:ext uri="{FF2B5EF4-FFF2-40B4-BE49-F238E27FC236}">
-                <a16:creationId xmlns:a16="http://schemas.microsoft.com/office/drawing/2014/main" id="{9A025E8F-DA8F-47A1-AF39-F1044558A4F9}"/>
+                <a16:creationId xmlns:a16="http://schemas.microsoft.com/office/drawing/2014/main" id="{413AEC9A-62B9-45BB-960C-27D2B7A0DD7B}"/>
               </a:ext>
             </a:extLst>
           </p:cNvPr>
@@ -7532,7 +7512,7 @@
           <p:cNvPr id="20" name="">
             <a:extLst xmlns:a="http://schemas.openxmlformats.org/drawingml/2006/main">
               <a:ext uri="{FF2B5EF4-FFF2-40B4-BE49-F238E27FC236}">
-                <a16:creationId xmlns:a16="http://schemas.microsoft.com/office/drawing/2014/main" id="{A7044C8D-4753-4BA5-9827-DBF290D30D0B}"/>
+                <a16:creationId xmlns:a16="http://schemas.microsoft.com/office/drawing/2014/main" id="{00AD92D6-2601-45BD-889F-0DB7CA02B7E5}"/>
               </a:ext>
             </a:extLst>
           </p:cNvPr>
@@ -7594,7 +7574,7 @@
           <p:cNvPr id="21" name="">
             <a:extLst xmlns:a="http://schemas.openxmlformats.org/drawingml/2006/main">
               <a:ext uri="{FF2B5EF4-FFF2-40B4-BE49-F238E27FC236}">
-                <a16:creationId xmlns:a16="http://schemas.microsoft.com/office/drawing/2014/main" id="{3A2D4558-C2A0-41B5-85AC-2D2A24829BD3}"/>
+                <a16:creationId xmlns:a16="http://schemas.microsoft.com/office/drawing/2014/main" id="{0D7DA0E8-4040-4813-9C46-E7C0541E9144}"/>
               </a:ext>
             </a:extLst>
           </p:cNvPr>
@@ -7656,7 +7636,7 @@
           <p:cNvPr id="22" name="footer-rule-13">
             <a:extLst xmlns:a="http://schemas.openxmlformats.org/drawingml/2006/main">
               <a:ext uri="{FF2B5EF4-FFF2-40B4-BE49-F238E27FC236}">
-                <a16:creationId xmlns:a16="http://schemas.microsoft.com/office/drawing/2014/main" id="{A41F8105-68A5-4A8C-B630-6B5DE38F879B}"/>
+                <a16:creationId xmlns:a16="http://schemas.microsoft.com/office/drawing/2014/main" id="{810DEB95-11A5-42D1-A7E7-F044EC464AF9}"/>
               </a:ext>
             </a:extLst>
           </p:cNvPr>
@@ -7687,7 +7667,7 @@
           <p:cNvPr id="23" name="footer-label-13">
             <a:extLst xmlns:a="http://schemas.openxmlformats.org/drawingml/2006/main">
               <a:ext uri="{FF2B5EF4-FFF2-40B4-BE49-F238E27FC236}">
-                <a16:creationId xmlns:a16="http://schemas.microsoft.com/office/drawing/2014/main" id="{21985A8A-9F26-4551-B1F5-84B945BF3B4A}"/>
+                <a16:creationId xmlns:a16="http://schemas.microsoft.com/office/drawing/2014/main" id="{DE634315-EE2A-49D3-8952-BA6E0B5762DC}"/>
               </a:ext>
             </a:extLst>
           </p:cNvPr>
@@ -7749,7 +7729,7 @@
           <p:cNvPr id="24" name="footer-page-13">
             <a:extLst xmlns:a="http://schemas.openxmlformats.org/drawingml/2006/main">
               <a:ext uri="{FF2B5EF4-FFF2-40B4-BE49-F238E27FC236}">
-                <a16:creationId xmlns:a16="http://schemas.microsoft.com/office/drawing/2014/main" id="{C29476E7-4348-4C31-AEE9-48582EB2F709}"/>
+                <a16:creationId xmlns:a16="http://schemas.microsoft.com/office/drawing/2014/main" id="{8CC611E7-CAFD-4796-B42B-58F408E6EF85}"/>
               </a:ext>
             </a:extLst>
           </p:cNvPr>
@@ -7809,7 +7789,7 @@
     </p:spTree>
     <p:extLst>
       <p:ext uri="{BB962C8B-B14F-4D97-AF65-F5344CB8AC3E}">
-        <p14:creationId xmlns:p14="http://schemas.microsoft.com/office/powerpoint/2010/main" val="11830988"/>
+        <p14:creationId xmlns:p14="http://schemas.microsoft.com/office/powerpoint/2010/main" val="732991347"/>
       </p:ext>
     </p:extLst>
   </p:cSld>
@@ -7840,7 +7820,7 @@
           <p:cNvPr id="24" name="side-accent-14">
             <a:extLst xmlns:a="http://schemas.openxmlformats.org/drawingml/2006/main">
               <a:ext uri="{FF2B5EF4-FFF2-40B4-BE49-F238E27FC236}">
-                <a16:creationId xmlns:a16="http://schemas.microsoft.com/office/drawing/2014/main" id="{E7E61249-37B3-44DD-8CD9-E25BAA75A473}"/>
+                <a16:creationId xmlns:a16="http://schemas.microsoft.com/office/drawing/2014/main" id="{8EC9D9AA-F17B-4398-9CE5-221BCFC257E9}"/>
               </a:ext>
             </a:extLst>
           </p:cNvPr>
@@ -7871,7 +7851,7 @@
           <p:cNvPr id="2" name="kicker-14">
             <a:extLst xmlns:a="http://schemas.openxmlformats.org/drawingml/2006/main">
               <a:ext uri="{FF2B5EF4-FFF2-40B4-BE49-F238E27FC236}">
-                <a16:creationId xmlns:a16="http://schemas.microsoft.com/office/drawing/2014/main" id="{BEE148F4-9D10-46FA-8C02-3CFE8C4F73D2}"/>
+                <a16:creationId xmlns:a16="http://schemas.microsoft.com/office/drawing/2014/main" id="{CDE58F1B-1C7A-4010-A264-C52BB7E9749C}"/>
               </a:ext>
             </a:extLst>
           </p:cNvPr>
@@ -7933,7 +7913,7 @@
           <p:cNvPr id="3" name="title-14">
             <a:extLst xmlns:a="http://schemas.openxmlformats.org/drawingml/2006/main">
               <a:ext uri="{FF2B5EF4-FFF2-40B4-BE49-F238E27FC236}">
-                <a16:creationId xmlns:a16="http://schemas.microsoft.com/office/drawing/2014/main" id="{2FBF3238-067C-4ED6-9332-2778C9F82473}"/>
+                <a16:creationId xmlns:a16="http://schemas.microsoft.com/office/drawing/2014/main" id="{674F1C1D-13C2-423E-BA9C-0467F3EF9060}"/>
               </a:ext>
             </a:extLst>
           </p:cNvPr>
@@ -7995,7 +7975,7 @@
           <p:cNvPr id="4" name="">
             <a:extLst xmlns:a="http://schemas.openxmlformats.org/drawingml/2006/main">
               <a:ext uri="{FF2B5EF4-FFF2-40B4-BE49-F238E27FC236}">
-                <a16:creationId xmlns:a16="http://schemas.microsoft.com/office/drawing/2014/main" id="{23DDE482-5C1D-4E41-92AE-10FCAAD513EE}"/>
+                <a16:creationId xmlns:a16="http://schemas.microsoft.com/office/drawing/2014/main" id="{C97BA457-441D-4828-9A2A-D6FC28C36766}"/>
               </a:ext>
             </a:extLst>
           </p:cNvPr>
@@ -8057,7 +8037,7 @@
           <p:cNvPr id="5" name="">
             <a:extLst xmlns:a="http://schemas.openxmlformats.org/drawingml/2006/main">
               <a:ext uri="{FF2B5EF4-FFF2-40B4-BE49-F238E27FC236}">
-                <a16:creationId xmlns:a16="http://schemas.microsoft.com/office/drawing/2014/main" id="{896010E4-AA49-4ACA-B1F6-C5B85E91267D}"/>
+                <a16:creationId xmlns:a16="http://schemas.microsoft.com/office/drawing/2014/main" id="{F02FE065-4827-46C5-A3FB-9CCB6C5A9A12}"/>
               </a:ext>
             </a:extLst>
           </p:cNvPr>
@@ -8119,7 +8099,7 @@
           <p:cNvPr id="6" name="">
             <a:extLst xmlns:a="http://schemas.openxmlformats.org/drawingml/2006/main">
               <a:ext uri="{FF2B5EF4-FFF2-40B4-BE49-F238E27FC236}">
-                <a16:creationId xmlns:a16="http://schemas.microsoft.com/office/drawing/2014/main" id="{7147E208-0B78-4A45-9220-D9A0685DA07A}"/>
+                <a16:creationId xmlns:a16="http://schemas.microsoft.com/office/drawing/2014/main" id="{7CCBD25F-2CC0-47D3-9FE8-DEBB315889B2}"/>
               </a:ext>
             </a:extLst>
           </p:cNvPr>
@@ -8181,7 +8161,7 @@
           <p:cNvPr id="7" name="">
             <a:extLst xmlns:a="http://schemas.openxmlformats.org/drawingml/2006/main">
               <a:ext uri="{FF2B5EF4-FFF2-40B4-BE49-F238E27FC236}">
-                <a16:creationId xmlns:a16="http://schemas.microsoft.com/office/drawing/2014/main" id="{9CCBB400-82D2-4EBC-9AD5-51FB9291F958}"/>
+                <a16:creationId xmlns:a16="http://schemas.microsoft.com/office/drawing/2014/main" id="{A2E1F41E-276F-4655-B83D-72566D70CA1D}"/>
               </a:ext>
             </a:extLst>
           </p:cNvPr>
@@ -8212,7 +8192,7 @@
           <p:cNvPr id="8" name="">
             <a:extLst xmlns:a="http://schemas.openxmlformats.org/drawingml/2006/main">
               <a:ext uri="{FF2B5EF4-FFF2-40B4-BE49-F238E27FC236}">
-                <a16:creationId xmlns:a16="http://schemas.microsoft.com/office/drawing/2014/main" id="{9ECB5CDF-65BA-4E5D-9815-4673263F5E63}"/>
+                <a16:creationId xmlns:a16="http://schemas.microsoft.com/office/drawing/2014/main" id="{12806E1A-5028-490E-8080-A69DB18B831B}"/>
               </a:ext>
             </a:extLst>
           </p:cNvPr>
@@ -8274,7 +8254,7 @@
           <p:cNvPr id="9" name="">
             <a:extLst xmlns:a="http://schemas.openxmlformats.org/drawingml/2006/main">
               <a:ext uri="{FF2B5EF4-FFF2-40B4-BE49-F238E27FC236}">
-                <a16:creationId xmlns:a16="http://schemas.microsoft.com/office/drawing/2014/main" id="{A0456426-970C-445C-8DA1-AAC5481CA5BA}"/>
+                <a16:creationId xmlns:a16="http://schemas.microsoft.com/office/drawing/2014/main" id="{995D8C2D-F43A-4E91-95AC-8A3A28242AD7}"/>
               </a:ext>
             </a:extLst>
           </p:cNvPr>
@@ -8336,7 +8316,7 @@
           <p:cNvPr id="10" name="">
             <a:extLst xmlns:a="http://schemas.openxmlformats.org/drawingml/2006/main">
               <a:ext uri="{FF2B5EF4-FFF2-40B4-BE49-F238E27FC236}">
-                <a16:creationId xmlns:a16="http://schemas.microsoft.com/office/drawing/2014/main" id="{AEA78C8F-EAA9-449A-B8DB-3A1D34163F55}"/>
+                <a16:creationId xmlns:a16="http://schemas.microsoft.com/office/drawing/2014/main" id="{D1F1EAD1-A2C9-442A-A0F0-07832019657F}"/>
               </a:ext>
             </a:extLst>
           </p:cNvPr>
@@ -8398,7 +8378,7 @@
           <p:cNvPr id="11" name="">
             <a:extLst xmlns:a="http://schemas.openxmlformats.org/drawingml/2006/main">
               <a:ext uri="{FF2B5EF4-FFF2-40B4-BE49-F238E27FC236}">
-                <a16:creationId xmlns:a16="http://schemas.microsoft.com/office/drawing/2014/main" id="{25CD10ED-9841-4367-9E7E-B0E57FB383F1}"/>
+                <a16:creationId xmlns:a16="http://schemas.microsoft.com/office/drawing/2014/main" id="{79D664F3-9963-4219-B157-EB8FE0F587A1}"/>
               </a:ext>
             </a:extLst>
           </p:cNvPr>
@@ -8429,7 +8409,7 @@
           <p:cNvPr id="12" name="">
             <a:extLst xmlns:a="http://schemas.openxmlformats.org/drawingml/2006/main">
               <a:ext uri="{FF2B5EF4-FFF2-40B4-BE49-F238E27FC236}">
-                <a16:creationId xmlns:a16="http://schemas.microsoft.com/office/drawing/2014/main" id="{4CF7E23B-5B7B-475E-B2FE-4D928C7B0087}"/>
+                <a16:creationId xmlns:a16="http://schemas.microsoft.com/office/drawing/2014/main" id="{DC663217-89D0-4CBC-89DF-AE1A32F29A93}"/>
               </a:ext>
             </a:extLst>
           </p:cNvPr>
@@ -8491,7 +8471,7 @@
           <p:cNvPr id="13" name="">
             <a:extLst xmlns:a="http://schemas.openxmlformats.org/drawingml/2006/main">
               <a:ext uri="{FF2B5EF4-FFF2-40B4-BE49-F238E27FC236}">
-                <a16:creationId xmlns:a16="http://schemas.microsoft.com/office/drawing/2014/main" id="{370B4D10-8229-4A38-AF27-8FC3B2C318FB}"/>
+                <a16:creationId xmlns:a16="http://schemas.microsoft.com/office/drawing/2014/main" id="{B2873E3F-5F08-4BB8-ACBF-C50C252E995E}"/>
               </a:ext>
             </a:extLst>
           </p:cNvPr>
@@ -8553,7 +8533,7 @@
           <p:cNvPr id="14" name="">
             <a:extLst xmlns:a="http://schemas.openxmlformats.org/drawingml/2006/main">
               <a:ext uri="{FF2B5EF4-FFF2-40B4-BE49-F238E27FC236}">
-                <a16:creationId xmlns:a16="http://schemas.microsoft.com/office/drawing/2014/main" id="{86547992-9363-4C81-B97C-7AB1C73A12B0}"/>
+                <a16:creationId xmlns:a16="http://schemas.microsoft.com/office/drawing/2014/main" id="{D282DAEF-B3A8-4BB6-8E66-146E9A112D0B}"/>
               </a:ext>
             </a:extLst>
           </p:cNvPr>
@@ -8615,7 +8595,7 @@
           <p:cNvPr id="15" name="">
             <a:extLst xmlns:a="http://schemas.openxmlformats.org/drawingml/2006/main">
               <a:ext uri="{FF2B5EF4-FFF2-40B4-BE49-F238E27FC236}">
-                <a16:creationId xmlns:a16="http://schemas.microsoft.com/office/drawing/2014/main" id="{F3B85ED3-45D0-4DF7-A56D-FEA685D634F0}"/>
+                <a16:creationId xmlns:a16="http://schemas.microsoft.com/office/drawing/2014/main" id="{E63DEB49-259F-4EB3-A90C-564635B88E35}"/>
               </a:ext>
             </a:extLst>
           </p:cNvPr>
@@ -8646,7 +8626,7 @@
           <p:cNvPr id="16" name="">
             <a:extLst xmlns:a="http://schemas.openxmlformats.org/drawingml/2006/main">
               <a:ext uri="{FF2B5EF4-FFF2-40B4-BE49-F238E27FC236}">
-                <a16:creationId xmlns:a16="http://schemas.microsoft.com/office/drawing/2014/main" id="{9CF818E3-94C7-4597-BCB3-062AE8E325CA}"/>
+                <a16:creationId xmlns:a16="http://schemas.microsoft.com/office/drawing/2014/main" id="{8E496DF3-40C1-4E6D-BC3B-ADBB2A5EB887}"/>
               </a:ext>
             </a:extLst>
           </p:cNvPr>
@@ -8708,7 +8688,7 @@
           <p:cNvPr id="17" name="">
             <a:extLst xmlns:a="http://schemas.openxmlformats.org/drawingml/2006/main">
               <a:ext uri="{FF2B5EF4-FFF2-40B4-BE49-F238E27FC236}">
-                <a16:creationId xmlns:a16="http://schemas.microsoft.com/office/drawing/2014/main" id="{B7346C92-179F-4428-B4F0-097ADA824B15}"/>
+                <a16:creationId xmlns:a16="http://schemas.microsoft.com/office/drawing/2014/main" id="{DDD656AE-F42D-4F5C-BBBF-3063324C091A}"/>
               </a:ext>
             </a:extLst>
           </p:cNvPr>
@@ -8770,7 +8750,7 @@
           <p:cNvPr id="18" name="">
             <a:extLst xmlns:a="http://schemas.openxmlformats.org/drawingml/2006/main">
               <a:ext uri="{FF2B5EF4-FFF2-40B4-BE49-F238E27FC236}">
-                <a16:creationId xmlns:a16="http://schemas.microsoft.com/office/drawing/2014/main" id="{4B4EA409-4339-4C37-B7C4-83FB1FFDE149}"/>
+                <a16:creationId xmlns:a16="http://schemas.microsoft.com/office/drawing/2014/main" id="{EAC433BA-A542-4F5C-BCF3-63C2AF7BDCAC}"/>
               </a:ext>
             </a:extLst>
           </p:cNvPr>
@@ -8832,7 +8812,7 @@
           <p:cNvPr id="19" name="">
             <a:extLst xmlns:a="http://schemas.openxmlformats.org/drawingml/2006/main">
               <a:ext uri="{FF2B5EF4-FFF2-40B4-BE49-F238E27FC236}">
-                <a16:creationId xmlns:a16="http://schemas.microsoft.com/office/drawing/2014/main" id="{D005060F-71BB-454F-A5A4-38A9435AAC5E}"/>
+                <a16:creationId xmlns:a16="http://schemas.microsoft.com/office/drawing/2014/main" id="{AAF5C1B2-9261-4053-94CE-34F0D6C52D60}"/>
               </a:ext>
             </a:extLst>
           </p:cNvPr>
@@ -8865,7 +8845,7 @@
           <p:cNvPr id="20" name="">
             <a:extLst xmlns:a="http://schemas.openxmlformats.org/drawingml/2006/main">
               <a:ext uri="{FF2B5EF4-FFF2-40B4-BE49-F238E27FC236}">
-                <a16:creationId xmlns:a16="http://schemas.microsoft.com/office/drawing/2014/main" id="{10E49677-5A81-4F99-A204-27409B808362}"/>
+                <a16:creationId xmlns:a16="http://schemas.microsoft.com/office/drawing/2014/main" id="{C178CCA4-9DD7-4314-B8D5-8BBF8FD40BA1}"/>
               </a:ext>
             </a:extLst>
           </p:cNvPr>
@@ -8927,7 +8907,7 @@
           <p:cNvPr id="21" name="footer-rule-14">
             <a:extLst xmlns:a="http://schemas.openxmlformats.org/drawingml/2006/main">
               <a:ext uri="{FF2B5EF4-FFF2-40B4-BE49-F238E27FC236}">
-                <a16:creationId xmlns:a16="http://schemas.microsoft.com/office/drawing/2014/main" id="{8130C154-D678-4D5F-90B9-D3244C2EC448}"/>
+                <a16:creationId xmlns:a16="http://schemas.microsoft.com/office/drawing/2014/main" id="{AE1066EB-1B4A-4BDC-B627-E9152365CEA0}"/>
               </a:ext>
             </a:extLst>
           </p:cNvPr>
@@ -8958,7 +8938,7 @@
           <p:cNvPr id="22" name="footer-label-14">
             <a:extLst xmlns:a="http://schemas.openxmlformats.org/drawingml/2006/main">
               <a:ext uri="{FF2B5EF4-FFF2-40B4-BE49-F238E27FC236}">
-                <a16:creationId xmlns:a16="http://schemas.microsoft.com/office/drawing/2014/main" id="{1ECA81E3-8217-4D0B-BC47-A02AE8B34148}"/>
+                <a16:creationId xmlns:a16="http://schemas.microsoft.com/office/drawing/2014/main" id="{05FD0C01-1E9D-4EA1-AFBB-9EDB873E884B}"/>
               </a:ext>
             </a:extLst>
           </p:cNvPr>
@@ -9020,7 +9000,7 @@
           <p:cNvPr id="23" name="footer-page-14">
             <a:extLst xmlns:a="http://schemas.openxmlformats.org/drawingml/2006/main">
               <a:ext uri="{FF2B5EF4-FFF2-40B4-BE49-F238E27FC236}">
-                <a16:creationId xmlns:a16="http://schemas.microsoft.com/office/drawing/2014/main" id="{EC9CC329-0E3D-4AD8-AF8F-CA7D9094EAA7}"/>
+                <a16:creationId xmlns:a16="http://schemas.microsoft.com/office/drawing/2014/main" id="{12AB1DA2-BD9A-4251-A6CB-C5D5FD627C1A}"/>
               </a:ext>
             </a:extLst>
           </p:cNvPr>
@@ -9080,7 +9060,7 @@
     </p:spTree>
     <p:extLst>
       <p:ext uri="{BB962C8B-B14F-4D97-AF65-F5344CB8AC3E}">
-        <p14:creationId xmlns:p14="http://schemas.microsoft.com/office/powerpoint/2010/main" val="2131735040"/>
+        <p14:creationId xmlns:p14="http://schemas.microsoft.com/office/powerpoint/2010/main" val="346054975"/>
       </p:ext>
     </p:extLst>
   </p:cSld>
@@ -9111,7 +9091,7 @@
           <p:cNvPr id="21" name="side-accent-15">
             <a:extLst xmlns:a="http://schemas.openxmlformats.org/drawingml/2006/main">
               <a:ext uri="{FF2B5EF4-FFF2-40B4-BE49-F238E27FC236}">
-                <a16:creationId xmlns:a16="http://schemas.microsoft.com/office/drawing/2014/main" id="{65E8F0B2-3A22-490F-94A8-E98CA0C95D13}"/>
+                <a16:creationId xmlns:a16="http://schemas.microsoft.com/office/drawing/2014/main" id="{65DE5D91-1B85-4822-9147-62327A9D6A00}"/>
               </a:ext>
             </a:extLst>
           </p:cNvPr>
@@ -9142,7 +9122,7 @@
           <p:cNvPr id="2" name="kicker-15">
             <a:extLst xmlns:a="http://schemas.openxmlformats.org/drawingml/2006/main">
               <a:ext uri="{FF2B5EF4-FFF2-40B4-BE49-F238E27FC236}">
-                <a16:creationId xmlns:a16="http://schemas.microsoft.com/office/drawing/2014/main" id="{16D2208A-426C-43E0-A81A-77549A0E4AD0}"/>
+                <a16:creationId xmlns:a16="http://schemas.microsoft.com/office/drawing/2014/main" id="{F861F1D8-6458-42E1-AC56-734EF3A7CE00}"/>
               </a:ext>
             </a:extLst>
           </p:cNvPr>
@@ -9204,7 +9184,7 @@
           <p:cNvPr id="3" name="title-15">
             <a:extLst xmlns:a="http://schemas.openxmlformats.org/drawingml/2006/main">
               <a:ext uri="{FF2B5EF4-FFF2-40B4-BE49-F238E27FC236}">
-                <a16:creationId xmlns:a16="http://schemas.microsoft.com/office/drawing/2014/main" id="{DDCD7F3E-5E38-419B-8FE8-D71410E51A7F}"/>
+                <a16:creationId xmlns:a16="http://schemas.microsoft.com/office/drawing/2014/main" id="{9A258906-983B-4D85-8C15-C71384C6CC15}"/>
               </a:ext>
             </a:extLst>
           </p:cNvPr>
@@ -9266,7 +9246,7 @@
           <p:cNvPr id="4" name="">
             <a:extLst xmlns:a="http://schemas.openxmlformats.org/drawingml/2006/main">
               <a:ext uri="{FF2B5EF4-FFF2-40B4-BE49-F238E27FC236}">
-                <a16:creationId xmlns:a16="http://schemas.microsoft.com/office/drawing/2014/main" id="{068AFDB4-7B4E-466F-9692-839B9AB654B6}"/>
+                <a16:creationId xmlns:a16="http://schemas.microsoft.com/office/drawing/2014/main" id="{9D78E473-3B3B-4E8C-97A9-D48CC64554B3}"/>
               </a:ext>
             </a:extLst>
           </p:cNvPr>
@@ -9297,7 +9277,7 @@
           <p:cNvPr id="5" name="">
             <a:extLst xmlns:a="http://schemas.openxmlformats.org/drawingml/2006/main">
               <a:ext uri="{FF2B5EF4-FFF2-40B4-BE49-F238E27FC236}">
-                <a16:creationId xmlns:a16="http://schemas.microsoft.com/office/drawing/2014/main" id="{3A727D31-1855-476A-8FEE-91B2320CAF34}"/>
+                <a16:creationId xmlns:a16="http://schemas.microsoft.com/office/drawing/2014/main" id="{1F9AC738-43EC-4F8A-AC61-5299E82B01F0}"/>
               </a:ext>
             </a:extLst>
           </p:cNvPr>
@@ -9328,7 +9308,7 @@
           <p:cNvPr id="6" name="">
             <a:extLst xmlns:a="http://schemas.openxmlformats.org/drawingml/2006/main">
               <a:ext uri="{FF2B5EF4-FFF2-40B4-BE49-F238E27FC236}">
-                <a16:creationId xmlns:a16="http://schemas.microsoft.com/office/drawing/2014/main" id="{49BDC3A1-B96E-4B9E-B06E-7B855A156E91}"/>
+                <a16:creationId xmlns:a16="http://schemas.microsoft.com/office/drawing/2014/main" id="{941FDAAF-8CE5-490A-ACE9-4C39A47B11B9}"/>
               </a:ext>
             </a:extLst>
           </p:cNvPr>
@@ -9390,7 +9370,7 @@
           <p:cNvPr id="7" name="">
             <a:extLst xmlns:a="http://schemas.openxmlformats.org/drawingml/2006/main">
               <a:ext uri="{FF2B5EF4-FFF2-40B4-BE49-F238E27FC236}">
-                <a16:creationId xmlns:a16="http://schemas.microsoft.com/office/drawing/2014/main" id="{76C8AE93-5C0A-4F69-986A-645BD28EC842}"/>
+                <a16:creationId xmlns:a16="http://schemas.microsoft.com/office/drawing/2014/main" id="{FA9C59B0-4986-486F-B396-DBB0EE2B6D27}"/>
               </a:ext>
             </a:extLst>
           </p:cNvPr>
@@ -9452,7 +9432,7 @@
           <p:cNvPr id="8" name="">
             <a:extLst xmlns:a="http://schemas.openxmlformats.org/drawingml/2006/main">
               <a:ext uri="{FF2B5EF4-FFF2-40B4-BE49-F238E27FC236}">
-                <a16:creationId xmlns:a16="http://schemas.microsoft.com/office/drawing/2014/main" id="{D87DCC1B-4501-4E3D-86AD-0C0380CFBFF2}"/>
+                <a16:creationId xmlns:a16="http://schemas.microsoft.com/office/drawing/2014/main" id="{B10391D4-4116-4E87-870A-6A4792AF5488}"/>
               </a:ext>
             </a:extLst>
           </p:cNvPr>
@@ -9514,7 +9494,7 @@
           <p:cNvPr id="9" name="">
             <a:extLst xmlns:a="http://schemas.openxmlformats.org/drawingml/2006/main">
               <a:ext uri="{FF2B5EF4-FFF2-40B4-BE49-F238E27FC236}">
-                <a16:creationId xmlns:a16="http://schemas.microsoft.com/office/drawing/2014/main" id="{445471E6-D6E7-4FD5-913F-8AE4D42C551A}"/>
+                <a16:creationId xmlns:a16="http://schemas.microsoft.com/office/drawing/2014/main" id="{461CD313-C80E-4A48-8218-E90DCF14E553}"/>
               </a:ext>
             </a:extLst>
           </p:cNvPr>
@@ -9545,7 +9525,7 @@
           <p:cNvPr id="10" name="">
             <a:extLst xmlns:a="http://schemas.openxmlformats.org/drawingml/2006/main">
               <a:ext uri="{FF2B5EF4-FFF2-40B4-BE49-F238E27FC236}">
-                <a16:creationId xmlns:a16="http://schemas.microsoft.com/office/drawing/2014/main" id="{C28F477F-7705-408A-96D6-0F5FBB36FFAE}"/>
+                <a16:creationId xmlns:a16="http://schemas.microsoft.com/office/drawing/2014/main" id="{DAC42356-F852-4095-AFCB-243C52ECB345}"/>
               </a:ext>
             </a:extLst>
           </p:cNvPr>
@@ -9607,7 +9587,7 @@
           <p:cNvPr id="11" name="">
             <a:extLst xmlns:a="http://schemas.openxmlformats.org/drawingml/2006/main">
               <a:ext uri="{FF2B5EF4-FFF2-40B4-BE49-F238E27FC236}">
-                <a16:creationId xmlns:a16="http://schemas.microsoft.com/office/drawing/2014/main" id="{D2892893-3206-481C-BADC-46329804D61C}"/>
+                <a16:creationId xmlns:a16="http://schemas.microsoft.com/office/drawing/2014/main" id="{391D01D0-8B6C-4DA4-9895-BFC4D3D66D28}"/>
               </a:ext>
             </a:extLst>
           </p:cNvPr>
@@ -9669,7 +9649,7 @@
           <p:cNvPr id="12" name="">
             <a:extLst xmlns:a="http://schemas.openxmlformats.org/drawingml/2006/main">
               <a:ext uri="{FF2B5EF4-FFF2-40B4-BE49-F238E27FC236}">
-                <a16:creationId xmlns:a16="http://schemas.microsoft.com/office/drawing/2014/main" id="{5D12E9CF-686A-408A-825E-D305F527A20D}"/>
+                <a16:creationId xmlns:a16="http://schemas.microsoft.com/office/drawing/2014/main" id="{6C46357F-F1FE-42F4-AFB1-FEBD061FA35E}"/>
               </a:ext>
             </a:extLst>
           </p:cNvPr>
@@ -9731,7 +9711,7 @@
           <p:cNvPr id="13" name="">
             <a:extLst xmlns:a="http://schemas.openxmlformats.org/drawingml/2006/main">
               <a:ext uri="{FF2B5EF4-FFF2-40B4-BE49-F238E27FC236}">
-                <a16:creationId xmlns:a16="http://schemas.microsoft.com/office/drawing/2014/main" id="{4FBAE909-000B-4207-B95B-24951917F2FC}"/>
+                <a16:creationId xmlns:a16="http://schemas.microsoft.com/office/drawing/2014/main" id="{280193F9-5027-47A8-85C4-9DB55232F037}"/>
               </a:ext>
             </a:extLst>
           </p:cNvPr>
@@ -9762,7 +9742,7 @@
           <p:cNvPr id="14" name="">
             <a:extLst xmlns:a="http://schemas.openxmlformats.org/drawingml/2006/main">
               <a:ext uri="{FF2B5EF4-FFF2-40B4-BE49-F238E27FC236}">
-                <a16:creationId xmlns:a16="http://schemas.microsoft.com/office/drawing/2014/main" id="{18C672F4-CCC9-4CBF-A8E3-3978B6ECEB47}"/>
+                <a16:creationId xmlns:a16="http://schemas.microsoft.com/office/drawing/2014/main" id="{84A1A169-D3E9-4506-B7DF-3D26B9914215}"/>
               </a:ext>
             </a:extLst>
           </p:cNvPr>
@@ -9824,7 +9804,7 @@
           <p:cNvPr id="15" name="">
             <a:extLst xmlns:a="http://schemas.openxmlformats.org/drawingml/2006/main">
               <a:ext uri="{FF2B5EF4-FFF2-40B4-BE49-F238E27FC236}">
-                <a16:creationId xmlns:a16="http://schemas.microsoft.com/office/drawing/2014/main" id="{416B3E0F-7013-4B8D-895E-11718061CC9E}"/>
+                <a16:creationId xmlns:a16="http://schemas.microsoft.com/office/drawing/2014/main" id="{A152CF58-1F96-4A4D-97BC-4AB2BC06ABA2}"/>
               </a:ext>
             </a:extLst>
           </p:cNvPr>
@@ -9886,7 +9866,7 @@
           <p:cNvPr id="16" name="">
             <a:extLst xmlns:a="http://schemas.openxmlformats.org/drawingml/2006/main">
               <a:ext uri="{FF2B5EF4-FFF2-40B4-BE49-F238E27FC236}">
-                <a16:creationId xmlns:a16="http://schemas.microsoft.com/office/drawing/2014/main" id="{AB6B2A83-E7BD-47A2-A1B7-D77D835C974F}"/>
+                <a16:creationId xmlns:a16="http://schemas.microsoft.com/office/drawing/2014/main" id="{D71A292C-99D0-4E03-8CEA-8A9557203CC8}"/>
               </a:ext>
             </a:extLst>
           </p:cNvPr>
@@ -9948,7 +9928,7 @@
           <p:cNvPr id="17" name="">
             <a:extLst xmlns:a="http://schemas.openxmlformats.org/drawingml/2006/main">
               <a:ext uri="{FF2B5EF4-FFF2-40B4-BE49-F238E27FC236}">
-                <a16:creationId xmlns:a16="http://schemas.microsoft.com/office/drawing/2014/main" id="{D77DCBF5-9C4C-4F8A-AB14-6F38ACB26E74}"/>
+                <a16:creationId xmlns:a16="http://schemas.microsoft.com/office/drawing/2014/main" id="{0BB98FBC-3BD6-4ACD-ACC7-8D8ADB917878}"/>
               </a:ext>
             </a:extLst>
           </p:cNvPr>
@@ -10010,7 +9990,7 @@
           <p:cNvPr id="18" name="footer-rule-15">
             <a:extLst xmlns:a="http://schemas.openxmlformats.org/drawingml/2006/main">
               <a:ext uri="{FF2B5EF4-FFF2-40B4-BE49-F238E27FC236}">
-                <a16:creationId xmlns:a16="http://schemas.microsoft.com/office/drawing/2014/main" id="{F990B003-15A8-49E3-AC2A-869786177975}"/>
+                <a16:creationId xmlns:a16="http://schemas.microsoft.com/office/drawing/2014/main" id="{13DA2112-B57A-4AE3-B0A7-1BA91D933210}"/>
               </a:ext>
             </a:extLst>
           </p:cNvPr>
@@ -10041,7 +10021,7 @@
           <p:cNvPr id="19" name="footer-label-15">
             <a:extLst xmlns:a="http://schemas.openxmlformats.org/drawingml/2006/main">
               <a:ext uri="{FF2B5EF4-FFF2-40B4-BE49-F238E27FC236}">
-                <a16:creationId xmlns:a16="http://schemas.microsoft.com/office/drawing/2014/main" id="{05E30A51-5324-4086-9F23-C37943055C24}"/>
+                <a16:creationId xmlns:a16="http://schemas.microsoft.com/office/drawing/2014/main" id="{83621ED0-A6FC-42CB-BD80-E8E83483A1F7}"/>
               </a:ext>
             </a:extLst>
           </p:cNvPr>
@@ -10103,7 +10083,7 @@
           <p:cNvPr id="20" name="footer-page-15">
             <a:extLst xmlns:a="http://schemas.openxmlformats.org/drawingml/2006/main">
               <a:ext uri="{FF2B5EF4-FFF2-40B4-BE49-F238E27FC236}">
-                <a16:creationId xmlns:a16="http://schemas.microsoft.com/office/drawing/2014/main" id="{9B674EBC-4D6F-4DD9-B51F-3BA77CCE0653}"/>
+                <a16:creationId xmlns:a16="http://schemas.microsoft.com/office/drawing/2014/main" id="{ED87F764-E28E-4ABD-9B65-E832E77922BB}"/>
               </a:ext>
             </a:extLst>
           </p:cNvPr>
@@ -10163,7 +10143,7 @@
     </p:spTree>
     <p:extLst>
       <p:ext uri="{BB962C8B-B14F-4D97-AF65-F5344CB8AC3E}">
-        <p14:creationId xmlns:p14="http://schemas.microsoft.com/office/powerpoint/2010/main" val="952809358"/>
+        <p14:creationId xmlns:p14="http://schemas.microsoft.com/office/powerpoint/2010/main" val="810133022"/>
       </p:ext>
     </p:extLst>
   </p:cSld>
@@ -10194,7 +10174,7 @@
           <p:cNvPr id="11" name="">
             <a:extLst xmlns:a="http://schemas.openxmlformats.org/drawingml/2006/main">
               <a:ext uri="{FF2B5EF4-FFF2-40B4-BE49-F238E27FC236}">
-                <a16:creationId xmlns:a16="http://schemas.microsoft.com/office/drawing/2014/main" id="{55C890DD-7F03-4F9B-B5A3-88984F484177}"/>
+                <a16:creationId xmlns:a16="http://schemas.microsoft.com/office/drawing/2014/main" id="{2FEBB63A-29FA-48B5-B234-10506DDDE829}"/>
               </a:ext>
             </a:extLst>
           </p:cNvPr>
@@ -10225,7 +10205,7 @@
           <p:cNvPr id="2" name="">
             <a:extLst xmlns:a="http://schemas.openxmlformats.org/drawingml/2006/main">
               <a:ext uri="{FF2B5EF4-FFF2-40B4-BE49-F238E27FC236}">
-                <a16:creationId xmlns:a16="http://schemas.microsoft.com/office/drawing/2014/main" id="{239777F4-E490-4ED1-A880-599EC9E4D284}"/>
+                <a16:creationId xmlns:a16="http://schemas.microsoft.com/office/drawing/2014/main" id="{CF4D2B35-73A7-4B80-A687-BE290E2BC020}"/>
               </a:ext>
             </a:extLst>
           </p:cNvPr>
@@ -10287,7 +10267,7 @@
           <p:cNvPr id="3" name="">
             <a:extLst xmlns:a="http://schemas.openxmlformats.org/drawingml/2006/main">
               <a:ext uri="{FF2B5EF4-FFF2-40B4-BE49-F238E27FC236}">
-                <a16:creationId xmlns:a16="http://schemas.microsoft.com/office/drawing/2014/main" id="{E1528C5F-17F7-43A9-823F-BC6C6AF8E68F}"/>
+                <a16:creationId xmlns:a16="http://schemas.microsoft.com/office/drawing/2014/main" id="{B14BF846-7184-4534-84C0-9E16E39FC621}"/>
               </a:ext>
             </a:extLst>
           </p:cNvPr>
@@ -10376,7 +10356,7 @@
           <p:cNvPr id="4" name="">
             <a:extLst xmlns:a="http://schemas.openxmlformats.org/drawingml/2006/main">
               <a:ext uri="{FF2B5EF4-FFF2-40B4-BE49-F238E27FC236}">
-                <a16:creationId xmlns:a16="http://schemas.microsoft.com/office/drawing/2014/main" id="{9F91BEC7-C76F-498E-A273-B04B1CFE2D98}"/>
+                <a16:creationId xmlns:a16="http://schemas.microsoft.com/office/drawing/2014/main" id="{150AAF56-6778-490E-AF87-E85D9AD78428}"/>
               </a:ext>
             </a:extLst>
           </p:cNvPr>
@@ -10438,7 +10418,7 @@
           <p:cNvPr id="5" name="">
             <a:extLst xmlns:a="http://schemas.openxmlformats.org/drawingml/2006/main">
               <a:ext uri="{FF2B5EF4-FFF2-40B4-BE49-F238E27FC236}">
-                <a16:creationId xmlns:a16="http://schemas.microsoft.com/office/drawing/2014/main" id="{F9B9C9D0-85F5-45F0-9B72-2551A871A366}"/>
+                <a16:creationId xmlns:a16="http://schemas.microsoft.com/office/drawing/2014/main" id="{9F77C05A-A466-4E5E-94E9-B8C11981EE9A}"/>
               </a:ext>
             </a:extLst>
           </p:cNvPr>
@@ -10471,7 +10451,7 @@
           <p:cNvPr id="6" name="">
             <a:extLst xmlns:a="http://schemas.openxmlformats.org/drawingml/2006/main">
               <a:ext uri="{FF2B5EF4-FFF2-40B4-BE49-F238E27FC236}">
-                <a16:creationId xmlns:a16="http://schemas.microsoft.com/office/drawing/2014/main" id="{20CDA5A5-B229-4515-BBD1-D7D9A3D252BD}"/>
+                <a16:creationId xmlns:a16="http://schemas.microsoft.com/office/drawing/2014/main" id="{61252D34-F6E0-49AB-B1A6-FFF5F51BCBCE}"/>
               </a:ext>
             </a:extLst>
           </p:cNvPr>
@@ -10533,7 +10513,7 @@
           <p:cNvPr id="7" name="">
             <a:extLst xmlns:a="http://schemas.openxmlformats.org/drawingml/2006/main">
               <a:ext uri="{FF2B5EF4-FFF2-40B4-BE49-F238E27FC236}">
-                <a16:creationId xmlns:a16="http://schemas.microsoft.com/office/drawing/2014/main" id="{25AD7F2A-8C6F-4F70-B9C0-8415D3FD9B1E}"/>
+                <a16:creationId xmlns:a16="http://schemas.microsoft.com/office/drawing/2014/main" id="{23FE2508-0555-44FC-B2D6-4465EDF8CAB7}"/>
               </a:ext>
             </a:extLst>
           </p:cNvPr>
@@ -10595,7 +10575,7 @@
           <p:cNvPr id="8" name="">
             <a:extLst xmlns:a="http://schemas.openxmlformats.org/drawingml/2006/main">
               <a:ext uri="{FF2B5EF4-FFF2-40B4-BE49-F238E27FC236}">
-                <a16:creationId xmlns:a16="http://schemas.microsoft.com/office/drawing/2014/main" id="{D1A97E3D-E0EA-4B00-B094-797013FAA54E}"/>
+                <a16:creationId xmlns:a16="http://schemas.microsoft.com/office/drawing/2014/main" id="{97CF94C5-8E78-48F6-8BB6-058FA6E8AF5E}"/>
               </a:ext>
             </a:extLst>
           </p:cNvPr>
@@ -10684,7 +10664,7 @@
           <p:cNvPr id="9" name="">
             <a:extLst xmlns:a="http://schemas.openxmlformats.org/drawingml/2006/main">
               <a:ext uri="{FF2B5EF4-FFF2-40B4-BE49-F238E27FC236}">
-                <a16:creationId xmlns:a16="http://schemas.microsoft.com/office/drawing/2014/main" id="{2CDEAE77-25CF-4841-BB14-E5E8F3FF23D2}"/>
+                <a16:creationId xmlns:a16="http://schemas.microsoft.com/office/drawing/2014/main" id="{CC0C1186-4F4E-44A5-8E89-E97ECEEC5D9B}"/>
               </a:ext>
             </a:extLst>
           </p:cNvPr>
@@ -10746,7 +10726,7 @@
           <p:cNvPr id="10" name="">
             <a:extLst xmlns:a="http://schemas.openxmlformats.org/drawingml/2006/main">
               <a:ext uri="{FF2B5EF4-FFF2-40B4-BE49-F238E27FC236}">
-                <a16:creationId xmlns:a16="http://schemas.microsoft.com/office/drawing/2014/main" id="{8C70A26D-F96E-493E-B226-558423428A67}"/>
+                <a16:creationId xmlns:a16="http://schemas.microsoft.com/office/drawing/2014/main" id="{C1769757-AC2C-45D1-91E9-D0B509C32A56}"/>
               </a:ext>
             </a:extLst>
           </p:cNvPr>
@@ -10806,7 +10786,7 @@
     </p:spTree>
     <p:extLst>
       <p:ext uri="{BB962C8B-B14F-4D97-AF65-F5344CB8AC3E}">
-        <p14:creationId xmlns:p14="http://schemas.microsoft.com/office/powerpoint/2010/main" val="1167331332"/>
+        <p14:creationId xmlns:p14="http://schemas.microsoft.com/office/powerpoint/2010/main" val="207291217"/>
       </p:ext>
     </p:extLst>
   </p:cSld>
@@ -10837,7 +10817,7 @@
           <p:cNvPr id="22" name="side-accent-17">
             <a:extLst xmlns:a="http://schemas.openxmlformats.org/drawingml/2006/main">
               <a:ext uri="{FF2B5EF4-FFF2-40B4-BE49-F238E27FC236}">
-                <a16:creationId xmlns:a16="http://schemas.microsoft.com/office/drawing/2014/main" id="{6B13CA2B-202B-42CE-906F-FDEE0BEEC295}"/>
+                <a16:creationId xmlns:a16="http://schemas.microsoft.com/office/drawing/2014/main" id="{2607A672-FF1E-43CD-97CD-E7ED72AEE16C}"/>
               </a:ext>
             </a:extLst>
           </p:cNvPr>
@@ -10868,7 +10848,7 @@
           <p:cNvPr id="2" name="kicker-17">
             <a:extLst xmlns:a="http://schemas.openxmlformats.org/drawingml/2006/main">
               <a:ext uri="{FF2B5EF4-FFF2-40B4-BE49-F238E27FC236}">
-                <a16:creationId xmlns:a16="http://schemas.microsoft.com/office/drawing/2014/main" id="{35D5B3CF-B37D-4B54-8F53-60A4F2F62289}"/>
+                <a16:creationId xmlns:a16="http://schemas.microsoft.com/office/drawing/2014/main" id="{40F98F5F-87B1-412B-AE7D-E48F1AA50CA8}"/>
               </a:ext>
             </a:extLst>
           </p:cNvPr>
@@ -10930,7 +10910,7 @@
           <p:cNvPr id="3" name="title-17">
             <a:extLst xmlns:a="http://schemas.openxmlformats.org/drawingml/2006/main">
               <a:ext uri="{FF2B5EF4-FFF2-40B4-BE49-F238E27FC236}">
-                <a16:creationId xmlns:a16="http://schemas.microsoft.com/office/drawing/2014/main" id="{4AD2C962-6B18-47EC-B89C-072105A2AC05}"/>
+                <a16:creationId xmlns:a16="http://schemas.microsoft.com/office/drawing/2014/main" id="{195A18FB-9BAB-468A-B5BB-F7895FB94D7A}"/>
               </a:ext>
             </a:extLst>
           </p:cNvPr>
@@ -10992,7 +10972,7 @@
           <p:cNvPr id="4" name="">
             <a:extLst xmlns:a="http://schemas.openxmlformats.org/drawingml/2006/main">
               <a:ext uri="{FF2B5EF4-FFF2-40B4-BE49-F238E27FC236}">
-                <a16:creationId xmlns:a16="http://schemas.microsoft.com/office/drawing/2014/main" id="{9F407690-D2E8-4EFE-9F5A-6C4103B5F6C1}"/>
+                <a16:creationId xmlns:a16="http://schemas.microsoft.com/office/drawing/2014/main" id="{E4460265-0EC3-4F2B-8BA7-285BA25AF361}"/>
               </a:ext>
             </a:extLst>
           </p:cNvPr>
@@ -11054,7 +11034,7 @@
           <p:cNvPr id="5" name="">
             <a:extLst xmlns:a="http://schemas.openxmlformats.org/drawingml/2006/main">
               <a:ext uri="{FF2B5EF4-FFF2-40B4-BE49-F238E27FC236}">
-                <a16:creationId xmlns:a16="http://schemas.microsoft.com/office/drawing/2014/main" id="{1089F501-1FEC-424C-85E9-F8B7E8CDE27A}"/>
+                <a16:creationId xmlns:a16="http://schemas.microsoft.com/office/drawing/2014/main" id="{266250CD-3BF5-4036-8CB1-D77ADA7B8B71}"/>
               </a:ext>
             </a:extLst>
           </p:cNvPr>
@@ -11085,7 +11065,7 @@
           <p:cNvPr id="6" name="">
             <a:extLst xmlns:a="http://schemas.openxmlformats.org/drawingml/2006/main">
               <a:ext uri="{FF2B5EF4-FFF2-40B4-BE49-F238E27FC236}">
-                <a16:creationId xmlns:a16="http://schemas.microsoft.com/office/drawing/2014/main" id="{E26F98A7-96B9-4784-86A2-B6EA31D46738}"/>
+                <a16:creationId xmlns:a16="http://schemas.microsoft.com/office/drawing/2014/main" id="{9F16DC3A-01F6-40C8-ADED-27C5690773D4}"/>
               </a:ext>
             </a:extLst>
           </p:cNvPr>
@@ -11147,7 +11127,7 @@
           <p:cNvPr id="7" name="">
             <a:extLst xmlns:a="http://schemas.openxmlformats.org/drawingml/2006/main">
               <a:ext uri="{FF2B5EF4-FFF2-40B4-BE49-F238E27FC236}">
-                <a16:creationId xmlns:a16="http://schemas.microsoft.com/office/drawing/2014/main" id="{F46DBAC2-D280-4DE3-82BA-FAA233C5E5B8}"/>
+                <a16:creationId xmlns:a16="http://schemas.microsoft.com/office/drawing/2014/main" id="{EE7789FA-928B-496D-8A8E-1AA2A09F74CD}"/>
               </a:ext>
             </a:extLst>
           </p:cNvPr>
@@ -11209,7 +11189,7 @@
           <p:cNvPr id="8" name="">
             <a:extLst xmlns:a="http://schemas.openxmlformats.org/drawingml/2006/main">
               <a:ext uri="{FF2B5EF4-FFF2-40B4-BE49-F238E27FC236}">
-                <a16:creationId xmlns:a16="http://schemas.microsoft.com/office/drawing/2014/main" id="{EE9D2A76-936F-46EE-9D06-DA4B67B73539}"/>
+                <a16:creationId xmlns:a16="http://schemas.microsoft.com/office/drawing/2014/main" id="{A13ED775-DE02-4076-AD57-C27611EC19B4}"/>
               </a:ext>
             </a:extLst>
           </p:cNvPr>
@@ -11240,7 +11220,7 @@
           <p:cNvPr id="9" name="">
             <a:extLst xmlns:a="http://schemas.openxmlformats.org/drawingml/2006/main">
               <a:ext uri="{FF2B5EF4-FFF2-40B4-BE49-F238E27FC236}">
-                <a16:creationId xmlns:a16="http://schemas.microsoft.com/office/drawing/2014/main" id="{7600CEFC-E6A9-4F43-8D9A-78D92D3B0899}"/>
+                <a16:creationId xmlns:a16="http://schemas.microsoft.com/office/drawing/2014/main" id="{32CC115B-89B1-4810-BD38-ECE0A13542F3}"/>
               </a:ext>
             </a:extLst>
           </p:cNvPr>
@@ -11302,7 +11282,7 @@
           <p:cNvPr id="10" name="">
             <a:extLst xmlns:a="http://schemas.openxmlformats.org/drawingml/2006/main">
               <a:ext uri="{FF2B5EF4-FFF2-40B4-BE49-F238E27FC236}">
-                <a16:creationId xmlns:a16="http://schemas.microsoft.com/office/drawing/2014/main" id="{9209C532-69F5-482F-8172-5D5F21FCFC3F}"/>
+                <a16:creationId xmlns:a16="http://schemas.microsoft.com/office/drawing/2014/main" id="{E91EF92E-C426-46B3-B33C-DBB3F695C109}"/>
               </a:ext>
             </a:extLst>
           </p:cNvPr>
@@ -11364,7 +11344,7 @@
           <p:cNvPr id="11" name="">
             <a:extLst xmlns:a="http://schemas.openxmlformats.org/drawingml/2006/main">
               <a:ext uri="{FF2B5EF4-FFF2-40B4-BE49-F238E27FC236}">
-                <a16:creationId xmlns:a16="http://schemas.microsoft.com/office/drawing/2014/main" id="{9CC49C3C-2092-4785-BBC3-422E7A2E0B16}"/>
+                <a16:creationId xmlns:a16="http://schemas.microsoft.com/office/drawing/2014/main" id="{B38CE94B-B1DB-4814-89C0-58DD9C58EF0F}"/>
               </a:ext>
             </a:extLst>
           </p:cNvPr>
@@ -11395,7 +11375,7 @@
           <p:cNvPr id="12" name="">
             <a:extLst xmlns:a="http://schemas.openxmlformats.org/drawingml/2006/main">
               <a:ext uri="{FF2B5EF4-FFF2-40B4-BE49-F238E27FC236}">
-                <a16:creationId xmlns:a16="http://schemas.microsoft.com/office/drawing/2014/main" id="{2BDE9AF3-38F1-4ED3-8116-65124CCE4624}"/>
+                <a16:creationId xmlns:a16="http://schemas.microsoft.com/office/drawing/2014/main" id="{2F172379-FABB-419D-B624-9F1DB964DDF0}"/>
               </a:ext>
             </a:extLst>
           </p:cNvPr>
@@ -11457,7 +11437,7 @@
           <p:cNvPr id="13" name="">
             <a:extLst xmlns:a="http://schemas.openxmlformats.org/drawingml/2006/main">
               <a:ext uri="{FF2B5EF4-FFF2-40B4-BE49-F238E27FC236}">
-                <a16:creationId xmlns:a16="http://schemas.microsoft.com/office/drawing/2014/main" id="{8764CC31-3E33-4F79-BFAD-87DACA282EF6}"/>
+                <a16:creationId xmlns:a16="http://schemas.microsoft.com/office/drawing/2014/main" id="{D9844777-B76F-425B-BA8C-C5773212623E}"/>
               </a:ext>
             </a:extLst>
           </p:cNvPr>
@@ -11519,7 +11499,7 @@
           <p:cNvPr id="14" name="">
             <a:extLst xmlns:a="http://schemas.openxmlformats.org/drawingml/2006/main">
               <a:ext uri="{FF2B5EF4-FFF2-40B4-BE49-F238E27FC236}">
-                <a16:creationId xmlns:a16="http://schemas.microsoft.com/office/drawing/2014/main" id="{6E26EBB7-BEB7-41A3-84D5-16A4946EB796}"/>
+                <a16:creationId xmlns:a16="http://schemas.microsoft.com/office/drawing/2014/main" id="{60BC495C-B470-4C02-A159-D532137DBC29}"/>
               </a:ext>
             </a:extLst>
           </p:cNvPr>
@@ -11550,7 +11530,7 @@
           <p:cNvPr id="15" name="">
             <a:extLst xmlns:a="http://schemas.openxmlformats.org/drawingml/2006/main">
               <a:ext uri="{FF2B5EF4-FFF2-40B4-BE49-F238E27FC236}">
-                <a16:creationId xmlns:a16="http://schemas.microsoft.com/office/drawing/2014/main" id="{B9BF14D3-EDAD-4585-BF45-10BD695D8529}"/>
+                <a16:creationId xmlns:a16="http://schemas.microsoft.com/office/drawing/2014/main" id="{2EC49B80-7CAD-48DB-8744-95AB34F238E1}"/>
               </a:ext>
             </a:extLst>
           </p:cNvPr>
@@ -11612,7 +11592,7 @@
           <p:cNvPr id="16" name="">
             <a:extLst xmlns:a="http://schemas.openxmlformats.org/drawingml/2006/main">
               <a:ext uri="{FF2B5EF4-FFF2-40B4-BE49-F238E27FC236}">
-                <a16:creationId xmlns:a16="http://schemas.microsoft.com/office/drawing/2014/main" id="{B1CC3479-166E-4609-BE65-224DB69DBA57}"/>
+                <a16:creationId xmlns:a16="http://schemas.microsoft.com/office/drawing/2014/main" id="{793BDD5F-9650-45F5-9C3E-F9C0511948C4}"/>
               </a:ext>
             </a:extLst>
           </p:cNvPr>
@@ -11674,7 +11654,7 @@
           <p:cNvPr id="17" name="">
             <a:extLst xmlns:a="http://schemas.openxmlformats.org/drawingml/2006/main">
               <a:ext uri="{FF2B5EF4-FFF2-40B4-BE49-F238E27FC236}">
-                <a16:creationId xmlns:a16="http://schemas.microsoft.com/office/drawing/2014/main" id="{63BEB550-07CA-4037-8C11-CD644C3202CA}"/>
+                <a16:creationId xmlns:a16="http://schemas.microsoft.com/office/drawing/2014/main" id="{7D9747FD-271C-4ACD-A8A7-EA37F6FE61B5}"/>
               </a:ext>
             </a:extLst>
           </p:cNvPr>
@@ -11707,7 +11687,7 @@
           <p:cNvPr id="18" name="">
             <a:extLst xmlns:a="http://schemas.openxmlformats.org/drawingml/2006/main">
               <a:ext uri="{FF2B5EF4-FFF2-40B4-BE49-F238E27FC236}">
-                <a16:creationId xmlns:a16="http://schemas.microsoft.com/office/drawing/2014/main" id="{B1B40B3C-AC2B-4A89-A931-E5588F59C49C}"/>
+                <a16:creationId xmlns:a16="http://schemas.microsoft.com/office/drawing/2014/main" id="{B1B14685-701A-4284-BE37-4D06F8F1A088}"/>
               </a:ext>
             </a:extLst>
           </p:cNvPr>
@@ -11769,7 +11749,7 @@
           <p:cNvPr id="19" name="footer-rule-17">
             <a:extLst xmlns:a="http://schemas.openxmlformats.org/drawingml/2006/main">
               <a:ext uri="{FF2B5EF4-FFF2-40B4-BE49-F238E27FC236}">
-                <a16:creationId xmlns:a16="http://schemas.microsoft.com/office/drawing/2014/main" id="{CCFE86E3-AB6C-4976-9159-AAB8E098C0E3}"/>
+                <a16:creationId xmlns:a16="http://schemas.microsoft.com/office/drawing/2014/main" id="{5A639236-83B9-4740-8BBE-E8692927FE65}"/>
               </a:ext>
             </a:extLst>
           </p:cNvPr>
@@ -11800,7 +11780,7 @@
           <p:cNvPr id="20" name="footer-label-17">
             <a:extLst xmlns:a="http://schemas.openxmlformats.org/drawingml/2006/main">
               <a:ext uri="{FF2B5EF4-FFF2-40B4-BE49-F238E27FC236}">
-                <a16:creationId xmlns:a16="http://schemas.microsoft.com/office/drawing/2014/main" id="{FE077FE7-1031-472B-A8E6-68E5A3DA71F6}"/>
+                <a16:creationId xmlns:a16="http://schemas.microsoft.com/office/drawing/2014/main" id="{86A16327-9993-4CE9-A7E8-45A06A17C50D}"/>
               </a:ext>
             </a:extLst>
           </p:cNvPr>
@@ -11862,7 +11842,7 @@
           <p:cNvPr id="21" name="footer-page-17">
             <a:extLst xmlns:a="http://schemas.openxmlformats.org/drawingml/2006/main">
               <a:ext uri="{FF2B5EF4-FFF2-40B4-BE49-F238E27FC236}">
-                <a16:creationId xmlns:a16="http://schemas.microsoft.com/office/drawing/2014/main" id="{9A9C69F0-8B12-4788-8471-8CD82746A3A3}"/>
+                <a16:creationId xmlns:a16="http://schemas.microsoft.com/office/drawing/2014/main" id="{8404C1F1-219E-4451-8EDB-E8CE6C0E1F76}"/>
               </a:ext>
             </a:extLst>
           </p:cNvPr>
@@ -11922,7 +11902,7 @@
     </p:spTree>
     <p:extLst>
       <p:ext uri="{BB962C8B-B14F-4D97-AF65-F5344CB8AC3E}">
-        <p14:creationId xmlns:p14="http://schemas.microsoft.com/office/powerpoint/2010/main" val="427539656"/>
+        <p14:creationId xmlns:p14="http://schemas.microsoft.com/office/powerpoint/2010/main" val="1883007895"/>
       </p:ext>
     </p:extLst>
   </p:cSld>
@@ -11953,7 +11933,7 @@
           <p:cNvPr id="25" name="side-accent-18">
             <a:extLst xmlns:a="http://schemas.openxmlformats.org/drawingml/2006/main">
               <a:ext uri="{FF2B5EF4-FFF2-40B4-BE49-F238E27FC236}">
-                <a16:creationId xmlns:a16="http://schemas.microsoft.com/office/drawing/2014/main" id="{DD3AC5B3-D01D-4653-BFBA-0F4C4309633A}"/>
+                <a16:creationId xmlns:a16="http://schemas.microsoft.com/office/drawing/2014/main" id="{46C45337-6A42-4895-93A3-5EE630505849}"/>
               </a:ext>
             </a:extLst>
           </p:cNvPr>
@@ -11984,7 +11964,7 @@
           <p:cNvPr id="2" name="kicker-18">
             <a:extLst xmlns:a="http://schemas.openxmlformats.org/drawingml/2006/main">
               <a:ext uri="{FF2B5EF4-FFF2-40B4-BE49-F238E27FC236}">
-                <a16:creationId xmlns:a16="http://schemas.microsoft.com/office/drawing/2014/main" id="{95F26A6D-48C9-4D32-A312-FC0C66D6883B}"/>
+                <a16:creationId xmlns:a16="http://schemas.microsoft.com/office/drawing/2014/main" id="{6F454CA1-5DA2-4E88-9843-634B32E3C1BA}"/>
               </a:ext>
             </a:extLst>
           </p:cNvPr>
@@ -12046,7 +12026,7 @@
           <p:cNvPr id="3" name="title-18">
             <a:extLst xmlns:a="http://schemas.openxmlformats.org/drawingml/2006/main">
               <a:ext uri="{FF2B5EF4-FFF2-40B4-BE49-F238E27FC236}">
-                <a16:creationId xmlns:a16="http://schemas.microsoft.com/office/drawing/2014/main" id="{AE753012-99A2-4A4C-A8AC-8CD6102B2C9E}"/>
+                <a16:creationId xmlns:a16="http://schemas.microsoft.com/office/drawing/2014/main" id="{6C907F55-270C-4F26-AAAE-0EBF48A1A476}"/>
               </a:ext>
             </a:extLst>
           </p:cNvPr>
@@ -12108,7 +12088,7 @@
           <p:cNvPr id="4" name="">
             <a:extLst xmlns:a="http://schemas.openxmlformats.org/drawingml/2006/main">
               <a:ext uri="{FF2B5EF4-FFF2-40B4-BE49-F238E27FC236}">
-                <a16:creationId xmlns:a16="http://schemas.microsoft.com/office/drawing/2014/main" id="{AAB41DC0-DE23-484E-81F7-37E076A00CD0}"/>
+                <a16:creationId xmlns:a16="http://schemas.microsoft.com/office/drawing/2014/main" id="{E5FE6E75-2017-48EB-903B-051AC86EE03A}"/>
               </a:ext>
             </a:extLst>
           </p:cNvPr>
@@ -12170,7 +12150,7 @@
           <p:cNvPr id="5" name="">
             <a:extLst xmlns:a="http://schemas.openxmlformats.org/drawingml/2006/main">
               <a:ext uri="{FF2B5EF4-FFF2-40B4-BE49-F238E27FC236}">
-                <a16:creationId xmlns:a16="http://schemas.microsoft.com/office/drawing/2014/main" id="{DAC8F901-CF7A-4F42-B1F7-1D2AD606F4A0}"/>
+                <a16:creationId xmlns:a16="http://schemas.microsoft.com/office/drawing/2014/main" id="{4DF15792-7A78-47F6-81C9-0BA51F2D8E82}"/>
               </a:ext>
             </a:extLst>
           </p:cNvPr>
@@ -12232,7 +12212,7 @@
           <p:cNvPr id="6" name="">
             <a:extLst xmlns:a="http://schemas.openxmlformats.org/drawingml/2006/main">
               <a:ext uri="{FF2B5EF4-FFF2-40B4-BE49-F238E27FC236}">
-                <a16:creationId xmlns:a16="http://schemas.microsoft.com/office/drawing/2014/main" id="{234B66DD-572B-41A8-907E-E3DD3E19A7A9}"/>
+                <a16:creationId xmlns:a16="http://schemas.microsoft.com/office/drawing/2014/main" id="{2D418D47-1AE4-46F8-8030-B1C17101E0CA}"/>
               </a:ext>
             </a:extLst>
           </p:cNvPr>
@@ -12294,7 +12274,7 @@
           <p:cNvPr id="7" name="">
             <a:extLst xmlns:a="http://schemas.openxmlformats.org/drawingml/2006/main">
               <a:ext uri="{FF2B5EF4-FFF2-40B4-BE49-F238E27FC236}">
-                <a16:creationId xmlns:a16="http://schemas.microsoft.com/office/drawing/2014/main" id="{3B373C9B-E12D-4895-A5A7-EA35F8515AE9}"/>
+                <a16:creationId xmlns:a16="http://schemas.microsoft.com/office/drawing/2014/main" id="{EBD9E9FF-9F81-43C5-B298-C58B143831C4}"/>
               </a:ext>
             </a:extLst>
           </p:cNvPr>
@@ -12325,7 +12305,7 @@
           <p:cNvPr id="8" name="">
             <a:extLst xmlns:a="http://schemas.openxmlformats.org/drawingml/2006/main">
               <a:ext uri="{FF2B5EF4-FFF2-40B4-BE49-F238E27FC236}">
-                <a16:creationId xmlns:a16="http://schemas.microsoft.com/office/drawing/2014/main" id="{AF8D74F4-658B-4305-A6D8-D4F06EE00A7F}"/>
+                <a16:creationId xmlns:a16="http://schemas.microsoft.com/office/drawing/2014/main" id="{4B93E80A-1226-48E7-92CE-DB29690138A3}"/>
               </a:ext>
             </a:extLst>
           </p:cNvPr>
@@ -12387,7 +12367,7 @@
           <p:cNvPr id="9" name="">
             <a:extLst xmlns:a="http://schemas.openxmlformats.org/drawingml/2006/main">
               <a:ext uri="{FF2B5EF4-FFF2-40B4-BE49-F238E27FC236}">
-                <a16:creationId xmlns:a16="http://schemas.microsoft.com/office/drawing/2014/main" id="{8D5C9B33-A78C-4C4E-95CD-50955F94459D}"/>
+                <a16:creationId xmlns:a16="http://schemas.microsoft.com/office/drawing/2014/main" id="{35BA8370-C39F-43F4-A4F1-3AA45A0604E4}"/>
               </a:ext>
             </a:extLst>
           </p:cNvPr>
@@ -12449,7 +12429,7 @@
           <p:cNvPr id="10" name="">
             <a:extLst xmlns:a="http://schemas.openxmlformats.org/drawingml/2006/main">
               <a:ext uri="{FF2B5EF4-FFF2-40B4-BE49-F238E27FC236}">
-                <a16:creationId xmlns:a16="http://schemas.microsoft.com/office/drawing/2014/main" id="{BC99F73A-D465-48C8-82C0-30569FB9857C}"/>
+                <a16:creationId xmlns:a16="http://schemas.microsoft.com/office/drawing/2014/main" id="{C4AA75C2-5DE4-4B69-BC40-3A026F528C85}"/>
               </a:ext>
             </a:extLst>
           </p:cNvPr>
@@ -12511,7 +12491,7 @@
           <p:cNvPr id="11" name="">
             <a:extLst xmlns:a="http://schemas.openxmlformats.org/drawingml/2006/main">
               <a:ext uri="{FF2B5EF4-FFF2-40B4-BE49-F238E27FC236}">
-                <a16:creationId xmlns:a16="http://schemas.microsoft.com/office/drawing/2014/main" id="{4F743074-4BCA-47A8-BDA1-58E2569D0128}"/>
+                <a16:creationId xmlns:a16="http://schemas.microsoft.com/office/drawing/2014/main" id="{4CAD8420-820A-4FBD-88E2-9A0B1A5155C0}"/>
               </a:ext>
             </a:extLst>
           </p:cNvPr>
@@ -12542,7 +12522,7 @@
           <p:cNvPr id="12" name="">
             <a:extLst xmlns:a="http://schemas.openxmlformats.org/drawingml/2006/main">
               <a:ext uri="{FF2B5EF4-FFF2-40B4-BE49-F238E27FC236}">
-                <a16:creationId xmlns:a16="http://schemas.microsoft.com/office/drawing/2014/main" id="{072A0386-B8F9-4B00-99CC-D9DB178406CA}"/>
+                <a16:creationId xmlns:a16="http://schemas.microsoft.com/office/drawing/2014/main" id="{8D23403F-9F69-4821-B431-F12E18104B66}"/>
               </a:ext>
             </a:extLst>
           </p:cNvPr>
@@ -12604,7 +12584,7 @@
           <p:cNvPr id="13" name="">
             <a:extLst xmlns:a="http://schemas.openxmlformats.org/drawingml/2006/main">
               <a:ext uri="{FF2B5EF4-FFF2-40B4-BE49-F238E27FC236}">
-                <a16:creationId xmlns:a16="http://schemas.microsoft.com/office/drawing/2014/main" id="{66054BB3-9C57-4E3B-8400-B0D7AFD3D680}"/>
+                <a16:creationId xmlns:a16="http://schemas.microsoft.com/office/drawing/2014/main" id="{8E85FC8D-57C0-41AA-8FC9-553F1D6E8E76}"/>
               </a:ext>
             </a:extLst>
           </p:cNvPr>
@@ -12666,7 +12646,7 @@
           <p:cNvPr id="14" name="">
             <a:extLst xmlns:a="http://schemas.openxmlformats.org/drawingml/2006/main">
               <a:ext uri="{FF2B5EF4-FFF2-40B4-BE49-F238E27FC236}">
-                <a16:creationId xmlns:a16="http://schemas.microsoft.com/office/drawing/2014/main" id="{1C023E0C-F1A0-4465-B65A-3CEB8CFEAAC2}"/>
+                <a16:creationId xmlns:a16="http://schemas.microsoft.com/office/drawing/2014/main" id="{B4128E10-167F-4292-A082-23356DDF00BF}"/>
               </a:ext>
             </a:extLst>
           </p:cNvPr>
@@ -12728,7 +12708,7 @@
           <p:cNvPr id="15" name="">
             <a:extLst xmlns:a="http://schemas.openxmlformats.org/drawingml/2006/main">
               <a:ext uri="{FF2B5EF4-FFF2-40B4-BE49-F238E27FC236}">
-                <a16:creationId xmlns:a16="http://schemas.microsoft.com/office/drawing/2014/main" id="{4FF94DE6-893B-4A4C-AF96-95D4EC4BF395}"/>
+                <a16:creationId xmlns:a16="http://schemas.microsoft.com/office/drawing/2014/main" id="{94ACD821-894F-4238-A87D-B39276E54CE4}"/>
               </a:ext>
             </a:extLst>
           </p:cNvPr>
@@ -12759,7 +12739,7 @@
           <p:cNvPr id="16" name="">
             <a:extLst xmlns:a="http://schemas.openxmlformats.org/drawingml/2006/main">
               <a:ext uri="{FF2B5EF4-FFF2-40B4-BE49-F238E27FC236}">
-                <a16:creationId xmlns:a16="http://schemas.microsoft.com/office/drawing/2014/main" id="{F4AD6F69-396C-4DAC-9DA3-7467E37CAC88}"/>
+                <a16:creationId xmlns:a16="http://schemas.microsoft.com/office/drawing/2014/main" id="{B616FFF9-BC5F-49B6-8471-DDBBEC8A7603}"/>
               </a:ext>
             </a:extLst>
           </p:cNvPr>
@@ -12821,7 +12801,7 @@
           <p:cNvPr id="17" name="">
             <a:extLst xmlns:a="http://schemas.openxmlformats.org/drawingml/2006/main">
               <a:ext uri="{FF2B5EF4-FFF2-40B4-BE49-F238E27FC236}">
-                <a16:creationId xmlns:a16="http://schemas.microsoft.com/office/drawing/2014/main" id="{0D6A4380-4EEC-4600-97A2-51FC621B2F93}"/>
+                <a16:creationId xmlns:a16="http://schemas.microsoft.com/office/drawing/2014/main" id="{9B2A9F82-4506-4E43-A65B-0BFB0A8EE8FC}"/>
               </a:ext>
             </a:extLst>
           </p:cNvPr>
@@ -12883,7 +12863,7 @@
           <p:cNvPr id="18" name="">
             <a:extLst xmlns:a="http://schemas.openxmlformats.org/drawingml/2006/main">
               <a:ext uri="{FF2B5EF4-FFF2-40B4-BE49-F238E27FC236}">
-                <a16:creationId xmlns:a16="http://schemas.microsoft.com/office/drawing/2014/main" id="{5ACFEF26-4013-47EC-ABDA-977E5B4C1D57}"/>
+                <a16:creationId xmlns:a16="http://schemas.microsoft.com/office/drawing/2014/main" id="{4F530EEB-6767-4671-AE5E-EDB2EC8B7169}"/>
               </a:ext>
             </a:extLst>
           </p:cNvPr>
@@ -12945,7 +12925,7 @@
           <p:cNvPr id="19" name="">
             <a:extLst xmlns:a="http://schemas.openxmlformats.org/drawingml/2006/main">
               <a:ext uri="{FF2B5EF4-FFF2-40B4-BE49-F238E27FC236}">
-                <a16:creationId xmlns:a16="http://schemas.microsoft.com/office/drawing/2014/main" id="{B1A674B1-BD5B-4D85-B12D-7154F39C02C5}"/>
+                <a16:creationId xmlns:a16="http://schemas.microsoft.com/office/drawing/2014/main" id="{98870709-DE11-42A5-937F-36146AD205FA}"/>
               </a:ext>
             </a:extLst>
           </p:cNvPr>
@@ -12978,7 +12958,7 @@
           <p:cNvPr id="20" name="">
             <a:extLst xmlns:a="http://schemas.openxmlformats.org/drawingml/2006/main">
               <a:ext uri="{FF2B5EF4-FFF2-40B4-BE49-F238E27FC236}">
-                <a16:creationId xmlns:a16="http://schemas.microsoft.com/office/drawing/2014/main" id="{3E4F7AD6-2A76-4DDC-9836-263235E8C571}"/>
+                <a16:creationId xmlns:a16="http://schemas.microsoft.com/office/drawing/2014/main" id="{022531DF-038C-4617-B878-846F879087D1}"/>
               </a:ext>
             </a:extLst>
           </p:cNvPr>
@@ -13044,7 +13024,7 @@
           <p:nvPr/>
         </p:nvPicPr>
         <p:blipFill>
-          <a:blip xmlns:r="http://schemas.openxmlformats.org/officeDocument/2006/relationships" xmlns:a="http://schemas.openxmlformats.org/drawingml/2006/main" r:embed="R28175df7ed2f4a88"/>
+          <a:blip xmlns:r="http://schemas.openxmlformats.org/officeDocument/2006/relationships" xmlns:a="http://schemas.openxmlformats.org/drawingml/2006/main" r:embed="R519a014eae364329"/>
           <a:stretch xmlns:a="http://schemas.openxmlformats.org/drawingml/2006/main"/>
         </p:blipFill>
         <p:spPr>
@@ -13062,7 +13042,7 @@
           <p:cNvPr id="22" name="footer-rule-18">
             <a:extLst xmlns:a="http://schemas.openxmlformats.org/drawingml/2006/main">
               <a:ext uri="{FF2B5EF4-FFF2-40B4-BE49-F238E27FC236}">
-                <a16:creationId xmlns:a16="http://schemas.microsoft.com/office/drawing/2014/main" id="{363FD4A9-396E-4D38-A995-92B93734CF2D}"/>
+                <a16:creationId xmlns:a16="http://schemas.microsoft.com/office/drawing/2014/main" id="{134AB00B-BEA2-457A-99C4-26D4DD683092}"/>
               </a:ext>
             </a:extLst>
           </p:cNvPr>
@@ -13093,7 +13073,7 @@
           <p:cNvPr id="23" name="footer-label-18">
             <a:extLst xmlns:a="http://schemas.openxmlformats.org/drawingml/2006/main">
               <a:ext uri="{FF2B5EF4-FFF2-40B4-BE49-F238E27FC236}">
-                <a16:creationId xmlns:a16="http://schemas.microsoft.com/office/drawing/2014/main" id="{C9A01771-94FA-4733-8A9D-3A462A460AFB}"/>
+                <a16:creationId xmlns:a16="http://schemas.microsoft.com/office/drawing/2014/main" id="{D3E83408-7121-4A0E-81DE-2B1503DC10E4}"/>
               </a:ext>
             </a:extLst>
           </p:cNvPr>
@@ -13155,7 +13135,7 @@
           <p:cNvPr id="24" name="footer-page-18">
             <a:extLst xmlns:a="http://schemas.openxmlformats.org/drawingml/2006/main">
               <a:ext uri="{FF2B5EF4-FFF2-40B4-BE49-F238E27FC236}">
-                <a16:creationId xmlns:a16="http://schemas.microsoft.com/office/drawing/2014/main" id="{B4E1D69A-96CB-47EC-B755-15787404D91F}"/>
+                <a16:creationId xmlns:a16="http://schemas.microsoft.com/office/drawing/2014/main" id="{F99FE2A4-9322-4805-9A70-5DE1D93215D4}"/>
               </a:ext>
             </a:extLst>
           </p:cNvPr>
@@ -13215,7 +13195,7 @@
     </p:spTree>
     <p:extLst>
       <p:ext uri="{BB962C8B-B14F-4D97-AF65-F5344CB8AC3E}">
-        <p14:creationId xmlns:p14="http://schemas.microsoft.com/office/powerpoint/2010/main" val="765405666"/>
+        <p14:creationId xmlns:p14="http://schemas.microsoft.com/office/powerpoint/2010/main" val="265127143"/>
       </p:ext>
     </p:extLst>
   </p:cSld>
@@ -13246,7 +13226,7 @@
           <p:cNvPr id="20" name="side-accent-2">
             <a:extLst xmlns:a="http://schemas.openxmlformats.org/drawingml/2006/main">
               <a:ext uri="{FF2B5EF4-FFF2-40B4-BE49-F238E27FC236}">
-                <a16:creationId xmlns:a16="http://schemas.microsoft.com/office/drawing/2014/main" id="{595D5517-BDB8-4C82-ADB1-24BDBED234EC}"/>
+                <a16:creationId xmlns:a16="http://schemas.microsoft.com/office/drawing/2014/main" id="{211C507D-B721-422A-B101-CD25D5989BD6}"/>
               </a:ext>
             </a:extLst>
           </p:cNvPr>
@@ -13277,7 +13257,7 @@
           <p:cNvPr id="2" name="kicker-2">
             <a:extLst xmlns:a="http://schemas.openxmlformats.org/drawingml/2006/main">
               <a:ext uri="{FF2B5EF4-FFF2-40B4-BE49-F238E27FC236}">
-                <a16:creationId xmlns:a16="http://schemas.microsoft.com/office/drawing/2014/main" id="{B6EF33E4-4B40-449F-B216-0F0A823107C5}"/>
+                <a16:creationId xmlns:a16="http://schemas.microsoft.com/office/drawing/2014/main" id="{C87BC976-05A6-4599-93CD-4F006DF4AAA3}"/>
               </a:ext>
             </a:extLst>
           </p:cNvPr>
@@ -13339,7 +13319,7 @@
           <p:cNvPr id="3" name="title-2">
             <a:extLst xmlns:a="http://schemas.openxmlformats.org/drawingml/2006/main">
               <a:ext uri="{FF2B5EF4-FFF2-40B4-BE49-F238E27FC236}">
-                <a16:creationId xmlns:a16="http://schemas.microsoft.com/office/drawing/2014/main" id="{8F20A0A4-EE23-457C-BF93-73F45D891BDD}"/>
+                <a16:creationId xmlns:a16="http://schemas.microsoft.com/office/drawing/2014/main" id="{B4D5B124-5BBD-4871-84AB-98F11CC1E6A1}"/>
               </a:ext>
             </a:extLst>
           </p:cNvPr>
@@ -13401,7 +13381,7 @@
           <p:cNvPr id="4" name="">
             <a:extLst xmlns:a="http://schemas.openxmlformats.org/drawingml/2006/main">
               <a:ext uri="{FF2B5EF4-FFF2-40B4-BE49-F238E27FC236}">
-                <a16:creationId xmlns:a16="http://schemas.microsoft.com/office/drawing/2014/main" id="{3BF35536-ABF3-4C09-84A5-C11F20B37E4E}"/>
+                <a16:creationId xmlns:a16="http://schemas.microsoft.com/office/drawing/2014/main" id="{FCC4636B-E9A1-48FE-9FD4-75752EB33FC5}"/>
               </a:ext>
             </a:extLst>
           </p:cNvPr>
@@ -13463,7 +13443,7 @@
           <p:cNvPr id="5" name="">
             <a:extLst xmlns:a="http://schemas.openxmlformats.org/drawingml/2006/main">
               <a:ext uri="{FF2B5EF4-FFF2-40B4-BE49-F238E27FC236}">
-                <a16:creationId xmlns:a16="http://schemas.microsoft.com/office/drawing/2014/main" id="{3972673B-2F60-4828-86B1-856D5929A235}"/>
+                <a16:creationId xmlns:a16="http://schemas.microsoft.com/office/drawing/2014/main" id="{969AF8DE-F542-4E1B-9572-F9B5F8B493CC}"/>
               </a:ext>
             </a:extLst>
           </p:cNvPr>
@@ -13525,7 +13505,7 @@
           <p:cNvPr id="6" name="">
             <a:extLst xmlns:a="http://schemas.openxmlformats.org/drawingml/2006/main">
               <a:ext uri="{FF2B5EF4-FFF2-40B4-BE49-F238E27FC236}">
-                <a16:creationId xmlns:a16="http://schemas.microsoft.com/office/drawing/2014/main" id="{0D082179-8453-4DDB-B090-6A2A622497DC}"/>
+                <a16:creationId xmlns:a16="http://schemas.microsoft.com/office/drawing/2014/main" id="{1C214B04-43C1-4451-9001-F83BCF0C608F}"/>
               </a:ext>
             </a:extLst>
           </p:cNvPr>
@@ -13556,7 +13536,7 @@
           <p:cNvPr id="7" name="">
             <a:extLst xmlns:a="http://schemas.openxmlformats.org/drawingml/2006/main">
               <a:ext uri="{FF2B5EF4-FFF2-40B4-BE49-F238E27FC236}">
-                <a16:creationId xmlns:a16="http://schemas.microsoft.com/office/drawing/2014/main" id="{EF3572E0-F992-498B-8569-EA14E1B10241}"/>
+                <a16:creationId xmlns:a16="http://schemas.microsoft.com/office/drawing/2014/main" id="{5E725EAD-F7A2-4A8A-B688-CABC9CD8CC92}"/>
               </a:ext>
             </a:extLst>
           </p:cNvPr>
@@ -13618,7 +13598,7 @@
           <p:cNvPr id="8" name="">
             <a:extLst xmlns:a="http://schemas.openxmlformats.org/drawingml/2006/main">
               <a:ext uri="{FF2B5EF4-FFF2-40B4-BE49-F238E27FC236}">
-                <a16:creationId xmlns:a16="http://schemas.microsoft.com/office/drawing/2014/main" id="{35DA4B7D-EC42-45B8-AD85-CDF50B68C2BD}"/>
+                <a16:creationId xmlns:a16="http://schemas.microsoft.com/office/drawing/2014/main" id="{BECA5600-7FF9-434C-819C-0244253B32CB}"/>
               </a:ext>
             </a:extLst>
           </p:cNvPr>
@@ -13680,7 +13660,7 @@
           <p:cNvPr id="9" name="">
             <a:extLst xmlns:a="http://schemas.openxmlformats.org/drawingml/2006/main">
               <a:ext uri="{FF2B5EF4-FFF2-40B4-BE49-F238E27FC236}">
-                <a16:creationId xmlns:a16="http://schemas.microsoft.com/office/drawing/2014/main" id="{A2EB07C2-6203-40F3-A9E3-66360130733A}"/>
+                <a16:creationId xmlns:a16="http://schemas.microsoft.com/office/drawing/2014/main" id="{941307CD-DF1A-4A49-9A4F-16B1E2060B3D}"/>
               </a:ext>
             </a:extLst>
           </p:cNvPr>
@@ -13711,7 +13691,7 @@
           <p:cNvPr id="10" name="">
             <a:extLst xmlns:a="http://schemas.openxmlformats.org/drawingml/2006/main">
               <a:ext uri="{FF2B5EF4-FFF2-40B4-BE49-F238E27FC236}">
-                <a16:creationId xmlns:a16="http://schemas.microsoft.com/office/drawing/2014/main" id="{6BD242B7-0FB2-40C7-98C4-D4DD7519351D}"/>
+                <a16:creationId xmlns:a16="http://schemas.microsoft.com/office/drawing/2014/main" id="{3478B4F6-ACDD-42D0-AC05-18FA2A511C03}"/>
               </a:ext>
             </a:extLst>
           </p:cNvPr>
@@ -13773,7 +13753,7 @@
           <p:cNvPr id="11" name="">
             <a:extLst xmlns:a="http://schemas.openxmlformats.org/drawingml/2006/main">
               <a:ext uri="{FF2B5EF4-FFF2-40B4-BE49-F238E27FC236}">
-                <a16:creationId xmlns:a16="http://schemas.microsoft.com/office/drawing/2014/main" id="{F78712DF-864C-41A3-BF26-4E2F7AC2060C}"/>
+                <a16:creationId xmlns:a16="http://schemas.microsoft.com/office/drawing/2014/main" id="{A055CDBA-14C7-450E-8384-176DBDEC6DF5}"/>
               </a:ext>
             </a:extLst>
           </p:cNvPr>
@@ -13835,7 +13815,7 @@
           <p:cNvPr id="12" name="">
             <a:extLst xmlns:a="http://schemas.openxmlformats.org/drawingml/2006/main">
               <a:ext uri="{FF2B5EF4-FFF2-40B4-BE49-F238E27FC236}">
-                <a16:creationId xmlns:a16="http://schemas.microsoft.com/office/drawing/2014/main" id="{4AA49086-F734-40BE-AC97-327DAAE9F011}"/>
+                <a16:creationId xmlns:a16="http://schemas.microsoft.com/office/drawing/2014/main" id="{9B4648BF-4664-4505-96FB-5A4423A6D876}"/>
               </a:ext>
             </a:extLst>
           </p:cNvPr>
@@ -13866,7 +13846,7 @@
           <p:cNvPr id="13" name="">
             <a:extLst xmlns:a="http://schemas.openxmlformats.org/drawingml/2006/main">
               <a:ext uri="{FF2B5EF4-FFF2-40B4-BE49-F238E27FC236}">
-                <a16:creationId xmlns:a16="http://schemas.microsoft.com/office/drawing/2014/main" id="{5A53E785-5E1A-4793-81D7-052BAAE772D2}"/>
+                <a16:creationId xmlns:a16="http://schemas.microsoft.com/office/drawing/2014/main" id="{5A30BC93-D7C7-4BC5-B0C8-A1A0A3A4CEC1}"/>
               </a:ext>
             </a:extLst>
           </p:cNvPr>
@@ -13928,7 +13908,7 @@
           <p:cNvPr id="14" name="outcome-mark">
             <a:extLst xmlns:a="http://schemas.openxmlformats.org/drawingml/2006/main">
               <a:ext uri="{FF2B5EF4-FFF2-40B4-BE49-F238E27FC236}">
-                <a16:creationId xmlns:a16="http://schemas.microsoft.com/office/drawing/2014/main" id="{63ABE921-9B98-4392-BCA2-74FFF5916D17}"/>
+                <a16:creationId xmlns:a16="http://schemas.microsoft.com/office/drawing/2014/main" id="{5D909F34-439B-46C6-A2B4-8D1AF0DC5D6E}"/>
               </a:ext>
             </a:extLst>
           </p:cNvPr>
@@ -13963,7 +13943,7 @@
           <p:cNvPr id="15" name="">
             <a:extLst xmlns:a="http://schemas.openxmlformats.org/drawingml/2006/main">
               <a:ext uri="{FF2B5EF4-FFF2-40B4-BE49-F238E27FC236}">
-                <a16:creationId xmlns:a16="http://schemas.microsoft.com/office/drawing/2014/main" id="{FA5D7812-2117-44F3-8C68-ED13A55AF723}"/>
+                <a16:creationId xmlns:a16="http://schemas.microsoft.com/office/drawing/2014/main" id="{F726CBB2-EB71-46B7-BC3D-1F695F03168E}"/>
               </a:ext>
             </a:extLst>
           </p:cNvPr>
@@ -14025,7 +14005,7 @@
           <p:cNvPr id="16" name="">
             <a:extLst xmlns:a="http://schemas.openxmlformats.org/drawingml/2006/main">
               <a:ext uri="{FF2B5EF4-FFF2-40B4-BE49-F238E27FC236}">
-                <a16:creationId xmlns:a16="http://schemas.microsoft.com/office/drawing/2014/main" id="{670A6AE7-8547-49AB-B41F-5D20257636F0}"/>
+                <a16:creationId xmlns:a16="http://schemas.microsoft.com/office/drawing/2014/main" id="{13F1F9BF-018F-4C02-A167-EAA89A38C66D}"/>
               </a:ext>
             </a:extLst>
           </p:cNvPr>
@@ -14114,7 +14094,7 @@
           <p:cNvPr id="17" name="footer-rule-2">
             <a:extLst xmlns:a="http://schemas.openxmlformats.org/drawingml/2006/main">
               <a:ext uri="{FF2B5EF4-FFF2-40B4-BE49-F238E27FC236}">
-                <a16:creationId xmlns:a16="http://schemas.microsoft.com/office/drawing/2014/main" id="{79BCA9B5-AA47-4686-86C3-BC65643C8FE1}"/>
+                <a16:creationId xmlns:a16="http://schemas.microsoft.com/office/drawing/2014/main" id="{F00AD064-DA15-4DE0-B24B-39D4106CE040}"/>
               </a:ext>
             </a:extLst>
           </p:cNvPr>
@@ -14145,7 +14125,7 @@
           <p:cNvPr id="18" name="footer-label-2">
             <a:extLst xmlns:a="http://schemas.openxmlformats.org/drawingml/2006/main">
               <a:ext uri="{FF2B5EF4-FFF2-40B4-BE49-F238E27FC236}">
-                <a16:creationId xmlns:a16="http://schemas.microsoft.com/office/drawing/2014/main" id="{DFA3F33A-FD33-429F-861D-A3172F6C9F3D}"/>
+                <a16:creationId xmlns:a16="http://schemas.microsoft.com/office/drawing/2014/main" id="{97C825A9-FD88-4CB5-80DF-68CF15F47B0B}"/>
               </a:ext>
             </a:extLst>
           </p:cNvPr>
@@ -14207,7 +14187,7 @@
           <p:cNvPr id="19" name="footer-page-2">
             <a:extLst xmlns:a="http://schemas.openxmlformats.org/drawingml/2006/main">
               <a:ext uri="{FF2B5EF4-FFF2-40B4-BE49-F238E27FC236}">
-                <a16:creationId xmlns:a16="http://schemas.microsoft.com/office/drawing/2014/main" id="{013C686F-1EAF-492C-80BF-BBA90206CFE6}"/>
+                <a16:creationId xmlns:a16="http://schemas.microsoft.com/office/drawing/2014/main" id="{6EFEC37C-BC06-483D-BE52-81098144281A}"/>
               </a:ext>
             </a:extLst>
           </p:cNvPr>
@@ -14267,7 +14247,7 @@
     </p:spTree>
     <p:extLst>
       <p:ext uri="{BB962C8B-B14F-4D97-AF65-F5344CB8AC3E}">
-        <p14:creationId xmlns:p14="http://schemas.microsoft.com/office/powerpoint/2010/main" val="1265464420"/>
+        <p14:creationId xmlns:p14="http://schemas.microsoft.com/office/powerpoint/2010/main" val="798694613"/>
       </p:ext>
     </p:extLst>
   </p:cSld>
@@ -14298,7 +14278,7 @@
           <p:cNvPr id="31" name="side-accent-3">
             <a:extLst xmlns:a="http://schemas.openxmlformats.org/drawingml/2006/main">
               <a:ext uri="{FF2B5EF4-FFF2-40B4-BE49-F238E27FC236}">
-                <a16:creationId xmlns:a16="http://schemas.microsoft.com/office/drawing/2014/main" id="{40224BDF-F3DD-4277-8D17-C8256EA57152}"/>
+                <a16:creationId xmlns:a16="http://schemas.microsoft.com/office/drawing/2014/main" id="{CC27CB7C-F608-4E2B-A7CD-84FC0F4EA389}"/>
               </a:ext>
             </a:extLst>
           </p:cNvPr>
@@ -14329,7 +14309,7 @@
           <p:cNvPr id="2" name="kicker-3">
             <a:extLst xmlns:a="http://schemas.openxmlformats.org/drawingml/2006/main">
               <a:ext uri="{FF2B5EF4-FFF2-40B4-BE49-F238E27FC236}">
-                <a16:creationId xmlns:a16="http://schemas.microsoft.com/office/drawing/2014/main" id="{811B5D4C-16FE-4ED2-8E7C-64A86B412D82}"/>
+                <a16:creationId xmlns:a16="http://schemas.microsoft.com/office/drawing/2014/main" id="{612BB743-7907-4847-AB8F-F46268B3FEEA}"/>
               </a:ext>
             </a:extLst>
           </p:cNvPr>
@@ -14391,7 +14371,7 @@
           <p:cNvPr id="3" name="title-3">
             <a:extLst xmlns:a="http://schemas.openxmlformats.org/drawingml/2006/main">
               <a:ext uri="{FF2B5EF4-FFF2-40B4-BE49-F238E27FC236}">
-                <a16:creationId xmlns:a16="http://schemas.microsoft.com/office/drawing/2014/main" id="{7EFF107A-DF10-43C7-AD13-609B61790CFA}"/>
+                <a16:creationId xmlns:a16="http://schemas.microsoft.com/office/drawing/2014/main" id="{CB8A3CD5-8558-4921-A964-0CCA60EEEF75}"/>
               </a:ext>
             </a:extLst>
           </p:cNvPr>
@@ -14453,7 +14433,7 @@
           <p:cNvPr id="4" name="">
             <a:extLst xmlns:a="http://schemas.openxmlformats.org/drawingml/2006/main">
               <a:ext uri="{FF2B5EF4-FFF2-40B4-BE49-F238E27FC236}">
-                <a16:creationId xmlns:a16="http://schemas.microsoft.com/office/drawing/2014/main" id="{835F8572-13E0-4F2B-8F42-35042F8F2A21}"/>
+                <a16:creationId xmlns:a16="http://schemas.microsoft.com/office/drawing/2014/main" id="{C51C11EB-9229-4026-A16E-41511132D8B3}"/>
               </a:ext>
             </a:extLst>
           </p:cNvPr>
@@ -14515,7 +14495,7 @@
           <p:cNvPr id="5" name="system-function-line">
             <a:extLst xmlns:a="http://schemas.openxmlformats.org/drawingml/2006/main">
               <a:ext uri="{FF2B5EF4-FFF2-40B4-BE49-F238E27FC236}">
-                <a16:creationId xmlns:a16="http://schemas.microsoft.com/office/drawing/2014/main" id="{D2C1CA43-A563-4D85-B7CB-E0540A97630E}"/>
+                <a16:creationId xmlns:a16="http://schemas.microsoft.com/office/drawing/2014/main" id="{E7D1F0A6-8F3B-431B-B36F-6FF9D6B82E89}"/>
               </a:ext>
             </a:extLst>
           </p:cNvPr>
@@ -14546,7 +14526,7 @@
           <p:cNvPr id="6" name="">
             <a:extLst xmlns:a="http://schemas.openxmlformats.org/drawingml/2006/main">
               <a:ext uri="{FF2B5EF4-FFF2-40B4-BE49-F238E27FC236}">
-                <a16:creationId xmlns:a16="http://schemas.microsoft.com/office/drawing/2014/main" id="{0BBA4C0F-3976-414B-ACD7-B3841ADC71F2}"/>
+                <a16:creationId xmlns:a16="http://schemas.microsoft.com/office/drawing/2014/main" id="{198D6A8A-3BEA-4408-86A2-AF9060863C22}"/>
               </a:ext>
             </a:extLst>
           </p:cNvPr>
@@ -14577,7 +14557,7 @@
           <p:cNvPr id="7" name="">
             <a:extLst xmlns:a="http://schemas.openxmlformats.org/drawingml/2006/main">
               <a:ext uri="{FF2B5EF4-FFF2-40B4-BE49-F238E27FC236}">
-                <a16:creationId xmlns:a16="http://schemas.microsoft.com/office/drawing/2014/main" id="{222DE765-EA3C-4FAE-8330-27614B0A7EA3}"/>
+                <a16:creationId xmlns:a16="http://schemas.microsoft.com/office/drawing/2014/main" id="{1493A43F-BCA5-4F40-B46B-F1A655F8AD41}"/>
               </a:ext>
             </a:extLst>
           </p:cNvPr>
@@ -14639,7 +14619,7 @@
           <p:cNvPr id="8" name="">
             <a:extLst xmlns:a="http://schemas.openxmlformats.org/drawingml/2006/main">
               <a:ext uri="{FF2B5EF4-FFF2-40B4-BE49-F238E27FC236}">
-                <a16:creationId xmlns:a16="http://schemas.microsoft.com/office/drawing/2014/main" id="{EF2488C4-AA4C-4591-9DBD-23D3D457CF7B}"/>
+                <a16:creationId xmlns:a16="http://schemas.microsoft.com/office/drawing/2014/main" id="{4277F38E-DF8B-4C32-A017-018DA8F3715B}"/>
               </a:ext>
             </a:extLst>
           </p:cNvPr>
@@ -14701,7 +14681,7 @@
           <p:cNvPr id="9" name="">
             <a:extLst xmlns:a="http://schemas.openxmlformats.org/drawingml/2006/main">
               <a:ext uri="{FF2B5EF4-FFF2-40B4-BE49-F238E27FC236}">
-                <a16:creationId xmlns:a16="http://schemas.microsoft.com/office/drawing/2014/main" id="{A5DB427B-84BA-4258-8B33-D80169E1498F}"/>
+                <a16:creationId xmlns:a16="http://schemas.microsoft.com/office/drawing/2014/main" id="{B67B1A35-C65E-49AB-91DD-575FBD9B7D73}"/>
               </a:ext>
             </a:extLst>
           </p:cNvPr>
@@ -14763,7 +14743,7 @@
           <p:cNvPr id="10" name="">
             <a:extLst xmlns:a="http://schemas.openxmlformats.org/drawingml/2006/main">
               <a:ext uri="{FF2B5EF4-FFF2-40B4-BE49-F238E27FC236}">
-                <a16:creationId xmlns:a16="http://schemas.microsoft.com/office/drawing/2014/main" id="{D35D022C-B608-41A6-9216-4035F887499D}"/>
+                <a16:creationId xmlns:a16="http://schemas.microsoft.com/office/drawing/2014/main" id="{57C778D2-1299-457C-8805-D7F201F457C0}"/>
               </a:ext>
             </a:extLst>
           </p:cNvPr>
@@ -14794,7 +14774,7 @@
           <p:cNvPr id="11" name="">
             <a:extLst xmlns:a="http://schemas.openxmlformats.org/drawingml/2006/main">
               <a:ext uri="{FF2B5EF4-FFF2-40B4-BE49-F238E27FC236}">
-                <a16:creationId xmlns:a16="http://schemas.microsoft.com/office/drawing/2014/main" id="{F34D7062-32B6-497C-84D5-06DE1C5AD158}"/>
+                <a16:creationId xmlns:a16="http://schemas.microsoft.com/office/drawing/2014/main" id="{E5E4EAB3-9F4C-4C4D-8F4F-8EC5D6FC890A}"/>
               </a:ext>
             </a:extLst>
           </p:cNvPr>
@@ -14856,7 +14836,7 @@
           <p:cNvPr id="12" name="">
             <a:extLst xmlns:a="http://schemas.openxmlformats.org/drawingml/2006/main">
               <a:ext uri="{FF2B5EF4-FFF2-40B4-BE49-F238E27FC236}">
-                <a16:creationId xmlns:a16="http://schemas.microsoft.com/office/drawing/2014/main" id="{8C3A6B27-7834-4FC6-87CC-A23CE75B7627}"/>
+                <a16:creationId xmlns:a16="http://schemas.microsoft.com/office/drawing/2014/main" id="{1CAB7327-6D63-4570-B8F4-9257A27F6673}"/>
               </a:ext>
             </a:extLst>
           </p:cNvPr>
@@ -14918,7 +14898,7 @@
           <p:cNvPr id="13" name="">
             <a:extLst xmlns:a="http://schemas.openxmlformats.org/drawingml/2006/main">
               <a:ext uri="{FF2B5EF4-FFF2-40B4-BE49-F238E27FC236}">
-                <a16:creationId xmlns:a16="http://schemas.microsoft.com/office/drawing/2014/main" id="{0E344782-8FD9-486F-B766-EA47A5CFD206}"/>
+                <a16:creationId xmlns:a16="http://schemas.microsoft.com/office/drawing/2014/main" id="{4BF6164B-EF33-4FD5-954B-9E1E6C8073EA}"/>
               </a:ext>
             </a:extLst>
           </p:cNvPr>
@@ -14980,7 +14960,7 @@
           <p:cNvPr id="14" name="">
             <a:extLst xmlns:a="http://schemas.openxmlformats.org/drawingml/2006/main">
               <a:ext uri="{FF2B5EF4-FFF2-40B4-BE49-F238E27FC236}">
-                <a16:creationId xmlns:a16="http://schemas.microsoft.com/office/drawing/2014/main" id="{EAAC5204-A6CE-4091-A537-642E59CB7851}"/>
+                <a16:creationId xmlns:a16="http://schemas.microsoft.com/office/drawing/2014/main" id="{E80C5504-D4B7-43ED-B03C-8B4D62D7F168}"/>
               </a:ext>
             </a:extLst>
           </p:cNvPr>
@@ -15011,7 +14991,7 @@
           <p:cNvPr id="15" name="">
             <a:extLst xmlns:a="http://schemas.openxmlformats.org/drawingml/2006/main">
               <a:ext uri="{FF2B5EF4-FFF2-40B4-BE49-F238E27FC236}">
-                <a16:creationId xmlns:a16="http://schemas.microsoft.com/office/drawing/2014/main" id="{4FFE7BCF-77E1-4638-98EB-84F50004F6F4}"/>
+                <a16:creationId xmlns:a16="http://schemas.microsoft.com/office/drawing/2014/main" id="{542C5F19-0264-4766-B811-CD9C4CA614E8}"/>
               </a:ext>
             </a:extLst>
           </p:cNvPr>
@@ -15073,7 +15053,7 @@
           <p:cNvPr id="16" name="">
             <a:extLst xmlns:a="http://schemas.openxmlformats.org/drawingml/2006/main">
               <a:ext uri="{FF2B5EF4-FFF2-40B4-BE49-F238E27FC236}">
-                <a16:creationId xmlns:a16="http://schemas.microsoft.com/office/drawing/2014/main" id="{E5276103-1A8F-42A7-A173-F2DF08415FDD}"/>
+                <a16:creationId xmlns:a16="http://schemas.microsoft.com/office/drawing/2014/main" id="{53B1E18B-8C23-43E4-9C0E-919980261401}"/>
               </a:ext>
             </a:extLst>
           </p:cNvPr>
@@ -15135,7 +15115,7 @@
           <p:cNvPr id="17" name="">
             <a:extLst xmlns:a="http://schemas.openxmlformats.org/drawingml/2006/main">
               <a:ext uri="{FF2B5EF4-FFF2-40B4-BE49-F238E27FC236}">
-                <a16:creationId xmlns:a16="http://schemas.microsoft.com/office/drawing/2014/main" id="{D45B3336-40DF-4162-A9A7-A71AE5A7BF20}"/>
+                <a16:creationId xmlns:a16="http://schemas.microsoft.com/office/drawing/2014/main" id="{A2EDF3C5-6DE0-44A5-9F57-09ABE3828026}"/>
               </a:ext>
             </a:extLst>
           </p:cNvPr>
@@ -15197,7 +15177,7 @@
           <p:cNvPr id="18" name="">
             <a:extLst xmlns:a="http://schemas.openxmlformats.org/drawingml/2006/main">
               <a:ext uri="{FF2B5EF4-FFF2-40B4-BE49-F238E27FC236}">
-                <a16:creationId xmlns:a16="http://schemas.microsoft.com/office/drawing/2014/main" id="{BEA7A5F7-F4F2-47D4-B6E4-E4CFDE9F20CB}"/>
+                <a16:creationId xmlns:a16="http://schemas.microsoft.com/office/drawing/2014/main" id="{387D24D0-6B14-4090-941A-C119E9A4AB1A}"/>
               </a:ext>
             </a:extLst>
           </p:cNvPr>
@@ -15228,7 +15208,7 @@
           <p:cNvPr id="19" name="">
             <a:extLst xmlns:a="http://schemas.openxmlformats.org/drawingml/2006/main">
               <a:ext uri="{FF2B5EF4-FFF2-40B4-BE49-F238E27FC236}">
-                <a16:creationId xmlns:a16="http://schemas.microsoft.com/office/drawing/2014/main" id="{86D65A02-415A-44F8-A121-0AFEE6CE45D4}"/>
+                <a16:creationId xmlns:a16="http://schemas.microsoft.com/office/drawing/2014/main" id="{84976EEB-23E7-4C28-B364-AC17D17C66A5}"/>
               </a:ext>
             </a:extLst>
           </p:cNvPr>
@@ -15290,7 +15270,7 @@
           <p:cNvPr id="20" name="">
             <a:extLst xmlns:a="http://schemas.openxmlformats.org/drawingml/2006/main">
               <a:ext uri="{FF2B5EF4-FFF2-40B4-BE49-F238E27FC236}">
-                <a16:creationId xmlns:a16="http://schemas.microsoft.com/office/drawing/2014/main" id="{7707FE86-1927-4A19-A495-6E0817D60474}"/>
+                <a16:creationId xmlns:a16="http://schemas.microsoft.com/office/drawing/2014/main" id="{4029ACE9-1C96-4F3D-B29E-3D39619EEB09}"/>
               </a:ext>
             </a:extLst>
           </p:cNvPr>
@@ -15352,7 +15332,7 @@
           <p:cNvPr id="21" name="">
             <a:extLst xmlns:a="http://schemas.openxmlformats.org/drawingml/2006/main">
               <a:ext uri="{FF2B5EF4-FFF2-40B4-BE49-F238E27FC236}">
-                <a16:creationId xmlns:a16="http://schemas.microsoft.com/office/drawing/2014/main" id="{C04B04FE-F57A-4DD1-A6C9-E08EDA9484F3}"/>
+                <a16:creationId xmlns:a16="http://schemas.microsoft.com/office/drawing/2014/main" id="{AF48EBAC-0271-4771-930C-FB749B0FF24F}"/>
               </a:ext>
             </a:extLst>
           </p:cNvPr>
@@ -15414,7 +15394,7 @@
           <p:cNvPr id="22" name="">
             <a:extLst xmlns:a="http://schemas.openxmlformats.org/drawingml/2006/main">
               <a:ext uri="{FF2B5EF4-FFF2-40B4-BE49-F238E27FC236}">
-                <a16:creationId xmlns:a16="http://schemas.microsoft.com/office/drawing/2014/main" id="{BDFE7E7F-EA5C-45BE-AC76-DFEFDB7E363B}"/>
+                <a16:creationId xmlns:a16="http://schemas.microsoft.com/office/drawing/2014/main" id="{87B0AF29-6706-4ED2-BDF3-C285E6A16805}"/>
               </a:ext>
             </a:extLst>
           </p:cNvPr>
@@ -15445,7 +15425,7 @@
           <p:cNvPr id="23" name="">
             <a:extLst xmlns:a="http://schemas.openxmlformats.org/drawingml/2006/main">
               <a:ext uri="{FF2B5EF4-FFF2-40B4-BE49-F238E27FC236}">
-                <a16:creationId xmlns:a16="http://schemas.microsoft.com/office/drawing/2014/main" id="{5795F742-A652-485D-8249-07FE7AEF0767}"/>
+                <a16:creationId xmlns:a16="http://schemas.microsoft.com/office/drawing/2014/main" id="{AEADBC2E-5D84-43AA-B461-515D84112EBC}"/>
               </a:ext>
             </a:extLst>
           </p:cNvPr>
@@ -15507,7 +15487,7 @@
           <p:cNvPr id="24" name="">
             <a:extLst xmlns:a="http://schemas.openxmlformats.org/drawingml/2006/main">
               <a:ext uri="{FF2B5EF4-FFF2-40B4-BE49-F238E27FC236}">
-                <a16:creationId xmlns:a16="http://schemas.microsoft.com/office/drawing/2014/main" id="{E2686F3D-0ABF-46ED-8622-89423E24835E}"/>
+                <a16:creationId xmlns:a16="http://schemas.microsoft.com/office/drawing/2014/main" id="{0E6FBA1F-D0F3-4E58-BFBF-357CB232BB8E}"/>
               </a:ext>
             </a:extLst>
           </p:cNvPr>
@@ -15569,7 +15549,7 @@
           <p:cNvPr id="25" name="">
             <a:extLst xmlns:a="http://schemas.openxmlformats.org/drawingml/2006/main">
               <a:ext uri="{FF2B5EF4-FFF2-40B4-BE49-F238E27FC236}">
-                <a16:creationId xmlns:a16="http://schemas.microsoft.com/office/drawing/2014/main" id="{274D21A2-8CD0-4517-8499-4C1E1749BD59}"/>
+                <a16:creationId xmlns:a16="http://schemas.microsoft.com/office/drawing/2014/main" id="{641546FB-61FA-4016-9BA5-ED9E4CE370B5}"/>
               </a:ext>
             </a:extLst>
           </p:cNvPr>
@@ -15631,7 +15611,7 @@
           <p:cNvPr id="26" name="">
             <a:extLst xmlns:a="http://schemas.openxmlformats.org/drawingml/2006/main">
               <a:ext uri="{FF2B5EF4-FFF2-40B4-BE49-F238E27FC236}">
-                <a16:creationId xmlns:a16="http://schemas.microsoft.com/office/drawing/2014/main" id="{CAA66A98-E9D2-4923-8182-4EC070C234B8}"/>
+                <a16:creationId xmlns:a16="http://schemas.microsoft.com/office/drawing/2014/main" id="{03D7451E-97C4-44DB-965C-56F9C83C630A}"/>
               </a:ext>
             </a:extLst>
           </p:cNvPr>
@@ -15664,7 +15644,7 @@
           <p:cNvPr id="27" name="">
             <a:extLst xmlns:a="http://schemas.openxmlformats.org/drawingml/2006/main">
               <a:ext uri="{FF2B5EF4-FFF2-40B4-BE49-F238E27FC236}">
-                <a16:creationId xmlns:a16="http://schemas.microsoft.com/office/drawing/2014/main" id="{7E3DE113-A9E5-4C65-AF08-A4946DFDBEFE}"/>
+                <a16:creationId xmlns:a16="http://schemas.microsoft.com/office/drawing/2014/main" id="{5268F9C3-B678-42CA-BDF7-79A09180D27A}"/>
               </a:ext>
             </a:extLst>
           </p:cNvPr>
@@ -15726,7 +15706,7 @@
           <p:cNvPr id="28" name="footer-rule-3">
             <a:extLst xmlns:a="http://schemas.openxmlformats.org/drawingml/2006/main">
               <a:ext uri="{FF2B5EF4-FFF2-40B4-BE49-F238E27FC236}">
-                <a16:creationId xmlns:a16="http://schemas.microsoft.com/office/drawing/2014/main" id="{6E151584-4831-4291-B101-F31A8D10550E}"/>
+                <a16:creationId xmlns:a16="http://schemas.microsoft.com/office/drawing/2014/main" id="{0523BDB6-D632-47AC-AA40-6E1FEAED5548}"/>
               </a:ext>
             </a:extLst>
           </p:cNvPr>
@@ -15757,7 +15737,7 @@
           <p:cNvPr id="29" name="footer-label-3">
             <a:extLst xmlns:a="http://schemas.openxmlformats.org/drawingml/2006/main">
               <a:ext uri="{FF2B5EF4-FFF2-40B4-BE49-F238E27FC236}">
-                <a16:creationId xmlns:a16="http://schemas.microsoft.com/office/drawing/2014/main" id="{AA366E99-6EB2-4D71-BE4F-CB85AEC27641}"/>
+                <a16:creationId xmlns:a16="http://schemas.microsoft.com/office/drawing/2014/main" id="{42354588-35B6-494E-AF54-5D073DC7C43D}"/>
               </a:ext>
             </a:extLst>
           </p:cNvPr>
@@ -15819,7 +15799,7 @@
           <p:cNvPr id="30" name="footer-page-3">
             <a:extLst xmlns:a="http://schemas.openxmlformats.org/drawingml/2006/main">
               <a:ext uri="{FF2B5EF4-FFF2-40B4-BE49-F238E27FC236}">
-                <a16:creationId xmlns:a16="http://schemas.microsoft.com/office/drawing/2014/main" id="{226C910F-AA79-4587-A2C3-C6269422A3E1}"/>
+                <a16:creationId xmlns:a16="http://schemas.microsoft.com/office/drawing/2014/main" id="{B8D83A2A-3223-4C3C-82F3-2D753BE73B41}"/>
               </a:ext>
             </a:extLst>
           </p:cNvPr>
@@ -15879,7 +15859,7 @@
     </p:spTree>
     <p:extLst>
       <p:ext uri="{BB962C8B-B14F-4D97-AF65-F5344CB8AC3E}">
-        <p14:creationId xmlns:p14="http://schemas.microsoft.com/office/powerpoint/2010/main" val="436023858"/>
+        <p14:creationId xmlns:p14="http://schemas.microsoft.com/office/powerpoint/2010/main" val="1173242664"/>
       </p:ext>
     </p:extLst>
   </p:cSld>
@@ -15910,7 +15890,7 @@
           <p:cNvPr id="28" name="side-accent-4">
             <a:extLst xmlns:a="http://schemas.openxmlformats.org/drawingml/2006/main">
               <a:ext uri="{FF2B5EF4-FFF2-40B4-BE49-F238E27FC236}">
-                <a16:creationId xmlns:a16="http://schemas.microsoft.com/office/drawing/2014/main" id="{1C31631C-CB40-4FA5-BD7C-A25307FA990F}"/>
+                <a16:creationId xmlns:a16="http://schemas.microsoft.com/office/drawing/2014/main" id="{D18D29E8-5D22-4083-86B2-8930A64A550A}"/>
               </a:ext>
             </a:extLst>
           </p:cNvPr>
@@ -15941,7 +15921,7 @@
           <p:cNvPr id="2" name="kicker-4">
             <a:extLst xmlns:a="http://schemas.openxmlformats.org/drawingml/2006/main">
               <a:ext uri="{FF2B5EF4-FFF2-40B4-BE49-F238E27FC236}">
-                <a16:creationId xmlns:a16="http://schemas.microsoft.com/office/drawing/2014/main" id="{D61E902E-A8D9-4F85-B759-ACAB9C5EE1F9}"/>
+                <a16:creationId xmlns:a16="http://schemas.microsoft.com/office/drawing/2014/main" id="{06A63D43-5AA8-44E5-9077-DFA3BC862A88}"/>
               </a:ext>
             </a:extLst>
           </p:cNvPr>
@@ -16003,7 +15983,7 @@
           <p:cNvPr id="3" name="title-4">
             <a:extLst xmlns:a="http://schemas.openxmlformats.org/drawingml/2006/main">
               <a:ext uri="{FF2B5EF4-FFF2-40B4-BE49-F238E27FC236}">
-                <a16:creationId xmlns:a16="http://schemas.microsoft.com/office/drawing/2014/main" id="{23D67EA1-22C4-497F-A919-5789291F7141}"/>
+                <a16:creationId xmlns:a16="http://schemas.microsoft.com/office/drawing/2014/main" id="{A07C7D98-86FF-4789-B2D5-BCA7E19250EE}"/>
               </a:ext>
             </a:extLst>
           </p:cNvPr>
@@ -16065,7 +16045,7 @@
           <p:cNvPr id="4" name="">
             <a:extLst xmlns:a="http://schemas.openxmlformats.org/drawingml/2006/main">
               <a:ext uri="{FF2B5EF4-FFF2-40B4-BE49-F238E27FC236}">
-                <a16:creationId xmlns:a16="http://schemas.microsoft.com/office/drawing/2014/main" id="{1DA08E93-37E2-4DB7-85B3-F0BCD0F65B85}"/>
+                <a16:creationId xmlns:a16="http://schemas.microsoft.com/office/drawing/2014/main" id="{8D8B1C69-1613-40E1-90C4-9D29109ED431}"/>
               </a:ext>
             </a:extLst>
           </p:cNvPr>
@@ -16127,7 +16107,7 @@
           <p:cNvPr id="5" name="">
             <a:extLst xmlns:a="http://schemas.openxmlformats.org/drawingml/2006/main">
               <a:ext uri="{FF2B5EF4-FFF2-40B4-BE49-F238E27FC236}">
-                <a16:creationId xmlns:a16="http://schemas.microsoft.com/office/drawing/2014/main" id="{18ECF113-32D3-449A-BFEF-A6F33B953427}"/>
+                <a16:creationId xmlns:a16="http://schemas.microsoft.com/office/drawing/2014/main" id="{42A16EF2-AC5F-4F95-9103-4A4788CB3B48}"/>
               </a:ext>
             </a:extLst>
           </p:cNvPr>
@@ -16189,7 +16169,7 @@
           <p:cNvPr id="6" name="">
             <a:extLst xmlns:a="http://schemas.openxmlformats.org/drawingml/2006/main">
               <a:ext uri="{FF2B5EF4-FFF2-40B4-BE49-F238E27FC236}">
-                <a16:creationId xmlns:a16="http://schemas.microsoft.com/office/drawing/2014/main" id="{073F2673-1F94-4F7F-A981-62D6115A7325}"/>
+                <a16:creationId xmlns:a16="http://schemas.microsoft.com/office/drawing/2014/main" id="{924D38AA-8442-4B30-8027-E68C97FB5904}"/>
               </a:ext>
             </a:extLst>
           </p:cNvPr>
@@ -16251,7 +16231,7 @@
           <p:cNvPr id="7" name="">
             <a:extLst xmlns:a="http://schemas.openxmlformats.org/drawingml/2006/main">
               <a:ext uri="{FF2B5EF4-FFF2-40B4-BE49-F238E27FC236}">
-                <a16:creationId xmlns:a16="http://schemas.microsoft.com/office/drawing/2014/main" id="{9CC19653-8A37-4620-9FB1-A1013E7369E7}"/>
+                <a16:creationId xmlns:a16="http://schemas.microsoft.com/office/drawing/2014/main" id="{C292FA0B-997D-4071-BBD2-A1786256A89C}"/>
               </a:ext>
             </a:extLst>
           </p:cNvPr>
@@ -16282,7 +16262,7 @@
           <p:cNvPr id="8" name="">
             <a:extLst xmlns:a="http://schemas.openxmlformats.org/drawingml/2006/main">
               <a:ext uri="{FF2B5EF4-FFF2-40B4-BE49-F238E27FC236}">
-                <a16:creationId xmlns:a16="http://schemas.microsoft.com/office/drawing/2014/main" id="{AAA7BADF-FAB1-4AE3-80A9-B664F921F89B}"/>
+                <a16:creationId xmlns:a16="http://schemas.microsoft.com/office/drawing/2014/main" id="{2B1C1262-AE07-4CF4-9F40-B6F5CE89580D}"/>
               </a:ext>
             </a:extLst>
           </p:cNvPr>
@@ -16344,7 +16324,7 @@
           <p:cNvPr id="9" name="">
             <a:extLst xmlns:a="http://schemas.openxmlformats.org/drawingml/2006/main">
               <a:ext uri="{FF2B5EF4-FFF2-40B4-BE49-F238E27FC236}">
-                <a16:creationId xmlns:a16="http://schemas.microsoft.com/office/drawing/2014/main" id="{18711FDF-BAC0-4A21-B326-FA44BCDC9FD2}"/>
+                <a16:creationId xmlns:a16="http://schemas.microsoft.com/office/drawing/2014/main" id="{D03660B5-D112-459C-91C4-1191B9E761EB}"/>
               </a:ext>
             </a:extLst>
           </p:cNvPr>
@@ -16406,7 +16386,7 @@
           <p:cNvPr id="10" name="">
             <a:extLst xmlns:a="http://schemas.openxmlformats.org/drawingml/2006/main">
               <a:ext uri="{FF2B5EF4-FFF2-40B4-BE49-F238E27FC236}">
-                <a16:creationId xmlns:a16="http://schemas.microsoft.com/office/drawing/2014/main" id="{FDF3C91D-7E9D-439A-9F9D-E2A8904921BD}"/>
+                <a16:creationId xmlns:a16="http://schemas.microsoft.com/office/drawing/2014/main" id="{C50F5E57-00C0-4D87-834E-BB9330DAB33D}"/>
               </a:ext>
             </a:extLst>
           </p:cNvPr>
@@ -16468,7 +16448,7 @@
           <p:cNvPr id="11" name="">
             <a:extLst xmlns:a="http://schemas.openxmlformats.org/drawingml/2006/main">
               <a:ext uri="{FF2B5EF4-FFF2-40B4-BE49-F238E27FC236}">
-                <a16:creationId xmlns:a16="http://schemas.microsoft.com/office/drawing/2014/main" id="{5B923009-D664-4A9F-BE06-E3F093D22582}"/>
+                <a16:creationId xmlns:a16="http://schemas.microsoft.com/office/drawing/2014/main" id="{82D9B906-E2BC-4689-ACFF-B9CA0A379DF8}"/>
               </a:ext>
             </a:extLst>
           </p:cNvPr>
@@ -16499,7 +16479,7 @@
           <p:cNvPr id="12" name="">
             <a:extLst xmlns:a="http://schemas.openxmlformats.org/drawingml/2006/main">
               <a:ext uri="{FF2B5EF4-FFF2-40B4-BE49-F238E27FC236}">
-                <a16:creationId xmlns:a16="http://schemas.microsoft.com/office/drawing/2014/main" id="{70C3CE3C-C0BC-4DAA-8CFB-A6EA298DB6FA}"/>
+                <a16:creationId xmlns:a16="http://schemas.microsoft.com/office/drawing/2014/main" id="{C5647003-DA5D-428A-891C-CDD05367232A}"/>
               </a:ext>
             </a:extLst>
           </p:cNvPr>
@@ -16561,7 +16541,7 @@
           <p:cNvPr id="13" name="">
             <a:extLst xmlns:a="http://schemas.openxmlformats.org/drawingml/2006/main">
               <a:ext uri="{FF2B5EF4-FFF2-40B4-BE49-F238E27FC236}">
-                <a16:creationId xmlns:a16="http://schemas.microsoft.com/office/drawing/2014/main" id="{436C8105-7DAD-4892-9F66-6FA6185F2801}"/>
+                <a16:creationId xmlns:a16="http://schemas.microsoft.com/office/drawing/2014/main" id="{C3379F28-6511-4160-BA8C-A3BC92DB1373}"/>
               </a:ext>
             </a:extLst>
           </p:cNvPr>
@@ -16623,7 +16603,7 @@
           <p:cNvPr id="14" name="">
             <a:extLst xmlns:a="http://schemas.openxmlformats.org/drawingml/2006/main">
               <a:ext uri="{FF2B5EF4-FFF2-40B4-BE49-F238E27FC236}">
-                <a16:creationId xmlns:a16="http://schemas.microsoft.com/office/drawing/2014/main" id="{2CDF91BE-DC4F-4DCC-8C7D-44E6DD9209A8}"/>
+                <a16:creationId xmlns:a16="http://schemas.microsoft.com/office/drawing/2014/main" id="{7A4C8DE6-0EF6-4EFF-B0A6-CEAC33F7BC97}"/>
               </a:ext>
             </a:extLst>
           </p:cNvPr>
@@ -16685,7 +16665,7 @@
           <p:cNvPr id="15" name="">
             <a:extLst xmlns:a="http://schemas.openxmlformats.org/drawingml/2006/main">
               <a:ext uri="{FF2B5EF4-FFF2-40B4-BE49-F238E27FC236}">
-                <a16:creationId xmlns:a16="http://schemas.microsoft.com/office/drawing/2014/main" id="{EBB4EFC4-9C79-4861-A93D-D9B9EA383B84}"/>
+                <a16:creationId xmlns:a16="http://schemas.microsoft.com/office/drawing/2014/main" id="{F973937D-4CC6-4209-BED0-E595A37EE2BD}"/>
               </a:ext>
             </a:extLst>
           </p:cNvPr>
@@ -16716,7 +16696,7 @@
           <p:cNvPr id="16" name="">
             <a:extLst xmlns:a="http://schemas.openxmlformats.org/drawingml/2006/main">
               <a:ext uri="{FF2B5EF4-FFF2-40B4-BE49-F238E27FC236}">
-                <a16:creationId xmlns:a16="http://schemas.microsoft.com/office/drawing/2014/main" id="{8555D467-2491-4204-85F5-EF9458F02718}"/>
+                <a16:creationId xmlns:a16="http://schemas.microsoft.com/office/drawing/2014/main" id="{276ECD87-BCFB-4F80-B0E4-EFDB6EC52302}"/>
               </a:ext>
             </a:extLst>
           </p:cNvPr>
@@ -16778,7 +16758,7 @@
           <p:cNvPr id="17" name="">
             <a:extLst xmlns:a="http://schemas.openxmlformats.org/drawingml/2006/main">
               <a:ext uri="{FF2B5EF4-FFF2-40B4-BE49-F238E27FC236}">
-                <a16:creationId xmlns:a16="http://schemas.microsoft.com/office/drawing/2014/main" id="{15814E78-9889-4D92-95F5-666FEFBF48E0}"/>
+                <a16:creationId xmlns:a16="http://schemas.microsoft.com/office/drawing/2014/main" id="{50B6B961-1CC8-4C10-A802-2B19E063EE51}"/>
               </a:ext>
             </a:extLst>
           </p:cNvPr>
@@ -16840,7 +16820,7 @@
           <p:cNvPr id="18" name="">
             <a:extLst xmlns:a="http://schemas.openxmlformats.org/drawingml/2006/main">
               <a:ext uri="{FF2B5EF4-FFF2-40B4-BE49-F238E27FC236}">
-                <a16:creationId xmlns:a16="http://schemas.microsoft.com/office/drawing/2014/main" id="{CB160DB2-73BA-4FE7-B7BB-2CB244AA8C22}"/>
+                <a16:creationId xmlns:a16="http://schemas.microsoft.com/office/drawing/2014/main" id="{8CC93A1B-33F6-4C2A-82AE-A46A84814E27}"/>
               </a:ext>
             </a:extLst>
           </p:cNvPr>
@@ -16902,7 +16882,7 @@
           <p:cNvPr id="19" name="">
             <a:extLst xmlns:a="http://schemas.openxmlformats.org/drawingml/2006/main">
               <a:ext uri="{FF2B5EF4-FFF2-40B4-BE49-F238E27FC236}">
-                <a16:creationId xmlns:a16="http://schemas.microsoft.com/office/drawing/2014/main" id="{3B30BE2A-E669-4B41-8227-14A938E7A1C6}"/>
+                <a16:creationId xmlns:a16="http://schemas.microsoft.com/office/drawing/2014/main" id="{147CD1BD-3104-4405-BA35-972195FBA0CD}"/>
               </a:ext>
             </a:extLst>
           </p:cNvPr>
@@ -16933,7 +16913,7 @@
           <p:cNvPr id="20" name="">
             <a:extLst xmlns:a="http://schemas.openxmlformats.org/drawingml/2006/main">
               <a:ext uri="{FF2B5EF4-FFF2-40B4-BE49-F238E27FC236}">
-                <a16:creationId xmlns:a16="http://schemas.microsoft.com/office/drawing/2014/main" id="{AB101D15-D96D-4241-ABCF-141CE2673F6E}"/>
+                <a16:creationId xmlns:a16="http://schemas.microsoft.com/office/drawing/2014/main" id="{E69DA737-321B-4F22-9555-68AF49F91670}"/>
               </a:ext>
             </a:extLst>
           </p:cNvPr>
@@ -16995,7 +16975,7 @@
           <p:cNvPr id="21" name="">
             <a:extLst xmlns:a="http://schemas.openxmlformats.org/drawingml/2006/main">
               <a:ext uri="{FF2B5EF4-FFF2-40B4-BE49-F238E27FC236}">
-                <a16:creationId xmlns:a16="http://schemas.microsoft.com/office/drawing/2014/main" id="{9A14BA09-E2AB-4281-8F94-2F851226AD8B}"/>
+                <a16:creationId xmlns:a16="http://schemas.microsoft.com/office/drawing/2014/main" id="{9E5A317A-FD10-423E-8B26-890727FA3F31}"/>
               </a:ext>
             </a:extLst>
           </p:cNvPr>
@@ -17057,7 +17037,7 @@
           <p:cNvPr id="22" name="">
             <a:extLst xmlns:a="http://schemas.openxmlformats.org/drawingml/2006/main">
               <a:ext uri="{FF2B5EF4-FFF2-40B4-BE49-F238E27FC236}">
-                <a16:creationId xmlns:a16="http://schemas.microsoft.com/office/drawing/2014/main" id="{B64F3F27-B149-4FCE-93A2-396643E801F3}"/>
+                <a16:creationId xmlns:a16="http://schemas.microsoft.com/office/drawing/2014/main" id="{20074870-4C18-4432-9EF8-8809DCB6E46B}"/>
               </a:ext>
             </a:extLst>
           </p:cNvPr>
@@ -17119,7 +17099,7 @@
           <p:cNvPr id="23" name="">
             <a:extLst xmlns:a="http://schemas.openxmlformats.org/drawingml/2006/main">
               <a:ext uri="{FF2B5EF4-FFF2-40B4-BE49-F238E27FC236}">
-                <a16:creationId xmlns:a16="http://schemas.microsoft.com/office/drawing/2014/main" id="{2D39D6B0-5EAC-4FA0-B1FC-E36F8DE43BE0}"/>
+                <a16:creationId xmlns:a16="http://schemas.microsoft.com/office/drawing/2014/main" id="{7EDD442F-89FE-454A-965B-9C39B4B56B4C}"/>
               </a:ext>
             </a:extLst>
           </p:cNvPr>
@@ -17152,7 +17132,7 @@
           <p:cNvPr id="24" name="">
             <a:extLst xmlns:a="http://schemas.openxmlformats.org/drawingml/2006/main">
               <a:ext uri="{FF2B5EF4-FFF2-40B4-BE49-F238E27FC236}">
-                <a16:creationId xmlns:a16="http://schemas.microsoft.com/office/drawing/2014/main" id="{5AA3CF00-82C7-4825-BA5B-FFAF4A46B28B}"/>
+                <a16:creationId xmlns:a16="http://schemas.microsoft.com/office/drawing/2014/main" id="{B45BDA5F-E4F2-4884-928D-A3F4CCF1FE6D}"/>
               </a:ext>
             </a:extLst>
           </p:cNvPr>
@@ -17214,7 +17194,7 @@
           <p:cNvPr id="25" name="footer-rule-4">
             <a:extLst xmlns:a="http://schemas.openxmlformats.org/drawingml/2006/main">
               <a:ext uri="{FF2B5EF4-FFF2-40B4-BE49-F238E27FC236}">
-                <a16:creationId xmlns:a16="http://schemas.microsoft.com/office/drawing/2014/main" id="{E16B757F-4FBC-4504-B8C7-7BBEA0E404D4}"/>
+                <a16:creationId xmlns:a16="http://schemas.microsoft.com/office/drawing/2014/main" id="{533F35AB-BA18-4A24-ABC5-26562E6386DC}"/>
               </a:ext>
             </a:extLst>
           </p:cNvPr>
@@ -17245,7 +17225,7 @@
           <p:cNvPr id="26" name="footer-label-4">
             <a:extLst xmlns:a="http://schemas.openxmlformats.org/drawingml/2006/main">
               <a:ext uri="{FF2B5EF4-FFF2-40B4-BE49-F238E27FC236}">
-                <a16:creationId xmlns:a16="http://schemas.microsoft.com/office/drawing/2014/main" id="{E122E80C-1682-4BED-BF81-7B76B1E72127}"/>
+                <a16:creationId xmlns:a16="http://schemas.microsoft.com/office/drawing/2014/main" id="{F9676D34-A6C9-486A-BE6F-3DE6D6357011}"/>
               </a:ext>
             </a:extLst>
           </p:cNvPr>
@@ -17307,7 +17287,7 @@
           <p:cNvPr id="27" name="footer-page-4">
             <a:extLst xmlns:a="http://schemas.openxmlformats.org/drawingml/2006/main">
               <a:ext uri="{FF2B5EF4-FFF2-40B4-BE49-F238E27FC236}">
-                <a16:creationId xmlns:a16="http://schemas.microsoft.com/office/drawing/2014/main" id="{2ACC9EEC-A7DC-4435-B4E6-92906AC07800}"/>
+                <a16:creationId xmlns:a16="http://schemas.microsoft.com/office/drawing/2014/main" id="{EFB99EAA-5954-4318-B0DD-B3443564F913}"/>
               </a:ext>
             </a:extLst>
           </p:cNvPr>
@@ -17367,7 +17347,7 @@
     </p:spTree>
     <p:extLst>
       <p:ext uri="{BB962C8B-B14F-4D97-AF65-F5344CB8AC3E}">
-        <p14:creationId xmlns:p14="http://schemas.microsoft.com/office/powerpoint/2010/main" val="275505797"/>
+        <p14:creationId xmlns:p14="http://schemas.microsoft.com/office/powerpoint/2010/main" val="1705209886"/>
       </p:ext>
     </p:extLst>
   </p:cSld>
@@ -17398,7 +17378,7 @@
           <p:cNvPr id="31" name="side-accent-5">
             <a:extLst xmlns:a="http://schemas.openxmlformats.org/drawingml/2006/main">
               <a:ext uri="{FF2B5EF4-FFF2-40B4-BE49-F238E27FC236}">
-                <a16:creationId xmlns:a16="http://schemas.microsoft.com/office/drawing/2014/main" id="{52F0CBEE-DEC6-42DF-AB7D-D998A49DFE77}"/>
+                <a16:creationId xmlns:a16="http://schemas.microsoft.com/office/drawing/2014/main" id="{20454ECD-EC9C-4E1B-906C-5C8B87D3B3BE}"/>
               </a:ext>
             </a:extLst>
           </p:cNvPr>
@@ -17429,7 +17409,7 @@
           <p:cNvPr id="2" name="kicker-5">
             <a:extLst xmlns:a="http://schemas.openxmlformats.org/drawingml/2006/main">
               <a:ext uri="{FF2B5EF4-FFF2-40B4-BE49-F238E27FC236}">
-                <a16:creationId xmlns:a16="http://schemas.microsoft.com/office/drawing/2014/main" id="{876EC145-33D7-43D7-B0E1-6D0D5E550D5B}"/>
+                <a16:creationId xmlns:a16="http://schemas.microsoft.com/office/drawing/2014/main" id="{4C23934D-1678-4323-81E1-418F96B9CBDE}"/>
               </a:ext>
             </a:extLst>
           </p:cNvPr>
@@ -17491,7 +17471,7 @@
           <p:cNvPr id="3" name="title-5">
             <a:extLst xmlns:a="http://schemas.openxmlformats.org/drawingml/2006/main">
               <a:ext uri="{FF2B5EF4-FFF2-40B4-BE49-F238E27FC236}">
-                <a16:creationId xmlns:a16="http://schemas.microsoft.com/office/drawing/2014/main" id="{03C44222-23B6-43E6-B77B-CF4A95CB46ED}"/>
+                <a16:creationId xmlns:a16="http://schemas.microsoft.com/office/drawing/2014/main" id="{D279A9AA-EE9C-4DD2-8ECF-C0A2776FD4DF}"/>
               </a:ext>
             </a:extLst>
           </p:cNvPr>
@@ -17553,7 +17533,7 @@
           <p:cNvPr id="4" name="">
             <a:extLst xmlns:a="http://schemas.openxmlformats.org/drawingml/2006/main">
               <a:ext uri="{FF2B5EF4-FFF2-40B4-BE49-F238E27FC236}">
-                <a16:creationId xmlns:a16="http://schemas.microsoft.com/office/drawing/2014/main" id="{C6814513-6079-4D5D-AF3D-1463B27BAE02}"/>
+                <a16:creationId xmlns:a16="http://schemas.microsoft.com/office/drawing/2014/main" id="{8B1CB665-E9FA-4BA3-A089-B889C5A02EFC}"/>
               </a:ext>
             </a:extLst>
           </p:cNvPr>
@@ -17615,7 +17595,7 @@
           <p:cNvPr id="5" name="workflow-line">
             <a:extLst xmlns:a="http://schemas.openxmlformats.org/drawingml/2006/main">
               <a:ext uri="{FF2B5EF4-FFF2-40B4-BE49-F238E27FC236}">
-                <a16:creationId xmlns:a16="http://schemas.microsoft.com/office/drawing/2014/main" id="{8FD48846-3F87-4F7F-89B5-C1537CCBB95F}"/>
+                <a16:creationId xmlns:a16="http://schemas.microsoft.com/office/drawing/2014/main" id="{5B42BAA6-F927-4EBD-99F2-9F191564C85F}"/>
               </a:ext>
             </a:extLst>
           </p:cNvPr>
@@ -17646,7 +17626,7 @@
           <p:cNvPr id="6" name="workflow-arrow">
             <a:extLst xmlns:a="http://schemas.openxmlformats.org/drawingml/2006/main">
               <a:ext uri="{FF2B5EF4-FFF2-40B4-BE49-F238E27FC236}">
-                <a16:creationId xmlns:a16="http://schemas.microsoft.com/office/drawing/2014/main" id="{7A02170A-68FC-4345-A961-FB5A22CA5B80}"/>
+                <a16:creationId xmlns:a16="http://schemas.microsoft.com/office/drawing/2014/main" id="{58C21FD4-3306-46C7-8517-2A584C1E7196}"/>
               </a:ext>
             </a:extLst>
           </p:cNvPr>
@@ -17677,7 +17657,7 @@
           <p:cNvPr id="7" name="">
             <a:extLst xmlns:a="http://schemas.openxmlformats.org/drawingml/2006/main">
               <a:ext uri="{FF2B5EF4-FFF2-40B4-BE49-F238E27FC236}">
-                <a16:creationId xmlns:a16="http://schemas.microsoft.com/office/drawing/2014/main" id="{A846D3D6-43F8-4019-A4C4-9F923C259C47}"/>
+                <a16:creationId xmlns:a16="http://schemas.microsoft.com/office/drawing/2014/main" id="{00451AA4-AD84-46C4-8460-F2E59C17AD62}"/>
               </a:ext>
             </a:extLst>
           </p:cNvPr>
@@ -17708,7 +17688,7 @@
           <p:cNvPr id="8" name="">
             <a:extLst xmlns:a="http://schemas.openxmlformats.org/drawingml/2006/main">
               <a:ext uri="{FF2B5EF4-FFF2-40B4-BE49-F238E27FC236}">
-                <a16:creationId xmlns:a16="http://schemas.microsoft.com/office/drawing/2014/main" id="{AA1EEA82-238C-4D16-993D-DAF308A334BF}"/>
+                <a16:creationId xmlns:a16="http://schemas.microsoft.com/office/drawing/2014/main" id="{841BAD7C-F24E-4433-998C-F4ABE0186841}"/>
               </a:ext>
             </a:extLst>
           </p:cNvPr>
@@ -17770,7 +17750,7 @@
           <p:cNvPr id="9" name="">
             <a:extLst xmlns:a="http://schemas.openxmlformats.org/drawingml/2006/main">
               <a:ext uri="{FF2B5EF4-FFF2-40B4-BE49-F238E27FC236}">
-                <a16:creationId xmlns:a16="http://schemas.microsoft.com/office/drawing/2014/main" id="{EA1CED0C-FCEC-4119-90A5-BF3A4C5502E4}"/>
+                <a16:creationId xmlns:a16="http://schemas.microsoft.com/office/drawing/2014/main" id="{163749FE-4E32-4239-87FA-A02DB5B0A290}"/>
               </a:ext>
             </a:extLst>
           </p:cNvPr>
@@ -17832,7 +17812,7 @@
           <p:cNvPr id="10" name="">
             <a:extLst xmlns:a="http://schemas.openxmlformats.org/drawingml/2006/main">
               <a:ext uri="{FF2B5EF4-FFF2-40B4-BE49-F238E27FC236}">
-                <a16:creationId xmlns:a16="http://schemas.microsoft.com/office/drawing/2014/main" id="{4E866579-AF2D-4AA0-9C3F-40CAD2F482CC}"/>
+                <a16:creationId xmlns:a16="http://schemas.microsoft.com/office/drawing/2014/main" id="{A94F0FE5-7B64-448C-BC80-12FE55B62C61}"/>
               </a:ext>
             </a:extLst>
           </p:cNvPr>
@@ -17894,7 +17874,7 @@
           <p:cNvPr id="11" name="">
             <a:extLst xmlns:a="http://schemas.openxmlformats.org/drawingml/2006/main">
               <a:ext uri="{FF2B5EF4-FFF2-40B4-BE49-F238E27FC236}">
-                <a16:creationId xmlns:a16="http://schemas.microsoft.com/office/drawing/2014/main" id="{A5DBBAE1-0996-4F7A-B98B-B92783DF4905}"/>
+                <a16:creationId xmlns:a16="http://schemas.microsoft.com/office/drawing/2014/main" id="{863A68CE-5195-43EA-A14C-A53CA4F35993}"/>
               </a:ext>
             </a:extLst>
           </p:cNvPr>
@@ -17925,7 +17905,7 @@
           <p:cNvPr id="12" name="">
             <a:extLst xmlns:a="http://schemas.openxmlformats.org/drawingml/2006/main">
               <a:ext uri="{FF2B5EF4-FFF2-40B4-BE49-F238E27FC236}">
-                <a16:creationId xmlns:a16="http://schemas.microsoft.com/office/drawing/2014/main" id="{7F56661D-081C-4D93-9902-A6260E02E367}"/>
+                <a16:creationId xmlns:a16="http://schemas.microsoft.com/office/drawing/2014/main" id="{33759EEB-FE08-44F9-8BE9-21DABD6D4DEF}"/>
               </a:ext>
             </a:extLst>
           </p:cNvPr>
@@ -17987,7 +17967,7 @@
           <p:cNvPr id="13" name="">
             <a:extLst xmlns:a="http://schemas.openxmlformats.org/drawingml/2006/main">
               <a:ext uri="{FF2B5EF4-FFF2-40B4-BE49-F238E27FC236}">
-                <a16:creationId xmlns:a16="http://schemas.microsoft.com/office/drawing/2014/main" id="{53225F62-D06A-42BE-9271-C28154C64AC8}"/>
+                <a16:creationId xmlns:a16="http://schemas.microsoft.com/office/drawing/2014/main" id="{B73B5F03-A89D-443A-88C4-AA24963BE7F5}"/>
               </a:ext>
             </a:extLst>
           </p:cNvPr>
@@ -18049,7 +18029,7 @@
           <p:cNvPr id="14" name="">
             <a:extLst xmlns:a="http://schemas.openxmlformats.org/drawingml/2006/main">
               <a:ext uri="{FF2B5EF4-FFF2-40B4-BE49-F238E27FC236}">
-                <a16:creationId xmlns:a16="http://schemas.microsoft.com/office/drawing/2014/main" id="{00B40E10-1E07-4E9D-95FD-9FE5ABA37DCE}"/>
+                <a16:creationId xmlns:a16="http://schemas.microsoft.com/office/drawing/2014/main" id="{1A1130BC-1C7D-49F1-8E12-CA8CDCCB5463}"/>
               </a:ext>
             </a:extLst>
           </p:cNvPr>
@@ -18111,7 +18091,7 @@
           <p:cNvPr id="15" name="">
             <a:extLst xmlns:a="http://schemas.openxmlformats.org/drawingml/2006/main">
               <a:ext uri="{FF2B5EF4-FFF2-40B4-BE49-F238E27FC236}">
-                <a16:creationId xmlns:a16="http://schemas.microsoft.com/office/drawing/2014/main" id="{ABC52C5B-EE82-4CF7-9338-C2C335ECF6D3}"/>
+                <a16:creationId xmlns:a16="http://schemas.microsoft.com/office/drawing/2014/main" id="{D40EACDD-9864-49E2-A009-486F6E282FE2}"/>
               </a:ext>
             </a:extLst>
           </p:cNvPr>
@@ -18142,7 +18122,7 @@
           <p:cNvPr id="16" name="">
             <a:extLst xmlns:a="http://schemas.openxmlformats.org/drawingml/2006/main">
               <a:ext uri="{FF2B5EF4-FFF2-40B4-BE49-F238E27FC236}">
-                <a16:creationId xmlns:a16="http://schemas.microsoft.com/office/drawing/2014/main" id="{BC4B9550-B081-49C0-B8D5-AD910A7ADB0F}"/>
+                <a16:creationId xmlns:a16="http://schemas.microsoft.com/office/drawing/2014/main" id="{2C1953B3-13DF-45DE-A505-7A0D9297F3FC}"/>
               </a:ext>
             </a:extLst>
           </p:cNvPr>
@@ -18204,7 +18184,7 @@
           <p:cNvPr id="17" name="">
             <a:extLst xmlns:a="http://schemas.openxmlformats.org/drawingml/2006/main">
               <a:ext uri="{FF2B5EF4-FFF2-40B4-BE49-F238E27FC236}">
-                <a16:creationId xmlns:a16="http://schemas.microsoft.com/office/drawing/2014/main" id="{97012519-6F32-4A02-9CAB-407A82B3E444}"/>
+                <a16:creationId xmlns:a16="http://schemas.microsoft.com/office/drawing/2014/main" id="{73A40CDB-F9BD-49AA-AD0B-BA30916013AF}"/>
               </a:ext>
             </a:extLst>
           </p:cNvPr>
@@ -18266,7 +18246,7 @@
           <p:cNvPr id="18" name="">
             <a:extLst xmlns:a="http://schemas.openxmlformats.org/drawingml/2006/main">
               <a:ext uri="{FF2B5EF4-FFF2-40B4-BE49-F238E27FC236}">
-                <a16:creationId xmlns:a16="http://schemas.microsoft.com/office/drawing/2014/main" id="{5D92F9C2-57C8-4E59-9308-E54D54069537}"/>
+                <a16:creationId xmlns:a16="http://schemas.microsoft.com/office/drawing/2014/main" id="{667B284D-171C-4AA2-B57A-2E9357FBCFC9}"/>
               </a:ext>
             </a:extLst>
           </p:cNvPr>
@@ -18328,7 +18308,7 @@
           <p:cNvPr id="19" name="">
             <a:extLst xmlns:a="http://schemas.openxmlformats.org/drawingml/2006/main">
               <a:ext uri="{FF2B5EF4-FFF2-40B4-BE49-F238E27FC236}">
-                <a16:creationId xmlns:a16="http://schemas.microsoft.com/office/drawing/2014/main" id="{247FC7D4-0B97-4F38-B532-602C986DBF66}"/>
+                <a16:creationId xmlns:a16="http://schemas.microsoft.com/office/drawing/2014/main" id="{0E0454E1-8A61-4ADA-85E4-985FAD17BB15}"/>
               </a:ext>
             </a:extLst>
           </p:cNvPr>
@@ -18359,7 +18339,7 @@
           <p:cNvPr id="20" name="">
             <a:extLst xmlns:a="http://schemas.openxmlformats.org/drawingml/2006/main">
               <a:ext uri="{FF2B5EF4-FFF2-40B4-BE49-F238E27FC236}">
-                <a16:creationId xmlns:a16="http://schemas.microsoft.com/office/drawing/2014/main" id="{53971E38-0A20-4111-AA17-1DA66AD1788B}"/>
+                <a16:creationId xmlns:a16="http://schemas.microsoft.com/office/drawing/2014/main" id="{ACBCE747-88C7-4C02-85F4-B9137F5E1C45}"/>
               </a:ext>
             </a:extLst>
           </p:cNvPr>
@@ -18421,7 +18401,7 @@
           <p:cNvPr id="21" name="">
             <a:extLst xmlns:a="http://schemas.openxmlformats.org/drawingml/2006/main">
               <a:ext uri="{FF2B5EF4-FFF2-40B4-BE49-F238E27FC236}">
-                <a16:creationId xmlns:a16="http://schemas.microsoft.com/office/drawing/2014/main" id="{EA95AFD4-06BD-4E37-BD35-975F1E11A56D}"/>
+                <a16:creationId xmlns:a16="http://schemas.microsoft.com/office/drawing/2014/main" id="{0D56664E-587E-4686-A614-4D33ECA76B24}"/>
               </a:ext>
             </a:extLst>
           </p:cNvPr>
@@ -18483,7 +18463,7 @@
           <p:cNvPr id="22" name="">
             <a:extLst xmlns:a="http://schemas.openxmlformats.org/drawingml/2006/main">
               <a:ext uri="{FF2B5EF4-FFF2-40B4-BE49-F238E27FC236}">
-                <a16:creationId xmlns:a16="http://schemas.microsoft.com/office/drawing/2014/main" id="{3FF35B7D-4775-4C98-88A3-09890084AF93}"/>
+                <a16:creationId xmlns:a16="http://schemas.microsoft.com/office/drawing/2014/main" id="{50728F10-6893-4FD2-ACCB-2EED94BF0DBB}"/>
               </a:ext>
             </a:extLst>
           </p:cNvPr>
@@ -18545,7 +18525,7 @@
           <p:cNvPr id="23" name="">
             <a:extLst xmlns:a="http://schemas.openxmlformats.org/drawingml/2006/main">
               <a:ext uri="{FF2B5EF4-FFF2-40B4-BE49-F238E27FC236}">
-                <a16:creationId xmlns:a16="http://schemas.microsoft.com/office/drawing/2014/main" id="{850B7CBD-D5A8-43A7-8F4B-D0BD8F526EB5}"/>
+                <a16:creationId xmlns:a16="http://schemas.microsoft.com/office/drawing/2014/main" id="{A5A066A9-90DD-4F5E-9A29-B6ACD85E8755}"/>
               </a:ext>
             </a:extLst>
           </p:cNvPr>
@@ -18576,7 +18556,7 @@
           <p:cNvPr id="24" name="">
             <a:extLst xmlns:a="http://schemas.openxmlformats.org/drawingml/2006/main">
               <a:ext uri="{FF2B5EF4-FFF2-40B4-BE49-F238E27FC236}">
-                <a16:creationId xmlns:a16="http://schemas.microsoft.com/office/drawing/2014/main" id="{2E5BA04A-F1F7-4610-8F28-F8A4E7B175BE}"/>
+                <a16:creationId xmlns:a16="http://schemas.microsoft.com/office/drawing/2014/main" id="{01AE4093-A392-4585-ACB2-30486785B64D}"/>
               </a:ext>
             </a:extLst>
           </p:cNvPr>
@@ -18638,7 +18618,7 @@
           <p:cNvPr id="25" name="">
             <a:extLst xmlns:a="http://schemas.openxmlformats.org/drawingml/2006/main">
               <a:ext uri="{FF2B5EF4-FFF2-40B4-BE49-F238E27FC236}">
-                <a16:creationId xmlns:a16="http://schemas.microsoft.com/office/drawing/2014/main" id="{10890EF6-4E15-4C1D-8822-FBF76FA82091}"/>
+                <a16:creationId xmlns:a16="http://schemas.microsoft.com/office/drawing/2014/main" id="{A3327FB4-D04F-4840-BF44-D9C8671A64FC}"/>
               </a:ext>
             </a:extLst>
           </p:cNvPr>
@@ -18700,7 +18680,7 @@
           <p:cNvPr id="26" name="">
             <a:extLst xmlns:a="http://schemas.openxmlformats.org/drawingml/2006/main">
               <a:ext uri="{FF2B5EF4-FFF2-40B4-BE49-F238E27FC236}">
-                <a16:creationId xmlns:a16="http://schemas.microsoft.com/office/drawing/2014/main" id="{9C4FF5BB-6986-4320-8A6A-D31F51911B55}"/>
+                <a16:creationId xmlns:a16="http://schemas.microsoft.com/office/drawing/2014/main" id="{58D7B444-E4D4-4156-9BEF-28B275B3403E}"/>
               </a:ext>
             </a:extLst>
           </p:cNvPr>
@@ -18762,7 +18742,7 @@
           <p:cNvPr id="27" name="">
             <a:extLst xmlns:a="http://schemas.openxmlformats.org/drawingml/2006/main">
               <a:ext uri="{FF2B5EF4-FFF2-40B4-BE49-F238E27FC236}">
-                <a16:creationId xmlns:a16="http://schemas.microsoft.com/office/drawing/2014/main" id="{54F01127-0658-42ED-BAFD-67EF551ABCDB}"/>
+                <a16:creationId xmlns:a16="http://schemas.microsoft.com/office/drawing/2014/main" id="{4F33CCEC-EC85-4853-85D9-EDCA91156254}"/>
               </a:ext>
             </a:extLst>
           </p:cNvPr>
@@ -18824,7 +18804,7 @@
           <p:cNvPr id="28" name="footer-rule-5">
             <a:extLst xmlns:a="http://schemas.openxmlformats.org/drawingml/2006/main">
               <a:ext uri="{FF2B5EF4-FFF2-40B4-BE49-F238E27FC236}">
-                <a16:creationId xmlns:a16="http://schemas.microsoft.com/office/drawing/2014/main" id="{3F36D4D6-5FE4-460D-BBA2-8C8B79A965B2}"/>
+                <a16:creationId xmlns:a16="http://schemas.microsoft.com/office/drawing/2014/main" id="{5D728F36-203B-4118-BAA1-EA71C7112ACE}"/>
               </a:ext>
             </a:extLst>
           </p:cNvPr>
@@ -18855,7 +18835,7 @@
           <p:cNvPr id="29" name="footer-label-5">
             <a:extLst xmlns:a="http://schemas.openxmlformats.org/drawingml/2006/main">
               <a:ext uri="{FF2B5EF4-FFF2-40B4-BE49-F238E27FC236}">
-                <a16:creationId xmlns:a16="http://schemas.microsoft.com/office/drawing/2014/main" id="{32556ABD-E190-4B00-B65A-E7B1DE6DF186}"/>
+                <a16:creationId xmlns:a16="http://schemas.microsoft.com/office/drawing/2014/main" id="{BAD9A98A-EDF5-41ED-9945-3320111295E8}"/>
               </a:ext>
             </a:extLst>
           </p:cNvPr>
@@ -18917,7 +18897,7 @@
           <p:cNvPr id="30" name="footer-page-5">
             <a:extLst xmlns:a="http://schemas.openxmlformats.org/drawingml/2006/main">
               <a:ext uri="{FF2B5EF4-FFF2-40B4-BE49-F238E27FC236}">
-                <a16:creationId xmlns:a16="http://schemas.microsoft.com/office/drawing/2014/main" id="{B3931475-3D09-4038-8A3E-B92551CAF475}"/>
+                <a16:creationId xmlns:a16="http://schemas.microsoft.com/office/drawing/2014/main" id="{076211D0-F360-4236-A328-1CC0CDABF045}"/>
               </a:ext>
             </a:extLst>
           </p:cNvPr>
@@ -18977,7 +18957,7 @@
     </p:spTree>
     <p:extLst>
       <p:ext uri="{BB962C8B-B14F-4D97-AF65-F5344CB8AC3E}">
-        <p14:creationId xmlns:p14="http://schemas.microsoft.com/office/powerpoint/2010/main" val="548547154"/>
+        <p14:creationId xmlns:p14="http://schemas.microsoft.com/office/powerpoint/2010/main" val="540316928"/>
       </p:ext>
     </p:extLst>
   </p:cSld>
@@ -19008,7 +18988,7 @@
           <p:cNvPr id="22" name="side-accent-6">
             <a:extLst xmlns:a="http://schemas.openxmlformats.org/drawingml/2006/main">
               <a:ext uri="{FF2B5EF4-FFF2-40B4-BE49-F238E27FC236}">
-                <a16:creationId xmlns:a16="http://schemas.microsoft.com/office/drawing/2014/main" id="{288255DD-6640-45B5-9DE8-5739CAEF62A9}"/>
+                <a16:creationId xmlns:a16="http://schemas.microsoft.com/office/drawing/2014/main" id="{96A7D9CA-640F-406C-8955-AFB86A3C108D}"/>
               </a:ext>
             </a:extLst>
           </p:cNvPr>
@@ -19039,7 +19019,7 @@
           <p:cNvPr id="2" name="kicker-6">
             <a:extLst xmlns:a="http://schemas.openxmlformats.org/drawingml/2006/main">
               <a:ext uri="{FF2B5EF4-FFF2-40B4-BE49-F238E27FC236}">
-                <a16:creationId xmlns:a16="http://schemas.microsoft.com/office/drawing/2014/main" id="{CA09F1F1-94DA-4AC7-958A-9855ECA9987F}"/>
+                <a16:creationId xmlns:a16="http://schemas.microsoft.com/office/drawing/2014/main" id="{462494FB-2A4F-438A-B97F-4CF2F32B06D8}"/>
               </a:ext>
             </a:extLst>
           </p:cNvPr>
@@ -19101,7 +19081,7 @@
           <p:cNvPr id="3" name="title-6">
             <a:extLst xmlns:a="http://schemas.openxmlformats.org/drawingml/2006/main">
               <a:ext uri="{FF2B5EF4-FFF2-40B4-BE49-F238E27FC236}">
-                <a16:creationId xmlns:a16="http://schemas.microsoft.com/office/drawing/2014/main" id="{1F996BAE-A2BF-484D-9C40-BB8C2E76A2B9}"/>
+                <a16:creationId xmlns:a16="http://schemas.microsoft.com/office/drawing/2014/main" id="{892B815B-DEB6-4E2B-9E52-2ACCCC910DAB}"/>
               </a:ext>
             </a:extLst>
           </p:cNvPr>
@@ -19163,7 +19143,7 @@
           <p:cNvPr id="4" name="">
             <a:extLst xmlns:a="http://schemas.openxmlformats.org/drawingml/2006/main">
               <a:ext uri="{FF2B5EF4-FFF2-40B4-BE49-F238E27FC236}">
-                <a16:creationId xmlns:a16="http://schemas.microsoft.com/office/drawing/2014/main" id="{1F801C2A-10AC-4479-9E3A-82EBEFA9F02D}"/>
+                <a16:creationId xmlns:a16="http://schemas.microsoft.com/office/drawing/2014/main" id="{3813B364-F6A4-422A-91DD-21FA653F425C}"/>
               </a:ext>
             </a:extLst>
           </p:cNvPr>
@@ -19225,7 +19205,7 @@
           <p:cNvPr id="5" name="">
             <a:extLst xmlns:a="http://schemas.openxmlformats.org/drawingml/2006/main">
               <a:ext uri="{FF2B5EF4-FFF2-40B4-BE49-F238E27FC236}">
-                <a16:creationId xmlns:a16="http://schemas.microsoft.com/office/drawing/2014/main" id="{E48364ED-AF38-4E0D-AFD0-F8DDB8C6146B}"/>
+                <a16:creationId xmlns:a16="http://schemas.microsoft.com/office/drawing/2014/main" id="{C0F52C25-A7E6-4914-9B8C-2F396F78E669}"/>
               </a:ext>
             </a:extLst>
           </p:cNvPr>
@@ -19287,7 +19267,7 @@
           <p:cNvPr id="6" name="">
             <a:extLst xmlns:a="http://schemas.openxmlformats.org/drawingml/2006/main">
               <a:ext uri="{FF2B5EF4-FFF2-40B4-BE49-F238E27FC236}">
-                <a16:creationId xmlns:a16="http://schemas.microsoft.com/office/drawing/2014/main" id="{5F7727E3-DF84-4D21-A549-6B71835AC368}"/>
+                <a16:creationId xmlns:a16="http://schemas.microsoft.com/office/drawing/2014/main" id="{55960CA7-2796-4356-BC68-96FEC9255820}"/>
               </a:ext>
             </a:extLst>
           </p:cNvPr>
@@ -19349,7 +19329,7 @@
           <p:cNvPr id="7" name="">
             <a:extLst xmlns:a="http://schemas.openxmlformats.org/drawingml/2006/main">
               <a:ext uri="{FF2B5EF4-FFF2-40B4-BE49-F238E27FC236}">
-                <a16:creationId xmlns:a16="http://schemas.microsoft.com/office/drawing/2014/main" id="{4E69FECC-6A1E-4364-B438-E21794DA7D47}"/>
+                <a16:creationId xmlns:a16="http://schemas.microsoft.com/office/drawing/2014/main" id="{0B300621-EE0F-434B-A2E6-58AF58C522CF}"/>
               </a:ext>
             </a:extLst>
           </p:cNvPr>
@@ -19380,7 +19360,7 @@
           <p:cNvPr id="8" name="">
             <a:extLst xmlns:a="http://schemas.openxmlformats.org/drawingml/2006/main">
               <a:ext uri="{FF2B5EF4-FFF2-40B4-BE49-F238E27FC236}">
-                <a16:creationId xmlns:a16="http://schemas.microsoft.com/office/drawing/2014/main" id="{D8C0A20F-9180-4DC2-AEE8-B270B9C5A2B0}"/>
+                <a16:creationId xmlns:a16="http://schemas.microsoft.com/office/drawing/2014/main" id="{9A154997-8773-4C1A-BA75-B4A35E619AEF}"/>
               </a:ext>
             </a:extLst>
           </p:cNvPr>
@@ -19469,7 +19449,7 @@
           <p:cNvPr id="9" name="">
             <a:extLst xmlns:a="http://schemas.openxmlformats.org/drawingml/2006/main">
               <a:ext uri="{FF2B5EF4-FFF2-40B4-BE49-F238E27FC236}">
-                <a16:creationId xmlns:a16="http://schemas.microsoft.com/office/drawing/2014/main" id="{5297DCD2-0CF2-442C-827D-A564A9D6956A}"/>
+                <a16:creationId xmlns:a16="http://schemas.microsoft.com/office/drawing/2014/main" id="{AD0F056B-07C3-443E-9F01-27FBC0DA9076}"/>
               </a:ext>
             </a:extLst>
           </p:cNvPr>
@@ -19531,7 +19511,7 @@
           <p:cNvPr id="10" name="">
             <a:extLst xmlns:a="http://schemas.openxmlformats.org/drawingml/2006/main">
               <a:ext uri="{FF2B5EF4-FFF2-40B4-BE49-F238E27FC236}">
-                <a16:creationId xmlns:a16="http://schemas.microsoft.com/office/drawing/2014/main" id="{EA55E268-FE00-4247-8ED4-BAD8F6C6F39E}"/>
+                <a16:creationId xmlns:a16="http://schemas.microsoft.com/office/drawing/2014/main" id="{B6C94610-C785-4628-86C4-507D67D15F09}"/>
               </a:ext>
             </a:extLst>
           </p:cNvPr>
@@ -19593,7 +19573,7 @@
           <p:cNvPr id="11" name="">
             <a:extLst xmlns:a="http://schemas.openxmlformats.org/drawingml/2006/main">
               <a:ext uri="{FF2B5EF4-FFF2-40B4-BE49-F238E27FC236}">
-                <a16:creationId xmlns:a16="http://schemas.microsoft.com/office/drawing/2014/main" id="{3CA9F633-A1A5-40CF-82F5-326EF7E96C72}"/>
+                <a16:creationId xmlns:a16="http://schemas.microsoft.com/office/drawing/2014/main" id="{78468635-05EE-4A4C-ADE9-0E702B3C7066}"/>
               </a:ext>
             </a:extLst>
           </p:cNvPr>
@@ -19624,7 +19604,7 @@
           <p:cNvPr id="12" name="">
             <a:extLst xmlns:a="http://schemas.openxmlformats.org/drawingml/2006/main">
               <a:ext uri="{FF2B5EF4-FFF2-40B4-BE49-F238E27FC236}">
-                <a16:creationId xmlns:a16="http://schemas.microsoft.com/office/drawing/2014/main" id="{1731B229-A357-4BB2-B3A4-572ED308D0EA}"/>
+                <a16:creationId xmlns:a16="http://schemas.microsoft.com/office/drawing/2014/main" id="{21BDEDE8-C5D3-425C-B673-9534D7921D40}"/>
               </a:ext>
             </a:extLst>
           </p:cNvPr>
@@ -19713,7 +19693,7 @@
           <p:cNvPr id="13" name="">
             <a:extLst xmlns:a="http://schemas.openxmlformats.org/drawingml/2006/main">
               <a:ext uri="{FF2B5EF4-FFF2-40B4-BE49-F238E27FC236}">
-                <a16:creationId xmlns:a16="http://schemas.microsoft.com/office/drawing/2014/main" id="{FA400A76-1921-42CF-9A1B-4BA40B3CE332}"/>
+                <a16:creationId xmlns:a16="http://schemas.microsoft.com/office/drawing/2014/main" id="{D8D2A976-D978-4E98-9FB7-4B718A9BF2B1}"/>
               </a:ext>
             </a:extLst>
           </p:cNvPr>
@@ -19775,7 +19755,7 @@
           <p:cNvPr id="14" name="">
             <a:extLst xmlns:a="http://schemas.openxmlformats.org/drawingml/2006/main">
               <a:ext uri="{FF2B5EF4-FFF2-40B4-BE49-F238E27FC236}">
-                <a16:creationId xmlns:a16="http://schemas.microsoft.com/office/drawing/2014/main" id="{C256F7DF-A3C0-48FA-B5FB-8BC662FAF6F8}"/>
+                <a16:creationId xmlns:a16="http://schemas.microsoft.com/office/drawing/2014/main" id="{F1158B86-545A-4104-AE41-F7465C3F7783}"/>
               </a:ext>
             </a:extLst>
           </p:cNvPr>
@@ -19837,7 +19817,7 @@
           <p:cNvPr id="15" name="">
             <a:extLst xmlns:a="http://schemas.openxmlformats.org/drawingml/2006/main">
               <a:ext uri="{FF2B5EF4-FFF2-40B4-BE49-F238E27FC236}">
-                <a16:creationId xmlns:a16="http://schemas.microsoft.com/office/drawing/2014/main" id="{6E7279B7-2B13-4F02-9644-7BBBD8F80548}"/>
+                <a16:creationId xmlns:a16="http://schemas.microsoft.com/office/drawing/2014/main" id="{75068006-0445-4DEC-8459-0938EE972858}"/>
               </a:ext>
             </a:extLst>
           </p:cNvPr>
@@ -19868,7 +19848,7 @@
           <p:cNvPr id="16" name="">
             <a:extLst xmlns:a="http://schemas.openxmlformats.org/drawingml/2006/main">
               <a:ext uri="{FF2B5EF4-FFF2-40B4-BE49-F238E27FC236}">
-                <a16:creationId xmlns:a16="http://schemas.microsoft.com/office/drawing/2014/main" id="{C6D8B489-C11E-4C79-9431-0024095B1B8C}"/>
+                <a16:creationId xmlns:a16="http://schemas.microsoft.com/office/drawing/2014/main" id="{1DC878CC-C012-470F-9782-695B8B7ABF0B}"/>
               </a:ext>
             </a:extLst>
           </p:cNvPr>
@@ -19957,7 +19937,7 @@
           <p:cNvPr id="17" name="">
             <a:extLst xmlns:a="http://schemas.openxmlformats.org/drawingml/2006/main">
               <a:ext uri="{FF2B5EF4-FFF2-40B4-BE49-F238E27FC236}">
-                <a16:creationId xmlns:a16="http://schemas.microsoft.com/office/drawing/2014/main" id="{601AEBB5-D27A-429C-8BC2-508B896EBFCE}"/>
+                <a16:creationId xmlns:a16="http://schemas.microsoft.com/office/drawing/2014/main" id="{4CADB517-25C7-4703-8359-0C1D6808A8E4}"/>
               </a:ext>
             </a:extLst>
           </p:cNvPr>
@@ -19990,7 +19970,7 @@
           <p:cNvPr id="18" name="">
             <a:extLst xmlns:a="http://schemas.openxmlformats.org/drawingml/2006/main">
               <a:ext uri="{FF2B5EF4-FFF2-40B4-BE49-F238E27FC236}">
-                <a16:creationId xmlns:a16="http://schemas.microsoft.com/office/drawing/2014/main" id="{850CA92E-71FF-4368-9EB3-781B54E67C7A}"/>
+                <a16:creationId xmlns:a16="http://schemas.microsoft.com/office/drawing/2014/main" id="{EF0E1202-24B3-414A-9F9E-C88F371D479D}"/>
               </a:ext>
             </a:extLst>
           </p:cNvPr>
@@ -20079,7 +20059,7 @@
           <p:cNvPr id="19" name="footer-rule-6">
             <a:extLst xmlns:a="http://schemas.openxmlformats.org/drawingml/2006/main">
               <a:ext uri="{FF2B5EF4-FFF2-40B4-BE49-F238E27FC236}">
-                <a16:creationId xmlns:a16="http://schemas.microsoft.com/office/drawing/2014/main" id="{5BD37E18-25B2-4C79-885E-FA5C0A73A1C9}"/>
+                <a16:creationId xmlns:a16="http://schemas.microsoft.com/office/drawing/2014/main" id="{B5B3F8B6-EF52-4635-810E-8530470E987F}"/>
               </a:ext>
             </a:extLst>
           </p:cNvPr>
@@ -20110,7 +20090,7 @@
           <p:cNvPr id="20" name="footer-label-6">
             <a:extLst xmlns:a="http://schemas.openxmlformats.org/drawingml/2006/main">
               <a:ext uri="{FF2B5EF4-FFF2-40B4-BE49-F238E27FC236}">
-                <a16:creationId xmlns:a16="http://schemas.microsoft.com/office/drawing/2014/main" id="{56835014-A94C-4DAE-90DE-BA01E59FAFFD}"/>
+                <a16:creationId xmlns:a16="http://schemas.microsoft.com/office/drawing/2014/main" id="{6F3C2DD0-077E-42AF-85D6-B60251261DDD}"/>
               </a:ext>
             </a:extLst>
           </p:cNvPr>
@@ -20172,7 +20152,7 @@
           <p:cNvPr id="21" name="footer-page-6">
             <a:extLst xmlns:a="http://schemas.openxmlformats.org/drawingml/2006/main">
               <a:ext uri="{FF2B5EF4-FFF2-40B4-BE49-F238E27FC236}">
-                <a16:creationId xmlns:a16="http://schemas.microsoft.com/office/drawing/2014/main" id="{903D463F-FA1E-4DC0-A49D-6DFAF7128F13}"/>
+                <a16:creationId xmlns:a16="http://schemas.microsoft.com/office/drawing/2014/main" id="{3D22904A-B510-4867-9720-881FE55CCDEC}"/>
               </a:ext>
             </a:extLst>
           </p:cNvPr>
@@ -20232,7 +20212,7 @@
     </p:spTree>
     <p:extLst>
       <p:ext uri="{BB962C8B-B14F-4D97-AF65-F5344CB8AC3E}">
-        <p14:creationId xmlns:p14="http://schemas.microsoft.com/office/powerpoint/2010/main" val="2027408015"/>
+        <p14:creationId xmlns:p14="http://schemas.microsoft.com/office/powerpoint/2010/main" val="224956049"/>
       </p:ext>
     </p:extLst>
   </p:cSld>
@@ -20263,7 +20243,7 @@
           <p:cNvPr id="28" name="side-accent-7">
             <a:extLst xmlns:a="http://schemas.openxmlformats.org/drawingml/2006/main">
               <a:ext uri="{FF2B5EF4-FFF2-40B4-BE49-F238E27FC236}">
-                <a16:creationId xmlns:a16="http://schemas.microsoft.com/office/drawing/2014/main" id="{B397A22D-859E-455A-9525-C77271CFAFFD}"/>
+                <a16:creationId xmlns:a16="http://schemas.microsoft.com/office/drawing/2014/main" id="{9B4372F5-D313-4D89-BBF7-B90E2F7C406D}"/>
               </a:ext>
             </a:extLst>
           </p:cNvPr>
@@ -20294,7 +20274,7 @@
           <p:cNvPr id="2" name="kicker-7">
             <a:extLst xmlns:a="http://schemas.openxmlformats.org/drawingml/2006/main">
               <a:ext uri="{FF2B5EF4-FFF2-40B4-BE49-F238E27FC236}">
-                <a16:creationId xmlns:a16="http://schemas.microsoft.com/office/drawing/2014/main" id="{3FB26EE2-BDD0-4C87-ABEE-3CA7B5DBE007}"/>
+                <a16:creationId xmlns:a16="http://schemas.microsoft.com/office/drawing/2014/main" id="{54132BF3-B24C-4627-990C-8DEAEE743116}"/>
               </a:ext>
             </a:extLst>
           </p:cNvPr>
@@ -20356,7 +20336,7 @@
           <p:cNvPr id="3" name="title-7">
             <a:extLst xmlns:a="http://schemas.openxmlformats.org/drawingml/2006/main">
               <a:ext uri="{FF2B5EF4-FFF2-40B4-BE49-F238E27FC236}">
-                <a16:creationId xmlns:a16="http://schemas.microsoft.com/office/drawing/2014/main" id="{CB8C9C4E-F718-4A15-9696-914A7F00AC6F}"/>
+                <a16:creationId xmlns:a16="http://schemas.microsoft.com/office/drawing/2014/main" id="{208617F6-FB6A-4681-AC68-3CAE27F5B9FF}"/>
               </a:ext>
             </a:extLst>
           </p:cNvPr>
@@ -20418,7 +20398,7 @@
           <p:cNvPr id="4" name="">
             <a:extLst xmlns:a="http://schemas.openxmlformats.org/drawingml/2006/main">
               <a:ext uri="{FF2B5EF4-FFF2-40B4-BE49-F238E27FC236}">
-                <a16:creationId xmlns:a16="http://schemas.microsoft.com/office/drawing/2014/main" id="{1DD49E9B-1A59-4530-B00B-1ED486364B36}"/>
+                <a16:creationId xmlns:a16="http://schemas.microsoft.com/office/drawing/2014/main" id="{BE82332F-ABD3-41F2-B2A5-2BAD1510346F}"/>
               </a:ext>
             </a:extLst>
           </p:cNvPr>
@@ -20480,7 +20460,7 @@
           <p:cNvPr id="5" name="">
             <a:extLst xmlns:a="http://schemas.openxmlformats.org/drawingml/2006/main">
               <a:ext uri="{FF2B5EF4-FFF2-40B4-BE49-F238E27FC236}">
-                <a16:creationId xmlns:a16="http://schemas.microsoft.com/office/drawing/2014/main" id="{1C804F82-6E80-4F7E-8307-4145FA4F0005}"/>
+                <a16:creationId xmlns:a16="http://schemas.microsoft.com/office/drawing/2014/main" id="{4B4E5E66-99F0-48C1-8A69-71DF965D6501}"/>
               </a:ext>
             </a:extLst>
           </p:cNvPr>
@@ -20511,7 +20491,7 @@
           <p:cNvPr id="6" name="">
             <a:extLst xmlns:a="http://schemas.openxmlformats.org/drawingml/2006/main">
               <a:ext uri="{FF2B5EF4-FFF2-40B4-BE49-F238E27FC236}">
-                <a16:creationId xmlns:a16="http://schemas.microsoft.com/office/drawing/2014/main" id="{CA131B23-0426-4E2C-B045-B70AA5A03CFF}"/>
+                <a16:creationId xmlns:a16="http://schemas.microsoft.com/office/drawing/2014/main" id="{BD9847FF-6495-420B-BA23-43675B6ACF74}"/>
               </a:ext>
             </a:extLst>
           </p:cNvPr>
@@ -20573,7 +20553,7 @@
           <p:cNvPr id="7" name="">
             <a:extLst xmlns:a="http://schemas.openxmlformats.org/drawingml/2006/main">
               <a:ext uri="{FF2B5EF4-FFF2-40B4-BE49-F238E27FC236}">
-                <a16:creationId xmlns:a16="http://schemas.microsoft.com/office/drawing/2014/main" id="{28605076-0D0C-4E0C-B950-9ED870F83B3C}"/>
+                <a16:creationId xmlns:a16="http://schemas.microsoft.com/office/drawing/2014/main" id="{F874C223-AB94-4BCD-92A8-5C311A68371F}"/>
               </a:ext>
             </a:extLst>
           </p:cNvPr>
@@ -20635,7 +20615,7 @@
           <p:cNvPr id="8" name="">
             <a:extLst xmlns:a="http://schemas.openxmlformats.org/drawingml/2006/main">
               <a:ext uri="{FF2B5EF4-FFF2-40B4-BE49-F238E27FC236}">
-                <a16:creationId xmlns:a16="http://schemas.microsoft.com/office/drawing/2014/main" id="{27AB68E8-A62A-4224-BE2E-A3A6E97225E5}"/>
+                <a16:creationId xmlns:a16="http://schemas.microsoft.com/office/drawing/2014/main" id="{15194C42-E5B5-4C0C-8B15-8E3076CFE7FE}"/>
               </a:ext>
             </a:extLst>
           </p:cNvPr>
@@ -20697,7 +20677,7 @@
           <p:cNvPr id="9" name="">
             <a:extLst xmlns:a="http://schemas.openxmlformats.org/drawingml/2006/main">
               <a:ext uri="{FF2B5EF4-FFF2-40B4-BE49-F238E27FC236}">
-                <a16:creationId xmlns:a16="http://schemas.microsoft.com/office/drawing/2014/main" id="{D7991D8F-EE4C-40AD-91DA-E64EC4BAAD9F}"/>
+                <a16:creationId xmlns:a16="http://schemas.microsoft.com/office/drawing/2014/main" id="{392EBA10-3442-4F29-A8AE-FE18C97A2DDF}"/>
               </a:ext>
             </a:extLst>
           </p:cNvPr>
@@ -20728,7 +20708,7 @@
           <p:cNvPr id="10" name="">
             <a:extLst xmlns:a="http://schemas.openxmlformats.org/drawingml/2006/main">
               <a:ext uri="{FF2B5EF4-FFF2-40B4-BE49-F238E27FC236}">
-                <a16:creationId xmlns:a16="http://schemas.microsoft.com/office/drawing/2014/main" id="{3851888A-4FF7-4EC1-BFB8-0633E51FC603}"/>
+                <a16:creationId xmlns:a16="http://schemas.microsoft.com/office/drawing/2014/main" id="{C7394575-E5C7-49D5-85C5-DCADFE67C823}"/>
               </a:ext>
             </a:extLst>
           </p:cNvPr>
@@ -20790,7 +20770,7 @@
           <p:cNvPr id="11" name="">
             <a:extLst xmlns:a="http://schemas.openxmlformats.org/drawingml/2006/main">
               <a:ext uri="{FF2B5EF4-FFF2-40B4-BE49-F238E27FC236}">
-                <a16:creationId xmlns:a16="http://schemas.microsoft.com/office/drawing/2014/main" id="{06D5EBAC-4A13-40C5-9901-0113E8E8992F}"/>
+                <a16:creationId xmlns:a16="http://schemas.microsoft.com/office/drawing/2014/main" id="{0F31714E-4DD3-4C49-957F-22A969020C0E}"/>
               </a:ext>
             </a:extLst>
           </p:cNvPr>
@@ -20852,7 +20832,7 @@
           <p:cNvPr id="12" name="">
             <a:extLst xmlns:a="http://schemas.openxmlformats.org/drawingml/2006/main">
               <a:ext uri="{FF2B5EF4-FFF2-40B4-BE49-F238E27FC236}">
-                <a16:creationId xmlns:a16="http://schemas.microsoft.com/office/drawing/2014/main" id="{DAE8955E-788D-41D7-BAE6-6A51820BF8B0}"/>
+                <a16:creationId xmlns:a16="http://schemas.microsoft.com/office/drawing/2014/main" id="{4800E0E9-6958-4A15-879B-D7B814BB22B9}"/>
               </a:ext>
             </a:extLst>
           </p:cNvPr>
@@ -20914,7 +20894,7 @@
           <p:cNvPr id="13" name="">
             <a:extLst xmlns:a="http://schemas.openxmlformats.org/drawingml/2006/main">
               <a:ext uri="{FF2B5EF4-FFF2-40B4-BE49-F238E27FC236}">
-                <a16:creationId xmlns:a16="http://schemas.microsoft.com/office/drawing/2014/main" id="{46D98321-D951-4CE4-8C7A-F7B4ECDCC05B}"/>
+                <a16:creationId xmlns:a16="http://schemas.microsoft.com/office/drawing/2014/main" id="{C4529DB0-29F2-464C-B3EA-F9BC242B480E}"/>
               </a:ext>
             </a:extLst>
           </p:cNvPr>
@@ -20945,7 +20925,7 @@
           <p:cNvPr id="14" name="">
             <a:extLst xmlns:a="http://schemas.openxmlformats.org/drawingml/2006/main">
               <a:ext uri="{FF2B5EF4-FFF2-40B4-BE49-F238E27FC236}">
-                <a16:creationId xmlns:a16="http://schemas.microsoft.com/office/drawing/2014/main" id="{7FBAA4FC-034D-4BAA-BAB9-7E11A1F76F40}"/>
+                <a16:creationId xmlns:a16="http://schemas.microsoft.com/office/drawing/2014/main" id="{B51BCF44-4A4E-46FF-9CCA-708ABB68070F}"/>
               </a:ext>
             </a:extLst>
           </p:cNvPr>
@@ -21007,7 +20987,7 @@
           <p:cNvPr id="15" name="">
             <a:extLst xmlns:a="http://schemas.openxmlformats.org/drawingml/2006/main">
               <a:ext uri="{FF2B5EF4-FFF2-40B4-BE49-F238E27FC236}">
-                <a16:creationId xmlns:a16="http://schemas.microsoft.com/office/drawing/2014/main" id="{20DED32E-C45E-453E-8044-2405335E5DE7}"/>
+                <a16:creationId xmlns:a16="http://schemas.microsoft.com/office/drawing/2014/main" id="{466301A5-DADA-4C44-A6CA-F6B78008FA04}"/>
               </a:ext>
             </a:extLst>
           </p:cNvPr>
@@ -21069,7 +21049,7 @@
           <p:cNvPr id="16" name="">
             <a:extLst xmlns:a="http://schemas.openxmlformats.org/drawingml/2006/main">
               <a:ext uri="{FF2B5EF4-FFF2-40B4-BE49-F238E27FC236}">
-                <a16:creationId xmlns:a16="http://schemas.microsoft.com/office/drawing/2014/main" id="{33F42662-CAD9-4A71-8556-1D8B51B1258A}"/>
+                <a16:creationId xmlns:a16="http://schemas.microsoft.com/office/drawing/2014/main" id="{FF37319F-D11C-45FA-B0D7-56070528E078}"/>
               </a:ext>
             </a:extLst>
           </p:cNvPr>
@@ -21131,7 +21111,7 @@
           <p:cNvPr id="17" name="dashboard-preview">
             <a:extLst xmlns:a="http://schemas.openxmlformats.org/drawingml/2006/main">
               <a:ext uri="{FF2B5EF4-FFF2-40B4-BE49-F238E27FC236}">
-                <a16:creationId xmlns:a16="http://schemas.microsoft.com/office/drawing/2014/main" id="{35C85E97-8818-4511-A5B5-F97941446260}"/>
+                <a16:creationId xmlns:a16="http://schemas.microsoft.com/office/drawing/2014/main" id="{D9E1185B-08D8-4187-B8B0-4CB301D5046B}"/>
               </a:ext>
             </a:extLst>
           </p:cNvPr>
@@ -21166,7 +21146,7 @@
           <p:cNvPr id="18" name="">
             <a:extLst xmlns:a="http://schemas.openxmlformats.org/drawingml/2006/main">
               <a:ext uri="{FF2B5EF4-FFF2-40B4-BE49-F238E27FC236}">
-                <a16:creationId xmlns:a16="http://schemas.microsoft.com/office/drawing/2014/main" id="{113BDF15-A151-481A-BC55-672AFBE47B60}"/>
+                <a16:creationId xmlns:a16="http://schemas.microsoft.com/office/drawing/2014/main" id="{C0DC3F27-C8E5-405A-B207-451E3BA3B92D}"/>
               </a:ext>
             </a:extLst>
           </p:cNvPr>
@@ -21228,7 +21208,7 @@
           <p:cNvPr id="19" name="">
             <a:extLst xmlns:a="http://schemas.openxmlformats.org/drawingml/2006/main">
               <a:ext uri="{FF2B5EF4-FFF2-40B4-BE49-F238E27FC236}">
-                <a16:creationId xmlns:a16="http://schemas.microsoft.com/office/drawing/2014/main" id="{8D97A8C7-8068-441B-B1BE-FF84FFC0735B}"/>
+                <a16:creationId xmlns:a16="http://schemas.microsoft.com/office/drawing/2014/main" id="{B5E32F7C-AAE0-47DB-AF85-32B6D4C3ADFE}"/>
               </a:ext>
             </a:extLst>
           </p:cNvPr>
@@ -21259,7 +21239,7 @@
           <p:cNvPr id="20" name="">
             <a:extLst xmlns:a="http://schemas.openxmlformats.org/drawingml/2006/main">
               <a:ext uri="{FF2B5EF4-FFF2-40B4-BE49-F238E27FC236}">
-                <a16:creationId xmlns:a16="http://schemas.microsoft.com/office/drawing/2014/main" id="{7E3B7729-84C2-4009-956B-566C6700FC7A}"/>
+                <a16:creationId xmlns:a16="http://schemas.microsoft.com/office/drawing/2014/main" id="{28C9FC7E-0AC3-417B-9A7C-AF6B59492CBC}"/>
               </a:ext>
             </a:extLst>
           </p:cNvPr>
@@ -21321,7 +21301,7 @@
           <p:cNvPr id="21" name="">
             <a:extLst xmlns:a="http://schemas.openxmlformats.org/drawingml/2006/main">
               <a:ext uri="{FF2B5EF4-FFF2-40B4-BE49-F238E27FC236}">
-                <a16:creationId xmlns:a16="http://schemas.microsoft.com/office/drawing/2014/main" id="{FA181EE3-6ECF-45DF-8E68-794451A2DC43}"/>
+                <a16:creationId xmlns:a16="http://schemas.microsoft.com/office/drawing/2014/main" id="{33DB07AF-0F51-4556-9FEF-64E02FDD3197}"/>
               </a:ext>
             </a:extLst>
           </p:cNvPr>
@@ -21352,7 +21332,7 @@
           <p:cNvPr id="22" name="">
             <a:extLst xmlns:a="http://schemas.openxmlformats.org/drawingml/2006/main">
               <a:ext uri="{FF2B5EF4-FFF2-40B4-BE49-F238E27FC236}">
-                <a16:creationId xmlns:a16="http://schemas.microsoft.com/office/drawing/2014/main" id="{0B729DF3-4972-4B07-9654-F3DFC710FD44}"/>
+                <a16:creationId xmlns:a16="http://schemas.microsoft.com/office/drawing/2014/main" id="{261D5617-AB94-4E4C-945C-3DE988949AF8}"/>
               </a:ext>
             </a:extLst>
           </p:cNvPr>
@@ -21383,7 +21363,7 @@
           <p:cNvPr id="23" name="">
             <a:extLst xmlns:a="http://schemas.openxmlformats.org/drawingml/2006/main">
               <a:ext uri="{FF2B5EF4-FFF2-40B4-BE49-F238E27FC236}">
-                <a16:creationId xmlns:a16="http://schemas.microsoft.com/office/drawing/2014/main" id="{696D28CA-C9EE-43EB-870C-73BDC33019D1}"/>
+                <a16:creationId xmlns:a16="http://schemas.microsoft.com/office/drawing/2014/main" id="{48127895-9BE1-4832-A34A-6D0751F19062}"/>
               </a:ext>
             </a:extLst>
           </p:cNvPr>
@@ -21416,7 +21396,7 @@
           <p:cNvPr id="24" name="">
             <a:extLst xmlns:a="http://schemas.openxmlformats.org/drawingml/2006/main">
               <a:ext uri="{FF2B5EF4-FFF2-40B4-BE49-F238E27FC236}">
-                <a16:creationId xmlns:a16="http://schemas.microsoft.com/office/drawing/2014/main" id="{CB2ECFAA-4E51-4FA4-B495-5EEFCA1A520D}"/>
+                <a16:creationId xmlns:a16="http://schemas.microsoft.com/office/drawing/2014/main" id="{A7716547-151B-4E04-9486-CF19CA191782}"/>
               </a:ext>
             </a:extLst>
           </p:cNvPr>
@@ -21478,7 +21458,7 @@
           <p:cNvPr id="25" name="footer-rule-7">
             <a:extLst xmlns:a="http://schemas.openxmlformats.org/drawingml/2006/main">
               <a:ext uri="{FF2B5EF4-FFF2-40B4-BE49-F238E27FC236}">
-                <a16:creationId xmlns:a16="http://schemas.microsoft.com/office/drawing/2014/main" id="{699AB444-FBA3-4643-B31C-C327C070D298}"/>
+                <a16:creationId xmlns:a16="http://schemas.microsoft.com/office/drawing/2014/main" id="{0A599B75-FAA5-4607-A667-442FDCDB7345}"/>
               </a:ext>
             </a:extLst>
           </p:cNvPr>
@@ -21509,7 +21489,7 @@
           <p:cNvPr id="26" name="footer-label-7">
             <a:extLst xmlns:a="http://schemas.openxmlformats.org/drawingml/2006/main">
               <a:ext uri="{FF2B5EF4-FFF2-40B4-BE49-F238E27FC236}">
-                <a16:creationId xmlns:a16="http://schemas.microsoft.com/office/drawing/2014/main" id="{B3B2B729-40C2-4DBB-A48A-07BD8A073ED9}"/>
+                <a16:creationId xmlns:a16="http://schemas.microsoft.com/office/drawing/2014/main" id="{CC4E7A8E-E8B4-4C5E-A423-98EE0A10FC5C}"/>
               </a:ext>
             </a:extLst>
           </p:cNvPr>
@@ -21571,7 +21551,7 @@
           <p:cNvPr id="27" name="footer-page-7">
             <a:extLst xmlns:a="http://schemas.openxmlformats.org/drawingml/2006/main">
               <a:ext uri="{FF2B5EF4-FFF2-40B4-BE49-F238E27FC236}">
-                <a16:creationId xmlns:a16="http://schemas.microsoft.com/office/drawing/2014/main" id="{CD41699A-F334-47ED-9E23-E6EA56DC43BC}"/>
+                <a16:creationId xmlns:a16="http://schemas.microsoft.com/office/drawing/2014/main" id="{CCD08EF8-1DE6-45F5-BCE9-E89C7532F028}"/>
               </a:ext>
             </a:extLst>
           </p:cNvPr>
@@ -21631,7 +21611,7 @@
     </p:spTree>
     <p:extLst>
       <p:ext uri="{BB962C8B-B14F-4D97-AF65-F5344CB8AC3E}">
-        <p14:creationId xmlns:p14="http://schemas.microsoft.com/office/powerpoint/2010/main" val="1381427731"/>
+        <p14:creationId xmlns:p14="http://schemas.microsoft.com/office/powerpoint/2010/main" val="1927335102"/>
       </p:ext>
     </p:extLst>
   </p:cSld>
@@ -21662,7 +21642,7 @@
           <p:cNvPr id="26" name="side-accent-8">
             <a:extLst xmlns:a="http://schemas.openxmlformats.org/drawingml/2006/main">
               <a:ext uri="{FF2B5EF4-FFF2-40B4-BE49-F238E27FC236}">
-                <a16:creationId xmlns:a16="http://schemas.microsoft.com/office/drawing/2014/main" id="{B2E65A84-5630-48BC-8ADA-B74213425ABA}"/>
+                <a16:creationId xmlns:a16="http://schemas.microsoft.com/office/drawing/2014/main" id="{24CBBD4C-EA63-4B0D-BC9B-2D01A016BD81}"/>
               </a:ext>
             </a:extLst>
           </p:cNvPr>
@@ -21693,7 +21673,7 @@
           <p:cNvPr id="2" name="kicker-8">
             <a:extLst xmlns:a="http://schemas.openxmlformats.org/drawingml/2006/main">
               <a:ext uri="{FF2B5EF4-FFF2-40B4-BE49-F238E27FC236}">
-                <a16:creationId xmlns:a16="http://schemas.microsoft.com/office/drawing/2014/main" id="{B4ED36FE-71B6-47E7-9605-29D21EAD9398}"/>
+                <a16:creationId xmlns:a16="http://schemas.microsoft.com/office/drawing/2014/main" id="{6D3DBB0B-47EB-42CF-845E-42324D4D9EF4}"/>
               </a:ext>
             </a:extLst>
           </p:cNvPr>
@@ -21755,7 +21735,7 @@
           <p:cNvPr id="3" name="title-8">
             <a:extLst xmlns:a="http://schemas.openxmlformats.org/drawingml/2006/main">
               <a:ext uri="{FF2B5EF4-FFF2-40B4-BE49-F238E27FC236}">
-                <a16:creationId xmlns:a16="http://schemas.microsoft.com/office/drawing/2014/main" id="{D851C8E6-D24F-4ACB-93EF-A670FECF6440}"/>
+                <a16:creationId xmlns:a16="http://schemas.microsoft.com/office/drawing/2014/main" id="{FC14FA47-1CDB-4E8F-BE0A-E4BAC93FEA95}"/>
               </a:ext>
             </a:extLst>
           </p:cNvPr>
@@ -21817,7 +21797,7 @@
           <p:cNvPr id="4" name="">
             <a:extLst xmlns:a="http://schemas.openxmlformats.org/drawingml/2006/main">
               <a:ext uri="{FF2B5EF4-FFF2-40B4-BE49-F238E27FC236}">
-                <a16:creationId xmlns:a16="http://schemas.microsoft.com/office/drawing/2014/main" id="{0ED3FF94-F5D0-4BD7-BF9E-3AC0E4D585DB}"/>
+                <a16:creationId xmlns:a16="http://schemas.microsoft.com/office/drawing/2014/main" id="{0F4B21D8-1872-4F2D-9100-D5EAE8B34580}"/>
               </a:ext>
             </a:extLst>
           </p:cNvPr>
@@ -21879,7 +21859,7 @@
           <p:cNvPr id="5" name="">
             <a:extLst xmlns:a="http://schemas.openxmlformats.org/drawingml/2006/main">
               <a:ext uri="{FF2B5EF4-FFF2-40B4-BE49-F238E27FC236}">
-                <a16:creationId xmlns:a16="http://schemas.microsoft.com/office/drawing/2014/main" id="{45350EEB-FAC1-44A2-89D4-1419B27F3056}"/>
+                <a16:creationId xmlns:a16="http://schemas.microsoft.com/office/drawing/2014/main" id="{CBF1579D-E094-4D43-8010-0FE0C56C5DCA}"/>
               </a:ext>
             </a:extLst>
           </p:cNvPr>
@@ -21910,7 +21890,7 @@
           <p:cNvPr id="6" name="">
             <a:extLst xmlns:a="http://schemas.openxmlformats.org/drawingml/2006/main">
               <a:ext uri="{FF2B5EF4-FFF2-40B4-BE49-F238E27FC236}">
-                <a16:creationId xmlns:a16="http://schemas.microsoft.com/office/drawing/2014/main" id="{276A741C-EA45-44CF-BAA1-1F097A4FFDD8}"/>
+                <a16:creationId xmlns:a16="http://schemas.microsoft.com/office/drawing/2014/main" id="{0FAF7E0E-352E-4FBF-A32C-D554C97E4783}"/>
               </a:ext>
             </a:extLst>
           </p:cNvPr>
@@ -21941,7 +21921,7 @@
           <p:cNvPr id="7" name="">
             <a:extLst xmlns:a="http://schemas.openxmlformats.org/drawingml/2006/main">
               <a:ext uri="{FF2B5EF4-FFF2-40B4-BE49-F238E27FC236}">
-                <a16:creationId xmlns:a16="http://schemas.microsoft.com/office/drawing/2014/main" id="{098DC43A-D070-4A82-881A-BBC407FC56D7}"/>
+                <a16:creationId xmlns:a16="http://schemas.microsoft.com/office/drawing/2014/main" id="{18DE1D29-C3CB-471B-A8BC-9D62FFA531AE}"/>
               </a:ext>
             </a:extLst>
           </p:cNvPr>
@@ -22003,7 +21983,7 @@
           <p:cNvPr id="8" name="">
             <a:extLst xmlns:a="http://schemas.openxmlformats.org/drawingml/2006/main">
               <a:ext uri="{FF2B5EF4-FFF2-40B4-BE49-F238E27FC236}">
-                <a16:creationId xmlns:a16="http://schemas.microsoft.com/office/drawing/2014/main" id="{9BE1325E-4A6D-4DEA-961B-845B49ACA676}"/>
+                <a16:creationId xmlns:a16="http://schemas.microsoft.com/office/drawing/2014/main" id="{686FAC4C-7D9C-4BC7-9EF4-C2FBDAFCE625}"/>
               </a:ext>
             </a:extLst>
           </p:cNvPr>
@@ -22065,7 +22045,7 @@
           <p:cNvPr id="9" name="">
             <a:extLst xmlns:a="http://schemas.openxmlformats.org/drawingml/2006/main">
               <a:ext uri="{FF2B5EF4-FFF2-40B4-BE49-F238E27FC236}">
-                <a16:creationId xmlns:a16="http://schemas.microsoft.com/office/drawing/2014/main" id="{C6CCB6C5-9B23-413F-9DB5-FFC67ABCDF8C}"/>
+                <a16:creationId xmlns:a16="http://schemas.microsoft.com/office/drawing/2014/main" id="{066BB28B-9E24-47D4-ADA3-7813E18A0890}"/>
               </a:ext>
             </a:extLst>
           </p:cNvPr>
@@ -22127,7 +22107,7 @@
           <p:cNvPr id="10" name="">
             <a:extLst xmlns:a="http://schemas.openxmlformats.org/drawingml/2006/main">
               <a:ext uri="{FF2B5EF4-FFF2-40B4-BE49-F238E27FC236}">
-                <a16:creationId xmlns:a16="http://schemas.microsoft.com/office/drawing/2014/main" id="{C067306A-09A9-46C1-B625-DF1B980447C1}"/>
+                <a16:creationId xmlns:a16="http://schemas.microsoft.com/office/drawing/2014/main" id="{C4C33D2B-3F83-473A-A1D8-D5DE63BA7861}"/>
               </a:ext>
             </a:extLst>
           </p:cNvPr>
@@ -22158,7 +22138,7 @@
           <p:cNvPr id="11" name="">
             <a:extLst xmlns:a="http://schemas.openxmlformats.org/drawingml/2006/main">
               <a:ext uri="{FF2B5EF4-FFF2-40B4-BE49-F238E27FC236}">
-                <a16:creationId xmlns:a16="http://schemas.microsoft.com/office/drawing/2014/main" id="{A069B195-3D40-47DE-AD54-08BD61E5BC04}"/>
+                <a16:creationId xmlns:a16="http://schemas.microsoft.com/office/drawing/2014/main" id="{68825B47-4377-4ABE-9780-D30835F06F04}"/>
               </a:ext>
             </a:extLst>
           </p:cNvPr>
@@ -22220,7 +22200,7 @@
           <p:cNvPr id="12" name="">
             <a:extLst xmlns:a="http://schemas.openxmlformats.org/drawingml/2006/main">
               <a:ext uri="{FF2B5EF4-FFF2-40B4-BE49-F238E27FC236}">
-                <a16:creationId xmlns:a16="http://schemas.microsoft.com/office/drawing/2014/main" id="{A583D3A9-319E-4E60-990C-BB7F53AF0408}"/>
+                <a16:creationId xmlns:a16="http://schemas.microsoft.com/office/drawing/2014/main" id="{2A1F14C8-EBAE-4A97-8B87-9DAF47938805}"/>
               </a:ext>
             </a:extLst>
           </p:cNvPr>
@@ -22282,7 +22262,7 @@
           <p:cNvPr id="13" name="">
             <a:extLst xmlns:a="http://schemas.openxmlformats.org/drawingml/2006/main">
               <a:ext uri="{FF2B5EF4-FFF2-40B4-BE49-F238E27FC236}">
-                <a16:creationId xmlns:a16="http://schemas.microsoft.com/office/drawing/2014/main" id="{A8C017FB-2942-40FC-9005-7FB48EBEA19A}"/>
+                <a16:creationId xmlns:a16="http://schemas.microsoft.com/office/drawing/2014/main" id="{A12CE7ED-6DB0-4B9F-A24E-813AD3D8E0DB}"/>
               </a:ext>
             </a:extLst>
           </p:cNvPr>
@@ -22344,7 +22324,7 @@
           <p:cNvPr id="14" name="">
             <a:extLst xmlns:a="http://schemas.openxmlformats.org/drawingml/2006/main">
               <a:ext uri="{FF2B5EF4-FFF2-40B4-BE49-F238E27FC236}">
-                <a16:creationId xmlns:a16="http://schemas.microsoft.com/office/drawing/2014/main" id="{E586EC16-D7AC-4847-A868-E0B56493C886}"/>
+                <a16:creationId xmlns:a16="http://schemas.microsoft.com/office/drawing/2014/main" id="{6575CCC6-833D-4F44-96B7-917338940011}"/>
               </a:ext>
             </a:extLst>
           </p:cNvPr>
@@ -22375,7 +22355,7 @@
           <p:cNvPr id="15" name="">
             <a:extLst xmlns:a="http://schemas.openxmlformats.org/drawingml/2006/main">
               <a:ext uri="{FF2B5EF4-FFF2-40B4-BE49-F238E27FC236}">
-                <a16:creationId xmlns:a16="http://schemas.microsoft.com/office/drawing/2014/main" id="{7E973665-F06F-4E46-9406-2CC89FC0EBC8}"/>
+                <a16:creationId xmlns:a16="http://schemas.microsoft.com/office/drawing/2014/main" id="{97957B90-F9B5-405A-A3BA-E12CAA8BA76A}"/>
               </a:ext>
             </a:extLst>
           </p:cNvPr>
@@ -22437,7 +22417,7 @@
           <p:cNvPr id="16" name="">
             <a:extLst xmlns:a="http://schemas.openxmlformats.org/drawingml/2006/main">
               <a:ext uri="{FF2B5EF4-FFF2-40B4-BE49-F238E27FC236}">
-                <a16:creationId xmlns:a16="http://schemas.microsoft.com/office/drawing/2014/main" id="{542E3932-ACCE-477E-8FD4-6816B0593F56}"/>
+                <a16:creationId xmlns:a16="http://schemas.microsoft.com/office/drawing/2014/main" id="{56D56FF0-EAF9-461F-88AC-EDCF30F482EC}"/>
               </a:ext>
             </a:extLst>
           </p:cNvPr>
@@ -22499,7 +22479,7 @@
           <p:cNvPr id="17" name="">
             <a:extLst xmlns:a="http://schemas.openxmlformats.org/drawingml/2006/main">
               <a:ext uri="{FF2B5EF4-FFF2-40B4-BE49-F238E27FC236}">
-                <a16:creationId xmlns:a16="http://schemas.microsoft.com/office/drawing/2014/main" id="{57AC7C67-A832-4804-AE41-5E4A4FD53A96}"/>
+                <a16:creationId xmlns:a16="http://schemas.microsoft.com/office/drawing/2014/main" id="{57FD26F8-F928-490D-A163-4F81C6F013B5}"/>
               </a:ext>
             </a:extLst>
           </p:cNvPr>
@@ -22561,7 +22541,7 @@
           <p:cNvPr id="18" name="">
             <a:extLst xmlns:a="http://schemas.openxmlformats.org/drawingml/2006/main">
               <a:ext uri="{FF2B5EF4-FFF2-40B4-BE49-F238E27FC236}">
-                <a16:creationId xmlns:a16="http://schemas.microsoft.com/office/drawing/2014/main" id="{F2AA7947-A0F7-409E-8DE5-B631DCDD4727}"/>
+                <a16:creationId xmlns:a16="http://schemas.microsoft.com/office/drawing/2014/main" id="{7ED3654B-BE6B-45D8-9113-FA9A57EA2D1C}"/>
               </a:ext>
             </a:extLst>
           </p:cNvPr>
@@ -22592,7 +22572,7 @@
           <p:cNvPr id="19" name="">
             <a:extLst xmlns:a="http://schemas.openxmlformats.org/drawingml/2006/main">
               <a:ext uri="{FF2B5EF4-FFF2-40B4-BE49-F238E27FC236}">
-                <a16:creationId xmlns:a16="http://schemas.microsoft.com/office/drawing/2014/main" id="{0BBFBCFF-4399-4F42-A0E9-978A1EB097A0}"/>
+                <a16:creationId xmlns:a16="http://schemas.microsoft.com/office/drawing/2014/main" id="{2ACEA1A8-3ED5-44C7-977F-4065D7EDF81E}"/>
               </a:ext>
             </a:extLst>
           </p:cNvPr>
@@ -22654,7 +22634,7 @@
           <p:cNvPr id="20" name="">
             <a:extLst xmlns:a="http://schemas.openxmlformats.org/drawingml/2006/main">
               <a:ext uri="{FF2B5EF4-FFF2-40B4-BE49-F238E27FC236}">
-                <a16:creationId xmlns:a16="http://schemas.microsoft.com/office/drawing/2014/main" id="{8ABA09C8-87A1-456B-B0CF-C034C33DD246}"/>
+                <a16:creationId xmlns:a16="http://schemas.microsoft.com/office/drawing/2014/main" id="{00447E79-DDCC-4AD7-BCD9-BBD02A7F4FF8}"/>
               </a:ext>
             </a:extLst>
           </p:cNvPr>
@@ -22716,7 +22696,7 @@
           <p:cNvPr id="21" name="">
             <a:extLst xmlns:a="http://schemas.openxmlformats.org/drawingml/2006/main">
               <a:ext uri="{FF2B5EF4-FFF2-40B4-BE49-F238E27FC236}">
-                <a16:creationId xmlns:a16="http://schemas.microsoft.com/office/drawing/2014/main" id="{A6AD2EEC-5DCE-4DA2-A707-BB49AA5CA6A5}"/>
+                <a16:creationId xmlns:a16="http://schemas.microsoft.com/office/drawing/2014/main" id="{07B6843A-09AB-4819-95FA-C77F0C1EB27D}"/>
               </a:ext>
             </a:extLst>
           </p:cNvPr>
@@ -22778,7 +22758,7 @@
           <p:cNvPr id="22" name="">
             <a:extLst xmlns:a="http://schemas.openxmlformats.org/drawingml/2006/main">
               <a:ext uri="{FF2B5EF4-FFF2-40B4-BE49-F238E27FC236}">
-                <a16:creationId xmlns:a16="http://schemas.microsoft.com/office/drawing/2014/main" id="{57C9426B-CFAF-4A90-B769-5CBC58D86837}"/>
+                <a16:creationId xmlns:a16="http://schemas.microsoft.com/office/drawing/2014/main" id="{5469C0CD-62A4-44F4-8AB9-C5985DBF94D5}"/>
               </a:ext>
             </a:extLst>
           </p:cNvPr>
@@ -22840,7 +22820,7 @@
           <p:cNvPr id="23" name="footer-rule-8">
             <a:extLst xmlns:a="http://schemas.openxmlformats.org/drawingml/2006/main">
               <a:ext uri="{FF2B5EF4-FFF2-40B4-BE49-F238E27FC236}">
-                <a16:creationId xmlns:a16="http://schemas.microsoft.com/office/drawing/2014/main" id="{8C7B7E6E-0E46-4710-9CF1-3CEFFA0DEF0D}"/>
+                <a16:creationId xmlns:a16="http://schemas.microsoft.com/office/drawing/2014/main" id="{3F130250-15F7-451D-81A9-74134718C5FD}"/>
               </a:ext>
             </a:extLst>
           </p:cNvPr>
@@ -22871,7 +22851,7 @@
           <p:cNvPr id="24" name="footer-label-8">
             <a:extLst xmlns:a="http://schemas.openxmlformats.org/drawingml/2006/main">
               <a:ext uri="{FF2B5EF4-FFF2-40B4-BE49-F238E27FC236}">
-                <a16:creationId xmlns:a16="http://schemas.microsoft.com/office/drawing/2014/main" id="{3B748BCD-342A-46AC-9F03-003BC22E296B}"/>
+                <a16:creationId xmlns:a16="http://schemas.microsoft.com/office/drawing/2014/main" id="{5E5C470A-E854-4863-A1C2-CA9B3B70AE1B}"/>
               </a:ext>
             </a:extLst>
           </p:cNvPr>
@@ -22933,7 +22913,7 @@
           <p:cNvPr id="25" name="footer-page-8">
             <a:extLst xmlns:a="http://schemas.openxmlformats.org/drawingml/2006/main">
               <a:ext uri="{FF2B5EF4-FFF2-40B4-BE49-F238E27FC236}">
-                <a16:creationId xmlns:a16="http://schemas.microsoft.com/office/drawing/2014/main" id="{D715C5DE-F1F5-487B-88B2-8E5C74ADFC14}"/>
+                <a16:creationId xmlns:a16="http://schemas.microsoft.com/office/drawing/2014/main" id="{8EEE3246-E411-4418-BA5F-A817CEC45FB1}"/>
               </a:ext>
             </a:extLst>
           </p:cNvPr>
@@ -22993,7 +22973,7 @@
     </p:spTree>
     <p:extLst>
       <p:ext uri="{BB962C8B-B14F-4D97-AF65-F5344CB8AC3E}">
-        <p14:creationId xmlns:p14="http://schemas.microsoft.com/office/powerpoint/2010/main" val="1791987177"/>
+        <p14:creationId xmlns:p14="http://schemas.microsoft.com/office/powerpoint/2010/main" val="1752682799"/>
       </p:ext>
     </p:extLst>
   </p:cSld>
@@ -23024,7 +23004,7 @@
           <p:cNvPr id="25" name="side-accent-9">
             <a:extLst xmlns:a="http://schemas.openxmlformats.org/drawingml/2006/main">
               <a:ext uri="{FF2B5EF4-FFF2-40B4-BE49-F238E27FC236}">
-                <a16:creationId xmlns:a16="http://schemas.microsoft.com/office/drawing/2014/main" id="{B8D8418E-542F-4661-80A1-7DD5583C312B}"/>
+                <a16:creationId xmlns:a16="http://schemas.microsoft.com/office/drawing/2014/main" id="{5502924F-5029-44DF-94F5-7743242E5EBD}"/>
               </a:ext>
             </a:extLst>
           </p:cNvPr>
@@ -23055,7 +23035,7 @@
           <p:cNvPr id="2" name="kicker-9">
             <a:extLst xmlns:a="http://schemas.openxmlformats.org/drawingml/2006/main">
               <a:ext uri="{FF2B5EF4-FFF2-40B4-BE49-F238E27FC236}">
-                <a16:creationId xmlns:a16="http://schemas.microsoft.com/office/drawing/2014/main" id="{F1A90147-21A9-46B7-A10F-B27390433C30}"/>
+                <a16:creationId xmlns:a16="http://schemas.microsoft.com/office/drawing/2014/main" id="{C64C8E90-B59F-4088-9122-BCA6FB0C2D82}"/>
               </a:ext>
             </a:extLst>
           </p:cNvPr>
@@ -23117,7 +23097,7 @@
           <p:cNvPr id="3" name="title-9">
             <a:extLst xmlns:a="http://schemas.openxmlformats.org/drawingml/2006/main">
               <a:ext uri="{FF2B5EF4-FFF2-40B4-BE49-F238E27FC236}">
-                <a16:creationId xmlns:a16="http://schemas.microsoft.com/office/drawing/2014/main" id="{22161C86-B410-442C-A5F1-553CD5F31D7D}"/>
+                <a16:creationId xmlns:a16="http://schemas.microsoft.com/office/drawing/2014/main" id="{92B6E0D3-9B2D-42AD-82FB-FAFBBDD1181B}"/>
               </a:ext>
             </a:extLst>
           </p:cNvPr>
@@ -23179,7 +23159,7 @@
           <p:cNvPr id="4" name="">
             <a:extLst xmlns:a="http://schemas.openxmlformats.org/drawingml/2006/main">
               <a:ext uri="{FF2B5EF4-FFF2-40B4-BE49-F238E27FC236}">
-                <a16:creationId xmlns:a16="http://schemas.microsoft.com/office/drawing/2014/main" id="{A692A8E0-EB19-4926-B43F-F42F790A6D91}"/>
+                <a16:creationId xmlns:a16="http://schemas.microsoft.com/office/drawing/2014/main" id="{96A9990E-E77B-4E2B-806C-35F889149A8A}"/>
               </a:ext>
             </a:extLst>
           </p:cNvPr>
@@ -23241,7 +23221,7 @@
           <p:cNvPr id="5" name="">
             <a:extLst xmlns:a="http://schemas.openxmlformats.org/drawingml/2006/main">
               <a:ext uri="{FF2B5EF4-FFF2-40B4-BE49-F238E27FC236}">
-                <a16:creationId xmlns:a16="http://schemas.microsoft.com/office/drawing/2014/main" id="{E88ACF05-A9FC-412F-8D0D-7C0902BA660B}"/>
+                <a16:creationId xmlns:a16="http://schemas.microsoft.com/office/drawing/2014/main" id="{6CE3C390-14B5-4D9E-8255-D89EAE874261}"/>
               </a:ext>
             </a:extLst>
           </p:cNvPr>
@@ -23276,7 +23256,7 @@
           <p:cNvPr id="6" name="">
             <a:extLst xmlns:a="http://schemas.openxmlformats.org/drawingml/2006/main">
               <a:ext uri="{FF2B5EF4-FFF2-40B4-BE49-F238E27FC236}">
-                <a16:creationId xmlns:a16="http://schemas.microsoft.com/office/drawing/2014/main" id="{67F5C5CA-71C1-4964-9240-A7D285129D35}"/>
+                <a16:creationId xmlns:a16="http://schemas.microsoft.com/office/drawing/2014/main" id="{A483E6C0-E57E-4F90-9C73-4046924CC2CE}"/>
               </a:ext>
             </a:extLst>
           </p:cNvPr>
@@ -23338,7 +23318,7 @@
           <p:cNvPr id="7" name="">
             <a:extLst xmlns:a="http://schemas.openxmlformats.org/drawingml/2006/main">
               <a:ext uri="{FF2B5EF4-FFF2-40B4-BE49-F238E27FC236}">
-                <a16:creationId xmlns:a16="http://schemas.microsoft.com/office/drawing/2014/main" id="{65ABF04C-039A-4246-BD4D-F05D345F0B97}"/>
+                <a16:creationId xmlns:a16="http://schemas.microsoft.com/office/drawing/2014/main" id="{217A7C78-E755-4EE6-AF47-9BB6E411E26E}"/>
               </a:ext>
             </a:extLst>
           </p:cNvPr>
@@ -23400,7 +23380,7 @@
           <p:cNvPr id="8" name="">
             <a:extLst xmlns:a="http://schemas.openxmlformats.org/drawingml/2006/main">
               <a:ext uri="{FF2B5EF4-FFF2-40B4-BE49-F238E27FC236}">
-                <a16:creationId xmlns:a16="http://schemas.microsoft.com/office/drawing/2014/main" id="{7504D161-B740-464B-8A74-20B27C00BF75}"/>
+                <a16:creationId xmlns:a16="http://schemas.microsoft.com/office/drawing/2014/main" id="{7AE6D746-12CB-44D8-B246-2FF6621BEF56}"/>
               </a:ext>
             </a:extLst>
           </p:cNvPr>
@@ -23462,7 +23442,7 @@
           <p:cNvPr id="9" name="">
             <a:extLst xmlns:a="http://schemas.openxmlformats.org/drawingml/2006/main">
               <a:ext uri="{FF2B5EF4-FFF2-40B4-BE49-F238E27FC236}">
-                <a16:creationId xmlns:a16="http://schemas.microsoft.com/office/drawing/2014/main" id="{84030399-A86B-4C9B-B41F-19DBDE1D22FB}"/>
+                <a16:creationId xmlns:a16="http://schemas.microsoft.com/office/drawing/2014/main" id="{DF32875A-5EB2-420F-A6AE-EFB21E649386}"/>
               </a:ext>
             </a:extLst>
           </p:cNvPr>
@@ -23497,7 +23477,7 @@
           <p:cNvPr id="10" name="">
             <a:extLst xmlns:a="http://schemas.openxmlformats.org/drawingml/2006/main">
               <a:ext uri="{FF2B5EF4-FFF2-40B4-BE49-F238E27FC236}">
-                <a16:creationId xmlns:a16="http://schemas.microsoft.com/office/drawing/2014/main" id="{2F8A393A-99C1-47BD-870C-82462FAE54ED}"/>
+                <a16:creationId xmlns:a16="http://schemas.microsoft.com/office/drawing/2014/main" id="{28F8B61D-BAFF-4FAB-8173-C55DE9B21D54}"/>
               </a:ext>
             </a:extLst>
           </p:cNvPr>
@@ -23559,7 +23539,7 @@
           <p:cNvPr id="11" name="">
             <a:extLst xmlns:a="http://schemas.openxmlformats.org/drawingml/2006/main">
               <a:ext uri="{FF2B5EF4-FFF2-40B4-BE49-F238E27FC236}">
-                <a16:creationId xmlns:a16="http://schemas.microsoft.com/office/drawing/2014/main" id="{94C8307C-9EB8-4854-AB67-C6A72DE8633A}"/>
+                <a16:creationId xmlns:a16="http://schemas.microsoft.com/office/drawing/2014/main" id="{650714D3-19C2-48AB-BE70-F38D5C12811C}"/>
               </a:ext>
             </a:extLst>
           </p:cNvPr>
@@ -23621,7 +23601,7 @@
           <p:cNvPr id="12" name="">
             <a:extLst xmlns:a="http://schemas.openxmlformats.org/drawingml/2006/main">
               <a:ext uri="{FF2B5EF4-FFF2-40B4-BE49-F238E27FC236}">
-                <a16:creationId xmlns:a16="http://schemas.microsoft.com/office/drawing/2014/main" id="{84658773-5521-4E6C-B81A-2EF44469326B}"/>
+                <a16:creationId xmlns:a16="http://schemas.microsoft.com/office/drawing/2014/main" id="{809591B1-237F-4C2C-BFCC-98F1BB673A06}"/>
               </a:ext>
             </a:extLst>
           </p:cNvPr>
@@ -23683,7 +23663,7 @@
           <p:cNvPr id="13" name="">
             <a:extLst xmlns:a="http://schemas.openxmlformats.org/drawingml/2006/main">
               <a:ext uri="{FF2B5EF4-FFF2-40B4-BE49-F238E27FC236}">
-                <a16:creationId xmlns:a16="http://schemas.microsoft.com/office/drawing/2014/main" id="{F8CFA185-7CB8-4997-913B-774619B48C68}"/>
+                <a16:creationId xmlns:a16="http://schemas.microsoft.com/office/drawing/2014/main" id="{250906A2-B552-4BDA-8A35-B69FA8AB298C}"/>
               </a:ext>
             </a:extLst>
           </p:cNvPr>
@@ -23718,7 +23698,7 @@
           <p:cNvPr id="14" name="">
             <a:extLst xmlns:a="http://schemas.openxmlformats.org/drawingml/2006/main">
               <a:ext uri="{FF2B5EF4-FFF2-40B4-BE49-F238E27FC236}">
-                <a16:creationId xmlns:a16="http://schemas.microsoft.com/office/drawing/2014/main" id="{AA09A41D-97B1-4266-9063-007FE912CD4C}"/>
+                <a16:creationId xmlns:a16="http://schemas.microsoft.com/office/drawing/2014/main" id="{8265D1D9-23AA-45D1-B90F-F2C11B3C5998}"/>
               </a:ext>
             </a:extLst>
           </p:cNvPr>
@@ -23780,7 +23760,7 @@
           <p:cNvPr id="15" name="">
             <a:extLst xmlns:a="http://schemas.openxmlformats.org/drawingml/2006/main">
               <a:ext uri="{FF2B5EF4-FFF2-40B4-BE49-F238E27FC236}">
-                <a16:creationId xmlns:a16="http://schemas.microsoft.com/office/drawing/2014/main" id="{AA3AF012-DB48-49E3-B3A5-4029282E8052}"/>
+                <a16:creationId xmlns:a16="http://schemas.microsoft.com/office/drawing/2014/main" id="{AF3BD0B1-CA25-4A74-8043-D840C28DAD30}"/>
               </a:ext>
             </a:extLst>
           </p:cNvPr>
@@ -23842,7 +23822,7 @@
           <p:cNvPr id="16" name="">
             <a:extLst xmlns:a="http://schemas.openxmlformats.org/drawingml/2006/main">
               <a:ext uri="{FF2B5EF4-FFF2-40B4-BE49-F238E27FC236}">
-                <a16:creationId xmlns:a16="http://schemas.microsoft.com/office/drawing/2014/main" id="{07F38926-9414-48A0-8F1E-77B620956E52}"/>
+                <a16:creationId xmlns:a16="http://schemas.microsoft.com/office/drawing/2014/main" id="{C821F93F-1793-411B-A014-894286CAFFA1}"/>
               </a:ext>
             </a:extLst>
           </p:cNvPr>
@@ -23904,7 +23884,7 @@
           <p:cNvPr id="17" name="">
             <a:extLst xmlns:a="http://schemas.openxmlformats.org/drawingml/2006/main">
               <a:ext uri="{FF2B5EF4-FFF2-40B4-BE49-F238E27FC236}">
-                <a16:creationId xmlns:a16="http://schemas.microsoft.com/office/drawing/2014/main" id="{F8D05DA1-ABAE-4C10-8021-0C1308D29BBF}"/>
+                <a16:creationId xmlns:a16="http://schemas.microsoft.com/office/drawing/2014/main" id="{3FEC4484-DBE2-40F4-A14C-0B551FFE160C}"/>
               </a:ext>
             </a:extLst>
           </p:cNvPr>
@@ -23939,7 +23919,7 @@
           <p:cNvPr id="18" name="">
             <a:extLst xmlns:a="http://schemas.openxmlformats.org/drawingml/2006/main">
               <a:ext uri="{FF2B5EF4-FFF2-40B4-BE49-F238E27FC236}">
-                <a16:creationId xmlns:a16="http://schemas.microsoft.com/office/drawing/2014/main" id="{13A4842F-6249-4B19-B8F0-2F094707DA6D}"/>
+                <a16:creationId xmlns:a16="http://schemas.microsoft.com/office/drawing/2014/main" id="{40CE5DDC-45B8-49C6-8346-1ABB86EB32AC}"/>
               </a:ext>
             </a:extLst>
           </p:cNvPr>
@@ -24001,7 +23981,7 @@
           <p:cNvPr id="19" name="">
             <a:extLst xmlns:a="http://schemas.openxmlformats.org/drawingml/2006/main">
               <a:ext uri="{FF2B5EF4-FFF2-40B4-BE49-F238E27FC236}">
-                <a16:creationId xmlns:a16="http://schemas.microsoft.com/office/drawing/2014/main" id="{6E6D1012-2B6B-408D-A1CD-575DA157688D}"/>
+                <a16:creationId xmlns:a16="http://schemas.microsoft.com/office/drawing/2014/main" id="{65C077DD-CA0D-478D-B0EA-3CAA332DF03A}"/>
               </a:ext>
             </a:extLst>
           </p:cNvPr>
@@ -24063,7 +24043,7 @@
           <p:cNvPr id="20" name="">
             <a:extLst xmlns:a="http://schemas.openxmlformats.org/drawingml/2006/main">
               <a:ext uri="{FF2B5EF4-FFF2-40B4-BE49-F238E27FC236}">
-                <a16:creationId xmlns:a16="http://schemas.microsoft.com/office/drawing/2014/main" id="{7346906A-8349-4FE8-B87D-2715DEBA3FCB}"/>
+                <a16:creationId xmlns:a16="http://schemas.microsoft.com/office/drawing/2014/main" id="{154BFF4B-DDEF-430A-B417-484FBC6F8BDD}"/>
               </a:ext>
             </a:extLst>
           </p:cNvPr>
@@ -24125,7 +24105,7 @@
           <p:cNvPr id="21" name="">
             <a:extLst xmlns:a="http://schemas.openxmlformats.org/drawingml/2006/main">
               <a:ext uri="{FF2B5EF4-FFF2-40B4-BE49-F238E27FC236}">
-                <a16:creationId xmlns:a16="http://schemas.microsoft.com/office/drawing/2014/main" id="{D4EBC4BE-9C32-4963-BB5A-4724EF47DF60}"/>
+                <a16:creationId xmlns:a16="http://schemas.microsoft.com/office/drawing/2014/main" id="{E9F3B95E-76F1-4FB6-9FC1-4CC2765B4D1A}"/>
               </a:ext>
             </a:extLst>
           </p:cNvPr>
@@ -24187,7 +24167,7 @@
           <p:cNvPr id="22" name="footer-rule-9">
             <a:extLst xmlns:a="http://schemas.openxmlformats.org/drawingml/2006/main">
               <a:ext uri="{FF2B5EF4-FFF2-40B4-BE49-F238E27FC236}">
-                <a16:creationId xmlns:a16="http://schemas.microsoft.com/office/drawing/2014/main" id="{79EE0F16-B2F7-41CD-AB5C-E3B1CD9EFFEE}"/>
+                <a16:creationId xmlns:a16="http://schemas.microsoft.com/office/drawing/2014/main" id="{3E22E8E5-C3E4-41C3-9AAD-708DD9529382}"/>
               </a:ext>
             </a:extLst>
           </p:cNvPr>
@@ -24218,7 +24198,7 @@
           <p:cNvPr id="23" name="footer-label-9">
             <a:extLst xmlns:a="http://schemas.openxmlformats.org/drawingml/2006/main">
               <a:ext uri="{FF2B5EF4-FFF2-40B4-BE49-F238E27FC236}">
-                <a16:creationId xmlns:a16="http://schemas.microsoft.com/office/drawing/2014/main" id="{98FE90D6-43C8-4D20-BCAD-5A0480C437C6}"/>
+                <a16:creationId xmlns:a16="http://schemas.microsoft.com/office/drawing/2014/main" id="{D3AE3B5D-4745-43DF-9275-B1562A6BE3E8}"/>
               </a:ext>
             </a:extLst>
           </p:cNvPr>
@@ -24280,7 +24260,7 @@
           <p:cNvPr id="24" name="footer-page-9">
             <a:extLst xmlns:a="http://schemas.openxmlformats.org/drawingml/2006/main">
               <a:ext uri="{FF2B5EF4-FFF2-40B4-BE49-F238E27FC236}">
-                <a16:creationId xmlns:a16="http://schemas.microsoft.com/office/drawing/2014/main" id="{6C24F219-6E3C-464A-A6BB-A439357FAE25}"/>
+                <a16:creationId xmlns:a16="http://schemas.microsoft.com/office/drawing/2014/main" id="{C1880235-09F0-4A52-B9FC-0EE8E6696623}"/>
               </a:ext>
             </a:extLst>
           </p:cNvPr>
@@ -24340,7 +24320,7 @@
     </p:spTree>
     <p:extLst>
       <p:ext uri="{BB962C8B-B14F-4D97-AF65-F5344CB8AC3E}">
-        <p14:creationId xmlns:p14="http://schemas.microsoft.com/office/powerpoint/2010/main" val="1342875843"/>
+        <p14:creationId xmlns:p14="http://schemas.microsoft.com/office/powerpoint/2010/main" val="1742977018"/>
       </p:ext>
     </p:extLst>
   </p:cSld>

</xml_diff>

<commit_message>
docs: clarify facilitator speaker notes
</commit_message>
<xml_diff>
--- a/docs/MSU-EVA-อบรมสายวิชาการ-ฉบับวิทยากร.pptx
+++ b/docs/MSU-EVA-อบรมสายวิชาการ-ฉบับวิทยากร.pptx
@@ -2,30 +2,30 @@
 <file path=ppt/presentation.xml><?xml version="1.0" encoding="utf-8"?>
 <p:presentation xmlns:p="http://schemas.openxmlformats.org/presentationml/2006/main">
   <p:sldMasterIdLst>
-    <p:sldMasterId xmlns:r="http://schemas.openxmlformats.org/officeDocument/2006/relationships" id="2147483648" r:id="R35f91effc18d4f70"/>
+    <p:sldMasterId xmlns:r="http://schemas.openxmlformats.org/officeDocument/2006/relationships" id="2147483648" r:id="Ra2f3865bc70645e8"/>
   </p:sldMasterIdLst>
   <p:notesMasterIdLst>
-    <p:notesMasterId xmlns:r="http://schemas.openxmlformats.org/officeDocument/2006/relationships" r:id="Rc99ea6f0941d4264"/>
+    <p:notesMasterId xmlns:r="http://schemas.openxmlformats.org/officeDocument/2006/relationships" r:id="Rc90f9b4150b0486a"/>
   </p:notesMasterIdLst>
   <p:sldIdLst>
-    <p:sldId xmlns:r="http://schemas.openxmlformats.org/officeDocument/2006/relationships" id="256" r:id="R4a8c07ac9f984cb8"/>
-    <p:sldId xmlns:r="http://schemas.openxmlformats.org/officeDocument/2006/relationships" id="257" r:id="R391983b9ef2b4e75"/>
-    <p:sldId xmlns:r="http://schemas.openxmlformats.org/officeDocument/2006/relationships" id="258" r:id="R8afcdcd27c744aa8"/>
-    <p:sldId xmlns:r="http://schemas.openxmlformats.org/officeDocument/2006/relationships" id="259" r:id="R9702882e7e5f4558"/>
-    <p:sldId xmlns:r="http://schemas.openxmlformats.org/officeDocument/2006/relationships" id="260" r:id="R0a1f5aaf97f24d08"/>
-    <p:sldId xmlns:r="http://schemas.openxmlformats.org/officeDocument/2006/relationships" id="261" r:id="R8a743b8740e34c86"/>
-    <p:sldId xmlns:r="http://schemas.openxmlformats.org/officeDocument/2006/relationships" id="262" r:id="R26129a33df784596"/>
-    <p:sldId xmlns:r="http://schemas.openxmlformats.org/officeDocument/2006/relationships" id="263" r:id="Re44fffe7c81c4644"/>
-    <p:sldId xmlns:r="http://schemas.openxmlformats.org/officeDocument/2006/relationships" id="264" r:id="R134bb089b6254071"/>
-    <p:sldId xmlns:r="http://schemas.openxmlformats.org/officeDocument/2006/relationships" id="265" r:id="Rc3c9a7783c914049"/>
-    <p:sldId xmlns:r="http://schemas.openxmlformats.org/officeDocument/2006/relationships" id="266" r:id="Rb7c23baa118e4c3b"/>
-    <p:sldId xmlns:r="http://schemas.openxmlformats.org/officeDocument/2006/relationships" id="267" r:id="Rf9d6b96246fe4941"/>
-    <p:sldId xmlns:r="http://schemas.openxmlformats.org/officeDocument/2006/relationships" id="268" r:id="R0fbcaf35c4c14903"/>
-    <p:sldId xmlns:r="http://schemas.openxmlformats.org/officeDocument/2006/relationships" id="269" r:id="Rc906777dbc6c4f8d"/>
-    <p:sldId xmlns:r="http://schemas.openxmlformats.org/officeDocument/2006/relationships" id="270" r:id="R6b3c5f8449eb43d4"/>
-    <p:sldId xmlns:r="http://schemas.openxmlformats.org/officeDocument/2006/relationships" id="271" r:id="Ra3a04178a20448d0"/>
-    <p:sldId xmlns:r="http://schemas.openxmlformats.org/officeDocument/2006/relationships" id="272" r:id="R76864a6c612d46ec"/>
-    <p:sldId xmlns:r="http://schemas.openxmlformats.org/officeDocument/2006/relationships" id="273" r:id="R04c3372932944ff7"/>
+    <p:sldId xmlns:r="http://schemas.openxmlformats.org/officeDocument/2006/relationships" id="256" r:id="R0d2e09d5c05b4529"/>
+    <p:sldId xmlns:r="http://schemas.openxmlformats.org/officeDocument/2006/relationships" id="257" r:id="R8c825009b9f141f9"/>
+    <p:sldId xmlns:r="http://schemas.openxmlformats.org/officeDocument/2006/relationships" id="258" r:id="R3d39dc5311704740"/>
+    <p:sldId xmlns:r="http://schemas.openxmlformats.org/officeDocument/2006/relationships" id="259" r:id="Rd3290863a00d4fa7"/>
+    <p:sldId xmlns:r="http://schemas.openxmlformats.org/officeDocument/2006/relationships" id="260" r:id="Re27383f829cf463c"/>
+    <p:sldId xmlns:r="http://schemas.openxmlformats.org/officeDocument/2006/relationships" id="261" r:id="R90595feea1b84186"/>
+    <p:sldId xmlns:r="http://schemas.openxmlformats.org/officeDocument/2006/relationships" id="262" r:id="Ra93b6904acb443b5"/>
+    <p:sldId xmlns:r="http://schemas.openxmlformats.org/officeDocument/2006/relationships" id="263" r:id="R8e62e7147c724d2e"/>
+    <p:sldId xmlns:r="http://schemas.openxmlformats.org/officeDocument/2006/relationships" id="264" r:id="R220b6c7f4a9e4f29"/>
+    <p:sldId xmlns:r="http://schemas.openxmlformats.org/officeDocument/2006/relationships" id="265" r:id="R079a4fc1d14f4c67"/>
+    <p:sldId xmlns:r="http://schemas.openxmlformats.org/officeDocument/2006/relationships" id="266" r:id="R382abd9b3d7d4739"/>
+    <p:sldId xmlns:r="http://schemas.openxmlformats.org/officeDocument/2006/relationships" id="267" r:id="Re3fa7f2e4d304a7c"/>
+    <p:sldId xmlns:r="http://schemas.openxmlformats.org/officeDocument/2006/relationships" id="268" r:id="R2e343e8ba02f483c"/>
+    <p:sldId xmlns:r="http://schemas.openxmlformats.org/officeDocument/2006/relationships" id="269" r:id="R53e9c028a9064461"/>
+    <p:sldId xmlns:r="http://schemas.openxmlformats.org/officeDocument/2006/relationships" id="270" r:id="R1431c129ef3f4105"/>
+    <p:sldId xmlns:r="http://schemas.openxmlformats.org/officeDocument/2006/relationships" id="271" r:id="R055b242a6e744f4b"/>
+    <p:sldId xmlns:r="http://schemas.openxmlformats.org/officeDocument/2006/relationships" id="272" r:id="R17588f8129524bf9"/>
+    <p:sldId xmlns:r="http://schemas.openxmlformats.org/officeDocument/2006/relationships" id="273" r:id="Rfb1158b3f3c44efa"/>
   </p:sldIdLst>
   <p:sldSz cx="12192000" cy="6858000"/>
   <p:notesSz cx="6858000" cy="9144000"/>
@@ -564,7 +564,7 @@
           <a:lstStyle xmlns:a="http://schemas.openxmlformats.org/drawingml/2006/main"/>
           <a:p xmlns:a="http://schemas.openxmlformats.org/drawingml/2006/main">
             <a:r>
-              <a:t>[พูด] ทีนี้มาดูข้อมูลเชิงคุณภาพครับ ส่วนนี้ไม่จำเป็นต้องเขียนยาว แต่ควรตอบให้ครบสามเรื่องว่าเราทำอะไร เกิดผลอย่างไร และตรวจจากหลักฐานใด ลองคิดว่าผู้ประเมินอ่านเพียงครั้งเดียวแล้วควรเห็นภาพงานของเราได้ครับ หลีกเลี่ยงคำกว้าง ๆ ที่ไม่บอกบทบาทหรือผลลัพธ์ ถ้าข้อความสัมพันธ์กับเกณฑ์และหลักฐาน ก็ถือว่าพร้อมในระดับหนึ่งแล้ว ต่อไปเรามาตรวจว่าหลักฐานแบบไหนจึงจะใช้งานได้จริงครับ</a:t>
+              <a:t>[พูด] ข้อมูลเชิงคุณภาพไม่จำเป็นต้องเขียนยาวครับ แต่ควรตอบให้ครบ 3 เรื่อง คือ ทำอะไร เกิดผลอย่างไร และใช้หลักฐานใดตรวจสอบ ผู้ประเมินควรอ่านครั้งเดียวแล้วเข้าใจงานได้ หลีกเลี่ยงข้อความกว้าง ๆ ที่ไม่บอกบทบาทหรือผลลัพธ์ เมื่อข้อความตรงกับเกณฑ์และหลักฐาน ข้อมูลก็พร้อมให้ผู้ประเมินตรวจครับ ต่อไปเรามาดูวิธีตรวจหลักฐานกันครับ</a:t>
             </a:r>
           </a:p>
           <a:p xmlns:a="http://schemas.openxmlformats.org/drawingml/2006/main">
@@ -659,7 +659,7 @@
           <a:lstStyle xmlns:a="http://schemas.openxmlformats.org/drawingml/2006/main"/>
           <a:p xmlns:a="http://schemas.openxmlformats.org/drawingml/2006/main">
             <a:r>
-              <a:t>[พูด] ตรงนี้ขอเน้นนิดหนึ่งครับ หลักฐานที่แนบไม่ได้วัดแค่ว่ามีหรือไม่มี แต่ต้องเปิดได้ ตรงกับรายการ และรู้ว่าเป็นเอกสารอะไร ทางที่ดีให้ทดลองเปิดลิงก์ในหน้าต่างที่ไม่ได้ใช้บัญชีเจ้าของเอกสาร จะได้เห็นเหมือนที่ผู้ประเมินเห็น หลักฐานควรผ่านการตรวจทั้งการเปิดลิงก์และความตรงกับรายการครับ</a:t>
+              <a:t>[พูด] หลักฐานที่แนบต้องตรวจได้จริงครับ ให้ตรวจ 3 เรื่อง คือ เปิดได้ ตรงกับรายการ และชื่อเอกสารบอกได้ว่าเป็นหลักฐานอะไร ควรทดลองเปิดลิงก์ในหน้าต่างที่ไม่ได้ใช้บัญชีเจ้าของเอกสาร เพื่อให้เห็นเหมือนที่ผู้ประเมินเห็นครับ</a:t>
             </a:r>
           </a:p>
           <a:p xmlns:a="http://schemas.openxmlformats.org/drawingml/2006/main">
@@ -949,7 +949,7 @@
           <a:lstStyle xmlns:a="http://schemas.openxmlformats.org/drawingml/2006/main"/>
           <a:p xmlns:a="http://schemas.openxmlformats.org/drawingml/2006/main">
             <a:r>
-              <a:t>[พูด] ตอนนี้เรามองจากฝั่งผู้ประเมินนะครับ เมื่อได้รับงาน สิ่งแรกที่ควรทำคืออ่านข้อมูลให้ตรงกับเกณฑ์ ตรวจคะแนน และเปิดหลักฐานจริงก่อนให้ผล ถ้าข้อมูลไม่ครบ ให้ใช้ตัวเลือกที่ระบบเปิดให้ตามสิทธิ์ ไม่ควรเดาจากชื่อรายการอย่างเดียว เมื่อผู้ประเมินได้รับงาน ควรแยกให้ชัดว่าข้อมูลใดมาจากผู้รับการประเมิน และส่วนใดเป็นการตัดสินใจของผู้ประเมินครับ</a:t>
+              <a:t>[พูด] ตอนนี้เรามาดูฝั่งผู้ประเมินครับ เมื่อได้รับงาน ให้ตรวจ 3 เรื่องตามลำดับ คือ ข้อมูลตรงกับเกณฑ์หรือไม่ คะแนนถูกต้องหรือไม่ และหลักฐานเปิดได้และตรงกับข้อมูลหรือไม่ หากข้อมูลยังไม่ครบ ยังไม่ต้องบันทึกผล ให้แจ้งผู้เกี่ยวข้องตามขั้นตอนที่หน่วยงานกำหนดครับ บนหน้าจอให้สังเกตด้วยว่า ส่วนใดเป็นข้อมูลที่ผู้รับการประเมินกรอก และส่วนใดเป็นผลที่ผู้ประเมินต้องบันทึกครับ</a:t>
             </a:r>
           </a:p>
           <a:p xmlns:a="http://schemas.openxmlformats.org/drawingml/2006/main">
@@ -1619,7 +1619,7 @@
           <a:lstStyle xmlns:a="http://schemas.openxmlformats.org/drawingml/2006/main"/>
           <a:p xmlns:a="http://schemas.openxmlformats.org/drawingml/2006/main">
             <a:r>
-              <a:t>[พูด] ใช่ครับ หลายท่านอาจคุ้นกับระบบในฐานะหน้ากรอกแบบประเมิน แต่จริง ๆ ระบบดูแลงานตั้งแต่ต้นจนจบเลยครับ เริ่มจากผู้ใช้และสิทธิ์ เกณฑ์ประเมิน รอบและการมอบหมายงาน ไปจนถึงการกรอก การประเมิน การติดตามสถานะ และการส่งออกรายงาน ส่วนการเตรียมระบบเหล่านี้เป็นหน้าที่ของ Admin ผู้ใช้งานทั่วไปจึงไม่ต้องสร้างหรือเลือกรอบประเมินเองครับ เราเพียงตรวจรอบกับงานที่ได้รับ แล้วทำตามสิทธิ์ของเรา ทีนี้เรามาดูกันครับว่าในระบบมีใครบ้าง</a:t>
+              <a:t>[พูด] ใช่ครับ หลายท่านอาจคุ้นกับระบบจากหน้ากรอกแบบประเมิน แต่ระบบครอบคลุมขั้นตอนอื่นด้วยครับ Admin จะจัดการผู้ใช้ สิทธิ์ เกณฑ์ รอบประเมิน และการมอบหมายงาน ส่วนผู้ใช้งานจะทำงานตามรายการและสิทธิ์ที่ได้รับ ตั้งแต่การกรอกข้อมูล การประเมิน การติดตามสถานะ จนถึงการออกรายงาน ดังนั้นผู้ใช้งานทั่วไปไม่ต้องสร้างหรือเลือกรอบประเมินเองครับ เพียงตรวจว่ารอบและรายการที่ได้รับถูกต้อง แล้วทำหน้าที่ของตนเอง ต่อไปเรามาดูกันว่าในระบบมีผู้ใช้งานกลุ่มใดบ้างครับ</a:t>
             </a:r>
           </a:p>
           <a:p xmlns:a="http://schemas.openxmlformats.org/drawingml/2006/main">
@@ -1919,7 +1919,7 @@
           <a:lstStyle xmlns:a="http://schemas.openxmlformats.org/drawingml/2006/main"/>
           <a:p xmlns:a="http://schemas.openxmlformats.org/drawingml/2006/main">
             <a:r>
-              <a:t>[พูด] ในขั้นแรก ผู้รับการประเมินต้องกรอกข้อมูลและแนบหลักฐานให้ครบครับ ถ้ายังไม่ครบ ให้บันทึกร่างไว้ก่อน ยังไม่ต้องส่งแบบประเมิน ผู้ประเมินจะตัดสินใจจากสิ่งที่เราเตรียมไว้ ถ้าข้อมูลชัดและหลักฐานเปิดได้ งานก็เดินต่อได้ง่าย เมื่อเข้าใจหน้าที่นี้แล้ว ต่อไปเรามาดูจุดเริ่มต้นบนแดชบอร์ดครับ</a:t>
+              <a:t>[พูด] ในขั้นแรก ผู้รับการประเมินต้องกรอกข้อมูลและแนบหลักฐานให้ครบครับ ถ้ายังไม่ครบ ให้บันทึกร่างไว้ก่อน ยังไม่ต้องส่งแบบประเมิน ผู้ประเมินจะใช้ข้อมูลและหลักฐานนี้ในการประเมิน ดังนั้นควรตรวจให้ชัดเจนและเปิดหลักฐานได้ก่อนส่งครับ ต่อไปเรามาดูจุดเริ่มต้นบนแดชบอร์ดครับ</a:t>
             </a:r>
           </a:p>
           <a:p xmlns:a="http://schemas.openxmlformats.org/drawingml/2006/main">
@@ -2104,7 +2104,7 @@
           <a:lstStyle xmlns:a="http://schemas.openxmlformats.org/drawingml/2006/main"/>
           <a:p xmlns:a="http://schemas.openxmlformats.org/drawingml/2006/main">
             <a:r>
-              <a:t>[พูด] เมื่อเปิดรายการเข้ามาแล้ว ลองสังเกตนะครับว่ารายวิชา ภาระงาน ผลงาน และหลักฐานควรเล่าเรื่องเดียวกัน รายวิชาบอกบริบท ภาระงานบอกว่าเราทำอะไรและทำมากน้อยเพียงใด ผลงานบอกผลที่เกิดขึ้น ส่วนหลักฐานช่วยยืนยันข้อมูล ถ้าสี่ส่วนนี้ไม่สัมพันธ์กัน ผู้ประเมินก็จะต้องเดาหรือขอข้อมูลเพิ่มครับ เพราะฉะนั้นก่อนกรอก เราควรเลือกเกณฑ์ให้ตรงกับงานจริงก่อน แล้วค่อยไปดูข้อมูลเชิงปริมาณครับ</a:t>
+              <a:t>[พูด] เมื่อเปิดรายการแล้ว ให้ตรวจว่าข้อมูล 4 ส่วนสอดคล้องกันครับ หนึ่ง รายวิชาบอกว่างานนี้อยู่ในบริบทใด สอง ภาระงานบอกว่าทำอะไรและมีปริมาณเท่าไร สาม ผลงานบอกผลที่เกิดขึ้น และสี่ หลักฐานใช้ยืนยันข้อมูลที่กรอก หากข้อมูลส่วนใดไม่ตรงกัน ผู้ประเมินอาจต้องขอข้อมูลเพิ่มครับ ดังนั้นให้เลือกเกณฑ์ที่ตรงกับงานจริงก่อน แล้วจึงกรอกข้อมูลเชิงปริมาณครับ</a:t>
             </a:r>
           </a:p>
           <a:p xmlns:a="http://schemas.openxmlformats.org/drawingml/2006/main">
@@ -2287,7 +2287,7 @@
   </p:cSld>
   <p:clrMap bg1="lt1" tx1="dk1" bg2="lt2" tx2="dk2" accent1="accent1" accent2="accent2" accent3="accent3" accent4="accent4" accent5="accent5" accent6="accent6" hlink="hlink" folHlink="folHlink"/>
   <p:sldLayoutIdLst>
-    <p:sldLayoutId xmlns:r="http://schemas.openxmlformats.org/officeDocument/2006/relationships" id="2147483649" r:id="R88db4b85b20349f2"/>
+    <p:sldLayoutId xmlns:r="http://schemas.openxmlformats.org/officeDocument/2006/relationships" id="2147483649" r:id="R7f3428e08d3d4b46"/>
   </p:sldLayoutIdLst>
   <p:txStyles>
     <p:titleStyle>
@@ -2842,7 +2842,7 @@
           <p:nvPr/>
         </p:nvPicPr>
         <p:blipFill>
-          <a:blip xmlns:r="http://schemas.openxmlformats.org/officeDocument/2006/relationships" xmlns:a="http://schemas.openxmlformats.org/drawingml/2006/main" r:embed="Rdd4b60b12ebb428e"/>
+          <a:blip xmlns:r="http://schemas.openxmlformats.org/officeDocument/2006/relationships" xmlns:a="http://schemas.openxmlformats.org/drawingml/2006/main" r:embed="Rca806ae180c1486d"/>
           <a:srcRect xmlns:a="http://schemas.openxmlformats.org/drawingml/2006/main" l="2579" t="0" r="2579" b="0"/>
           <a:stretch xmlns:a="http://schemas.openxmlformats.org/drawingml/2006/main">
             <a:fillRect l="0" t="0" r="0" b="0"/>
@@ -2863,7 +2863,7 @@
           <p:cNvPr id="2" name="cover-panel">
             <a:extLst xmlns:a="http://schemas.openxmlformats.org/drawingml/2006/main">
               <a:ext uri="{FF2B5EF4-FFF2-40B4-BE49-F238E27FC236}">
-                <a16:creationId xmlns:a16="http://schemas.microsoft.com/office/drawing/2014/main" id="{C4B0946B-6107-469F-B9D5-B9737BFDEAD7}"/>
+                <a16:creationId xmlns:a16="http://schemas.microsoft.com/office/drawing/2014/main" id="{D9F7B61F-FF6C-4CC4-B6D6-154B85B4F3B3}"/>
               </a:ext>
             </a:extLst>
           </p:cNvPr>
@@ -2894,7 +2894,7 @@
           <p:cNvPr id="3" name="cover-accent">
             <a:extLst xmlns:a="http://schemas.openxmlformats.org/drawingml/2006/main">
               <a:ext uri="{FF2B5EF4-FFF2-40B4-BE49-F238E27FC236}">
-                <a16:creationId xmlns:a16="http://schemas.microsoft.com/office/drawing/2014/main" id="{C69941B3-44A2-4355-BA98-CA539C172E05}"/>
+                <a16:creationId xmlns:a16="http://schemas.microsoft.com/office/drawing/2014/main" id="{7C1F980C-5A4B-4643-92C5-FD6032B3AF70}"/>
               </a:ext>
             </a:extLst>
           </p:cNvPr>
@@ -2929,7 +2929,7 @@
           <p:nvPr/>
         </p:nvPicPr>
         <p:blipFill>
-          <a:blip xmlns:r="http://schemas.openxmlformats.org/officeDocument/2006/relationships" xmlns:a="http://schemas.openxmlformats.org/drawingml/2006/main" r:embed="R407a9fb1dff74a7a"/>
+          <a:blip xmlns:r="http://schemas.openxmlformats.org/officeDocument/2006/relationships" xmlns:a="http://schemas.openxmlformats.org/drawingml/2006/main" r:embed="R603230b501ae4cd3"/>
           <a:stretch xmlns:a="http://schemas.openxmlformats.org/drawingml/2006/main"/>
         </p:blipFill>
         <p:spPr>
@@ -2947,7 +2947,7 @@
           <p:cNvPr id="5" name="cover-institution">
             <a:extLst xmlns:a="http://schemas.openxmlformats.org/drawingml/2006/main">
               <a:ext uri="{FF2B5EF4-FFF2-40B4-BE49-F238E27FC236}">
-                <a16:creationId xmlns:a16="http://schemas.microsoft.com/office/drawing/2014/main" id="{BDFE09EA-C2F7-4549-8191-0F2A63B1E17C}"/>
+                <a16:creationId xmlns:a16="http://schemas.microsoft.com/office/drawing/2014/main" id="{4C0E8EC3-F8A9-4004-A09A-C29DCA627BB7}"/>
               </a:ext>
             </a:extLst>
           </p:cNvPr>
@@ -3009,7 +3009,7 @@
           <p:cNvPr id="6" name="cover-session">
             <a:extLst xmlns:a="http://schemas.openxmlformats.org/drawingml/2006/main">
               <a:ext uri="{FF2B5EF4-FFF2-40B4-BE49-F238E27FC236}">
-                <a16:creationId xmlns:a16="http://schemas.microsoft.com/office/drawing/2014/main" id="{C523DD44-F312-4A39-8F38-11AF213D2310}"/>
+                <a16:creationId xmlns:a16="http://schemas.microsoft.com/office/drawing/2014/main" id="{DF7CA376-C781-4D85-959D-5DCCFD08B6D7}"/>
               </a:ext>
             </a:extLst>
           </p:cNvPr>
@@ -3071,7 +3071,7 @@
           <p:cNvPr id="7" name="cover-title">
             <a:extLst xmlns:a="http://schemas.openxmlformats.org/drawingml/2006/main">
               <a:ext uri="{FF2B5EF4-FFF2-40B4-BE49-F238E27FC236}">
-                <a16:creationId xmlns:a16="http://schemas.microsoft.com/office/drawing/2014/main" id="{380E5CED-3D5A-4DD7-AA83-CE2095269F58}"/>
+                <a16:creationId xmlns:a16="http://schemas.microsoft.com/office/drawing/2014/main" id="{D125778D-D4C5-40C3-A14A-A70590F76DEC}"/>
               </a:ext>
             </a:extLst>
           </p:cNvPr>
@@ -3133,7 +3133,7 @@
           <p:cNvPr id="8" name="cover-system-short-name">
             <a:extLst xmlns:a="http://schemas.openxmlformats.org/drawingml/2006/main">
               <a:ext uri="{FF2B5EF4-FFF2-40B4-BE49-F238E27FC236}">
-                <a16:creationId xmlns:a16="http://schemas.microsoft.com/office/drawing/2014/main" id="{9BE074B6-3789-45FB-AE3E-CA931F0A6145}"/>
+                <a16:creationId xmlns:a16="http://schemas.microsoft.com/office/drawing/2014/main" id="{19114847-2AAC-4854-AFE8-04C19C9567C7}"/>
               </a:ext>
             </a:extLst>
           </p:cNvPr>
@@ -3195,7 +3195,7 @@
           <p:cNvPr id="9" name="cover-gold-rule">
             <a:extLst xmlns:a="http://schemas.openxmlformats.org/drawingml/2006/main">
               <a:ext uri="{FF2B5EF4-FFF2-40B4-BE49-F238E27FC236}">
-                <a16:creationId xmlns:a16="http://schemas.microsoft.com/office/drawing/2014/main" id="{4F427874-3743-4806-929F-DE22DC011ED7}"/>
+                <a16:creationId xmlns:a16="http://schemas.microsoft.com/office/drawing/2014/main" id="{9266E308-0BB1-4105-BA9F-C1A9D5888F52}"/>
               </a:ext>
             </a:extLst>
           </p:cNvPr>
@@ -3226,7 +3226,7 @@
           <p:cNvPr id="10" name="cover-promise">
             <a:extLst xmlns:a="http://schemas.openxmlformats.org/drawingml/2006/main">
               <a:ext uri="{FF2B5EF4-FFF2-40B4-BE49-F238E27FC236}">
-                <a16:creationId xmlns:a16="http://schemas.microsoft.com/office/drawing/2014/main" id="{ECD510E4-8F15-48FE-B349-4B54024BCD3F}"/>
+                <a16:creationId xmlns:a16="http://schemas.microsoft.com/office/drawing/2014/main" id="{73810668-F0A8-4536-A91B-F7BAA14D6216}"/>
               </a:ext>
             </a:extLst>
           </p:cNvPr>
@@ -3288,7 +3288,7 @@
           <p:cNvPr id="11" name="cover-style">
             <a:extLst xmlns:a="http://schemas.openxmlformats.org/drawingml/2006/main">
               <a:ext uri="{FF2B5EF4-FFF2-40B4-BE49-F238E27FC236}">
-                <a16:creationId xmlns:a16="http://schemas.microsoft.com/office/drawing/2014/main" id="{95CBF337-228E-434D-8632-D1B944A39C92}"/>
+                <a16:creationId xmlns:a16="http://schemas.microsoft.com/office/drawing/2014/main" id="{70274488-4F01-4669-917C-4D3B1A7EE70E}"/>
               </a:ext>
             </a:extLst>
           </p:cNvPr>
@@ -3354,7 +3354,7 @@
           <p:nvPr/>
         </p:nvPicPr>
         <p:blipFill>
-          <a:blip xmlns:r="http://schemas.openxmlformats.org/officeDocument/2006/relationships" xmlns:a="http://schemas.openxmlformats.org/drawingml/2006/main" r:embed="Re8911f8adc144843"/>
+          <a:blip xmlns:r="http://schemas.openxmlformats.org/officeDocument/2006/relationships" xmlns:a="http://schemas.openxmlformats.org/drawingml/2006/main" r:embed="Rb9fb159f1d604f27"/>
           <a:stretch xmlns:a="http://schemas.openxmlformats.org/drawingml/2006/main"/>
         </p:blipFill>
         <p:spPr>
@@ -3370,7 +3370,7 @@
     </p:spTree>
     <p:extLst>
       <p:ext uri="{BB962C8B-B14F-4D97-AF65-F5344CB8AC3E}">
-        <p14:creationId xmlns:p14="http://schemas.microsoft.com/office/powerpoint/2010/main" val="2116163541"/>
+        <p14:creationId xmlns:p14="http://schemas.microsoft.com/office/powerpoint/2010/main" val="470109294"/>
       </p:ext>
     </p:extLst>
   </p:cSld>
@@ -3401,7 +3401,7 @@
           <p:cNvPr id="21" name="side-accent-10">
             <a:extLst xmlns:a="http://schemas.openxmlformats.org/drawingml/2006/main">
               <a:ext uri="{FF2B5EF4-FFF2-40B4-BE49-F238E27FC236}">
-                <a16:creationId xmlns:a16="http://schemas.microsoft.com/office/drawing/2014/main" id="{5511CF8E-84FB-494F-A8C3-DB413AE3297F}"/>
+                <a16:creationId xmlns:a16="http://schemas.microsoft.com/office/drawing/2014/main" id="{A8765A30-8DB1-4BB3-93B4-49316C6AC3CA}"/>
               </a:ext>
             </a:extLst>
           </p:cNvPr>
@@ -3432,7 +3432,7 @@
           <p:cNvPr id="2" name="kicker-10">
             <a:extLst xmlns:a="http://schemas.openxmlformats.org/drawingml/2006/main">
               <a:ext uri="{FF2B5EF4-FFF2-40B4-BE49-F238E27FC236}">
-                <a16:creationId xmlns:a16="http://schemas.microsoft.com/office/drawing/2014/main" id="{6F52CB69-CA90-4CF9-9135-B90F5B056D4C}"/>
+                <a16:creationId xmlns:a16="http://schemas.microsoft.com/office/drawing/2014/main" id="{34E4C6F1-1D54-40E6-8278-3D3A88E07596}"/>
               </a:ext>
             </a:extLst>
           </p:cNvPr>
@@ -3494,7 +3494,7 @@
           <p:cNvPr id="3" name="title-10">
             <a:extLst xmlns:a="http://schemas.openxmlformats.org/drawingml/2006/main">
               <a:ext uri="{FF2B5EF4-FFF2-40B4-BE49-F238E27FC236}">
-                <a16:creationId xmlns:a16="http://schemas.microsoft.com/office/drawing/2014/main" id="{986D3608-D93F-4C19-9B7D-69421AFFF253}"/>
+                <a16:creationId xmlns:a16="http://schemas.microsoft.com/office/drawing/2014/main" id="{3B6C2C92-27C1-4777-90C4-D4260EB27E9B}"/>
               </a:ext>
             </a:extLst>
           </p:cNvPr>
@@ -3556,7 +3556,7 @@
           <p:cNvPr id="4" name="">
             <a:extLst xmlns:a="http://schemas.openxmlformats.org/drawingml/2006/main">
               <a:ext uri="{FF2B5EF4-FFF2-40B4-BE49-F238E27FC236}">
-                <a16:creationId xmlns:a16="http://schemas.microsoft.com/office/drawing/2014/main" id="{5CDD6400-9A25-4B29-9285-B47AA2859579}"/>
+                <a16:creationId xmlns:a16="http://schemas.microsoft.com/office/drawing/2014/main" id="{429E33B3-416C-4481-BDD1-162BFF1453D4}"/>
               </a:ext>
             </a:extLst>
           </p:cNvPr>
@@ -3618,7 +3618,7 @@
           <p:cNvPr id="5" name="">
             <a:extLst xmlns:a="http://schemas.openxmlformats.org/drawingml/2006/main">
               <a:ext uri="{FF2B5EF4-FFF2-40B4-BE49-F238E27FC236}">
-                <a16:creationId xmlns:a16="http://schemas.microsoft.com/office/drawing/2014/main" id="{0505CF0D-1487-43AD-8E43-1C47AD90B434}"/>
+                <a16:creationId xmlns:a16="http://schemas.microsoft.com/office/drawing/2014/main" id="{B3DA07D0-9F19-4F0B-9587-9DC07A62069D}"/>
               </a:ext>
             </a:extLst>
           </p:cNvPr>
@@ -3680,7 +3680,7 @@
           <p:cNvPr id="6" name="">
             <a:extLst xmlns:a="http://schemas.openxmlformats.org/drawingml/2006/main">
               <a:ext uri="{FF2B5EF4-FFF2-40B4-BE49-F238E27FC236}">
-                <a16:creationId xmlns:a16="http://schemas.microsoft.com/office/drawing/2014/main" id="{CCDB8269-D28A-46AB-ACD6-E7A460D20A0B}"/>
+                <a16:creationId xmlns:a16="http://schemas.microsoft.com/office/drawing/2014/main" id="{3867B4AE-3C58-4E74-9632-94409C2E29B6}"/>
               </a:ext>
             </a:extLst>
           </p:cNvPr>
@@ -3742,7 +3742,7 @@
           <p:cNvPr id="7" name="">
             <a:extLst xmlns:a="http://schemas.openxmlformats.org/drawingml/2006/main">
               <a:ext uri="{FF2B5EF4-FFF2-40B4-BE49-F238E27FC236}">
-                <a16:creationId xmlns:a16="http://schemas.microsoft.com/office/drawing/2014/main" id="{EFDC43A1-4224-4893-92EC-9F6184AC6D92}"/>
+                <a16:creationId xmlns:a16="http://schemas.microsoft.com/office/drawing/2014/main" id="{AE0AD4DD-2C6A-47F7-9A84-CB24DC78BD2A}"/>
               </a:ext>
             </a:extLst>
           </p:cNvPr>
@@ -3804,7 +3804,7 @@
           <p:cNvPr id="8" name="">
             <a:extLst xmlns:a="http://schemas.openxmlformats.org/drawingml/2006/main">
               <a:ext uri="{FF2B5EF4-FFF2-40B4-BE49-F238E27FC236}">
-                <a16:creationId xmlns:a16="http://schemas.microsoft.com/office/drawing/2014/main" id="{D67033AC-D101-481B-BE28-EB7770645335}"/>
+                <a16:creationId xmlns:a16="http://schemas.microsoft.com/office/drawing/2014/main" id="{A647A177-39F8-4376-A6F9-6015A0C9D1D4}"/>
               </a:ext>
             </a:extLst>
           </p:cNvPr>
@@ -3835,7 +3835,7 @@
           <p:cNvPr id="9" name="">
             <a:extLst xmlns:a="http://schemas.openxmlformats.org/drawingml/2006/main">
               <a:ext uri="{FF2B5EF4-FFF2-40B4-BE49-F238E27FC236}">
-                <a16:creationId xmlns:a16="http://schemas.microsoft.com/office/drawing/2014/main" id="{44011C73-B93C-4EDB-B98B-52D5743306C2}"/>
+                <a16:creationId xmlns:a16="http://schemas.microsoft.com/office/drawing/2014/main" id="{1E7ED4FE-AC82-40F8-9B03-9B0AF2650F8A}"/>
               </a:ext>
             </a:extLst>
           </p:cNvPr>
@@ -3897,7 +3897,7 @@
           <p:cNvPr id="10" name="">
             <a:extLst xmlns:a="http://schemas.openxmlformats.org/drawingml/2006/main">
               <a:ext uri="{FF2B5EF4-FFF2-40B4-BE49-F238E27FC236}">
-                <a16:creationId xmlns:a16="http://schemas.microsoft.com/office/drawing/2014/main" id="{E63DBE7F-1AEE-4E11-B2E6-2E3868AD92BA}"/>
+                <a16:creationId xmlns:a16="http://schemas.microsoft.com/office/drawing/2014/main" id="{15E70E6A-07DD-4D73-8DB1-3165780160E7}"/>
               </a:ext>
             </a:extLst>
           </p:cNvPr>
@@ -3959,7 +3959,7 @@
           <p:cNvPr id="11" name="">
             <a:extLst xmlns:a="http://schemas.openxmlformats.org/drawingml/2006/main">
               <a:ext uri="{FF2B5EF4-FFF2-40B4-BE49-F238E27FC236}">
-                <a16:creationId xmlns:a16="http://schemas.microsoft.com/office/drawing/2014/main" id="{C9C93F54-D11A-40AC-AF8B-4491A6E86DD9}"/>
+                <a16:creationId xmlns:a16="http://schemas.microsoft.com/office/drawing/2014/main" id="{4506C08E-F8C2-4D8A-B24D-E33F110A2049}"/>
               </a:ext>
             </a:extLst>
           </p:cNvPr>
@@ -4021,7 +4021,7 @@
           <p:cNvPr id="12" name="">
             <a:extLst xmlns:a="http://schemas.openxmlformats.org/drawingml/2006/main">
               <a:ext uri="{FF2B5EF4-FFF2-40B4-BE49-F238E27FC236}">
-                <a16:creationId xmlns:a16="http://schemas.microsoft.com/office/drawing/2014/main" id="{3F7D95C9-1722-4EFC-970B-C5844A87B974}"/>
+                <a16:creationId xmlns:a16="http://schemas.microsoft.com/office/drawing/2014/main" id="{52CC0F3A-B296-469E-B541-D3A78727AB61}"/>
               </a:ext>
             </a:extLst>
           </p:cNvPr>
@@ -4052,7 +4052,7 @@
           <p:cNvPr id="13" name="">
             <a:extLst xmlns:a="http://schemas.openxmlformats.org/drawingml/2006/main">
               <a:ext uri="{FF2B5EF4-FFF2-40B4-BE49-F238E27FC236}">
-                <a16:creationId xmlns:a16="http://schemas.microsoft.com/office/drawing/2014/main" id="{E3C3ACC4-B3A2-4166-A2CD-4382438461BB}"/>
+                <a16:creationId xmlns:a16="http://schemas.microsoft.com/office/drawing/2014/main" id="{50CB6AA6-F549-496B-9E47-7A819EFACEB8}"/>
               </a:ext>
             </a:extLst>
           </p:cNvPr>
@@ -4114,7 +4114,7 @@
           <p:cNvPr id="14" name="">
             <a:extLst xmlns:a="http://schemas.openxmlformats.org/drawingml/2006/main">
               <a:ext uri="{FF2B5EF4-FFF2-40B4-BE49-F238E27FC236}">
-                <a16:creationId xmlns:a16="http://schemas.microsoft.com/office/drawing/2014/main" id="{9D095548-C100-452A-BF3F-11E30C8BF745}"/>
+                <a16:creationId xmlns:a16="http://schemas.microsoft.com/office/drawing/2014/main" id="{1F1DC087-86EF-4B72-ADC4-E40A5ADC0566}"/>
               </a:ext>
             </a:extLst>
           </p:cNvPr>
@@ -4176,7 +4176,7 @@
           <p:cNvPr id="15" name="">
             <a:extLst xmlns:a="http://schemas.openxmlformats.org/drawingml/2006/main">
               <a:ext uri="{FF2B5EF4-FFF2-40B4-BE49-F238E27FC236}">
-                <a16:creationId xmlns:a16="http://schemas.microsoft.com/office/drawing/2014/main" id="{2D499111-C4ED-4F89-86DA-10BB6E4A72EA}"/>
+                <a16:creationId xmlns:a16="http://schemas.microsoft.com/office/drawing/2014/main" id="{8F04002B-EFE6-46E8-A4CF-43E04570784A}"/>
               </a:ext>
             </a:extLst>
           </p:cNvPr>
@@ -4238,7 +4238,7 @@
           <p:cNvPr id="16" name="">
             <a:extLst xmlns:a="http://schemas.openxmlformats.org/drawingml/2006/main">
               <a:ext uri="{FF2B5EF4-FFF2-40B4-BE49-F238E27FC236}">
-                <a16:creationId xmlns:a16="http://schemas.microsoft.com/office/drawing/2014/main" id="{C129A65A-D835-4986-98A5-B8337C990F4A}"/>
+                <a16:creationId xmlns:a16="http://schemas.microsoft.com/office/drawing/2014/main" id="{CCBABFE4-9FE4-46C3-91FE-ABBE7388D173}"/>
               </a:ext>
             </a:extLst>
           </p:cNvPr>
@@ -4271,7 +4271,7 @@
           <p:cNvPr id="17" name="">
             <a:extLst xmlns:a="http://schemas.openxmlformats.org/drawingml/2006/main">
               <a:ext uri="{FF2B5EF4-FFF2-40B4-BE49-F238E27FC236}">
-                <a16:creationId xmlns:a16="http://schemas.microsoft.com/office/drawing/2014/main" id="{C0B15CD9-9A01-4293-B0E0-F394055A01ED}"/>
+                <a16:creationId xmlns:a16="http://schemas.microsoft.com/office/drawing/2014/main" id="{8AD95533-73F4-4AC4-8CB0-A117CD84C0B1}"/>
               </a:ext>
             </a:extLst>
           </p:cNvPr>
@@ -4333,7 +4333,7 @@
           <p:cNvPr id="18" name="footer-rule-10">
             <a:extLst xmlns:a="http://schemas.openxmlformats.org/drawingml/2006/main">
               <a:ext uri="{FF2B5EF4-FFF2-40B4-BE49-F238E27FC236}">
-                <a16:creationId xmlns:a16="http://schemas.microsoft.com/office/drawing/2014/main" id="{29D51F18-5E10-4409-ABC5-A38E9BC511BC}"/>
+                <a16:creationId xmlns:a16="http://schemas.microsoft.com/office/drawing/2014/main" id="{0FB54278-ADF1-462D-AE21-9F56E4100309}"/>
               </a:ext>
             </a:extLst>
           </p:cNvPr>
@@ -4364,7 +4364,7 @@
           <p:cNvPr id="19" name="footer-label-10">
             <a:extLst xmlns:a="http://schemas.openxmlformats.org/drawingml/2006/main">
               <a:ext uri="{FF2B5EF4-FFF2-40B4-BE49-F238E27FC236}">
-                <a16:creationId xmlns:a16="http://schemas.microsoft.com/office/drawing/2014/main" id="{C408B435-58EE-4D98-AA88-A9742775213E}"/>
+                <a16:creationId xmlns:a16="http://schemas.microsoft.com/office/drawing/2014/main" id="{FB5D8E37-9333-4342-86F9-FB572898585B}"/>
               </a:ext>
             </a:extLst>
           </p:cNvPr>
@@ -4426,7 +4426,7 @@
           <p:cNvPr id="20" name="footer-page-10">
             <a:extLst xmlns:a="http://schemas.openxmlformats.org/drawingml/2006/main">
               <a:ext uri="{FF2B5EF4-FFF2-40B4-BE49-F238E27FC236}">
-                <a16:creationId xmlns:a16="http://schemas.microsoft.com/office/drawing/2014/main" id="{6A861462-4ABD-4F84-9174-94A542FDE445}"/>
+                <a16:creationId xmlns:a16="http://schemas.microsoft.com/office/drawing/2014/main" id="{05A2E422-F2FB-4469-B94E-475CA58B4D4D}"/>
               </a:ext>
             </a:extLst>
           </p:cNvPr>
@@ -4486,7 +4486,7 @@
     </p:spTree>
     <p:extLst>
       <p:ext uri="{BB962C8B-B14F-4D97-AF65-F5344CB8AC3E}">
-        <p14:creationId xmlns:p14="http://schemas.microsoft.com/office/powerpoint/2010/main" val="1503182251"/>
+        <p14:creationId xmlns:p14="http://schemas.microsoft.com/office/powerpoint/2010/main" val="570829991"/>
       </p:ext>
     </p:extLst>
   </p:cSld>
@@ -4517,7 +4517,7 @@
           <p:cNvPr id="22" name="side-accent-11">
             <a:extLst xmlns:a="http://schemas.openxmlformats.org/drawingml/2006/main">
               <a:ext uri="{FF2B5EF4-FFF2-40B4-BE49-F238E27FC236}">
-                <a16:creationId xmlns:a16="http://schemas.microsoft.com/office/drawing/2014/main" id="{F994ED44-8431-43AA-940A-81F012E85E74}"/>
+                <a16:creationId xmlns:a16="http://schemas.microsoft.com/office/drawing/2014/main" id="{FFB29332-E203-46BE-8945-242C77E66FE8}"/>
               </a:ext>
             </a:extLst>
           </p:cNvPr>
@@ -4548,7 +4548,7 @@
           <p:cNvPr id="2" name="kicker-11">
             <a:extLst xmlns:a="http://schemas.openxmlformats.org/drawingml/2006/main">
               <a:ext uri="{FF2B5EF4-FFF2-40B4-BE49-F238E27FC236}">
-                <a16:creationId xmlns:a16="http://schemas.microsoft.com/office/drawing/2014/main" id="{1F5F6255-756B-4A18-BE58-F1FBE2E08ABB}"/>
+                <a16:creationId xmlns:a16="http://schemas.microsoft.com/office/drawing/2014/main" id="{F716D330-8400-4D2C-9A38-F117E6F29CD0}"/>
               </a:ext>
             </a:extLst>
           </p:cNvPr>
@@ -4610,7 +4610,7 @@
           <p:cNvPr id="3" name="title-11">
             <a:extLst xmlns:a="http://schemas.openxmlformats.org/drawingml/2006/main">
               <a:ext uri="{FF2B5EF4-FFF2-40B4-BE49-F238E27FC236}">
-                <a16:creationId xmlns:a16="http://schemas.microsoft.com/office/drawing/2014/main" id="{8FA8193C-DF0C-468D-A868-3DA27BAFE77F}"/>
+                <a16:creationId xmlns:a16="http://schemas.microsoft.com/office/drawing/2014/main" id="{922BEFC7-EFC2-4794-8640-464142F23CEB}"/>
               </a:ext>
             </a:extLst>
           </p:cNvPr>
@@ -4672,7 +4672,7 @@
           <p:cNvPr id="4" name="">
             <a:extLst xmlns:a="http://schemas.openxmlformats.org/drawingml/2006/main">
               <a:ext uri="{FF2B5EF4-FFF2-40B4-BE49-F238E27FC236}">
-                <a16:creationId xmlns:a16="http://schemas.microsoft.com/office/drawing/2014/main" id="{6EE8EACB-0BFB-4ADF-8AE8-575817347CC1}"/>
+                <a16:creationId xmlns:a16="http://schemas.microsoft.com/office/drawing/2014/main" id="{BC97170E-DB1A-41EC-BC07-E406F17725DA}"/>
               </a:ext>
             </a:extLst>
           </p:cNvPr>
@@ -4734,7 +4734,7 @@
           <p:cNvPr id="5" name="">
             <a:extLst xmlns:a="http://schemas.openxmlformats.org/drawingml/2006/main">
               <a:ext uri="{FF2B5EF4-FFF2-40B4-BE49-F238E27FC236}">
-                <a16:creationId xmlns:a16="http://schemas.microsoft.com/office/drawing/2014/main" id="{5C7402DD-9FF7-414D-829C-8EE23249EA69}"/>
+                <a16:creationId xmlns:a16="http://schemas.microsoft.com/office/drawing/2014/main" id="{2599A78B-226E-4049-82E7-5E5CF81F3A98}"/>
               </a:ext>
             </a:extLst>
           </p:cNvPr>
@@ -4765,7 +4765,7 @@
           <p:cNvPr id="6" name="">
             <a:extLst xmlns:a="http://schemas.openxmlformats.org/drawingml/2006/main">
               <a:ext uri="{FF2B5EF4-FFF2-40B4-BE49-F238E27FC236}">
-                <a16:creationId xmlns:a16="http://schemas.microsoft.com/office/drawing/2014/main" id="{1848CCFE-FB2A-4143-933D-38C114442E08}"/>
+                <a16:creationId xmlns:a16="http://schemas.microsoft.com/office/drawing/2014/main" id="{A2783728-519B-4B83-9856-AB9DD2C7862E}"/>
               </a:ext>
             </a:extLst>
           </p:cNvPr>
@@ -4827,7 +4827,7 @@
           <p:cNvPr id="7" name="">
             <a:extLst xmlns:a="http://schemas.openxmlformats.org/drawingml/2006/main">
               <a:ext uri="{FF2B5EF4-FFF2-40B4-BE49-F238E27FC236}">
-                <a16:creationId xmlns:a16="http://schemas.microsoft.com/office/drawing/2014/main" id="{73B0CAD6-BD21-40D9-936D-58B2A7D26CDC}"/>
+                <a16:creationId xmlns:a16="http://schemas.microsoft.com/office/drawing/2014/main" id="{97140E0D-88BF-46BA-B341-F785A8939B39}"/>
               </a:ext>
             </a:extLst>
           </p:cNvPr>
@@ -4889,7 +4889,7 @@
           <p:cNvPr id="8" name="">
             <a:extLst xmlns:a="http://schemas.openxmlformats.org/drawingml/2006/main">
               <a:ext uri="{FF2B5EF4-FFF2-40B4-BE49-F238E27FC236}">
-                <a16:creationId xmlns:a16="http://schemas.microsoft.com/office/drawing/2014/main" id="{68073530-3336-4211-9675-FAF03F8E203E}"/>
+                <a16:creationId xmlns:a16="http://schemas.microsoft.com/office/drawing/2014/main" id="{C7EC20FF-26F3-43CE-9339-AA1D5F5F74E5}"/>
               </a:ext>
             </a:extLst>
           </p:cNvPr>
@@ -4951,7 +4951,7 @@
           <p:cNvPr id="9" name="">
             <a:extLst xmlns:a="http://schemas.openxmlformats.org/drawingml/2006/main">
               <a:ext uri="{FF2B5EF4-FFF2-40B4-BE49-F238E27FC236}">
-                <a16:creationId xmlns:a16="http://schemas.microsoft.com/office/drawing/2014/main" id="{D7EF8313-0EA9-4386-8895-2ECDD7F92690}"/>
+                <a16:creationId xmlns:a16="http://schemas.microsoft.com/office/drawing/2014/main" id="{445195DB-449E-4797-999D-C50FC502C6A7}"/>
               </a:ext>
             </a:extLst>
           </p:cNvPr>
@@ -4982,7 +4982,7 @@
           <p:cNvPr id="10" name="">
             <a:extLst xmlns:a="http://schemas.openxmlformats.org/drawingml/2006/main">
               <a:ext uri="{FF2B5EF4-FFF2-40B4-BE49-F238E27FC236}">
-                <a16:creationId xmlns:a16="http://schemas.microsoft.com/office/drawing/2014/main" id="{A07D7A5B-58B5-4024-8A9C-DE9CCA31237E}"/>
+                <a16:creationId xmlns:a16="http://schemas.microsoft.com/office/drawing/2014/main" id="{F58AEF96-9573-43EA-8149-1E59951A3449}"/>
               </a:ext>
             </a:extLst>
           </p:cNvPr>
@@ -5044,7 +5044,7 @@
           <p:cNvPr id="11" name="">
             <a:extLst xmlns:a="http://schemas.openxmlformats.org/drawingml/2006/main">
               <a:ext uri="{FF2B5EF4-FFF2-40B4-BE49-F238E27FC236}">
-                <a16:creationId xmlns:a16="http://schemas.microsoft.com/office/drawing/2014/main" id="{B2838495-1034-4BBB-8C84-58BE6095D8F0}"/>
+                <a16:creationId xmlns:a16="http://schemas.microsoft.com/office/drawing/2014/main" id="{58A130BC-7997-4FB7-8FB3-E7E5C8A4F7FD}"/>
               </a:ext>
             </a:extLst>
           </p:cNvPr>
@@ -5106,7 +5106,7 @@
           <p:cNvPr id="12" name="">
             <a:extLst xmlns:a="http://schemas.openxmlformats.org/drawingml/2006/main">
               <a:ext uri="{FF2B5EF4-FFF2-40B4-BE49-F238E27FC236}">
-                <a16:creationId xmlns:a16="http://schemas.microsoft.com/office/drawing/2014/main" id="{77C8A669-AF52-4534-B4F1-BEAD95359C1F}"/>
+                <a16:creationId xmlns:a16="http://schemas.microsoft.com/office/drawing/2014/main" id="{1C2191E4-C79B-4E6C-9235-057993A2C416}"/>
               </a:ext>
             </a:extLst>
           </p:cNvPr>
@@ -5168,7 +5168,7 @@
           <p:cNvPr id="13" name="">
             <a:extLst xmlns:a="http://schemas.openxmlformats.org/drawingml/2006/main">
               <a:ext uri="{FF2B5EF4-FFF2-40B4-BE49-F238E27FC236}">
-                <a16:creationId xmlns:a16="http://schemas.microsoft.com/office/drawing/2014/main" id="{F8C3CC84-69F8-43E1-8CF6-AE0926C43500}"/>
+                <a16:creationId xmlns:a16="http://schemas.microsoft.com/office/drawing/2014/main" id="{376E2C3F-4663-47F7-97FA-F67F72E5AA3B}"/>
               </a:ext>
             </a:extLst>
           </p:cNvPr>
@@ -5199,7 +5199,7 @@
           <p:cNvPr id="14" name="">
             <a:extLst xmlns:a="http://schemas.openxmlformats.org/drawingml/2006/main">
               <a:ext uri="{FF2B5EF4-FFF2-40B4-BE49-F238E27FC236}">
-                <a16:creationId xmlns:a16="http://schemas.microsoft.com/office/drawing/2014/main" id="{B14F7F27-F5FF-4F48-A008-99E8E6A2806F}"/>
+                <a16:creationId xmlns:a16="http://schemas.microsoft.com/office/drawing/2014/main" id="{910BE494-5FE6-4D88-A9C2-66623E3733B4}"/>
               </a:ext>
             </a:extLst>
           </p:cNvPr>
@@ -5261,7 +5261,7 @@
           <p:cNvPr id="15" name="">
             <a:extLst xmlns:a="http://schemas.openxmlformats.org/drawingml/2006/main">
               <a:ext uri="{FF2B5EF4-FFF2-40B4-BE49-F238E27FC236}">
-                <a16:creationId xmlns:a16="http://schemas.microsoft.com/office/drawing/2014/main" id="{E7DF2112-84C0-4CA7-8C90-5903E5EC513E}"/>
+                <a16:creationId xmlns:a16="http://schemas.microsoft.com/office/drawing/2014/main" id="{4409A8D2-756A-4BC1-AF1B-5263081CE883}"/>
               </a:ext>
             </a:extLst>
           </p:cNvPr>
@@ -5323,7 +5323,7 @@
           <p:cNvPr id="16" name="">
             <a:extLst xmlns:a="http://schemas.openxmlformats.org/drawingml/2006/main">
               <a:ext uri="{FF2B5EF4-FFF2-40B4-BE49-F238E27FC236}">
-                <a16:creationId xmlns:a16="http://schemas.microsoft.com/office/drawing/2014/main" id="{B2B7DF88-FEC4-4440-BF73-18F84B71AD61}"/>
+                <a16:creationId xmlns:a16="http://schemas.microsoft.com/office/drawing/2014/main" id="{FC39A93F-024C-4207-9332-9597CBD7C87F}"/>
               </a:ext>
             </a:extLst>
           </p:cNvPr>
@@ -5385,7 +5385,7 @@
           <p:cNvPr id="17" name="">
             <a:extLst xmlns:a="http://schemas.openxmlformats.org/drawingml/2006/main">
               <a:ext uri="{FF2B5EF4-FFF2-40B4-BE49-F238E27FC236}">
-                <a16:creationId xmlns:a16="http://schemas.microsoft.com/office/drawing/2014/main" id="{C4F8D805-1FD8-4F80-AA06-65DE8CE34350}"/>
+                <a16:creationId xmlns:a16="http://schemas.microsoft.com/office/drawing/2014/main" id="{663D66B6-7378-41F3-AB83-415281DCA916}"/>
               </a:ext>
             </a:extLst>
           </p:cNvPr>
@@ -5420,7 +5420,7 @@
           <p:cNvPr id="18" name="">
             <a:extLst xmlns:a="http://schemas.openxmlformats.org/drawingml/2006/main">
               <a:ext uri="{FF2B5EF4-FFF2-40B4-BE49-F238E27FC236}">
-                <a16:creationId xmlns:a16="http://schemas.microsoft.com/office/drawing/2014/main" id="{7066A29D-46B8-4962-B04B-E61882FFD8DC}"/>
+                <a16:creationId xmlns:a16="http://schemas.microsoft.com/office/drawing/2014/main" id="{345F6741-335A-4AD2-9FA4-4AFE8E141B4E}"/>
               </a:ext>
             </a:extLst>
           </p:cNvPr>
@@ -5509,7 +5509,7 @@
           <p:cNvPr id="19" name="footer-rule-11">
             <a:extLst xmlns:a="http://schemas.openxmlformats.org/drawingml/2006/main">
               <a:ext uri="{FF2B5EF4-FFF2-40B4-BE49-F238E27FC236}">
-                <a16:creationId xmlns:a16="http://schemas.microsoft.com/office/drawing/2014/main" id="{FB0355AE-D150-4754-AD13-02863A0AB4EC}"/>
+                <a16:creationId xmlns:a16="http://schemas.microsoft.com/office/drawing/2014/main" id="{BA2CE536-8F09-4689-AF70-8A670CC33768}"/>
               </a:ext>
             </a:extLst>
           </p:cNvPr>
@@ -5540,7 +5540,7 @@
           <p:cNvPr id="20" name="footer-label-11">
             <a:extLst xmlns:a="http://schemas.openxmlformats.org/drawingml/2006/main">
               <a:ext uri="{FF2B5EF4-FFF2-40B4-BE49-F238E27FC236}">
-                <a16:creationId xmlns:a16="http://schemas.microsoft.com/office/drawing/2014/main" id="{D75E6824-8866-4D23-9F2A-600D73015034}"/>
+                <a16:creationId xmlns:a16="http://schemas.microsoft.com/office/drawing/2014/main" id="{A4BF5D2A-9101-4E94-BA2A-A11AF3CA54BB}"/>
               </a:ext>
             </a:extLst>
           </p:cNvPr>
@@ -5602,7 +5602,7 @@
           <p:cNvPr id="21" name="footer-page-11">
             <a:extLst xmlns:a="http://schemas.openxmlformats.org/drawingml/2006/main">
               <a:ext uri="{FF2B5EF4-FFF2-40B4-BE49-F238E27FC236}">
-                <a16:creationId xmlns:a16="http://schemas.microsoft.com/office/drawing/2014/main" id="{DFFA6110-DE81-40C9-A168-2E5266FBD00E}"/>
+                <a16:creationId xmlns:a16="http://schemas.microsoft.com/office/drawing/2014/main" id="{6EE60B62-3FF4-43DE-82CC-F9C0AFEB2B76}"/>
               </a:ext>
             </a:extLst>
           </p:cNvPr>
@@ -5662,7 +5662,7 @@
     </p:spTree>
     <p:extLst>
       <p:ext uri="{BB962C8B-B14F-4D97-AF65-F5344CB8AC3E}">
-        <p14:creationId xmlns:p14="http://schemas.microsoft.com/office/powerpoint/2010/main" val="824608286"/>
+        <p14:creationId xmlns:p14="http://schemas.microsoft.com/office/powerpoint/2010/main" val="40875906"/>
       </p:ext>
     </p:extLst>
   </p:cSld>
@@ -5693,7 +5693,7 @@
           <p:cNvPr id="14" name="side-accent-12">
             <a:extLst xmlns:a="http://schemas.openxmlformats.org/drawingml/2006/main">
               <a:ext uri="{FF2B5EF4-FFF2-40B4-BE49-F238E27FC236}">
-                <a16:creationId xmlns:a16="http://schemas.microsoft.com/office/drawing/2014/main" id="{B3CE86C3-44B4-4446-B1B2-F0697D658BF5}"/>
+                <a16:creationId xmlns:a16="http://schemas.microsoft.com/office/drawing/2014/main" id="{A2C78C74-82EB-4A2C-9F11-E807FBB6D58F}"/>
               </a:ext>
             </a:extLst>
           </p:cNvPr>
@@ -5724,7 +5724,7 @@
           <p:cNvPr id="2" name="kicker-12">
             <a:extLst xmlns:a="http://schemas.openxmlformats.org/drawingml/2006/main">
               <a:ext uri="{FF2B5EF4-FFF2-40B4-BE49-F238E27FC236}">
-                <a16:creationId xmlns:a16="http://schemas.microsoft.com/office/drawing/2014/main" id="{C244AD4A-F5DA-48BE-A327-9A8509D0142F}"/>
+                <a16:creationId xmlns:a16="http://schemas.microsoft.com/office/drawing/2014/main" id="{099F4006-505C-40F1-B0AA-EED6C2FB9795}"/>
               </a:ext>
             </a:extLst>
           </p:cNvPr>
@@ -5786,7 +5786,7 @@
           <p:cNvPr id="3" name="title-12">
             <a:extLst xmlns:a="http://schemas.openxmlformats.org/drawingml/2006/main">
               <a:ext uri="{FF2B5EF4-FFF2-40B4-BE49-F238E27FC236}">
-                <a16:creationId xmlns:a16="http://schemas.microsoft.com/office/drawing/2014/main" id="{EEB4D030-61EC-43E3-8D5B-38654028BE03}"/>
+                <a16:creationId xmlns:a16="http://schemas.microsoft.com/office/drawing/2014/main" id="{2F1D2059-F483-4392-A8E9-F836CEC4AA0C}"/>
               </a:ext>
             </a:extLst>
           </p:cNvPr>
@@ -5848,7 +5848,7 @@
           <p:cNvPr id="4" name="draft-panel">
             <a:extLst xmlns:a="http://schemas.openxmlformats.org/drawingml/2006/main">
               <a:ext uri="{FF2B5EF4-FFF2-40B4-BE49-F238E27FC236}">
-                <a16:creationId xmlns:a16="http://schemas.microsoft.com/office/drawing/2014/main" id="{A8911B29-D4B2-469D-971D-96F49431D72A}"/>
+                <a16:creationId xmlns:a16="http://schemas.microsoft.com/office/drawing/2014/main" id="{4671A35F-45BE-4F5A-A259-B1BC4AB2C7FD}"/>
               </a:ext>
             </a:extLst>
           </p:cNvPr>
@@ -5883,7 +5883,7 @@
           <p:cNvPr id="5" name="">
             <a:extLst xmlns:a="http://schemas.openxmlformats.org/drawingml/2006/main">
               <a:ext uri="{FF2B5EF4-FFF2-40B4-BE49-F238E27FC236}">
-                <a16:creationId xmlns:a16="http://schemas.microsoft.com/office/drawing/2014/main" id="{D85D8725-6DFE-437A-8FDF-94FF199926D5}"/>
+                <a16:creationId xmlns:a16="http://schemas.microsoft.com/office/drawing/2014/main" id="{DB77EA38-79E3-49F5-BFED-E61BA6170F50}"/>
               </a:ext>
             </a:extLst>
           </p:cNvPr>
@@ -5945,7 +5945,7 @@
           <p:cNvPr id="6" name="">
             <a:extLst xmlns:a="http://schemas.openxmlformats.org/drawingml/2006/main">
               <a:ext uri="{FF2B5EF4-FFF2-40B4-BE49-F238E27FC236}">
-                <a16:creationId xmlns:a16="http://schemas.microsoft.com/office/drawing/2014/main" id="{41C26044-2E6E-4228-82E9-F4D175CA675A}"/>
+                <a16:creationId xmlns:a16="http://schemas.microsoft.com/office/drawing/2014/main" id="{57FD923E-3F1B-4A47-BDE8-E246B9E1D505}"/>
               </a:ext>
             </a:extLst>
           </p:cNvPr>
@@ -6061,7 +6061,7 @@
           <p:cNvPr id="7" name="submit-panel">
             <a:extLst xmlns:a="http://schemas.openxmlformats.org/drawingml/2006/main">
               <a:ext uri="{FF2B5EF4-FFF2-40B4-BE49-F238E27FC236}">
-                <a16:creationId xmlns:a16="http://schemas.microsoft.com/office/drawing/2014/main" id="{47BE46EC-0404-4B54-AD90-A5BE3A46A204}"/>
+                <a16:creationId xmlns:a16="http://schemas.microsoft.com/office/drawing/2014/main" id="{E873492B-8DBE-48AE-A338-26E60AB712D0}"/>
               </a:ext>
             </a:extLst>
           </p:cNvPr>
@@ -6096,7 +6096,7 @@
           <p:cNvPr id="8" name="">
             <a:extLst xmlns:a="http://schemas.openxmlformats.org/drawingml/2006/main">
               <a:ext uri="{FF2B5EF4-FFF2-40B4-BE49-F238E27FC236}">
-                <a16:creationId xmlns:a16="http://schemas.microsoft.com/office/drawing/2014/main" id="{5E926FEA-C515-4307-A1D5-12CE5648824F}"/>
+                <a16:creationId xmlns:a16="http://schemas.microsoft.com/office/drawing/2014/main" id="{509C3533-68BE-4477-A3F4-D8ADB00167EE}"/>
               </a:ext>
             </a:extLst>
           </p:cNvPr>
@@ -6158,7 +6158,7 @@
           <p:cNvPr id="9" name="">
             <a:extLst xmlns:a="http://schemas.openxmlformats.org/drawingml/2006/main">
               <a:ext uri="{FF2B5EF4-FFF2-40B4-BE49-F238E27FC236}">
-                <a16:creationId xmlns:a16="http://schemas.microsoft.com/office/drawing/2014/main" id="{B8EE55A3-E32B-4B43-9390-120307511B44}"/>
+                <a16:creationId xmlns:a16="http://schemas.microsoft.com/office/drawing/2014/main" id="{57D338BA-FCC7-4936-92CB-A09804FA4AB6}"/>
               </a:ext>
             </a:extLst>
           </p:cNvPr>
@@ -6274,7 +6274,7 @@
           <p:cNvPr id="10" name="">
             <a:extLst xmlns:a="http://schemas.openxmlformats.org/drawingml/2006/main">
               <a:ext uri="{FF2B5EF4-FFF2-40B4-BE49-F238E27FC236}">
-                <a16:creationId xmlns:a16="http://schemas.microsoft.com/office/drawing/2014/main" id="{A9485C3E-962F-41E7-9F7D-141C49683677}"/>
+                <a16:creationId xmlns:a16="http://schemas.microsoft.com/office/drawing/2014/main" id="{A2A1B40F-8D9B-4D22-A40B-16C97628E090}"/>
               </a:ext>
             </a:extLst>
           </p:cNvPr>
@@ -6336,7 +6336,7 @@
           <p:cNvPr id="11" name="footer-rule-12">
             <a:extLst xmlns:a="http://schemas.openxmlformats.org/drawingml/2006/main">
               <a:ext uri="{FF2B5EF4-FFF2-40B4-BE49-F238E27FC236}">
-                <a16:creationId xmlns:a16="http://schemas.microsoft.com/office/drawing/2014/main" id="{5F10302F-AFF3-4549-969B-AEF2B265E971}"/>
+                <a16:creationId xmlns:a16="http://schemas.microsoft.com/office/drawing/2014/main" id="{D4237CF0-899A-4FBB-9FD0-B0ED7258F8E0}"/>
               </a:ext>
             </a:extLst>
           </p:cNvPr>
@@ -6367,7 +6367,7 @@
           <p:cNvPr id="12" name="footer-label-12">
             <a:extLst xmlns:a="http://schemas.openxmlformats.org/drawingml/2006/main">
               <a:ext uri="{FF2B5EF4-FFF2-40B4-BE49-F238E27FC236}">
-                <a16:creationId xmlns:a16="http://schemas.microsoft.com/office/drawing/2014/main" id="{01996034-55CF-4740-8018-7E4A23638541}"/>
+                <a16:creationId xmlns:a16="http://schemas.microsoft.com/office/drawing/2014/main" id="{B40865C0-73AE-4F5B-B852-415E4A439C1A}"/>
               </a:ext>
             </a:extLst>
           </p:cNvPr>
@@ -6429,7 +6429,7 @@
           <p:cNvPr id="13" name="footer-page-12">
             <a:extLst xmlns:a="http://schemas.openxmlformats.org/drawingml/2006/main">
               <a:ext uri="{FF2B5EF4-FFF2-40B4-BE49-F238E27FC236}">
-                <a16:creationId xmlns:a16="http://schemas.microsoft.com/office/drawing/2014/main" id="{59D35A8B-5799-4CB5-A100-CEC2703276E4}"/>
+                <a16:creationId xmlns:a16="http://schemas.microsoft.com/office/drawing/2014/main" id="{E503171F-6D55-4D02-A0B1-A690B9FCBB44}"/>
               </a:ext>
             </a:extLst>
           </p:cNvPr>
@@ -6489,7 +6489,7 @@
     </p:spTree>
     <p:extLst>
       <p:ext uri="{BB962C8B-B14F-4D97-AF65-F5344CB8AC3E}">
-        <p14:creationId xmlns:p14="http://schemas.microsoft.com/office/powerpoint/2010/main" val="545933456"/>
+        <p14:creationId xmlns:p14="http://schemas.microsoft.com/office/powerpoint/2010/main" val="1578658044"/>
       </p:ext>
     </p:extLst>
   </p:cSld>
@@ -6520,7 +6520,7 @@
           <p:cNvPr id="25" name="side-accent-13">
             <a:extLst xmlns:a="http://schemas.openxmlformats.org/drawingml/2006/main">
               <a:ext uri="{FF2B5EF4-FFF2-40B4-BE49-F238E27FC236}">
-                <a16:creationId xmlns:a16="http://schemas.microsoft.com/office/drawing/2014/main" id="{B22AB5FF-CF1F-404A-A09F-7AD3A3E8FFCE}"/>
+                <a16:creationId xmlns:a16="http://schemas.microsoft.com/office/drawing/2014/main" id="{AAB6A0FA-F268-47D6-8758-0699873DC3C1}"/>
               </a:ext>
             </a:extLst>
           </p:cNvPr>
@@ -6551,7 +6551,7 @@
           <p:cNvPr id="2" name="kicker-13">
             <a:extLst xmlns:a="http://schemas.openxmlformats.org/drawingml/2006/main">
               <a:ext uri="{FF2B5EF4-FFF2-40B4-BE49-F238E27FC236}">
-                <a16:creationId xmlns:a16="http://schemas.microsoft.com/office/drawing/2014/main" id="{B6B0D437-9C3C-4810-8724-69E2687EE1D6}"/>
+                <a16:creationId xmlns:a16="http://schemas.microsoft.com/office/drawing/2014/main" id="{835D40BE-920D-4398-A57E-26590E3EB0A0}"/>
               </a:ext>
             </a:extLst>
           </p:cNvPr>
@@ -6613,7 +6613,7 @@
           <p:cNvPr id="3" name="title-13">
             <a:extLst xmlns:a="http://schemas.openxmlformats.org/drawingml/2006/main">
               <a:ext uri="{FF2B5EF4-FFF2-40B4-BE49-F238E27FC236}">
-                <a16:creationId xmlns:a16="http://schemas.microsoft.com/office/drawing/2014/main" id="{33917CF5-E16D-4AF0-9917-7D1FB1FA575A}"/>
+                <a16:creationId xmlns:a16="http://schemas.microsoft.com/office/drawing/2014/main" id="{5A9E0D30-4069-4202-AB04-54E934572EC4}"/>
               </a:ext>
             </a:extLst>
           </p:cNvPr>
@@ -6675,7 +6675,7 @@
           <p:cNvPr id="4" name="">
             <a:extLst xmlns:a="http://schemas.openxmlformats.org/drawingml/2006/main">
               <a:ext uri="{FF2B5EF4-FFF2-40B4-BE49-F238E27FC236}">
-                <a16:creationId xmlns:a16="http://schemas.microsoft.com/office/drawing/2014/main" id="{5DDAF352-9911-4646-AC23-FF569C5698C8}"/>
+                <a16:creationId xmlns:a16="http://schemas.microsoft.com/office/drawing/2014/main" id="{5B6738A1-DF13-4406-8856-8DC774F706F8}"/>
               </a:ext>
             </a:extLst>
           </p:cNvPr>
@@ -6706,7 +6706,7 @@
           <p:cNvPr id="5" name="">
             <a:extLst xmlns:a="http://schemas.openxmlformats.org/drawingml/2006/main">
               <a:ext uri="{FF2B5EF4-FFF2-40B4-BE49-F238E27FC236}">
-                <a16:creationId xmlns:a16="http://schemas.microsoft.com/office/drawing/2014/main" id="{608EA923-37A9-45AF-A91B-378E3FD62EE9}"/>
+                <a16:creationId xmlns:a16="http://schemas.microsoft.com/office/drawing/2014/main" id="{755AF4E4-B1C4-45FF-92E5-F2ED8FFA0B1A}"/>
               </a:ext>
             </a:extLst>
           </p:cNvPr>
@@ -6737,7 +6737,7 @@
           <p:cNvPr id="6" name="">
             <a:extLst xmlns:a="http://schemas.openxmlformats.org/drawingml/2006/main">
               <a:ext uri="{FF2B5EF4-FFF2-40B4-BE49-F238E27FC236}">
-                <a16:creationId xmlns:a16="http://schemas.microsoft.com/office/drawing/2014/main" id="{C5EC51EB-BB8F-4E55-93C1-5AA52B555409}"/>
+                <a16:creationId xmlns:a16="http://schemas.microsoft.com/office/drawing/2014/main" id="{143C1751-C42E-491E-BDAC-B71DBEB36DF3}"/>
               </a:ext>
             </a:extLst>
           </p:cNvPr>
@@ -6799,7 +6799,7 @@
           <p:cNvPr id="7" name="">
             <a:extLst xmlns:a="http://schemas.openxmlformats.org/drawingml/2006/main">
               <a:ext uri="{FF2B5EF4-FFF2-40B4-BE49-F238E27FC236}">
-                <a16:creationId xmlns:a16="http://schemas.microsoft.com/office/drawing/2014/main" id="{52C88982-12EF-4D5C-80D1-3C99ADFF7BA5}"/>
+                <a16:creationId xmlns:a16="http://schemas.microsoft.com/office/drawing/2014/main" id="{27B4053A-E713-4266-B89E-C7EB3BF4614D}"/>
               </a:ext>
             </a:extLst>
           </p:cNvPr>
@@ -6861,7 +6861,7 @@
           <p:cNvPr id="8" name="">
             <a:extLst xmlns:a="http://schemas.openxmlformats.org/drawingml/2006/main">
               <a:ext uri="{FF2B5EF4-FFF2-40B4-BE49-F238E27FC236}">
-                <a16:creationId xmlns:a16="http://schemas.microsoft.com/office/drawing/2014/main" id="{D3D15D18-8122-4FEE-A4D9-E3EF3E012C6F}"/>
+                <a16:creationId xmlns:a16="http://schemas.microsoft.com/office/drawing/2014/main" id="{8E1AC46C-63E4-465E-9254-93AC7E443E79}"/>
               </a:ext>
             </a:extLst>
           </p:cNvPr>
@@ -6923,7 +6923,7 @@
           <p:cNvPr id="9" name="">
             <a:extLst xmlns:a="http://schemas.openxmlformats.org/drawingml/2006/main">
               <a:ext uri="{FF2B5EF4-FFF2-40B4-BE49-F238E27FC236}">
-                <a16:creationId xmlns:a16="http://schemas.microsoft.com/office/drawing/2014/main" id="{62AC64D7-E3BA-4988-99EC-26EE098063C3}"/>
+                <a16:creationId xmlns:a16="http://schemas.microsoft.com/office/drawing/2014/main" id="{B6DB2628-5A05-4153-A49C-622BC81D7F4A}"/>
               </a:ext>
             </a:extLst>
           </p:cNvPr>
@@ -6954,7 +6954,7 @@
           <p:cNvPr id="10" name="">
             <a:extLst xmlns:a="http://schemas.openxmlformats.org/drawingml/2006/main">
               <a:ext uri="{FF2B5EF4-FFF2-40B4-BE49-F238E27FC236}">
-                <a16:creationId xmlns:a16="http://schemas.microsoft.com/office/drawing/2014/main" id="{59EB0917-29BE-4E4F-BE95-C27A8C86AF07}"/>
+                <a16:creationId xmlns:a16="http://schemas.microsoft.com/office/drawing/2014/main" id="{E019CF54-B282-4CC3-84C3-96479970E12F}"/>
               </a:ext>
             </a:extLst>
           </p:cNvPr>
@@ -7016,7 +7016,7 @@
           <p:cNvPr id="11" name="">
             <a:extLst xmlns:a="http://schemas.openxmlformats.org/drawingml/2006/main">
               <a:ext uri="{FF2B5EF4-FFF2-40B4-BE49-F238E27FC236}">
-                <a16:creationId xmlns:a16="http://schemas.microsoft.com/office/drawing/2014/main" id="{50A95850-1400-40E2-B177-ADB9E4231B03}"/>
+                <a16:creationId xmlns:a16="http://schemas.microsoft.com/office/drawing/2014/main" id="{091FE2C8-9EC2-4081-9F3B-B9006CA178B3}"/>
               </a:ext>
             </a:extLst>
           </p:cNvPr>
@@ -7078,7 +7078,7 @@
           <p:cNvPr id="12" name="">
             <a:extLst xmlns:a="http://schemas.openxmlformats.org/drawingml/2006/main">
               <a:ext uri="{FF2B5EF4-FFF2-40B4-BE49-F238E27FC236}">
-                <a16:creationId xmlns:a16="http://schemas.microsoft.com/office/drawing/2014/main" id="{13EBC39C-C212-4953-AABD-31B1555BE762}"/>
+                <a16:creationId xmlns:a16="http://schemas.microsoft.com/office/drawing/2014/main" id="{75419926-8E0B-4BBF-B240-7DED8D01E23C}"/>
               </a:ext>
             </a:extLst>
           </p:cNvPr>
@@ -7140,7 +7140,7 @@
           <p:cNvPr id="13" name="">
             <a:extLst xmlns:a="http://schemas.openxmlformats.org/drawingml/2006/main">
               <a:ext uri="{FF2B5EF4-FFF2-40B4-BE49-F238E27FC236}">
-                <a16:creationId xmlns:a16="http://schemas.microsoft.com/office/drawing/2014/main" id="{58D4A3BF-0FC3-4B89-AF03-1491D5285273}"/>
+                <a16:creationId xmlns:a16="http://schemas.microsoft.com/office/drawing/2014/main" id="{D1C1B1EB-F545-4D1D-8922-89AF3608FD2A}"/>
               </a:ext>
             </a:extLst>
           </p:cNvPr>
@@ -7171,7 +7171,7 @@
           <p:cNvPr id="14" name="">
             <a:extLst xmlns:a="http://schemas.openxmlformats.org/drawingml/2006/main">
               <a:ext uri="{FF2B5EF4-FFF2-40B4-BE49-F238E27FC236}">
-                <a16:creationId xmlns:a16="http://schemas.microsoft.com/office/drawing/2014/main" id="{FC1871FE-2AD2-4F8F-819E-8F9C4DEE7C74}"/>
+                <a16:creationId xmlns:a16="http://schemas.microsoft.com/office/drawing/2014/main" id="{FADDC3CA-C7B2-488A-949B-D5F1FF894BE5}"/>
               </a:ext>
             </a:extLst>
           </p:cNvPr>
@@ -7233,7 +7233,7 @@
           <p:cNvPr id="15" name="">
             <a:extLst xmlns:a="http://schemas.openxmlformats.org/drawingml/2006/main">
               <a:ext uri="{FF2B5EF4-FFF2-40B4-BE49-F238E27FC236}">
-                <a16:creationId xmlns:a16="http://schemas.microsoft.com/office/drawing/2014/main" id="{FF9863B1-8043-472C-BDEF-C084CA4F862A}"/>
+                <a16:creationId xmlns:a16="http://schemas.microsoft.com/office/drawing/2014/main" id="{F32C6AAD-0BBB-4443-8CC2-0A542D8669DB}"/>
               </a:ext>
             </a:extLst>
           </p:cNvPr>
@@ -7295,7 +7295,7 @@
           <p:cNvPr id="16" name="">
             <a:extLst xmlns:a="http://schemas.openxmlformats.org/drawingml/2006/main">
               <a:ext uri="{FF2B5EF4-FFF2-40B4-BE49-F238E27FC236}">
-                <a16:creationId xmlns:a16="http://schemas.microsoft.com/office/drawing/2014/main" id="{C9C34626-5652-4BCB-9E25-6FFDF3385621}"/>
+                <a16:creationId xmlns:a16="http://schemas.microsoft.com/office/drawing/2014/main" id="{1EEC459C-CA55-4596-B57C-22414FFA8216}"/>
               </a:ext>
             </a:extLst>
           </p:cNvPr>
@@ -7357,7 +7357,7 @@
           <p:cNvPr id="17" name="">
             <a:extLst xmlns:a="http://schemas.openxmlformats.org/drawingml/2006/main">
               <a:ext uri="{FF2B5EF4-FFF2-40B4-BE49-F238E27FC236}">
-                <a16:creationId xmlns:a16="http://schemas.microsoft.com/office/drawing/2014/main" id="{D4D1CA06-5428-4019-9AC7-A98A8AEE814C}"/>
+                <a16:creationId xmlns:a16="http://schemas.microsoft.com/office/drawing/2014/main" id="{29FB069A-DCF4-41E9-8892-8AAD34246B02}"/>
               </a:ext>
             </a:extLst>
           </p:cNvPr>
@@ -7388,7 +7388,7 @@
           <p:cNvPr id="18" name="">
             <a:extLst xmlns:a="http://schemas.openxmlformats.org/drawingml/2006/main">
               <a:ext uri="{FF2B5EF4-FFF2-40B4-BE49-F238E27FC236}">
-                <a16:creationId xmlns:a16="http://schemas.microsoft.com/office/drawing/2014/main" id="{342565EF-CF20-4B06-9478-916B566CA08F}"/>
+                <a16:creationId xmlns:a16="http://schemas.microsoft.com/office/drawing/2014/main" id="{4D6874C8-188C-443B-893C-659EEF222C56}"/>
               </a:ext>
             </a:extLst>
           </p:cNvPr>
@@ -7450,7 +7450,7 @@
           <p:cNvPr id="19" name="">
             <a:extLst xmlns:a="http://schemas.openxmlformats.org/drawingml/2006/main">
               <a:ext uri="{FF2B5EF4-FFF2-40B4-BE49-F238E27FC236}">
-                <a16:creationId xmlns:a16="http://schemas.microsoft.com/office/drawing/2014/main" id="{413AEC9A-62B9-45BB-960C-27D2B7A0DD7B}"/>
+                <a16:creationId xmlns:a16="http://schemas.microsoft.com/office/drawing/2014/main" id="{BC164CB1-C9D6-421D-AC9D-2989F9D9443C}"/>
               </a:ext>
             </a:extLst>
           </p:cNvPr>
@@ -7512,7 +7512,7 @@
           <p:cNvPr id="20" name="">
             <a:extLst xmlns:a="http://schemas.openxmlformats.org/drawingml/2006/main">
               <a:ext uri="{FF2B5EF4-FFF2-40B4-BE49-F238E27FC236}">
-                <a16:creationId xmlns:a16="http://schemas.microsoft.com/office/drawing/2014/main" id="{00AD92D6-2601-45BD-889F-0DB7CA02B7E5}"/>
+                <a16:creationId xmlns:a16="http://schemas.microsoft.com/office/drawing/2014/main" id="{12AABCE5-A5D9-4DCA-B340-B34C01812C5E}"/>
               </a:ext>
             </a:extLst>
           </p:cNvPr>
@@ -7574,7 +7574,7 @@
           <p:cNvPr id="21" name="">
             <a:extLst xmlns:a="http://schemas.openxmlformats.org/drawingml/2006/main">
               <a:ext uri="{FF2B5EF4-FFF2-40B4-BE49-F238E27FC236}">
-                <a16:creationId xmlns:a16="http://schemas.microsoft.com/office/drawing/2014/main" id="{0D7DA0E8-4040-4813-9C46-E7C0541E9144}"/>
+                <a16:creationId xmlns:a16="http://schemas.microsoft.com/office/drawing/2014/main" id="{233110BD-50B9-4964-8945-A177395EA302}"/>
               </a:ext>
             </a:extLst>
           </p:cNvPr>
@@ -7636,7 +7636,7 @@
           <p:cNvPr id="22" name="footer-rule-13">
             <a:extLst xmlns:a="http://schemas.openxmlformats.org/drawingml/2006/main">
               <a:ext uri="{FF2B5EF4-FFF2-40B4-BE49-F238E27FC236}">
-                <a16:creationId xmlns:a16="http://schemas.microsoft.com/office/drawing/2014/main" id="{810DEB95-11A5-42D1-A7E7-F044EC464AF9}"/>
+                <a16:creationId xmlns:a16="http://schemas.microsoft.com/office/drawing/2014/main" id="{7654F778-5F91-4905-A9C4-EFCDE1820311}"/>
               </a:ext>
             </a:extLst>
           </p:cNvPr>
@@ -7667,7 +7667,7 @@
           <p:cNvPr id="23" name="footer-label-13">
             <a:extLst xmlns:a="http://schemas.openxmlformats.org/drawingml/2006/main">
               <a:ext uri="{FF2B5EF4-FFF2-40B4-BE49-F238E27FC236}">
-                <a16:creationId xmlns:a16="http://schemas.microsoft.com/office/drawing/2014/main" id="{DE634315-EE2A-49D3-8952-BA6E0B5762DC}"/>
+                <a16:creationId xmlns:a16="http://schemas.microsoft.com/office/drawing/2014/main" id="{AFF4F16D-6AA4-4FF0-9647-C396B01C88D2}"/>
               </a:ext>
             </a:extLst>
           </p:cNvPr>
@@ -7729,7 +7729,7 @@
           <p:cNvPr id="24" name="footer-page-13">
             <a:extLst xmlns:a="http://schemas.openxmlformats.org/drawingml/2006/main">
               <a:ext uri="{FF2B5EF4-FFF2-40B4-BE49-F238E27FC236}">
-                <a16:creationId xmlns:a16="http://schemas.microsoft.com/office/drawing/2014/main" id="{8CC611E7-CAFD-4796-B42B-58F408E6EF85}"/>
+                <a16:creationId xmlns:a16="http://schemas.microsoft.com/office/drawing/2014/main" id="{4E2CF203-C1E1-4EF6-83BB-E27925FC4B03}"/>
               </a:ext>
             </a:extLst>
           </p:cNvPr>
@@ -7789,7 +7789,7 @@
     </p:spTree>
     <p:extLst>
       <p:ext uri="{BB962C8B-B14F-4D97-AF65-F5344CB8AC3E}">
-        <p14:creationId xmlns:p14="http://schemas.microsoft.com/office/powerpoint/2010/main" val="732991347"/>
+        <p14:creationId xmlns:p14="http://schemas.microsoft.com/office/powerpoint/2010/main" val="171972524"/>
       </p:ext>
     </p:extLst>
   </p:cSld>
@@ -7820,7 +7820,7 @@
           <p:cNvPr id="24" name="side-accent-14">
             <a:extLst xmlns:a="http://schemas.openxmlformats.org/drawingml/2006/main">
               <a:ext uri="{FF2B5EF4-FFF2-40B4-BE49-F238E27FC236}">
-                <a16:creationId xmlns:a16="http://schemas.microsoft.com/office/drawing/2014/main" id="{8EC9D9AA-F17B-4398-9CE5-221BCFC257E9}"/>
+                <a16:creationId xmlns:a16="http://schemas.microsoft.com/office/drawing/2014/main" id="{C22C029D-202B-4322-90EF-1D65B0CB4532}"/>
               </a:ext>
             </a:extLst>
           </p:cNvPr>
@@ -7851,7 +7851,7 @@
           <p:cNvPr id="2" name="kicker-14">
             <a:extLst xmlns:a="http://schemas.openxmlformats.org/drawingml/2006/main">
               <a:ext uri="{FF2B5EF4-FFF2-40B4-BE49-F238E27FC236}">
-                <a16:creationId xmlns:a16="http://schemas.microsoft.com/office/drawing/2014/main" id="{CDE58F1B-1C7A-4010-A264-C52BB7E9749C}"/>
+                <a16:creationId xmlns:a16="http://schemas.microsoft.com/office/drawing/2014/main" id="{1DAAA7A6-D85B-4F09-849F-7A42214A0AF8}"/>
               </a:ext>
             </a:extLst>
           </p:cNvPr>
@@ -7913,7 +7913,7 @@
           <p:cNvPr id="3" name="title-14">
             <a:extLst xmlns:a="http://schemas.openxmlformats.org/drawingml/2006/main">
               <a:ext uri="{FF2B5EF4-FFF2-40B4-BE49-F238E27FC236}">
-                <a16:creationId xmlns:a16="http://schemas.microsoft.com/office/drawing/2014/main" id="{674F1C1D-13C2-423E-BA9C-0467F3EF9060}"/>
+                <a16:creationId xmlns:a16="http://schemas.microsoft.com/office/drawing/2014/main" id="{78BF02B6-FC47-4002-A61F-D3F80992BE48}"/>
               </a:ext>
             </a:extLst>
           </p:cNvPr>
@@ -7975,7 +7975,7 @@
           <p:cNvPr id="4" name="">
             <a:extLst xmlns:a="http://schemas.openxmlformats.org/drawingml/2006/main">
               <a:ext uri="{FF2B5EF4-FFF2-40B4-BE49-F238E27FC236}">
-                <a16:creationId xmlns:a16="http://schemas.microsoft.com/office/drawing/2014/main" id="{C97BA457-441D-4828-9A2A-D6FC28C36766}"/>
+                <a16:creationId xmlns:a16="http://schemas.microsoft.com/office/drawing/2014/main" id="{0CDD444C-A28D-4E62-82E2-856EA34BA4EC}"/>
               </a:ext>
             </a:extLst>
           </p:cNvPr>
@@ -8037,7 +8037,7 @@
           <p:cNvPr id="5" name="">
             <a:extLst xmlns:a="http://schemas.openxmlformats.org/drawingml/2006/main">
               <a:ext uri="{FF2B5EF4-FFF2-40B4-BE49-F238E27FC236}">
-                <a16:creationId xmlns:a16="http://schemas.microsoft.com/office/drawing/2014/main" id="{F02FE065-4827-46C5-A3FB-9CCB6C5A9A12}"/>
+                <a16:creationId xmlns:a16="http://schemas.microsoft.com/office/drawing/2014/main" id="{FFB9A896-EAFC-4CCF-9897-065C3B6739C5}"/>
               </a:ext>
             </a:extLst>
           </p:cNvPr>
@@ -8099,7 +8099,7 @@
           <p:cNvPr id="6" name="">
             <a:extLst xmlns:a="http://schemas.openxmlformats.org/drawingml/2006/main">
               <a:ext uri="{FF2B5EF4-FFF2-40B4-BE49-F238E27FC236}">
-                <a16:creationId xmlns:a16="http://schemas.microsoft.com/office/drawing/2014/main" id="{7CCBD25F-2CC0-47D3-9FE8-DEBB315889B2}"/>
+                <a16:creationId xmlns:a16="http://schemas.microsoft.com/office/drawing/2014/main" id="{FB286CF7-C001-40CD-BAA1-11A47FA76DAA}"/>
               </a:ext>
             </a:extLst>
           </p:cNvPr>
@@ -8161,7 +8161,7 @@
           <p:cNvPr id="7" name="">
             <a:extLst xmlns:a="http://schemas.openxmlformats.org/drawingml/2006/main">
               <a:ext uri="{FF2B5EF4-FFF2-40B4-BE49-F238E27FC236}">
-                <a16:creationId xmlns:a16="http://schemas.microsoft.com/office/drawing/2014/main" id="{A2E1F41E-276F-4655-B83D-72566D70CA1D}"/>
+                <a16:creationId xmlns:a16="http://schemas.microsoft.com/office/drawing/2014/main" id="{499C9C15-7E70-4F59-8BF7-C7862F7134D4}"/>
               </a:ext>
             </a:extLst>
           </p:cNvPr>
@@ -8192,7 +8192,7 @@
           <p:cNvPr id="8" name="">
             <a:extLst xmlns:a="http://schemas.openxmlformats.org/drawingml/2006/main">
               <a:ext uri="{FF2B5EF4-FFF2-40B4-BE49-F238E27FC236}">
-                <a16:creationId xmlns:a16="http://schemas.microsoft.com/office/drawing/2014/main" id="{12806E1A-5028-490E-8080-A69DB18B831B}"/>
+                <a16:creationId xmlns:a16="http://schemas.microsoft.com/office/drawing/2014/main" id="{06177B58-4D19-4DBF-9133-4D969B3DB4AE}"/>
               </a:ext>
             </a:extLst>
           </p:cNvPr>
@@ -8254,7 +8254,7 @@
           <p:cNvPr id="9" name="">
             <a:extLst xmlns:a="http://schemas.openxmlformats.org/drawingml/2006/main">
               <a:ext uri="{FF2B5EF4-FFF2-40B4-BE49-F238E27FC236}">
-                <a16:creationId xmlns:a16="http://schemas.microsoft.com/office/drawing/2014/main" id="{995D8C2D-F43A-4E91-95AC-8A3A28242AD7}"/>
+                <a16:creationId xmlns:a16="http://schemas.microsoft.com/office/drawing/2014/main" id="{204BA3FE-DFC7-48B8-8D41-1FB85D9C6741}"/>
               </a:ext>
             </a:extLst>
           </p:cNvPr>
@@ -8316,7 +8316,7 @@
           <p:cNvPr id="10" name="">
             <a:extLst xmlns:a="http://schemas.openxmlformats.org/drawingml/2006/main">
               <a:ext uri="{FF2B5EF4-FFF2-40B4-BE49-F238E27FC236}">
-                <a16:creationId xmlns:a16="http://schemas.microsoft.com/office/drawing/2014/main" id="{D1F1EAD1-A2C9-442A-A0F0-07832019657F}"/>
+                <a16:creationId xmlns:a16="http://schemas.microsoft.com/office/drawing/2014/main" id="{23CA5975-D4D6-4406-A097-C78E59CEE96B}"/>
               </a:ext>
             </a:extLst>
           </p:cNvPr>
@@ -8378,7 +8378,7 @@
           <p:cNvPr id="11" name="">
             <a:extLst xmlns:a="http://schemas.openxmlformats.org/drawingml/2006/main">
               <a:ext uri="{FF2B5EF4-FFF2-40B4-BE49-F238E27FC236}">
-                <a16:creationId xmlns:a16="http://schemas.microsoft.com/office/drawing/2014/main" id="{79D664F3-9963-4219-B157-EB8FE0F587A1}"/>
+                <a16:creationId xmlns:a16="http://schemas.microsoft.com/office/drawing/2014/main" id="{3D5ED00E-5734-4730-8349-8017A7BE5B2D}"/>
               </a:ext>
             </a:extLst>
           </p:cNvPr>
@@ -8409,7 +8409,7 @@
           <p:cNvPr id="12" name="">
             <a:extLst xmlns:a="http://schemas.openxmlformats.org/drawingml/2006/main">
               <a:ext uri="{FF2B5EF4-FFF2-40B4-BE49-F238E27FC236}">
-                <a16:creationId xmlns:a16="http://schemas.microsoft.com/office/drawing/2014/main" id="{DC663217-89D0-4CBC-89DF-AE1A32F29A93}"/>
+                <a16:creationId xmlns:a16="http://schemas.microsoft.com/office/drawing/2014/main" id="{26C81B1E-7F89-452C-8ACC-B661D97F9669}"/>
               </a:ext>
             </a:extLst>
           </p:cNvPr>
@@ -8471,7 +8471,7 @@
           <p:cNvPr id="13" name="">
             <a:extLst xmlns:a="http://schemas.openxmlformats.org/drawingml/2006/main">
               <a:ext uri="{FF2B5EF4-FFF2-40B4-BE49-F238E27FC236}">
-                <a16:creationId xmlns:a16="http://schemas.microsoft.com/office/drawing/2014/main" id="{B2873E3F-5F08-4BB8-ACBF-C50C252E995E}"/>
+                <a16:creationId xmlns:a16="http://schemas.microsoft.com/office/drawing/2014/main" id="{A0B2DF03-EFC7-4D4D-A9FD-E143F6273FB6}"/>
               </a:ext>
             </a:extLst>
           </p:cNvPr>
@@ -8533,7 +8533,7 @@
           <p:cNvPr id="14" name="">
             <a:extLst xmlns:a="http://schemas.openxmlformats.org/drawingml/2006/main">
               <a:ext uri="{FF2B5EF4-FFF2-40B4-BE49-F238E27FC236}">
-                <a16:creationId xmlns:a16="http://schemas.microsoft.com/office/drawing/2014/main" id="{D282DAEF-B3A8-4BB6-8E66-146E9A112D0B}"/>
+                <a16:creationId xmlns:a16="http://schemas.microsoft.com/office/drawing/2014/main" id="{C27F87C4-E033-4135-8F33-4818A342CCC2}"/>
               </a:ext>
             </a:extLst>
           </p:cNvPr>
@@ -8595,7 +8595,7 @@
           <p:cNvPr id="15" name="">
             <a:extLst xmlns:a="http://schemas.openxmlformats.org/drawingml/2006/main">
               <a:ext uri="{FF2B5EF4-FFF2-40B4-BE49-F238E27FC236}">
-                <a16:creationId xmlns:a16="http://schemas.microsoft.com/office/drawing/2014/main" id="{E63DEB49-259F-4EB3-A90C-564635B88E35}"/>
+                <a16:creationId xmlns:a16="http://schemas.microsoft.com/office/drawing/2014/main" id="{FD7FF364-8197-4DE4-88D4-15F7B1BD0E22}"/>
               </a:ext>
             </a:extLst>
           </p:cNvPr>
@@ -8626,7 +8626,7 @@
           <p:cNvPr id="16" name="">
             <a:extLst xmlns:a="http://schemas.openxmlformats.org/drawingml/2006/main">
               <a:ext uri="{FF2B5EF4-FFF2-40B4-BE49-F238E27FC236}">
-                <a16:creationId xmlns:a16="http://schemas.microsoft.com/office/drawing/2014/main" id="{8E496DF3-40C1-4E6D-BC3B-ADBB2A5EB887}"/>
+                <a16:creationId xmlns:a16="http://schemas.microsoft.com/office/drawing/2014/main" id="{523615D1-632E-4C98-84BB-D8D8929DC324}"/>
               </a:ext>
             </a:extLst>
           </p:cNvPr>
@@ -8688,7 +8688,7 @@
           <p:cNvPr id="17" name="">
             <a:extLst xmlns:a="http://schemas.openxmlformats.org/drawingml/2006/main">
               <a:ext uri="{FF2B5EF4-FFF2-40B4-BE49-F238E27FC236}">
-                <a16:creationId xmlns:a16="http://schemas.microsoft.com/office/drawing/2014/main" id="{DDD656AE-F42D-4F5C-BBBF-3063324C091A}"/>
+                <a16:creationId xmlns:a16="http://schemas.microsoft.com/office/drawing/2014/main" id="{8DBFBA10-73DD-40F9-942E-747F31C3AC26}"/>
               </a:ext>
             </a:extLst>
           </p:cNvPr>
@@ -8750,7 +8750,7 @@
           <p:cNvPr id="18" name="">
             <a:extLst xmlns:a="http://schemas.openxmlformats.org/drawingml/2006/main">
               <a:ext uri="{FF2B5EF4-FFF2-40B4-BE49-F238E27FC236}">
-                <a16:creationId xmlns:a16="http://schemas.microsoft.com/office/drawing/2014/main" id="{EAC433BA-A542-4F5C-BCF3-63C2AF7BDCAC}"/>
+                <a16:creationId xmlns:a16="http://schemas.microsoft.com/office/drawing/2014/main" id="{8A201ED7-66DE-4D01-8D97-FF68C44F2D13}"/>
               </a:ext>
             </a:extLst>
           </p:cNvPr>
@@ -8812,7 +8812,7 @@
           <p:cNvPr id="19" name="">
             <a:extLst xmlns:a="http://schemas.openxmlformats.org/drawingml/2006/main">
               <a:ext uri="{FF2B5EF4-FFF2-40B4-BE49-F238E27FC236}">
-                <a16:creationId xmlns:a16="http://schemas.microsoft.com/office/drawing/2014/main" id="{AAF5C1B2-9261-4053-94CE-34F0D6C52D60}"/>
+                <a16:creationId xmlns:a16="http://schemas.microsoft.com/office/drawing/2014/main" id="{F381F582-2ADC-4B9B-9B95-A831BA3E22B3}"/>
               </a:ext>
             </a:extLst>
           </p:cNvPr>
@@ -8845,7 +8845,7 @@
           <p:cNvPr id="20" name="">
             <a:extLst xmlns:a="http://schemas.openxmlformats.org/drawingml/2006/main">
               <a:ext uri="{FF2B5EF4-FFF2-40B4-BE49-F238E27FC236}">
-                <a16:creationId xmlns:a16="http://schemas.microsoft.com/office/drawing/2014/main" id="{C178CCA4-9DD7-4314-B8D5-8BBF8FD40BA1}"/>
+                <a16:creationId xmlns:a16="http://schemas.microsoft.com/office/drawing/2014/main" id="{FAF84720-374E-4737-82E1-B1A39F7DB54D}"/>
               </a:ext>
             </a:extLst>
           </p:cNvPr>
@@ -8907,7 +8907,7 @@
           <p:cNvPr id="21" name="footer-rule-14">
             <a:extLst xmlns:a="http://schemas.openxmlformats.org/drawingml/2006/main">
               <a:ext uri="{FF2B5EF4-FFF2-40B4-BE49-F238E27FC236}">
-                <a16:creationId xmlns:a16="http://schemas.microsoft.com/office/drawing/2014/main" id="{AE1066EB-1B4A-4BDC-B627-E9152365CEA0}"/>
+                <a16:creationId xmlns:a16="http://schemas.microsoft.com/office/drawing/2014/main" id="{8E3A983B-1174-44CB-9914-3AA8909B0C1B}"/>
               </a:ext>
             </a:extLst>
           </p:cNvPr>
@@ -8938,7 +8938,7 @@
           <p:cNvPr id="22" name="footer-label-14">
             <a:extLst xmlns:a="http://schemas.openxmlformats.org/drawingml/2006/main">
               <a:ext uri="{FF2B5EF4-FFF2-40B4-BE49-F238E27FC236}">
-                <a16:creationId xmlns:a16="http://schemas.microsoft.com/office/drawing/2014/main" id="{05FD0C01-1E9D-4EA1-AFBB-9EDB873E884B}"/>
+                <a16:creationId xmlns:a16="http://schemas.microsoft.com/office/drawing/2014/main" id="{A9CC7EA9-F6B1-4707-89D7-0BCCA57693D9}"/>
               </a:ext>
             </a:extLst>
           </p:cNvPr>
@@ -9000,7 +9000,7 @@
           <p:cNvPr id="23" name="footer-page-14">
             <a:extLst xmlns:a="http://schemas.openxmlformats.org/drawingml/2006/main">
               <a:ext uri="{FF2B5EF4-FFF2-40B4-BE49-F238E27FC236}">
-                <a16:creationId xmlns:a16="http://schemas.microsoft.com/office/drawing/2014/main" id="{12AB1DA2-BD9A-4251-A6CB-C5D5FD627C1A}"/>
+                <a16:creationId xmlns:a16="http://schemas.microsoft.com/office/drawing/2014/main" id="{795800E4-D67C-4033-BD81-231DE674AF00}"/>
               </a:ext>
             </a:extLst>
           </p:cNvPr>
@@ -9060,7 +9060,7 @@
     </p:spTree>
     <p:extLst>
       <p:ext uri="{BB962C8B-B14F-4D97-AF65-F5344CB8AC3E}">
-        <p14:creationId xmlns:p14="http://schemas.microsoft.com/office/powerpoint/2010/main" val="346054975"/>
+        <p14:creationId xmlns:p14="http://schemas.microsoft.com/office/powerpoint/2010/main" val="1586498836"/>
       </p:ext>
     </p:extLst>
   </p:cSld>
@@ -9091,7 +9091,7 @@
           <p:cNvPr id="21" name="side-accent-15">
             <a:extLst xmlns:a="http://schemas.openxmlformats.org/drawingml/2006/main">
               <a:ext uri="{FF2B5EF4-FFF2-40B4-BE49-F238E27FC236}">
-                <a16:creationId xmlns:a16="http://schemas.microsoft.com/office/drawing/2014/main" id="{65DE5D91-1B85-4822-9147-62327A9D6A00}"/>
+                <a16:creationId xmlns:a16="http://schemas.microsoft.com/office/drawing/2014/main" id="{A9EE4E31-4371-4923-A455-6ED759157692}"/>
               </a:ext>
             </a:extLst>
           </p:cNvPr>
@@ -9122,7 +9122,7 @@
           <p:cNvPr id="2" name="kicker-15">
             <a:extLst xmlns:a="http://schemas.openxmlformats.org/drawingml/2006/main">
               <a:ext uri="{FF2B5EF4-FFF2-40B4-BE49-F238E27FC236}">
-                <a16:creationId xmlns:a16="http://schemas.microsoft.com/office/drawing/2014/main" id="{F861F1D8-6458-42E1-AC56-734EF3A7CE00}"/>
+                <a16:creationId xmlns:a16="http://schemas.microsoft.com/office/drawing/2014/main" id="{995A366E-DF99-43BE-BD3A-04CB3120AA9E}"/>
               </a:ext>
             </a:extLst>
           </p:cNvPr>
@@ -9184,7 +9184,7 @@
           <p:cNvPr id="3" name="title-15">
             <a:extLst xmlns:a="http://schemas.openxmlformats.org/drawingml/2006/main">
               <a:ext uri="{FF2B5EF4-FFF2-40B4-BE49-F238E27FC236}">
-                <a16:creationId xmlns:a16="http://schemas.microsoft.com/office/drawing/2014/main" id="{9A258906-983B-4D85-8C15-C71384C6CC15}"/>
+                <a16:creationId xmlns:a16="http://schemas.microsoft.com/office/drawing/2014/main" id="{124915BC-C6F3-4185-8F8F-D81C922F11D0}"/>
               </a:ext>
             </a:extLst>
           </p:cNvPr>
@@ -9246,7 +9246,7 @@
           <p:cNvPr id="4" name="">
             <a:extLst xmlns:a="http://schemas.openxmlformats.org/drawingml/2006/main">
               <a:ext uri="{FF2B5EF4-FFF2-40B4-BE49-F238E27FC236}">
-                <a16:creationId xmlns:a16="http://schemas.microsoft.com/office/drawing/2014/main" id="{9D78E473-3B3B-4E8C-97A9-D48CC64554B3}"/>
+                <a16:creationId xmlns:a16="http://schemas.microsoft.com/office/drawing/2014/main" id="{2450BCE8-C65E-434A-9EAE-12A3CA074F66}"/>
               </a:ext>
             </a:extLst>
           </p:cNvPr>
@@ -9277,7 +9277,7 @@
           <p:cNvPr id="5" name="">
             <a:extLst xmlns:a="http://schemas.openxmlformats.org/drawingml/2006/main">
               <a:ext uri="{FF2B5EF4-FFF2-40B4-BE49-F238E27FC236}">
-                <a16:creationId xmlns:a16="http://schemas.microsoft.com/office/drawing/2014/main" id="{1F9AC738-43EC-4F8A-AC61-5299E82B01F0}"/>
+                <a16:creationId xmlns:a16="http://schemas.microsoft.com/office/drawing/2014/main" id="{CA9C6F5E-E4A7-42ED-80EB-5428B921C2CD}"/>
               </a:ext>
             </a:extLst>
           </p:cNvPr>
@@ -9308,7 +9308,7 @@
           <p:cNvPr id="6" name="">
             <a:extLst xmlns:a="http://schemas.openxmlformats.org/drawingml/2006/main">
               <a:ext uri="{FF2B5EF4-FFF2-40B4-BE49-F238E27FC236}">
-                <a16:creationId xmlns:a16="http://schemas.microsoft.com/office/drawing/2014/main" id="{941FDAAF-8CE5-490A-ACE9-4C39A47B11B9}"/>
+                <a16:creationId xmlns:a16="http://schemas.microsoft.com/office/drawing/2014/main" id="{09C4E36B-B848-479E-A80D-2CA811583ACF}"/>
               </a:ext>
             </a:extLst>
           </p:cNvPr>
@@ -9370,7 +9370,7 @@
           <p:cNvPr id="7" name="">
             <a:extLst xmlns:a="http://schemas.openxmlformats.org/drawingml/2006/main">
               <a:ext uri="{FF2B5EF4-FFF2-40B4-BE49-F238E27FC236}">
-                <a16:creationId xmlns:a16="http://schemas.microsoft.com/office/drawing/2014/main" id="{FA9C59B0-4986-486F-B396-DBB0EE2B6D27}"/>
+                <a16:creationId xmlns:a16="http://schemas.microsoft.com/office/drawing/2014/main" id="{51828252-1DC6-40AD-942A-9D7041E28883}"/>
               </a:ext>
             </a:extLst>
           </p:cNvPr>
@@ -9432,7 +9432,7 @@
           <p:cNvPr id="8" name="">
             <a:extLst xmlns:a="http://schemas.openxmlformats.org/drawingml/2006/main">
               <a:ext uri="{FF2B5EF4-FFF2-40B4-BE49-F238E27FC236}">
-                <a16:creationId xmlns:a16="http://schemas.microsoft.com/office/drawing/2014/main" id="{B10391D4-4116-4E87-870A-6A4792AF5488}"/>
+                <a16:creationId xmlns:a16="http://schemas.microsoft.com/office/drawing/2014/main" id="{46B63D3B-F712-416B-9ED6-626A8585BED3}"/>
               </a:ext>
             </a:extLst>
           </p:cNvPr>
@@ -9494,7 +9494,7 @@
           <p:cNvPr id="9" name="">
             <a:extLst xmlns:a="http://schemas.openxmlformats.org/drawingml/2006/main">
               <a:ext uri="{FF2B5EF4-FFF2-40B4-BE49-F238E27FC236}">
-                <a16:creationId xmlns:a16="http://schemas.microsoft.com/office/drawing/2014/main" id="{461CD313-C80E-4A48-8218-E90DCF14E553}"/>
+                <a16:creationId xmlns:a16="http://schemas.microsoft.com/office/drawing/2014/main" id="{4128B4E2-3222-4050-B2FB-5BF584C91FE8}"/>
               </a:ext>
             </a:extLst>
           </p:cNvPr>
@@ -9525,7 +9525,7 @@
           <p:cNvPr id="10" name="">
             <a:extLst xmlns:a="http://schemas.openxmlformats.org/drawingml/2006/main">
               <a:ext uri="{FF2B5EF4-FFF2-40B4-BE49-F238E27FC236}">
-                <a16:creationId xmlns:a16="http://schemas.microsoft.com/office/drawing/2014/main" id="{DAC42356-F852-4095-AFCB-243C52ECB345}"/>
+                <a16:creationId xmlns:a16="http://schemas.microsoft.com/office/drawing/2014/main" id="{4BF7A277-2292-466C-AF74-09BDD9930A39}"/>
               </a:ext>
             </a:extLst>
           </p:cNvPr>
@@ -9587,7 +9587,7 @@
           <p:cNvPr id="11" name="">
             <a:extLst xmlns:a="http://schemas.openxmlformats.org/drawingml/2006/main">
               <a:ext uri="{FF2B5EF4-FFF2-40B4-BE49-F238E27FC236}">
-                <a16:creationId xmlns:a16="http://schemas.microsoft.com/office/drawing/2014/main" id="{391D01D0-8B6C-4DA4-9895-BFC4D3D66D28}"/>
+                <a16:creationId xmlns:a16="http://schemas.microsoft.com/office/drawing/2014/main" id="{7EC184A0-E234-4373-AEDA-0164B1D48A19}"/>
               </a:ext>
             </a:extLst>
           </p:cNvPr>
@@ -9649,7 +9649,7 @@
           <p:cNvPr id="12" name="">
             <a:extLst xmlns:a="http://schemas.openxmlformats.org/drawingml/2006/main">
               <a:ext uri="{FF2B5EF4-FFF2-40B4-BE49-F238E27FC236}">
-                <a16:creationId xmlns:a16="http://schemas.microsoft.com/office/drawing/2014/main" id="{6C46357F-F1FE-42F4-AFB1-FEBD061FA35E}"/>
+                <a16:creationId xmlns:a16="http://schemas.microsoft.com/office/drawing/2014/main" id="{5D71068A-6F6A-442F-9D31-36591BD6BED5}"/>
               </a:ext>
             </a:extLst>
           </p:cNvPr>
@@ -9711,7 +9711,7 @@
           <p:cNvPr id="13" name="">
             <a:extLst xmlns:a="http://schemas.openxmlformats.org/drawingml/2006/main">
               <a:ext uri="{FF2B5EF4-FFF2-40B4-BE49-F238E27FC236}">
-                <a16:creationId xmlns:a16="http://schemas.microsoft.com/office/drawing/2014/main" id="{280193F9-5027-47A8-85C4-9DB55232F037}"/>
+                <a16:creationId xmlns:a16="http://schemas.microsoft.com/office/drawing/2014/main" id="{3A711F04-2E57-4745-AFF1-B58519E53C40}"/>
               </a:ext>
             </a:extLst>
           </p:cNvPr>
@@ -9742,7 +9742,7 @@
           <p:cNvPr id="14" name="">
             <a:extLst xmlns:a="http://schemas.openxmlformats.org/drawingml/2006/main">
               <a:ext uri="{FF2B5EF4-FFF2-40B4-BE49-F238E27FC236}">
-                <a16:creationId xmlns:a16="http://schemas.microsoft.com/office/drawing/2014/main" id="{84A1A169-D3E9-4506-B7DF-3D26B9914215}"/>
+                <a16:creationId xmlns:a16="http://schemas.microsoft.com/office/drawing/2014/main" id="{3F411CB8-9569-418D-8955-EFE6719B3A19}"/>
               </a:ext>
             </a:extLst>
           </p:cNvPr>
@@ -9804,7 +9804,7 @@
           <p:cNvPr id="15" name="">
             <a:extLst xmlns:a="http://schemas.openxmlformats.org/drawingml/2006/main">
               <a:ext uri="{FF2B5EF4-FFF2-40B4-BE49-F238E27FC236}">
-                <a16:creationId xmlns:a16="http://schemas.microsoft.com/office/drawing/2014/main" id="{A152CF58-1F96-4A4D-97BC-4AB2BC06ABA2}"/>
+                <a16:creationId xmlns:a16="http://schemas.microsoft.com/office/drawing/2014/main" id="{577D26F0-B28F-4010-8213-66D0315996C1}"/>
               </a:ext>
             </a:extLst>
           </p:cNvPr>
@@ -9866,7 +9866,7 @@
           <p:cNvPr id="16" name="">
             <a:extLst xmlns:a="http://schemas.openxmlformats.org/drawingml/2006/main">
               <a:ext uri="{FF2B5EF4-FFF2-40B4-BE49-F238E27FC236}">
-                <a16:creationId xmlns:a16="http://schemas.microsoft.com/office/drawing/2014/main" id="{D71A292C-99D0-4E03-8CEA-8A9557203CC8}"/>
+                <a16:creationId xmlns:a16="http://schemas.microsoft.com/office/drawing/2014/main" id="{6A735BA9-B585-46F8-B3A0-CAAE110D821E}"/>
               </a:ext>
             </a:extLst>
           </p:cNvPr>
@@ -9928,7 +9928,7 @@
           <p:cNvPr id="17" name="">
             <a:extLst xmlns:a="http://schemas.openxmlformats.org/drawingml/2006/main">
               <a:ext uri="{FF2B5EF4-FFF2-40B4-BE49-F238E27FC236}">
-                <a16:creationId xmlns:a16="http://schemas.microsoft.com/office/drawing/2014/main" id="{0BB98FBC-3BD6-4ACD-ACC7-8D8ADB917878}"/>
+                <a16:creationId xmlns:a16="http://schemas.microsoft.com/office/drawing/2014/main" id="{A5AB007D-9B65-458C-885C-14FEFFBA372E}"/>
               </a:ext>
             </a:extLst>
           </p:cNvPr>
@@ -9990,7 +9990,7 @@
           <p:cNvPr id="18" name="footer-rule-15">
             <a:extLst xmlns:a="http://schemas.openxmlformats.org/drawingml/2006/main">
               <a:ext uri="{FF2B5EF4-FFF2-40B4-BE49-F238E27FC236}">
-                <a16:creationId xmlns:a16="http://schemas.microsoft.com/office/drawing/2014/main" id="{13DA2112-B57A-4AE3-B0A7-1BA91D933210}"/>
+                <a16:creationId xmlns:a16="http://schemas.microsoft.com/office/drawing/2014/main" id="{1B7E3F8E-90A2-487E-833B-B8452F77F08A}"/>
               </a:ext>
             </a:extLst>
           </p:cNvPr>
@@ -10021,7 +10021,7 @@
           <p:cNvPr id="19" name="footer-label-15">
             <a:extLst xmlns:a="http://schemas.openxmlformats.org/drawingml/2006/main">
               <a:ext uri="{FF2B5EF4-FFF2-40B4-BE49-F238E27FC236}">
-                <a16:creationId xmlns:a16="http://schemas.microsoft.com/office/drawing/2014/main" id="{83621ED0-A6FC-42CB-BD80-E8E83483A1F7}"/>
+                <a16:creationId xmlns:a16="http://schemas.microsoft.com/office/drawing/2014/main" id="{B9919573-5B62-4D27-9248-5B03D3C46417}"/>
               </a:ext>
             </a:extLst>
           </p:cNvPr>
@@ -10083,7 +10083,7 @@
           <p:cNvPr id="20" name="footer-page-15">
             <a:extLst xmlns:a="http://schemas.openxmlformats.org/drawingml/2006/main">
               <a:ext uri="{FF2B5EF4-FFF2-40B4-BE49-F238E27FC236}">
-                <a16:creationId xmlns:a16="http://schemas.microsoft.com/office/drawing/2014/main" id="{ED87F764-E28E-4ABD-9B65-E832E77922BB}"/>
+                <a16:creationId xmlns:a16="http://schemas.microsoft.com/office/drawing/2014/main" id="{ECCBF928-6349-4FDD-ABCB-27BE4EC2CE27}"/>
               </a:ext>
             </a:extLst>
           </p:cNvPr>
@@ -10143,7 +10143,7 @@
     </p:spTree>
     <p:extLst>
       <p:ext uri="{BB962C8B-B14F-4D97-AF65-F5344CB8AC3E}">
-        <p14:creationId xmlns:p14="http://schemas.microsoft.com/office/powerpoint/2010/main" val="810133022"/>
+        <p14:creationId xmlns:p14="http://schemas.microsoft.com/office/powerpoint/2010/main" val="1682079328"/>
       </p:ext>
     </p:extLst>
   </p:cSld>
@@ -10174,7 +10174,7 @@
           <p:cNvPr id="11" name="">
             <a:extLst xmlns:a="http://schemas.openxmlformats.org/drawingml/2006/main">
               <a:ext uri="{FF2B5EF4-FFF2-40B4-BE49-F238E27FC236}">
-                <a16:creationId xmlns:a16="http://schemas.microsoft.com/office/drawing/2014/main" id="{2FEBB63A-29FA-48B5-B234-10506DDDE829}"/>
+                <a16:creationId xmlns:a16="http://schemas.microsoft.com/office/drawing/2014/main" id="{B924713A-73AD-43E7-9CF0-8C5EA14194A5}"/>
               </a:ext>
             </a:extLst>
           </p:cNvPr>
@@ -10205,7 +10205,7 @@
           <p:cNvPr id="2" name="">
             <a:extLst xmlns:a="http://schemas.openxmlformats.org/drawingml/2006/main">
               <a:ext uri="{FF2B5EF4-FFF2-40B4-BE49-F238E27FC236}">
-                <a16:creationId xmlns:a16="http://schemas.microsoft.com/office/drawing/2014/main" id="{CF4D2B35-73A7-4B80-A687-BE290E2BC020}"/>
+                <a16:creationId xmlns:a16="http://schemas.microsoft.com/office/drawing/2014/main" id="{0F169712-D21E-4DB7-8165-698CFC8D2B25}"/>
               </a:ext>
             </a:extLst>
           </p:cNvPr>
@@ -10267,7 +10267,7 @@
           <p:cNvPr id="3" name="">
             <a:extLst xmlns:a="http://schemas.openxmlformats.org/drawingml/2006/main">
               <a:ext uri="{FF2B5EF4-FFF2-40B4-BE49-F238E27FC236}">
-                <a16:creationId xmlns:a16="http://schemas.microsoft.com/office/drawing/2014/main" id="{B14BF846-7184-4534-84C0-9E16E39FC621}"/>
+                <a16:creationId xmlns:a16="http://schemas.microsoft.com/office/drawing/2014/main" id="{4C448397-9942-4A33-8116-EE67F714ACA3}"/>
               </a:ext>
             </a:extLst>
           </p:cNvPr>
@@ -10356,7 +10356,7 @@
           <p:cNvPr id="4" name="">
             <a:extLst xmlns:a="http://schemas.openxmlformats.org/drawingml/2006/main">
               <a:ext uri="{FF2B5EF4-FFF2-40B4-BE49-F238E27FC236}">
-                <a16:creationId xmlns:a16="http://schemas.microsoft.com/office/drawing/2014/main" id="{150AAF56-6778-490E-AF87-E85D9AD78428}"/>
+                <a16:creationId xmlns:a16="http://schemas.microsoft.com/office/drawing/2014/main" id="{A82D380F-7EE3-41DE-8308-8002242E7771}"/>
               </a:ext>
             </a:extLst>
           </p:cNvPr>
@@ -10418,7 +10418,7 @@
           <p:cNvPr id="5" name="">
             <a:extLst xmlns:a="http://schemas.openxmlformats.org/drawingml/2006/main">
               <a:ext uri="{FF2B5EF4-FFF2-40B4-BE49-F238E27FC236}">
-                <a16:creationId xmlns:a16="http://schemas.microsoft.com/office/drawing/2014/main" id="{9F77C05A-A466-4E5E-94E9-B8C11981EE9A}"/>
+                <a16:creationId xmlns:a16="http://schemas.microsoft.com/office/drawing/2014/main" id="{381D8815-F476-4416-8DDC-26E0619B3347}"/>
               </a:ext>
             </a:extLst>
           </p:cNvPr>
@@ -10451,7 +10451,7 @@
           <p:cNvPr id="6" name="">
             <a:extLst xmlns:a="http://schemas.openxmlformats.org/drawingml/2006/main">
               <a:ext uri="{FF2B5EF4-FFF2-40B4-BE49-F238E27FC236}">
-                <a16:creationId xmlns:a16="http://schemas.microsoft.com/office/drawing/2014/main" id="{61252D34-F6E0-49AB-B1A6-FFF5F51BCBCE}"/>
+                <a16:creationId xmlns:a16="http://schemas.microsoft.com/office/drawing/2014/main" id="{25FD56AB-E600-4489-9EED-BB70481D9C0E}"/>
               </a:ext>
             </a:extLst>
           </p:cNvPr>
@@ -10513,7 +10513,7 @@
           <p:cNvPr id="7" name="">
             <a:extLst xmlns:a="http://schemas.openxmlformats.org/drawingml/2006/main">
               <a:ext uri="{FF2B5EF4-FFF2-40B4-BE49-F238E27FC236}">
-                <a16:creationId xmlns:a16="http://schemas.microsoft.com/office/drawing/2014/main" id="{23FE2508-0555-44FC-B2D6-4465EDF8CAB7}"/>
+                <a16:creationId xmlns:a16="http://schemas.microsoft.com/office/drawing/2014/main" id="{555A8734-746D-41D0-9443-2B9ADD363F55}"/>
               </a:ext>
             </a:extLst>
           </p:cNvPr>
@@ -10575,7 +10575,7 @@
           <p:cNvPr id="8" name="">
             <a:extLst xmlns:a="http://schemas.openxmlformats.org/drawingml/2006/main">
               <a:ext uri="{FF2B5EF4-FFF2-40B4-BE49-F238E27FC236}">
-                <a16:creationId xmlns:a16="http://schemas.microsoft.com/office/drawing/2014/main" id="{97CF94C5-8E78-48F6-8BB6-058FA6E8AF5E}"/>
+                <a16:creationId xmlns:a16="http://schemas.microsoft.com/office/drawing/2014/main" id="{9181F49E-1678-4FC2-A394-426A0D2D3CD4}"/>
               </a:ext>
             </a:extLst>
           </p:cNvPr>
@@ -10664,7 +10664,7 @@
           <p:cNvPr id="9" name="">
             <a:extLst xmlns:a="http://schemas.openxmlformats.org/drawingml/2006/main">
               <a:ext uri="{FF2B5EF4-FFF2-40B4-BE49-F238E27FC236}">
-                <a16:creationId xmlns:a16="http://schemas.microsoft.com/office/drawing/2014/main" id="{CC0C1186-4F4E-44A5-8E89-E97ECEEC5D9B}"/>
+                <a16:creationId xmlns:a16="http://schemas.microsoft.com/office/drawing/2014/main" id="{30765B22-F285-4463-A059-C11DD8B5105F}"/>
               </a:ext>
             </a:extLst>
           </p:cNvPr>
@@ -10726,7 +10726,7 @@
           <p:cNvPr id="10" name="">
             <a:extLst xmlns:a="http://schemas.openxmlformats.org/drawingml/2006/main">
               <a:ext uri="{FF2B5EF4-FFF2-40B4-BE49-F238E27FC236}">
-                <a16:creationId xmlns:a16="http://schemas.microsoft.com/office/drawing/2014/main" id="{C1769757-AC2C-45D1-91E9-D0B509C32A56}"/>
+                <a16:creationId xmlns:a16="http://schemas.microsoft.com/office/drawing/2014/main" id="{58D77815-AC66-489A-8A46-8379948AFB35}"/>
               </a:ext>
             </a:extLst>
           </p:cNvPr>
@@ -10786,7 +10786,7 @@
     </p:spTree>
     <p:extLst>
       <p:ext uri="{BB962C8B-B14F-4D97-AF65-F5344CB8AC3E}">
-        <p14:creationId xmlns:p14="http://schemas.microsoft.com/office/powerpoint/2010/main" val="207291217"/>
+        <p14:creationId xmlns:p14="http://schemas.microsoft.com/office/powerpoint/2010/main" val="715077152"/>
       </p:ext>
     </p:extLst>
   </p:cSld>
@@ -10817,7 +10817,7 @@
           <p:cNvPr id="22" name="side-accent-17">
             <a:extLst xmlns:a="http://schemas.openxmlformats.org/drawingml/2006/main">
               <a:ext uri="{FF2B5EF4-FFF2-40B4-BE49-F238E27FC236}">
-                <a16:creationId xmlns:a16="http://schemas.microsoft.com/office/drawing/2014/main" id="{2607A672-FF1E-43CD-97CD-E7ED72AEE16C}"/>
+                <a16:creationId xmlns:a16="http://schemas.microsoft.com/office/drawing/2014/main" id="{08D665F1-F37A-475E-895C-C0BFB866E59E}"/>
               </a:ext>
             </a:extLst>
           </p:cNvPr>
@@ -10848,7 +10848,7 @@
           <p:cNvPr id="2" name="kicker-17">
             <a:extLst xmlns:a="http://schemas.openxmlformats.org/drawingml/2006/main">
               <a:ext uri="{FF2B5EF4-FFF2-40B4-BE49-F238E27FC236}">
-                <a16:creationId xmlns:a16="http://schemas.microsoft.com/office/drawing/2014/main" id="{40F98F5F-87B1-412B-AE7D-E48F1AA50CA8}"/>
+                <a16:creationId xmlns:a16="http://schemas.microsoft.com/office/drawing/2014/main" id="{5F421105-1FA4-48A6-8D1B-EAB50F27896E}"/>
               </a:ext>
             </a:extLst>
           </p:cNvPr>
@@ -10910,7 +10910,7 @@
           <p:cNvPr id="3" name="title-17">
             <a:extLst xmlns:a="http://schemas.openxmlformats.org/drawingml/2006/main">
               <a:ext uri="{FF2B5EF4-FFF2-40B4-BE49-F238E27FC236}">
-                <a16:creationId xmlns:a16="http://schemas.microsoft.com/office/drawing/2014/main" id="{195A18FB-9BAB-468A-B5BB-F7895FB94D7A}"/>
+                <a16:creationId xmlns:a16="http://schemas.microsoft.com/office/drawing/2014/main" id="{3A64DB9E-046E-447E-B99D-7D27E33E6348}"/>
               </a:ext>
             </a:extLst>
           </p:cNvPr>
@@ -10972,7 +10972,7 @@
           <p:cNvPr id="4" name="">
             <a:extLst xmlns:a="http://schemas.openxmlformats.org/drawingml/2006/main">
               <a:ext uri="{FF2B5EF4-FFF2-40B4-BE49-F238E27FC236}">
-                <a16:creationId xmlns:a16="http://schemas.microsoft.com/office/drawing/2014/main" id="{E4460265-0EC3-4F2B-8BA7-285BA25AF361}"/>
+                <a16:creationId xmlns:a16="http://schemas.microsoft.com/office/drawing/2014/main" id="{52A94B8E-148F-416A-8F50-0BEB46785C74}"/>
               </a:ext>
             </a:extLst>
           </p:cNvPr>
@@ -11034,7 +11034,7 @@
           <p:cNvPr id="5" name="">
             <a:extLst xmlns:a="http://schemas.openxmlformats.org/drawingml/2006/main">
               <a:ext uri="{FF2B5EF4-FFF2-40B4-BE49-F238E27FC236}">
-                <a16:creationId xmlns:a16="http://schemas.microsoft.com/office/drawing/2014/main" id="{266250CD-3BF5-4036-8CB1-D77ADA7B8B71}"/>
+                <a16:creationId xmlns:a16="http://schemas.microsoft.com/office/drawing/2014/main" id="{982AF829-73E9-4B18-AE73-6F809A94CC89}"/>
               </a:ext>
             </a:extLst>
           </p:cNvPr>
@@ -11065,7 +11065,7 @@
           <p:cNvPr id="6" name="">
             <a:extLst xmlns:a="http://schemas.openxmlformats.org/drawingml/2006/main">
               <a:ext uri="{FF2B5EF4-FFF2-40B4-BE49-F238E27FC236}">
-                <a16:creationId xmlns:a16="http://schemas.microsoft.com/office/drawing/2014/main" id="{9F16DC3A-01F6-40C8-ADED-27C5690773D4}"/>
+                <a16:creationId xmlns:a16="http://schemas.microsoft.com/office/drawing/2014/main" id="{C689FD59-9632-4797-9E1A-BED49232D742}"/>
               </a:ext>
             </a:extLst>
           </p:cNvPr>
@@ -11127,7 +11127,7 @@
           <p:cNvPr id="7" name="">
             <a:extLst xmlns:a="http://schemas.openxmlformats.org/drawingml/2006/main">
               <a:ext uri="{FF2B5EF4-FFF2-40B4-BE49-F238E27FC236}">
-                <a16:creationId xmlns:a16="http://schemas.microsoft.com/office/drawing/2014/main" id="{EE7789FA-928B-496D-8A8E-1AA2A09F74CD}"/>
+                <a16:creationId xmlns:a16="http://schemas.microsoft.com/office/drawing/2014/main" id="{11505D4F-B033-47C1-B525-D89217A79A98}"/>
               </a:ext>
             </a:extLst>
           </p:cNvPr>
@@ -11189,7 +11189,7 @@
           <p:cNvPr id="8" name="">
             <a:extLst xmlns:a="http://schemas.openxmlformats.org/drawingml/2006/main">
               <a:ext uri="{FF2B5EF4-FFF2-40B4-BE49-F238E27FC236}">
-                <a16:creationId xmlns:a16="http://schemas.microsoft.com/office/drawing/2014/main" id="{A13ED775-DE02-4076-AD57-C27611EC19B4}"/>
+                <a16:creationId xmlns:a16="http://schemas.microsoft.com/office/drawing/2014/main" id="{4E802DEB-A135-47CC-8BCB-C86E8F53427B}"/>
               </a:ext>
             </a:extLst>
           </p:cNvPr>
@@ -11220,7 +11220,7 @@
           <p:cNvPr id="9" name="">
             <a:extLst xmlns:a="http://schemas.openxmlformats.org/drawingml/2006/main">
               <a:ext uri="{FF2B5EF4-FFF2-40B4-BE49-F238E27FC236}">
-                <a16:creationId xmlns:a16="http://schemas.microsoft.com/office/drawing/2014/main" id="{32CC115B-89B1-4810-BD38-ECE0A13542F3}"/>
+                <a16:creationId xmlns:a16="http://schemas.microsoft.com/office/drawing/2014/main" id="{6288EACA-9935-43E7-B74E-6F3110B5499B}"/>
               </a:ext>
             </a:extLst>
           </p:cNvPr>
@@ -11282,7 +11282,7 @@
           <p:cNvPr id="10" name="">
             <a:extLst xmlns:a="http://schemas.openxmlformats.org/drawingml/2006/main">
               <a:ext uri="{FF2B5EF4-FFF2-40B4-BE49-F238E27FC236}">
-                <a16:creationId xmlns:a16="http://schemas.microsoft.com/office/drawing/2014/main" id="{E91EF92E-C426-46B3-B33C-DBB3F695C109}"/>
+                <a16:creationId xmlns:a16="http://schemas.microsoft.com/office/drawing/2014/main" id="{15243BE1-A7CA-48EB-9369-E4AFBC24E330}"/>
               </a:ext>
             </a:extLst>
           </p:cNvPr>
@@ -11344,7 +11344,7 @@
           <p:cNvPr id="11" name="">
             <a:extLst xmlns:a="http://schemas.openxmlformats.org/drawingml/2006/main">
               <a:ext uri="{FF2B5EF4-FFF2-40B4-BE49-F238E27FC236}">
-                <a16:creationId xmlns:a16="http://schemas.microsoft.com/office/drawing/2014/main" id="{B38CE94B-B1DB-4814-89C0-58DD9C58EF0F}"/>
+                <a16:creationId xmlns:a16="http://schemas.microsoft.com/office/drawing/2014/main" id="{DD725286-AAEA-4931-8007-870794E7FF5E}"/>
               </a:ext>
             </a:extLst>
           </p:cNvPr>
@@ -11375,7 +11375,7 @@
           <p:cNvPr id="12" name="">
             <a:extLst xmlns:a="http://schemas.openxmlformats.org/drawingml/2006/main">
               <a:ext uri="{FF2B5EF4-FFF2-40B4-BE49-F238E27FC236}">
-                <a16:creationId xmlns:a16="http://schemas.microsoft.com/office/drawing/2014/main" id="{2F172379-FABB-419D-B624-9F1DB964DDF0}"/>
+                <a16:creationId xmlns:a16="http://schemas.microsoft.com/office/drawing/2014/main" id="{F979C8E3-A650-4A29-BC67-893907F03F3C}"/>
               </a:ext>
             </a:extLst>
           </p:cNvPr>
@@ -11437,7 +11437,7 @@
           <p:cNvPr id="13" name="">
             <a:extLst xmlns:a="http://schemas.openxmlformats.org/drawingml/2006/main">
               <a:ext uri="{FF2B5EF4-FFF2-40B4-BE49-F238E27FC236}">
-                <a16:creationId xmlns:a16="http://schemas.microsoft.com/office/drawing/2014/main" id="{D9844777-B76F-425B-BA8C-C5773212623E}"/>
+                <a16:creationId xmlns:a16="http://schemas.microsoft.com/office/drawing/2014/main" id="{8BFF7EC0-3DB3-403E-95A4-0DE4852756CA}"/>
               </a:ext>
             </a:extLst>
           </p:cNvPr>
@@ -11499,7 +11499,7 @@
           <p:cNvPr id="14" name="">
             <a:extLst xmlns:a="http://schemas.openxmlformats.org/drawingml/2006/main">
               <a:ext uri="{FF2B5EF4-FFF2-40B4-BE49-F238E27FC236}">
-                <a16:creationId xmlns:a16="http://schemas.microsoft.com/office/drawing/2014/main" id="{60BC495C-B470-4C02-A159-D532137DBC29}"/>
+                <a16:creationId xmlns:a16="http://schemas.microsoft.com/office/drawing/2014/main" id="{91DF9493-CE1D-4EFD-9EBE-6CEADF58B878}"/>
               </a:ext>
             </a:extLst>
           </p:cNvPr>
@@ -11530,7 +11530,7 @@
           <p:cNvPr id="15" name="">
             <a:extLst xmlns:a="http://schemas.openxmlformats.org/drawingml/2006/main">
               <a:ext uri="{FF2B5EF4-FFF2-40B4-BE49-F238E27FC236}">
-                <a16:creationId xmlns:a16="http://schemas.microsoft.com/office/drawing/2014/main" id="{2EC49B80-7CAD-48DB-8744-95AB34F238E1}"/>
+                <a16:creationId xmlns:a16="http://schemas.microsoft.com/office/drawing/2014/main" id="{67EEE42D-20AD-4819-8D01-E701F1F27A98}"/>
               </a:ext>
             </a:extLst>
           </p:cNvPr>
@@ -11592,7 +11592,7 @@
           <p:cNvPr id="16" name="">
             <a:extLst xmlns:a="http://schemas.openxmlformats.org/drawingml/2006/main">
               <a:ext uri="{FF2B5EF4-FFF2-40B4-BE49-F238E27FC236}">
-                <a16:creationId xmlns:a16="http://schemas.microsoft.com/office/drawing/2014/main" id="{793BDD5F-9650-45F5-9C3E-F9C0511948C4}"/>
+                <a16:creationId xmlns:a16="http://schemas.microsoft.com/office/drawing/2014/main" id="{3C6DD5E6-9743-4EC4-A62E-58EE9BCABD82}"/>
               </a:ext>
             </a:extLst>
           </p:cNvPr>
@@ -11654,7 +11654,7 @@
           <p:cNvPr id="17" name="">
             <a:extLst xmlns:a="http://schemas.openxmlformats.org/drawingml/2006/main">
               <a:ext uri="{FF2B5EF4-FFF2-40B4-BE49-F238E27FC236}">
-                <a16:creationId xmlns:a16="http://schemas.microsoft.com/office/drawing/2014/main" id="{7D9747FD-271C-4ACD-A8A7-EA37F6FE61B5}"/>
+                <a16:creationId xmlns:a16="http://schemas.microsoft.com/office/drawing/2014/main" id="{960B14C6-0548-40E9-B66E-EBA7E9331233}"/>
               </a:ext>
             </a:extLst>
           </p:cNvPr>
@@ -11687,7 +11687,7 @@
           <p:cNvPr id="18" name="">
             <a:extLst xmlns:a="http://schemas.openxmlformats.org/drawingml/2006/main">
               <a:ext uri="{FF2B5EF4-FFF2-40B4-BE49-F238E27FC236}">
-                <a16:creationId xmlns:a16="http://schemas.microsoft.com/office/drawing/2014/main" id="{B1B14685-701A-4284-BE37-4D06F8F1A088}"/>
+                <a16:creationId xmlns:a16="http://schemas.microsoft.com/office/drawing/2014/main" id="{3458F375-20F4-4A5E-B220-9B74E6BA3314}"/>
               </a:ext>
             </a:extLst>
           </p:cNvPr>
@@ -11749,7 +11749,7 @@
           <p:cNvPr id="19" name="footer-rule-17">
             <a:extLst xmlns:a="http://schemas.openxmlformats.org/drawingml/2006/main">
               <a:ext uri="{FF2B5EF4-FFF2-40B4-BE49-F238E27FC236}">
-                <a16:creationId xmlns:a16="http://schemas.microsoft.com/office/drawing/2014/main" id="{5A639236-83B9-4740-8BBE-E8692927FE65}"/>
+                <a16:creationId xmlns:a16="http://schemas.microsoft.com/office/drawing/2014/main" id="{41D231AD-C953-4118-B22A-4D4E42C26FDF}"/>
               </a:ext>
             </a:extLst>
           </p:cNvPr>
@@ -11780,7 +11780,7 @@
           <p:cNvPr id="20" name="footer-label-17">
             <a:extLst xmlns:a="http://schemas.openxmlformats.org/drawingml/2006/main">
               <a:ext uri="{FF2B5EF4-FFF2-40B4-BE49-F238E27FC236}">
-                <a16:creationId xmlns:a16="http://schemas.microsoft.com/office/drawing/2014/main" id="{86A16327-9993-4CE9-A7E8-45A06A17C50D}"/>
+                <a16:creationId xmlns:a16="http://schemas.microsoft.com/office/drawing/2014/main" id="{03006319-02AE-48AA-8E33-74B93EFF294A}"/>
               </a:ext>
             </a:extLst>
           </p:cNvPr>
@@ -11842,7 +11842,7 @@
           <p:cNvPr id="21" name="footer-page-17">
             <a:extLst xmlns:a="http://schemas.openxmlformats.org/drawingml/2006/main">
               <a:ext uri="{FF2B5EF4-FFF2-40B4-BE49-F238E27FC236}">
-                <a16:creationId xmlns:a16="http://schemas.microsoft.com/office/drawing/2014/main" id="{8404C1F1-219E-4451-8EDB-E8CE6C0E1F76}"/>
+                <a16:creationId xmlns:a16="http://schemas.microsoft.com/office/drawing/2014/main" id="{5C830F05-B761-4F8D-85F5-13536FAAD19B}"/>
               </a:ext>
             </a:extLst>
           </p:cNvPr>
@@ -11902,7 +11902,7 @@
     </p:spTree>
     <p:extLst>
       <p:ext uri="{BB962C8B-B14F-4D97-AF65-F5344CB8AC3E}">
-        <p14:creationId xmlns:p14="http://schemas.microsoft.com/office/powerpoint/2010/main" val="1883007895"/>
+        <p14:creationId xmlns:p14="http://schemas.microsoft.com/office/powerpoint/2010/main" val="1249572360"/>
       </p:ext>
     </p:extLst>
   </p:cSld>
@@ -11933,7 +11933,7 @@
           <p:cNvPr id="25" name="side-accent-18">
             <a:extLst xmlns:a="http://schemas.openxmlformats.org/drawingml/2006/main">
               <a:ext uri="{FF2B5EF4-FFF2-40B4-BE49-F238E27FC236}">
-                <a16:creationId xmlns:a16="http://schemas.microsoft.com/office/drawing/2014/main" id="{46C45337-6A42-4895-93A3-5EE630505849}"/>
+                <a16:creationId xmlns:a16="http://schemas.microsoft.com/office/drawing/2014/main" id="{9C9B99F3-0244-488B-A11C-01F64B41F5F7}"/>
               </a:ext>
             </a:extLst>
           </p:cNvPr>
@@ -11964,7 +11964,7 @@
           <p:cNvPr id="2" name="kicker-18">
             <a:extLst xmlns:a="http://schemas.openxmlformats.org/drawingml/2006/main">
               <a:ext uri="{FF2B5EF4-FFF2-40B4-BE49-F238E27FC236}">
-                <a16:creationId xmlns:a16="http://schemas.microsoft.com/office/drawing/2014/main" id="{6F454CA1-5DA2-4E88-9843-634B32E3C1BA}"/>
+                <a16:creationId xmlns:a16="http://schemas.microsoft.com/office/drawing/2014/main" id="{0CF046A1-0EFB-4571-91A1-9BF190497BFD}"/>
               </a:ext>
             </a:extLst>
           </p:cNvPr>
@@ -12026,7 +12026,7 @@
           <p:cNvPr id="3" name="title-18">
             <a:extLst xmlns:a="http://schemas.openxmlformats.org/drawingml/2006/main">
               <a:ext uri="{FF2B5EF4-FFF2-40B4-BE49-F238E27FC236}">
-                <a16:creationId xmlns:a16="http://schemas.microsoft.com/office/drawing/2014/main" id="{6C907F55-270C-4F26-AAAE-0EBF48A1A476}"/>
+                <a16:creationId xmlns:a16="http://schemas.microsoft.com/office/drawing/2014/main" id="{F198F0BA-AA70-46D9-955D-9F8861F94F12}"/>
               </a:ext>
             </a:extLst>
           </p:cNvPr>
@@ -12088,7 +12088,7 @@
           <p:cNvPr id="4" name="">
             <a:extLst xmlns:a="http://schemas.openxmlformats.org/drawingml/2006/main">
               <a:ext uri="{FF2B5EF4-FFF2-40B4-BE49-F238E27FC236}">
-                <a16:creationId xmlns:a16="http://schemas.microsoft.com/office/drawing/2014/main" id="{E5FE6E75-2017-48EB-903B-051AC86EE03A}"/>
+                <a16:creationId xmlns:a16="http://schemas.microsoft.com/office/drawing/2014/main" id="{21A2C036-AB94-47F9-8E71-70523C10FE0A}"/>
               </a:ext>
             </a:extLst>
           </p:cNvPr>
@@ -12150,7 +12150,7 @@
           <p:cNvPr id="5" name="">
             <a:extLst xmlns:a="http://schemas.openxmlformats.org/drawingml/2006/main">
               <a:ext uri="{FF2B5EF4-FFF2-40B4-BE49-F238E27FC236}">
-                <a16:creationId xmlns:a16="http://schemas.microsoft.com/office/drawing/2014/main" id="{4DF15792-7A78-47F6-81C9-0BA51F2D8E82}"/>
+                <a16:creationId xmlns:a16="http://schemas.microsoft.com/office/drawing/2014/main" id="{2BA78A1E-C900-4BAF-97EA-085CBAC0CEBE}"/>
               </a:ext>
             </a:extLst>
           </p:cNvPr>
@@ -12212,7 +12212,7 @@
           <p:cNvPr id="6" name="">
             <a:extLst xmlns:a="http://schemas.openxmlformats.org/drawingml/2006/main">
               <a:ext uri="{FF2B5EF4-FFF2-40B4-BE49-F238E27FC236}">
-                <a16:creationId xmlns:a16="http://schemas.microsoft.com/office/drawing/2014/main" id="{2D418D47-1AE4-46F8-8030-B1C17101E0CA}"/>
+                <a16:creationId xmlns:a16="http://schemas.microsoft.com/office/drawing/2014/main" id="{F2526256-2636-468F-8B33-E3F93068E138}"/>
               </a:ext>
             </a:extLst>
           </p:cNvPr>
@@ -12274,7 +12274,7 @@
           <p:cNvPr id="7" name="">
             <a:extLst xmlns:a="http://schemas.openxmlformats.org/drawingml/2006/main">
               <a:ext uri="{FF2B5EF4-FFF2-40B4-BE49-F238E27FC236}">
-                <a16:creationId xmlns:a16="http://schemas.microsoft.com/office/drawing/2014/main" id="{EBD9E9FF-9F81-43C5-B298-C58B143831C4}"/>
+                <a16:creationId xmlns:a16="http://schemas.microsoft.com/office/drawing/2014/main" id="{92DF9465-87ED-4B10-8454-F1B9750D925E}"/>
               </a:ext>
             </a:extLst>
           </p:cNvPr>
@@ -12305,7 +12305,7 @@
           <p:cNvPr id="8" name="">
             <a:extLst xmlns:a="http://schemas.openxmlformats.org/drawingml/2006/main">
               <a:ext uri="{FF2B5EF4-FFF2-40B4-BE49-F238E27FC236}">
-                <a16:creationId xmlns:a16="http://schemas.microsoft.com/office/drawing/2014/main" id="{4B93E80A-1226-48E7-92CE-DB29690138A3}"/>
+                <a16:creationId xmlns:a16="http://schemas.microsoft.com/office/drawing/2014/main" id="{0651EB3B-2331-49D9-A775-F1CDD86186E5}"/>
               </a:ext>
             </a:extLst>
           </p:cNvPr>
@@ -12367,7 +12367,7 @@
           <p:cNvPr id="9" name="">
             <a:extLst xmlns:a="http://schemas.openxmlformats.org/drawingml/2006/main">
               <a:ext uri="{FF2B5EF4-FFF2-40B4-BE49-F238E27FC236}">
-                <a16:creationId xmlns:a16="http://schemas.microsoft.com/office/drawing/2014/main" id="{35BA8370-C39F-43F4-A4F1-3AA45A0604E4}"/>
+                <a16:creationId xmlns:a16="http://schemas.microsoft.com/office/drawing/2014/main" id="{59F2E674-E36C-422A-97F3-14B1F04002E0}"/>
               </a:ext>
             </a:extLst>
           </p:cNvPr>
@@ -12429,7 +12429,7 @@
           <p:cNvPr id="10" name="">
             <a:extLst xmlns:a="http://schemas.openxmlformats.org/drawingml/2006/main">
               <a:ext uri="{FF2B5EF4-FFF2-40B4-BE49-F238E27FC236}">
-                <a16:creationId xmlns:a16="http://schemas.microsoft.com/office/drawing/2014/main" id="{C4AA75C2-5DE4-4B69-BC40-3A026F528C85}"/>
+                <a16:creationId xmlns:a16="http://schemas.microsoft.com/office/drawing/2014/main" id="{AAE6C8D4-535D-470B-9363-4B1492D76873}"/>
               </a:ext>
             </a:extLst>
           </p:cNvPr>
@@ -12491,7 +12491,7 @@
           <p:cNvPr id="11" name="">
             <a:extLst xmlns:a="http://schemas.openxmlformats.org/drawingml/2006/main">
               <a:ext uri="{FF2B5EF4-FFF2-40B4-BE49-F238E27FC236}">
-                <a16:creationId xmlns:a16="http://schemas.microsoft.com/office/drawing/2014/main" id="{4CAD8420-820A-4FBD-88E2-9A0B1A5155C0}"/>
+                <a16:creationId xmlns:a16="http://schemas.microsoft.com/office/drawing/2014/main" id="{43C9E218-7F19-4F66-B7CD-EB838489ABCD}"/>
               </a:ext>
             </a:extLst>
           </p:cNvPr>
@@ -12522,7 +12522,7 @@
           <p:cNvPr id="12" name="">
             <a:extLst xmlns:a="http://schemas.openxmlformats.org/drawingml/2006/main">
               <a:ext uri="{FF2B5EF4-FFF2-40B4-BE49-F238E27FC236}">
-                <a16:creationId xmlns:a16="http://schemas.microsoft.com/office/drawing/2014/main" id="{8D23403F-9F69-4821-B431-F12E18104B66}"/>
+                <a16:creationId xmlns:a16="http://schemas.microsoft.com/office/drawing/2014/main" id="{F3AA680E-5B56-4100-B24E-6B8703B9A692}"/>
               </a:ext>
             </a:extLst>
           </p:cNvPr>
@@ -12584,7 +12584,7 @@
           <p:cNvPr id="13" name="">
             <a:extLst xmlns:a="http://schemas.openxmlformats.org/drawingml/2006/main">
               <a:ext uri="{FF2B5EF4-FFF2-40B4-BE49-F238E27FC236}">
-                <a16:creationId xmlns:a16="http://schemas.microsoft.com/office/drawing/2014/main" id="{8E85FC8D-57C0-41AA-8FC9-553F1D6E8E76}"/>
+                <a16:creationId xmlns:a16="http://schemas.microsoft.com/office/drawing/2014/main" id="{93A2AB27-2DC9-470B-8970-C18A82900C21}"/>
               </a:ext>
             </a:extLst>
           </p:cNvPr>
@@ -12646,7 +12646,7 @@
           <p:cNvPr id="14" name="">
             <a:extLst xmlns:a="http://schemas.openxmlformats.org/drawingml/2006/main">
               <a:ext uri="{FF2B5EF4-FFF2-40B4-BE49-F238E27FC236}">
-                <a16:creationId xmlns:a16="http://schemas.microsoft.com/office/drawing/2014/main" id="{B4128E10-167F-4292-A082-23356DDF00BF}"/>
+                <a16:creationId xmlns:a16="http://schemas.microsoft.com/office/drawing/2014/main" id="{1475BBCF-9A28-4391-BC48-3C8D4392D485}"/>
               </a:ext>
             </a:extLst>
           </p:cNvPr>
@@ -12708,7 +12708,7 @@
           <p:cNvPr id="15" name="">
             <a:extLst xmlns:a="http://schemas.openxmlformats.org/drawingml/2006/main">
               <a:ext uri="{FF2B5EF4-FFF2-40B4-BE49-F238E27FC236}">
-                <a16:creationId xmlns:a16="http://schemas.microsoft.com/office/drawing/2014/main" id="{94ACD821-894F-4238-A87D-B39276E54CE4}"/>
+                <a16:creationId xmlns:a16="http://schemas.microsoft.com/office/drawing/2014/main" id="{3CABE4D0-4E9C-456F-9783-443C7A961E79}"/>
               </a:ext>
             </a:extLst>
           </p:cNvPr>
@@ -12739,7 +12739,7 @@
           <p:cNvPr id="16" name="">
             <a:extLst xmlns:a="http://schemas.openxmlformats.org/drawingml/2006/main">
               <a:ext uri="{FF2B5EF4-FFF2-40B4-BE49-F238E27FC236}">
-                <a16:creationId xmlns:a16="http://schemas.microsoft.com/office/drawing/2014/main" id="{B616FFF9-BC5F-49B6-8471-DDBBEC8A7603}"/>
+                <a16:creationId xmlns:a16="http://schemas.microsoft.com/office/drawing/2014/main" id="{1E4B5B6E-5F27-42BE-957D-2E473BA13F9F}"/>
               </a:ext>
             </a:extLst>
           </p:cNvPr>
@@ -12801,7 +12801,7 @@
           <p:cNvPr id="17" name="">
             <a:extLst xmlns:a="http://schemas.openxmlformats.org/drawingml/2006/main">
               <a:ext uri="{FF2B5EF4-FFF2-40B4-BE49-F238E27FC236}">
-                <a16:creationId xmlns:a16="http://schemas.microsoft.com/office/drawing/2014/main" id="{9B2A9F82-4506-4E43-A65B-0BFB0A8EE8FC}"/>
+                <a16:creationId xmlns:a16="http://schemas.microsoft.com/office/drawing/2014/main" id="{5B5937EC-6111-41EB-8F1F-66A31192EB40}"/>
               </a:ext>
             </a:extLst>
           </p:cNvPr>
@@ -12863,7 +12863,7 @@
           <p:cNvPr id="18" name="">
             <a:extLst xmlns:a="http://schemas.openxmlformats.org/drawingml/2006/main">
               <a:ext uri="{FF2B5EF4-FFF2-40B4-BE49-F238E27FC236}">
-                <a16:creationId xmlns:a16="http://schemas.microsoft.com/office/drawing/2014/main" id="{4F530EEB-6767-4671-AE5E-EDB2EC8B7169}"/>
+                <a16:creationId xmlns:a16="http://schemas.microsoft.com/office/drawing/2014/main" id="{135C4414-BB40-44C5-A886-6278C6A9721E}"/>
               </a:ext>
             </a:extLst>
           </p:cNvPr>
@@ -12925,7 +12925,7 @@
           <p:cNvPr id="19" name="">
             <a:extLst xmlns:a="http://schemas.openxmlformats.org/drawingml/2006/main">
               <a:ext uri="{FF2B5EF4-FFF2-40B4-BE49-F238E27FC236}">
-                <a16:creationId xmlns:a16="http://schemas.microsoft.com/office/drawing/2014/main" id="{98870709-DE11-42A5-937F-36146AD205FA}"/>
+                <a16:creationId xmlns:a16="http://schemas.microsoft.com/office/drawing/2014/main" id="{2EF2A527-4CAA-4802-A0A6-2E39241CFED6}"/>
               </a:ext>
             </a:extLst>
           </p:cNvPr>
@@ -12958,7 +12958,7 @@
           <p:cNvPr id="20" name="">
             <a:extLst xmlns:a="http://schemas.openxmlformats.org/drawingml/2006/main">
               <a:ext uri="{FF2B5EF4-FFF2-40B4-BE49-F238E27FC236}">
-                <a16:creationId xmlns:a16="http://schemas.microsoft.com/office/drawing/2014/main" id="{022531DF-038C-4617-B878-846F879087D1}"/>
+                <a16:creationId xmlns:a16="http://schemas.microsoft.com/office/drawing/2014/main" id="{0BB77F0C-8884-4AB8-8940-E2C640FFD823}"/>
               </a:ext>
             </a:extLst>
           </p:cNvPr>
@@ -13024,7 +13024,7 @@
           <p:nvPr/>
         </p:nvPicPr>
         <p:blipFill>
-          <a:blip xmlns:r="http://schemas.openxmlformats.org/officeDocument/2006/relationships" xmlns:a="http://schemas.openxmlformats.org/drawingml/2006/main" r:embed="R519a014eae364329"/>
+          <a:blip xmlns:r="http://schemas.openxmlformats.org/officeDocument/2006/relationships" xmlns:a="http://schemas.openxmlformats.org/drawingml/2006/main" r:embed="Rf6699a90e5bc4d32"/>
           <a:stretch xmlns:a="http://schemas.openxmlformats.org/drawingml/2006/main"/>
         </p:blipFill>
         <p:spPr>
@@ -13042,7 +13042,7 @@
           <p:cNvPr id="22" name="footer-rule-18">
             <a:extLst xmlns:a="http://schemas.openxmlformats.org/drawingml/2006/main">
               <a:ext uri="{FF2B5EF4-FFF2-40B4-BE49-F238E27FC236}">
-                <a16:creationId xmlns:a16="http://schemas.microsoft.com/office/drawing/2014/main" id="{134AB00B-BEA2-457A-99C4-26D4DD683092}"/>
+                <a16:creationId xmlns:a16="http://schemas.microsoft.com/office/drawing/2014/main" id="{13652DA9-2FDE-4DEC-8992-1AFC6381A5C9}"/>
               </a:ext>
             </a:extLst>
           </p:cNvPr>
@@ -13073,7 +13073,7 @@
           <p:cNvPr id="23" name="footer-label-18">
             <a:extLst xmlns:a="http://schemas.openxmlformats.org/drawingml/2006/main">
               <a:ext uri="{FF2B5EF4-FFF2-40B4-BE49-F238E27FC236}">
-                <a16:creationId xmlns:a16="http://schemas.microsoft.com/office/drawing/2014/main" id="{D3E83408-7121-4A0E-81DE-2B1503DC10E4}"/>
+                <a16:creationId xmlns:a16="http://schemas.microsoft.com/office/drawing/2014/main" id="{E57228F5-37CC-4D9E-9398-F711BF19BB9C}"/>
               </a:ext>
             </a:extLst>
           </p:cNvPr>
@@ -13135,7 +13135,7 @@
           <p:cNvPr id="24" name="footer-page-18">
             <a:extLst xmlns:a="http://schemas.openxmlformats.org/drawingml/2006/main">
               <a:ext uri="{FF2B5EF4-FFF2-40B4-BE49-F238E27FC236}">
-                <a16:creationId xmlns:a16="http://schemas.microsoft.com/office/drawing/2014/main" id="{F99FE2A4-9322-4805-9A70-5DE1D93215D4}"/>
+                <a16:creationId xmlns:a16="http://schemas.microsoft.com/office/drawing/2014/main" id="{398E40EC-4A21-4391-A468-28434DB33834}"/>
               </a:ext>
             </a:extLst>
           </p:cNvPr>
@@ -13195,7 +13195,7 @@
     </p:spTree>
     <p:extLst>
       <p:ext uri="{BB962C8B-B14F-4D97-AF65-F5344CB8AC3E}">
-        <p14:creationId xmlns:p14="http://schemas.microsoft.com/office/powerpoint/2010/main" val="265127143"/>
+        <p14:creationId xmlns:p14="http://schemas.microsoft.com/office/powerpoint/2010/main" val="381672940"/>
       </p:ext>
     </p:extLst>
   </p:cSld>
@@ -13226,7 +13226,7 @@
           <p:cNvPr id="20" name="side-accent-2">
             <a:extLst xmlns:a="http://schemas.openxmlformats.org/drawingml/2006/main">
               <a:ext uri="{FF2B5EF4-FFF2-40B4-BE49-F238E27FC236}">
-                <a16:creationId xmlns:a16="http://schemas.microsoft.com/office/drawing/2014/main" id="{211C507D-B721-422A-B101-CD25D5989BD6}"/>
+                <a16:creationId xmlns:a16="http://schemas.microsoft.com/office/drawing/2014/main" id="{3E46C2ED-1243-4B33-808C-A2D854DE672E}"/>
               </a:ext>
             </a:extLst>
           </p:cNvPr>
@@ -13257,7 +13257,7 @@
           <p:cNvPr id="2" name="kicker-2">
             <a:extLst xmlns:a="http://schemas.openxmlformats.org/drawingml/2006/main">
               <a:ext uri="{FF2B5EF4-FFF2-40B4-BE49-F238E27FC236}">
-                <a16:creationId xmlns:a16="http://schemas.microsoft.com/office/drawing/2014/main" id="{C87BC976-05A6-4599-93CD-4F006DF4AAA3}"/>
+                <a16:creationId xmlns:a16="http://schemas.microsoft.com/office/drawing/2014/main" id="{29962F8D-A593-4425-B7F4-816A70DDA471}"/>
               </a:ext>
             </a:extLst>
           </p:cNvPr>
@@ -13319,7 +13319,7 @@
           <p:cNvPr id="3" name="title-2">
             <a:extLst xmlns:a="http://schemas.openxmlformats.org/drawingml/2006/main">
               <a:ext uri="{FF2B5EF4-FFF2-40B4-BE49-F238E27FC236}">
-                <a16:creationId xmlns:a16="http://schemas.microsoft.com/office/drawing/2014/main" id="{B4D5B124-5BBD-4871-84AB-98F11CC1E6A1}"/>
+                <a16:creationId xmlns:a16="http://schemas.microsoft.com/office/drawing/2014/main" id="{BADD951F-A624-4DA8-B874-D246766366E2}"/>
               </a:ext>
             </a:extLst>
           </p:cNvPr>
@@ -13381,7 +13381,7 @@
           <p:cNvPr id="4" name="">
             <a:extLst xmlns:a="http://schemas.openxmlformats.org/drawingml/2006/main">
               <a:ext uri="{FF2B5EF4-FFF2-40B4-BE49-F238E27FC236}">
-                <a16:creationId xmlns:a16="http://schemas.microsoft.com/office/drawing/2014/main" id="{FCC4636B-E9A1-48FE-9FD4-75752EB33FC5}"/>
+                <a16:creationId xmlns:a16="http://schemas.microsoft.com/office/drawing/2014/main" id="{794305C9-7416-4C22-903C-B875811333E9}"/>
               </a:ext>
             </a:extLst>
           </p:cNvPr>
@@ -13443,7 +13443,7 @@
           <p:cNvPr id="5" name="">
             <a:extLst xmlns:a="http://schemas.openxmlformats.org/drawingml/2006/main">
               <a:ext uri="{FF2B5EF4-FFF2-40B4-BE49-F238E27FC236}">
-                <a16:creationId xmlns:a16="http://schemas.microsoft.com/office/drawing/2014/main" id="{969AF8DE-F542-4E1B-9572-F9B5F8B493CC}"/>
+                <a16:creationId xmlns:a16="http://schemas.microsoft.com/office/drawing/2014/main" id="{A59D85AA-FD46-4E84-B7B0-DEAC31C32A72}"/>
               </a:ext>
             </a:extLst>
           </p:cNvPr>
@@ -13505,7 +13505,7 @@
           <p:cNvPr id="6" name="">
             <a:extLst xmlns:a="http://schemas.openxmlformats.org/drawingml/2006/main">
               <a:ext uri="{FF2B5EF4-FFF2-40B4-BE49-F238E27FC236}">
-                <a16:creationId xmlns:a16="http://schemas.microsoft.com/office/drawing/2014/main" id="{1C214B04-43C1-4451-9001-F83BCF0C608F}"/>
+                <a16:creationId xmlns:a16="http://schemas.microsoft.com/office/drawing/2014/main" id="{2CF34A0C-5A88-4B01-A1E7-44FD7BDDBFBC}"/>
               </a:ext>
             </a:extLst>
           </p:cNvPr>
@@ -13536,7 +13536,7 @@
           <p:cNvPr id="7" name="">
             <a:extLst xmlns:a="http://schemas.openxmlformats.org/drawingml/2006/main">
               <a:ext uri="{FF2B5EF4-FFF2-40B4-BE49-F238E27FC236}">
-                <a16:creationId xmlns:a16="http://schemas.microsoft.com/office/drawing/2014/main" id="{5E725EAD-F7A2-4A8A-B688-CABC9CD8CC92}"/>
+                <a16:creationId xmlns:a16="http://schemas.microsoft.com/office/drawing/2014/main" id="{427BB930-48D9-4572-A8FF-E58141678900}"/>
               </a:ext>
             </a:extLst>
           </p:cNvPr>
@@ -13598,7 +13598,7 @@
           <p:cNvPr id="8" name="">
             <a:extLst xmlns:a="http://schemas.openxmlformats.org/drawingml/2006/main">
               <a:ext uri="{FF2B5EF4-FFF2-40B4-BE49-F238E27FC236}">
-                <a16:creationId xmlns:a16="http://schemas.microsoft.com/office/drawing/2014/main" id="{BECA5600-7FF9-434C-819C-0244253B32CB}"/>
+                <a16:creationId xmlns:a16="http://schemas.microsoft.com/office/drawing/2014/main" id="{D7F5DADF-A91F-494F-A052-980C7D73CE69}"/>
               </a:ext>
             </a:extLst>
           </p:cNvPr>
@@ -13660,7 +13660,7 @@
           <p:cNvPr id="9" name="">
             <a:extLst xmlns:a="http://schemas.openxmlformats.org/drawingml/2006/main">
               <a:ext uri="{FF2B5EF4-FFF2-40B4-BE49-F238E27FC236}">
-                <a16:creationId xmlns:a16="http://schemas.microsoft.com/office/drawing/2014/main" id="{941307CD-DF1A-4A49-9A4F-16B1E2060B3D}"/>
+                <a16:creationId xmlns:a16="http://schemas.microsoft.com/office/drawing/2014/main" id="{DDDC07E2-7E55-41DA-BD61-51CEFA762E98}"/>
               </a:ext>
             </a:extLst>
           </p:cNvPr>
@@ -13691,7 +13691,7 @@
           <p:cNvPr id="10" name="">
             <a:extLst xmlns:a="http://schemas.openxmlformats.org/drawingml/2006/main">
               <a:ext uri="{FF2B5EF4-FFF2-40B4-BE49-F238E27FC236}">
-                <a16:creationId xmlns:a16="http://schemas.microsoft.com/office/drawing/2014/main" id="{3478B4F6-ACDD-42D0-AC05-18FA2A511C03}"/>
+                <a16:creationId xmlns:a16="http://schemas.microsoft.com/office/drawing/2014/main" id="{AA53CCA1-F278-49FB-8521-0D01389D607E}"/>
               </a:ext>
             </a:extLst>
           </p:cNvPr>
@@ -13753,7 +13753,7 @@
           <p:cNvPr id="11" name="">
             <a:extLst xmlns:a="http://schemas.openxmlformats.org/drawingml/2006/main">
               <a:ext uri="{FF2B5EF4-FFF2-40B4-BE49-F238E27FC236}">
-                <a16:creationId xmlns:a16="http://schemas.microsoft.com/office/drawing/2014/main" id="{A055CDBA-14C7-450E-8384-176DBDEC6DF5}"/>
+                <a16:creationId xmlns:a16="http://schemas.microsoft.com/office/drawing/2014/main" id="{D4A5E4FF-2613-4330-98CE-D38C3DFB8A7A}"/>
               </a:ext>
             </a:extLst>
           </p:cNvPr>
@@ -13815,7 +13815,7 @@
           <p:cNvPr id="12" name="">
             <a:extLst xmlns:a="http://schemas.openxmlformats.org/drawingml/2006/main">
               <a:ext uri="{FF2B5EF4-FFF2-40B4-BE49-F238E27FC236}">
-                <a16:creationId xmlns:a16="http://schemas.microsoft.com/office/drawing/2014/main" id="{9B4648BF-4664-4505-96FB-5A4423A6D876}"/>
+                <a16:creationId xmlns:a16="http://schemas.microsoft.com/office/drawing/2014/main" id="{27668328-31DA-4517-92CC-D02D516483D3}"/>
               </a:ext>
             </a:extLst>
           </p:cNvPr>
@@ -13846,7 +13846,7 @@
           <p:cNvPr id="13" name="">
             <a:extLst xmlns:a="http://schemas.openxmlformats.org/drawingml/2006/main">
               <a:ext uri="{FF2B5EF4-FFF2-40B4-BE49-F238E27FC236}">
-                <a16:creationId xmlns:a16="http://schemas.microsoft.com/office/drawing/2014/main" id="{5A30BC93-D7C7-4BC5-B0C8-A1A0A3A4CEC1}"/>
+                <a16:creationId xmlns:a16="http://schemas.microsoft.com/office/drawing/2014/main" id="{CCC39814-2343-4D1B-A956-B13FC2BF6AA5}"/>
               </a:ext>
             </a:extLst>
           </p:cNvPr>
@@ -13908,7 +13908,7 @@
           <p:cNvPr id="14" name="outcome-mark">
             <a:extLst xmlns:a="http://schemas.openxmlformats.org/drawingml/2006/main">
               <a:ext uri="{FF2B5EF4-FFF2-40B4-BE49-F238E27FC236}">
-                <a16:creationId xmlns:a16="http://schemas.microsoft.com/office/drawing/2014/main" id="{5D909F34-439B-46C6-A2B4-8D1AF0DC5D6E}"/>
+                <a16:creationId xmlns:a16="http://schemas.microsoft.com/office/drawing/2014/main" id="{906517F7-6235-4092-BE3D-F111EDD56A3D}"/>
               </a:ext>
             </a:extLst>
           </p:cNvPr>
@@ -13943,7 +13943,7 @@
           <p:cNvPr id="15" name="">
             <a:extLst xmlns:a="http://schemas.openxmlformats.org/drawingml/2006/main">
               <a:ext uri="{FF2B5EF4-FFF2-40B4-BE49-F238E27FC236}">
-                <a16:creationId xmlns:a16="http://schemas.microsoft.com/office/drawing/2014/main" id="{F726CBB2-EB71-46B7-BC3D-1F695F03168E}"/>
+                <a16:creationId xmlns:a16="http://schemas.microsoft.com/office/drawing/2014/main" id="{F22757CA-EAF7-495F-A099-99636CD1CF39}"/>
               </a:ext>
             </a:extLst>
           </p:cNvPr>
@@ -14005,7 +14005,7 @@
           <p:cNvPr id="16" name="">
             <a:extLst xmlns:a="http://schemas.openxmlformats.org/drawingml/2006/main">
               <a:ext uri="{FF2B5EF4-FFF2-40B4-BE49-F238E27FC236}">
-                <a16:creationId xmlns:a16="http://schemas.microsoft.com/office/drawing/2014/main" id="{13F1F9BF-018F-4C02-A167-EAA89A38C66D}"/>
+                <a16:creationId xmlns:a16="http://schemas.microsoft.com/office/drawing/2014/main" id="{55EDEEC3-E019-439D-8723-D3448F78CCF5}"/>
               </a:ext>
             </a:extLst>
           </p:cNvPr>
@@ -14094,7 +14094,7 @@
           <p:cNvPr id="17" name="footer-rule-2">
             <a:extLst xmlns:a="http://schemas.openxmlformats.org/drawingml/2006/main">
               <a:ext uri="{FF2B5EF4-FFF2-40B4-BE49-F238E27FC236}">
-                <a16:creationId xmlns:a16="http://schemas.microsoft.com/office/drawing/2014/main" id="{F00AD064-DA15-4DE0-B24B-39D4106CE040}"/>
+                <a16:creationId xmlns:a16="http://schemas.microsoft.com/office/drawing/2014/main" id="{636BB1CB-AE50-41E2-8E0A-122404F509D0}"/>
               </a:ext>
             </a:extLst>
           </p:cNvPr>
@@ -14125,7 +14125,7 @@
           <p:cNvPr id="18" name="footer-label-2">
             <a:extLst xmlns:a="http://schemas.openxmlformats.org/drawingml/2006/main">
               <a:ext uri="{FF2B5EF4-FFF2-40B4-BE49-F238E27FC236}">
-                <a16:creationId xmlns:a16="http://schemas.microsoft.com/office/drawing/2014/main" id="{97C825A9-FD88-4CB5-80DF-68CF15F47B0B}"/>
+                <a16:creationId xmlns:a16="http://schemas.microsoft.com/office/drawing/2014/main" id="{69F0790B-6E69-4F23-9D01-8A2DAD93123F}"/>
               </a:ext>
             </a:extLst>
           </p:cNvPr>
@@ -14187,7 +14187,7 @@
           <p:cNvPr id="19" name="footer-page-2">
             <a:extLst xmlns:a="http://schemas.openxmlformats.org/drawingml/2006/main">
               <a:ext uri="{FF2B5EF4-FFF2-40B4-BE49-F238E27FC236}">
-                <a16:creationId xmlns:a16="http://schemas.microsoft.com/office/drawing/2014/main" id="{6EFEC37C-BC06-483D-BE52-81098144281A}"/>
+                <a16:creationId xmlns:a16="http://schemas.microsoft.com/office/drawing/2014/main" id="{3720C8DD-D98F-492E-BC34-9E4A213EFB18}"/>
               </a:ext>
             </a:extLst>
           </p:cNvPr>
@@ -14247,7 +14247,7 @@
     </p:spTree>
     <p:extLst>
       <p:ext uri="{BB962C8B-B14F-4D97-AF65-F5344CB8AC3E}">
-        <p14:creationId xmlns:p14="http://schemas.microsoft.com/office/powerpoint/2010/main" val="798694613"/>
+        <p14:creationId xmlns:p14="http://schemas.microsoft.com/office/powerpoint/2010/main" val="1746396076"/>
       </p:ext>
     </p:extLst>
   </p:cSld>
@@ -14278,7 +14278,7 @@
           <p:cNvPr id="31" name="side-accent-3">
             <a:extLst xmlns:a="http://schemas.openxmlformats.org/drawingml/2006/main">
               <a:ext uri="{FF2B5EF4-FFF2-40B4-BE49-F238E27FC236}">
-                <a16:creationId xmlns:a16="http://schemas.microsoft.com/office/drawing/2014/main" id="{CC27CB7C-F608-4E2B-A7CD-84FC0F4EA389}"/>
+                <a16:creationId xmlns:a16="http://schemas.microsoft.com/office/drawing/2014/main" id="{6EA24435-49B9-4A62-8B06-A7E2A1706BED}"/>
               </a:ext>
             </a:extLst>
           </p:cNvPr>
@@ -14309,7 +14309,7 @@
           <p:cNvPr id="2" name="kicker-3">
             <a:extLst xmlns:a="http://schemas.openxmlformats.org/drawingml/2006/main">
               <a:ext uri="{FF2B5EF4-FFF2-40B4-BE49-F238E27FC236}">
-                <a16:creationId xmlns:a16="http://schemas.microsoft.com/office/drawing/2014/main" id="{612BB743-7907-4847-AB8F-F46268B3FEEA}"/>
+                <a16:creationId xmlns:a16="http://schemas.microsoft.com/office/drawing/2014/main" id="{3F145EDA-6EB7-45C3-9D4C-A69CC9AD500F}"/>
               </a:ext>
             </a:extLst>
           </p:cNvPr>
@@ -14371,7 +14371,7 @@
           <p:cNvPr id="3" name="title-3">
             <a:extLst xmlns:a="http://schemas.openxmlformats.org/drawingml/2006/main">
               <a:ext uri="{FF2B5EF4-FFF2-40B4-BE49-F238E27FC236}">
-                <a16:creationId xmlns:a16="http://schemas.microsoft.com/office/drawing/2014/main" id="{CB8A3CD5-8558-4921-A964-0CCA60EEEF75}"/>
+                <a16:creationId xmlns:a16="http://schemas.microsoft.com/office/drawing/2014/main" id="{AF2D1107-1AE0-4A09-B5AF-F63E15DBD520}"/>
               </a:ext>
             </a:extLst>
           </p:cNvPr>
@@ -14433,7 +14433,7 @@
           <p:cNvPr id="4" name="">
             <a:extLst xmlns:a="http://schemas.openxmlformats.org/drawingml/2006/main">
               <a:ext uri="{FF2B5EF4-FFF2-40B4-BE49-F238E27FC236}">
-                <a16:creationId xmlns:a16="http://schemas.microsoft.com/office/drawing/2014/main" id="{C51C11EB-9229-4026-A16E-41511132D8B3}"/>
+                <a16:creationId xmlns:a16="http://schemas.microsoft.com/office/drawing/2014/main" id="{EAB535BD-CEE8-4F0A-90D2-9AF93F94AADC}"/>
               </a:ext>
             </a:extLst>
           </p:cNvPr>
@@ -14495,7 +14495,7 @@
           <p:cNvPr id="5" name="system-function-line">
             <a:extLst xmlns:a="http://schemas.openxmlformats.org/drawingml/2006/main">
               <a:ext uri="{FF2B5EF4-FFF2-40B4-BE49-F238E27FC236}">
-                <a16:creationId xmlns:a16="http://schemas.microsoft.com/office/drawing/2014/main" id="{E7D1F0A6-8F3B-431B-B36F-6FF9D6B82E89}"/>
+                <a16:creationId xmlns:a16="http://schemas.microsoft.com/office/drawing/2014/main" id="{8339BDA6-1B83-4137-BEF1-3F4688F3E35B}"/>
               </a:ext>
             </a:extLst>
           </p:cNvPr>
@@ -14526,7 +14526,7 @@
           <p:cNvPr id="6" name="">
             <a:extLst xmlns:a="http://schemas.openxmlformats.org/drawingml/2006/main">
               <a:ext uri="{FF2B5EF4-FFF2-40B4-BE49-F238E27FC236}">
-                <a16:creationId xmlns:a16="http://schemas.microsoft.com/office/drawing/2014/main" id="{198D6A8A-3BEA-4408-86A2-AF9060863C22}"/>
+                <a16:creationId xmlns:a16="http://schemas.microsoft.com/office/drawing/2014/main" id="{34DCBDF1-2BC0-4BFE-B989-C1AA83F3DBAD}"/>
               </a:ext>
             </a:extLst>
           </p:cNvPr>
@@ -14557,7 +14557,7 @@
           <p:cNvPr id="7" name="">
             <a:extLst xmlns:a="http://schemas.openxmlformats.org/drawingml/2006/main">
               <a:ext uri="{FF2B5EF4-FFF2-40B4-BE49-F238E27FC236}">
-                <a16:creationId xmlns:a16="http://schemas.microsoft.com/office/drawing/2014/main" id="{1493A43F-BCA5-4F40-B46B-F1A655F8AD41}"/>
+                <a16:creationId xmlns:a16="http://schemas.microsoft.com/office/drawing/2014/main" id="{7B2B4744-8579-4321-85B5-1CB3A4E6C573}"/>
               </a:ext>
             </a:extLst>
           </p:cNvPr>
@@ -14619,7 +14619,7 @@
           <p:cNvPr id="8" name="">
             <a:extLst xmlns:a="http://schemas.openxmlformats.org/drawingml/2006/main">
               <a:ext uri="{FF2B5EF4-FFF2-40B4-BE49-F238E27FC236}">
-                <a16:creationId xmlns:a16="http://schemas.microsoft.com/office/drawing/2014/main" id="{4277F38E-DF8B-4C32-A017-018DA8F3715B}"/>
+                <a16:creationId xmlns:a16="http://schemas.microsoft.com/office/drawing/2014/main" id="{70EA661C-5237-4B44-8941-BDB2A0107CDD}"/>
               </a:ext>
             </a:extLst>
           </p:cNvPr>
@@ -14681,7 +14681,7 @@
           <p:cNvPr id="9" name="">
             <a:extLst xmlns:a="http://schemas.openxmlformats.org/drawingml/2006/main">
               <a:ext uri="{FF2B5EF4-FFF2-40B4-BE49-F238E27FC236}">
-                <a16:creationId xmlns:a16="http://schemas.microsoft.com/office/drawing/2014/main" id="{B67B1A35-C65E-49AB-91DD-575FBD9B7D73}"/>
+                <a16:creationId xmlns:a16="http://schemas.microsoft.com/office/drawing/2014/main" id="{FAB82052-9BCF-4337-9B5F-41C4CE21266D}"/>
               </a:ext>
             </a:extLst>
           </p:cNvPr>
@@ -14743,7 +14743,7 @@
           <p:cNvPr id="10" name="">
             <a:extLst xmlns:a="http://schemas.openxmlformats.org/drawingml/2006/main">
               <a:ext uri="{FF2B5EF4-FFF2-40B4-BE49-F238E27FC236}">
-                <a16:creationId xmlns:a16="http://schemas.microsoft.com/office/drawing/2014/main" id="{57C778D2-1299-457C-8805-D7F201F457C0}"/>
+                <a16:creationId xmlns:a16="http://schemas.microsoft.com/office/drawing/2014/main" id="{019B34FA-9544-4A7F-9FCA-8C5C0C37F54D}"/>
               </a:ext>
             </a:extLst>
           </p:cNvPr>
@@ -14774,7 +14774,7 @@
           <p:cNvPr id="11" name="">
             <a:extLst xmlns:a="http://schemas.openxmlformats.org/drawingml/2006/main">
               <a:ext uri="{FF2B5EF4-FFF2-40B4-BE49-F238E27FC236}">
-                <a16:creationId xmlns:a16="http://schemas.microsoft.com/office/drawing/2014/main" id="{E5E4EAB3-9F4C-4C4D-8F4F-8EC5D6FC890A}"/>
+                <a16:creationId xmlns:a16="http://schemas.microsoft.com/office/drawing/2014/main" id="{DC059392-B19D-4798-9B5B-CC9BF4BA56DC}"/>
               </a:ext>
             </a:extLst>
           </p:cNvPr>
@@ -14836,7 +14836,7 @@
           <p:cNvPr id="12" name="">
             <a:extLst xmlns:a="http://schemas.openxmlformats.org/drawingml/2006/main">
               <a:ext uri="{FF2B5EF4-FFF2-40B4-BE49-F238E27FC236}">
-                <a16:creationId xmlns:a16="http://schemas.microsoft.com/office/drawing/2014/main" id="{1CAB7327-6D63-4570-B8F4-9257A27F6673}"/>
+                <a16:creationId xmlns:a16="http://schemas.microsoft.com/office/drawing/2014/main" id="{8706CDAF-E916-4157-AA86-2C6ADD3A8C7F}"/>
               </a:ext>
             </a:extLst>
           </p:cNvPr>
@@ -14898,7 +14898,7 @@
           <p:cNvPr id="13" name="">
             <a:extLst xmlns:a="http://schemas.openxmlformats.org/drawingml/2006/main">
               <a:ext uri="{FF2B5EF4-FFF2-40B4-BE49-F238E27FC236}">
-                <a16:creationId xmlns:a16="http://schemas.microsoft.com/office/drawing/2014/main" id="{4BF6164B-EF33-4FD5-954B-9E1E6C8073EA}"/>
+                <a16:creationId xmlns:a16="http://schemas.microsoft.com/office/drawing/2014/main" id="{C3340CE9-1ED0-4A21-B726-DEC97FB13F2F}"/>
               </a:ext>
             </a:extLst>
           </p:cNvPr>
@@ -14960,7 +14960,7 @@
           <p:cNvPr id="14" name="">
             <a:extLst xmlns:a="http://schemas.openxmlformats.org/drawingml/2006/main">
               <a:ext uri="{FF2B5EF4-FFF2-40B4-BE49-F238E27FC236}">
-                <a16:creationId xmlns:a16="http://schemas.microsoft.com/office/drawing/2014/main" id="{E80C5504-D4B7-43ED-B03C-8B4D62D7F168}"/>
+                <a16:creationId xmlns:a16="http://schemas.microsoft.com/office/drawing/2014/main" id="{D8C34B91-912A-48D4-AA41-7348AE222165}"/>
               </a:ext>
             </a:extLst>
           </p:cNvPr>
@@ -14991,7 +14991,7 @@
           <p:cNvPr id="15" name="">
             <a:extLst xmlns:a="http://schemas.openxmlformats.org/drawingml/2006/main">
               <a:ext uri="{FF2B5EF4-FFF2-40B4-BE49-F238E27FC236}">
-                <a16:creationId xmlns:a16="http://schemas.microsoft.com/office/drawing/2014/main" id="{542C5F19-0264-4766-B811-CD9C4CA614E8}"/>
+                <a16:creationId xmlns:a16="http://schemas.microsoft.com/office/drawing/2014/main" id="{7E4EA6F5-C412-44DC-9E36-F00951EDD44F}"/>
               </a:ext>
             </a:extLst>
           </p:cNvPr>
@@ -15053,7 +15053,7 @@
           <p:cNvPr id="16" name="">
             <a:extLst xmlns:a="http://schemas.openxmlformats.org/drawingml/2006/main">
               <a:ext uri="{FF2B5EF4-FFF2-40B4-BE49-F238E27FC236}">
-                <a16:creationId xmlns:a16="http://schemas.microsoft.com/office/drawing/2014/main" id="{53B1E18B-8C23-43E4-9C0E-919980261401}"/>
+                <a16:creationId xmlns:a16="http://schemas.microsoft.com/office/drawing/2014/main" id="{C38F2214-AF5D-4847-A18D-5C32CD0FEE81}"/>
               </a:ext>
             </a:extLst>
           </p:cNvPr>
@@ -15115,7 +15115,7 @@
           <p:cNvPr id="17" name="">
             <a:extLst xmlns:a="http://schemas.openxmlformats.org/drawingml/2006/main">
               <a:ext uri="{FF2B5EF4-FFF2-40B4-BE49-F238E27FC236}">
-                <a16:creationId xmlns:a16="http://schemas.microsoft.com/office/drawing/2014/main" id="{A2EDF3C5-6DE0-44A5-9F57-09ABE3828026}"/>
+                <a16:creationId xmlns:a16="http://schemas.microsoft.com/office/drawing/2014/main" id="{48F0624F-EFF6-4A5A-AA86-2D29AC4BBD12}"/>
               </a:ext>
             </a:extLst>
           </p:cNvPr>
@@ -15177,7 +15177,7 @@
           <p:cNvPr id="18" name="">
             <a:extLst xmlns:a="http://schemas.openxmlformats.org/drawingml/2006/main">
               <a:ext uri="{FF2B5EF4-FFF2-40B4-BE49-F238E27FC236}">
-                <a16:creationId xmlns:a16="http://schemas.microsoft.com/office/drawing/2014/main" id="{387D24D0-6B14-4090-941A-C119E9A4AB1A}"/>
+                <a16:creationId xmlns:a16="http://schemas.microsoft.com/office/drawing/2014/main" id="{AD7A283B-BD7B-4934-988A-C5EB89E41264}"/>
               </a:ext>
             </a:extLst>
           </p:cNvPr>
@@ -15208,7 +15208,7 @@
           <p:cNvPr id="19" name="">
             <a:extLst xmlns:a="http://schemas.openxmlformats.org/drawingml/2006/main">
               <a:ext uri="{FF2B5EF4-FFF2-40B4-BE49-F238E27FC236}">
-                <a16:creationId xmlns:a16="http://schemas.microsoft.com/office/drawing/2014/main" id="{84976EEB-23E7-4C28-B364-AC17D17C66A5}"/>
+                <a16:creationId xmlns:a16="http://schemas.microsoft.com/office/drawing/2014/main" id="{923E5D89-7A50-4595-9203-F56F90EA9884}"/>
               </a:ext>
             </a:extLst>
           </p:cNvPr>
@@ -15270,7 +15270,7 @@
           <p:cNvPr id="20" name="">
             <a:extLst xmlns:a="http://schemas.openxmlformats.org/drawingml/2006/main">
               <a:ext uri="{FF2B5EF4-FFF2-40B4-BE49-F238E27FC236}">
-                <a16:creationId xmlns:a16="http://schemas.microsoft.com/office/drawing/2014/main" id="{4029ACE9-1C96-4F3D-B29E-3D39619EEB09}"/>
+                <a16:creationId xmlns:a16="http://schemas.microsoft.com/office/drawing/2014/main" id="{7EF62850-3BCD-4F56-BFF6-BEF4D4558B5F}"/>
               </a:ext>
             </a:extLst>
           </p:cNvPr>
@@ -15332,7 +15332,7 @@
           <p:cNvPr id="21" name="">
             <a:extLst xmlns:a="http://schemas.openxmlformats.org/drawingml/2006/main">
               <a:ext uri="{FF2B5EF4-FFF2-40B4-BE49-F238E27FC236}">
-                <a16:creationId xmlns:a16="http://schemas.microsoft.com/office/drawing/2014/main" id="{AF48EBAC-0271-4771-930C-FB749B0FF24F}"/>
+                <a16:creationId xmlns:a16="http://schemas.microsoft.com/office/drawing/2014/main" id="{A505B241-948A-43DF-9FEC-D0016D6E622E}"/>
               </a:ext>
             </a:extLst>
           </p:cNvPr>
@@ -15394,7 +15394,7 @@
           <p:cNvPr id="22" name="">
             <a:extLst xmlns:a="http://schemas.openxmlformats.org/drawingml/2006/main">
               <a:ext uri="{FF2B5EF4-FFF2-40B4-BE49-F238E27FC236}">
-                <a16:creationId xmlns:a16="http://schemas.microsoft.com/office/drawing/2014/main" id="{87B0AF29-6706-4ED2-BDF3-C285E6A16805}"/>
+                <a16:creationId xmlns:a16="http://schemas.microsoft.com/office/drawing/2014/main" id="{83A2D3C3-3A6B-4AAA-AE53-B3D069F36B80}"/>
               </a:ext>
             </a:extLst>
           </p:cNvPr>
@@ -15425,7 +15425,7 @@
           <p:cNvPr id="23" name="">
             <a:extLst xmlns:a="http://schemas.openxmlformats.org/drawingml/2006/main">
               <a:ext uri="{FF2B5EF4-FFF2-40B4-BE49-F238E27FC236}">
-                <a16:creationId xmlns:a16="http://schemas.microsoft.com/office/drawing/2014/main" id="{AEADBC2E-5D84-43AA-B461-515D84112EBC}"/>
+                <a16:creationId xmlns:a16="http://schemas.microsoft.com/office/drawing/2014/main" id="{506E4853-5085-4444-B286-F87E3C9B25B3}"/>
               </a:ext>
             </a:extLst>
           </p:cNvPr>
@@ -15487,7 +15487,7 @@
           <p:cNvPr id="24" name="">
             <a:extLst xmlns:a="http://schemas.openxmlformats.org/drawingml/2006/main">
               <a:ext uri="{FF2B5EF4-FFF2-40B4-BE49-F238E27FC236}">
-                <a16:creationId xmlns:a16="http://schemas.microsoft.com/office/drawing/2014/main" id="{0E6FBA1F-D0F3-4E58-BFBF-357CB232BB8E}"/>
+                <a16:creationId xmlns:a16="http://schemas.microsoft.com/office/drawing/2014/main" id="{5C4CE50A-2626-4372-949F-14AFD00560CD}"/>
               </a:ext>
             </a:extLst>
           </p:cNvPr>
@@ -15549,7 +15549,7 @@
           <p:cNvPr id="25" name="">
             <a:extLst xmlns:a="http://schemas.openxmlformats.org/drawingml/2006/main">
               <a:ext uri="{FF2B5EF4-FFF2-40B4-BE49-F238E27FC236}">
-                <a16:creationId xmlns:a16="http://schemas.microsoft.com/office/drawing/2014/main" id="{641546FB-61FA-4016-9BA5-ED9E4CE370B5}"/>
+                <a16:creationId xmlns:a16="http://schemas.microsoft.com/office/drawing/2014/main" id="{A849BDAD-E66E-43AC-B959-E827719E2360}"/>
               </a:ext>
             </a:extLst>
           </p:cNvPr>
@@ -15611,7 +15611,7 @@
           <p:cNvPr id="26" name="">
             <a:extLst xmlns:a="http://schemas.openxmlformats.org/drawingml/2006/main">
               <a:ext uri="{FF2B5EF4-FFF2-40B4-BE49-F238E27FC236}">
-                <a16:creationId xmlns:a16="http://schemas.microsoft.com/office/drawing/2014/main" id="{03D7451E-97C4-44DB-965C-56F9C83C630A}"/>
+                <a16:creationId xmlns:a16="http://schemas.microsoft.com/office/drawing/2014/main" id="{37260AC6-EF2E-4F98-90E7-94C20EBA32F1}"/>
               </a:ext>
             </a:extLst>
           </p:cNvPr>
@@ -15644,7 +15644,7 @@
           <p:cNvPr id="27" name="">
             <a:extLst xmlns:a="http://schemas.openxmlformats.org/drawingml/2006/main">
               <a:ext uri="{FF2B5EF4-FFF2-40B4-BE49-F238E27FC236}">
-                <a16:creationId xmlns:a16="http://schemas.microsoft.com/office/drawing/2014/main" id="{5268F9C3-B678-42CA-BDF7-79A09180D27A}"/>
+                <a16:creationId xmlns:a16="http://schemas.microsoft.com/office/drawing/2014/main" id="{2FDE013D-B55B-463A-A629-0C24F05F473D}"/>
               </a:ext>
             </a:extLst>
           </p:cNvPr>
@@ -15706,7 +15706,7 @@
           <p:cNvPr id="28" name="footer-rule-3">
             <a:extLst xmlns:a="http://schemas.openxmlformats.org/drawingml/2006/main">
               <a:ext uri="{FF2B5EF4-FFF2-40B4-BE49-F238E27FC236}">
-                <a16:creationId xmlns:a16="http://schemas.microsoft.com/office/drawing/2014/main" id="{0523BDB6-D632-47AC-AA40-6E1FEAED5548}"/>
+                <a16:creationId xmlns:a16="http://schemas.microsoft.com/office/drawing/2014/main" id="{2F970D33-3934-4C6C-9FA3-7DD3D9CDD281}"/>
               </a:ext>
             </a:extLst>
           </p:cNvPr>
@@ -15737,7 +15737,7 @@
           <p:cNvPr id="29" name="footer-label-3">
             <a:extLst xmlns:a="http://schemas.openxmlformats.org/drawingml/2006/main">
               <a:ext uri="{FF2B5EF4-FFF2-40B4-BE49-F238E27FC236}">
-                <a16:creationId xmlns:a16="http://schemas.microsoft.com/office/drawing/2014/main" id="{42354588-35B6-494E-AF54-5D073DC7C43D}"/>
+                <a16:creationId xmlns:a16="http://schemas.microsoft.com/office/drawing/2014/main" id="{68F0F43C-1BE2-443A-8786-B8769A13DA28}"/>
               </a:ext>
             </a:extLst>
           </p:cNvPr>
@@ -15799,7 +15799,7 @@
           <p:cNvPr id="30" name="footer-page-3">
             <a:extLst xmlns:a="http://schemas.openxmlformats.org/drawingml/2006/main">
               <a:ext uri="{FF2B5EF4-FFF2-40B4-BE49-F238E27FC236}">
-                <a16:creationId xmlns:a16="http://schemas.microsoft.com/office/drawing/2014/main" id="{B8D83A2A-3223-4C3C-82F3-2D753BE73B41}"/>
+                <a16:creationId xmlns:a16="http://schemas.microsoft.com/office/drawing/2014/main" id="{24C9EC6C-C09E-48BB-8D02-384DF43A3B78}"/>
               </a:ext>
             </a:extLst>
           </p:cNvPr>
@@ -15859,7 +15859,7 @@
     </p:spTree>
     <p:extLst>
       <p:ext uri="{BB962C8B-B14F-4D97-AF65-F5344CB8AC3E}">
-        <p14:creationId xmlns:p14="http://schemas.microsoft.com/office/powerpoint/2010/main" val="1173242664"/>
+        <p14:creationId xmlns:p14="http://schemas.microsoft.com/office/powerpoint/2010/main" val="1929736205"/>
       </p:ext>
     </p:extLst>
   </p:cSld>
@@ -15890,7 +15890,7 @@
           <p:cNvPr id="28" name="side-accent-4">
             <a:extLst xmlns:a="http://schemas.openxmlformats.org/drawingml/2006/main">
               <a:ext uri="{FF2B5EF4-FFF2-40B4-BE49-F238E27FC236}">
-                <a16:creationId xmlns:a16="http://schemas.microsoft.com/office/drawing/2014/main" id="{D18D29E8-5D22-4083-86B2-8930A64A550A}"/>
+                <a16:creationId xmlns:a16="http://schemas.microsoft.com/office/drawing/2014/main" id="{277BA8FF-AAEA-4C50-915A-4C1FF0C85F92}"/>
               </a:ext>
             </a:extLst>
           </p:cNvPr>
@@ -15921,7 +15921,7 @@
           <p:cNvPr id="2" name="kicker-4">
             <a:extLst xmlns:a="http://schemas.openxmlformats.org/drawingml/2006/main">
               <a:ext uri="{FF2B5EF4-FFF2-40B4-BE49-F238E27FC236}">
-                <a16:creationId xmlns:a16="http://schemas.microsoft.com/office/drawing/2014/main" id="{06A63D43-5AA8-44E5-9077-DFA3BC862A88}"/>
+                <a16:creationId xmlns:a16="http://schemas.microsoft.com/office/drawing/2014/main" id="{BBEF98C0-0FE1-48DC-977C-1CF0B8D49CC3}"/>
               </a:ext>
             </a:extLst>
           </p:cNvPr>
@@ -15983,7 +15983,7 @@
           <p:cNvPr id="3" name="title-4">
             <a:extLst xmlns:a="http://schemas.openxmlformats.org/drawingml/2006/main">
               <a:ext uri="{FF2B5EF4-FFF2-40B4-BE49-F238E27FC236}">
-                <a16:creationId xmlns:a16="http://schemas.microsoft.com/office/drawing/2014/main" id="{A07C7D98-86FF-4789-B2D5-BCA7E19250EE}"/>
+                <a16:creationId xmlns:a16="http://schemas.microsoft.com/office/drawing/2014/main" id="{6823376E-EB38-486F-A9A2-9FDEF36B8D42}"/>
               </a:ext>
             </a:extLst>
           </p:cNvPr>
@@ -16045,7 +16045,7 @@
           <p:cNvPr id="4" name="">
             <a:extLst xmlns:a="http://schemas.openxmlformats.org/drawingml/2006/main">
               <a:ext uri="{FF2B5EF4-FFF2-40B4-BE49-F238E27FC236}">
-                <a16:creationId xmlns:a16="http://schemas.microsoft.com/office/drawing/2014/main" id="{8D8B1C69-1613-40E1-90C4-9D29109ED431}"/>
+                <a16:creationId xmlns:a16="http://schemas.microsoft.com/office/drawing/2014/main" id="{B3B850FE-F384-4DAB-B96B-8481879D3899}"/>
               </a:ext>
             </a:extLst>
           </p:cNvPr>
@@ -16107,7 +16107,7 @@
           <p:cNvPr id="5" name="">
             <a:extLst xmlns:a="http://schemas.openxmlformats.org/drawingml/2006/main">
               <a:ext uri="{FF2B5EF4-FFF2-40B4-BE49-F238E27FC236}">
-                <a16:creationId xmlns:a16="http://schemas.microsoft.com/office/drawing/2014/main" id="{42A16EF2-AC5F-4F95-9103-4A4788CB3B48}"/>
+                <a16:creationId xmlns:a16="http://schemas.microsoft.com/office/drawing/2014/main" id="{743D2EB1-727D-4B03-8448-20CF1267E6B5}"/>
               </a:ext>
             </a:extLst>
           </p:cNvPr>
@@ -16169,7 +16169,7 @@
           <p:cNvPr id="6" name="">
             <a:extLst xmlns:a="http://schemas.openxmlformats.org/drawingml/2006/main">
               <a:ext uri="{FF2B5EF4-FFF2-40B4-BE49-F238E27FC236}">
-                <a16:creationId xmlns:a16="http://schemas.microsoft.com/office/drawing/2014/main" id="{924D38AA-8442-4B30-8027-E68C97FB5904}"/>
+                <a16:creationId xmlns:a16="http://schemas.microsoft.com/office/drawing/2014/main" id="{C2CCC9C7-1E99-43FB-875F-94B7005B9E57}"/>
               </a:ext>
             </a:extLst>
           </p:cNvPr>
@@ -16231,7 +16231,7 @@
           <p:cNvPr id="7" name="">
             <a:extLst xmlns:a="http://schemas.openxmlformats.org/drawingml/2006/main">
               <a:ext uri="{FF2B5EF4-FFF2-40B4-BE49-F238E27FC236}">
-                <a16:creationId xmlns:a16="http://schemas.microsoft.com/office/drawing/2014/main" id="{C292FA0B-997D-4071-BBD2-A1786256A89C}"/>
+                <a16:creationId xmlns:a16="http://schemas.microsoft.com/office/drawing/2014/main" id="{CB3A9687-EECC-44C4-8EA3-6CD8AA317D6C}"/>
               </a:ext>
             </a:extLst>
           </p:cNvPr>
@@ -16262,7 +16262,7 @@
           <p:cNvPr id="8" name="">
             <a:extLst xmlns:a="http://schemas.openxmlformats.org/drawingml/2006/main">
               <a:ext uri="{FF2B5EF4-FFF2-40B4-BE49-F238E27FC236}">
-                <a16:creationId xmlns:a16="http://schemas.microsoft.com/office/drawing/2014/main" id="{2B1C1262-AE07-4CF4-9F40-B6F5CE89580D}"/>
+                <a16:creationId xmlns:a16="http://schemas.microsoft.com/office/drawing/2014/main" id="{8A1220AD-F58D-48FE-9D76-40F204C861D7}"/>
               </a:ext>
             </a:extLst>
           </p:cNvPr>
@@ -16324,7 +16324,7 @@
           <p:cNvPr id="9" name="">
             <a:extLst xmlns:a="http://schemas.openxmlformats.org/drawingml/2006/main">
               <a:ext uri="{FF2B5EF4-FFF2-40B4-BE49-F238E27FC236}">
-                <a16:creationId xmlns:a16="http://schemas.microsoft.com/office/drawing/2014/main" id="{D03660B5-D112-459C-91C4-1191B9E761EB}"/>
+                <a16:creationId xmlns:a16="http://schemas.microsoft.com/office/drawing/2014/main" id="{7CD6D16C-7FC7-4FF4-8953-1B8C16155117}"/>
               </a:ext>
             </a:extLst>
           </p:cNvPr>
@@ -16386,7 +16386,7 @@
           <p:cNvPr id="10" name="">
             <a:extLst xmlns:a="http://schemas.openxmlformats.org/drawingml/2006/main">
               <a:ext uri="{FF2B5EF4-FFF2-40B4-BE49-F238E27FC236}">
-                <a16:creationId xmlns:a16="http://schemas.microsoft.com/office/drawing/2014/main" id="{C50F5E57-00C0-4D87-834E-BB9330DAB33D}"/>
+                <a16:creationId xmlns:a16="http://schemas.microsoft.com/office/drawing/2014/main" id="{5F493DFA-5E06-4F57-935F-B03B6A209343}"/>
               </a:ext>
             </a:extLst>
           </p:cNvPr>
@@ -16448,7 +16448,7 @@
           <p:cNvPr id="11" name="">
             <a:extLst xmlns:a="http://schemas.openxmlformats.org/drawingml/2006/main">
               <a:ext uri="{FF2B5EF4-FFF2-40B4-BE49-F238E27FC236}">
-                <a16:creationId xmlns:a16="http://schemas.microsoft.com/office/drawing/2014/main" id="{82D9B906-E2BC-4689-ACFF-B9CA0A379DF8}"/>
+                <a16:creationId xmlns:a16="http://schemas.microsoft.com/office/drawing/2014/main" id="{74E6835B-F2D3-457D-ABB1-A0E3AE0A8385}"/>
               </a:ext>
             </a:extLst>
           </p:cNvPr>
@@ -16479,7 +16479,7 @@
           <p:cNvPr id="12" name="">
             <a:extLst xmlns:a="http://schemas.openxmlformats.org/drawingml/2006/main">
               <a:ext uri="{FF2B5EF4-FFF2-40B4-BE49-F238E27FC236}">
-                <a16:creationId xmlns:a16="http://schemas.microsoft.com/office/drawing/2014/main" id="{C5647003-DA5D-428A-891C-CDD05367232A}"/>
+                <a16:creationId xmlns:a16="http://schemas.microsoft.com/office/drawing/2014/main" id="{507D6753-1A63-4DC9-880E-822FD545A00D}"/>
               </a:ext>
             </a:extLst>
           </p:cNvPr>
@@ -16541,7 +16541,7 @@
           <p:cNvPr id="13" name="">
             <a:extLst xmlns:a="http://schemas.openxmlformats.org/drawingml/2006/main">
               <a:ext uri="{FF2B5EF4-FFF2-40B4-BE49-F238E27FC236}">
-                <a16:creationId xmlns:a16="http://schemas.microsoft.com/office/drawing/2014/main" id="{C3379F28-6511-4160-BA8C-A3BC92DB1373}"/>
+                <a16:creationId xmlns:a16="http://schemas.microsoft.com/office/drawing/2014/main" id="{63F540DD-CB48-4579-A501-26FC3ECE006E}"/>
               </a:ext>
             </a:extLst>
           </p:cNvPr>
@@ -16603,7 +16603,7 @@
           <p:cNvPr id="14" name="">
             <a:extLst xmlns:a="http://schemas.openxmlformats.org/drawingml/2006/main">
               <a:ext uri="{FF2B5EF4-FFF2-40B4-BE49-F238E27FC236}">
-                <a16:creationId xmlns:a16="http://schemas.microsoft.com/office/drawing/2014/main" id="{7A4C8DE6-0EF6-4EFF-B0A6-CEAC33F7BC97}"/>
+                <a16:creationId xmlns:a16="http://schemas.microsoft.com/office/drawing/2014/main" id="{8CA2852F-657B-4411-8E2F-8B954663C6EB}"/>
               </a:ext>
             </a:extLst>
           </p:cNvPr>
@@ -16665,7 +16665,7 @@
           <p:cNvPr id="15" name="">
             <a:extLst xmlns:a="http://schemas.openxmlformats.org/drawingml/2006/main">
               <a:ext uri="{FF2B5EF4-FFF2-40B4-BE49-F238E27FC236}">
-                <a16:creationId xmlns:a16="http://schemas.microsoft.com/office/drawing/2014/main" id="{F973937D-4CC6-4209-BED0-E595A37EE2BD}"/>
+                <a16:creationId xmlns:a16="http://schemas.microsoft.com/office/drawing/2014/main" id="{D98C3725-D0AA-43E0-BB87-1D1713912A6B}"/>
               </a:ext>
             </a:extLst>
           </p:cNvPr>
@@ -16696,7 +16696,7 @@
           <p:cNvPr id="16" name="">
             <a:extLst xmlns:a="http://schemas.openxmlformats.org/drawingml/2006/main">
               <a:ext uri="{FF2B5EF4-FFF2-40B4-BE49-F238E27FC236}">
-                <a16:creationId xmlns:a16="http://schemas.microsoft.com/office/drawing/2014/main" id="{276ECD87-BCFB-4F80-B0E4-EFDB6EC52302}"/>
+                <a16:creationId xmlns:a16="http://schemas.microsoft.com/office/drawing/2014/main" id="{70393BEA-0994-460C-AEC1-8D76699EF6E1}"/>
               </a:ext>
             </a:extLst>
           </p:cNvPr>
@@ -16758,7 +16758,7 @@
           <p:cNvPr id="17" name="">
             <a:extLst xmlns:a="http://schemas.openxmlformats.org/drawingml/2006/main">
               <a:ext uri="{FF2B5EF4-FFF2-40B4-BE49-F238E27FC236}">
-                <a16:creationId xmlns:a16="http://schemas.microsoft.com/office/drawing/2014/main" id="{50B6B961-1CC8-4C10-A802-2B19E063EE51}"/>
+                <a16:creationId xmlns:a16="http://schemas.microsoft.com/office/drawing/2014/main" id="{86868B60-9B3A-4590-BD4E-A879A1A485B4}"/>
               </a:ext>
             </a:extLst>
           </p:cNvPr>
@@ -16820,7 +16820,7 @@
           <p:cNvPr id="18" name="">
             <a:extLst xmlns:a="http://schemas.openxmlformats.org/drawingml/2006/main">
               <a:ext uri="{FF2B5EF4-FFF2-40B4-BE49-F238E27FC236}">
-                <a16:creationId xmlns:a16="http://schemas.microsoft.com/office/drawing/2014/main" id="{8CC93A1B-33F6-4C2A-82AE-A46A84814E27}"/>
+                <a16:creationId xmlns:a16="http://schemas.microsoft.com/office/drawing/2014/main" id="{42BDFEC8-E08A-47BF-8852-4007503F5270}"/>
               </a:ext>
             </a:extLst>
           </p:cNvPr>
@@ -16882,7 +16882,7 @@
           <p:cNvPr id="19" name="">
             <a:extLst xmlns:a="http://schemas.openxmlformats.org/drawingml/2006/main">
               <a:ext uri="{FF2B5EF4-FFF2-40B4-BE49-F238E27FC236}">
-                <a16:creationId xmlns:a16="http://schemas.microsoft.com/office/drawing/2014/main" id="{147CD1BD-3104-4405-BA35-972195FBA0CD}"/>
+                <a16:creationId xmlns:a16="http://schemas.microsoft.com/office/drawing/2014/main" id="{1822F0C0-6B8D-4C6C-86A3-16C436310744}"/>
               </a:ext>
             </a:extLst>
           </p:cNvPr>
@@ -16913,7 +16913,7 @@
           <p:cNvPr id="20" name="">
             <a:extLst xmlns:a="http://schemas.openxmlformats.org/drawingml/2006/main">
               <a:ext uri="{FF2B5EF4-FFF2-40B4-BE49-F238E27FC236}">
-                <a16:creationId xmlns:a16="http://schemas.microsoft.com/office/drawing/2014/main" id="{E69DA737-321B-4F22-9555-68AF49F91670}"/>
+                <a16:creationId xmlns:a16="http://schemas.microsoft.com/office/drawing/2014/main" id="{1B6C2235-956F-4EF3-8F0D-D398416E74A1}"/>
               </a:ext>
             </a:extLst>
           </p:cNvPr>
@@ -16975,7 +16975,7 @@
           <p:cNvPr id="21" name="">
             <a:extLst xmlns:a="http://schemas.openxmlformats.org/drawingml/2006/main">
               <a:ext uri="{FF2B5EF4-FFF2-40B4-BE49-F238E27FC236}">
-                <a16:creationId xmlns:a16="http://schemas.microsoft.com/office/drawing/2014/main" id="{9E5A317A-FD10-423E-8B26-890727FA3F31}"/>
+                <a16:creationId xmlns:a16="http://schemas.microsoft.com/office/drawing/2014/main" id="{68B6F766-E384-4946-BC75-7FAEA72CD339}"/>
               </a:ext>
             </a:extLst>
           </p:cNvPr>
@@ -17037,7 +17037,7 @@
           <p:cNvPr id="22" name="">
             <a:extLst xmlns:a="http://schemas.openxmlformats.org/drawingml/2006/main">
               <a:ext uri="{FF2B5EF4-FFF2-40B4-BE49-F238E27FC236}">
-                <a16:creationId xmlns:a16="http://schemas.microsoft.com/office/drawing/2014/main" id="{20074870-4C18-4432-9EF8-8809DCB6E46B}"/>
+                <a16:creationId xmlns:a16="http://schemas.microsoft.com/office/drawing/2014/main" id="{1C64210C-EFC8-4D92-B1D3-CEC6457C9358}"/>
               </a:ext>
             </a:extLst>
           </p:cNvPr>
@@ -17099,7 +17099,7 @@
           <p:cNvPr id="23" name="">
             <a:extLst xmlns:a="http://schemas.openxmlformats.org/drawingml/2006/main">
               <a:ext uri="{FF2B5EF4-FFF2-40B4-BE49-F238E27FC236}">
-                <a16:creationId xmlns:a16="http://schemas.microsoft.com/office/drawing/2014/main" id="{7EDD442F-89FE-454A-965B-9C39B4B56B4C}"/>
+                <a16:creationId xmlns:a16="http://schemas.microsoft.com/office/drawing/2014/main" id="{6F226FBC-2910-41EF-B8AE-377256B3AB42}"/>
               </a:ext>
             </a:extLst>
           </p:cNvPr>
@@ -17132,7 +17132,7 @@
           <p:cNvPr id="24" name="">
             <a:extLst xmlns:a="http://schemas.openxmlformats.org/drawingml/2006/main">
               <a:ext uri="{FF2B5EF4-FFF2-40B4-BE49-F238E27FC236}">
-                <a16:creationId xmlns:a16="http://schemas.microsoft.com/office/drawing/2014/main" id="{B45BDA5F-E4F2-4884-928D-A3F4CCF1FE6D}"/>
+                <a16:creationId xmlns:a16="http://schemas.microsoft.com/office/drawing/2014/main" id="{700576CC-4EB9-45A7-8E7A-D1C675BDCC75}"/>
               </a:ext>
             </a:extLst>
           </p:cNvPr>
@@ -17194,7 +17194,7 @@
           <p:cNvPr id="25" name="footer-rule-4">
             <a:extLst xmlns:a="http://schemas.openxmlformats.org/drawingml/2006/main">
               <a:ext uri="{FF2B5EF4-FFF2-40B4-BE49-F238E27FC236}">
-                <a16:creationId xmlns:a16="http://schemas.microsoft.com/office/drawing/2014/main" id="{533F35AB-BA18-4A24-ABC5-26562E6386DC}"/>
+                <a16:creationId xmlns:a16="http://schemas.microsoft.com/office/drawing/2014/main" id="{C962899B-FE40-40A2-8A09-A68BC5508568}"/>
               </a:ext>
             </a:extLst>
           </p:cNvPr>
@@ -17225,7 +17225,7 @@
           <p:cNvPr id="26" name="footer-label-4">
             <a:extLst xmlns:a="http://schemas.openxmlformats.org/drawingml/2006/main">
               <a:ext uri="{FF2B5EF4-FFF2-40B4-BE49-F238E27FC236}">
-                <a16:creationId xmlns:a16="http://schemas.microsoft.com/office/drawing/2014/main" id="{F9676D34-A6C9-486A-BE6F-3DE6D6357011}"/>
+                <a16:creationId xmlns:a16="http://schemas.microsoft.com/office/drawing/2014/main" id="{3AB4DF54-C674-4D3A-9750-A22D22488231}"/>
               </a:ext>
             </a:extLst>
           </p:cNvPr>
@@ -17287,7 +17287,7 @@
           <p:cNvPr id="27" name="footer-page-4">
             <a:extLst xmlns:a="http://schemas.openxmlformats.org/drawingml/2006/main">
               <a:ext uri="{FF2B5EF4-FFF2-40B4-BE49-F238E27FC236}">
-                <a16:creationId xmlns:a16="http://schemas.microsoft.com/office/drawing/2014/main" id="{EFB99EAA-5954-4318-B0DD-B3443564F913}"/>
+                <a16:creationId xmlns:a16="http://schemas.microsoft.com/office/drawing/2014/main" id="{8CBD13CE-DCFD-4A1D-8119-8A1AB5397380}"/>
               </a:ext>
             </a:extLst>
           </p:cNvPr>
@@ -17347,7 +17347,7 @@
     </p:spTree>
     <p:extLst>
       <p:ext uri="{BB962C8B-B14F-4D97-AF65-F5344CB8AC3E}">
-        <p14:creationId xmlns:p14="http://schemas.microsoft.com/office/powerpoint/2010/main" val="1705209886"/>
+        <p14:creationId xmlns:p14="http://schemas.microsoft.com/office/powerpoint/2010/main" val="1673515504"/>
       </p:ext>
     </p:extLst>
   </p:cSld>
@@ -17378,7 +17378,7 @@
           <p:cNvPr id="31" name="side-accent-5">
             <a:extLst xmlns:a="http://schemas.openxmlformats.org/drawingml/2006/main">
               <a:ext uri="{FF2B5EF4-FFF2-40B4-BE49-F238E27FC236}">
-                <a16:creationId xmlns:a16="http://schemas.microsoft.com/office/drawing/2014/main" id="{20454ECD-EC9C-4E1B-906C-5C8B87D3B3BE}"/>
+                <a16:creationId xmlns:a16="http://schemas.microsoft.com/office/drawing/2014/main" id="{68926CA1-8407-44A7-ACB1-5B17E7BBE723}"/>
               </a:ext>
             </a:extLst>
           </p:cNvPr>
@@ -17409,7 +17409,7 @@
           <p:cNvPr id="2" name="kicker-5">
             <a:extLst xmlns:a="http://schemas.openxmlformats.org/drawingml/2006/main">
               <a:ext uri="{FF2B5EF4-FFF2-40B4-BE49-F238E27FC236}">
-                <a16:creationId xmlns:a16="http://schemas.microsoft.com/office/drawing/2014/main" id="{4C23934D-1678-4323-81E1-418F96B9CBDE}"/>
+                <a16:creationId xmlns:a16="http://schemas.microsoft.com/office/drawing/2014/main" id="{C9F6716A-C31E-4420-BA1F-7D6282D75E6D}"/>
               </a:ext>
             </a:extLst>
           </p:cNvPr>
@@ -17471,7 +17471,7 @@
           <p:cNvPr id="3" name="title-5">
             <a:extLst xmlns:a="http://schemas.openxmlformats.org/drawingml/2006/main">
               <a:ext uri="{FF2B5EF4-FFF2-40B4-BE49-F238E27FC236}">
-                <a16:creationId xmlns:a16="http://schemas.microsoft.com/office/drawing/2014/main" id="{D279A9AA-EE9C-4DD2-8ECF-C0A2776FD4DF}"/>
+                <a16:creationId xmlns:a16="http://schemas.microsoft.com/office/drawing/2014/main" id="{D4CE200B-BC7F-485F-92B7-450DA6D77242}"/>
               </a:ext>
             </a:extLst>
           </p:cNvPr>
@@ -17533,7 +17533,7 @@
           <p:cNvPr id="4" name="">
             <a:extLst xmlns:a="http://schemas.openxmlformats.org/drawingml/2006/main">
               <a:ext uri="{FF2B5EF4-FFF2-40B4-BE49-F238E27FC236}">
-                <a16:creationId xmlns:a16="http://schemas.microsoft.com/office/drawing/2014/main" id="{8B1CB665-E9FA-4BA3-A089-B889C5A02EFC}"/>
+                <a16:creationId xmlns:a16="http://schemas.microsoft.com/office/drawing/2014/main" id="{94A306F3-9474-4012-B5AA-E765EAF827FE}"/>
               </a:ext>
             </a:extLst>
           </p:cNvPr>
@@ -17595,7 +17595,7 @@
           <p:cNvPr id="5" name="workflow-line">
             <a:extLst xmlns:a="http://schemas.openxmlformats.org/drawingml/2006/main">
               <a:ext uri="{FF2B5EF4-FFF2-40B4-BE49-F238E27FC236}">
-                <a16:creationId xmlns:a16="http://schemas.microsoft.com/office/drawing/2014/main" id="{5B42BAA6-F927-4EBD-99F2-9F191564C85F}"/>
+                <a16:creationId xmlns:a16="http://schemas.microsoft.com/office/drawing/2014/main" id="{6CB6E66E-657B-4749-AFCF-78B87D79D600}"/>
               </a:ext>
             </a:extLst>
           </p:cNvPr>
@@ -17626,7 +17626,7 @@
           <p:cNvPr id="6" name="workflow-arrow">
             <a:extLst xmlns:a="http://schemas.openxmlformats.org/drawingml/2006/main">
               <a:ext uri="{FF2B5EF4-FFF2-40B4-BE49-F238E27FC236}">
-                <a16:creationId xmlns:a16="http://schemas.microsoft.com/office/drawing/2014/main" id="{58C21FD4-3306-46C7-8517-2A584C1E7196}"/>
+                <a16:creationId xmlns:a16="http://schemas.microsoft.com/office/drawing/2014/main" id="{61FEF3F8-C8BE-45AC-A6F2-26D0ED7A4E4B}"/>
               </a:ext>
             </a:extLst>
           </p:cNvPr>
@@ -17657,7 +17657,7 @@
           <p:cNvPr id="7" name="">
             <a:extLst xmlns:a="http://schemas.openxmlformats.org/drawingml/2006/main">
               <a:ext uri="{FF2B5EF4-FFF2-40B4-BE49-F238E27FC236}">
-                <a16:creationId xmlns:a16="http://schemas.microsoft.com/office/drawing/2014/main" id="{00451AA4-AD84-46C4-8460-F2E59C17AD62}"/>
+                <a16:creationId xmlns:a16="http://schemas.microsoft.com/office/drawing/2014/main" id="{C95D79B2-7869-4500-9FC2-3FD53A30CFB7}"/>
               </a:ext>
             </a:extLst>
           </p:cNvPr>
@@ -17688,7 +17688,7 @@
           <p:cNvPr id="8" name="">
             <a:extLst xmlns:a="http://schemas.openxmlformats.org/drawingml/2006/main">
               <a:ext uri="{FF2B5EF4-FFF2-40B4-BE49-F238E27FC236}">
-                <a16:creationId xmlns:a16="http://schemas.microsoft.com/office/drawing/2014/main" id="{841BAD7C-F24E-4433-998C-F4ABE0186841}"/>
+                <a16:creationId xmlns:a16="http://schemas.microsoft.com/office/drawing/2014/main" id="{CAEDEC67-FAA4-4297-827A-9FA842BDC817}"/>
               </a:ext>
             </a:extLst>
           </p:cNvPr>
@@ -17750,7 +17750,7 @@
           <p:cNvPr id="9" name="">
             <a:extLst xmlns:a="http://schemas.openxmlformats.org/drawingml/2006/main">
               <a:ext uri="{FF2B5EF4-FFF2-40B4-BE49-F238E27FC236}">
-                <a16:creationId xmlns:a16="http://schemas.microsoft.com/office/drawing/2014/main" id="{163749FE-4E32-4239-87FA-A02DB5B0A290}"/>
+                <a16:creationId xmlns:a16="http://schemas.microsoft.com/office/drawing/2014/main" id="{9DE07F4E-FD7A-4822-99BE-F5A88B0F2696}"/>
               </a:ext>
             </a:extLst>
           </p:cNvPr>
@@ -17812,7 +17812,7 @@
           <p:cNvPr id="10" name="">
             <a:extLst xmlns:a="http://schemas.openxmlformats.org/drawingml/2006/main">
               <a:ext uri="{FF2B5EF4-FFF2-40B4-BE49-F238E27FC236}">
-                <a16:creationId xmlns:a16="http://schemas.microsoft.com/office/drawing/2014/main" id="{A94F0FE5-7B64-448C-BC80-12FE55B62C61}"/>
+                <a16:creationId xmlns:a16="http://schemas.microsoft.com/office/drawing/2014/main" id="{3A63F34C-6E49-4E73-878B-D831323A174B}"/>
               </a:ext>
             </a:extLst>
           </p:cNvPr>
@@ -17874,7 +17874,7 @@
           <p:cNvPr id="11" name="">
             <a:extLst xmlns:a="http://schemas.openxmlformats.org/drawingml/2006/main">
               <a:ext uri="{FF2B5EF4-FFF2-40B4-BE49-F238E27FC236}">
-                <a16:creationId xmlns:a16="http://schemas.microsoft.com/office/drawing/2014/main" id="{863A68CE-5195-43EA-A14C-A53CA4F35993}"/>
+                <a16:creationId xmlns:a16="http://schemas.microsoft.com/office/drawing/2014/main" id="{8C026761-FD69-41EB-912D-EDF959DAA8B0}"/>
               </a:ext>
             </a:extLst>
           </p:cNvPr>
@@ -17905,7 +17905,7 @@
           <p:cNvPr id="12" name="">
             <a:extLst xmlns:a="http://schemas.openxmlformats.org/drawingml/2006/main">
               <a:ext uri="{FF2B5EF4-FFF2-40B4-BE49-F238E27FC236}">
-                <a16:creationId xmlns:a16="http://schemas.microsoft.com/office/drawing/2014/main" id="{33759EEB-FE08-44F9-8BE9-21DABD6D4DEF}"/>
+                <a16:creationId xmlns:a16="http://schemas.microsoft.com/office/drawing/2014/main" id="{999DDCF1-5B2D-4C6C-9000-C6121AD355D5}"/>
               </a:ext>
             </a:extLst>
           </p:cNvPr>
@@ -17967,7 +17967,7 @@
           <p:cNvPr id="13" name="">
             <a:extLst xmlns:a="http://schemas.openxmlformats.org/drawingml/2006/main">
               <a:ext uri="{FF2B5EF4-FFF2-40B4-BE49-F238E27FC236}">
-                <a16:creationId xmlns:a16="http://schemas.microsoft.com/office/drawing/2014/main" id="{B73B5F03-A89D-443A-88C4-AA24963BE7F5}"/>
+                <a16:creationId xmlns:a16="http://schemas.microsoft.com/office/drawing/2014/main" id="{13072788-3F6F-4D83-9D84-2759CF92CF72}"/>
               </a:ext>
             </a:extLst>
           </p:cNvPr>
@@ -18029,7 +18029,7 @@
           <p:cNvPr id="14" name="">
             <a:extLst xmlns:a="http://schemas.openxmlformats.org/drawingml/2006/main">
               <a:ext uri="{FF2B5EF4-FFF2-40B4-BE49-F238E27FC236}">
-                <a16:creationId xmlns:a16="http://schemas.microsoft.com/office/drawing/2014/main" id="{1A1130BC-1C7D-49F1-8E12-CA8CDCCB5463}"/>
+                <a16:creationId xmlns:a16="http://schemas.microsoft.com/office/drawing/2014/main" id="{2CADEB66-43AD-40B7-BC10-B05CA0EE13D7}"/>
               </a:ext>
             </a:extLst>
           </p:cNvPr>
@@ -18091,7 +18091,7 @@
           <p:cNvPr id="15" name="">
             <a:extLst xmlns:a="http://schemas.openxmlformats.org/drawingml/2006/main">
               <a:ext uri="{FF2B5EF4-FFF2-40B4-BE49-F238E27FC236}">
-                <a16:creationId xmlns:a16="http://schemas.microsoft.com/office/drawing/2014/main" id="{D40EACDD-9864-49E2-A009-486F6E282FE2}"/>
+                <a16:creationId xmlns:a16="http://schemas.microsoft.com/office/drawing/2014/main" id="{48B2CFFA-8456-42A2-9983-2C05D7740FA4}"/>
               </a:ext>
             </a:extLst>
           </p:cNvPr>
@@ -18122,7 +18122,7 @@
           <p:cNvPr id="16" name="">
             <a:extLst xmlns:a="http://schemas.openxmlformats.org/drawingml/2006/main">
               <a:ext uri="{FF2B5EF4-FFF2-40B4-BE49-F238E27FC236}">
-                <a16:creationId xmlns:a16="http://schemas.microsoft.com/office/drawing/2014/main" id="{2C1953B3-13DF-45DE-A505-7A0D9297F3FC}"/>
+                <a16:creationId xmlns:a16="http://schemas.microsoft.com/office/drawing/2014/main" id="{197FAB4F-160A-47D5-8366-51134DC8CF40}"/>
               </a:ext>
             </a:extLst>
           </p:cNvPr>
@@ -18184,7 +18184,7 @@
           <p:cNvPr id="17" name="">
             <a:extLst xmlns:a="http://schemas.openxmlformats.org/drawingml/2006/main">
               <a:ext uri="{FF2B5EF4-FFF2-40B4-BE49-F238E27FC236}">
-                <a16:creationId xmlns:a16="http://schemas.microsoft.com/office/drawing/2014/main" id="{73A40CDB-F9BD-49AA-AD0B-BA30916013AF}"/>
+                <a16:creationId xmlns:a16="http://schemas.microsoft.com/office/drawing/2014/main" id="{281D034D-F365-49CC-BDCE-15B6FAD9DBCC}"/>
               </a:ext>
             </a:extLst>
           </p:cNvPr>
@@ -18246,7 +18246,7 @@
           <p:cNvPr id="18" name="">
             <a:extLst xmlns:a="http://schemas.openxmlformats.org/drawingml/2006/main">
               <a:ext uri="{FF2B5EF4-FFF2-40B4-BE49-F238E27FC236}">
-                <a16:creationId xmlns:a16="http://schemas.microsoft.com/office/drawing/2014/main" id="{667B284D-171C-4AA2-B57A-2E9357FBCFC9}"/>
+                <a16:creationId xmlns:a16="http://schemas.microsoft.com/office/drawing/2014/main" id="{10C67D32-CCFE-4CB9-9E5E-3C8FBEFD4571}"/>
               </a:ext>
             </a:extLst>
           </p:cNvPr>
@@ -18308,7 +18308,7 @@
           <p:cNvPr id="19" name="">
             <a:extLst xmlns:a="http://schemas.openxmlformats.org/drawingml/2006/main">
               <a:ext uri="{FF2B5EF4-FFF2-40B4-BE49-F238E27FC236}">
-                <a16:creationId xmlns:a16="http://schemas.microsoft.com/office/drawing/2014/main" id="{0E0454E1-8A61-4ADA-85E4-985FAD17BB15}"/>
+                <a16:creationId xmlns:a16="http://schemas.microsoft.com/office/drawing/2014/main" id="{C527E59B-0822-4430-B763-D2003D9EB88B}"/>
               </a:ext>
             </a:extLst>
           </p:cNvPr>
@@ -18339,7 +18339,7 @@
           <p:cNvPr id="20" name="">
             <a:extLst xmlns:a="http://schemas.openxmlformats.org/drawingml/2006/main">
               <a:ext uri="{FF2B5EF4-FFF2-40B4-BE49-F238E27FC236}">
-                <a16:creationId xmlns:a16="http://schemas.microsoft.com/office/drawing/2014/main" id="{ACBCE747-88C7-4C02-85F4-B9137F5E1C45}"/>
+                <a16:creationId xmlns:a16="http://schemas.microsoft.com/office/drawing/2014/main" id="{4FE2639F-86F0-4A30-975F-F9440EBFB082}"/>
               </a:ext>
             </a:extLst>
           </p:cNvPr>
@@ -18401,7 +18401,7 @@
           <p:cNvPr id="21" name="">
             <a:extLst xmlns:a="http://schemas.openxmlformats.org/drawingml/2006/main">
               <a:ext uri="{FF2B5EF4-FFF2-40B4-BE49-F238E27FC236}">
-                <a16:creationId xmlns:a16="http://schemas.microsoft.com/office/drawing/2014/main" id="{0D56664E-587E-4686-A614-4D33ECA76B24}"/>
+                <a16:creationId xmlns:a16="http://schemas.microsoft.com/office/drawing/2014/main" id="{EE4C5C95-8188-462B-9F53-C9C37AB14053}"/>
               </a:ext>
             </a:extLst>
           </p:cNvPr>
@@ -18463,7 +18463,7 @@
           <p:cNvPr id="22" name="">
             <a:extLst xmlns:a="http://schemas.openxmlformats.org/drawingml/2006/main">
               <a:ext uri="{FF2B5EF4-FFF2-40B4-BE49-F238E27FC236}">
-                <a16:creationId xmlns:a16="http://schemas.microsoft.com/office/drawing/2014/main" id="{50728F10-6893-4FD2-ACCB-2EED94BF0DBB}"/>
+                <a16:creationId xmlns:a16="http://schemas.microsoft.com/office/drawing/2014/main" id="{4EA66755-7962-4CF8-B971-EC0BC632B67B}"/>
               </a:ext>
             </a:extLst>
           </p:cNvPr>
@@ -18525,7 +18525,7 @@
           <p:cNvPr id="23" name="">
             <a:extLst xmlns:a="http://schemas.openxmlformats.org/drawingml/2006/main">
               <a:ext uri="{FF2B5EF4-FFF2-40B4-BE49-F238E27FC236}">
-                <a16:creationId xmlns:a16="http://schemas.microsoft.com/office/drawing/2014/main" id="{A5A066A9-90DD-4F5E-9A29-B6ACD85E8755}"/>
+                <a16:creationId xmlns:a16="http://schemas.microsoft.com/office/drawing/2014/main" id="{71581D7F-4FE1-4BA2-9CEB-D506A3DB96E7}"/>
               </a:ext>
             </a:extLst>
           </p:cNvPr>
@@ -18556,7 +18556,7 @@
           <p:cNvPr id="24" name="">
             <a:extLst xmlns:a="http://schemas.openxmlformats.org/drawingml/2006/main">
               <a:ext uri="{FF2B5EF4-FFF2-40B4-BE49-F238E27FC236}">
-                <a16:creationId xmlns:a16="http://schemas.microsoft.com/office/drawing/2014/main" id="{01AE4093-A392-4585-ACB2-30486785B64D}"/>
+                <a16:creationId xmlns:a16="http://schemas.microsoft.com/office/drawing/2014/main" id="{9ABFE1AE-D14E-4D75-8B9B-0DA1881A8EB9}"/>
               </a:ext>
             </a:extLst>
           </p:cNvPr>
@@ -18618,7 +18618,7 @@
           <p:cNvPr id="25" name="">
             <a:extLst xmlns:a="http://schemas.openxmlformats.org/drawingml/2006/main">
               <a:ext uri="{FF2B5EF4-FFF2-40B4-BE49-F238E27FC236}">
-                <a16:creationId xmlns:a16="http://schemas.microsoft.com/office/drawing/2014/main" id="{A3327FB4-D04F-4840-BF44-D9C8671A64FC}"/>
+                <a16:creationId xmlns:a16="http://schemas.microsoft.com/office/drawing/2014/main" id="{D2E98963-1218-4BD5-9B3C-885DD50BC1C2}"/>
               </a:ext>
             </a:extLst>
           </p:cNvPr>
@@ -18680,7 +18680,7 @@
           <p:cNvPr id="26" name="">
             <a:extLst xmlns:a="http://schemas.openxmlformats.org/drawingml/2006/main">
               <a:ext uri="{FF2B5EF4-FFF2-40B4-BE49-F238E27FC236}">
-                <a16:creationId xmlns:a16="http://schemas.microsoft.com/office/drawing/2014/main" id="{58D7B444-E4D4-4156-9BEF-28B275B3403E}"/>
+                <a16:creationId xmlns:a16="http://schemas.microsoft.com/office/drawing/2014/main" id="{40ECA634-3ABF-461F-B4D7-B49F1311133A}"/>
               </a:ext>
             </a:extLst>
           </p:cNvPr>
@@ -18742,7 +18742,7 @@
           <p:cNvPr id="27" name="">
             <a:extLst xmlns:a="http://schemas.openxmlformats.org/drawingml/2006/main">
               <a:ext uri="{FF2B5EF4-FFF2-40B4-BE49-F238E27FC236}">
-                <a16:creationId xmlns:a16="http://schemas.microsoft.com/office/drawing/2014/main" id="{4F33CCEC-EC85-4853-85D9-EDCA91156254}"/>
+                <a16:creationId xmlns:a16="http://schemas.microsoft.com/office/drawing/2014/main" id="{11AF99EA-BAB1-4564-87BF-C86042B1FFBE}"/>
               </a:ext>
             </a:extLst>
           </p:cNvPr>
@@ -18804,7 +18804,7 @@
           <p:cNvPr id="28" name="footer-rule-5">
             <a:extLst xmlns:a="http://schemas.openxmlformats.org/drawingml/2006/main">
               <a:ext uri="{FF2B5EF4-FFF2-40B4-BE49-F238E27FC236}">
-                <a16:creationId xmlns:a16="http://schemas.microsoft.com/office/drawing/2014/main" id="{5D728F36-203B-4118-BAA1-EA71C7112ACE}"/>
+                <a16:creationId xmlns:a16="http://schemas.microsoft.com/office/drawing/2014/main" id="{AA3C3B0B-C034-4F5C-BCE6-7986BF80B3F2}"/>
               </a:ext>
             </a:extLst>
           </p:cNvPr>
@@ -18835,7 +18835,7 @@
           <p:cNvPr id="29" name="footer-label-5">
             <a:extLst xmlns:a="http://schemas.openxmlformats.org/drawingml/2006/main">
               <a:ext uri="{FF2B5EF4-FFF2-40B4-BE49-F238E27FC236}">
-                <a16:creationId xmlns:a16="http://schemas.microsoft.com/office/drawing/2014/main" id="{BAD9A98A-EDF5-41ED-9945-3320111295E8}"/>
+                <a16:creationId xmlns:a16="http://schemas.microsoft.com/office/drawing/2014/main" id="{3E4B7D0E-3AF8-4AA1-8737-14B9EE4A576F}"/>
               </a:ext>
             </a:extLst>
           </p:cNvPr>
@@ -18897,7 +18897,7 @@
           <p:cNvPr id="30" name="footer-page-5">
             <a:extLst xmlns:a="http://schemas.openxmlformats.org/drawingml/2006/main">
               <a:ext uri="{FF2B5EF4-FFF2-40B4-BE49-F238E27FC236}">
-                <a16:creationId xmlns:a16="http://schemas.microsoft.com/office/drawing/2014/main" id="{076211D0-F360-4236-A328-1CC0CDABF045}"/>
+                <a16:creationId xmlns:a16="http://schemas.microsoft.com/office/drawing/2014/main" id="{5F96EAB1-F01F-4DF7-9BC1-EAE84CBF0768}"/>
               </a:ext>
             </a:extLst>
           </p:cNvPr>
@@ -18957,7 +18957,7 @@
     </p:spTree>
     <p:extLst>
       <p:ext uri="{BB962C8B-B14F-4D97-AF65-F5344CB8AC3E}">
-        <p14:creationId xmlns:p14="http://schemas.microsoft.com/office/powerpoint/2010/main" val="540316928"/>
+        <p14:creationId xmlns:p14="http://schemas.microsoft.com/office/powerpoint/2010/main" val="127235886"/>
       </p:ext>
     </p:extLst>
   </p:cSld>
@@ -18988,7 +18988,7 @@
           <p:cNvPr id="22" name="side-accent-6">
             <a:extLst xmlns:a="http://schemas.openxmlformats.org/drawingml/2006/main">
               <a:ext uri="{FF2B5EF4-FFF2-40B4-BE49-F238E27FC236}">
-                <a16:creationId xmlns:a16="http://schemas.microsoft.com/office/drawing/2014/main" id="{96A7D9CA-640F-406C-8955-AFB86A3C108D}"/>
+                <a16:creationId xmlns:a16="http://schemas.microsoft.com/office/drawing/2014/main" id="{FD2F40DD-59F5-4471-B18C-DA25F77F7454}"/>
               </a:ext>
             </a:extLst>
           </p:cNvPr>
@@ -19019,7 +19019,7 @@
           <p:cNvPr id="2" name="kicker-6">
             <a:extLst xmlns:a="http://schemas.openxmlformats.org/drawingml/2006/main">
               <a:ext uri="{FF2B5EF4-FFF2-40B4-BE49-F238E27FC236}">
-                <a16:creationId xmlns:a16="http://schemas.microsoft.com/office/drawing/2014/main" id="{462494FB-2A4F-438A-B97F-4CF2F32B06D8}"/>
+                <a16:creationId xmlns:a16="http://schemas.microsoft.com/office/drawing/2014/main" id="{D26EFAF9-E653-455D-B9E8-3C28252084BE}"/>
               </a:ext>
             </a:extLst>
           </p:cNvPr>
@@ -19081,7 +19081,7 @@
           <p:cNvPr id="3" name="title-6">
             <a:extLst xmlns:a="http://schemas.openxmlformats.org/drawingml/2006/main">
               <a:ext uri="{FF2B5EF4-FFF2-40B4-BE49-F238E27FC236}">
-                <a16:creationId xmlns:a16="http://schemas.microsoft.com/office/drawing/2014/main" id="{892B815B-DEB6-4E2B-9E52-2ACCCC910DAB}"/>
+                <a16:creationId xmlns:a16="http://schemas.microsoft.com/office/drawing/2014/main" id="{0B23B70C-191F-4403-B27D-62BA91425582}"/>
               </a:ext>
             </a:extLst>
           </p:cNvPr>
@@ -19143,7 +19143,7 @@
           <p:cNvPr id="4" name="">
             <a:extLst xmlns:a="http://schemas.openxmlformats.org/drawingml/2006/main">
               <a:ext uri="{FF2B5EF4-FFF2-40B4-BE49-F238E27FC236}">
-                <a16:creationId xmlns:a16="http://schemas.microsoft.com/office/drawing/2014/main" id="{3813B364-F6A4-422A-91DD-21FA653F425C}"/>
+                <a16:creationId xmlns:a16="http://schemas.microsoft.com/office/drawing/2014/main" id="{8E798583-E733-4132-997F-D0255CB6CDBA}"/>
               </a:ext>
             </a:extLst>
           </p:cNvPr>
@@ -19205,7 +19205,7 @@
           <p:cNvPr id="5" name="">
             <a:extLst xmlns:a="http://schemas.openxmlformats.org/drawingml/2006/main">
               <a:ext uri="{FF2B5EF4-FFF2-40B4-BE49-F238E27FC236}">
-                <a16:creationId xmlns:a16="http://schemas.microsoft.com/office/drawing/2014/main" id="{C0F52C25-A7E6-4914-9B8C-2F396F78E669}"/>
+                <a16:creationId xmlns:a16="http://schemas.microsoft.com/office/drawing/2014/main" id="{8B18D433-6544-4989-A9DE-574B61BF01CB}"/>
               </a:ext>
             </a:extLst>
           </p:cNvPr>
@@ -19267,7 +19267,7 @@
           <p:cNvPr id="6" name="">
             <a:extLst xmlns:a="http://schemas.openxmlformats.org/drawingml/2006/main">
               <a:ext uri="{FF2B5EF4-FFF2-40B4-BE49-F238E27FC236}">
-                <a16:creationId xmlns:a16="http://schemas.microsoft.com/office/drawing/2014/main" id="{55960CA7-2796-4356-BC68-96FEC9255820}"/>
+                <a16:creationId xmlns:a16="http://schemas.microsoft.com/office/drawing/2014/main" id="{930F8681-FF26-436B-A0E6-AB4BB7B0B10C}"/>
               </a:ext>
             </a:extLst>
           </p:cNvPr>
@@ -19329,7 +19329,7 @@
           <p:cNvPr id="7" name="">
             <a:extLst xmlns:a="http://schemas.openxmlformats.org/drawingml/2006/main">
               <a:ext uri="{FF2B5EF4-FFF2-40B4-BE49-F238E27FC236}">
-                <a16:creationId xmlns:a16="http://schemas.microsoft.com/office/drawing/2014/main" id="{0B300621-EE0F-434B-A2E6-58AF58C522CF}"/>
+                <a16:creationId xmlns:a16="http://schemas.microsoft.com/office/drawing/2014/main" id="{958E17F0-FC87-4EBF-ABB9-AE3DF2F161A6}"/>
               </a:ext>
             </a:extLst>
           </p:cNvPr>
@@ -19360,7 +19360,7 @@
           <p:cNvPr id="8" name="">
             <a:extLst xmlns:a="http://schemas.openxmlformats.org/drawingml/2006/main">
               <a:ext uri="{FF2B5EF4-FFF2-40B4-BE49-F238E27FC236}">
-                <a16:creationId xmlns:a16="http://schemas.microsoft.com/office/drawing/2014/main" id="{9A154997-8773-4C1A-BA75-B4A35E619AEF}"/>
+                <a16:creationId xmlns:a16="http://schemas.microsoft.com/office/drawing/2014/main" id="{9EBA14CA-1855-496B-8599-22A802A75A6A}"/>
               </a:ext>
             </a:extLst>
           </p:cNvPr>
@@ -19449,7 +19449,7 @@
           <p:cNvPr id="9" name="">
             <a:extLst xmlns:a="http://schemas.openxmlformats.org/drawingml/2006/main">
               <a:ext uri="{FF2B5EF4-FFF2-40B4-BE49-F238E27FC236}">
-                <a16:creationId xmlns:a16="http://schemas.microsoft.com/office/drawing/2014/main" id="{AD0F056B-07C3-443E-9F01-27FBC0DA9076}"/>
+                <a16:creationId xmlns:a16="http://schemas.microsoft.com/office/drawing/2014/main" id="{B2BD9183-EF3C-4D9E-AE72-117C17472835}"/>
               </a:ext>
             </a:extLst>
           </p:cNvPr>
@@ -19511,7 +19511,7 @@
           <p:cNvPr id="10" name="">
             <a:extLst xmlns:a="http://schemas.openxmlformats.org/drawingml/2006/main">
               <a:ext uri="{FF2B5EF4-FFF2-40B4-BE49-F238E27FC236}">
-                <a16:creationId xmlns:a16="http://schemas.microsoft.com/office/drawing/2014/main" id="{B6C94610-C785-4628-86C4-507D67D15F09}"/>
+                <a16:creationId xmlns:a16="http://schemas.microsoft.com/office/drawing/2014/main" id="{35CF48C8-ED0B-46BD-BCA7-E8862B3F430B}"/>
               </a:ext>
             </a:extLst>
           </p:cNvPr>
@@ -19573,7 +19573,7 @@
           <p:cNvPr id="11" name="">
             <a:extLst xmlns:a="http://schemas.openxmlformats.org/drawingml/2006/main">
               <a:ext uri="{FF2B5EF4-FFF2-40B4-BE49-F238E27FC236}">
-                <a16:creationId xmlns:a16="http://schemas.microsoft.com/office/drawing/2014/main" id="{78468635-05EE-4A4C-ADE9-0E702B3C7066}"/>
+                <a16:creationId xmlns:a16="http://schemas.microsoft.com/office/drawing/2014/main" id="{02122303-42A5-4171-B2EF-BB914B9C77AF}"/>
               </a:ext>
             </a:extLst>
           </p:cNvPr>
@@ -19604,7 +19604,7 @@
           <p:cNvPr id="12" name="">
             <a:extLst xmlns:a="http://schemas.openxmlformats.org/drawingml/2006/main">
               <a:ext uri="{FF2B5EF4-FFF2-40B4-BE49-F238E27FC236}">
-                <a16:creationId xmlns:a16="http://schemas.microsoft.com/office/drawing/2014/main" id="{21BDEDE8-C5D3-425C-B673-9534D7921D40}"/>
+                <a16:creationId xmlns:a16="http://schemas.microsoft.com/office/drawing/2014/main" id="{F09EB690-B7B7-44DC-95DE-667A5FBEBC9D}"/>
               </a:ext>
             </a:extLst>
           </p:cNvPr>
@@ -19693,7 +19693,7 @@
           <p:cNvPr id="13" name="">
             <a:extLst xmlns:a="http://schemas.openxmlformats.org/drawingml/2006/main">
               <a:ext uri="{FF2B5EF4-FFF2-40B4-BE49-F238E27FC236}">
-                <a16:creationId xmlns:a16="http://schemas.microsoft.com/office/drawing/2014/main" id="{D8D2A976-D978-4E98-9FB7-4B718A9BF2B1}"/>
+                <a16:creationId xmlns:a16="http://schemas.microsoft.com/office/drawing/2014/main" id="{5998BD44-FC6A-4313-A94C-3477701331D3}"/>
               </a:ext>
             </a:extLst>
           </p:cNvPr>
@@ -19755,7 +19755,7 @@
           <p:cNvPr id="14" name="">
             <a:extLst xmlns:a="http://schemas.openxmlformats.org/drawingml/2006/main">
               <a:ext uri="{FF2B5EF4-FFF2-40B4-BE49-F238E27FC236}">
-                <a16:creationId xmlns:a16="http://schemas.microsoft.com/office/drawing/2014/main" id="{F1158B86-545A-4104-AE41-F7465C3F7783}"/>
+                <a16:creationId xmlns:a16="http://schemas.microsoft.com/office/drawing/2014/main" id="{087E6517-63D2-410E-A37F-4868884CFB6C}"/>
               </a:ext>
             </a:extLst>
           </p:cNvPr>
@@ -19817,7 +19817,7 @@
           <p:cNvPr id="15" name="">
             <a:extLst xmlns:a="http://schemas.openxmlformats.org/drawingml/2006/main">
               <a:ext uri="{FF2B5EF4-FFF2-40B4-BE49-F238E27FC236}">
-                <a16:creationId xmlns:a16="http://schemas.microsoft.com/office/drawing/2014/main" id="{75068006-0445-4DEC-8459-0938EE972858}"/>
+                <a16:creationId xmlns:a16="http://schemas.microsoft.com/office/drawing/2014/main" id="{739AD4E8-6721-4EE0-9933-E303741922DD}"/>
               </a:ext>
             </a:extLst>
           </p:cNvPr>
@@ -19848,7 +19848,7 @@
           <p:cNvPr id="16" name="">
             <a:extLst xmlns:a="http://schemas.openxmlformats.org/drawingml/2006/main">
               <a:ext uri="{FF2B5EF4-FFF2-40B4-BE49-F238E27FC236}">
-                <a16:creationId xmlns:a16="http://schemas.microsoft.com/office/drawing/2014/main" id="{1DC878CC-C012-470F-9782-695B8B7ABF0B}"/>
+                <a16:creationId xmlns:a16="http://schemas.microsoft.com/office/drawing/2014/main" id="{09EDC4ED-95DC-4094-AF21-F0110525811D}"/>
               </a:ext>
             </a:extLst>
           </p:cNvPr>
@@ -19937,7 +19937,7 @@
           <p:cNvPr id="17" name="">
             <a:extLst xmlns:a="http://schemas.openxmlformats.org/drawingml/2006/main">
               <a:ext uri="{FF2B5EF4-FFF2-40B4-BE49-F238E27FC236}">
-                <a16:creationId xmlns:a16="http://schemas.microsoft.com/office/drawing/2014/main" id="{4CADB517-25C7-4703-8359-0C1D6808A8E4}"/>
+                <a16:creationId xmlns:a16="http://schemas.microsoft.com/office/drawing/2014/main" id="{705F3508-F49E-4F8E-A498-0F4A86F2F018}"/>
               </a:ext>
             </a:extLst>
           </p:cNvPr>
@@ -19970,7 +19970,7 @@
           <p:cNvPr id="18" name="">
             <a:extLst xmlns:a="http://schemas.openxmlformats.org/drawingml/2006/main">
               <a:ext uri="{FF2B5EF4-FFF2-40B4-BE49-F238E27FC236}">
-                <a16:creationId xmlns:a16="http://schemas.microsoft.com/office/drawing/2014/main" id="{EF0E1202-24B3-414A-9F9E-C88F371D479D}"/>
+                <a16:creationId xmlns:a16="http://schemas.microsoft.com/office/drawing/2014/main" id="{595EC03C-A9A9-4B25-8F8A-FA487E313610}"/>
               </a:ext>
             </a:extLst>
           </p:cNvPr>
@@ -20059,7 +20059,7 @@
           <p:cNvPr id="19" name="footer-rule-6">
             <a:extLst xmlns:a="http://schemas.openxmlformats.org/drawingml/2006/main">
               <a:ext uri="{FF2B5EF4-FFF2-40B4-BE49-F238E27FC236}">
-                <a16:creationId xmlns:a16="http://schemas.microsoft.com/office/drawing/2014/main" id="{B5B3F8B6-EF52-4635-810E-8530470E987F}"/>
+                <a16:creationId xmlns:a16="http://schemas.microsoft.com/office/drawing/2014/main" id="{33A3442F-6410-43EC-81B4-B45375EE7143}"/>
               </a:ext>
             </a:extLst>
           </p:cNvPr>
@@ -20090,7 +20090,7 @@
           <p:cNvPr id="20" name="footer-label-6">
             <a:extLst xmlns:a="http://schemas.openxmlformats.org/drawingml/2006/main">
               <a:ext uri="{FF2B5EF4-FFF2-40B4-BE49-F238E27FC236}">
-                <a16:creationId xmlns:a16="http://schemas.microsoft.com/office/drawing/2014/main" id="{6F3C2DD0-077E-42AF-85D6-B60251261DDD}"/>
+                <a16:creationId xmlns:a16="http://schemas.microsoft.com/office/drawing/2014/main" id="{6C7230D1-4BC9-4150-94D5-2E0E87925A2F}"/>
               </a:ext>
             </a:extLst>
           </p:cNvPr>
@@ -20152,7 +20152,7 @@
           <p:cNvPr id="21" name="footer-page-6">
             <a:extLst xmlns:a="http://schemas.openxmlformats.org/drawingml/2006/main">
               <a:ext uri="{FF2B5EF4-FFF2-40B4-BE49-F238E27FC236}">
-                <a16:creationId xmlns:a16="http://schemas.microsoft.com/office/drawing/2014/main" id="{3D22904A-B510-4867-9720-881FE55CCDEC}"/>
+                <a16:creationId xmlns:a16="http://schemas.microsoft.com/office/drawing/2014/main" id="{80E60C70-B2D3-419B-B5D8-5A5F0E2422BF}"/>
               </a:ext>
             </a:extLst>
           </p:cNvPr>
@@ -20212,7 +20212,7 @@
     </p:spTree>
     <p:extLst>
       <p:ext uri="{BB962C8B-B14F-4D97-AF65-F5344CB8AC3E}">
-        <p14:creationId xmlns:p14="http://schemas.microsoft.com/office/powerpoint/2010/main" val="224956049"/>
+        <p14:creationId xmlns:p14="http://schemas.microsoft.com/office/powerpoint/2010/main" val="803117463"/>
       </p:ext>
     </p:extLst>
   </p:cSld>
@@ -20243,7 +20243,7 @@
           <p:cNvPr id="28" name="side-accent-7">
             <a:extLst xmlns:a="http://schemas.openxmlformats.org/drawingml/2006/main">
               <a:ext uri="{FF2B5EF4-FFF2-40B4-BE49-F238E27FC236}">
-                <a16:creationId xmlns:a16="http://schemas.microsoft.com/office/drawing/2014/main" id="{9B4372F5-D313-4D89-BBF7-B90E2F7C406D}"/>
+                <a16:creationId xmlns:a16="http://schemas.microsoft.com/office/drawing/2014/main" id="{2A78D2FB-BF7A-4FE9-BCBD-16F59CAB9763}"/>
               </a:ext>
             </a:extLst>
           </p:cNvPr>
@@ -20274,7 +20274,7 @@
           <p:cNvPr id="2" name="kicker-7">
             <a:extLst xmlns:a="http://schemas.openxmlformats.org/drawingml/2006/main">
               <a:ext uri="{FF2B5EF4-FFF2-40B4-BE49-F238E27FC236}">
-                <a16:creationId xmlns:a16="http://schemas.microsoft.com/office/drawing/2014/main" id="{54132BF3-B24C-4627-990C-8DEAEE743116}"/>
+                <a16:creationId xmlns:a16="http://schemas.microsoft.com/office/drawing/2014/main" id="{3B84D24B-7560-430F-9177-F81DCFF5D939}"/>
               </a:ext>
             </a:extLst>
           </p:cNvPr>
@@ -20336,7 +20336,7 @@
           <p:cNvPr id="3" name="title-7">
             <a:extLst xmlns:a="http://schemas.openxmlformats.org/drawingml/2006/main">
               <a:ext uri="{FF2B5EF4-FFF2-40B4-BE49-F238E27FC236}">
-                <a16:creationId xmlns:a16="http://schemas.microsoft.com/office/drawing/2014/main" id="{208617F6-FB6A-4681-AC68-3CAE27F5B9FF}"/>
+                <a16:creationId xmlns:a16="http://schemas.microsoft.com/office/drawing/2014/main" id="{C741A931-E4BF-48F2-9F7B-B5147E6C6DBD}"/>
               </a:ext>
             </a:extLst>
           </p:cNvPr>
@@ -20398,7 +20398,7 @@
           <p:cNvPr id="4" name="">
             <a:extLst xmlns:a="http://schemas.openxmlformats.org/drawingml/2006/main">
               <a:ext uri="{FF2B5EF4-FFF2-40B4-BE49-F238E27FC236}">
-                <a16:creationId xmlns:a16="http://schemas.microsoft.com/office/drawing/2014/main" id="{BE82332F-ABD3-41F2-B2A5-2BAD1510346F}"/>
+                <a16:creationId xmlns:a16="http://schemas.microsoft.com/office/drawing/2014/main" id="{3C937F02-917A-4CD9-9573-4F72B9583767}"/>
               </a:ext>
             </a:extLst>
           </p:cNvPr>
@@ -20460,7 +20460,7 @@
           <p:cNvPr id="5" name="">
             <a:extLst xmlns:a="http://schemas.openxmlformats.org/drawingml/2006/main">
               <a:ext uri="{FF2B5EF4-FFF2-40B4-BE49-F238E27FC236}">
-                <a16:creationId xmlns:a16="http://schemas.microsoft.com/office/drawing/2014/main" id="{4B4E5E66-99F0-48C1-8A69-71DF965D6501}"/>
+                <a16:creationId xmlns:a16="http://schemas.microsoft.com/office/drawing/2014/main" id="{CC13C44E-9994-40E2-9C58-7A9CB3F7A2C5}"/>
               </a:ext>
             </a:extLst>
           </p:cNvPr>
@@ -20491,7 +20491,7 @@
           <p:cNvPr id="6" name="">
             <a:extLst xmlns:a="http://schemas.openxmlformats.org/drawingml/2006/main">
               <a:ext uri="{FF2B5EF4-FFF2-40B4-BE49-F238E27FC236}">
-                <a16:creationId xmlns:a16="http://schemas.microsoft.com/office/drawing/2014/main" id="{BD9847FF-6495-420B-BA23-43675B6ACF74}"/>
+                <a16:creationId xmlns:a16="http://schemas.microsoft.com/office/drawing/2014/main" id="{E89CBFCC-2E04-4725-B7B1-86BD15D34C37}"/>
               </a:ext>
             </a:extLst>
           </p:cNvPr>
@@ -20553,7 +20553,7 @@
           <p:cNvPr id="7" name="">
             <a:extLst xmlns:a="http://schemas.openxmlformats.org/drawingml/2006/main">
               <a:ext uri="{FF2B5EF4-FFF2-40B4-BE49-F238E27FC236}">
-                <a16:creationId xmlns:a16="http://schemas.microsoft.com/office/drawing/2014/main" id="{F874C223-AB94-4BCD-92A8-5C311A68371F}"/>
+                <a16:creationId xmlns:a16="http://schemas.microsoft.com/office/drawing/2014/main" id="{8F733E21-9A66-4BE5-9BDA-398E3DF0ADE7}"/>
               </a:ext>
             </a:extLst>
           </p:cNvPr>
@@ -20615,7 +20615,7 @@
           <p:cNvPr id="8" name="">
             <a:extLst xmlns:a="http://schemas.openxmlformats.org/drawingml/2006/main">
               <a:ext uri="{FF2B5EF4-FFF2-40B4-BE49-F238E27FC236}">
-                <a16:creationId xmlns:a16="http://schemas.microsoft.com/office/drawing/2014/main" id="{15194C42-E5B5-4C0C-8B15-8E3076CFE7FE}"/>
+                <a16:creationId xmlns:a16="http://schemas.microsoft.com/office/drawing/2014/main" id="{B730C2F6-FF00-488B-850F-E356F29142A5}"/>
               </a:ext>
             </a:extLst>
           </p:cNvPr>
@@ -20677,7 +20677,7 @@
           <p:cNvPr id="9" name="">
             <a:extLst xmlns:a="http://schemas.openxmlformats.org/drawingml/2006/main">
               <a:ext uri="{FF2B5EF4-FFF2-40B4-BE49-F238E27FC236}">
-                <a16:creationId xmlns:a16="http://schemas.microsoft.com/office/drawing/2014/main" id="{392EBA10-3442-4F29-A8AE-FE18C97A2DDF}"/>
+                <a16:creationId xmlns:a16="http://schemas.microsoft.com/office/drawing/2014/main" id="{17848D15-D4F2-49CD-A3BB-11FE33031491}"/>
               </a:ext>
             </a:extLst>
           </p:cNvPr>
@@ -20708,7 +20708,7 @@
           <p:cNvPr id="10" name="">
             <a:extLst xmlns:a="http://schemas.openxmlformats.org/drawingml/2006/main">
               <a:ext uri="{FF2B5EF4-FFF2-40B4-BE49-F238E27FC236}">
-                <a16:creationId xmlns:a16="http://schemas.microsoft.com/office/drawing/2014/main" id="{C7394575-E5C7-49D5-85C5-DCADFE67C823}"/>
+                <a16:creationId xmlns:a16="http://schemas.microsoft.com/office/drawing/2014/main" id="{34A72051-64FF-4D6B-A2C2-0B12379960AF}"/>
               </a:ext>
             </a:extLst>
           </p:cNvPr>
@@ -20770,7 +20770,7 @@
           <p:cNvPr id="11" name="">
             <a:extLst xmlns:a="http://schemas.openxmlformats.org/drawingml/2006/main">
               <a:ext uri="{FF2B5EF4-FFF2-40B4-BE49-F238E27FC236}">
-                <a16:creationId xmlns:a16="http://schemas.microsoft.com/office/drawing/2014/main" id="{0F31714E-4DD3-4C49-957F-22A969020C0E}"/>
+                <a16:creationId xmlns:a16="http://schemas.microsoft.com/office/drawing/2014/main" id="{24BA9D3A-BF1D-495B-B0A1-D407B512FA31}"/>
               </a:ext>
             </a:extLst>
           </p:cNvPr>
@@ -20832,7 +20832,7 @@
           <p:cNvPr id="12" name="">
             <a:extLst xmlns:a="http://schemas.openxmlformats.org/drawingml/2006/main">
               <a:ext uri="{FF2B5EF4-FFF2-40B4-BE49-F238E27FC236}">
-                <a16:creationId xmlns:a16="http://schemas.microsoft.com/office/drawing/2014/main" id="{4800E0E9-6958-4A15-879B-D7B814BB22B9}"/>
+                <a16:creationId xmlns:a16="http://schemas.microsoft.com/office/drawing/2014/main" id="{4A8AFCA8-D84B-4BD3-A032-38E43936349B}"/>
               </a:ext>
             </a:extLst>
           </p:cNvPr>
@@ -20894,7 +20894,7 @@
           <p:cNvPr id="13" name="">
             <a:extLst xmlns:a="http://schemas.openxmlformats.org/drawingml/2006/main">
               <a:ext uri="{FF2B5EF4-FFF2-40B4-BE49-F238E27FC236}">
-                <a16:creationId xmlns:a16="http://schemas.microsoft.com/office/drawing/2014/main" id="{C4529DB0-29F2-464C-B3EA-F9BC242B480E}"/>
+                <a16:creationId xmlns:a16="http://schemas.microsoft.com/office/drawing/2014/main" id="{2124BF45-832D-47E8-A90D-2248C30082B5}"/>
               </a:ext>
             </a:extLst>
           </p:cNvPr>
@@ -20925,7 +20925,7 @@
           <p:cNvPr id="14" name="">
             <a:extLst xmlns:a="http://schemas.openxmlformats.org/drawingml/2006/main">
               <a:ext uri="{FF2B5EF4-FFF2-40B4-BE49-F238E27FC236}">
-                <a16:creationId xmlns:a16="http://schemas.microsoft.com/office/drawing/2014/main" id="{B51BCF44-4A4E-46FF-9CCA-708ABB68070F}"/>
+                <a16:creationId xmlns:a16="http://schemas.microsoft.com/office/drawing/2014/main" id="{1B57B772-1C96-4878-A0A2-930C52FDDC3C}"/>
               </a:ext>
             </a:extLst>
           </p:cNvPr>
@@ -20987,7 +20987,7 @@
           <p:cNvPr id="15" name="">
             <a:extLst xmlns:a="http://schemas.openxmlformats.org/drawingml/2006/main">
               <a:ext uri="{FF2B5EF4-FFF2-40B4-BE49-F238E27FC236}">
-                <a16:creationId xmlns:a16="http://schemas.microsoft.com/office/drawing/2014/main" id="{466301A5-DADA-4C44-A6CA-F6B78008FA04}"/>
+                <a16:creationId xmlns:a16="http://schemas.microsoft.com/office/drawing/2014/main" id="{148B5286-BE65-439A-8DE1-29F4E88D4170}"/>
               </a:ext>
             </a:extLst>
           </p:cNvPr>
@@ -21049,7 +21049,7 @@
           <p:cNvPr id="16" name="">
             <a:extLst xmlns:a="http://schemas.openxmlformats.org/drawingml/2006/main">
               <a:ext uri="{FF2B5EF4-FFF2-40B4-BE49-F238E27FC236}">
-                <a16:creationId xmlns:a16="http://schemas.microsoft.com/office/drawing/2014/main" id="{FF37319F-D11C-45FA-B0D7-56070528E078}"/>
+                <a16:creationId xmlns:a16="http://schemas.microsoft.com/office/drawing/2014/main" id="{0B5D34EB-2F71-49A7-9ED6-36F41FEE4A86}"/>
               </a:ext>
             </a:extLst>
           </p:cNvPr>
@@ -21111,7 +21111,7 @@
           <p:cNvPr id="17" name="dashboard-preview">
             <a:extLst xmlns:a="http://schemas.openxmlformats.org/drawingml/2006/main">
               <a:ext uri="{FF2B5EF4-FFF2-40B4-BE49-F238E27FC236}">
-                <a16:creationId xmlns:a16="http://schemas.microsoft.com/office/drawing/2014/main" id="{D9E1185B-08D8-4187-B8B0-4CB301D5046B}"/>
+                <a16:creationId xmlns:a16="http://schemas.microsoft.com/office/drawing/2014/main" id="{EB75AB39-465B-4AFB-ADB2-37D8C295657C}"/>
               </a:ext>
             </a:extLst>
           </p:cNvPr>
@@ -21146,7 +21146,7 @@
           <p:cNvPr id="18" name="">
             <a:extLst xmlns:a="http://schemas.openxmlformats.org/drawingml/2006/main">
               <a:ext uri="{FF2B5EF4-FFF2-40B4-BE49-F238E27FC236}">
-                <a16:creationId xmlns:a16="http://schemas.microsoft.com/office/drawing/2014/main" id="{C0DC3F27-C8E5-405A-B207-451E3BA3B92D}"/>
+                <a16:creationId xmlns:a16="http://schemas.microsoft.com/office/drawing/2014/main" id="{6E6928F9-8E85-4EA4-A907-1189759E2C68}"/>
               </a:ext>
             </a:extLst>
           </p:cNvPr>
@@ -21208,7 +21208,7 @@
           <p:cNvPr id="19" name="">
             <a:extLst xmlns:a="http://schemas.openxmlformats.org/drawingml/2006/main">
               <a:ext uri="{FF2B5EF4-FFF2-40B4-BE49-F238E27FC236}">
-                <a16:creationId xmlns:a16="http://schemas.microsoft.com/office/drawing/2014/main" id="{B5E32F7C-AAE0-47DB-AF85-32B6D4C3ADFE}"/>
+                <a16:creationId xmlns:a16="http://schemas.microsoft.com/office/drawing/2014/main" id="{1BD68DF1-A4BB-4936-91D7-3165955102C2}"/>
               </a:ext>
             </a:extLst>
           </p:cNvPr>
@@ -21239,7 +21239,7 @@
           <p:cNvPr id="20" name="">
             <a:extLst xmlns:a="http://schemas.openxmlformats.org/drawingml/2006/main">
               <a:ext uri="{FF2B5EF4-FFF2-40B4-BE49-F238E27FC236}">
-                <a16:creationId xmlns:a16="http://schemas.microsoft.com/office/drawing/2014/main" id="{28C9FC7E-0AC3-417B-9A7C-AF6B59492CBC}"/>
+                <a16:creationId xmlns:a16="http://schemas.microsoft.com/office/drawing/2014/main" id="{538AA042-8475-40F3-BBDD-076F34F3E0FD}"/>
               </a:ext>
             </a:extLst>
           </p:cNvPr>
@@ -21301,7 +21301,7 @@
           <p:cNvPr id="21" name="">
             <a:extLst xmlns:a="http://schemas.openxmlformats.org/drawingml/2006/main">
               <a:ext uri="{FF2B5EF4-FFF2-40B4-BE49-F238E27FC236}">
-                <a16:creationId xmlns:a16="http://schemas.microsoft.com/office/drawing/2014/main" id="{33DB07AF-0F51-4556-9FEF-64E02FDD3197}"/>
+                <a16:creationId xmlns:a16="http://schemas.microsoft.com/office/drawing/2014/main" id="{E675EAA7-E819-4077-A9E5-A029C7CB48B8}"/>
               </a:ext>
             </a:extLst>
           </p:cNvPr>
@@ -21332,7 +21332,7 @@
           <p:cNvPr id="22" name="">
             <a:extLst xmlns:a="http://schemas.openxmlformats.org/drawingml/2006/main">
               <a:ext uri="{FF2B5EF4-FFF2-40B4-BE49-F238E27FC236}">
-                <a16:creationId xmlns:a16="http://schemas.microsoft.com/office/drawing/2014/main" id="{261D5617-AB94-4E4C-945C-3DE988949AF8}"/>
+                <a16:creationId xmlns:a16="http://schemas.microsoft.com/office/drawing/2014/main" id="{A4B76ED9-A05A-41C3-9C1B-D48433887372}"/>
               </a:ext>
             </a:extLst>
           </p:cNvPr>
@@ -21363,7 +21363,7 @@
           <p:cNvPr id="23" name="">
             <a:extLst xmlns:a="http://schemas.openxmlformats.org/drawingml/2006/main">
               <a:ext uri="{FF2B5EF4-FFF2-40B4-BE49-F238E27FC236}">
-                <a16:creationId xmlns:a16="http://schemas.microsoft.com/office/drawing/2014/main" id="{48127895-9BE1-4832-A34A-6D0751F19062}"/>
+                <a16:creationId xmlns:a16="http://schemas.microsoft.com/office/drawing/2014/main" id="{54FA30C7-D379-4F6E-B49A-C5C84CF517E0}"/>
               </a:ext>
             </a:extLst>
           </p:cNvPr>
@@ -21396,7 +21396,7 @@
           <p:cNvPr id="24" name="">
             <a:extLst xmlns:a="http://schemas.openxmlformats.org/drawingml/2006/main">
               <a:ext uri="{FF2B5EF4-FFF2-40B4-BE49-F238E27FC236}">
-                <a16:creationId xmlns:a16="http://schemas.microsoft.com/office/drawing/2014/main" id="{A7716547-151B-4E04-9486-CF19CA191782}"/>
+                <a16:creationId xmlns:a16="http://schemas.microsoft.com/office/drawing/2014/main" id="{368B421F-6553-47CB-8195-5B2D2F04B8E0}"/>
               </a:ext>
             </a:extLst>
           </p:cNvPr>
@@ -21458,7 +21458,7 @@
           <p:cNvPr id="25" name="footer-rule-7">
             <a:extLst xmlns:a="http://schemas.openxmlformats.org/drawingml/2006/main">
               <a:ext uri="{FF2B5EF4-FFF2-40B4-BE49-F238E27FC236}">
-                <a16:creationId xmlns:a16="http://schemas.microsoft.com/office/drawing/2014/main" id="{0A599B75-FAA5-4607-A667-442FDCDB7345}"/>
+                <a16:creationId xmlns:a16="http://schemas.microsoft.com/office/drawing/2014/main" id="{F34EC543-DDB4-4B58-949B-9CE120839DA5}"/>
               </a:ext>
             </a:extLst>
           </p:cNvPr>
@@ -21489,7 +21489,7 @@
           <p:cNvPr id="26" name="footer-label-7">
             <a:extLst xmlns:a="http://schemas.openxmlformats.org/drawingml/2006/main">
               <a:ext uri="{FF2B5EF4-FFF2-40B4-BE49-F238E27FC236}">
-                <a16:creationId xmlns:a16="http://schemas.microsoft.com/office/drawing/2014/main" id="{CC4E7A8E-E8B4-4C5E-A423-98EE0A10FC5C}"/>
+                <a16:creationId xmlns:a16="http://schemas.microsoft.com/office/drawing/2014/main" id="{14AE3DE4-2063-44FD-8273-72823FD6592C}"/>
               </a:ext>
             </a:extLst>
           </p:cNvPr>
@@ -21551,7 +21551,7 @@
           <p:cNvPr id="27" name="footer-page-7">
             <a:extLst xmlns:a="http://schemas.openxmlformats.org/drawingml/2006/main">
               <a:ext uri="{FF2B5EF4-FFF2-40B4-BE49-F238E27FC236}">
-                <a16:creationId xmlns:a16="http://schemas.microsoft.com/office/drawing/2014/main" id="{CCD08EF8-1DE6-45F5-BCE9-E89C7532F028}"/>
+                <a16:creationId xmlns:a16="http://schemas.microsoft.com/office/drawing/2014/main" id="{D6F46EC2-032E-41D8-98D6-E94CE4035625}"/>
               </a:ext>
             </a:extLst>
           </p:cNvPr>
@@ -21611,7 +21611,7 @@
     </p:spTree>
     <p:extLst>
       <p:ext uri="{BB962C8B-B14F-4D97-AF65-F5344CB8AC3E}">
-        <p14:creationId xmlns:p14="http://schemas.microsoft.com/office/powerpoint/2010/main" val="1927335102"/>
+        <p14:creationId xmlns:p14="http://schemas.microsoft.com/office/powerpoint/2010/main" val="1764458369"/>
       </p:ext>
     </p:extLst>
   </p:cSld>
@@ -21642,7 +21642,7 @@
           <p:cNvPr id="26" name="side-accent-8">
             <a:extLst xmlns:a="http://schemas.openxmlformats.org/drawingml/2006/main">
               <a:ext uri="{FF2B5EF4-FFF2-40B4-BE49-F238E27FC236}">
-                <a16:creationId xmlns:a16="http://schemas.microsoft.com/office/drawing/2014/main" id="{24CBBD4C-EA63-4B0D-BC9B-2D01A016BD81}"/>
+                <a16:creationId xmlns:a16="http://schemas.microsoft.com/office/drawing/2014/main" id="{3AB54EC4-C75C-4C5F-B8AB-3962D5D19D55}"/>
               </a:ext>
             </a:extLst>
           </p:cNvPr>
@@ -21673,7 +21673,7 @@
           <p:cNvPr id="2" name="kicker-8">
             <a:extLst xmlns:a="http://schemas.openxmlformats.org/drawingml/2006/main">
               <a:ext uri="{FF2B5EF4-FFF2-40B4-BE49-F238E27FC236}">
-                <a16:creationId xmlns:a16="http://schemas.microsoft.com/office/drawing/2014/main" id="{6D3DBB0B-47EB-42CF-845E-42324D4D9EF4}"/>
+                <a16:creationId xmlns:a16="http://schemas.microsoft.com/office/drawing/2014/main" id="{DA66F23D-6B0D-4078-A324-8329F1D442EC}"/>
               </a:ext>
             </a:extLst>
           </p:cNvPr>
@@ -21735,7 +21735,7 @@
           <p:cNvPr id="3" name="title-8">
             <a:extLst xmlns:a="http://schemas.openxmlformats.org/drawingml/2006/main">
               <a:ext uri="{FF2B5EF4-FFF2-40B4-BE49-F238E27FC236}">
-                <a16:creationId xmlns:a16="http://schemas.microsoft.com/office/drawing/2014/main" id="{FC14FA47-1CDB-4E8F-BE0A-E4BAC93FEA95}"/>
+                <a16:creationId xmlns:a16="http://schemas.microsoft.com/office/drawing/2014/main" id="{00880EC9-754E-4E18-9EB2-871EFF7B40DD}"/>
               </a:ext>
             </a:extLst>
           </p:cNvPr>
@@ -21797,7 +21797,7 @@
           <p:cNvPr id="4" name="">
             <a:extLst xmlns:a="http://schemas.openxmlformats.org/drawingml/2006/main">
               <a:ext uri="{FF2B5EF4-FFF2-40B4-BE49-F238E27FC236}">
-                <a16:creationId xmlns:a16="http://schemas.microsoft.com/office/drawing/2014/main" id="{0F4B21D8-1872-4F2D-9100-D5EAE8B34580}"/>
+                <a16:creationId xmlns:a16="http://schemas.microsoft.com/office/drawing/2014/main" id="{04B88BC5-415E-46B1-AF7E-81C7812562B4}"/>
               </a:ext>
             </a:extLst>
           </p:cNvPr>
@@ -21859,7 +21859,7 @@
           <p:cNvPr id="5" name="">
             <a:extLst xmlns:a="http://schemas.openxmlformats.org/drawingml/2006/main">
               <a:ext uri="{FF2B5EF4-FFF2-40B4-BE49-F238E27FC236}">
-                <a16:creationId xmlns:a16="http://schemas.microsoft.com/office/drawing/2014/main" id="{CBF1579D-E094-4D43-8010-0FE0C56C5DCA}"/>
+                <a16:creationId xmlns:a16="http://schemas.microsoft.com/office/drawing/2014/main" id="{2CFA5C4A-9DFD-4413-954B-7F4A9463850E}"/>
               </a:ext>
             </a:extLst>
           </p:cNvPr>
@@ -21890,7 +21890,7 @@
           <p:cNvPr id="6" name="">
             <a:extLst xmlns:a="http://schemas.openxmlformats.org/drawingml/2006/main">
               <a:ext uri="{FF2B5EF4-FFF2-40B4-BE49-F238E27FC236}">
-                <a16:creationId xmlns:a16="http://schemas.microsoft.com/office/drawing/2014/main" id="{0FAF7E0E-352E-4FBF-A32C-D554C97E4783}"/>
+                <a16:creationId xmlns:a16="http://schemas.microsoft.com/office/drawing/2014/main" id="{E83CD29E-C7FC-4A28-82D7-94F0893CE424}"/>
               </a:ext>
             </a:extLst>
           </p:cNvPr>
@@ -21921,7 +21921,7 @@
           <p:cNvPr id="7" name="">
             <a:extLst xmlns:a="http://schemas.openxmlformats.org/drawingml/2006/main">
               <a:ext uri="{FF2B5EF4-FFF2-40B4-BE49-F238E27FC236}">
-                <a16:creationId xmlns:a16="http://schemas.microsoft.com/office/drawing/2014/main" id="{18DE1D29-C3CB-471B-A8BC-9D62FFA531AE}"/>
+                <a16:creationId xmlns:a16="http://schemas.microsoft.com/office/drawing/2014/main" id="{4EAAE85D-D75E-4050-B7E3-27BAE1F93561}"/>
               </a:ext>
             </a:extLst>
           </p:cNvPr>
@@ -21983,7 +21983,7 @@
           <p:cNvPr id="8" name="">
             <a:extLst xmlns:a="http://schemas.openxmlformats.org/drawingml/2006/main">
               <a:ext uri="{FF2B5EF4-FFF2-40B4-BE49-F238E27FC236}">
-                <a16:creationId xmlns:a16="http://schemas.microsoft.com/office/drawing/2014/main" id="{686FAC4C-7D9C-4BC7-9EF4-C2FBDAFCE625}"/>
+                <a16:creationId xmlns:a16="http://schemas.microsoft.com/office/drawing/2014/main" id="{6C8126FA-E03C-4EA4-B7F2-9E5390B844B0}"/>
               </a:ext>
             </a:extLst>
           </p:cNvPr>
@@ -22045,7 +22045,7 @@
           <p:cNvPr id="9" name="">
             <a:extLst xmlns:a="http://schemas.openxmlformats.org/drawingml/2006/main">
               <a:ext uri="{FF2B5EF4-FFF2-40B4-BE49-F238E27FC236}">
-                <a16:creationId xmlns:a16="http://schemas.microsoft.com/office/drawing/2014/main" id="{066BB28B-9E24-47D4-ADA3-7813E18A0890}"/>
+                <a16:creationId xmlns:a16="http://schemas.microsoft.com/office/drawing/2014/main" id="{0B4A3CE2-A1BF-43D6-B8DE-B38F34124886}"/>
               </a:ext>
             </a:extLst>
           </p:cNvPr>
@@ -22107,7 +22107,7 @@
           <p:cNvPr id="10" name="">
             <a:extLst xmlns:a="http://schemas.openxmlformats.org/drawingml/2006/main">
               <a:ext uri="{FF2B5EF4-FFF2-40B4-BE49-F238E27FC236}">
-                <a16:creationId xmlns:a16="http://schemas.microsoft.com/office/drawing/2014/main" id="{C4C33D2B-3F83-473A-A1D8-D5DE63BA7861}"/>
+                <a16:creationId xmlns:a16="http://schemas.microsoft.com/office/drawing/2014/main" id="{AA360AF8-A3F3-4699-9DDB-1CFC3686ACAB}"/>
               </a:ext>
             </a:extLst>
           </p:cNvPr>
@@ -22138,7 +22138,7 @@
           <p:cNvPr id="11" name="">
             <a:extLst xmlns:a="http://schemas.openxmlformats.org/drawingml/2006/main">
               <a:ext uri="{FF2B5EF4-FFF2-40B4-BE49-F238E27FC236}">
-                <a16:creationId xmlns:a16="http://schemas.microsoft.com/office/drawing/2014/main" id="{68825B47-4377-4ABE-9780-D30835F06F04}"/>
+                <a16:creationId xmlns:a16="http://schemas.microsoft.com/office/drawing/2014/main" id="{5E8B8E53-98FF-425D-BE06-B30E4AEA395C}"/>
               </a:ext>
             </a:extLst>
           </p:cNvPr>
@@ -22200,7 +22200,7 @@
           <p:cNvPr id="12" name="">
             <a:extLst xmlns:a="http://schemas.openxmlformats.org/drawingml/2006/main">
               <a:ext uri="{FF2B5EF4-FFF2-40B4-BE49-F238E27FC236}">
-                <a16:creationId xmlns:a16="http://schemas.microsoft.com/office/drawing/2014/main" id="{2A1F14C8-EBAE-4A97-8B87-9DAF47938805}"/>
+                <a16:creationId xmlns:a16="http://schemas.microsoft.com/office/drawing/2014/main" id="{021A9E48-AF71-4BAB-8C08-B7E6EE119A9D}"/>
               </a:ext>
             </a:extLst>
           </p:cNvPr>
@@ -22262,7 +22262,7 @@
           <p:cNvPr id="13" name="">
             <a:extLst xmlns:a="http://schemas.openxmlformats.org/drawingml/2006/main">
               <a:ext uri="{FF2B5EF4-FFF2-40B4-BE49-F238E27FC236}">
-                <a16:creationId xmlns:a16="http://schemas.microsoft.com/office/drawing/2014/main" id="{A12CE7ED-6DB0-4B9F-A24E-813AD3D8E0DB}"/>
+                <a16:creationId xmlns:a16="http://schemas.microsoft.com/office/drawing/2014/main" id="{1160882F-EE69-4E59-94A2-164919EA1BEB}"/>
               </a:ext>
             </a:extLst>
           </p:cNvPr>
@@ -22324,7 +22324,7 @@
           <p:cNvPr id="14" name="">
             <a:extLst xmlns:a="http://schemas.openxmlformats.org/drawingml/2006/main">
               <a:ext uri="{FF2B5EF4-FFF2-40B4-BE49-F238E27FC236}">
-                <a16:creationId xmlns:a16="http://schemas.microsoft.com/office/drawing/2014/main" id="{6575CCC6-833D-4F44-96B7-917338940011}"/>
+                <a16:creationId xmlns:a16="http://schemas.microsoft.com/office/drawing/2014/main" id="{0301152C-7D87-44C6-9A44-A31BCEC84101}"/>
               </a:ext>
             </a:extLst>
           </p:cNvPr>
@@ -22355,7 +22355,7 @@
           <p:cNvPr id="15" name="">
             <a:extLst xmlns:a="http://schemas.openxmlformats.org/drawingml/2006/main">
               <a:ext uri="{FF2B5EF4-FFF2-40B4-BE49-F238E27FC236}">
-                <a16:creationId xmlns:a16="http://schemas.microsoft.com/office/drawing/2014/main" id="{97957B90-F9B5-405A-A3BA-E12CAA8BA76A}"/>
+                <a16:creationId xmlns:a16="http://schemas.microsoft.com/office/drawing/2014/main" id="{F0A0CC65-9189-4703-8CD6-FF865B0CC2F2}"/>
               </a:ext>
             </a:extLst>
           </p:cNvPr>
@@ -22417,7 +22417,7 @@
           <p:cNvPr id="16" name="">
             <a:extLst xmlns:a="http://schemas.openxmlformats.org/drawingml/2006/main">
               <a:ext uri="{FF2B5EF4-FFF2-40B4-BE49-F238E27FC236}">
-                <a16:creationId xmlns:a16="http://schemas.microsoft.com/office/drawing/2014/main" id="{56D56FF0-EAF9-461F-88AC-EDCF30F482EC}"/>
+                <a16:creationId xmlns:a16="http://schemas.microsoft.com/office/drawing/2014/main" id="{086690A6-92EB-418A-B683-BAA677C7C7F9}"/>
               </a:ext>
             </a:extLst>
           </p:cNvPr>
@@ -22479,7 +22479,7 @@
           <p:cNvPr id="17" name="">
             <a:extLst xmlns:a="http://schemas.openxmlformats.org/drawingml/2006/main">
               <a:ext uri="{FF2B5EF4-FFF2-40B4-BE49-F238E27FC236}">
-                <a16:creationId xmlns:a16="http://schemas.microsoft.com/office/drawing/2014/main" id="{57FD26F8-F928-490D-A163-4F81C6F013B5}"/>
+                <a16:creationId xmlns:a16="http://schemas.microsoft.com/office/drawing/2014/main" id="{26A5C8AC-D2D1-41F8-A101-E73D6834AAEA}"/>
               </a:ext>
             </a:extLst>
           </p:cNvPr>
@@ -22541,7 +22541,7 @@
           <p:cNvPr id="18" name="">
             <a:extLst xmlns:a="http://schemas.openxmlformats.org/drawingml/2006/main">
               <a:ext uri="{FF2B5EF4-FFF2-40B4-BE49-F238E27FC236}">
-                <a16:creationId xmlns:a16="http://schemas.microsoft.com/office/drawing/2014/main" id="{7ED3654B-BE6B-45D8-9113-FA9A57EA2D1C}"/>
+                <a16:creationId xmlns:a16="http://schemas.microsoft.com/office/drawing/2014/main" id="{ECE8C131-BE7E-4919-8CF4-D5820E71FCA2}"/>
               </a:ext>
             </a:extLst>
           </p:cNvPr>
@@ -22572,7 +22572,7 @@
           <p:cNvPr id="19" name="">
             <a:extLst xmlns:a="http://schemas.openxmlformats.org/drawingml/2006/main">
               <a:ext uri="{FF2B5EF4-FFF2-40B4-BE49-F238E27FC236}">
-                <a16:creationId xmlns:a16="http://schemas.microsoft.com/office/drawing/2014/main" id="{2ACEA1A8-3ED5-44C7-977F-4065D7EDF81E}"/>
+                <a16:creationId xmlns:a16="http://schemas.microsoft.com/office/drawing/2014/main" id="{14FE03CB-98CB-410E-AC1B-4C3649540B05}"/>
               </a:ext>
             </a:extLst>
           </p:cNvPr>
@@ -22634,7 +22634,7 @@
           <p:cNvPr id="20" name="">
             <a:extLst xmlns:a="http://schemas.openxmlformats.org/drawingml/2006/main">
               <a:ext uri="{FF2B5EF4-FFF2-40B4-BE49-F238E27FC236}">
-                <a16:creationId xmlns:a16="http://schemas.microsoft.com/office/drawing/2014/main" id="{00447E79-DDCC-4AD7-BCD9-BBD02A7F4FF8}"/>
+                <a16:creationId xmlns:a16="http://schemas.microsoft.com/office/drawing/2014/main" id="{8C640FD2-308D-4AA3-B872-A7760E119DB5}"/>
               </a:ext>
             </a:extLst>
           </p:cNvPr>
@@ -22696,7 +22696,7 @@
           <p:cNvPr id="21" name="">
             <a:extLst xmlns:a="http://schemas.openxmlformats.org/drawingml/2006/main">
               <a:ext uri="{FF2B5EF4-FFF2-40B4-BE49-F238E27FC236}">
-                <a16:creationId xmlns:a16="http://schemas.microsoft.com/office/drawing/2014/main" id="{07B6843A-09AB-4819-95FA-C77F0C1EB27D}"/>
+                <a16:creationId xmlns:a16="http://schemas.microsoft.com/office/drawing/2014/main" id="{CF30F53C-C1E0-46BC-8B2B-128634A6612E}"/>
               </a:ext>
             </a:extLst>
           </p:cNvPr>
@@ -22758,7 +22758,7 @@
           <p:cNvPr id="22" name="">
             <a:extLst xmlns:a="http://schemas.openxmlformats.org/drawingml/2006/main">
               <a:ext uri="{FF2B5EF4-FFF2-40B4-BE49-F238E27FC236}">
-                <a16:creationId xmlns:a16="http://schemas.microsoft.com/office/drawing/2014/main" id="{5469C0CD-62A4-44F4-8AB9-C5985DBF94D5}"/>
+                <a16:creationId xmlns:a16="http://schemas.microsoft.com/office/drawing/2014/main" id="{CF0232D8-BD29-4E66-B6DB-C593346C2EC9}"/>
               </a:ext>
             </a:extLst>
           </p:cNvPr>
@@ -22820,7 +22820,7 @@
           <p:cNvPr id="23" name="footer-rule-8">
             <a:extLst xmlns:a="http://schemas.openxmlformats.org/drawingml/2006/main">
               <a:ext uri="{FF2B5EF4-FFF2-40B4-BE49-F238E27FC236}">
-                <a16:creationId xmlns:a16="http://schemas.microsoft.com/office/drawing/2014/main" id="{3F130250-15F7-451D-81A9-74134718C5FD}"/>
+                <a16:creationId xmlns:a16="http://schemas.microsoft.com/office/drawing/2014/main" id="{883EDFB6-1566-4EC1-A62F-592201A851E8}"/>
               </a:ext>
             </a:extLst>
           </p:cNvPr>
@@ -22851,7 +22851,7 @@
           <p:cNvPr id="24" name="footer-label-8">
             <a:extLst xmlns:a="http://schemas.openxmlformats.org/drawingml/2006/main">
               <a:ext uri="{FF2B5EF4-FFF2-40B4-BE49-F238E27FC236}">
-                <a16:creationId xmlns:a16="http://schemas.microsoft.com/office/drawing/2014/main" id="{5E5C470A-E854-4863-A1C2-CA9B3B70AE1B}"/>
+                <a16:creationId xmlns:a16="http://schemas.microsoft.com/office/drawing/2014/main" id="{2543DB9B-4DAB-429D-973D-BA3091315039}"/>
               </a:ext>
             </a:extLst>
           </p:cNvPr>
@@ -22913,7 +22913,7 @@
           <p:cNvPr id="25" name="footer-page-8">
             <a:extLst xmlns:a="http://schemas.openxmlformats.org/drawingml/2006/main">
               <a:ext uri="{FF2B5EF4-FFF2-40B4-BE49-F238E27FC236}">
-                <a16:creationId xmlns:a16="http://schemas.microsoft.com/office/drawing/2014/main" id="{8EEE3246-E411-4418-BA5F-A817CEC45FB1}"/>
+                <a16:creationId xmlns:a16="http://schemas.microsoft.com/office/drawing/2014/main" id="{0EA1E7B7-29C4-4965-9CB4-3F347D16D12D}"/>
               </a:ext>
             </a:extLst>
           </p:cNvPr>
@@ -22973,7 +22973,7 @@
     </p:spTree>
     <p:extLst>
       <p:ext uri="{BB962C8B-B14F-4D97-AF65-F5344CB8AC3E}">
-        <p14:creationId xmlns:p14="http://schemas.microsoft.com/office/powerpoint/2010/main" val="1752682799"/>
+        <p14:creationId xmlns:p14="http://schemas.microsoft.com/office/powerpoint/2010/main" val="279510956"/>
       </p:ext>
     </p:extLst>
   </p:cSld>
@@ -23004,7 +23004,7 @@
           <p:cNvPr id="25" name="side-accent-9">
             <a:extLst xmlns:a="http://schemas.openxmlformats.org/drawingml/2006/main">
               <a:ext uri="{FF2B5EF4-FFF2-40B4-BE49-F238E27FC236}">
-                <a16:creationId xmlns:a16="http://schemas.microsoft.com/office/drawing/2014/main" id="{5502924F-5029-44DF-94F5-7743242E5EBD}"/>
+                <a16:creationId xmlns:a16="http://schemas.microsoft.com/office/drawing/2014/main" id="{4B3F8C4A-0A65-4138-A495-046AC47425FA}"/>
               </a:ext>
             </a:extLst>
           </p:cNvPr>
@@ -23035,7 +23035,7 @@
           <p:cNvPr id="2" name="kicker-9">
             <a:extLst xmlns:a="http://schemas.openxmlformats.org/drawingml/2006/main">
               <a:ext uri="{FF2B5EF4-FFF2-40B4-BE49-F238E27FC236}">
-                <a16:creationId xmlns:a16="http://schemas.microsoft.com/office/drawing/2014/main" id="{C64C8E90-B59F-4088-9122-BCA6FB0C2D82}"/>
+                <a16:creationId xmlns:a16="http://schemas.microsoft.com/office/drawing/2014/main" id="{6B0B73A5-DB27-455F-B5D3-0243DDFEC697}"/>
               </a:ext>
             </a:extLst>
           </p:cNvPr>
@@ -23097,7 +23097,7 @@
           <p:cNvPr id="3" name="title-9">
             <a:extLst xmlns:a="http://schemas.openxmlformats.org/drawingml/2006/main">
               <a:ext uri="{FF2B5EF4-FFF2-40B4-BE49-F238E27FC236}">
-                <a16:creationId xmlns:a16="http://schemas.microsoft.com/office/drawing/2014/main" id="{92B6E0D3-9B2D-42AD-82FB-FAFBBDD1181B}"/>
+                <a16:creationId xmlns:a16="http://schemas.microsoft.com/office/drawing/2014/main" id="{4E204E3D-3D8D-4BB6-BE38-E3162BF3BDAA}"/>
               </a:ext>
             </a:extLst>
           </p:cNvPr>
@@ -23159,7 +23159,7 @@
           <p:cNvPr id="4" name="">
             <a:extLst xmlns:a="http://schemas.openxmlformats.org/drawingml/2006/main">
               <a:ext uri="{FF2B5EF4-FFF2-40B4-BE49-F238E27FC236}">
-                <a16:creationId xmlns:a16="http://schemas.microsoft.com/office/drawing/2014/main" id="{96A9990E-E77B-4E2B-806C-35F889149A8A}"/>
+                <a16:creationId xmlns:a16="http://schemas.microsoft.com/office/drawing/2014/main" id="{778787D3-59C7-408C-AAC5-EB6B8FE90615}"/>
               </a:ext>
             </a:extLst>
           </p:cNvPr>
@@ -23221,7 +23221,7 @@
           <p:cNvPr id="5" name="">
             <a:extLst xmlns:a="http://schemas.openxmlformats.org/drawingml/2006/main">
               <a:ext uri="{FF2B5EF4-FFF2-40B4-BE49-F238E27FC236}">
-                <a16:creationId xmlns:a16="http://schemas.microsoft.com/office/drawing/2014/main" id="{6CE3C390-14B5-4D9E-8255-D89EAE874261}"/>
+                <a16:creationId xmlns:a16="http://schemas.microsoft.com/office/drawing/2014/main" id="{F5324C86-7598-4FF7-BB2B-F820E07D5BCD}"/>
               </a:ext>
             </a:extLst>
           </p:cNvPr>
@@ -23256,7 +23256,7 @@
           <p:cNvPr id="6" name="">
             <a:extLst xmlns:a="http://schemas.openxmlformats.org/drawingml/2006/main">
               <a:ext uri="{FF2B5EF4-FFF2-40B4-BE49-F238E27FC236}">
-                <a16:creationId xmlns:a16="http://schemas.microsoft.com/office/drawing/2014/main" id="{A483E6C0-E57E-4F90-9C73-4046924CC2CE}"/>
+                <a16:creationId xmlns:a16="http://schemas.microsoft.com/office/drawing/2014/main" id="{C877015B-A2F8-4B20-8BEF-98A895D53568}"/>
               </a:ext>
             </a:extLst>
           </p:cNvPr>
@@ -23318,7 +23318,7 @@
           <p:cNvPr id="7" name="">
             <a:extLst xmlns:a="http://schemas.openxmlformats.org/drawingml/2006/main">
               <a:ext uri="{FF2B5EF4-FFF2-40B4-BE49-F238E27FC236}">
-                <a16:creationId xmlns:a16="http://schemas.microsoft.com/office/drawing/2014/main" id="{217A7C78-E755-4EE6-AF47-9BB6E411E26E}"/>
+                <a16:creationId xmlns:a16="http://schemas.microsoft.com/office/drawing/2014/main" id="{D6CC9B50-8D39-491A-809F-874F7CD9FFE4}"/>
               </a:ext>
             </a:extLst>
           </p:cNvPr>
@@ -23380,7 +23380,7 @@
           <p:cNvPr id="8" name="">
             <a:extLst xmlns:a="http://schemas.openxmlformats.org/drawingml/2006/main">
               <a:ext uri="{FF2B5EF4-FFF2-40B4-BE49-F238E27FC236}">
-                <a16:creationId xmlns:a16="http://schemas.microsoft.com/office/drawing/2014/main" id="{7AE6D746-12CB-44D8-B246-2FF6621BEF56}"/>
+                <a16:creationId xmlns:a16="http://schemas.microsoft.com/office/drawing/2014/main" id="{07B22CCC-A135-4EA5-BD00-A80834FA6C03}"/>
               </a:ext>
             </a:extLst>
           </p:cNvPr>
@@ -23442,7 +23442,7 @@
           <p:cNvPr id="9" name="">
             <a:extLst xmlns:a="http://schemas.openxmlformats.org/drawingml/2006/main">
               <a:ext uri="{FF2B5EF4-FFF2-40B4-BE49-F238E27FC236}">
-                <a16:creationId xmlns:a16="http://schemas.microsoft.com/office/drawing/2014/main" id="{DF32875A-5EB2-420F-A6AE-EFB21E649386}"/>
+                <a16:creationId xmlns:a16="http://schemas.microsoft.com/office/drawing/2014/main" id="{DE29241F-E656-4FFB-A1E8-F39412F77E6B}"/>
               </a:ext>
             </a:extLst>
           </p:cNvPr>
@@ -23477,7 +23477,7 @@
           <p:cNvPr id="10" name="">
             <a:extLst xmlns:a="http://schemas.openxmlformats.org/drawingml/2006/main">
               <a:ext uri="{FF2B5EF4-FFF2-40B4-BE49-F238E27FC236}">
-                <a16:creationId xmlns:a16="http://schemas.microsoft.com/office/drawing/2014/main" id="{28F8B61D-BAFF-4FAB-8173-C55DE9B21D54}"/>
+                <a16:creationId xmlns:a16="http://schemas.microsoft.com/office/drawing/2014/main" id="{D4A8E042-0448-48AD-BF09-99261B6856F0}"/>
               </a:ext>
             </a:extLst>
           </p:cNvPr>
@@ -23539,7 +23539,7 @@
           <p:cNvPr id="11" name="">
             <a:extLst xmlns:a="http://schemas.openxmlformats.org/drawingml/2006/main">
               <a:ext uri="{FF2B5EF4-FFF2-40B4-BE49-F238E27FC236}">
-                <a16:creationId xmlns:a16="http://schemas.microsoft.com/office/drawing/2014/main" id="{650714D3-19C2-48AB-BE70-F38D5C12811C}"/>
+                <a16:creationId xmlns:a16="http://schemas.microsoft.com/office/drawing/2014/main" id="{D0877AE2-55C2-4558-8C03-3B5DD40D6BD9}"/>
               </a:ext>
             </a:extLst>
           </p:cNvPr>
@@ -23601,7 +23601,7 @@
           <p:cNvPr id="12" name="">
             <a:extLst xmlns:a="http://schemas.openxmlformats.org/drawingml/2006/main">
               <a:ext uri="{FF2B5EF4-FFF2-40B4-BE49-F238E27FC236}">
-                <a16:creationId xmlns:a16="http://schemas.microsoft.com/office/drawing/2014/main" id="{809591B1-237F-4C2C-BFCC-98F1BB673A06}"/>
+                <a16:creationId xmlns:a16="http://schemas.microsoft.com/office/drawing/2014/main" id="{1ACAFE52-4C26-444F-B5BD-FB1A309536E2}"/>
               </a:ext>
             </a:extLst>
           </p:cNvPr>
@@ -23663,7 +23663,7 @@
           <p:cNvPr id="13" name="">
             <a:extLst xmlns:a="http://schemas.openxmlformats.org/drawingml/2006/main">
               <a:ext uri="{FF2B5EF4-FFF2-40B4-BE49-F238E27FC236}">
-                <a16:creationId xmlns:a16="http://schemas.microsoft.com/office/drawing/2014/main" id="{250906A2-B552-4BDA-8A35-B69FA8AB298C}"/>
+                <a16:creationId xmlns:a16="http://schemas.microsoft.com/office/drawing/2014/main" id="{3764D00B-9161-450A-ACB8-45772E2132F1}"/>
               </a:ext>
             </a:extLst>
           </p:cNvPr>
@@ -23698,7 +23698,7 @@
           <p:cNvPr id="14" name="">
             <a:extLst xmlns:a="http://schemas.openxmlformats.org/drawingml/2006/main">
               <a:ext uri="{FF2B5EF4-FFF2-40B4-BE49-F238E27FC236}">
-                <a16:creationId xmlns:a16="http://schemas.microsoft.com/office/drawing/2014/main" id="{8265D1D9-23AA-45D1-B90F-F2C11B3C5998}"/>
+                <a16:creationId xmlns:a16="http://schemas.microsoft.com/office/drawing/2014/main" id="{61283989-8D86-4DB1-9F98-CE674E9CA52E}"/>
               </a:ext>
             </a:extLst>
           </p:cNvPr>
@@ -23760,7 +23760,7 @@
           <p:cNvPr id="15" name="">
             <a:extLst xmlns:a="http://schemas.openxmlformats.org/drawingml/2006/main">
               <a:ext uri="{FF2B5EF4-FFF2-40B4-BE49-F238E27FC236}">
-                <a16:creationId xmlns:a16="http://schemas.microsoft.com/office/drawing/2014/main" id="{AF3BD0B1-CA25-4A74-8043-D840C28DAD30}"/>
+                <a16:creationId xmlns:a16="http://schemas.microsoft.com/office/drawing/2014/main" id="{9DEBE0F5-6B7C-42A6-81A9-0DE3D15EE51C}"/>
               </a:ext>
             </a:extLst>
           </p:cNvPr>
@@ -23822,7 +23822,7 @@
           <p:cNvPr id="16" name="">
             <a:extLst xmlns:a="http://schemas.openxmlformats.org/drawingml/2006/main">
               <a:ext uri="{FF2B5EF4-FFF2-40B4-BE49-F238E27FC236}">
-                <a16:creationId xmlns:a16="http://schemas.microsoft.com/office/drawing/2014/main" id="{C821F93F-1793-411B-A014-894286CAFFA1}"/>
+                <a16:creationId xmlns:a16="http://schemas.microsoft.com/office/drawing/2014/main" id="{F6F53C49-683E-4188-90A5-D457543DB46E}"/>
               </a:ext>
             </a:extLst>
           </p:cNvPr>
@@ -23884,7 +23884,7 @@
           <p:cNvPr id="17" name="">
             <a:extLst xmlns:a="http://schemas.openxmlformats.org/drawingml/2006/main">
               <a:ext uri="{FF2B5EF4-FFF2-40B4-BE49-F238E27FC236}">
-                <a16:creationId xmlns:a16="http://schemas.microsoft.com/office/drawing/2014/main" id="{3FEC4484-DBE2-40F4-A14C-0B551FFE160C}"/>
+                <a16:creationId xmlns:a16="http://schemas.microsoft.com/office/drawing/2014/main" id="{CF7882D4-44A7-4FCB-A34F-DA8E6F38A11F}"/>
               </a:ext>
             </a:extLst>
           </p:cNvPr>
@@ -23919,7 +23919,7 @@
           <p:cNvPr id="18" name="">
             <a:extLst xmlns:a="http://schemas.openxmlformats.org/drawingml/2006/main">
               <a:ext uri="{FF2B5EF4-FFF2-40B4-BE49-F238E27FC236}">
-                <a16:creationId xmlns:a16="http://schemas.microsoft.com/office/drawing/2014/main" id="{40CE5DDC-45B8-49C6-8346-1ABB86EB32AC}"/>
+                <a16:creationId xmlns:a16="http://schemas.microsoft.com/office/drawing/2014/main" id="{3E1374F4-1E1F-47B7-B4E6-720A7C3E17C9}"/>
               </a:ext>
             </a:extLst>
           </p:cNvPr>
@@ -23981,7 +23981,7 @@
           <p:cNvPr id="19" name="">
             <a:extLst xmlns:a="http://schemas.openxmlformats.org/drawingml/2006/main">
               <a:ext uri="{FF2B5EF4-FFF2-40B4-BE49-F238E27FC236}">
-                <a16:creationId xmlns:a16="http://schemas.microsoft.com/office/drawing/2014/main" id="{65C077DD-CA0D-478D-B0EA-3CAA332DF03A}"/>
+                <a16:creationId xmlns:a16="http://schemas.microsoft.com/office/drawing/2014/main" id="{A35DBE73-287B-49D8-BE06-086B881BD158}"/>
               </a:ext>
             </a:extLst>
           </p:cNvPr>
@@ -24043,7 +24043,7 @@
           <p:cNvPr id="20" name="">
             <a:extLst xmlns:a="http://schemas.openxmlformats.org/drawingml/2006/main">
               <a:ext uri="{FF2B5EF4-FFF2-40B4-BE49-F238E27FC236}">
-                <a16:creationId xmlns:a16="http://schemas.microsoft.com/office/drawing/2014/main" id="{154BFF4B-DDEF-430A-B417-484FBC6F8BDD}"/>
+                <a16:creationId xmlns:a16="http://schemas.microsoft.com/office/drawing/2014/main" id="{ABF43252-393A-4B14-B802-71493AD82BD6}"/>
               </a:ext>
             </a:extLst>
           </p:cNvPr>
@@ -24105,7 +24105,7 @@
           <p:cNvPr id="21" name="">
             <a:extLst xmlns:a="http://schemas.openxmlformats.org/drawingml/2006/main">
               <a:ext uri="{FF2B5EF4-FFF2-40B4-BE49-F238E27FC236}">
-                <a16:creationId xmlns:a16="http://schemas.microsoft.com/office/drawing/2014/main" id="{E9F3B95E-76F1-4FB6-9FC1-4CC2765B4D1A}"/>
+                <a16:creationId xmlns:a16="http://schemas.microsoft.com/office/drawing/2014/main" id="{1E94C4AE-4478-4F00-8571-0E6CD073DFFA}"/>
               </a:ext>
             </a:extLst>
           </p:cNvPr>
@@ -24167,7 +24167,7 @@
           <p:cNvPr id="22" name="footer-rule-9">
             <a:extLst xmlns:a="http://schemas.openxmlformats.org/drawingml/2006/main">
               <a:ext uri="{FF2B5EF4-FFF2-40B4-BE49-F238E27FC236}">
-                <a16:creationId xmlns:a16="http://schemas.microsoft.com/office/drawing/2014/main" id="{3E22E8E5-C3E4-41C3-9AAD-708DD9529382}"/>
+                <a16:creationId xmlns:a16="http://schemas.microsoft.com/office/drawing/2014/main" id="{8F98F8F3-B117-408C-A057-88AE322E8BA2}"/>
               </a:ext>
             </a:extLst>
           </p:cNvPr>
@@ -24198,7 +24198,7 @@
           <p:cNvPr id="23" name="footer-label-9">
             <a:extLst xmlns:a="http://schemas.openxmlformats.org/drawingml/2006/main">
               <a:ext uri="{FF2B5EF4-FFF2-40B4-BE49-F238E27FC236}">
-                <a16:creationId xmlns:a16="http://schemas.microsoft.com/office/drawing/2014/main" id="{D3AE3B5D-4745-43DF-9275-B1562A6BE3E8}"/>
+                <a16:creationId xmlns:a16="http://schemas.microsoft.com/office/drawing/2014/main" id="{F9963923-4A4D-4515-AE25-8BD80F5AF084}"/>
               </a:ext>
             </a:extLst>
           </p:cNvPr>
@@ -24260,7 +24260,7 @@
           <p:cNvPr id="24" name="footer-page-9">
             <a:extLst xmlns:a="http://schemas.openxmlformats.org/drawingml/2006/main">
               <a:ext uri="{FF2B5EF4-FFF2-40B4-BE49-F238E27FC236}">
-                <a16:creationId xmlns:a16="http://schemas.microsoft.com/office/drawing/2014/main" id="{C1880235-09F0-4A52-B9FC-0EE8E6696623}"/>
+                <a16:creationId xmlns:a16="http://schemas.microsoft.com/office/drawing/2014/main" id="{775CA1A7-2998-413A-964A-C6AD37471D64}"/>
               </a:ext>
             </a:extLst>
           </p:cNvPr>
@@ -24320,7 +24320,7 @@
     </p:spTree>
     <p:extLst>
       <p:ext uri="{BB962C8B-B14F-4D97-AF65-F5344CB8AC3E}">
-        <p14:creationId xmlns:p14="http://schemas.microsoft.com/office/powerpoint/2010/main" val="1742977018"/>
+        <p14:creationId xmlns:p14="http://schemas.microsoft.com/office/powerpoint/2010/main" val="1632273968"/>
       </p:ext>
     </p:extLst>
   </p:cSld>

</xml_diff>

<commit_message>
docs: add training test link to facilitator decks
</commit_message>
<xml_diff>
--- a/docs/MSU-EVA-อบรมสายวิชาการ-ฉบับวิทยากร.pptx
+++ b/docs/MSU-EVA-อบรมสายวิชาการ-ฉบับวิทยากร.pptx
@@ -2,30 +2,30 @@
 <file path=ppt/presentation.xml><?xml version="1.0" encoding="utf-8"?>
 <p:presentation xmlns:p="http://schemas.openxmlformats.org/presentationml/2006/main">
   <p:sldMasterIdLst>
-    <p:sldMasterId xmlns:r="http://schemas.openxmlformats.org/officeDocument/2006/relationships" id="2147483648" r:id="Ra2f3865bc70645e8"/>
+    <p:sldMasterId xmlns:r="http://schemas.openxmlformats.org/officeDocument/2006/relationships" id="2147483648" r:id="R6594becfddc94061"/>
   </p:sldMasterIdLst>
   <p:notesMasterIdLst>
-    <p:notesMasterId xmlns:r="http://schemas.openxmlformats.org/officeDocument/2006/relationships" r:id="Rc90f9b4150b0486a"/>
+    <p:notesMasterId xmlns:r="http://schemas.openxmlformats.org/officeDocument/2006/relationships" r:id="R872114b434e041b5"/>
   </p:notesMasterIdLst>
   <p:sldIdLst>
-    <p:sldId xmlns:r="http://schemas.openxmlformats.org/officeDocument/2006/relationships" id="256" r:id="R0d2e09d5c05b4529"/>
-    <p:sldId xmlns:r="http://schemas.openxmlformats.org/officeDocument/2006/relationships" id="257" r:id="R8c825009b9f141f9"/>
-    <p:sldId xmlns:r="http://schemas.openxmlformats.org/officeDocument/2006/relationships" id="258" r:id="R3d39dc5311704740"/>
-    <p:sldId xmlns:r="http://schemas.openxmlformats.org/officeDocument/2006/relationships" id="259" r:id="Rd3290863a00d4fa7"/>
-    <p:sldId xmlns:r="http://schemas.openxmlformats.org/officeDocument/2006/relationships" id="260" r:id="Re27383f829cf463c"/>
-    <p:sldId xmlns:r="http://schemas.openxmlformats.org/officeDocument/2006/relationships" id="261" r:id="R90595feea1b84186"/>
-    <p:sldId xmlns:r="http://schemas.openxmlformats.org/officeDocument/2006/relationships" id="262" r:id="Ra93b6904acb443b5"/>
-    <p:sldId xmlns:r="http://schemas.openxmlformats.org/officeDocument/2006/relationships" id="263" r:id="R8e62e7147c724d2e"/>
-    <p:sldId xmlns:r="http://schemas.openxmlformats.org/officeDocument/2006/relationships" id="264" r:id="R220b6c7f4a9e4f29"/>
-    <p:sldId xmlns:r="http://schemas.openxmlformats.org/officeDocument/2006/relationships" id="265" r:id="R079a4fc1d14f4c67"/>
-    <p:sldId xmlns:r="http://schemas.openxmlformats.org/officeDocument/2006/relationships" id="266" r:id="R382abd9b3d7d4739"/>
-    <p:sldId xmlns:r="http://schemas.openxmlformats.org/officeDocument/2006/relationships" id="267" r:id="Re3fa7f2e4d304a7c"/>
-    <p:sldId xmlns:r="http://schemas.openxmlformats.org/officeDocument/2006/relationships" id="268" r:id="R2e343e8ba02f483c"/>
-    <p:sldId xmlns:r="http://schemas.openxmlformats.org/officeDocument/2006/relationships" id="269" r:id="R53e9c028a9064461"/>
-    <p:sldId xmlns:r="http://schemas.openxmlformats.org/officeDocument/2006/relationships" id="270" r:id="R1431c129ef3f4105"/>
-    <p:sldId xmlns:r="http://schemas.openxmlformats.org/officeDocument/2006/relationships" id="271" r:id="R055b242a6e744f4b"/>
-    <p:sldId xmlns:r="http://schemas.openxmlformats.org/officeDocument/2006/relationships" id="272" r:id="R17588f8129524bf9"/>
-    <p:sldId xmlns:r="http://schemas.openxmlformats.org/officeDocument/2006/relationships" id="273" r:id="Rfb1158b3f3c44efa"/>
+    <p:sldId xmlns:r="http://schemas.openxmlformats.org/officeDocument/2006/relationships" id="256" r:id="R62b45ff64af9436e"/>
+    <p:sldId xmlns:r="http://schemas.openxmlformats.org/officeDocument/2006/relationships" id="257" r:id="R0377878b46794d06"/>
+    <p:sldId xmlns:r="http://schemas.openxmlformats.org/officeDocument/2006/relationships" id="258" r:id="Re8b785c47ee049ac"/>
+    <p:sldId xmlns:r="http://schemas.openxmlformats.org/officeDocument/2006/relationships" id="259" r:id="Rcee89dfdb6ae49d6"/>
+    <p:sldId xmlns:r="http://schemas.openxmlformats.org/officeDocument/2006/relationships" id="260" r:id="R3c5c1c4cc4a6422a"/>
+    <p:sldId xmlns:r="http://schemas.openxmlformats.org/officeDocument/2006/relationships" id="261" r:id="Ra8dcc7be8081475e"/>
+    <p:sldId xmlns:r="http://schemas.openxmlformats.org/officeDocument/2006/relationships" id="262" r:id="R3f5f180afdd94b14"/>
+    <p:sldId xmlns:r="http://schemas.openxmlformats.org/officeDocument/2006/relationships" id="263" r:id="R602afda7d9e4410b"/>
+    <p:sldId xmlns:r="http://schemas.openxmlformats.org/officeDocument/2006/relationships" id="264" r:id="Rb73134d20b0a46b6"/>
+    <p:sldId xmlns:r="http://schemas.openxmlformats.org/officeDocument/2006/relationships" id="265" r:id="Rd6de1162bf714bbe"/>
+    <p:sldId xmlns:r="http://schemas.openxmlformats.org/officeDocument/2006/relationships" id="266" r:id="Rfd9aa8c91f17464a"/>
+    <p:sldId xmlns:r="http://schemas.openxmlformats.org/officeDocument/2006/relationships" id="267" r:id="R69e03d56fd8d4021"/>
+    <p:sldId xmlns:r="http://schemas.openxmlformats.org/officeDocument/2006/relationships" id="268" r:id="R55aa15a3e2ec4e8c"/>
+    <p:sldId xmlns:r="http://schemas.openxmlformats.org/officeDocument/2006/relationships" id="269" r:id="R77105109b8234e93"/>
+    <p:sldId xmlns:r="http://schemas.openxmlformats.org/officeDocument/2006/relationships" id="270" r:id="R4254d6c37a4f46f6"/>
+    <p:sldId xmlns:r="http://schemas.openxmlformats.org/officeDocument/2006/relationships" id="271" r:id="R297973c6cb104715"/>
+    <p:sldId xmlns:r="http://schemas.openxmlformats.org/officeDocument/2006/relationships" id="272" r:id="R80280e627d2d44ec"/>
+    <p:sldId xmlns:r="http://schemas.openxmlformats.org/officeDocument/2006/relationships" id="273" r:id="R34103bbd841343a7"/>
   </p:sldIdLst>
   <p:sldSz cx="12192000" cy="6858000"/>
   <p:notesSz cx="6858000" cy="9144000"/>
@@ -1304,7 +1304,7 @@
           <a:lstStyle xmlns:a="http://schemas.openxmlformats.org/drawingml/2006/main"/>
           <a:p xmlns:a="http://schemas.openxmlformats.org/drawingml/2006/main">
             <a:r>
-              <a:t>[พูด] เมื่อเห็นภาพครบแล้ว ต่อไปเป็นเวลาของทุกท่านครับ ให้เปิดบัญชีที่เตรียมไว้ ผู้ที่เคยทดสอบแล้วลองเน้นตรวจความครบถ้วนและช่วยสังเกตสิ่งที่เปลี่ยนไป ส่วนผู้ที่เพิ่งเริ่ม ให้ทำทีละข้อ ไม่ต้องรีบครับ เลือกรายการ กรอกข้อมูล ตรวจคะแนน แนบหลักฐาน แล้วบันทึกร่าง เมื่อทำเสร็จให้ยกมือเรียกผมหรือทีมงานได้เลย ยังไม่ต้องกดส่งแบบประเมินนะครับ เราจะตรวจความพร้อมร่วมกันก่อน</a:t>
+              <a:t>[พูด] เมื่อเห็นภาพครบแล้ว ต่อไปเป็นเวลาของทุกท่านครับ ลิงก์ที่แสดงบนหน้าจอใช้สำหรับทดสอบระบบ ให้เปิด http://149.28.142.186/login แล้วเข้าสู่ระบบด้วยบัญชีที่เตรียมไว้ ลิงก์นี้ใช้สำหรับทดสอบระบบ เมื่อทุกท่านตรวจสอบแล้วและไม่มีประเด็นที่ต้องปรับแก้เพิ่มเติม ทีมงานจะนำระบบไปติดตั้งบนเซิร์ฟเวอร์ของคณะทันทีครับ สำหรับการทดลอง ให้เลือกรายการ กรอกข้อมูล ตรวจคะแนน แนบหลักฐาน แล้วบันทึกร่างครับ ผู้ที่เคยทดสอบแล้วให้ช่วยตรวจความครบถ้วน ส่วนผู้ที่เพิ่งเริ่มให้ทำทีละข้อ ไม่ต้องรีบ หากติดขัดให้ยกมือเรียกผมหรือทีมงานได้เลย ยังไม่ต้องกดส่งแบบประเมินนะครับ เราจะตรวจความพร้อมร่วมกันก่อน</a:t>
             </a:r>
           </a:p>
           <a:p xmlns:a="http://schemas.openxmlformats.org/drawingml/2006/main">
@@ -2287,7 +2287,7 @@
   </p:cSld>
   <p:clrMap bg1="lt1" tx1="dk1" bg2="lt2" tx2="dk2" accent1="accent1" accent2="accent2" accent3="accent3" accent4="accent4" accent5="accent5" accent6="accent6" hlink="hlink" folHlink="folHlink"/>
   <p:sldLayoutIdLst>
-    <p:sldLayoutId xmlns:r="http://schemas.openxmlformats.org/officeDocument/2006/relationships" id="2147483649" r:id="R7f3428e08d3d4b46"/>
+    <p:sldLayoutId xmlns:r="http://schemas.openxmlformats.org/officeDocument/2006/relationships" id="2147483649" r:id="Rf0c23d0697814a7b"/>
   </p:sldLayoutIdLst>
   <p:txStyles>
     <p:titleStyle>
@@ -2842,7 +2842,7 @@
           <p:nvPr/>
         </p:nvPicPr>
         <p:blipFill>
-          <a:blip xmlns:r="http://schemas.openxmlformats.org/officeDocument/2006/relationships" xmlns:a="http://schemas.openxmlformats.org/drawingml/2006/main" r:embed="Rca806ae180c1486d"/>
+          <a:blip xmlns:r="http://schemas.openxmlformats.org/officeDocument/2006/relationships" xmlns:a="http://schemas.openxmlformats.org/drawingml/2006/main" r:embed="R49f8b4439ded4034"/>
           <a:srcRect xmlns:a="http://schemas.openxmlformats.org/drawingml/2006/main" l="2579" t="0" r="2579" b="0"/>
           <a:stretch xmlns:a="http://schemas.openxmlformats.org/drawingml/2006/main">
             <a:fillRect l="0" t="0" r="0" b="0"/>
@@ -2863,7 +2863,7 @@
           <p:cNvPr id="2" name="cover-panel">
             <a:extLst xmlns:a="http://schemas.openxmlformats.org/drawingml/2006/main">
               <a:ext uri="{FF2B5EF4-FFF2-40B4-BE49-F238E27FC236}">
-                <a16:creationId xmlns:a16="http://schemas.microsoft.com/office/drawing/2014/main" id="{D9F7B61F-FF6C-4CC4-B6D6-154B85B4F3B3}"/>
+                <a16:creationId xmlns:a16="http://schemas.microsoft.com/office/drawing/2014/main" id="{6CABBDA7-9F13-4FB7-97B8-FE2449584D54}"/>
               </a:ext>
             </a:extLst>
           </p:cNvPr>
@@ -2894,7 +2894,7 @@
           <p:cNvPr id="3" name="cover-accent">
             <a:extLst xmlns:a="http://schemas.openxmlformats.org/drawingml/2006/main">
               <a:ext uri="{FF2B5EF4-FFF2-40B4-BE49-F238E27FC236}">
-                <a16:creationId xmlns:a16="http://schemas.microsoft.com/office/drawing/2014/main" id="{7C1F980C-5A4B-4643-92C5-FD6032B3AF70}"/>
+                <a16:creationId xmlns:a16="http://schemas.microsoft.com/office/drawing/2014/main" id="{620ADE58-8FF5-4F0C-B43F-B432E34E0EE4}"/>
               </a:ext>
             </a:extLst>
           </p:cNvPr>
@@ -2929,7 +2929,7 @@
           <p:nvPr/>
         </p:nvPicPr>
         <p:blipFill>
-          <a:blip xmlns:r="http://schemas.openxmlformats.org/officeDocument/2006/relationships" xmlns:a="http://schemas.openxmlformats.org/drawingml/2006/main" r:embed="R603230b501ae4cd3"/>
+          <a:blip xmlns:r="http://schemas.openxmlformats.org/officeDocument/2006/relationships" xmlns:a="http://schemas.openxmlformats.org/drawingml/2006/main" r:embed="Rbd8774dc63ea4173"/>
           <a:stretch xmlns:a="http://schemas.openxmlformats.org/drawingml/2006/main"/>
         </p:blipFill>
         <p:spPr>
@@ -2947,7 +2947,7 @@
           <p:cNvPr id="5" name="cover-institution">
             <a:extLst xmlns:a="http://schemas.openxmlformats.org/drawingml/2006/main">
               <a:ext uri="{FF2B5EF4-FFF2-40B4-BE49-F238E27FC236}">
-                <a16:creationId xmlns:a16="http://schemas.microsoft.com/office/drawing/2014/main" id="{4C0E8EC3-F8A9-4004-A09A-C29DCA627BB7}"/>
+                <a16:creationId xmlns:a16="http://schemas.microsoft.com/office/drawing/2014/main" id="{CD4BE0B5-2015-472B-AE8C-975E04E4EFD7}"/>
               </a:ext>
             </a:extLst>
           </p:cNvPr>
@@ -3009,7 +3009,7 @@
           <p:cNvPr id="6" name="cover-session">
             <a:extLst xmlns:a="http://schemas.openxmlformats.org/drawingml/2006/main">
               <a:ext uri="{FF2B5EF4-FFF2-40B4-BE49-F238E27FC236}">
-                <a16:creationId xmlns:a16="http://schemas.microsoft.com/office/drawing/2014/main" id="{DF7CA376-C781-4D85-959D-5DCCFD08B6D7}"/>
+                <a16:creationId xmlns:a16="http://schemas.microsoft.com/office/drawing/2014/main" id="{C6A1E8A4-116D-4B72-96C5-515CADB11800}"/>
               </a:ext>
             </a:extLst>
           </p:cNvPr>
@@ -3071,7 +3071,7 @@
           <p:cNvPr id="7" name="cover-title">
             <a:extLst xmlns:a="http://schemas.openxmlformats.org/drawingml/2006/main">
               <a:ext uri="{FF2B5EF4-FFF2-40B4-BE49-F238E27FC236}">
-                <a16:creationId xmlns:a16="http://schemas.microsoft.com/office/drawing/2014/main" id="{D125778D-D4C5-40C3-A14A-A70590F76DEC}"/>
+                <a16:creationId xmlns:a16="http://schemas.microsoft.com/office/drawing/2014/main" id="{9C355E65-D3EC-4B9A-9283-E1248FBFBCE7}"/>
               </a:ext>
             </a:extLst>
           </p:cNvPr>
@@ -3133,7 +3133,7 @@
           <p:cNvPr id="8" name="cover-system-short-name">
             <a:extLst xmlns:a="http://schemas.openxmlformats.org/drawingml/2006/main">
               <a:ext uri="{FF2B5EF4-FFF2-40B4-BE49-F238E27FC236}">
-                <a16:creationId xmlns:a16="http://schemas.microsoft.com/office/drawing/2014/main" id="{19114847-2AAC-4854-AFE8-04C19C9567C7}"/>
+                <a16:creationId xmlns:a16="http://schemas.microsoft.com/office/drawing/2014/main" id="{AD836E94-EA91-46F7-979D-1FE0633FE2C8}"/>
               </a:ext>
             </a:extLst>
           </p:cNvPr>
@@ -3195,7 +3195,7 @@
           <p:cNvPr id="9" name="cover-gold-rule">
             <a:extLst xmlns:a="http://schemas.openxmlformats.org/drawingml/2006/main">
               <a:ext uri="{FF2B5EF4-FFF2-40B4-BE49-F238E27FC236}">
-                <a16:creationId xmlns:a16="http://schemas.microsoft.com/office/drawing/2014/main" id="{9266E308-0BB1-4105-BA9F-C1A9D5888F52}"/>
+                <a16:creationId xmlns:a16="http://schemas.microsoft.com/office/drawing/2014/main" id="{7DF97864-7B8E-48A9-ADF8-0F9CC5BF3A7D}"/>
               </a:ext>
             </a:extLst>
           </p:cNvPr>
@@ -3226,7 +3226,7 @@
           <p:cNvPr id="10" name="cover-promise">
             <a:extLst xmlns:a="http://schemas.openxmlformats.org/drawingml/2006/main">
               <a:ext uri="{FF2B5EF4-FFF2-40B4-BE49-F238E27FC236}">
-                <a16:creationId xmlns:a16="http://schemas.microsoft.com/office/drawing/2014/main" id="{73810668-F0A8-4536-A91B-F7BAA14D6216}"/>
+                <a16:creationId xmlns:a16="http://schemas.microsoft.com/office/drawing/2014/main" id="{F2DDFF40-F48D-4C35-982A-5D033AB8E9DF}"/>
               </a:ext>
             </a:extLst>
           </p:cNvPr>
@@ -3288,7 +3288,7 @@
           <p:cNvPr id="11" name="cover-style">
             <a:extLst xmlns:a="http://schemas.openxmlformats.org/drawingml/2006/main">
               <a:ext uri="{FF2B5EF4-FFF2-40B4-BE49-F238E27FC236}">
-                <a16:creationId xmlns:a16="http://schemas.microsoft.com/office/drawing/2014/main" id="{70274488-4F01-4669-917C-4D3B1A7EE70E}"/>
+                <a16:creationId xmlns:a16="http://schemas.microsoft.com/office/drawing/2014/main" id="{5D839FC5-AA05-4F0B-B745-CDA298002A3B}"/>
               </a:ext>
             </a:extLst>
           </p:cNvPr>
@@ -3354,7 +3354,7 @@
           <p:nvPr/>
         </p:nvPicPr>
         <p:blipFill>
-          <a:blip xmlns:r="http://schemas.openxmlformats.org/officeDocument/2006/relationships" xmlns:a="http://schemas.openxmlformats.org/drawingml/2006/main" r:embed="Rb9fb159f1d604f27"/>
+          <a:blip xmlns:r="http://schemas.openxmlformats.org/officeDocument/2006/relationships" xmlns:a="http://schemas.openxmlformats.org/drawingml/2006/main" r:embed="R8c25570b21914144"/>
           <a:stretch xmlns:a="http://schemas.openxmlformats.org/drawingml/2006/main"/>
         </p:blipFill>
         <p:spPr>
@@ -3370,7 +3370,7 @@
     </p:spTree>
     <p:extLst>
       <p:ext uri="{BB962C8B-B14F-4D97-AF65-F5344CB8AC3E}">
-        <p14:creationId xmlns:p14="http://schemas.microsoft.com/office/powerpoint/2010/main" val="470109294"/>
+        <p14:creationId xmlns:p14="http://schemas.microsoft.com/office/powerpoint/2010/main" val="898233222"/>
       </p:ext>
     </p:extLst>
   </p:cSld>
@@ -3401,7 +3401,7 @@
           <p:cNvPr id="21" name="side-accent-10">
             <a:extLst xmlns:a="http://schemas.openxmlformats.org/drawingml/2006/main">
               <a:ext uri="{FF2B5EF4-FFF2-40B4-BE49-F238E27FC236}">
-                <a16:creationId xmlns:a16="http://schemas.microsoft.com/office/drawing/2014/main" id="{A8765A30-8DB1-4BB3-93B4-49316C6AC3CA}"/>
+                <a16:creationId xmlns:a16="http://schemas.microsoft.com/office/drawing/2014/main" id="{93A135D8-B992-4221-8FE3-FFCBFCE93A81}"/>
               </a:ext>
             </a:extLst>
           </p:cNvPr>
@@ -3432,7 +3432,7 @@
           <p:cNvPr id="2" name="kicker-10">
             <a:extLst xmlns:a="http://schemas.openxmlformats.org/drawingml/2006/main">
               <a:ext uri="{FF2B5EF4-FFF2-40B4-BE49-F238E27FC236}">
-                <a16:creationId xmlns:a16="http://schemas.microsoft.com/office/drawing/2014/main" id="{34E4C6F1-1D54-40E6-8278-3D3A88E07596}"/>
+                <a16:creationId xmlns:a16="http://schemas.microsoft.com/office/drawing/2014/main" id="{2CAC109D-959D-4B55-B628-9AF2BF677997}"/>
               </a:ext>
             </a:extLst>
           </p:cNvPr>
@@ -3494,7 +3494,7 @@
           <p:cNvPr id="3" name="title-10">
             <a:extLst xmlns:a="http://schemas.openxmlformats.org/drawingml/2006/main">
               <a:ext uri="{FF2B5EF4-FFF2-40B4-BE49-F238E27FC236}">
-                <a16:creationId xmlns:a16="http://schemas.microsoft.com/office/drawing/2014/main" id="{3B6C2C92-27C1-4777-90C4-D4260EB27E9B}"/>
+                <a16:creationId xmlns:a16="http://schemas.microsoft.com/office/drawing/2014/main" id="{794D7026-26D6-4190-83F1-B38B699D5483}"/>
               </a:ext>
             </a:extLst>
           </p:cNvPr>
@@ -3556,7 +3556,7 @@
           <p:cNvPr id="4" name="">
             <a:extLst xmlns:a="http://schemas.openxmlformats.org/drawingml/2006/main">
               <a:ext uri="{FF2B5EF4-FFF2-40B4-BE49-F238E27FC236}">
-                <a16:creationId xmlns:a16="http://schemas.microsoft.com/office/drawing/2014/main" id="{429E33B3-416C-4481-BDD1-162BFF1453D4}"/>
+                <a16:creationId xmlns:a16="http://schemas.microsoft.com/office/drawing/2014/main" id="{FE6713F9-0B02-471D-952B-2CEC3DBF6EF3}"/>
               </a:ext>
             </a:extLst>
           </p:cNvPr>
@@ -3618,7 +3618,7 @@
           <p:cNvPr id="5" name="">
             <a:extLst xmlns:a="http://schemas.openxmlformats.org/drawingml/2006/main">
               <a:ext uri="{FF2B5EF4-FFF2-40B4-BE49-F238E27FC236}">
-                <a16:creationId xmlns:a16="http://schemas.microsoft.com/office/drawing/2014/main" id="{B3DA07D0-9F19-4F0B-9587-9DC07A62069D}"/>
+                <a16:creationId xmlns:a16="http://schemas.microsoft.com/office/drawing/2014/main" id="{AA293987-8D79-4CEA-9E76-BB4FAC0D6325}"/>
               </a:ext>
             </a:extLst>
           </p:cNvPr>
@@ -3680,7 +3680,7 @@
           <p:cNvPr id="6" name="">
             <a:extLst xmlns:a="http://schemas.openxmlformats.org/drawingml/2006/main">
               <a:ext uri="{FF2B5EF4-FFF2-40B4-BE49-F238E27FC236}">
-                <a16:creationId xmlns:a16="http://schemas.microsoft.com/office/drawing/2014/main" id="{3867B4AE-3C58-4E74-9632-94409C2E29B6}"/>
+                <a16:creationId xmlns:a16="http://schemas.microsoft.com/office/drawing/2014/main" id="{285209F1-BDAC-421C-A044-FA6923559FFF}"/>
               </a:ext>
             </a:extLst>
           </p:cNvPr>
@@ -3742,7 +3742,7 @@
           <p:cNvPr id="7" name="">
             <a:extLst xmlns:a="http://schemas.openxmlformats.org/drawingml/2006/main">
               <a:ext uri="{FF2B5EF4-FFF2-40B4-BE49-F238E27FC236}">
-                <a16:creationId xmlns:a16="http://schemas.microsoft.com/office/drawing/2014/main" id="{AE0AD4DD-2C6A-47F7-9A84-CB24DC78BD2A}"/>
+                <a16:creationId xmlns:a16="http://schemas.microsoft.com/office/drawing/2014/main" id="{80034C15-98B6-4480-B7C0-8CCB7CCEDCF2}"/>
               </a:ext>
             </a:extLst>
           </p:cNvPr>
@@ -3804,7 +3804,7 @@
           <p:cNvPr id="8" name="">
             <a:extLst xmlns:a="http://schemas.openxmlformats.org/drawingml/2006/main">
               <a:ext uri="{FF2B5EF4-FFF2-40B4-BE49-F238E27FC236}">
-                <a16:creationId xmlns:a16="http://schemas.microsoft.com/office/drawing/2014/main" id="{A647A177-39F8-4376-A6F9-6015A0C9D1D4}"/>
+                <a16:creationId xmlns:a16="http://schemas.microsoft.com/office/drawing/2014/main" id="{C706E3E1-829B-45AD-A88D-E5C23A3BE0D5}"/>
               </a:ext>
             </a:extLst>
           </p:cNvPr>
@@ -3835,7 +3835,7 @@
           <p:cNvPr id="9" name="">
             <a:extLst xmlns:a="http://schemas.openxmlformats.org/drawingml/2006/main">
               <a:ext uri="{FF2B5EF4-FFF2-40B4-BE49-F238E27FC236}">
-                <a16:creationId xmlns:a16="http://schemas.microsoft.com/office/drawing/2014/main" id="{1E7ED4FE-AC82-40F8-9B03-9B0AF2650F8A}"/>
+                <a16:creationId xmlns:a16="http://schemas.microsoft.com/office/drawing/2014/main" id="{11CBBD48-3AAD-4F2B-895A-B1991EF17A31}"/>
               </a:ext>
             </a:extLst>
           </p:cNvPr>
@@ -3897,7 +3897,7 @@
           <p:cNvPr id="10" name="">
             <a:extLst xmlns:a="http://schemas.openxmlformats.org/drawingml/2006/main">
               <a:ext uri="{FF2B5EF4-FFF2-40B4-BE49-F238E27FC236}">
-                <a16:creationId xmlns:a16="http://schemas.microsoft.com/office/drawing/2014/main" id="{15E70E6A-07DD-4D73-8DB1-3165780160E7}"/>
+                <a16:creationId xmlns:a16="http://schemas.microsoft.com/office/drawing/2014/main" id="{586EEECB-CB34-485A-BE03-5FF6B5D999BD}"/>
               </a:ext>
             </a:extLst>
           </p:cNvPr>
@@ -3959,7 +3959,7 @@
           <p:cNvPr id="11" name="">
             <a:extLst xmlns:a="http://schemas.openxmlformats.org/drawingml/2006/main">
               <a:ext uri="{FF2B5EF4-FFF2-40B4-BE49-F238E27FC236}">
-                <a16:creationId xmlns:a16="http://schemas.microsoft.com/office/drawing/2014/main" id="{4506C08E-F8C2-4D8A-B24D-E33F110A2049}"/>
+                <a16:creationId xmlns:a16="http://schemas.microsoft.com/office/drawing/2014/main" id="{33AF18D6-8799-46A2-A957-E371F07CE853}"/>
               </a:ext>
             </a:extLst>
           </p:cNvPr>
@@ -4021,7 +4021,7 @@
           <p:cNvPr id="12" name="">
             <a:extLst xmlns:a="http://schemas.openxmlformats.org/drawingml/2006/main">
               <a:ext uri="{FF2B5EF4-FFF2-40B4-BE49-F238E27FC236}">
-                <a16:creationId xmlns:a16="http://schemas.microsoft.com/office/drawing/2014/main" id="{52CC0F3A-B296-469E-B541-D3A78727AB61}"/>
+                <a16:creationId xmlns:a16="http://schemas.microsoft.com/office/drawing/2014/main" id="{4848770C-CE9D-4C98-A944-00D3E308E000}"/>
               </a:ext>
             </a:extLst>
           </p:cNvPr>
@@ -4052,7 +4052,7 @@
           <p:cNvPr id="13" name="">
             <a:extLst xmlns:a="http://schemas.openxmlformats.org/drawingml/2006/main">
               <a:ext uri="{FF2B5EF4-FFF2-40B4-BE49-F238E27FC236}">
-                <a16:creationId xmlns:a16="http://schemas.microsoft.com/office/drawing/2014/main" id="{50CB6AA6-F549-496B-9E47-7A819EFACEB8}"/>
+                <a16:creationId xmlns:a16="http://schemas.microsoft.com/office/drawing/2014/main" id="{01CE8866-105C-457B-B1BF-1F6D86ACD0B5}"/>
               </a:ext>
             </a:extLst>
           </p:cNvPr>
@@ -4114,7 +4114,7 @@
           <p:cNvPr id="14" name="">
             <a:extLst xmlns:a="http://schemas.openxmlformats.org/drawingml/2006/main">
               <a:ext uri="{FF2B5EF4-FFF2-40B4-BE49-F238E27FC236}">
-                <a16:creationId xmlns:a16="http://schemas.microsoft.com/office/drawing/2014/main" id="{1F1DC087-86EF-4B72-ADC4-E40A5ADC0566}"/>
+                <a16:creationId xmlns:a16="http://schemas.microsoft.com/office/drawing/2014/main" id="{BEB69AFA-22BE-44AA-B1F0-DC10F0801B72}"/>
               </a:ext>
             </a:extLst>
           </p:cNvPr>
@@ -4176,7 +4176,7 @@
           <p:cNvPr id="15" name="">
             <a:extLst xmlns:a="http://schemas.openxmlformats.org/drawingml/2006/main">
               <a:ext uri="{FF2B5EF4-FFF2-40B4-BE49-F238E27FC236}">
-                <a16:creationId xmlns:a16="http://schemas.microsoft.com/office/drawing/2014/main" id="{8F04002B-EFE6-46E8-A4CF-43E04570784A}"/>
+                <a16:creationId xmlns:a16="http://schemas.microsoft.com/office/drawing/2014/main" id="{BDE2AA52-4AE6-4A86-8312-5A61ACFCDD61}"/>
               </a:ext>
             </a:extLst>
           </p:cNvPr>
@@ -4238,7 +4238,7 @@
           <p:cNvPr id="16" name="">
             <a:extLst xmlns:a="http://schemas.openxmlformats.org/drawingml/2006/main">
               <a:ext uri="{FF2B5EF4-FFF2-40B4-BE49-F238E27FC236}">
-                <a16:creationId xmlns:a16="http://schemas.microsoft.com/office/drawing/2014/main" id="{CCBABFE4-9FE4-46C3-91FE-ABBE7388D173}"/>
+                <a16:creationId xmlns:a16="http://schemas.microsoft.com/office/drawing/2014/main" id="{D1210652-594E-424B-9D94-647C4F2D111C}"/>
               </a:ext>
             </a:extLst>
           </p:cNvPr>
@@ -4271,7 +4271,7 @@
           <p:cNvPr id="17" name="">
             <a:extLst xmlns:a="http://schemas.openxmlformats.org/drawingml/2006/main">
               <a:ext uri="{FF2B5EF4-FFF2-40B4-BE49-F238E27FC236}">
-                <a16:creationId xmlns:a16="http://schemas.microsoft.com/office/drawing/2014/main" id="{8AD95533-73F4-4AC4-8CB0-A117CD84C0B1}"/>
+                <a16:creationId xmlns:a16="http://schemas.microsoft.com/office/drawing/2014/main" id="{D61944AE-AB6F-4395-822F-609DCA320844}"/>
               </a:ext>
             </a:extLst>
           </p:cNvPr>
@@ -4333,7 +4333,7 @@
           <p:cNvPr id="18" name="footer-rule-10">
             <a:extLst xmlns:a="http://schemas.openxmlformats.org/drawingml/2006/main">
               <a:ext uri="{FF2B5EF4-FFF2-40B4-BE49-F238E27FC236}">
-                <a16:creationId xmlns:a16="http://schemas.microsoft.com/office/drawing/2014/main" id="{0FB54278-ADF1-462D-AE21-9F56E4100309}"/>
+                <a16:creationId xmlns:a16="http://schemas.microsoft.com/office/drawing/2014/main" id="{C01DEF9B-28B6-43B2-A040-37740098BCD2}"/>
               </a:ext>
             </a:extLst>
           </p:cNvPr>
@@ -4364,7 +4364,7 @@
           <p:cNvPr id="19" name="footer-label-10">
             <a:extLst xmlns:a="http://schemas.openxmlformats.org/drawingml/2006/main">
               <a:ext uri="{FF2B5EF4-FFF2-40B4-BE49-F238E27FC236}">
-                <a16:creationId xmlns:a16="http://schemas.microsoft.com/office/drawing/2014/main" id="{FB5D8E37-9333-4342-86F9-FB572898585B}"/>
+                <a16:creationId xmlns:a16="http://schemas.microsoft.com/office/drawing/2014/main" id="{814014FF-E209-4224-A25C-5356A8370D61}"/>
               </a:ext>
             </a:extLst>
           </p:cNvPr>
@@ -4426,7 +4426,7 @@
           <p:cNvPr id="20" name="footer-page-10">
             <a:extLst xmlns:a="http://schemas.openxmlformats.org/drawingml/2006/main">
               <a:ext uri="{FF2B5EF4-FFF2-40B4-BE49-F238E27FC236}">
-                <a16:creationId xmlns:a16="http://schemas.microsoft.com/office/drawing/2014/main" id="{05A2E422-F2FB-4469-B94E-475CA58B4D4D}"/>
+                <a16:creationId xmlns:a16="http://schemas.microsoft.com/office/drawing/2014/main" id="{07F195E2-15A4-4B6E-9E00-5B3C1B1DFB52}"/>
               </a:ext>
             </a:extLst>
           </p:cNvPr>
@@ -4486,7 +4486,7 @@
     </p:spTree>
     <p:extLst>
       <p:ext uri="{BB962C8B-B14F-4D97-AF65-F5344CB8AC3E}">
-        <p14:creationId xmlns:p14="http://schemas.microsoft.com/office/powerpoint/2010/main" val="570829991"/>
+        <p14:creationId xmlns:p14="http://schemas.microsoft.com/office/powerpoint/2010/main" val="2027149281"/>
       </p:ext>
     </p:extLst>
   </p:cSld>
@@ -4517,7 +4517,7 @@
           <p:cNvPr id="22" name="side-accent-11">
             <a:extLst xmlns:a="http://schemas.openxmlformats.org/drawingml/2006/main">
               <a:ext uri="{FF2B5EF4-FFF2-40B4-BE49-F238E27FC236}">
-                <a16:creationId xmlns:a16="http://schemas.microsoft.com/office/drawing/2014/main" id="{FFB29332-E203-46BE-8945-242C77E66FE8}"/>
+                <a16:creationId xmlns:a16="http://schemas.microsoft.com/office/drawing/2014/main" id="{E06C723F-DCBE-44A0-A4DA-89C12E0DF386}"/>
               </a:ext>
             </a:extLst>
           </p:cNvPr>
@@ -4548,7 +4548,7 @@
           <p:cNvPr id="2" name="kicker-11">
             <a:extLst xmlns:a="http://schemas.openxmlformats.org/drawingml/2006/main">
               <a:ext uri="{FF2B5EF4-FFF2-40B4-BE49-F238E27FC236}">
-                <a16:creationId xmlns:a16="http://schemas.microsoft.com/office/drawing/2014/main" id="{F716D330-8400-4D2C-9A38-F117E6F29CD0}"/>
+                <a16:creationId xmlns:a16="http://schemas.microsoft.com/office/drawing/2014/main" id="{C47EC59F-9722-418E-855F-FD493E92463D}"/>
               </a:ext>
             </a:extLst>
           </p:cNvPr>
@@ -4610,7 +4610,7 @@
           <p:cNvPr id="3" name="title-11">
             <a:extLst xmlns:a="http://schemas.openxmlformats.org/drawingml/2006/main">
               <a:ext uri="{FF2B5EF4-FFF2-40B4-BE49-F238E27FC236}">
-                <a16:creationId xmlns:a16="http://schemas.microsoft.com/office/drawing/2014/main" id="{922BEFC7-EFC2-4794-8640-464142F23CEB}"/>
+                <a16:creationId xmlns:a16="http://schemas.microsoft.com/office/drawing/2014/main" id="{21A24228-3AEC-4035-9D16-E2956EFC7BDC}"/>
               </a:ext>
             </a:extLst>
           </p:cNvPr>
@@ -4672,7 +4672,7 @@
           <p:cNvPr id="4" name="">
             <a:extLst xmlns:a="http://schemas.openxmlformats.org/drawingml/2006/main">
               <a:ext uri="{FF2B5EF4-FFF2-40B4-BE49-F238E27FC236}">
-                <a16:creationId xmlns:a16="http://schemas.microsoft.com/office/drawing/2014/main" id="{BC97170E-DB1A-41EC-BC07-E406F17725DA}"/>
+                <a16:creationId xmlns:a16="http://schemas.microsoft.com/office/drawing/2014/main" id="{2EC9B0D0-06BF-46F9-8515-22F094E21FEE}"/>
               </a:ext>
             </a:extLst>
           </p:cNvPr>
@@ -4734,7 +4734,7 @@
           <p:cNvPr id="5" name="">
             <a:extLst xmlns:a="http://schemas.openxmlformats.org/drawingml/2006/main">
               <a:ext uri="{FF2B5EF4-FFF2-40B4-BE49-F238E27FC236}">
-                <a16:creationId xmlns:a16="http://schemas.microsoft.com/office/drawing/2014/main" id="{2599A78B-226E-4049-82E7-5E5CF81F3A98}"/>
+                <a16:creationId xmlns:a16="http://schemas.microsoft.com/office/drawing/2014/main" id="{5E7A2A9B-1C5C-4B7F-B059-492E49697077}"/>
               </a:ext>
             </a:extLst>
           </p:cNvPr>
@@ -4765,7 +4765,7 @@
           <p:cNvPr id="6" name="">
             <a:extLst xmlns:a="http://schemas.openxmlformats.org/drawingml/2006/main">
               <a:ext uri="{FF2B5EF4-FFF2-40B4-BE49-F238E27FC236}">
-                <a16:creationId xmlns:a16="http://schemas.microsoft.com/office/drawing/2014/main" id="{A2783728-519B-4B83-9856-AB9DD2C7862E}"/>
+                <a16:creationId xmlns:a16="http://schemas.microsoft.com/office/drawing/2014/main" id="{CE34C448-F054-4728-839E-6FCAFF8EC574}"/>
               </a:ext>
             </a:extLst>
           </p:cNvPr>
@@ -4827,7 +4827,7 @@
           <p:cNvPr id="7" name="">
             <a:extLst xmlns:a="http://schemas.openxmlformats.org/drawingml/2006/main">
               <a:ext uri="{FF2B5EF4-FFF2-40B4-BE49-F238E27FC236}">
-                <a16:creationId xmlns:a16="http://schemas.microsoft.com/office/drawing/2014/main" id="{97140E0D-88BF-46BA-B341-F785A8939B39}"/>
+                <a16:creationId xmlns:a16="http://schemas.microsoft.com/office/drawing/2014/main" id="{1D6F0897-8DA7-4550-B133-8BFA8594E852}"/>
               </a:ext>
             </a:extLst>
           </p:cNvPr>
@@ -4889,7 +4889,7 @@
           <p:cNvPr id="8" name="">
             <a:extLst xmlns:a="http://schemas.openxmlformats.org/drawingml/2006/main">
               <a:ext uri="{FF2B5EF4-FFF2-40B4-BE49-F238E27FC236}">
-                <a16:creationId xmlns:a16="http://schemas.microsoft.com/office/drawing/2014/main" id="{C7EC20FF-26F3-43CE-9339-AA1D5F5F74E5}"/>
+                <a16:creationId xmlns:a16="http://schemas.microsoft.com/office/drawing/2014/main" id="{D0ECF5F7-FFEB-4DDF-946C-32A90578A326}"/>
               </a:ext>
             </a:extLst>
           </p:cNvPr>
@@ -4951,7 +4951,7 @@
           <p:cNvPr id="9" name="">
             <a:extLst xmlns:a="http://schemas.openxmlformats.org/drawingml/2006/main">
               <a:ext uri="{FF2B5EF4-FFF2-40B4-BE49-F238E27FC236}">
-                <a16:creationId xmlns:a16="http://schemas.microsoft.com/office/drawing/2014/main" id="{445195DB-449E-4797-999D-C50FC502C6A7}"/>
+                <a16:creationId xmlns:a16="http://schemas.microsoft.com/office/drawing/2014/main" id="{D3A7DE8D-374A-47CC-BFDB-0DB811DC9FE4}"/>
               </a:ext>
             </a:extLst>
           </p:cNvPr>
@@ -4982,7 +4982,7 @@
           <p:cNvPr id="10" name="">
             <a:extLst xmlns:a="http://schemas.openxmlformats.org/drawingml/2006/main">
               <a:ext uri="{FF2B5EF4-FFF2-40B4-BE49-F238E27FC236}">
-                <a16:creationId xmlns:a16="http://schemas.microsoft.com/office/drawing/2014/main" id="{F58AEF96-9573-43EA-8149-1E59951A3449}"/>
+                <a16:creationId xmlns:a16="http://schemas.microsoft.com/office/drawing/2014/main" id="{E12A160F-DA6E-4769-B8F6-C5FB1FD64FE3}"/>
               </a:ext>
             </a:extLst>
           </p:cNvPr>
@@ -5044,7 +5044,7 @@
           <p:cNvPr id="11" name="">
             <a:extLst xmlns:a="http://schemas.openxmlformats.org/drawingml/2006/main">
               <a:ext uri="{FF2B5EF4-FFF2-40B4-BE49-F238E27FC236}">
-                <a16:creationId xmlns:a16="http://schemas.microsoft.com/office/drawing/2014/main" id="{58A130BC-7997-4FB7-8FB3-E7E5C8A4F7FD}"/>
+                <a16:creationId xmlns:a16="http://schemas.microsoft.com/office/drawing/2014/main" id="{BBC134AD-C4F8-494B-9489-25430C6291B6}"/>
               </a:ext>
             </a:extLst>
           </p:cNvPr>
@@ -5106,7 +5106,7 @@
           <p:cNvPr id="12" name="">
             <a:extLst xmlns:a="http://schemas.openxmlformats.org/drawingml/2006/main">
               <a:ext uri="{FF2B5EF4-FFF2-40B4-BE49-F238E27FC236}">
-                <a16:creationId xmlns:a16="http://schemas.microsoft.com/office/drawing/2014/main" id="{1C2191E4-C79B-4E6C-9235-057993A2C416}"/>
+                <a16:creationId xmlns:a16="http://schemas.microsoft.com/office/drawing/2014/main" id="{B9F05342-BAE9-457C-AA2A-DA9CAEF6FCA3}"/>
               </a:ext>
             </a:extLst>
           </p:cNvPr>
@@ -5168,7 +5168,7 @@
           <p:cNvPr id="13" name="">
             <a:extLst xmlns:a="http://schemas.openxmlformats.org/drawingml/2006/main">
               <a:ext uri="{FF2B5EF4-FFF2-40B4-BE49-F238E27FC236}">
-                <a16:creationId xmlns:a16="http://schemas.microsoft.com/office/drawing/2014/main" id="{376E2C3F-4663-47F7-97FA-F67F72E5AA3B}"/>
+                <a16:creationId xmlns:a16="http://schemas.microsoft.com/office/drawing/2014/main" id="{CCA90D15-26CD-4E4B-9835-BD14CA258650}"/>
               </a:ext>
             </a:extLst>
           </p:cNvPr>
@@ -5199,7 +5199,7 @@
           <p:cNvPr id="14" name="">
             <a:extLst xmlns:a="http://schemas.openxmlformats.org/drawingml/2006/main">
               <a:ext uri="{FF2B5EF4-FFF2-40B4-BE49-F238E27FC236}">
-                <a16:creationId xmlns:a16="http://schemas.microsoft.com/office/drawing/2014/main" id="{910BE494-5FE6-4D88-A9C2-66623E3733B4}"/>
+                <a16:creationId xmlns:a16="http://schemas.microsoft.com/office/drawing/2014/main" id="{ABD1434D-575B-492A-874C-DF716171B688}"/>
               </a:ext>
             </a:extLst>
           </p:cNvPr>
@@ -5261,7 +5261,7 @@
           <p:cNvPr id="15" name="">
             <a:extLst xmlns:a="http://schemas.openxmlformats.org/drawingml/2006/main">
               <a:ext uri="{FF2B5EF4-FFF2-40B4-BE49-F238E27FC236}">
-                <a16:creationId xmlns:a16="http://schemas.microsoft.com/office/drawing/2014/main" id="{4409A8D2-756A-4BC1-AF1B-5263081CE883}"/>
+                <a16:creationId xmlns:a16="http://schemas.microsoft.com/office/drawing/2014/main" id="{29C6105C-7CAF-45F1-9795-B1DC1B330DCE}"/>
               </a:ext>
             </a:extLst>
           </p:cNvPr>
@@ -5323,7 +5323,7 @@
           <p:cNvPr id="16" name="">
             <a:extLst xmlns:a="http://schemas.openxmlformats.org/drawingml/2006/main">
               <a:ext uri="{FF2B5EF4-FFF2-40B4-BE49-F238E27FC236}">
-                <a16:creationId xmlns:a16="http://schemas.microsoft.com/office/drawing/2014/main" id="{FC39A93F-024C-4207-9332-9597CBD7C87F}"/>
+                <a16:creationId xmlns:a16="http://schemas.microsoft.com/office/drawing/2014/main" id="{41A8D8B3-428F-4FC4-9781-178597F88EDA}"/>
               </a:ext>
             </a:extLst>
           </p:cNvPr>
@@ -5385,7 +5385,7 @@
           <p:cNvPr id="17" name="">
             <a:extLst xmlns:a="http://schemas.openxmlformats.org/drawingml/2006/main">
               <a:ext uri="{FF2B5EF4-FFF2-40B4-BE49-F238E27FC236}">
-                <a16:creationId xmlns:a16="http://schemas.microsoft.com/office/drawing/2014/main" id="{663D66B6-7378-41F3-AB83-415281DCA916}"/>
+                <a16:creationId xmlns:a16="http://schemas.microsoft.com/office/drawing/2014/main" id="{19ECF44D-131D-4313-872F-286164529C49}"/>
               </a:ext>
             </a:extLst>
           </p:cNvPr>
@@ -5420,7 +5420,7 @@
           <p:cNvPr id="18" name="">
             <a:extLst xmlns:a="http://schemas.openxmlformats.org/drawingml/2006/main">
               <a:ext uri="{FF2B5EF4-FFF2-40B4-BE49-F238E27FC236}">
-                <a16:creationId xmlns:a16="http://schemas.microsoft.com/office/drawing/2014/main" id="{345F6741-335A-4AD2-9FA4-4AFE8E141B4E}"/>
+                <a16:creationId xmlns:a16="http://schemas.microsoft.com/office/drawing/2014/main" id="{2677478C-5281-444D-9453-0852C203BEF3}"/>
               </a:ext>
             </a:extLst>
           </p:cNvPr>
@@ -5509,7 +5509,7 @@
           <p:cNvPr id="19" name="footer-rule-11">
             <a:extLst xmlns:a="http://schemas.openxmlformats.org/drawingml/2006/main">
               <a:ext uri="{FF2B5EF4-FFF2-40B4-BE49-F238E27FC236}">
-                <a16:creationId xmlns:a16="http://schemas.microsoft.com/office/drawing/2014/main" id="{BA2CE536-8F09-4689-AF70-8A670CC33768}"/>
+                <a16:creationId xmlns:a16="http://schemas.microsoft.com/office/drawing/2014/main" id="{F0A5BC53-D7F0-4982-9A5C-1BF7EA8B5504}"/>
               </a:ext>
             </a:extLst>
           </p:cNvPr>
@@ -5540,7 +5540,7 @@
           <p:cNvPr id="20" name="footer-label-11">
             <a:extLst xmlns:a="http://schemas.openxmlformats.org/drawingml/2006/main">
               <a:ext uri="{FF2B5EF4-FFF2-40B4-BE49-F238E27FC236}">
-                <a16:creationId xmlns:a16="http://schemas.microsoft.com/office/drawing/2014/main" id="{A4BF5D2A-9101-4E94-BA2A-A11AF3CA54BB}"/>
+                <a16:creationId xmlns:a16="http://schemas.microsoft.com/office/drawing/2014/main" id="{09317719-387A-470D-9713-F2C440C93406}"/>
               </a:ext>
             </a:extLst>
           </p:cNvPr>
@@ -5602,7 +5602,7 @@
           <p:cNvPr id="21" name="footer-page-11">
             <a:extLst xmlns:a="http://schemas.openxmlformats.org/drawingml/2006/main">
               <a:ext uri="{FF2B5EF4-FFF2-40B4-BE49-F238E27FC236}">
-                <a16:creationId xmlns:a16="http://schemas.microsoft.com/office/drawing/2014/main" id="{6EE60B62-3FF4-43DE-82CC-F9C0AFEB2B76}"/>
+                <a16:creationId xmlns:a16="http://schemas.microsoft.com/office/drawing/2014/main" id="{0136F0CC-CA40-4499-9EA0-E7C6A485EEB4}"/>
               </a:ext>
             </a:extLst>
           </p:cNvPr>
@@ -5662,7 +5662,7 @@
     </p:spTree>
     <p:extLst>
       <p:ext uri="{BB962C8B-B14F-4D97-AF65-F5344CB8AC3E}">
-        <p14:creationId xmlns:p14="http://schemas.microsoft.com/office/powerpoint/2010/main" val="40875906"/>
+        <p14:creationId xmlns:p14="http://schemas.microsoft.com/office/powerpoint/2010/main" val="698321889"/>
       </p:ext>
     </p:extLst>
   </p:cSld>
@@ -5693,7 +5693,7 @@
           <p:cNvPr id="14" name="side-accent-12">
             <a:extLst xmlns:a="http://schemas.openxmlformats.org/drawingml/2006/main">
               <a:ext uri="{FF2B5EF4-FFF2-40B4-BE49-F238E27FC236}">
-                <a16:creationId xmlns:a16="http://schemas.microsoft.com/office/drawing/2014/main" id="{A2C78C74-82EB-4A2C-9F11-E807FBB6D58F}"/>
+                <a16:creationId xmlns:a16="http://schemas.microsoft.com/office/drawing/2014/main" id="{9CA8E64A-5DA3-46AA-8A45-B196CC48C2EA}"/>
               </a:ext>
             </a:extLst>
           </p:cNvPr>
@@ -5724,7 +5724,7 @@
           <p:cNvPr id="2" name="kicker-12">
             <a:extLst xmlns:a="http://schemas.openxmlformats.org/drawingml/2006/main">
               <a:ext uri="{FF2B5EF4-FFF2-40B4-BE49-F238E27FC236}">
-                <a16:creationId xmlns:a16="http://schemas.microsoft.com/office/drawing/2014/main" id="{099F4006-505C-40F1-B0AA-EED6C2FB9795}"/>
+                <a16:creationId xmlns:a16="http://schemas.microsoft.com/office/drawing/2014/main" id="{8D77D764-D209-42E2-91D9-155FBCBC0E14}"/>
               </a:ext>
             </a:extLst>
           </p:cNvPr>
@@ -5786,7 +5786,7 @@
           <p:cNvPr id="3" name="title-12">
             <a:extLst xmlns:a="http://schemas.openxmlformats.org/drawingml/2006/main">
               <a:ext uri="{FF2B5EF4-FFF2-40B4-BE49-F238E27FC236}">
-                <a16:creationId xmlns:a16="http://schemas.microsoft.com/office/drawing/2014/main" id="{2F1D2059-F483-4392-A8E9-F836CEC4AA0C}"/>
+                <a16:creationId xmlns:a16="http://schemas.microsoft.com/office/drawing/2014/main" id="{ADDEA42A-44C6-43FB-A4D7-D4ED298B19AF}"/>
               </a:ext>
             </a:extLst>
           </p:cNvPr>
@@ -5848,7 +5848,7 @@
           <p:cNvPr id="4" name="draft-panel">
             <a:extLst xmlns:a="http://schemas.openxmlformats.org/drawingml/2006/main">
               <a:ext uri="{FF2B5EF4-FFF2-40B4-BE49-F238E27FC236}">
-                <a16:creationId xmlns:a16="http://schemas.microsoft.com/office/drawing/2014/main" id="{4671A35F-45BE-4F5A-A259-B1BC4AB2C7FD}"/>
+                <a16:creationId xmlns:a16="http://schemas.microsoft.com/office/drawing/2014/main" id="{8DC37421-FFE1-4DAE-90F1-FAD2A828D5B8}"/>
               </a:ext>
             </a:extLst>
           </p:cNvPr>
@@ -5883,7 +5883,7 @@
           <p:cNvPr id="5" name="">
             <a:extLst xmlns:a="http://schemas.openxmlformats.org/drawingml/2006/main">
               <a:ext uri="{FF2B5EF4-FFF2-40B4-BE49-F238E27FC236}">
-                <a16:creationId xmlns:a16="http://schemas.microsoft.com/office/drawing/2014/main" id="{DB77EA38-79E3-49F5-BFED-E61BA6170F50}"/>
+                <a16:creationId xmlns:a16="http://schemas.microsoft.com/office/drawing/2014/main" id="{623D4B2D-6A04-4789-BAA1-AE62C436CA5A}"/>
               </a:ext>
             </a:extLst>
           </p:cNvPr>
@@ -5945,7 +5945,7 @@
           <p:cNvPr id="6" name="">
             <a:extLst xmlns:a="http://schemas.openxmlformats.org/drawingml/2006/main">
               <a:ext uri="{FF2B5EF4-FFF2-40B4-BE49-F238E27FC236}">
-                <a16:creationId xmlns:a16="http://schemas.microsoft.com/office/drawing/2014/main" id="{57FD923E-3F1B-4A47-BDE8-E246B9E1D505}"/>
+                <a16:creationId xmlns:a16="http://schemas.microsoft.com/office/drawing/2014/main" id="{01DCF48D-9E4A-42C2-AE99-ADBFFF0DDC23}"/>
               </a:ext>
             </a:extLst>
           </p:cNvPr>
@@ -6061,7 +6061,7 @@
           <p:cNvPr id="7" name="submit-panel">
             <a:extLst xmlns:a="http://schemas.openxmlformats.org/drawingml/2006/main">
               <a:ext uri="{FF2B5EF4-FFF2-40B4-BE49-F238E27FC236}">
-                <a16:creationId xmlns:a16="http://schemas.microsoft.com/office/drawing/2014/main" id="{E873492B-8DBE-48AE-A338-26E60AB712D0}"/>
+                <a16:creationId xmlns:a16="http://schemas.microsoft.com/office/drawing/2014/main" id="{B9EFED19-38E5-4254-8CDE-DC8694CE4236}"/>
               </a:ext>
             </a:extLst>
           </p:cNvPr>
@@ -6096,7 +6096,7 @@
           <p:cNvPr id="8" name="">
             <a:extLst xmlns:a="http://schemas.openxmlformats.org/drawingml/2006/main">
               <a:ext uri="{FF2B5EF4-FFF2-40B4-BE49-F238E27FC236}">
-                <a16:creationId xmlns:a16="http://schemas.microsoft.com/office/drawing/2014/main" id="{509C3533-68BE-4477-A3F4-D8ADB00167EE}"/>
+                <a16:creationId xmlns:a16="http://schemas.microsoft.com/office/drawing/2014/main" id="{83853CEF-D4D4-4D1D-BF95-1FC15EBB824F}"/>
               </a:ext>
             </a:extLst>
           </p:cNvPr>
@@ -6158,7 +6158,7 @@
           <p:cNvPr id="9" name="">
             <a:extLst xmlns:a="http://schemas.openxmlformats.org/drawingml/2006/main">
               <a:ext uri="{FF2B5EF4-FFF2-40B4-BE49-F238E27FC236}">
-                <a16:creationId xmlns:a16="http://schemas.microsoft.com/office/drawing/2014/main" id="{57D338BA-FCC7-4936-92CB-A09804FA4AB6}"/>
+                <a16:creationId xmlns:a16="http://schemas.microsoft.com/office/drawing/2014/main" id="{C1A57F7B-72FF-409B-8139-575AB94F94EF}"/>
               </a:ext>
             </a:extLst>
           </p:cNvPr>
@@ -6274,7 +6274,7 @@
           <p:cNvPr id="10" name="">
             <a:extLst xmlns:a="http://schemas.openxmlformats.org/drawingml/2006/main">
               <a:ext uri="{FF2B5EF4-FFF2-40B4-BE49-F238E27FC236}">
-                <a16:creationId xmlns:a16="http://schemas.microsoft.com/office/drawing/2014/main" id="{A2A1B40F-8D9B-4D22-A40B-16C97628E090}"/>
+                <a16:creationId xmlns:a16="http://schemas.microsoft.com/office/drawing/2014/main" id="{F6D782B9-A465-42DC-8DA7-D03623D82DA3}"/>
               </a:ext>
             </a:extLst>
           </p:cNvPr>
@@ -6336,7 +6336,7 @@
           <p:cNvPr id="11" name="footer-rule-12">
             <a:extLst xmlns:a="http://schemas.openxmlformats.org/drawingml/2006/main">
               <a:ext uri="{FF2B5EF4-FFF2-40B4-BE49-F238E27FC236}">
-                <a16:creationId xmlns:a16="http://schemas.microsoft.com/office/drawing/2014/main" id="{D4237CF0-899A-4FBB-9FD0-B0ED7258F8E0}"/>
+                <a16:creationId xmlns:a16="http://schemas.microsoft.com/office/drawing/2014/main" id="{D2BF0F77-4326-4416-9A05-C4E644706139}"/>
               </a:ext>
             </a:extLst>
           </p:cNvPr>
@@ -6367,7 +6367,7 @@
           <p:cNvPr id="12" name="footer-label-12">
             <a:extLst xmlns:a="http://schemas.openxmlformats.org/drawingml/2006/main">
               <a:ext uri="{FF2B5EF4-FFF2-40B4-BE49-F238E27FC236}">
-                <a16:creationId xmlns:a16="http://schemas.microsoft.com/office/drawing/2014/main" id="{B40865C0-73AE-4F5B-B852-415E4A439C1A}"/>
+                <a16:creationId xmlns:a16="http://schemas.microsoft.com/office/drawing/2014/main" id="{D7F65B39-6597-43F2-896E-1925FCB78BDA}"/>
               </a:ext>
             </a:extLst>
           </p:cNvPr>
@@ -6429,7 +6429,7 @@
           <p:cNvPr id="13" name="footer-page-12">
             <a:extLst xmlns:a="http://schemas.openxmlformats.org/drawingml/2006/main">
               <a:ext uri="{FF2B5EF4-FFF2-40B4-BE49-F238E27FC236}">
-                <a16:creationId xmlns:a16="http://schemas.microsoft.com/office/drawing/2014/main" id="{E503171F-6D55-4D02-A0B1-A690B9FCBB44}"/>
+                <a16:creationId xmlns:a16="http://schemas.microsoft.com/office/drawing/2014/main" id="{6CE39BE8-73D6-4777-99B9-574E625ECC22}"/>
               </a:ext>
             </a:extLst>
           </p:cNvPr>
@@ -6489,7 +6489,7 @@
     </p:spTree>
     <p:extLst>
       <p:ext uri="{BB962C8B-B14F-4D97-AF65-F5344CB8AC3E}">
-        <p14:creationId xmlns:p14="http://schemas.microsoft.com/office/powerpoint/2010/main" val="1578658044"/>
+        <p14:creationId xmlns:p14="http://schemas.microsoft.com/office/powerpoint/2010/main" val="1122592038"/>
       </p:ext>
     </p:extLst>
   </p:cSld>
@@ -6520,7 +6520,7 @@
           <p:cNvPr id="25" name="side-accent-13">
             <a:extLst xmlns:a="http://schemas.openxmlformats.org/drawingml/2006/main">
               <a:ext uri="{FF2B5EF4-FFF2-40B4-BE49-F238E27FC236}">
-                <a16:creationId xmlns:a16="http://schemas.microsoft.com/office/drawing/2014/main" id="{AAB6A0FA-F268-47D6-8758-0699873DC3C1}"/>
+                <a16:creationId xmlns:a16="http://schemas.microsoft.com/office/drawing/2014/main" id="{57E44C8A-6D0F-4B7F-9164-3C444EB7B800}"/>
               </a:ext>
             </a:extLst>
           </p:cNvPr>
@@ -6551,7 +6551,7 @@
           <p:cNvPr id="2" name="kicker-13">
             <a:extLst xmlns:a="http://schemas.openxmlformats.org/drawingml/2006/main">
               <a:ext uri="{FF2B5EF4-FFF2-40B4-BE49-F238E27FC236}">
-                <a16:creationId xmlns:a16="http://schemas.microsoft.com/office/drawing/2014/main" id="{835D40BE-920D-4398-A57E-26590E3EB0A0}"/>
+                <a16:creationId xmlns:a16="http://schemas.microsoft.com/office/drawing/2014/main" id="{0CBF2408-894F-4A94-9DE5-D7D801E320A1}"/>
               </a:ext>
             </a:extLst>
           </p:cNvPr>
@@ -6613,7 +6613,7 @@
           <p:cNvPr id="3" name="title-13">
             <a:extLst xmlns:a="http://schemas.openxmlformats.org/drawingml/2006/main">
               <a:ext uri="{FF2B5EF4-FFF2-40B4-BE49-F238E27FC236}">
-                <a16:creationId xmlns:a16="http://schemas.microsoft.com/office/drawing/2014/main" id="{5A9E0D30-4069-4202-AB04-54E934572EC4}"/>
+                <a16:creationId xmlns:a16="http://schemas.microsoft.com/office/drawing/2014/main" id="{6AC04F84-29BF-4924-9241-EE19D2CD39C6}"/>
               </a:ext>
             </a:extLst>
           </p:cNvPr>
@@ -6675,7 +6675,7 @@
           <p:cNvPr id="4" name="">
             <a:extLst xmlns:a="http://schemas.openxmlformats.org/drawingml/2006/main">
               <a:ext uri="{FF2B5EF4-FFF2-40B4-BE49-F238E27FC236}">
-                <a16:creationId xmlns:a16="http://schemas.microsoft.com/office/drawing/2014/main" id="{5B6738A1-DF13-4406-8856-8DC774F706F8}"/>
+                <a16:creationId xmlns:a16="http://schemas.microsoft.com/office/drawing/2014/main" id="{E1F2B309-58B9-4D64-A2F3-7B7A928F5696}"/>
               </a:ext>
             </a:extLst>
           </p:cNvPr>
@@ -6706,7 +6706,7 @@
           <p:cNvPr id="5" name="">
             <a:extLst xmlns:a="http://schemas.openxmlformats.org/drawingml/2006/main">
               <a:ext uri="{FF2B5EF4-FFF2-40B4-BE49-F238E27FC236}">
-                <a16:creationId xmlns:a16="http://schemas.microsoft.com/office/drawing/2014/main" id="{755AF4E4-B1C4-45FF-92E5-F2ED8FFA0B1A}"/>
+                <a16:creationId xmlns:a16="http://schemas.microsoft.com/office/drawing/2014/main" id="{47D3171E-ACBA-4D31-9C18-DAB5F55DA302}"/>
               </a:ext>
             </a:extLst>
           </p:cNvPr>
@@ -6737,7 +6737,7 @@
           <p:cNvPr id="6" name="">
             <a:extLst xmlns:a="http://schemas.openxmlformats.org/drawingml/2006/main">
               <a:ext uri="{FF2B5EF4-FFF2-40B4-BE49-F238E27FC236}">
-                <a16:creationId xmlns:a16="http://schemas.microsoft.com/office/drawing/2014/main" id="{143C1751-C42E-491E-BDAC-B71DBEB36DF3}"/>
+                <a16:creationId xmlns:a16="http://schemas.microsoft.com/office/drawing/2014/main" id="{13A82FA3-CB91-4F87-A0E3-A569B1E0E5AB}"/>
               </a:ext>
             </a:extLst>
           </p:cNvPr>
@@ -6799,7 +6799,7 @@
           <p:cNvPr id="7" name="">
             <a:extLst xmlns:a="http://schemas.openxmlformats.org/drawingml/2006/main">
               <a:ext uri="{FF2B5EF4-FFF2-40B4-BE49-F238E27FC236}">
-                <a16:creationId xmlns:a16="http://schemas.microsoft.com/office/drawing/2014/main" id="{27B4053A-E713-4266-B89E-C7EB3BF4614D}"/>
+                <a16:creationId xmlns:a16="http://schemas.microsoft.com/office/drawing/2014/main" id="{005A8180-F006-4A77-BCA1-2F98B8F109B5}"/>
               </a:ext>
             </a:extLst>
           </p:cNvPr>
@@ -6861,7 +6861,7 @@
           <p:cNvPr id="8" name="">
             <a:extLst xmlns:a="http://schemas.openxmlformats.org/drawingml/2006/main">
               <a:ext uri="{FF2B5EF4-FFF2-40B4-BE49-F238E27FC236}">
-                <a16:creationId xmlns:a16="http://schemas.microsoft.com/office/drawing/2014/main" id="{8E1AC46C-63E4-465E-9254-93AC7E443E79}"/>
+                <a16:creationId xmlns:a16="http://schemas.microsoft.com/office/drawing/2014/main" id="{C182BCB3-03A5-4D75-BF25-32C43A0C44E6}"/>
               </a:ext>
             </a:extLst>
           </p:cNvPr>
@@ -6923,7 +6923,7 @@
           <p:cNvPr id="9" name="">
             <a:extLst xmlns:a="http://schemas.openxmlformats.org/drawingml/2006/main">
               <a:ext uri="{FF2B5EF4-FFF2-40B4-BE49-F238E27FC236}">
-                <a16:creationId xmlns:a16="http://schemas.microsoft.com/office/drawing/2014/main" id="{B6DB2628-5A05-4153-A49C-622BC81D7F4A}"/>
+                <a16:creationId xmlns:a16="http://schemas.microsoft.com/office/drawing/2014/main" id="{74EF22EC-1D7F-441A-9815-DDF44B90A85C}"/>
               </a:ext>
             </a:extLst>
           </p:cNvPr>
@@ -6954,7 +6954,7 @@
           <p:cNvPr id="10" name="">
             <a:extLst xmlns:a="http://schemas.openxmlformats.org/drawingml/2006/main">
               <a:ext uri="{FF2B5EF4-FFF2-40B4-BE49-F238E27FC236}">
-                <a16:creationId xmlns:a16="http://schemas.microsoft.com/office/drawing/2014/main" id="{E019CF54-B282-4CC3-84C3-96479970E12F}"/>
+                <a16:creationId xmlns:a16="http://schemas.microsoft.com/office/drawing/2014/main" id="{A0323CF5-0863-4E2A-A272-008F668A91CA}"/>
               </a:ext>
             </a:extLst>
           </p:cNvPr>
@@ -7016,7 +7016,7 @@
           <p:cNvPr id="11" name="">
             <a:extLst xmlns:a="http://schemas.openxmlformats.org/drawingml/2006/main">
               <a:ext uri="{FF2B5EF4-FFF2-40B4-BE49-F238E27FC236}">
-                <a16:creationId xmlns:a16="http://schemas.microsoft.com/office/drawing/2014/main" id="{091FE2C8-9EC2-4081-9F3B-B9006CA178B3}"/>
+                <a16:creationId xmlns:a16="http://schemas.microsoft.com/office/drawing/2014/main" id="{EE4FBF08-8DC6-441F-881D-0C2C9082CD99}"/>
               </a:ext>
             </a:extLst>
           </p:cNvPr>
@@ -7078,7 +7078,7 @@
           <p:cNvPr id="12" name="">
             <a:extLst xmlns:a="http://schemas.openxmlformats.org/drawingml/2006/main">
               <a:ext uri="{FF2B5EF4-FFF2-40B4-BE49-F238E27FC236}">
-                <a16:creationId xmlns:a16="http://schemas.microsoft.com/office/drawing/2014/main" id="{75419926-8E0B-4BBF-B240-7DED8D01E23C}"/>
+                <a16:creationId xmlns:a16="http://schemas.microsoft.com/office/drawing/2014/main" id="{8CE44274-9EFD-4DFC-8734-AD780966E3E0}"/>
               </a:ext>
             </a:extLst>
           </p:cNvPr>
@@ -7140,7 +7140,7 @@
           <p:cNvPr id="13" name="">
             <a:extLst xmlns:a="http://schemas.openxmlformats.org/drawingml/2006/main">
               <a:ext uri="{FF2B5EF4-FFF2-40B4-BE49-F238E27FC236}">
-                <a16:creationId xmlns:a16="http://schemas.microsoft.com/office/drawing/2014/main" id="{D1C1B1EB-F545-4D1D-8922-89AF3608FD2A}"/>
+                <a16:creationId xmlns:a16="http://schemas.microsoft.com/office/drawing/2014/main" id="{3D7688F6-46C1-47CD-9746-E742DD9BE1BC}"/>
               </a:ext>
             </a:extLst>
           </p:cNvPr>
@@ -7171,7 +7171,7 @@
           <p:cNvPr id="14" name="">
             <a:extLst xmlns:a="http://schemas.openxmlformats.org/drawingml/2006/main">
               <a:ext uri="{FF2B5EF4-FFF2-40B4-BE49-F238E27FC236}">
-                <a16:creationId xmlns:a16="http://schemas.microsoft.com/office/drawing/2014/main" id="{FADDC3CA-C7B2-488A-949B-D5F1FF894BE5}"/>
+                <a16:creationId xmlns:a16="http://schemas.microsoft.com/office/drawing/2014/main" id="{4CBDBD0F-B1C4-4144-A0AC-8E21B5641B00}"/>
               </a:ext>
             </a:extLst>
           </p:cNvPr>
@@ -7233,7 +7233,7 @@
           <p:cNvPr id="15" name="">
             <a:extLst xmlns:a="http://schemas.openxmlformats.org/drawingml/2006/main">
               <a:ext uri="{FF2B5EF4-FFF2-40B4-BE49-F238E27FC236}">
-                <a16:creationId xmlns:a16="http://schemas.microsoft.com/office/drawing/2014/main" id="{F32C6AAD-0BBB-4443-8CC2-0A542D8669DB}"/>
+                <a16:creationId xmlns:a16="http://schemas.microsoft.com/office/drawing/2014/main" id="{1AEC644B-6C48-480D-8F1C-58038572DBD0}"/>
               </a:ext>
             </a:extLst>
           </p:cNvPr>
@@ -7295,7 +7295,7 @@
           <p:cNvPr id="16" name="">
             <a:extLst xmlns:a="http://schemas.openxmlformats.org/drawingml/2006/main">
               <a:ext uri="{FF2B5EF4-FFF2-40B4-BE49-F238E27FC236}">
-                <a16:creationId xmlns:a16="http://schemas.microsoft.com/office/drawing/2014/main" id="{1EEC459C-CA55-4596-B57C-22414FFA8216}"/>
+                <a16:creationId xmlns:a16="http://schemas.microsoft.com/office/drawing/2014/main" id="{C3033829-DD5F-47EA-9648-2BEC804F94E3}"/>
               </a:ext>
             </a:extLst>
           </p:cNvPr>
@@ -7357,7 +7357,7 @@
           <p:cNvPr id="17" name="">
             <a:extLst xmlns:a="http://schemas.openxmlformats.org/drawingml/2006/main">
               <a:ext uri="{FF2B5EF4-FFF2-40B4-BE49-F238E27FC236}">
-                <a16:creationId xmlns:a16="http://schemas.microsoft.com/office/drawing/2014/main" id="{29FB069A-DCF4-41E9-8892-8AAD34246B02}"/>
+                <a16:creationId xmlns:a16="http://schemas.microsoft.com/office/drawing/2014/main" id="{A6FF1364-7DA2-4F8D-8A3C-1EBB5E3C3363}"/>
               </a:ext>
             </a:extLst>
           </p:cNvPr>
@@ -7388,7 +7388,7 @@
           <p:cNvPr id="18" name="">
             <a:extLst xmlns:a="http://schemas.openxmlformats.org/drawingml/2006/main">
               <a:ext uri="{FF2B5EF4-FFF2-40B4-BE49-F238E27FC236}">
-                <a16:creationId xmlns:a16="http://schemas.microsoft.com/office/drawing/2014/main" id="{4D6874C8-188C-443B-893C-659EEF222C56}"/>
+                <a16:creationId xmlns:a16="http://schemas.microsoft.com/office/drawing/2014/main" id="{42050005-2A8B-423F-8635-2BEC73BF97AA}"/>
               </a:ext>
             </a:extLst>
           </p:cNvPr>
@@ -7450,7 +7450,7 @@
           <p:cNvPr id="19" name="">
             <a:extLst xmlns:a="http://schemas.openxmlformats.org/drawingml/2006/main">
               <a:ext uri="{FF2B5EF4-FFF2-40B4-BE49-F238E27FC236}">
-                <a16:creationId xmlns:a16="http://schemas.microsoft.com/office/drawing/2014/main" id="{BC164CB1-C9D6-421D-AC9D-2989F9D9443C}"/>
+                <a16:creationId xmlns:a16="http://schemas.microsoft.com/office/drawing/2014/main" id="{16863D41-659F-46FB-86A9-E6DD550D6A6C}"/>
               </a:ext>
             </a:extLst>
           </p:cNvPr>
@@ -7512,7 +7512,7 @@
           <p:cNvPr id="20" name="">
             <a:extLst xmlns:a="http://schemas.openxmlformats.org/drawingml/2006/main">
               <a:ext uri="{FF2B5EF4-FFF2-40B4-BE49-F238E27FC236}">
-                <a16:creationId xmlns:a16="http://schemas.microsoft.com/office/drawing/2014/main" id="{12AABCE5-A5D9-4DCA-B340-B34C01812C5E}"/>
+                <a16:creationId xmlns:a16="http://schemas.microsoft.com/office/drawing/2014/main" id="{0433C3FD-7165-4331-877A-CF12F2499B9D}"/>
               </a:ext>
             </a:extLst>
           </p:cNvPr>
@@ -7574,7 +7574,7 @@
           <p:cNvPr id="21" name="">
             <a:extLst xmlns:a="http://schemas.openxmlformats.org/drawingml/2006/main">
               <a:ext uri="{FF2B5EF4-FFF2-40B4-BE49-F238E27FC236}">
-                <a16:creationId xmlns:a16="http://schemas.microsoft.com/office/drawing/2014/main" id="{233110BD-50B9-4964-8945-A177395EA302}"/>
+                <a16:creationId xmlns:a16="http://schemas.microsoft.com/office/drawing/2014/main" id="{CFDB03B7-C5B7-4114-8060-B8AD315D26D5}"/>
               </a:ext>
             </a:extLst>
           </p:cNvPr>
@@ -7636,7 +7636,7 @@
           <p:cNvPr id="22" name="footer-rule-13">
             <a:extLst xmlns:a="http://schemas.openxmlformats.org/drawingml/2006/main">
               <a:ext uri="{FF2B5EF4-FFF2-40B4-BE49-F238E27FC236}">
-                <a16:creationId xmlns:a16="http://schemas.microsoft.com/office/drawing/2014/main" id="{7654F778-5F91-4905-A9C4-EFCDE1820311}"/>
+                <a16:creationId xmlns:a16="http://schemas.microsoft.com/office/drawing/2014/main" id="{B38187DC-1722-47D4-9233-7759C652729B}"/>
               </a:ext>
             </a:extLst>
           </p:cNvPr>
@@ -7667,7 +7667,7 @@
           <p:cNvPr id="23" name="footer-label-13">
             <a:extLst xmlns:a="http://schemas.openxmlformats.org/drawingml/2006/main">
               <a:ext uri="{FF2B5EF4-FFF2-40B4-BE49-F238E27FC236}">
-                <a16:creationId xmlns:a16="http://schemas.microsoft.com/office/drawing/2014/main" id="{AFF4F16D-6AA4-4FF0-9647-C396B01C88D2}"/>
+                <a16:creationId xmlns:a16="http://schemas.microsoft.com/office/drawing/2014/main" id="{B280351D-45A3-47E6-9F06-67D4DEDBDD2E}"/>
               </a:ext>
             </a:extLst>
           </p:cNvPr>
@@ -7729,7 +7729,7 @@
           <p:cNvPr id="24" name="footer-page-13">
             <a:extLst xmlns:a="http://schemas.openxmlformats.org/drawingml/2006/main">
               <a:ext uri="{FF2B5EF4-FFF2-40B4-BE49-F238E27FC236}">
-                <a16:creationId xmlns:a16="http://schemas.microsoft.com/office/drawing/2014/main" id="{4E2CF203-C1E1-4EF6-83BB-E27925FC4B03}"/>
+                <a16:creationId xmlns:a16="http://schemas.microsoft.com/office/drawing/2014/main" id="{7E077CAD-2F5E-48F7-A09A-126B7A432D5A}"/>
               </a:ext>
             </a:extLst>
           </p:cNvPr>
@@ -7789,7 +7789,7 @@
     </p:spTree>
     <p:extLst>
       <p:ext uri="{BB962C8B-B14F-4D97-AF65-F5344CB8AC3E}">
-        <p14:creationId xmlns:p14="http://schemas.microsoft.com/office/powerpoint/2010/main" val="171972524"/>
+        <p14:creationId xmlns:p14="http://schemas.microsoft.com/office/powerpoint/2010/main" val="307451378"/>
       </p:ext>
     </p:extLst>
   </p:cSld>
@@ -7820,7 +7820,7 @@
           <p:cNvPr id="24" name="side-accent-14">
             <a:extLst xmlns:a="http://schemas.openxmlformats.org/drawingml/2006/main">
               <a:ext uri="{FF2B5EF4-FFF2-40B4-BE49-F238E27FC236}">
-                <a16:creationId xmlns:a16="http://schemas.microsoft.com/office/drawing/2014/main" id="{C22C029D-202B-4322-90EF-1D65B0CB4532}"/>
+                <a16:creationId xmlns:a16="http://schemas.microsoft.com/office/drawing/2014/main" id="{708E2CD7-2F91-4F2D-9003-AB5B0FB331E4}"/>
               </a:ext>
             </a:extLst>
           </p:cNvPr>
@@ -7851,7 +7851,7 @@
           <p:cNvPr id="2" name="kicker-14">
             <a:extLst xmlns:a="http://schemas.openxmlformats.org/drawingml/2006/main">
               <a:ext uri="{FF2B5EF4-FFF2-40B4-BE49-F238E27FC236}">
-                <a16:creationId xmlns:a16="http://schemas.microsoft.com/office/drawing/2014/main" id="{1DAAA7A6-D85B-4F09-849F-7A42214A0AF8}"/>
+                <a16:creationId xmlns:a16="http://schemas.microsoft.com/office/drawing/2014/main" id="{6E70A515-20BC-4A19-A482-2E1566158B29}"/>
               </a:ext>
             </a:extLst>
           </p:cNvPr>
@@ -7913,7 +7913,7 @@
           <p:cNvPr id="3" name="title-14">
             <a:extLst xmlns:a="http://schemas.openxmlformats.org/drawingml/2006/main">
               <a:ext uri="{FF2B5EF4-FFF2-40B4-BE49-F238E27FC236}">
-                <a16:creationId xmlns:a16="http://schemas.microsoft.com/office/drawing/2014/main" id="{78BF02B6-FC47-4002-A61F-D3F80992BE48}"/>
+                <a16:creationId xmlns:a16="http://schemas.microsoft.com/office/drawing/2014/main" id="{D09AF672-EE82-4143-9959-CAE1C89C4B7E}"/>
               </a:ext>
             </a:extLst>
           </p:cNvPr>
@@ -7975,7 +7975,7 @@
           <p:cNvPr id="4" name="">
             <a:extLst xmlns:a="http://schemas.openxmlformats.org/drawingml/2006/main">
               <a:ext uri="{FF2B5EF4-FFF2-40B4-BE49-F238E27FC236}">
-                <a16:creationId xmlns:a16="http://schemas.microsoft.com/office/drawing/2014/main" id="{0CDD444C-A28D-4E62-82E2-856EA34BA4EC}"/>
+                <a16:creationId xmlns:a16="http://schemas.microsoft.com/office/drawing/2014/main" id="{B452D8FE-76BC-48EF-BDC6-4FCB385B9B34}"/>
               </a:ext>
             </a:extLst>
           </p:cNvPr>
@@ -8037,7 +8037,7 @@
           <p:cNvPr id="5" name="">
             <a:extLst xmlns:a="http://schemas.openxmlformats.org/drawingml/2006/main">
               <a:ext uri="{FF2B5EF4-FFF2-40B4-BE49-F238E27FC236}">
-                <a16:creationId xmlns:a16="http://schemas.microsoft.com/office/drawing/2014/main" id="{FFB9A896-EAFC-4CCF-9897-065C3B6739C5}"/>
+                <a16:creationId xmlns:a16="http://schemas.microsoft.com/office/drawing/2014/main" id="{918AA832-9E5E-4DBA-ADAE-9FEBEF7E9C3A}"/>
               </a:ext>
             </a:extLst>
           </p:cNvPr>
@@ -8099,7 +8099,7 @@
           <p:cNvPr id="6" name="">
             <a:extLst xmlns:a="http://schemas.openxmlformats.org/drawingml/2006/main">
               <a:ext uri="{FF2B5EF4-FFF2-40B4-BE49-F238E27FC236}">
-                <a16:creationId xmlns:a16="http://schemas.microsoft.com/office/drawing/2014/main" id="{FB286CF7-C001-40CD-BAA1-11A47FA76DAA}"/>
+                <a16:creationId xmlns:a16="http://schemas.microsoft.com/office/drawing/2014/main" id="{E8999719-32B0-4218-831F-32E11B983D71}"/>
               </a:ext>
             </a:extLst>
           </p:cNvPr>
@@ -8161,7 +8161,7 @@
           <p:cNvPr id="7" name="">
             <a:extLst xmlns:a="http://schemas.openxmlformats.org/drawingml/2006/main">
               <a:ext uri="{FF2B5EF4-FFF2-40B4-BE49-F238E27FC236}">
-                <a16:creationId xmlns:a16="http://schemas.microsoft.com/office/drawing/2014/main" id="{499C9C15-7E70-4F59-8BF7-C7862F7134D4}"/>
+                <a16:creationId xmlns:a16="http://schemas.microsoft.com/office/drawing/2014/main" id="{E654E16D-C48E-48E0-94F2-C11F01E67032}"/>
               </a:ext>
             </a:extLst>
           </p:cNvPr>
@@ -8192,7 +8192,7 @@
           <p:cNvPr id="8" name="">
             <a:extLst xmlns:a="http://schemas.openxmlformats.org/drawingml/2006/main">
               <a:ext uri="{FF2B5EF4-FFF2-40B4-BE49-F238E27FC236}">
-                <a16:creationId xmlns:a16="http://schemas.microsoft.com/office/drawing/2014/main" id="{06177B58-4D19-4DBF-9133-4D969B3DB4AE}"/>
+                <a16:creationId xmlns:a16="http://schemas.microsoft.com/office/drawing/2014/main" id="{8E4DB345-0384-438B-B643-E47BA3C92665}"/>
               </a:ext>
             </a:extLst>
           </p:cNvPr>
@@ -8254,7 +8254,7 @@
           <p:cNvPr id="9" name="">
             <a:extLst xmlns:a="http://schemas.openxmlformats.org/drawingml/2006/main">
               <a:ext uri="{FF2B5EF4-FFF2-40B4-BE49-F238E27FC236}">
-                <a16:creationId xmlns:a16="http://schemas.microsoft.com/office/drawing/2014/main" id="{204BA3FE-DFC7-48B8-8D41-1FB85D9C6741}"/>
+                <a16:creationId xmlns:a16="http://schemas.microsoft.com/office/drawing/2014/main" id="{7B2F07D2-BA33-4755-B20A-91CBE6F6E314}"/>
               </a:ext>
             </a:extLst>
           </p:cNvPr>
@@ -8316,7 +8316,7 @@
           <p:cNvPr id="10" name="">
             <a:extLst xmlns:a="http://schemas.openxmlformats.org/drawingml/2006/main">
               <a:ext uri="{FF2B5EF4-FFF2-40B4-BE49-F238E27FC236}">
-                <a16:creationId xmlns:a16="http://schemas.microsoft.com/office/drawing/2014/main" id="{23CA5975-D4D6-4406-A097-C78E59CEE96B}"/>
+                <a16:creationId xmlns:a16="http://schemas.microsoft.com/office/drawing/2014/main" id="{0FC489E4-18A9-4D6D-96F6-9BDAD8EC476F}"/>
               </a:ext>
             </a:extLst>
           </p:cNvPr>
@@ -8378,7 +8378,7 @@
           <p:cNvPr id="11" name="">
             <a:extLst xmlns:a="http://schemas.openxmlformats.org/drawingml/2006/main">
               <a:ext uri="{FF2B5EF4-FFF2-40B4-BE49-F238E27FC236}">
-                <a16:creationId xmlns:a16="http://schemas.microsoft.com/office/drawing/2014/main" id="{3D5ED00E-5734-4730-8349-8017A7BE5B2D}"/>
+                <a16:creationId xmlns:a16="http://schemas.microsoft.com/office/drawing/2014/main" id="{498E508B-B64D-4184-8CDA-E49055BB48D0}"/>
               </a:ext>
             </a:extLst>
           </p:cNvPr>
@@ -8409,7 +8409,7 @@
           <p:cNvPr id="12" name="">
             <a:extLst xmlns:a="http://schemas.openxmlformats.org/drawingml/2006/main">
               <a:ext uri="{FF2B5EF4-FFF2-40B4-BE49-F238E27FC236}">
-                <a16:creationId xmlns:a16="http://schemas.microsoft.com/office/drawing/2014/main" id="{26C81B1E-7F89-452C-8ACC-B661D97F9669}"/>
+                <a16:creationId xmlns:a16="http://schemas.microsoft.com/office/drawing/2014/main" id="{17BFEFBC-8DF7-4ED0-9755-0E0570F5E745}"/>
               </a:ext>
             </a:extLst>
           </p:cNvPr>
@@ -8471,7 +8471,7 @@
           <p:cNvPr id="13" name="">
             <a:extLst xmlns:a="http://schemas.openxmlformats.org/drawingml/2006/main">
               <a:ext uri="{FF2B5EF4-FFF2-40B4-BE49-F238E27FC236}">
-                <a16:creationId xmlns:a16="http://schemas.microsoft.com/office/drawing/2014/main" id="{A0B2DF03-EFC7-4D4D-A9FD-E143F6273FB6}"/>
+                <a16:creationId xmlns:a16="http://schemas.microsoft.com/office/drawing/2014/main" id="{8259BD0A-A715-499A-925F-D16E1D869436}"/>
               </a:ext>
             </a:extLst>
           </p:cNvPr>
@@ -8533,7 +8533,7 @@
           <p:cNvPr id="14" name="">
             <a:extLst xmlns:a="http://schemas.openxmlformats.org/drawingml/2006/main">
               <a:ext uri="{FF2B5EF4-FFF2-40B4-BE49-F238E27FC236}">
-                <a16:creationId xmlns:a16="http://schemas.microsoft.com/office/drawing/2014/main" id="{C27F87C4-E033-4135-8F33-4818A342CCC2}"/>
+                <a16:creationId xmlns:a16="http://schemas.microsoft.com/office/drawing/2014/main" id="{9B920A27-9AFC-4756-A3BE-CACF5C406151}"/>
               </a:ext>
             </a:extLst>
           </p:cNvPr>
@@ -8595,7 +8595,7 @@
           <p:cNvPr id="15" name="">
             <a:extLst xmlns:a="http://schemas.openxmlformats.org/drawingml/2006/main">
               <a:ext uri="{FF2B5EF4-FFF2-40B4-BE49-F238E27FC236}">
-                <a16:creationId xmlns:a16="http://schemas.microsoft.com/office/drawing/2014/main" id="{FD7FF364-8197-4DE4-88D4-15F7B1BD0E22}"/>
+                <a16:creationId xmlns:a16="http://schemas.microsoft.com/office/drawing/2014/main" id="{F13EC367-CD14-47BD-8F7C-19B13AA25F54}"/>
               </a:ext>
             </a:extLst>
           </p:cNvPr>
@@ -8626,7 +8626,7 @@
           <p:cNvPr id="16" name="">
             <a:extLst xmlns:a="http://schemas.openxmlformats.org/drawingml/2006/main">
               <a:ext uri="{FF2B5EF4-FFF2-40B4-BE49-F238E27FC236}">
-                <a16:creationId xmlns:a16="http://schemas.microsoft.com/office/drawing/2014/main" id="{523615D1-632E-4C98-84BB-D8D8929DC324}"/>
+                <a16:creationId xmlns:a16="http://schemas.microsoft.com/office/drawing/2014/main" id="{953C888D-D2AE-4E4D-83D9-02EB2BA50FE2}"/>
               </a:ext>
             </a:extLst>
           </p:cNvPr>
@@ -8688,7 +8688,7 @@
           <p:cNvPr id="17" name="">
             <a:extLst xmlns:a="http://schemas.openxmlformats.org/drawingml/2006/main">
               <a:ext uri="{FF2B5EF4-FFF2-40B4-BE49-F238E27FC236}">
-                <a16:creationId xmlns:a16="http://schemas.microsoft.com/office/drawing/2014/main" id="{8DBFBA10-73DD-40F9-942E-747F31C3AC26}"/>
+                <a16:creationId xmlns:a16="http://schemas.microsoft.com/office/drawing/2014/main" id="{E53BB785-7395-4D43-89DD-517B8180CAA7}"/>
               </a:ext>
             </a:extLst>
           </p:cNvPr>
@@ -8750,7 +8750,7 @@
           <p:cNvPr id="18" name="">
             <a:extLst xmlns:a="http://schemas.openxmlformats.org/drawingml/2006/main">
               <a:ext uri="{FF2B5EF4-FFF2-40B4-BE49-F238E27FC236}">
-                <a16:creationId xmlns:a16="http://schemas.microsoft.com/office/drawing/2014/main" id="{8A201ED7-66DE-4D01-8D97-FF68C44F2D13}"/>
+                <a16:creationId xmlns:a16="http://schemas.microsoft.com/office/drawing/2014/main" id="{F355F7EF-7F42-4E9F-BD81-18711A692195}"/>
               </a:ext>
             </a:extLst>
           </p:cNvPr>
@@ -8812,7 +8812,7 @@
           <p:cNvPr id="19" name="">
             <a:extLst xmlns:a="http://schemas.openxmlformats.org/drawingml/2006/main">
               <a:ext uri="{FF2B5EF4-FFF2-40B4-BE49-F238E27FC236}">
-                <a16:creationId xmlns:a16="http://schemas.microsoft.com/office/drawing/2014/main" id="{F381F582-2ADC-4B9B-9B95-A831BA3E22B3}"/>
+                <a16:creationId xmlns:a16="http://schemas.microsoft.com/office/drawing/2014/main" id="{03333974-FC41-40D7-87AE-1A24106F2A26}"/>
               </a:ext>
             </a:extLst>
           </p:cNvPr>
@@ -8845,7 +8845,7 @@
           <p:cNvPr id="20" name="">
             <a:extLst xmlns:a="http://schemas.openxmlformats.org/drawingml/2006/main">
               <a:ext uri="{FF2B5EF4-FFF2-40B4-BE49-F238E27FC236}">
-                <a16:creationId xmlns:a16="http://schemas.microsoft.com/office/drawing/2014/main" id="{FAF84720-374E-4737-82E1-B1A39F7DB54D}"/>
+                <a16:creationId xmlns:a16="http://schemas.microsoft.com/office/drawing/2014/main" id="{A1E47084-EE02-4544-9DCE-0B9AB3C902D5}"/>
               </a:ext>
             </a:extLst>
           </p:cNvPr>
@@ -8907,7 +8907,7 @@
           <p:cNvPr id="21" name="footer-rule-14">
             <a:extLst xmlns:a="http://schemas.openxmlformats.org/drawingml/2006/main">
               <a:ext uri="{FF2B5EF4-FFF2-40B4-BE49-F238E27FC236}">
-                <a16:creationId xmlns:a16="http://schemas.microsoft.com/office/drawing/2014/main" id="{8E3A983B-1174-44CB-9914-3AA8909B0C1B}"/>
+                <a16:creationId xmlns:a16="http://schemas.microsoft.com/office/drawing/2014/main" id="{3DD560BB-496C-4E9F-99F1-B8D88307872D}"/>
               </a:ext>
             </a:extLst>
           </p:cNvPr>
@@ -8938,7 +8938,7 @@
           <p:cNvPr id="22" name="footer-label-14">
             <a:extLst xmlns:a="http://schemas.openxmlformats.org/drawingml/2006/main">
               <a:ext uri="{FF2B5EF4-FFF2-40B4-BE49-F238E27FC236}">
-                <a16:creationId xmlns:a16="http://schemas.microsoft.com/office/drawing/2014/main" id="{A9CC7EA9-F6B1-4707-89D7-0BCCA57693D9}"/>
+                <a16:creationId xmlns:a16="http://schemas.microsoft.com/office/drawing/2014/main" id="{457B9EFF-1D47-47DE-B7E2-5A17F31878A5}"/>
               </a:ext>
             </a:extLst>
           </p:cNvPr>
@@ -9000,7 +9000,7 @@
           <p:cNvPr id="23" name="footer-page-14">
             <a:extLst xmlns:a="http://schemas.openxmlformats.org/drawingml/2006/main">
               <a:ext uri="{FF2B5EF4-FFF2-40B4-BE49-F238E27FC236}">
-                <a16:creationId xmlns:a16="http://schemas.microsoft.com/office/drawing/2014/main" id="{795800E4-D67C-4033-BD81-231DE674AF00}"/>
+                <a16:creationId xmlns:a16="http://schemas.microsoft.com/office/drawing/2014/main" id="{76FD468D-AF97-4558-9026-9C3A2D103722}"/>
               </a:ext>
             </a:extLst>
           </p:cNvPr>
@@ -9060,7 +9060,7 @@
     </p:spTree>
     <p:extLst>
       <p:ext uri="{BB962C8B-B14F-4D97-AF65-F5344CB8AC3E}">
-        <p14:creationId xmlns:p14="http://schemas.microsoft.com/office/powerpoint/2010/main" val="1586498836"/>
+        <p14:creationId xmlns:p14="http://schemas.microsoft.com/office/powerpoint/2010/main" val="1358597631"/>
       </p:ext>
     </p:extLst>
   </p:cSld>
@@ -9091,7 +9091,7 @@
           <p:cNvPr id="21" name="side-accent-15">
             <a:extLst xmlns:a="http://schemas.openxmlformats.org/drawingml/2006/main">
               <a:ext uri="{FF2B5EF4-FFF2-40B4-BE49-F238E27FC236}">
-                <a16:creationId xmlns:a16="http://schemas.microsoft.com/office/drawing/2014/main" id="{A9EE4E31-4371-4923-A455-6ED759157692}"/>
+                <a16:creationId xmlns:a16="http://schemas.microsoft.com/office/drawing/2014/main" id="{78303166-DAD7-45BC-ADB9-1AE2C2E9F317}"/>
               </a:ext>
             </a:extLst>
           </p:cNvPr>
@@ -9122,7 +9122,7 @@
           <p:cNvPr id="2" name="kicker-15">
             <a:extLst xmlns:a="http://schemas.openxmlformats.org/drawingml/2006/main">
               <a:ext uri="{FF2B5EF4-FFF2-40B4-BE49-F238E27FC236}">
-                <a16:creationId xmlns:a16="http://schemas.microsoft.com/office/drawing/2014/main" id="{995A366E-DF99-43BE-BD3A-04CB3120AA9E}"/>
+                <a16:creationId xmlns:a16="http://schemas.microsoft.com/office/drawing/2014/main" id="{20B193B2-2EE4-46B4-9CB4-DE0E643D4381}"/>
               </a:ext>
             </a:extLst>
           </p:cNvPr>
@@ -9184,7 +9184,7 @@
           <p:cNvPr id="3" name="title-15">
             <a:extLst xmlns:a="http://schemas.openxmlformats.org/drawingml/2006/main">
               <a:ext uri="{FF2B5EF4-FFF2-40B4-BE49-F238E27FC236}">
-                <a16:creationId xmlns:a16="http://schemas.microsoft.com/office/drawing/2014/main" id="{124915BC-C6F3-4185-8F8F-D81C922F11D0}"/>
+                <a16:creationId xmlns:a16="http://schemas.microsoft.com/office/drawing/2014/main" id="{F2D11C67-4F2B-44E1-84EA-644D4C783A68}"/>
               </a:ext>
             </a:extLst>
           </p:cNvPr>
@@ -9246,7 +9246,7 @@
           <p:cNvPr id="4" name="">
             <a:extLst xmlns:a="http://schemas.openxmlformats.org/drawingml/2006/main">
               <a:ext uri="{FF2B5EF4-FFF2-40B4-BE49-F238E27FC236}">
-                <a16:creationId xmlns:a16="http://schemas.microsoft.com/office/drawing/2014/main" id="{2450BCE8-C65E-434A-9EAE-12A3CA074F66}"/>
+                <a16:creationId xmlns:a16="http://schemas.microsoft.com/office/drawing/2014/main" id="{F0BF6EF5-4249-4507-8665-4F61FE5AE496}"/>
               </a:ext>
             </a:extLst>
           </p:cNvPr>
@@ -9277,7 +9277,7 @@
           <p:cNvPr id="5" name="">
             <a:extLst xmlns:a="http://schemas.openxmlformats.org/drawingml/2006/main">
               <a:ext uri="{FF2B5EF4-FFF2-40B4-BE49-F238E27FC236}">
-                <a16:creationId xmlns:a16="http://schemas.microsoft.com/office/drawing/2014/main" id="{CA9C6F5E-E4A7-42ED-80EB-5428B921C2CD}"/>
+                <a16:creationId xmlns:a16="http://schemas.microsoft.com/office/drawing/2014/main" id="{8D78CAF5-BCBB-4EA5-8DB6-2DB17550BA02}"/>
               </a:ext>
             </a:extLst>
           </p:cNvPr>
@@ -9308,7 +9308,7 @@
           <p:cNvPr id="6" name="">
             <a:extLst xmlns:a="http://schemas.openxmlformats.org/drawingml/2006/main">
               <a:ext uri="{FF2B5EF4-FFF2-40B4-BE49-F238E27FC236}">
-                <a16:creationId xmlns:a16="http://schemas.microsoft.com/office/drawing/2014/main" id="{09C4E36B-B848-479E-A80D-2CA811583ACF}"/>
+                <a16:creationId xmlns:a16="http://schemas.microsoft.com/office/drawing/2014/main" id="{74B155EA-606B-4E3E-9FAB-56C3388FE5D8}"/>
               </a:ext>
             </a:extLst>
           </p:cNvPr>
@@ -9370,7 +9370,7 @@
           <p:cNvPr id="7" name="">
             <a:extLst xmlns:a="http://schemas.openxmlformats.org/drawingml/2006/main">
               <a:ext uri="{FF2B5EF4-FFF2-40B4-BE49-F238E27FC236}">
-                <a16:creationId xmlns:a16="http://schemas.microsoft.com/office/drawing/2014/main" id="{51828252-1DC6-40AD-942A-9D7041E28883}"/>
+                <a16:creationId xmlns:a16="http://schemas.microsoft.com/office/drawing/2014/main" id="{2496260D-AF4C-4F07-A246-5B3FF940DAF1}"/>
               </a:ext>
             </a:extLst>
           </p:cNvPr>
@@ -9432,7 +9432,7 @@
           <p:cNvPr id="8" name="">
             <a:extLst xmlns:a="http://schemas.openxmlformats.org/drawingml/2006/main">
               <a:ext uri="{FF2B5EF4-FFF2-40B4-BE49-F238E27FC236}">
-                <a16:creationId xmlns:a16="http://schemas.microsoft.com/office/drawing/2014/main" id="{46B63D3B-F712-416B-9ED6-626A8585BED3}"/>
+                <a16:creationId xmlns:a16="http://schemas.microsoft.com/office/drawing/2014/main" id="{2E2F192D-6030-45A4-A1B5-C206F51F66EF}"/>
               </a:ext>
             </a:extLst>
           </p:cNvPr>
@@ -9494,7 +9494,7 @@
           <p:cNvPr id="9" name="">
             <a:extLst xmlns:a="http://schemas.openxmlformats.org/drawingml/2006/main">
               <a:ext uri="{FF2B5EF4-FFF2-40B4-BE49-F238E27FC236}">
-                <a16:creationId xmlns:a16="http://schemas.microsoft.com/office/drawing/2014/main" id="{4128B4E2-3222-4050-B2FB-5BF584C91FE8}"/>
+                <a16:creationId xmlns:a16="http://schemas.microsoft.com/office/drawing/2014/main" id="{2EAE6A81-DE38-44DD-954E-3B9855BE49CA}"/>
               </a:ext>
             </a:extLst>
           </p:cNvPr>
@@ -9525,7 +9525,7 @@
           <p:cNvPr id="10" name="">
             <a:extLst xmlns:a="http://schemas.openxmlformats.org/drawingml/2006/main">
               <a:ext uri="{FF2B5EF4-FFF2-40B4-BE49-F238E27FC236}">
-                <a16:creationId xmlns:a16="http://schemas.microsoft.com/office/drawing/2014/main" id="{4BF7A277-2292-466C-AF74-09BDD9930A39}"/>
+                <a16:creationId xmlns:a16="http://schemas.microsoft.com/office/drawing/2014/main" id="{A092D458-16A5-41AD-80D3-E820654EECC3}"/>
               </a:ext>
             </a:extLst>
           </p:cNvPr>
@@ -9587,7 +9587,7 @@
           <p:cNvPr id="11" name="">
             <a:extLst xmlns:a="http://schemas.openxmlformats.org/drawingml/2006/main">
               <a:ext uri="{FF2B5EF4-FFF2-40B4-BE49-F238E27FC236}">
-                <a16:creationId xmlns:a16="http://schemas.microsoft.com/office/drawing/2014/main" id="{7EC184A0-E234-4373-AEDA-0164B1D48A19}"/>
+                <a16:creationId xmlns:a16="http://schemas.microsoft.com/office/drawing/2014/main" id="{11D9B7E3-0A2C-43CC-AFD3-13589AF0C5D8}"/>
               </a:ext>
             </a:extLst>
           </p:cNvPr>
@@ -9649,7 +9649,7 @@
           <p:cNvPr id="12" name="">
             <a:extLst xmlns:a="http://schemas.openxmlformats.org/drawingml/2006/main">
               <a:ext uri="{FF2B5EF4-FFF2-40B4-BE49-F238E27FC236}">
-                <a16:creationId xmlns:a16="http://schemas.microsoft.com/office/drawing/2014/main" id="{5D71068A-6F6A-442F-9D31-36591BD6BED5}"/>
+                <a16:creationId xmlns:a16="http://schemas.microsoft.com/office/drawing/2014/main" id="{95ECA370-DDC2-4036-9B22-3A66FDF595EE}"/>
               </a:ext>
             </a:extLst>
           </p:cNvPr>
@@ -9711,7 +9711,7 @@
           <p:cNvPr id="13" name="">
             <a:extLst xmlns:a="http://schemas.openxmlformats.org/drawingml/2006/main">
               <a:ext uri="{FF2B5EF4-FFF2-40B4-BE49-F238E27FC236}">
-                <a16:creationId xmlns:a16="http://schemas.microsoft.com/office/drawing/2014/main" id="{3A711F04-2E57-4745-AFF1-B58519E53C40}"/>
+                <a16:creationId xmlns:a16="http://schemas.microsoft.com/office/drawing/2014/main" id="{120CC19B-B79E-49A8-B402-2273DCE8A768}"/>
               </a:ext>
             </a:extLst>
           </p:cNvPr>
@@ -9742,7 +9742,7 @@
           <p:cNvPr id="14" name="">
             <a:extLst xmlns:a="http://schemas.openxmlformats.org/drawingml/2006/main">
               <a:ext uri="{FF2B5EF4-FFF2-40B4-BE49-F238E27FC236}">
-                <a16:creationId xmlns:a16="http://schemas.microsoft.com/office/drawing/2014/main" id="{3F411CB8-9569-418D-8955-EFE6719B3A19}"/>
+                <a16:creationId xmlns:a16="http://schemas.microsoft.com/office/drawing/2014/main" id="{2993581C-A142-4813-AB40-0377A72BA7D7}"/>
               </a:ext>
             </a:extLst>
           </p:cNvPr>
@@ -9804,7 +9804,7 @@
           <p:cNvPr id="15" name="">
             <a:extLst xmlns:a="http://schemas.openxmlformats.org/drawingml/2006/main">
               <a:ext uri="{FF2B5EF4-FFF2-40B4-BE49-F238E27FC236}">
-                <a16:creationId xmlns:a16="http://schemas.microsoft.com/office/drawing/2014/main" id="{577D26F0-B28F-4010-8213-66D0315996C1}"/>
+                <a16:creationId xmlns:a16="http://schemas.microsoft.com/office/drawing/2014/main" id="{2CA669F7-A43A-46C1-A63B-ED8C3BA66E1D}"/>
               </a:ext>
             </a:extLst>
           </p:cNvPr>
@@ -9866,7 +9866,7 @@
           <p:cNvPr id="16" name="">
             <a:extLst xmlns:a="http://schemas.openxmlformats.org/drawingml/2006/main">
               <a:ext uri="{FF2B5EF4-FFF2-40B4-BE49-F238E27FC236}">
-                <a16:creationId xmlns:a16="http://schemas.microsoft.com/office/drawing/2014/main" id="{6A735BA9-B585-46F8-B3A0-CAAE110D821E}"/>
+                <a16:creationId xmlns:a16="http://schemas.microsoft.com/office/drawing/2014/main" id="{64C96EE9-EAA0-4DDA-BE45-43BABDF3C06F}"/>
               </a:ext>
             </a:extLst>
           </p:cNvPr>
@@ -9928,7 +9928,7 @@
           <p:cNvPr id="17" name="">
             <a:extLst xmlns:a="http://schemas.openxmlformats.org/drawingml/2006/main">
               <a:ext uri="{FF2B5EF4-FFF2-40B4-BE49-F238E27FC236}">
-                <a16:creationId xmlns:a16="http://schemas.microsoft.com/office/drawing/2014/main" id="{A5AB007D-9B65-458C-885C-14FEFFBA372E}"/>
+                <a16:creationId xmlns:a16="http://schemas.microsoft.com/office/drawing/2014/main" id="{142006C2-19BA-4712-9F45-295CEC414BD9}"/>
               </a:ext>
             </a:extLst>
           </p:cNvPr>
@@ -9990,7 +9990,7 @@
           <p:cNvPr id="18" name="footer-rule-15">
             <a:extLst xmlns:a="http://schemas.openxmlformats.org/drawingml/2006/main">
               <a:ext uri="{FF2B5EF4-FFF2-40B4-BE49-F238E27FC236}">
-                <a16:creationId xmlns:a16="http://schemas.microsoft.com/office/drawing/2014/main" id="{1B7E3F8E-90A2-487E-833B-B8452F77F08A}"/>
+                <a16:creationId xmlns:a16="http://schemas.microsoft.com/office/drawing/2014/main" id="{0C91A751-9EEB-40E8-80D0-CB62CBE4E4A3}"/>
               </a:ext>
             </a:extLst>
           </p:cNvPr>
@@ -10021,7 +10021,7 @@
           <p:cNvPr id="19" name="footer-label-15">
             <a:extLst xmlns:a="http://schemas.openxmlformats.org/drawingml/2006/main">
               <a:ext uri="{FF2B5EF4-FFF2-40B4-BE49-F238E27FC236}">
-                <a16:creationId xmlns:a16="http://schemas.microsoft.com/office/drawing/2014/main" id="{B9919573-5B62-4D27-9248-5B03D3C46417}"/>
+                <a16:creationId xmlns:a16="http://schemas.microsoft.com/office/drawing/2014/main" id="{302092E7-E649-44E7-B26C-5BDA9D3000A0}"/>
               </a:ext>
             </a:extLst>
           </p:cNvPr>
@@ -10083,7 +10083,7 @@
           <p:cNvPr id="20" name="footer-page-15">
             <a:extLst xmlns:a="http://schemas.openxmlformats.org/drawingml/2006/main">
               <a:ext uri="{FF2B5EF4-FFF2-40B4-BE49-F238E27FC236}">
-                <a16:creationId xmlns:a16="http://schemas.microsoft.com/office/drawing/2014/main" id="{ECCBF928-6349-4FDD-ABCB-27BE4EC2CE27}"/>
+                <a16:creationId xmlns:a16="http://schemas.microsoft.com/office/drawing/2014/main" id="{8039386E-CB30-445B-B771-E5ED3F266FE9}"/>
               </a:ext>
             </a:extLst>
           </p:cNvPr>
@@ -10143,7 +10143,7 @@
     </p:spTree>
     <p:extLst>
       <p:ext uri="{BB962C8B-B14F-4D97-AF65-F5344CB8AC3E}">
-        <p14:creationId xmlns:p14="http://schemas.microsoft.com/office/powerpoint/2010/main" val="1682079328"/>
+        <p14:creationId xmlns:p14="http://schemas.microsoft.com/office/powerpoint/2010/main" val="860348387"/>
       </p:ext>
     </p:extLst>
   </p:cSld>
@@ -10174,7 +10174,7 @@
           <p:cNvPr id="11" name="">
             <a:extLst xmlns:a="http://schemas.openxmlformats.org/drawingml/2006/main">
               <a:ext uri="{FF2B5EF4-FFF2-40B4-BE49-F238E27FC236}">
-                <a16:creationId xmlns:a16="http://schemas.microsoft.com/office/drawing/2014/main" id="{B924713A-73AD-43E7-9CF0-8C5EA14194A5}"/>
+                <a16:creationId xmlns:a16="http://schemas.microsoft.com/office/drawing/2014/main" id="{01711DB4-0E01-476E-A44F-633A975B9AAA}"/>
               </a:ext>
             </a:extLst>
           </p:cNvPr>
@@ -10205,7 +10205,7 @@
           <p:cNvPr id="2" name="">
             <a:extLst xmlns:a="http://schemas.openxmlformats.org/drawingml/2006/main">
               <a:ext uri="{FF2B5EF4-FFF2-40B4-BE49-F238E27FC236}">
-                <a16:creationId xmlns:a16="http://schemas.microsoft.com/office/drawing/2014/main" id="{0F169712-D21E-4DB7-8165-698CFC8D2B25}"/>
+                <a16:creationId xmlns:a16="http://schemas.microsoft.com/office/drawing/2014/main" id="{018073B7-BCBB-4B55-8550-EFD10A5E8503}"/>
               </a:ext>
             </a:extLst>
           </p:cNvPr>
@@ -10267,7 +10267,7 @@
           <p:cNvPr id="3" name="">
             <a:extLst xmlns:a="http://schemas.openxmlformats.org/drawingml/2006/main">
               <a:ext uri="{FF2B5EF4-FFF2-40B4-BE49-F238E27FC236}">
-                <a16:creationId xmlns:a16="http://schemas.microsoft.com/office/drawing/2014/main" id="{4C448397-9942-4A33-8116-EE67F714ACA3}"/>
+                <a16:creationId xmlns:a16="http://schemas.microsoft.com/office/drawing/2014/main" id="{ABE681CE-6D43-4BFA-BFA9-748558B162B9}"/>
               </a:ext>
             </a:extLst>
           </p:cNvPr>
@@ -10356,7 +10356,7 @@
           <p:cNvPr id="4" name="">
             <a:extLst xmlns:a="http://schemas.openxmlformats.org/drawingml/2006/main">
               <a:ext uri="{FF2B5EF4-FFF2-40B4-BE49-F238E27FC236}">
-                <a16:creationId xmlns:a16="http://schemas.microsoft.com/office/drawing/2014/main" id="{A82D380F-7EE3-41DE-8308-8002242E7771}"/>
+                <a16:creationId xmlns:a16="http://schemas.microsoft.com/office/drawing/2014/main" id="{D65DC250-451F-4720-B87F-13BC511E242F}"/>
               </a:ext>
             </a:extLst>
           </p:cNvPr>
@@ -10418,7 +10418,7 @@
           <p:cNvPr id="5" name="">
             <a:extLst xmlns:a="http://schemas.openxmlformats.org/drawingml/2006/main">
               <a:ext uri="{FF2B5EF4-FFF2-40B4-BE49-F238E27FC236}">
-                <a16:creationId xmlns:a16="http://schemas.microsoft.com/office/drawing/2014/main" id="{381D8815-F476-4416-8DDC-26E0619B3347}"/>
+                <a16:creationId xmlns:a16="http://schemas.microsoft.com/office/drawing/2014/main" id="{33A251E9-37A5-4AA5-8EA4-C9158AB6DFFE}"/>
               </a:ext>
             </a:extLst>
           </p:cNvPr>
@@ -10451,7 +10451,7 @@
           <p:cNvPr id="6" name="">
             <a:extLst xmlns:a="http://schemas.openxmlformats.org/drawingml/2006/main">
               <a:ext uri="{FF2B5EF4-FFF2-40B4-BE49-F238E27FC236}">
-                <a16:creationId xmlns:a16="http://schemas.microsoft.com/office/drawing/2014/main" id="{25FD56AB-E600-4489-9EED-BB70481D9C0E}"/>
+                <a16:creationId xmlns:a16="http://schemas.microsoft.com/office/drawing/2014/main" id="{B10C0217-D7BF-4E13-A615-75D32DB5FCD6}"/>
               </a:ext>
             </a:extLst>
           </p:cNvPr>
@@ -10513,7 +10513,7 @@
           <p:cNvPr id="7" name="">
             <a:extLst xmlns:a="http://schemas.openxmlformats.org/drawingml/2006/main">
               <a:ext uri="{FF2B5EF4-FFF2-40B4-BE49-F238E27FC236}">
-                <a16:creationId xmlns:a16="http://schemas.microsoft.com/office/drawing/2014/main" id="{555A8734-746D-41D0-9443-2B9ADD363F55}"/>
+                <a16:creationId xmlns:a16="http://schemas.microsoft.com/office/drawing/2014/main" id="{28FBD3CF-FE4D-445B-B5B3-0AEC239493CE}"/>
               </a:ext>
             </a:extLst>
           </p:cNvPr>
@@ -10575,7 +10575,7 @@
           <p:cNvPr id="8" name="">
             <a:extLst xmlns:a="http://schemas.openxmlformats.org/drawingml/2006/main">
               <a:ext uri="{FF2B5EF4-FFF2-40B4-BE49-F238E27FC236}">
-                <a16:creationId xmlns:a16="http://schemas.microsoft.com/office/drawing/2014/main" id="{9181F49E-1678-4FC2-A394-426A0D2D3CD4}"/>
+                <a16:creationId xmlns:a16="http://schemas.microsoft.com/office/drawing/2014/main" id="{FEAD74D4-3BF0-4BFD-A04A-1631DD96EEEB}"/>
               </a:ext>
             </a:extLst>
           </p:cNvPr>
@@ -10664,7 +10664,7 @@
           <p:cNvPr id="9" name="">
             <a:extLst xmlns:a="http://schemas.openxmlformats.org/drawingml/2006/main">
               <a:ext uri="{FF2B5EF4-FFF2-40B4-BE49-F238E27FC236}">
-                <a16:creationId xmlns:a16="http://schemas.microsoft.com/office/drawing/2014/main" id="{30765B22-F285-4463-A059-C11DD8B5105F}"/>
+                <a16:creationId xmlns:a16="http://schemas.microsoft.com/office/drawing/2014/main" id="{2ACCE40E-336E-4B7A-8A70-9E6B70B1B305}"/>
               </a:ext>
             </a:extLst>
           </p:cNvPr>
@@ -10726,7 +10726,7 @@
           <p:cNvPr id="10" name="">
             <a:extLst xmlns:a="http://schemas.openxmlformats.org/drawingml/2006/main">
               <a:ext uri="{FF2B5EF4-FFF2-40B4-BE49-F238E27FC236}">
-                <a16:creationId xmlns:a16="http://schemas.microsoft.com/office/drawing/2014/main" id="{58D77815-AC66-489A-8A46-8379948AFB35}"/>
+                <a16:creationId xmlns:a16="http://schemas.microsoft.com/office/drawing/2014/main" id="{4305A543-2349-452D-887A-768994AF3CD4}"/>
               </a:ext>
             </a:extLst>
           </p:cNvPr>
@@ -10786,7 +10786,7 @@
     </p:spTree>
     <p:extLst>
       <p:ext uri="{BB962C8B-B14F-4D97-AF65-F5344CB8AC3E}">
-        <p14:creationId xmlns:p14="http://schemas.microsoft.com/office/powerpoint/2010/main" val="715077152"/>
+        <p14:creationId xmlns:p14="http://schemas.microsoft.com/office/powerpoint/2010/main" val="1281975391"/>
       </p:ext>
     </p:extLst>
   </p:cSld>
@@ -10814,10 +10814,10 @@
       </p:grpSpPr>
       <p:sp>
         <p:nvSpPr>
-          <p:cNvPr id="22" name="side-accent-17">
-            <a:extLst xmlns:a="http://schemas.openxmlformats.org/drawingml/2006/main">
-              <a:ext uri="{FF2B5EF4-FFF2-40B4-BE49-F238E27FC236}">
-                <a16:creationId xmlns:a16="http://schemas.microsoft.com/office/drawing/2014/main" id="{08D665F1-F37A-475E-895C-C0BFB866E59E}"/>
+          <p:cNvPr id="23" name="side-accent-17">
+            <a:extLst xmlns:a="http://schemas.openxmlformats.org/drawingml/2006/main">
+              <a:ext uri="{FF2B5EF4-FFF2-40B4-BE49-F238E27FC236}">
+                <a16:creationId xmlns:a16="http://schemas.microsoft.com/office/drawing/2014/main" id="{27D542DB-9A7E-44C9-9AF1-36F2B9759E2A}"/>
               </a:ext>
             </a:extLst>
           </p:cNvPr>
@@ -10848,7 +10848,7 @@
           <p:cNvPr id="2" name="kicker-17">
             <a:extLst xmlns:a="http://schemas.openxmlformats.org/drawingml/2006/main">
               <a:ext uri="{FF2B5EF4-FFF2-40B4-BE49-F238E27FC236}">
-                <a16:creationId xmlns:a16="http://schemas.microsoft.com/office/drawing/2014/main" id="{5F421105-1FA4-48A6-8D1B-EAB50F27896E}"/>
+                <a16:creationId xmlns:a16="http://schemas.microsoft.com/office/drawing/2014/main" id="{FD9873F2-5A08-4110-9BA6-1D329F092BE1}"/>
               </a:ext>
             </a:extLst>
           </p:cNvPr>
@@ -10910,7 +10910,7 @@
           <p:cNvPr id="3" name="title-17">
             <a:extLst xmlns:a="http://schemas.openxmlformats.org/drawingml/2006/main">
               <a:ext uri="{FF2B5EF4-FFF2-40B4-BE49-F238E27FC236}">
-                <a16:creationId xmlns:a16="http://schemas.microsoft.com/office/drawing/2014/main" id="{3A64DB9E-046E-447E-B99D-7D27E33E6348}"/>
+                <a16:creationId xmlns:a16="http://schemas.microsoft.com/office/drawing/2014/main" id="{C2AB776D-81CF-401D-B397-D9EC5A5AFE67}"/>
               </a:ext>
             </a:extLst>
           </p:cNvPr>
@@ -10972,19 +10972,19 @@
           <p:cNvPr id="4" name="">
             <a:extLst xmlns:a="http://schemas.openxmlformats.org/drawingml/2006/main">
               <a:ext uri="{FF2B5EF4-FFF2-40B4-BE49-F238E27FC236}">
-                <a16:creationId xmlns:a16="http://schemas.microsoft.com/office/drawing/2014/main" id="{52A94B8E-148F-416A-8F50-0BEB46785C74}"/>
-              </a:ext>
-            </a:extLst>
-          </p:cNvPr>
-          <p:cNvSpPr>
-            <a:spLocks xmlns:a="http://schemas.openxmlformats.org/drawingml/2006/main" noGrp="1"/>
-          </p:cNvSpPr>
-          <p:nvPr/>
-        </p:nvSpPr>
-        <p:spPr>
-          <a:xfrm xmlns:a="http://schemas.openxmlformats.org/drawingml/2006/main">
-            <a:off x="609600" y="1847850"/>
-            <a:ext cx="8382000" cy="361950"/>
+                <a16:creationId xmlns:a16="http://schemas.microsoft.com/office/drawing/2014/main" id="{7092EA7E-7AAB-4619-8A35-6E879DC4A342}"/>
+              </a:ext>
+            </a:extLst>
+          </p:cNvPr>
+          <p:cNvSpPr>
+            <a:spLocks xmlns:a="http://schemas.openxmlformats.org/drawingml/2006/main" noGrp="1"/>
+          </p:cNvSpPr>
+          <p:nvPr/>
+        </p:nvSpPr>
+        <p:spPr>
+          <a:xfrm xmlns:a="http://schemas.openxmlformats.org/drawingml/2006/main">
+            <a:off x="609600" y="1695450"/>
+            <a:ext cx="10972800" cy="533400"/>
           </a:xfrm>
           <a:prstGeom xmlns:a="http://schemas.openxmlformats.org/drawingml/2006/main" prst="rect">
             <a:avLst/>
@@ -11006,7 +11006,7 @@
                 <a:spcPct val="100000"/>
               </a:lnSpc>
               <a:buNone/>
-              <a:defRPr sz="1725" b="0">
+              <a:defRPr sz="1575" b="0">
                 <a:solidFill>
                   <a:srgbClr val="61758A"/>
                 </a:solidFill>
@@ -11016,7 +11016,7 @@
               </a:defRPr>
             </a:pPr>
             <a:r>
-              <a:rPr sz="1725" b="0">
+              <a:rPr sz="1575" b="0">
                 <a:solidFill>
                   <a:srgbClr val="61758A"/>
                 </a:solidFill>
@@ -11024,7 +11024,34 @@
                 <a:ea typeface="Tahoma"/>
                 <a:cs typeface="Tahoma"/>
               </a:rPr>
-              <a:t>ทำตามลำดับ แล้วเรียกวิทยากรตรวจเมื่อครบ</a:t>
+              <a:t>ลิงก์นี้ใช้สำหรับทดสอบระบบ เมื่อทุกท่านตรวจสอบแล้วและไม่มีข้อเสนอให้ปรับแก้</a:t>
+            </a:r>
+          </a:p>
+          <a:p xmlns:a="http://schemas.openxmlformats.org/drawingml/2006/main">
+            <a:pPr algn="l">
+              <a:lnSpc>
+                <a:spcPct val="100000"/>
+              </a:lnSpc>
+              <a:buNone/>
+              <a:defRPr sz="1575" b="0">
+                <a:solidFill>
+                  <a:srgbClr val="61758A"/>
+                </a:solidFill>
+                <a:latin typeface="Tahoma"/>
+                <a:ea typeface="Tahoma"/>
+                <a:cs typeface="Tahoma"/>
+              </a:defRPr>
+            </a:pPr>
+            <a:r>
+              <a:rPr sz="1575" b="0">
+                <a:solidFill>
+                  <a:srgbClr val="61758A"/>
+                </a:solidFill>
+                <a:latin typeface="Tahoma"/>
+                <a:ea typeface="Tahoma"/>
+                <a:cs typeface="Tahoma"/>
+              </a:rPr>
+              <a:t>ทีมงานจะนำระบบไปติดตั้งบนเซิร์ฟเวอร์ของคณะทันทีครับ</a:t>
             </a:r>
           </a:p>
         </p:txBody>
@@ -11034,18 +11061,81 @@
           <p:cNvPr id="5" name="">
             <a:extLst xmlns:a="http://schemas.openxmlformats.org/drawingml/2006/main">
               <a:ext uri="{FF2B5EF4-FFF2-40B4-BE49-F238E27FC236}">
-                <a16:creationId xmlns:a16="http://schemas.microsoft.com/office/drawing/2014/main" id="{982AF829-73E9-4B18-AE73-6F809A94CC89}"/>
-              </a:ext>
-            </a:extLst>
-          </p:cNvPr>
-          <p:cNvSpPr>
-            <a:spLocks xmlns:a="http://schemas.openxmlformats.org/drawingml/2006/main" noGrp="1"/>
-          </p:cNvSpPr>
-          <p:nvPr/>
-        </p:nvSpPr>
-        <p:spPr>
-          <a:xfrm xmlns:a="http://schemas.openxmlformats.org/drawingml/2006/main">
-            <a:off x="609600" y="2724150"/>
+                <a16:creationId xmlns:a16="http://schemas.microsoft.com/office/drawing/2014/main" id="{300C3FB9-6F7A-43E7-911F-38DDAEB3C71D}"/>
+              </a:ext>
+            </a:extLst>
+          </p:cNvPr>
+          <p:cNvSpPr>
+            <a:spLocks xmlns:a="http://schemas.openxmlformats.org/drawingml/2006/main" noGrp="1"/>
+          </p:cNvSpPr>
+          <p:nvPr/>
+        </p:nvSpPr>
+        <p:spPr>
+          <a:xfrm xmlns:a="http://schemas.openxmlformats.org/drawingml/2006/main">
+            <a:off x="609600" y="2247900"/>
+            <a:ext cx="6858000" cy="400050"/>
+          </a:xfrm>
+          <a:prstGeom xmlns:a="http://schemas.openxmlformats.org/drawingml/2006/main" prst="rect">
+            <a:avLst/>
+          </a:prstGeom>
+          <a:noFill xmlns:a="http://schemas.openxmlformats.org/drawingml/2006/main"/>
+          <a:ln xmlns:a="http://schemas.openxmlformats.org/drawingml/2006/main" w="0">
+            <a:noFill/>
+            <a:prstDash val="solid"/>
+          </a:ln>
+        </p:spPr>
+        <p:txBody>
+          <a:bodyPr xmlns:a="http://schemas.openxmlformats.org/drawingml/2006/main" lIns="0" tIns="0" rIns="0" bIns="0" anchor="t">
+            <a:noAutofit/>
+          </a:bodyPr>
+          <a:lstStyle xmlns:a="http://schemas.openxmlformats.org/drawingml/2006/main"/>
+          <a:p xmlns:a="http://schemas.openxmlformats.org/drawingml/2006/main">
+            <a:pPr algn="l">
+              <a:lnSpc>
+                <a:spcPct val="100000"/>
+              </a:lnSpc>
+              <a:buNone/>
+              <a:defRPr sz="2100" b="1" u="sng">
+                <a:solidFill>
+                  <a:srgbClr val="283887"/>
+                </a:solidFill>
+                <a:latin typeface="Tahoma"/>
+                <a:ea typeface="Tahoma"/>
+                <a:cs typeface="Tahoma"/>
+              </a:defRPr>
+            </a:pPr>
+            <a:r>
+              <a:rPr sz="2100" b="1" u="sng">
+                <a:solidFill>
+                  <a:srgbClr val="283887"/>
+                </a:solidFill>
+                <a:latin typeface="Tahoma"/>
+                <a:ea typeface="Tahoma"/>
+                <a:cs typeface="Tahoma"/>
+                <a:hlinkClick xmlns:r="http://schemas.openxmlformats.org/officeDocument/2006/relationships" r:id="R37ca6c9f41e44bea"/>
+              </a:rPr>
+              <a:t>http://149.28.142.186/login</a:t>
+            </a:r>
+          </a:p>
+        </p:txBody>
+      </p:sp>
+      <p:sp>
+        <p:nvSpPr>
+          <p:cNvPr id="6" name="">
+            <a:extLst xmlns:a="http://schemas.openxmlformats.org/drawingml/2006/main">
+              <a:ext uri="{FF2B5EF4-FFF2-40B4-BE49-F238E27FC236}">
+                <a16:creationId xmlns:a16="http://schemas.microsoft.com/office/drawing/2014/main" id="{403DCF46-A2A7-4D50-8767-F5C632595C53}"/>
+              </a:ext>
+            </a:extLst>
+          </p:cNvPr>
+          <p:cNvSpPr>
+            <a:spLocks xmlns:a="http://schemas.openxmlformats.org/drawingml/2006/main" noGrp="1"/>
+          </p:cNvSpPr>
+          <p:nvPr/>
+        </p:nvSpPr>
+        <p:spPr>
+          <a:xfrm xmlns:a="http://schemas.openxmlformats.org/drawingml/2006/main">
+            <a:off x="609600" y="3067050"/>
             <a:ext cx="514350" cy="514350"/>
           </a:xfrm>
           <a:prstGeom xmlns:a="http://schemas.openxmlformats.org/drawingml/2006/main" prst="ellipse">
@@ -11062,21 +11152,21 @@
       </p:sp>
       <p:sp>
         <p:nvSpPr>
-          <p:cNvPr id="6" name="">
-            <a:extLst xmlns:a="http://schemas.openxmlformats.org/drawingml/2006/main">
-              <a:ext uri="{FF2B5EF4-FFF2-40B4-BE49-F238E27FC236}">
-                <a16:creationId xmlns:a16="http://schemas.microsoft.com/office/drawing/2014/main" id="{C689FD59-9632-4797-9E1A-BED49232D742}"/>
-              </a:ext>
-            </a:extLst>
-          </p:cNvPr>
-          <p:cNvSpPr>
-            <a:spLocks xmlns:a="http://schemas.openxmlformats.org/drawingml/2006/main" noGrp="1"/>
-          </p:cNvSpPr>
-          <p:nvPr/>
-        </p:nvSpPr>
-        <p:spPr>
-          <a:xfrm xmlns:a="http://schemas.openxmlformats.org/drawingml/2006/main">
-            <a:off x="609600" y="2809875"/>
+          <p:cNvPr id="7" name="">
+            <a:extLst xmlns:a="http://schemas.openxmlformats.org/drawingml/2006/main">
+              <a:ext uri="{FF2B5EF4-FFF2-40B4-BE49-F238E27FC236}">
+                <a16:creationId xmlns:a16="http://schemas.microsoft.com/office/drawing/2014/main" id="{D202485B-B4BD-4F09-B0B3-03495ADEA4D7}"/>
+              </a:ext>
+            </a:extLst>
+          </p:cNvPr>
+          <p:cNvSpPr>
+            <a:spLocks xmlns:a="http://schemas.openxmlformats.org/drawingml/2006/main" noGrp="1"/>
+          </p:cNvSpPr>
+          <p:nvPr/>
+        </p:nvSpPr>
+        <p:spPr>
+          <a:xfrm xmlns:a="http://schemas.openxmlformats.org/drawingml/2006/main">
+            <a:off x="609600" y="3152775"/>
             <a:ext cx="514350" cy="323850"/>
           </a:xfrm>
           <a:prstGeom xmlns:a="http://schemas.openxmlformats.org/drawingml/2006/main" prst="rect">
@@ -11124,21 +11214,21 @@
       </p:sp>
       <p:sp>
         <p:nvSpPr>
-          <p:cNvPr id="7" name="">
-            <a:extLst xmlns:a="http://schemas.openxmlformats.org/drawingml/2006/main">
-              <a:ext uri="{FF2B5EF4-FFF2-40B4-BE49-F238E27FC236}">
-                <a16:creationId xmlns:a16="http://schemas.microsoft.com/office/drawing/2014/main" id="{11505D4F-B033-47C1-B525-D89217A79A98}"/>
-              </a:ext>
-            </a:extLst>
-          </p:cNvPr>
-          <p:cNvSpPr>
-            <a:spLocks xmlns:a="http://schemas.openxmlformats.org/drawingml/2006/main" noGrp="1"/>
-          </p:cNvSpPr>
-          <p:nvPr/>
-        </p:nvSpPr>
-        <p:spPr>
-          <a:xfrm xmlns:a="http://schemas.openxmlformats.org/drawingml/2006/main">
-            <a:off x="1390650" y="2705100"/>
+          <p:cNvPr id="8" name="">
+            <a:extLst xmlns:a="http://schemas.openxmlformats.org/drawingml/2006/main">
+              <a:ext uri="{FF2B5EF4-FFF2-40B4-BE49-F238E27FC236}">
+                <a16:creationId xmlns:a16="http://schemas.microsoft.com/office/drawing/2014/main" id="{E2F596FF-D1B6-4E4C-A336-DF6379CB2640}"/>
+              </a:ext>
+            </a:extLst>
+          </p:cNvPr>
+          <p:cNvSpPr>
+            <a:spLocks xmlns:a="http://schemas.openxmlformats.org/drawingml/2006/main" noGrp="1"/>
+          </p:cNvSpPr>
+          <p:nvPr/>
+        </p:nvSpPr>
+        <p:spPr>
+          <a:xfrm xmlns:a="http://schemas.openxmlformats.org/drawingml/2006/main">
+            <a:off x="1390650" y="3048000"/>
             <a:ext cx="4191000" cy="609600"/>
           </a:xfrm>
           <a:prstGeom xmlns:a="http://schemas.openxmlformats.org/drawingml/2006/main" prst="rect">
@@ -11186,21 +11276,21 @@
       </p:sp>
       <p:sp>
         <p:nvSpPr>
-          <p:cNvPr id="8" name="">
-            <a:extLst xmlns:a="http://schemas.openxmlformats.org/drawingml/2006/main">
-              <a:ext uri="{FF2B5EF4-FFF2-40B4-BE49-F238E27FC236}">
-                <a16:creationId xmlns:a16="http://schemas.microsoft.com/office/drawing/2014/main" id="{4E802DEB-A135-47CC-8BCB-C86E8F53427B}"/>
-              </a:ext>
-            </a:extLst>
-          </p:cNvPr>
-          <p:cNvSpPr>
-            <a:spLocks xmlns:a="http://schemas.openxmlformats.org/drawingml/2006/main" noGrp="1"/>
-          </p:cNvSpPr>
-          <p:nvPr/>
-        </p:nvSpPr>
-        <p:spPr>
-          <a:xfrm xmlns:a="http://schemas.openxmlformats.org/drawingml/2006/main">
-            <a:off x="6096000" y="2724150"/>
+          <p:cNvPr id="9" name="">
+            <a:extLst xmlns:a="http://schemas.openxmlformats.org/drawingml/2006/main">
+              <a:ext uri="{FF2B5EF4-FFF2-40B4-BE49-F238E27FC236}">
+                <a16:creationId xmlns:a16="http://schemas.microsoft.com/office/drawing/2014/main" id="{C5290F3A-BEDC-467E-88E5-80BF3ABC0028}"/>
+              </a:ext>
+            </a:extLst>
+          </p:cNvPr>
+          <p:cNvSpPr>
+            <a:spLocks xmlns:a="http://schemas.openxmlformats.org/drawingml/2006/main" noGrp="1"/>
+          </p:cNvSpPr>
+          <p:nvPr/>
+        </p:nvSpPr>
+        <p:spPr>
+          <a:xfrm xmlns:a="http://schemas.openxmlformats.org/drawingml/2006/main">
+            <a:off x="6096000" y="3067050"/>
             <a:ext cx="514350" cy="514350"/>
           </a:xfrm>
           <a:prstGeom xmlns:a="http://schemas.openxmlformats.org/drawingml/2006/main" prst="ellipse">
@@ -11217,21 +11307,21 @@
       </p:sp>
       <p:sp>
         <p:nvSpPr>
-          <p:cNvPr id="9" name="">
-            <a:extLst xmlns:a="http://schemas.openxmlformats.org/drawingml/2006/main">
-              <a:ext uri="{FF2B5EF4-FFF2-40B4-BE49-F238E27FC236}">
-                <a16:creationId xmlns:a16="http://schemas.microsoft.com/office/drawing/2014/main" id="{6288EACA-9935-43E7-B74E-6F3110B5499B}"/>
-              </a:ext>
-            </a:extLst>
-          </p:cNvPr>
-          <p:cNvSpPr>
-            <a:spLocks xmlns:a="http://schemas.openxmlformats.org/drawingml/2006/main" noGrp="1"/>
-          </p:cNvSpPr>
-          <p:nvPr/>
-        </p:nvSpPr>
-        <p:spPr>
-          <a:xfrm xmlns:a="http://schemas.openxmlformats.org/drawingml/2006/main">
-            <a:off x="6096000" y="2809875"/>
+          <p:cNvPr id="10" name="">
+            <a:extLst xmlns:a="http://schemas.openxmlformats.org/drawingml/2006/main">
+              <a:ext uri="{FF2B5EF4-FFF2-40B4-BE49-F238E27FC236}">
+                <a16:creationId xmlns:a16="http://schemas.microsoft.com/office/drawing/2014/main" id="{912CEBDB-3999-4264-9F7F-427A238D7A62}"/>
+              </a:ext>
+            </a:extLst>
+          </p:cNvPr>
+          <p:cNvSpPr>
+            <a:spLocks xmlns:a="http://schemas.openxmlformats.org/drawingml/2006/main" noGrp="1"/>
+          </p:cNvSpPr>
+          <p:nvPr/>
+        </p:nvSpPr>
+        <p:spPr>
+          <a:xfrm xmlns:a="http://schemas.openxmlformats.org/drawingml/2006/main">
+            <a:off x="6096000" y="3152775"/>
             <a:ext cx="514350" cy="323850"/>
           </a:xfrm>
           <a:prstGeom xmlns:a="http://schemas.openxmlformats.org/drawingml/2006/main" prst="rect">
@@ -11279,21 +11369,21 @@
       </p:sp>
       <p:sp>
         <p:nvSpPr>
-          <p:cNvPr id="10" name="">
-            <a:extLst xmlns:a="http://schemas.openxmlformats.org/drawingml/2006/main">
-              <a:ext uri="{FF2B5EF4-FFF2-40B4-BE49-F238E27FC236}">
-                <a16:creationId xmlns:a16="http://schemas.microsoft.com/office/drawing/2014/main" id="{15243BE1-A7CA-48EB-9369-E4AFBC24E330}"/>
-              </a:ext>
-            </a:extLst>
-          </p:cNvPr>
-          <p:cNvSpPr>
-            <a:spLocks xmlns:a="http://schemas.openxmlformats.org/drawingml/2006/main" noGrp="1"/>
-          </p:cNvSpPr>
-          <p:nvPr/>
-        </p:nvSpPr>
-        <p:spPr>
-          <a:xfrm xmlns:a="http://schemas.openxmlformats.org/drawingml/2006/main">
-            <a:off x="6877050" y="2705100"/>
+          <p:cNvPr id="11" name="">
+            <a:extLst xmlns:a="http://schemas.openxmlformats.org/drawingml/2006/main">
+              <a:ext uri="{FF2B5EF4-FFF2-40B4-BE49-F238E27FC236}">
+                <a16:creationId xmlns:a16="http://schemas.microsoft.com/office/drawing/2014/main" id="{DF904F06-6E44-4632-B80D-0893A727B4F4}"/>
+              </a:ext>
+            </a:extLst>
+          </p:cNvPr>
+          <p:cNvSpPr>
+            <a:spLocks xmlns:a="http://schemas.openxmlformats.org/drawingml/2006/main" noGrp="1"/>
+          </p:cNvSpPr>
+          <p:nvPr/>
+        </p:nvSpPr>
+        <p:spPr>
+          <a:xfrm xmlns:a="http://schemas.openxmlformats.org/drawingml/2006/main">
+            <a:off x="6877050" y="3048000"/>
             <a:ext cx="4191000" cy="609600"/>
           </a:xfrm>
           <a:prstGeom xmlns:a="http://schemas.openxmlformats.org/drawingml/2006/main" prst="rect">
@@ -11341,21 +11431,21 @@
       </p:sp>
       <p:sp>
         <p:nvSpPr>
-          <p:cNvPr id="11" name="">
-            <a:extLst xmlns:a="http://schemas.openxmlformats.org/drawingml/2006/main">
-              <a:ext uri="{FF2B5EF4-FFF2-40B4-BE49-F238E27FC236}">
-                <a16:creationId xmlns:a16="http://schemas.microsoft.com/office/drawing/2014/main" id="{DD725286-AAEA-4931-8007-870794E7FF5E}"/>
-              </a:ext>
-            </a:extLst>
-          </p:cNvPr>
-          <p:cNvSpPr>
-            <a:spLocks xmlns:a="http://schemas.openxmlformats.org/drawingml/2006/main" noGrp="1"/>
-          </p:cNvSpPr>
-          <p:nvPr/>
-        </p:nvSpPr>
-        <p:spPr>
-          <a:xfrm xmlns:a="http://schemas.openxmlformats.org/drawingml/2006/main">
-            <a:off x="609600" y="3924300"/>
+          <p:cNvPr id="12" name="">
+            <a:extLst xmlns:a="http://schemas.openxmlformats.org/drawingml/2006/main">
+              <a:ext uri="{FF2B5EF4-FFF2-40B4-BE49-F238E27FC236}">
+                <a16:creationId xmlns:a16="http://schemas.microsoft.com/office/drawing/2014/main" id="{EB13EEED-9DB7-40D1-9D05-B76145421E0C}"/>
+              </a:ext>
+            </a:extLst>
+          </p:cNvPr>
+          <p:cNvSpPr>
+            <a:spLocks xmlns:a="http://schemas.openxmlformats.org/drawingml/2006/main" noGrp="1"/>
+          </p:cNvSpPr>
+          <p:nvPr/>
+        </p:nvSpPr>
+        <p:spPr>
+          <a:xfrm xmlns:a="http://schemas.openxmlformats.org/drawingml/2006/main">
+            <a:off x="609600" y="4133850"/>
             <a:ext cx="514350" cy="514350"/>
           </a:xfrm>
           <a:prstGeom xmlns:a="http://schemas.openxmlformats.org/drawingml/2006/main" prst="ellipse">
@@ -11372,21 +11462,21 @@
       </p:sp>
       <p:sp>
         <p:nvSpPr>
-          <p:cNvPr id="12" name="">
-            <a:extLst xmlns:a="http://schemas.openxmlformats.org/drawingml/2006/main">
-              <a:ext uri="{FF2B5EF4-FFF2-40B4-BE49-F238E27FC236}">
-                <a16:creationId xmlns:a16="http://schemas.microsoft.com/office/drawing/2014/main" id="{F979C8E3-A650-4A29-BC67-893907F03F3C}"/>
-              </a:ext>
-            </a:extLst>
-          </p:cNvPr>
-          <p:cNvSpPr>
-            <a:spLocks xmlns:a="http://schemas.openxmlformats.org/drawingml/2006/main" noGrp="1"/>
-          </p:cNvSpPr>
-          <p:nvPr/>
-        </p:nvSpPr>
-        <p:spPr>
-          <a:xfrm xmlns:a="http://schemas.openxmlformats.org/drawingml/2006/main">
-            <a:off x="609600" y="4010025"/>
+          <p:cNvPr id="13" name="">
+            <a:extLst xmlns:a="http://schemas.openxmlformats.org/drawingml/2006/main">
+              <a:ext uri="{FF2B5EF4-FFF2-40B4-BE49-F238E27FC236}">
+                <a16:creationId xmlns:a16="http://schemas.microsoft.com/office/drawing/2014/main" id="{09357445-3358-439B-92BB-597ACD99AA67}"/>
+              </a:ext>
+            </a:extLst>
+          </p:cNvPr>
+          <p:cNvSpPr>
+            <a:spLocks xmlns:a="http://schemas.openxmlformats.org/drawingml/2006/main" noGrp="1"/>
+          </p:cNvSpPr>
+          <p:nvPr/>
+        </p:nvSpPr>
+        <p:spPr>
+          <a:xfrm xmlns:a="http://schemas.openxmlformats.org/drawingml/2006/main">
+            <a:off x="609600" y="4219575"/>
             <a:ext cx="514350" cy="323850"/>
           </a:xfrm>
           <a:prstGeom xmlns:a="http://schemas.openxmlformats.org/drawingml/2006/main" prst="rect">
@@ -11434,21 +11524,21 @@
       </p:sp>
       <p:sp>
         <p:nvSpPr>
-          <p:cNvPr id="13" name="">
-            <a:extLst xmlns:a="http://schemas.openxmlformats.org/drawingml/2006/main">
-              <a:ext uri="{FF2B5EF4-FFF2-40B4-BE49-F238E27FC236}">
-                <a16:creationId xmlns:a16="http://schemas.microsoft.com/office/drawing/2014/main" id="{8BFF7EC0-3DB3-403E-95A4-0DE4852756CA}"/>
-              </a:ext>
-            </a:extLst>
-          </p:cNvPr>
-          <p:cNvSpPr>
-            <a:spLocks xmlns:a="http://schemas.openxmlformats.org/drawingml/2006/main" noGrp="1"/>
-          </p:cNvSpPr>
-          <p:nvPr/>
-        </p:nvSpPr>
-        <p:spPr>
-          <a:xfrm xmlns:a="http://schemas.openxmlformats.org/drawingml/2006/main">
-            <a:off x="1390650" y="3905250"/>
+          <p:cNvPr id="14" name="">
+            <a:extLst xmlns:a="http://schemas.openxmlformats.org/drawingml/2006/main">
+              <a:ext uri="{FF2B5EF4-FFF2-40B4-BE49-F238E27FC236}">
+                <a16:creationId xmlns:a16="http://schemas.microsoft.com/office/drawing/2014/main" id="{EB94BE04-E23C-4DA5-81CD-D487AF154304}"/>
+              </a:ext>
+            </a:extLst>
+          </p:cNvPr>
+          <p:cNvSpPr>
+            <a:spLocks xmlns:a="http://schemas.openxmlformats.org/drawingml/2006/main" noGrp="1"/>
+          </p:cNvSpPr>
+          <p:nvPr/>
+        </p:nvSpPr>
+        <p:spPr>
+          <a:xfrm xmlns:a="http://schemas.openxmlformats.org/drawingml/2006/main">
+            <a:off x="1390650" y="4114800"/>
             <a:ext cx="4191000" cy="609600"/>
           </a:xfrm>
           <a:prstGeom xmlns:a="http://schemas.openxmlformats.org/drawingml/2006/main" prst="rect">
@@ -11496,21 +11586,21 @@
       </p:sp>
       <p:sp>
         <p:nvSpPr>
-          <p:cNvPr id="14" name="">
-            <a:extLst xmlns:a="http://schemas.openxmlformats.org/drawingml/2006/main">
-              <a:ext uri="{FF2B5EF4-FFF2-40B4-BE49-F238E27FC236}">
-                <a16:creationId xmlns:a16="http://schemas.microsoft.com/office/drawing/2014/main" id="{91DF9493-CE1D-4EFD-9EBE-6CEADF58B878}"/>
-              </a:ext>
-            </a:extLst>
-          </p:cNvPr>
-          <p:cNvSpPr>
-            <a:spLocks xmlns:a="http://schemas.openxmlformats.org/drawingml/2006/main" noGrp="1"/>
-          </p:cNvSpPr>
-          <p:nvPr/>
-        </p:nvSpPr>
-        <p:spPr>
-          <a:xfrm xmlns:a="http://schemas.openxmlformats.org/drawingml/2006/main">
-            <a:off x="6096000" y="3924300"/>
+          <p:cNvPr id="15" name="">
+            <a:extLst xmlns:a="http://schemas.openxmlformats.org/drawingml/2006/main">
+              <a:ext uri="{FF2B5EF4-FFF2-40B4-BE49-F238E27FC236}">
+                <a16:creationId xmlns:a16="http://schemas.microsoft.com/office/drawing/2014/main" id="{7A25BC65-62FF-41E7-B914-54568CDF7821}"/>
+              </a:ext>
+            </a:extLst>
+          </p:cNvPr>
+          <p:cNvSpPr>
+            <a:spLocks xmlns:a="http://schemas.openxmlformats.org/drawingml/2006/main" noGrp="1"/>
+          </p:cNvSpPr>
+          <p:nvPr/>
+        </p:nvSpPr>
+        <p:spPr>
+          <a:xfrm xmlns:a="http://schemas.openxmlformats.org/drawingml/2006/main">
+            <a:off x="6096000" y="4133850"/>
             <a:ext cx="514350" cy="514350"/>
           </a:xfrm>
           <a:prstGeom xmlns:a="http://schemas.openxmlformats.org/drawingml/2006/main" prst="ellipse">
@@ -11527,21 +11617,21 @@
       </p:sp>
       <p:sp>
         <p:nvSpPr>
-          <p:cNvPr id="15" name="">
-            <a:extLst xmlns:a="http://schemas.openxmlformats.org/drawingml/2006/main">
-              <a:ext uri="{FF2B5EF4-FFF2-40B4-BE49-F238E27FC236}">
-                <a16:creationId xmlns:a16="http://schemas.microsoft.com/office/drawing/2014/main" id="{67EEE42D-20AD-4819-8D01-E701F1F27A98}"/>
-              </a:ext>
-            </a:extLst>
-          </p:cNvPr>
-          <p:cNvSpPr>
-            <a:spLocks xmlns:a="http://schemas.openxmlformats.org/drawingml/2006/main" noGrp="1"/>
-          </p:cNvSpPr>
-          <p:nvPr/>
-        </p:nvSpPr>
-        <p:spPr>
-          <a:xfrm xmlns:a="http://schemas.openxmlformats.org/drawingml/2006/main">
-            <a:off x="6096000" y="4010025"/>
+          <p:cNvPr id="16" name="">
+            <a:extLst xmlns:a="http://schemas.openxmlformats.org/drawingml/2006/main">
+              <a:ext uri="{FF2B5EF4-FFF2-40B4-BE49-F238E27FC236}">
+                <a16:creationId xmlns:a16="http://schemas.microsoft.com/office/drawing/2014/main" id="{CB08E12C-6836-48C1-9933-C4620FF513BC}"/>
+              </a:ext>
+            </a:extLst>
+          </p:cNvPr>
+          <p:cNvSpPr>
+            <a:spLocks xmlns:a="http://schemas.openxmlformats.org/drawingml/2006/main" noGrp="1"/>
+          </p:cNvSpPr>
+          <p:nvPr/>
+        </p:nvSpPr>
+        <p:spPr>
+          <a:xfrm xmlns:a="http://schemas.openxmlformats.org/drawingml/2006/main">
+            <a:off x="6096000" y="4219575"/>
             <a:ext cx="514350" cy="323850"/>
           </a:xfrm>
           <a:prstGeom xmlns:a="http://schemas.openxmlformats.org/drawingml/2006/main" prst="rect">
@@ -11589,21 +11679,21 @@
       </p:sp>
       <p:sp>
         <p:nvSpPr>
-          <p:cNvPr id="16" name="">
-            <a:extLst xmlns:a="http://schemas.openxmlformats.org/drawingml/2006/main">
-              <a:ext uri="{FF2B5EF4-FFF2-40B4-BE49-F238E27FC236}">
-                <a16:creationId xmlns:a16="http://schemas.microsoft.com/office/drawing/2014/main" id="{3C6DD5E6-9743-4EC4-A62E-58EE9BCABD82}"/>
-              </a:ext>
-            </a:extLst>
-          </p:cNvPr>
-          <p:cNvSpPr>
-            <a:spLocks xmlns:a="http://schemas.openxmlformats.org/drawingml/2006/main" noGrp="1"/>
-          </p:cNvSpPr>
-          <p:nvPr/>
-        </p:nvSpPr>
-        <p:spPr>
-          <a:xfrm xmlns:a="http://schemas.openxmlformats.org/drawingml/2006/main">
-            <a:off x="6877050" y="3905250"/>
+          <p:cNvPr id="17" name="">
+            <a:extLst xmlns:a="http://schemas.openxmlformats.org/drawingml/2006/main">
+              <a:ext uri="{FF2B5EF4-FFF2-40B4-BE49-F238E27FC236}">
+                <a16:creationId xmlns:a16="http://schemas.microsoft.com/office/drawing/2014/main" id="{DF7DF842-B29C-45F9-A179-60BBC456A7CF}"/>
+              </a:ext>
+            </a:extLst>
+          </p:cNvPr>
+          <p:cNvSpPr>
+            <a:spLocks xmlns:a="http://schemas.openxmlformats.org/drawingml/2006/main" noGrp="1"/>
+          </p:cNvSpPr>
+          <p:nvPr/>
+        </p:nvSpPr>
+        <p:spPr>
+          <a:xfrm xmlns:a="http://schemas.openxmlformats.org/drawingml/2006/main">
+            <a:off x="6877050" y="4114800"/>
             <a:ext cx="4191000" cy="609600"/>
           </a:xfrm>
           <a:prstGeom xmlns:a="http://schemas.openxmlformats.org/drawingml/2006/main" prst="rect">
@@ -11651,10 +11741,10 @@
       </p:sp>
       <p:sp>
         <p:nvSpPr>
-          <p:cNvPr id="17" name="">
-            <a:extLst xmlns:a="http://schemas.openxmlformats.org/drawingml/2006/main">
-              <a:ext uri="{FF2B5EF4-FFF2-40B4-BE49-F238E27FC236}">
-                <a16:creationId xmlns:a16="http://schemas.microsoft.com/office/drawing/2014/main" id="{960B14C6-0548-40E9-B66E-EBA7E9331233}"/>
+          <p:cNvPr id="18" name="">
+            <a:extLst xmlns:a="http://schemas.openxmlformats.org/drawingml/2006/main">
+              <a:ext uri="{FF2B5EF4-FFF2-40B4-BE49-F238E27FC236}">
+                <a16:creationId xmlns:a16="http://schemas.microsoft.com/office/drawing/2014/main" id="{9DD4DE4C-DDDF-484B-92DE-CC7EEE79E801}"/>
               </a:ext>
             </a:extLst>
           </p:cNvPr>
@@ -11684,10 +11774,10 @@
       </p:sp>
       <p:sp>
         <p:nvSpPr>
-          <p:cNvPr id="18" name="">
-            <a:extLst xmlns:a="http://schemas.openxmlformats.org/drawingml/2006/main">
-              <a:ext uri="{FF2B5EF4-FFF2-40B4-BE49-F238E27FC236}">
-                <a16:creationId xmlns:a16="http://schemas.microsoft.com/office/drawing/2014/main" id="{3458F375-20F4-4A5E-B220-9B74E6BA3314}"/>
+          <p:cNvPr id="19" name="">
+            <a:extLst xmlns:a="http://schemas.openxmlformats.org/drawingml/2006/main">
+              <a:ext uri="{FF2B5EF4-FFF2-40B4-BE49-F238E27FC236}">
+                <a16:creationId xmlns:a16="http://schemas.microsoft.com/office/drawing/2014/main" id="{AA833DC4-8FC3-4315-8FA6-0631E4C21083}"/>
               </a:ext>
             </a:extLst>
           </p:cNvPr>
@@ -11746,10 +11836,10 @@
       </p:sp>
       <p:sp>
         <p:nvSpPr>
-          <p:cNvPr id="19" name="footer-rule-17">
-            <a:extLst xmlns:a="http://schemas.openxmlformats.org/drawingml/2006/main">
-              <a:ext uri="{FF2B5EF4-FFF2-40B4-BE49-F238E27FC236}">
-                <a16:creationId xmlns:a16="http://schemas.microsoft.com/office/drawing/2014/main" id="{41D231AD-C953-4118-B22A-4D4E42C26FDF}"/>
+          <p:cNvPr id="20" name="footer-rule-17">
+            <a:extLst xmlns:a="http://schemas.openxmlformats.org/drawingml/2006/main">
+              <a:ext uri="{FF2B5EF4-FFF2-40B4-BE49-F238E27FC236}">
+                <a16:creationId xmlns:a16="http://schemas.microsoft.com/office/drawing/2014/main" id="{0F0E61D6-18D1-44F4-A1C5-BD0428B2B571}"/>
               </a:ext>
             </a:extLst>
           </p:cNvPr>
@@ -11777,10 +11867,10 @@
       </p:sp>
       <p:sp>
         <p:nvSpPr>
-          <p:cNvPr id="20" name="footer-label-17">
-            <a:extLst xmlns:a="http://schemas.openxmlformats.org/drawingml/2006/main">
-              <a:ext uri="{FF2B5EF4-FFF2-40B4-BE49-F238E27FC236}">
-                <a16:creationId xmlns:a16="http://schemas.microsoft.com/office/drawing/2014/main" id="{03006319-02AE-48AA-8E33-74B93EFF294A}"/>
+          <p:cNvPr id="21" name="footer-label-17">
+            <a:extLst xmlns:a="http://schemas.openxmlformats.org/drawingml/2006/main">
+              <a:ext uri="{FF2B5EF4-FFF2-40B4-BE49-F238E27FC236}">
+                <a16:creationId xmlns:a16="http://schemas.microsoft.com/office/drawing/2014/main" id="{BA3A9B4B-7D8E-454A-80DA-11D6153A46DC}"/>
               </a:ext>
             </a:extLst>
           </p:cNvPr>
@@ -11839,10 +11929,10 @@
       </p:sp>
       <p:sp>
         <p:nvSpPr>
-          <p:cNvPr id="21" name="footer-page-17">
-            <a:extLst xmlns:a="http://schemas.openxmlformats.org/drawingml/2006/main">
-              <a:ext uri="{FF2B5EF4-FFF2-40B4-BE49-F238E27FC236}">
-                <a16:creationId xmlns:a16="http://schemas.microsoft.com/office/drawing/2014/main" id="{5C830F05-B761-4F8D-85F5-13536FAAD19B}"/>
+          <p:cNvPr id="22" name="footer-page-17">
+            <a:extLst xmlns:a="http://schemas.openxmlformats.org/drawingml/2006/main">
+              <a:ext uri="{FF2B5EF4-FFF2-40B4-BE49-F238E27FC236}">
+                <a16:creationId xmlns:a16="http://schemas.microsoft.com/office/drawing/2014/main" id="{DB5D6309-2417-400D-8177-F402800A95B6}"/>
               </a:ext>
             </a:extLst>
           </p:cNvPr>
@@ -11902,7 +11992,7 @@
     </p:spTree>
     <p:extLst>
       <p:ext uri="{BB962C8B-B14F-4D97-AF65-F5344CB8AC3E}">
-        <p14:creationId xmlns:p14="http://schemas.microsoft.com/office/powerpoint/2010/main" val="1249572360"/>
+        <p14:creationId xmlns:p14="http://schemas.microsoft.com/office/powerpoint/2010/main" val="1021470599"/>
       </p:ext>
     </p:extLst>
   </p:cSld>
@@ -11933,7 +12023,7 @@
           <p:cNvPr id="25" name="side-accent-18">
             <a:extLst xmlns:a="http://schemas.openxmlformats.org/drawingml/2006/main">
               <a:ext uri="{FF2B5EF4-FFF2-40B4-BE49-F238E27FC236}">
-                <a16:creationId xmlns:a16="http://schemas.microsoft.com/office/drawing/2014/main" id="{9C9B99F3-0244-488B-A11C-01F64B41F5F7}"/>
+                <a16:creationId xmlns:a16="http://schemas.microsoft.com/office/drawing/2014/main" id="{DC0BD7BA-F558-4D89-900D-F9C9C219F4B2}"/>
               </a:ext>
             </a:extLst>
           </p:cNvPr>
@@ -11964,7 +12054,7 @@
           <p:cNvPr id="2" name="kicker-18">
             <a:extLst xmlns:a="http://schemas.openxmlformats.org/drawingml/2006/main">
               <a:ext uri="{FF2B5EF4-FFF2-40B4-BE49-F238E27FC236}">
-                <a16:creationId xmlns:a16="http://schemas.microsoft.com/office/drawing/2014/main" id="{0CF046A1-0EFB-4571-91A1-9BF190497BFD}"/>
+                <a16:creationId xmlns:a16="http://schemas.microsoft.com/office/drawing/2014/main" id="{782EBDD5-84BF-4DFB-9358-5ED846374278}"/>
               </a:ext>
             </a:extLst>
           </p:cNvPr>
@@ -12026,7 +12116,7 @@
           <p:cNvPr id="3" name="title-18">
             <a:extLst xmlns:a="http://schemas.openxmlformats.org/drawingml/2006/main">
               <a:ext uri="{FF2B5EF4-FFF2-40B4-BE49-F238E27FC236}">
-                <a16:creationId xmlns:a16="http://schemas.microsoft.com/office/drawing/2014/main" id="{F198F0BA-AA70-46D9-955D-9F8861F94F12}"/>
+                <a16:creationId xmlns:a16="http://schemas.microsoft.com/office/drawing/2014/main" id="{405B6229-916D-4C00-8CE6-7DF5C97B455A}"/>
               </a:ext>
             </a:extLst>
           </p:cNvPr>
@@ -12088,7 +12178,7 @@
           <p:cNvPr id="4" name="">
             <a:extLst xmlns:a="http://schemas.openxmlformats.org/drawingml/2006/main">
               <a:ext uri="{FF2B5EF4-FFF2-40B4-BE49-F238E27FC236}">
-                <a16:creationId xmlns:a16="http://schemas.microsoft.com/office/drawing/2014/main" id="{21A2C036-AB94-47F9-8E71-70523C10FE0A}"/>
+                <a16:creationId xmlns:a16="http://schemas.microsoft.com/office/drawing/2014/main" id="{692E5A14-F338-48DC-92BD-6B2B20DEB893}"/>
               </a:ext>
             </a:extLst>
           </p:cNvPr>
@@ -12150,7 +12240,7 @@
           <p:cNvPr id="5" name="">
             <a:extLst xmlns:a="http://schemas.openxmlformats.org/drawingml/2006/main">
               <a:ext uri="{FF2B5EF4-FFF2-40B4-BE49-F238E27FC236}">
-                <a16:creationId xmlns:a16="http://schemas.microsoft.com/office/drawing/2014/main" id="{2BA78A1E-C900-4BAF-97EA-085CBAC0CEBE}"/>
+                <a16:creationId xmlns:a16="http://schemas.microsoft.com/office/drawing/2014/main" id="{ADC60080-3530-4C1B-A092-B96D1699DB1F}"/>
               </a:ext>
             </a:extLst>
           </p:cNvPr>
@@ -12212,7 +12302,7 @@
           <p:cNvPr id="6" name="">
             <a:extLst xmlns:a="http://schemas.openxmlformats.org/drawingml/2006/main">
               <a:ext uri="{FF2B5EF4-FFF2-40B4-BE49-F238E27FC236}">
-                <a16:creationId xmlns:a16="http://schemas.microsoft.com/office/drawing/2014/main" id="{F2526256-2636-468F-8B33-E3F93068E138}"/>
+                <a16:creationId xmlns:a16="http://schemas.microsoft.com/office/drawing/2014/main" id="{20558017-387A-4001-A4BE-4E9788B8C99E}"/>
               </a:ext>
             </a:extLst>
           </p:cNvPr>
@@ -12274,7 +12364,7 @@
           <p:cNvPr id="7" name="">
             <a:extLst xmlns:a="http://schemas.openxmlformats.org/drawingml/2006/main">
               <a:ext uri="{FF2B5EF4-FFF2-40B4-BE49-F238E27FC236}">
-                <a16:creationId xmlns:a16="http://schemas.microsoft.com/office/drawing/2014/main" id="{92DF9465-87ED-4B10-8454-F1B9750D925E}"/>
+                <a16:creationId xmlns:a16="http://schemas.microsoft.com/office/drawing/2014/main" id="{C7A692C4-55C1-4762-9AAE-D112A39EC4B0}"/>
               </a:ext>
             </a:extLst>
           </p:cNvPr>
@@ -12305,7 +12395,7 @@
           <p:cNvPr id="8" name="">
             <a:extLst xmlns:a="http://schemas.openxmlformats.org/drawingml/2006/main">
               <a:ext uri="{FF2B5EF4-FFF2-40B4-BE49-F238E27FC236}">
-                <a16:creationId xmlns:a16="http://schemas.microsoft.com/office/drawing/2014/main" id="{0651EB3B-2331-49D9-A775-F1CDD86186E5}"/>
+                <a16:creationId xmlns:a16="http://schemas.microsoft.com/office/drawing/2014/main" id="{6F7F0283-E35A-4C10-8512-BD7307BF3A6C}"/>
               </a:ext>
             </a:extLst>
           </p:cNvPr>
@@ -12367,7 +12457,7 @@
           <p:cNvPr id="9" name="">
             <a:extLst xmlns:a="http://schemas.openxmlformats.org/drawingml/2006/main">
               <a:ext uri="{FF2B5EF4-FFF2-40B4-BE49-F238E27FC236}">
-                <a16:creationId xmlns:a16="http://schemas.microsoft.com/office/drawing/2014/main" id="{59F2E674-E36C-422A-97F3-14B1F04002E0}"/>
+                <a16:creationId xmlns:a16="http://schemas.microsoft.com/office/drawing/2014/main" id="{C582A883-C5A0-432C-9BC9-DD1DD758E4C4}"/>
               </a:ext>
             </a:extLst>
           </p:cNvPr>
@@ -12429,7 +12519,7 @@
           <p:cNvPr id="10" name="">
             <a:extLst xmlns:a="http://schemas.openxmlformats.org/drawingml/2006/main">
               <a:ext uri="{FF2B5EF4-FFF2-40B4-BE49-F238E27FC236}">
-                <a16:creationId xmlns:a16="http://schemas.microsoft.com/office/drawing/2014/main" id="{AAE6C8D4-535D-470B-9363-4B1492D76873}"/>
+                <a16:creationId xmlns:a16="http://schemas.microsoft.com/office/drawing/2014/main" id="{8527B235-DD67-413A-8996-E847BE25DAE4}"/>
               </a:ext>
             </a:extLst>
           </p:cNvPr>
@@ -12491,7 +12581,7 @@
           <p:cNvPr id="11" name="">
             <a:extLst xmlns:a="http://schemas.openxmlformats.org/drawingml/2006/main">
               <a:ext uri="{FF2B5EF4-FFF2-40B4-BE49-F238E27FC236}">
-                <a16:creationId xmlns:a16="http://schemas.microsoft.com/office/drawing/2014/main" id="{43C9E218-7F19-4F66-B7CD-EB838489ABCD}"/>
+                <a16:creationId xmlns:a16="http://schemas.microsoft.com/office/drawing/2014/main" id="{FED84521-79D9-4068-B7F4-8405D6AFDF8F}"/>
               </a:ext>
             </a:extLst>
           </p:cNvPr>
@@ -12522,7 +12612,7 @@
           <p:cNvPr id="12" name="">
             <a:extLst xmlns:a="http://schemas.openxmlformats.org/drawingml/2006/main">
               <a:ext uri="{FF2B5EF4-FFF2-40B4-BE49-F238E27FC236}">
-                <a16:creationId xmlns:a16="http://schemas.microsoft.com/office/drawing/2014/main" id="{F3AA680E-5B56-4100-B24E-6B8703B9A692}"/>
+                <a16:creationId xmlns:a16="http://schemas.microsoft.com/office/drawing/2014/main" id="{F4F34063-4BEA-46BF-AB1E-EDC2F82900D2}"/>
               </a:ext>
             </a:extLst>
           </p:cNvPr>
@@ -12584,7 +12674,7 @@
           <p:cNvPr id="13" name="">
             <a:extLst xmlns:a="http://schemas.openxmlformats.org/drawingml/2006/main">
               <a:ext uri="{FF2B5EF4-FFF2-40B4-BE49-F238E27FC236}">
-                <a16:creationId xmlns:a16="http://schemas.microsoft.com/office/drawing/2014/main" id="{93A2AB27-2DC9-470B-8970-C18A82900C21}"/>
+                <a16:creationId xmlns:a16="http://schemas.microsoft.com/office/drawing/2014/main" id="{1E41A066-9962-443D-9240-5FD157C67B66}"/>
               </a:ext>
             </a:extLst>
           </p:cNvPr>
@@ -12646,7 +12736,7 @@
           <p:cNvPr id="14" name="">
             <a:extLst xmlns:a="http://schemas.openxmlformats.org/drawingml/2006/main">
               <a:ext uri="{FF2B5EF4-FFF2-40B4-BE49-F238E27FC236}">
-                <a16:creationId xmlns:a16="http://schemas.microsoft.com/office/drawing/2014/main" id="{1475BBCF-9A28-4391-BC48-3C8D4392D485}"/>
+                <a16:creationId xmlns:a16="http://schemas.microsoft.com/office/drawing/2014/main" id="{6E7FDC6D-FC49-425A-8481-8B3D4DF8F4EB}"/>
               </a:ext>
             </a:extLst>
           </p:cNvPr>
@@ -12708,7 +12798,7 @@
           <p:cNvPr id="15" name="">
             <a:extLst xmlns:a="http://schemas.openxmlformats.org/drawingml/2006/main">
               <a:ext uri="{FF2B5EF4-FFF2-40B4-BE49-F238E27FC236}">
-                <a16:creationId xmlns:a16="http://schemas.microsoft.com/office/drawing/2014/main" id="{3CABE4D0-4E9C-456F-9783-443C7A961E79}"/>
+                <a16:creationId xmlns:a16="http://schemas.microsoft.com/office/drawing/2014/main" id="{618917BA-FB6F-4AE0-829D-9DA958E5C1AD}"/>
               </a:ext>
             </a:extLst>
           </p:cNvPr>
@@ -12739,7 +12829,7 @@
           <p:cNvPr id="16" name="">
             <a:extLst xmlns:a="http://schemas.openxmlformats.org/drawingml/2006/main">
               <a:ext uri="{FF2B5EF4-FFF2-40B4-BE49-F238E27FC236}">
-                <a16:creationId xmlns:a16="http://schemas.microsoft.com/office/drawing/2014/main" id="{1E4B5B6E-5F27-42BE-957D-2E473BA13F9F}"/>
+                <a16:creationId xmlns:a16="http://schemas.microsoft.com/office/drawing/2014/main" id="{B50D640C-FFB1-4B81-81A2-921258F9673E}"/>
               </a:ext>
             </a:extLst>
           </p:cNvPr>
@@ -12801,7 +12891,7 @@
           <p:cNvPr id="17" name="">
             <a:extLst xmlns:a="http://schemas.openxmlformats.org/drawingml/2006/main">
               <a:ext uri="{FF2B5EF4-FFF2-40B4-BE49-F238E27FC236}">
-                <a16:creationId xmlns:a16="http://schemas.microsoft.com/office/drawing/2014/main" id="{5B5937EC-6111-41EB-8F1F-66A31192EB40}"/>
+                <a16:creationId xmlns:a16="http://schemas.microsoft.com/office/drawing/2014/main" id="{538864C7-B9F2-4E49-A49B-F04CD1B9566A}"/>
               </a:ext>
             </a:extLst>
           </p:cNvPr>
@@ -12863,7 +12953,7 @@
           <p:cNvPr id="18" name="">
             <a:extLst xmlns:a="http://schemas.openxmlformats.org/drawingml/2006/main">
               <a:ext uri="{FF2B5EF4-FFF2-40B4-BE49-F238E27FC236}">
-                <a16:creationId xmlns:a16="http://schemas.microsoft.com/office/drawing/2014/main" id="{135C4414-BB40-44C5-A886-6278C6A9721E}"/>
+                <a16:creationId xmlns:a16="http://schemas.microsoft.com/office/drawing/2014/main" id="{02E0FCE5-A899-4DFA-A8B3-133CB2BE0634}"/>
               </a:ext>
             </a:extLst>
           </p:cNvPr>
@@ -12925,7 +13015,7 @@
           <p:cNvPr id="19" name="">
             <a:extLst xmlns:a="http://schemas.openxmlformats.org/drawingml/2006/main">
               <a:ext uri="{FF2B5EF4-FFF2-40B4-BE49-F238E27FC236}">
-                <a16:creationId xmlns:a16="http://schemas.microsoft.com/office/drawing/2014/main" id="{2EF2A527-4CAA-4802-A0A6-2E39241CFED6}"/>
+                <a16:creationId xmlns:a16="http://schemas.microsoft.com/office/drawing/2014/main" id="{0F1CF75A-462F-46CB-8DB2-B51DF743799E}"/>
               </a:ext>
             </a:extLst>
           </p:cNvPr>
@@ -12958,7 +13048,7 @@
           <p:cNvPr id="20" name="">
             <a:extLst xmlns:a="http://schemas.openxmlformats.org/drawingml/2006/main">
               <a:ext uri="{FF2B5EF4-FFF2-40B4-BE49-F238E27FC236}">
-                <a16:creationId xmlns:a16="http://schemas.microsoft.com/office/drawing/2014/main" id="{0BB77F0C-8884-4AB8-8940-E2C640FFD823}"/>
+                <a16:creationId xmlns:a16="http://schemas.microsoft.com/office/drawing/2014/main" id="{BB079555-1FC1-40AB-8EFC-83BE1EB86D80}"/>
               </a:ext>
             </a:extLst>
           </p:cNvPr>
@@ -13024,7 +13114,7 @@
           <p:nvPr/>
         </p:nvPicPr>
         <p:blipFill>
-          <a:blip xmlns:r="http://schemas.openxmlformats.org/officeDocument/2006/relationships" xmlns:a="http://schemas.openxmlformats.org/drawingml/2006/main" r:embed="Rf6699a90e5bc4d32"/>
+          <a:blip xmlns:r="http://schemas.openxmlformats.org/officeDocument/2006/relationships" xmlns:a="http://schemas.openxmlformats.org/drawingml/2006/main" r:embed="Rd7630af23c624370"/>
           <a:stretch xmlns:a="http://schemas.openxmlformats.org/drawingml/2006/main"/>
         </p:blipFill>
         <p:spPr>
@@ -13042,7 +13132,7 @@
           <p:cNvPr id="22" name="footer-rule-18">
             <a:extLst xmlns:a="http://schemas.openxmlformats.org/drawingml/2006/main">
               <a:ext uri="{FF2B5EF4-FFF2-40B4-BE49-F238E27FC236}">
-                <a16:creationId xmlns:a16="http://schemas.microsoft.com/office/drawing/2014/main" id="{13652DA9-2FDE-4DEC-8992-1AFC6381A5C9}"/>
+                <a16:creationId xmlns:a16="http://schemas.microsoft.com/office/drawing/2014/main" id="{8763C335-3B10-4680-9C69-10681DE2D153}"/>
               </a:ext>
             </a:extLst>
           </p:cNvPr>
@@ -13073,7 +13163,7 @@
           <p:cNvPr id="23" name="footer-label-18">
             <a:extLst xmlns:a="http://schemas.openxmlformats.org/drawingml/2006/main">
               <a:ext uri="{FF2B5EF4-FFF2-40B4-BE49-F238E27FC236}">
-                <a16:creationId xmlns:a16="http://schemas.microsoft.com/office/drawing/2014/main" id="{E57228F5-37CC-4D9E-9398-F711BF19BB9C}"/>
+                <a16:creationId xmlns:a16="http://schemas.microsoft.com/office/drawing/2014/main" id="{C6284399-3BB1-49D0-B087-BF42C9079AE6}"/>
               </a:ext>
             </a:extLst>
           </p:cNvPr>
@@ -13135,7 +13225,7 @@
           <p:cNvPr id="24" name="footer-page-18">
             <a:extLst xmlns:a="http://schemas.openxmlformats.org/drawingml/2006/main">
               <a:ext uri="{FF2B5EF4-FFF2-40B4-BE49-F238E27FC236}">
-                <a16:creationId xmlns:a16="http://schemas.microsoft.com/office/drawing/2014/main" id="{398E40EC-4A21-4391-A468-28434DB33834}"/>
+                <a16:creationId xmlns:a16="http://schemas.microsoft.com/office/drawing/2014/main" id="{2185AB8E-10B6-4261-9D08-D0E1DCC3471E}"/>
               </a:ext>
             </a:extLst>
           </p:cNvPr>
@@ -13195,7 +13285,7 @@
     </p:spTree>
     <p:extLst>
       <p:ext uri="{BB962C8B-B14F-4D97-AF65-F5344CB8AC3E}">
-        <p14:creationId xmlns:p14="http://schemas.microsoft.com/office/powerpoint/2010/main" val="381672940"/>
+        <p14:creationId xmlns:p14="http://schemas.microsoft.com/office/powerpoint/2010/main" val="2075898901"/>
       </p:ext>
     </p:extLst>
   </p:cSld>
@@ -13226,7 +13316,7 @@
           <p:cNvPr id="20" name="side-accent-2">
             <a:extLst xmlns:a="http://schemas.openxmlformats.org/drawingml/2006/main">
               <a:ext uri="{FF2B5EF4-FFF2-40B4-BE49-F238E27FC236}">
-                <a16:creationId xmlns:a16="http://schemas.microsoft.com/office/drawing/2014/main" id="{3E46C2ED-1243-4B33-808C-A2D854DE672E}"/>
+                <a16:creationId xmlns:a16="http://schemas.microsoft.com/office/drawing/2014/main" id="{338B8330-F36C-4B9E-B80B-1F0B68ACF2A9}"/>
               </a:ext>
             </a:extLst>
           </p:cNvPr>
@@ -13257,7 +13347,7 @@
           <p:cNvPr id="2" name="kicker-2">
             <a:extLst xmlns:a="http://schemas.openxmlformats.org/drawingml/2006/main">
               <a:ext uri="{FF2B5EF4-FFF2-40B4-BE49-F238E27FC236}">
-                <a16:creationId xmlns:a16="http://schemas.microsoft.com/office/drawing/2014/main" id="{29962F8D-A593-4425-B7F4-816A70DDA471}"/>
+                <a16:creationId xmlns:a16="http://schemas.microsoft.com/office/drawing/2014/main" id="{B202D29F-764D-4EEC-AE99-768485D2EA4D}"/>
               </a:ext>
             </a:extLst>
           </p:cNvPr>
@@ -13319,7 +13409,7 @@
           <p:cNvPr id="3" name="title-2">
             <a:extLst xmlns:a="http://schemas.openxmlformats.org/drawingml/2006/main">
               <a:ext uri="{FF2B5EF4-FFF2-40B4-BE49-F238E27FC236}">
-                <a16:creationId xmlns:a16="http://schemas.microsoft.com/office/drawing/2014/main" id="{BADD951F-A624-4DA8-B874-D246766366E2}"/>
+                <a16:creationId xmlns:a16="http://schemas.microsoft.com/office/drawing/2014/main" id="{1E5F87A8-227D-4B67-AB84-D1B0C268F5EC}"/>
               </a:ext>
             </a:extLst>
           </p:cNvPr>
@@ -13381,7 +13471,7 @@
           <p:cNvPr id="4" name="">
             <a:extLst xmlns:a="http://schemas.openxmlformats.org/drawingml/2006/main">
               <a:ext uri="{FF2B5EF4-FFF2-40B4-BE49-F238E27FC236}">
-                <a16:creationId xmlns:a16="http://schemas.microsoft.com/office/drawing/2014/main" id="{794305C9-7416-4C22-903C-B875811333E9}"/>
+                <a16:creationId xmlns:a16="http://schemas.microsoft.com/office/drawing/2014/main" id="{E9E90743-873E-4554-B06D-8643BE93FB1B}"/>
               </a:ext>
             </a:extLst>
           </p:cNvPr>
@@ -13443,7 +13533,7 @@
           <p:cNvPr id="5" name="">
             <a:extLst xmlns:a="http://schemas.openxmlformats.org/drawingml/2006/main">
               <a:ext uri="{FF2B5EF4-FFF2-40B4-BE49-F238E27FC236}">
-                <a16:creationId xmlns:a16="http://schemas.microsoft.com/office/drawing/2014/main" id="{A59D85AA-FD46-4E84-B7B0-DEAC31C32A72}"/>
+                <a16:creationId xmlns:a16="http://schemas.microsoft.com/office/drawing/2014/main" id="{B13A34CA-BE5B-4232-9970-9AA08ED55DE4}"/>
               </a:ext>
             </a:extLst>
           </p:cNvPr>
@@ -13505,7 +13595,7 @@
           <p:cNvPr id="6" name="">
             <a:extLst xmlns:a="http://schemas.openxmlformats.org/drawingml/2006/main">
               <a:ext uri="{FF2B5EF4-FFF2-40B4-BE49-F238E27FC236}">
-                <a16:creationId xmlns:a16="http://schemas.microsoft.com/office/drawing/2014/main" id="{2CF34A0C-5A88-4B01-A1E7-44FD7BDDBFBC}"/>
+                <a16:creationId xmlns:a16="http://schemas.microsoft.com/office/drawing/2014/main" id="{14BB841B-DD93-4732-A56F-9852F2FABF94}"/>
               </a:ext>
             </a:extLst>
           </p:cNvPr>
@@ -13536,7 +13626,7 @@
           <p:cNvPr id="7" name="">
             <a:extLst xmlns:a="http://schemas.openxmlformats.org/drawingml/2006/main">
               <a:ext uri="{FF2B5EF4-FFF2-40B4-BE49-F238E27FC236}">
-                <a16:creationId xmlns:a16="http://schemas.microsoft.com/office/drawing/2014/main" id="{427BB930-48D9-4572-A8FF-E58141678900}"/>
+                <a16:creationId xmlns:a16="http://schemas.microsoft.com/office/drawing/2014/main" id="{851A8F72-4D9A-45D2-8A0B-FA98B7245758}"/>
               </a:ext>
             </a:extLst>
           </p:cNvPr>
@@ -13598,7 +13688,7 @@
           <p:cNvPr id="8" name="">
             <a:extLst xmlns:a="http://schemas.openxmlformats.org/drawingml/2006/main">
               <a:ext uri="{FF2B5EF4-FFF2-40B4-BE49-F238E27FC236}">
-                <a16:creationId xmlns:a16="http://schemas.microsoft.com/office/drawing/2014/main" id="{D7F5DADF-A91F-494F-A052-980C7D73CE69}"/>
+                <a16:creationId xmlns:a16="http://schemas.microsoft.com/office/drawing/2014/main" id="{7B266733-0950-4CEB-B4F5-FF41E23406FA}"/>
               </a:ext>
             </a:extLst>
           </p:cNvPr>
@@ -13660,7 +13750,7 @@
           <p:cNvPr id="9" name="">
             <a:extLst xmlns:a="http://schemas.openxmlformats.org/drawingml/2006/main">
               <a:ext uri="{FF2B5EF4-FFF2-40B4-BE49-F238E27FC236}">
-                <a16:creationId xmlns:a16="http://schemas.microsoft.com/office/drawing/2014/main" id="{DDDC07E2-7E55-41DA-BD61-51CEFA762E98}"/>
+                <a16:creationId xmlns:a16="http://schemas.microsoft.com/office/drawing/2014/main" id="{AFE9DA23-69D7-4C9C-909A-2F0795D0E73A}"/>
               </a:ext>
             </a:extLst>
           </p:cNvPr>
@@ -13691,7 +13781,7 @@
           <p:cNvPr id="10" name="">
             <a:extLst xmlns:a="http://schemas.openxmlformats.org/drawingml/2006/main">
               <a:ext uri="{FF2B5EF4-FFF2-40B4-BE49-F238E27FC236}">
-                <a16:creationId xmlns:a16="http://schemas.microsoft.com/office/drawing/2014/main" id="{AA53CCA1-F278-49FB-8521-0D01389D607E}"/>
+                <a16:creationId xmlns:a16="http://schemas.microsoft.com/office/drawing/2014/main" id="{CEACE2C2-4165-4CE2-B249-84C43D1CC538}"/>
               </a:ext>
             </a:extLst>
           </p:cNvPr>
@@ -13753,7 +13843,7 @@
           <p:cNvPr id="11" name="">
             <a:extLst xmlns:a="http://schemas.openxmlformats.org/drawingml/2006/main">
               <a:ext uri="{FF2B5EF4-FFF2-40B4-BE49-F238E27FC236}">
-                <a16:creationId xmlns:a16="http://schemas.microsoft.com/office/drawing/2014/main" id="{D4A5E4FF-2613-4330-98CE-D38C3DFB8A7A}"/>
+                <a16:creationId xmlns:a16="http://schemas.microsoft.com/office/drawing/2014/main" id="{F102DAB8-5B98-4158-BBB6-2B12717D9D64}"/>
               </a:ext>
             </a:extLst>
           </p:cNvPr>
@@ -13815,7 +13905,7 @@
           <p:cNvPr id="12" name="">
             <a:extLst xmlns:a="http://schemas.openxmlformats.org/drawingml/2006/main">
               <a:ext uri="{FF2B5EF4-FFF2-40B4-BE49-F238E27FC236}">
-                <a16:creationId xmlns:a16="http://schemas.microsoft.com/office/drawing/2014/main" id="{27668328-31DA-4517-92CC-D02D516483D3}"/>
+                <a16:creationId xmlns:a16="http://schemas.microsoft.com/office/drawing/2014/main" id="{436FB513-3464-4142-90C8-F10DE17BC40F}"/>
               </a:ext>
             </a:extLst>
           </p:cNvPr>
@@ -13846,7 +13936,7 @@
           <p:cNvPr id="13" name="">
             <a:extLst xmlns:a="http://schemas.openxmlformats.org/drawingml/2006/main">
               <a:ext uri="{FF2B5EF4-FFF2-40B4-BE49-F238E27FC236}">
-                <a16:creationId xmlns:a16="http://schemas.microsoft.com/office/drawing/2014/main" id="{CCC39814-2343-4D1B-A956-B13FC2BF6AA5}"/>
+                <a16:creationId xmlns:a16="http://schemas.microsoft.com/office/drawing/2014/main" id="{6F4B5865-8ABD-4600-8380-D043200B5F4E}"/>
               </a:ext>
             </a:extLst>
           </p:cNvPr>
@@ -13908,7 +13998,7 @@
           <p:cNvPr id="14" name="outcome-mark">
             <a:extLst xmlns:a="http://schemas.openxmlformats.org/drawingml/2006/main">
               <a:ext uri="{FF2B5EF4-FFF2-40B4-BE49-F238E27FC236}">
-                <a16:creationId xmlns:a16="http://schemas.microsoft.com/office/drawing/2014/main" id="{906517F7-6235-4092-BE3D-F111EDD56A3D}"/>
+                <a16:creationId xmlns:a16="http://schemas.microsoft.com/office/drawing/2014/main" id="{19819231-9EB5-497A-8B4E-7CF41ACD9D3D}"/>
               </a:ext>
             </a:extLst>
           </p:cNvPr>
@@ -13943,7 +14033,7 @@
           <p:cNvPr id="15" name="">
             <a:extLst xmlns:a="http://schemas.openxmlformats.org/drawingml/2006/main">
               <a:ext uri="{FF2B5EF4-FFF2-40B4-BE49-F238E27FC236}">
-                <a16:creationId xmlns:a16="http://schemas.microsoft.com/office/drawing/2014/main" id="{F22757CA-EAF7-495F-A099-99636CD1CF39}"/>
+                <a16:creationId xmlns:a16="http://schemas.microsoft.com/office/drawing/2014/main" id="{9A3554D8-24BE-4A0F-B208-EF6DDB4A2AE2}"/>
               </a:ext>
             </a:extLst>
           </p:cNvPr>
@@ -14005,7 +14095,7 @@
           <p:cNvPr id="16" name="">
             <a:extLst xmlns:a="http://schemas.openxmlformats.org/drawingml/2006/main">
               <a:ext uri="{FF2B5EF4-FFF2-40B4-BE49-F238E27FC236}">
-                <a16:creationId xmlns:a16="http://schemas.microsoft.com/office/drawing/2014/main" id="{55EDEEC3-E019-439D-8723-D3448F78CCF5}"/>
+                <a16:creationId xmlns:a16="http://schemas.microsoft.com/office/drawing/2014/main" id="{A39A4478-9135-41AD-9CA9-B79F6C4FBB95}"/>
               </a:ext>
             </a:extLst>
           </p:cNvPr>
@@ -14094,7 +14184,7 @@
           <p:cNvPr id="17" name="footer-rule-2">
             <a:extLst xmlns:a="http://schemas.openxmlformats.org/drawingml/2006/main">
               <a:ext uri="{FF2B5EF4-FFF2-40B4-BE49-F238E27FC236}">
-                <a16:creationId xmlns:a16="http://schemas.microsoft.com/office/drawing/2014/main" id="{636BB1CB-AE50-41E2-8E0A-122404F509D0}"/>
+                <a16:creationId xmlns:a16="http://schemas.microsoft.com/office/drawing/2014/main" id="{424896EA-3497-4DD4-A318-512EE5507489}"/>
               </a:ext>
             </a:extLst>
           </p:cNvPr>
@@ -14125,7 +14215,7 @@
           <p:cNvPr id="18" name="footer-label-2">
             <a:extLst xmlns:a="http://schemas.openxmlformats.org/drawingml/2006/main">
               <a:ext uri="{FF2B5EF4-FFF2-40B4-BE49-F238E27FC236}">
-                <a16:creationId xmlns:a16="http://schemas.microsoft.com/office/drawing/2014/main" id="{69F0790B-6E69-4F23-9D01-8A2DAD93123F}"/>
+                <a16:creationId xmlns:a16="http://schemas.microsoft.com/office/drawing/2014/main" id="{633D6486-6ED9-43A5-B6C3-1F8E501F096C}"/>
               </a:ext>
             </a:extLst>
           </p:cNvPr>
@@ -14187,7 +14277,7 @@
           <p:cNvPr id="19" name="footer-page-2">
             <a:extLst xmlns:a="http://schemas.openxmlformats.org/drawingml/2006/main">
               <a:ext uri="{FF2B5EF4-FFF2-40B4-BE49-F238E27FC236}">
-                <a16:creationId xmlns:a16="http://schemas.microsoft.com/office/drawing/2014/main" id="{3720C8DD-D98F-492E-BC34-9E4A213EFB18}"/>
+                <a16:creationId xmlns:a16="http://schemas.microsoft.com/office/drawing/2014/main" id="{8BCBD3B8-BAAB-4399-8224-2E2C93C39EE0}"/>
               </a:ext>
             </a:extLst>
           </p:cNvPr>
@@ -14247,7 +14337,7 @@
     </p:spTree>
     <p:extLst>
       <p:ext uri="{BB962C8B-B14F-4D97-AF65-F5344CB8AC3E}">
-        <p14:creationId xmlns:p14="http://schemas.microsoft.com/office/powerpoint/2010/main" val="1746396076"/>
+        <p14:creationId xmlns:p14="http://schemas.microsoft.com/office/powerpoint/2010/main" val="1200389130"/>
       </p:ext>
     </p:extLst>
   </p:cSld>
@@ -14278,7 +14368,7 @@
           <p:cNvPr id="31" name="side-accent-3">
             <a:extLst xmlns:a="http://schemas.openxmlformats.org/drawingml/2006/main">
               <a:ext uri="{FF2B5EF4-FFF2-40B4-BE49-F238E27FC236}">
-                <a16:creationId xmlns:a16="http://schemas.microsoft.com/office/drawing/2014/main" id="{6EA24435-49B9-4A62-8B06-A7E2A1706BED}"/>
+                <a16:creationId xmlns:a16="http://schemas.microsoft.com/office/drawing/2014/main" id="{22BAE097-C269-47A7-9F60-A06CCCD2497C}"/>
               </a:ext>
             </a:extLst>
           </p:cNvPr>
@@ -14309,7 +14399,7 @@
           <p:cNvPr id="2" name="kicker-3">
             <a:extLst xmlns:a="http://schemas.openxmlformats.org/drawingml/2006/main">
               <a:ext uri="{FF2B5EF4-FFF2-40B4-BE49-F238E27FC236}">
-                <a16:creationId xmlns:a16="http://schemas.microsoft.com/office/drawing/2014/main" id="{3F145EDA-6EB7-45C3-9D4C-A69CC9AD500F}"/>
+                <a16:creationId xmlns:a16="http://schemas.microsoft.com/office/drawing/2014/main" id="{C844F45D-5178-40AB-866B-0482CFE2AF87}"/>
               </a:ext>
             </a:extLst>
           </p:cNvPr>
@@ -14371,7 +14461,7 @@
           <p:cNvPr id="3" name="title-3">
             <a:extLst xmlns:a="http://schemas.openxmlformats.org/drawingml/2006/main">
               <a:ext uri="{FF2B5EF4-FFF2-40B4-BE49-F238E27FC236}">
-                <a16:creationId xmlns:a16="http://schemas.microsoft.com/office/drawing/2014/main" id="{AF2D1107-1AE0-4A09-B5AF-F63E15DBD520}"/>
+                <a16:creationId xmlns:a16="http://schemas.microsoft.com/office/drawing/2014/main" id="{FEC98D71-3CF1-4D92-A5B4-9CA1D01CE07E}"/>
               </a:ext>
             </a:extLst>
           </p:cNvPr>
@@ -14433,7 +14523,7 @@
           <p:cNvPr id="4" name="">
             <a:extLst xmlns:a="http://schemas.openxmlformats.org/drawingml/2006/main">
               <a:ext uri="{FF2B5EF4-FFF2-40B4-BE49-F238E27FC236}">
-                <a16:creationId xmlns:a16="http://schemas.microsoft.com/office/drawing/2014/main" id="{EAB535BD-CEE8-4F0A-90D2-9AF93F94AADC}"/>
+                <a16:creationId xmlns:a16="http://schemas.microsoft.com/office/drawing/2014/main" id="{7B8AA832-856B-4F68-A55C-C258BFA38F29}"/>
               </a:ext>
             </a:extLst>
           </p:cNvPr>
@@ -14495,7 +14585,7 @@
           <p:cNvPr id="5" name="system-function-line">
             <a:extLst xmlns:a="http://schemas.openxmlformats.org/drawingml/2006/main">
               <a:ext uri="{FF2B5EF4-FFF2-40B4-BE49-F238E27FC236}">
-                <a16:creationId xmlns:a16="http://schemas.microsoft.com/office/drawing/2014/main" id="{8339BDA6-1B83-4137-BEF1-3F4688F3E35B}"/>
+                <a16:creationId xmlns:a16="http://schemas.microsoft.com/office/drawing/2014/main" id="{C6ABC659-85B8-414B-BE11-5EECBFE0CB62}"/>
               </a:ext>
             </a:extLst>
           </p:cNvPr>
@@ -14526,7 +14616,7 @@
           <p:cNvPr id="6" name="">
             <a:extLst xmlns:a="http://schemas.openxmlformats.org/drawingml/2006/main">
               <a:ext uri="{FF2B5EF4-FFF2-40B4-BE49-F238E27FC236}">
-                <a16:creationId xmlns:a16="http://schemas.microsoft.com/office/drawing/2014/main" id="{34DCBDF1-2BC0-4BFE-B989-C1AA83F3DBAD}"/>
+                <a16:creationId xmlns:a16="http://schemas.microsoft.com/office/drawing/2014/main" id="{0AFCE43F-FDC8-4872-A139-6EF93F1D7C3D}"/>
               </a:ext>
             </a:extLst>
           </p:cNvPr>
@@ -14557,7 +14647,7 @@
           <p:cNvPr id="7" name="">
             <a:extLst xmlns:a="http://schemas.openxmlformats.org/drawingml/2006/main">
               <a:ext uri="{FF2B5EF4-FFF2-40B4-BE49-F238E27FC236}">
-                <a16:creationId xmlns:a16="http://schemas.microsoft.com/office/drawing/2014/main" id="{7B2B4744-8579-4321-85B5-1CB3A4E6C573}"/>
+                <a16:creationId xmlns:a16="http://schemas.microsoft.com/office/drawing/2014/main" id="{25AF1775-612B-4C3F-B1C1-3C3547A2BA41}"/>
               </a:ext>
             </a:extLst>
           </p:cNvPr>
@@ -14619,7 +14709,7 @@
           <p:cNvPr id="8" name="">
             <a:extLst xmlns:a="http://schemas.openxmlformats.org/drawingml/2006/main">
               <a:ext uri="{FF2B5EF4-FFF2-40B4-BE49-F238E27FC236}">
-                <a16:creationId xmlns:a16="http://schemas.microsoft.com/office/drawing/2014/main" id="{70EA661C-5237-4B44-8941-BDB2A0107CDD}"/>
+                <a16:creationId xmlns:a16="http://schemas.microsoft.com/office/drawing/2014/main" id="{470E3161-CE35-4AF1-A7AD-4EBBFBDB68BC}"/>
               </a:ext>
             </a:extLst>
           </p:cNvPr>
@@ -14681,7 +14771,7 @@
           <p:cNvPr id="9" name="">
             <a:extLst xmlns:a="http://schemas.openxmlformats.org/drawingml/2006/main">
               <a:ext uri="{FF2B5EF4-FFF2-40B4-BE49-F238E27FC236}">
-                <a16:creationId xmlns:a16="http://schemas.microsoft.com/office/drawing/2014/main" id="{FAB82052-9BCF-4337-9B5F-41C4CE21266D}"/>
+                <a16:creationId xmlns:a16="http://schemas.microsoft.com/office/drawing/2014/main" id="{3B8B0E10-4DC4-4F4C-ADF5-1434D5F17123}"/>
               </a:ext>
             </a:extLst>
           </p:cNvPr>
@@ -14743,7 +14833,7 @@
           <p:cNvPr id="10" name="">
             <a:extLst xmlns:a="http://schemas.openxmlformats.org/drawingml/2006/main">
               <a:ext uri="{FF2B5EF4-FFF2-40B4-BE49-F238E27FC236}">
-                <a16:creationId xmlns:a16="http://schemas.microsoft.com/office/drawing/2014/main" id="{019B34FA-9544-4A7F-9FCA-8C5C0C37F54D}"/>
+                <a16:creationId xmlns:a16="http://schemas.microsoft.com/office/drawing/2014/main" id="{2C832419-1F8B-4C53-9AD9-6CA94C71A97F}"/>
               </a:ext>
             </a:extLst>
           </p:cNvPr>
@@ -14774,7 +14864,7 @@
           <p:cNvPr id="11" name="">
             <a:extLst xmlns:a="http://schemas.openxmlformats.org/drawingml/2006/main">
               <a:ext uri="{FF2B5EF4-FFF2-40B4-BE49-F238E27FC236}">
-                <a16:creationId xmlns:a16="http://schemas.microsoft.com/office/drawing/2014/main" id="{DC059392-B19D-4798-9B5B-CC9BF4BA56DC}"/>
+                <a16:creationId xmlns:a16="http://schemas.microsoft.com/office/drawing/2014/main" id="{55323E74-0CEC-405E-A9EE-DF50CC4A0055}"/>
               </a:ext>
             </a:extLst>
           </p:cNvPr>
@@ -14836,7 +14926,7 @@
           <p:cNvPr id="12" name="">
             <a:extLst xmlns:a="http://schemas.openxmlformats.org/drawingml/2006/main">
               <a:ext uri="{FF2B5EF4-FFF2-40B4-BE49-F238E27FC236}">
-                <a16:creationId xmlns:a16="http://schemas.microsoft.com/office/drawing/2014/main" id="{8706CDAF-E916-4157-AA86-2C6ADD3A8C7F}"/>
+                <a16:creationId xmlns:a16="http://schemas.microsoft.com/office/drawing/2014/main" id="{443AE556-194C-4071-8CEB-1588B2684875}"/>
               </a:ext>
             </a:extLst>
           </p:cNvPr>
@@ -14898,7 +14988,7 @@
           <p:cNvPr id="13" name="">
             <a:extLst xmlns:a="http://schemas.openxmlformats.org/drawingml/2006/main">
               <a:ext uri="{FF2B5EF4-FFF2-40B4-BE49-F238E27FC236}">
-                <a16:creationId xmlns:a16="http://schemas.microsoft.com/office/drawing/2014/main" id="{C3340CE9-1ED0-4A21-B726-DEC97FB13F2F}"/>
+                <a16:creationId xmlns:a16="http://schemas.microsoft.com/office/drawing/2014/main" id="{1239C092-B6C8-4EF7-AD6C-87823CF76CF1}"/>
               </a:ext>
             </a:extLst>
           </p:cNvPr>
@@ -14960,7 +15050,7 @@
           <p:cNvPr id="14" name="">
             <a:extLst xmlns:a="http://schemas.openxmlformats.org/drawingml/2006/main">
               <a:ext uri="{FF2B5EF4-FFF2-40B4-BE49-F238E27FC236}">
-                <a16:creationId xmlns:a16="http://schemas.microsoft.com/office/drawing/2014/main" id="{D8C34B91-912A-48D4-AA41-7348AE222165}"/>
+                <a16:creationId xmlns:a16="http://schemas.microsoft.com/office/drawing/2014/main" id="{745E5DA6-9DF6-4340-8376-53293721F4AF}"/>
               </a:ext>
             </a:extLst>
           </p:cNvPr>
@@ -14991,7 +15081,7 @@
           <p:cNvPr id="15" name="">
             <a:extLst xmlns:a="http://schemas.openxmlformats.org/drawingml/2006/main">
               <a:ext uri="{FF2B5EF4-FFF2-40B4-BE49-F238E27FC236}">
-                <a16:creationId xmlns:a16="http://schemas.microsoft.com/office/drawing/2014/main" id="{7E4EA6F5-C412-44DC-9E36-F00951EDD44F}"/>
+                <a16:creationId xmlns:a16="http://schemas.microsoft.com/office/drawing/2014/main" id="{85D98DFF-C831-4B05-935F-22AD7F42FFEF}"/>
               </a:ext>
             </a:extLst>
           </p:cNvPr>
@@ -15053,7 +15143,7 @@
           <p:cNvPr id="16" name="">
             <a:extLst xmlns:a="http://schemas.openxmlformats.org/drawingml/2006/main">
               <a:ext uri="{FF2B5EF4-FFF2-40B4-BE49-F238E27FC236}">
-                <a16:creationId xmlns:a16="http://schemas.microsoft.com/office/drawing/2014/main" id="{C38F2214-AF5D-4847-A18D-5C32CD0FEE81}"/>
+                <a16:creationId xmlns:a16="http://schemas.microsoft.com/office/drawing/2014/main" id="{E42972C2-1076-4F69-981A-ABAC8E82B529}"/>
               </a:ext>
             </a:extLst>
           </p:cNvPr>
@@ -15115,7 +15205,7 @@
           <p:cNvPr id="17" name="">
             <a:extLst xmlns:a="http://schemas.openxmlformats.org/drawingml/2006/main">
               <a:ext uri="{FF2B5EF4-FFF2-40B4-BE49-F238E27FC236}">
-                <a16:creationId xmlns:a16="http://schemas.microsoft.com/office/drawing/2014/main" id="{48F0624F-EFF6-4A5A-AA86-2D29AC4BBD12}"/>
+                <a16:creationId xmlns:a16="http://schemas.microsoft.com/office/drawing/2014/main" id="{398D745C-55B6-4867-B112-436D590993FB}"/>
               </a:ext>
             </a:extLst>
           </p:cNvPr>
@@ -15177,7 +15267,7 @@
           <p:cNvPr id="18" name="">
             <a:extLst xmlns:a="http://schemas.openxmlformats.org/drawingml/2006/main">
               <a:ext uri="{FF2B5EF4-FFF2-40B4-BE49-F238E27FC236}">
-                <a16:creationId xmlns:a16="http://schemas.microsoft.com/office/drawing/2014/main" id="{AD7A283B-BD7B-4934-988A-C5EB89E41264}"/>
+                <a16:creationId xmlns:a16="http://schemas.microsoft.com/office/drawing/2014/main" id="{D2E50C16-A77F-4D10-B7ED-D11BA4AB7BD0}"/>
               </a:ext>
             </a:extLst>
           </p:cNvPr>
@@ -15208,7 +15298,7 @@
           <p:cNvPr id="19" name="">
             <a:extLst xmlns:a="http://schemas.openxmlformats.org/drawingml/2006/main">
               <a:ext uri="{FF2B5EF4-FFF2-40B4-BE49-F238E27FC236}">
-                <a16:creationId xmlns:a16="http://schemas.microsoft.com/office/drawing/2014/main" id="{923E5D89-7A50-4595-9203-F56F90EA9884}"/>
+                <a16:creationId xmlns:a16="http://schemas.microsoft.com/office/drawing/2014/main" id="{7C8EF5D8-0A08-4D6D-9A3D-4136433124D0}"/>
               </a:ext>
             </a:extLst>
           </p:cNvPr>
@@ -15270,7 +15360,7 @@
           <p:cNvPr id="20" name="">
             <a:extLst xmlns:a="http://schemas.openxmlformats.org/drawingml/2006/main">
               <a:ext uri="{FF2B5EF4-FFF2-40B4-BE49-F238E27FC236}">
-                <a16:creationId xmlns:a16="http://schemas.microsoft.com/office/drawing/2014/main" id="{7EF62850-3BCD-4F56-BFF6-BEF4D4558B5F}"/>
+                <a16:creationId xmlns:a16="http://schemas.microsoft.com/office/drawing/2014/main" id="{985A8F9A-E28D-4DAF-8C8C-00D528329833}"/>
               </a:ext>
             </a:extLst>
           </p:cNvPr>
@@ -15332,7 +15422,7 @@
           <p:cNvPr id="21" name="">
             <a:extLst xmlns:a="http://schemas.openxmlformats.org/drawingml/2006/main">
               <a:ext uri="{FF2B5EF4-FFF2-40B4-BE49-F238E27FC236}">
-                <a16:creationId xmlns:a16="http://schemas.microsoft.com/office/drawing/2014/main" id="{A505B241-948A-43DF-9FEC-D0016D6E622E}"/>
+                <a16:creationId xmlns:a16="http://schemas.microsoft.com/office/drawing/2014/main" id="{85554718-285F-40AA-A005-CCADCC363829}"/>
               </a:ext>
             </a:extLst>
           </p:cNvPr>
@@ -15394,7 +15484,7 @@
           <p:cNvPr id="22" name="">
             <a:extLst xmlns:a="http://schemas.openxmlformats.org/drawingml/2006/main">
               <a:ext uri="{FF2B5EF4-FFF2-40B4-BE49-F238E27FC236}">
-                <a16:creationId xmlns:a16="http://schemas.microsoft.com/office/drawing/2014/main" id="{83A2D3C3-3A6B-4AAA-AE53-B3D069F36B80}"/>
+                <a16:creationId xmlns:a16="http://schemas.microsoft.com/office/drawing/2014/main" id="{65A37460-B057-4B56-9652-987FE854EDBF}"/>
               </a:ext>
             </a:extLst>
           </p:cNvPr>
@@ -15425,7 +15515,7 @@
           <p:cNvPr id="23" name="">
             <a:extLst xmlns:a="http://schemas.openxmlformats.org/drawingml/2006/main">
               <a:ext uri="{FF2B5EF4-FFF2-40B4-BE49-F238E27FC236}">
-                <a16:creationId xmlns:a16="http://schemas.microsoft.com/office/drawing/2014/main" id="{506E4853-5085-4444-B286-F87E3C9B25B3}"/>
+                <a16:creationId xmlns:a16="http://schemas.microsoft.com/office/drawing/2014/main" id="{44BED3B2-E4C2-4121-BCF1-D582A17B3E6B}"/>
               </a:ext>
             </a:extLst>
           </p:cNvPr>
@@ -15487,7 +15577,7 @@
           <p:cNvPr id="24" name="">
             <a:extLst xmlns:a="http://schemas.openxmlformats.org/drawingml/2006/main">
               <a:ext uri="{FF2B5EF4-FFF2-40B4-BE49-F238E27FC236}">
-                <a16:creationId xmlns:a16="http://schemas.microsoft.com/office/drawing/2014/main" id="{5C4CE50A-2626-4372-949F-14AFD00560CD}"/>
+                <a16:creationId xmlns:a16="http://schemas.microsoft.com/office/drawing/2014/main" id="{FB828CA7-6860-4B58-92E3-D9675B36E7A7}"/>
               </a:ext>
             </a:extLst>
           </p:cNvPr>
@@ -15549,7 +15639,7 @@
           <p:cNvPr id="25" name="">
             <a:extLst xmlns:a="http://schemas.openxmlformats.org/drawingml/2006/main">
               <a:ext uri="{FF2B5EF4-FFF2-40B4-BE49-F238E27FC236}">
-                <a16:creationId xmlns:a16="http://schemas.microsoft.com/office/drawing/2014/main" id="{A849BDAD-E66E-43AC-B959-E827719E2360}"/>
+                <a16:creationId xmlns:a16="http://schemas.microsoft.com/office/drawing/2014/main" id="{52AA6C54-4961-49C4-B439-708052FDB408}"/>
               </a:ext>
             </a:extLst>
           </p:cNvPr>
@@ -15611,7 +15701,7 @@
           <p:cNvPr id="26" name="">
             <a:extLst xmlns:a="http://schemas.openxmlformats.org/drawingml/2006/main">
               <a:ext uri="{FF2B5EF4-FFF2-40B4-BE49-F238E27FC236}">
-                <a16:creationId xmlns:a16="http://schemas.microsoft.com/office/drawing/2014/main" id="{37260AC6-EF2E-4F98-90E7-94C20EBA32F1}"/>
+                <a16:creationId xmlns:a16="http://schemas.microsoft.com/office/drawing/2014/main" id="{F1D17D18-602A-4EDB-8BC5-80FC578E6D09}"/>
               </a:ext>
             </a:extLst>
           </p:cNvPr>
@@ -15644,7 +15734,7 @@
           <p:cNvPr id="27" name="">
             <a:extLst xmlns:a="http://schemas.openxmlformats.org/drawingml/2006/main">
               <a:ext uri="{FF2B5EF4-FFF2-40B4-BE49-F238E27FC236}">
-                <a16:creationId xmlns:a16="http://schemas.microsoft.com/office/drawing/2014/main" id="{2FDE013D-B55B-463A-A629-0C24F05F473D}"/>
+                <a16:creationId xmlns:a16="http://schemas.microsoft.com/office/drawing/2014/main" id="{A62249A3-029B-42B7-942B-4551B1FA1AAA}"/>
               </a:ext>
             </a:extLst>
           </p:cNvPr>
@@ -15706,7 +15796,7 @@
           <p:cNvPr id="28" name="footer-rule-3">
             <a:extLst xmlns:a="http://schemas.openxmlformats.org/drawingml/2006/main">
               <a:ext uri="{FF2B5EF4-FFF2-40B4-BE49-F238E27FC236}">
-                <a16:creationId xmlns:a16="http://schemas.microsoft.com/office/drawing/2014/main" id="{2F970D33-3934-4C6C-9FA3-7DD3D9CDD281}"/>
+                <a16:creationId xmlns:a16="http://schemas.microsoft.com/office/drawing/2014/main" id="{8121DEDD-37DA-4899-8DF7-7A4C382B642C}"/>
               </a:ext>
             </a:extLst>
           </p:cNvPr>
@@ -15737,7 +15827,7 @@
           <p:cNvPr id="29" name="footer-label-3">
             <a:extLst xmlns:a="http://schemas.openxmlformats.org/drawingml/2006/main">
               <a:ext uri="{FF2B5EF4-FFF2-40B4-BE49-F238E27FC236}">
-                <a16:creationId xmlns:a16="http://schemas.microsoft.com/office/drawing/2014/main" id="{68F0F43C-1BE2-443A-8786-B8769A13DA28}"/>
+                <a16:creationId xmlns:a16="http://schemas.microsoft.com/office/drawing/2014/main" id="{AA8EF157-7CB0-4B61-A3A7-DC5E372F2937}"/>
               </a:ext>
             </a:extLst>
           </p:cNvPr>
@@ -15799,7 +15889,7 @@
           <p:cNvPr id="30" name="footer-page-3">
             <a:extLst xmlns:a="http://schemas.openxmlformats.org/drawingml/2006/main">
               <a:ext uri="{FF2B5EF4-FFF2-40B4-BE49-F238E27FC236}">
-                <a16:creationId xmlns:a16="http://schemas.microsoft.com/office/drawing/2014/main" id="{24C9EC6C-C09E-48BB-8D02-384DF43A3B78}"/>
+                <a16:creationId xmlns:a16="http://schemas.microsoft.com/office/drawing/2014/main" id="{0F66195C-3EDE-4F12-8417-A7CD5BDB6659}"/>
               </a:ext>
             </a:extLst>
           </p:cNvPr>
@@ -15859,7 +15949,7 @@
     </p:spTree>
     <p:extLst>
       <p:ext uri="{BB962C8B-B14F-4D97-AF65-F5344CB8AC3E}">
-        <p14:creationId xmlns:p14="http://schemas.microsoft.com/office/powerpoint/2010/main" val="1929736205"/>
+        <p14:creationId xmlns:p14="http://schemas.microsoft.com/office/powerpoint/2010/main" val="846518144"/>
       </p:ext>
     </p:extLst>
   </p:cSld>
@@ -15890,7 +15980,7 @@
           <p:cNvPr id="28" name="side-accent-4">
             <a:extLst xmlns:a="http://schemas.openxmlformats.org/drawingml/2006/main">
               <a:ext uri="{FF2B5EF4-FFF2-40B4-BE49-F238E27FC236}">
-                <a16:creationId xmlns:a16="http://schemas.microsoft.com/office/drawing/2014/main" id="{277BA8FF-AAEA-4C50-915A-4C1FF0C85F92}"/>
+                <a16:creationId xmlns:a16="http://schemas.microsoft.com/office/drawing/2014/main" id="{71B96F99-D5A7-437C-8E67-C7F4B6740266}"/>
               </a:ext>
             </a:extLst>
           </p:cNvPr>
@@ -15921,7 +16011,7 @@
           <p:cNvPr id="2" name="kicker-4">
             <a:extLst xmlns:a="http://schemas.openxmlformats.org/drawingml/2006/main">
               <a:ext uri="{FF2B5EF4-FFF2-40B4-BE49-F238E27FC236}">
-                <a16:creationId xmlns:a16="http://schemas.microsoft.com/office/drawing/2014/main" id="{BBEF98C0-0FE1-48DC-977C-1CF0B8D49CC3}"/>
+                <a16:creationId xmlns:a16="http://schemas.microsoft.com/office/drawing/2014/main" id="{2F8EDD19-3930-40B1-83EB-3E6F7090F5A2}"/>
               </a:ext>
             </a:extLst>
           </p:cNvPr>
@@ -15983,7 +16073,7 @@
           <p:cNvPr id="3" name="title-4">
             <a:extLst xmlns:a="http://schemas.openxmlformats.org/drawingml/2006/main">
               <a:ext uri="{FF2B5EF4-FFF2-40B4-BE49-F238E27FC236}">
-                <a16:creationId xmlns:a16="http://schemas.microsoft.com/office/drawing/2014/main" id="{6823376E-EB38-486F-A9A2-9FDEF36B8D42}"/>
+                <a16:creationId xmlns:a16="http://schemas.microsoft.com/office/drawing/2014/main" id="{6A74F638-640F-46FF-B3B0-EF440046DB8A}"/>
               </a:ext>
             </a:extLst>
           </p:cNvPr>
@@ -16045,7 +16135,7 @@
           <p:cNvPr id="4" name="">
             <a:extLst xmlns:a="http://schemas.openxmlformats.org/drawingml/2006/main">
               <a:ext uri="{FF2B5EF4-FFF2-40B4-BE49-F238E27FC236}">
-                <a16:creationId xmlns:a16="http://schemas.microsoft.com/office/drawing/2014/main" id="{B3B850FE-F384-4DAB-B96B-8481879D3899}"/>
+                <a16:creationId xmlns:a16="http://schemas.microsoft.com/office/drawing/2014/main" id="{FFD0238C-85EA-4DE6-81AC-9E17B058CDEC}"/>
               </a:ext>
             </a:extLst>
           </p:cNvPr>
@@ -16107,7 +16197,7 @@
           <p:cNvPr id="5" name="">
             <a:extLst xmlns:a="http://schemas.openxmlformats.org/drawingml/2006/main">
               <a:ext uri="{FF2B5EF4-FFF2-40B4-BE49-F238E27FC236}">
-                <a16:creationId xmlns:a16="http://schemas.microsoft.com/office/drawing/2014/main" id="{743D2EB1-727D-4B03-8448-20CF1267E6B5}"/>
+                <a16:creationId xmlns:a16="http://schemas.microsoft.com/office/drawing/2014/main" id="{70B6E0A1-6A6D-4913-A32F-3CABCA0D9641}"/>
               </a:ext>
             </a:extLst>
           </p:cNvPr>
@@ -16169,7 +16259,7 @@
           <p:cNvPr id="6" name="">
             <a:extLst xmlns:a="http://schemas.openxmlformats.org/drawingml/2006/main">
               <a:ext uri="{FF2B5EF4-FFF2-40B4-BE49-F238E27FC236}">
-                <a16:creationId xmlns:a16="http://schemas.microsoft.com/office/drawing/2014/main" id="{C2CCC9C7-1E99-43FB-875F-94B7005B9E57}"/>
+                <a16:creationId xmlns:a16="http://schemas.microsoft.com/office/drawing/2014/main" id="{56D2E5C5-E971-42C6-9977-A3E312822B0D}"/>
               </a:ext>
             </a:extLst>
           </p:cNvPr>
@@ -16231,7 +16321,7 @@
           <p:cNvPr id="7" name="">
             <a:extLst xmlns:a="http://schemas.openxmlformats.org/drawingml/2006/main">
               <a:ext uri="{FF2B5EF4-FFF2-40B4-BE49-F238E27FC236}">
-                <a16:creationId xmlns:a16="http://schemas.microsoft.com/office/drawing/2014/main" id="{CB3A9687-EECC-44C4-8EA3-6CD8AA317D6C}"/>
+                <a16:creationId xmlns:a16="http://schemas.microsoft.com/office/drawing/2014/main" id="{F3E103D8-A775-43C5-9019-43CF0246277B}"/>
               </a:ext>
             </a:extLst>
           </p:cNvPr>
@@ -16262,7 +16352,7 @@
           <p:cNvPr id="8" name="">
             <a:extLst xmlns:a="http://schemas.openxmlformats.org/drawingml/2006/main">
               <a:ext uri="{FF2B5EF4-FFF2-40B4-BE49-F238E27FC236}">
-                <a16:creationId xmlns:a16="http://schemas.microsoft.com/office/drawing/2014/main" id="{8A1220AD-F58D-48FE-9D76-40F204C861D7}"/>
+                <a16:creationId xmlns:a16="http://schemas.microsoft.com/office/drawing/2014/main" id="{24E3F37A-8348-4F35-9FF0-011C8C6C8680}"/>
               </a:ext>
             </a:extLst>
           </p:cNvPr>
@@ -16324,7 +16414,7 @@
           <p:cNvPr id="9" name="">
             <a:extLst xmlns:a="http://schemas.openxmlformats.org/drawingml/2006/main">
               <a:ext uri="{FF2B5EF4-FFF2-40B4-BE49-F238E27FC236}">
-                <a16:creationId xmlns:a16="http://schemas.microsoft.com/office/drawing/2014/main" id="{7CD6D16C-7FC7-4FF4-8953-1B8C16155117}"/>
+                <a16:creationId xmlns:a16="http://schemas.microsoft.com/office/drawing/2014/main" id="{8C182E28-1267-49EC-9987-5FC140373DDC}"/>
               </a:ext>
             </a:extLst>
           </p:cNvPr>
@@ -16386,7 +16476,7 @@
           <p:cNvPr id="10" name="">
             <a:extLst xmlns:a="http://schemas.openxmlformats.org/drawingml/2006/main">
               <a:ext uri="{FF2B5EF4-FFF2-40B4-BE49-F238E27FC236}">
-                <a16:creationId xmlns:a16="http://schemas.microsoft.com/office/drawing/2014/main" id="{5F493DFA-5E06-4F57-935F-B03B6A209343}"/>
+                <a16:creationId xmlns:a16="http://schemas.microsoft.com/office/drawing/2014/main" id="{6B23364B-A8C0-400C-A21E-DDDB7AEC0EFA}"/>
               </a:ext>
             </a:extLst>
           </p:cNvPr>
@@ -16448,7 +16538,7 @@
           <p:cNvPr id="11" name="">
             <a:extLst xmlns:a="http://schemas.openxmlformats.org/drawingml/2006/main">
               <a:ext uri="{FF2B5EF4-FFF2-40B4-BE49-F238E27FC236}">
-                <a16:creationId xmlns:a16="http://schemas.microsoft.com/office/drawing/2014/main" id="{74E6835B-F2D3-457D-ABB1-A0E3AE0A8385}"/>
+                <a16:creationId xmlns:a16="http://schemas.microsoft.com/office/drawing/2014/main" id="{C106976C-4846-431E-80A6-7717501F02F3}"/>
               </a:ext>
             </a:extLst>
           </p:cNvPr>
@@ -16479,7 +16569,7 @@
           <p:cNvPr id="12" name="">
             <a:extLst xmlns:a="http://schemas.openxmlformats.org/drawingml/2006/main">
               <a:ext uri="{FF2B5EF4-FFF2-40B4-BE49-F238E27FC236}">
-                <a16:creationId xmlns:a16="http://schemas.microsoft.com/office/drawing/2014/main" id="{507D6753-1A63-4DC9-880E-822FD545A00D}"/>
+                <a16:creationId xmlns:a16="http://schemas.microsoft.com/office/drawing/2014/main" id="{9137EA5F-D45F-4830-BD4B-E942EC3F1A6D}"/>
               </a:ext>
             </a:extLst>
           </p:cNvPr>
@@ -16541,7 +16631,7 @@
           <p:cNvPr id="13" name="">
             <a:extLst xmlns:a="http://schemas.openxmlformats.org/drawingml/2006/main">
               <a:ext uri="{FF2B5EF4-FFF2-40B4-BE49-F238E27FC236}">
-                <a16:creationId xmlns:a16="http://schemas.microsoft.com/office/drawing/2014/main" id="{63F540DD-CB48-4579-A501-26FC3ECE006E}"/>
+                <a16:creationId xmlns:a16="http://schemas.microsoft.com/office/drawing/2014/main" id="{4852D322-1F2A-47F4-9B53-6BC022449C2F}"/>
               </a:ext>
             </a:extLst>
           </p:cNvPr>
@@ -16603,7 +16693,7 @@
           <p:cNvPr id="14" name="">
             <a:extLst xmlns:a="http://schemas.openxmlformats.org/drawingml/2006/main">
               <a:ext uri="{FF2B5EF4-FFF2-40B4-BE49-F238E27FC236}">
-                <a16:creationId xmlns:a16="http://schemas.microsoft.com/office/drawing/2014/main" id="{8CA2852F-657B-4411-8E2F-8B954663C6EB}"/>
+                <a16:creationId xmlns:a16="http://schemas.microsoft.com/office/drawing/2014/main" id="{63A2DF91-B350-4F71-9CCE-9BACFB6E41A0}"/>
               </a:ext>
             </a:extLst>
           </p:cNvPr>
@@ -16665,7 +16755,7 @@
           <p:cNvPr id="15" name="">
             <a:extLst xmlns:a="http://schemas.openxmlformats.org/drawingml/2006/main">
               <a:ext uri="{FF2B5EF4-FFF2-40B4-BE49-F238E27FC236}">
-                <a16:creationId xmlns:a16="http://schemas.microsoft.com/office/drawing/2014/main" id="{D98C3725-D0AA-43E0-BB87-1D1713912A6B}"/>
+                <a16:creationId xmlns:a16="http://schemas.microsoft.com/office/drawing/2014/main" id="{1DA0EA04-4D1D-4DA4-B3AF-EB3EF06921DE}"/>
               </a:ext>
             </a:extLst>
           </p:cNvPr>
@@ -16696,7 +16786,7 @@
           <p:cNvPr id="16" name="">
             <a:extLst xmlns:a="http://schemas.openxmlformats.org/drawingml/2006/main">
               <a:ext uri="{FF2B5EF4-FFF2-40B4-BE49-F238E27FC236}">
-                <a16:creationId xmlns:a16="http://schemas.microsoft.com/office/drawing/2014/main" id="{70393BEA-0994-460C-AEC1-8D76699EF6E1}"/>
+                <a16:creationId xmlns:a16="http://schemas.microsoft.com/office/drawing/2014/main" id="{18F9A1D9-71DB-47A2-96C8-6329DE872DE6}"/>
               </a:ext>
             </a:extLst>
           </p:cNvPr>
@@ -16758,7 +16848,7 @@
           <p:cNvPr id="17" name="">
             <a:extLst xmlns:a="http://schemas.openxmlformats.org/drawingml/2006/main">
               <a:ext uri="{FF2B5EF4-FFF2-40B4-BE49-F238E27FC236}">
-                <a16:creationId xmlns:a16="http://schemas.microsoft.com/office/drawing/2014/main" id="{86868B60-9B3A-4590-BD4E-A879A1A485B4}"/>
+                <a16:creationId xmlns:a16="http://schemas.microsoft.com/office/drawing/2014/main" id="{62FC706E-09A6-429D-A97D-8EE4CF785A8A}"/>
               </a:ext>
             </a:extLst>
           </p:cNvPr>
@@ -16820,7 +16910,7 @@
           <p:cNvPr id="18" name="">
             <a:extLst xmlns:a="http://schemas.openxmlformats.org/drawingml/2006/main">
               <a:ext uri="{FF2B5EF4-FFF2-40B4-BE49-F238E27FC236}">
-                <a16:creationId xmlns:a16="http://schemas.microsoft.com/office/drawing/2014/main" id="{42BDFEC8-E08A-47BF-8852-4007503F5270}"/>
+                <a16:creationId xmlns:a16="http://schemas.microsoft.com/office/drawing/2014/main" id="{D14E1CDD-A2DE-4DD9-866B-FB9670C1E5F0}"/>
               </a:ext>
             </a:extLst>
           </p:cNvPr>
@@ -16882,7 +16972,7 @@
           <p:cNvPr id="19" name="">
             <a:extLst xmlns:a="http://schemas.openxmlformats.org/drawingml/2006/main">
               <a:ext uri="{FF2B5EF4-FFF2-40B4-BE49-F238E27FC236}">
-                <a16:creationId xmlns:a16="http://schemas.microsoft.com/office/drawing/2014/main" id="{1822F0C0-6B8D-4C6C-86A3-16C436310744}"/>
+                <a16:creationId xmlns:a16="http://schemas.microsoft.com/office/drawing/2014/main" id="{24A9511E-D619-4EE7-860F-16605EE35815}"/>
               </a:ext>
             </a:extLst>
           </p:cNvPr>
@@ -16913,7 +17003,7 @@
           <p:cNvPr id="20" name="">
             <a:extLst xmlns:a="http://schemas.openxmlformats.org/drawingml/2006/main">
               <a:ext uri="{FF2B5EF4-FFF2-40B4-BE49-F238E27FC236}">
-                <a16:creationId xmlns:a16="http://schemas.microsoft.com/office/drawing/2014/main" id="{1B6C2235-956F-4EF3-8F0D-D398416E74A1}"/>
+                <a16:creationId xmlns:a16="http://schemas.microsoft.com/office/drawing/2014/main" id="{37579ADB-16B1-4EB0-8F7C-5050B803B412}"/>
               </a:ext>
             </a:extLst>
           </p:cNvPr>
@@ -16975,7 +17065,7 @@
           <p:cNvPr id="21" name="">
             <a:extLst xmlns:a="http://schemas.openxmlformats.org/drawingml/2006/main">
               <a:ext uri="{FF2B5EF4-FFF2-40B4-BE49-F238E27FC236}">
-                <a16:creationId xmlns:a16="http://schemas.microsoft.com/office/drawing/2014/main" id="{68B6F766-E384-4946-BC75-7FAEA72CD339}"/>
+                <a16:creationId xmlns:a16="http://schemas.microsoft.com/office/drawing/2014/main" id="{B7F84FC3-C639-4D7A-A82B-998C0E7012D2}"/>
               </a:ext>
             </a:extLst>
           </p:cNvPr>
@@ -17037,7 +17127,7 @@
           <p:cNvPr id="22" name="">
             <a:extLst xmlns:a="http://schemas.openxmlformats.org/drawingml/2006/main">
               <a:ext uri="{FF2B5EF4-FFF2-40B4-BE49-F238E27FC236}">
-                <a16:creationId xmlns:a16="http://schemas.microsoft.com/office/drawing/2014/main" id="{1C64210C-EFC8-4D92-B1D3-CEC6457C9358}"/>
+                <a16:creationId xmlns:a16="http://schemas.microsoft.com/office/drawing/2014/main" id="{DF1FFDB0-8BBC-44D2-820A-FF0B6CD65DFC}"/>
               </a:ext>
             </a:extLst>
           </p:cNvPr>
@@ -17099,7 +17189,7 @@
           <p:cNvPr id="23" name="">
             <a:extLst xmlns:a="http://schemas.openxmlformats.org/drawingml/2006/main">
               <a:ext uri="{FF2B5EF4-FFF2-40B4-BE49-F238E27FC236}">
-                <a16:creationId xmlns:a16="http://schemas.microsoft.com/office/drawing/2014/main" id="{6F226FBC-2910-41EF-B8AE-377256B3AB42}"/>
+                <a16:creationId xmlns:a16="http://schemas.microsoft.com/office/drawing/2014/main" id="{CC335B0B-C451-4635-BC4F-2531AADD469A}"/>
               </a:ext>
             </a:extLst>
           </p:cNvPr>
@@ -17132,7 +17222,7 @@
           <p:cNvPr id="24" name="">
             <a:extLst xmlns:a="http://schemas.openxmlformats.org/drawingml/2006/main">
               <a:ext uri="{FF2B5EF4-FFF2-40B4-BE49-F238E27FC236}">
-                <a16:creationId xmlns:a16="http://schemas.microsoft.com/office/drawing/2014/main" id="{700576CC-4EB9-45A7-8E7A-D1C675BDCC75}"/>
+                <a16:creationId xmlns:a16="http://schemas.microsoft.com/office/drawing/2014/main" id="{6B510C19-4540-4E06-A7F2-A3E8F520D02F}"/>
               </a:ext>
             </a:extLst>
           </p:cNvPr>
@@ -17194,7 +17284,7 @@
           <p:cNvPr id="25" name="footer-rule-4">
             <a:extLst xmlns:a="http://schemas.openxmlformats.org/drawingml/2006/main">
               <a:ext uri="{FF2B5EF4-FFF2-40B4-BE49-F238E27FC236}">
-                <a16:creationId xmlns:a16="http://schemas.microsoft.com/office/drawing/2014/main" id="{C962899B-FE40-40A2-8A09-A68BC5508568}"/>
+                <a16:creationId xmlns:a16="http://schemas.microsoft.com/office/drawing/2014/main" id="{724D14E2-34E4-40B3-88DC-C16EEBBD98E6}"/>
               </a:ext>
             </a:extLst>
           </p:cNvPr>
@@ -17225,7 +17315,7 @@
           <p:cNvPr id="26" name="footer-label-4">
             <a:extLst xmlns:a="http://schemas.openxmlformats.org/drawingml/2006/main">
               <a:ext uri="{FF2B5EF4-FFF2-40B4-BE49-F238E27FC236}">
-                <a16:creationId xmlns:a16="http://schemas.microsoft.com/office/drawing/2014/main" id="{3AB4DF54-C674-4D3A-9750-A22D22488231}"/>
+                <a16:creationId xmlns:a16="http://schemas.microsoft.com/office/drawing/2014/main" id="{5ECA35FA-FEFD-479F-9CBB-35D93885BD11}"/>
               </a:ext>
             </a:extLst>
           </p:cNvPr>
@@ -17287,7 +17377,7 @@
           <p:cNvPr id="27" name="footer-page-4">
             <a:extLst xmlns:a="http://schemas.openxmlformats.org/drawingml/2006/main">
               <a:ext uri="{FF2B5EF4-FFF2-40B4-BE49-F238E27FC236}">
-                <a16:creationId xmlns:a16="http://schemas.microsoft.com/office/drawing/2014/main" id="{8CBD13CE-DCFD-4A1D-8119-8A1AB5397380}"/>
+                <a16:creationId xmlns:a16="http://schemas.microsoft.com/office/drawing/2014/main" id="{093EA907-9A1D-4056-8E59-9008DB2B2F12}"/>
               </a:ext>
             </a:extLst>
           </p:cNvPr>
@@ -17347,7 +17437,7 @@
     </p:spTree>
     <p:extLst>
       <p:ext uri="{BB962C8B-B14F-4D97-AF65-F5344CB8AC3E}">
-        <p14:creationId xmlns:p14="http://schemas.microsoft.com/office/powerpoint/2010/main" val="1673515504"/>
+        <p14:creationId xmlns:p14="http://schemas.microsoft.com/office/powerpoint/2010/main" val="954556313"/>
       </p:ext>
     </p:extLst>
   </p:cSld>
@@ -17378,7 +17468,7 @@
           <p:cNvPr id="31" name="side-accent-5">
             <a:extLst xmlns:a="http://schemas.openxmlformats.org/drawingml/2006/main">
               <a:ext uri="{FF2B5EF4-FFF2-40B4-BE49-F238E27FC236}">
-                <a16:creationId xmlns:a16="http://schemas.microsoft.com/office/drawing/2014/main" id="{68926CA1-8407-44A7-ACB1-5B17E7BBE723}"/>
+                <a16:creationId xmlns:a16="http://schemas.microsoft.com/office/drawing/2014/main" id="{511A7AC0-45B7-4EB2-ACEC-6757DDDC5C28}"/>
               </a:ext>
             </a:extLst>
           </p:cNvPr>
@@ -17409,7 +17499,7 @@
           <p:cNvPr id="2" name="kicker-5">
             <a:extLst xmlns:a="http://schemas.openxmlformats.org/drawingml/2006/main">
               <a:ext uri="{FF2B5EF4-FFF2-40B4-BE49-F238E27FC236}">
-                <a16:creationId xmlns:a16="http://schemas.microsoft.com/office/drawing/2014/main" id="{C9F6716A-C31E-4420-BA1F-7D6282D75E6D}"/>
+                <a16:creationId xmlns:a16="http://schemas.microsoft.com/office/drawing/2014/main" id="{0E8A9A36-4D62-4E08-A340-5A4F53489466}"/>
               </a:ext>
             </a:extLst>
           </p:cNvPr>
@@ -17471,7 +17561,7 @@
           <p:cNvPr id="3" name="title-5">
             <a:extLst xmlns:a="http://schemas.openxmlformats.org/drawingml/2006/main">
               <a:ext uri="{FF2B5EF4-FFF2-40B4-BE49-F238E27FC236}">
-                <a16:creationId xmlns:a16="http://schemas.microsoft.com/office/drawing/2014/main" id="{D4CE200B-BC7F-485F-92B7-450DA6D77242}"/>
+                <a16:creationId xmlns:a16="http://schemas.microsoft.com/office/drawing/2014/main" id="{F5B2890E-622F-4B96-B429-0C9F4040236A}"/>
               </a:ext>
             </a:extLst>
           </p:cNvPr>
@@ -17533,7 +17623,7 @@
           <p:cNvPr id="4" name="">
             <a:extLst xmlns:a="http://schemas.openxmlformats.org/drawingml/2006/main">
               <a:ext uri="{FF2B5EF4-FFF2-40B4-BE49-F238E27FC236}">
-                <a16:creationId xmlns:a16="http://schemas.microsoft.com/office/drawing/2014/main" id="{94A306F3-9474-4012-B5AA-E765EAF827FE}"/>
+                <a16:creationId xmlns:a16="http://schemas.microsoft.com/office/drawing/2014/main" id="{C2A84E6A-EB4D-47A9-82F4-CB49041E16ED}"/>
               </a:ext>
             </a:extLst>
           </p:cNvPr>
@@ -17595,7 +17685,7 @@
           <p:cNvPr id="5" name="workflow-line">
             <a:extLst xmlns:a="http://schemas.openxmlformats.org/drawingml/2006/main">
               <a:ext uri="{FF2B5EF4-FFF2-40B4-BE49-F238E27FC236}">
-                <a16:creationId xmlns:a16="http://schemas.microsoft.com/office/drawing/2014/main" id="{6CB6E66E-657B-4749-AFCF-78B87D79D600}"/>
+                <a16:creationId xmlns:a16="http://schemas.microsoft.com/office/drawing/2014/main" id="{7A8D3CA6-6EFA-49B2-AEB8-515861F33B55}"/>
               </a:ext>
             </a:extLst>
           </p:cNvPr>
@@ -17626,7 +17716,7 @@
           <p:cNvPr id="6" name="workflow-arrow">
             <a:extLst xmlns:a="http://schemas.openxmlformats.org/drawingml/2006/main">
               <a:ext uri="{FF2B5EF4-FFF2-40B4-BE49-F238E27FC236}">
-                <a16:creationId xmlns:a16="http://schemas.microsoft.com/office/drawing/2014/main" id="{61FEF3F8-C8BE-45AC-A6F2-26D0ED7A4E4B}"/>
+                <a16:creationId xmlns:a16="http://schemas.microsoft.com/office/drawing/2014/main" id="{E631874B-B7C2-404C-B3CB-ECB83BFBE129}"/>
               </a:ext>
             </a:extLst>
           </p:cNvPr>
@@ -17657,7 +17747,7 @@
           <p:cNvPr id="7" name="">
             <a:extLst xmlns:a="http://schemas.openxmlformats.org/drawingml/2006/main">
               <a:ext uri="{FF2B5EF4-FFF2-40B4-BE49-F238E27FC236}">
-                <a16:creationId xmlns:a16="http://schemas.microsoft.com/office/drawing/2014/main" id="{C95D79B2-7869-4500-9FC2-3FD53A30CFB7}"/>
+                <a16:creationId xmlns:a16="http://schemas.microsoft.com/office/drawing/2014/main" id="{3F7AAAE7-5D27-40A4-A468-7095FDFDB69E}"/>
               </a:ext>
             </a:extLst>
           </p:cNvPr>
@@ -17688,7 +17778,7 @@
           <p:cNvPr id="8" name="">
             <a:extLst xmlns:a="http://schemas.openxmlformats.org/drawingml/2006/main">
               <a:ext uri="{FF2B5EF4-FFF2-40B4-BE49-F238E27FC236}">
-                <a16:creationId xmlns:a16="http://schemas.microsoft.com/office/drawing/2014/main" id="{CAEDEC67-FAA4-4297-827A-9FA842BDC817}"/>
+                <a16:creationId xmlns:a16="http://schemas.microsoft.com/office/drawing/2014/main" id="{B0ADA7A3-95F3-4425-9017-6EF1ACB6CC8F}"/>
               </a:ext>
             </a:extLst>
           </p:cNvPr>
@@ -17750,7 +17840,7 @@
           <p:cNvPr id="9" name="">
             <a:extLst xmlns:a="http://schemas.openxmlformats.org/drawingml/2006/main">
               <a:ext uri="{FF2B5EF4-FFF2-40B4-BE49-F238E27FC236}">
-                <a16:creationId xmlns:a16="http://schemas.microsoft.com/office/drawing/2014/main" id="{9DE07F4E-FD7A-4822-99BE-F5A88B0F2696}"/>
+                <a16:creationId xmlns:a16="http://schemas.microsoft.com/office/drawing/2014/main" id="{99C03597-572A-41CA-8DDE-3D520CC318B3}"/>
               </a:ext>
             </a:extLst>
           </p:cNvPr>
@@ -17812,7 +17902,7 @@
           <p:cNvPr id="10" name="">
             <a:extLst xmlns:a="http://schemas.openxmlformats.org/drawingml/2006/main">
               <a:ext uri="{FF2B5EF4-FFF2-40B4-BE49-F238E27FC236}">
-                <a16:creationId xmlns:a16="http://schemas.microsoft.com/office/drawing/2014/main" id="{3A63F34C-6E49-4E73-878B-D831323A174B}"/>
+                <a16:creationId xmlns:a16="http://schemas.microsoft.com/office/drawing/2014/main" id="{E50DD15A-93F6-456B-924A-CE858910E4BE}"/>
               </a:ext>
             </a:extLst>
           </p:cNvPr>
@@ -17874,7 +17964,7 @@
           <p:cNvPr id="11" name="">
             <a:extLst xmlns:a="http://schemas.openxmlformats.org/drawingml/2006/main">
               <a:ext uri="{FF2B5EF4-FFF2-40B4-BE49-F238E27FC236}">
-                <a16:creationId xmlns:a16="http://schemas.microsoft.com/office/drawing/2014/main" id="{8C026761-FD69-41EB-912D-EDF959DAA8B0}"/>
+                <a16:creationId xmlns:a16="http://schemas.microsoft.com/office/drawing/2014/main" id="{F6914BBD-56FA-4ACE-96B6-475618B8678A}"/>
               </a:ext>
             </a:extLst>
           </p:cNvPr>
@@ -17905,7 +17995,7 @@
           <p:cNvPr id="12" name="">
             <a:extLst xmlns:a="http://schemas.openxmlformats.org/drawingml/2006/main">
               <a:ext uri="{FF2B5EF4-FFF2-40B4-BE49-F238E27FC236}">
-                <a16:creationId xmlns:a16="http://schemas.microsoft.com/office/drawing/2014/main" id="{999DDCF1-5B2D-4C6C-9000-C6121AD355D5}"/>
+                <a16:creationId xmlns:a16="http://schemas.microsoft.com/office/drawing/2014/main" id="{EF240E82-C53E-4FB1-AB8F-BCBAE3516597}"/>
               </a:ext>
             </a:extLst>
           </p:cNvPr>
@@ -17967,7 +18057,7 @@
           <p:cNvPr id="13" name="">
             <a:extLst xmlns:a="http://schemas.openxmlformats.org/drawingml/2006/main">
               <a:ext uri="{FF2B5EF4-FFF2-40B4-BE49-F238E27FC236}">
-                <a16:creationId xmlns:a16="http://schemas.microsoft.com/office/drawing/2014/main" id="{13072788-3F6F-4D83-9D84-2759CF92CF72}"/>
+                <a16:creationId xmlns:a16="http://schemas.microsoft.com/office/drawing/2014/main" id="{6AA50AA9-265B-45F1-8CA5-776E6913D1AE}"/>
               </a:ext>
             </a:extLst>
           </p:cNvPr>
@@ -18029,7 +18119,7 @@
           <p:cNvPr id="14" name="">
             <a:extLst xmlns:a="http://schemas.openxmlformats.org/drawingml/2006/main">
               <a:ext uri="{FF2B5EF4-FFF2-40B4-BE49-F238E27FC236}">
-                <a16:creationId xmlns:a16="http://schemas.microsoft.com/office/drawing/2014/main" id="{2CADEB66-43AD-40B7-BC10-B05CA0EE13D7}"/>
+                <a16:creationId xmlns:a16="http://schemas.microsoft.com/office/drawing/2014/main" id="{C7C7F78F-99D6-4F4E-850F-A1B1F3174E52}"/>
               </a:ext>
             </a:extLst>
           </p:cNvPr>
@@ -18091,7 +18181,7 @@
           <p:cNvPr id="15" name="">
             <a:extLst xmlns:a="http://schemas.openxmlformats.org/drawingml/2006/main">
               <a:ext uri="{FF2B5EF4-FFF2-40B4-BE49-F238E27FC236}">
-                <a16:creationId xmlns:a16="http://schemas.microsoft.com/office/drawing/2014/main" id="{48B2CFFA-8456-42A2-9983-2C05D7740FA4}"/>
+                <a16:creationId xmlns:a16="http://schemas.microsoft.com/office/drawing/2014/main" id="{E671B7E9-A435-4109-9581-EC1355588EC8}"/>
               </a:ext>
             </a:extLst>
           </p:cNvPr>
@@ -18122,7 +18212,7 @@
           <p:cNvPr id="16" name="">
             <a:extLst xmlns:a="http://schemas.openxmlformats.org/drawingml/2006/main">
               <a:ext uri="{FF2B5EF4-FFF2-40B4-BE49-F238E27FC236}">
-                <a16:creationId xmlns:a16="http://schemas.microsoft.com/office/drawing/2014/main" id="{197FAB4F-160A-47D5-8366-51134DC8CF40}"/>
+                <a16:creationId xmlns:a16="http://schemas.microsoft.com/office/drawing/2014/main" id="{F174C69B-F5B3-4B98-8F27-2C669F2A048C}"/>
               </a:ext>
             </a:extLst>
           </p:cNvPr>
@@ -18184,7 +18274,7 @@
           <p:cNvPr id="17" name="">
             <a:extLst xmlns:a="http://schemas.openxmlformats.org/drawingml/2006/main">
               <a:ext uri="{FF2B5EF4-FFF2-40B4-BE49-F238E27FC236}">
-                <a16:creationId xmlns:a16="http://schemas.microsoft.com/office/drawing/2014/main" id="{281D034D-F365-49CC-BDCE-15B6FAD9DBCC}"/>
+                <a16:creationId xmlns:a16="http://schemas.microsoft.com/office/drawing/2014/main" id="{179B9A51-71EC-46D7-8382-032CB31F1E67}"/>
               </a:ext>
             </a:extLst>
           </p:cNvPr>
@@ -18246,7 +18336,7 @@
           <p:cNvPr id="18" name="">
             <a:extLst xmlns:a="http://schemas.openxmlformats.org/drawingml/2006/main">
               <a:ext uri="{FF2B5EF4-FFF2-40B4-BE49-F238E27FC236}">
-                <a16:creationId xmlns:a16="http://schemas.microsoft.com/office/drawing/2014/main" id="{10C67D32-CCFE-4CB9-9E5E-3C8FBEFD4571}"/>
+                <a16:creationId xmlns:a16="http://schemas.microsoft.com/office/drawing/2014/main" id="{CAB7D6D5-C0D7-4547-B20E-B48DAA3657C5}"/>
               </a:ext>
             </a:extLst>
           </p:cNvPr>
@@ -18308,7 +18398,7 @@
           <p:cNvPr id="19" name="">
             <a:extLst xmlns:a="http://schemas.openxmlformats.org/drawingml/2006/main">
               <a:ext uri="{FF2B5EF4-FFF2-40B4-BE49-F238E27FC236}">
-                <a16:creationId xmlns:a16="http://schemas.microsoft.com/office/drawing/2014/main" id="{C527E59B-0822-4430-B763-D2003D9EB88B}"/>
+                <a16:creationId xmlns:a16="http://schemas.microsoft.com/office/drawing/2014/main" id="{D9A6B8DC-DD34-41E7-B543-7197162D37F2}"/>
               </a:ext>
             </a:extLst>
           </p:cNvPr>
@@ -18339,7 +18429,7 @@
           <p:cNvPr id="20" name="">
             <a:extLst xmlns:a="http://schemas.openxmlformats.org/drawingml/2006/main">
               <a:ext uri="{FF2B5EF4-FFF2-40B4-BE49-F238E27FC236}">
-                <a16:creationId xmlns:a16="http://schemas.microsoft.com/office/drawing/2014/main" id="{4FE2639F-86F0-4A30-975F-F9440EBFB082}"/>
+                <a16:creationId xmlns:a16="http://schemas.microsoft.com/office/drawing/2014/main" id="{8E93CCE0-92CB-4009-B83C-1454DBD0DBAD}"/>
               </a:ext>
             </a:extLst>
           </p:cNvPr>
@@ -18401,7 +18491,7 @@
           <p:cNvPr id="21" name="">
             <a:extLst xmlns:a="http://schemas.openxmlformats.org/drawingml/2006/main">
               <a:ext uri="{FF2B5EF4-FFF2-40B4-BE49-F238E27FC236}">
-                <a16:creationId xmlns:a16="http://schemas.microsoft.com/office/drawing/2014/main" id="{EE4C5C95-8188-462B-9F53-C9C37AB14053}"/>
+                <a16:creationId xmlns:a16="http://schemas.microsoft.com/office/drawing/2014/main" id="{E95E446A-7637-4C47-A494-DDF8DF6DAEA2}"/>
               </a:ext>
             </a:extLst>
           </p:cNvPr>
@@ -18463,7 +18553,7 @@
           <p:cNvPr id="22" name="">
             <a:extLst xmlns:a="http://schemas.openxmlformats.org/drawingml/2006/main">
               <a:ext uri="{FF2B5EF4-FFF2-40B4-BE49-F238E27FC236}">
-                <a16:creationId xmlns:a16="http://schemas.microsoft.com/office/drawing/2014/main" id="{4EA66755-7962-4CF8-B971-EC0BC632B67B}"/>
+                <a16:creationId xmlns:a16="http://schemas.microsoft.com/office/drawing/2014/main" id="{83C786DC-90D7-4710-AECB-4D70B34E41CE}"/>
               </a:ext>
             </a:extLst>
           </p:cNvPr>
@@ -18525,7 +18615,7 @@
           <p:cNvPr id="23" name="">
             <a:extLst xmlns:a="http://schemas.openxmlformats.org/drawingml/2006/main">
               <a:ext uri="{FF2B5EF4-FFF2-40B4-BE49-F238E27FC236}">
-                <a16:creationId xmlns:a16="http://schemas.microsoft.com/office/drawing/2014/main" id="{71581D7F-4FE1-4BA2-9CEB-D506A3DB96E7}"/>
+                <a16:creationId xmlns:a16="http://schemas.microsoft.com/office/drawing/2014/main" id="{A4912A10-F608-49C0-8D7A-6C0BECBD2E75}"/>
               </a:ext>
             </a:extLst>
           </p:cNvPr>
@@ -18556,7 +18646,7 @@
           <p:cNvPr id="24" name="">
             <a:extLst xmlns:a="http://schemas.openxmlformats.org/drawingml/2006/main">
               <a:ext uri="{FF2B5EF4-FFF2-40B4-BE49-F238E27FC236}">
-                <a16:creationId xmlns:a16="http://schemas.microsoft.com/office/drawing/2014/main" id="{9ABFE1AE-D14E-4D75-8B9B-0DA1881A8EB9}"/>
+                <a16:creationId xmlns:a16="http://schemas.microsoft.com/office/drawing/2014/main" id="{E8F01206-B127-4E85-8D31-8EBB2F353681}"/>
               </a:ext>
             </a:extLst>
           </p:cNvPr>
@@ -18618,7 +18708,7 @@
           <p:cNvPr id="25" name="">
             <a:extLst xmlns:a="http://schemas.openxmlformats.org/drawingml/2006/main">
               <a:ext uri="{FF2B5EF4-FFF2-40B4-BE49-F238E27FC236}">
-                <a16:creationId xmlns:a16="http://schemas.microsoft.com/office/drawing/2014/main" id="{D2E98963-1218-4BD5-9B3C-885DD50BC1C2}"/>
+                <a16:creationId xmlns:a16="http://schemas.microsoft.com/office/drawing/2014/main" id="{F126EAF8-687B-4419-ABC0-89B877193582}"/>
               </a:ext>
             </a:extLst>
           </p:cNvPr>
@@ -18680,7 +18770,7 @@
           <p:cNvPr id="26" name="">
             <a:extLst xmlns:a="http://schemas.openxmlformats.org/drawingml/2006/main">
               <a:ext uri="{FF2B5EF4-FFF2-40B4-BE49-F238E27FC236}">
-                <a16:creationId xmlns:a16="http://schemas.microsoft.com/office/drawing/2014/main" id="{40ECA634-3ABF-461F-B4D7-B49F1311133A}"/>
+                <a16:creationId xmlns:a16="http://schemas.microsoft.com/office/drawing/2014/main" id="{F752ECB7-53CC-4737-9BC7-E637A7D7741F}"/>
               </a:ext>
             </a:extLst>
           </p:cNvPr>
@@ -18742,7 +18832,7 @@
           <p:cNvPr id="27" name="">
             <a:extLst xmlns:a="http://schemas.openxmlformats.org/drawingml/2006/main">
               <a:ext uri="{FF2B5EF4-FFF2-40B4-BE49-F238E27FC236}">
-                <a16:creationId xmlns:a16="http://schemas.microsoft.com/office/drawing/2014/main" id="{11AF99EA-BAB1-4564-87BF-C86042B1FFBE}"/>
+                <a16:creationId xmlns:a16="http://schemas.microsoft.com/office/drawing/2014/main" id="{AA077182-790B-4C7A-9696-820D3F51A1CA}"/>
               </a:ext>
             </a:extLst>
           </p:cNvPr>
@@ -18804,7 +18894,7 @@
           <p:cNvPr id="28" name="footer-rule-5">
             <a:extLst xmlns:a="http://schemas.openxmlformats.org/drawingml/2006/main">
               <a:ext uri="{FF2B5EF4-FFF2-40B4-BE49-F238E27FC236}">
-                <a16:creationId xmlns:a16="http://schemas.microsoft.com/office/drawing/2014/main" id="{AA3C3B0B-C034-4F5C-BCE6-7986BF80B3F2}"/>
+                <a16:creationId xmlns:a16="http://schemas.microsoft.com/office/drawing/2014/main" id="{CB0E1738-9779-4CB1-B75E-9DFD870558A9}"/>
               </a:ext>
             </a:extLst>
           </p:cNvPr>
@@ -18835,7 +18925,7 @@
           <p:cNvPr id="29" name="footer-label-5">
             <a:extLst xmlns:a="http://schemas.openxmlformats.org/drawingml/2006/main">
               <a:ext uri="{FF2B5EF4-FFF2-40B4-BE49-F238E27FC236}">
-                <a16:creationId xmlns:a16="http://schemas.microsoft.com/office/drawing/2014/main" id="{3E4B7D0E-3AF8-4AA1-8737-14B9EE4A576F}"/>
+                <a16:creationId xmlns:a16="http://schemas.microsoft.com/office/drawing/2014/main" id="{5AF53DBA-9D83-4DEF-8F4D-CB5593D9DF52}"/>
               </a:ext>
             </a:extLst>
           </p:cNvPr>
@@ -18897,7 +18987,7 @@
           <p:cNvPr id="30" name="footer-page-5">
             <a:extLst xmlns:a="http://schemas.openxmlformats.org/drawingml/2006/main">
               <a:ext uri="{FF2B5EF4-FFF2-40B4-BE49-F238E27FC236}">
-                <a16:creationId xmlns:a16="http://schemas.microsoft.com/office/drawing/2014/main" id="{5F96EAB1-F01F-4DF7-9BC1-EAE84CBF0768}"/>
+                <a16:creationId xmlns:a16="http://schemas.microsoft.com/office/drawing/2014/main" id="{726FC2EA-43B1-4096-8F1C-2754C9CB6392}"/>
               </a:ext>
             </a:extLst>
           </p:cNvPr>
@@ -18957,7 +19047,7 @@
     </p:spTree>
     <p:extLst>
       <p:ext uri="{BB962C8B-B14F-4D97-AF65-F5344CB8AC3E}">
-        <p14:creationId xmlns:p14="http://schemas.microsoft.com/office/powerpoint/2010/main" val="127235886"/>
+        <p14:creationId xmlns:p14="http://schemas.microsoft.com/office/powerpoint/2010/main" val="642301529"/>
       </p:ext>
     </p:extLst>
   </p:cSld>
@@ -18988,7 +19078,7 @@
           <p:cNvPr id="22" name="side-accent-6">
             <a:extLst xmlns:a="http://schemas.openxmlformats.org/drawingml/2006/main">
               <a:ext uri="{FF2B5EF4-FFF2-40B4-BE49-F238E27FC236}">
-                <a16:creationId xmlns:a16="http://schemas.microsoft.com/office/drawing/2014/main" id="{FD2F40DD-59F5-4471-B18C-DA25F77F7454}"/>
+                <a16:creationId xmlns:a16="http://schemas.microsoft.com/office/drawing/2014/main" id="{9421C0EA-E239-411C-BE73-23846B24D04A}"/>
               </a:ext>
             </a:extLst>
           </p:cNvPr>
@@ -19019,7 +19109,7 @@
           <p:cNvPr id="2" name="kicker-6">
             <a:extLst xmlns:a="http://schemas.openxmlformats.org/drawingml/2006/main">
               <a:ext uri="{FF2B5EF4-FFF2-40B4-BE49-F238E27FC236}">
-                <a16:creationId xmlns:a16="http://schemas.microsoft.com/office/drawing/2014/main" id="{D26EFAF9-E653-455D-B9E8-3C28252084BE}"/>
+                <a16:creationId xmlns:a16="http://schemas.microsoft.com/office/drawing/2014/main" id="{82E9ED72-8C97-43EE-9CC1-6D68B54281FB}"/>
               </a:ext>
             </a:extLst>
           </p:cNvPr>
@@ -19081,7 +19171,7 @@
           <p:cNvPr id="3" name="title-6">
             <a:extLst xmlns:a="http://schemas.openxmlformats.org/drawingml/2006/main">
               <a:ext uri="{FF2B5EF4-FFF2-40B4-BE49-F238E27FC236}">
-                <a16:creationId xmlns:a16="http://schemas.microsoft.com/office/drawing/2014/main" id="{0B23B70C-191F-4403-B27D-62BA91425582}"/>
+                <a16:creationId xmlns:a16="http://schemas.microsoft.com/office/drawing/2014/main" id="{92624DA7-511A-4D18-B4DE-3EBE032B441C}"/>
               </a:ext>
             </a:extLst>
           </p:cNvPr>
@@ -19143,7 +19233,7 @@
           <p:cNvPr id="4" name="">
             <a:extLst xmlns:a="http://schemas.openxmlformats.org/drawingml/2006/main">
               <a:ext uri="{FF2B5EF4-FFF2-40B4-BE49-F238E27FC236}">
-                <a16:creationId xmlns:a16="http://schemas.microsoft.com/office/drawing/2014/main" id="{8E798583-E733-4132-997F-D0255CB6CDBA}"/>
+                <a16:creationId xmlns:a16="http://schemas.microsoft.com/office/drawing/2014/main" id="{AFE9A20C-3CC0-4E6D-9436-1488B04D5533}"/>
               </a:ext>
             </a:extLst>
           </p:cNvPr>
@@ -19205,7 +19295,7 @@
           <p:cNvPr id="5" name="">
             <a:extLst xmlns:a="http://schemas.openxmlformats.org/drawingml/2006/main">
               <a:ext uri="{FF2B5EF4-FFF2-40B4-BE49-F238E27FC236}">
-                <a16:creationId xmlns:a16="http://schemas.microsoft.com/office/drawing/2014/main" id="{8B18D433-6544-4989-A9DE-574B61BF01CB}"/>
+                <a16:creationId xmlns:a16="http://schemas.microsoft.com/office/drawing/2014/main" id="{81AC82DD-CAB5-432E-85D3-7491D845796A}"/>
               </a:ext>
             </a:extLst>
           </p:cNvPr>
@@ -19267,7 +19357,7 @@
           <p:cNvPr id="6" name="">
             <a:extLst xmlns:a="http://schemas.openxmlformats.org/drawingml/2006/main">
               <a:ext uri="{FF2B5EF4-FFF2-40B4-BE49-F238E27FC236}">
-                <a16:creationId xmlns:a16="http://schemas.microsoft.com/office/drawing/2014/main" id="{930F8681-FF26-436B-A0E6-AB4BB7B0B10C}"/>
+                <a16:creationId xmlns:a16="http://schemas.microsoft.com/office/drawing/2014/main" id="{233C0B55-6734-4B9E-BE11-9182296DFD1E}"/>
               </a:ext>
             </a:extLst>
           </p:cNvPr>
@@ -19329,7 +19419,7 @@
           <p:cNvPr id="7" name="">
             <a:extLst xmlns:a="http://schemas.openxmlformats.org/drawingml/2006/main">
               <a:ext uri="{FF2B5EF4-FFF2-40B4-BE49-F238E27FC236}">
-                <a16:creationId xmlns:a16="http://schemas.microsoft.com/office/drawing/2014/main" id="{958E17F0-FC87-4EBF-ABB9-AE3DF2F161A6}"/>
+                <a16:creationId xmlns:a16="http://schemas.microsoft.com/office/drawing/2014/main" id="{72321C85-D577-42B7-B965-42065F51F9B3}"/>
               </a:ext>
             </a:extLst>
           </p:cNvPr>
@@ -19360,7 +19450,7 @@
           <p:cNvPr id="8" name="">
             <a:extLst xmlns:a="http://schemas.openxmlformats.org/drawingml/2006/main">
               <a:ext uri="{FF2B5EF4-FFF2-40B4-BE49-F238E27FC236}">
-                <a16:creationId xmlns:a16="http://schemas.microsoft.com/office/drawing/2014/main" id="{9EBA14CA-1855-496B-8599-22A802A75A6A}"/>
+                <a16:creationId xmlns:a16="http://schemas.microsoft.com/office/drawing/2014/main" id="{74EA3A36-C03F-4818-A6F8-E9B1230781B2}"/>
               </a:ext>
             </a:extLst>
           </p:cNvPr>
@@ -19449,7 +19539,7 @@
           <p:cNvPr id="9" name="">
             <a:extLst xmlns:a="http://schemas.openxmlformats.org/drawingml/2006/main">
               <a:ext uri="{FF2B5EF4-FFF2-40B4-BE49-F238E27FC236}">
-                <a16:creationId xmlns:a16="http://schemas.microsoft.com/office/drawing/2014/main" id="{B2BD9183-EF3C-4D9E-AE72-117C17472835}"/>
+                <a16:creationId xmlns:a16="http://schemas.microsoft.com/office/drawing/2014/main" id="{FABF256D-D2FE-4B72-9C26-D5FEC272C24F}"/>
               </a:ext>
             </a:extLst>
           </p:cNvPr>
@@ -19511,7 +19601,7 @@
           <p:cNvPr id="10" name="">
             <a:extLst xmlns:a="http://schemas.openxmlformats.org/drawingml/2006/main">
               <a:ext uri="{FF2B5EF4-FFF2-40B4-BE49-F238E27FC236}">
-                <a16:creationId xmlns:a16="http://schemas.microsoft.com/office/drawing/2014/main" id="{35CF48C8-ED0B-46BD-BCA7-E8862B3F430B}"/>
+                <a16:creationId xmlns:a16="http://schemas.microsoft.com/office/drawing/2014/main" id="{4B8D07D9-B257-482D-8E9F-AE4C8005F99A}"/>
               </a:ext>
             </a:extLst>
           </p:cNvPr>
@@ -19573,7 +19663,7 @@
           <p:cNvPr id="11" name="">
             <a:extLst xmlns:a="http://schemas.openxmlformats.org/drawingml/2006/main">
               <a:ext uri="{FF2B5EF4-FFF2-40B4-BE49-F238E27FC236}">
-                <a16:creationId xmlns:a16="http://schemas.microsoft.com/office/drawing/2014/main" id="{02122303-42A5-4171-B2EF-BB914B9C77AF}"/>
+                <a16:creationId xmlns:a16="http://schemas.microsoft.com/office/drawing/2014/main" id="{EEAEEFAC-378F-4557-BFA1-442FCC48028D}"/>
               </a:ext>
             </a:extLst>
           </p:cNvPr>
@@ -19604,7 +19694,7 @@
           <p:cNvPr id="12" name="">
             <a:extLst xmlns:a="http://schemas.openxmlformats.org/drawingml/2006/main">
               <a:ext uri="{FF2B5EF4-FFF2-40B4-BE49-F238E27FC236}">
-                <a16:creationId xmlns:a16="http://schemas.microsoft.com/office/drawing/2014/main" id="{F09EB690-B7B7-44DC-95DE-667A5FBEBC9D}"/>
+                <a16:creationId xmlns:a16="http://schemas.microsoft.com/office/drawing/2014/main" id="{FDC0B3F3-13C1-437D-8859-26B64563092F}"/>
               </a:ext>
             </a:extLst>
           </p:cNvPr>
@@ -19693,7 +19783,7 @@
           <p:cNvPr id="13" name="">
             <a:extLst xmlns:a="http://schemas.openxmlformats.org/drawingml/2006/main">
               <a:ext uri="{FF2B5EF4-FFF2-40B4-BE49-F238E27FC236}">
-                <a16:creationId xmlns:a16="http://schemas.microsoft.com/office/drawing/2014/main" id="{5998BD44-FC6A-4313-A94C-3477701331D3}"/>
+                <a16:creationId xmlns:a16="http://schemas.microsoft.com/office/drawing/2014/main" id="{7E13F828-DD13-4E7C-B1CF-A4AC06BED53B}"/>
               </a:ext>
             </a:extLst>
           </p:cNvPr>
@@ -19755,7 +19845,7 @@
           <p:cNvPr id="14" name="">
             <a:extLst xmlns:a="http://schemas.openxmlformats.org/drawingml/2006/main">
               <a:ext uri="{FF2B5EF4-FFF2-40B4-BE49-F238E27FC236}">
-                <a16:creationId xmlns:a16="http://schemas.microsoft.com/office/drawing/2014/main" id="{087E6517-63D2-410E-A37F-4868884CFB6C}"/>
+                <a16:creationId xmlns:a16="http://schemas.microsoft.com/office/drawing/2014/main" id="{0F331190-1D44-4445-8B6A-45149C51E64A}"/>
               </a:ext>
             </a:extLst>
           </p:cNvPr>
@@ -19817,7 +19907,7 @@
           <p:cNvPr id="15" name="">
             <a:extLst xmlns:a="http://schemas.openxmlformats.org/drawingml/2006/main">
               <a:ext uri="{FF2B5EF4-FFF2-40B4-BE49-F238E27FC236}">
-                <a16:creationId xmlns:a16="http://schemas.microsoft.com/office/drawing/2014/main" id="{739AD4E8-6721-4EE0-9933-E303741922DD}"/>
+                <a16:creationId xmlns:a16="http://schemas.microsoft.com/office/drawing/2014/main" id="{73AB76AB-D5CE-4216-9779-DC935E9D9C8F}"/>
               </a:ext>
             </a:extLst>
           </p:cNvPr>
@@ -19848,7 +19938,7 @@
           <p:cNvPr id="16" name="">
             <a:extLst xmlns:a="http://schemas.openxmlformats.org/drawingml/2006/main">
               <a:ext uri="{FF2B5EF4-FFF2-40B4-BE49-F238E27FC236}">
-                <a16:creationId xmlns:a16="http://schemas.microsoft.com/office/drawing/2014/main" id="{09EDC4ED-95DC-4094-AF21-F0110525811D}"/>
+                <a16:creationId xmlns:a16="http://schemas.microsoft.com/office/drawing/2014/main" id="{83914221-AEF9-4C59-AB88-46A2A2959DEB}"/>
               </a:ext>
             </a:extLst>
           </p:cNvPr>
@@ -19937,7 +20027,7 @@
           <p:cNvPr id="17" name="">
             <a:extLst xmlns:a="http://schemas.openxmlformats.org/drawingml/2006/main">
               <a:ext uri="{FF2B5EF4-FFF2-40B4-BE49-F238E27FC236}">
-                <a16:creationId xmlns:a16="http://schemas.microsoft.com/office/drawing/2014/main" id="{705F3508-F49E-4F8E-A498-0F4A86F2F018}"/>
+                <a16:creationId xmlns:a16="http://schemas.microsoft.com/office/drawing/2014/main" id="{1AD71BC0-B928-4E2F-8684-F2FE68625E49}"/>
               </a:ext>
             </a:extLst>
           </p:cNvPr>
@@ -19970,7 +20060,7 @@
           <p:cNvPr id="18" name="">
             <a:extLst xmlns:a="http://schemas.openxmlformats.org/drawingml/2006/main">
               <a:ext uri="{FF2B5EF4-FFF2-40B4-BE49-F238E27FC236}">
-                <a16:creationId xmlns:a16="http://schemas.microsoft.com/office/drawing/2014/main" id="{595EC03C-A9A9-4B25-8F8A-FA487E313610}"/>
+                <a16:creationId xmlns:a16="http://schemas.microsoft.com/office/drawing/2014/main" id="{D471BA59-6047-485B-A6A0-15A8DBF8CF43}"/>
               </a:ext>
             </a:extLst>
           </p:cNvPr>
@@ -20059,7 +20149,7 @@
           <p:cNvPr id="19" name="footer-rule-6">
             <a:extLst xmlns:a="http://schemas.openxmlformats.org/drawingml/2006/main">
               <a:ext uri="{FF2B5EF4-FFF2-40B4-BE49-F238E27FC236}">
-                <a16:creationId xmlns:a16="http://schemas.microsoft.com/office/drawing/2014/main" id="{33A3442F-6410-43EC-81B4-B45375EE7143}"/>
+                <a16:creationId xmlns:a16="http://schemas.microsoft.com/office/drawing/2014/main" id="{73513B1A-EFFF-4E94-AB76-4829E998B201}"/>
               </a:ext>
             </a:extLst>
           </p:cNvPr>
@@ -20090,7 +20180,7 @@
           <p:cNvPr id="20" name="footer-label-6">
             <a:extLst xmlns:a="http://schemas.openxmlformats.org/drawingml/2006/main">
               <a:ext uri="{FF2B5EF4-FFF2-40B4-BE49-F238E27FC236}">
-                <a16:creationId xmlns:a16="http://schemas.microsoft.com/office/drawing/2014/main" id="{6C7230D1-4BC9-4150-94D5-2E0E87925A2F}"/>
+                <a16:creationId xmlns:a16="http://schemas.microsoft.com/office/drawing/2014/main" id="{E00A64EB-4AE1-49AC-AAAF-94CE248DECB0}"/>
               </a:ext>
             </a:extLst>
           </p:cNvPr>
@@ -20152,7 +20242,7 @@
           <p:cNvPr id="21" name="footer-page-6">
             <a:extLst xmlns:a="http://schemas.openxmlformats.org/drawingml/2006/main">
               <a:ext uri="{FF2B5EF4-FFF2-40B4-BE49-F238E27FC236}">
-                <a16:creationId xmlns:a16="http://schemas.microsoft.com/office/drawing/2014/main" id="{80E60C70-B2D3-419B-B5D8-5A5F0E2422BF}"/>
+                <a16:creationId xmlns:a16="http://schemas.microsoft.com/office/drawing/2014/main" id="{2AFB564C-1CF3-4BEB-981A-EF66301598FC}"/>
               </a:ext>
             </a:extLst>
           </p:cNvPr>
@@ -20212,7 +20302,7 @@
     </p:spTree>
     <p:extLst>
       <p:ext uri="{BB962C8B-B14F-4D97-AF65-F5344CB8AC3E}">
-        <p14:creationId xmlns:p14="http://schemas.microsoft.com/office/powerpoint/2010/main" val="803117463"/>
+        <p14:creationId xmlns:p14="http://schemas.microsoft.com/office/powerpoint/2010/main" val="1518142344"/>
       </p:ext>
     </p:extLst>
   </p:cSld>
@@ -20243,7 +20333,7 @@
           <p:cNvPr id="28" name="side-accent-7">
             <a:extLst xmlns:a="http://schemas.openxmlformats.org/drawingml/2006/main">
               <a:ext uri="{FF2B5EF4-FFF2-40B4-BE49-F238E27FC236}">
-                <a16:creationId xmlns:a16="http://schemas.microsoft.com/office/drawing/2014/main" id="{2A78D2FB-BF7A-4FE9-BCBD-16F59CAB9763}"/>
+                <a16:creationId xmlns:a16="http://schemas.microsoft.com/office/drawing/2014/main" id="{9CD1C123-8AE2-48A0-B6AE-36A0CA8CF167}"/>
               </a:ext>
             </a:extLst>
           </p:cNvPr>
@@ -20274,7 +20364,7 @@
           <p:cNvPr id="2" name="kicker-7">
             <a:extLst xmlns:a="http://schemas.openxmlformats.org/drawingml/2006/main">
               <a:ext uri="{FF2B5EF4-FFF2-40B4-BE49-F238E27FC236}">
-                <a16:creationId xmlns:a16="http://schemas.microsoft.com/office/drawing/2014/main" id="{3B84D24B-7560-430F-9177-F81DCFF5D939}"/>
+                <a16:creationId xmlns:a16="http://schemas.microsoft.com/office/drawing/2014/main" id="{16DE649A-20FF-4B4E-9B75-5091FAB9A59F}"/>
               </a:ext>
             </a:extLst>
           </p:cNvPr>
@@ -20336,7 +20426,7 @@
           <p:cNvPr id="3" name="title-7">
             <a:extLst xmlns:a="http://schemas.openxmlformats.org/drawingml/2006/main">
               <a:ext uri="{FF2B5EF4-FFF2-40B4-BE49-F238E27FC236}">
-                <a16:creationId xmlns:a16="http://schemas.microsoft.com/office/drawing/2014/main" id="{C741A931-E4BF-48F2-9F7B-B5147E6C6DBD}"/>
+                <a16:creationId xmlns:a16="http://schemas.microsoft.com/office/drawing/2014/main" id="{7C8D752C-224D-48ED-B882-D6D3C869DF5D}"/>
               </a:ext>
             </a:extLst>
           </p:cNvPr>
@@ -20398,7 +20488,7 @@
           <p:cNvPr id="4" name="">
             <a:extLst xmlns:a="http://schemas.openxmlformats.org/drawingml/2006/main">
               <a:ext uri="{FF2B5EF4-FFF2-40B4-BE49-F238E27FC236}">
-                <a16:creationId xmlns:a16="http://schemas.microsoft.com/office/drawing/2014/main" id="{3C937F02-917A-4CD9-9573-4F72B9583767}"/>
+                <a16:creationId xmlns:a16="http://schemas.microsoft.com/office/drawing/2014/main" id="{D553E51C-294E-4952-8D5B-DFC672E16459}"/>
               </a:ext>
             </a:extLst>
           </p:cNvPr>
@@ -20460,7 +20550,7 @@
           <p:cNvPr id="5" name="">
             <a:extLst xmlns:a="http://schemas.openxmlformats.org/drawingml/2006/main">
               <a:ext uri="{FF2B5EF4-FFF2-40B4-BE49-F238E27FC236}">
-                <a16:creationId xmlns:a16="http://schemas.microsoft.com/office/drawing/2014/main" id="{CC13C44E-9994-40E2-9C58-7A9CB3F7A2C5}"/>
+                <a16:creationId xmlns:a16="http://schemas.microsoft.com/office/drawing/2014/main" id="{82C730EC-90E4-4027-83BD-7C8CBE64318D}"/>
               </a:ext>
             </a:extLst>
           </p:cNvPr>
@@ -20491,7 +20581,7 @@
           <p:cNvPr id="6" name="">
             <a:extLst xmlns:a="http://schemas.openxmlformats.org/drawingml/2006/main">
               <a:ext uri="{FF2B5EF4-FFF2-40B4-BE49-F238E27FC236}">
-                <a16:creationId xmlns:a16="http://schemas.microsoft.com/office/drawing/2014/main" id="{E89CBFCC-2E04-4725-B7B1-86BD15D34C37}"/>
+                <a16:creationId xmlns:a16="http://schemas.microsoft.com/office/drawing/2014/main" id="{0C4D8879-AA7B-45C1-AA86-3C9C6AB65466}"/>
               </a:ext>
             </a:extLst>
           </p:cNvPr>
@@ -20553,7 +20643,7 @@
           <p:cNvPr id="7" name="">
             <a:extLst xmlns:a="http://schemas.openxmlformats.org/drawingml/2006/main">
               <a:ext uri="{FF2B5EF4-FFF2-40B4-BE49-F238E27FC236}">
-                <a16:creationId xmlns:a16="http://schemas.microsoft.com/office/drawing/2014/main" id="{8F733E21-9A66-4BE5-9BDA-398E3DF0ADE7}"/>
+                <a16:creationId xmlns:a16="http://schemas.microsoft.com/office/drawing/2014/main" id="{66607D71-3944-4487-8BDC-C79469D867A4}"/>
               </a:ext>
             </a:extLst>
           </p:cNvPr>
@@ -20615,7 +20705,7 @@
           <p:cNvPr id="8" name="">
             <a:extLst xmlns:a="http://schemas.openxmlformats.org/drawingml/2006/main">
               <a:ext uri="{FF2B5EF4-FFF2-40B4-BE49-F238E27FC236}">
-                <a16:creationId xmlns:a16="http://schemas.microsoft.com/office/drawing/2014/main" id="{B730C2F6-FF00-488B-850F-E356F29142A5}"/>
+                <a16:creationId xmlns:a16="http://schemas.microsoft.com/office/drawing/2014/main" id="{3FEDCB8A-26C4-4C9F-A585-7DAE4360F362}"/>
               </a:ext>
             </a:extLst>
           </p:cNvPr>
@@ -20677,7 +20767,7 @@
           <p:cNvPr id="9" name="">
             <a:extLst xmlns:a="http://schemas.openxmlformats.org/drawingml/2006/main">
               <a:ext uri="{FF2B5EF4-FFF2-40B4-BE49-F238E27FC236}">
-                <a16:creationId xmlns:a16="http://schemas.microsoft.com/office/drawing/2014/main" id="{17848D15-D4F2-49CD-A3BB-11FE33031491}"/>
+                <a16:creationId xmlns:a16="http://schemas.microsoft.com/office/drawing/2014/main" id="{33DE8D5C-72AA-4249-AD26-79F7ED2F7D24}"/>
               </a:ext>
             </a:extLst>
           </p:cNvPr>
@@ -20708,7 +20798,7 @@
           <p:cNvPr id="10" name="">
             <a:extLst xmlns:a="http://schemas.openxmlformats.org/drawingml/2006/main">
               <a:ext uri="{FF2B5EF4-FFF2-40B4-BE49-F238E27FC236}">
-                <a16:creationId xmlns:a16="http://schemas.microsoft.com/office/drawing/2014/main" id="{34A72051-64FF-4D6B-A2C2-0B12379960AF}"/>
+                <a16:creationId xmlns:a16="http://schemas.microsoft.com/office/drawing/2014/main" id="{2CD6CD00-CC30-4F41-97DE-C6938EE942B5}"/>
               </a:ext>
             </a:extLst>
           </p:cNvPr>
@@ -20770,7 +20860,7 @@
           <p:cNvPr id="11" name="">
             <a:extLst xmlns:a="http://schemas.openxmlformats.org/drawingml/2006/main">
               <a:ext uri="{FF2B5EF4-FFF2-40B4-BE49-F238E27FC236}">
-                <a16:creationId xmlns:a16="http://schemas.microsoft.com/office/drawing/2014/main" id="{24BA9D3A-BF1D-495B-B0A1-D407B512FA31}"/>
+                <a16:creationId xmlns:a16="http://schemas.microsoft.com/office/drawing/2014/main" id="{06C4C404-63FE-4E13-B1F9-1EF9199845DC}"/>
               </a:ext>
             </a:extLst>
           </p:cNvPr>
@@ -20832,7 +20922,7 @@
           <p:cNvPr id="12" name="">
             <a:extLst xmlns:a="http://schemas.openxmlformats.org/drawingml/2006/main">
               <a:ext uri="{FF2B5EF4-FFF2-40B4-BE49-F238E27FC236}">
-                <a16:creationId xmlns:a16="http://schemas.microsoft.com/office/drawing/2014/main" id="{4A8AFCA8-D84B-4BD3-A032-38E43936349B}"/>
+                <a16:creationId xmlns:a16="http://schemas.microsoft.com/office/drawing/2014/main" id="{41A2D0DD-AE16-4FEB-99F8-502D1E242F99}"/>
               </a:ext>
             </a:extLst>
           </p:cNvPr>
@@ -20894,7 +20984,7 @@
           <p:cNvPr id="13" name="">
             <a:extLst xmlns:a="http://schemas.openxmlformats.org/drawingml/2006/main">
               <a:ext uri="{FF2B5EF4-FFF2-40B4-BE49-F238E27FC236}">
-                <a16:creationId xmlns:a16="http://schemas.microsoft.com/office/drawing/2014/main" id="{2124BF45-832D-47E8-A90D-2248C30082B5}"/>
+                <a16:creationId xmlns:a16="http://schemas.microsoft.com/office/drawing/2014/main" id="{8AA010C8-B1C6-427B-9667-8362F9FD0F59}"/>
               </a:ext>
             </a:extLst>
           </p:cNvPr>
@@ -20925,7 +21015,7 @@
           <p:cNvPr id="14" name="">
             <a:extLst xmlns:a="http://schemas.openxmlformats.org/drawingml/2006/main">
               <a:ext uri="{FF2B5EF4-FFF2-40B4-BE49-F238E27FC236}">
-                <a16:creationId xmlns:a16="http://schemas.microsoft.com/office/drawing/2014/main" id="{1B57B772-1C96-4878-A0A2-930C52FDDC3C}"/>
+                <a16:creationId xmlns:a16="http://schemas.microsoft.com/office/drawing/2014/main" id="{6C80DB05-6695-4D1D-965C-F7EBDF628802}"/>
               </a:ext>
             </a:extLst>
           </p:cNvPr>
@@ -20987,7 +21077,7 @@
           <p:cNvPr id="15" name="">
             <a:extLst xmlns:a="http://schemas.openxmlformats.org/drawingml/2006/main">
               <a:ext uri="{FF2B5EF4-FFF2-40B4-BE49-F238E27FC236}">
-                <a16:creationId xmlns:a16="http://schemas.microsoft.com/office/drawing/2014/main" id="{148B5286-BE65-439A-8DE1-29F4E88D4170}"/>
+                <a16:creationId xmlns:a16="http://schemas.microsoft.com/office/drawing/2014/main" id="{3B583D82-FC20-4EC2-B79E-90D957560E81}"/>
               </a:ext>
             </a:extLst>
           </p:cNvPr>
@@ -21049,7 +21139,7 @@
           <p:cNvPr id="16" name="">
             <a:extLst xmlns:a="http://schemas.openxmlformats.org/drawingml/2006/main">
               <a:ext uri="{FF2B5EF4-FFF2-40B4-BE49-F238E27FC236}">
-                <a16:creationId xmlns:a16="http://schemas.microsoft.com/office/drawing/2014/main" id="{0B5D34EB-2F71-49A7-9ED6-36F41FEE4A86}"/>
+                <a16:creationId xmlns:a16="http://schemas.microsoft.com/office/drawing/2014/main" id="{E619398B-D7B3-4351-9421-AFB21765E23D}"/>
               </a:ext>
             </a:extLst>
           </p:cNvPr>
@@ -21111,7 +21201,7 @@
           <p:cNvPr id="17" name="dashboard-preview">
             <a:extLst xmlns:a="http://schemas.openxmlformats.org/drawingml/2006/main">
               <a:ext uri="{FF2B5EF4-FFF2-40B4-BE49-F238E27FC236}">
-                <a16:creationId xmlns:a16="http://schemas.microsoft.com/office/drawing/2014/main" id="{EB75AB39-465B-4AFB-ADB2-37D8C295657C}"/>
+                <a16:creationId xmlns:a16="http://schemas.microsoft.com/office/drawing/2014/main" id="{F11FF85D-D5FF-495E-AE24-A3FBBAD8E8BC}"/>
               </a:ext>
             </a:extLst>
           </p:cNvPr>
@@ -21146,7 +21236,7 @@
           <p:cNvPr id="18" name="">
             <a:extLst xmlns:a="http://schemas.openxmlformats.org/drawingml/2006/main">
               <a:ext uri="{FF2B5EF4-FFF2-40B4-BE49-F238E27FC236}">
-                <a16:creationId xmlns:a16="http://schemas.microsoft.com/office/drawing/2014/main" id="{6E6928F9-8E85-4EA4-A907-1189759E2C68}"/>
+                <a16:creationId xmlns:a16="http://schemas.microsoft.com/office/drawing/2014/main" id="{FF92D6A0-6E5A-4EFB-BDD0-E969C48BAD4F}"/>
               </a:ext>
             </a:extLst>
           </p:cNvPr>
@@ -21208,7 +21298,7 @@
           <p:cNvPr id="19" name="">
             <a:extLst xmlns:a="http://schemas.openxmlformats.org/drawingml/2006/main">
               <a:ext uri="{FF2B5EF4-FFF2-40B4-BE49-F238E27FC236}">
-                <a16:creationId xmlns:a16="http://schemas.microsoft.com/office/drawing/2014/main" id="{1BD68DF1-A4BB-4936-91D7-3165955102C2}"/>
+                <a16:creationId xmlns:a16="http://schemas.microsoft.com/office/drawing/2014/main" id="{274E63D7-2217-419B-B6E3-2BB2EE07DDC9}"/>
               </a:ext>
             </a:extLst>
           </p:cNvPr>
@@ -21239,7 +21329,7 @@
           <p:cNvPr id="20" name="">
             <a:extLst xmlns:a="http://schemas.openxmlformats.org/drawingml/2006/main">
               <a:ext uri="{FF2B5EF4-FFF2-40B4-BE49-F238E27FC236}">
-                <a16:creationId xmlns:a16="http://schemas.microsoft.com/office/drawing/2014/main" id="{538AA042-8475-40F3-BBDD-076F34F3E0FD}"/>
+                <a16:creationId xmlns:a16="http://schemas.microsoft.com/office/drawing/2014/main" id="{CFC42416-5BFD-4FE7-9A2C-754BC22BA425}"/>
               </a:ext>
             </a:extLst>
           </p:cNvPr>
@@ -21301,7 +21391,7 @@
           <p:cNvPr id="21" name="">
             <a:extLst xmlns:a="http://schemas.openxmlformats.org/drawingml/2006/main">
               <a:ext uri="{FF2B5EF4-FFF2-40B4-BE49-F238E27FC236}">
-                <a16:creationId xmlns:a16="http://schemas.microsoft.com/office/drawing/2014/main" id="{E675EAA7-E819-4077-A9E5-A029C7CB48B8}"/>
+                <a16:creationId xmlns:a16="http://schemas.microsoft.com/office/drawing/2014/main" id="{A252D44F-B319-42C4-BC9F-5077797492C6}"/>
               </a:ext>
             </a:extLst>
           </p:cNvPr>
@@ -21332,7 +21422,7 @@
           <p:cNvPr id="22" name="">
             <a:extLst xmlns:a="http://schemas.openxmlformats.org/drawingml/2006/main">
               <a:ext uri="{FF2B5EF4-FFF2-40B4-BE49-F238E27FC236}">
-                <a16:creationId xmlns:a16="http://schemas.microsoft.com/office/drawing/2014/main" id="{A4B76ED9-A05A-41C3-9C1B-D48433887372}"/>
+                <a16:creationId xmlns:a16="http://schemas.microsoft.com/office/drawing/2014/main" id="{2D6E790A-B0E5-4468-9573-5446FDC305E8}"/>
               </a:ext>
             </a:extLst>
           </p:cNvPr>
@@ -21363,7 +21453,7 @@
           <p:cNvPr id="23" name="">
             <a:extLst xmlns:a="http://schemas.openxmlformats.org/drawingml/2006/main">
               <a:ext uri="{FF2B5EF4-FFF2-40B4-BE49-F238E27FC236}">
-                <a16:creationId xmlns:a16="http://schemas.microsoft.com/office/drawing/2014/main" id="{54FA30C7-D379-4F6E-B49A-C5C84CF517E0}"/>
+                <a16:creationId xmlns:a16="http://schemas.microsoft.com/office/drawing/2014/main" id="{56286B4B-DA0E-4C2F-B041-5841798AF921}"/>
               </a:ext>
             </a:extLst>
           </p:cNvPr>
@@ -21396,7 +21486,7 @@
           <p:cNvPr id="24" name="">
             <a:extLst xmlns:a="http://schemas.openxmlformats.org/drawingml/2006/main">
               <a:ext uri="{FF2B5EF4-FFF2-40B4-BE49-F238E27FC236}">
-                <a16:creationId xmlns:a16="http://schemas.microsoft.com/office/drawing/2014/main" id="{368B421F-6553-47CB-8195-5B2D2F04B8E0}"/>
+                <a16:creationId xmlns:a16="http://schemas.microsoft.com/office/drawing/2014/main" id="{505E21E2-EFE6-400C-864B-7169E5B2FD6A}"/>
               </a:ext>
             </a:extLst>
           </p:cNvPr>
@@ -21458,7 +21548,7 @@
           <p:cNvPr id="25" name="footer-rule-7">
             <a:extLst xmlns:a="http://schemas.openxmlformats.org/drawingml/2006/main">
               <a:ext uri="{FF2B5EF4-FFF2-40B4-BE49-F238E27FC236}">
-                <a16:creationId xmlns:a16="http://schemas.microsoft.com/office/drawing/2014/main" id="{F34EC543-DDB4-4B58-949B-9CE120839DA5}"/>
+                <a16:creationId xmlns:a16="http://schemas.microsoft.com/office/drawing/2014/main" id="{791F3EC0-C106-47C3-A9DB-6685AA8C0C09}"/>
               </a:ext>
             </a:extLst>
           </p:cNvPr>
@@ -21489,7 +21579,7 @@
           <p:cNvPr id="26" name="footer-label-7">
             <a:extLst xmlns:a="http://schemas.openxmlformats.org/drawingml/2006/main">
               <a:ext uri="{FF2B5EF4-FFF2-40B4-BE49-F238E27FC236}">
-                <a16:creationId xmlns:a16="http://schemas.microsoft.com/office/drawing/2014/main" id="{14AE3DE4-2063-44FD-8273-72823FD6592C}"/>
+                <a16:creationId xmlns:a16="http://schemas.microsoft.com/office/drawing/2014/main" id="{561ABF90-4623-47AB-9AF1-8EF025842D35}"/>
               </a:ext>
             </a:extLst>
           </p:cNvPr>
@@ -21551,7 +21641,7 @@
           <p:cNvPr id="27" name="footer-page-7">
             <a:extLst xmlns:a="http://schemas.openxmlformats.org/drawingml/2006/main">
               <a:ext uri="{FF2B5EF4-FFF2-40B4-BE49-F238E27FC236}">
-                <a16:creationId xmlns:a16="http://schemas.microsoft.com/office/drawing/2014/main" id="{D6F46EC2-032E-41D8-98D6-E94CE4035625}"/>
+                <a16:creationId xmlns:a16="http://schemas.microsoft.com/office/drawing/2014/main" id="{BE51249D-DCFA-4223-BC73-16F7655798E4}"/>
               </a:ext>
             </a:extLst>
           </p:cNvPr>
@@ -21611,7 +21701,7 @@
     </p:spTree>
     <p:extLst>
       <p:ext uri="{BB962C8B-B14F-4D97-AF65-F5344CB8AC3E}">
-        <p14:creationId xmlns:p14="http://schemas.microsoft.com/office/powerpoint/2010/main" val="1764458369"/>
+        <p14:creationId xmlns:p14="http://schemas.microsoft.com/office/powerpoint/2010/main" val="726108846"/>
       </p:ext>
     </p:extLst>
   </p:cSld>
@@ -21642,7 +21732,7 @@
           <p:cNvPr id="26" name="side-accent-8">
             <a:extLst xmlns:a="http://schemas.openxmlformats.org/drawingml/2006/main">
               <a:ext uri="{FF2B5EF4-FFF2-40B4-BE49-F238E27FC236}">
-                <a16:creationId xmlns:a16="http://schemas.microsoft.com/office/drawing/2014/main" id="{3AB54EC4-C75C-4C5F-B8AB-3962D5D19D55}"/>
+                <a16:creationId xmlns:a16="http://schemas.microsoft.com/office/drawing/2014/main" id="{0A95D1E5-853D-4B6F-A346-C5467F50A312}"/>
               </a:ext>
             </a:extLst>
           </p:cNvPr>
@@ -21673,7 +21763,7 @@
           <p:cNvPr id="2" name="kicker-8">
             <a:extLst xmlns:a="http://schemas.openxmlformats.org/drawingml/2006/main">
               <a:ext uri="{FF2B5EF4-FFF2-40B4-BE49-F238E27FC236}">
-                <a16:creationId xmlns:a16="http://schemas.microsoft.com/office/drawing/2014/main" id="{DA66F23D-6B0D-4078-A324-8329F1D442EC}"/>
+                <a16:creationId xmlns:a16="http://schemas.microsoft.com/office/drawing/2014/main" id="{ECB10EBA-7E2F-4307-8AE4-7003D40A633B}"/>
               </a:ext>
             </a:extLst>
           </p:cNvPr>
@@ -21735,7 +21825,7 @@
           <p:cNvPr id="3" name="title-8">
             <a:extLst xmlns:a="http://schemas.openxmlformats.org/drawingml/2006/main">
               <a:ext uri="{FF2B5EF4-FFF2-40B4-BE49-F238E27FC236}">
-                <a16:creationId xmlns:a16="http://schemas.microsoft.com/office/drawing/2014/main" id="{00880EC9-754E-4E18-9EB2-871EFF7B40DD}"/>
+                <a16:creationId xmlns:a16="http://schemas.microsoft.com/office/drawing/2014/main" id="{3C6555F9-73FF-4C43-A434-C1353B3463D5}"/>
               </a:ext>
             </a:extLst>
           </p:cNvPr>
@@ -21797,7 +21887,7 @@
           <p:cNvPr id="4" name="">
             <a:extLst xmlns:a="http://schemas.openxmlformats.org/drawingml/2006/main">
               <a:ext uri="{FF2B5EF4-FFF2-40B4-BE49-F238E27FC236}">
-                <a16:creationId xmlns:a16="http://schemas.microsoft.com/office/drawing/2014/main" id="{04B88BC5-415E-46B1-AF7E-81C7812562B4}"/>
+                <a16:creationId xmlns:a16="http://schemas.microsoft.com/office/drawing/2014/main" id="{4A94C5F6-5099-4DB0-96AF-48E80B917392}"/>
               </a:ext>
             </a:extLst>
           </p:cNvPr>
@@ -21859,7 +21949,7 @@
           <p:cNvPr id="5" name="">
             <a:extLst xmlns:a="http://schemas.openxmlformats.org/drawingml/2006/main">
               <a:ext uri="{FF2B5EF4-FFF2-40B4-BE49-F238E27FC236}">
-                <a16:creationId xmlns:a16="http://schemas.microsoft.com/office/drawing/2014/main" id="{2CFA5C4A-9DFD-4413-954B-7F4A9463850E}"/>
+                <a16:creationId xmlns:a16="http://schemas.microsoft.com/office/drawing/2014/main" id="{30146459-07F0-403C-9CB8-8362D25B6A03}"/>
               </a:ext>
             </a:extLst>
           </p:cNvPr>
@@ -21890,7 +21980,7 @@
           <p:cNvPr id="6" name="">
             <a:extLst xmlns:a="http://schemas.openxmlformats.org/drawingml/2006/main">
               <a:ext uri="{FF2B5EF4-FFF2-40B4-BE49-F238E27FC236}">
-                <a16:creationId xmlns:a16="http://schemas.microsoft.com/office/drawing/2014/main" id="{E83CD29E-C7FC-4A28-82D7-94F0893CE424}"/>
+                <a16:creationId xmlns:a16="http://schemas.microsoft.com/office/drawing/2014/main" id="{D06D0F15-DDD2-4B90-A2ED-706499C56EF4}"/>
               </a:ext>
             </a:extLst>
           </p:cNvPr>
@@ -21921,7 +22011,7 @@
           <p:cNvPr id="7" name="">
             <a:extLst xmlns:a="http://schemas.openxmlformats.org/drawingml/2006/main">
               <a:ext uri="{FF2B5EF4-FFF2-40B4-BE49-F238E27FC236}">
-                <a16:creationId xmlns:a16="http://schemas.microsoft.com/office/drawing/2014/main" id="{4EAAE85D-D75E-4050-B7E3-27BAE1F93561}"/>
+                <a16:creationId xmlns:a16="http://schemas.microsoft.com/office/drawing/2014/main" id="{A0C1EB3A-B6CE-45F8-A646-C870492BB6E1}"/>
               </a:ext>
             </a:extLst>
           </p:cNvPr>
@@ -21983,7 +22073,7 @@
           <p:cNvPr id="8" name="">
             <a:extLst xmlns:a="http://schemas.openxmlformats.org/drawingml/2006/main">
               <a:ext uri="{FF2B5EF4-FFF2-40B4-BE49-F238E27FC236}">
-                <a16:creationId xmlns:a16="http://schemas.microsoft.com/office/drawing/2014/main" id="{6C8126FA-E03C-4EA4-B7F2-9E5390B844B0}"/>
+                <a16:creationId xmlns:a16="http://schemas.microsoft.com/office/drawing/2014/main" id="{E1EFF98E-77C6-486D-A294-0115953F5E98}"/>
               </a:ext>
             </a:extLst>
           </p:cNvPr>
@@ -22045,7 +22135,7 @@
           <p:cNvPr id="9" name="">
             <a:extLst xmlns:a="http://schemas.openxmlformats.org/drawingml/2006/main">
               <a:ext uri="{FF2B5EF4-FFF2-40B4-BE49-F238E27FC236}">
-                <a16:creationId xmlns:a16="http://schemas.microsoft.com/office/drawing/2014/main" id="{0B4A3CE2-A1BF-43D6-B8DE-B38F34124886}"/>
+                <a16:creationId xmlns:a16="http://schemas.microsoft.com/office/drawing/2014/main" id="{29E85E21-1696-4706-816C-669039BDC471}"/>
               </a:ext>
             </a:extLst>
           </p:cNvPr>
@@ -22107,7 +22197,7 @@
           <p:cNvPr id="10" name="">
             <a:extLst xmlns:a="http://schemas.openxmlformats.org/drawingml/2006/main">
               <a:ext uri="{FF2B5EF4-FFF2-40B4-BE49-F238E27FC236}">
-                <a16:creationId xmlns:a16="http://schemas.microsoft.com/office/drawing/2014/main" id="{AA360AF8-A3F3-4699-9DDB-1CFC3686ACAB}"/>
+                <a16:creationId xmlns:a16="http://schemas.microsoft.com/office/drawing/2014/main" id="{845EFC7A-0B70-4CDF-B9AF-4EA40D94A08D}"/>
               </a:ext>
             </a:extLst>
           </p:cNvPr>
@@ -22138,7 +22228,7 @@
           <p:cNvPr id="11" name="">
             <a:extLst xmlns:a="http://schemas.openxmlformats.org/drawingml/2006/main">
               <a:ext uri="{FF2B5EF4-FFF2-40B4-BE49-F238E27FC236}">
-                <a16:creationId xmlns:a16="http://schemas.microsoft.com/office/drawing/2014/main" id="{5E8B8E53-98FF-425D-BE06-B30E4AEA395C}"/>
+                <a16:creationId xmlns:a16="http://schemas.microsoft.com/office/drawing/2014/main" id="{388EBD17-7FA6-423C-B890-E6C7F3D984B8}"/>
               </a:ext>
             </a:extLst>
           </p:cNvPr>
@@ -22200,7 +22290,7 @@
           <p:cNvPr id="12" name="">
             <a:extLst xmlns:a="http://schemas.openxmlformats.org/drawingml/2006/main">
               <a:ext uri="{FF2B5EF4-FFF2-40B4-BE49-F238E27FC236}">
-                <a16:creationId xmlns:a16="http://schemas.microsoft.com/office/drawing/2014/main" id="{021A9E48-AF71-4BAB-8C08-B7E6EE119A9D}"/>
+                <a16:creationId xmlns:a16="http://schemas.microsoft.com/office/drawing/2014/main" id="{0B38FC4A-DC23-45E5-9F55-89CF57E53646}"/>
               </a:ext>
             </a:extLst>
           </p:cNvPr>
@@ -22262,7 +22352,7 @@
           <p:cNvPr id="13" name="">
             <a:extLst xmlns:a="http://schemas.openxmlformats.org/drawingml/2006/main">
               <a:ext uri="{FF2B5EF4-FFF2-40B4-BE49-F238E27FC236}">
-                <a16:creationId xmlns:a16="http://schemas.microsoft.com/office/drawing/2014/main" id="{1160882F-EE69-4E59-94A2-164919EA1BEB}"/>
+                <a16:creationId xmlns:a16="http://schemas.microsoft.com/office/drawing/2014/main" id="{2423C092-F847-4ACB-AC8A-925C1FB4F584}"/>
               </a:ext>
             </a:extLst>
           </p:cNvPr>
@@ -22324,7 +22414,7 @@
           <p:cNvPr id="14" name="">
             <a:extLst xmlns:a="http://schemas.openxmlformats.org/drawingml/2006/main">
               <a:ext uri="{FF2B5EF4-FFF2-40B4-BE49-F238E27FC236}">
-                <a16:creationId xmlns:a16="http://schemas.microsoft.com/office/drawing/2014/main" id="{0301152C-7D87-44C6-9A44-A31BCEC84101}"/>
+                <a16:creationId xmlns:a16="http://schemas.microsoft.com/office/drawing/2014/main" id="{E4A09661-9DF4-486B-907C-D9053BAA06D9}"/>
               </a:ext>
             </a:extLst>
           </p:cNvPr>
@@ -22355,7 +22445,7 @@
           <p:cNvPr id="15" name="">
             <a:extLst xmlns:a="http://schemas.openxmlformats.org/drawingml/2006/main">
               <a:ext uri="{FF2B5EF4-FFF2-40B4-BE49-F238E27FC236}">
-                <a16:creationId xmlns:a16="http://schemas.microsoft.com/office/drawing/2014/main" id="{F0A0CC65-9189-4703-8CD6-FF865B0CC2F2}"/>
+                <a16:creationId xmlns:a16="http://schemas.microsoft.com/office/drawing/2014/main" id="{7A128D72-DDAF-40E1-9814-638721FDD3F9}"/>
               </a:ext>
             </a:extLst>
           </p:cNvPr>
@@ -22417,7 +22507,7 @@
           <p:cNvPr id="16" name="">
             <a:extLst xmlns:a="http://schemas.openxmlformats.org/drawingml/2006/main">
               <a:ext uri="{FF2B5EF4-FFF2-40B4-BE49-F238E27FC236}">
-                <a16:creationId xmlns:a16="http://schemas.microsoft.com/office/drawing/2014/main" id="{086690A6-92EB-418A-B683-BAA677C7C7F9}"/>
+                <a16:creationId xmlns:a16="http://schemas.microsoft.com/office/drawing/2014/main" id="{4FD8500A-5E93-4C21-9C27-FBE486B5936B}"/>
               </a:ext>
             </a:extLst>
           </p:cNvPr>
@@ -22479,7 +22569,7 @@
           <p:cNvPr id="17" name="">
             <a:extLst xmlns:a="http://schemas.openxmlformats.org/drawingml/2006/main">
               <a:ext uri="{FF2B5EF4-FFF2-40B4-BE49-F238E27FC236}">
-                <a16:creationId xmlns:a16="http://schemas.microsoft.com/office/drawing/2014/main" id="{26A5C8AC-D2D1-41F8-A101-E73D6834AAEA}"/>
+                <a16:creationId xmlns:a16="http://schemas.microsoft.com/office/drawing/2014/main" id="{68625546-E0D5-45C3-BE2F-FBB2434FC61E}"/>
               </a:ext>
             </a:extLst>
           </p:cNvPr>
@@ -22541,7 +22631,7 @@
           <p:cNvPr id="18" name="">
             <a:extLst xmlns:a="http://schemas.openxmlformats.org/drawingml/2006/main">
               <a:ext uri="{FF2B5EF4-FFF2-40B4-BE49-F238E27FC236}">
-                <a16:creationId xmlns:a16="http://schemas.microsoft.com/office/drawing/2014/main" id="{ECE8C131-BE7E-4919-8CF4-D5820E71FCA2}"/>
+                <a16:creationId xmlns:a16="http://schemas.microsoft.com/office/drawing/2014/main" id="{4AF1985C-31C5-4EEE-8BC8-FDC5BAE3E982}"/>
               </a:ext>
             </a:extLst>
           </p:cNvPr>
@@ -22572,7 +22662,7 @@
           <p:cNvPr id="19" name="">
             <a:extLst xmlns:a="http://schemas.openxmlformats.org/drawingml/2006/main">
               <a:ext uri="{FF2B5EF4-FFF2-40B4-BE49-F238E27FC236}">
-                <a16:creationId xmlns:a16="http://schemas.microsoft.com/office/drawing/2014/main" id="{14FE03CB-98CB-410E-AC1B-4C3649540B05}"/>
+                <a16:creationId xmlns:a16="http://schemas.microsoft.com/office/drawing/2014/main" id="{6ED1CAB5-292B-4B85-A8C6-7510B503B436}"/>
               </a:ext>
             </a:extLst>
           </p:cNvPr>
@@ -22634,7 +22724,7 @@
           <p:cNvPr id="20" name="">
             <a:extLst xmlns:a="http://schemas.openxmlformats.org/drawingml/2006/main">
               <a:ext uri="{FF2B5EF4-FFF2-40B4-BE49-F238E27FC236}">
-                <a16:creationId xmlns:a16="http://schemas.microsoft.com/office/drawing/2014/main" id="{8C640FD2-308D-4AA3-B872-A7760E119DB5}"/>
+                <a16:creationId xmlns:a16="http://schemas.microsoft.com/office/drawing/2014/main" id="{792DDD77-E389-476E-942A-1C234317FB3D}"/>
               </a:ext>
             </a:extLst>
           </p:cNvPr>
@@ -22696,7 +22786,7 @@
           <p:cNvPr id="21" name="">
             <a:extLst xmlns:a="http://schemas.openxmlformats.org/drawingml/2006/main">
               <a:ext uri="{FF2B5EF4-FFF2-40B4-BE49-F238E27FC236}">
-                <a16:creationId xmlns:a16="http://schemas.microsoft.com/office/drawing/2014/main" id="{CF30F53C-C1E0-46BC-8B2B-128634A6612E}"/>
+                <a16:creationId xmlns:a16="http://schemas.microsoft.com/office/drawing/2014/main" id="{2C6B4244-4E31-448A-BBB9-583D2514E45F}"/>
               </a:ext>
             </a:extLst>
           </p:cNvPr>
@@ -22758,7 +22848,7 @@
           <p:cNvPr id="22" name="">
             <a:extLst xmlns:a="http://schemas.openxmlformats.org/drawingml/2006/main">
               <a:ext uri="{FF2B5EF4-FFF2-40B4-BE49-F238E27FC236}">
-                <a16:creationId xmlns:a16="http://schemas.microsoft.com/office/drawing/2014/main" id="{CF0232D8-BD29-4E66-B6DB-C593346C2EC9}"/>
+                <a16:creationId xmlns:a16="http://schemas.microsoft.com/office/drawing/2014/main" id="{39C1130C-01A3-463C-9045-D5C4D2C29D13}"/>
               </a:ext>
             </a:extLst>
           </p:cNvPr>
@@ -22820,7 +22910,7 @@
           <p:cNvPr id="23" name="footer-rule-8">
             <a:extLst xmlns:a="http://schemas.openxmlformats.org/drawingml/2006/main">
               <a:ext uri="{FF2B5EF4-FFF2-40B4-BE49-F238E27FC236}">
-                <a16:creationId xmlns:a16="http://schemas.microsoft.com/office/drawing/2014/main" id="{883EDFB6-1566-4EC1-A62F-592201A851E8}"/>
+                <a16:creationId xmlns:a16="http://schemas.microsoft.com/office/drawing/2014/main" id="{B59AAB43-E89E-4EC7-AAEC-8E2E67524FA2}"/>
               </a:ext>
             </a:extLst>
           </p:cNvPr>
@@ -22851,7 +22941,7 @@
           <p:cNvPr id="24" name="footer-label-8">
             <a:extLst xmlns:a="http://schemas.openxmlformats.org/drawingml/2006/main">
               <a:ext uri="{FF2B5EF4-FFF2-40B4-BE49-F238E27FC236}">
-                <a16:creationId xmlns:a16="http://schemas.microsoft.com/office/drawing/2014/main" id="{2543DB9B-4DAB-429D-973D-BA3091315039}"/>
+                <a16:creationId xmlns:a16="http://schemas.microsoft.com/office/drawing/2014/main" id="{33A64181-CBC0-4A19-9958-593D1994881F}"/>
               </a:ext>
             </a:extLst>
           </p:cNvPr>
@@ -22913,7 +23003,7 @@
           <p:cNvPr id="25" name="footer-page-8">
             <a:extLst xmlns:a="http://schemas.openxmlformats.org/drawingml/2006/main">
               <a:ext uri="{FF2B5EF4-FFF2-40B4-BE49-F238E27FC236}">
-                <a16:creationId xmlns:a16="http://schemas.microsoft.com/office/drawing/2014/main" id="{0EA1E7B7-29C4-4965-9CB4-3F347D16D12D}"/>
+                <a16:creationId xmlns:a16="http://schemas.microsoft.com/office/drawing/2014/main" id="{E1002F01-7438-42F8-ACB7-3C3F32CF525C}"/>
               </a:ext>
             </a:extLst>
           </p:cNvPr>
@@ -22973,7 +23063,7 @@
     </p:spTree>
     <p:extLst>
       <p:ext uri="{BB962C8B-B14F-4D97-AF65-F5344CB8AC3E}">
-        <p14:creationId xmlns:p14="http://schemas.microsoft.com/office/powerpoint/2010/main" val="279510956"/>
+        <p14:creationId xmlns:p14="http://schemas.microsoft.com/office/powerpoint/2010/main" val="702474417"/>
       </p:ext>
     </p:extLst>
   </p:cSld>
@@ -23004,7 +23094,7 @@
           <p:cNvPr id="25" name="side-accent-9">
             <a:extLst xmlns:a="http://schemas.openxmlformats.org/drawingml/2006/main">
               <a:ext uri="{FF2B5EF4-FFF2-40B4-BE49-F238E27FC236}">
-                <a16:creationId xmlns:a16="http://schemas.microsoft.com/office/drawing/2014/main" id="{4B3F8C4A-0A65-4138-A495-046AC47425FA}"/>
+                <a16:creationId xmlns:a16="http://schemas.microsoft.com/office/drawing/2014/main" id="{5985D43E-F987-4619-8FFD-077FDE440262}"/>
               </a:ext>
             </a:extLst>
           </p:cNvPr>
@@ -23035,7 +23125,7 @@
           <p:cNvPr id="2" name="kicker-9">
             <a:extLst xmlns:a="http://schemas.openxmlformats.org/drawingml/2006/main">
               <a:ext uri="{FF2B5EF4-FFF2-40B4-BE49-F238E27FC236}">
-                <a16:creationId xmlns:a16="http://schemas.microsoft.com/office/drawing/2014/main" id="{6B0B73A5-DB27-455F-B5D3-0243DDFEC697}"/>
+                <a16:creationId xmlns:a16="http://schemas.microsoft.com/office/drawing/2014/main" id="{73F933FE-93F0-4E50-802C-96DA7D1DB06D}"/>
               </a:ext>
             </a:extLst>
           </p:cNvPr>
@@ -23097,7 +23187,7 @@
           <p:cNvPr id="3" name="title-9">
             <a:extLst xmlns:a="http://schemas.openxmlformats.org/drawingml/2006/main">
               <a:ext uri="{FF2B5EF4-FFF2-40B4-BE49-F238E27FC236}">
-                <a16:creationId xmlns:a16="http://schemas.microsoft.com/office/drawing/2014/main" id="{4E204E3D-3D8D-4BB6-BE38-E3162BF3BDAA}"/>
+                <a16:creationId xmlns:a16="http://schemas.microsoft.com/office/drawing/2014/main" id="{5FB83FF5-CD7E-49F4-8F36-3F2DB63A41CE}"/>
               </a:ext>
             </a:extLst>
           </p:cNvPr>
@@ -23159,7 +23249,7 @@
           <p:cNvPr id="4" name="">
             <a:extLst xmlns:a="http://schemas.openxmlformats.org/drawingml/2006/main">
               <a:ext uri="{FF2B5EF4-FFF2-40B4-BE49-F238E27FC236}">
-                <a16:creationId xmlns:a16="http://schemas.microsoft.com/office/drawing/2014/main" id="{778787D3-59C7-408C-AAC5-EB6B8FE90615}"/>
+                <a16:creationId xmlns:a16="http://schemas.microsoft.com/office/drawing/2014/main" id="{1219BCC3-EE5A-4DAF-9D9E-27ED59ECC3C4}"/>
               </a:ext>
             </a:extLst>
           </p:cNvPr>
@@ -23221,7 +23311,7 @@
           <p:cNvPr id="5" name="">
             <a:extLst xmlns:a="http://schemas.openxmlformats.org/drawingml/2006/main">
               <a:ext uri="{FF2B5EF4-FFF2-40B4-BE49-F238E27FC236}">
-                <a16:creationId xmlns:a16="http://schemas.microsoft.com/office/drawing/2014/main" id="{F5324C86-7598-4FF7-BB2B-F820E07D5BCD}"/>
+                <a16:creationId xmlns:a16="http://schemas.microsoft.com/office/drawing/2014/main" id="{3C43CAFE-E078-413E-B616-F01948507485}"/>
               </a:ext>
             </a:extLst>
           </p:cNvPr>
@@ -23256,7 +23346,7 @@
           <p:cNvPr id="6" name="">
             <a:extLst xmlns:a="http://schemas.openxmlformats.org/drawingml/2006/main">
               <a:ext uri="{FF2B5EF4-FFF2-40B4-BE49-F238E27FC236}">
-                <a16:creationId xmlns:a16="http://schemas.microsoft.com/office/drawing/2014/main" id="{C877015B-A2F8-4B20-8BEF-98A895D53568}"/>
+                <a16:creationId xmlns:a16="http://schemas.microsoft.com/office/drawing/2014/main" id="{84275875-31B9-4EF5-9DF7-9568FD06D9C4}"/>
               </a:ext>
             </a:extLst>
           </p:cNvPr>
@@ -23318,7 +23408,7 @@
           <p:cNvPr id="7" name="">
             <a:extLst xmlns:a="http://schemas.openxmlformats.org/drawingml/2006/main">
               <a:ext uri="{FF2B5EF4-FFF2-40B4-BE49-F238E27FC236}">
-                <a16:creationId xmlns:a16="http://schemas.microsoft.com/office/drawing/2014/main" id="{D6CC9B50-8D39-491A-809F-874F7CD9FFE4}"/>
+                <a16:creationId xmlns:a16="http://schemas.microsoft.com/office/drawing/2014/main" id="{405B07ED-4D87-428D-9CC0-B15F5BE10324}"/>
               </a:ext>
             </a:extLst>
           </p:cNvPr>
@@ -23380,7 +23470,7 @@
           <p:cNvPr id="8" name="">
             <a:extLst xmlns:a="http://schemas.openxmlformats.org/drawingml/2006/main">
               <a:ext uri="{FF2B5EF4-FFF2-40B4-BE49-F238E27FC236}">
-                <a16:creationId xmlns:a16="http://schemas.microsoft.com/office/drawing/2014/main" id="{07B22CCC-A135-4EA5-BD00-A80834FA6C03}"/>
+                <a16:creationId xmlns:a16="http://schemas.microsoft.com/office/drawing/2014/main" id="{7349E953-BA13-4DB5-B103-5DE0805D8927}"/>
               </a:ext>
             </a:extLst>
           </p:cNvPr>
@@ -23442,7 +23532,7 @@
           <p:cNvPr id="9" name="">
             <a:extLst xmlns:a="http://schemas.openxmlformats.org/drawingml/2006/main">
               <a:ext uri="{FF2B5EF4-FFF2-40B4-BE49-F238E27FC236}">
-                <a16:creationId xmlns:a16="http://schemas.microsoft.com/office/drawing/2014/main" id="{DE29241F-E656-4FFB-A1E8-F39412F77E6B}"/>
+                <a16:creationId xmlns:a16="http://schemas.microsoft.com/office/drawing/2014/main" id="{B9385952-E2A5-499E-B7FD-2C413CA2E95B}"/>
               </a:ext>
             </a:extLst>
           </p:cNvPr>
@@ -23477,7 +23567,7 @@
           <p:cNvPr id="10" name="">
             <a:extLst xmlns:a="http://schemas.openxmlformats.org/drawingml/2006/main">
               <a:ext uri="{FF2B5EF4-FFF2-40B4-BE49-F238E27FC236}">
-                <a16:creationId xmlns:a16="http://schemas.microsoft.com/office/drawing/2014/main" id="{D4A8E042-0448-48AD-BF09-99261B6856F0}"/>
+                <a16:creationId xmlns:a16="http://schemas.microsoft.com/office/drawing/2014/main" id="{A4F18D95-38BA-44BA-BF97-C65802916789}"/>
               </a:ext>
             </a:extLst>
           </p:cNvPr>
@@ -23539,7 +23629,7 @@
           <p:cNvPr id="11" name="">
             <a:extLst xmlns:a="http://schemas.openxmlformats.org/drawingml/2006/main">
               <a:ext uri="{FF2B5EF4-FFF2-40B4-BE49-F238E27FC236}">
-                <a16:creationId xmlns:a16="http://schemas.microsoft.com/office/drawing/2014/main" id="{D0877AE2-55C2-4558-8C03-3B5DD40D6BD9}"/>
+                <a16:creationId xmlns:a16="http://schemas.microsoft.com/office/drawing/2014/main" id="{1B067939-5611-4B99-A1B6-B3A0BB55D1F6}"/>
               </a:ext>
             </a:extLst>
           </p:cNvPr>
@@ -23601,7 +23691,7 @@
           <p:cNvPr id="12" name="">
             <a:extLst xmlns:a="http://schemas.openxmlformats.org/drawingml/2006/main">
               <a:ext uri="{FF2B5EF4-FFF2-40B4-BE49-F238E27FC236}">
-                <a16:creationId xmlns:a16="http://schemas.microsoft.com/office/drawing/2014/main" id="{1ACAFE52-4C26-444F-B5BD-FB1A309536E2}"/>
+                <a16:creationId xmlns:a16="http://schemas.microsoft.com/office/drawing/2014/main" id="{FE683D6E-D1A8-4A9E-A3BF-702520A6ACC8}"/>
               </a:ext>
             </a:extLst>
           </p:cNvPr>
@@ -23663,7 +23753,7 @@
           <p:cNvPr id="13" name="">
             <a:extLst xmlns:a="http://schemas.openxmlformats.org/drawingml/2006/main">
               <a:ext uri="{FF2B5EF4-FFF2-40B4-BE49-F238E27FC236}">
-                <a16:creationId xmlns:a16="http://schemas.microsoft.com/office/drawing/2014/main" id="{3764D00B-9161-450A-ACB8-45772E2132F1}"/>
+                <a16:creationId xmlns:a16="http://schemas.microsoft.com/office/drawing/2014/main" id="{77B93D2A-212E-451A-810F-B355992430D0}"/>
               </a:ext>
             </a:extLst>
           </p:cNvPr>
@@ -23698,7 +23788,7 @@
           <p:cNvPr id="14" name="">
             <a:extLst xmlns:a="http://schemas.openxmlformats.org/drawingml/2006/main">
               <a:ext uri="{FF2B5EF4-FFF2-40B4-BE49-F238E27FC236}">
-                <a16:creationId xmlns:a16="http://schemas.microsoft.com/office/drawing/2014/main" id="{61283989-8D86-4DB1-9F98-CE674E9CA52E}"/>
+                <a16:creationId xmlns:a16="http://schemas.microsoft.com/office/drawing/2014/main" id="{346567A7-3AC8-49EE-B0D3-667E494A47D4}"/>
               </a:ext>
             </a:extLst>
           </p:cNvPr>
@@ -23760,7 +23850,7 @@
           <p:cNvPr id="15" name="">
             <a:extLst xmlns:a="http://schemas.openxmlformats.org/drawingml/2006/main">
               <a:ext uri="{FF2B5EF4-FFF2-40B4-BE49-F238E27FC236}">
-                <a16:creationId xmlns:a16="http://schemas.microsoft.com/office/drawing/2014/main" id="{9DEBE0F5-6B7C-42A6-81A9-0DE3D15EE51C}"/>
+                <a16:creationId xmlns:a16="http://schemas.microsoft.com/office/drawing/2014/main" id="{FFF9FB05-8C09-4AD3-9AB3-641AF0247A9F}"/>
               </a:ext>
             </a:extLst>
           </p:cNvPr>
@@ -23822,7 +23912,7 @@
           <p:cNvPr id="16" name="">
             <a:extLst xmlns:a="http://schemas.openxmlformats.org/drawingml/2006/main">
               <a:ext uri="{FF2B5EF4-FFF2-40B4-BE49-F238E27FC236}">
-                <a16:creationId xmlns:a16="http://schemas.microsoft.com/office/drawing/2014/main" id="{F6F53C49-683E-4188-90A5-D457543DB46E}"/>
+                <a16:creationId xmlns:a16="http://schemas.microsoft.com/office/drawing/2014/main" id="{976542B0-8547-4C49-A628-A3D3CD29753E}"/>
               </a:ext>
             </a:extLst>
           </p:cNvPr>
@@ -23884,7 +23974,7 @@
           <p:cNvPr id="17" name="">
             <a:extLst xmlns:a="http://schemas.openxmlformats.org/drawingml/2006/main">
               <a:ext uri="{FF2B5EF4-FFF2-40B4-BE49-F238E27FC236}">
-                <a16:creationId xmlns:a16="http://schemas.microsoft.com/office/drawing/2014/main" id="{CF7882D4-44A7-4FCB-A34F-DA8E6F38A11F}"/>
+                <a16:creationId xmlns:a16="http://schemas.microsoft.com/office/drawing/2014/main" id="{F8D64A54-5519-43B6-9CBB-8EA1AB6111D5}"/>
               </a:ext>
             </a:extLst>
           </p:cNvPr>
@@ -23919,7 +24009,7 @@
           <p:cNvPr id="18" name="">
             <a:extLst xmlns:a="http://schemas.openxmlformats.org/drawingml/2006/main">
               <a:ext uri="{FF2B5EF4-FFF2-40B4-BE49-F238E27FC236}">
-                <a16:creationId xmlns:a16="http://schemas.microsoft.com/office/drawing/2014/main" id="{3E1374F4-1E1F-47B7-B4E6-720A7C3E17C9}"/>
+                <a16:creationId xmlns:a16="http://schemas.microsoft.com/office/drawing/2014/main" id="{1A0D9EAF-3FB6-4281-AA40-9BB0C41BE6C2}"/>
               </a:ext>
             </a:extLst>
           </p:cNvPr>
@@ -23981,7 +24071,7 @@
           <p:cNvPr id="19" name="">
             <a:extLst xmlns:a="http://schemas.openxmlformats.org/drawingml/2006/main">
               <a:ext uri="{FF2B5EF4-FFF2-40B4-BE49-F238E27FC236}">
-                <a16:creationId xmlns:a16="http://schemas.microsoft.com/office/drawing/2014/main" id="{A35DBE73-287B-49D8-BE06-086B881BD158}"/>
+                <a16:creationId xmlns:a16="http://schemas.microsoft.com/office/drawing/2014/main" id="{96835626-E9B3-4B2F-95BB-905500C8AA4D}"/>
               </a:ext>
             </a:extLst>
           </p:cNvPr>
@@ -24043,7 +24133,7 @@
           <p:cNvPr id="20" name="">
             <a:extLst xmlns:a="http://schemas.openxmlformats.org/drawingml/2006/main">
               <a:ext uri="{FF2B5EF4-FFF2-40B4-BE49-F238E27FC236}">
-                <a16:creationId xmlns:a16="http://schemas.microsoft.com/office/drawing/2014/main" id="{ABF43252-393A-4B14-B802-71493AD82BD6}"/>
+                <a16:creationId xmlns:a16="http://schemas.microsoft.com/office/drawing/2014/main" id="{84D65322-538E-4669-B2AF-445EF9E6B501}"/>
               </a:ext>
             </a:extLst>
           </p:cNvPr>
@@ -24105,7 +24195,7 @@
           <p:cNvPr id="21" name="">
             <a:extLst xmlns:a="http://schemas.openxmlformats.org/drawingml/2006/main">
               <a:ext uri="{FF2B5EF4-FFF2-40B4-BE49-F238E27FC236}">
-                <a16:creationId xmlns:a16="http://schemas.microsoft.com/office/drawing/2014/main" id="{1E94C4AE-4478-4F00-8571-0E6CD073DFFA}"/>
+                <a16:creationId xmlns:a16="http://schemas.microsoft.com/office/drawing/2014/main" id="{7F5A54F6-F9BC-4857-BEE3-89C45A288192}"/>
               </a:ext>
             </a:extLst>
           </p:cNvPr>
@@ -24167,7 +24257,7 @@
           <p:cNvPr id="22" name="footer-rule-9">
             <a:extLst xmlns:a="http://schemas.openxmlformats.org/drawingml/2006/main">
               <a:ext uri="{FF2B5EF4-FFF2-40B4-BE49-F238E27FC236}">
-                <a16:creationId xmlns:a16="http://schemas.microsoft.com/office/drawing/2014/main" id="{8F98F8F3-B117-408C-A057-88AE322E8BA2}"/>
+                <a16:creationId xmlns:a16="http://schemas.microsoft.com/office/drawing/2014/main" id="{4C945C22-18DA-4FF8-9529-7E68C6492EC1}"/>
               </a:ext>
             </a:extLst>
           </p:cNvPr>
@@ -24198,7 +24288,7 @@
           <p:cNvPr id="23" name="footer-label-9">
             <a:extLst xmlns:a="http://schemas.openxmlformats.org/drawingml/2006/main">
               <a:ext uri="{FF2B5EF4-FFF2-40B4-BE49-F238E27FC236}">
-                <a16:creationId xmlns:a16="http://schemas.microsoft.com/office/drawing/2014/main" id="{F9963923-4A4D-4515-AE25-8BD80F5AF084}"/>
+                <a16:creationId xmlns:a16="http://schemas.microsoft.com/office/drawing/2014/main" id="{5480F5E6-CAAC-447C-91B3-08FD81E2C3C0}"/>
               </a:ext>
             </a:extLst>
           </p:cNvPr>
@@ -24260,7 +24350,7 @@
           <p:cNvPr id="24" name="footer-page-9">
             <a:extLst xmlns:a="http://schemas.openxmlformats.org/drawingml/2006/main">
               <a:ext uri="{FF2B5EF4-FFF2-40B4-BE49-F238E27FC236}">
-                <a16:creationId xmlns:a16="http://schemas.microsoft.com/office/drawing/2014/main" id="{775CA1A7-2998-413A-964A-C6AD37471D64}"/>
+                <a16:creationId xmlns:a16="http://schemas.microsoft.com/office/drawing/2014/main" id="{B766764C-EF9B-45C1-A4F9-0C3D71EB3B5F}"/>
               </a:ext>
             </a:extLst>
           </p:cNvPr>
@@ -24320,7 +24410,7 @@
     </p:spTree>
     <p:extLst>
       <p:ext uri="{BB962C8B-B14F-4D97-AF65-F5344CB8AC3E}">
-        <p14:creationId xmlns:p14="http://schemas.microsoft.com/office/powerpoint/2010/main" val="1632273968"/>
+        <p14:creationId xmlns:p14="http://schemas.microsoft.com/office/powerpoint/2010/main" val="569432134"/>
       </p:ext>
     </p:extLst>
   </p:cSld>

</xml_diff>

<commit_message>
docs: refine evidence and closing copy
</commit_message>
<xml_diff>
--- a/docs/MSU-EVA-อบรมสายวิชาการ-ฉบับวิทยากร.pptx
+++ b/docs/MSU-EVA-อบรมสายวิชาการ-ฉบับวิทยากร.pptx
@@ -2,30 +2,30 @@
 <file path=ppt/presentation.xml><?xml version="1.0" encoding="utf-8"?>
 <p:presentation xmlns:p="http://schemas.openxmlformats.org/presentationml/2006/main">
   <p:sldMasterIdLst>
-    <p:sldMasterId xmlns:r="http://schemas.openxmlformats.org/officeDocument/2006/relationships" id="2147483648" r:id="R6594becfddc94061"/>
+    <p:sldMasterId xmlns:r="http://schemas.openxmlformats.org/officeDocument/2006/relationships" id="2147483648" r:id="R894dd7a3d2bd4015"/>
   </p:sldMasterIdLst>
   <p:notesMasterIdLst>
-    <p:notesMasterId xmlns:r="http://schemas.openxmlformats.org/officeDocument/2006/relationships" r:id="R872114b434e041b5"/>
+    <p:notesMasterId xmlns:r="http://schemas.openxmlformats.org/officeDocument/2006/relationships" r:id="R7bcb9afdc453447d"/>
   </p:notesMasterIdLst>
   <p:sldIdLst>
-    <p:sldId xmlns:r="http://schemas.openxmlformats.org/officeDocument/2006/relationships" id="256" r:id="R62b45ff64af9436e"/>
-    <p:sldId xmlns:r="http://schemas.openxmlformats.org/officeDocument/2006/relationships" id="257" r:id="R0377878b46794d06"/>
-    <p:sldId xmlns:r="http://schemas.openxmlformats.org/officeDocument/2006/relationships" id="258" r:id="Re8b785c47ee049ac"/>
-    <p:sldId xmlns:r="http://schemas.openxmlformats.org/officeDocument/2006/relationships" id="259" r:id="Rcee89dfdb6ae49d6"/>
-    <p:sldId xmlns:r="http://schemas.openxmlformats.org/officeDocument/2006/relationships" id="260" r:id="R3c5c1c4cc4a6422a"/>
-    <p:sldId xmlns:r="http://schemas.openxmlformats.org/officeDocument/2006/relationships" id="261" r:id="Ra8dcc7be8081475e"/>
-    <p:sldId xmlns:r="http://schemas.openxmlformats.org/officeDocument/2006/relationships" id="262" r:id="R3f5f180afdd94b14"/>
-    <p:sldId xmlns:r="http://schemas.openxmlformats.org/officeDocument/2006/relationships" id="263" r:id="R602afda7d9e4410b"/>
-    <p:sldId xmlns:r="http://schemas.openxmlformats.org/officeDocument/2006/relationships" id="264" r:id="Rb73134d20b0a46b6"/>
-    <p:sldId xmlns:r="http://schemas.openxmlformats.org/officeDocument/2006/relationships" id="265" r:id="Rd6de1162bf714bbe"/>
-    <p:sldId xmlns:r="http://schemas.openxmlformats.org/officeDocument/2006/relationships" id="266" r:id="Rfd9aa8c91f17464a"/>
-    <p:sldId xmlns:r="http://schemas.openxmlformats.org/officeDocument/2006/relationships" id="267" r:id="R69e03d56fd8d4021"/>
-    <p:sldId xmlns:r="http://schemas.openxmlformats.org/officeDocument/2006/relationships" id="268" r:id="R55aa15a3e2ec4e8c"/>
-    <p:sldId xmlns:r="http://schemas.openxmlformats.org/officeDocument/2006/relationships" id="269" r:id="R77105109b8234e93"/>
-    <p:sldId xmlns:r="http://schemas.openxmlformats.org/officeDocument/2006/relationships" id="270" r:id="R4254d6c37a4f46f6"/>
-    <p:sldId xmlns:r="http://schemas.openxmlformats.org/officeDocument/2006/relationships" id="271" r:id="R297973c6cb104715"/>
-    <p:sldId xmlns:r="http://schemas.openxmlformats.org/officeDocument/2006/relationships" id="272" r:id="R80280e627d2d44ec"/>
-    <p:sldId xmlns:r="http://schemas.openxmlformats.org/officeDocument/2006/relationships" id="273" r:id="R34103bbd841343a7"/>
+    <p:sldId xmlns:r="http://schemas.openxmlformats.org/officeDocument/2006/relationships" id="256" r:id="Rbf8a4b6783c84261"/>
+    <p:sldId xmlns:r="http://schemas.openxmlformats.org/officeDocument/2006/relationships" id="257" r:id="Rf73d81e262064f8e"/>
+    <p:sldId xmlns:r="http://schemas.openxmlformats.org/officeDocument/2006/relationships" id="258" r:id="R303694ab41c84459"/>
+    <p:sldId xmlns:r="http://schemas.openxmlformats.org/officeDocument/2006/relationships" id="259" r:id="Rd92a90c5e2de4267"/>
+    <p:sldId xmlns:r="http://schemas.openxmlformats.org/officeDocument/2006/relationships" id="260" r:id="Re5176bdd7fa347fb"/>
+    <p:sldId xmlns:r="http://schemas.openxmlformats.org/officeDocument/2006/relationships" id="261" r:id="R4506b4199c2a4474"/>
+    <p:sldId xmlns:r="http://schemas.openxmlformats.org/officeDocument/2006/relationships" id="262" r:id="R4687cf1652ad47df"/>
+    <p:sldId xmlns:r="http://schemas.openxmlformats.org/officeDocument/2006/relationships" id="263" r:id="Rbe7eb0a32b5b4261"/>
+    <p:sldId xmlns:r="http://schemas.openxmlformats.org/officeDocument/2006/relationships" id="264" r:id="R2780dd051ef145db"/>
+    <p:sldId xmlns:r="http://schemas.openxmlformats.org/officeDocument/2006/relationships" id="265" r:id="R7106b3931c3c4a9c"/>
+    <p:sldId xmlns:r="http://schemas.openxmlformats.org/officeDocument/2006/relationships" id="266" r:id="R977811ca77a740b0"/>
+    <p:sldId xmlns:r="http://schemas.openxmlformats.org/officeDocument/2006/relationships" id="267" r:id="R28a051924e554605"/>
+    <p:sldId xmlns:r="http://schemas.openxmlformats.org/officeDocument/2006/relationships" id="268" r:id="Re9b290df11bb432c"/>
+    <p:sldId xmlns:r="http://schemas.openxmlformats.org/officeDocument/2006/relationships" id="269" r:id="R1e4d6f943023441c"/>
+    <p:sldId xmlns:r="http://schemas.openxmlformats.org/officeDocument/2006/relationships" id="270" r:id="Rd93b4f8e3be44554"/>
+    <p:sldId xmlns:r="http://schemas.openxmlformats.org/officeDocument/2006/relationships" id="271" r:id="Refe3324e62244eb5"/>
+    <p:sldId xmlns:r="http://schemas.openxmlformats.org/officeDocument/2006/relationships" id="272" r:id="R4e5c1c729e6344e2"/>
+    <p:sldId xmlns:r="http://schemas.openxmlformats.org/officeDocument/2006/relationships" id="273" r:id="R27a5630c0e9f408e"/>
   </p:sldIdLst>
   <p:sldSz cx="12192000" cy="6858000"/>
   <p:notesSz cx="6858000" cy="9144000"/>
@@ -659,7 +659,7 @@
           <a:lstStyle xmlns:a="http://schemas.openxmlformats.org/drawingml/2006/main"/>
           <a:p xmlns:a="http://schemas.openxmlformats.org/drawingml/2006/main">
             <a:r>
-              <a:t>[พูด] หลักฐานที่แนบต้องตรวจได้จริงครับ ให้ตรวจ 3 เรื่อง คือ เปิดได้ ตรงกับรายการ และชื่อเอกสารบอกได้ว่าเป็นหลักฐานอะไร ควรทดลองเปิดลิงก์ในหน้าต่างที่ไม่ได้ใช้บัญชีเจ้าของเอกสาร เพื่อให้เห็นเหมือนที่ผู้ประเมินเห็นครับ</a:t>
+              <a:t>[พูด] หลักฐานที่แนบต้องตรวจได้จริงครับ ให้ตรวจ 3 เรื่อง คือ ลิงก์เปิดได้ หลักฐานตรงกับรายการ และเมื่อเปิดลิงก์แล้วรู้ว่าเป็นหลักฐานของรายการใด ควรทดลองเปิดลิงก์ในหน้าต่างที่ไม่ได้ใช้บัญชีเจ้าของเอกสาร เพื่อให้เห็นเหมือนที่ผู้ประเมินเห็นครับ</a:t>
             </a:r>
           </a:p>
           <a:p xmlns:a="http://schemas.openxmlformats.org/drawingml/2006/main">
@@ -1419,7 +1419,7 @@
           </a:p>
           <a:p xmlns:a="http://schemas.openxmlformats.org/drawingml/2006/main">
             <a:r>
-              <a:t>[พูด] ถ้าไม่มีคำถามเพิ่มเติม วันนี้ขอให้จำไว้สามเรื่องครับ ตรวจงานให้ถูก กรอกข้อมูลให้ครบ และบันทึกร่างก่อนส่งจริง ขอบคุณทุกท่านครับ</a:t>
+              <a:t>[พูด] หากท่านใดมีคำถามหรือข้อเสนอแนะเพิ่มเติม สามารถแจ้งได้เลยนะครับ ข้อมูลจากทุกท่านจะช่วยให้ทีมงานปรับระบบให้พร้อมใช้งานมากยิ่งขึ้น ขอบพระคุณทุกท่านที่สละเวลาร่วมทดสอบระบบครับ</a:t>
             </a:r>
           </a:p>
           <a:p xmlns:a="http://schemas.openxmlformats.org/drawingml/2006/main">
@@ -2287,7 +2287,7 @@
   </p:cSld>
   <p:clrMap bg1="lt1" tx1="dk1" bg2="lt2" tx2="dk2" accent1="accent1" accent2="accent2" accent3="accent3" accent4="accent4" accent5="accent5" accent6="accent6" hlink="hlink" folHlink="folHlink"/>
   <p:sldLayoutIdLst>
-    <p:sldLayoutId xmlns:r="http://schemas.openxmlformats.org/officeDocument/2006/relationships" id="2147483649" r:id="Rf0c23d0697814a7b"/>
+    <p:sldLayoutId xmlns:r="http://schemas.openxmlformats.org/officeDocument/2006/relationships" id="2147483649" r:id="R20b5a58c13444278"/>
   </p:sldLayoutIdLst>
   <p:txStyles>
     <p:titleStyle>
@@ -2842,7 +2842,7 @@
           <p:nvPr/>
         </p:nvPicPr>
         <p:blipFill>
-          <a:blip xmlns:r="http://schemas.openxmlformats.org/officeDocument/2006/relationships" xmlns:a="http://schemas.openxmlformats.org/drawingml/2006/main" r:embed="R49f8b4439ded4034"/>
+          <a:blip xmlns:r="http://schemas.openxmlformats.org/officeDocument/2006/relationships" xmlns:a="http://schemas.openxmlformats.org/drawingml/2006/main" r:embed="Rdf8a1e277ab8401b"/>
           <a:srcRect xmlns:a="http://schemas.openxmlformats.org/drawingml/2006/main" l="2579" t="0" r="2579" b="0"/>
           <a:stretch xmlns:a="http://schemas.openxmlformats.org/drawingml/2006/main">
             <a:fillRect l="0" t="0" r="0" b="0"/>
@@ -2863,7 +2863,7 @@
           <p:cNvPr id="2" name="cover-panel">
             <a:extLst xmlns:a="http://schemas.openxmlformats.org/drawingml/2006/main">
               <a:ext uri="{FF2B5EF4-FFF2-40B4-BE49-F238E27FC236}">
-                <a16:creationId xmlns:a16="http://schemas.microsoft.com/office/drawing/2014/main" id="{6CABBDA7-9F13-4FB7-97B8-FE2449584D54}"/>
+                <a16:creationId xmlns:a16="http://schemas.microsoft.com/office/drawing/2014/main" id="{4527FC63-85EB-411E-9FDB-77700EE476FA}"/>
               </a:ext>
             </a:extLst>
           </p:cNvPr>
@@ -2894,7 +2894,7 @@
           <p:cNvPr id="3" name="cover-accent">
             <a:extLst xmlns:a="http://schemas.openxmlformats.org/drawingml/2006/main">
               <a:ext uri="{FF2B5EF4-FFF2-40B4-BE49-F238E27FC236}">
-                <a16:creationId xmlns:a16="http://schemas.microsoft.com/office/drawing/2014/main" id="{620ADE58-8FF5-4F0C-B43F-B432E34E0EE4}"/>
+                <a16:creationId xmlns:a16="http://schemas.microsoft.com/office/drawing/2014/main" id="{FAC4C0DE-604C-4379-80D1-B248996C949B}"/>
               </a:ext>
             </a:extLst>
           </p:cNvPr>
@@ -2929,7 +2929,7 @@
           <p:nvPr/>
         </p:nvPicPr>
         <p:blipFill>
-          <a:blip xmlns:r="http://schemas.openxmlformats.org/officeDocument/2006/relationships" xmlns:a="http://schemas.openxmlformats.org/drawingml/2006/main" r:embed="Rbd8774dc63ea4173"/>
+          <a:blip xmlns:r="http://schemas.openxmlformats.org/officeDocument/2006/relationships" xmlns:a="http://schemas.openxmlformats.org/drawingml/2006/main" r:embed="R585d3f9c6af04f23"/>
           <a:stretch xmlns:a="http://schemas.openxmlformats.org/drawingml/2006/main"/>
         </p:blipFill>
         <p:spPr>
@@ -2947,7 +2947,7 @@
           <p:cNvPr id="5" name="cover-institution">
             <a:extLst xmlns:a="http://schemas.openxmlformats.org/drawingml/2006/main">
               <a:ext uri="{FF2B5EF4-FFF2-40B4-BE49-F238E27FC236}">
-                <a16:creationId xmlns:a16="http://schemas.microsoft.com/office/drawing/2014/main" id="{CD4BE0B5-2015-472B-AE8C-975E04E4EFD7}"/>
+                <a16:creationId xmlns:a16="http://schemas.microsoft.com/office/drawing/2014/main" id="{50C0F961-F1D3-4C4C-AACB-D98DD57BECED}"/>
               </a:ext>
             </a:extLst>
           </p:cNvPr>
@@ -3009,7 +3009,7 @@
           <p:cNvPr id="6" name="cover-session">
             <a:extLst xmlns:a="http://schemas.openxmlformats.org/drawingml/2006/main">
               <a:ext uri="{FF2B5EF4-FFF2-40B4-BE49-F238E27FC236}">
-                <a16:creationId xmlns:a16="http://schemas.microsoft.com/office/drawing/2014/main" id="{C6A1E8A4-116D-4B72-96C5-515CADB11800}"/>
+                <a16:creationId xmlns:a16="http://schemas.microsoft.com/office/drawing/2014/main" id="{0691C973-9F15-4DFB-8224-779282F12074}"/>
               </a:ext>
             </a:extLst>
           </p:cNvPr>
@@ -3071,7 +3071,7 @@
           <p:cNvPr id="7" name="cover-title">
             <a:extLst xmlns:a="http://schemas.openxmlformats.org/drawingml/2006/main">
               <a:ext uri="{FF2B5EF4-FFF2-40B4-BE49-F238E27FC236}">
-                <a16:creationId xmlns:a16="http://schemas.microsoft.com/office/drawing/2014/main" id="{9C355E65-D3EC-4B9A-9283-E1248FBFBCE7}"/>
+                <a16:creationId xmlns:a16="http://schemas.microsoft.com/office/drawing/2014/main" id="{2FA9482D-1E7B-4885-9382-23FC2670605B}"/>
               </a:ext>
             </a:extLst>
           </p:cNvPr>
@@ -3133,7 +3133,7 @@
           <p:cNvPr id="8" name="cover-system-short-name">
             <a:extLst xmlns:a="http://schemas.openxmlformats.org/drawingml/2006/main">
               <a:ext uri="{FF2B5EF4-FFF2-40B4-BE49-F238E27FC236}">
-                <a16:creationId xmlns:a16="http://schemas.microsoft.com/office/drawing/2014/main" id="{AD836E94-EA91-46F7-979D-1FE0633FE2C8}"/>
+                <a16:creationId xmlns:a16="http://schemas.microsoft.com/office/drawing/2014/main" id="{2CA628EB-F864-4B2C-A2FD-612EFA5A3A40}"/>
               </a:ext>
             </a:extLst>
           </p:cNvPr>
@@ -3195,7 +3195,7 @@
           <p:cNvPr id="9" name="cover-gold-rule">
             <a:extLst xmlns:a="http://schemas.openxmlformats.org/drawingml/2006/main">
               <a:ext uri="{FF2B5EF4-FFF2-40B4-BE49-F238E27FC236}">
-                <a16:creationId xmlns:a16="http://schemas.microsoft.com/office/drawing/2014/main" id="{7DF97864-7B8E-48A9-ADF8-0F9CC5BF3A7D}"/>
+                <a16:creationId xmlns:a16="http://schemas.microsoft.com/office/drawing/2014/main" id="{A45F08A2-F90F-4926-ACE5-2155E6D852CB}"/>
               </a:ext>
             </a:extLst>
           </p:cNvPr>
@@ -3226,7 +3226,7 @@
           <p:cNvPr id="10" name="cover-promise">
             <a:extLst xmlns:a="http://schemas.openxmlformats.org/drawingml/2006/main">
               <a:ext uri="{FF2B5EF4-FFF2-40B4-BE49-F238E27FC236}">
-                <a16:creationId xmlns:a16="http://schemas.microsoft.com/office/drawing/2014/main" id="{F2DDFF40-F48D-4C35-982A-5D033AB8E9DF}"/>
+                <a16:creationId xmlns:a16="http://schemas.microsoft.com/office/drawing/2014/main" id="{218FA6EB-1A47-4043-A03D-014D364C0D7E}"/>
               </a:ext>
             </a:extLst>
           </p:cNvPr>
@@ -3288,7 +3288,7 @@
           <p:cNvPr id="11" name="cover-style">
             <a:extLst xmlns:a="http://schemas.openxmlformats.org/drawingml/2006/main">
               <a:ext uri="{FF2B5EF4-FFF2-40B4-BE49-F238E27FC236}">
-                <a16:creationId xmlns:a16="http://schemas.microsoft.com/office/drawing/2014/main" id="{5D839FC5-AA05-4F0B-B745-CDA298002A3B}"/>
+                <a16:creationId xmlns:a16="http://schemas.microsoft.com/office/drawing/2014/main" id="{A864B51A-32AF-4D59-AA98-4E37B58D10DD}"/>
               </a:ext>
             </a:extLst>
           </p:cNvPr>
@@ -3354,7 +3354,7 @@
           <p:nvPr/>
         </p:nvPicPr>
         <p:blipFill>
-          <a:blip xmlns:r="http://schemas.openxmlformats.org/officeDocument/2006/relationships" xmlns:a="http://schemas.openxmlformats.org/drawingml/2006/main" r:embed="R8c25570b21914144"/>
+          <a:blip xmlns:r="http://schemas.openxmlformats.org/officeDocument/2006/relationships" xmlns:a="http://schemas.openxmlformats.org/drawingml/2006/main" r:embed="R1f40831e49104c5d"/>
           <a:stretch xmlns:a="http://schemas.openxmlformats.org/drawingml/2006/main"/>
         </p:blipFill>
         <p:spPr>
@@ -3370,7 +3370,7 @@
     </p:spTree>
     <p:extLst>
       <p:ext uri="{BB962C8B-B14F-4D97-AF65-F5344CB8AC3E}">
-        <p14:creationId xmlns:p14="http://schemas.microsoft.com/office/powerpoint/2010/main" val="898233222"/>
+        <p14:creationId xmlns:p14="http://schemas.microsoft.com/office/powerpoint/2010/main" val="1554894641"/>
       </p:ext>
     </p:extLst>
   </p:cSld>
@@ -3401,7 +3401,7 @@
           <p:cNvPr id="21" name="side-accent-10">
             <a:extLst xmlns:a="http://schemas.openxmlformats.org/drawingml/2006/main">
               <a:ext uri="{FF2B5EF4-FFF2-40B4-BE49-F238E27FC236}">
-                <a16:creationId xmlns:a16="http://schemas.microsoft.com/office/drawing/2014/main" id="{93A135D8-B992-4221-8FE3-FFCBFCE93A81}"/>
+                <a16:creationId xmlns:a16="http://schemas.microsoft.com/office/drawing/2014/main" id="{5E8CF509-4823-48B5-91E5-25608C71CAA6}"/>
               </a:ext>
             </a:extLst>
           </p:cNvPr>
@@ -3432,7 +3432,7 @@
           <p:cNvPr id="2" name="kicker-10">
             <a:extLst xmlns:a="http://schemas.openxmlformats.org/drawingml/2006/main">
               <a:ext uri="{FF2B5EF4-FFF2-40B4-BE49-F238E27FC236}">
-                <a16:creationId xmlns:a16="http://schemas.microsoft.com/office/drawing/2014/main" id="{2CAC109D-959D-4B55-B628-9AF2BF677997}"/>
+                <a16:creationId xmlns:a16="http://schemas.microsoft.com/office/drawing/2014/main" id="{828C74F8-EC76-4387-8E9F-208BF10CE676}"/>
               </a:ext>
             </a:extLst>
           </p:cNvPr>
@@ -3494,7 +3494,7 @@
           <p:cNvPr id="3" name="title-10">
             <a:extLst xmlns:a="http://schemas.openxmlformats.org/drawingml/2006/main">
               <a:ext uri="{FF2B5EF4-FFF2-40B4-BE49-F238E27FC236}">
-                <a16:creationId xmlns:a16="http://schemas.microsoft.com/office/drawing/2014/main" id="{794D7026-26D6-4190-83F1-B38B699D5483}"/>
+                <a16:creationId xmlns:a16="http://schemas.microsoft.com/office/drawing/2014/main" id="{96A29111-45F6-4C90-ABB2-ABA2CEB47D93}"/>
               </a:ext>
             </a:extLst>
           </p:cNvPr>
@@ -3556,7 +3556,7 @@
           <p:cNvPr id="4" name="">
             <a:extLst xmlns:a="http://schemas.openxmlformats.org/drawingml/2006/main">
               <a:ext uri="{FF2B5EF4-FFF2-40B4-BE49-F238E27FC236}">
-                <a16:creationId xmlns:a16="http://schemas.microsoft.com/office/drawing/2014/main" id="{FE6713F9-0B02-471D-952B-2CEC3DBF6EF3}"/>
+                <a16:creationId xmlns:a16="http://schemas.microsoft.com/office/drawing/2014/main" id="{F198B602-AE63-4C9A-9467-24A04055809E}"/>
               </a:ext>
             </a:extLst>
           </p:cNvPr>
@@ -3618,7 +3618,7 @@
           <p:cNvPr id="5" name="">
             <a:extLst xmlns:a="http://schemas.openxmlformats.org/drawingml/2006/main">
               <a:ext uri="{FF2B5EF4-FFF2-40B4-BE49-F238E27FC236}">
-                <a16:creationId xmlns:a16="http://schemas.microsoft.com/office/drawing/2014/main" id="{AA293987-8D79-4CEA-9E76-BB4FAC0D6325}"/>
+                <a16:creationId xmlns:a16="http://schemas.microsoft.com/office/drawing/2014/main" id="{DC99A885-D05B-42F8-811C-A83CC0DBD18C}"/>
               </a:ext>
             </a:extLst>
           </p:cNvPr>
@@ -3680,7 +3680,7 @@
           <p:cNvPr id="6" name="">
             <a:extLst xmlns:a="http://schemas.openxmlformats.org/drawingml/2006/main">
               <a:ext uri="{FF2B5EF4-FFF2-40B4-BE49-F238E27FC236}">
-                <a16:creationId xmlns:a16="http://schemas.microsoft.com/office/drawing/2014/main" id="{285209F1-BDAC-421C-A044-FA6923559FFF}"/>
+                <a16:creationId xmlns:a16="http://schemas.microsoft.com/office/drawing/2014/main" id="{A2302A84-3664-48C5-AAE2-768313279D54}"/>
               </a:ext>
             </a:extLst>
           </p:cNvPr>
@@ -3742,7 +3742,7 @@
           <p:cNvPr id="7" name="">
             <a:extLst xmlns:a="http://schemas.openxmlformats.org/drawingml/2006/main">
               <a:ext uri="{FF2B5EF4-FFF2-40B4-BE49-F238E27FC236}">
-                <a16:creationId xmlns:a16="http://schemas.microsoft.com/office/drawing/2014/main" id="{80034C15-98B6-4480-B7C0-8CCB7CCEDCF2}"/>
+                <a16:creationId xmlns:a16="http://schemas.microsoft.com/office/drawing/2014/main" id="{682F8C60-3403-4F5C-904A-A48DE12CD2F1}"/>
               </a:ext>
             </a:extLst>
           </p:cNvPr>
@@ -3804,7 +3804,7 @@
           <p:cNvPr id="8" name="">
             <a:extLst xmlns:a="http://schemas.openxmlformats.org/drawingml/2006/main">
               <a:ext uri="{FF2B5EF4-FFF2-40B4-BE49-F238E27FC236}">
-                <a16:creationId xmlns:a16="http://schemas.microsoft.com/office/drawing/2014/main" id="{C706E3E1-829B-45AD-A88D-E5C23A3BE0D5}"/>
+                <a16:creationId xmlns:a16="http://schemas.microsoft.com/office/drawing/2014/main" id="{03651D1C-EE2A-4958-8C4B-8B6CE3CD94D6}"/>
               </a:ext>
             </a:extLst>
           </p:cNvPr>
@@ -3835,7 +3835,7 @@
           <p:cNvPr id="9" name="">
             <a:extLst xmlns:a="http://schemas.openxmlformats.org/drawingml/2006/main">
               <a:ext uri="{FF2B5EF4-FFF2-40B4-BE49-F238E27FC236}">
-                <a16:creationId xmlns:a16="http://schemas.microsoft.com/office/drawing/2014/main" id="{11CBBD48-3AAD-4F2B-895A-B1991EF17A31}"/>
+                <a16:creationId xmlns:a16="http://schemas.microsoft.com/office/drawing/2014/main" id="{EF22236C-FFDF-4020-8CDE-C0A3779E2818}"/>
               </a:ext>
             </a:extLst>
           </p:cNvPr>
@@ -3897,7 +3897,7 @@
           <p:cNvPr id="10" name="">
             <a:extLst xmlns:a="http://schemas.openxmlformats.org/drawingml/2006/main">
               <a:ext uri="{FF2B5EF4-FFF2-40B4-BE49-F238E27FC236}">
-                <a16:creationId xmlns:a16="http://schemas.microsoft.com/office/drawing/2014/main" id="{586EEECB-CB34-485A-BE03-5FF6B5D999BD}"/>
+                <a16:creationId xmlns:a16="http://schemas.microsoft.com/office/drawing/2014/main" id="{585F7AB1-5DFF-4D09-8A76-C8E7361C668A}"/>
               </a:ext>
             </a:extLst>
           </p:cNvPr>
@@ -3959,7 +3959,7 @@
           <p:cNvPr id="11" name="">
             <a:extLst xmlns:a="http://schemas.openxmlformats.org/drawingml/2006/main">
               <a:ext uri="{FF2B5EF4-FFF2-40B4-BE49-F238E27FC236}">
-                <a16:creationId xmlns:a16="http://schemas.microsoft.com/office/drawing/2014/main" id="{33AF18D6-8799-46A2-A957-E371F07CE853}"/>
+                <a16:creationId xmlns:a16="http://schemas.microsoft.com/office/drawing/2014/main" id="{280110DD-C7AF-4E75-B5B5-1E74AFAC8FED}"/>
               </a:ext>
             </a:extLst>
           </p:cNvPr>
@@ -4021,7 +4021,7 @@
           <p:cNvPr id="12" name="">
             <a:extLst xmlns:a="http://schemas.openxmlformats.org/drawingml/2006/main">
               <a:ext uri="{FF2B5EF4-FFF2-40B4-BE49-F238E27FC236}">
-                <a16:creationId xmlns:a16="http://schemas.microsoft.com/office/drawing/2014/main" id="{4848770C-CE9D-4C98-A944-00D3E308E000}"/>
+                <a16:creationId xmlns:a16="http://schemas.microsoft.com/office/drawing/2014/main" id="{DE8D235D-E6B5-4F02-9918-42E586E1AE0C}"/>
               </a:ext>
             </a:extLst>
           </p:cNvPr>
@@ -4052,7 +4052,7 @@
           <p:cNvPr id="13" name="">
             <a:extLst xmlns:a="http://schemas.openxmlformats.org/drawingml/2006/main">
               <a:ext uri="{FF2B5EF4-FFF2-40B4-BE49-F238E27FC236}">
-                <a16:creationId xmlns:a16="http://schemas.microsoft.com/office/drawing/2014/main" id="{01CE8866-105C-457B-B1BF-1F6D86ACD0B5}"/>
+                <a16:creationId xmlns:a16="http://schemas.microsoft.com/office/drawing/2014/main" id="{848649AB-6F31-4411-8833-9F58B270CD14}"/>
               </a:ext>
             </a:extLst>
           </p:cNvPr>
@@ -4114,7 +4114,7 @@
           <p:cNvPr id="14" name="">
             <a:extLst xmlns:a="http://schemas.openxmlformats.org/drawingml/2006/main">
               <a:ext uri="{FF2B5EF4-FFF2-40B4-BE49-F238E27FC236}">
-                <a16:creationId xmlns:a16="http://schemas.microsoft.com/office/drawing/2014/main" id="{BEB69AFA-22BE-44AA-B1F0-DC10F0801B72}"/>
+                <a16:creationId xmlns:a16="http://schemas.microsoft.com/office/drawing/2014/main" id="{C464E6CC-1BF7-4CFE-A405-0CA9FE4863DB}"/>
               </a:ext>
             </a:extLst>
           </p:cNvPr>
@@ -4176,7 +4176,7 @@
           <p:cNvPr id="15" name="">
             <a:extLst xmlns:a="http://schemas.openxmlformats.org/drawingml/2006/main">
               <a:ext uri="{FF2B5EF4-FFF2-40B4-BE49-F238E27FC236}">
-                <a16:creationId xmlns:a16="http://schemas.microsoft.com/office/drawing/2014/main" id="{BDE2AA52-4AE6-4A86-8312-5A61ACFCDD61}"/>
+                <a16:creationId xmlns:a16="http://schemas.microsoft.com/office/drawing/2014/main" id="{C2252B2D-F1CC-48DD-9BB5-A9B3CF826354}"/>
               </a:ext>
             </a:extLst>
           </p:cNvPr>
@@ -4238,7 +4238,7 @@
           <p:cNvPr id="16" name="">
             <a:extLst xmlns:a="http://schemas.openxmlformats.org/drawingml/2006/main">
               <a:ext uri="{FF2B5EF4-FFF2-40B4-BE49-F238E27FC236}">
-                <a16:creationId xmlns:a16="http://schemas.microsoft.com/office/drawing/2014/main" id="{D1210652-594E-424B-9D94-647C4F2D111C}"/>
+                <a16:creationId xmlns:a16="http://schemas.microsoft.com/office/drawing/2014/main" id="{6CB46652-90F6-4D77-BB2C-F9F97BF97CC4}"/>
               </a:ext>
             </a:extLst>
           </p:cNvPr>
@@ -4271,7 +4271,7 @@
           <p:cNvPr id="17" name="">
             <a:extLst xmlns:a="http://schemas.openxmlformats.org/drawingml/2006/main">
               <a:ext uri="{FF2B5EF4-FFF2-40B4-BE49-F238E27FC236}">
-                <a16:creationId xmlns:a16="http://schemas.microsoft.com/office/drawing/2014/main" id="{D61944AE-AB6F-4395-822F-609DCA320844}"/>
+                <a16:creationId xmlns:a16="http://schemas.microsoft.com/office/drawing/2014/main" id="{7C938011-8C98-41A1-AEB2-5BBBEBD50D5E}"/>
               </a:ext>
             </a:extLst>
           </p:cNvPr>
@@ -4333,7 +4333,7 @@
           <p:cNvPr id="18" name="footer-rule-10">
             <a:extLst xmlns:a="http://schemas.openxmlformats.org/drawingml/2006/main">
               <a:ext uri="{FF2B5EF4-FFF2-40B4-BE49-F238E27FC236}">
-                <a16:creationId xmlns:a16="http://schemas.microsoft.com/office/drawing/2014/main" id="{C01DEF9B-28B6-43B2-A040-37740098BCD2}"/>
+                <a16:creationId xmlns:a16="http://schemas.microsoft.com/office/drawing/2014/main" id="{19621DA8-B822-4EA8-837B-DDBFBC6754E7}"/>
               </a:ext>
             </a:extLst>
           </p:cNvPr>
@@ -4364,7 +4364,7 @@
           <p:cNvPr id="19" name="footer-label-10">
             <a:extLst xmlns:a="http://schemas.openxmlformats.org/drawingml/2006/main">
               <a:ext uri="{FF2B5EF4-FFF2-40B4-BE49-F238E27FC236}">
-                <a16:creationId xmlns:a16="http://schemas.microsoft.com/office/drawing/2014/main" id="{814014FF-E209-4224-A25C-5356A8370D61}"/>
+                <a16:creationId xmlns:a16="http://schemas.microsoft.com/office/drawing/2014/main" id="{D6EBDBAD-DC89-4EAA-B9C6-088C77D2491E}"/>
               </a:ext>
             </a:extLst>
           </p:cNvPr>
@@ -4426,7 +4426,7 @@
           <p:cNvPr id="20" name="footer-page-10">
             <a:extLst xmlns:a="http://schemas.openxmlformats.org/drawingml/2006/main">
               <a:ext uri="{FF2B5EF4-FFF2-40B4-BE49-F238E27FC236}">
-                <a16:creationId xmlns:a16="http://schemas.microsoft.com/office/drawing/2014/main" id="{07F195E2-15A4-4B6E-9E00-5B3C1B1DFB52}"/>
+                <a16:creationId xmlns:a16="http://schemas.microsoft.com/office/drawing/2014/main" id="{3B120B82-E62C-412B-B3EF-BBDAA1C5A2F2}"/>
               </a:ext>
             </a:extLst>
           </p:cNvPr>
@@ -4486,7 +4486,7 @@
     </p:spTree>
     <p:extLst>
       <p:ext uri="{BB962C8B-B14F-4D97-AF65-F5344CB8AC3E}">
-        <p14:creationId xmlns:p14="http://schemas.microsoft.com/office/powerpoint/2010/main" val="2027149281"/>
+        <p14:creationId xmlns:p14="http://schemas.microsoft.com/office/powerpoint/2010/main" val="265427576"/>
       </p:ext>
     </p:extLst>
   </p:cSld>
@@ -4517,7 +4517,7 @@
           <p:cNvPr id="22" name="side-accent-11">
             <a:extLst xmlns:a="http://schemas.openxmlformats.org/drawingml/2006/main">
               <a:ext uri="{FF2B5EF4-FFF2-40B4-BE49-F238E27FC236}">
-                <a16:creationId xmlns:a16="http://schemas.microsoft.com/office/drawing/2014/main" id="{E06C723F-DCBE-44A0-A4DA-89C12E0DF386}"/>
+                <a16:creationId xmlns:a16="http://schemas.microsoft.com/office/drawing/2014/main" id="{822C1089-E268-4676-B42F-D3910D9EB55A}"/>
               </a:ext>
             </a:extLst>
           </p:cNvPr>
@@ -4548,7 +4548,7 @@
           <p:cNvPr id="2" name="kicker-11">
             <a:extLst xmlns:a="http://schemas.openxmlformats.org/drawingml/2006/main">
               <a:ext uri="{FF2B5EF4-FFF2-40B4-BE49-F238E27FC236}">
-                <a16:creationId xmlns:a16="http://schemas.microsoft.com/office/drawing/2014/main" id="{C47EC59F-9722-418E-855F-FD493E92463D}"/>
+                <a16:creationId xmlns:a16="http://schemas.microsoft.com/office/drawing/2014/main" id="{AED4B9E9-490C-4BF3-BD27-D6117D049FDC}"/>
               </a:ext>
             </a:extLst>
           </p:cNvPr>
@@ -4610,7 +4610,7 @@
           <p:cNvPr id="3" name="title-11">
             <a:extLst xmlns:a="http://schemas.openxmlformats.org/drawingml/2006/main">
               <a:ext uri="{FF2B5EF4-FFF2-40B4-BE49-F238E27FC236}">
-                <a16:creationId xmlns:a16="http://schemas.microsoft.com/office/drawing/2014/main" id="{21A24228-3AEC-4035-9D16-E2956EFC7BDC}"/>
+                <a16:creationId xmlns:a16="http://schemas.microsoft.com/office/drawing/2014/main" id="{C2024E65-737B-4604-91A8-59B62E6E059E}"/>
               </a:ext>
             </a:extLst>
           </p:cNvPr>
@@ -4672,7 +4672,7 @@
           <p:cNvPr id="4" name="">
             <a:extLst xmlns:a="http://schemas.openxmlformats.org/drawingml/2006/main">
               <a:ext uri="{FF2B5EF4-FFF2-40B4-BE49-F238E27FC236}">
-                <a16:creationId xmlns:a16="http://schemas.microsoft.com/office/drawing/2014/main" id="{2EC9B0D0-06BF-46F9-8515-22F094E21FEE}"/>
+                <a16:creationId xmlns:a16="http://schemas.microsoft.com/office/drawing/2014/main" id="{129E957F-89FA-48D1-AB9A-9F190189262B}"/>
               </a:ext>
             </a:extLst>
           </p:cNvPr>
@@ -4734,7 +4734,7 @@
           <p:cNvPr id="5" name="">
             <a:extLst xmlns:a="http://schemas.openxmlformats.org/drawingml/2006/main">
               <a:ext uri="{FF2B5EF4-FFF2-40B4-BE49-F238E27FC236}">
-                <a16:creationId xmlns:a16="http://schemas.microsoft.com/office/drawing/2014/main" id="{5E7A2A9B-1C5C-4B7F-B059-492E49697077}"/>
+                <a16:creationId xmlns:a16="http://schemas.microsoft.com/office/drawing/2014/main" id="{C67F6A78-06C3-4C9C-855E-8A9ACCDF64A7}"/>
               </a:ext>
             </a:extLst>
           </p:cNvPr>
@@ -4765,7 +4765,7 @@
           <p:cNvPr id="6" name="">
             <a:extLst xmlns:a="http://schemas.openxmlformats.org/drawingml/2006/main">
               <a:ext uri="{FF2B5EF4-FFF2-40B4-BE49-F238E27FC236}">
-                <a16:creationId xmlns:a16="http://schemas.microsoft.com/office/drawing/2014/main" id="{CE34C448-F054-4728-839E-6FCAFF8EC574}"/>
+                <a16:creationId xmlns:a16="http://schemas.microsoft.com/office/drawing/2014/main" id="{9789766D-037A-4418-9934-6BD8A6D40AB9}"/>
               </a:ext>
             </a:extLst>
           </p:cNvPr>
@@ -4827,7 +4827,7 @@
           <p:cNvPr id="7" name="">
             <a:extLst xmlns:a="http://schemas.openxmlformats.org/drawingml/2006/main">
               <a:ext uri="{FF2B5EF4-FFF2-40B4-BE49-F238E27FC236}">
-                <a16:creationId xmlns:a16="http://schemas.microsoft.com/office/drawing/2014/main" id="{1D6F0897-8DA7-4550-B133-8BFA8594E852}"/>
+                <a16:creationId xmlns:a16="http://schemas.microsoft.com/office/drawing/2014/main" id="{C65FA5AA-883A-4B4D-A253-6E37A8FBC0FE}"/>
               </a:ext>
             </a:extLst>
           </p:cNvPr>
@@ -4839,7 +4839,7 @@
         <p:spPr>
           <a:xfrm xmlns:a="http://schemas.openxmlformats.org/drawingml/2006/main">
             <a:off x="1390650" y="2762250"/>
-            <a:ext cx="2286000" cy="400050"/>
+            <a:ext cx="2857500" cy="400050"/>
           </a:xfrm>
           <a:prstGeom xmlns:a="http://schemas.openxmlformats.org/drawingml/2006/main" prst="rect">
             <a:avLst/>
@@ -4889,19 +4889,19 @@
           <p:cNvPr id="8" name="">
             <a:extLst xmlns:a="http://schemas.openxmlformats.org/drawingml/2006/main">
               <a:ext uri="{FF2B5EF4-FFF2-40B4-BE49-F238E27FC236}">
-                <a16:creationId xmlns:a16="http://schemas.microsoft.com/office/drawing/2014/main" id="{D0ECF5F7-FFEB-4DDF-946C-32A90578A326}"/>
-              </a:ext>
-            </a:extLst>
-          </p:cNvPr>
-          <p:cNvSpPr>
-            <a:spLocks xmlns:a="http://schemas.openxmlformats.org/drawingml/2006/main" noGrp="1"/>
-          </p:cNvSpPr>
-          <p:nvPr/>
-        </p:nvSpPr>
-        <p:spPr>
-          <a:xfrm xmlns:a="http://schemas.openxmlformats.org/drawingml/2006/main">
-            <a:off x="3905250" y="2781300"/>
-            <a:ext cx="6667500" cy="438150"/>
+                <a16:creationId xmlns:a16="http://schemas.microsoft.com/office/drawing/2014/main" id="{6DF7B4D8-F099-4810-B3FE-0BF77CB356B7}"/>
+              </a:ext>
+            </a:extLst>
+          </p:cNvPr>
+          <p:cNvSpPr>
+            <a:spLocks xmlns:a="http://schemas.openxmlformats.org/drawingml/2006/main" noGrp="1"/>
+          </p:cNvSpPr>
+          <p:nvPr/>
+        </p:nvSpPr>
+        <p:spPr>
+          <a:xfrm xmlns:a="http://schemas.openxmlformats.org/drawingml/2006/main">
+            <a:off x="4476750" y="2781300"/>
+            <a:ext cx="6572250" cy="438150"/>
           </a:xfrm>
           <a:prstGeom xmlns:a="http://schemas.openxmlformats.org/drawingml/2006/main" prst="rect">
             <a:avLst/>
@@ -4951,7 +4951,7 @@
           <p:cNvPr id="9" name="">
             <a:extLst xmlns:a="http://schemas.openxmlformats.org/drawingml/2006/main">
               <a:ext uri="{FF2B5EF4-FFF2-40B4-BE49-F238E27FC236}">
-                <a16:creationId xmlns:a16="http://schemas.microsoft.com/office/drawing/2014/main" id="{D3A7DE8D-374A-47CC-BFDB-0DB811DC9FE4}"/>
+                <a16:creationId xmlns:a16="http://schemas.microsoft.com/office/drawing/2014/main" id="{E95A8A2B-4BA5-4149-B51D-0E128A0AFEDE}"/>
               </a:ext>
             </a:extLst>
           </p:cNvPr>
@@ -4982,7 +4982,7 @@
           <p:cNvPr id="10" name="">
             <a:extLst xmlns:a="http://schemas.openxmlformats.org/drawingml/2006/main">
               <a:ext uri="{FF2B5EF4-FFF2-40B4-BE49-F238E27FC236}">
-                <a16:creationId xmlns:a16="http://schemas.microsoft.com/office/drawing/2014/main" id="{E12A160F-DA6E-4769-B8F6-C5FB1FD64FE3}"/>
+                <a16:creationId xmlns:a16="http://schemas.microsoft.com/office/drawing/2014/main" id="{79730703-B819-45F5-8010-ED71C5ED6577}"/>
               </a:ext>
             </a:extLst>
           </p:cNvPr>
@@ -5044,7 +5044,7 @@
           <p:cNvPr id="11" name="">
             <a:extLst xmlns:a="http://schemas.openxmlformats.org/drawingml/2006/main">
               <a:ext uri="{FF2B5EF4-FFF2-40B4-BE49-F238E27FC236}">
-                <a16:creationId xmlns:a16="http://schemas.microsoft.com/office/drawing/2014/main" id="{BBC134AD-C4F8-494B-9489-25430C6291B6}"/>
+                <a16:creationId xmlns:a16="http://schemas.microsoft.com/office/drawing/2014/main" id="{7E947044-7A8E-4BD6-81B3-E17D5AA63948}"/>
               </a:ext>
             </a:extLst>
           </p:cNvPr>
@@ -5056,7 +5056,7 @@
         <p:spPr>
           <a:xfrm xmlns:a="http://schemas.openxmlformats.org/drawingml/2006/main">
             <a:off x="1390650" y="3695700"/>
-            <a:ext cx="2286000" cy="400050"/>
+            <a:ext cx="2857500" cy="400050"/>
           </a:xfrm>
           <a:prstGeom xmlns:a="http://schemas.openxmlformats.org/drawingml/2006/main" prst="rect">
             <a:avLst/>
@@ -5106,19 +5106,19 @@
           <p:cNvPr id="12" name="">
             <a:extLst xmlns:a="http://schemas.openxmlformats.org/drawingml/2006/main">
               <a:ext uri="{FF2B5EF4-FFF2-40B4-BE49-F238E27FC236}">
-                <a16:creationId xmlns:a16="http://schemas.microsoft.com/office/drawing/2014/main" id="{B9F05342-BAE9-457C-AA2A-DA9CAEF6FCA3}"/>
-              </a:ext>
-            </a:extLst>
-          </p:cNvPr>
-          <p:cNvSpPr>
-            <a:spLocks xmlns:a="http://schemas.openxmlformats.org/drawingml/2006/main" noGrp="1"/>
-          </p:cNvSpPr>
-          <p:nvPr/>
-        </p:nvSpPr>
-        <p:spPr>
-          <a:xfrm xmlns:a="http://schemas.openxmlformats.org/drawingml/2006/main">
-            <a:off x="3905250" y="3714750"/>
-            <a:ext cx="6667500" cy="438150"/>
+                <a16:creationId xmlns:a16="http://schemas.microsoft.com/office/drawing/2014/main" id="{1CA45362-0076-41AB-B184-D8953423A4C6}"/>
+              </a:ext>
+            </a:extLst>
+          </p:cNvPr>
+          <p:cNvSpPr>
+            <a:spLocks xmlns:a="http://schemas.openxmlformats.org/drawingml/2006/main" noGrp="1"/>
+          </p:cNvSpPr>
+          <p:nvPr/>
+        </p:nvSpPr>
+        <p:spPr>
+          <a:xfrm xmlns:a="http://schemas.openxmlformats.org/drawingml/2006/main">
+            <a:off x="4476750" y="3714750"/>
+            <a:ext cx="6572250" cy="438150"/>
           </a:xfrm>
           <a:prstGeom xmlns:a="http://schemas.openxmlformats.org/drawingml/2006/main" prst="rect">
             <a:avLst/>
@@ -5168,7 +5168,7 @@
           <p:cNvPr id="13" name="">
             <a:extLst xmlns:a="http://schemas.openxmlformats.org/drawingml/2006/main">
               <a:ext uri="{FF2B5EF4-FFF2-40B4-BE49-F238E27FC236}">
-                <a16:creationId xmlns:a16="http://schemas.microsoft.com/office/drawing/2014/main" id="{CCA90D15-26CD-4E4B-9835-BD14CA258650}"/>
+                <a16:creationId xmlns:a16="http://schemas.microsoft.com/office/drawing/2014/main" id="{B73FD503-09D4-4D58-B8A2-A62B056C3E14}"/>
               </a:ext>
             </a:extLst>
           </p:cNvPr>
@@ -5199,7 +5199,7 @@
           <p:cNvPr id="14" name="">
             <a:extLst xmlns:a="http://schemas.openxmlformats.org/drawingml/2006/main">
               <a:ext uri="{FF2B5EF4-FFF2-40B4-BE49-F238E27FC236}">
-                <a16:creationId xmlns:a16="http://schemas.microsoft.com/office/drawing/2014/main" id="{ABD1434D-575B-492A-874C-DF716171B688}"/>
+                <a16:creationId xmlns:a16="http://schemas.microsoft.com/office/drawing/2014/main" id="{5158B848-037B-4066-8721-E34D717DC21F}"/>
               </a:ext>
             </a:extLst>
           </p:cNvPr>
@@ -5261,7 +5261,7 @@
           <p:cNvPr id="15" name="">
             <a:extLst xmlns:a="http://schemas.openxmlformats.org/drawingml/2006/main">
               <a:ext uri="{FF2B5EF4-FFF2-40B4-BE49-F238E27FC236}">
-                <a16:creationId xmlns:a16="http://schemas.microsoft.com/office/drawing/2014/main" id="{29C6105C-7CAF-45F1-9795-B1DC1B330DCE}"/>
+                <a16:creationId xmlns:a16="http://schemas.microsoft.com/office/drawing/2014/main" id="{8E9DF60C-1D66-4A48-B6C0-40845DDE2AE0}"/>
               </a:ext>
             </a:extLst>
           </p:cNvPr>
@@ -5273,7 +5273,7 @@
         <p:spPr>
           <a:xfrm xmlns:a="http://schemas.openxmlformats.org/drawingml/2006/main">
             <a:off x="1390650" y="4629150"/>
-            <a:ext cx="2286000" cy="400050"/>
+            <a:ext cx="2857500" cy="400050"/>
           </a:xfrm>
           <a:prstGeom xmlns:a="http://schemas.openxmlformats.org/drawingml/2006/main" prst="rect">
             <a:avLst/>
@@ -5295,7 +5295,7 @@
                 <a:spcPct val="100000"/>
               </a:lnSpc>
               <a:buNone/>
-              <a:defRPr sz="2100" b="1">
+              <a:defRPr sz="1950" b="1">
                 <a:solidFill>
                   <a:srgbClr val="102A43"/>
                 </a:solidFill>
@@ -5305,7 +5305,7 @@
               </a:defRPr>
             </a:pPr>
             <a:r>
-              <a:rPr sz="2100" b="1">
+              <a:rPr sz="1950" b="1">
                 <a:solidFill>
                   <a:srgbClr val="102A43"/>
                 </a:solidFill>
@@ -5313,7 +5313,7 @@
                 <a:ea typeface="Tahoma"/>
                 <a:cs typeface="Tahoma"/>
               </a:rPr>
-              <a:t>ระบุตัวตนได้</a:t>
+              <a:t>ตรวจสอบได้ชัดเจน</a:t>
             </a:r>
           </a:p>
         </p:txBody>
@@ -5323,19 +5323,19 @@
           <p:cNvPr id="16" name="">
             <a:extLst xmlns:a="http://schemas.openxmlformats.org/drawingml/2006/main">
               <a:ext uri="{FF2B5EF4-FFF2-40B4-BE49-F238E27FC236}">
-                <a16:creationId xmlns:a16="http://schemas.microsoft.com/office/drawing/2014/main" id="{41A8D8B3-428F-4FC4-9781-178597F88EDA}"/>
-              </a:ext>
-            </a:extLst>
-          </p:cNvPr>
-          <p:cNvSpPr>
-            <a:spLocks xmlns:a="http://schemas.openxmlformats.org/drawingml/2006/main" noGrp="1"/>
-          </p:cNvSpPr>
-          <p:nvPr/>
-        </p:nvSpPr>
-        <p:spPr>
-          <a:xfrm xmlns:a="http://schemas.openxmlformats.org/drawingml/2006/main">
-            <a:off x="3905250" y="4648200"/>
-            <a:ext cx="6667500" cy="438150"/>
+                <a16:creationId xmlns:a16="http://schemas.microsoft.com/office/drawing/2014/main" id="{C5355FF2-AED7-4C4A-A80C-D99B4B8634C5}"/>
+              </a:ext>
+            </a:extLst>
+          </p:cNvPr>
+          <p:cNvSpPr>
+            <a:spLocks xmlns:a="http://schemas.openxmlformats.org/drawingml/2006/main" noGrp="1"/>
+          </p:cNvSpPr>
+          <p:nvPr/>
+        </p:nvSpPr>
+        <p:spPr>
+          <a:xfrm xmlns:a="http://schemas.openxmlformats.org/drawingml/2006/main">
+            <a:off x="4476750" y="4648200"/>
+            <a:ext cx="6572250" cy="438150"/>
           </a:xfrm>
           <a:prstGeom xmlns:a="http://schemas.openxmlformats.org/drawingml/2006/main" prst="rect">
             <a:avLst/>
@@ -5375,7 +5375,7 @@
                 <a:ea typeface="Tahoma"/>
                 <a:cs typeface="Tahoma"/>
               </a:rPr>
-              <a:t>ตั้งชื่อไฟล์หรือเอกสารให้เข้าใจง่าย</a:t>
+              <a:t>เปิดลิงก์แล้วรู้ว่าเป็นหลักฐานของรายการใด</a:t>
             </a:r>
           </a:p>
         </p:txBody>
@@ -5385,7 +5385,7 @@
           <p:cNvPr id="17" name="">
             <a:extLst xmlns:a="http://schemas.openxmlformats.org/drawingml/2006/main">
               <a:ext uri="{FF2B5EF4-FFF2-40B4-BE49-F238E27FC236}">
-                <a16:creationId xmlns:a16="http://schemas.microsoft.com/office/drawing/2014/main" id="{19ECF44D-131D-4313-872F-286164529C49}"/>
+                <a16:creationId xmlns:a16="http://schemas.microsoft.com/office/drawing/2014/main" id="{8AEE2F58-3396-49AD-8B43-13EC8CA12B17}"/>
               </a:ext>
             </a:extLst>
           </p:cNvPr>
@@ -5420,7 +5420,7 @@
           <p:cNvPr id="18" name="">
             <a:extLst xmlns:a="http://schemas.openxmlformats.org/drawingml/2006/main">
               <a:ext uri="{FF2B5EF4-FFF2-40B4-BE49-F238E27FC236}">
-                <a16:creationId xmlns:a16="http://schemas.microsoft.com/office/drawing/2014/main" id="{2677478C-5281-444D-9453-0852C203BEF3}"/>
+                <a16:creationId xmlns:a16="http://schemas.microsoft.com/office/drawing/2014/main" id="{FFE076BD-8449-41EA-9E50-63452E2A35B1}"/>
               </a:ext>
             </a:extLst>
           </p:cNvPr>
@@ -5509,7 +5509,7 @@
           <p:cNvPr id="19" name="footer-rule-11">
             <a:extLst xmlns:a="http://schemas.openxmlformats.org/drawingml/2006/main">
               <a:ext uri="{FF2B5EF4-FFF2-40B4-BE49-F238E27FC236}">
-                <a16:creationId xmlns:a16="http://schemas.microsoft.com/office/drawing/2014/main" id="{F0A5BC53-D7F0-4982-9A5C-1BF7EA8B5504}"/>
+                <a16:creationId xmlns:a16="http://schemas.microsoft.com/office/drawing/2014/main" id="{005C6DC7-9351-43EC-BF4C-F707A6400FDC}"/>
               </a:ext>
             </a:extLst>
           </p:cNvPr>
@@ -5540,7 +5540,7 @@
           <p:cNvPr id="20" name="footer-label-11">
             <a:extLst xmlns:a="http://schemas.openxmlformats.org/drawingml/2006/main">
               <a:ext uri="{FF2B5EF4-FFF2-40B4-BE49-F238E27FC236}">
-                <a16:creationId xmlns:a16="http://schemas.microsoft.com/office/drawing/2014/main" id="{09317719-387A-470D-9713-F2C440C93406}"/>
+                <a16:creationId xmlns:a16="http://schemas.microsoft.com/office/drawing/2014/main" id="{EC808725-422A-4B68-9608-37A057DA1D59}"/>
               </a:ext>
             </a:extLst>
           </p:cNvPr>
@@ -5602,7 +5602,7 @@
           <p:cNvPr id="21" name="footer-page-11">
             <a:extLst xmlns:a="http://schemas.openxmlformats.org/drawingml/2006/main">
               <a:ext uri="{FF2B5EF4-FFF2-40B4-BE49-F238E27FC236}">
-                <a16:creationId xmlns:a16="http://schemas.microsoft.com/office/drawing/2014/main" id="{0136F0CC-CA40-4499-9EA0-E7C6A485EEB4}"/>
+                <a16:creationId xmlns:a16="http://schemas.microsoft.com/office/drawing/2014/main" id="{5B06FBD3-E8F2-422E-8A6F-560EB70CB94F}"/>
               </a:ext>
             </a:extLst>
           </p:cNvPr>
@@ -5662,7 +5662,7 @@
     </p:spTree>
     <p:extLst>
       <p:ext uri="{BB962C8B-B14F-4D97-AF65-F5344CB8AC3E}">
-        <p14:creationId xmlns:p14="http://schemas.microsoft.com/office/powerpoint/2010/main" val="698321889"/>
+        <p14:creationId xmlns:p14="http://schemas.microsoft.com/office/powerpoint/2010/main" val="2038656602"/>
       </p:ext>
     </p:extLst>
   </p:cSld>
@@ -5693,7 +5693,7 @@
           <p:cNvPr id="14" name="side-accent-12">
             <a:extLst xmlns:a="http://schemas.openxmlformats.org/drawingml/2006/main">
               <a:ext uri="{FF2B5EF4-FFF2-40B4-BE49-F238E27FC236}">
-                <a16:creationId xmlns:a16="http://schemas.microsoft.com/office/drawing/2014/main" id="{9CA8E64A-5DA3-46AA-8A45-B196CC48C2EA}"/>
+                <a16:creationId xmlns:a16="http://schemas.microsoft.com/office/drawing/2014/main" id="{FCACF24F-AA80-4772-A0DE-3665EC3C86BD}"/>
               </a:ext>
             </a:extLst>
           </p:cNvPr>
@@ -5724,7 +5724,7 @@
           <p:cNvPr id="2" name="kicker-12">
             <a:extLst xmlns:a="http://schemas.openxmlformats.org/drawingml/2006/main">
               <a:ext uri="{FF2B5EF4-FFF2-40B4-BE49-F238E27FC236}">
-                <a16:creationId xmlns:a16="http://schemas.microsoft.com/office/drawing/2014/main" id="{8D77D764-D209-42E2-91D9-155FBCBC0E14}"/>
+                <a16:creationId xmlns:a16="http://schemas.microsoft.com/office/drawing/2014/main" id="{F897A959-08A4-44E6-889C-8D5A525B3191}"/>
               </a:ext>
             </a:extLst>
           </p:cNvPr>
@@ -5786,7 +5786,7 @@
           <p:cNvPr id="3" name="title-12">
             <a:extLst xmlns:a="http://schemas.openxmlformats.org/drawingml/2006/main">
               <a:ext uri="{FF2B5EF4-FFF2-40B4-BE49-F238E27FC236}">
-                <a16:creationId xmlns:a16="http://schemas.microsoft.com/office/drawing/2014/main" id="{ADDEA42A-44C6-43FB-A4D7-D4ED298B19AF}"/>
+                <a16:creationId xmlns:a16="http://schemas.microsoft.com/office/drawing/2014/main" id="{0B5716BA-BF55-457C-B1CD-B53BD4A55D6C}"/>
               </a:ext>
             </a:extLst>
           </p:cNvPr>
@@ -5848,7 +5848,7 @@
           <p:cNvPr id="4" name="draft-panel">
             <a:extLst xmlns:a="http://schemas.openxmlformats.org/drawingml/2006/main">
               <a:ext uri="{FF2B5EF4-FFF2-40B4-BE49-F238E27FC236}">
-                <a16:creationId xmlns:a16="http://schemas.microsoft.com/office/drawing/2014/main" id="{8DC37421-FFE1-4DAE-90F1-FAD2A828D5B8}"/>
+                <a16:creationId xmlns:a16="http://schemas.microsoft.com/office/drawing/2014/main" id="{A02584B7-D3AA-4F43-80D4-E82FD4CFA358}"/>
               </a:ext>
             </a:extLst>
           </p:cNvPr>
@@ -5883,7 +5883,7 @@
           <p:cNvPr id="5" name="">
             <a:extLst xmlns:a="http://schemas.openxmlformats.org/drawingml/2006/main">
               <a:ext uri="{FF2B5EF4-FFF2-40B4-BE49-F238E27FC236}">
-                <a16:creationId xmlns:a16="http://schemas.microsoft.com/office/drawing/2014/main" id="{623D4B2D-6A04-4789-BAA1-AE62C436CA5A}"/>
+                <a16:creationId xmlns:a16="http://schemas.microsoft.com/office/drawing/2014/main" id="{2128617F-5E64-482E-9F29-15371161A310}"/>
               </a:ext>
             </a:extLst>
           </p:cNvPr>
@@ -5945,7 +5945,7 @@
           <p:cNvPr id="6" name="">
             <a:extLst xmlns:a="http://schemas.openxmlformats.org/drawingml/2006/main">
               <a:ext uri="{FF2B5EF4-FFF2-40B4-BE49-F238E27FC236}">
-                <a16:creationId xmlns:a16="http://schemas.microsoft.com/office/drawing/2014/main" id="{01DCF48D-9E4A-42C2-AE99-ADBFFF0DDC23}"/>
+                <a16:creationId xmlns:a16="http://schemas.microsoft.com/office/drawing/2014/main" id="{02643DE8-0B74-423A-8842-01809758801E}"/>
               </a:ext>
             </a:extLst>
           </p:cNvPr>
@@ -6061,7 +6061,7 @@
           <p:cNvPr id="7" name="submit-panel">
             <a:extLst xmlns:a="http://schemas.openxmlformats.org/drawingml/2006/main">
               <a:ext uri="{FF2B5EF4-FFF2-40B4-BE49-F238E27FC236}">
-                <a16:creationId xmlns:a16="http://schemas.microsoft.com/office/drawing/2014/main" id="{B9EFED19-38E5-4254-8CDE-DC8694CE4236}"/>
+                <a16:creationId xmlns:a16="http://schemas.microsoft.com/office/drawing/2014/main" id="{F8ACC95C-4B32-4213-B45A-1AD2BD3F1F79}"/>
               </a:ext>
             </a:extLst>
           </p:cNvPr>
@@ -6096,7 +6096,7 @@
           <p:cNvPr id="8" name="">
             <a:extLst xmlns:a="http://schemas.openxmlformats.org/drawingml/2006/main">
               <a:ext uri="{FF2B5EF4-FFF2-40B4-BE49-F238E27FC236}">
-                <a16:creationId xmlns:a16="http://schemas.microsoft.com/office/drawing/2014/main" id="{83853CEF-D4D4-4D1D-BF95-1FC15EBB824F}"/>
+                <a16:creationId xmlns:a16="http://schemas.microsoft.com/office/drawing/2014/main" id="{A89954FC-040A-4F24-A539-E3B64AFB8F93}"/>
               </a:ext>
             </a:extLst>
           </p:cNvPr>
@@ -6158,7 +6158,7 @@
           <p:cNvPr id="9" name="">
             <a:extLst xmlns:a="http://schemas.openxmlformats.org/drawingml/2006/main">
               <a:ext uri="{FF2B5EF4-FFF2-40B4-BE49-F238E27FC236}">
-                <a16:creationId xmlns:a16="http://schemas.microsoft.com/office/drawing/2014/main" id="{C1A57F7B-72FF-409B-8139-575AB94F94EF}"/>
+                <a16:creationId xmlns:a16="http://schemas.microsoft.com/office/drawing/2014/main" id="{B8D5D2AA-74F6-4027-88EB-4CC85D1903E4}"/>
               </a:ext>
             </a:extLst>
           </p:cNvPr>
@@ -6274,7 +6274,7 @@
           <p:cNvPr id="10" name="">
             <a:extLst xmlns:a="http://schemas.openxmlformats.org/drawingml/2006/main">
               <a:ext uri="{FF2B5EF4-FFF2-40B4-BE49-F238E27FC236}">
-                <a16:creationId xmlns:a16="http://schemas.microsoft.com/office/drawing/2014/main" id="{F6D782B9-A465-42DC-8DA7-D03623D82DA3}"/>
+                <a16:creationId xmlns:a16="http://schemas.microsoft.com/office/drawing/2014/main" id="{6F5E09B1-E2F4-489B-8317-29240B198D30}"/>
               </a:ext>
             </a:extLst>
           </p:cNvPr>
@@ -6336,7 +6336,7 @@
           <p:cNvPr id="11" name="footer-rule-12">
             <a:extLst xmlns:a="http://schemas.openxmlformats.org/drawingml/2006/main">
               <a:ext uri="{FF2B5EF4-FFF2-40B4-BE49-F238E27FC236}">
-                <a16:creationId xmlns:a16="http://schemas.microsoft.com/office/drawing/2014/main" id="{D2BF0F77-4326-4416-9A05-C4E644706139}"/>
+                <a16:creationId xmlns:a16="http://schemas.microsoft.com/office/drawing/2014/main" id="{65F12010-2200-4A84-870E-9287F2D93973}"/>
               </a:ext>
             </a:extLst>
           </p:cNvPr>
@@ -6367,7 +6367,7 @@
           <p:cNvPr id="12" name="footer-label-12">
             <a:extLst xmlns:a="http://schemas.openxmlformats.org/drawingml/2006/main">
               <a:ext uri="{FF2B5EF4-FFF2-40B4-BE49-F238E27FC236}">
-                <a16:creationId xmlns:a16="http://schemas.microsoft.com/office/drawing/2014/main" id="{D7F65B39-6597-43F2-896E-1925FCB78BDA}"/>
+                <a16:creationId xmlns:a16="http://schemas.microsoft.com/office/drawing/2014/main" id="{24BC07A5-03B7-4E04-BD9C-666E68C03799}"/>
               </a:ext>
             </a:extLst>
           </p:cNvPr>
@@ -6429,7 +6429,7 @@
           <p:cNvPr id="13" name="footer-page-12">
             <a:extLst xmlns:a="http://schemas.openxmlformats.org/drawingml/2006/main">
               <a:ext uri="{FF2B5EF4-FFF2-40B4-BE49-F238E27FC236}">
-                <a16:creationId xmlns:a16="http://schemas.microsoft.com/office/drawing/2014/main" id="{6CE39BE8-73D6-4777-99B9-574E625ECC22}"/>
+                <a16:creationId xmlns:a16="http://schemas.microsoft.com/office/drawing/2014/main" id="{F6808344-B338-474D-BE40-138DAF6F3CE4}"/>
               </a:ext>
             </a:extLst>
           </p:cNvPr>
@@ -6489,7 +6489,7 @@
     </p:spTree>
     <p:extLst>
       <p:ext uri="{BB962C8B-B14F-4D97-AF65-F5344CB8AC3E}">
-        <p14:creationId xmlns:p14="http://schemas.microsoft.com/office/powerpoint/2010/main" val="1122592038"/>
+        <p14:creationId xmlns:p14="http://schemas.microsoft.com/office/powerpoint/2010/main" val="2052014103"/>
       </p:ext>
     </p:extLst>
   </p:cSld>
@@ -6520,7 +6520,7 @@
           <p:cNvPr id="25" name="side-accent-13">
             <a:extLst xmlns:a="http://schemas.openxmlformats.org/drawingml/2006/main">
               <a:ext uri="{FF2B5EF4-FFF2-40B4-BE49-F238E27FC236}">
-                <a16:creationId xmlns:a16="http://schemas.microsoft.com/office/drawing/2014/main" id="{57E44C8A-6D0F-4B7F-9164-3C444EB7B800}"/>
+                <a16:creationId xmlns:a16="http://schemas.microsoft.com/office/drawing/2014/main" id="{02E6A072-9048-40CA-9EBE-F1F1A089497D}"/>
               </a:ext>
             </a:extLst>
           </p:cNvPr>
@@ -6551,7 +6551,7 @@
           <p:cNvPr id="2" name="kicker-13">
             <a:extLst xmlns:a="http://schemas.openxmlformats.org/drawingml/2006/main">
               <a:ext uri="{FF2B5EF4-FFF2-40B4-BE49-F238E27FC236}">
-                <a16:creationId xmlns:a16="http://schemas.microsoft.com/office/drawing/2014/main" id="{0CBF2408-894F-4A94-9DE5-D7D801E320A1}"/>
+                <a16:creationId xmlns:a16="http://schemas.microsoft.com/office/drawing/2014/main" id="{5C6DF204-9ADB-48D9-BFF1-9098F8FB0B41}"/>
               </a:ext>
             </a:extLst>
           </p:cNvPr>
@@ -6613,7 +6613,7 @@
           <p:cNvPr id="3" name="title-13">
             <a:extLst xmlns:a="http://schemas.openxmlformats.org/drawingml/2006/main">
               <a:ext uri="{FF2B5EF4-FFF2-40B4-BE49-F238E27FC236}">
-                <a16:creationId xmlns:a16="http://schemas.microsoft.com/office/drawing/2014/main" id="{6AC04F84-29BF-4924-9241-EE19D2CD39C6}"/>
+                <a16:creationId xmlns:a16="http://schemas.microsoft.com/office/drawing/2014/main" id="{7C30150E-1EA6-4A23-AE00-DF78A6C26A73}"/>
               </a:ext>
             </a:extLst>
           </p:cNvPr>
@@ -6675,7 +6675,7 @@
           <p:cNvPr id="4" name="">
             <a:extLst xmlns:a="http://schemas.openxmlformats.org/drawingml/2006/main">
               <a:ext uri="{FF2B5EF4-FFF2-40B4-BE49-F238E27FC236}">
-                <a16:creationId xmlns:a16="http://schemas.microsoft.com/office/drawing/2014/main" id="{E1F2B309-58B9-4D64-A2F3-7B7A928F5696}"/>
+                <a16:creationId xmlns:a16="http://schemas.microsoft.com/office/drawing/2014/main" id="{4FABC7F2-D7DC-4764-9D3A-C42BF281251B}"/>
               </a:ext>
             </a:extLst>
           </p:cNvPr>
@@ -6706,7 +6706,7 @@
           <p:cNvPr id="5" name="">
             <a:extLst xmlns:a="http://schemas.openxmlformats.org/drawingml/2006/main">
               <a:ext uri="{FF2B5EF4-FFF2-40B4-BE49-F238E27FC236}">
-                <a16:creationId xmlns:a16="http://schemas.microsoft.com/office/drawing/2014/main" id="{47D3171E-ACBA-4D31-9C18-DAB5F55DA302}"/>
+                <a16:creationId xmlns:a16="http://schemas.microsoft.com/office/drawing/2014/main" id="{128AB717-B38B-4185-9E1B-FC74F9464DBC}"/>
               </a:ext>
             </a:extLst>
           </p:cNvPr>
@@ -6737,7 +6737,7 @@
           <p:cNvPr id="6" name="">
             <a:extLst xmlns:a="http://schemas.openxmlformats.org/drawingml/2006/main">
               <a:ext uri="{FF2B5EF4-FFF2-40B4-BE49-F238E27FC236}">
-                <a16:creationId xmlns:a16="http://schemas.microsoft.com/office/drawing/2014/main" id="{13A82FA3-CB91-4F87-A0E3-A569B1E0E5AB}"/>
+                <a16:creationId xmlns:a16="http://schemas.microsoft.com/office/drawing/2014/main" id="{3F2077BA-9F2D-40F8-82B2-64D9FD1756CB}"/>
               </a:ext>
             </a:extLst>
           </p:cNvPr>
@@ -6799,7 +6799,7 @@
           <p:cNvPr id="7" name="">
             <a:extLst xmlns:a="http://schemas.openxmlformats.org/drawingml/2006/main">
               <a:ext uri="{FF2B5EF4-FFF2-40B4-BE49-F238E27FC236}">
-                <a16:creationId xmlns:a16="http://schemas.microsoft.com/office/drawing/2014/main" id="{005A8180-F006-4A77-BCA1-2F98B8F109B5}"/>
+                <a16:creationId xmlns:a16="http://schemas.microsoft.com/office/drawing/2014/main" id="{D9A74E68-002E-4A60-8D79-569A116C2536}"/>
               </a:ext>
             </a:extLst>
           </p:cNvPr>
@@ -6861,7 +6861,7 @@
           <p:cNvPr id="8" name="">
             <a:extLst xmlns:a="http://schemas.openxmlformats.org/drawingml/2006/main">
               <a:ext uri="{FF2B5EF4-FFF2-40B4-BE49-F238E27FC236}">
-                <a16:creationId xmlns:a16="http://schemas.microsoft.com/office/drawing/2014/main" id="{C182BCB3-03A5-4D75-BF25-32C43A0C44E6}"/>
+                <a16:creationId xmlns:a16="http://schemas.microsoft.com/office/drawing/2014/main" id="{144373F5-7130-4132-AA06-76A9493DDA56}"/>
               </a:ext>
             </a:extLst>
           </p:cNvPr>
@@ -6923,7 +6923,7 @@
           <p:cNvPr id="9" name="">
             <a:extLst xmlns:a="http://schemas.openxmlformats.org/drawingml/2006/main">
               <a:ext uri="{FF2B5EF4-FFF2-40B4-BE49-F238E27FC236}">
-                <a16:creationId xmlns:a16="http://schemas.microsoft.com/office/drawing/2014/main" id="{74EF22EC-1D7F-441A-9815-DDF44B90A85C}"/>
+                <a16:creationId xmlns:a16="http://schemas.microsoft.com/office/drawing/2014/main" id="{0BDA81F3-EB87-4FBA-B5FC-C9BCD98012E3}"/>
               </a:ext>
             </a:extLst>
           </p:cNvPr>
@@ -6954,7 +6954,7 @@
           <p:cNvPr id="10" name="">
             <a:extLst xmlns:a="http://schemas.openxmlformats.org/drawingml/2006/main">
               <a:ext uri="{FF2B5EF4-FFF2-40B4-BE49-F238E27FC236}">
-                <a16:creationId xmlns:a16="http://schemas.microsoft.com/office/drawing/2014/main" id="{A0323CF5-0863-4E2A-A272-008F668A91CA}"/>
+                <a16:creationId xmlns:a16="http://schemas.microsoft.com/office/drawing/2014/main" id="{A80CE0C4-AD95-409B-AD55-3D571E67F96E}"/>
               </a:ext>
             </a:extLst>
           </p:cNvPr>
@@ -7016,7 +7016,7 @@
           <p:cNvPr id="11" name="">
             <a:extLst xmlns:a="http://schemas.openxmlformats.org/drawingml/2006/main">
               <a:ext uri="{FF2B5EF4-FFF2-40B4-BE49-F238E27FC236}">
-                <a16:creationId xmlns:a16="http://schemas.microsoft.com/office/drawing/2014/main" id="{EE4FBF08-8DC6-441F-881D-0C2C9082CD99}"/>
+                <a16:creationId xmlns:a16="http://schemas.microsoft.com/office/drawing/2014/main" id="{3BD1E5AD-7FF9-4C0C-AB82-4A1FE462CB5F}"/>
               </a:ext>
             </a:extLst>
           </p:cNvPr>
@@ -7078,7 +7078,7 @@
           <p:cNvPr id="12" name="">
             <a:extLst xmlns:a="http://schemas.openxmlformats.org/drawingml/2006/main">
               <a:ext uri="{FF2B5EF4-FFF2-40B4-BE49-F238E27FC236}">
-                <a16:creationId xmlns:a16="http://schemas.microsoft.com/office/drawing/2014/main" id="{8CE44274-9EFD-4DFC-8734-AD780966E3E0}"/>
+                <a16:creationId xmlns:a16="http://schemas.microsoft.com/office/drawing/2014/main" id="{4049A9FD-6626-4813-B0E9-3F23317BAE3E}"/>
               </a:ext>
             </a:extLst>
           </p:cNvPr>
@@ -7140,7 +7140,7 @@
           <p:cNvPr id="13" name="">
             <a:extLst xmlns:a="http://schemas.openxmlformats.org/drawingml/2006/main">
               <a:ext uri="{FF2B5EF4-FFF2-40B4-BE49-F238E27FC236}">
-                <a16:creationId xmlns:a16="http://schemas.microsoft.com/office/drawing/2014/main" id="{3D7688F6-46C1-47CD-9746-E742DD9BE1BC}"/>
+                <a16:creationId xmlns:a16="http://schemas.microsoft.com/office/drawing/2014/main" id="{40B580D9-139B-4621-B7C0-1FE346F8C7D4}"/>
               </a:ext>
             </a:extLst>
           </p:cNvPr>
@@ -7171,7 +7171,7 @@
           <p:cNvPr id="14" name="">
             <a:extLst xmlns:a="http://schemas.openxmlformats.org/drawingml/2006/main">
               <a:ext uri="{FF2B5EF4-FFF2-40B4-BE49-F238E27FC236}">
-                <a16:creationId xmlns:a16="http://schemas.microsoft.com/office/drawing/2014/main" id="{4CBDBD0F-B1C4-4144-A0AC-8E21B5641B00}"/>
+                <a16:creationId xmlns:a16="http://schemas.microsoft.com/office/drawing/2014/main" id="{6B805B21-525F-46C8-92D0-6E47E9776AD7}"/>
               </a:ext>
             </a:extLst>
           </p:cNvPr>
@@ -7233,7 +7233,7 @@
           <p:cNvPr id="15" name="">
             <a:extLst xmlns:a="http://schemas.openxmlformats.org/drawingml/2006/main">
               <a:ext uri="{FF2B5EF4-FFF2-40B4-BE49-F238E27FC236}">
-                <a16:creationId xmlns:a16="http://schemas.microsoft.com/office/drawing/2014/main" id="{1AEC644B-6C48-480D-8F1C-58038572DBD0}"/>
+                <a16:creationId xmlns:a16="http://schemas.microsoft.com/office/drawing/2014/main" id="{947226E3-2AA1-48D2-9105-DAF00BA1A05F}"/>
               </a:ext>
             </a:extLst>
           </p:cNvPr>
@@ -7295,7 +7295,7 @@
           <p:cNvPr id="16" name="">
             <a:extLst xmlns:a="http://schemas.openxmlformats.org/drawingml/2006/main">
               <a:ext uri="{FF2B5EF4-FFF2-40B4-BE49-F238E27FC236}">
-                <a16:creationId xmlns:a16="http://schemas.microsoft.com/office/drawing/2014/main" id="{C3033829-DD5F-47EA-9648-2BEC804F94E3}"/>
+                <a16:creationId xmlns:a16="http://schemas.microsoft.com/office/drawing/2014/main" id="{BCA98603-1D38-4720-80C4-A04B46B820CB}"/>
               </a:ext>
             </a:extLst>
           </p:cNvPr>
@@ -7357,7 +7357,7 @@
           <p:cNvPr id="17" name="">
             <a:extLst xmlns:a="http://schemas.openxmlformats.org/drawingml/2006/main">
               <a:ext uri="{FF2B5EF4-FFF2-40B4-BE49-F238E27FC236}">
-                <a16:creationId xmlns:a16="http://schemas.microsoft.com/office/drawing/2014/main" id="{A6FF1364-7DA2-4F8D-8A3C-1EBB5E3C3363}"/>
+                <a16:creationId xmlns:a16="http://schemas.microsoft.com/office/drawing/2014/main" id="{B6F384BD-4235-45E8-A563-D0919E4EB6FD}"/>
               </a:ext>
             </a:extLst>
           </p:cNvPr>
@@ -7388,7 +7388,7 @@
           <p:cNvPr id="18" name="">
             <a:extLst xmlns:a="http://schemas.openxmlformats.org/drawingml/2006/main">
               <a:ext uri="{FF2B5EF4-FFF2-40B4-BE49-F238E27FC236}">
-                <a16:creationId xmlns:a16="http://schemas.microsoft.com/office/drawing/2014/main" id="{42050005-2A8B-423F-8635-2BEC73BF97AA}"/>
+                <a16:creationId xmlns:a16="http://schemas.microsoft.com/office/drawing/2014/main" id="{74E875DC-ED3E-42BF-8B02-16E08DAA74E1}"/>
               </a:ext>
             </a:extLst>
           </p:cNvPr>
@@ -7450,7 +7450,7 @@
           <p:cNvPr id="19" name="">
             <a:extLst xmlns:a="http://schemas.openxmlformats.org/drawingml/2006/main">
               <a:ext uri="{FF2B5EF4-FFF2-40B4-BE49-F238E27FC236}">
-                <a16:creationId xmlns:a16="http://schemas.microsoft.com/office/drawing/2014/main" id="{16863D41-659F-46FB-86A9-E6DD550D6A6C}"/>
+                <a16:creationId xmlns:a16="http://schemas.microsoft.com/office/drawing/2014/main" id="{E690ECAD-6012-4210-8360-000F5B744CF3}"/>
               </a:ext>
             </a:extLst>
           </p:cNvPr>
@@ -7512,7 +7512,7 @@
           <p:cNvPr id="20" name="">
             <a:extLst xmlns:a="http://schemas.openxmlformats.org/drawingml/2006/main">
               <a:ext uri="{FF2B5EF4-FFF2-40B4-BE49-F238E27FC236}">
-                <a16:creationId xmlns:a16="http://schemas.microsoft.com/office/drawing/2014/main" id="{0433C3FD-7165-4331-877A-CF12F2499B9D}"/>
+                <a16:creationId xmlns:a16="http://schemas.microsoft.com/office/drawing/2014/main" id="{BA889C7C-D867-4C08-AE85-BD7FF219894E}"/>
               </a:ext>
             </a:extLst>
           </p:cNvPr>
@@ -7574,7 +7574,7 @@
           <p:cNvPr id="21" name="">
             <a:extLst xmlns:a="http://schemas.openxmlformats.org/drawingml/2006/main">
               <a:ext uri="{FF2B5EF4-FFF2-40B4-BE49-F238E27FC236}">
-                <a16:creationId xmlns:a16="http://schemas.microsoft.com/office/drawing/2014/main" id="{CFDB03B7-C5B7-4114-8060-B8AD315D26D5}"/>
+                <a16:creationId xmlns:a16="http://schemas.microsoft.com/office/drawing/2014/main" id="{E17977F6-01EB-470D-A708-07D98A3FA362}"/>
               </a:ext>
             </a:extLst>
           </p:cNvPr>
@@ -7636,7 +7636,7 @@
           <p:cNvPr id="22" name="footer-rule-13">
             <a:extLst xmlns:a="http://schemas.openxmlformats.org/drawingml/2006/main">
               <a:ext uri="{FF2B5EF4-FFF2-40B4-BE49-F238E27FC236}">
-                <a16:creationId xmlns:a16="http://schemas.microsoft.com/office/drawing/2014/main" id="{B38187DC-1722-47D4-9233-7759C652729B}"/>
+                <a16:creationId xmlns:a16="http://schemas.microsoft.com/office/drawing/2014/main" id="{A27E8301-1CF0-47CF-8F62-D8528182AAE0}"/>
               </a:ext>
             </a:extLst>
           </p:cNvPr>
@@ -7667,7 +7667,7 @@
           <p:cNvPr id="23" name="footer-label-13">
             <a:extLst xmlns:a="http://schemas.openxmlformats.org/drawingml/2006/main">
               <a:ext uri="{FF2B5EF4-FFF2-40B4-BE49-F238E27FC236}">
-                <a16:creationId xmlns:a16="http://schemas.microsoft.com/office/drawing/2014/main" id="{B280351D-45A3-47E6-9F06-67D4DEDBDD2E}"/>
+                <a16:creationId xmlns:a16="http://schemas.microsoft.com/office/drawing/2014/main" id="{C52AA75D-55BE-4556-A00B-4D35A83D09B0}"/>
               </a:ext>
             </a:extLst>
           </p:cNvPr>
@@ -7729,7 +7729,7 @@
           <p:cNvPr id="24" name="footer-page-13">
             <a:extLst xmlns:a="http://schemas.openxmlformats.org/drawingml/2006/main">
               <a:ext uri="{FF2B5EF4-FFF2-40B4-BE49-F238E27FC236}">
-                <a16:creationId xmlns:a16="http://schemas.microsoft.com/office/drawing/2014/main" id="{7E077CAD-2F5E-48F7-A09A-126B7A432D5A}"/>
+                <a16:creationId xmlns:a16="http://schemas.microsoft.com/office/drawing/2014/main" id="{5A9F7C9A-AF32-4DB9-84AC-86E10B1D1EA0}"/>
               </a:ext>
             </a:extLst>
           </p:cNvPr>
@@ -7789,7 +7789,7 @@
     </p:spTree>
     <p:extLst>
       <p:ext uri="{BB962C8B-B14F-4D97-AF65-F5344CB8AC3E}">
-        <p14:creationId xmlns:p14="http://schemas.microsoft.com/office/powerpoint/2010/main" val="307451378"/>
+        <p14:creationId xmlns:p14="http://schemas.microsoft.com/office/powerpoint/2010/main" val="619624013"/>
       </p:ext>
     </p:extLst>
   </p:cSld>
@@ -7820,7 +7820,7 @@
           <p:cNvPr id="24" name="side-accent-14">
             <a:extLst xmlns:a="http://schemas.openxmlformats.org/drawingml/2006/main">
               <a:ext uri="{FF2B5EF4-FFF2-40B4-BE49-F238E27FC236}">
-                <a16:creationId xmlns:a16="http://schemas.microsoft.com/office/drawing/2014/main" id="{708E2CD7-2F91-4F2D-9003-AB5B0FB331E4}"/>
+                <a16:creationId xmlns:a16="http://schemas.microsoft.com/office/drawing/2014/main" id="{A11172F1-7E92-49DD-8EE6-2D096C21A95F}"/>
               </a:ext>
             </a:extLst>
           </p:cNvPr>
@@ -7851,7 +7851,7 @@
           <p:cNvPr id="2" name="kicker-14">
             <a:extLst xmlns:a="http://schemas.openxmlformats.org/drawingml/2006/main">
               <a:ext uri="{FF2B5EF4-FFF2-40B4-BE49-F238E27FC236}">
-                <a16:creationId xmlns:a16="http://schemas.microsoft.com/office/drawing/2014/main" id="{6E70A515-20BC-4A19-A482-2E1566158B29}"/>
+                <a16:creationId xmlns:a16="http://schemas.microsoft.com/office/drawing/2014/main" id="{9AFA4924-D60D-4B99-9840-904B22BB2090}"/>
               </a:ext>
             </a:extLst>
           </p:cNvPr>
@@ -7913,7 +7913,7 @@
           <p:cNvPr id="3" name="title-14">
             <a:extLst xmlns:a="http://schemas.openxmlformats.org/drawingml/2006/main">
               <a:ext uri="{FF2B5EF4-FFF2-40B4-BE49-F238E27FC236}">
-                <a16:creationId xmlns:a16="http://schemas.microsoft.com/office/drawing/2014/main" id="{D09AF672-EE82-4143-9959-CAE1C89C4B7E}"/>
+                <a16:creationId xmlns:a16="http://schemas.microsoft.com/office/drawing/2014/main" id="{06605C9A-CE21-494B-92E3-72FAD7F1C31D}"/>
               </a:ext>
             </a:extLst>
           </p:cNvPr>
@@ -7975,7 +7975,7 @@
           <p:cNvPr id="4" name="">
             <a:extLst xmlns:a="http://schemas.openxmlformats.org/drawingml/2006/main">
               <a:ext uri="{FF2B5EF4-FFF2-40B4-BE49-F238E27FC236}">
-                <a16:creationId xmlns:a16="http://schemas.microsoft.com/office/drawing/2014/main" id="{B452D8FE-76BC-48EF-BDC6-4FCB385B9B34}"/>
+                <a16:creationId xmlns:a16="http://schemas.microsoft.com/office/drawing/2014/main" id="{BA205457-4FC6-488F-A4A4-DF6BC953FD8B}"/>
               </a:ext>
             </a:extLst>
           </p:cNvPr>
@@ -8037,7 +8037,7 @@
           <p:cNvPr id="5" name="">
             <a:extLst xmlns:a="http://schemas.openxmlformats.org/drawingml/2006/main">
               <a:ext uri="{FF2B5EF4-FFF2-40B4-BE49-F238E27FC236}">
-                <a16:creationId xmlns:a16="http://schemas.microsoft.com/office/drawing/2014/main" id="{918AA832-9E5E-4DBA-ADAE-9FEBEF7E9C3A}"/>
+                <a16:creationId xmlns:a16="http://schemas.microsoft.com/office/drawing/2014/main" id="{E2863707-0073-499F-A7DC-E935F996BBC4}"/>
               </a:ext>
             </a:extLst>
           </p:cNvPr>
@@ -8099,7 +8099,7 @@
           <p:cNvPr id="6" name="">
             <a:extLst xmlns:a="http://schemas.openxmlformats.org/drawingml/2006/main">
               <a:ext uri="{FF2B5EF4-FFF2-40B4-BE49-F238E27FC236}">
-                <a16:creationId xmlns:a16="http://schemas.microsoft.com/office/drawing/2014/main" id="{E8999719-32B0-4218-831F-32E11B983D71}"/>
+                <a16:creationId xmlns:a16="http://schemas.microsoft.com/office/drawing/2014/main" id="{69B5BA5F-22C4-4AA8-B669-D640F6B20800}"/>
               </a:ext>
             </a:extLst>
           </p:cNvPr>
@@ -8161,7 +8161,7 @@
           <p:cNvPr id="7" name="">
             <a:extLst xmlns:a="http://schemas.openxmlformats.org/drawingml/2006/main">
               <a:ext uri="{FF2B5EF4-FFF2-40B4-BE49-F238E27FC236}">
-                <a16:creationId xmlns:a16="http://schemas.microsoft.com/office/drawing/2014/main" id="{E654E16D-C48E-48E0-94F2-C11F01E67032}"/>
+                <a16:creationId xmlns:a16="http://schemas.microsoft.com/office/drawing/2014/main" id="{FE6CD381-7EA1-4D11-80D9-1A7AB1926A25}"/>
               </a:ext>
             </a:extLst>
           </p:cNvPr>
@@ -8192,7 +8192,7 @@
           <p:cNvPr id="8" name="">
             <a:extLst xmlns:a="http://schemas.openxmlformats.org/drawingml/2006/main">
               <a:ext uri="{FF2B5EF4-FFF2-40B4-BE49-F238E27FC236}">
-                <a16:creationId xmlns:a16="http://schemas.microsoft.com/office/drawing/2014/main" id="{8E4DB345-0384-438B-B643-E47BA3C92665}"/>
+                <a16:creationId xmlns:a16="http://schemas.microsoft.com/office/drawing/2014/main" id="{D63145A7-D174-44B1-B9CA-191360CD80E3}"/>
               </a:ext>
             </a:extLst>
           </p:cNvPr>
@@ -8254,7 +8254,7 @@
           <p:cNvPr id="9" name="">
             <a:extLst xmlns:a="http://schemas.openxmlformats.org/drawingml/2006/main">
               <a:ext uri="{FF2B5EF4-FFF2-40B4-BE49-F238E27FC236}">
-                <a16:creationId xmlns:a16="http://schemas.microsoft.com/office/drawing/2014/main" id="{7B2F07D2-BA33-4755-B20A-91CBE6F6E314}"/>
+                <a16:creationId xmlns:a16="http://schemas.microsoft.com/office/drawing/2014/main" id="{9624A4A0-BB18-45AA-AA09-8D4CAD1B4927}"/>
               </a:ext>
             </a:extLst>
           </p:cNvPr>
@@ -8316,7 +8316,7 @@
           <p:cNvPr id="10" name="">
             <a:extLst xmlns:a="http://schemas.openxmlformats.org/drawingml/2006/main">
               <a:ext uri="{FF2B5EF4-FFF2-40B4-BE49-F238E27FC236}">
-                <a16:creationId xmlns:a16="http://schemas.microsoft.com/office/drawing/2014/main" id="{0FC489E4-18A9-4D6D-96F6-9BDAD8EC476F}"/>
+                <a16:creationId xmlns:a16="http://schemas.microsoft.com/office/drawing/2014/main" id="{16916672-FFB0-4F00-A642-4D75EB630E49}"/>
               </a:ext>
             </a:extLst>
           </p:cNvPr>
@@ -8378,7 +8378,7 @@
           <p:cNvPr id="11" name="">
             <a:extLst xmlns:a="http://schemas.openxmlformats.org/drawingml/2006/main">
               <a:ext uri="{FF2B5EF4-FFF2-40B4-BE49-F238E27FC236}">
-                <a16:creationId xmlns:a16="http://schemas.microsoft.com/office/drawing/2014/main" id="{498E508B-B64D-4184-8CDA-E49055BB48D0}"/>
+                <a16:creationId xmlns:a16="http://schemas.microsoft.com/office/drawing/2014/main" id="{15ED2FF4-D41F-477A-81BE-7C57E0BDF5AD}"/>
               </a:ext>
             </a:extLst>
           </p:cNvPr>
@@ -8409,7 +8409,7 @@
           <p:cNvPr id="12" name="">
             <a:extLst xmlns:a="http://schemas.openxmlformats.org/drawingml/2006/main">
               <a:ext uri="{FF2B5EF4-FFF2-40B4-BE49-F238E27FC236}">
-                <a16:creationId xmlns:a16="http://schemas.microsoft.com/office/drawing/2014/main" id="{17BFEFBC-8DF7-4ED0-9755-0E0570F5E745}"/>
+                <a16:creationId xmlns:a16="http://schemas.microsoft.com/office/drawing/2014/main" id="{A49EF7A8-4EE6-4E5A-9993-5F075A7929B8}"/>
               </a:ext>
             </a:extLst>
           </p:cNvPr>
@@ -8471,7 +8471,7 @@
           <p:cNvPr id="13" name="">
             <a:extLst xmlns:a="http://schemas.openxmlformats.org/drawingml/2006/main">
               <a:ext uri="{FF2B5EF4-FFF2-40B4-BE49-F238E27FC236}">
-                <a16:creationId xmlns:a16="http://schemas.microsoft.com/office/drawing/2014/main" id="{8259BD0A-A715-499A-925F-D16E1D869436}"/>
+                <a16:creationId xmlns:a16="http://schemas.microsoft.com/office/drawing/2014/main" id="{8C7E6134-7705-4E6C-99AC-C2E83019EBB1}"/>
               </a:ext>
             </a:extLst>
           </p:cNvPr>
@@ -8533,7 +8533,7 @@
           <p:cNvPr id="14" name="">
             <a:extLst xmlns:a="http://schemas.openxmlformats.org/drawingml/2006/main">
               <a:ext uri="{FF2B5EF4-FFF2-40B4-BE49-F238E27FC236}">
-                <a16:creationId xmlns:a16="http://schemas.microsoft.com/office/drawing/2014/main" id="{9B920A27-9AFC-4756-A3BE-CACF5C406151}"/>
+                <a16:creationId xmlns:a16="http://schemas.microsoft.com/office/drawing/2014/main" id="{266A0557-3A12-4522-9A49-35D34C79D9A3}"/>
               </a:ext>
             </a:extLst>
           </p:cNvPr>
@@ -8595,7 +8595,7 @@
           <p:cNvPr id="15" name="">
             <a:extLst xmlns:a="http://schemas.openxmlformats.org/drawingml/2006/main">
               <a:ext uri="{FF2B5EF4-FFF2-40B4-BE49-F238E27FC236}">
-                <a16:creationId xmlns:a16="http://schemas.microsoft.com/office/drawing/2014/main" id="{F13EC367-CD14-47BD-8F7C-19B13AA25F54}"/>
+                <a16:creationId xmlns:a16="http://schemas.microsoft.com/office/drawing/2014/main" id="{250E4A9B-0A32-4FCA-BCF5-FA59C994E3A7}"/>
               </a:ext>
             </a:extLst>
           </p:cNvPr>
@@ -8626,7 +8626,7 @@
           <p:cNvPr id="16" name="">
             <a:extLst xmlns:a="http://schemas.openxmlformats.org/drawingml/2006/main">
               <a:ext uri="{FF2B5EF4-FFF2-40B4-BE49-F238E27FC236}">
-                <a16:creationId xmlns:a16="http://schemas.microsoft.com/office/drawing/2014/main" id="{953C888D-D2AE-4E4D-83D9-02EB2BA50FE2}"/>
+                <a16:creationId xmlns:a16="http://schemas.microsoft.com/office/drawing/2014/main" id="{18A9ABD8-C921-4F89-8A48-2D373B4C04CE}"/>
               </a:ext>
             </a:extLst>
           </p:cNvPr>
@@ -8688,7 +8688,7 @@
           <p:cNvPr id="17" name="">
             <a:extLst xmlns:a="http://schemas.openxmlformats.org/drawingml/2006/main">
               <a:ext uri="{FF2B5EF4-FFF2-40B4-BE49-F238E27FC236}">
-                <a16:creationId xmlns:a16="http://schemas.microsoft.com/office/drawing/2014/main" id="{E53BB785-7395-4D43-89DD-517B8180CAA7}"/>
+                <a16:creationId xmlns:a16="http://schemas.microsoft.com/office/drawing/2014/main" id="{7FAF5E30-E292-413D-B1BD-4E5D44BA6428}"/>
               </a:ext>
             </a:extLst>
           </p:cNvPr>
@@ -8750,7 +8750,7 @@
           <p:cNvPr id="18" name="">
             <a:extLst xmlns:a="http://schemas.openxmlformats.org/drawingml/2006/main">
               <a:ext uri="{FF2B5EF4-FFF2-40B4-BE49-F238E27FC236}">
-                <a16:creationId xmlns:a16="http://schemas.microsoft.com/office/drawing/2014/main" id="{F355F7EF-7F42-4E9F-BD81-18711A692195}"/>
+                <a16:creationId xmlns:a16="http://schemas.microsoft.com/office/drawing/2014/main" id="{30064575-0250-4C00-9E97-31A3BA48C996}"/>
               </a:ext>
             </a:extLst>
           </p:cNvPr>
@@ -8812,7 +8812,7 @@
           <p:cNvPr id="19" name="">
             <a:extLst xmlns:a="http://schemas.openxmlformats.org/drawingml/2006/main">
               <a:ext uri="{FF2B5EF4-FFF2-40B4-BE49-F238E27FC236}">
-                <a16:creationId xmlns:a16="http://schemas.microsoft.com/office/drawing/2014/main" id="{03333974-FC41-40D7-87AE-1A24106F2A26}"/>
+                <a16:creationId xmlns:a16="http://schemas.microsoft.com/office/drawing/2014/main" id="{E6564055-4D8C-4DE0-BB7C-1069C7A01685}"/>
               </a:ext>
             </a:extLst>
           </p:cNvPr>
@@ -8845,7 +8845,7 @@
           <p:cNvPr id="20" name="">
             <a:extLst xmlns:a="http://schemas.openxmlformats.org/drawingml/2006/main">
               <a:ext uri="{FF2B5EF4-FFF2-40B4-BE49-F238E27FC236}">
-                <a16:creationId xmlns:a16="http://schemas.microsoft.com/office/drawing/2014/main" id="{A1E47084-EE02-4544-9DCE-0B9AB3C902D5}"/>
+                <a16:creationId xmlns:a16="http://schemas.microsoft.com/office/drawing/2014/main" id="{B199D2EA-92E3-46D4-945A-603545A50F32}"/>
               </a:ext>
             </a:extLst>
           </p:cNvPr>
@@ -8907,7 +8907,7 @@
           <p:cNvPr id="21" name="footer-rule-14">
             <a:extLst xmlns:a="http://schemas.openxmlformats.org/drawingml/2006/main">
               <a:ext uri="{FF2B5EF4-FFF2-40B4-BE49-F238E27FC236}">
-                <a16:creationId xmlns:a16="http://schemas.microsoft.com/office/drawing/2014/main" id="{3DD560BB-496C-4E9F-99F1-B8D88307872D}"/>
+                <a16:creationId xmlns:a16="http://schemas.microsoft.com/office/drawing/2014/main" id="{51492C18-E591-49D6-A8C7-A7E2EB7C6EA1}"/>
               </a:ext>
             </a:extLst>
           </p:cNvPr>
@@ -8938,7 +8938,7 @@
           <p:cNvPr id="22" name="footer-label-14">
             <a:extLst xmlns:a="http://schemas.openxmlformats.org/drawingml/2006/main">
               <a:ext uri="{FF2B5EF4-FFF2-40B4-BE49-F238E27FC236}">
-                <a16:creationId xmlns:a16="http://schemas.microsoft.com/office/drawing/2014/main" id="{457B9EFF-1D47-47DE-B7E2-5A17F31878A5}"/>
+                <a16:creationId xmlns:a16="http://schemas.microsoft.com/office/drawing/2014/main" id="{5057BD51-B254-4F40-9FD3-3D6AD378DB77}"/>
               </a:ext>
             </a:extLst>
           </p:cNvPr>
@@ -9000,7 +9000,7 @@
           <p:cNvPr id="23" name="footer-page-14">
             <a:extLst xmlns:a="http://schemas.openxmlformats.org/drawingml/2006/main">
               <a:ext uri="{FF2B5EF4-FFF2-40B4-BE49-F238E27FC236}">
-                <a16:creationId xmlns:a16="http://schemas.microsoft.com/office/drawing/2014/main" id="{76FD468D-AF97-4558-9026-9C3A2D103722}"/>
+                <a16:creationId xmlns:a16="http://schemas.microsoft.com/office/drawing/2014/main" id="{52A3D4CC-67BF-43E7-9AC3-EEF5F568BD1A}"/>
               </a:ext>
             </a:extLst>
           </p:cNvPr>
@@ -9060,7 +9060,7 @@
     </p:spTree>
     <p:extLst>
       <p:ext uri="{BB962C8B-B14F-4D97-AF65-F5344CB8AC3E}">
-        <p14:creationId xmlns:p14="http://schemas.microsoft.com/office/powerpoint/2010/main" val="1358597631"/>
+        <p14:creationId xmlns:p14="http://schemas.microsoft.com/office/powerpoint/2010/main" val="886921940"/>
       </p:ext>
     </p:extLst>
   </p:cSld>
@@ -9091,7 +9091,7 @@
           <p:cNvPr id="21" name="side-accent-15">
             <a:extLst xmlns:a="http://schemas.openxmlformats.org/drawingml/2006/main">
               <a:ext uri="{FF2B5EF4-FFF2-40B4-BE49-F238E27FC236}">
-                <a16:creationId xmlns:a16="http://schemas.microsoft.com/office/drawing/2014/main" id="{78303166-DAD7-45BC-ADB9-1AE2C2E9F317}"/>
+                <a16:creationId xmlns:a16="http://schemas.microsoft.com/office/drawing/2014/main" id="{0A85E8AE-B42E-41B3-9018-A48A55D319A0}"/>
               </a:ext>
             </a:extLst>
           </p:cNvPr>
@@ -9122,7 +9122,7 @@
           <p:cNvPr id="2" name="kicker-15">
             <a:extLst xmlns:a="http://schemas.openxmlformats.org/drawingml/2006/main">
               <a:ext uri="{FF2B5EF4-FFF2-40B4-BE49-F238E27FC236}">
-                <a16:creationId xmlns:a16="http://schemas.microsoft.com/office/drawing/2014/main" id="{20B193B2-2EE4-46B4-9CB4-DE0E643D4381}"/>
+                <a16:creationId xmlns:a16="http://schemas.microsoft.com/office/drawing/2014/main" id="{584D6BE3-10B5-4942-B663-68DEA10E0835}"/>
               </a:ext>
             </a:extLst>
           </p:cNvPr>
@@ -9184,7 +9184,7 @@
           <p:cNvPr id="3" name="title-15">
             <a:extLst xmlns:a="http://schemas.openxmlformats.org/drawingml/2006/main">
               <a:ext uri="{FF2B5EF4-FFF2-40B4-BE49-F238E27FC236}">
-                <a16:creationId xmlns:a16="http://schemas.microsoft.com/office/drawing/2014/main" id="{F2D11C67-4F2B-44E1-84EA-644D4C783A68}"/>
+                <a16:creationId xmlns:a16="http://schemas.microsoft.com/office/drawing/2014/main" id="{AA77C788-2133-4D2D-BA62-324E14A641FD}"/>
               </a:ext>
             </a:extLst>
           </p:cNvPr>
@@ -9246,7 +9246,7 @@
           <p:cNvPr id="4" name="">
             <a:extLst xmlns:a="http://schemas.openxmlformats.org/drawingml/2006/main">
               <a:ext uri="{FF2B5EF4-FFF2-40B4-BE49-F238E27FC236}">
-                <a16:creationId xmlns:a16="http://schemas.microsoft.com/office/drawing/2014/main" id="{F0BF6EF5-4249-4507-8665-4F61FE5AE496}"/>
+                <a16:creationId xmlns:a16="http://schemas.microsoft.com/office/drawing/2014/main" id="{807DFCF1-F38E-4767-87E5-511041F08A29}"/>
               </a:ext>
             </a:extLst>
           </p:cNvPr>
@@ -9277,7 +9277,7 @@
           <p:cNvPr id="5" name="">
             <a:extLst xmlns:a="http://schemas.openxmlformats.org/drawingml/2006/main">
               <a:ext uri="{FF2B5EF4-FFF2-40B4-BE49-F238E27FC236}">
-                <a16:creationId xmlns:a16="http://schemas.microsoft.com/office/drawing/2014/main" id="{8D78CAF5-BCBB-4EA5-8DB6-2DB17550BA02}"/>
+                <a16:creationId xmlns:a16="http://schemas.microsoft.com/office/drawing/2014/main" id="{7EA3556E-1B4E-444A-9C2A-5BC8D2E7F00F}"/>
               </a:ext>
             </a:extLst>
           </p:cNvPr>
@@ -9308,7 +9308,7 @@
           <p:cNvPr id="6" name="">
             <a:extLst xmlns:a="http://schemas.openxmlformats.org/drawingml/2006/main">
               <a:ext uri="{FF2B5EF4-FFF2-40B4-BE49-F238E27FC236}">
-                <a16:creationId xmlns:a16="http://schemas.microsoft.com/office/drawing/2014/main" id="{74B155EA-606B-4E3E-9FAB-56C3388FE5D8}"/>
+                <a16:creationId xmlns:a16="http://schemas.microsoft.com/office/drawing/2014/main" id="{E63C7B0D-5874-49A6-9E70-791EAF851316}"/>
               </a:ext>
             </a:extLst>
           </p:cNvPr>
@@ -9370,7 +9370,7 @@
           <p:cNvPr id="7" name="">
             <a:extLst xmlns:a="http://schemas.openxmlformats.org/drawingml/2006/main">
               <a:ext uri="{FF2B5EF4-FFF2-40B4-BE49-F238E27FC236}">
-                <a16:creationId xmlns:a16="http://schemas.microsoft.com/office/drawing/2014/main" id="{2496260D-AF4C-4F07-A246-5B3FF940DAF1}"/>
+                <a16:creationId xmlns:a16="http://schemas.microsoft.com/office/drawing/2014/main" id="{8371A605-6218-41F4-A6E7-0C2928304A6E}"/>
               </a:ext>
             </a:extLst>
           </p:cNvPr>
@@ -9432,7 +9432,7 @@
           <p:cNvPr id="8" name="">
             <a:extLst xmlns:a="http://schemas.openxmlformats.org/drawingml/2006/main">
               <a:ext uri="{FF2B5EF4-FFF2-40B4-BE49-F238E27FC236}">
-                <a16:creationId xmlns:a16="http://schemas.microsoft.com/office/drawing/2014/main" id="{2E2F192D-6030-45A4-A1B5-C206F51F66EF}"/>
+                <a16:creationId xmlns:a16="http://schemas.microsoft.com/office/drawing/2014/main" id="{2AEE4260-272F-4E8C-9F8B-E46B0A65BF13}"/>
               </a:ext>
             </a:extLst>
           </p:cNvPr>
@@ -9494,7 +9494,7 @@
           <p:cNvPr id="9" name="">
             <a:extLst xmlns:a="http://schemas.openxmlformats.org/drawingml/2006/main">
               <a:ext uri="{FF2B5EF4-FFF2-40B4-BE49-F238E27FC236}">
-                <a16:creationId xmlns:a16="http://schemas.microsoft.com/office/drawing/2014/main" id="{2EAE6A81-DE38-44DD-954E-3B9855BE49CA}"/>
+                <a16:creationId xmlns:a16="http://schemas.microsoft.com/office/drawing/2014/main" id="{AE239C08-2870-42A5-B3D3-A18DEA285D7C}"/>
               </a:ext>
             </a:extLst>
           </p:cNvPr>
@@ -9525,7 +9525,7 @@
           <p:cNvPr id="10" name="">
             <a:extLst xmlns:a="http://schemas.openxmlformats.org/drawingml/2006/main">
               <a:ext uri="{FF2B5EF4-FFF2-40B4-BE49-F238E27FC236}">
-                <a16:creationId xmlns:a16="http://schemas.microsoft.com/office/drawing/2014/main" id="{A092D458-16A5-41AD-80D3-E820654EECC3}"/>
+                <a16:creationId xmlns:a16="http://schemas.microsoft.com/office/drawing/2014/main" id="{97BAF11D-F626-4D18-863F-AC9884FE47C3}"/>
               </a:ext>
             </a:extLst>
           </p:cNvPr>
@@ -9587,7 +9587,7 @@
           <p:cNvPr id="11" name="">
             <a:extLst xmlns:a="http://schemas.openxmlformats.org/drawingml/2006/main">
               <a:ext uri="{FF2B5EF4-FFF2-40B4-BE49-F238E27FC236}">
-                <a16:creationId xmlns:a16="http://schemas.microsoft.com/office/drawing/2014/main" id="{11D9B7E3-0A2C-43CC-AFD3-13589AF0C5D8}"/>
+                <a16:creationId xmlns:a16="http://schemas.microsoft.com/office/drawing/2014/main" id="{61AFC37D-CAD7-4520-815E-0B1514071F73}"/>
               </a:ext>
             </a:extLst>
           </p:cNvPr>
@@ -9649,7 +9649,7 @@
           <p:cNvPr id="12" name="">
             <a:extLst xmlns:a="http://schemas.openxmlformats.org/drawingml/2006/main">
               <a:ext uri="{FF2B5EF4-FFF2-40B4-BE49-F238E27FC236}">
-                <a16:creationId xmlns:a16="http://schemas.microsoft.com/office/drawing/2014/main" id="{95ECA370-DDC2-4036-9B22-3A66FDF595EE}"/>
+                <a16:creationId xmlns:a16="http://schemas.microsoft.com/office/drawing/2014/main" id="{C7770AA2-A3D2-4C00-A8FD-5C46960C4089}"/>
               </a:ext>
             </a:extLst>
           </p:cNvPr>
@@ -9711,7 +9711,7 @@
           <p:cNvPr id="13" name="">
             <a:extLst xmlns:a="http://schemas.openxmlformats.org/drawingml/2006/main">
               <a:ext uri="{FF2B5EF4-FFF2-40B4-BE49-F238E27FC236}">
-                <a16:creationId xmlns:a16="http://schemas.microsoft.com/office/drawing/2014/main" id="{120CC19B-B79E-49A8-B402-2273DCE8A768}"/>
+                <a16:creationId xmlns:a16="http://schemas.microsoft.com/office/drawing/2014/main" id="{FA15C234-1223-45AA-823E-FE1C7B39DE5C}"/>
               </a:ext>
             </a:extLst>
           </p:cNvPr>
@@ -9742,7 +9742,7 @@
           <p:cNvPr id="14" name="">
             <a:extLst xmlns:a="http://schemas.openxmlformats.org/drawingml/2006/main">
               <a:ext uri="{FF2B5EF4-FFF2-40B4-BE49-F238E27FC236}">
-                <a16:creationId xmlns:a16="http://schemas.microsoft.com/office/drawing/2014/main" id="{2993581C-A142-4813-AB40-0377A72BA7D7}"/>
+                <a16:creationId xmlns:a16="http://schemas.microsoft.com/office/drawing/2014/main" id="{C36C3D7F-B9FE-45D1-AE8D-228E18A3FBC6}"/>
               </a:ext>
             </a:extLst>
           </p:cNvPr>
@@ -9804,7 +9804,7 @@
           <p:cNvPr id="15" name="">
             <a:extLst xmlns:a="http://schemas.openxmlformats.org/drawingml/2006/main">
               <a:ext uri="{FF2B5EF4-FFF2-40B4-BE49-F238E27FC236}">
-                <a16:creationId xmlns:a16="http://schemas.microsoft.com/office/drawing/2014/main" id="{2CA669F7-A43A-46C1-A63B-ED8C3BA66E1D}"/>
+                <a16:creationId xmlns:a16="http://schemas.microsoft.com/office/drawing/2014/main" id="{A6F59452-56B2-4F1B-B881-C11C16043AC4}"/>
               </a:ext>
             </a:extLst>
           </p:cNvPr>
@@ -9866,7 +9866,7 @@
           <p:cNvPr id="16" name="">
             <a:extLst xmlns:a="http://schemas.openxmlformats.org/drawingml/2006/main">
               <a:ext uri="{FF2B5EF4-FFF2-40B4-BE49-F238E27FC236}">
-                <a16:creationId xmlns:a16="http://schemas.microsoft.com/office/drawing/2014/main" id="{64C96EE9-EAA0-4DDA-BE45-43BABDF3C06F}"/>
+                <a16:creationId xmlns:a16="http://schemas.microsoft.com/office/drawing/2014/main" id="{44143517-BB69-4330-BD0B-24B7250C1A3C}"/>
               </a:ext>
             </a:extLst>
           </p:cNvPr>
@@ -9928,7 +9928,7 @@
           <p:cNvPr id="17" name="">
             <a:extLst xmlns:a="http://schemas.openxmlformats.org/drawingml/2006/main">
               <a:ext uri="{FF2B5EF4-FFF2-40B4-BE49-F238E27FC236}">
-                <a16:creationId xmlns:a16="http://schemas.microsoft.com/office/drawing/2014/main" id="{142006C2-19BA-4712-9F45-295CEC414BD9}"/>
+                <a16:creationId xmlns:a16="http://schemas.microsoft.com/office/drawing/2014/main" id="{883120F1-F232-4ED4-8A2C-654EE163E1B3}"/>
               </a:ext>
             </a:extLst>
           </p:cNvPr>
@@ -9990,7 +9990,7 @@
           <p:cNvPr id="18" name="footer-rule-15">
             <a:extLst xmlns:a="http://schemas.openxmlformats.org/drawingml/2006/main">
               <a:ext uri="{FF2B5EF4-FFF2-40B4-BE49-F238E27FC236}">
-                <a16:creationId xmlns:a16="http://schemas.microsoft.com/office/drawing/2014/main" id="{0C91A751-9EEB-40E8-80D0-CB62CBE4E4A3}"/>
+                <a16:creationId xmlns:a16="http://schemas.microsoft.com/office/drawing/2014/main" id="{FB83AEE7-9F8F-430A-814D-B25AB0579940}"/>
               </a:ext>
             </a:extLst>
           </p:cNvPr>
@@ -10021,7 +10021,7 @@
           <p:cNvPr id="19" name="footer-label-15">
             <a:extLst xmlns:a="http://schemas.openxmlformats.org/drawingml/2006/main">
               <a:ext uri="{FF2B5EF4-FFF2-40B4-BE49-F238E27FC236}">
-                <a16:creationId xmlns:a16="http://schemas.microsoft.com/office/drawing/2014/main" id="{302092E7-E649-44E7-B26C-5BDA9D3000A0}"/>
+                <a16:creationId xmlns:a16="http://schemas.microsoft.com/office/drawing/2014/main" id="{B073DFA2-F8B2-438C-AD45-B58D99121CDE}"/>
               </a:ext>
             </a:extLst>
           </p:cNvPr>
@@ -10083,7 +10083,7 @@
           <p:cNvPr id="20" name="footer-page-15">
             <a:extLst xmlns:a="http://schemas.openxmlformats.org/drawingml/2006/main">
               <a:ext uri="{FF2B5EF4-FFF2-40B4-BE49-F238E27FC236}">
-                <a16:creationId xmlns:a16="http://schemas.microsoft.com/office/drawing/2014/main" id="{8039386E-CB30-445B-B771-E5ED3F266FE9}"/>
+                <a16:creationId xmlns:a16="http://schemas.microsoft.com/office/drawing/2014/main" id="{AE810D6B-88BB-4F30-8CFF-AA9DF820C969}"/>
               </a:ext>
             </a:extLst>
           </p:cNvPr>
@@ -10143,7 +10143,7 @@
     </p:spTree>
     <p:extLst>
       <p:ext uri="{BB962C8B-B14F-4D97-AF65-F5344CB8AC3E}">
-        <p14:creationId xmlns:p14="http://schemas.microsoft.com/office/powerpoint/2010/main" val="860348387"/>
+        <p14:creationId xmlns:p14="http://schemas.microsoft.com/office/powerpoint/2010/main" val="574092899"/>
       </p:ext>
     </p:extLst>
   </p:cSld>
@@ -10174,7 +10174,7 @@
           <p:cNvPr id="11" name="">
             <a:extLst xmlns:a="http://schemas.openxmlformats.org/drawingml/2006/main">
               <a:ext uri="{FF2B5EF4-FFF2-40B4-BE49-F238E27FC236}">
-                <a16:creationId xmlns:a16="http://schemas.microsoft.com/office/drawing/2014/main" id="{01711DB4-0E01-476E-A44F-633A975B9AAA}"/>
+                <a16:creationId xmlns:a16="http://schemas.microsoft.com/office/drawing/2014/main" id="{FA670A46-F2A9-4138-9890-C150EFC8C584}"/>
               </a:ext>
             </a:extLst>
           </p:cNvPr>
@@ -10205,7 +10205,7 @@
           <p:cNvPr id="2" name="">
             <a:extLst xmlns:a="http://schemas.openxmlformats.org/drawingml/2006/main">
               <a:ext uri="{FF2B5EF4-FFF2-40B4-BE49-F238E27FC236}">
-                <a16:creationId xmlns:a16="http://schemas.microsoft.com/office/drawing/2014/main" id="{018073B7-BCBB-4B55-8550-EFD10A5E8503}"/>
+                <a16:creationId xmlns:a16="http://schemas.microsoft.com/office/drawing/2014/main" id="{4A2DAEFB-5556-45F5-A6F7-381A9D237E44}"/>
               </a:ext>
             </a:extLst>
           </p:cNvPr>
@@ -10267,7 +10267,7 @@
           <p:cNvPr id="3" name="">
             <a:extLst xmlns:a="http://schemas.openxmlformats.org/drawingml/2006/main">
               <a:ext uri="{FF2B5EF4-FFF2-40B4-BE49-F238E27FC236}">
-                <a16:creationId xmlns:a16="http://schemas.microsoft.com/office/drawing/2014/main" id="{ABE681CE-6D43-4BFA-BFA9-748558B162B9}"/>
+                <a16:creationId xmlns:a16="http://schemas.microsoft.com/office/drawing/2014/main" id="{8EC478C7-122B-4509-92EE-99BACAA22F72}"/>
               </a:ext>
             </a:extLst>
           </p:cNvPr>
@@ -10356,7 +10356,7 @@
           <p:cNvPr id="4" name="">
             <a:extLst xmlns:a="http://schemas.openxmlformats.org/drawingml/2006/main">
               <a:ext uri="{FF2B5EF4-FFF2-40B4-BE49-F238E27FC236}">
-                <a16:creationId xmlns:a16="http://schemas.microsoft.com/office/drawing/2014/main" id="{D65DC250-451F-4720-B87F-13BC511E242F}"/>
+                <a16:creationId xmlns:a16="http://schemas.microsoft.com/office/drawing/2014/main" id="{0996A329-0DFB-47BE-8446-BAEFA8BB459A}"/>
               </a:ext>
             </a:extLst>
           </p:cNvPr>
@@ -10418,7 +10418,7 @@
           <p:cNvPr id="5" name="">
             <a:extLst xmlns:a="http://schemas.openxmlformats.org/drawingml/2006/main">
               <a:ext uri="{FF2B5EF4-FFF2-40B4-BE49-F238E27FC236}">
-                <a16:creationId xmlns:a16="http://schemas.microsoft.com/office/drawing/2014/main" id="{33A251E9-37A5-4AA5-8EA4-C9158AB6DFFE}"/>
+                <a16:creationId xmlns:a16="http://schemas.microsoft.com/office/drawing/2014/main" id="{FD547549-8FEA-45C0-A21A-0B86AB630F40}"/>
               </a:ext>
             </a:extLst>
           </p:cNvPr>
@@ -10451,7 +10451,7 @@
           <p:cNvPr id="6" name="">
             <a:extLst xmlns:a="http://schemas.openxmlformats.org/drawingml/2006/main">
               <a:ext uri="{FF2B5EF4-FFF2-40B4-BE49-F238E27FC236}">
-                <a16:creationId xmlns:a16="http://schemas.microsoft.com/office/drawing/2014/main" id="{B10C0217-D7BF-4E13-A615-75D32DB5FCD6}"/>
+                <a16:creationId xmlns:a16="http://schemas.microsoft.com/office/drawing/2014/main" id="{240B1158-77B5-4C4D-AA40-40B4320E8ABB}"/>
               </a:ext>
             </a:extLst>
           </p:cNvPr>
@@ -10513,7 +10513,7 @@
           <p:cNvPr id="7" name="">
             <a:extLst xmlns:a="http://schemas.openxmlformats.org/drawingml/2006/main">
               <a:ext uri="{FF2B5EF4-FFF2-40B4-BE49-F238E27FC236}">
-                <a16:creationId xmlns:a16="http://schemas.microsoft.com/office/drawing/2014/main" id="{28FBD3CF-FE4D-445B-B5B3-0AEC239493CE}"/>
+                <a16:creationId xmlns:a16="http://schemas.microsoft.com/office/drawing/2014/main" id="{F00F282E-9B20-4F6C-BF16-31D6300B5635}"/>
               </a:ext>
             </a:extLst>
           </p:cNvPr>
@@ -10575,7 +10575,7 @@
           <p:cNvPr id="8" name="">
             <a:extLst xmlns:a="http://schemas.openxmlformats.org/drawingml/2006/main">
               <a:ext uri="{FF2B5EF4-FFF2-40B4-BE49-F238E27FC236}">
-                <a16:creationId xmlns:a16="http://schemas.microsoft.com/office/drawing/2014/main" id="{FEAD74D4-3BF0-4BFD-A04A-1631DD96EEEB}"/>
+                <a16:creationId xmlns:a16="http://schemas.microsoft.com/office/drawing/2014/main" id="{51E40774-A08E-4795-8EBA-42422FEEFEDD}"/>
               </a:ext>
             </a:extLst>
           </p:cNvPr>
@@ -10664,7 +10664,7 @@
           <p:cNvPr id="9" name="">
             <a:extLst xmlns:a="http://schemas.openxmlformats.org/drawingml/2006/main">
               <a:ext uri="{FF2B5EF4-FFF2-40B4-BE49-F238E27FC236}">
-                <a16:creationId xmlns:a16="http://schemas.microsoft.com/office/drawing/2014/main" id="{2ACCE40E-336E-4B7A-8A70-9E6B70B1B305}"/>
+                <a16:creationId xmlns:a16="http://schemas.microsoft.com/office/drawing/2014/main" id="{7D5C6D90-C4DC-4EDD-92B1-3BF7E3D71427}"/>
               </a:ext>
             </a:extLst>
           </p:cNvPr>
@@ -10726,7 +10726,7 @@
           <p:cNvPr id="10" name="">
             <a:extLst xmlns:a="http://schemas.openxmlformats.org/drawingml/2006/main">
               <a:ext uri="{FF2B5EF4-FFF2-40B4-BE49-F238E27FC236}">
-                <a16:creationId xmlns:a16="http://schemas.microsoft.com/office/drawing/2014/main" id="{4305A543-2349-452D-887A-768994AF3CD4}"/>
+                <a16:creationId xmlns:a16="http://schemas.microsoft.com/office/drawing/2014/main" id="{B5CD2B46-88F9-4D7C-8290-B1F44D884F1A}"/>
               </a:ext>
             </a:extLst>
           </p:cNvPr>
@@ -10786,7 +10786,7 @@
     </p:spTree>
     <p:extLst>
       <p:ext uri="{BB962C8B-B14F-4D97-AF65-F5344CB8AC3E}">
-        <p14:creationId xmlns:p14="http://schemas.microsoft.com/office/powerpoint/2010/main" val="1281975391"/>
+        <p14:creationId xmlns:p14="http://schemas.microsoft.com/office/powerpoint/2010/main" val="1376727427"/>
       </p:ext>
     </p:extLst>
   </p:cSld>
@@ -10817,7 +10817,7 @@
           <p:cNvPr id="23" name="side-accent-17">
             <a:extLst xmlns:a="http://schemas.openxmlformats.org/drawingml/2006/main">
               <a:ext uri="{FF2B5EF4-FFF2-40B4-BE49-F238E27FC236}">
-                <a16:creationId xmlns:a16="http://schemas.microsoft.com/office/drawing/2014/main" id="{27D542DB-9A7E-44C9-9AF1-36F2B9759E2A}"/>
+                <a16:creationId xmlns:a16="http://schemas.microsoft.com/office/drawing/2014/main" id="{1F6B1BFD-FADD-4A60-AA51-8E3BAE654360}"/>
               </a:ext>
             </a:extLst>
           </p:cNvPr>
@@ -10848,7 +10848,7 @@
           <p:cNvPr id="2" name="kicker-17">
             <a:extLst xmlns:a="http://schemas.openxmlformats.org/drawingml/2006/main">
               <a:ext uri="{FF2B5EF4-FFF2-40B4-BE49-F238E27FC236}">
-                <a16:creationId xmlns:a16="http://schemas.microsoft.com/office/drawing/2014/main" id="{FD9873F2-5A08-4110-9BA6-1D329F092BE1}"/>
+                <a16:creationId xmlns:a16="http://schemas.microsoft.com/office/drawing/2014/main" id="{E0849F2B-5C9F-4F77-8AE7-231056918CAF}"/>
               </a:ext>
             </a:extLst>
           </p:cNvPr>
@@ -10910,7 +10910,7 @@
           <p:cNvPr id="3" name="title-17">
             <a:extLst xmlns:a="http://schemas.openxmlformats.org/drawingml/2006/main">
               <a:ext uri="{FF2B5EF4-FFF2-40B4-BE49-F238E27FC236}">
-                <a16:creationId xmlns:a16="http://schemas.microsoft.com/office/drawing/2014/main" id="{C2AB776D-81CF-401D-B397-D9EC5A5AFE67}"/>
+                <a16:creationId xmlns:a16="http://schemas.microsoft.com/office/drawing/2014/main" id="{9ED6E25F-1E8D-4758-A9B3-A25FF2FD85EB}"/>
               </a:ext>
             </a:extLst>
           </p:cNvPr>
@@ -10972,7 +10972,7 @@
           <p:cNvPr id="4" name="">
             <a:extLst xmlns:a="http://schemas.openxmlformats.org/drawingml/2006/main">
               <a:ext uri="{FF2B5EF4-FFF2-40B4-BE49-F238E27FC236}">
-                <a16:creationId xmlns:a16="http://schemas.microsoft.com/office/drawing/2014/main" id="{7092EA7E-7AAB-4619-8A35-6E879DC4A342}"/>
+                <a16:creationId xmlns:a16="http://schemas.microsoft.com/office/drawing/2014/main" id="{E37FF2D8-7CDB-4020-9737-16C4A05B05AA}"/>
               </a:ext>
             </a:extLst>
           </p:cNvPr>
@@ -11061,7 +11061,7 @@
           <p:cNvPr id="5" name="">
             <a:extLst xmlns:a="http://schemas.openxmlformats.org/drawingml/2006/main">
               <a:ext uri="{FF2B5EF4-FFF2-40B4-BE49-F238E27FC236}">
-                <a16:creationId xmlns:a16="http://schemas.microsoft.com/office/drawing/2014/main" id="{300C3FB9-6F7A-43E7-911F-38DDAEB3C71D}"/>
+                <a16:creationId xmlns:a16="http://schemas.microsoft.com/office/drawing/2014/main" id="{B97B085C-8D56-4937-AD88-51212AB81BE2}"/>
               </a:ext>
             </a:extLst>
           </p:cNvPr>
@@ -11112,7 +11112,7 @@
                 <a:latin typeface="Tahoma"/>
                 <a:ea typeface="Tahoma"/>
                 <a:cs typeface="Tahoma"/>
-                <a:hlinkClick xmlns:r="http://schemas.openxmlformats.org/officeDocument/2006/relationships" r:id="R37ca6c9f41e44bea"/>
+                <a:hlinkClick xmlns:r="http://schemas.openxmlformats.org/officeDocument/2006/relationships" r:id="R30b1b3724a6d4a7b"/>
               </a:rPr>
               <a:t>http://149.28.142.186/login</a:t>
             </a:r>
@@ -11124,7 +11124,7 @@
           <p:cNvPr id="6" name="">
             <a:extLst xmlns:a="http://schemas.openxmlformats.org/drawingml/2006/main">
               <a:ext uri="{FF2B5EF4-FFF2-40B4-BE49-F238E27FC236}">
-                <a16:creationId xmlns:a16="http://schemas.microsoft.com/office/drawing/2014/main" id="{403DCF46-A2A7-4D50-8767-F5C632595C53}"/>
+                <a16:creationId xmlns:a16="http://schemas.microsoft.com/office/drawing/2014/main" id="{754BEBFF-19A6-40DE-9CAF-31EC6620A409}"/>
               </a:ext>
             </a:extLst>
           </p:cNvPr>
@@ -11155,7 +11155,7 @@
           <p:cNvPr id="7" name="">
             <a:extLst xmlns:a="http://schemas.openxmlformats.org/drawingml/2006/main">
               <a:ext uri="{FF2B5EF4-FFF2-40B4-BE49-F238E27FC236}">
-                <a16:creationId xmlns:a16="http://schemas.microsoft.com/office/drawing/2014/main" id="{D202485B-B4BD-4F09-B0B3-03495ADEA4D7}"/>
+                <a16:creationId xmlns:a16="http://schemas.microsoft.com/office/drawing/2014/main" id="{CEB9C2D1-D68C-4ADB-8113-CB61542B3BEC}"/>
               </a:ext>
             </a:extLst>
           </p:cNvPr>
@@ -11217,7 +11217,7 @@
           <p:cNvPr id="8" name="">
             <a:extLst xmlns:a="http://schemas.openxmlformats.org/drawingml/2006/main">
               <a:ext uri="{FF2B5EF4-FFF2-40B4-BE49-F238E27FC236}">
-                <a16:creationId xmlns:a16="http://schemas.microsoft.com/office/drawing/2014/main" id="{E2F596FF-D1B6-4E4C-A336-DF6379CB2640}"/>
+                <a16:creationId xmlns:a16="http://schemas.microsoft.com/office/drawing/2014/main" id="{CAA5B929-DE17-4719-B725-0D95A8C39568}"/>
               </a:ext>
             </a:extLst>
           </p:cNvPr>
@@ -11279,7 +11279,7 @@
           <p:cNvPr id="9" name="">
             <a:extLst xmlns:a="http://schemas.openxmlformats.org/drawingml/2006/main">
               <a:ext uri="{FF2B5EF4-FFF2-40B4-BE49-F238E27FC236}">
-                <a16:creationId xmlns:a16="http://schemas.microsoft.com/office/drawing/2014/main" id="{C5290F3A-BEDC-467E-88E5-80BF3ABC0028}"/>
+                <a16:creationId xmlns:a16="http://schemas.microsoft.com/office/drawing/2014/main" id="{AEDF0E1B-0DCB-4C50-BB89-8B9376095F25}"/>
               </a:ext>
             </a:extLst>
           </p:cNvPr>
@@ -11310,7 +11310,7 @@
           <p:cNvPr id="10" name="">
             <a:extLst xmlns:a="http://schemas.openxmlformats.org/drawingml/2006/main">
               <a:ext uri="{FF2B5EF4-FFF2-40B4-BE49-F238E27FC236}">
-                <a16:creationId xmlns:a16="http://schemas.microsoft.com/office/drawing/2014/main" id="{912CEBDB-3999-4264-9F7F-427A238D7A62}"/>
+                <a16:creationId xmlns:a16="http://schemas.microsoft.com/office/drawing/2014/main" id="{7AC2CA1E-B287-4321-AC7D-593AC876702B}"/>
               </a:ext>
             </a:extLst>
           </p:cNvPr>
@@ -11372,7 +11372,7 @@
           <p:cNvPr id="11" name="">
             <a:extLst xmlns:a="http://schemas.openxmlformats.org/drawingml/2006/main">
               <a:ext uri="{FF2B5EF4-FFF2-40B4-BE49-F238E27FC236}">
-                <a16:creationId xmlns:a16="http://schemas.microsoft.com/office/drawing/2014/main" id="{DF904F06-6E44-4632-B80D-0893A727B4F4}"/>
+                <a16:creationId xmlns:a16="http://schemas.microsoft.com/office/drawing/2014/main" id="{5F4C4E26-0F18-46C6-9F66-E2E9BE6D3D5C}"/>
               </a:ext>
             </a:extLst>
           </p:cNvPr>
@@ -11434,7 +11434,7 @@
           <p:cNvPr id="12" name="">
             <a:extLst xmlns:a="http://schemas.openxmlformats.org/drawingml/2006/main">
               <a:ext uri="{FF2B5EF4-FFF2-40B4-BE49-F238E27FC236}">
-                <a16:creationId xmlns:a16="http://schemas.microsoft.com/office/drawing/2014/main" id="{EB13EEED-9DB7-40D1-9D05-B76145421E0C}"/>
+                <a16:creationId xmlns:a16="http://schemas.microsoft.com/office/drawing/2014/main" id="{13D99469-784D-40DA-A4BC-28EB76A3AAEC}"/>
               </a:ext>
             </a:extLst>
           </p:cNvPr>
@@ -11465,7 +11465,7 @@
           <p:cNvPr id="13" name="">
             <a:extLst xmlns:a="http://schemas.openxmlformats.org/drawingml/2006/main">
               <a:ext uri="{FF2B5EF4-FFF2-40B4-BE49-F238E27FC236}">
-                <a16:creationId xmlns:a16="http://schemas.microsoft.com/office/drawing/2014/main" id="{09357445-3358-439B-92BB-597ACD99AA67}"/>
+                <a16:creationId xmlns:a16="http://schemas.microsoft.com/office/drawing/2014/main" id="{D4AE0E1D-EEF4-491D-8ECC-37008A6419C5}"/>
               </a:ext>
             </a:extLst>
           </p:cNvPr>
@@ -11527,7 +11527,7 @@
           <p:cNvPr id="14" name="">
             <a:extLst xmlns:a="http://schemas.openxmlformats.org/drawingml/2006/main">
               <a:ext uri="{FF2B5EF4-FFF2-40B4-BE49-F238E27FC236}">
-                <a16:creationId xmlns:a16="http://schemas.microsoft.com/office/drawing/2014/main" id="{EB94BE04-E23C-4DA5-81CD-D487AF154304}"/>
+                <a16:creationId xmlns:a16="http://schemas.microsoft.com/office/drawing/2014/main" id="{3F1F9765-EFA5-49DA-B5D4-F0E8A2544609}"/>
               </a:ext>
             </a:extLst>
           </p:cNvPr>
@@ -11589,7 +11589,7 @@
           <p:cNvPr id="15" name="">
             <a:extLst xmlns:a="http://schemas.openxmlformats.org/drawingml/2006/main">
               <a:ext uri="{FF2B5EF4-FFF2-40B4-BE49-F238E27FC236}">
-                <a16:creationId xmlns:a16="http://schemas.microsoft.com/office/drawing/2014/main" id="{7A25BC65-62FF-41E7-B914-54568CDF7821}"/>
+                <a16:creationId xmlns:a16="http://schemas.microsoft.com/office/drawing/2014/main" id="{3F2A9CC5-A383-45CA-BDB1-7E3590541239}"/>
               </a:ext>
             </a:extLst>
           </p:cNvPr>
@@ -11620,7 +11620,7 @@
           <p:cNvPr id="16" name="">
             <a:extLst xmlns:a="http://schemas.openxmlformats.org/drawingml/2006/main">
               <a:ext uri="{FF2B5EF4-FFF2-40B4-BE49-F238E27FC236}">
-                <a16:creationId xmlns:a16="http://schemas.microsoft.com/office/drawing/2014/main" id="{CB08E12C-6836-48C1-9933-C4620FF513BC}"/>
+                <a16:creationId xmlns:a16="http://schemas.microsoft.com/office/drawing/2014/main" id="{5EE2FB71-C6F8-4654-BB2F-45DD647A2E21}"/>
               </a:ext>
             </a:extLst>
           </p:cNvPr>
@@ -11682,7 +11682,7 @@
           <p:cNvPr id="17" name="">
             <a:extLst xmlns:a="http://schemas.openxmlformats.org/drawingml/2006/main">
               <a:ext uri="{FF2B5EF4-FFF2-40B4-BE49-F238E27FC236}">
-                <a16:creationId xmlns:a16="http://schemas.microsoft.com/office/drawing/2014/main" id="{DF7DF842-B29C-45F9-A179-60BBC456A7CF}"/>
+                <a16:creationId xmlns:a16="http://schemas.microsoft.com/office/drawing/2014/main" id="{F71DDB93-8A7E-4597-A60F-850D8EB05920}"/>
               </a:ext>
             </a:extLst>
           </p:cNvPr>
@@ -11744,7 +11744,7 @@
           <p:cNvPr id="18" name="">
             <a:extLst xmlns:a="http://schemas.openxmlformats.org/drawingml/2006/main">
               <a:ext uri="{FF2B5EF4-FFF2-40B4-BE49-F238E27FC236}">
-                <a16:creationId xmlns:a16="http://schemas.microsoft.com/office/drawing/2014/main" id="{9DD4DE4C-DDDF-484B-92DE-CC7EEE79E801}"/>
+                <a16:creationId xmlns:a16="http://schemas.microsoft.com/office/drawing/2014/main" id="{69DB73B1-FC27-4F63-9636-0E93713E4749}"/>
               </a:ext>
             </a:extLst>
           </p:cNvPr>
@@ -11777,7 +11777,7 @@
           <p:cNvPr id="19" name="">
             <a:extLst xmlns:a="http://schemas.openxmlformats.org/drawingml/2006/main">
               <a:ext uri="{FF2B5EF4-FFF2-40B4-BE49-F238E27FC236}">
-                <a16:creationId xmlns:a16="http://schemas.microsoft.com/office/drawing/2014/main" id="{AA833DC4-8FC3-4315-8FA6-0631E4C21083}"/>
+                <a16:creationId xmlns:a16="http://schemas.microsoft.com/office/drawing/2014/main" id="{46354C33-B61B-47E6-8A2B-A74B9BD383F5}"/>
               </a:ext>
             </a:extLst>
           </p:cNvPr>
@@ -11839,7 +11839,7 @@
           <p:cNvPr id="20" name="footer-rule-17">
             <a:extLst xmlns:a="http://schemas.openxmlformats.org/drawingml/2006/main">
               <a:ext uri="{FF2B5EF4-FFF2-40B4-BE49-F238E27FC236}">
-                <a16:creationId xmlns:a16="http://schemas.microsoft.com/office/drawing/2014/main" id="{0F0E61D6-18D1-44F4-A1C5-BD0428B2B571}"/>
+                <a16:creationId xmlns:a16="http://schemas.microsoft.com/office/drawing/2014/main" id="{7A3D5A9A-AA2A-4158-92F3-B5CDADBB13E5}"/>
               </a:ext>
             </a:extLst>
           </p:cNvPr>
@@ -11870,7 +11870,7 @@
           <p:cNvPr id="21" name="footer-label-17">
             <a:extLst xmlns:a="http://schemas.openxmlformats.org/drawingml/2006/main">
               <a:ext uri="{FF2B5EF4-FFF2-40B4-BE49-F238E27FC236}">
-                <a16:creationId xmlns:a16="http://schemas.microsoft.com/office/drawing/2014/main" id="{BA3A9B4B-7D8E-454A-80DA-11D6153A46DC}"/>
+                <a16:creationId xmlns:a16="http://schemas.microsoft.com/office/drawing/2014/main" id="{DDFB6971-B165-41CF-AB46-9478D5488204}"/>
               </a:ext>
             </a:extLst>
           </p:cNvPr>
@@ -11932,7 +11932,7 @@
           <p:cNvPr id="22" name="footer-page-17">
             <a:extLst xmlns:a="http://schemas.openxmlformats.org/drawingml/2006/main">
               <a:ext uri="{FF2B5EF4-FFF2-40B4-BE49-F238E27FC236}">
-                <a16:creationId xmlns:a16="http://schemas.microsoft.com/office/drawing/2014/main" id="{DB5D6309-2417-400D-8177-F402800A95B6}"/>
+                <a16:creationId xmlns:a16="http://schemas.microsoft.com/office/drawing/2014/main" id="{E97955A9-396D-44EF-8216-265381293C61}"/>
               </a:ext>
             </a:extLst>
           </p:cNvPr>
@@ -11992,7 +11992,7 @@
     </p:spTree>
     <p:extLst>
       <p:ext uri="{BB962C8B-B14F-4D97-AF65-F5344CB8AC3E}">
-        <p14:creationId xmlns:p14="http://schemas.microsoft.com/office/powerpoint/2010/main" val="1021470599"/>
+        <p14:creationId xmlns:p14="http://schemas.microsoft.com/office/powerpoint/2010/main" val="2054918486"/>
       </p:ext>
     </p:extLst>
   </p:cSld>
@@ -12023,7 +12023,7 @@
           <p:cNvPr id="25" name="side-accent-18">
             <a:extLst xmlns:a="http://schemas.openxmlformats.org/drawingml/2006/main">
               <a:ext uri="{FF2B5EF4-FFF2-40B4-BE49-F238E27FC236}">
-                <a16:creationId xmlns:a16="http://schemas.microsoft.com/office/drawing/2014/main" id="{DC0BD7BA-F558-4D89-900D-F9C9C219F4B2}"/>
+                <a16:creationId xmlns:a16="http://schemas.microsoft.com/office/drawing/2014/main" id="{3D3C14CC-B649-4669-8CAF-5D310D805E74}"/>
               </a:ext>
             </a:extLst>
           </p:cNvPr>
@@ -12054,7 +12054,7 @@
           <p:cNvPr id="2" name="kicker-18">
             <a:extLst xmlns:a="http://schemas.openxmlformats.org/drawingml/2006/main">
               <a:ext uri="{FF2B5EF4-FFF2-40B4-BE49-F238E27FC236}">
-                <a16:creationId xmlns:a16="http://schemas.microsoft.com/office/drawing/2014/main" id="{782EBDD5-84BF-4DFB-9358-5ED846374278}"/>
+                <a16:creationId xmlns:a16="http://schemas.microsoft.com/office/drawing/2014/main" id="{A5A9F8EF-C745-4D68-B59A-DC84A48C918C}"/>
               </a:ext>
             </a:extLst>
           </p:cNvPr>
@@ -12116,7 +12116,7 @@
           <p:cNvPr id="3" name="title-18">
             <a:extLst xmlns:a="http://schemas.openxmlformats.org/drawingml/2006/main">
               <a:ext uri="{FF2B5EF4-FFF2-40B4-BE49-F238E27FC236}">
-                <a16:creationId xmlns:a16="http://schemas.microsoft.com/office/drawing/2014/main" id="{405B6229-916D-4C00-8CE6-7DF5C97B455A}"/>
+                <a16:creationId xmlns:a16="http://schemas.microsoft.com/office/drawing/2014/main" id="{6BF57099-B3F5-4472-A37B-27FF2A921677}"/>
               </a:ext>
             </a:extLst>
           </p:cNvPr>
@@ -12178,7 +12178,7 @@
           <p:cNvPr id="4" name="">
             <a:extLst xmlns:a="http://schemas.openxmlformats.org/drawingml/2006/main">
               <a:ext uri="{FF2B5EF4-FFF2-40B4-BE49-F238E27FC236}">
-                <a16:creationId xmlns:a16="http://schemas.microsoft.com/office/drawing/2014/main" id="{692E5A14-F338-48DC-92BD-6B2B20DEB893}"/>
+                <a16:creationId xmlns:a16="http://schemas.microsoft.com/office/drawing/2014/main" id="{B73A8E49-CC4C-4392-89F1-5392B692220E}"/>
               </a:ext>
             </a:extLst>
           </p:cNvPr>
@@ -12240,7 +12240,7 @@
           <p:cNvPr id="5" name="">
             <a:extLst xmlns:a="http://schemas.openxmlformats.org/drawingml/2006/main">
               <a:ext uri="{FF2B5EF4-FFF2-40B4-BE49-F238E27FC236}">
-                <a16:creationId xmlns:a16="http://schemas.microsoft.com/office/drawing/2014/main" id="{ADC60080-3530-4C1B-A092-B96D1699DB1F}"/>
+                <a16:creationId xmlns:a16="http://schemas.microsoft.com/office/drawing/2014/main" id="{6ABED2A7-FB53-4EBE-B638-7F750C929A7E}"/>
               </a:ext>
             </a:extLst>
           </p:cNvPr>
@@ -12302,7 +12302,7 @@
           <p:cNvPr id="6" name="">
             <a:extLst xmlns:a="http://schemas.openxmlformats.org/drawingml/2006/main">
               <a:ext uri="{FF2B5EF4-FFF2-40B4-BE49-F238E27FC236}">
-                <a16:creationId xmlns:a16="http://schemas.microsoft.com/office/drawing/2014/main" id="{20558017-387A-4001-A4BE-4E9788B8C99E}"/>
+                <a16:creationId xmlns:a16="http://schemas.microsoft.com/office/drawing/2014/main" id="{8A798736-AF8D-4DA0-8182-CDCC90F49ACF}"/>
               </a:ext>
             </a:extLst>
           </p:cNvPr>
@@ -12364,7 +12364,7 @@
           <p:cNvPr id="7" name="">
             <a:extLst xmlns:a="http://schemas.openxmlformats.org/drawingml/2006/main">
               <a:ext uri="{FF2B5EF4-FFF2-40B4-BE49-F238E27FC236}">
-                <a16:creationId xmlns:a16="http://schemas.microsoft.com/office/drawing/2014/main" id="{C7A692C4-55C1-4762-9AAE-D112A39EC4B0}"/>
+                <a16:creationId xmlns:a16="http://schemas.microsoft.com/office/drawing/2014/main" id="{11EB5548-FF92-493A-BC09-4DA719CCABF9}"/>
               </a:ext>
             </a:extLst>
           </p:cNvPr>
@@ -12395,7 +12395,7 @@
           <p:cNvPr id="8" name="">
             <a:extLst xmlns:a="http://schemas.openxmlformats.org/drawingml/2006/main">
               <a:ext uri="{FF2B5EF4-FFF2-40B4-BE49-F238E27FC236}">
-                <a16:creationId xmlns:a16="http://schemas.microsoft.com/office/drawing/2014/main" id="{6F7F0283-E35A-4C10-8512-BD7307BF3A6C}"/>
+                <a16:creationId xmlns:a16="http://schemas.microsoft.com/office/drawing/2014/main" id="{8B6A0230-75C6-4FD9-BD55-5E6F8B5374E8}"/>
               </a:ext>
             </a:extLst>
           </p:cNvPr>
@@ -12457,7 +12457,7 @@
           <p:cNvPr id="9" name="">
             <a:extLst xmlns:a="http://schemas.openxmlformats.org/drawingml/2006/main">
               <a:ext uri="{FF2B5EF4-FFF2-40B4-BE49-F238E27FC236}">
-                <a16:creationId xmlns:a16="http://schemas.microsoft.com/office/drawing/2014/main" id="{C582A883-C5A0-432C-9BC9-DD1DD758E4C4}"/>
+                <a16:creationId xmlns:a16="http://schemas.microsoft.com/office/drawing/2014/main" id="{6F00FC7F-8B18-463B-88D3-8E7EA732D607}"/>
               </a:ext>
             </a:extLst>
           </p:cNvPr>
@@ -12519,7 +12519,7 @@
           <p:cNvPr id="10" name="">
             <a:extLst xmlns:a="http://schemas.openxmlformats.org/drawingml/2006/main">
               <a:ext uri="{FF2B5EF4-FFF2-40B4-BE49-F238E27FC236}">
-                <a16:creationId xmlns:a16="http://schemas.microsoft.com/office/drawing/2014/main" id="{8527B235-DD67-413A-8996-E847BE25DAE4}"/>
+                <a16:creationId xmlns:a16="http://schemas.microsoft.com/office/drawing/2014/main" id="{3ECFA22C-8246-4147-8127-851FA36B298F}"/>
               </a:ext>
             </a:extLst>
           </p:cNvPr>
@@ -12581,7 +12581,7 @@
           <p:cNvPr id="11" name="">
             <a:extLst xmlns:a="http://schemas.openxmlformats.org/drawingml/2006/main">
               <a:ext uri="{FF2B5EF4-FFF2-40B4-BE49-F238E27FC236}">
-                <a16:creationId xmlns:a16="http://schemas.microsoft.com/office/drawing/2014/main" id="{FED84521-79D9-4068-B7F4-8405D6AFDF8F}"/>
+                <a16:creationId xmlns:a16="http://schemas.microsoft.com/office/drawing/2014/main" id="{5CCE26AA-08B5-4973-9CD5-3AC7F21DA679}"/>
               </a:ext>
             </a:extLst>
           </p:cNvPr>
@@ -12612,7 +12612,7 @@
           <p:cNvPr id="12" name="">
             <a:extLst xmlns:a="http://schemas.openxmlformats.org/drawingml/2006/main">
               <a:ext uri="{FF2B5EF4-FFF2-40B4-BE49-F238E27FC236}">
-                <a16:creationId xmlns:a16="http://schemas.microsoft.com/office/drawing/2014/main" id="{F4F34063-4BEA-46BF-AB1E-EDC2F82900D2}"/>
+                <a16:creationId xmlns:a16="http://schemas.microsoft.com/office/drawing/2014/main" id="{2D7CEF3B-A5D7-4403-A507-BDEC828EAC67}"/>
               </a:ext>
             </a:extLst>
           </p:cNvPr>
@@ -12674,7 +12674,7 @@
           <p:cNvPr id="13" name="">
             <a:extLst xmlns:a="http://schemas.openxmlformats.org/drawingml/2006/main">
               <a:ext uri="{FF2B5EF4-FFF2-40B4-BE49-F238E27FC236}">
-                <a16:creationId xmlns:a16="http://schemas.microsoft.com/office/drawing/2014/main" id="{1E41A066-9962-443D-9240-5FD157C67B66}"/>
+                <a16:creationId xmlns:a16="http://schemas.microsoft.com/office/drawing/2014/main" id="{6313D2B6-DC8D-487A-836E-F75735ED08D8}"/>
               </a:ext>
             </a:extLst>
           </p:cNvPr>
@@ -12736,7 +12736,7 @@
           <p:cNvPr id="14" name="">
             <a:extLst xmlns:a="http://schemas.openxmlformats.org/drawingml/2006/main">
               <a:ext uri="{FF2B5EF4-FFF2-40B4-BE49-F238E27FC236}">
-                <a16:creationId xmlns:a16="http://schemas.microsoft.com/office/drawing/2014/main" id="{6E7FDC6D-FC49-425A-8481-8B3D4DF8F4EB}"/>
+                <a16:creationId xmlns:a16="http://schemas.microsoft.com/office/drawing/2014/main" id="{D4E18CDD-7772-4E37-9E7F-B9D425015D7F}"/>
               </a:ext>
             </a:extLst>
           </p:cNvPr>
@@ -12798,7 +12798,7 @@
           <p:cNvPr id="15" name="">
             <a:extLst xmlns:a="http://schemas.openxmlformats.org/drawingml/2006/main">
               <a:ext uri="{FF2B5EF4-FFF2-40B4-BE49-F238E27FC236}">
-                <a16:creationId xmlns:a16="http://schemas.microsoft.com/office/drawing/2014/main" id="{618917BA-FB6F-4AE0-829D-9DA958E5C1AD}"/>
+                <a16:creationId xmlns:a16="http://schemas.microsoft.com/office/drawing/2014/main" id="{C3C9E29B-DC12-4720-86C0-5353B866EC42}"/>
               </a:ext>
             </a:extLst>
           </p:cNvPr>
@@ -12829,7 +12829,7 @@
           <p:cNvPr id="16" name="">
             <a:extLst xmlns:a="http://schemas.openxmlformats.org/drawingml/2006/main">
               <a:ext uri="{FF2B5EF4-FFF2-40B4-BE49-F238E27FC236}">
-                <a16:creationId xmlns:a16="http://schemas.microsoft.com/office/drawing/2014/main" id="{B50D640C-FFB1-4B81-81A2-921258F9673E}"/>
+                <a16:creationId xmlns:a16="http://schemas.microsoft.com/office/drawing/2014/main" id="{998BA751-147C-4253-9E46-3D20C8E55756}"/>
               </a:ext>
             </a:extLst>
           </p:cNvPr>
@@ -12891,7 +12891,7 @@
           <p:cNvPr id="17" name="">
             <a:extLst xmlns:a="http://schemas.openxmlformats.org/drawingml/2006/main">
               <a:ext uri="{FF2B5EF4-FFF2-40B4-BE49-F238E27FC236}">
-                <a16:creationId xmlns:a16="http://schemas.microsoft.com/office/drawing/2014/main" id="{538864C7-B9F2-4E49-A49B-F04CD1B9566A}"/>
+                <a16:creationId xmlns:a16="http://schemas.microsoft.com/office/drawing/2014/main" id="{96B954FC-6065-4FB4-A848-8941E4B36889}"/>
               </a:ext>
             </a:extLst>
           </p:cNvPr>
@@ -12953,7 +12953,7 @@
           <p:cNvPr id="18" name="">
             <a:extLst xmlns:a="http://schemas.openxmlformats.org/drawingml/2006/main">
               <a:ext uri="{FF2B5EF4-FFF2-40B4-BE49-F238E27FC236}">
-                <a16:creationId xmlns:a16="http://schemas.microsoft.com/office/drawing/2014/main" id="{02E0FCE5-A899-4DFA-A8B3-133CB2BE0634}"/>
+                <a16:creationId xmlns:a16="http://schemas.microsoft.com/office/drawing/2014/main" id="{1598AC3A-D00D-4C71-951A-329B2568B2CA}"/>
               </a:ext>
             </a:extLst>
           </p:cNvPr>
@@ -13015,7 +13015,7 @@
           <p:cNvPr id="19" name="">
             <a:extLst xmlns:a="http://schemas.openxmlformats.org/drawingml/2006/main">
               <a:ext uri="{FF2B5EF4-FFF2-40B4-BE49-F238E27FC236}">
-                <a16:creationId xmlns:a16="http://schemas.microsoft.com/office/drawing/2014/main" id="{0F1CF75A-462F-46CB-8DB2-B51DF743799E}"/>
+                <a16:creationId xmlns:a16="http://schemas.microsoft.com/office/drawing/2014/main" id="{4C3FB429-8775-4C9C-A7A8-4EEB831FA515}"/>
               </a:ext>
             </a:extLst>
           </p:cNvPr>
@@ -13048,7 +13048,7 @@
           <p:cNvPr id="20" name="">
             <a:extLst xmlns:a="http://schemas.openxmlformats.org/drawingml/2006/main">
               <a:ext uri="{FF2B5EF4-FFF2-40B4-BE49-F238E27FC236}">
-                <a16:creationId xmlns:a16="http://schemas.microsoft.com/office/drawing/2014/main" id="{BB079555-1FC1-40AB-8EFC-83BE1EB86D80}"/>
+                <a16:creationId xmlns:a16="http://schemas.microsoft.com/office/drawing/2014/main" id="{9DB463CE-8D5D-491B-8E7D-03B7DFA36B43}"/>
               </a:ext>
             </a:extLst>
           </p:cNvPr>
@@ -13114,7 +13114,7 @@
           <p:nvPr/>
         </p:nvPicPr>
         <p:blipFill>
-          <a:blip xmlns:r="http://schemas.openxmlformats.org/officeDocument/2006/relationships" xmlns:a="http://schemas.openxmlformats.org/drawingml/2006/main" r:embed="Rd7630af23c624370"/>
+          <a:blip xmlns:r="http://schemas.openxmlformats.org/officeDocument/2006/relationships" xmlns:a="http://schemas.openxmlformats.org/drawingml/2006/main" r:embed="Rdf7edd77728c463f"/>
           <a:stretch xmlns:a="http://schemas.openxmlformats.org/drawingml/2006/main"/>
         </p:blipFill>
         <p:spPr>
@@ -13132,7 +13132,7 @@
           <p:cNvPr id="22" name="footer-rule-18">
             <a:extLst xmlns:a="http://schemas.openxmlformats.org/drawingml/2006/main">
               <a:ext uri="{FF2B5EF4-FFF2-40B4-BE49-F238E27FC236}">
-                <a16:creationId xmlns:a16="http://schemas.microsoft.com/office/drawing/2014/main" id="{8763C335-3B10-4680-9C69-10681DE2D153}"/>
+                <a16:creationId xmlns:a16="http://schemas.microsoft.com/office/drawing/2014/main" id="{36072E0B-EDBE-4B3A-A13D-9C534E90DB5C}"/>
               </a:ext>
             </a:extLst>
           </p:cNvPr>
@@ -13163,7 +13163,7 @@
           <p:cNvPr id="23" name="footer-label-18">
             <a:extLst xmlns:a="http://schemas.openxmlformats.org/drawingml/2006/main">
               <a:ext uri="{FF2B5EF4-FFF2-40B4-BE49-F238E27FC236}">
-                <a16:creationId xmlns:a16="http://schemas.microsoft.com/office/drawing/2014/main" id="{C6284399-3BB1-49D0-B087-BF42C9079AE6}"/>
+                <a16:creationId xmlns:a16="http://schemas.microsoft.com/office/drawing/2014/main" id="{C64BDEC3-8527-4C32-839F-F4142859AA47}"/>
               </a:ext>
             </a:extLst>
           </p:cNvPr>
@@ -13225,7 +13225,7 @@
           <p:cNvPr id="24" name="footer-page-18">
             <a:extLst xmlns:a="http://schemas.openxmlformats.org/drawingml/2006/main">
               <a:ext uri="{FF2B5EF4-FFF2-40B4-BE49-F238E27FC236}">
-                <a16:creationId xmlns:a16="http://schemas.microsoft.com/office/drawing/2014/main" id="{2185AB8E-10B6-4261-9D08-D0E1DCC3471E}"/>
+                <a16:creationId xmlns:a16="http://schemas.microsoft.com/office/drawing/2014/main" id="{96889ACA-9A8A-4441-B9A8-9F8F30DDD1FC}"/>
               </a:ext>
             </a:extLst>
           </p:cNvPr>
@@ -13285,7 +13285,7 @@
     </p:spTree>
     <p:extLst>
       <p:ext uri="{BB962C8B-B14F-4D97-AF65-F5344CB8AC3E}">
-        <p14:creationId xmlns:p14="http://schemas.microsoft.com/office/powerpoint/2010/main" val="2075898901"/>
+        <p14:creationId xmlns:p14="http://schemas.microsoft.com/office/powerpoint/2010/main" val="1900363953"/>
       </p:ext>
     </p:extLst>
   </p:cSld>
@@ -13316,7 +13316,7 @@
           <p:cNvPr id="20" name="side-accent-2">
             <a:extLst xmlns:a="http://schemas.openxmlformats.org/drawingml/2006/main">
               <a:ext uri="{FF2B5EF4-FFF2-40B4-BE49-F238E27FC236}">
-                <a16:creationId xmlns:a16="http://schemas.microsoft.com/office/drawing/2014/main" id="{338B8330-F36C-4B9E-B80B-1F0B68ACF2A9}"/>
+                <a16:creationId xmlns:a16="http://schemas.microsoft.com/office/drawing/2014/main" id="{68F537F3-9F3A-491D-8A4A-A86226232C8D}"/>
               </a:ext>
             </a:extLst>
           </p:cNvPr>
@@ -13347,7 +13347,7 @@
           <p:cNvPr id="2" name="kicker-2">
             <a:extLst xmlns:a="http://schemas.openxmlformats.org/drawingml/2006/main">
               <a:ext uri="{FF2B5EF4-FFF2-40B4-BE49-F238E27FC236}">
-                <a16:creationId xmlns:a16="http://schemas.microsoft.com/office/drawing/2014/main" id="{B202D29F-764D-4EEC-AE99-768485D2EA4D}"/>
+                <a16:creationId xmlns:a16="http://schemas.microsoft.com/office/drawing/2014/main" id="{E6F04AAA-1279-44D2-B831-A4B26368B37D}"/>
               </a:ext>
             </a:extLst>
           </p:cNvPr>
@@ -13409,7 +13409,7 @@
           <p:cNvPr id="3" name="title-2">
             <a:extLst xmlns:a="http://schemas.openxmlformats.org/drawingml/2006/main">
               <a:ext uri="{FF2B5EF4-FFF2-40B4-BE49-F238E27FC236}">
-                <a16:creationId xmlns:a16="http://schemas.microsoft.com/office/drawing/2014/main" id="{1E5F87A8-227D-4B67-AB84-D1B0C268F5EC}"/>
+                <a16:creationId xmlns:a16="http://schemas.microsoft.com/office/drawing/2014/main" id="{1BA6201C-9578-41FF-B4D8-0A7D6E606FEA}"/>
               </a:ext>
             </a:extLst>
           </p:cNvPr>
@@ -13471,7 +13471,7 @@
           <p:cNvPr id="4" name="">
             <a:extLst xmlns:a="http://schemas.openxmlformats.org/drawingml/2006/main">
               <a:ext uri="{FF2B5EF4-FFF2-40B4-BE49-F238E27FC236}">
-                <a16:creationId xmlns:a16="http://schemas.microsoft.com/office/drawing/2014/main" id="{E9E90743-873E-4554-B06D-8643BE93FB1B}"/>
+                <a16:creationId xmlns:a16="http://schemas.microsoft.com/office/drawing/2014/main" id="{31C2D1FC-AF58-4BDB-95B5-93E044FE894F}"/>
               </a:ext>
             </a:extLst>
           </p:cNvPr>
@@ -13533,7 +13533,7 @@
           <p:cNvPr id="5" name="">
             <a:extLst xmlns:a="http://schemas.openxmlformats.org/drawingml/2006/main">
               <a:ext uri="{FF2B5EF4-FFF2-40B4-BE49-F238E27FC236}">
-                <a16:creationId xmlns:a16="http://schemas.microsoft.com/office/drawing/2014/main" id="{B13A34CA-BE5B-4232-9970-9AA08ED55DE4}"/>
+                <a16:creationId xmlns:a16="http://schemas.microsoft.com/office/drawing/2014/main" id="{41B9AA2A-BBD9-4B9D-9B2F-2083F77310D2}"/>
               </a:ext>
             </a:extLst>
           </p:cNvPr>
@@ -13595,7 +13595,7 @@
           <p:cNvPr id="6" name="">
             <a:extLst xmlns:a="http://schemas.openxmlformats.org/drawingml/2006/main">
               <a:ext uri="{FF2B5EF4-FFF2-40B4-BE49-F238E27FC236}">
-                <a16:creationId xmlns:a16="http://schemas.microsoft.com/office/drawing/2014/main" id="{14BB841B-DD93-4732-A56F-9852F2FABF94}"/>
+                <a16:creationId xmlns:a16="http://schemas.microsoft.com/office/drawing/2014/main" id="{3198103F-3779-49F4-859D-A76E487D254F}"/>
               </a:ext>
             </a:extLst>
           </p:cNvPr>
@@ -13626,7 +13626,7 @@
           <p:cNvPr id="7" name="">
             <a:extLst xmlns:a="http://schemas.openxmlformats.org/drawingml/2006/main">
               <a:ext uri="{FF2B5EF4-FFF2-40B4-BE49-F238E27FC236}">
-                <a16:creationId xmlns:a16="http://schemas.microsoft.com/office/drawing/2014/main" id="{851A8F72-4D9A-45D2-8A0B-FA98B7245758}"/>
+                <a16:creationId xmlns:a16="http://schemas.microsoft.com/office/drawing/2014/main" id="{91944725-1039-42F9-9444-082788F23279}"/>
               </a:ext>
             </a:extLst>
           </p:cNvPr>
@@ -13688,7 +13688,7 @@
           <p:cNvPr id="8" name="">
             <a:extLst xmlns:a="http://schemas.openxmlformats.org/drawingml/2006/main">
               <a:ext uri="{FF2B5EF4-FFF2-40B4-BE49-F238E27FC236}">
-                <a16:creationId xmlns:a16="http://schemas.microsoft.com/office/drawing/2014/main" id="{7B266733-0950-4CEB-B4F5-FF41E23406FA}"/>
+                <a16:creationId xmlns:a16="http://schemas.microsoft.com/office/drawing/2014/main" id="{133D7875-A052-4A7B-82A2-1452403BDE89}"/>
               </a:ext>
             </a:extLst>
           </p:cNvPr>
@@ -13750,7 +13750,7 @@
           <p:cNvPr id="9" name="">
             <a:extLst xmlns:a="http://schemas.openxmlformats.org/drawingml/2006/main">
               <a:ext uri="{FF2B5EF4-FFF2-40B4-BE49-F238E27FC236}">
-                <a16:creationId xmlns:a16="http://schemas.microsoft.com/office/drawing/2014/main" id="{AFE9DA23-69D7-4C9C-909A-2F0795D0E73A}"/>
+                <a16:creationId xmlns:a16="http://schemas.microsoft.com/office/drawing/2014/main" id="{EFF58F51-6980-48F5-9915-4437D68C07B2}"/>
               </a:ext>
             </a:extLst>
           </p:cNvPr>
@@ -13781,7 +13781,7 @@
           <p:cNvPr id="10" name="">
             <a:extLst xmlns:a="http://schemas.openxmlformats.org/drawingml/2006/main">
               <a:ext uri="{FF2B5EF4-FFF2-40B4-BE49-F238E27FC236}">
-                <a16:creationId xmlns:a16="http://schemas.microsoft.com/office/drawing/2014/main" id="{CEACE2C2-4165-4CE2-B249-84C43D1CC538}"/>
+                <a16:creationId xmlns:a16="http://schemas.microsoft.com/office/drawing/2014/main" id="{F184DA56-C02B-466A-AF1F-D0D234763801}"/>
               </a:ext>
             </a:extLst>
           </p:cNvPr>
@@ -13843,7 +13843,7 @@
           <p:cNvPr id="11" name="">
             <a:extLst xmlns:a="http://schemas.openxmlformats.org/drawingml/2006/main">
               <a:ext uri="{FF2B5EF4-FFF2-40B4-BE49-F238E27FC236}">
-                <a16:creationId xmlns:a16="http://schemas.microsoft.com/office/drawing/2014/main" id="{F102DAB8-5B98-4158-BBB6-2B12717D9D64}"/>
+                <a16:creationId xmlns:a16="http://schemas.microsoft.com/office/drawing/2014/main" id="{3B5332E6-742B-4601-A48A-F8CC0E5CA7B9}"/>
               </a:ext>
             </a:extLst>
           </p:cNvPr>
@@ -13905,7 +13905,7 @@
           <p:cNvPr id="12" name="">
             <a:extLst xmlns:a="http://schemas.openxmlformats.org/drawingml/2006/main">
               <a:ext uri="{FF2B5EF4-FFF2-40B4-BE49-F238E27FC236}">
-                <a16:creationId xmlns:a16="http://schemas.microsoft.com/office/drawing/2014/main" id="{436FB513-3464-4142-90C8-F10DE17BC40F}"/>
+                <a16:creationId xmlns:a16="http://schemas.microsoft.com/office/drawing/2014/main" id="{5F2AB7C8-A49B-48FE-BDE2-DC740E528B74}"/>
               </a:ext>
             </a:extLst>
           </p:cNvPr>
@@ -13936,7 +13936,7 @@
           <p:cNvPr id="13" name="">
             <a:extLst xmlns:a="http://schemas.openxmlformats.org/drawingml/2006/main">
               <a:ext uri="{FF2B5EF4-FFF2-40B4-BE49-F238E27FC236}">
-                <a16:creationId xmlns:a16="http://schemas.microsoft.com/office/drawing/2014/main" id="{6F4B5865-8ABD-4600-8380-D043200B5F4E}"/>
+                <a16:creationId xmlns:a16="http://schemas.microsoft.com/office/drawing/2014/main" id="{E6AB4F69-41FC-4294-B3B7-B763FBA8CACE}"/>
               </a:ext>
             </a:extLst>
           </p:cNvPr>
@@ -13998,7 +13998,7 @@
           <p:cNvPr id="14" name="outcome-mark">
             <a:extLst xmlns:a="http://schemas.openxmlformats.org/drawingml/2006/main">
               <a:ext uri="{FF2B5EF4-FFF2-40B4-BE49-F238E27FC236}">
-                <a16:creationId xmlns:a16="http://schemas.microsoft.com/office/drawing/2014/main" id="{19819231-9EB5-497A-8B4E-7CF41ACD9D3D}"/>
+                <a16:creationId xmlns:a16="http://schemas.microsoft.com/office/drawing/2014/main" id="{18EAE038-CB66-4678-A3ED-65C4891D1593}"/>
               </a:ext>
             </a:extLst>
           </p:cNvPr>
@@ -14033,7 +14033,7 @@
           <p:cNvPr id="15" name="">
             <a:extLst xmlns:a="http://schemas.openxmlformats.org/drawingml/2006/main">
               <a:ext uri="{FF2B5EF4-FFF2-40B4-BE49-F238E27FC236}">
-                <a16:creationId xmlns:a16="http://schemas.microsoft.com/office/drawing/2014/main" id="{9A3554D8-24BE-4A0F-B208-EF6DDB4A2AE2}"/>
+                <a16:creationId xmlns:a16="http://schemas.microsoft.com/office/drawing/2014/main" id="{4264E528-C0DA-4C0A-9F53-C76B9093B7C0}"/>
               </a:ext>
             </a:extLst>
           </p:cNvPr>
@@ -14095,7 +14095,7 @@
           <p:cNvPr id="16" name="">
             <a:extLst xmlns:a="http://schemas.openxmlformats.org/drawingml/2006/main">
               <a:ext uri="{FF2B5EF4-FFF2-40B4-BE49-F238E27FC236}">
-                <a16:creationId xmlns:a16="http://schemas.microsoft.com/office/drawing/2014/main" id="{A39A4478-9135-41AD-9CA9-B79F6C4FBB95}"/>
+                <a16:creationId xmlns:a16="http://schemas.microsoft.com/office/drawing/2014/main" id="{01E97F7E-A06F-4FB4-AFE0-2DE8294469BE}"/>
               </a:ext>
             </a:extLst>
           </p:cNvPr>
@@ -14184,7 +14184,7 @@
           <p:cNvPr id="17" name="footer-rule-2">
             <a:extLst xmlns:a="http://schemas.openxmlformats.org/drawingml/2006/main">
               <a:ext uri="{FF2B5EF4-FFF2-40B4-BE49-F238E27FC236}">
-                <a16:creationId xmlns:a16="http://schemas.microsoft.com/office/drawing/2014/main" id="{424896EA-3497-4DD4-A318-512EE5507489}"/>
+                <a16:creationId xmlns:a16="http://schemas.microsoft.com/office/drawing/2014/main" id="{833835F2-8DCD-47C6-8556-A30DD590D12A}"/>
               </a:ext>
             </a:extLst>
           </p:cNvPr>
@@ -14215,7 +14215,7 @@
           <p:cNvPr id="18" name="footer-label-2">
             <a:extLst xmlns:a="http://schemas.openxmlformats.org/drawingml/2006/main">
               <a:ext uri="{FF2B5EF4-FFF2-40B4-BE49-F238E27FC236}">
-                <a16:creationId xmlns:a16="http://schemas.microsoft.com/office/drawing/2014/main" id="{633D6486-6ED9-43A5-B6C3-1F8E501F096C}"/>
+                <a16:creationId xmlns:a16="http://schemas.microsoft.com/office/drawing/2014/main" id="{9903A14F-15A0-46C9-AC65-FFB6B950F225}"/>
               </a:ext>
             </a:extLst>
           </p:cNvPr>
@@ -14277,7 +14277,7 @@
           <p:cNvPr id="19" name="footer-page-2">
             <a:extLst xmlns:a="http://schemas.openxmlformats.org/drawingml/2006/main">
               <a:ext uri="{FF2B5EF4-FFF2-40B4-BE49-F238E27FC236}">
-                <a16:creationId xmlns:a16="http://schemas.microsoft.com/office/drawing/2014/main" id="{8BCBD3B8-BAAB-4399-8224-2E2C93C39EE0}"/>
+                <a16:creationId xmlns:a16="http://schemas.microsoft.com/office/drawing/2014/main" id="{188A3C2E-6B72-4087-9E60-EF9B9A44FBC7}"/>
               </a:ext>
             </a:extLst>
           </p:cNvPr>
@@ -14337,7 +14337,7 @@
     </p:spTree>
     <p:extLst>
       <p:ext uri="{BB962C8B-B14F-4D97-AF65-F5344CB8AC3E}">
-        <p14:creationId xmlns:p14="http://schemas.microsoft.com/office/powerpoint/2010/main" val="1200389130"/>
+        <p14:creationId xmlns:p14="http://schemas.microsoft.com/office/powerpoint/2010/main" val="1446429918"/>
       </p:ext>
     </p:extLst>
   </p:cSld>
@@ -14368,7 +14368,7 @@
           <p:cNvPr id="31" name="side-accent-3">
             <a:extLst xmlns:a="http://schemas.openxmlformats.org/drawingml/2006/main">
               <a:ext uri="{FF2B5EF4-FFF2-40B4-BE49-F238E27FC236}">
-                <a16:creationId xmlns:a16="http://schemas.microsoft.com/office/drawing/2014/main" id="{22BAE097-C269-47A7-9F60-A06CCCD2497C}"/>
+                <a16:creationId xmlns:a16="http://schemas.microsoft.com/office/drawing/2014/main" id="{C28F4FB7-6C5B-4CB3-B87A-7EFFF04322B8}"/>
               </a:ext>
             </a:extLst>
           </p:cNvPr>
@@ -14399,7 +14399,7 @@
           <p:cNvPr id="2" name="kicker-3">
             <a:extLst xmlns:a="http://schemas.openxmlformats.org/drawingml/2006/main">
               <a:ext uri="{FF2B5EF4-FFF2-40B4-BE49-F238E27FC236}">
-                <a16:creationId xmlns:a16="http://schemas.microsoft.com/office/drawing/2014/main" id="{C844F45D-5178-40AB-866B-0482CFE2AF87}"/>
+                <a16:creationId xmlns:a16="http://schemas.microsoft.com/office/drawing/2014/main" id="{F0A33ECB-4256-4C4A-8B48-98544C3C538D}"/>
               </a:ext>
             </a:extLst>
           </p:cNvPr>
@@ -14461,7 +14461,7 @@
           <p:cNvPr id="3" name="title-3">
             <a:extLst xmlns:a="http://schemas.openxmlformats.org/drawingml/2006/main">
               <a:ext uri="{FF2B5EF4-FFF2-40B4-BE49-F238E27FC236}">
-                <a16:creationId xmlns:a16="http://schemas.microsoft.com/office/drawing/2014/main" id="{FEC98D71-3CF1-4D92-A5B4-9CA1D01CE07E}"/>
+                <a16:creationId xmlns:a16="http://schemas.microsoft.com/office/drawing/2014/main" id="{FA037163-7789-41C0-BA45-622AA315A9A0}"/>
               </a:ext>
             </a:extLst>
           </p:cNvPr>
@@ -14523,7 +14523,7 @@
           <p:cNvPr id="4" name="">
             <a:extLst xmlns:a="http://schemas.openxmlformats.org/drawingml/2006/main">
               <a:ext uri="{FF2B5EF4-FFF2-40B4-BE49-F238E27FC236}">
-                <a16:creationId xmlns:a16="http://schemas.microsoft.com/office/drawing/2014/main" id="{7B8AA832-856B-4F68-A55C-C258BFA38F29}"/>
+                <a16:creationId xmlns:a16="http://schemas.microsoft.com/office/drawing/2014/main" id="{7E73B032-ABD4-46D4-A025-29589C71B37B}"/>
               </a:ext>
             </a:extLst>
           </p:cNvPr>
@@ -14585,7 +14585,7 @@
           <p:cNvPr id="5" name="system-function-line">
             <a:extLst xmlns:a="http://schemas.openxmlformats.org/drawingml/2006/main">
               <a:ext uri="{FF2B5EF4-FFF2-40B4-BE49-F238E27FC236}">
-                <a16:creationId xmlns:a16="http://schemas.microsoft.com/office/drawing/2014/main" id="{C6ABC659-85B8-414B-BE11-5EECBFE0CB62}"/>
+                <a16:creationId xmlns:a16="http://schemas.microsoft.com/office/drawing/2014/main" id="{589A8443-0342-4B09-9A6E-6BCD0C4F698B}"/>
               </a:ext>
             </a:extLst>
           </p:cNvPr>
@@ -14616,7 +14616,7 @@
           <p:cNvPr id="6" name="">
             <a:extLst xmlns:a="http://schemas.openxmlformats.org/drawingml/2006/main">
               <a:ext uri="{FF2B5EF4-FFF2-40B4-BE49-F238E27FC236}">
-                <a16:creationId xmlns:a16="http://schemas.microsoft.com/office/drawing/2014/main" id="{0AFCE43F-FDC8-4872-A139-6EF93F1D7C3D}"/>
+                <a16:creationId xmlns:a16="http://schemas.microsoft.com/office/drawing/2014/main" id="{F0A58E2F-1EB5-46EC-A942-B98F450A9C7C}"/>
               </a:ext>
             </a:extLst>
           </p:cNvPr>
@@ -14647,7 +14647,7 @@
           <p:cNvPr id="7" name="">
             <a:extLst xmlns:a="http://schemas.openxmlformats.org/drawingml/2006/main">
               <a:ext uri="{FF2B5EF4-FFF2-40B4-BE49-F238E27FC236}">
-                <a16:creationId xmlns:a16="http://schemas.microsoft.com/office/drawing/2014/main" id="{25AF1775-612B-4C3F-B1C1-3C3547A2BA41}"/>
+                <a16:creationId xmlns:a16="http://schemas.microsoft.com/office/drawing/2014/main" id="{B209C9CF-AA77-4595-8A5A-A71E511FBBB7}"/>
               </a:ext>
             </a:extLst>
           </p:cNvPr>
@@ -14709,7 +14709,7 @@
           <p:cNvPr id="8" name="">
             <a:extLst xmlns:a="http://schemas.openxmlformats.org/drawingml/2006/main">
               <a:ext uri="{FF2B5EF4-FFF2-40B4-BE49-F238E27FC236}">
-                <a16:creationId xmlns:a16="http://schemas.microsoft.com/office/drawing/2014/main" id="{470E3161-CE35-4AF1-A7AD-4EBBFBDB68BC}"/>
+                <a16:creationId xmlns:a16="http://schemas.microsoft.com/office/drawing/2014/main" id="{4C7A22ED-2F69-49C0-84D0-36E6CBA21A2B}"/>
               </a:ext>
             </a:extLst>
           </p:cNvPr>
@@ -14771,7 +14771,7 @@
           <p:cNvPr id="9" name="">
             <a:extLst xmlns:a="http://schemas.openxmlformats.org/drawingml/2006/main">
               <a:ext uri="{FF2B5EF4-FFF2-40B4-BE49-F238E27FC236}">
-                <a16:creationId xmlns:a16="http://schemas.microsoft.com/office/drawing/2014/main" id="{3B8B0E10-4DC4-4F4C-ADF5-1434D5F17123}"/>
+                <a16:creationId xmlns:a16="http://schemas.microsoft.com/office/drawing/2014/main" id="{9CB0B0E7-498E-4F78-BD19-06168A9D1EF6}"/>
               </a:ext>
             </a:extLst>
           </p:cNvPr>
@@ -14833,7 +14833,7 @@
           <p:cNvPr id="10" name="">
             <a:extLst xmlns:a="http://schemas.openxmlformats.org/drawingml/2006/main">
               <a:ext uri="{FF2B5EF4-FFF2-40B4-BE49-F238E27FC236}">
-                <a16:creationId xmlns:a16="http://schemas.microsoft.com/office/drawing/2014/main" id="{2C832419-1F8B-4C53-9AD9-6CA94C71A97F}"/>
+                <a16:creationId xmlns:a16="http://schemas.microsoft.com/office/drawing/2014/main" id="{02D649BF-2E6E-45CE-B0C0-CE88A991205C}"/>
               </a:ext>
             </a:extLst>
           </p:cNvPr>
@@ -14864,7 +14864,7 @@
           <p:cNvPr id="11" name="">
             <a:extLst xmlns:a="http://schemas.openxmlformats.org/drawingml/2006/main">
               <a:ext uri="{FF2B5EF4-FFF2-40B4-BE49-F238E27FC236}">
-                <a16:creationId xmlns:a16="http://schemas.microsoft.com/office/drawing/2014/main" id="{55323E74-0CEC-405E-A9EE-DF50CC4A0055}"/>
+                <a16:creationId xmlns:a16="http://schemas.microsoft.com/office/drawing/2014/main" id="{01229B28-22E6-487B-A1F3-F6E50BD98A93}"/>
               </a:ext>
             </a:extLst>
           </p:cNvPr>
@@ -14926,7 +14926,7 @@
           <p:cNvPr id="12" name="">
             <a:extLst xmlns:a="http://schemas.openxmlformats.org/drawingml/2006/main">
               <a:ext uri="{FF2B5EF4-FFF2-40B4-BE49-F238E27FC236}">
-                <a16:creationId xmlns:a16="http://schemas.microsoft.com/office/drawing/2014/main" id="{443AE556-194C-4071-8CEB-1588B2684875}"/>
+                <a16:creationId xmlns:a16="http://schemas.microsoft.com/office/drawing/2014/main" id="{EF027C0A-058C-45C6-B133-EFE852E9FCA9}"/>
               </a:ext>
             </a:extLst>
           </p:cNvPr>
@@ -14988,7 +14988,7 @@
           <p:cNvPr id="13" name="">
             <a:extLst xmlns:a="http://schemas.openxmlformats.org/drawingml/2006/main">
               <a:ext uri="{FF2B5EF4-FFF2-40B4-BE49-F238E27FC236}">
-                <a16:creationId xmlns:a16="http://schemas.microsoft.com/office/drawing/2014/main" id="{1239C092-B6C8-4EF7-AD6C-87823CF76CF1}"/>
+                <a16:creationId xmlns:a16="http://schemas.microsoft.com/office/drawing/2014/main" id="{A3E228EB-2C83-422D-BB60-347A3FAE1108}"/>
               </a:ext>
             </a:extLst>
           </p:cNvPr>
@@ -15050,7 +15050,7 @@
           <p:cNvPr id="14" name="">
             <a:extLst xmlns:a="http://schemas.openxmlformats.org/drawingml/2006/main">
               <a:ext uri="{FF2B5EF4-FFF2-40B4-BE49-F238E27FC236}">
-                <a16:creationId xmlns:a16="http://schemas.microsoft.com/office/drawing/2014/main" id="{745E5DA6-9DF6-4340-8376-53293721F4AF}"/>
+                <a16:creationId xmlns:a16="http://schemas.microsoft.com/office/drawing/2014/main" id="{4E185A21-752F-400E-817E-0801201E2BE0}"/>
               </a:ext>
             </a:extLst>
           </p:cNvPr>
@@ -15081,7 +15081,7 @@
           <p:cNvPr id="15" name="">
             <a:extLst xmlns:a="http://schemas.openxmlformats.org/drawingml/2006/main">
               <a:ext uri="{FF2B5EF4-FFF2-40B4-BE49-F238E27FC236}">
-                <a16:creationId xmlns:a16="http://schemas.microsoft.com/office/drawing/2014/main" id="{85D98DFF-C831-4B05-935F-22AD7F42FFEF}"/>
+                <a16:creationId xmlns:a16="http://schemas.microsoft.com/office/drawing/2014/main" id="{76C02AE3-23B3-4C99-AF6F-0852191DBDB6}"/>
               </a:ext>
             </a:extLst>
           </p:cNvPr>
@@ -15143,7 +15143,7 @@
           <p:cNvPr id="16" name="">
             <a:extLst xmlns:a="http://schemas.openxmlformats.org/drawingml/2006/main">
               <a:ext uri="{FF2B5EF4-FFF2-40B4-BE49-F238E27FC236}">
-                <a16:creationId xmlns:a16="http://schemas.microsoft.com/office/drawing/2014/main" id="{E42972C2-1076-4F69-981A-ABAC8E82B529}"/>
+                <a16:creationId xmlns:a16="http://schemas.microsoft.com/office/drawing/2014/main" id="{CD82EF4E-6298-4DE4-81B1-CDA3906DC5BF}"/>
               </a:ext>
             </a:extLst>
           </p:cNvPr>
@@ -15205,7 +15205,7 @@
           <p:cNvPr id="17" name="">
             <a:extLst xmlns:a="http://schemas.openxmlformats.org/drawingml/2006/main">
               <a:ext uri="{FF2B5EF4-FFF2-40B4-BE49-F238E27FC236}">
-                <a16:creationId xmlns:a16="http://schemas.microsoft.com/office/drawing/2014/main" id="{398D745C-55B6-4867-B112-436D590993FB}"/>
+                <a16:creationId xmlns:a16="http://schemas.microsoft.com/office/drawing/2014/main" id="{6F3CDCB2-2AA2-4B70-B158-FD9ED2760FA6}"/>
               </a:ext>
             </a:extLst>
           </p:cNvPr>
@@ -15267,7 +15267,7 @@
           <p:cNvPr id="18" name="">
             <a:extLst xmlns:a="http://schemas.openxmlformats.org/drawingml/2006/main">
               <a:ext uri="{FF2B5EF4-FFF2-40B4-BE49-F238E27FC236}">
-                <a16:creationId xmlns:a16="http://schemas.microsoft.com/office/drawing/2014/main" id="{D2E50C16-A77F-4D10-B7ED-D11BA4AB7BD0}"/>
+                <a16:creationId xmlns:a16="http://schemas.microsoft.com/office/drawing/2014/main" id="{244A158B-36A2-4D90-802D-6C7D6DE793FD}"/>
               </a:ext>
             </a:extLst>
           </p:cNvPr>
@@ -15298,7 +15298,7 @@
           <p:cNvPr id="19" name="">
             <a:extLst xmlns:a="http://schemas.openxmlformats.org/drawingml/2006/main">
               <a:ext uri="{FF2B5EF4-FFF2-40B4-BE49-F238E27FC236}">
-                <a16:creationId xmlns:a16="http://schemas.microsoft.com/office/drawing/2014/main" id="{7C8EF5D8-0A08-4D6D-9A3D-4136433124D0}"/>
+                <a16:creationId xmlns:a16="http://schemas.microsoft.com/office/drawing/2014/main" id="{D2BDFD73-5A22-45EE-BCBE-1DDA5138EE63}"/>
               </a:ext>
             </a:extLst>
           </p:cNvPr>
@@ -15360,7 +15360,7 @@
           <p:cNvPr id="20" name="">
             <a:extLst xmlns:a="http://schemas.openxmlformats.org/drawingml/2006/main">
               <a:ext uri="{FF2B5EF4-FFF2-40B4-BE49-F238E27FC236}">
-                <a16:creationId xmlns:a16="http://schemas.microsoft.com/office/drawing/2014/main" id="{985A8F9A-E28D-4DAF-8C8C-00D528329833}"/>
+                <a16:creationId xmlns:a16="http://schemas.microsoft.com/office/drawing/2014/main" id="{DF44447A-B49B-479B-8D00-CB11F6221031}"/>
               </a:ext>
             </a:extLst>
           </p:cNvPr>
@@ -15422,7 +15422,7 @@
           <p:cNvPr id="21" name="">
             <a:extLst xmlns:a="http://schemas.openxmlformats.org/drawingml/2006/main">
               <a:ext uri="{FF2B5EF4-FFF2-40B4-BE49-F238E27FC236}">
-                <a16:creationId xmlns:a16="http://schemas.microsoft.com/office/drawing/2014/main" id="{85554718-285F-40AA-A005-CCADCC363829}"/>
+                <a16:creationId xmlns:a16="http://schemas.microsoft.com/office/drawing/2014/main" id="{5367613C-FD9D-4584-A2EA-C435F724C677}"/>
               </a:ext>
             </a:extLst>
           </p:cNvPr>
@@ -15484,7 +15484,7 @@
           <p:cNvPr id="22" name="">
             <a:extLst xmlns:a="http://schemas.openxmlformats.org/drawingml/2006/main">
               <a:ext uri="{FF2B5EF4-FFF2-40B4-BE49-F238E27FC236}">
-                <a16:creationId xmlns:a16="http://schemas.microsoft.com/office/drawing/2014/main" id="{65A37460-B057-4B56-9652-987FE854EDBF}"/>
+                <a16:creationId xmlns:a16="http://schemas.microsoft.com/office/drawing/2014/main" id="{50DC856B-00B3-43B5-AAD5-B834BB9E613F}"/>
               </a:ext>
             </a:extLst>
           </p:cNvPr>
@@ -15515,7 +15515,7 @@
           <p:cNvPr id="23" name="">
             <a:extLst xmlns:a="http://schemas.openxmlformats.org/drawingml/2006/main">
               <a:ext uri="{FF2B5EF4-FFF2-40B4-BE49-F238E27FC236}">
-                <a16:creationId xmlns:a16="http://schemas.microsoft.com/office/drawing/2014/main" id="{44BED3B2-E4C2-4121-BCF1-D582A17B3E6B}"/>
+                <a16:creationId xmlns:a16="http://schemas.microsoft.com/office/drawing/2014/main" id="{88DAE5F6-7D1B-4077-82F7-8E423A2EC8DB}"/>
               </a:ext>
             </a:extLst>
           </p:cNvPr>
@@ -15577,7 +15577,7 @@
           <p:cNvPr id="24" name="">
             <a:extLst xmlns:a="http://schemas.openxmlformats.org/drawingml/2006/main">
               <a:ext uri="{FF2B5EF4-FFF2-40B4-BE49-F238E27FC236}">
-                <a16:creationId xmlns:a16="http://schemas.microsoft.com/office/drawing/2014/main" id="{FB828CA7-6860-4B58-92E3-D9675B36E7A7}"/>
+                <a16:creationId xmlns:a16="http://schemas.microsoft.com/office/drawing/2014/main" id="{D4D1A30B-9944-4375-9142-837C94E125AC}"/>
               </a:ext>
             </a:extLst>
           </p:cNvPr>
@@ -15639,7 +15639,7 @@
           <p:cNvPr id="25" name="">
             <a:extLst xmlns:a="http://schemas.openxmlformats.org/drawingml/2006/main">
               <a:ext uri="{FF2B5EF4-FFF2-40B4-BE49-F238E27FC236}">
-                <a16:creationId xmlns:a16="http://schemas.microsoft.com/office/drawing/2014/main" id="{52AA6C54-4961-49C4-B439-708052FDB408}"/>
+                <a16:creationId xmlns:a16="http://schemas.microsoft.com/office/drawing/2014/main" id="{34F732CE-F7D7-48A8-8758-E845D2289053}"/>
               </a:ext>
             </a:extLst>
           </p:cNvPr>
@@ -15701,7 +15701,7 @@
           <p:cNvPr id="26" name="">
             <a:extLst xmlns:a="http://schemas.openxmlformats.org/drawingml/2006/main">
               <a:ext uri="{FF2B5EF4-FFF2-40B4-BE49-F238E27FC236}">
-                <a16:creationId xmlns:a16="http://schemas.microsoft.com/office/drawing/2014/main" id="{F1D17D18-602A-4EDB-8BC5-80FC578E6D09}"/>
+                <a16:creationId xmlns:a16="http://schemas.microsoft.com/office/drawing/2014/main" id="{6CD44FE0-B735-4DF5-8B53-04C9FE5480D7}"/>
               </a:ext>
             </a:extLst>
           </p:cNvPr>
@@ -15734,7 +15734,7 @@
           <p:cNvPr id="27" name="">
             <a:extLst xmlns:a="http://schemas.openxmlformats.org/drawingml/2006/main">
               <a:ext uri="{FF2B5EF4-FFF2-40B4-BE49-F238E27FC236}">
-                <a16:creationId xmlns:a16="http://schemas.microsoft.com/office/drawing/2014/main" id="{A62249A3-029B-42B7-942B-4551B1FA1AAA}"/>
+                <a16:creationId xmlns:a16="http://schemas.microsoft.com/office/drawing/2014/main" id="{454F54E2-8B0C-4B24-BC3A-48A0D35154D8}"/>
               </a:ext>
             </a:extLst>
           </p:cNvPr>
@@ -15796,7 +15796,7 @@
           <p:cNvPr id="28" name="footer-rule-3">
             <a:extLst xmlns:a="http://schemas.openxmlformats.org/drawingml/2006/main">
               <a:ext uri="{FF2B5EF4-FFF2-40B4-BE49-F238E27FC236}">
-                <a16:creationId xmlns:a16="http://schemas.microsoft.com/office/drawing/2014/main" id="{8121DEDD-37DA-4899-8DF7-7A4C382B642C}"/>
+                <a16:creationId xmlns:a16="http://schemas.microsoft.com/office/drawing/2014/main" id="{95C64ADE-7F9F-4067-B054-B225F06CD141}"/>
               </a:ext>
             </a:extLst>
           </p:cNvPr>
@@ -15827,7 +15827,7 @@
           <p:cNvPr id="29" name="footer-label-3">
             <a:extLst xmlns:a="http://schemas.openxmlformats.org/drawingml/2006/main">
               <a:ext uri="{FF2B5EF4-FFF2-40B4-BE49-F238E27FC236}">
-                <a16:creationId xmlns:a16="http://schemas.microsoft.com/office/drawing/2014/main" id="{AA8EF157-7CB0-4B61-A3A7-DC5E372F2937}"/>
+                <a16:creationId xmlns:a16="http://schemas.microsoft.com/office/drawing/2014/main" id="{7EBDFD8E-90F6-4F85-ABE9-D76F2FACC5AC}"/>
               </a:ext>
             </a:extLst>
           </p:cNvPr>
@@ -15889,7 +15889,7 @@
           <p:cNvPr id="30" name="footer-page-3">
             <a:extLst xmlns:a="http://schemas.openxmlformats.org/drawingml/2006/main">
               <a:ext uri="{FF2B5EF4-FFF2-40B4-BE49-F238E27FC236}">
-                <a16:creationId xmlns:a16="http://schemas.microsoft.com/office/drawing/2014/main" id="{0F66195C-3EDE-4F12-8417-A7CD5BDB6659}"/>
+                <a16:creationId xmlns:a16="http://schemas.microsoft.com/office/drawing/2014/main" id="{9EA898FC-7931-45EB-98F4-E78259AB7A11}"/>
               </a:ext>
             </a:extLst>
           </p:cNvPr>
@@ -15949,7 +15949,7 @@
     </p:spTree>
     <p:extLst>
       <p:ext uri="{BB962C8B-B14F-4D97-AF65-F5344CB8AC3E}">
-        <p14:creationId xmlns:p14="http://schemas.microsoft.com/office/powerpoint/2010/main" val="846518144"/>
+        <p14:creationId xmlns:p14="http://schemas.microsoft.com/office/powerpoint/2010/main" val="1211672452"/>
       </p:ext>
     </p:extLst>
   </p:cSld>
@@ -15980,7 +15980,7 @@
           <p:cNvPr id="28" name="side-accent-4">
             <a:extLst xmlns:a="http://schemas.openxmlformats.org/drawingml/2006/main">
               <a:ext uri="{FF2B5EF4-FFF2-40B4-BE49-F238E27FC236}">
-                <a16:creationId xmlns:a16="http://schemas.microsoft.com/office/drawing/2014/main" id="{71B96F99-D5A7-437C-8E67-C7F4B6740266}"/>
+                <a16:creationId xmlns:a16="http://schemas.microsoft.com/office/drawing/2014/main" id="{61CA69C0-D33E-4521-89F3-11AF1CEF7C59}"/>
               </a:ext>
             </a:extLst>
           </p:cNvPr>
@@ -16011,7 +16011,7 @@
           <p:cNvPr id="2" name="kicker-4">
             <a:extLst xmlns:a="http://schemas.openxmlformats.org/drawingml/2006/main">
               <a:ext uri="{FF2B5EF4-FFF2-40B4-BE49-F238E27FC236}">
-                <a16:creationId xmlns:a16="http://schemas.microsoft.com/office/drawing/2014/main" id="{2F8EDD19-3930-40B1-83EB-3E6F7090F5A2}"/>
+                <a16:creationId xmlns:a16="http://schemas.microsoft.com/office/drawing/2014/main" id="{EB206954-A7F8-4445-845D-3159E5DACC95}"/>
               </a:ext>
             </a:extLst>
           </p:cNvPr>
@@ -16073,7 +16073,7 @@
           <p:cNvPr id="3" name="title-4">
             <a:extLst xmlns:a="http://schemas.openxmlformats.org/drawingml/2006/main">
               <a:ext uri="{FF2B5EF4-FFF2-40B4-BE49-F238E27FC236}">
-                <a16:creationId xmlns:a16="http://schemas.microsoft.com/office/drawing/2014/main" id="{6A74F638-640F-46FF-B3B0-EF440046DB8A}"/>
+                <a16:creationId xmlns:a16="http://schemas.microsoft.com/office/drawing/2014/main" id="{077A81A6-402B-42B2-8648-0D8DC64D37C4}"/>
               </a:ext>
             </a:extLst>
           </p:cNvPr>
@@ -16135,7 +16135,7 @@
           <p:cNvPr id="4" name="">
             <a:extLst xmlns:a="http://schemas.openxmlformats.org/drawingml/2006/main">
               <a:ext uri="{FF2B5EF4-FFF2-40B4-BE49-F238E27FC236}">
-                <a16:creationId xmlns:a16="http://schemas.microsoft.com/office/drawing/2014/main" id="{FFD0238C-85EA-4DE6-81AC-9E17B058CDEC}"/>
+                <a16:creationId xmlns:a16="http://schemas.microsoft.com/office/drawing/2014/main" id="{986EBCC6-452D-43BC-9D64-9AC6E4B09969}"/>
               </a:ext>
             </a:extLst>
           </p:cNvPr>
@@ -16197,7 +16197,7 @@
           <p:cNvPr id="5" name="">
             <a:extLst xmlns:a="http://schemas.openxmlformats.org/drawingml/2006/main">
               <a:ext uri="{FF2B5EF4-FFF2-40B4-BE49-F238E27FC236}">
-                <a16:creationId xmlns:a16="http://schemas.microsoft.com/office/drawing/2014/main" id="{70B6E0A1-6A6D-4913-A32F-3CABCA0D9641}"/>
+                <a16:creationId xmlns:a16="http://schemas.microsoft.com/office/drawing/2014/main" id="{81384945-506F-4EA6-B89B-B8C36B1575BD}"/>
               </a:ext>
             </a:extLst>
           </p:cNvPr>
@@ -16259,7 +16259,7 @@
           <p:cNvPr id="6" name="">
             <a:extLst xmlns:a="http://schemas.openxmlformats.org/drawingml/2006/main">
               <a:ext uri="{FF2B5EF4-FFF2-40B4-BE49-F238E27FC236}">
-                <a16:creationId xmlns:a16="http://schemas.microsoft.com/office/drawing/2014/main" id="{56D2E5C5-E971-42C6-9977-A3E312822B0D}"/>
+                <a16:creationId xmlns:a16="http://schemas.microsoft.com/office/drawing/2014/main" id="{731EBE54-7D5D-45EC-9271-1722B6D75CCC}"/>
               </a:ext>
             </a:extLst>
           </p:cNvPr>
@@ -16321,7 +16321,7 @@
           <p:cNvPr id="7" name="">
             <a:extLst xmlns:a="http://schemas.openxmlformats.org/drawingml/2006/main">
               <a:ext uri="{FF2B5EF4-FFF2-40B4-BE49-F238E27FC236}">
-                <a16:creationId xmlns:a16="http://schemas.microsoft.com/office/drawing/2014/main" id="{F3E103D8-A775-43C5-9019-43CF0246277B}"/>
+                <a16:creationId xmlns:a16="http://schemas.microsoft.com/office/drawing/2014/main" id="{783A3039-932D-405C-8BF3-D23D0144E75D}"/>
               </a:ext>
             </a:extLst>
           </p:cNvPr>
@@ -16352,7 +16352,7 @@
           <p:cNvPr id="8" name="">
             <a:extLst xmlns:a="http://schemas.openxmlformats.org/drawingml/2006/main">
               <a:ext uri="{FF2B5EF4-FFF2-40B4-BE49-F238E27FC236}">
-                <a16:creationId xmlns:a16="http://schemas.microsoft.com/office/drawing/2014/main" id="{24E3F37A-8348-4F35-9FF0-011C8C6C8680}"/>
+                <a16:creationId xmlns:a16="http://schemas.microsoft.com/office/drawing/2014/main" id="{F622AD5D-B5F5-40D0-AEB8-6AD5DBAA041D}"/>
               </a:ext>
             </a:extLst>
           </p:cNvPr>
@@ -16414,7 +16414,7 @@
           <p:cNvPr id="9" name="">
             <a:extLst xmlns:a="http://schemas.openxmlformats.org/drawingml/2006/main">
               <a:ext uri="{FF2B5EF4-FFF2-40B4-BE49-F238E27FC236}">
-                <a16:creationId xmlns:a16="http://schemas.microsoft.com/office/drawing/2014/main" id="{8C182E28-1267-49EC-9987-5FC140373DDC}"/>
+                <a16:creationId xmlns:a16="http://schemas.microsoft.com/office/drawing/2014/main" id="{D796ADCF-7C9E-43B0-B35B-8C0CD66AB799}"/>
               </a:ext>
             </a:extLst>
           </p:cNvPr>
@@ -16476,7 +16476,7 @@
           <p:cNvPr id="10" name="">
             <a:extLst xmlns:a="http://schemas.openxmlformats.org/drawingml/2006/main">
               <a:ext uri="{FF2B5EF4-FFF2-40B4-BE49-F238E27FC236}">
-                <a16:creationId xmlns:a16="http://schemas.microsoft.com/office/drawing/2014/main" id="{6B23364B-A8C0-400C-A21E-DDDB7AEC0EFA}"/>
+                <a16:creationId xmlns:a16="http://schemas.microsoft.com/office/drawing/2014/main" id="{22E73E5F-B158-406C-8B01-088C44CCD516}"/>
               </a:ext>
             </a:extLst>
           </p:cNvPr>
@@ -16538,7 +16538,7 @@
           <p:cNvPr id="11" name="">
             <a:extLst xmlns:a="http://schemas.openxmlformats.org/drawingml/2006/main">
               <a:ext uri="{FF2B5EF4-FFF2-40B4-BE49-F238E27FC236}">
-                <a16:creationId xmlns:a16="http://schemas.microsoft.com/office/drawing/2014/main" id="{C106976C-4846-431E-80A6-7717501F02F3}"/>
+                <a16:creationId xmlns:a16="http://schemas.microsoft.com/office/drawing/2014/main" id="{776C2010-9794-43E1-BF8B-03C061A719E9}"/>
               </a:ext>
             </a:extLst>
           </p:cNvPr>
@@ -16569,7 +16569,7 @@
           <p:cNvPr id="12" name="">
             <a:extLst xmlns:a="http://schemas.openxmlformats.org/drawingml/2006/main">
               <a:ext uri="{FF2B5EF4-FFF2-40B4-BE49-F238E27FC236}">
-                <a16:creationId xmlns:a16="http://schemas.microsoft.com/office/drawing/2014/main" id="{9137EA5F-D45F-4830-BD4B-E942EC3F1A6D}"/>
+                <a16:creationId xmlns:a16="http://schemas.microsoft.com/office/drawing/2014/main" id="{21CA8931-C41D-49AF-8038-FC5465330143}"/>
               </a:ext>
             </a:extLst>
           </p:cNvPr>
@@ -16631,7 +16631,7 @@
           <p:cNvPr id="13" name="">
             <a:extLst xmlns:a="http://schemas.openxmlformats.org/drawingml/2006/main">
               <a:ext uri="{FF2B5EF4-FFF2-40B4-BE49-F238E27FC236}">
-                <a16:creationId xmlns:a16="http://schemas.microsoft.com/office/drawing/2014/main" id="{4852D322-1F2A-47F4-9B53-6BC022449C2F}"/>
+                <a16:creationId xmlns:a16="http://schemas.microsoft.com/office/drawing/2014/main" id="{1F967A09-CBD4-4366-9F44-69F8E20CE52E}"/>
               </a:ext>
             </a:extLst>
           </p:cNvPr>
@@ -16693,7 +16693,7 @@
           <p:cNvPr id="14" name="">
             <a:extLst xmlns:a="http://schemas.openxmlformats.org/drawingml/2006/main">
               <a:ext uri="{FF2B5EF4-FFF2-40B4-BE49-F238E27FC236}">
-                <a16:creationId xmlns:a16="http://schemas.microsoft.com/office/drawing/2014/main" id="{63A2DF91-B350-4F71-9CCE-9BACFB6E41A0}"/>
+                <a16:creationId xmlns:a16="http://schemas.microsoft.com/office/drawing/2014/main" id="{988D74A9-085C-4B35-8085-F1B67ECE1F75}"/>
               </a:ext>
             </a:extLst>
           </p:cNvPr>
@@ -16755,7 +16755,7 @@
           <p:cNvPr id="15" name="">
             <a:extLst xmlns:a="http://schemas.openxmlformats.org/drawingml/2006/main">
               <a:ext uri="{FF2B5EF4-FFF2-40B4-BE49-F238E27FC236}">
-                <a16:creationId xmlns:a16="http://schemas.microsoft.com/office/drawing/2014/main" id="{1DA0EA04-4D1D-4DA4-B3AF-EB3EF06921DE}"/>
+                <a16:creationId xmlns:a16="http://schemas.microsoft.com/office/drawing/2014/main" id="{0EAF2681-B484-4657-8433-69C03A765CA0}"/>
               </a:ext>
             </a:extLst>
           </p:cNvPr>
@@ -16786,7 +16786,7 @@
           <p:cNvPr id="16" name="">
             <a:extLst xmlns:a="http://schemas.openxmlformats.org/drawingml/2006/main">
               <a:ext uri="{FF2B5EF4-FFF2-40B4-BE49-F238E27FC236}">
-                <a16:creationId xmlns:a16="http://schemas.microsoft.com/office/drawing/2014/main" id="{18F9A1D9-71DB-47A2-96C8-6329DE872DE6}"/>
+                <a16:creationId xmlns:a16="http://schemas.microsoft.com/office/drawing/2014/main" id="{8CC9D8CB-821C-41D8-A932-06FD9C61ED87}"/>
               </a:ext>
             </a:extLst>
           </p:cNvPr>
@@ -16848,7 +16848,7 @@
           <p:cNvPr id="17" name="">
             <a:extLst xmlns:a="http://schemas.openxmlformats.org/drawingml/2006/main">
               <a:ext uri="{FF2B5EF4-FFF2-40B4-BE49-F238E27FC236}">
-                <a16:creationId xmlns:a16="http://schemas.microsoft.com/office/drawing/2014/main" id="{62FC706E-09A6-429D-A97D-8EE4CF785A8A}"/>
+                <a16:creationId xmlns:a16="http://schemas.microsoft.com/office/drawing/2014/main" id="{F66F69A1-1603-4902-9BA1-1AF63C94157E}"/>
               </a:ext>
             </a:extLst>
           </p:cNvPr>
@@ -16910,7 +16910,7 @@
           <p:cNvPr id="18" name="">
             <a:extLst xmlns:a="http://schemas.openxmlformats.org/drawingml/2006/main">
               <a:ext uri="{FF2B5EF4-FFF2-40B4-BE49-F238E27FC236}">
-                <a16:creationId xmlns:a16="http://schemas.microsoft.com/office/drawing/2014/main" id="{D14E1CDD-A2DE-4DD9-866B-FB9670C1E5F0}"/>
+                <a16:creationId xmlns:a16="http://schemas.microsoft.com/office/drawing/2014/main" id="{116DA24B-E8E7-4509-AF25-6A7DDAB9FCDB}"/>
               </a:ext>
             </a:extLst>
           </p:cNvPr>
@@ -16972,7 +16972,7 @@
           <p:cNvPr id="19" name="">
             <a:extLst xmlns:a="http://schemas.openxmlformats.org/drawingml/2006/main">
               <a:ext uri="{FF2B5EF4-FFF2-40B4-BE49-F238E27FC236}">
-                <a16:creationId xmlns:a16="http://schemas.microsoft.com/office/drawing/2014/main" id="{24A9511E-D619-4EE7-860F-16605EE35815}"/>
+                <a16:creationId xmlns:a16="http://schemas.microsoft.com/office/drawing/2014/main" id="{7038A9A0-6A98-43C0-9202-30BE5D19BA27}"/>
               </a:ext>
             </a:extLst>
           </p:cNvPr>
@@ -17003,7 +17003,7 @@
           <p:cNvPr id="20" name="">
             <a:extLst xmlns:a="http://schemas.openxmlformats.org/drawingml/2006/main">
               <a:ext uri="{FF2B5EF4-FFF2-40B4-BE49-F238E27FC236}">
-                <a16:creationId xmlns:a16="http://schemas.microsoft.com/office/drawing/2014/main" id="{37579ADB-16B1-4EB0-8F7C-5050B803B412}"/>
+                <a16:creationId xmlns:a16="http://schemas.microsoft.com/office/drawing/2014/main" id="{4F07EFFF-C1C8-4CCD-AA9D-908E201550A7}"/>
               </a:ext>
             </a:extLst>
           </p:cNvPr>
@@ -17065,7 +17065,7 @@
           <p:cNvPr id="21" name="">
             <a:extLst xmlns:a="http://schemas.openxmlformats.org/drawingml/2006/main">
               <a:ext uri="{FF2B5EF4-FFF2-40B4-BE49-F238E27FC236}">
-                <a16:creationId xmlns:a16="http://schemas.microsoft.com/office/drawing/2014/main" id="{B7F84FC3-C639-4D7A-A82B-998C0E7012D2}"/>
+                <a16:creationId xmlns:a16="http://schemas.microsoft.com/office/drawing/2014/main" id="{FBC70AA0-C162-49FA-B8E5-85BAB8F38E87}"/>
               </a:ext>
             </a:extLst>
           </p:cNvPr>
@@ -17127,7 +17127,7 @@
           <p:cNvPr id="22" name="">
             <a:extLst xmlns:a="http://schemas.openxmlformats.org/drawingml/2006/main">
               <a:ext uri="{FF2B5EF4-FFF2-40B4-BE49-F238E27FC236}">
-                <a16:creationId xmlns:a16="http://schemas.microsoft.com/office/drawing/2014/main" id="{DF1FFDB0-8BBC-44D2-820A-FF0B6CD65DFC}"/>
+                <a16:creationId xmlns:a16="http://schemas.microsoft.com/office/drawing/2014/main" id="{98F091C5-A773-43B1-8DEF-120D32A2C6F5}"/>
               </a:ext>
             </a:extLst>
           </p:cNvPr>
@@ -17189,7 +17189,7 @@
           <p:cNvPr id="23" name="">
             <a:extLst xmlns:a="http://schemas.openxmlformats.org/drawingml/2006/main">
               <a:ext uri="{FF2B5EF4-FFF2-40B4-BE49-F238E27FC236}">
-                <a16:creationId xmlns:a16="http://schemas.microsoft.com/office/drawing/2014/main" id="{CC335B0B-C451-4635-BC4F-2531AADD469A}"/>
+                <a16:creationId xmlns:a16="http://schemas.microsoft.com/office/drawing/2014/main" id="{C328B28E-660D-4683-9364-FCBEC9924548}"/>
               </a:ext>
             </a:extLst>
           </p:cNvPr>
@@ -17222,7 +17222,7 @@
           <p:cNvPr id="24" name="">
             <a:extLst xmlns:a="http://schemas.openxmlformats.org/drawingml/2006/main">
               <a:ext uri="{FF2B5EF4-FFF2-40B4-BE49-F238E27FC236}">
-                <a16:creationId xmlns:a16="http://schemas.microsoft.com/office/drawing/2014/main" id="{6B510C19-4540-4E06-A7F2-A3E8F520D02F}"/>
+                <a16:creationId xmlns:a16="http://schemas.microsoft.com/office/drawing/2014/main" id="{741FC515-BB0C-4ACC-8761-14F6C54BD4A9}"/>
               </a:ext>
             </a:extLst>
           </p:cNvPr>
@@ -17284,7 +17284,7 @@
           <p:cNvPr id="25" name="footer-rule-4">
             <a:extLst xmlns:a="http://schemas.openxmlformats.org/drawingml/2006/main">
               <a:ext uri="{FF2B5EF4-FFF2-40B4-BE49-F238E27FC236}">
-                <a16:creationId xmlns:a16="http://schemas.microsoft.com/office/drawing/2014/main" id="{724D14E2-34E4-40B3-88DC-C16EEBBD98E6}"/>
+                <a16:creationId xmlns:a16="http://schemas.microsoft.com/office/drawing/2014/main" id="{784CA9E9-BF73-4B4A-A1FF-C69B00066AE9}"/>
               </a:ext>
             </a:extLst>
           </p:cNvPr>
@@ -17315,7 +17315,7 @@
           <p:cNvPr id="26" name="footer-label-4">
             <a:extLst xmlns:a="http://schemas.openxmlformats.org/drawingml/2006/main">
               <a:ext uri="{FF2B5EF4-FFF2-40B4-BE49-F238E27FC236}">
-                <a16:creationId xmlns:a16="http://schemas.microsoft.com/office/drawing/2014/main" id="{5ECA35FA-FEFD-479F-9CBB-35D93885BD11}"/>
+                <a16:creationId xmlns:a16="http://schemas.microsoft.com/office/drawing/2014/main" id="{63F00E68-0E9E-48CD-A7C9-2FD83CE85E38}"/>
               </a:ext>
             </a:extLst>
           </p:cNvPr>
@@ -17377,7 +17377,7 @@
           <p:cNvPr id="27" name="footer-page-4">
             <a:extLst xmlns:a="http://schemas.openxmlformats.org/drawingml/2006/main">
               <a:ext uri="{FF2B5EF4-FFF2-40B4-BE49-F238E27FC236}">
-                <a16:creationId xmlns:a16="http://schemas.microsoft.com/office/drawing/2014/main" id="{093EA907-9A1D-4056-8E59-9008DB2B2F12}"/>
+                <a16:creationId xmlns:a16="http://schemas.microsoft.com/office/drawing/2014/main" id="{1CB80ABB-F579-4A47-B55F-42CC878E1B1D}"/>
               </a:ext>
             </a:extLst>
           </p:cNvPr>
@@ -17437,7 +17437,7 @@
     </p:spTree>
     <p:extLst>
       <p:ext uri="{BB962C8B-B14F-4D97-AF65-F5344CB8AC3E}">
-        <p14:creationId xmlns:p14="http://schemas.microsoft.com/office/powerpoint/2010/main" val="954556313"/>
+        <p14:creationId xmlns:p14="http://schemas.microsoft.com/office/powerpoint/2010/main" val="2000432337"/>
       </p:ext>
     </p:extLst>
   </p:cSld>
@@ -17468,7 +17468,7 @@
           <p:cNvPr id="31" name="side-accent-5">
             <a:extLst xmlns:a="http://schemas.openxmlformats.org/drawingml/2006/main">
               <a:ext uri="{FF2B5EF4-FFF2-40B4-BE49-F238E27FC236}">
-                <a16:creationId xmlns:a16="http://schemas.microsoft.com/office/drawing/2014/main" id="{511A7AC0-45B7-4EB2-ACEC-6757DDDC5C28}"/>
+                <a16:creationId xmlns:a16="http://schemas.microsoft.com/office/drawing/2014/main" id="{1B96C5C7-A5A2-4999-842C-F41406D5AAE9}"/>
               </a:ext>
             </a:extLst>
           </p:cNvPr>
@@ -17499,7 +17499,7 @@
           <p:cNvPr id="2" name="kicker-5">
             <a:extLst xmlns:a="http://schemas.openxmlformats.org/drawingml/2006/main">
               <a:ext uri="{FF2B5EF4-FFF2-40B4-BE49-F238E27FC236}">
-                <a16:creationId xmlns:a16="http://schemas.microsoft.com/office/drawing/2014/main" id="{0E8A9A36-4D62-4E08-A340-5A4F53489466}"/>
+                <a16:creationId xmlns:a16="http://schemas.microsoft.com/office/drawing/2014/main" id="{6469B4A0-DC58-4D47-81D4-BA0AF48B4055}"/>
               </a:ext>
             </a:extLst>
           </p:cNvPr>
@@ -17561,7 +17561,7 @@
           <p:cNvPr id="3" name="title-5">
             <a:extLst xmlns:a="http://schemas.openxmlformats.org/drawingml/2006/main">
               <a:ext uri="{FF2B5EF4-FFF2-40B4-BE49-F238E27FC236}">
-                <a16:creationId xmlns:a16="http://schemas.microsoft.com/office/drawing/2014/main" id="{F5B2890E-622F-4B96-B429-0C9F4040236A}"/>
+                <a16:creationId xmlns:a16="http://schemas.microsoft.com/office/drawing/2014/main" id="{26F151D8-237B-43F7-9FDD-EBEF45332821}"/>
               </a:ext>
             </a:extLst>
           </p:cNvPr>
@@ -17623,7 +17623,7 @@
           <p:cNvPr id="4" name="">
             <a:extLst xmlns:a="http://schemas.openxmlformats.org/drawingml/2006/main">
               <a:ext uri="{FF2B5EF4-FFF2-40B4-BE49-F238E27FC236}">
-                <a16:creationId xmlns:a16="http://schemas.microsoft.com/office/drawing/2014/main" id="{C2A84E6A-EB4D-47A9-82F4-CB49041E16ED}"/>
+                <a16:creationId xmlns:a16="http://schemas.microsoft.com/office/drawing/2014/main" id="{72F8F9B6-3A47-4521-9EED-4B7111F080FE}"/>
               </a:ext>
             </a:extLst>
           </p:cNvPr>
@@ -17685,7 +17685,7 @@
           <p:cNvPr id="5" name="workflow-line">
             <a:extLst xmlns:a="http://schemas.openxmlformats.org/drawingml/2006/main">
               <a:ext uri="{FF2B5EF4-FFF2-40B4-BE49-F238E27FC236}">
-                <a16:creationId xmlns:a16="http://schemas.microsoft.com/office/drawing/2014/main" id="{7A8D3CA6-6EFA-49B2-AEB8-515861F33B55}"/>
+                <a16:creationId xmlns:a16="http://schemas.microsoft.com/office/drawing/2014/main" id="{D37B5096-8AC5-49EC-B77A-72A4871B9C64}"/>
               </a:ext>
             </a:extLst>
           </p:cNvPr>
@@ -17716,7 +17716,7 @@
           <p:cNvPr id="6" name="workflow-arrow">
             <a:extLst xmlns:a="http://schemas.openxmlformats.org/drawingml/2006/main">
               <a:ext uri="{FF2B5EF4-FFF2-40B4-BE49-F238E27FC236}">
-                <a16:creationId xmlns:a16="http://schemas.microsoft.com/office/drawing/2014/main" id="{E631874B-B7C2-404C-B3CB-ECB83BFBE129}"/>
+                <a16:creationId xmlns:a16="http://schemas.microsoft.com/office/drawing/2014/main" id="{AC21DA29-3E44-4902-AFFE-C0B2B97EA893}"/>
               </a:ext>
             </a:extLst>
           </p:cNvPr>
@@ -17747,7 +17747,7 @@
           <p:cNvPr id="7" name="">
             <a:extLst xmlns:a="http://schemas.openxmlformats.org/drawingml/2006/main">
               <a:ext uri="{FF2B5EF4-FFF2-40B4-BE49-F238E27FC236}">
-                <a16:creationId xmlns:a16="http://schemas.microsoft.com/office/drawing/2014/main" id="{3F7AAAE7-5D27-40A4-A468-7095FDFDB69E}"/>
+                <a16:creationId xmlns:a16="http://schemas.microsoft.com/office/drawing/2014/main" id="{3858BB69-CD77-4387-B54E-8E5922CA875C}"/>
               </a:ext>
             </a:extLst>
           </p:cNvPr>
@@ -17778,7 +17778,7 @@
           <p:cNvPr id="8" name="">
             <a:extLst xmlns:a="http://schemas.openxmlformats.org/drawingml/2006/main">
               <a:ext uri="{FF2B5EF4-FFF2-40B4-BE49-F238E27FC236}">
-                <a16:creationId xmlns:a16="http://schemas.microsoft.com/office/drawing/2014/main" id="{B0ADA7A3-95F3-4425-9017-6EF1ACB6CC8F}"/>
+                <a16:creationId xmlns:a16="http://schemas.microsoft.com/office/drawing/2014/main" id="{2E884A2F-504B-460B-89BC-3379E9FCC5B4}"/>
               </a:ext>
             </a:extLst>
           </p:cNvPr>
@@ -17840,7 +17840,7 @@
           <p:cNvPr id="9" name="">
             <a:extLst xmlns:a="http://schemas.openxmlformats.org/drawingml/2006/main">
               <a:ext uri="{FF2B5EF4-FFF2-40B4-BE49-F238E27FC236}">
-                <a16:creationId xmlns:a16="http://schemas.microsoft.com/office/drawing/2014/main" id="{99C03597-572A-41CA-8DDE-3D520CC318B3}"/>
+                <a16:creationId xmlns:a16="http://schemas.microsoft.com/office/drawing/2014/main" id="{172C53FC-C314-4861-B16D-98F54E1C3447}"/>
               </a:ext>
             </a:extLst>
           </p:cNvPr>
@@ -17902,7 +17902,7 @@
           <p:cNvPr id="10" name="">
             <a:extLst xmlns:a="http://schemas.openxmlformats.org/drawingml/2006/main">
               <a:ext uri="{FF2B5EF4-FFF2-40B4-BE49-F238E27FC236}">
-                <a16:creationId xmlns:a16="http://schemas.microsoft.com/office/drawing/2014/main" id="{E50DD15A-93F6-456B-924A-CE858910E4BE}"/>
+                <a16:creationId xmlns:a16="http://schemas.microsoft.com/office/drawing/2014/main" id="{0219DA88-5E38-4FA9-9403-453359E3AD1D}"/>
               </a:ext>
             </a:extLst>
           </p:cNvPr>
@@ -17964,7 +17964,7 @@
           <p:cNvPr id="11" name="">
             <a:extLst xmlns:a="http://schemas.openxmlformats.org/drawingml/2006/main">
               <a:ext uri="{FF2B5EF4-FFF2-40B4-BE49-F238E27FC236}">
-                <a16:creationId xmlns:a16="http://schemas.microsoft.com/office/drawing/2014/main" id="{F6914BBD-56FA-4ACE-96B6-475618B8678A}"/>
+                <a16:creationId xmlns:a16="http://schemas.microsoft.com/office/drawing/2014/main" id="{CF77DEE1-EB32-4526-A816-6062A788A3E3}"/>
               </a:ext>
             </a:extLst>
           </p:cNvPr>
@@ -17995,7 +17995,7 @@
           <p:cNvPr id="12" name="">
             <a:extLst xmlns:a="http://schemas.openxmlformats.org/drawingml/2006/main">
               <a:ext uri="{FF2B5EF4-FFF2-40B4-BE49-F238E27FC236}">
-                <a16:creationId xmlns:a16="http://schemas.microsoft.com/office/drawing/2014/main" id="{EF240E82-C53E-4FB1-AB8F-BCBAE3516597}"/>
+                <a16:creationId xmlns:a16="http://schemas.microsoft.com/office/drawing/2014/main" id="{0D2EA391-4F55-4D9B-A0EF-51DDC9F7BE2E}"/>
               </a:ext>
             </a:extLst>
           </p:cNvPr>
@@ -18057,7 +18057,7 @@
           <p:cNvPr id="13" name="">
             <a:extLst xmlns:a="http://schemas.openxmlformats.org/drawingml/2006/main">
               <a:ext uri="{FF2B5EF4-FFF2-40B4-BE49-F238E27FC236}">
-                <a16:creationId xmlns:a16="http://schemas.microsoft.com/office/drawing/2014/main" id="{6AA50AA9-265B-45F1-8CA5-776E6913D1AE}"/>
+                <a16:creationId xmlns:a16="http://schemas.microsoft.com/office/drawing/2014/main" id="{15990536-51BF-40C3-966B-4655976B4877}"/>
               </a:ext>
             </a:extLst>
           </p:cNvPr>
@@ -18119,7 +18119,7 @@
           <p:cNvPr id="14" name="">
             <a:extLst xmlns:a="http://schemas.openxmlformats.org/drawingml/2006/main">
               <a:ext uri="{FF2B5EF4-FFF2-40B4-BE49-F238E27FC236}">
-                <a16:creationId xmlns:a16="http://schemas.microsoft.com/office/drawing/2014/main" id="{C7C7F78F-99D6-4F4E-850F-A1B1F3174E52}"/>
+                <a16:creationId xmlns:a16="http://schemas.microsoft.com/office/drawing/2014/main" id="{DBFC21EE-7FA7-425F-A1DF-FCB6C3FFA14A}"/>
               </a:ext>
             </a:extLst>
           </p:cNvPr>
@@ -18181,7 +18181,7 @@
           <p:cNvPr id="15" name="">
             <a:extLst xmlns:a="http://schemas.openxmlformats.org/drawingml/2006/main">
               <a:ext uri="{FF2B5EF4-FFF2-40B4-BE49-F238E27FC236}">
-                <a16:creationId xmlns:a16="http://schemas.microsoft.com/office/drawing/2014/main" id="{E671B7E9-A435-4109-9581-EC1355588EC8}"/>
+                <a16:creationId xmlns:a16="http://schemas.microsoft.com/office/drawing/2014/main" id="{93554279-5CA1-4DCB-8041-385B3618DE15}"/>
               </a:ext>
             </a:extLst>
           </p:cNvPr>
@@ -18212,7 +18212,7 @@
           <p:cNvPr id="16" name="">
             <a:extLst xmlns:a="http://schemas.openxmlformats.org/drawingml/2006/main">
               <a:ext uri="{FF2B5EF4-FFF2-40B4-BE49-F238E27FC236}">
-                <a16:creationId xmlns:a16="http://schemas.microsoft.com/office/drawing/2014/main" id="{F174C69B-F5B3-4B98-8F27-2C669F2A048C}"/>
+                <a16:creationId xmlns:a16="http://schemas.microsoft.com/office/drawing/2014/main" id="{2580A71C-DF7B-40C9-9CB7-1F5F7F686090}"/>
               </a:ext>
             </a:extLst>
           </p:cNvPr>
@@ -18274,7 +18274,7 @@
           <p:cNvPr id="17" name="">
             <a:extLst xmlns:a="http://schemas.openxmlformats.org/drawingml/2006/main">
               <a:ext uri="{FF2B5EF4-FFF2-40B4-BE49-F238E27FC236}">
-                <a16:creationId xmlns:a16="http://schemas.microsoft.com/office/drawing/2014/main" id="{179B9A51-71EC-46D7-8382-032CB31F1E67}"/>
+                <a16:creationId xmlns:a16="http://schemas.microsoft.com/office/drawing/2014/main" id="{9E0B82AB-736E-4FF3-B87D-51B2CBB9B310}"/>
               </a:ext>
             </a:extLst>
           </p:cNvPr>
@@ -18336,7 +18336,7 @@
           <p:cNvPr id="18" name="">
             <a:extLst xmlns:a="http://schemas.openxmlformats.org/drawingml/2006/main">
               <a:ext uri="{FF2B5EF4-FFF2-40B4-BE49-F238E27FC236}">
-                <a16:creationId xmlns:a16="http://schemas.microsoft.com/office/drawing/2014/main" id="{CAB7D6D5-C0D7-4547-B20E-B48DAA3657C5}"/>
+                <a16:creationId xmlns:a16="http://schemas.microsoft.com/office/drawing/2014/main" id="{D42EFC18-119D-4BD8-8AA8-E484402280F6}"/>
               </a:ext>
             </a:extLst>
           </p:cNvPr>
@@ -18398,7 +18398,7 @@
           <p:cNvPr id="19" name="">
             <a:extLst xmlns:a="http://schemas.openxmlformats.org/drawingml/2006/main">
               <a:ext uri="{FF2B5EF4-FFF2-40B4-BE49-F238E27FC236}">
-                <a16:creationId xmlns:a16="http://schemas.microsoft.com/office/drawing/2014/main" id="{D9A6B8DC-DD34-41E7-B543-7197162D37F2}"/>
+                <a16:creationId xmlns:a16="http://schemas.microsoft.com/office/drawing/2014/main" id="{3655C904-F506-4A56-9A2A-665BB913C794}"/>
               </a:ext>
             </a:extLst>
           </p:cNvPr>
@@ -18429,7 +18429,7 @@
           <p:cNvPr id="20" name="">
             <a:extLst xmlns:a="http://schemas.openxmlformats.org/drawingml/2006/main">
               <a:ext uri="{FF2B5EF4-FFF2-40B4-BE49-F238E27FC236}">
-                <a16:creationId xmlns:a16="http://schemas.microsoft.com/office/drawing/2014/main" id="{8E93CCE0-92CB-4009-B83C-1454DBD0DBAD}"/>
+                <a16:creationId xmlns:a16="http://schemas.microsoft.com/office/drawing/2014/main" id="{CAF7B147-2EB4-484B-A2D9-D12073D6CF9A}"/>
               </a:ext>
             </a:extLst>
           </p:cNvPr>
@@ -18491,7 +18491,7 @@
           <p:cNvPr id="21" name="">
             <a:extLst xmlns:a="http://schemas.openxmlformats.org/drawingml/2006/main">
               <a:ext uri="{FF2B5EF4-FFF2-40B4-BE49-F238E27FC236}">
-                <a16:creationId xmlns:a16="http://schemas.microsoft.com/office/drawing/2014/main" id="{E95E446A-7637-4C47-A494-DDF8DF6DAEA2}"/>
+                <a16:creationId xmlns:a16="http://schemas.microsoft.com/office/drawing/2014/main" id="{6B48794C-7D55-444F-B775-7C2B5C79EF22}"/>
               </a:ext>
             </a:extLst>
           </p:cNvPr>
@@ -18553,7 +18553,7 @@
           <p:cNvPr id="22" name="">
             <a:extLst xmlns:a="http://schemas.openxmlformats.org/drawingml/2006/main">
               <a:ext uri="{FF2B5EF4-FFF2-40B4-BE49-F238E27FC236}">
-                <a16:creationId xmlns:a16="http://schemas.microsoft.com/office/drawing/2014/main" id="{83C786DC-90D7-4710-AECB-4D70B34E41CE}"/>
+                <a16:creationId xmlns:a16="http://schemas.microsoft.com/office/drawing/2014/main" id="{620EBCFF-8C0F-4DB7-9160-BDE7D8C512FF}"/>
               </a:ext>
             </a:extLst>
           </p:cNvPr>
@@ -18615,7 +18615,7 @@
           <p:cNvPr id="23" name="">
             <a:extLst xmlns:a="http://schemas.openxmlformats.org/drawingml/2006/main">
               <a:ext uri="{FF2B5EF4-FFF2-40B4-BE49-F238E27FC236}">
-                <a16:creationId xmlns:a16="http://schemas.microsoft.com/office/drawing/2014/main" id="{A4912A10-F608-49C0-8D7A-6C0BECBD2E75}"/>
+                <a16:creationId xmlns:a16="http://schemas.microsoft.com/office/drawing/2014/main" id="{4B9EC066-A317-4E1B-977C-BF456CCD2408}"/>
               </a:ext>
             </a:extLst>
           </p:cNvPr>
@@ -18646,7 +18646,7 @@
           <p:cNvPr id="24" name="">
             <a:extLst xmlns:a="http://schemas.openxmlformats.org/drawingml/2006/main">
               <a:ext uri="{FF2B5EF4-FFF2-40B4-BE49-F238E27FC236}">
-                <a16:creationId xmlns:a16="http://schemas.microsoft.com/office/drawing/2014/main" id="{E8F01206-B127-4E85-8D31-8EBB2F353681}"/>
+                <a16:creationId xmlns:a16="http://schemas.microsoft.com/office/drawing/2014/main" id="{5A54BDFB-2816-450A-ABD9-1D8DA105DBAA}"/>
               </a:ext>
             </a:extLst>
           </p:cNvPr>
@@ -18708,7 +18708,7 @@
           <p:cNvPr id="25" name="">
             <a:extLst xmlns:a="http://schemas.openxmlformats.org/drawingml/2006/main">
               <a:ext uri="{FF2B5EF4-FFF2-40B4-BE49-F238E27FC236}">
-                <a16:creationId xmlns:a16="http://schemas.microsoft.com/office/drawing/2014/main" id="{F126EAF8-687B-4419-ABC0-89B877193582}"/>
+                <a16:creationId xmlns:a16="http://schemas.microsoft.com/office/drawing/2014/main" id="{42DD49DD-58FB-4659-94A9-AD34FDD377F3}"/>
               </a:ext>
             </a:extLst>
           </p:cNvPr>
@@ -18770,7 +18770,7 @@
           <p:cNvPr id="26" name="">
             <a:extLst xmlns:a="http://schemas.openxmlformats.org/drawingml/2006/main">
               <a:ext uri="{FF2B5EF4-FFF2-40B4-BE49-F238E27FC236}">
-                <a16:creationId xmlns:a16="http://schemas.microsoft.com/office/drawing/2014/main" id="{F752ECB7-53CC-4737-9BC7-E637A7D7741F}"/>
+                <a16:creationId xmlns:a16="http://schemas.microsoft.com/office/drawing/2014/main" id="{2E6081FB-252B-44DE-B54F-B474FF2488A8}"/>
               </a:ext>
             </a:extLst>
           </p:cNvPr>
@@ -18832,7 +18832,7 @@
           <p:cNvPr id="27" name="">
             <a:extLst xmlns:a="http://schemas.openxmlformats.org/drawingml/2006/main">
               <a:ext uri="{FF2B5EF4-FFF2-40B4-BE49-F238E27FC236}">
-                <a16:creationId xmlns:a16="http://schemas.microsoft.com/office/drawing/2014/main" id="{AA077182-790B-4C7A-9696-820D3F51A1CA}"/>
+                <a16:creationId xmlns:a16="http://schemas.microsoft.com/office/drawing/2014/main" id="{A172388E-2853-48BE-A437-7C83A2AC9799}"/>
               </a:ext>
             </a:extLst>
           </p:cNvPr>
@@ -18894,7 +18894,7 @@
           <p:cNvPr id="28" name="footer-rule-5">
             <a:extLst xmlns:a="http://schemas.openxmlformats.org/drawingml/2006/main">
               <a:ext uri="{FF2B5EF4-FFF2-40B4-BE49-F238E27FC236}">
-                <a16:creationId xmlns:a16="http://schemas.microsoft.com/office/drawing/2014/main" id="{CB0E1738-9779-4CB1-B75E-9DFD870558A9}"/>
+                <a16:creationId xmlns:a16="http://schemas.microsoft.com/office/drawing/2014/main" id="{82F06F4A-2C84-42CC-A29F-C23BC0C0B9EF}"/>
               </a:ext>
             </a:extLst>
           </p:cNvPr>
@@ -18925,7 +18925,7 @@
           <p:cNvPr id="29" name="footer-label-5">
             <a:extLst xmlns:a="http://schemas.openxmlformats.org/drawingml/2006/main">
               <a:ext uri="{FF2B5EF4-FFF2-40B4-BE49-F238E27FC236}">
-                <a16:creationId xmlns:a16="http://schemas.microsoft.com/office/drawing/2014/main" id="{5AF53DBA-9D83-4DEF-8F4D-CB5593D9DF52}"/>
+                <a16:creationId xmlns:a16="http://schemas.microsoft.com/office/drawing/2014/main" id="{CB7CA7DC-871D-4790-B432-EAC11AD53770}"/>
               </a:ext>
             </a:extLst>
           </p:cNvPr>
@@ -18987,7 +18987,7 @@
           <p:cNvPr id="30" name="footer-page-5">
             <a:extLst xmlns:a="http://schemas.openxmlformats.org/drawingml/2006/main">
               <a:ext uri="{FF2B5EF4-FFF2-40B4-BE49-F238E27FC236}">
-                <a16:creationId xmlns:a16="http://schemas.microsoft.com/office/drawing/2014/main" id="{726FC2EA-43B1-4096-8F1C-2754C9CB6392}"/>
+                <a16:creationId xmlns:a16="http://schemas.microsoft.com/office/drawing/2014/main" id="{5AD5A5FC-171F-470C-82A4-EEEA03694073}"/>
               </a:ext>
             </a:extLst>
           </p:cNvPr>
@@ -19047,7 +19047,7 @@
     </p:spTree>
     <p:extLst>
       <p:ext uri="{BB962C8B-B14F-4D97-AF65-F5344CB8AC3E}">
-        <p14:creationId xmlns:p14="http://schemas.microsoft.com/office/powerpoint/2010/main" val="642301529"/>
+        <p14:creationId xmlns:p14="http://schemas.microsoft.com/office/powerpoint/2010/main" val="1411574485"/>
       </p:ext>
     </p:extLst>
   </p:cSld>
@@ -19078,7 +19078,7 @@
           <p:cNvPr id="22" name="side-accent-6">
             <a:extLst xmlns:a="http://schemas.openxmlformats.org/drawingml/2006/main">
               <a:ext uri="{FF2B5EF4-FFF2-40B4-BE49-F238E27FC236}">
-                <a16:creationId xmlns:a16="http://schemas.microsoft.com/office/drawing/2014/main" id="{9421C0EA-E239-411C-BE73-23846B24D04A}"/>
+                <a16:creationId xmlns:a16="http://schemas.microsoft.com/office/drawing/2014/main" id="{511DBA63-1844-4E95-95F6-AB26A7F4B3B3}"/>
               </a:ext>
             </a:extLst>
           </p:cNvPr>
@@ -19109,7 +19109,7 @@
           <p:cNvPr id="2" name="kicker-6">
             <a:extLst xmlns:a="http://schemas.openxmlformats.org/drawingml/2006/main">
               <a:ext uri="{FF2B5EF4-FFF2-40B4-BE49-F238E27FC236}">
-                <a16:creationId xmlns:a16="http://schemas.microsoft.com/office/drawing/2014/main" id="{82E9ED72-8C97-43EE-9CC1-6D68B54281FB}"/>
+                <a16:creationId xmlns:a16="http://schemas.microsoft.com/office/drawing/2014/main" id="{E8DC5B25-63AB-4835-A084-3470148ECE69}"/>
               </a:ext>
             </a:extLst>
           </p:cNvPr>
@@ -19171,7 +19171,7 @@
           <p:cNvPr id="3" name="title-6">
             <a:extLst xmlns:a="http://schemas.openxmlformats.org/drawingml/2006/main">
               <a:ext uri="{FF2B5EF4-FFF2-40B4-BE49-F238E27FC236}">
-                <a16:creationId xmlns:a16="http://schemas.microsoft.com/office/drawing/2014/main" id="{92624DA7-511A-4D18-B4DE-3EBE032B441C}"/>
+                <a16:creationId xmlns:a16="http://schemas.microsoft.com/office/drawing/2014/main" id="{69230694-89B5-4DB2-B577-E45DF7D3E206}"/>
               </a:ext>
             </a:extLst>
           </p:cNvPr>
@@ -19233,7 +19233,7 @@
           <p:cNvPr id="4" name="">
             <a:extLst xmlns:a="http://schemas.openxmlformats.org/drawingml/2006/main">
               <a:ext uri="{FF2B5EF4-FFF2-40B4-BE49-F238E27FC236}">
-                <a16:creationId xmlns:a16="http://schemas.microsoft.com/office/drawing/2014/main" id="{AFE9A20C-3CC0-4E6D-9436-1488B04D5533}"/>
+                <a16:creationId xmlns:a16="http://schemas.microsoft.com/office/drawing/2014/main" id="{1341F5F3-73A6-4C9A-B15D-E1F5C06B2F37}"/>
               </a:ext>
             </a:extLst>
           </p:cNvPr>
@@ -19295,7 +19295,7 @@
           <p:cNvPr id="5" name="">
             <a:extLst xmlns:a="http://schemas.openxmlformats.org/drawingml/2006/main">
               <a:ext uri="{FF2B5EF4-FFF2-40B4-BE49-F238E27FC236}">
-                <a16:creationId xmlns:a16="http://schemas.microsoft.com/office/drawing/2014/main" id="{81AC82DD-CAB5-432E-85D3-7491D845796A}"/>
+                <a16:creationId xmlns:a16="http://schemas.microsoft.com/office/drawing/2014/main" id="{B3AE1C97-78CE-40C0-97F4-F5BE112BEF5C}"/>
               </a:ext>
             </a:extLst>
           </p:cNvPr>
@@ -19357,7 +19357,7 @@
           <p:cNvPr id="6" name="">
             <a:extLst xmlns:a="http://schemas.openxmlformats.org/drawingml/2006/main">
               <a:ext uri="{FF2B5EF4-FFF2-40B4-BE49-F238E27FC236}">
-                <a16:creationId xmlns:a16="http://schemas.microsoft.com/office/drawing/2014/main" id="{233C0B55-6734-4B9E-BE11-9182296DFD1E}"/>
+                <a16:creationId xmlns:a16="http://schemas.microsoft.com/office/drawing/2014/main" id="{26B12A56-919C-4F65-A668-7F500895F4FF}"/>
               </a:ext>
             </a:extLst>
           </p:cNvPr>
@@ -19419,7 +19419,7 @@
           <p:cNvPr id="7" name="">
             <a:extLst xmlns:a="http://schemas.openxmlformats.org/drawingml/2006/main">
               <a:ext uri="{FF2B5EF4-FFF2-40B4-BE49-F238E27FC236}">
-                <a16:creationId xmlns:a16="http://schemas.microsoft.com/office/drawing/2014/main" id="{72321C85-D577-42B7-B965-42065F51F9B3}"/>
+                <a16:creationId xmlns:a16="http://schemas.microsoft.com/office/drawing/2014/main" id="{1465F21A-02C1-4875-8CEF-0FF7C3104B79}"/>
               </a:ext>
             </a:extLst>
           </p:cNvPr>
@@ -19450,7 +19450,7 @@
           <p:cNvPr id="8" name="">
             <a:extLst xmlns:a="http://schemas.openxmlformats.org/drawingml/2006/main">
               <a:ext uri="{FF2B5EF4-FFF2-40B4-BE49-F238E27FC236}">
-                <a16:creationId xmlns:a16="http://schemas.microsoft.com/office/drawing/2014/main" id="{74EA3A36-C03F-4818-A6F8-E9B1230781B2}"/>
+                <a16:creationId xmlns:a16="http://schemas.microsoft.com/office/drawing/2014/main" id="{EA4A9BFB-AFA0-4126-AE6B-E086BB51F6FD}"/>
               </a:ext>
             </a:extLst>
           </p:cNvPr>
@@ -19539,7 +19539,7 @@
           <p:cNvPr id="9" name="">
             <a:extLst xmlns:a="http://schemas.openxmlformats.org/drawingml/2006/main">
               <a:ext uri="{FF2B5EF4-FFF2-40B4-BE49-F238E27FC236}">
-                <a16:creationId xmlns:a16="http://schemas.microsoft.com/office/drawing/2014/main" id="{FABF256D-D2FE-4B72-9C26-D5FEC272C24F}"/>
+                <a16:creationId xmlns:a16="http://schemas.microsoft.com/office/drawing/2014/main" id="{B2A796B7-369B-4A4B-A37A-F7D072DF7C5A}"/>
               </a:ext>
             </a:extLst>
           </p:cNvPr>
@@ -19601,7 +19601,7 @@
           <p:cNvPr id="10" name="">
             <a:extLst xmlns:a="http://schemas.openxmlformats.org/drawingml/2006/main">
               <a:ext uri="{FF2B5EF4-FFF2-40B4-BE49-F238E27FC236}">
-                <a16:creationId xmlns:a16="http://schemas.microsoft.com/office/drawing/2014/main" id="{4B8D07D9-B257-482D-8E9F-AE4C8005F99A}"/>
+                <a16:creationId xmlns:a16="http://schemas.microsoft.com/office/drawing/2014/main" id="{BC35CA37-26F7-48D5-9500-E22246E7B310}"/>
               </a:ext>
             </a:extLst>
           </p:cNvPr>
@@ -19663,7 +19663,7 @@
           <p:cNvPr id="11" name="">
             <a:extLst xmlns:a="http://schemas.openxmlformats.org/drawingml/2006/main">
               <a:ext uri="{FF2B5EF4-FFF2-40B4-BE49-F238E27FC236}">
-                <a16:creationId xmlns:a16="http://schemas.microsoft.com/office/drawing/2014/main" id="{EEAEEFAC-378F-4557-BFA1-442FCC48028D}"/>
+                <a16:creationId xmlns:a16="http://schemas.microsoft.com/office/drawing/2014/main" id="{A910A1F7-2C4C-4980-B459-204D498EC08D}"/>
               </a:ext>
             </a:extLst>
           </p:cNvPr>
@@ -19694,7 +19694,7 @@
           <p:cNvPr id="12" name="">
             <a:extLst xmlns:a="http://schemas.openxmlformats.org/drawingml/2006/main">
               <a:ext uri="{FF2B5EF4-FFF2-40B4-BE49-F238E27FC236}">
-                <a16:creationId xmlns:a16="http://schemas.microsoft.com/office/drawing/2014/main" id="{FDC0B3F3-13C1-437D-8859-26B64563092F}"/>
+                <a16:creationId xmlns:a16="http://schemas.microsoft.com/office/drawing/2014/main" id="{C756A083-A99B-493A-B31C-E195437AA0B8}"/>
               </a:ext>
             </a:extLst>
           </p:cNvPr>
@@ -19783,7 +19783,7 @@
           <p:cNvPr id="13" name="">
             <a:extLst xmlns:a="http://schemas.openxmlformats.org/drawingml/2006/main">
               <a:ext uri="{FF2B5EF4-FFF2-40B4-BE49-F238E27FC236}">
-                <a16:creationId xmlns:a16="http://schemas.microsoft.com/office/drawing/2014/main" id="{7E13F828-DD13-4E7C-B1CF-A4AC06BED53B}"/>
+                <a16:creationId xmlns:a16="http://schemas.microsoft.com/office/drawing/2014/main" id="{198273E0-8F56-4E46-BEA1-0FB057C6E40A}"/>
               </a:ext>
             </a:extLst>
           </p:cNvPr>
@@ -19845,7 +19845,7 @@
           <p:cNvPr id="14" name="">
             <a:extLst xmlns:a="http://schemas.openxmlformats.org/drawingml/2006/main">
               <a:ext uri="{FF2B5EF4-FFF2-40B4-BE49-F238E27FC236}">
-                <a16:creationId xmlns:a16="http://schemas.microsoft.com/office/drawing/2014/main" id="{0F331190-1D44-4445-8B6A-45149C51E64A}"/>
+                <a16:creationId xmlns:a16="http://schemas.microsoft.com/office/drawing/2014/main" id="{D27FB78A-9AEF-4CD3-8398-19F26FC8DD65}"/>
               </a:ext>
             </a:extLst>
           </p:cNvPr>
@@ -19907,7 +19907,7 @@
           <p:cNvPr id="15" name="">
             <a:extLst xmlns:a="http://schemas.openxmlformats.org/drawingml/2006/main">
               <a:ext uri="{FF2B5EF4-FFF2-40B4-BE49-F238E27FC236}">
-                <a16:creationId xmlns:a16="http://schemas.microsoft.com/office/drawing/2014/main" id="{73AB76AB-D5CE-4216-9779-DC935E9D9C8F}"/>
+                <a16:creationId xmlns:a16="http://schemas.microsoft.com/office/drawing/2014/main" id="{6C2DD88F-168E-42E9-BFE5-50EEE30F9D65}"/>
               </a:ext>
             </a:extLst>
           </p:cNvPr>
@@ -19938,7 +19938,7 @@
           <p:cNvPr id="16" name="">
             <a:extLst xmlns:a="http://schemas.openxmlformats.org/drawingml/2006/main">
               <a:ext uri="{FF2B5EF4-FFF2-40B4-BE49-F238E27FC236}">
-                <a16:creationId xmlns:a16="http://schemas.microsoft.com/office/drawing/2014/main" id="{83914221-AEF9-4C59-AB88-46A2A2959DEB}"/>
+                <a16:creationId xmlns:a16="http://schemas.microsoft.com/office/drawing/2014/main" id="{2C76DE6E-8381-4A12-A71D-DA26702459A3}"/>
               </a:ext>
             </a:extLst>
           </p:cNvPr>
@@ -20027,7 +20027,7 @@
           <p:cNvPr id="17" name="">
             <a:extLst xmlns:a="http://schemas.openxmlformats.org/drawingml/2006/main">
               <a:ext uri="{FF2B5EF4-FFF2-40B4-BE49-F238E27FC236}">
-                <a16:creationId xmlns:a16="http://schemas.microsoft.com/office/drawing/2014/main" id="{1AD71BC0-B928-4E2F-8684-F2FE68625E49}"/>
+                <a16:creationId xmlns:a16="http://schemas.microsoft.com/office/drawing/2014/main" id="{10215936-A1A0-4C6E-AB15-FCF92380F1A5}"/>
               </a:ext>
             </a:extLst>
           </p:cNvPr>
@@ -20060,7 +20060,7 @@
           <p:cNvPr id="18" name="">
             <a:extLst xmlns:a="http://schemas.openxmlformats.org/drawingml/2006/main">
               <a:ext uri="{FF2B5EF4-FFF2-40B4-BE49-F238E27FC236}">
-                <a16:creationId xmlns:a16="http://schemas.microsoft.com/office/drawing/2014/main" id="{D471BA59-6047-485B-A6A0-15A8DBF8CF43}"/>
+                <a16:creationId xmlns:a16="http://schemas.microsoft.com/office/drawing/2014/main" id="{B0D47A8F-134E-4C3A-9FE5-5B378E3C7BF7}"/>
               </a:ext>
             </a:extLst>
           </p:cNvPr>
@@ -20149,7 +20149,7 @@
           <p:cNvPr id="19" name="footer-rule-6">
             <a:extLst xmlns:a="http://schemas.openxmlformats.org/drawingml/2006/main">
               <a:ext uri="{FF2B5EF4-FFF2-40B4-BE49-F238E27FC236}">
-                <a16:creationId xmlns:a16="http://schemas.microsoft.com/office/drawing/2014/main" id="{73513B1A-EFFF-4E94-AB76-4829E998B201}"/>
+                <a16:creationId xmlns:a16="http://schemas.microsoft.com/office/drawing/2014/main" id="{3B00B5E3-9503-48E5-B91A-748032316FBA}"/>
               </a:ext>
             </a:extLst>
           </p:cNvPr>
@@ -20180,7 +20180,7 @@
           <p:cNvPr id="20" name="footer-label-6">
             <a:extLst xmlns:a="http://schemas.openxmlformats.org/drawingml/2006/main">
               <a:ext uri="{FF2B5EF4-FFF2-40B4-BE49-F238E27FC236}">
-                <a16:creationId xmlns:a16="http://schemas.microsoft.com/office/drawing/2014/main" id="{E00A64EB-4AE1-49AC-AAAF-94CE248DECB0}"/>
+                <a16:creationId xmlns:a16="http://schemas.microsoft.com/office/drawing/2014/main" id="{B6BA59B2-9B25-4CB7-AC67-8B8B90383B82}"/>
               </a:ext>
             </a:extLst>
           </p:cNvPr>
@@ -20242,7 +20242,7 @@
           <p:cNvPr id="21" name="footer-page-6">
             <a:extLst xmlns:a="http://schemas.openxmlformats.org/drawingml/2006/main">
               <a:ext uri="{FF2B5EF4-FFF2-40B4-BE49-F238E27FC236}">
-                <a16:creationId xmlns:a16="http://schemas.microsoft.com/office/drawing/2014/main" id="{2AFB564C-1CF3-4BEB-981A-EF66301598FC}"/>
+                <a16:creationId xmlns:a16="http://schemas.microsoft.com/office/drawing/2014/main" id="{9F7D1429-BD37-486F-BEE4-A06D0BB1A70F}"/>
               </a:ext>
             </a:extLst>
           </p:cNvPr>
@@ -20302,7 +20302,7 @@
     </p:spTree>
     <p:extLst>
       <p:ext uri="{BB962C8B-B14F-4D97-AF65-F5344CB8AC3E}">
-        <p14:creationId xmlns:p14="http://schemas.microsoft.com/office/powerpoint/2010/main" val="1518142344"/>
+        <p14:creationId xmlns:p14="http://schemas.microsoft.com/office/powerpoint/2010/main" val="1233449940"/>
       </p:ext>
     </p:extLst>
   </p:cSld>
@@ -20333,7 +20333,7 @@
           <p:cNvPr id="28" name="side-accent-7">
             <a:extLst xmlns:a="http://schemas.openxmlformats.org/drawingml/2006/main">
               <a:ext uri="{FF2B5EF4-FFF2-40B4-BE49-F238E27FC236}">
-                <a16:creationId xmlns:a16="http://schemas.microsoft.com/office/drawing/2014/main" id="{9CD1C123-8AE2-48A0-B6AE-36A0CA8CF167}"/>
+                <a16:creationId xmlns:a16="http://schemas.microsoft.com/office/drawing/2014/main" id="{117944D3-3BDF-4307-A8F5-E08FFE3C4525}"/>
               </a:ext>
             </a:extLst>
           </p:cNvPr>
@@ -20364,7 +20364,7 @@
           <p:cNvPr id="2" name="kicker-7">
             <a:extLst xmlns:a="http://schemas.openxmlformats.org/drawingml/2006/main">
               <a:ext uri="{FF2B5EF4-FFF2-40B4-BE49-F238E27FC236}">
-                <a16:creationId xmlns:a16="http://schemas.microsoft.com/office/drawing/2014/main" id="{16DE649A-20FF-4B4E-9B75-5091FAB9A59F}"/>
+                <a16:creationId xmlns:a16="http://schemas.microsoft.com/office/drawing/2014/main" id="{734649C0-9414-413A-873A-C7789A780B1E}"/>
               </a:ext>
             </a:extLst>
           </p:cNvPr>
@@ -20426,7 +20426,7 @@
           <p:cNvPr id="3" name="title-7">
             <a:extLst xmlns:a="http://schemas.openxmlformats.org/drawingml/2006/main">
               <a:ext uri="{FF2B5EF4-FFF2-40B4-BE49-F238E27FC236}">
-                <a16:creationId xmlns:a16="http://schemas.microsoft.com/office/drawing/2014/main" id="{7C8D752C-224D-48ED-B882-D6D3C869DF5D}"/>
+                <a16:creationId xmlns:a16="http://schemas.microsoft.com/office/drawing/2014/main" id="{C0DC4879-C138-47D0-82D3-81D6BBB76EEA}"/>
               </a:ext>
             </a:extLst>
           </p:cNvPr>
@@ -20488,7 +20488,7 @@
           <p:cNvPr id="4" name="">
             <a:extLst xmlns:a="http://schemas.openxmlformats.org/drawingml/2006/main">
               <a:ext uri="{FF2B5EF4-FFF2-40B4-BE49-F238E27FC236}">
-                <a16:creationId xmlns:a16="http://schemas.microsoft.com/office/drawing/2014/main" id="{D553E51C-294E-4952-8D5B-DFC672E16459}"/>
+                <a16:creationId xmlns:a16="http://schemas.microsoft.com/office/drawing/2014/main" id="{02E6DCF4-547F-412D-98F0-F5F899E23C2E}"/>
               </a:ext>
             </a:extLst>
           </p:cNvPr>
@@ -20550,7 +20550,7 @@
           <p:cNvPr id="5" name="">
             <a:extLst xmlns:a="http://schemas.openxmlformats.org/drawingml/2006/main">
               <a:ext uri="{FF2B5EF4-FFF2-40B4-BE49-F238E27FC236}">
-                <a16:creationId xmlns:a16="http://schemas.microsoft.com/office/drawing/2014/main" id="{82C730EC-90E4-4027-83BD-7C8CBE64318D}"/>
+                <a16:creationId xmlns:a16="http://schemas.microsoft.com/office/drawing/2014/main" id="{DAE82400-EF2A-4F3A-8422-D67B95E6A38E}"/>
               </a:ext>
             </a:extLst>
           </p:cNvPr>
@@ -20581,7 +20581,7 @@
           <p:cNvPr id="6" name="">
             <a:extLst xmlns:a="http://schemas.openxmlformats.org/drawingml/2006/main">
               <a:ext uri="{FF2B5EF4-FFF2-40B4-BE49-F238E27FC236}">
-                <a16:creationId xmlns:a16="http://schemas.microsoft.com/office/drawing/2014/main" id="{0C4D8879-AA7B-45C1-AA86-3C9C6AB65466}"/>
+                <a16:creationId xmlns:a16="http://schemas.microsoft.com/office/drawing/2014/main" id="{DEEDAA8C-B6B5-424E-92BF-8FA0900F16A2}"/>
               </a:ext>
             </a:extLst>
           </p:cNvPr>
@@ -20643,7 +20643,7 @@
           <p:cNvPr id="7" name="">
             <a:extLst xmlns:a="http://schemas.openxmlformats.org/drawingml/2006/main">
               <a:ext uri="{FF2B5EF4-FFF2-40B4-BE49-F238E27FC236}">
-                <a16:creationId xmlns:a16="http://schemas.microsoft.com/office/drawing/2014/main" id="{66607D71-3944-4487-8BDC-C79469D867A4}"/>
+                <a16:creationId xmlns:a16="http://schemas.microsoft.com/office/drawing/2014/main" id="{DAB23379-8DAE-4483-A629-F4474370040C}"/>
               </a:ext>
             </a:extLst>
           </p:cNvPr>
@@ -20705,7 +20705,7 @@
           <p:cNvPr id="8" name="">
             <a:extLst xmlns:a="http://schemas.openxmlformats.org/drawingml/2006/main">
               <a:ext uri="{FF2B5EF4-FFF2-40B4-BE49-F238E27FC236}">
-                <a16:creationId xmlns:a16="http://schemas.microsoft.com/office/drawing/2014/main" id="{3FEDCB8A-26C4-4C9F-A585-7DAE4360F362}"/>
+                <a16:creationId xmlns:a16="http://schemas.microsoft.com/office/drawing/2014/main" id="{63CC9DE4-33D8-43DE-8F52-6F46BA405FD3}"/>
               </a:ext>
             </a:extLst>
           </p:cNvPr>
@@ -20767,7 +20767,7 @@
           <p:cNvPr id="9" name="">
             <a:extLst xmlns:a="http://schemas.openxmlformats.org/drawingml/2006/main">
               <a:ext uri="{FF2B5EF4-FFF2-40B4-BE49-F238E27FC236}">
-                <a16:creationId xmlns:a16="http://schemas.microsoft.com/office/drawing/2014/main" id="{33DE8D5C-72AA-4249-AD26-79F7ED2F7D24}"/>
+                <a16:creationId xmlns:a16="http://schemas.microsoft.com/office/drawing/2014/main" id="{67E3C7F0-EA66-4401-A1F7-1EEA36EFB7A4}"/>
               </a:ext>
             </a:extLst>
           </p:cNvPr>
@@ -20798,7 +20798,7 @@
           <p:cNvPr id="10" name="">
             <a:extLst xmlns:a="http://schemas.openxmlformats.org/drawingml/2006/main">
               <a:ext uri="{FF2B5EF4-FFF2-40B4-BE49-F238E27FC236}">
-                <a16:creationId xmlns:a16="http://schemas.microsoft.com/office/drawing/2014/main" id="{2CD6CD00-CC30-4F41-97DE-C6938EE942B5}"/>
+                <a16:creationId xmlns:a16="http://schemas.microsoft.com/office/drawing/2014/main" id="{CAFC2CEE-35B1-4C3E-8455-2C5F6FB85ECE}"/>
               </a:ext>
             </a:extLst>
           </p:cNvPr>
@@ -20860,7 +20860,7 @@
           <p:cNvPr id="11" name="">
             <a:extLst xmlns:a="http://schemas.openxmlformats.org/drawingml/2006/main">
               <a:ext uri="{FF2B5EF4-FFF2-40B4-BE49-F238E27FC236}">
-                <a16:creationId xmlns:a16="http://schemas.microsoft.com/office/drawing/2014/main" id="{06C4C404-63FE-4E13-B1F9-1EF9199845DC}"/>
+                <a16:creationId xmlns:a16="http://schemas.microsoft.com/office/drawing/2014/main" id="{316E0F36-F9F6-4A67-A80D-03399A53E6BC}"/>
               </a:ext>
             </a:extLst>
           </p:cNvPr>
@@ -20922,7 +20922,7 @@
           <p:cNvPr id="12" name="">
             <a:extLst xmlns:a="http://schemas.openxmlformats.org/drawingml/2006/main">
               <a:ext uri="{FF2B5EF4-FFF2-40B4-BE49-F238E27FC236}">
-                <a16:creationId xmlns:a16="http://schemas.microsoft.com/office/drawing/2014/main" id="{41A2D0DD-AE16-4FEB-99F8-502D1E242F99}"/>
+                <a16:creationId xmlns:a16="http://schemas.microsoft.com/office/drawing/2014/main" id="{4B414909-46C5-4C23-BE66-8E3FE245ED3D}"/>
               </a:ext>
             </a:extLst>
           </p:cNvPr>
@@ -20984,7 +20984,7 @@
           <p:cNvPr id="13" name="">
             <a:extLst xmlns:a="http://schemas.openxmlformats.org/drawingml/2006/main">
               <a:ext uri="{FF2B5EF4-FFF2-40B4-BE49-F238E27FC236}">
-                <a16:creationId xmlns:a16="http://schemas.microsoft.com/office/drawing/2014/main" id="{8AA010C8-B1C6-427B-9667-8362F9FD0F59}"/>
+                <a16:creationId xmlns:a16="http://schemas.microsoft.com/office/drawing/2014/main" id="{A90254A5-7805-4C60-B05B-E7B8ACD5D4CA}"/>
               </a:ext>
             </a:extLst>
           </p:cNvPr>
@@ -21015,7 +21015,7 @@
           <p:cNvPr id="14" name="">
             <a:extLst xmlns:a="http://schemas.openxmlformats.org/drawingml/2006/main">
               <a:ext uri="{FF2B5EF4-FFF2-40B4-BE49-F238E27FC236}">
-                <a16:creationId xmlns:a16="http://schemas.microsoft.com/office/drawing/2014/main" id="{6C80DB05-6695-4D1D-965C-F7EBDF628802}"/>
+                <a16:creationId xmlns:a16="http://schemas.microsoft.com/office/drawing/2014/main" id="{6BC3A27E-AF97-441C-AE23-9C99E63AE7AB}"/>
               </a:ext>
             </a:extLst>
           </p:cNvPr>
@@ -21077,7 +21077,7 @@
           <p:cNvPr id="15" name="">
             <a:extLst xmlns:a="http://schemas.openxmlformats.org/drawingml/2006/main">
               <a:ext uri="{FF2B5EF4-FFF2-40B4-BE49-F238E27FC236}">
-                <a16:creationId xmlns:a16="http://schemas.microsoft.com/office/drawing/2014/main" id="{3B583D82-FC20-4EC2-B79E-90D957560E81}"/>
+                <a16:creationId xmlns:a16="http://schemas.microsoft.com/office/drawing/2014/main" id="{A8D8B7E9-430B-4AE8-AEB2-87F7D7F25890}"/>
               </a:ext>
             </a:extLst>
           </p:cNvPr>
@@ -21139,7 +21139,7 @@
           <p:cNvPr id="16" name="">
             <a:extLst xmlns:a="http://schemas.openxmlformats.org/drawingml/2006/main">
               <a:ext uri="{FF2B5EF4-FFF2-40B4-BE49-F238E27FC236}">
-                <a16:creationId xmlns:a16="http://schemas.microsoft.com/office/drawing/2014/main" id="{E619398B-D7B3-4351-9421-AFB21765E23D}"/>
+                <a16:creationId xmlns:a16="http://schemas.microsoft.com/office/drawing/2014/main" id="{A6FD7F40-DF6C-465C-B70F-148D173E6545}"/>
               </a:ext>
             </a:extLst>
           </p:cNvPr>
@@ -21201,7 +21201,7 @@
           <p:cNvPr id="17" name="dashboard-preview">
             <a:extLst xmlns:a="http://schemas.openxmlformats.org/drawingml/2006/main">
               <a:ext uri="{FF2B5EF4-FFF2-40B4-BE49-F238E27FC236}">
-                <a16:creationId xmlns:a16="http://schemas.microsoft.com/office/drawing/2014/main" id="{F11FF85D-D5FF-495E-AE24-A3FBBAD8E8BC}"/>
+                <a16:creationId xmlns:a16="http://schemas.microsoft.com/office/drawing/2014/main" id="{6FC33AEB-880C-4542-AF2C-983459907C5F}"/>
               </a:ext>
             </a:extLst>
           </p:cNvPr>
@@ -21236,7 +21236,7 @@
           <p:cNvPr id="18" name="">
             <a:extLst xmlns:a="http://schemas.openxmlformats.org/drawingml/2006/main">
               <a:ext uri="{FF2B5EF4-FFF2-40B4-BE49-F238E27FC236}">
-                <a16:creationId xmlns:a16="http://schemas.microsoft.com/office/drawing/2014/main" id="{FF92D6A0-6E5A-4EFB-BDD0-E969C48BAD4F}"/>
+                <a16:creationId xmlns:a16="http://schemas.microsoft.com/office/drawing/2014/main" id="{1A2189F0-FC2A-447D-A2A4-B062DC2E9E3C}"/>
               </a:ext>
             </a:extLst>
           </p:cNvPr>
@@ -21298,7 +21298,7 @@
           <p:cNvPr id="19" name="">
             <a:extLst xmlns:a="http://schemas.openxmlformats.org/drawingml/2006/main">
               <a:ext uri="{FF2B5EF4-FFF2-40B4-BE49-F238E27FC236}">
-                <a16:creationId xmlns:a16="http://schemas.microsoft.com/office/drawing/2014/main" id="{274E63D7-2217-419B-B6E3-2BB2EE07DDC9}"/>
+                <a16:creationId xmlns:a16="http://schemas.microsoft.com/office/drawing/2014/main" id="{104C1B9D-C58B-4CE2-9827-B57EBE631272}"/>
               </a:ext>
             </a:extLst>
           </p:cNvPr>
@@ -21329,7 +21329,7 @@
           <p:cNvPr id="20" name="">
             <a:extLst xmlns:a="http://schemas.openxmlformats.org/drawingml/2006/main">
               <a:ext uri="{FF2B5EF4-FFF2-40B4-BE49-F238E27FC236}">
-                <a16:creationId xmlns:a16="http://schemas.microsoft.com/office/drawing/2014/main" id="{CFC42416-5BFD-4FE7-9A2C-754BC22BA425}"/>
+                <a16:creationId xmlns:a16="http://schemas.microsoft.com/office/drawing/2014/main" id="{E11EEDEC-BF47-4A82-BD97-9B71CBEFC620}"/>
               </a:ext>
             </a:extLst>
           </p:cNvPr>
@@ -21391,7 +21391,7 @@
           <p:cNvPr id="21" name="">
             <a:extLst xmlns:a="http://schemas.openxmlformats.org/drawingml/2006/main">
               <a:ext uri="{FF2B5EF4-FFF2-40B4-BE49-F238E27FC236}">
-                <a16:creationId xmlns:a16="http://schemas.microsoft.com/office/drawing/2014/main" id="{A252D44F-B319-42C4-BC9F-5077797492C6}"/>
+                <a16:creationId xmlns:a16="http://schemas.microsoft.com/office/drawing/2014/main" id="{533E33B5-A542-4860-8575-DA4180B8EA48}"/>
               </a:ext>
             </a:extLst>
           </p:cNvPr>
@@ -21422,7 +21422,7 @@
           <p:cNvPr id="22" name="">
             <a:extLst xmlns:a="http://schemas.openxmlformats.org/drawingml/2006/main">
               <a:ext uri="{FF2B5EF4-FFF2-40B4-BE49-F238E27FC236}">
-                <a16:creationId xmlns:a16="http://schemas.microsoft.com/office/drawing/2014/main" id="{2D6E790A-B0E5-4468-9573-5446FDC305E8}"/>
+                <a16:creationId xmlns:a16="http://schemas.microsoft.com/office/drawing/2014/main" id="{AB897459-2C5C-40DE-8D35-88FE75B0A133}"/>
               </a:ext>
             </a:extLst>
           </p:cNvPr>
@@ -21453,7 +21453,7 @@
           <p:cNvPr id="23" name="">
             <a:extLst xmlns:a="http://schemas.openxmlformats.org/drawingml/2006/main">
               <a:ext uri="{FF2B5EF4-FFF2-40B4-BE49-F238E27FC236}">
-                <a16:creationId xmlns:a16="http://schemas.microsoft.com/office/drawing/2014/main" id="{56286B4B-DA0E-4C2F-B041-5841798AF921}"/>
+                <a16:creationId xmlns:a16="http://schemas.microsoft.com/office/drawing/2014/main" id="{167341EF-CFC0-4548-85B2-AF8CE4D9CE5F}"/>
               </a:ext>
             </a:extLst>
           </p:cNvPr>
@@ -21486,7 +21486,7 @@
           <p:cNvPr id="24" name="">
             <a:extLst xmlns:a="http://schemas.openxmlformats.org/drawingml/2006/main">
               <a:ext uri="{FF2B5EF4-FFF2-40B4-BE49-F238E27FC236}">
-                <a16:creationId xmlns:a16="http://schemas.microsoft.com/office/drawing/2014/main" id="{505E21E2-EFE6-400C-864B-7169E5B2FD6A}"/>
+                <a16:creationId xmlns:a16="http://schemas.microsoft.com/office/drawing/2014/main" id="{0AB9D564-686A-481E-A287-895FDFC62AE3}"/>
               </a:ext>
             </a:extLst>
           </p:cNvPr>
@@ -21548,7 +21548,7 @@
           <p:cNvPr id="25" name="footer-rule-7">
             <a:extLst xmlns:a="http://schemas.openxmlformats.org/drawingml/2006/main">
               <a:ext uri="{FF2B5EF4-FFF2-40B4-BE49-F238E27FC236}">
-                <a16:creationId xmlns:a16="http://schemas.microsoft.com/office/drawing/2014/main" id="{791F3EC0-C106-47C3-A9DB-6685AA8C0C09}"/>
+                <a16:creationId xmlns:a16="http://schemas.microsoft.com/office/drawing/2014/main" id="{8064F24E-55B9-4324-A251-9744AFA37452}"/>
               </a:ext>
             </a:extLst>
           </p:cNvPr>
@@ -21579,7 +21579,7 @@
           <p:cNvPr id="26" name="footer-label-7">
             <a:extLst xmlns:a="http://schemas.openxmlformats.org/drawingml/2006/main">
               <a:ext uri="{FF2B5EF4-FFF2-40B4-BE49-F238E27FC236}">
-                <a16:creationId xmlns:a16="http://schemas.microsoft.com/office/drawing/2014/main" id="{561ABF90-4623-47AB-9AF1-8EF025842D35}"/>
+                <a16:creationId xmlns:a16="http://schemas.microsoft.com/office/drawing/2014/main" id="{2B009DAF-5ED8-4AF5-A726-1FD6B38BA00B}"/>
               </a:ext>
             </a:extLst>
           </p:cNvPr>
@@ -21641,7 +21641,7 @@
           <p:cNvPr id="27" name="footer-page-7">
             <a:extLst xmlns:a="http://schemas.openxmlformats.org/drawingml/2006/main">
               <a:ext uri="{FF2B5EF4-FFF2-40B4-BE49-F238E27FC236}">
-                <a16:creationId xmlns:a16="http://schemas.microsoft.com/office/drawing/2014/main" id="{BE51249D-DCFA-4223-BC73-16F7655798E4}"/>
+                <a16:creationId xmlns:a16="http://schemas.microsoft.com/office/drawing/2014/main" id="{FBCEF0D7-E0CC-4B1F-9733-EAC0844447C7}"/>
               </a:ext>
             </a:extLst>
           </p:cNvPr>
@@ -21701,7 +21701,7 @@
     </p:spTree>
     <p:extLst>
       <p:ext uri="{BB962C8B-B14F-4D97-AF65-F5344CB8AC3E}">
-        <p14:creationId xmlns:p14="http://schemas.microsoft.com/office/powerpoint/2010/main" val="726108846"/>
+        <p14:creationId xmlns:p14="http://schemas.microsoft.com/office/powerpoint/2010/main" val="695976809"/>
       </p:ext>
     </p:extLst>
   </p:cSld>
@@ -21732,7 +21732,7 @@
           <p:cNvPr id="26" name="side-accent-8">
             <a:extLst xmlns:a="http://schemas.openxmlformats.org/drawingml/2006/main">
               <a:ext uri="{FF2B5EF4-FFF2-40B4-BE49-F238E27FC236}">
-                <a16:creationId xmlns:a16="http://schemas.microsoft.com/office/drawing/2014/main" id="{0A95D1E5-853D-4B6F-A346-C5467F50A312}"/>
+                <a16:creationId xmlns:a16="http://schemas.microsoft.com/office/drawing/2014/main" id="{4FE0F47D-3E3E-4122-AC1F-CFC45FE5EA80}"/>
               </a:ext>
             </a:extLst>
           </p:cNvPr>
@@ -21763,7 +21763,7 @@
           <p:cNvPr id="2" name="kicker-8">
             <a:extLst xmlns:a="http://schemas.openxmlformats.org/drawingml/2006/main">
               <a:ext uri="{FF2B5EF4-FFF2-40B4-BE49-F238E27FC236}">
-                <a16:creationId xmlns:a16="http://schemas.microsoft.com/office/drawing/2014/main" id="{ECB10EBA-7E2F-4307-8AE4-7003D40A633B}"/>
+                <a16:creationId xmlns:a16="http://schemas.microsoft.com/office/drawing/2014/main" id="{0F27A498-3EA1-4D0F-B993-AD0E43168CCA}"/>
               </a:ext>
             </a:extLst>
           </p:cNvPr>
@@ -21825,7 +21825,7 @@
           <p:cNvPr id="3" name="title-8">
             <a:extLst xmlns:a="http://schemas.openxmlformats.org/drawingml/2006/main">
               <a:ext uri="{FF2B5EF4-FFF2-40B4-BE49-F238E27FC236}">
-                <a16:creationId xmlns:a16="http://schemas.microsoft.com/office/drawing/2014/main" id="{3C6555F9-73FF-4C43-A434-C1353B3463D5}"/>
+                <a16:creationId xmlns:a16="http://schemas.microsoft.com/office/drawing/2014/main" id="{014FA77E-9906-400B-A3B6-DE1DF5E4E9E7}"/>
               </a:ext>
             </a:extLst>
           </p:cNvPr>
@@ -21887,7 +21887,7 @@
           <p:cNvPr id="4" name="">
             <a:extLst xmlns:a="http://schemas.openxmlformats.org/drawingml/2006/main">
               <a:ext uri="{FF2B5EF4-FFF2-40B4-BE49-F238E27FC236}">
-                <a16:creationId xmlns:a16="http://schemas.microsoft.com/office/drawing/2014/main" id="{4A94C5F6-5099-4DB0-96AF-48E80B917392}"/>
+                <a16:creationId xmlns:a16="http://schemas.microsoft.com/office/drawing/2014/main" id="{994D7D68-1FA6-4250-A6C4-D8DFF08EE352}"/>
               </a:ext>
             </a:extLst>
           </p:cNvPr>
@@ -21949,7 +21949,7 @@
           <p:cNvPr id="5" name="">
             <a:extLst xmlns:a="http://schemas.openxmlformats.org/drawingml/2006/main">
               <a:ext uri="{FF2B5EF4-FFF2-40B4-BE49-F238E27FC236}">
-                <a16:creationId xmlns:a16="http://schemas.microsoft.com/office/drawing/2014/main" id="{30146459-07F0-403C-9CB8-8362D25B6A03}"/>
+                <a16:creationId xmlns:a16="http://schemas.microsoft.com/office/drawing/2014/main" id="{67DDB22E-5A7A-4874-B0E8-3C9F9E06BBC6}"/>
               </a:ext>
             </a:extLst>
           </p:cNvPr>
@@ -21980,7 +21980,7 @@
           <p:cNvPr id="6" name="">
             <a:extLst xmlns:a="http://schemas.openxmlformats.org/drawingml/2006/main">
               <a:ext uri="{FF2B5EF4-FFF2-40B4-BE49-F238E27FC236}">
-                <a16:creationId xmlns:a16="http://schemas.microsoft.com/office/drawing/2014/main" id="{D06D0F15-DDD2-4B90-A2ED-706499C56EF4}"/>
+                <a16:creationId xmlns:a16="http://schemas.microsoft.com/office/drawing/2014/main" id="{F64EB688-3194-4C9F-8DA4-AC09826E17FE}"/>
               </a:ext>
             </a:extLst>
           </p:cNvPr>
@@ -22011,7 +22011,7 @@
           <p:cNvPr id="7" name="">
             <a:extLst xmlns:a="http://schemas.openxmlformats.org/drawingml/2006/main">
               <a:ext uri="{FF2B5EF4-FFF2-40B4-BE49-F238E27FC236}">
-                <a16:creationId xmlns:a16="http://schemas.microsoft.com/office/drawing/2014/main" id="{A0C1EB3A-B6CE-45F8-A646-C870492BB6E1}"/>
+                <a16:creationId xmlns:a16="http://schemas.microsoft.com/office/drawing/2014/main" id="{C4B8BF0A-4BAD-446C-A143-8DB9770DA1B0}"/>
               </a:ext>
             </a:extLst>
           </p:cNvPr>
@@ -22073,7 +22073,7 @@
           <p:cNvPr id="8" name="">
             <a:extLst xmlns:a="http://schemas.openxmlformats.org/drawingml/2006/main">
               <a:ext uri="{FF2B5EF4-FFF2-40B4-BE49-F238E27FC236}">
-                <a16:creationId xmlns:a16="http://schemas.microsoft.com/office/drawing/2014/main" id="{E1EFF98E-77C6-486D-A294-0115953F5E98}"/>
+                <a16:creationId xmlns:a16="http://schemas.microsoft.com/office/drawing/2014/main" id="{F8113D44-E16F-48B4-AC13-6E8EF85E1643}"/>
               </a:ext>
             </a:extLst>
           </p:cNvPr>
@@ -22135,7 +22135,7 @@
           <p:cNvPr id="9" name="">
             <a:extLst xmlns:a="http://schemas.openxmlformats.org/drawingml/2006/main">
               <a:ext uri="{FF2B5EF4-FFF2-40B4-BE49-F238E27FC236}">
-                <a16:creationId xmlns:a16="http://schemas.microsoft.com/office/drawing/2014/main" id="{29E85E21-1696-4706-816C-669039BDC471}"/>
+                <a16:creationId xmlns:a16="http://schemas.microsoft.com/office/drawing/2014/main" id="{0F527775-953D-47CC-8B7A-D0CD99D59052}"/>
               </a:ext>
             </a:extLst>
           </p:cNvPr>
@@ -22197,7 +22197,7 @@
           <p:cNvPr id="10" name="">
             <a:extLst xmlns:a="http://schemas.openxmlformats.org/drawingml/2006/main">
               <a:ext uri="{FF2B5EF4-FFF2-40B4-BE49-F238E27FC236}">
-                <a16:creationId xmlns:a16="http://schemas.microsoft.com/office/drawing/2014/main" id="{845EFC7A-0B70-4CDF-B9AF-4EA40D94A08D}"/>
+                <a16:creationId xmlns:a16="http://schemas.microsoft.com/office/drawing/2014/main" id="{68F9BF01-0E21-4997-B954-1DD94545072B}"/>
               </a:ext>
             </a:extLst>
           </p:cNvPr>
@@ -22228,7 +22228,7 @@
           <p:cNvPr id="11" name="">
             <a:extLst xmlns:a="http://schemas.openxmlformats.org/drawingml/2006/main">
               <a:ext uri="{FF2B5EF4-FFF2-40B4-BE49-F238E27FC236}">
-                <a16:creationId xmlns:a16="http://schemas.microsoft.com/office/drawing/2014/main" id="{388EBD17-7FA6-423C-B890-E6C7F3D984B8}"/>
+                <a16:creationId xmlns:a16="http://schemas.microsoft.com/office/drawing/2014/main" id="{72D50489-B37F-4250-B792-246BFF7714D0}"/>
               </a:ext>
             </a:extLst>
           </p:cNvPr>
@@ -22290,7 +22290,7 @@
           <p:cNvPr id="12" name="">
             <a:extLst xmlns:a="http://schemas.openxmlformats.org/drawingml/2006/main">
               <a:ext uri="{FF2B5EF4-FFF2-40B4-BE49-F238E27FC236}">
-                <a16:creationId xmlns:a16="http://schemas.microsoft.com/office/drawing/2014/main" id="{0B38FC4A-DC23-45E5-9F55-89CF57E53646}"/>
+                <a16:creationId xmlns:a16="http://schemas.microsoft.com/office/drawing/2014/main" id="{C292A9EC-994F-4D34-A459-7C355575A7CB}"/>
               </a:ext>
             </a:extLst>
           </p:cNvPr>
@@ -22352,7 +22352,7 @@
           <p:cNvPr id="13" name="">
             <a:extLst xmlns:a="http://schemas.openxmlformats.org/drawingml/2006/main">
               <a:ext uri="{FF2B5EF4-FFF2-40B4-BE49-F238E27FC236}">
-                <a16:creationId xmlns:a16="http://schemas.microsoft.com/office/drawing/2014/main" id="{2423C092-F847-4ACB-AC8A-925C1FB4F584}"/>
+                <a16:creationId xmlns:a16="http://schemas.microsoft.com/office/drawing/2014/main" id="{6F362708-97F1-49EB-8F88-DBB1C726DBB6}"/>
               </a:ext>
             </a:extLst>
           </p:cNvPr>
@@ -22414,7 +22414,7 @@
           <p:cNvPr id="14" name="">
             <a:extLst xmlns:a="http://schemas.openxmlformats.org/drawingml/2006/main">
               <a:ext uri="{FF2B5EF4-FFF2-40B4-BE49-F238E27FC236}">
-                <a16:creationId xmlns:a16="http://schemas.microsoft.com/office/drawing/2014/main" id="{E4A09661-9DF4-486B-907C-D9053BAA06D9}"/>
+                <a16:creationId xmlns:a16="http://schemas.microsoft.com/office/drawing/2014/main" id="{40743ED6-BA12-4A6F-B845-8CF10FDE2A92}"/>
               </a:ext>
             </a:extLst>
           </p:cNvPr>
@@ -22445,7 +22445,7 @@
           <p:cNvPr id="15" name="">
             <a:extLst xmlns:a="http://schemas.openxmlformats.org/drawingml/2006/main">
               <a:ext uri="{FF2B5EF4-FFF2-40B4-BE49-F238E27FC236}">
-                <a16:creationId xmlns:a16="http://schemas.microsoft.com/office/drawing/2014/main" id="{7A128D72-DDAF-40E1-9814-638721FDD3F9}"/>
+                <a16:creationId xmlns:a16="http://schemas.microsoft.com/office/drawing/2014/main" id="{FE494A4D-8B8B-4127-8021-87F5F9C6BB50}"/>
               </a:ext>
             </a:extLst>
           </p:cNvPr>
@@ -22507,7 +22507,7 @@
           <p:cNvPr id="16" name="">
             <a:extLst xmlns:a="http://schemas.openxmlformats.org/drawingml/2006/main">
               <a:ext uri="{FF2B5EF4-FFF2-40B4-BE49-F238E27FC236}">
-                <a16:creationId xmlns:a16="http://schemas.microsoft.com/office/drawing/2014/main" id="{4FD8500A-5E93-4C21-9C27-FBE486B5936B}"/>
+                <a16:creationId xmlns:a16="http://schemas.microsoft.com/office/drawing/2014/main" id="{DDD46DAB-71CD-4363-B621-9B919AABAE67}"/>
               </a:ext>
             </a:extLst>
           </p:cNvPr>
@@ -22569,7 +22569,7 @@
           <p:cNvPr id="17" name="">
             <a:extLst xmlns:a="http://schemas.openxmlformats.org/drawingml/2006/main">
               <a:ext uri="{FF2B5EF4-FFF2-40B4-BE49-F238E27FC236}">
-                <a16:creationId xmlns:a16="http://schemas.microsoft.com/office/drawing/2014/main" id="{68625546-E0D5-45C3-BE2F-FBB2434FC61E}"/>
+                <a16:creationId xmlns:a16="http://schemas.microsoft.com/office/drawing/2014/main" id="{744F02FE-1819-42E3-A559-F76314F4F762}"/>
               </a:ext>
             </a:extLst>
           </p:cNvPr>
@@ -22631,7 +22631,7 @@
           <p:cNvPr id="18" name="">
             <a:extLst xmlns:a="http://schemas.openxmlformats.org/drawingml/2006/main">
               <a:ext uri="{FF2B5EF4-FFF2-40B4-BE49-F238E27FC236}">
-                <a16:creationId xmlns:a16="http://schemas.microsoft.com/office/drawing/2014/main" id="{4AF1985C-31C5-4EEE-8BC8-FDC5BAE3E982}"/>
+                <a16:creationId xmlns:a16="http://schemas.microsoft.com/office/drawing/2014/main" id="{3A8DEDEB-82A4-4FC4-96A5-FFB1E6592452}"/>
               </a:ext>
             </a:extLst>
           </p:cNvPr>
@@ -22662,7 +22662,7 @@
           <p:cNvPr id="19" name="">
             <a:extLst xmlns:a="http://schemas.openxmlformats.org/drawingml/2006/main">
               <a:ext uri="{FF2B5EF4-FFF2-40B4-BE49-F238E27FC236}">
-                <a16:creationId xmlns:a16="http://schemas.microsoft.com/office/drawing/2014/main" id="{6ED1CAB5-292B-4B85-A8C6-7510B503B436}"/>
+                <a16:creationId xmlns:a16="http://schemas.microsoft.com/office/drawing/2014/main" id="{71D149EB-D976-41FF-A0FE-5A720143CFDE}"/>
               </a:ext>
             </a:extLst>
           </p:cNvPr>
@@ -22724,7 +22724,7 @@
           <p:cNvPr id="20" name="">
             <a:extLst xmlns:a="http://schemas.openxmlformats.org/drawingml/2006/main">
               <a:ext uri="{FF2B5EF4-FFF2-40B4-BE49-F238E27FC236}">
-                <a16:creationId xmlns:a16="http://schemas.microsoft.com/office/drawing/2014/main" id="{792DDD77-E389-476E-942A-1C234317FB3D}"/>
+                <a16:creationId xmlns:a16="http://schemas.microsoft.com/office/drawing/2014/main" id="{D4F50438-E334-407C-ADE0-3826F0C92089}"/>
               </a:ext>
             </a:extLst>
           </p:cNvPr>
@@ -22786,7 +22786,7 @@
           <p:cNvPr id="21" name="">
             <a:extLst xmlns:a="http://schemas.openxmlformats.org/drawingml/2006/main">
               <a:ext uri="{FF2B5EF4-FFF2-40B4-BE49-F238E27FC236}">
-                <a16:creationId xmlns:a16="http://schemas.microsoft.com/office/drawing/2014/main" id="{2C6B4244-4E31-448A-BBB9-583D2514E45F}"/>
+                <a16:creationId xmlns:a16="http://schemas.microsoft.com/office/drawing/2014/main" id="{65C122F5-9436-452E-80BD-C69B8FFA12B7}"/>
               </a:ext>
             </a:extLst>
           </p:cNvPr>
@@ -22848,7 +22848,7 @@
           <p:cNvPr id="22" name="">
             <a:extLst xmlns:a="http://schemas.openxmlformats.org/drawingml/2006/main">
               <a:ext uri="{FF2B5EF4-FFF2-40B4-BE49-F238E27FC236}">
-                <a16:creationId xmlns:a16="http://schemas.microsoft.com/office/drawing/2014/main" id="{39C1130C-01A3-463C-9045-D5C4D2C29D13}"/>
+                <a16:creationId xmlns:a16="http://schemas.microsoft.com/office/drawing/2014/main" id="{2551F265-408B-4B9E-AFF6-8888E749E21F}"/>
               </a:ext>
             </a:extLst>
           </p:cNvPr>
@@ -22910,7 +22910,7 @@
           <p:cNvPr id="23" name="footer-rule-8">
             <a:extLst xmlns:a="http://schemas.openxmlformats.org/drawingml/2006/main">
               <a:ext uri="{FF2B5EF4-FFF2-40B4-BE49-F238E27FC236}">
-                <a16:creationId xmlns:a16="http://schemas.microsoft.com/office/drawing/2014/main" id="{B59AAB43-E89E-4EC7-AAEC-8E2E67524FA2}"/>
+                <a16:creationId xmlns:a16="http://schemas.microsoft.com/office/drawing/2014/main" id="{E49B474A-FB7B-4C71-9CED-6F23EFB1C46A}"/>
               </a:ext>
             </a:extLst>
           </p:cNvPr>
@@ -22941,7 +22941,7 @@
           <p:cNvPr id="24" name="footer-label-8">
             <a:extLst xmlns:a="http://schemas.openxmlformats.org/drawingml/2006/main">
               <a:ext uri="{FF2B5EF4-FFF2-40B4-BE49-F238E27FC236}">
-                <a16:creationId xmlns:a16="http://schemas.microsoft.com/office/drawing/2014/main" id="{33A64181-CBC0-4A19-9958-593D1994881F}"/>
+                <a16:creationId xmlns:a16="http://schemas.microsoft.com/office/drawing/2014/main" id="{F51C2937-3D2C-45E7-B245-911732EA55D4}"/>
               </a:ext>
             </a:extLst>
           </p:cNvPr>
@@ -23003,7 +23003,7 @@
           <p:cNvPr id="25" name="footer-page-8">
             <a:extLst xmlns:a="http://schemas.openxmlformats.org/drawingml/2006/main">
               <a:ext uri="{FF2B5EF4-FFF2-40B4-BE49-F238E27FC236}">
-                <a16:creationId xmlns:a16="http://schemas.microsoft.com/office/drawing/2014/main" id="{E1002F01-7438-42F8-ACB7-3C3F32CF525C}"/>
+                <a16:creationId xmlns:a16="http://schemas.microsoft.com/office/drawing/2014/main" id="{BFDEE606-B5A4-4BB6-AAF4-EB8234463FC1}"/>
               </a:ext>
             </a:extLst>
           </p:cNvPr>
@@ -23063,7 +23063,7 @@
     </p:spTree>
     <p:extLst>
       <p:ext uri="{BB962C8B-B14F-4D97-AF65-F5344CB8AC3E}">
-        <p14:creationId xmlns:p14="http://schemas.microsoft.com/office/powerpoint/2010/main" val="702474417"/>
+        <p14:creationId xmlns:p14="http://schemas.microsoft.com/office/powerpoint/2010/main" val="1753872912"/>
       </p:ext>
     </p:extLst>
   </p:cSld>
@@ -23094,7 +23094,7 @@
           <p:cNvPr id="25" name="side-accent-9">
             <a:extLst xmlns:a="http://schemas.openxmlformats.org/drawingml/2006/main">
               <a:ext uri="{FF2B5EF4-FFF2-40B4-BE49-F238E27FC236}">
-                <a16:creationId xmlns:a16="http://schemas.microsoft.com/office/drawing/2014/main" id="{5985D43E-F987-4619-8FFD-077FDE440262}"/>
+                <a16:creationId xmlns:a16="http://schemas.microsoft.com/office/drawing/2014/main" id="{C78283B8-FB1F-4507-AEC2-2AC92E883EEA}"/>
               </a:ext>
             </a:extLst>
           </p:cNvPr>
@@ -23125,7 +23125,7 @@
           <p:cNvPr id="2" name="kicker-9">
             <a:extLst xmlns:a="http://schemas.openxmlformats.org/drawingml/2006/main">
               <a:ext uri="{FF2B5EF4-FFF2-40B4-BE49-F238E27FC236}">
-                <a16:creationId xmlns:a16="http://schemas.microsoft.com/office/drawing/2014/main" id="{73F933FE-93F0-4E50-802C-96DA7D1DB06D}"/>
+                <a16:creationId xmlns:a16="http://schemas.microsoft.com/office/drawing/2014/main" id="{76960CCE-2440-4D95-AD36-0ABDDAE779EF}"/>
               </a:ext>
             </a:extLst>
           </p:cNvPr>
@@ -23187,7 +23187,7 @@
           <p:cNvPr id="3" name="title-9">
             <a:extLst xmlns:a="http://schemas.openxmlformats.org/drawingml/2006/main">
               <a:ext uri="{FF2B5EF4-FFF2-40B4-BE49-F238E27FC236}">
-                <a16:creationId xmlns:a16="http://schemas.microsoft.com/office/drawing/2014/main" id="{5FB83FF5-CD7E-49F4-8F36-3F2DB63A41CE}"/>
+                <a16:creationId xmlns:a16="http://schemas.microsoft.com/office/drawing/2014/main" id="{28EE3143-AB6E-47C3-9DD0-CD2FA106CFDE}"/>
               </a:ext>
             </a:extLst>
           </p:cNvPr>
@@ -23249,7 +23249,7 @@
           <p:cNvPr id="4" name="">
             <a:extLst xmlns:a="http://schemas.openxmlformats.org/drawingml/2006/main">
               <a:ext uri="{FF2B5EF4-FFF2-40B4-BE49-F238E27FC236}">
-                <a16:creationId xmlns:a16="http://schemas.microsoft.com/office/drawing/2014/main" id="{1219BCC3-EE5A-4DAF-9D9E-27ED59ECC3C4}"/>
+                <a16:creationId xmlns:a16="http://schemas.microsoft.com/office/drawing/2014/main" id="{3CA05851-C159-4D81-B8F0-0112A8831236}"/>
               </a:ext>
             </a:extLst>
           </p:cNvPr>
@@ -23311,7 +23311,7 @@
           <p:cNvPr id="5" name="">
             <a:extLst xmlns:a="http://schemas.openxmlformats.org/drawingml/2006/main">
               <a:ext uri="{FF2B5EF4-FFF2-40B4-BE49-F238E27FC236}">
-                <a16:creationId xmlns:a16="http://schemas.microsoft.com/office/drawing/2014/main" id="{3C43CAFE-E078-413E-B616-F01948507485}"/>
+                <a16:creationId xmlns:a16="http://schemas.microsoft.com/office/drawing/2014/main" id="{51F1FE74-0E03-4963-8C70-A3BF19B2C375}"/>
               </a:ext>
             </a:extLst>
           </p:cNvPr>
@@ -23346,7 +23346,7 @@
           <p:cNvPr id="6" name="">
             <a:extLst xmlns:a="http://schemas.openxmlformats.org/drawingml/2006/main">
               <a:ext uri="{FF2B5EF4-FFF2-40B4-BE49-F238E27FC236}">
-                <a16:creationId xmlns:a16="http://schemas.microsoft.com/office/drawing/2014/main" id="{84275875-31B9-4EF5-9DF7-9568FD06D9C4}"/>
+                <a16:creationId xmlns:a16="http://schemas.microsoft.com/office/drawing/2014/main" id="{EDE2C39B-79AB-4AE7-823E-0FC7EF980863}"/>
               </a:ext>
             </a:extLst>
           </p:cNvPr>
@@ -23408,7 +23408,7 @@
           <p:cNvPr id="7" name="">
             <a:extLst xmlns:a="http://schemas.openxmlformats.org/drawingml/2006/main">
               <a:ext uri="{FF2B5EF4-FFF2-40B4-BE49-F238E27FC236}">
-                <a16:creationId xmlns:a16="http://schemas.microsoft.com/office/drawing/2014/main" id="{405B07ED-4D87-428D-9CC0-B15F5BE10324}"/>
+                <a16:creationId xmlns:a16="http://schemas.microsoft.com/office/drawing/2014/main" id="{A8243402-3A60-404D-AAEA-451B10E01FDC}"/>
               </a:ext>
             </a:extLst>
           </p:cNvPr>
@@ -23470,7 +23470,7 @@
           <p:cNvPr id="8" name="">
             <a:extLst xmlns:a="http://schemas.openxmlformats.org/drawingml/2006/main">
               <a:ext uri="{FF2B5EF4-FFF2-40B4-BE49-F238E27FC236}">
-                <a16:creationId xmlns:a16="http://schemas.microsoft.com/office/drawing/2014/main" id="{7349E953-BA13-4DB5-B103-5DE0805D8927}"/>
+                <a16:creationId xmlns:a16="http://schemas.microsoft.com/office/drawing/2014/main" id="{D1A12859-5C03-495F-8E90-42038C40E1EC}"/>
               </a:ext>
             </a:extLst>
           </p:cNvPr>
@@ -23532,7 +23532,7 @@
           <p:cNvPr id="9" name="">
             <a:extLst xmlns:a="http://schemas.openxmlformats.org/drawingml/2006/main">
               <a:ext uri="{FF2B5EF4-FFF2-40B4-BE49-F238E27FC236}">
-                <a16:creationId xmlns:a16="http://schemas.microsoft.com/office/drawing/2014/main" id="{B9385952-E2A5-499E-B7FD-2C413CA2E95B}"/>
+                <a16:creationId xmlns:a16="http://schemas.microsoft.com/office/drawing/2014/main" id="{9CD0448E-C8E3-4125-9116-E93A58259B21}"/>
               </a:ext>
             </a:extLst>
           </p:cNvPr>
@@ -23567,7 +23567,7 @@
           <p:cNvPr id="10" name="">
             <a:extLst xmlns:a="http://schemas.openxmlformats.org/drawingml/2006/main">
               <a:ext uri="{FF2B5EF4-FFF2-40B4-BE49-F238E27FC236}">
-                <a16:creationId xmlns:a16="http://schemas.microsoft.com/office/drawing/2014/main" id="{A4F18D95-38BA-44BA-BF97-C65802916789}"/>
+                <a16:creationId xmlns:a16="http://schemas.microsoft.com/office/drawing/2014/main" id="{A16AB583-F6A4-4C15-BADD-F83CB489F450}"/>
               </a:ext>
             </a:extLst>
           </p:cNvPr>
@@ -23629,7 +23629,7 @@
           <p:cNvPr id="11" name="">
             <a:extLst xmlns:a="http://schemas.openxmlformats.org/drawingml/2006/main">
               <a:ext uri="{FF2B5EF4-FFF2-40B4-BE49-F238E27FC236}">
-                <a16:creationId xmlns:a16="http://schemas.microsoft.com/office/drawing/2014/main" id="{1B067939-5611-4B99-A1B6-B3A0BB55D1F6}"/>
+                <a16:creationId xmlns:a16="http://schemas.microsoft.com/office/drawing/2014/main" id="{B71544F7-7D4B-4980-8087-53E6D819C8FF}"/>
               </a:ext>
             </a:extLst>
           </p:cNvPr>
@@ -23691,7 +23691,7 @@
           <p:cNvPr id="12" name="">
             <a:extLst xmlns:a="http://schemas.openxmlformats.org/drawingml/2006/main">
               <a:ext uri="{FF2B5EF4-FFF2-40B4-BE49-F238E27FC236}">
-                <a16:creationId xmlns:a16="http://schemas.microsoft.com/office/drawing/2014/main" id="{FE683D6E-D1A8-4A9E-A3BF-702520A6ACC8}"/>
+                <a16:creationId xmlns:a16="http://schemas.microsoft.com/office/drawing/2014/main" id="{10822E94-38DA-4CC2-A5F4-21106C87999C}"/>
               </a:ext>
             </a:extLst>
           </p:cNvPr>
@@ -23753,7 +23753,7 @@
           <p:cNvPr id="13" name="">
             <a:extLst xmlns:a="http://schemas.openxmlformats.org/drawingml/2006/main">
               <a:ext uri="{FF2B5EF4-FFF2-40B4-BE49-F238E27FC236}">
-                <a16:creationId xmlns:a16="http://schemas.microsoft.com/office/drawing/2014/main" id="{77B93D2A-212E-451A-810F-B355992430D0}"/>
+                <a16:creationId xmlns:a16="http://schemas.microsoft.com/office/drawing/2014/main" id="{F196CFD2-8D3C-43B5-B82D-14024728343B}"/>
               </a:ext>
             </a:extLst>
           </p:cNvPr>
@@ -23788,7 +23788,7 @@
           <p:cNvPr id="14" name="">
             <a:extLst xmlns:a="http://schemas.openxmlformats.org/drawingml/2006/main">
               <a:ext uri="{FF2B5EF4-FFF2-40B4-BE49-F238E27FC236}">
-                <a16:creationId xmlns:a16="http://schemas.microsoft.com/office/drawing/2014/main" id="{346567A7-3AC8-49EE-B0D3-667E494A47D4}"/>
+                <a16:creationId xmlns:a16="http://schemas.microsoft.com/office/drawing/2014/main" id="{52348A75-E29F-48DB-B0A5-D54B4101DC42}"/>
               </a:ext>
             </a:extLst>
           </p:cNvPr>
@@ -23850,7 +23850,7 @@
           <p:cNvPr id="15" name="">
             <a:extLst xmlns:a="http://schemas.openxmlformats.org/drawingml/2006/main">
               <a:ext uri="{FF2B5EF4-FFF2-40B4-BE49-F238E27FC236}">
-                <a16:creationId xmlns:a16="http://schemas.microsoft.com/office/drawing/2014/main" id="{FFF9FB05-8C09-4AD3-9AB3-641AF0247A9F}"/>
+                <a16:creationId xmlns:a16="http://schemas.microsoft.com/office/drawing/2014/main" id="{5B1153C0-703F-4998-8461-2426DE0715BE}"/>
               </a:ext>
             </a:extLst>
           </p:cNvPr>
@@ -23912,7 +23912,7 @@
           <p:cNvPr id="16" name="">
             <a:extLst xmlns:a="http://schemas.openxmlformats.org/drawingml/2006/main">
               <a:ext uri="{FF2B5EF4-FFF2-40B4-BE49-F238E27FC236}">
-                <a16:creationId xmlns:a16="http://schemas.microsoft.com/office/drawing/2014/main" id="{976542B0-8547-4C49-A628-A3D3CD29753E}"/>
+                <a16:creationId xmlns:a16="http://schemas.microsoft.com/office/drawing/2014/main" id="{2995377B-80EA-4948-86C2-018686495D94}"/>
               </a:ext>
             </a:extLst>
           </p:cNvPr>
@@ -23974,7 +23974,7 @@
           <p:cNvPr id="17" name="">
             <a:extLst xmlns:a="http://schemas.openxmlformats.org/drawingml/2006/main">
               <a:ext uri="{FF2B5EF4-FFF2-40B4-BE49-F238E27FC236}">
-                <a16:creationId xmlns:a16="http://schemas.microsoft.com/office/drawing/2014/main" id="{F8D64A54-5519-43B6-9CBB-8EA1AB6111D5}"/>
+                <a16:creationId xmlns:a16="http://schemas.microsoft.com/office/drawing/2014/main" id="{EE5CFCB9-1D2A-4A3D-B7FC-08CC6CF3B500}"/>
               </a:ext>
             </a:extLst>
           </p:cNvPr>
@@ -24009,7 +24009,7 @@
           <p:cNvPr id="18" name="">
             <a:extLst xmlns:a="http://schemas.openxmlformats.org/drawingml/2006/main">
               <a:ext uri="{FF2B5EF4-FFF2-40B4-BE49-F238E27FC236}">
-                <a16:creationId xmlns:a16="http://schemas.microsoft.com/office/drawing/2014/main" id="{1A0D9EAF-3FB6-4281-AA40-9BB0C41BE6C2}"/>
+                <a16:creationId xmlns:a16="http://schemas.microsoft.com/office/drawing/2014/main" id="{7243B1B4-9EE7-4E39-BB5A-AC22FD153E5A}"/>
               </a:ext>
             </a:extLst>
           </p:cNvPr>
@@ -24071,7 +24071,7 @@
           <p:cNvPr id="19" name="">
             <a:extLst xmlns:a="http://schemas.openxmlformats.org/drawingml/2006/main">
               <a:ext uri="{FF2B5EF4-FFF2-40B4-BE49-F238E27FC236}">
-                <a16:creationId xmlns:a16="http://schemas.microsoft.com/office/drawing/2014/main" id="{96835626-E9B3-4B2F-95BB-905500C8AA4D}"/>
+                <a16:creationId xmlns:a16="http://schemas.microsoft.com/office/drawing/2014/main" id="{06C38341-A464-4487-ADF3-07416380F5B8}"/>
               </a:ext>
             </a:extLst>
           </p:cNvPr>
@@ -24133,7 +24133,7 @@
           <p:cNvPr id="20" name="">
             <a:extLst xmlns:a="http://schemas.openxmlformats.org/drawingml/2006/main">
               <a:ext uri="{FF2B5EF4-FFF2-40B4-BE49-F238E27FC236}">
-                <a16:creationId xmlns:a16="http://schemas.microsoft.com/office/drawing/2014/main" id="{84D65322-538E-4669-B2AF-445EF9E6B501}"/>
+                <a16:creationId xmlns:a16="http://schemas.microsoft.com/office/drawing/2014/main" id="{90014010-A5E1-49FB-AAD1-12D97D652C25}"/>
               </a:ext>
             </a:extLst>
           </p:cNvPr>
@@ -24195,7 +24195,7 @@
           <p:cNvPr id="21" name="">
             <a:extLst xmlns:a="http://schemas.openxmlformats.org/drawingml/2006/main">
               <a:ext uri="{FF2B5EF4-FFF2-40B4-BE49-F238E27FC236}">
-                <a16:creationId xmlns:a16="http://schemas.microsoft.com/office/drawing/2014/main" id="{7F5A54F6-F9BC-4857-BEE3-89C45A288192}"/>
+                <a16:creationId xmlns:a16="http://schemas.microsoft.com/office/drawing/2014/main" id="{27E363B8-F7EC-4FAA-B8B7-88DEECF3DA5C}"/>
               </a:ext>
             </a:extLst>
           </p:cNvPr>
@@ -24257,7 +24257,7 @@
           <p:cNvPr id="22" name="footer-rule-9">
             <a:extLst xmlns:a="http://schemas.openxmlformats.org/drawingml/2006/main">
               <a:ext uri="{FF2B5EF4-FFF2-40B4-BE49-F238E27FC236}">
-                <a16:creationId xmlns:a16="http://schemas.microsoft.com/office/drawing/2014/main" id="{4C945C22-18DA-4FF8-9529-7E68C6492EC1}"/>
+                <a16:creationId xmlns:a16="http://schemas.microsoft.com/office/drawing/2014/main" id="{89FA8AC9-30BD-4556-BE55-4BECFD2C5114}"/>
               </a:ext>
             </a:extLst>
           </p:cNvPr>
@@ -24288,7 +24288,7 @@
           <p:cNvPr id="23" name="footer-label-9">
             <a:extLst xmlns:a="http://schemas.openxmlformats.org/drawingml/2006/main">
               <a:ext uri="{FF2B5EF4-FFF2-40B4-BE49-F238E27FC236}">
-                <a16:creationId xmlns:a16="http://schemas.microsoft.com/office/drawing/2014/main" id="{5480F5E6-CAAC-447C-91B3-08FD81E2C3C0}"/>
+                <a16:creationId xmlns:a16="http://schemas.microsoft.com/office/drawing/2014/main" id="{A2A21B2A-8599-41DA-942C-22E78F04AD40}"/>
               </a:ext>
             </a:extLst>
           </p:cNvPr>
@@ -24350,7 +24350,7 @@
           <p:cNvPr id="24" name="footer-page-9">
             <a:extLst xmlns:a="http://schemas.openxmlformats.org/drawingml/2006/main">
               <a:ext uri="{FF2B5EF4-FFF2-40B4-BE49-F238E27FC236}">
-                <a16:creationId xmlns:a16="http://schemas.microsoft.com/office/drawing/2014/main" id="{B766764C-EF9B-45C1-A4F9-0C3D71EB3B5F}"/>
+                <a16:creationId xmlns:a16="http://schemas.microsoft.com/office/drawing/2014/main" id="{B92965BE-538F-4B1A-BAC2-BB338EF6EEE7}"/>
               </a:ext>
             </a:extLst>
           </p:cNvPr>
@@ -24410,7 +24410,7 @@
     </p:spTree>
     <p:extLst>
       <p:ext uri="{BB962C8B-B14F-4D97-AF65-F5344CB8AC3E}">
-        <p14:creationId xmlns:p14="http://schemas.microsoft.com/office/powerpoint/2010/main" val="569432134"/>
+        <p14:creationId xmlns:p14="http://schemas.microsoft.com/office/powerpoint/2010/main" val="1540877875"/>
       </p:ext>
     </p:extLst>
   </p:cSld>

</xml_diff>